<commit_message>
Add global prefetch margin evidence to manager deck
</commit_message>
<xml_diff>
--- a/sglang_direct_kv/artifacts/slides/agent_aware_kv_movement_manager_deck.pptx
+++ b/sglang_direct_kv/artifacts/slides/agent_aware_kv_movement_manager_deck.pptx
@@ -2,18 +2,19 @@
 <file path=ppt/presentation.xml><?xml version="1.0" encoding="utf-8"?>
 <p:presentation xmlns:p="http://schemas.openxmlformats.org/presentationml/2006/main">
   <p:sldMasterIdLst>
-    <p:sldMasterId xmlns:r="http://schemas.openxmlformats.org/officeDocument/2006/relationships" id="2147483648" r:id="Rfa00eb11843d4bc2"/>
+    <p:sldMasterId xmlns:r="http://schemas.openxmlformats.org/officeDocument/2006/relationships" id="2147483648" r:id="Rea2f3b2e08af44f7"/>
   </p:sldMasterIdLst>
   <p:notesMasterIdLst>
-    <p:notesMasterId xmlns:r="http://schemas.openxmlformats.org/officeDocument/2006/relationships" r:id="Rc4fa7c2f6d094a3c"/>
+    <p:notesMasterId xmlns:r="http://schemas.openxmlformats.org/officeDocument/2006/relationships" r:id="Rede9b1d8cd8847b6"/>
   </p:notesMasterIdLst>
   <p:sldIdLst>
-    <p:sldId xmlns:r="http://schemas.openxmlformats.org/officeDocument/2006/relationships" id="256" r:id="Re7c71b2ccdfb4b68"/>
-    <p:sldId xmlns:r="http://schemas.openxmlformats.org/officeDocument/2006/relationships" id="257" r:id="R536e8eeb992a49ab"/>
-    <p:sldId xmlns:r="http://schemas.openxmlformats.org/officeDocument/2006/relationships" id="258" r:id="R9db42e922a8b4c3a"/>
-    <p:sldId xmlns:r="http://schemas.openxmlformats.org/officeDocument/2006/relationships" id="259" r:id="R78d83a6c878d4765"/>
-    <p:sldId xmlns:r="http://schemas.openxmlformats.org/officeDocument/2006/relationships" id="260" r:id="Rb546ab3200894731"/>
-    <p:sldId xmlns:r="http://schemas.openxmlformats.org/officeDocument/2006/relationships" id="261" r:id="Rb5e8ac821d534cb3"/>
+    <p:sldId xmlns:r="http://schemas.openxmlformats.org/officeDocument/2006/relationships" id="256" r:id="R47780e98d4ba4e89"/>
+    <p:sldId xmlns:r="http://schemas.openxmlformats.org/officeDocument/2006/relationships" id="257" r:id="R93251a3c4ceb449c"/>
+    <p:sldId xmlns:r="http://schemas.openxmlformats.org/officeDocument/2006/relationships" id="258" r:id="R842fadeab3894f37"/>
+    <p:sldId xmlns:r="http://schemas.openxmlformats.org/officeDocument/2006/relationships" id="259" r:id="Rffe7b6e06a754a9d"/>
+    <p:sldId xmlns:r="http://schemas.openxmlformats.org/officeDocument/2006/relationships" id="260" r:id="R01057d24ff7e4320"/>
+    <p:sldId xmlns:r="http://schemas.openxmlformats.org/officeDocument/2006/relationships" id="261" r:id="R7677af7031d44c2c"/>
+    <p:sldId xmlns:r="http://schemas.openxmlformats.org/officeDocument/2006/relationships" id="262" r:id="Rf7c85b66392b4b72"/>
   </p:sldIdLst>
   <p:sldSz cx="12192000" cy="6858000"/>
   <p:notesSz cx="6858000" cy="9144000"/>
@@ -470,6 +471,11 @@
               <a:t>Local report: /Users/oluwolejaiyeoba/Documents/GitHub/agentic_hardware/sglang_direct_kv/artifacts/results/latest_master_report.html</a:t>
             </a:r>
           </a:p>
+          <a:p xmlns:a="http://schemas.openxmlformats.org/drawingml/2006/main">
+            <a:r>
+              <a:t>Backup report: /Users/oluwolejaiyeoba/Documents/GitHub/agentic_hardware/backups/latest_master_report-1.html</a:t>
+            </a:r>
+          </a:p>
         </p:txBody>
       </p:sp>
       <p:sp>
@@ -560,6 +566,11 @@
               <a:t>Local report: /Users/oluwolejaiyeoba/Documents/GitHub/agentic_hardware/sglang_direct_kv/artifacts/results/latest_master_report.html</a:t>
             </a:r>
           </a:p>
+          <a:p xmlns:a="http://schemas.openxmlformats.org/drawingml/2006/main">
+            <a:r>
+              <a:t>Backup report: /Users/oluwolejaiyeoba/Documents/GitHub/agentic_hardware/backups/latest_master_report-1.html</a:t>
+            </a:r>
+          </a:p>
         </p:txBody>
       </p:sp>
       <p:sp>
@@ -650,6 +661,11 @@
               <a:t>Local report: /Users/oluwolejaiyeoba/Documents/GitHub/agentic_hardware/sglang_direct_kv/artifacts/results/latest_master_report.html</a:t>
             </a:r>
           </a:p>
+          <a:p xmlns:a="http://schemas.openxmlformats.org/drawingml/2006/main">
+            <a:r>
+              <a:t>Backup report: /Users/oluwolejaiyeoba/Documents/GitHub/agentic_hardware/backups/latest_master_report-1.html</a:t>
+            </a:r>
+          </a:p>
         </p:txBody>
       </p:sp>
       <p:sp>
@@ -717,12 +733,12 @@
           <a:lstStyle xmlns:a="http://schemas.openxmlformats.org/drawingml/2006/main"/>
           <a:p xmlns:a="http://schemas.openxmlformats.org/drawingml/2006/main">
             <a:r>
-              <a:t>This is the aggregate evidence slide. The current controlled no-prefetch run reports 8 no-prefetch replay H2D gaps and 8 late H2D finishes.</a:t>
-            </a:r>
-          </a:p>
-          <a:p xmlns:a="http://schemas.openxmlformats.org/drawingml/2006/main">
-            <a:r>
-              <a:t>Measured claim source: Global Replay H2D Readiness table and dot plot in latest_master_report.html.</a:t>
+              <a:t>This slide is the global prefetch-attempt evidence. The backup report shows 114 matched prefetch attempts, 112 late, and 98.25% late.</a:t>
+            </a:r>
+          </a:p>
+          <a:p xmlns:a="http://schemas.openxmlformats.org/drawingml/2006/main">
+            <a:r>
+              <a:t>Use it to show that software prefetch through the normal serving path often misses tight replay windows.</a:t>
             </a:r>
           </a:p>
           <a:p xmlns:a="http://schemas.openxmlformats.org/drawingml/2006/main">
@@ -738,6 +754,11 @@
           <a:p xmlns:a="http://schemas.openxmlformats.org/drawingml/2006/main">
             <a:r>
               <a:t>Local report: /Users/oluwolejaiyeoba/Documents/GitHub/agentic_hardware/sglang_direct_kv/artifacts/results/latest_master_report.html</a:t>
+            </a:r>
+          </a:p>
+          <a:p xmlns:a="http://schemas.openxmlformats.org/drawingml/2006/main">
+            <a:r>
+              <a:t>Backup report: /Users/oluwolejaiyeoba/Documents/GitHub/agentic_hardware/backups/latest_master_report-1.html</a:t>
             </a:r>
           </a:p>
         </p:txBody>
@@ -807,12 +828,12 @@
           <a:lstStyle xmlns:a="http://schemas.openxmlformats.org/drawingml/2006/main"/>
           <a:p xmlns:a="http://schemas.openxmlformats.org/drawingml/2006/main">
             <a:r>
-              <a:t>This chart separates replay due, client submit, SGLang receive, scheduler queue/admit, H2D start, and H2D finish.</a:t>
-            </a:r>
-          </a:p>
-          <a:p xmlns:a="http://schemas.openxmlformats.org/drawingml/2006/main">
-            <a:r>
-              <a:t>The key manager takeaway: a hint-aware design should influence scheduling and priority, not merely request more copies.</a:t>
+              <a:t>This is the aggregate evidence slide. The current controlled no-prefetch run reports 8 no-prefetch replay H2D gaps and 8 late H2D finishes.</a:t>
+            </a:r>
+          </a:p>
+          <a:p xmlns:a="http://schemas.openxmlformats.org/drawingml/2006/main">
+            <a:r>
+              <a:t>Measured claim source: Global Replay H2D Readiness table and dot plot in latest_master_report.html.</a:t>
             </a:r>
           </a:p>
           <a:p xmlns:a="http://schemas.openxmlformats.org/drawingml/2006/main">
@@ -828,6 +849,11 @@
           <a:p xmlns:a="http://schemas.openxmlformats.org/drawingml/2006/main">
             <a:r>
               <a:t>Local report: /Users/oluwolejaiyeoba/Documents/GitHub/agentic_hardware/sglang_direct_kv/artifacts/results/latest_master_report.html</a:t>
+            </a:r>
+          </a:p>
+          <a:p xmlns:a="http://schemas.openxmlformats.org/drawingml/2006/main">
+            <a:r>
+              <a:t>Backup report: /Users/oluwolejaiyeoba/Documents/GitHub/agentic_hardware/backups/latest_master_report-1.html</a:t>
             </a:r>
           </a:p>
         </p:txBody>
@@ -897,6 +923,101 @@
           <a:lstStyle xmlns:a="http://schemas.openxmlformats.org/drawingml/2006/main"/>
           <a:p xmlns:a="http://schemas.openxmlformats.org/drawingml/2006/main">
             <a:r>
+              <a:t>This chart separates replay due, client submit, SGLang receive, scheduler queue/admit, H2D start, and H2D finish.</a:t>
+            </a:r>
+          </a:p>
+          <a:p xmlns:a="http://schemas.openxmlformats.org/drawingml/2006/main">
+            <a:r>
+              <a:t>The key manager takeaway: a hint-aware design should influence scheduling and priority, not merely request more copies.</a:t>
+            </a:r>
+          </a:p>
+          <a:p xmlns:a="http://schemas.openxmlformats.org/drawingml/2006/main">
+            <a:r>
+              <a:t/>
+            </a:r>
+          </a:p>
+          <a:p xmlns:a="http://schemas.openxmlformats.org/drawingml/2006/main">
+            <a:r>
+              <a:t>[Sources]</a:t>
+            </a:r>
+          </a:p>
+          <a:p xmlns:a="http://schemas.openxmlformats.org/drawingml/2006/main">
+            <a:r>
+              <a:t>Local report: /Users/oluwolejaiyeoba/Documents/GitHub/agentic_hardware/sglang_direct_kv/artifacts/results/latest_master_report.html</a:t>
+            </a:r>
+          </a:p>
+          <a:p xmlns:a="http://schemas.openxmlformats.org/drawingml/2006/main">
+            <a:r>
+              <a:t>Backup report: /Users/oluwolejaiyeoba/Documents/GitHub/agentic_hardware/backups/latest_master_report-1.html</a:t>
+            </a:r>
+          </a:p>
+        </p:txBody>
+      </p:sp>
+      <p:sp>
+        <p:nvSpPr>
+          <p:cNvPr id="4" name="Slide Number Placeholder 3"/>
+          <p:cNvSpPr>
+            <a:spLocks xmlns:a="http://schemas.openxmlformats.org/drawingml/2006/main" noGrp="1"/>
+          </p:cNvSpPr>
+          <p:nvPr>
+            <p:ph type="sldNum" idx="5"/>
+          </p:nvPr>
+        </p:nvSpPr>
+        <p:spPr/>
+        <p:txBody>
+          <a:bodyPr xmlns:a="http://schemas.openxmlformats.org/drawingml/2006/main"/>
+          <a:lstStyle xmlns:a="http://schemas.openxmlformats.org/drawingml/2006/main"/>
+          <a:p xmlns:a="http://schemas.openxmlformats.org/drawingml/2006/main"/>
+        </p:txBody>
+      </p:sp>
+    </p:spTree>
+  </p:cSld>
+  <p:clrMapOvr>
+    <a:masterClrMapping xmlns:a="http://schemas.openxmlformats.org/drawingml/2006/main"/>
+  </p:clrMapOvr>
+</p:notes>
+</file>
+
+<file path=ppt/notesSlides/notesSlide7.xml><?xml version="1.0" encoding="utf-8"?>
+<p:notes xmlns:p="http://schemas.openxmlformats.org/presentationml/2006/main">
+  <p:cSld>
+    <p:spTree>
+      <p:nvGrpSpPr>
+        <p:cNvPr id="1" name=""/>
+        <p:cNvGrpSpPr/>
+        <p:nvPr/>
+      </p:nvGrpSpPr>
+      <p:grpSpPr>
+        <a:xfrm xmlns:a="http://schemas.openxmlformats.org/drawingml/2006/main"/>
+      </p:grpSpPr>
+      <p:sp>
+        <p:nvSpPr>
+          <p:cNvPr id="2" name="Slide Image Placeholder 1"/>
+          <p:cNvSpPr>
+            <a:spLocks xmlns:a="http://schemas.openxmlformats.org/drawingml/2006/main" noGrp="1"/>
+          </p:cNvSpPr>
+          <p:nvPr>
+            <p:ph type="sldImg" idx="0"/>
+          </p:nvPr>
+        </p:nvSpPr>
+        <p:spPr/>
+      </p:sp>
+      <p:sp>
+        <p:nvSpPr>
+          <p:cNvPr id="3" name="Notes Placeholder 2"/>
+          <p:cNvSpPr>
+            <a:spLocks xmlns:a="http://schemas.openxmlformats.org/drawingml/2006/main" noGrp="1"/>
+          </p:cNvSpPr>
+          <p:nvPr>
+            <p:ph type="body" idx="1"/>
+          </p:nvPr>
+        </p:nvSpPr>
+        <p:spPr/>
+        <p:txBody>
+          <a:bodyPr xmlns:a="http://schemas.openxmlformats.org/drawingml/2006/main"/>
+          <a:lstStyle xmlns:a="http://schemas.openxmlformats.org/drawingml/2006/main"/>
+          <a:p xmlns:a="http://schemas.openxmlformats.org/drawingml/2006/main">
+            <a:r>
               <a:t>Closing slide. This translates observed software/runtime behavior into concrete hardware support candidates.</a:t>
             </a:r>
           </a:p>
@@ -918,6 +1039,11 @@
           <a:p xmlns:a="http://schemas.openxmlformats.org/drawingml/2006/main">
             <a:r>
               <a:t>Local report: /Users/oluwolejaiyeoba/Documents/GitHub/agentic_hardware/sglang_direct_kv/artifacts/results/latest_master_report.html</a:t>
+            </a:r>
+          </a:p>
+          <a:p xmlns:a="http://schemas.openxmlformats.org/drawingml/2006/main">
+            <a:r>
+              <a:t>Backup report: /Users/oluwolejaiyeoba/Documents/GitHub/agentic_hardware/backups/latest_master_report-1.html</a:t>
             </a:r>
           </a:p>
         </p:txBody>
@@ -985,7 +1111,7 @@
   </p:cSld>
   <p:clrMap bg1="lt1" tx1="dk1" bg2="lt2" tx2="dk2" accent1="accent1" accent2="accent2" accent3="accent3" accent4="accent4" accent5="accent5" accent6="accent6" hlink="hlink" folHlink="folHlink"/>
   <p:sldLayoutIdLst>
-    <p:sldLayoutId xmlns:r="http://schemas.openxmlformats.org/officeDocument/2006/relationships" id="2147483649" r:id="R1fb5cc151ed64635"/>
+    <p:sldLayoutId xmlns:r="http://schemas.openxmlformats.org/officeDocument/2006/relationships" id="2147483649" r:id="R2785d58bf67c4c75"/>
   </p:sldLayoutIdLst>
   <p:txStyles>
     <p:titleStyle>
@@ -1536,7 +1662,7 @@
           <p:cNvPr id="19" name="">
             <a:extLst xmlns:a="http://schemas.openxmlformats.org/drawingml/2006/main">
               <a:ext uri="{FF2B5EF4-FFF2-40B4-BE49-F238E27FC236}">
-                <a16:creationId xmlns:a16="http://schemas.microsoft.com/office/drawing/2014/main" id="{E1EADB0F-49D7-4CE2-B0A9-A801DB2828FD}"/>
+                <a16:creationId xmlns:a16="http://schemas.microsoft.com/office/drawing/2014/main" id="{20958EC4-084F-43BB-A1DF-CD70852880F9}"/>
               </a:ext>
             </a:extLst>
           </p:cNvPr>
@@ -1586,7 +1712,7 @@
           <p:cNvPr id="2" name="">
             <a:extLst xmlns:a="http://schemas.openxmlformats.org/drawingml/2006/main">
               <a:ext uri="{FF2B5EF4-FFF2-40B4-BE49-F238E27FC236}">
-                <a16:creationId xmlns:a16="http://schemas.microsoft.com/office/drawing/2014/main" id="{6BFC5422-B85A-4062-A80A-91899F478BBE}"/>
+                <a16:creationId xmlns:a16="http://schemas.microsoft.com/office/drawing/2014/main" id="{B66BBBD2-6EE6-4ECA-8239-23AF8406C37A}"/>
               </a:ext>
             </a:extLst>
           </p:cNvPr>
@@ -1636,7 +1762,7 @@
           <p:cNvPr id="3" name="">
             <a:extLst xmlns:a="http://schemas.openxmlformats.org/drawingml/2006/main">
               <a:ext uri="{FF2B5EF4-FFF2-40B4-BE49-F238E27FC236}">
-                <a16:creationId xmlns:a16="http://schemas.microsoft.com/office/drawing/2014/main" id="{2346B395-41D7-4DA8-8046-43DE515C5FD5}"/>
+                <a16:creationId xmlns:a16="http://schemas.microsoft.com/office/drawing/2014/main" id="{9A24E77F-CD02-47D5-AAEF-DE45FC5B0CC6}"/>
               </a:ext>
             </a:extLst>
           </p:cNvPr>
@@ -1671,7 +1797,7 @@
           <p:cNvPr id="4" name="">
             <a:extLst xmlns:a="http://schemas.openxmlformats.org/drawingml/2006/main">
               <a:ext uri="{FF2B5EF4-FFF2-40B4-BE49-F238E27FC236}">
-                <a16:creationId xmlns:a16="http://schemas.microsoft.com/office/drawing/2014/main" id="{5CDCA6F9-0A55-44C6-BCFF-2BB2ED5EA59D}"/>
+                <a16:creationId xmlns:a16="http://schemas.microsoft.com/office/drawing/2014/main" id="{DE5EC0E3-6AB8-4D2E-9C63-CB8E4A05C396}"/>
               </a:ext>
             </a:extLst>
           </p:cNvPr>
@@ -1721,7 +1847,7 @@
           <p:cNvPr id="5" name="">
             <a:extLst xmlns:a="http://schemas.openxmlformats.org/drawingml/2006/main">
               <a:ext uri="{FF2B5EF4-FFF2-40B4-BE49-F238E27FC236}">
-                <a16:creationId xmlns:a16="http://schemas.microsoft.com/office/drawing/2014/main" id="{3D25C52C-49AD-49B3-9C94-F3D7DAE7E6D5}"/>
+                <a16:creationId xmlns:a16="http://schemas.microsoft.com/office/drawing/2014/main" id="{BB8B087B-1ECE-4428-B50C-16198F8AC04F}"/>
               </a:ext>
             </a:extLst>
           </p:cNvPr>
@@ -1771,7 +1897,7 @@
           <p:cNvPr id="6" name="">
             <a:extLst xmlns:a="http://schemas.openxmlformats.org/drawingml/2006/main">
               <a:ext uri="{FF2B5EF4-FFF2-40B4-BE49-F238E27FC236}">
-                <a16:creationId xmlns:a16="http://schemas.microsoft.com/office/drawing/2014/main" id="{314C0130-DBE0-4468-ACCF-D258A71299FE}"/>
+                <a16:creationId xmlns:a16="http://schemas.microsoft.com/office/drawing/2014/main" id="{CF7FCF74-2AB3-4C7F-83B6-CB6784D717B2}"/>
               </a:ext>
             </a:extLst>
           </p:cNvPr>
@@ -1806,7 +1932,7 @@
           <p:cNvPr id="7" name="">
             <a:extLst xmlns:a="http://schemas.openxmlformats.org/drawingml/2006/main">
               <a:ext uri="{FF2B5EF4-FFF2-40B4-BE49-F238E27FC236}">
-                <a16:creationId xmlns:a16="http://schemas.microsoft.com/office/drawing/2014/main" id="{1E08C2FC-5508-4010-BA3C-B3341B774DCB}"/>
+                <a16:creationId xmlns:a16="http://schemas.microsoft.com/office/drawing/2014/main" id="{589F69EF-6C4C-4083-8A32-48E931A86499}"/>
               </a:ext>
             </a:extLst>
           </p:cNvPr>
@@ -1856,7 +1982,7 @@
           <p:cNvPr id="8" name="">
             <a:extLst xmlns:a="http://schemas.openxmlformats.org/drawingml/2006/main">
               <a:ext uri="{FF2B5EF4-FFF2-40B4-BE49-F238E27FC236}">
-                <a16:creationId xmlns:a16="http://schemas.microsoft.com/office/drawing/2014/main" id="{F88700EC-2951-4905-8B22-F2C2CCCD6C61}"/>
+                <a16:creationId xmlns:a16="http://schemas.microsoft.com/office/drawing/2014/main" id="{0AF886A2-E72D-4E46-8EBF-9AC24BAAC2BC}"/>
               </a:ext>
             </a:extLst>
           </p:cNvPr>
@@ -1906,7 +2032,7 @@
           <p:cNvPr id="9" name="">
             <a:extLst xmlns:a="http://schemas.openxmlformats.org/drawingml/2006/main">
               <a:ext uri="{FF2B5EF4-FFF2-40B4-BE49-F238E27FC236}">
-                <a16:creationId xmlns:a16="http://schemas.microsoft.com/office/drawing/2014/main" id="{83552F68-4D7F-4B17-9DA3-30D866BF7066}"/>
+                <a16:creationId xmlns:a16="http://schemas.microsoft.com/office/drawing/2014/main" id="{85150986-ADBA-4011-98F3-5CE43E19C2DA}"/>
               </a:ext>
             </a:extLst>
           </p:cNvPr>
@@ -1941,7 +2067,7 @@
           <p:cNvPr id="10" name="">
             <a:extLst xmlns:a="http://schemas.openxmlformats.org/drawingml/2006/main">
               <a:ext uri="{FF2B5EF4-FFF2-40B4-BE49-F238E27FC236}">
-                <a16:creationId xmlns:a16="http://schemas.microsoft.com/office/drawing/2014/main" id="{9AAC68FE-02A0-47AD-AF3E-534568F2E09B}"/>
+                <a16:creationId xmlns:a16="http://schemas.microsoft.com/office/drawing/2014/main" id="{B2E751F7-8EA2-4655-B922-69DC2007FDF7}"/>
               </a:ext>
             </a:extLst>
           </p:cNvPr>
@@ -1991,7 +2117,7 @@
           <p:cNvPr id="11" name="">
             <a:extLst xmlns:a="http://schemas.openxmlformats.org/drawingml/2006/main">
               <a:ext uri="{FF2B5EF4-FFF2-40B4-BE49-F238E27FC236}">
-                <a16:creationId xmlns:a16="http://schemas.microsoft.com/office/drawing/2014/main" id="{180A168D-AEE5-450F-BCFA-A89B32B0E7D3}"/>
+                <a16:creationId xmlns:a16="http://schemas.microsoft.com/office/drawing/2014/main" id="{BED304B6-3BAC-45A6-9F6C-53E46FA450C9}"/>
               </a:ext>
             </a:extLst>
           </p:cNvPr>
@@ -2041,7 +2167,7 @@
           <p:cNvPr id="12" name="">
             <a:extLst xmlns:a="http://schemas.openxmlformats.org/drawingml/2006/main">
               <a:ext uri="{FF2B5EF4-FFF2-40B4-BE49-F238E27FC236}">
-                <a16:creationId xmlns:a16="http://schemas.microsoft.com/office/drawing/2014/main" id="{6598B410-883B-415E-8838-FCDF98902BC1}"/>
+                <a16:creationId xmlns:a16="http://schemas.microsoft.com/office/drawing/2014/main" id="{E64430C5-FA62-4ACA-8146-EAFD2DADB5F3}"/>
               </a:ext>
             </a:extLst>
           </p:cNvPr>
@@ -2076,7 +2202,7 @@
           <p:cNvPr id="13" name="">
             <a:extLst xmlns:a="http://schemas.openxmlformats.org/drawingml/2006/main">
               <a:ext uri="{FF2B5EF4-FFF2-40B4-BE49-F238E27FC236}">
-                <a16:creationId xmlns:a16="http://schemas.microsoft.com/office/drawing/2014/main" id="{10D09B33-DD66-4D3C-AD0D-19A3433E7FA1}"/>
+                <a16:creationId xmlns:a16="http://schemas.microsoft.com/office/drawing/2014/main" id="{5F3E27A1-E09F-4C1E-95A0-40BDC32B69E7}"/>
               </a:ext>
             </a:extLst>
           </p:cNvPr>
@@ -2126,7 +2252,7 @@
           <p:cNvPr id="14" name="">
             <a:extLst xmlns:a="http://schemas.openxmlformats.org/drawingml/2006/main">
               <a:ext uri="{FF2B5EF4-FFF2-40B4-BE49-F238E27FC236}">
-                <a16:creationId xmlns:a16="http://schemas.microsoft.com/office/drawing/2014/main" id="{AAC68ADA-B8F2-44E8-B318-0A3C714D159B}"/>
+                <a16:creationId xmlns:a16="http://schemas.microsoft.com/office/drawing/2014/main" id="{BB2B1A88-8AE0-4005-A8C8-2C92055BC963}"/>
               </a:ext>
             </a:extLst>
           </p:cNvPr>
@@ -2161,7 +2287,7 @@
           <p:cNvPr id="15" name="">
             <a:extLst xmlns:a="http://schemas.openxmlformats.org/drawingml/2006/main">
               <a:ext uri="{FF2B5EF4-FFF2-40B4-BE49-F238E27FC236}">
-                <a16:creationId xmlns:a16="http://schemas.microsoft.com/office/drawing/2014/main" id="{1CA53E67-9E98-4171-855B-32CCCA087FD3}"/>
+                <a16:creationId xmlns:a16="http://schemas.microsoft.com/office/drawing/2014/main" id="{9DF9BA3E-33EB-43D1-A170-376786FF6407}"/>
               </a:ext>
             </a:extLst>
           </p:cNvPr>
@@ -2211,7 +2337,7 @@
           <p:cNvPr id="16" name="">
             <a:extLst xmlns:a="http://schemas.openxmlformats.org/drawingml/2006/main">
               <a:ext uri="{FF2B5EF4-FFF2-40B4-BE49-F238E27FC236}">
-                <a16:creationId xmlns:a16="http://schemas.microsoft.com/office/drawing/2014/main" id="{FDA69DF9-D559-4C38-9F63-2B043D1A6646}"/>
+                <a16:creationId xmlns:a16="http://schemas.microsoft.com/office/drawing/2014/main" id="{1D4D829E-C3B5-4F3D-8D8B-D1A6A987F3FB}"/>
               </a:ext>
             </a:extLst>
           </p:cNvPr>
@@ -2261,7 +2387,7 @@
           <p:cNvPr id="17" name="">
             <a:extLst xmlns:a="http://schemas.openxmlformats.org/drawingml/2006/main">
               <a:ext uri="{FF2B5EF4-FFF2-40B4-BE49-F238E27FC236}">
-                <a16:creationId xmlns:a16="http://schemas.microsoft.com/office/drawing/2014/main" id="{23E669C1-2E8F-418E-88EA-2B0D78BE8D75}"/>
+                <a16:creationId xmlns:a16="http://schemas.microsoft.com/office/drawing/2014/main" id="{22F9DADA-61E4-4736-AAFD-9F448C83B97A}"/>
               </a:ext>
             </a:extLst>
           </p:cNvPr>
@@ -2311,7 +2437,7 @@
           <p:cNvPr id="18" name="">
             <a:extLst xmlns:a="http://schemas.openxmlformats.org/drawingml/2006/main">
               <a:ext uri="{FF2B5EF4-FFF2-40B4-BE49-F238E27FC236}">
-                <a16:creationId xmlns:a16="http://schemas.microsoft.com/office/drawing/2014/main" id="{1143D428-A9F1-40B3-B4C4-7C187E29F973}"/>
+                <a16:creationId xmlns:a16="http://schemas.microsoft.com/office/drawing/2014/main" id="{B57BD7DA-0E88-4657-B260-F843302001AD}"/>
               </a:ext>
             </a:extLst>
           </p:cNvPr>
@@ -2359,7 +2485,7 @@
     </p:spTree>
     <p:extLst>
       <p:ext uri="{BB962C8B-B14F-4D97-AF65-F5344CB8AC3E}">
-        <p14:creationId xmlns:p14="http://schemas.microsoft.com/office/powerpoint/2010/main" val="1913860813"/>
+        <p14:creationId xmlns:p14="http://schemas.microsoft.com/office/powerpoint/2010/main" val="468445094"/>
       </p:ext>
     </p:extLst>
   </p:cSld>
@@ -2390,7 +2516,7 @@
           <p:cNvPr id="26" name="">
             <a:extLst xmlns:a="http://schemas.openxmlformats.org/drawingml/2006/main">
               <a:ext uri="{FF2B5EF4-FFF2-40B4-BE49-F238E27FC236}">
-                <a16:creationId xmlns:a16="http://schemas.microsoft.com/office/drawing/2014/main" id="{2B9816FF-82DB-47D8-BFD4-C0F521FF65D3}"/>
+                <a16:creationId xmlns:a16="http://schemas.microsoft.com/office/drawing/2014/main" id="{5B304212-966E-44B6-8F26-05EBEC3CDA44}"/>
               </a:ext>
             </a:extLst>
           </p:cNvPr>
@@ -2440,7 +2566,7 @@
           <p:cNvPr id="2" name="">
             <a:extLst xmlns:a="http://schemas.openxmlformats.org/drawingml/2006/main">
               <a:ext uri="{FF2B5EF4-FFF2-40B4-BE49-F238E27FC236}">
-                <a16:creationId xmlns:a16="http://schemas.microsoft.com/office/drawing/2014/main" id="{F25883DB-1BD9-4D0F-94F9-03E265D58787}"/>
+                <a16:creationId xmlns:a16="http://schemas.microsoft.com/office/drawing/2014/main" id="{B7C767E8-0849-45F5-8D52-B4AB742D0800}"/>
               </a:ext>
             </a:extLst>
           </p:cNvPr>
@@ -2490,7 +2616,7 @@
           <p:cNvPr id="3" name="">
             <a:extLst xmlns:a="http://schemas.openxmlformats.org/drawingml/2006/main">
               <a:ext uri="{FF2B5EF4-FFF2-40B4-BE49-F238E27FC236}">
-                <a16:creationId xmlns:a16="http://schemas.microsoft.com/office/drawing/2014/main" id="{3BDD7703-BC4A-4289-AB95-7815F69B8A67}"/>
+                <a16:creationId xmlns:a16="http://schemas.microsoft.com/office/drawing/2014/main" id="{65934149-74FB-4362-932E-00984051B5CC}"/>
               </a:ext>
             </a:extLst>
           </p:cNvPr>
@@ -2525,7 +2651,7 @@
           <p:cNvPr id="4" name="">
             <a:extLst xmlns:a="http://schemas.openxmlformats.org/drawingml/2006/main">
               <a:ext uri="{FF2B5EF4-FFF2-40B4-BE49-F238E27FC236}">
-                <a16:creationId xmlns:a16="http://schemas.microsoft.com/office/drawing/2014/main" id="{FE46C4BD-9069-429D-80DE-D9FEE72A444B}"/>
+                <a16:creationId xmlns:a16="http://schemas.microsoft.com/office/drawing/2014/main" id="{BF92E4E6-4CE4-4DA4-90DF-A8DAFFA0F10B}"/>
               </a:ext>
             </a:extLst>
           </p:cNvPr>
@@ -2575,7 +2701,7 @@
           <p:cNvPr id="5" name="">
             <a:extLst xmlns:a="http://schemas.openxmlformats.org/drawingml/2006/main">
               <a:ext uri="{FF2B5EF4-FFF2-40B4-BE49-F238E27FC236}">
-                <a16:creationId xmlns:a16="http://schemas.microsoft.com/office/drawing/2014/main" id="{3D4B8AE5-3311-4E84-AF9D-7308ED14B4E8}"/>
+                <a16:creationId xmlns:a16="http://schemas.microsoft.com/office/drawing/2014/main" id="{705A6D02-8F02-4A1E-B67B-3C8DD6639D01}"/>
               </a:ext>
             </a:extLst>
           </p:cNvPr>
@@ -2606,7 +2732,7 @@
           <p:cNvPr id="6" name="">
             <a:extLst xmlns:a="http://schemas.openxmlformats.org/drawingml/2006/main">
               <a:ext uri="{FF2B5EF4-FFF2-40B4-BE49-F238E27FC236}">
-                <a16:creationId xmlns:a16="http://schemas.microsoft.com/office/drawing/2014/main" id="{6538A279-057D-4E2E-93AC-AB75E01A0DBF}"/>
+                <a16:creationId xmlns:a16="http://schemas.microsoft.com/office/drawing/2014/main" id="{3A2B59A9-B308-4E3E-9279-DACB36CB6F4C}"/>
               </a:ext>
             </a:extLst>
           </p:cNvPr>
@@ -2656,7 +2782,7 @@
           <p:cNvPr id="7" name="">
             <a:extLst xmlns:a="http://schemas.openxmlformats.org/drawingml/2006/main">
               <a:ext uri="{FF2B5EF4-FFF2-40B4-BE49-F238E27FC236}">
-                <a16:creationId xmlns:a16="http://schemas.microsoft.com/office/drawing/2014/main" id="{879039AE-5D83-4BF9-9BF3-57DEEF1E8989}"/>
+                <a16:creationId xmlns:a16="http://schemas.microsoft.com/office/drawing/2014/main" id="{823DF2F5-C198-4BC6-878B-21A46003FB84}"/>
               </a:ext>
             </a:extLst>
           </p:cNvPr>
@@ -2687,7 +2813,7 @@
           <p:cNvPr id="8" name="">
             <a:extLst xmlns:a="http://schemas.openxmlformats.org/drawingml/2006/main">
               <a:ext uri="{FF2B5EF4-FFF2-40B4-BE49-F238E27FC236}">
-                <a16:creationId xmlns:a16="http://schemas.microsoft.com/office/drawing/2014/main" id="{6D188110-02BD-4907-84D6-7BA362270349}"/>
+                <a16:creationId xmlns:a16="http://schemas.microsoft.com/office/drawing/2014/main" id="{2FA0C711-3EC2-4004-8707-E9942CD12346}"/>
               </a:ext>
             </a:extLst>
           </p:cNvPr>
@@ -2737,7 +2863,7 @@
           <p:cNvPr id="9" name="">
             <a:extLst xmlns:a="http://schemas.openxmlformats.org/drawingml/2006/main">
               <a:ext uri="{FF2B5EF4-FFF2-40B4-BE49-F238E27FC236}">
-                <a16:creationId xmlns:a16="http://schemas.microsoft.com/office/drawing/2014/main" id="{3E9ED247-F8A6-414A-8A3B-D629DB2914F5}"/>
+                <a16:creationId xmlns:a16="http://schemas.microsoft.com/office/drawing/2014/main" id="{BF0E8A9E-C64B-4EAA-BBF8-583CB1DF4FEA}"/>
               </a:ext>
             </a:extLst>
           </p:cNvPr>
@@ -2768,7 +2894,7 @@
           <p:cNvPr id="10" name="">
             <a:extLst xmlns:a="http://schemas.openxmlformats.org/drawingml/2006/main">
               <a:ext uri="{FF2B5EF4-FFF2-40B4-BE49-F238E27FC236}">
-                <a16:creationId xmlns:a16="http://schemas.microsoft.com/office/drawing/2014/main" id="{0F0C1390-3EDD-47AD-B7C1-4D49BA5DB898}"/>
+                <a16:creationId xmlns:a16="http://schemas.microsoft.com/office/drawing/2014/main" id="{5B063394-4E0A-4ACC-B624-84E082594B77}"/>
               </a:ext>
             </a:extLst>
           </p:cNvPr>
@@ -2818,7 +2944,7 @@
           <p:cNvPr id="11" name="">
             <a:extLst xmlns:a="http://schemas.openxmlformats.org/drawingml/2006/main">
               <a:ext uri="{FF2B5EF4-FFF2-40B4-BE49-F238E27FC236}">
-                <a16:creationId xmlns:a16="http://schemas.microsoft.com/office/drawing/2014/main" id="{4B627C1F-3A22-4047-9B73-43ED06EE6CAB}"/>
+                <a16:creationId xmlns:a16="http://schemas.microsoft.com/office/drawing/2014/main" id="{E7D7D880-0AC8-48F1-93B7-D6559F8D4A8B}"/>
               </a:ext>
             </a:extLst>
           </p:cNvPr>
@@ -2849,7 +2975,7 @@
           <p:cNvPr id="12" name="">
             <a:extLst xmlns:a="http://schemas.openxmlformats.org/drawingml/2006/main">
               <a:ext uri="{FF2B5EF4-FFF2-40B4-BE49-F238E27FC236}">
-                <a16:creationId xmlns:a16="http://schemas.microsoft.com/office/drawing/2014/main" id="{49006351-E643-42D5-858A-ED49B635FBAA}"/>
+                <a16:creationId xmlns:a16="http://schemas.microsoft.com/office/drawing/2014/main" id="{7BE8E679-ADDB-4925-B4CF-C41A7CA918FA}"/>
               </a:ext>
             </a:extLst>
           </p:cNvPr>
@@ -2899,7 +3025,7 @@
           <p:cNvPr id="13" name="">
             <a:extLst xmlns:a="http://schemas.openxmlformats.org/drawingml/2006/main">
               <a:ext uri="{FF2B5EF4-FFF2-40B4-BE49-F238E27FC236}">
-                <a16:creationId xmlns:a16="http://schemas.microsoft.com/office/drawing/2014/main" id="{CD53DA4A-4D9C-417F-AC68-92D9F9EA6C5A}"/>
+                <a16:creationId xmlns:a16="http://schemas.microsoft.com/office/drawing/2014/main" id="{D4A0AFAA-1A9D-4D87-A732-A83E2648C18B}"/>
               </a:ext>
             </a:extLst>
           </p:cNvPr>
@@ -2949,7 +3075,7 @@
           <p:cNvPr id="14" name="">
             <a:extLst xmlns:a="http://schemas.openxmlformats.org/drawingml/2006/main">
               <a:ext uri="{FF2B5EF4-FFF2-40B4-BE49-F238E27FC236}">
-                <a16:creationId xmlns:a16="http://schemas.microsoft.com/office/drawing/2014/main" id="{AD167537-B8AD-4AF9-9845-06CFB72A3685}"/>
+                <a16:creationId xmlns:a16="http://schemas.microsoft.com/office/drawing/2014/main" id="{7FEDF2CE-312F-40F4-A22A-BA6916369483}"/>
               </a:ext>
             </a:extLst>
           </p:cNvPr>
@@ -2984,7 +3110,7 @@
           <p:cNvPr id="15" name="">
             <a:extLst xmlns:a="http://schemas.openxmlformats.org/drawingml/2006/main">
               <a:ext uri="{FF2B5EF4-FFF2-40B4-BE49-F238E27FC236}">
-                <a16:creationId xmlns:a16="http://schemas.microsoft.com/office/drawing/2014/main" id="{BECA992A-F1A9-44AE-BCFF-FA7EF834B5E2}"/>
+                <a16:creationId xmlns:a16="http://schemas.microsoft.com/office/drawing/2014/main" id="{A9090AA3-28D2-4F87-89FE-DFA241B0007F}"/>
               </a:ext>
             </a:extLst>
           </p:cNvPr>
@@ -3034,7 +3160,7 @@
           <p:cNvPr id="16" name="">
             <a:extLst xmlns:a="http://schemas.openxmlformats.org/drawingml/2006/main">
               <a:ext uri="{FF2B5EF4-FFF2-40B4-BE49-F238E27FC236}">
-                <a16:creationId xmlns:a16="http://schemas.microsoft.com/office/drawing/2014/main" id="{176B00C8-7327-4FE3-A4D3-76B174DD0338}"/>
+                <a16:creationId xmlns:a16="http://schemas.microsoft.com/office/drawing/2014/main" id="{3815F2C9-5625-48F2-A652-A91309A84376}"/>
               </a:ext>
             </a:extLst>
           </p:cNvPr>
@@ -3065,7 +3191,7 @@
           <p:cNvPr id="17" name="">
             <a:extLst xmlns:a="http://schemas.openxmlformats.org/drawingml/2006/main">
               <a:ext uri="{FF2B5EF4-FFF2-40B4-BE49-F238E27FC236}">
-                <a16:creationId xmlns:a16="http://schemas.microsoft.com/office/drawing/2014/main" id="{F0957BDD-4FAD-4766-AA4E-9BA9BDB9B31C}"/>
+                <a16:creationId xmlns:a16="http://schemas.microsoft.com/office/drawing/2014/main" id="{2787C321-2A85-43AB-8EA6-64CD02863F8C}"/>
               </a:ext>
             </a:extLst>
           </p:cNvPr>
@@ -3115,7 +3241,7 @@
           <p:cNvPr id="18" name="">
             <a:extLst xmlns:a="http://schemas.openxmlformats.org/drawingml/2006/main">
               <a:ext uri="{FF2B5EF4-FFF2-40B4-BE49-F238E27FC236}">
-                <a16:creationId xmlns:a16="http://schemas.microsoft.com/office/drawing/2014/main" id="{D313D257-40BF-4374-9F9B-62998477244A}"/>
+                <a16:creationId xmlns:a16="http://schemas.microsoft.com/office/drawing/2014/main" id="{06599CE1-73D1-4EA2-A7DC-C294D366267B}"/>
               </a:ext>
             </a:extLst>
           </p:cNvPr>
@@ -3146,7 +3272,7 @@
           <p:cNvPr id="19" name="">
             <a:extLst xmlns:a="http://schemas.openxmlformats.org/drawingml/2006/main">
               <a:ext uri="{FF2B5EF4-FFF2-40B4-BE49-F238E27FC236}">
-                <a16:creationId xmlns:a16="http://schemas.microsoft.com/office/drawing/2014/main" id="{74376744-BFA4-4D97-862D-F1DDD59A22D6}"/>
+                <a16:creationId xmlns:a16="http://schemas.microsoft.com/office/drawing/2014/main" id="{9CCAA3CE-315E-4226-8F0B-54282A0E12CF}"/>
               </a:ext>
             </a:extLst>
           </p:cNvPr>
@@ -3196,7 +3322,7 @@
           <p:cNvPr id="20" name="">
             <a:extLst xmlns:a="http://schemas.openxmlformats.org/drawingml/2006/main">
               <a:ext uri="{FF2B5EF4-FFF2-40B4-BE49-F238E27FC236}">
-                <a16:creationId xmlns:a16="http://schemas.microsoft.com/office/drawing/2014/main" id="{677C9423-A854-44EC-B675-5A0B40431DB1}"/>
+                <a16:creationId xmlns:a16="http://schemas.microsoft.com/office/drawing/2014/main" id="{69C77716-AC4D-438B-819E-3C6E03A895AD}"/>
               </a:ext>
             </a:extLst>
           </p:cNvPr>
@@ -3227,7 +3353,7 @@
           <p:cNvPr id="21" name="">
             <a:extLst xmlns:a="http://schemas.openxmlformats.org/drawingml/2006/main">
               <a:ext uri="{FF2B5EF4-FFF2-40B4-BE49-F238E27FC236}">
-                <a16:creationId xmlns:a16="http://schemas.microsoft.com/office/drawing/2014/main" id="{2A14B436-7026-47C6-A5CD-0F91E359CE9A}"/>
+                <a16:creationId xmlns:a16="http://schemas.microsoft.com/office/drawing/2014/main" id="{0D760743-DAF0-47B2-BE49-F25DE27A8F08}"/>
               </a:ext>
             </a:extLst>
           </p:cNvPr>
@@ -3277,7 +3403,7 @@
           <p:cNvPr id="22" name="">
             <a:extLst xmlns:a="http://schemas.openxmlformats.org/drawingml/2006/main">
               <a:ext uri="{FF2B5EF4-FFF2-40B4-BE49-F238E27FC236}">
-                <a16:creationId xmlns:a16="http://schemas.microsoft.com/office/drawing/2014/main" id="{D7091C2F-BF4F-4848-85B0-F66C27909D12}"/>
+                <a16:creationId xmlns:a16="http://schemas.microsoft.com/office/drawing/2014/main" id="{9DFE107B-59B8-4E4F-B26A-CC3CE2124A79}"/>
               </a:ext>
             </a:extLst>
           </p:cNvPr>
@@ -3308,7 +3434,7 @@
           <p:cNvPr id="23" name="">
             <a:extLst xmlns:a="http://schemas.openxmlformats.org/drawingml/2006/main">
               <a:ext uri="{FF2B5EF4-FFF2-40B4-BE49-F238E27FC236}">
-                <a16:creationId xmlns:a16="http://schemas.microsoft.com/office/drawing/2014/main" id="{64CDA3F0-A3C5-4265-A88D-24BEED9A7B0F}"/>
+                <a16:creationId xmlns:a16="http://schemas.microsoft.com/office/drawing/2014/main" id="{2112F94A-343E-4C13-9FCA-922739F3E044}"/>
               </a:ext>
             </a:extLst>
           </p:cNvPr>
@@ -3358,7 +3484,7 @@
           <p:cNvPr id="24" name="">
             <a:extLst xmlns:a="http://schemas.openxmlformats.org/drawingml/2006/main">
               <a:ext uri="{FF2B5EF4-FFF2-40B4-BE49-F238E27FC236}">
-                <a16:creationId xmlns:a16="http://schemas.microsoft.com/office/drawing/2014/main" id="{86321EF2-579C-428C-9265-2F02C44B6580}"/>
+                <a16:creationId xmlns:a16="http://schemas.microsoft.com/office/drawing/2014/main" id="{1822698B-ACCB-4A5D-B2C5-4CAA67B92AD7}"/>
               </a:ext>
             </a:extLst>
           </p:cNvPr>
@@ -3408,7 +3534,7 @@
           <p:cNvPr id="25" name="">
             <a:extLst xmlns:a="http://schemas.openxmlformats.org/drawingml/2006/main">
               <a:ext uri="{FF2B5EF4-FFF2-40B4-BE49-F238E27FC236}">
-                <a16:creationId xmlns:a16="http://schemas.microsoft.com/office/drawing/2014/main" id="{93540BE4-AE03-4F46-BBAB-24A7E0B53686}"/>
+                <a16:creationId xmlns:a16="http://schemas.microsoft.com/office/drawing/2014/main" id="{F8DD5701-4380-4B90-A7B8-797450EE8224}"/>
               </a:ext>
             </a:extLst>
           </p:cNvPr>
@@ -3456,7 +3582,7 @@
     </p:spTree>
     <p:extLst>
       <p:ext uri="{BB962C8B-B14F-4D97-AF65-F5344CB8AC3E}">
-        <p14:creationId xmlns:p14="http://schemas.microsoft.com/office/powerpoint/2010/main" val="1450084744"/>
+        <p14:creationId xmlns:p14="http://schemas.microsoft.com/office/powerpoint/2010/main" val="139990614"/>
       </p:ext>
     </p:extLst>
   </p:cSld>
@@ -3487,7 +3613,7 @@
           <p:cNvPr id="9" name="">
             <a:extLst xmlns:a="http://schemas.openxmlformats.org/drawingml/2006/main">
               <a:ext uri="{FF2B5EF4-FFF2-40B4-BE49-F238E27FC236}">
-                <a16:creationId xmlns:a16="http://schemas.microsoft.com/office/drawing/2014/main" id="{38163A18-99A0-4379-85A1-D0A45360C536}"/>
+                <a16:creationId xmlns:a16="http://schemas.microsoft.com/office/drawing/2014/main" id="{DB3ADE53-E13F-41F7-A79A-14D52B544E70}"/>
               </a:ext>
             </a:extLst>
           </p:cNvPr>
@@ -3537,7 +3663,7 @@
           <p:cNvPr id="2" name="">
             <a:extLst xmlns:a="http://schemas.openxmlformats.org/drawingml/2006/main">
               <a:ext uri="{FF2B5EF4-FFF2-40B4-BE49-F238E27FC236}">
-                <a16:creationId xmlns:a16="http://schemas.microsoft.com/office/drawing/2014/main" id="{6312A94F-C273-4BEE-B9FE-11AC2B57953B}"/>
+                <a16:creationId xmlns:a16="http://schemas.microsoft.com/office/drawing/2014/main" id="{B493FE3B-4FFB-4768-9A74-4B4E5A626C93}"/>
               </a:ext>
             </a:extLst>
           </p:cNvPr>
@@ -3587,7 +3713,7 @@
           <p:cNvPr id="3" name="">
             <a:extLst xmlns:a="http://schemas.openxmlformats.org/drawingml/2006/main">
               <a:ext uri="{FF2B5EF4-FFF2-40B4-BE49-F238E27FC236}">
-                <a16:creationId xmlns:a16="http://schemas.microsoft.com/office/drawing/2014/main" id="{EBEC1DAE-30AC-4B83-9111-C74AFA4E3600}"/>
+                <a16:creationId xmlns:a16="http://schemas.microsoft.com/office/drawing/2014/main" id="{950B79B7-8E04-4876-A622-AEA2BFF9DCB4}"/>
               </a:ext>
             </a:extLst>
           </p:cNvPr>
@@ -3626,7 +3752,7 @@
           <p:nvPr/>
         </p:nvPicPr>
         <p:blipFill>
-          <a:blip xmlns:r="http://schemas.openxmlformats.org/officeDocument/2006/relationships" xmlns:a="http://schemas.openxmlformats.org/drawingml/2006/main" r:embed="R904f5982cc054184"/>
+          <a:blip xmlns:r="http://schemas.openxmlformats.org/officeDocument/2006/relationships" xmlns:a="http://schemas.openxmlformats.org/drawingml/2006/main" r:embed="Rd205bdf265774c30"/>
           <a:stretch xmlns:a="http://schemas.openxmlformats.org/drawingml/2006/main"/>
         </p:blipFill>
         <p:spPr>
@@ -3644,7 +3770,7 @@
           <p:cNvPr id="5" name="">
             <a:extLst xmlns:a="http://schemas.openxmlformats.org/drawingml/2006/main">
               <a:ext uri="{FF2B5EF4-FFF2-40B4-BE49-F238E27FC236}">
-                <a16:creationId xmlns:a16="http://schemas.microsoft.com/office/drawing/2014/main" id="{60AA29D9-33AE-4A38-B932-CE380C312566}"/>
+                <a16:creationId xmlns:a16="http://schemas.microsoft.com/office/drawing/2014/main" id="{52D6755A-EA72-432A-8A67-F04EE0EB7C18}"/>
               </a:ext>
             </a:extLst>
           </p:cNvPr>
@@ -3694,7 +3820,7 @@
           <p:cNvPr id="6" name="">
             <a:extLst xmlns:a="http://schemas.openxmlformats.org/drawingml/2006/main">
               <a:ext uri="{FF2B5EF4-FFF2-40B4-BE49-F238E27FC236}">
-                <a16:creationId xmlns:a16="http://schemas.microsoft.com/office/drawing/2014/main" id="{ECACF17E-B070-4BD0-8684-EAE2AF9349DE}"/>
+                <a16:creationId xmlns:a16="http://schemas.microsoft.com/office/drawing/2014/main" id="{C795AD1A-DCCC-4772-A762-235967C0BB5C}"/>
               </a:ext>
             </a:extLst>
           </p:cNvPr>
@@ -3744,7 +3870,7 @@
           <p:cNvPr id="7" name="">
             <a:extLst xmlns:a="http://schemas.openxmlformats.org/drawingml/2006/main">
               <a:ext uri="{FF2B5EF4-FFF2-40B4-BE49-F238E27FC236}">
-                <a16:creationId xmlns:a16="http://schemas.microsoft.com/office/drawing/2014/main" id="{4AA7C600-DBF5-41D8-8509-1E9C7981BE13}"/>
+                <a16:creationId xmlns:a16="http://schemas.microsoft.com/office/drawing/2014/main" id="{5F937485-B4BC-4C65-9DE2-6B6DE76B5420}"/>
               </a:ext>
             </a:extLst>
           </p:cNvPr>
@@ -3794,7 +3920,7 @@
           <p:cNvPr id="8" name="">
             <a:extLst xmlns:a="http://schemas.openxmlformats.org/drawingml/2006/main">
               <a:ext uri="{FF2B5EF4-FFF2-40B4-BE49-F238E27FC236}">
-                <a16:creationId xmlns:a16="http://schemas.microsoft.com/office/drawing/2014/main" id="{68F852B1-CB83-4FE9-AB51-DBE332E7B921}"/>
+                <a16:creationId xmlns:a16="http://schemas.microsoft.com/office/drawing/2014/main" id="{708DB562-E129-4645-A1BB-4BE0C85A4DAE}"/>
               </a:ext>
             </a:extLst>
           </p:cNvPr>
@@ -3842,7 +3968,7 @@
     </p:spTree>
     <p:extLst>
       <p:ext uri="{BB962C8B-B14F-4D97-AF65-F5344CB8AC3E}">
-        <p14:creationId xmlns:p14="http://schemas.microsoft.com/office/powerpoint/2010/main" val="910424356"/>
+        <p14:creationId xmlns:p14="http://schemas.microsoft.com/office/powerpoint/2010/main" val="1359854724"/>
       </p:ext>
     </p:extLst>
   </p:cSld>
@@ -3870,10 +3996,10 @@
       </p:grpSpPr>
       <p:sp>
         <p:nvSpPr>
-          <p:cNvPr id="12" name="">
-            <a:extLst xmlns:a="http://schemas.openxmlformats.org/drawingml/2006/main">
-              <a:ext uri="{FF2B5EF4-FFF2-40B4-BE49-F238E27FC236}">
-                <a16:creationId xmlns:a16="http://schemas.microsoft.com/office/drawing/2014/main" id="{836188FE-90CB-4A27-B381-1AD956EE46DC}"/>
+          <p:cNvPr id="16" name="">
+            <a:extLst xmlns:a="http://schemas.openxmlformats.org/drawingml/2006/main">
+              <a:ext uri="{FF2B5EF4-FFF2-40B4-BE49-F238E27FC236}">
+                <a16:creationId xmlns:a16="http://schemas.microsoft.com/office/drawing/2014/main" id="{AB2DC89D-F5AD-4BE0-8539-A09A028F752D}"/>
               </a:ext>
             </a:extLst>
           </p:cNvPr>
@@ -3913,7 +4039,7 @@
                   <a:srgbClr val="0F172A"/>
                 </a:solidFill>
               </a:rPr>
-              <a:t>Replay-side KV loads missed the deadline in this run</a:t>
+              <a:t>Software prefetch often missed the agent replay deadline</a:t>
             </a:r>
           </a:p>
         </p:txBody>
@@ -3923,7 +4049,7 @@
           <p:cNvPr id="2" name="">
             <a:extLst xmlns:a="http://schemas.openxmlformats.org/drawingml/2006/main">
               <a:ext uri="{FF2B5EF4-FFF2-40B4-BE49-F238E27FC236}">
-                <a16:creationId xmlns:a16="http://schemas.microsoft.com/office/drawing/2014/main" id="{B87C5E26-241B-4EBD-8478-3E89BEB517E6}"/>
+                <a16:creationId xmlns:a16="http://schemas.microsoft.com/office/drawing/2014/main" id="{B8CFC005-2488-4C43-A4D4-8DA48077A7DD}"/>
               </a:ext>
             </a:extLst>
           </p:cNvPr>
@@ -3963,7 +4089,7 @@
                   <a:srgbClr val="64748B"/>
                 </a:solidFill>
               </a:rPr>
-              <a:t>The aggregate view shows whether KV H2D finished before or after replay was due.</a:t>
+              <a:t>Across live prefetch attempts, nearly every hint completed after the agent had already resumed.</a:t>
             </a:r>
           </a:p>
         </p:txBody>
@@ -3973,7 +4099,7 @@
           <p:cNvPr id="3" name="">
             <a:extLst xmlns:a="http://schemas.openxmlformats.org/drawingml/2006/main">
               <a:ext uri="{FF2B5EF4-FFF2-40B4-BE49-F238E27FC236}">
-                <a16:creationId xmlns:a16="http://schemas.microsoft.com/office/drawing/2014/main" id="{C117C6C8-4513-44D6-BA61-040BC00ED473}"/>
+                <a16:creationId xmlns:a16="http://schemas.microsoft.com/office/drawing/2014/main" id="{5F646132-09D9-4A24-A5FD-C9849F83B36C}"/>
               </a:ext>
             </a:extLst>
           </p:cNvPr>
@@ -3985,11 +4111,11 @@
         <p:spPr>
           <a:xfrm xmlns:a="http://schemas.openxmlformats.org/drawingml/2006/main">
             <a:off x="323850" y="1428750"/>
-            <a:ext cx="8724900" cy="3867150"/>
+            <a:ext cx="8572500" cy="3886200"/>
           </a:xfrm>
           <a:prstGeom xmlns:a="http://schemas.openxmlformats.org/drawingml/2006/main" prst="roundRect">
             <a:avLst>
-              <a:gd name="adj" fmla="val 1478"/>
+              <a:gd name="adj" fmla="val 1471"/>
             </a:avLst>
           </a:prstGeom>
           <a:solidFill xmlns:a="http://schemas.openxmlformats.org/drawingml/2006/main">
@@ -4005,20 +4131,20 @@
       </p:sp>
       <p:pic>
         <p:nvPicPr>
-          <p:cNvPr id="15" name=""/>
+          <p:cNvPr id="19" name=""/>
           <p:cNvPicPr>
             <a:picLocks xmlns:a="http://schemas.openxmlformats.org/drawingml/2006/main" noChangeAspect="1"/>
           </p:cNvPicPr>
           <p:nvPr/>
         </p:nvPicPr>
         <p:blipFill>
-          <a:blip xmlns:r="http://schemas.openxmlformats.org/officeDocument/2006/relationships" xmlns:a="http://schemas.openxmlformats.org/drawingml/2006/main" r:embed="R569416af77ed4c3b"/>
+          <a:blip xmlns:r="http://schemas.openxmlformats.org/officeDocument/2006/relationships" xmlns:a="http://schemas.openxmlformats.org/drawingml/2006/main" r:embed="Rd8aac8461c814508"/>
           <a:stretch xmlns:a="http://schemas.openxmlformats.org/drawingml/2006/main"/>
         </p:blipFill>
         <p:spPr>
           <a:xfrm xmlns:a="http://schemas.openxmlformats.org/drawingml/2006/main">
-            <a:off x="400050" y="1795905"/>
-            <a:ext cx="8572500" cy="3132841"/>
+            <a:off x="400050" y="1890170"/>
+            <a:ext cx="8420100" cy="2963361"/>
           </a:xfrm>
           <a:prstGeom xmlns:a="http://schemas.openxmlformats.org/drawingml/2006/main" prst="rect">
             <a:avLst/>
@@ -4030,23 +4156,23 @@
           <p:cNvPr id="5" name="">
             <a:extLst xmlns:a="http://schemas.openxmlformats.org/drawingml/2006/main">
               <a:ext uri="{FF2B5EF4-FFF2-40B4-BE49-F238E27FC236}">
-                <a16:creationId xmlns:a16="http://schemas.microsoft.com/office/drawing/2014/main" id="{90792A0B-0123-47FF-8221-95836A8E622E}"/>
-              </a:ext>
-            </a:extLst>
-          </p:cNvPr>
-          <p:cNvSpPr>
-            <a:spLocks xmlns:a="http://schemas.openxmlformats.org/drawingml/2006/main" noGrp="1"/>
-          </p:cNvSpPr>
-          <p:nvPr/>
-        </p:nvSpPr>
-        <p:spPr>
-          <a:xfrm xmlns:a="http://schemas.openxmlformats.org/drawingml/2006/main">
-            <a:off x="9258300" y="1847850"/>
-            <a:ext cx="2095500" cy="1104900"/>
+                <a16:creationId xmlns:a16="http://schemas.microsoft.com/office/drawing/2014/main" id="{DAEFECA4-A6EB-4280-AA42-E6BAD723BACB}"/>
+              </a:ext>
+            </a:extLst>
+          </p:cNvPr>
+          <p:cNvSpPr>
+            <a:spLocks xmlns:a="http://schemas.openxmlformats.org/drawingml/2006/main" noGrp="1"/>
+          </p:cNvSpPr>
+          <p:nvPr/>
+        </p:nvSpPr>
+        <p:spPr>
+          <a:xfrm xmlns:a="http://schemas.openxmlformats.org/drawingml/2006/main">
+            <a:off x="9124950" y="1600200"/>
+            <a:ext cx="2228850" cy="1295400"/>
           </a:xfrm>
           <a:prstGeom xmlns:a="http://schemas.openxmlformats.org/drawingml/2006/main" prst="roundRect">
             <a:avLst>
-              <a:gd name="adj" fmla="val 5172"/>
+              <a:gd name="adj" fmla="val 4412"/>
             </a:avLst>
           </a:prstGeom>
           <a:solidFill xmlns:a="http://schemas.openxmlformats.org/drawingml/2006/main">
@@ -4065,19 +4191,19 @@
           <p:cNvPr id="6" name="">
             <a:extLst xmlns:a="http://schemas.openxmlformats.org/drawingml/2006/main">
               <a:ext uri="{FF2B5EF4-FFF2-40B4-BE49-F238E27FC236}">
-                <a16:creationId xmlns:a16="http://schemas.microsoft.com/office/drawing/2014/main" id="{2FE54ECA-C630-47F5-94F7-80416BE380D9}"/>
-              </a:ext>
-            </a:extLst>
-          </p:cNvPr>
-          <p:cNvSpPr>
-            <a:spLocks xmlns:a="http://schemas.openxmlformats.org/drawingml/2006/main" noGrp="1"/>
-          </p:cNvSpPr>
-          <p:nvPr/>
-        </p:nvSpPr>
-        <p:spPr>
-          <a:xfrm xmlns:a="http://schemas.openxmlformats.org/drawingml/2006/main">
-            <a:off x="9505950" y="2076450"/>
-            <a:ext cx="1600200" cy="476250"/>
+                <a16:creationId xmlns:a16="http://schemas.microsoft.com/office/drawing/2014/main" id="{630A0F74-3141-49BF-81A1-E2A2FFBDA679}"/>
+              </a:ext>
+            </a:extLst>
+          </p:cNvPr>
+          <p:cNvSpPr>
+            <a:spLocks xmlns:a="http://schemas.openxmlformats.org/drawingml/2006/main" noGrp="1"/>
+          </p:cNvSpPr>
+          <p:nvPr/>
+        </p:nvSpPr>
+        <p:spPr>
+          <a:xfrm xmlns:a="http://schemas.openxmlformats.org/drawingml/2006/main">
+            <a:off x="9296400" y="1809750"/>
+            <a:ext cx="1885950" cy="438150"/>
           </a:xfrm>
           <a:prstGeom xmlns:a="http://schemas.openxmlformats.org/drawingml/2006/main" prst="rect">
             <a:avLst/>
@@ -4093,19 +4219,19 @@
           <a:lstStyle xmlns:a="http://schemas.openxmlformats.org/drawingml/2006/main"/>
           <a:p xmlns:a="http://schemas.openxmlformats.org/drawingml/2006/main">
             <a:pPr algn="ctr">
-              <a:defRPr sz="3600" b="1">
+              <a:defRPr sz="2700" b="1">
                 <a:solidFill>
                   <a:srgbClr val="B91C1C"/>
                 </a:solidFill>
               </a:defRPr>
             </a:pPr>
             <a:r>
-              <a:rPr sz="3600" b="1">
+              <a:rPr sz="2700" b="1">
                 <a:solidFill>
                   <a:srgbClr val="B91C1C"/>
                 </a:solidFill>
               </a:rPr>
-              <a:t>8 / 8</a:t>
+              <a:t>112 of 114</a:t>
             </a:r>
           </a:p>
         </p:txBody>
@@ -4115,19 +4241,204 @@
           <p:cNvPr id="7" name="">
             <a:extLst xmlns:a="http://schemas.openxmlformats.org/drawingml/2006/main">
               <a:ext uri="{FF2B5EF4-FFF2-40B4-BE49-F238E27FC236}">
-                <a16:creationId xmlns:a16="http://schemas.microsoft.com/office/drawing/2014/main" id="{97F3314B-0F90-4F2A-AAA5-9570C38859E1}"/>
-              </a:ext>
-            </a:extLst>
-          </p:cNvPr>
-          <p:cNvSpPr>
-            <a:spLocks xmlns:a="http://schemas.openxmlformats.org/drawingml/2006/main" noGrp="1"/>
-          </p:cNvSpPr>
-          <p:nvPr/>
-        </p:nvSpPr>
-        <p:spPr>
-          <a:xfrm xmlns:a="http://schemas.openxmlformats.org/drawingml/2006/main">
-            <a:off x="9505950" y="2628900"/>
-            <a:ext cx="1600200" cy="266700"/>
+                <a16:creationId xmlns:a16="http://schemas.microsoft.com/office/drawing/2014/main" id="{24B4DBF1-0DBE-441B-A570-748E3F755D4C}"/>
+              </a:ext>
+            </a:extLst>
+          </p:cNvPr>
+          <p:cNvSpPr>
+            <a:spLocks xmlns:a="http://schemas.openxmlformats.org/drawingml/2006/main" noGrp="1"/>
+          </p:cNvSpPr>
+          <p:nvPr/>
+        </p:nvSpPr>
+        <p:spPr>
+          <a:xfrm xmlns:a="http://schemas.openxmlformats.org/drawingml/2006/main">
+            <a:off x="9353550" y="2324100"/>
+            <a:ext cx="1771650" cy="228600"/>
+          </a:xfrm>
+          <a:prstGeom xmlns:a="http://schemas.openxmlformats.org/drawingml/2006/main" prst="rect">
+            <a:avLst/>
+          </a:prstGeom>
+          <a:noFill xmlns:a="http://schemas.openxmlformats.org/drawingml/2006/main"/>
+          <a:ln xmlns:a="http://schemas.openxmlformats.org/drawingml/2006/main" w="0">
+            <a:noFill/>
+            <a:prstDash val="solid"/>
+          </a:ln>
+        </p:spPr>
+        <p:txBody>
+          <a:bodyPr xmlns:a="http://schemas.openxmlformats.org/drawingml/2006/main" anchor="t"/>
+          <a:lstStyle xmlns:a="http://schemas.openxmlformats.org/drawingml/2006/main"/>
+          <a:p xmlns:a="http://schemas.openxmlformats.org/drawingml/2006/main">
+            <a:pPr algn="ctr">
+              <a:defRPr sz="1350" b="0">
+                <a:solidFill>
+                  <a:srgbClr val="334155"/>
+                </a:solidFill>
+              </a:defRPr>
+            </a:pPr>
+            <a:r>
+              <a:rPr sz="1350" b="0">
+                <a:solidFill>
+                  <a:srgbClr val="334155"/>
+                </a:solidFill>
+              </a:rPr>
+              <a:t>prefetch attempts</a:t>
+            </a:r>
+          </a:p>
+        </p:txBody>
+      </p:sp>
+      <p:sp>
+        <p:nvSpPr>
+          <p:cNvPr id="8" name="">
+            <a:extLst xmlns:a="http://schemas.openxmlformats.org/drawingml/2006/main">
+              <a:ext uri="{FF2B5EF4-FFF2-40B4-BE49-F238E27FC236}">
+                <a16:creationId xmlns:a16="http://schemas.microsoft.com/office/drawing/2014/main" id="{48355EA9-4C13-40C2-87B6-973A4FA0269D}"/>
+              </a:ext>
+            </a:extLst>
+          </p:cNvPr>
+          <p:cNvSpPr>
+            <a:spLocks xmlns:a="http://schemas.openxmlformats.org/drawingml/2006/main" noGrp="1"/>
+          </p:cNvSpPr>
+          <p:nvPr/>
+        </p:nvSpPr>
+        <p:spPr>
+          <a:xfrm xmlns:a="http://schemas.openxmlformats.org/drawingml/2006/main">
+            <a:off x="9353550" y="2571750"/>
+            <a:ext cx="1771650" cy="228600"/>
+          </a:xfrm>
+          <a:prstGeom xmlns:a="http://schemas.openxmlformats.org/drawingml/2006/main" prst="rect">
+            <a:avLst/>
+          </a:prstGeom>
+          <a:noFill xmlns:a="http://schemas.openxmlformats.org/drawingml/2006/main"/>
+          <a:ln xmlns:a="http://schemas.openxmlformats.org/drawingml/2006/main" w="0">
+            <a:noFill/>
+            <a:prstDash val="solid"/>
+          </a:ln>
+        </p:spPr>
+        <p:txBody>
+          <a:bodyPr xmlns:a="http://schemas.openxmlformats.org/drawingml/2006/main" anchor="t"/>
+          <a:lstStyle xmlns:a="http://schemas.openxmlformats.org/drawingml/2006/main"/>
+          <a:p xmlns:a="http://schemas.openxmlformats.org/drawingml/2006/main">
+            <a:pPr algn="ctr">
+              <a:defRPr sz="1350" b="0">
+                <a:solidFill>
+                  <a:srgbClr val="334155"/>
+                </a:solidFill>
+              </a:defRPr>
+            </a:pPr>
+            <a:r>
+              <a:rPr sz="1350" b="0">
+                <a:solidFill>
+                  <a:srgbClr val="334155"/>
+                </a:solidFill>
+              </a:rPr>
+              <a:t>were late</a:t>
+            </a:r>
+          </a:p>
+        </p:txBody>
+      </p:sp>
+      <p:sp>
+        <p:nvSpPr>
+          <p:cNvPr id="9" name="">
+            <a:extLst xmlns:a="http://schemas.openxmlformats.org/drawingml/2006/main">
+              <a:ext uri="{FF2B5EF4-FFF2-40B4-BE49-F238E27FC236}">
+                <a16:creationId xmlns:a16="http://schemas.microsoft.com/office/drawing/2014/main" id="{21517459-C31F-4DFD-912F-D56AB4829B27}"/>
+              </a:ext>
+            </a:extLst>
+          </p:cNvPr>
+          <p:cNvSpPr>
+            <a:spLocks xmlns:a="http://schemas.openxmlformats.org/drawingml/2006/main" noGrp="1"/>
+          </p:cNvSpPr>
+          <p:nvPr/>
+        </p:nvSpPr>
+        <p:spPr>
+          <a:xfrm xmlns:a="http://schemas.openxmlformats.org/drawingml/2006/main">
+            <a:off x="9124950" y="3143250"/>
+            <a:ext cx="2228850" cy="1066800"/>
+          </a:xfrm>
+          <a:prstGeom xmlns:a="http://schemas.openxmlformats.org/drawingml/2006/main" prst="roundRect">
+            <a:avLst>
+              <a:gd name="adj" fmla="val 5357"/>
+            </a:avLst>
+          </a:prstGeom>
+          <a:solidFill xmlns:a="http://schemas.openxmlformats.org/drawingml/2006/main">
+            <a:srgbClr val="FFF7ED"/>
+          </a:solidFill>
+          <a:ln xmlns:a="http://schemas.openxmlformats.org/drawingml/2006/main" w="9525">
+            <a:solidFill>
+              <a:srgbClr val="FED7AA"/>
+            </a:solidFill>
+            <a:prstDash val="solid"/>
+          </a:ln>
+        </p:spPr>
+      </p:sp>
+      <p:sp>
+        <p:nvSpPr>
+          <p:cNvPr id="10" name="">
+            <a:extLst xmlns:a="http://schemas.openxmlformats.org/drawingml/2006/main">
+              <a:ext uri="{FF2B5EF4-FFF2-40B4-BE49-F238E27FC236}">
+                <a16:creationId xmlns:a16="http://schemas.microsoft.com/office/drawing/2014/main" id="{CC2AB3B5-2F41-4374-9EEF-154ADC9DB725}"/>
+              </a:ext>
+            </a:extLst>
+          </p:cNvPr>
+          <p:cNvSpPr>
+            <a:spLocks xmlns:a="http://schemas.openxmlformats.org/drawingml/2006/main" noGrp="1"/>
+          </p:cNvSpPr>
+          <p:nvPr/>
+        </p:nvSpPr>
+        <p:spPr>
+          <a:xfrm xmlns:a="http://schemas.openxmlformats.org/drawingml/2006/main">
+            <a:off x="9353550" y="3333750"/>
+            <a:ext cx="1771650" cy="419100"/>
+          </a:xfrm>
+          <a:prstGeom xmlns:a="http://schemas.openxmlformats.org/drawingml/2006/main" prst="rect">
+            <a:avLst/>
+          </a:prstGeom>
+          <a:noFill xmlns:a="http://schemas.openxmlformats.org/drawingml/2006/main"/>
+          <a:ln xmlns:a="http://schemas.openxmlformats.org/drawingml/2006/main" w="0">
+            <a:noFill/>
+            <a:prstDash val="solid"/>
+          </a:ln>
+        </p:spPr>
+        <p:txBody>
+          <a:bodyPr xmlns:a="http://schemas.openxmlformats.org/drawingml/2006/main" anchor="t"/>
+          <a:lstStyle xmlns:a="http://schemas.openxmlformats.org/drawingml/2006/main"/>
+          <a:p xmlns:a="http://schemas.openxmlformats.org/drawingml/2006/main">
+            <a:pPr algn="ctr">
+              <a:defRPr sz="3000" b="1">
+                <a:solidFill>
+                  <a:srgbClr val="C2410C"/>
+                </a:solidFill>
+              </a:defRPr>
+            </a:pPr>
+            <a:r>
+              <a:rPr sz="3000" b="1">
+                <a:solidFill>
+                  <a:srgbClr val="C2410C"/>
+                </a:solidFill>
+              </a:rPr>
+              <a:t>98.25%</a:t>
+            </a:r>
+          </a:p>
+        </p:txBody>
+      </p:sp>
+      <p:sp>
+        <p:nvSpPr>
+          <p:cNvPr id="11" name="">
+            <a:extLst xmlns:a="http://schemas.openxmlformats.org/drawingml/2006/main">
+              <a:ext uri="{FF2B5EF4-FFF2-40B4-BE49-F238E27FC236}">
+                <a16:creationId xmlns:a16="http://schemas.microsoft.com/office/drawing/2014/main" id="{9BCC6BA4-2D5E-4772-B54E-872AD8CDCCDC}"/>
+              </a:ext>
+            </a:extLst>
+          </p:cNvPr>
+          <p:cNvSpPr>
+            <a:spLocks xmlns:a="http://schemas.openxmlformats.org/drawingml/2006/main" noGrp="1"/>
+          </p:cNvSpPr>
+          <p:nvPr/>
+        </p:nvSpPr>
+        <p:spPr>
+          <a:xfrm xmlns:a="http://schemas.openxmlformats.org/drawingml/2006/main">
+            <a:off x="9353550" y="3829050"/>
+            <a:ext cx="1771650" cy="285750"/>
           </a:xfrm>
           <a:prstGeom xmlns:a="http://schemas.openxmlformats.org/drawingml/2006/main" prst="rect">
             <a:avLst/>
@@ -4155,29 +4466,29 @@
                   <a:srgbClr val="334155"/>
                 </a:solidFill>
               </a:rPr>
-              <a:t>H2D loads finished late</a:t>
-            </a:r>
-          </a:p>
-        </p:txBody>
-      </p:sp>
-      <p:sp>
-        <p:nvSpPr>
-          <p:cNvPr id="8" name="">
-            <a:extLst xmlns:a="http://schemas.openxmlformats.org/drawingml/2006/main">
-              <a:ext uri="{FF2B5EF4-FFF2-40B4-BE49-F238E27FC236}">
-                <a16:creationId xmlns:a16="http://schemas.microsoft.com/office/drawing/2014/main" id="{8F4B3A82-B3CB-4F20-BE6A-D0DFB1CBFB16}"/>
-              </a:ext>
-            </a:extLst>
-          </p:cNvPr>
-          <p:cNvSpPr>
-            <a:spLocks xmlns:a="http://schemas.openxmlformats.org/drawingml/2006/main" noGrp="1"/>
-          </p:cNvSpPr>
-          <p:nvPr/>
-        </p:nvSpPr>
-        <p:spPr>
-          <a:xfrm xmlns:a="http://schemas.openxmlformats.org/drawingml/2006/main">
-            <a:off x="9258300" y="3524250"/>
-            <a:ext cx="2095500" cy="742950"/>
+              <a:t>missed replay due deadline</a:t>
+            </a:r>
+          </a:p>
+        </p:txBody>
+      </p:sp>
+      <p:sp>
+        <p:nvSpPr>
+          <p:cNvPr id="12" name="">
+            <a:extLst xmlns:a="http://schemas.openxmlformats.org/drawingml/2006/main">
+              <a:ext uri="{FF2B5EF4-FFF2-40B4-BE49-F238E27FC236}">
+                <a16:creationId xmlns:a16="http://schemas.microsoft.com/office/drawing/2014/main" id="{C2CCD508-2D55-4BA3-9A16-94D2FAB9249E}"/>
+              </a:ext>
+            </a:extLst>
+          </p:cNvPr>
+          <p:cNvSpPr>
+            <a:spLocks xmlns:a="http://schemas.openxmlformats.org/drawingml/2006/main" noGrp="1"/>
+          </p:cNvSpPr>
+          <p:nvPr/>
+        </p:nvSpPr>
+        <p:spPr>
+          <a:xfrm xmlns:a="http://schemas.openxmlformats.org/drawingml/2006/main">
+            <a:off x="9124950" y="4514850"/>
+            <a:ext cx="2247900" cy="685800"/>
           </a:xfrm>
           <a:prstGeom xmlns:a="http://schemas.openxmlformats.org/drawingml/2006/main" prst="rect">
             <a:avLst/>
@@ -4193,29 +4504,29 @@
           <a:lstStyle xmlns:a="http://schemas.openxmlformats.org/drawingml/2006/main"/>
           <a:p xmlns:a="http://schemas.openxmlformats.org/drawingml/2006/main">
             <a:pPr algn="l">
-              <a:defRPr sz="1575" b="0">
+              <a:defRPr sz="1500" b="0">
                 <a:solidFill>
                   <a:srgbClr val="334155"/>
                 </a:solidFill>
               </a:defRPr>
             </a:pPr>
             <a:r>
-              <a:rPr sz="1575" b="0">
+              <a:rPr sz="1500" b="0">
                 <a:solidFill>
                   <a:srgbClr val="334155"/>
                 </a:solidFill>
               </a:rPr>
-              <a:t>All visible replay-side KV loads finished below the 0 ms deadline line.</a:t>
-            </a:r>
-          </a:p>
-        </p:txBody>
-      </p:sp>
-      <p:sp>
-        <p:nvSpPr>
-          <p:cNvPr id="9" name="">
-            <a:extLst xmlns:a="http://schemas.openxmlformats.org/drawingml/2006/main">
-              <a:ext uri="{FF2B5EF4-FFF2-40B4-BE49-F238E27FC236}">
-                <a16:creationId xmlns:a16="http://schemas.microsoft.com/office/drawing/2014/main" id="{8E81CAC6-A636-46AE-B27D-9D6BD94352AB}"/>
+              <a:t>This shows that semantic knowledge alone is not enough if the movement path cannot act on hints predictably.</a:t>
+            </a:r>
+          </a:p>
+        </p:txBody>
+      </p:sp>
+      <p:sp>
+        <p:nvSpPr>
+          <p:cNvPr id="13" name="">
+            <a:extLst xmlns:a="http://schemas.openxmlformats.org/drawingml/2006/main">
+              <a:ext uri="{FF2B5EF4-FFF2-40B4-BE49-F238E27FC236}">
+                <a16:creationId xmlns:a16="http://schemas.microsoft.com/office/drawing/2014/main" id="{F32D7477-79BE-488A-AE55-6CC1F7610B93}"/>
               </a:ext>
             </a:extLst>
           </p:cNvPr>
@@ -4255,17 +4566,17 @@
                   <a:srgbClr val="64748B"/>
                 </a:solidFill>
               </a:rPr>
-              <a:t>Source: latest_master_report.html, Global Replay H2D Readiness</a:t>
-            </a:r>
-          </a:p>
-        </p:txBody>
-      </p:sp>
-      <p:sp>
-        <p:nvSpPr>
-          <p:cNvPr id="10" name="">
-            <a:extLst xmlns:a="http://schemas.openxmlformats.org/drawingml/2006/main">
-              <a:ext uri="{FF2B5EF4-FFF2-40B4-BE49-F238E27FC236}">
-                <a16:creationId xmlns:a16="http://schemas.microsoft.com/office/drawing/2014/main" id="{495E486E-DFBA-4005-8F65-E8B5E87301F2}"/>
+              <a:t>Source: backups/latest_master_report-1.html, Global Prefetch Margin</a:t>
+            </a:r>
+          </a:p>
+        </p:txBody>
+      </p:sp>
+      <p:sp>
+        <p:nvSpPr>
+          <p:cNvPr id="14" name="">
+            <a:extLst xmlns:a="http://schemas.openxmlformats.org/drawingml/2006/main">
+              <a:ext uri="{FF2B5EF4-FFF2-40B4-BE49-F238E27FC236}">
+                <a16:creationId xmlns:a16="http://schemas.microsoft.com/office/drawing/2014/main" id="{113422D1-3A7B-4DC6-9436-92AFF1C23ACA}"/>
               </a:ext>
             </a:extLst>
           </p:cNvPr>
@@ -4312,10 +4623,10 @@
       </p:sp>
       <p:sp>
         <p:nvSpPr>
-          <p:cNvPr id="11" name="">
-            <a:extLst xmlns:a="http://schemas.openxmlformats.org/drawingml/2006/main">
-              <a:ext uri="{FF2B5EF4-FFF2-40B4-BE49-F238E27FC236}">
-                <a16:creationId xmlns:a16="http://schemas.microsoft.com/office/drawing/2014/main" id="{D229F21F-B13D-423C-BD8B-1D71BD3347C9}"/>
+          <p:cNvPr id="15" name="">
+            <a:extLst xmlns:a="http://schemas.openxmlformats.org/drawingml/2006/main">
+              <a:ext uri="{FF2B5EF4-FFF2-40B4-BE49-F238E27FC236}">
+                <a16:creationId xmlns:a16="http://schemas.microsoft.com/office/drawing/2014/main" id="{390EF232-7664-4AFE-A323-CD44E0C519C8}"/>
               </a:ext>
             </a:extLst>
           </p:cNvPr>
@@ -4363,7 +4674,7 @@
     </p:spTree>
     <p:extLst>
       <p:ext uri="{BB962C8B-B14F-4D97-AF65-F5344CB8AC3E}">
-        <p14:creationId xmlns:p14="http://schemas.microsoft.com/office/powerpoint/2010/main" val="70773192"/>
+        <p14:creationId xmlns:p14="http://schemas.microsoft.com/office/powerpoint/2010/main" val="1853662573"/>
       </p:ext>
     </p:extLst>
   </p:cSld>
@@ -4391,10 +4702,10 @@
       </p:grpSpPr>
       <p:sp>
         <p:nvSpPr>
-          <p:cNvPr id="9" name="">
-            <a:extLst xmlns:a="http://schemas.openxmlformats.org/drawingml/2006/main">
-              <a:ext uri="{FF2B5EF4-FFF2-40B4-BE49-F238E27FC236}">
-                <a16:creationId xmlns:a16="http://schemas.microsoft.com/office/drawing/2014/main" id="{44749EED-AAFA-4359-A1A6-2D727E5F9620}"/>
+          <p:cNvPr id="12" name="">
+            <a:extLst xmlns:a="http://schemas.openxmlformats.org/drawingml/2006/main">
+              <a:ext uri="{FF2B5EF4-FFF2-40B4-BE49-F238E27FC236}">
+                <a16:creationId xmlns:a16="http://schemas.microsoft.com/office/drawing/2014/main" id="{5534C85D-6057-4C88-9AF6-4E72E7179DF7}"/>
               </a:ext>
             </a:extLst>
           </p:cNvPr>
@@ -4434,7 +4745,7 @@
                   <a:srgbClr val="0F172A"/>
                 </a:solidFill>
               </a:rPr>
-              <a:t>The delay is not just copy time</a:t>
+              <a:t>Replay-side KV loads missed the deadline in this run</a:t>
             </a:r>
           </a:p>
         </p:txBody>
@@ -4444,7 +4755,7 @@
           <p:cNvPr id="2" name="">
             <a:extLst xmlns:a="http://schemas.openxmlformats.org/drawingml/2006/main">
               <a:ext uri="{FF2B5EF4-FFF2-40B4-BE49-F238E27FC236}">
-                <a16:creationId xmlns:a16="http://schemas.microsoft.com/office/drawing/2014/main" id="{B163D638-3F9A-42F4-BF35-5ACCD656D1F7}"/>
+                <a16:creationId xmlns:a16="http://schemas.microsoft.com/office/drawing/2014/main" id="{86799D49-2C48-4D81-A49C-E339934F262C}"/>
               </a:ext>
             </a:extLst>
           </p:cNvPr>
@@ -4484,7 +4795,7 @@
                   <a:srgbClr val="64748B"/>
                 </a:solidFill>
               </a:rPr>
-              <a:t>The request enters normal software/runtime scheduling before visible KV H2D begins.</a:t>
+              <a:t>The aggregate view shows whether KV H2D finished before or after replay was due.</a:t>
             </a:r>
           </a:p>
         </p:txBody>
@@ -4494,23 +4805,23 @@
           <p:cNvPr id="3" name="">
             <a:extLst xmlns:a="http://schemas.openxmlformats.org/drawingml/2006/main">
               <a:ext uri="{FF2B5EF4-FFF2-40B4-BE49-F238E27FC236}">
-                <a16:creationId xmlns:a16="http://schemas.microsoft.com/office/drawing/2014/main" id="{689E3C96-1CAE-4F4A-B014-9ACD151D0297}"/>
-              </a:ext>
-            </a:extLst>
-          </p:cNvPr>
-          <p:cNvSpPr>
-            <a:spLocks xmlns:a="http://schemas.openxmlformats.org/drawingml/2006/main" noGrp="1"/>
-          </p:cNvSpPr>
-          <p:nvPr/>
-        </p:nvSpPr>
-        <p:spPr>
-          <a:xfrm xmlns:a="http://schemas.openxmlformats.org/drawingml/2006/main">
-            <a:off x="323850" y="1333500"/>
-            <a:ext cx="10820400" cy="4343400"/>
+                <a16:creationId xmlns:a16="http://schemas.microsoft.com/office/drawing/2014/main" id="{23F3C2D0-CCA3-4772-8CF8-0D091A9C4F66}"/>
+              </a:ext>
+            </a:extLst>
+          </p:cNvPr>
+          <p:cNvSpPr>
+            <a:spLocks xmlns:a="http://schemas.openxmlformats.org/drawingml/2006/main" noGrp="1"/>
+          </p:cNvSpPr>
+          <p:nvPr/>
+        </p:nvSpPr>
+        <p:spPr>
+          <a:xfrm xmlns:a="http://schemas.openxmlformats.org/drawingml/2006/main">
+            <a:off x="323850" y="1428750"/>
+            <a:ext cx="8724900" cy="3867150"/>
           </a:xfrm>
           <a:prstGeom xmlns:a="http://schemas.openxmlformats.org/drawingml/2006/main" prst="roundRect">
             <a:avLst>
-              <a:gd name="adj" fmla="val 1316"/>
+              <a:gd name="adj" fmla="val 1478"/>
             </a:avLst>
           </a:prstGeom>
           <a:solidFill xmlns:a="http://schemas.openxmlformats.org/drawingml/2006/main">
@@ -4526,20 +4837,20 @@
       </p:sp>
       <p:pic>
         <p:nvPicPr>
-          <p:cNvPr id="12" name=""/>
+          <p:cNvPr id="15" name=""/>
           <p:cNvPicPr>
             <a:picLocks xmlns:a="http://schemas.openxmlformats.org/drawingml/2006/main" noChangeAspect="1"/>
           </p:cNvPicPr>
           <p:nvPr/>
         </p:nvPicPr>
         <p:blipFill>
-          <a:blip xmlns:r="http://schemas.openxmlformats.org/officeDocument/2006/relationships" xmlns:a="http://schemas.openxmlformats.org/drawingml/2006/main" r:embed="R483368439f72412f"/>
+          <a:blip xmlns:r="http://schemas.openxmlformats.org/officeDocument/2006/relationships" xmlns:a="http://schemas.openxmlformats.org/drawingml/2006/main" r:embed="Rd0e0a79e4b864b1d"/>
           <a:stretch xmlns:a="http://schemas.openxmlformats.org/drawingml/2006/main"/>
         </p:blipFill>
         <p:spPr>
           <a:xfrm xmlns:a="http://schemas.openxmlformats.org/drawingml/2006/main">
-            <a:off x="1247835" y="1409700"/>
-            <a:ext cx="8972430" cy="4191000"/>
+            <a:off x="400050" y="1795905"/>
+            <a:ext cx="8572500" cy="3132841"/>
           </a:xfrm>
           <a:prstGeom xmlns:a="http://schemas.openxmlformats.org/drawingml/2006/main" prst="rect">
             <a:avLst/>
@@ -4551,19 +4862,154 @@
           <p:cNvPr id="5" name="">
             <a:extLst xmlns:a="http://schemas.openxmlformats.org/drawingml/2006/main">
               <a:ext uri="{FF2B5EF4-FFF2-40B4-BE49-F238E27FC236}">
-                <a16:creationId xmlns:a16="http://schemas.microsoft.com/office/drawing/2014/main" id="{46F4E18E-174D-4B0B-A9A4-161FD760894A}"/>
-              </a:ext>
-            </a:extLst>
-          </p:cNvPr>
-          <p:cNvSpPr>
-            <a:spLocks xmlns:a="http://schemas.openxmlformats.org/drawingml/2006/main" noGrp="1"/>
-          </p:cNvSpPr>
-          <p:nvPr/>
-        </p:nvSpPr>
-        <p:spPr>
-          <a:xfrm xmlns:a="http://schemas.openxmlformats.org/drawingml/2006/main">
-            <a:off x="685800" y="5791200"/>
-            <a:ext cx="9906000" cy="228600"/>
+                <a16:creationId xmlns:a16="http://schemas.microsoft.com/office/drawing/2014/main" id="{09EB8D9C-DBE0-4610-9A70-682BB6E8C8CF}"/>
+              </a:ext>
+            </a:extLst>
+          </p:cNvPr>
+          <p:cNvSpPr>
+            <a:spLocks xmlns:a="http://schemas.openxmlformats.org/drawingml/2006/main" noGrp="1"/>
+          </p:cNvSpPr>
+          <p:nvPr/>
+        </p:nvSpPr>
+        <p:spPr>
+          <a:xfrm xmlns:a="http://schemas.openxmlformats.org/drawingml/2006/main">
+            <a:off x="9258300" y="1847850"/>
+            <a:ext cx="2095500" cy="1104900"/>
+          </a:xfrm>
+          <a:prstGeom xmlns:a="http://schemas.openxmlformats.org/drawingml/2006/main" prst="roundRect">
+            <a:avLst>
+              <a:gd name="adj" fmla="val 5172"/>
+            </a:avLst>
+          </a:prstGeom>
+          <a:solidFill xmlns:a="http://schemas.openxmlformats.org/drawingml/2006/main">
+            <a:srgbClr val="FEF2F2"/>
+          </a:solidFill>
+          <a:ln xmlns:a="http://schemas.openxmlformats.org/drawingml/2006/main" w="9525">
+            <a:solidFill>
+              <a:srgbClr val="FECACA"/>
+            </a:solidFill>
+            <a:prstDash val="solid"/>
+          </a:ln>
+        </p:spPr>
+      </p:sp>
+      <p:sp>
+        <p:nvSpPr>
+          <p:cNvPr id="6" name="">
+            <a:extLst xmlns:a="http://schemas.openxmlformats.org/drawingml/2006/main">
+              <a:ext uri="{FF2B5EF4-FFF2-40B4-BE49-F238E27FC236}">
+                <a16:creationId xmlns:a16="http://schemas.microsoft.com/office/drawing/2014/main" id="{32DBEFC6-75E3-4F15-8AA6-15842CAFCF79}"/>
+              </a:ext>
+            </a:extLst>
+          </p:cNvPr>
+          <p:cNvSpPr>
+            <a:spLocks xmlns:a="http://schemas.openxmlformats.org/drawingml/2006/main" noGrp="1"/>
+          </p:cNvSpPr>
+          <p:nvPr/>
+        </p:nvSpPr>
+        <p:spPr>
+          <a:xfrm xmlns:a="http://schemas.openxmlformats.org/drawingml/2006/main">
+            <a:off x="9505950" y="2076450"/>
+            <a:ext cx="1600200" cy="476250"/>
+          </a:xfrm>
+          <a:prstGeom xmlns:a="http://schemas.openxmlformats.org/drawingml/2006/main" prst="rect">
+            <a:avLst/>
+          </a:prstGeom>
+          <a:noFill xmlns:a="http://schemas.openxmlformats.org/drawingml/2006/main"/>
+          <a:ln xmlns:a="http://schemas.openxmlformats.org/drawingml/2006/main" w="0">
+            <a:noFill/>
+            <a:prstDash val="solid"/>
+          </a:ln>
+        </p:spPr>
+        <p:txBody>
+          <a:bodyPr xmlns:a="http://schemas.openxmlformats.org/drawingml/2006/main" anchor="t"/>
+          <a:lstStyle xmlns:a="http://schemas.openxmlformats.org/drawingml/2006/main"/>
+          <a:p xmlns:a="http://schemas.openxmlformats.org/drawingml/2006/main">
+            <a:pPr algn="ctr">
+              <a:defRPr sz="3600" b="1">
+                <a:solidFill>
+                  <a:srgbClr val="B91C1C"/>
+                </a:solidFill>
+              </a:defRPr>
+            </a:pPr>
+            <a:r>
+              <a:rPr sz="3600" b="1">
+                <a:solidFill>
+                  <a:srgbClr val="B91C1C"/>
+                </a:solidFill>
+              </a:rPr>
+              <a:t>8 / 8</a:t>
+            </a:r>
+          </a:p>
+        </p:txBody>
+      </p:sp>
+      <p:sp>
+        <p:nvSpPr>
+          <p:cNvPr id="7" name="">
+            <a:extLst xmlns:a="http://schemas.openxmlformats.org/drawingml/2006/main">
+              <a:ext uri="{FF2B5EF4-FFF2-40B4-BE49-F238E27FC236}">
+                <a16:creationId xmlns:a16="http://schemas.microsoft.com/office/drawing/2014/main" id="{20E4A944-32A2-42B0-8057-20678AF1C78C}"/>
+              </a:ext>
+            </a:extLst>
+          </p:cNvPr>
+          <p:cNvSpPr>
+            <a:spLocks xmlns:a="http://schemas.openxmlformats.org/drawingml/2006/main" noGrp="1"/>
+          </p:cNvSpPr>
+          <p:nvPr/>
+        </p:nvSpPr>
+        <p:spPr>
+          <a:xfrm xmlns:a="http://schemas.openxmlformats.org/drawingml/2006/main">
+            <a:off x="9505950" y="2628900"/>
+            <a:ext cx="1600200" cy="266700"/>
+          </a:xfrm>
+          <a:prstGeom xmlns:a="http://schemas.openxmlformats.org/drawingml/2006/main" prst="rect">
+            <a:avLst/>
+          </a:prstGeom>
+          <a:noFill xmlns:a="http://schemas.openxmlformats.org/drawingml/2006/main"/>
+          <a:ln xmlns:a="http://schemas.openxmlformats.org/drawingml/2006/main" w="0">
+            <a:noFill/>
+            <a:prstDash val="solid"/>
+          </a:ln>
+        </p:spPr>
+        <p:txBody>
+          <a:bodyPr xmlns:a="http://schemas.openxmlformats.org/drawingml/2006/main" anchor="t"/>
+          <a:lstStyle xmlns:a="http://schemas.openxmlformats.org/drawingml/2006/main"/>
+          <a:p xmlns:a="http://schemas.openxmlformats.org/drawingml/2006/main">
+            <a:pPr algn="ctr">
+              <a:defRPr sz="1275" b="0">
+                <a:solidFill>
+                  <a:srgbClr val="334155"/>
+                </a:solidFill>
+              </a:defRPr>
+            </a:pPr>
+            <a:r>
+              <a:rPr sz="1275" b="0">
+                <a:solidFill>
+                  <a:srgbClr val="334155"/>
+                </a:solidFill>
+              </a:rPr>
+              <a:t>H2D loads finished late</a:t>
+            </a:r>
+          </a:p>
+        </p:txBody>
+      </p:sp>
+      <p:sp>
+        <p:nvSpPr>
+          <p:cNvPr id="8" name="">
+            <a:extLst xmlns:a="http://schemas.openxmlformats.org/drawingml/2006/main">
+              <a:ext uri="{FF2B5EF4-FFF2-40B4-BE49-F238E27FC236}">
+                <a16:creationId xmlns:a16="http://schemas.microsoft.com/office/drawing/2014/main" id="{AAB635A4-D551-40A1-A651-F0C1A4721D11}"/>
+              </a:ext>
+            </a:extLst>
+          </p:cNvPr>
+          <p:cNvSpPr>
+            <a:spLocks xmlns:a="http://schemas.openxmlformats.org/drawingml/2006/main" noGrp="1"/>
+          </p:cNvSpPr>
+          <p:nvPr/>
+        </p:nvSpPr>
+        <p:spPr>
+          <a:xfrm xmlns:a="http://schemas.openxmlformats.org/drawingml/2006/main">
+            <a:off x="9258300" y="3524250"/>
+            <a:ext cx="2095500" cy="742950"/>
           </a:xfrm>
           <a:prstGeom xmlns:a="http://schemas.openxmlformats.org/drawingml/2006/main" prst="rect">
             <a:avLst/>
@@ -4579,29 +5025,29 @@
           <a:lstStyle xmlns:a="http://schemas.openxmlformats.org/drawingml/2006/main"/>
           <a:p xmlns:a="http://schemas.openxmlformats.org/drawingml/2006/main">
             <a:pPr algn="l">
-              <a:defRPr sz="1275" b="0">
+              <a:defRPr sz="1575" b="0">
                 <a:solidFill>
                   <a:srgbClr val="334155"/>
                 </a:solidFill>
               </a:defRPr>
             </a:pPr>
             <a:r>
-              <a:rPr sz="1275" b="0">
+              <a:rPr sz="1575" b="0">
                 <a:solidFill>
                   <a:srgbClr val="334155"/>
                 </a:solidFill>
               </a:rPr>
-              <a:t>The stage markers separate submission, SGLang receive, scheduler queue/admit, and visible KV H2D movement.</a:t>
-            </a:r>
-          </a:p>
-        </p:txBody>
-      </p:sp>
-      <p:sp>
-        <p:nvSpPr>
-          <p:cNvPr id="6" name="">
-            <a:extLst xmlns:a="http://schemas.openxmlformats.org/drawingml/2006/main">
-              <a:ext uri="{FF2B5EF4-FFF2-40B4-BE49-F238E27FC236}">
-                <a16:creationId xmlns:a16="http://schemas.microsoft.com/office/drawing/2014/main" id="{4DA01D03-AC89-4290-93F6-7272C633CFD8}"/>
+              <a:t>All visible replay-side KV loads finished below the 0 ms deadline line.</a:t>
+            </a:r>
+          </a:p>
+        </p:txBody>
+      </p:sp>
+      <p:sp>
+        <p:nvSpPr>
+          <p:cNvPr id="9" name="">
+            <a:extLst xmlns:a="http://schemas.openxmlformats.org/drawingml/2006/main">
+              <a:ext uri="{FF2B5EF4-FFF2-40B4-BE49-F238E27FC236}">
+                <a16:creationId xmlns:a16="http://schemas.microsoft.com/office/drawing/2014/main" id="{CCA28ACA-C086-4CF9-AEA2-7496619A528C}"/>
               </a:ext>
             </a:extLst>
           </p:cNvPr>
@@ -4641,17 +5087,17 @@
                   <a:srgbClr val="64748B"/>
                 </a:solidFill>
               </a:rPr>
-              <a:t>Source: latest_master_report.html, Replay Queue Timeline vs H2D Start</a:t>
-            </a:r>
-          </a:p>
-        </p:txBody>
-      </p:sp>
-      <p:sp>
-        <p:nvSpPr>
-          <p:cNvPr id="7" name="">
-            <a:extLst xmlns:a="http://schemas.openxmlformats.org/drawingml/2006/main">
-              <a:ext uri="{FF2B5EF4-FFF2-40B4-BE49-F238E27FC236}">
-                <a16:creationId xmlns:a16="http://schemas.microsoft.com/office/drawing/2014/main" id="{1B4A36DA-B42D-4D5A-A089-4ACBB72920F9}"/>
+              <a:t>Source: latest_master_report.html, Global Replay H2D Readiness</a:t>
+            </a:r>
+          </a:p>
+        </p:txBody>
+      </p:sp>
+      <p:sp>
+        <p:nvSpPr>
+          <p:cNvPr id="10" name="">
+            <a:extLst xmlns:a="http://schemas.openxmlformats.org/drawingml/2006/main">
+              <a:ext uri="{FF2B5EF4-FFF2-40B4-BE49-F238E27FC236}">
+                <a16:creationId xmlns:a16="http://schemas.microsoft.com/office/drawing/2014/main" id="{9C7AF322-8E11-44C4-BDDA-936770C74CD4}"/>
               </a:ext>
             </a:extLst>
           </p:cNvPr>
@@ -4698,10 +5144,10 @@
       </p:sp>
       <p:sp>
         <p:nvSpPr>
-          <p:cNvPr id="8" name="">
-            <a:extLst xmlns:a="http://schemas.openxmlformats.org/drawingml/2006/main">
-              <a:ext uri="{FF2B5EF4-FFF2-40B4-BE49-F238E27FC236}">
-                <a16:creationId xmlns:a16="http://schemas.microsoft.com/office/drawing/2014/main" id="{C48ADDF0-503B-4A28-A3ED-65B32E8D5405}"/>
+          <p:cNvPr id="11" name="">
+            <a:extLst xmlns:a="http://schemas.openxmlformats.org/drawingml/2006/main">
+              <a:ext uri="{FF2B5EF4-FFF2-40B4-BE49-F238E27FC236}">
+                <a16:creationId xmlns:a16="http://schemas.microsoft.com/office/drawing/2014/main" id="{838BF824-E912-4F8D-91EA-516D138F72BE}"/>
               </a:ext>
             </a:extLst>
           </p:cNvPr>
@@ -4749,7 +5195,7 @@
     </p:spTree>
     <p:extLst>
       <p:ext uri="{BB962C8B-B14F-4D97-AF65-F5344CB8AC3E}">
-        <p14:creationId xmlns:p14="http://schemas.microsoft.com/office/powerpoint/2010/main" val="909645832"/>
+        <p14:creationId xmlns:p14="http://schemas.microsoft.com/office/powerpoint/2010/main" val="493676356"/>
       </p:ext>
     </p:extLst>
   </p:cSld>
@@ -4777,10 +5223,10 @@
       </p:grpSpPr>
       <p:sp>
         <p:nvSpPr>
-          <p:cNvPr id="27" name="">
-            <a:extLst xmlns:a="http://schemas.openxmlformats.org/drawingml/2006/main">
-              <a:ext uri="{FF2B5EF4-FFF2-40B4-BE49-F238E27FC236}">
-                <a16:creationId xmlns:a16="http://schemas.microsoft.com/office/drawing/2014/main" id="{7380A958-21D8-4D56-810F-DA3B104E3F16}"/>
+          <p:cNvPr id="9" name="">
+            <a:extLst xmlns:a="http://schemas.openxmlformats.org/drawingml/2006/main">
+              <a:ext uri="{FF2B5EF4-FFF2-40B4-BE49-F238E27FC236}">
+                <a16:creationId xmlns:a16="http://schemas.microsoft.com/office/drawing/2014/main" id="{6B33F2E9-22AF-4380-9DFA-4409422ECDA1}"/>
               </a:ext>
             </a:extLst>
           </p:cNvPr>
@@ -4820,7 +5266,7 @@
                   <a:srgbClr val="0F172A"/>
                 </a:solidFill>
               </a:rPr>
-              <a:t>Hardware support can make hints enforceable</a:t>
+              <a:t>The delay is not just copy time</a:t>
             </a:r>
           </a:p>
         </p:txBody>
@@ -4830,7 +5276,7 @@
           <p:cNvPr id="2" name="">
             <a:extLst xmlns:a="http://schemas.openxmlformats.org/drawingml/2006/main">
               <a:ext uri="{FF2B5EF4-FFF2-40B4-BE49-F238E27FC236}">
-                <a16:creationId xmlns:a16="http://schemas.microsoft.com/office/drawing/2014/main" id="{E0BBC465-D4D3-4B81-987D-F3A9108A37A2}"/>
+                <a16:creationId xmlns:a16="http://schemas.microsoft.com/office/drawing/2014/main" id="{007CDDEA-822B-4BE8-A35D-12140A59A157}"/>
               </a:ext>
             </a:extLst>
           </p:cNvPr>
@@ -4870,6 +5316,392 @@
                   <a:srgbClr val="64748B"/>
                 </a:solidFill>
               </a:rPr>
+              <a:t>The request enters normal software/runtime scheduling before visible KV H2D begins.</a:t>
+            </a:r>
+          </a:p>
+        </p:txBody>
+      </p:sp>
+      <p:sp>
+        <p:nvSpPr>
+          <p:cNvPr id="3" name="">
+            <a:extLst xmlns:a="http://schemas.openxmlformats.org/drawingml/2006/main">
+              <a:ext uri="{FF2B5EF4-FFF2-40B4-BE49-F238E27FC236}">
+                <a16:creationId xmlns:a16="http://schemas.microsoft.com/office/drawing/2014/main" id="{EB20A60D-E2AE-4FD5-9116-4E0AAB127BE3}"/>
+              </a:ext>
+            </a:extLst>
+          </p:cNvPr>
+          <p:cNvSpPr>
+            <a:spLocks xmlns:a="http://schemas.openxmlformats.org/drawingml/2006/main" noGrp="1"/>
+          </p:cNvSpPr>
+          <p:nvPr/>
+        </p:nvSpPr>
+        <p:spPr>
+          <a:xfrm xmlns:a="http://schemas.openxmlformats.org/drawingml/2006/main">
+            <a:off x="323850" y="1333500"/>
+            <a:ext cx="10820400" cy="4343400"/>
+          </a:xfrm>
+          <a:prstGeom xmlns:a="http://schemas.openxmlformats.org/drawingml/2006/main" prst="roundRect">
+            <a:avLst>
+              <a:gd name="adj" fmla="val 1316"/>
+            </a:avLst>
+          </a:prstGeom>
+          <a:solidFill xmlns:a="http://schemas.openxmlformats.org/drawingml/2006/main">
+            <a:srgbClr val="FFFFFF"/>
+          </a:solidFill>
+          <a:ln xmlns:a="http://schemas.openxmlformats.org/drawingml/2006/main" w="9525">
+            <a:solidFill>
+              <a:srgbClr val="E5E7EB"/>
+            </a:solidFill>
+            <a:prstDash val="solid"/>
+          </a:ln>
+        </p:spPr>
+      </p:sp>
+      <p:pic>
+        <p:nvPicPr>
+          <p:cNvPr id="12" name=""/>
+          <p:cNvPicPr>
+            <a:picLocks xmlns:a="http://schemas.openxmlformats.org/drawingml/2006/main" noChangeAspect="1"/>
+          </p:cNvPicPr>
+          <p:nvPr/>
+        </p:nvPicPr>
+        <p:blipFill>
+          <a:blip xmlns:r="http://schemas.openxmlformats.org/officeDocument/2006/relationships" xmlns:a="http://schemas.openxmlformats.org/drawingml/2006/main" r:embed="Rfaf9b8baf3cf40c3"/>
+          <a:stretch xmlns:a="http://schemas.openxmlformats.org/drawingml/2006/main"/>
+        </p:blipFill>
+        <p:spPr>
+          <a:xfrm xmlns:a="http://schemas.openxmlformats.org/drawingml/2006/main">
+            <a:off x="1247835" y="1409700"/>
+            <a:ext cx="8972430" cy="4191000"/>
+          </a:xfrm>
+          <a:prstGeom xmlns:a="http://schemas.openxmlformats.org/drawingml/2006/main" prst="rect">
+            <a:avLst/>
+          </a:prstGeom>
+        </p:spPr>
+      </p:pic>
+      <p:sp>
+        <p:nvSpPr>
+          <p:cNvPr id="5" name="">
+            <a:extLst xmlns:a="http://schemas.openxmlformats.org/drawingml/2006/main">
+              <a:ext uri="{FF2B5EF4-FFF2-40B4-BE49-F238E27FC236}">
+                <a16:creationId xmlns:a16="http://schemas.microsoft.com/office/drawing/2014/main" id="{52CCAF75-ACAB-4ECF-BA7E-9C3A5A71F52D}"/>
+              </a:ext>
+            </a:extLst>
+          </p:cNvPr>
+          <p:cNvSpPr>
+            <a:spLocks xmlns:a="http://schemas.openxmlformats.org/drawingml/2006/main" noGrp="1"/>
+          </p:cNvSpPr>
+          <p:nvPr/>
+        </p:nvSpPr>
+        <p:spPr>
+          <a:xfrm xmlns:a="http://schemas.openxmlformats.org/drawingml/2006/main">
+            <a:off x="685800" y="5791200"/>
+            <a:ext cx="9906000" cy="228600"/>
+          </a:xfrm>
+          <a:prstGeom xmlns:a="http://schemas.openxmlformats.org/drawingml/2006/main" prst="rect">
+            <a:avLst/>
+          </a:prstGeom>
+          <a:noFill xmlns:a="http://schemas.openxmlformats.org/drawingml/2006/main"/>
+          <a:ln xmlns:a="http://schemas.openxmlformats.org/drawingml/2006/main" w="0">
+            <a:noFill/>
+            <a:prstDash val="solid"/>
+          </a:ln>
+        </p:spPr>
+        <p:txBody>
+          <a:bodyPr xmlns:a="http://schemas.openxmlformats.org/drawingml/2006/main" anchor="t"/>
+          <a:lstStyle xmlns:a="http://schemas.openxmlformats.org/drawingml/2006/main"/>
+          <a:p xmlns:a="http://schemas.openxmlformats.org/drawingml/2006/main">
+            <a:pPr algn="l">
+              <a:defRPr sz="1275" b="0">
+                <a:solidFill>
+                  <a:srgbClr val="334155"/>
+                </a:solidFill>
+              </a:defRPr>
+            </a:pPr>
+            <a:r>
+              <a:rPr sz="1275" b="0">
+                <a:solidFill>
+                  <a:srgbClr val="334155"/>
+                </a:solidFill>
+              </a:rPr>
+              <a:t>The stage markers separate submission, SGLang receive, scheduler queue/admit, and visible KV H2D movement.</a:t>
+            </a:r>
+          </a:p>
+        </p:txBody>
+      </p:sp>
+      <p:sp>
+        <p:nvSpPr>
+          <p:cNvPr id="6" name="">
+            <a:extLst xmlns:a="http://schemas.openxmlformats.org/drawingml/2006/main">
+              <a:ext uri="{FF2B5EF4-FFF2-40B4-BE49-F238E27FC236}">
+                <a16:creationId xmlns:a16="http://schemas.microsoft.com/office/drawing/2014/main" id="{6EA3970D-492D-4BCD-B104-13E317CD2DDD}"/>
+              </a:ext>
+            </a:extLst>
+          </p:cNvPr>
+          <p:cNvSpPr>
+            <a:spLocks xmlns:a="http://schemas.openxmlformats.org/drawingml/2006/main" noGrp="1"/>
+          </p:cNvSpPr>
+          <p:nvPr/>
+        </p:nvSpPr>
+        <p:spPr>
+          <a:xfrm xmlns:a="http://schemas.openxmlformats.org/drawingml/2006/main">
+            <a:off x="400050" y="6153150"/>
+            <a:ext cx="7810500" cy="190500"/>
+          </a:xfrm>
+          <a:prstGeom xmlns:a="http://schemas.openxmlformats.org/drawingml/2006/main" prst="rect">
+            <a:avLst/>
+          </a:prstGeom>
+          <a:noFill xmlns:a="http://schemas.openxmlformats.org/drawingml/2006/main"/>
+          <a:ln xmlns:a="http://schemas.openxmlformats.org/drawingml/2006/main" w="0">
+            <a:noFill/>
+            <a:prstDash val="solid"/>
+          </a:ln>
+        </p:spPr>
+        <p:txBody>
+          <a:bodyPr xmlns:a="http://schemas.openxmlformats.org/drawingml/2006/main" anchor="t"/>
+          <a:lstStyle xmlns:a="http://schemas.openxmlformats.org/drawingml/2006/main"/>
+          <a:p xmlns:a="http://schemas.openxmlformats.org/drawingml/2006/main">
+            <a:pPr algn="l">
+              <a:defRPr sz="825" b="0">
+                <a:solidFill>
+                  <a:srgbClr val="64748B"/>
+                </a:solidFill>
+              </a:defRPr>
+            </a:pPr>
+            <a:r>
+              <a:rPr sz="825" b="0">
+                <a:solidFill>
+                  <a:srgbClr val="64748B"/>
+                </a:solidFill>
+              </a:rPr>
+              <a:t>Source: latest_master_report.html, Replay Queue Timeline vs H2D Start</a:t>
+            </a:r>
+          </a:p>
+        </p:txBody>
+      </p:sp>
+      <p:sp>
+        <p:nvSpPr>
+          <p:cNvPr id="7" name="">
+            <a:extLst xmlns:a="http://schemas.openxmlformats.org/drawingml/2006/main">
+              <a:ext uri="{FF2B5EF4-FFF2-40B4-BE49-F238E27FC236}">
+                <a16:creationId xmlns:a16="http://schemas.microsoft.com/office/drawing/2014/main" id="{EC8C91D9-929F-42A0-8700-6F1C5641E667}"/>
+              </a:ext>
+            </a:extLst>
+          </p:cNvPr>
+          <p:cNvSpPr>
+            <a:spLocks xmlns:a="http://schemas.openxmlformats.org/drawingml/2006/main" noGrp="1"/>
+          </p:cNvSpPr>
+          <p:nvPr/>
+        </p:nvSpPr>
+        <p:spPr>
+          <a:xfrm xmlns:a="http://schemas.openxmlformats.org/drawingml/2006/main">
+            <a:off x="400050" y="6381750"/>
+            <a:ext cx="3429000" cy="228600"/>
+          </a:xfrm>
+          <a:prstGeom xmlns:a="http://schemas.openxmlformats.org/drawingml/2006/main" prst="rect">
+            <a:avLst/>
+          </a:prstGeom>
+          <a:noFill xmlns:a="http://schemas.openxmlformats.org/drawingml/2006/main"/>
+          <a:ln xmlns:a="http://schemas.openxmlformats.org/drawingml/2006/main" w="0">
+            <a:noFill/>
+            <a:prstDash val="solid"/>
+          </a:ln>
+        </p:spPr>
+        <p:txBody>
+          <a:bodyPr xmlns:a="http://schemas.openxmlformats.org/drawingml/2006/main" anchor="t"/>
+          <a:lstStyle xmlns:a="http://schemas.openxmlformats.org/drawingml/2006/main"/>
+          <a:p xmlns:a="http://schemas.openxmlformats.org/drawingml/2006/main">
+            <a:pPr algn="l">
+              <a:defRPr sz="975" b="0">
+                <a:solidFill>
+                  <a:srgbClr val="64748B"/>
+                </a:solidFill>
+              </a:defRPr>
+            </a:pPr>
+            <a:r>
+              <a:rPr sz="975" b="0">
+                <a:solidFill>
+                  <a:srgbClr val="64748B"/>
+                </a:solidFill>
+              </a:rPr>
+              <a:t>Agent-aware KV movement</a:t>
+            </a:r>
+          </a:p>
+        </p:txBody>
+      </p:sp>
+      <p:sp>
+        <p:nvSpPr>
+          <p:cNvPr id="8" name="">
+            <a:extLst xmlns:a="http://schemas.openxmlformats.org/drawingml/2006/main">
+              <a:ext uri="{FF2B5EF4-FFF2-40B4-BE49-F238E27FC236}">
+                <a16:creationId xmlns:a16="http://schemas.microsoft.com/office/drawing/2014/main" id="{5B973A3F-0BDD-4E18-949B-C7E167527435}"/>
+              </a:ext>
+            </a:extLst>
+          </p:cNvPr>
+          <p:cNvSpPr>
+            <a:spLocks xmlns:a="http://schemas.openxmlformats.org/drawingml/2006/main" noGrp="1"/>
+          </p:cNvSpPr>
+          <p:nvPr/>
+        </p:nvSpPr>
+        <p:spPr>
+          <a:xfrm xmlns:a="http://schemas.openxmlformats.org/drawingml/2006/main">
+            <a:off x="11334750" y="6381750"/>
+            <a:ext cx="457200" cy="228600"/>
+          </a:xfrm>
+          <a:prstGeom xmlns:a="http://schemas.openxmlformats.org/drawingml/2006/main" prst="rect">
+            <a:avLst/>
+          </a:prstGeom>
+          <a:noFill xmlns:a="http://schemas.openxmlformats.org/drawingml/2006/main"/>
+          <a:ln xmlns:a="http://schemas.openxmlformats.org/drawingml/2006/main" w="0">
+            <a:noFill/>
+            <a:prstDash val="solid"/>
+          </a:ln>
+        </p:spPr>
+        <p:txBody>
+          <a:bodyPr xmlns:a="http://schemas.openxmlformats.org/drawingml/2006/main" anchor="t"/>
+          <a:lstStyle xmlns:a="http://schemas.openxmlformats.org/drawingml/2006/main"/>
+          <a:p xmlns:a="http://schemas.openxmlformats.org/drawingml/2006/main">
+            <a:pPr algn="r">
+              <a:defRPr sz="975" b="0">
+                <a:solidFill>
+                  <a:srgbClr val="64748B"/>
+                </a:solidFill>
+              </a:defRPr>
+            </a:pPr>
+            <a:r>
+              <a:rPr sz="975" b="0">
+                <a:solidFill>
+                  <a:srgbClr val="64748B"/>
+                </a:solidFill>
+              </a:rPr>
+              <a:t>06</a:t>
+            </a:r>
+          </a:p>
+        </p:txBody>
+      </p:sp>
+    </p:spTree>
+    <p:extLst>
+      <p:ext uri="{BB962C8B-B14F-4D97-AF65-F5344CB8AC3E}">
+        <p14:creationId xmlns:p14="http://schemas.microsoft.com/office/powerpoint/2010/main" val="1941687296"/>
+      </p:ext>
+    </p:extLst>
+  </p:cSld>
+</p:sld>
+</file>
+
+<file path=ppt/slides/slide7.xml><?xml version="1.0" encoding="utf-8"?>
+<p:sld xmlns:p="http://schemas.openxmlformats.org/presentationml/2006/main">
+  <p:cSld>
+    <p:bg>
+      <p:bgPr>
+        <a:solidFill xmlns:a="http://schemas.openxmlformats.org/drawingml/2006/main">
+          <a:srgbClr val="FFFFFF"/>
+        </a:solidFill>
+      </p:bgPr>
+    </p:bg>
+    <p:spTree>
+      <p:nvGrpSpPr>
+        <p:cNvPr id="1" name=""/>
+        <p:cNvGrpSpPr/>
+        <p:nvPr/>
+      </p:nvGrpSpPr>
+      <p:grpSpPr>
+        <a:xfrm xmlns:a="http://schemas.openxmlformats.org/drawingml/2006/main"/>
+      </p:grpSpPr>
+      <p:sp>
+        <p:nvSpPr>
+          <p:cNvPr id="27" name="">
+            <a:extLst xmlns:a="http://schemas.openxmlformats.org/drawingml/2006/main">
+              <a:ext uri="{FF2B5EF4-FFF2-40B4-BE49-F238E27FC236}">
+                <a16:creationId xmlns:a16="http://schemas.microsoft.com/office/drawing/2014/main" id="{A2BE1C4D-F180-497C-9B55-9DF703CC105B}"/>
+              </a:ext>
+            </a:extLst>
+          </p:cNvPr>
+          <p:cNvSpPr>
+            <a:spLocks xmlns:a="http://schemas.openxmlformats.org/drawingml/2006/main" noGrp="1"/>
+          </p:cNvSpPr>
+          <p:nvPr/>
+        </p:nvSpPr>
+        <p:spPr>
+          <a:xfrm xmlns:a="http://schemas.openxmlformats.org/drawingml/2006/main">
+            <a:off x="400050" y="323850"/>
+            <a:ext cx="10668000" cy="800100"/>
+          </a:xfrm>
+          <a:prstGeom xmlns:a="http://schemas.openxmlformats.org/drawingml/2006/main" prst="rect">
+            <a:avLst/>
+          </a:prstGeom>
+          <a:noFill xmlns:a="http://schemas.openxmlformats.org/drawingml/2006/main"/>
+          <a:ln xmlns:a="http://schemas.openxmlformats.org/drawingml/2006/main" w="0">
+            <a:noFill/>
+            <a:prstDash val="solid"/>
+          </a:ln>
+        </p:spPr>
+        <p:txBody>
+          <a:bodyPr xmlns:a="http://schemas.openxmlformats.org/drawingml/2006/main" anchor="t"/>
+          <a:lstStyle xmlns:a="http://schemas.openxmlformats.org/drawingml/2006/main"/>
+          <a:p xmlns:a="http://schemas.openxmlformats.org/drawingml/2006/main">
+            <a:pPr algn="l">
+              <a:defRPr sz="2850" b="1">
+                <a:solidFill>
+                  <a:srgbClr val="0F172A"/>
+                </a:solidFill>
+              </a:defRPr>
+            </a:pPr>
+            <a:r>
+              <a:rPr sz="2850" b="1">
+                <a:solidFill>
+                  <a:srgbClr val="0F172A"/>
+                </a:solidFill>
+              </a:rPr>
+              <a:t>Hardware support can make hints enforceable</a:t>
+            </a:r>
+          </a:p>
+        </p:txBody>
+      </p:sp>
+      <p:sp>
+        <p:nvSpPr>
+          <p:cNvPr id="2" name="">
+            <a:extLst xmlns:a="http://schemas.openxmlformats.org/drawingml/2006/main">
+              <a:ext uri="{FF2B5EF4-FFF2-40B4-BE49-F238E27FC236}">
+                <a16:creationId xmlns:a16="http://schemas.microsoft.com/office/drawing/2014/main" id="{FDFEB5C5-96BB-407E-A3CB-A841012521AB}"/>
+              </a:ext>
+            </a:extLst>
+          </p:cNvPr>
+          <p:cNvSpPr>
+            <a:spLocks xmlns:a="http://schemas.openxmlformats.org/drawingml/2006/main" noGrp="1"/>
+          </p:cNvSpPr>
+          <p:nvPr/>
+        </p:nvSpPr>
+        <p:spPr>
+          <a:xfrm xmlns:a="http://schemas.openxmlformats.org/drawingml/2006/main">
+            <a:off x="419100" y="1028700"/>
+            <a:ext cx="9715500" cy="419100"/>
+          </a:xfrm>
+          <a:prstGeom xmlns:a="http://schemas.openxmlformats.org/drawingml/2006/main" prst="rect">
+            <a:avLst/>
+          </a:prstGeom>
+          <a:noFill xmlns:a="http://schemas.openxmlformats.org/drawingml/2006/main"/>
+          <a:ln xmlns:a="http://schemas.openxmlformats.org/drawingml/2006/main" w="0">
+            <a:noFill/>
+            <a:prstDash val="solid"/>
+          </a:ln>
+        </p:spPr>
+        <p:txBody>
+          <a:bodyPr xmlns:a="http://schemas.openxmlformats.org/drawingml/2006/main" anchor="t"/>
+          <a:lstStyle xmlns:a="http://schemas.openxmlformats.org/drawingml/2006/main"/>
+          <a:p xmlns:a="http://schemas.openxmlformats.org/drawingml/2006/main">
+            <a:pPr algn="l">
+              <a:defRPr sz="1350" b="0">
+                <a:solidFill>
+                  <a:srgbClr val="64748B"/>
+                </a:solidFill>
+              </a:defRPr>
+            </a:pPr>
+            <a:r>
+              <a:rPr sz="1350" b="0">
+                <a:solidFill>
+                  <a:srgbClr val="64748B"/>
+                </a:solidFill>
+              </a:rPr>
               <a:t>The opportunity is to treat KV as deadline-sensitive memory, not generic bytes.</a:t>
             </a:r>
           </a:p>
@@ -4880,7 +5712,7 @@
           <p:cNvPr id="3" name="">
             <a:extLst xmlns:a="http://schemas.openxmlformats.org/drawingml/2006/main">
               <a:ext uri="{FF2B5EF4-FFF2-40B4-BE49-F238E27FC236}">
-                <a16:creationId xmlns:a16="http://schemas.microsoft.com/office/drawing/2014/main" id="{C65FEDFF-8CD4-4B69-931F-79230A0784CD}"/>
+                <a16:creationId xmlns:a16="http://schemas.microsoft.com/office/drawing/2014/main" id="{B189A253-142F-4314-BEDF-01EC237F564B}"/>
               </a:ext>
             </a:extLst>
           </p:cNvPr>
@@ -4915,7 +5747,7 @@
           <p:cNvPr id="4" name="">
             <a:extLst xmlns:a="http://schemas.openxmlformats.org/drawingml/2006/main">
               <a:ext uri="{FF2B5EF4-FFF2-40B4-BE49-F238E27FC236}">
-                <a16:creationId xmlns:a16="http://schemas.microsoft.com/office/drawing/2014/main" id="{16F44E9C-4F1D-4CD0-8C6C-68C40579B600}"/>
+                <a16:creationId xmlns:a16="http://schemas.microsoft.com/office/drawing/2014/main" id="{E13F40C2-F53F-4B35-99EA-6BEEB34BC4AE}"/>
               </a:ext>
             </a:extLst>
           </p:cNvPr>
@@ -4965,7 +5797,7 @@
           <p:cNvPr id="5" name="">
             <a:extLst xmlns:a="http://schemas.openxmlformats.org/drawingml/2006/main">
               <a:ext uri="{FF2B5EF4-FFF2-40B4-BE49-F238E27FC236}">
-                <a16:creationId xmlns:a16="http://schemas.microsoft.com/office/drawing/2014/main" id="{16571620-FC13-4163-84EB-F9438D82BE77}"/>
+                <a16:creationId xmlns:a16="http://schemas.microsoft.com/office/drawing/2014/main" id="{0A559254-5351-4076-A45F-854D6A5184FE}"/>
               </a:ext>
             </a:extLst>
           </p:cNvPr>
@@ -5015,7 +5847,7 @@
           <p:cNvPr id="6" name="">
             <a:extLst xmlns:a="http://schemas.openxmlformats.org/drawingml/2006/main">
               <a:ext uri="{FF2B5EF4-FFF2-40B4-BE49-F238E27FC236}">
-                <a16:creationId xmlns:a16="http://schemas.microsoft.com/office/drawing/2014/main" id="{51141F60-1187-40BC-AC1C-F04B47B3DB10}"/>
+                <a16:creationId xmlns:a16="http://schemas.microsoft.com/office/drawing/2014/main" id="{90F71924-6EF4-4DF2-BF23-9D145012EAFE}"/>
               </a:ext>
             </a:extLst>
           </p:cNvPr>
@@ -5065,7 +5897,7 @@
           <p:cNvPr id="7" name="">
             <a:extLst xmlns:a="http://schemas.openxmlformats.org/drawingml/2006/main">
               <a:ext uri="{FF2B5EF4-FFF2-40B4-BE49-F238E27FC236}">
-                <a16:creationId xmlns:a16="http://schemas.microsoft.com/office/drawing/2014/main" id="{52396A88-72F3-4692-9023-691166B6CC85}"/>
+                <a16:creationId xmlns:a16="http://schemas.microsoft.com/office/drawing/2014/main" id="{3419EDEF-517D-4AEC-82A9-E8F9E1AD7BD3}"/>
               </a:ext>
             </a:extLst>
           </p:cNvPr>
@@ -5100,7 +5932,7 @@
           <p:cNvPr id="8" name="">
             <a:extLst xmlns:a="http://schemas.openxmlformats.org/drawingml/2006/main">
               <a:ext uri="{FF2B5EF4-FFF2-40B4-BE49-F238E27FC236}">
-                <a16:creationId xmlns:a16="http://schemas.microsoft.com/office/drawing/2014/main" id="{9E97AC1E-4865-4BA0-AD0B-A52C0A616800}"/>
+                <a16:creationId xmlns:a16="http://schemas.microsoft.com/office/drawing/2014/main" id="{F2F02250-E0AD-4464-9CCD-7EAD258BA051}"/>
               </a:ext>
             </a:extLst>
           </p:cNvPr>
@@ -5150,7 +5982,7 @@
           <p:cNvPr id="9" name="">
             <a:extLst xmlns:a="http://schemas.openxmlformats.org/drawingml/2006/main">
               <a:ext uri="{FF2B5EF4-FFF2-40B4-BE49-F238E27FC236}">
-                <a16:creationId xmlns:a16="http://schemas.microsoft.com/office/drawing/2014/main" id="{7A51730D-310B-4A06-826C-DF13DDB55022}"/>
+                <a16:creationId xmlns:a16="http://schemas.microsoft.com/office/drawing/2014/main" id="{127FC27C-F73F-44F0-A1D1-2B9FFE2DADB9}"/>
               </a:ext>
             </a:extLst>
           </p:cNvPr>
@@ -5200,7 +6032,7 @@
           <p:cNvPr id="10" name="">
             <a:extLst xmlns:a="http://schemas.openxmlformats.org/drawingml/2006/main">
               <a:ext uri="{FF2B5EF4-FFF2-40B4-BE49-F238E27FC236}">
-                <a16:creationId xmlns:a16="http://schemas.microsoft.com/office/drawing/2014/main" id="{02443E85-1F0B-4129-B741-56427019BF1C}"/>
+                <a16:creationId xmlns:a16="http://schemas.microsoft.com/office/drawing/2014/main" id="{2E8A391C-8952-435C-9385-764BE90C3DD9}"/>
               </a:ext>
             </a:extLst>
           </p:cNvPr>
@@ -5250,7 +6082,7 @@
           <p:cNvPr id="11" name="">
             <a:extLst xmlns:a="http://schemas.openxmlformats.org/drawingml/2006/main">
               <a:ext uri="{FF2B5EF4-FFF2-40B4-BE49-F238E27FC236}">
-                <a16:creationId xmlns:a16="http://schemas.microsoft.com/office/drawing/2014/main" id="{07F62A97-C8E7-4CC7-A043-A7C0C43A3315}"/>
+                <a16:creationId xmlns:a16="http://schemas.microsoft.com/office/drawing/2014/main" id="{98F10325-6651-4906-9E8E-D7DDC30F1AD5}"/>
               </a:ext>
             </a:extLst>
           </p:cNvPr>
@@ -5285,7 +6117,7 @@
           <p:cNvPr id="12" name="">
             <a:extLst xmlns:a="http://schemas.openxmlformats.org/drawingml/2006/main">
               <a:ext uri="{FF2B5EF4-FFF2-40B4-BE49-F238E27FC236}">
-                <a16:creationId xmlns:a16="http://schemas.microsoft.com/office/drawing/2014/main" id="{B0DF029C-4FE1-4F63-BF15-9F53D517972C}"/>
+                <a16:creationId xmlns:a16="http://schemas.microsoft.com/office/drawing/2014/main" id="{16BBEC16-C93A-4A28-9FB6-2AFD9C402574}"/>
               </a:ext>
             </a:extLst>
           </p:cNvPr>
@@ -5335,7 +6167,7 @@
           <p:cNvPr id="13" name="">
             <a:extLst xmlns:a="http://schemas.openxmlformats.org/drawingml/2006/main">
               <a:ext uri="{FF2B5EF4-FFF2-40B4-BE49-F238E27FC236}">
-                <a16:creationId xmlns:a16="http://schemas.microsoft.com/office/drawing/2014/main" id="{C15E1012-4A57-4D19-80EB-4662875D2DD7}"/>
+                <a16:creationId xmlns:a16="http://schemas.microsoft.com/office/drawing/2014/main" id="{817F95AA-408D-4AD5-8A66-6ABFA8A70FE3}"/>
               </a:ext>
             </a:extLst>
           </p:cNvPr>
@@ -5385,7 +6217,7 @@
           <p:cNvPr id="14" name="">
             <a:extLst xmlns:a="http://schemas.openxmlformats.org/drawingml/2006/main">
               <a:ext uri="{FF2B5EF4-FFF2-40B4-BE49-F238E27FC236}">
-                <a16:creationId xmlns:a16="http://schemas.microsoft.com/office/drawing/2014/main" id="{9CAF74D2-55D4-499A-A235-1B719FA08AB6}"/>
+                <a16:creationId xmlns:a16="http://schemas.microsoft.com/office/drawing/2014/main" id="{5E399707-AE93-4850-97DF-847587CBE247}"/>
               </a:ext>
             </a:extLst>
           </p:cNvPr>
@@ -5435,7 +6267,7 @@
           <p:cNvPr id="15" name="">
             <a:extLst xmlns:a="http://schemas.openxmlformats.org/drawingml/2006/main">
               <a:ext uri="{FF2B5EF4-FFF2-40B4-BE49-F238E27FC236}">
-                <a16:creationId xmlns:a16="http://schemas.microsoft.com/office/drawing/2014/main" id="{D8E20F58-62C8-4B32-A2FC-6F3726F8F75D}"/>
+                <a16:creationId xmlns:a16="http://schemas.microsoft.com/office/drawing/2014/main" id="{2F0A63E3-8DD6-48C1-9D8F-A618D4B3D3FB}"/>
               </a:ext>
             </a:extLst>
           </p:cNvPr>
@@ -5470,7 +6302,7 @@
           <p:cNvPr id="16" name="">
             <a:extLst xmlns:a="http://schemas.openxmlformats.org/drawingml/2006/main">
               <a:ext uri="{FF2B5EF4-FFF2-40B4-BE49-F238E27FC236}">
-                <a16:creationId xmlns:a16="http://schemas.microsoft.com/office/drawing/2014/main" id="{EF2B1653-FFE9-4C4A-9CC9-83D0720D1C81}"/>
+                <a16:creationId xmlns:a16="http://schemas.microsoft.com/office/drawing/2014/main" id="{7292E7AD-34E6-4B8B-8EE8-F3E5DBC7E112}"/>
               </a:ext>
             </a:extLst>
           </p:cNvPr>
@@ -5520,7 +6352,7 @@
           <p:cNvPr id="17" name="">
             <a:extLst xmlns:a="http://schemas.openxmlformats.org/drawingml/2006/main">
               <a:ext uri="{FF2B5EF4-FFF2-40B4-BE49-F238E27FC236}">
-                <a16:creationId xmlns:a16="http://schemas.microsoft.com/office/drawing/2014/main" id="{DEB3D779-949B-489A-B903-2DB3F222D0A1}"/>
+                <a16:creationId xmlns:a16="http://schemas.microsoft.com/office/drawing/2014/main" id="{38601DF0-6589-45DE-BA89-22AF5DC1FFFF}"/>
               </a:ext>
             </a:extLst>
           </p:cNvPr>
@@ -5570,7 +6402,7 @@
           <p:cNvPr id="18" name="">
             <a:extLst xmlns:a="http://schemas.openxmlformats.org/drawingml/2006/main">
               <a:ext uri="{FF2B5EF4-FFF2-40B4-BE49-F238E27FC236}">
-                <a16:creationId xmlns:a16="http://schemas.microsoft.com/office/drawing/2014/main" id="{F28DF708-F949-4919-B1A8-2E18E0059F9F}"/>
+                <a16:creationId xmlns:a16="http://schemas.microsoft.com/office/drawing/2014/main" id="{EEDAA903-BC2C-4C49-B7DE-E1358D1F88FC}"/>
               </a:ext>
             </a:extLst>
           </p:cNvPr>
@@ -5620,7 +6452,7 @@
           <p:cNvPr id="19" name="">
             <a:extLst xmlns:a="http://schemas.openxmlformats.org/drawingml/2006/main">
               <a:ext uri="{FF2B5EF4-FFF2-40B4-BE49-F238E27FC236}">
-                <a16:creationId xmlns:a16="http://schemas.microsoft.com/office/drawing/2014/main" id="{95234086-D6EA-40CB-9426-D98DB7E68F1A}"/>
+                <a16:creationId xmlns:a16="http://schemas.microsoft.com/office/drawing/2014/main" id="{6D97EEB9-A53B-4D4A-838C-CC0645445F6A}"/>
               </a:ext>
             </a:extLst>
           </p:cNvPr>
@@ -5655,7 +6487,7 @@
           <p:cNvPr id="20" name="">
             <a:extLst xmlns:a="http://schemas.openxmlformats.org/drawingml/2006/main">
               <a:ext uri="{FF2B5EF4-FFF2-40B4-BE49-F238E27FC236}">
-                <a16:creationId xmlns:a16="http://schemas.microsoft.com/office/drawing/2014/main" id="{E45E27C1-B197-4969-A8CF-56D7EEFB3C5B}"/>
+                <a16:creationId xmlns:a16="http://schemas.microsoft.com/office/drawing/2014/main" id="{9D825824-019A-4516-A8AC-EEC5BFCC0570}"/>
               </a:ext>
             </a:extLst>
           </p:cNvPr>
@@ -5705,7 +6537,7 @@
           <p:cNvPr id="21" name="">
             <a:extLst xmlns:a="http://schemas.openxmlformats.org/drawingml/2006/main">
               <a:ext uri="{FF2B5EF4-FFF2-40B4-BE49-F238E27FC236}">
-                <a16:creationId xmlns:a16="http://schemas.microsoft.com/office/drawing/2014/main" id="{A76049FD-BFEA-4754-B809-5744FD3B3D1A}"/>
+                <a16:creationId xmlns:a16="http://schemas.microsoft.com/office/drawing/2014/main" id="{AC7637CB-CD0A-46FA-B51E-35AF59467BDF}"/>
               </a:ext>
             </a:extLst>
           </p:cNvPr>
@@ -5755,7 +6587,7 @@
           <p:cNvPr id="22" name="">
             <a:extLst xmlns:a="http://schemas.openxmlformats.org/drawingml/2006/main">
               <a:ext uri="{FF2B5EF4-FFF2-40B4-BE49-F238E27FC236}">
-                <a16:creationId xmlns:a16="http://schemas.microsoft.com/office/drawing/2014/main" id="{00ACEDB5-8430-42E5-9157-83F404087C00}"/>
+                <a16:creationId xmlns:a16="http://schemas.microsoft.com/office/drawing/2014/main" id="{4A8695E7-33FA-453E-B233-7B9F5B6260C3}"/>
               </a:ext>
             </a:extLst>
           </p:cNvPr>
@@ -5790,7 +6622,7 @@
           <p:cNvPr id="23" name="">
             <a:extLst xmlns:a="http://schemas.openxmlformats.org/drawingml/2006/main">
               <a:ext uri="{FF2B5EF4-FFF2-40B4-BE49-F238E27FC236}">
-                <a16:creationId xmlns:a16="http://schemas.microsoft.com/office/drawing/2014/main" id="{78B63F66-465D-46D8-8E28-414BEA6BC881}"/>
+                <a16:creationId xmlns:a16="http://schemas.microsoft.com/office/drawing/2014/main" id="{920336A3-EF52-437B-9FBD-956D02203DE7}"/>
               </a:ext>
             </a:extLst>
           </p:cNvPr>
@@ -5840,7 +6672,7 @@
           <p:cNvPr id="24" name="">
             <a:extLst xmlns:a="http://schemas.openxmlformats.org/drawingml/2006/main">
               <a:ext uri="{FF2B5EF4-FFF2-40B4-BE49-F238E27FC236}">
-                <a16:creationId xmlns:a16="http://schemas.microsoft.com/office/drawing/2014/main" id="{000E93F5-43D2-4659-A1A3-A1E8D8437416}"/>
+                <a16:creationId xmlns:a16="http://schemas.microsoft.com/office/drawing/2014/main" id="{05169DE4-E961-4784-9003-5BC12D55EC16}"/>
               </a:ext>
             </a:extLst>
           </p:cNvPr>
@@ -5890,7 +6722,7 @@
           <p:cNvPr id="25" name="">
             <a:extLst xmlns:a="http://schemas.openxmlformats.org/drawingml/2006/main">
               <a:ext uri="{FF2B5EF4-FFF2-40B4-BE49-F238E27FC236}">
-                <a16:creationId xmlns:a16="http://schemas.microsoft.com/office/drawing/2014/main" id="{4944D63C-558E-4078-8DC1-0DA95B1AAB36}"/>
+                <a16:creationId xmlns:a16="http://schemas.microsoft.com/office/drawing/2014/main" id="{654D1ADC-64EA-4539-97DC-E9A46EB095E1}"/>
               </a:ext>
             </a:extLst>
           </p:cNvPr>
@@ -5940,7 +6772,7 @@
           <p:cNvPr id="26" name="">
             <a:extLst xmlns:a="http://schemas.openxmlformats.org/drawingml/2006/main">
               <a:ext uri="{FF2B5EF4-FFF2-40B4-BE49-F238E27FC236}">
-                <a16:creationId xmlns:a16="http://schemas.microsoft.com/office/drawing/2014/main" id="{2BE5284F-FC69-4537-9B91-88C3CAA364AF}"/>
+                <a16:creationId xmlns:a16="http://schemas.microsoft.com/office/drawing/2014/main" id="{43017583-E283-4DFA-91DD-2C4B2C539622}"/>
               </a:ext>
             </a:extLst>
           </p:cNvPr>
@@ -5980,7 +6812,7 @@
                   <a:srgbClr val="64748B"/>
                 </a:solidFill>
               </a:rPr>
-              <a:t>06</a:t>
+              <a:t>07</a:t>
             </a:r>
           </a:p>
         </p:txBody>
@@ -5988,7 +6820,7 @@
     </p:spTree>
     <p:extLst>
       <p:ext uri="{BB962C8B-B14F-4D97-AF65-F5344CB8AC3E}">
-        <p14:creationId xmlns:p14="http://schemas.microsoft.com/office/powerpoint/2010/main" val="1560740317"/>
+        <p14:creationId xmlns:p14="http://schemas.microsoft.com/office/powerpoint/2010/main" val="576995225"/>
       </p:ext>
     </p:extLst>
   </p:cSld>

</xml_diff>

<commit_message>
Expand replay timeline view in manager deck
</commit_message>
<xml_diff>
--- a/sglang_direct_kv/artifacts/slides/agent_aware_kv_movement_manager_deck.pptx
+++ b/sglang_direct_kv/artifacts/slides/agent_aware_kv_movement_manager_deck.pptx
@@ -2,20 +2,20 @@
 <file path=ppt/presentation.xml><?xml version="1.0" encoding="utf-8"?>
 <p:presentation xmlns:p="http://schemas.openxmlformats.org/presentationml/2006/main">
   <p:sldMasterIdLst>
-    <p:sldMasterId xmlns:r="http://schemas.openxmlformats.org/officeDocument/2006/relationships" id="2147483648" r:id="R192ec0c512534232"/>
+    <p:sldMasterId xmlns:r="http://schemas.openxmlformats.org/officeDocument/2006/relationships" id="2147483648" r:id="R601185fe15184d04"/>
   </p:sldMasterIdLst>
   <p:notesMasterIdLst>
-    <p:notesMasterId xmlns:r="http://schemas.openxmlformats.org/officeDocument/2006/relationships" r:id="R53a9988d234a45d6"/>
+    <p:notesMasterId xmlns:r="http://schemas.openxmlformats.org/officeDocument/2006/relationships" r:id="Rb5f852de8d444456"/>
   </p:notesMasterIdLst>
   <p:sldIdLst>
-    <p:sldId xmlns:r="http://schemas.openxmlformats.org/officeDocument/2006/relationships" id="256" r:id="Re34d58e080024f18"/>
-    <p:sldId xmlns:r="http://schemas.openxmlformats.org/officeDocument/2006/relationships" id="257" r:id="Rb6cb70b5173140e1"/>
-    <p:sldId xmlns:r="http://schemas.openxmlformats.org/officeDocument/2006/relationships" id="258" r:id="R082ef5d2f2c54649"/>
-    <p:sldId xmlns:r="http://schemas.openxmlformats.org/officeDocument/2006/relationships" id="259" r:id="R7b9b19be8672452f"/>
-    <p:sldId xmlns:r="http://schemas.openxmlformats.org/officeDocument/2006/relationships" id="260" r:id="R847a68fd188f45c0"/>
-    <p:sldId xmlns:r="http://schemas.openxmlformats.org/officeDocument/2006/relationships" id="261" r:id="Rc609a81787d342cf"/>
-    <p:sldId xmlns:r="http://schemas.openxmlformats.org/officeDocument/2006/relationships" id="262" r:id="R8a1021d62f06433b"/>
-    <p:sldId xmlns:r="http://schemas.openxmlformats.org/officeDocument/2006/relationships" id="263" r:id="R9976faeb41d04066"/>
+    <p:sldId xmlns:r="http://schemas.openxmlformats.org/officeDocument/2006/relationships" id="256" r:id="R7daa26312cdc4e89"/>
+    <p:sldId xmlns:r="http://schemas.openxmlformats.org/officeDocument/2006/relationships" id="257" r:id="Rcf8d371f12da4fd9"/>
+    <p:sldId xmlns:r="http://schemas.openxmlformats.org/officeDocument/2006/relationships" id="258" r:id="R4387e18435334843"/>
+    <p:sldId xmlns:r="http://schemas.openxmlformats.org/officeDocument/2006/relationships" id="259" r:id="R7535cc3ff9094265"/>
+    <p:sldId xmlns:r="http://schemas.openxmlformats.org/officeDocument/2006/relationships" id="260" r:id="R92d0645070fd4a7e"/>
+    <p:sldId xmlns:r="http://schemas.openxmlformats.org/officeDocument/2006/relationships" id="261" r:id="Rd105dad3ca234f13"/>
+    <p:sldId xmlns:r="http://schemas.openxmlformats.org/officeDocument/2006/relationships" id="262" r:id="R855ed48d2828471d"/>
+    <p:sldId xmlns:r="http://schemas.openxmlformats.org/officeDocument/2006/relationships" id="263" r:id="R5b0c6fdbfb354bb6"/>
   </p:sldIdLst>
   <p:sldSz cx="12192000" cy="6858000"/>
   <p:notesSz cx="6858000" cy="9144000"/>
@@ -1207,7 +1207,7 @@
   </p:cSld>
   <p:clrMap bg1="lt1" tx1="dk1" bg2="lt2" tx2="dk2" accent1="accent1" accent2="accent2" accent3="accent3" accent4="accent4" accent5="accent5" accent6="accent6" hlink="hlink" folHlink="folHlink"/>
   <p:sldLayoutIdLst>
-    <p:sldLayoutId xmlns:r="http://schemas.openxmlformats.org/officeDocument/2006/relationships" id="2147483649" r:id="R7ea18fb3123640b4"/>
+    <p:sldLayoutId xmlns:r="http://schemas.openxmlformats.org/officeDocument/2006/relationships" id="2147483649" r:id="R406961d316ec4559"/>
   </p:sldLayoutIdLst>
   <p:txStyles>
     <p:titleStyle>
@@ -1758,7 +1758,7 @@
           <p:cNvPr id="16" name="">
             <a:extLst xmlns:a="http://schemas.openxmlformats.org/drawingml/2006/main">
               <a:ext uri="{FF2B5EF4-FFF2-40B4-BE49-F238E27FC236}">
-                <a16:creationId xmlns:a16="http://schemas.microsoft.com/office/drawing/2014/main" id="{0BA751AA-DA07-48DE-8EC8-BFDC164BC590}"/>
+                <a16:creationId xmlns:a16="http://schemas.microsoft.com/office/drawing/2014/main" id="{62FB2137-23A7-4BBA-82A2-4DADBBC59E9A}"/>
               </a:ext>
             </a:extLst>
           </p:cNvPr>
@@ -1808,7 +1808,7 @@
           <p:cNvPr id="2" name="">
             <a:extLst xmlns:a="http://schemas.openxmlformats.org/drawingml/2006/main">
               <a:ext uri="{FF2B5EF4-FFF2-40B4-BE49-F238E27FC236}">
-                <a16:creationId xmlns:a16="http://schemas.microsoft.com/office/drawing/2014/main" id="{0AF7E61D-5A88-4467-A5F9-BD9A46BF6CCC}"/>
+                <a16:creationId xmlns:a16="http://schemas.microsoft.com/office/drawing/2014/main" id="{6E355E9F-8557-4B62-BDF4-23539AB16002}"/>
               </a:ext>
             </a:extLst>
           </p:cNvPr>
@@ -1858,7 +1858,7 @@
           <p:cNvPr id="3" name="">
             <a:extLst xmlns:a="http://schemas.openxmlformats.org/drawingml/2006/main">
               <a:ext uri="{FF2B5EF4-FFF2-40B4-BE49-F238E27FC236}">
-                <a16:creationId xmlns:a16="http://schemas.microsoft.com/office/drawing/2014/main" id="{489BCDC5-8D32-4F24-8012-C090C9A6F95A}"/>
+                <a16:creationId xmlns:a16="http://schemas.microsoft.com/office/drawing/2014/main" id="{DA1F0853-039D-4C86-A71F-E072698AE8FC}"/>
               </a:ext>
             </a:extLst>
           </p:cNvPr>
@@ -1893,7 +1893,7 @@
           <p:cNvPr id="4" name="">
             <a:extLst xmlns:a="http://schemas.openxmlformats.org/drawingml/2006/main">
               <a:ext uri="{FF2B5EF4-FFF2-40B4-BE49-F238E27FC236}">
-                <a16:creationId xmlns:a16="http://schemas.microsoft.com/office/drawing/2014/main" id="{397A9E5F-7E4F-4B2D-AEED-A576C8F70253}"/>
+                <a16:creationId xmlns:a16="http://schemas.microsoft.com/office/drawing/2014/main" id="{7A3A1910-124C-474A-B3E8-DD5CE2C8B126}"/>
               </a:ext>
             </a:extLst>
           </p:cNvPr>
@@ -1943,7 +1943,7 @@
           <p:cNvPr id="5" name="">
             <a:extLst xmlns:a="http://schemas.openxmlformats.org/drawingml/2006/main">
               <a:ext uri="{FF2B5EF4-FFF2-40B4-BE49-F238E27FC236}">
-                <a16:creationId xmlns:a16="http://schemas.microsoft.com/office/drawing/2014/main" id="{2CBA0617-FF1F-4852-8AB9-E69708A179D1}"/>
+                <a16:creationId xmlns:a16="http://schemas.microsoft.com/office/drawing/2014/main" id="{2CBB6CA9-B912-4BEE-A8A5-D071D5EF73D4}"/>
               </a:ext>
             </a:extLst>
           </p:cNvPr>
@@ -1993,7 +1993,7 @@
           <p:cNvPr id="6" name="">
             <a:extLst xmlns:a="http://schemas.openxmlformats.org/drawingml/2006/main">
               <a:ext uri="{FF2B5EF4-FFF2-40B4-BE49-F238E27FC236}">
-                <a16:creationId xmlns:a16="http://schemas.microsoft.com/office/drawing/2014/main" id="{4DED71BA-614D-4160-88F5-7CFE73003F2C}"/>
+                <a16:creationId xmlns:a16="http://schemas.microsoft.com/office/drawing/2014/main" id="{4BE85BCF-32F8-4954-89A0-9F8DD5B43FC4}"/>
               </a:ext>
             </a:extLst>
           </p:cNvPr>
@@ -2028,7 +2028,7 @@
           <p:cNvPr id="7" name="">
             <a:extLst xmlns:a="http://schemas.openxmlformats.org/drawingml/2006/main">
               <a:ext uri="{FF2B5EF4-FFF2-40B4-BE49-F238E27FC236}">
-                <a16:creationId xmlns:a16="http://schemas.microsoft.com/office/drawing/2014/main" id="{B5A77795-127A-4B6D-ABF0-0C3705669DF6}"/>
+                <a16:creationId xmlns:a16="http://schemas.microsoft.com/office/drawing/2014/main" id="{994E34FD-E5DA-45F3-8D66-AED20147FE33}"/>
               </a:ext>
             </a:extLst>
           </p:cNvPr>
@@ -2078,7 +2078,7 @@
           <p:cNvPr id="8" name="">
             <a:extLst xmlns:a="http://schemas.openxmlformats.org/drawingml/2006/main">
               <a:ext uri="{FF2B5EF4-FFF2-40B4-BE49-F238E27FC236}">
-                <a16:creationId xmlns:a16="http://schemas.microsoft.com/office/drawing/2014/main" id="{BC15575F-1D32-4544-A13A-2F29689DBCDA}"/>
+                <a16:creationId xmlns:a16="http://schemas.microsoft.com/office/drawing/2014/main" id="{0938EB14-B8AB-429A-9E3E-CD9B37BDFED5}"/>
               </a:ext>
             </a:extLst>
           </p:cNvPr>
@@ -2128,7 +2128,7 @@
           <p:cNvPr id="9" name="">
             <a:extLst xmlns:a="http://schemas.openxmlformats.org/drawingml/2006/main">
               <a:ext uri="{FF2B5EF4-FFF2-40B4-BE49-F238E27FC236}">
-                <a16:creationId xmlns:a16="http://schemas.microsoft.com/office/drawing/2014/main" id="{C2C81932-2E11-4600-88F8-567227A2CE43}"/>
+                <a16:creationId xmlns:a16="http://schemas.microsoft.com/office/drawing/2014/main" id="{D8B1CD77-A766-4286-B4E6-001C63E22EDB}"/>
               </a:ext>
             </a:extLst>
           </p:cNvPr>
@@ -2163,7 +2163,7 @@
           <p:cNvPr id="10" name="">
             <a:extLst xmlns:a="http://schemas.openxmlformats.org/drawingml/2006/main">
               <a:ext uri="{FF2B5EF4-FFF2-40B4-BE49-F238E27FC236}">
-                <a16:creationId xmlns:a16="http://schemas.microsoft.com/office/drawing/2014/main" id="{D71F2028-771E-47D1-A353-D13A3F5A790A}"/>
+                <a16:creationId xmlns:a16="http://schemas.microsoft.com/office/drawing/2014/main" id="{96FBC1C6-BE07-422E-A6E4-6A7593983BB1}"/>
               </a:ext>
             </a:extLst>
           </p:cNvPr>
@@ -2213,7 +2213,7 @@
           <p:cNvPr id="11" name="">
             <a:extLst xmlns:a="http://schemas.openxmlformats.org/drawingml/2006/main">
               <a:ext uri="{FF2B5EF4-FFF2-40B4-BE49-F238E27FC236}">
-                <a16:creationId xmlns:a16="http://schemas.microsoft.com/office/drawing/2014/main" id="{912F86DB-BDE7-4917-B774-60BD3883D174}"/>
+                <a16:creationId xmlns:a16="http://schemas.microsoft.com/office/drawing/2014/main" id="{F6DCC0D0-5871-40D0-93AB-45F2D4D8F76D}"/>
               </a:ext>
             </a:extLst>
           </p:cNvPr>
@@ -2263,7 +2263,7 @@
           <p:cNvPr id="12" name="">
             <a:extLst xmlns:a="http://schemas.openxmlformats.org/drawingml/2006/main">
               <a:ext uri="{FF2B5EF4-FFF2-40B4-BE49-F238E27FC236}">
-                <a16:creationId xmlns:a16="http://schemas.microsoft.com/office/drawing/2014/main" id="{5D68CDBA-9A29-40DE-8885-0AFC21686D79}"/>
+                <a16:creationId xmlns:a16="http://schemas.microsoft.com/office/drawing/2014/main" id="{3FB49F3C-BA29-48A8-A6B6-CFDB96C7267A}"/>
               </a:ext>
             </a:extLst>
           </p:cNvPr>
@@ -2298,7 +2298,7 @@
           <p:cNvPr id="13" name="">
             <a:extLst xmlns:a="http://schemas.openxmlformats.org/drawingml/2006/main">
               <a:ext uri="{FF2B5EF4-FFF2-40B4-BE49-F238E27FC236}">
-                <a16:creationId xmlns:a16="http://schemas.microsoft.com/office/drawing/2014/main" id="{A38CD4DA-A930-489C-9310-14F05BA6BA5E}"/>
+                <a16:creationId xmlns:a16="http://schemas.microsoft.com/office/drawing/2014/main" id="{A5F29790-1E4C-4B81-AE33-A255BA16910C}"/>
               </a:ext>
             </a:extLst>
           </p:cNvPr>
@@ -2348,7 +2348,7 @@
           <p:cNvPr id="14" name="">
             <a:extLst xmlns:a="http://schemas.openxmlformats.org/drawingml/2006/main">
               <a:ext uri="{FF2B5EF4-FFF2-40B4-BE49-F238E27FC236}">
-                <a16:creationId xmlns:a16="http://schemas.microsoft.com/office/drawing/2014/main" id="{80F15CE9-1606-4C61-A104-B79AFF4814FA}"/>
+                <a16:creationId xmlns:a16="http://schemas.microsoft.com/office/drawing/2014/main" id="{B7AFF103-0AE0-4CB2-9144-92FA8E6068EC}"/>
               </a:ext>
             </a:extLst>
           </p:cNvPr>
@@ -2398,7 +2398,7 @@
           <p:cNvPr id="15" name="">
             <a:extLst xmlns:a="http://schemas.openxmlformats.org/drawingml/2006/main">
               <a:ext uri="{FF2B5EF4-FFF2-40B4-BE49-F238E27FC236}">
-                <a16:creationId xmlns:a16="http://schemas.microsoft.com/office/drawing/2014/main" id="{FE975BE0-7819-490A-A228-0064DC6F914F}"/>
+                <a16:creationId xmlns:a16="http://schemas.microsoft.com/office/drawing/2014/main" id="{072DEE50-D0D2-4EAE-9D61-55BBCE5FEDE9}"/>
               </a:ext>
             </a:extLst>
           </p:cNvPr>
@@ -2446,7 +2446,7 @@
     </p:spTree>
     <p:extLst>
       <p:ext uri="{BB962C8B-B14F-4D97-AF65-F5344CB8AC3E}">
-        <p14:creationId xmlns:p14="http://schemas.microsoft.com/office/powerpoint/2010/main" val="1549167142"/>
+        <p14:creationId xmlns:p14="http://schemas.microsoft.com/office/powerpoint/2010/main" val="1117321373"/>
       </p:ext>
     </p:extLst>
   </p:cSld>
@@ -2477,7 +2477,7 @@
           <p:cNvPr id="14" name="">
             <a:extLst xmlns:a="http://schemas.openxmlformats.org/drawingml/2006/main">
               <a:ext uri="{FF2B5EF4-FFF2-40B4-BE49-F238E27FC236}">
-                <a16:creationId xmlns:a16="http://schemas.microsoft.com/office/drawing/2014/main" id="{C16AA59A-BD22-4C13-B0C5-FAB2879E3C46}"/>
+                <a16:creationId xmlns:a16="http://schemas.microsoft.com/office/drawing/2014/main" id="{60536CB3-FB5C-45C9-B3EA-E43F0F619E87}"/>
               </a:ext>
             </a:extLst>
           </p:cNvPr>
@@ -2527,7 +2527,7 @@
           <p:cNvPr id="2" name="">
             <a:extLst xmlns:a="http://schemas.openxmlformats.org/drawingml/2006/main">
               <a:ext uri="{FF2B5EF4-FFF2-40B4-BE49-F238E27FC236}">
-                <a16:creationId xmlns:a16="http://schemas.microsoft.com/office/drawing/2014/main" id="{4B9124A5-F0DF-4F8B-A6F7-5C00736C990F}"/>
+                <a16:creationId xmlns:a16="http://schemas.microsoft.com/office/drawing/2014/main" id="{547E3963-FC62-4FBB-B3C5-20C3EC71709A}"/>
               </a:ext>
             </a:extLst>
           </p:cNvPr>
@@ -2577,7 +2577,7 @@
           <p:cNvPr id="3" name="">
             <a:extLst xmlns:a="http://schemas.openxmlformats.org/drawingml/2006/main">
               <a:ext uri="{FF2B5EF4-FFF2-40B4-BE49-F238E27FC236}">
-                <a16:creationId xmlns:a16="http://schemas.microsoft.com/office/drawing/2014/main" id="{23DA23A4-2D27-48C3-B1E5-D14DD439DBE8}"/>
+                <a16:creationId xmlns:a16="http://schemas.microsoft.com/office/drawing/2014/main" id="{71592BEF-D46E-4C83-A1B6-40C1089E11D8}"/>
               </a:ext>
             </a:extLst>
           </p:cNvPr>
@@ -2616,7 +2616,7 @@
           <p:nvPr/>
         </p:nvPicPr>
         <p:blipFill>
-          <a:blip xmlns:r="http://schemas.openxmlformats.org/officeDocument/2006/relationships" xmlns:a="http://schemas.openxmlformats.org/drawingml/2006/main" r:embed="Rc652ccb7afff48c1"/>
+          <a:blip xmlns:r="http://schemas.openxmlformats.org/officeDocument/2006/relationships" xmlns:a="http://schemas.openxmlformats.org/drawingml/2006/main" r:embed="Rb38c1f58a5844237"/>
           <a:stretch xmlns:a="http://schemas.openxmlformats.org/drawingml/2006/main"/>
         </p:blipFill>
         <p:spPr>
@@ -2634,7 +2634,7 @@
           <p:cNvPr id="5" name="">
             <a:extLst xmlns:a="http://schemas.openxmlformats.org/drawingml/2006/main">
               <a:ext uri="{FF2B5EF4-FFF2-40B4-BE49-F238E27FC236}">
-                <a16:creationId xmlns:a16="http://schemas.microsoft.com/office/drawing/2014/main" id="{799AB612-0BB8-4FFC-A7E6-0A1437B9CD6B}"/>
+                <a16:creationId xmlns:a16="http://schemas.microsoft.com/office/drawing/2014/main" id="{BBBD5418-8F0D-4E65-B2E8-951F265D5E67}"/>
               </a:ext>
             </a:extLst>
           </p:cNvPr>
@@ -2669,7 +2669,7 @@
           <p:cNvPr id="6" name="">
             <a:extLst xmlns:a="http://schemas.openxmlformats.org/drawingml/2006/main">
               <a:ext uri="{FF2B5EF4-FFF2-40B4-BE49-F238E27FC236}">
-                <a16:creationId xmlns:a16="http://schemas.microsoft.com/office/drawing/2014/main" id="{73569E6B-4898-4726-9DC8-63A85BA77CE6}"/>
+                <a16:creationId xmlns:a16="http://schemas.microsoft.com/office/drawing/2014/main" id="{95185ACD-37DA-414E-962D-89434056A095}"/>
               </a:ext>
             </a:extLst>
           </p:cNvPr>
@@ -2719,7 +2719,7 @@
           <p:cNvPr id="7" name="">
             <a:extLst xmlns:a="http://schemas.openxmlformats.org/drawingml/2006/main">
               <a:ext uri="{FF2B5EF4-FFF2-40B4-BE49-F238E27FC236}">
-                <a16:creationId xmlns:a16="http://schemas.microsoft.com/office/drawing/2014/main" id="{8AEF6E1E-6D4F-46A0-8C33-15A81B8F2806}"/>
+                <a16:creationId xmlns:a16="http://schemas.microsoft.com/office/drawing/2014/main" id="{7A771A9A-534B-4A69-84DE-567DA5974CAE}"/>
               </a:ext>
             </a:extLst>
           </p:cNvPr>
@@ -2769,7 +2769,7 @@
           <p:cNvPr id="8" name="">
             <a:extLst xmlns:a="http://schemas.openxmlformats.org/drawingml/2006/main">
               <a:ext uri="{FF2B5EF4-FFF2-40B4-BE49-F238E27FC236}">
-                <a16:creationId xmlns:a16="http://schemas.microsoft.com/office/drawing/2014/main" id="{95E25240-55B1-4486-8F1A-F8C93598E1E3}"/>
+                <a16:creationId xmlns:a16="http://schemas.microsoft.com/office/drawing/2014/main" id="{FB394521-18CF-475E-9BF0-49C76FF7EC9D}"/>
               </a:ext>
             </a:extLst>
           </p:cNvPr>
@@ -2804,7 +2804,7 @@
           <p:cNvPr id="9" name="">
             <a:extLst xmlns:a="http://schemas.openxmlformats.org/drawingml/2006/main">
               <a:ext uri="{FF2B5EF4-FFF2-40B4-BE49-F238E27FC236}">
-                <a16:creationId xmlns:a16="http://schemas.microsoft.com/office/drawing/2014/main" id="{3F461627-3B8C-4FEA-A511-73B437BFC36F}"/>
+                <a16:creationId xmlns:a16="http://schemas.microsoft.com/office/drawing/2014/main" id="{A753475D-A3FA-4D43-AB47-7C732BD2768D}"/>
               </a:ext>
             </a:extLst>
           </p:cNvPr>
@@ -2854,7 +2854,7 @@
           <p:cNvPr id="10" name="">
             <a:extLst xmlns:a="http://schemas.openxmlformats.org/drawingml/2006/main">
               <a:ext uri="{FF2B5EF4-FFF2-40B4-BE49-F238E27FC236}">
-                <a16:creationId xmlns:a16="http://schemas.microsoft.com/office/drawing/2014/main" id="{8976D35C-DC30-436E-8209-6C0F2DE23B81}"/>
+                <a16:creationId xmlns:a16="http://schemas.microsoft.com/office/drawing/2014/main" id="{C8E20A24-58CC-4010-8319-CC48E82E0AD2}"/>
               </a:ext>
             </a:extLst>
           </p:cNvPr>
@@ -2904,7 +2904,7 @@
           <p:cNvPr id="11" name="">
             <a:extLst xmlns:a="http://schemas.openxmlformats.org/drawingml/2006/main">
               <a:ext uri="{FF2B5EF4-FFF2-40B4-BE49-F238E27FC236}">
-                <a16:creationId xmlns:a16="http://schemas.microsoft.com/office/drawing/2014/main" id="{30B8261E-FE9F-4188-8282-64D462C2B5BA}"/>
+                <a16:creationId xmlns:a16="http://schemas.microsoft.com/office/drawing/2014/main" id="{BA32AE1C-3E0B-4743-93E7-508D8D1D0A0D}"/>
               </a:ext>
             </a:extLst>
           </p:cNvPr>
@@ -2954,7 +2954,7 @@
           <p:cNvPr id="12" name="">
             <a:extLst xmlns:a="http://schemas.openxmlformats.org/drawingml/2006/main">
               <a:ext uri="{FF2B5EF4-FFF2-40B4-BE49-F238E27FC236}">
-                <a16:creationId xmlns:a16="http://schemas.microsoft.com/office/drawing/2014/main" id="{EF074449-55C4-4A01-8526-7E76E1D0CD37}"/>
+                <a16:creationId xmlns:a16="http://schemas.microsoft.com/office/drawing/2014/main" id="{36B91FA5-5950-4DE6-9285-A14986342A28}"/>
               </a:ext>
             </a:extLst>
           </p:cNvPr>
@@ -3004,7 +3004,7 @@
           <p:cNvPr id="13" name="">
             <a:extLst xmlns:a="http://schemas.openxmlformats.org/drawingml/2006/main">
               <a:ext uri="{FF2B5EF4-FFF2-40B4-BE49-F238E27FC236}">
-                <a16:creationId xmlns:a16="http://schemas.microsoft.com/office/drawing/2014/main" id="{1896B789-3AC2-4CCA-B654-0E840877A6C5}"/>
+                <a16:creationId xmlns:a16="http://schemas.microsoft.com/office/drawing/2014/main" id="{AA6111C1-B653-4800-85A1-2AF3F854544A}"/>
               </a:ext>
             </a:extLst>
           </p:cNvPr>
@@ -3052,7 +3052,7 @@
     </p:spTree>
     <p:extLst>
       <p:ext uri="{BB962C8B-B14F-4D97-AF65-F5344CB8AC3E}">
-        <p14:creationId xmlns:p14="http://schemas.microsoft.com/office/powerpoint/2010/main" val="2140125121"/>
+        <p14:creationId xmlns:p14="http://schemas.microsoft.com/office/powerpoint/2010/main" val="1498469192"/>
       </p:ext>
     </p:extLst>
   </p:cSld>
@@ -3083,7 +3083,7 @@
           <p:cNvPr id="26" name="">
             <a:extLst xmlns:a="http://schemas.openxmlformats.org/drawingml/2006/main">
               <a:ext uri="{FF2B5EF4-FFF2-40B4-BE49-F238E27FC236}">
-                <a16:creationId xmlns:a16="http://schemas.microsoft.com/office/drawing/2014/main" id="{276BD223-2F6F-4FCA-901E-CC583D9A8DFF}"/>
+                <a16:creationId xmlns:a16="http://schemas.microsoft.com/office/drawing/2014/main" id="{5E5547E2-F8D1-41D3-BBFA-0FCED9F37510}"/>
               </a:ext>
             </a:extLst>
           </p:cNvPr>
@@ -3133,7 +3133,7 @@
           <p:cNvPr id="2" name="">
             <a:extLst xmlns:a="http://schemas.openxmlformats.org/drawingml/2006/main">
               <a:ext uri="{FF2B5EF4-FFF2-40B4-BE49-F238E27FC236}">
-                <a16:creationId xmlns:a16="http://schemas.microsoft.com/office/drawing/2014/main" id="{F6906ED2-FB7A-457A-8812-64E49C4E2BA9}"/>
+                <a16:creationId xmlns:a16="http://schemas.microsoft.com/office/drawing/2014/main" id="{118B0EAB-8AC2-4D72-B5BB-214EB5A7BAD9}"/>
               </a:ext>
             </a:extLst>
           </p:cNvPr>
@@ -3183,7 +3183,7 @@
           <p:cNvPr id="3" name="">
             <a:extLst xmlns:a="http://schemas.openxmlformats.org/drawingml/2006/main">
               <a:ext uri="{FF2B5EF4-FFF2-40B4-BE49-F238E27FC236}">
-                <a16:creationId xmlns:a16="http://schemas.microsoft.com/office/drawing/2014/main" id="{1D16494C-F1F1-47B3-8B02-312BC2770EC3}"/>
+                <a16:creationId xmlns:a16="http://schemas.microsoft.com/office/drawing/2014/main" id="{B78CB1B7-6F9B-4CBD-A056-E71D80CFAE44}"/>
               </a:ext>
             </a:extLst>
           </p:cNvPr>
@@ -3218,7 +3218,7 @@
           <p:cNvPr id="4" name="">
             <a:extLst xmlns:a="http://schemas.openxmlformats.org/drawingml/2006/main">
               <a:ext uri="{FF2B5EF4-FFF2-40B4-BE49-F238E27FC236}">
-                <a16:creationId xmlns:a16="http://schemas.microsoft.com/office/drawing/2014/main" id="{70BA4936-E19D-4E08-A1B8-917B7AAB8C28}"/>
+                <a16:creationId xmlns:a16="http://schemas.microsoft.com/office/drawing/2014/main" id="{386281B8-C2FD-48CF-93BF-A9E028834111}"/>
               </a:ext>
             </a:extLst>
           </p:cNvPr>
@@ -3268,7 +3268,7 @@
           <p:cNvPr id="5" name="">
             <a:extLst xmlns:a="http://schemas.openxmlformats.org/drawingml/2006/main">
               <a:ext uri="{FF2B5EF4-FFF2-40B4-BE49-F238E27FC236}">
-                <a16:creationId xmlns:a16="http://schemas.microsoft.com/office/drawing/2014/main" id="{C50D260D-CA1C-4FC4-BEB1-28F543C4B578}"/>
+                <a16:creationId xmlns:a16="http://schemas.microsoft.com/office/drawing/2014/main" id="{8389FD71-FA2A-4B4A-826E-3870DE69CD7C}"/>
               </a:ext>
             </a:extLst>
           </p:cNvPr>
@@ -3299,7 +3299,7 @@
           <p:cNvPr id="6" name="">
             <a:extLst xmlns:a="http://schemas.openxmlformats.org/drawingml/2006/main">
               <a:ext uri="{FF2B5EF4-FFF2-40B4-BE49-F238E27FC236}">
-                <a16:creationId xmlns:a16="http://schemas.microsoft.com/office/drawing/2014/main" id="{699B30B7-9799-4B0E-9532-7B75D66D6A38}"/>
+                <a16:creationId xmlns:a16="http://schemas.microsoft.com/office/drawing/2014/main" id="{5D01BB43-31B8-4899-91CA-91A20B1E3477}"/>
               </a:ext>
             </a:extLst>
           </p:cNvPr>
@@ -3349,7 +3349,7 @@
           <p:cNvPr id="7" name="">
             <a:extLst xmlns:a="http://schemas.openxmlformats.org/drawingml/2006/main">
               <a:ext uri="{FF2B5EF4-FFF2-40B4-BE49-F238E27FC236}">
-                <a16:creationId xmlns:a16="http://schemas.microsoft.com/office/drawing/2014/main" id="{76C394B8-600B-4AD1-804A-E8B29D7D3A1D}"/>
+                <a16:creationId xmlns:a16="http://schemas.microsoft.com/office/drawing/2014/main" id="{15E6D17C-A55F-4F53-BC96-5892BD12C8FC}"/>
               </a:ext>
             </a:extLst>
           </p:cNvPr>
@@ -3380,7 +3380,7 @@
           <p:cNvPr id="8" name="">
             <a:extLst xmlns:a="http://schemas.openxmlformats.org/drawingml/2006/main">
               <a:ext uri="{FF2B5EF4-FFF2-40B4-BE49-F238E27FC236}">
-                <a16:creationId xmlns:a16="http://schemas.microsoft.com/office/drawing/2014/main" id="{C838E098-87EE-46B4-80AB-4B2D847618D8}"/>
+                <a16:creationId xmlns:a16="http://schemas.microsoft.com/office/drawing/2014/main" id="{75AED1F2-493B-4BD8-ABE7-5E7F44F072AF}"/>
               </a:ext>
             </a:extLst>
           </p:cNvPr>
@@ -3430,7 +3430,7 @@
           <p:cNvPr id="9" name="">
             <a:extLst xmlns:a="http://schemas.openxmlformats.org/drawingml/2006/main">
               <a:ext uri="{FF2B5EF4-FFF2-40B4-BE49-F238E27FC236}">
-                <a16:creationId xmlns:a16="http://schemas.microsoft.com/office/drawing/2014/main" id="{55E060FD-85F2-4033-A03E-820286F85F30}"/>
+                <a16:creationId xmlns:a16="http://schemas.microsoft.com/office/drawing/2014/main" id="{4621232E-C824-4D6B-9CD4-259D2A91EE65}"/>
               </a:ext>
             </a:extLst>
           </p:cNvPr>
@@ -3461,7 +3461,7 @@
           <p:cNvPr id="10" name="">
             <a:extLst xmlns:a="http://schemas.openxmlformats.org/drawingml/2006/main">
               <a:ext uri="{FF2B5EF4-FFF2-40B4-BE49-F238E27FC236}">
-                <a16:creationId xmlns:a16="http://schemas.microsoft.com/office/drawing/2014/main" id="{BB2028D3-861A-46D0-AD9C-76AFBC03D434}"/>
+                <a16:creationId xmlns:a16="http://schemas.microsoft.com/office/drawing/2014/main" id="{887923AB-C389-47A4-AE18-81ABC92E0E1A}"/>
               </a:ext>
             </a:extLst>
           </p:cNvPr>
@@ -3511,7 +3511,7 @@
           <p:cNvPr id="11" name="">
             <a:extLst xmlns:a="http://schemas.openxmlformats.org/drawingml/2006/main">
               <a:ext uri="{FF2B5EF4-FFF2-40B4-BE49-F238E27FC236}">
-                <a16:creationId xmlns:a16="http://schemas.microsoft.com/office/drawing/2014/main" id="{1960C189-3D83-4249-9811-9A441B63D469}"/>
+                <a16:creationId xmlns:a16="http://schemas.microsoft.com/office/drawing/2014/main" id="{C0F9230A-43FE-462A-8492-B1C3E76104CC}"/>
               </a:ext>
             </a:extLst>
           </p:cNvPr>
@@ -3542,7 +3542,7 @@
           <p:cNvPr id="12" name="">
             <a:extLst xmlns:a="http://schemas.openxmlformats.org/drawingml/2006/main">
               <a:ext uri="{FF2B5EF4-FFF2-40B4-BE49-F238E27FC236}">
-                <a16:creationId xmlns:a16="http://schemas.microsoft.com/office/drawing/2014/main" id="{732FC0FF-963B-4053-B99D-D57B511B3224}"/>
+                <a16:creationId xmlns:a16="http://schemas.microsoft.com/office/drawing/2014/main" id="{3EEC4E6B-B8D9-4381-9935-5DE9FFE9AF5C}"/>
               </a:ext>
             </a:extLst>
           </p:cNvPr>
@@ -3592,7 +3592,7 @@
           <p:cNvPr id="13" name="">
             <a:extLst xmlns:a="http://schemas.openxmlformats.org/drawingml/2006/main">
               <a:ext uri="{FF2B5EF4-FFF2-40B4-BE49-F238E27FC236}">
-                <a16:creationId xmlns:a16="http://schemas.microsoft.com/office/drawing/2014/main" id="{05D78D9E-CA03-4F8D-8923-73B0C8030FB0}"/>
+                <a16:creationId xmlns:a16="http://schemas.microsoft.com/office/drawing/2014/main" id="{94E08F4C-EB1C-41D7-A96C-79C55BB2A616}"/>
               </a:ext>
             </a:extLst>
           </p:cNvPr>
@@ -3642,7 +3642,7 @@
           <p:cNvPr id="14" name="">
             <a:extLst xmlns:a="http://schemas.openxmlformats.org/drawingml/2006/main">
               <a:ext uri="{FF2B5EF4-FFF2-40B4-BE49-F238E27FC236}">
-                <a16:creationId xmlns:a16="http://schemas.microsoft.com/office/drawing/2014/main" id="{E1E64D29-68AA-4686-9270-A48950C5F2D4}"/>
+                <a16:creationId xmlns:a16="http://schemas.microsoft.com/office/drawing/2014/main" id="{4D190A19-6641-450E-97DA-6C4CF783BCA6}"/>
               </a:ext>
             </a:extLst>
           </p:cNvPr>
@@ -3677,7 +3677,7 @@
           <p:cNvPr id="15" name="">
             <a:extLst xmlns:a="http://schemas.openxmlformats.org/drawingml/2006/main">
               <a:ext uri="{FF2B5EF4-FFF2-40B4-BE49-F238E27FC236}">
-                <a16:creationId xmlns:a16="http://schemas.microsoft.com/office/drawing/2014/main" id="{2C32DBF2-FD8F-41D3-B9E7-BDC910DE608C}"/>
+                <a16:creationId xmlns:a16="http://schemas.microsoft.com/office/drawing/2014/main" id="{F064D7E3-AC43-489C-A2EE-A637224F5984}"/>
               </a:ext>
             </a:extLst>
           </p:cNvPr>
@@ -3727,7 +3727,7 @@
           <p:cNvPr id="16" name="">
             <a:extLst xmlns:a="http://schemas.openxmlformats.org/drawingml/2006/main">
               <a:ext uri="{FF2B5EF4-FFF2-40B4-BE49-F238E27FC236}">
-                <a16:creationId xmlns:a16="http://schemas.microsoft.com/office/drawing/2014/main" id="{F87EFA5B-6075-49B6-A79E-2C496BB66906}"/>
+                <a16:creationId xmlns:a16="http://schemas.microsoft.com/office/drawing/2014/main" id="{F5B7FD58-A639-478D-BD1C-08D1B331A1D3}"/>
               </a:ext>
             </a:extLst>
           </p:cNvPr>
@@ -3758,7 +3758,7 @@
           <p:cNvPr id="17" name="">
             <a:extLst xmlns:a="http://schemas.openxmlformats.org/drawingml/2006/main">
               <a:ext uri="{FF2B5EF4-FFF2-40B4-BE49-F238E27FC236}">
-                <a16:creationId xmlns:a16="http://schemas.microsoft.com/office/drawing/2014/main" id="{BD1E0FBD-FFB5-4F61-B52D-73900F41B197}"/>
+                <a16:creationId xmlns:a16="http://schemas.microsoft.com/office/drawing/2014/main" id="{E46B2366-7F83-43DF-87C5-0D734CE8A58E}"/>
               </a:ext>
             </a:extLst>
           </p:cNvPr>
@@ -3808,7 +3808,7 @@
           <p:cNvPr id="18" name="">
             <a:extLst xmlns:a="http://schemas.openxmlformats.org/drawingml/2006/main">
               <a:ext uri="{FF2B5EF4-FFF2-40B4-BE49-F238E27FC236}">
-                <a16:creationId xmlns:a16="http://schemas.microsoft.com/office/drawing/2014/main" id="{9F8BAC5C-5C39-41D4-8F44-9AA18A3B0C3A}"/>
+                <a16:creationId xmlns:a16="http://schemas.microsoft.com/office/drawing/2014/main" id="{063C8164-8C0C-4E53-B48F-C72F28B5142F}"/>
               </a:ext>
             </a:extLst>
           </p:cNvPr>
@@ -3839,7 +3839,7 @@
           <p:cNvPr id="19" name="">
             <a:extLst xmlns:a="http://schemas.openxmlformats.org/drawingml/2006/main">
               <a:ext uri="{FF2B5EF4-FFF2-40B4-BE49-F238E27FC236}">
-                <a16:creationId xmlns:a16="http://schemas.microsoft.com/office/drawing/2014/main" id="{FBBD1F50-4C2C-4335-9C67-055114E94591}"/>
+                <a16:creationId xmlns:a16="http://schemas.microsoft.com/office/drawing/2014/main" id="{8462A991-5144-4887-BD51-FB468D56540D}"/>
               </a:ext>
             </a:extLst>
           </p:cNvPr>
@@ -3889,7 +3889,7 @@
           <p:cNvPr id="20" name="">
             <a:extLst xmlns:a="http://schemas.openxmlformats.org/drawingml/2006/main">
               <a:ext uri="{FF2B5EF4-FFF2-40B4-BE49-F238E27FC236}">
-                <a16:creationId xmlns:a16="http://schemas.microsoft.com/office/drawing/2014/main" id="{D003EDC9-BF09-4D4E-BD4E-E085488A4981}"/>
+                <a16:creationId xmlns:a16="http://schemas.microsoft.com/office/drawing/2014/main" id="{B78EF5C9-1024-45F4-B8FB-852282DA1E4B}"/>
               </a:ext>
             </a:extLst>
           </p:cNvPr>
@@ -3920,7 +3920,7 @@
           <p:cNvPr id="21" name="">
             <a:extLst xmlns:a="http://schemas.openxmlformats.org/drawingml/2006/main">
               <a:ext uri="{FF2B5EF4-FFF2-40B4-BE49-F238E27FC236}">
-                <a16:creationId xmlns:a16="http://schemas.microsoft.com/office/drawing/2014/main" id="{11D831CD-8A59-414A-B720-9EFF3F9E0C3D}"/>
+                <a16:creationId xmlns:a16="http://schemas.microsoft.com/office/drawing/2014/main" id="{BC9514C3-1E44-46AD-A651-D137C9269369}"/>
               </a:ext>
             </a:extLst>
           </p:cNvPr>
@@ -3970,7 +3970,7 @@
           <p:cNvPr id="22" name="">
             <a:extLst xmlns:a="http://schemas.openxmlformats.org/drawingml/2006/main">
               <a:ext uri="{FF2B5EF4-FFF2-40B4-BE49-F238E27FC236}">
-                <a16:creationId xmlns:a16="http://schemas.microsoft.com/office/drawing/2014/main" id="{64DC2A31-72C5-4B2F-9DE8-E484282CF975}"/>
+                <a16:creationId xmlns:a16="http://schemas.microsoft.com/office/drawing/2014/main" id="{BF7A70BF-7DD1-4696-B309-DF85A47E2B77}"/>
               </a:ext>
             </a:extLst>
           </p:cNvPr>
@@ -4001,7 +4001,7 @@
           <p:cNvPr id="23" name="">
             <a:extLst xmlns:a="http://schemas.openxmlformats.org/drawingml/2006/main">
               <a:ext uri="{FF2B5EF4-FFF2-40B4-BE49-F238E27FC236}">
-                <a16:creationId xmlns:a16="http://schemas.microsoft.com/office/drawing/2014/main" id="{57A26081-F69A-43A0-B695-CEE2C8B2A024}"/>
+                <a16:creationId xmlns:a16="http://schemas.microsoft.com/office/drawing/2014/main" id="{18E23812-C9D8-4191-B32C-BC0064E98036}"/>
               </a:ext>
             </a:extLst>
           </p:cNvPr>
@@ -4051,7 +4051,7 @@
           <p:cNvPr id="24" name="">
             <a:extLst xmlns:a="http://schemas.openxmlformats.org/drawingml/2006/main">
               <a:ext uri="{FF2B5EF4-FFF2-40B4-BE49-F238E27FC236}">
-                <a16:creationId xmlns:a16="http://schemas.microsoft.com/office/drawing/2014/main" id="{1B1FC787-6117-4591-A247-C70AD4EC4EF8}"/>
+                <a16:creationId xmlns:a16="http://schemas.microsoft.com/office/drawing/2014/main" id="{99D051D7-325E-4400-87BB-A05491DC788C}"/>
               </a:ext>
             </a:extLst>
           </p:cNvPr>
@@ -4101,7 +4101,7 @@
           <p:cNvPr id="25" name="">
             <a:extLst xmlns:a="http://schemas.openxmlformats.org/drawingml/2006/main">
               <a:ext uri="{FF2B5EF4-FFF2-40B4-BE49-F238E27FC236}">
-                <a16:creationId xmlns:a16="http://schemas.microsoft.com/office/drawing/2014/main" id="{A405F162-4C48-42E9-909F-8C847513BB90}"/>
+                <a16:creationId xmlns:a16="http://schemas.microsoft.com/office/drawing/2014/main" id="{FA277944-A3E3-4A02-A665-7198791EFB1C}"/>
               </a:ext>
             </a:extLst>
           </p:cNvPr>
@@ -4149,7 +4149,7 @@
     </p:spTree>
     <p:extLst>
       <p:ext uri="{BB962C8B-B14F-4D97-AF65-F5344CB8AC3E}">
-        <p14:creationId xmlns:p14="http://schemas.microsoft.com/office/powerpoint/2010/main" val="200175440"/>
+        <p14:creationId xmlns:p14="http://schemas.microsoft.com/office/powerpoint/2010/main" val="1355220629"/>
       </p:ext>
     </p:extLst>
   </p:cSld>
@@ -4177,10 +4177,10 @@
       </p:grpSpPr>
       <p:sp>
         <p:nvSpPr>
-          <p:cNvPr id="9" name="">
-            <a:extLst xmlns:a="http://schemas.openxmlformats.org/drawingml/2006/main">
-              <a:ext uri="{FF2B5EF4-FFF2-40B4-BE49-F238E27FC236}">
-                <a16:creationId xmlns:a16="http://schemas.microsoft.com/office/drawing/2014/main" id="{0D95E657-4C7E-4B10-A25D-2BE6E78F0C24}"/>
+          <p:cNvPr id="8" name="">
+            <a:extLst xmlns:a="http://schemas.openxmlformats.org/drawingml/2006/main">
+              <a:ext uri="{FF2B5EF4-FFF2-40B4-BE49-F238E27FC236}">
+                <a16:creationId xmlns:a16="http://schemas.microsoft.com/office/drawing/2014/main" id="{544E4C8F-8A61-4A07-AC1F-3F6066AEE8BA}"/>
               </a:ext>
             </a:extLst>
           </p:cNvPr>
@@ -4230,7 +4230,7 @@
           <p:cNvPr id="2" name="">
             <a:extLst xmlns:a="http://schemas.openxmlformats.org/drawingml/2006/main">
               <a:ext uri="{FF2B5EF4-FFF2-40B4-BE49-F238E27FC236}">
-                <a16:creationId xmlns:a16="http://schemas.microsoft.com/office/drawing/2014/main" id="{179CB9E9-F6EC-4D0F-BAF3-166CDC45C672}"/>
+                <a16:creationId xmlns:a16="http://schemas.microsoft.com/office/drawing/2014/main" id="{8EE3802A-0C4C-4FD0-A291-B7D741582B0C}"/>
               </a:ext>
             </a:extLst>
           </p:cNvPr>
@@ -4270,7 +4270,7 @@
                   <a:srgbClr val="64748B"/>
                 </a:solidFill>
               </a:rPr>
-              <a:t>One tool-gap row shows where replay spends time before the first useful token.</a:t>
+              <a:t>Several tool-gap sessions show where replay spends time before the first useful token.</a:t>
             </a:r>
           </a:p>
         </p:txBody>
@@ -4280,23 +4280,23 @@
           <p:cNvPr id="3" name="">
             <a:extLst xmlns:a="http://schemas.openxmlformats.org/drawingml/2006/main">
               <a:ext uri="{FF2B5EF4-FFF2-40B4-BE49-F238E27FC236}">
-                <a16:creationId xmlns:a16="http://schemas.microsoft.com/office/drawing/2014/main" id="{7FB6521F-C60B-498F-99E2-1DB3FF66CB10}"/>
-              </a:ext>
-            </a:extLst>
-          </p:cNvPr>
-          <p:cNvSpPr>
-            <a:spLocks xmlns:a="http://schemas.openxmlformats.org/drawingml/2006/main" noGrp="1"/>
-          </p:cNvSpPr>
-          <p:nvPr/>
-        </p:nvSpPr>
-        <p:spPr>
-          <a:xfrm xmlns:a="http://schemas.openxmlformats.org/drawingml/2006/main">
-            <a:off x="323850" y="1371600"/>
-            <a:ext cx="11201400" cy="4438650"/>
+                <a16:creationId xmlns:a16="http://schemas.microsoft.com/office/drawing/2014/main" id="{E9E67C26-5CD8-4172-9AE2-3F1208A66164}"/>
+              </a:ext>
+            </a:extLst>
+          </p:cNvPr>
+          <p:cNvSpPr>
+            <a:spLocks xmlns:a="http://schemas.openxmlformats.org/drawingml/2006/main" noGrp="1"/>
+          </p:cNvSpPr>
+          <p:nvPr/>
+        </p:nvSpPr>
+        <p:spPr>
+          <a:xfrm xmlns:a="http://schemas.openxmlformats.org/drawingml/2006/main">
+            <a:off x="228600" y="1181100"/>
+            <a:ext cx="11734800" cy="4972050"/>
           </a:xfrm>
           <a:prstGeom xmlns:a="http://schemas.openxmlformats.org/drawingml/2006/main" prst="roundRect">
             <a:avLst>
-              <a:gd name="adj" fmla="val 1288"/>
+              <a:gd name="adj" fmla="val 1149"/>
             </a:avLst>
           </a:prstGeom>
           <a:solidFill xmlns:a="http://schemas.openxmlformats.org/drawingml/2006/main">
@@ -4312,20 +4312,20 @@
       </p:sp>
       <p:pic>
         <p:nvPicPr>
-          <p:cNvPr id="12" name=""/>
+          <p:cNvPr id="11" name=""/>
           <p:cNvPicPr>
             <a:picLocks xmlns:a="http://schemas.openxmlformats.org/drawingml/2006/main" noChangeAspect="1"/>
           </p:cNvPicPr>
           <p:nvPr/>
         </p:nvPicPr>
         <p:blipFill>
-          <a:blip xmlns:r="http://schemas.openxmlformats.org/officeDocument/2006/relationships" xmlns:a="http://schemas.openxmlformats.org/drawingml/2006/main" r:embed="R7e766f32f879457e"/>
+          <a:blip xmlns:r="http://schemas.openxmlformats.org/officeDocument/2006/relationships" xmlns:a="http://schemas.openxmlformats.org/drawingml/2006/main" r:embed="R17ca1f81781040ea"/>
           <a:stretch xmlns:a="http://schemas.openxmlformats.org/drawingml/2006/main"/>
         </p:blipFill>
         <p:spPr>
           <a:xfrm xmlns:a="http://schemas.openxmlformats.org/drawingml/2006/main">
-            <a:off x="400050" y="1448639"/>
-            <a:ext cx="11049000" cy="4284571"/>
+            <a:off x="304800" y="1285315"/>
+            <a:ext cx="11582400" cy="4763619"/>
           </a:xfrm>
           <a:prstGeom xmlns:a="http://schemas.openxmlformats.org/drawingml/2006/main" prst="rect">
             <a:avLst/>
@@ -4337,57 +4337,7 @@
           <p:cNvPr id="5" name="">
             <a:extLst xmlns:a="http://schemas.openxmlformats.org/drawingml/2006/main">
               <a:ext uri="{FF2B5EF4-FFF2-40B4-BE49-F238E27FC236}">
-                <a16:creationId xmlns:a16="http://schemas.microsoft.com/office/drawing/2014/main" id="{E2E5464B-FB44-4566-944F-80AAD20B35E8}"/>
-              </a:ext>
-            </a:extLst>
-          </p:cNvPr>
-          <p:cNvSpPr>
-            <a:spLocks xmlns:a="http://schemas.openxmlformats.org/drawingml/2006/main" noGrp="1"/>
-          </p:cNvSpPr>
-          <p:nvPr/>
-        </p:nvSpPr>
-        <p:spPr>
-          <a:xfrm xmlns:a="http://schemas.openxmlformats.org/drawingml/2006/main">
-            <a:off x="685800" y="5829300"/>
-            <a:ext cx="9810750" cy="228600"/>
-          </a:xfrm>
-          <a:prstGeom xmlns:a="http://schemas.openxmlformats.org/drawingml/2006/main" prst="rect">
-            <a:avLst/>
-          </a:prstGeom>
-          <a:noFill xmlns:a="http://schemas.openxmlformats.org/drawingml/2006/main"/>
-          <a:ln xmlns:a="http://schemas.openxmlformats.org/drawingml/2006/main" w="0">
-            <a:noFill/>
-            <a:prstDash val="solid"/>
-          </a:ln>
-        </p:spPr>
-        <p:txBody>
-          <a:bodyPr xmlns:a="http://schemas.openxmlformats.org/drawingml/2006/main" anchor="t"/>
-          <a:lstStyle xmlns:a="http://schemas.openxmlformats.org/drawingml/2006/main"/>
-          <a:p xmlns:a="http://schemas.openxmlformats.org/drawingml/2006/main">
-            <a:pPr algn="l">
-              <a:defRPr sz="1275" b="0">
-                <a:solidFill>
-                  <a:srgbClr val="334155"/>
-                </a:solidFill>
-              </a:defRPr>
-            </a:pPr>
-            <a:r>
-              <a:rPr sz="1275" b="0">
-                <a:solidFill>
-                  <a:srgbClr val="334155"/>
-                </a:solidFill>
-              </a:rPr>
-              <a:t>Read left to right: model turn → tool wait → replay path. Cyan is host-to-device KV load; magenta/gold are work before first token.</a:t>
-            </a:r>
-          </a:p>
-        </p:txBody>
-      </p:sp>
-      <p:sp>
-        <p:nvSpPr>
-          <p:cNvPr id="6" name="">
-            <a:extLst xmlns:a="http://schemas.openxmlformats.org/drawingml/2006/main">
-              <a:ext uri="{FF2B5EF4-FFF2-40B4-BE49-F238E27FC236}">
-                <a16:creationId xmlns:a16="http://schemas.microsoft.com/office/drawing/2014/main" id="{79B6D2BD-6F9A-4649-91D0-47DE8B472083}"/>
+                <a16:creationId xmlns:a16="http://schemas.microsoft.com/office/drawing/2014/main" id="{6B6ABFDA-3D76-4248-8F4B-E976567063D2}"/>
               </a:ext>
             </a:extLst>
           </p:cNvPr>
@@ -4434,10 +4384,10 @@
       </p:sp>
       <p:sp>
         <p:nvSpPr>
-          <p:cNvPr id="7" name="">
-            <a:extLst xmlns:a="http://schemas.openxmlformats.org/drawingml/2006/main">
-              <a:ext uri="{FF2B5EF4-FFF2-40B4-BE49-F238E27FC236}">
-                <a16:creationId xmlns:a16="http://schemas.microsoft.com/office/drawing/2014/main" id="{13660B54-4055-4DC6-9BA2-FC76F671A702}"/>
+          <p:cNvPr id="6" name="">
+            <a:extLst xmlns:a="http://schemas.openxmlformats.org/drawingml/2006/main">
+              <a:ext uri="{FF2B5EF4-FFF2-40B4-BE49-F238E27FC236}">
+                <a16:creationId xmlns:a16="http://schemas.microsoft.com/office/drawing/2014/main" id="{5BD9A2D0-8755-45BB-BEBB-FABF7E0BD5E0}"/>
               </a:ext>
             </a:extLst>
           </p:cNvPr>
@@ -4484,10 +4434,10 @@
       </p:sp>
       <p:sp>
         <p:nvSpPr>
-          <p:cNvPr id="8" name="">
-            <a:extLst xmlns:a="http://schemas.openxmlformats.org/drawingml/2006/main">
-              <a:ext uri="{FF2B5EF4-FFF2-40B4-BE49-F238E27FC236}">
-                <a16:creationId xmlns:a16="http://schemas.microsoft.com/office/drawing/2014/main" id="{9350C413-6416-4BDE-B2F3-0DD7B05784EA}"/>
+          <p:cNvPr id="7" name="">
+            <a:extLst xmlns:a="http://schemas.openxmlformats.org/drawingml/2006/main">
+              <a:ext uri="{FF2B5EF4-FFF2-40B4-BE49-F238E27FC236}">
+                <a16:creationId xmlns:a16="http://schemas.microsoft.com/office/drawing/2014/main" id="{D8ECD703-E2C7-4EE9-8797-2021C2220D16}"/>
               </a:ext>
             </a:extLst>
           </p:cNvPr>
@@ -4535,7 +4485,7 @@
     </p:spTree>
     <p:extLst>
       <p:ext uri="{BB962C8B-B14F-4D97-AF65-F5344CB8AC3E}">
-        <p14:creationId xmlns:p14="http://schemas.microsoft.com/office/powerpoint/2010/main" val="1443224644"/>
+        <p14:creationId xmlns:p14="http://schemas.microsoft.com/office/powerpoint/2010/main" val="638383710"/>
       </p:ext>
     </p:extLst>
   </p:cSld>
@@ -4566,7 +4516,7 @@
           <p:cNvPr id="16" name="">
             <a:extLst xmlns:a="http://schemas.openxmlformats.org/drawingml/2006/main">
               <a:ext uri="{FF2B5EF4-FFF2-40B4-BE49-F238E27FC236}">
-                <a16:creationId xmlns:a16="http://schemas.microsoft.com/office/drawing/2014/main" id="{81780E68-F39D-4CAA-B684-B6B63967E843}"/>
+                <a16:creationId xmlns:a16="http://schemas.microsoft.com/office/drawing/2014/main" id="{0AF20165-E0EE-4304-8FC5-39BD9A5E2F4A}"/>
               </a:ext>
             </a:extLst>
           </p:cNvPr>
@@ -4616,7 +4566,7 @@
           <p:cNvPr id="2" name="">
             <a:extLst xmlns:a="http://schemas.openxmlformats.org/drawingml/2006/main">
               <a:ext uri="{FF2B5EF4-FFF2-40B4-BE49-F238E27FC236}">
-                <a16:creationId xmlns:a16="http://schemas.microsoft.com/office/drawing/2014/main" id="{7E2DD1F0-53AB-4698-A3F4-05058BB281B2}"/>
+                <a16:creationId xmlns:a16="http://schemas.microsoft.com/office/drawing/2014/main" id="{A079478B-24A7-4DDC-A3E5-89C182630F86}"/>
               </a:ext>
             </a:extLst>
           </p:cNvPr>
@@ -4666,7 +4616,7 @@
           <p:cNvPr id="3" name="">
             <a:extLst xmlns:a="http://schemas.openxmlformats.org/drawingml/2006/main">
               <a:ext uri="{FF2B5EF4-FFF2-40B4-BE49-F238E27FC236}">
-                <a16:creationId xmlns:a16="http://schemas.microsoft.com/office/drawing/2014/main" id="{9682BCD0-3A5E-4FD1-9388-6917E642E1A3}"/>
+                <a16:creationId xmlns:a16="http://schemas.microsoft.com/office/drawing/2014/main" id="{0DCB7E3C-21C8-4407-9248-F61AFD86DC9A}"/>
               </a:ext>
             </a:extLst>
           </p:cNvPr>
@@ -4705,7 +4655,7 @@
           <p:nvPr/>
         </p:nvPicPr>
         <p:blipFill>
-          <a:blip xmlns:r="http://schemas.openxmlformats.org/officeDocument/2006/relationships" xmlns:a="http://schemas.openxmlformats.org/drawingml/2006/main" r:embed="R2b32a3f26fd14672"/>
+          <a:blip xmlns:r="http://schemas.openxmlformats.org/officeDocument/2006/relationships" xmlns:a="http://schemas.openxmlformats.org/drawingml/2006/main" r:embed="R4354e2c2031a4581"/>
           <a:stretch xmlns:a="http://schemas.openxmlformats.org/drawingml/2006/main"/>
         </p:blipFill>
         <p:spPr>
@@ -4723,7 +4673,7 @@
           <p:cNvPr id="5" name="">
             <a:extLst xmlns:a="http://schemas.openxmlformats.org/drawingml/2006/main">
               <a:ext uri="{FF2B5EF4-FFF2-40B4-BE49-F238E27FC236}">
-                <a16:creationId xmlns:a16="http://schemas.microsoft.com/office/drawing/2014/main" id="{5814B9E2-EC79-4017-A3AC-79C6DAE7C64A}"/>
+                <a16:creationId xmlns:a16="http://schemas.microsoft.com/office/drawing/2014/main" id="{3DC1BF31-9B2E-484B-B32A-151A763D1862}"/>
               </a:ext>
             </a:extLst>
           </p:cNvPr>
@@ -4758,7 +4708,7 @@
           <p:cNvPr id="6" name="">
             <a:extLst xmlns:a="http://schemas.openxmlformats.org/drawingml/2006/main">
               <a:ext uri="{FF2B5EF4-FFF2-40B4-BE49-F238E27FC236}">
-                <a16:creationId xmlns:a16="http://schemas.microsoft.com/office/drawing/2014/main" id="{D14983F6-72A1-48B7-8E39-1862299D5ECA}"/>
+                <a16:creationId xmlns:a16="http://schemas.microsoft.com/office/drawing/2014/main" id="{F9BC519B-CC45-4A8F-9111-EBE43D6E6BAB}"/>
               </a:ext>
             </a:extLst>
           </p:cNvPr>
@@ -4808,7 +4758,7 @@
           <p:cNvPr id="7" name="">
             <a:extLst xmlns:a="http://schemas.openxmlformats.org/drawingml/2006/main">
               <a:ext uri="{FF2B5EF4-FFF2-40B4-BE49-F238E27FC236}">
-                <a16:creationId xmlns:a16="http://schemas.microsoft.com/office/drawing/2014/main" id="{4CF89ED6-8534-4D62-AF86-67892F93CBFD}"/>
+                <a16:creationId xmlns:a16="http://schemas.microsoft.com/office/drawing/2014/main" id="{3BCD2609-8C0B-4DBF-B08A-5A3699130D0B}"/>
               </a:ext>
             </a:extLst>
           </p:cNvPr>
@@ -4858,7 +4808,7 @@
           <p:cNvPr id="8" name="">
             <a:extLst xmlns:a="http://schemas.openxmlformats.org/drawingml/2006/main">
               <a:ext uri="{FF2B5EF4-FFF2-40B4-BE49-F238E27FC236}">
-                <a16:creationId xmlns:a16="http://schemas.microsoft.com/office/drawing/2014/main" id="{E83491FB-3825-4EA4-9258-C5366DDA66E9}"/>
+                <a16:creationId xmlns:a16="http://schemas.microsoft.com/office/drawing/2014/main" id="{BC65F419-9551-41C2-8C85-21B638A49B33}"/>
               </a:ext>
             </a:extLst>
           </p:cNvPr>
@@ -4908,7 +4858,7 @@
           <p:cNvPr id="9" name="">
             <a:extLst xmlns:a="http://schemas.openxmlformats.org/drawingml/2006/main">
               <a:ext uri="{FF2B5EF4-FFF2-40B4-BE49-F238E27FC236}">
-                <a16:creationId xmlns:a16="http://schemas.microsoft.com/office/drawing/2014/main" id="{7FCB1E35-7C1A-4DE9-AFAA-0E85147FB2E6}"/>
+                <a16:creationId xmlns:a16="http://schemas.microsoft.com/office/drawing/2014/main" id="{3C50A6A6-2CB8-45A4-B4FF-3452DA3B7DBB}"/>
               </a:ext>
             </a:extLst>
           </p:cNvPr>
@@ -4943,7 +4893,7 @@
           <p:cNvPr id="10" name="">
             <a:extLst xmlns:a="http://schemas.openxmlformats.org/drawingml/2006/main">
               <a:ext uri="{FF2B5EF4-FFF2-40B4-BE49-F238E27FC236}">
-                <a16:creationId xmlns:a16="http://schemas.microsoft.com/office/drawing/2014/main" id="{678C4100-DD6B-4132-8CE2-A97F8DE72B4B}"/>
+                <a16:creationId xmlns:a16="http://schemas.microsoft.com/office/drawing/2014/main" id="{01E8DD12-6009-4562-971F-5BD7CF3F4501}"/>
               </a:ext>
             </a:extLst>
           </p:cNvPr>
@@ -4993,7 +4943,7 @@
           <p:cNvPr id="11" name="">
             <a:extLst xmlns:a="http://schemas.openxmlformats.org/drawingml/2006/main">
               <a:ext uri="{FF2B5EF4-FFF2-40B4-BE49-F238E27FC236}">
-                <a16:creationId xmlns:a16="http://schemas.microsoft.com/office/drawing/2014/main" id="{C341851C-F33D-4E45-A148-1D4450CAD2BC}"/>
+                <a16:creationId xmlns:a16="http://schemas.microsoft.com/office/drawing/2014/main" id="{19C77AE1-BBF2-4A8F-928E-2BA8A7A1BCF6}"/>
               </a:ext>
             </a:extLst>
           </p:cNvPr>
@@ -5043,7 +4993,7 @@
           <p:cNvPr id="12" name="">
             <a:extLst xmlns:a="http://schemas.openxmlformats.org/drawingml/2006/main">
               <a:ext uri="{FF2B5EF4-FFF2-40B4-BE49-F238E27FC236}">
-                <a16:creationId xmlns:a16="http://schemas.microsoft.com/office/drawing/2014/main" id="{937611C3-918F-479B-AEF3-D12A7B01AA32}"/>
+                <a16:creationId xmlns:a16="http://schemas.microsoft.com/office/drawing/2014/main" id="{CF4C2D29-6799-4FA9-8F1B-7A5E3A91E9AD}"/>
               </a:ext>
             </a:extLst>
           </p:cNvPr>
@@ -5093,7 +5043,7 @@
           <p:cNvPr id="13" name="">
             <a:extLst xmlns:a="http://schemas.openxmlformats.org/drawingml/2006/main">
               <a:ext uri="{FF2B5EF4-FFF2-40B4-BE49-F238E27FC236}">
-                <a16:creationId xmlns:a16="http://schemas.microsoft.com/office/drawing/2014/main" id="{10AD9847-D479-484A-BCA1-D22732B5D21A}"/>
+                <a16:creationId xmlns:a16="http://schemas.microsoft.com/office/drawing/2014/main" id="{857506D5-7B57-4F4B-B55F-89BE0F8F7CA5}"/>
               </a:ext>
             </a:extLst>
           </p:cNvPr>
@@ -5143,7 +5093,7 @@
           <p:cNvPr id="14" name="">
             <a:extLst xmlns:a="http://schemas.openxmlformats.org/drawingml/2006/main">
               <a:ext uri="{FF2B5EF4-FFF2-40B4-BE49-F238E27FC236}">
-                <a16:creationId xmlns:a16="http://schemas.microsoft.com/office/drawing/2014/main" id="{EE5E3AF0-892B-4742-9853-4623B4DE2826}"/>
+                <a16:creationId xmlns:a16="http://schemas.microsoft.com/office/drawing/2014/main" id="{3E784F4F-1AB5-4D61-B3FD-1982361AD487}"/>
               </a:ext>
             </a:extLst>
           </p:cNvPr>
@@ -5193,7 +5143,7 @@
           <p:cNvPr id="15" name="">
             <a:extLst xmlns:a="http://schemas.openxmlformats.org/drawingml/2006/main">
               <a:ext uri="{FF2B5EF4-FFF2-40B4-BE49-F238E27FC236}">
-                <a16:creationId xmlns:a16="http://schemas.microsoft.com/office/drawing/2014/main" id="{D1C7EACD-9FD3-4C5C-B71F-E3087E5AF3B8}"/>
+                <a16:creationId xmlns:a16="http://schemas.microsoft.com/office/drawing/2014/main" id="{112A6333-9B24-4DFD-B8B4-F8D4E1718959}"/>
               </a:ext>
             </a:extLst>
           </p:cNvPr>
@@ -5241,7 +5191,7 @@
     </p:spTree>
     <p:extLst>
       <p:ext uri="{BB962C8B-B14F-4D97-AF65-F5344CB8AC3E}">
-        <p14:creationId xmlns:p14="http://schemas.microsoft.com/office/powerpoint/2010/main" val="800335588"/>
+        <p14:creationId xmlns:p14="http://schemas.microsoft.com/office/powerpoint/2010/main" val="536714194"/>
       </p:ext>
     </p:extLst>
   </p:cSld>
@@ -5272,7 +5222,7 @@
           <p:cNvPr id="12" name="">
             <a:extLst xmlns:a="http://schemas.openxmlformats.org/drawingml/2006/main">
               <a:ext uri="{FF2B5EF4-FFF2-40B4-BE49-F238E27FC236}">
-                <a16:creationId xmlns:a16="http://schemas.microsoft.com/office/drawing/2014/main" id="{730089FF-3EF7-4EB2-A563-392526D1DD11}"/>
+                <a16:creationId xmlns:a16="http://schemas.microsoft.com/office/drawing/2014/main" id="{190A680A-6C87-4520-83DA-2DCDF1D1B767}"/>
               </a:ext>
             </a:extLst>
           </p:cNvPr>
@@ -5322,7 +5272,7 @@
           <p:cNvPr id="2" name="">
             <a:extLst xmlns:a="http://schemas.openxmlformats.org/drawingml/2006/main">
               <a:ext uri="{FF2B5EF4-FFF2-40B4-BE49-F238E27FC236}">
-                <a16:creationId xmlns:a16="http://schemas.microsoft.com/office/drawing/2014/main" id="{F69214AA-04BD-4EA8-9984-B1E14896D56D}"/>
+                <a16:creationId xmlns:a16="http://schemas.microsoft.com/office/drawing/2014/main" id="{C93026AD-F4B1-40CF-8401-EC7071FEB63C}"/>
               </a:ext>
             </a:extLst>
           </p:cNvPr>
@@ -5372,7 +5322,7 @@
           <p:cNvPr id="3" name="">
             <a:extLst xmlns:a="http://schemas.openxmlformats.org/drawingml/2006/main">
               <a:ext uri="{FF2B5EF4-FFF2-40B4-BE49-F238E27FC236}">
-                <a16:creationId xmlns:a16="http://schemas.microsoft.com/office/drawing/2014/main" id="{AE4A1B50-C618-4D62-8AE9-3D3498F67C55}"/>
+                <a16:creationId xmlns:a16="http://schemas.microsoft.com/office/drawing/2014/main" id="{2AD938CD-B4BE-4673-A59E-76121FF0D858}"/>
               </a:ext>
             </a:extLst>
           </p:cNvPr>
@@ -5411,7 +5361,7 @@
           <p:nvPr/>
         </p:nvPicPr>
         <p:blipFill>
-          <a:blip xmlns:r="http://schemas.openxmlformats.org/officeDocument/2006/relationships" xmlns:a="http://schemas.openxmlformats.org/drawingml/2006/main" r:embed="R0f2ba06b4cb54345"/>
+          <a:blip xmlns:r="http://schemas.openxmlformats.org/officeDocument/2006/relationships" xmlns:a="http://schemas.openxmlformats.org/drawingml/2006/main" r:embed="Ra2c93e584e3f462c"/>
           <a:stretch xmlns:a="http://schemas.openxmlformats.org/drawingml/2006/main"/>
         </p:blipFill>
         <p:spPr>
@@ -5429,7 +5379,7 @@
           <p:cNvPr id="5" name="">
             <a:extLst xmlns:a="http://schemas.openxmlformats.org/drawingml/2006/main">
               <a:ext uri="{FF2B5EF4-FFF2-40B4-BE49-F238E27FC236}">
-                <a16:creationId xmlns:a16="http://schemas.microsoft.com/office/drawing/2014/main" id="{1A371C9C-4E11-4364-9B17-A686138A5B12}"/>
+                <a16:creationId xmlns:a16="http://schemas.microsoft.com/office/drawing/2014/main" id="{B695C50C-6379-4C4F-A015-0D80A7546505}"/>
               </a:ext>
             </a:extLst>
           </p:cNvPr>
@@ -5464,7 +5414,7 @@
           <p:cNvPr id="6" name="">
             <a:extLst xmlns:a="http://schemas.openxmlformats.org/drawingml/2006/main">
               <a:ext uri="{FF2B5EF4-FFF2-40B4-BE49-F238E27FC236}">
-                <a16:creationId xmlns:a16="http://schemas.microsoft.com/office/drawing/2014/main" id="{36F17F41-E0DB-4F2D-91B2-2ABBFBF44484}"/>
+                <a16:creationId xmlns:a16="http://schemas.microsoft.com/office/drawing/2014/main" id="{6C572B9C-D3B8-4B6C-B370-AF2614355B5C}"/>
               </a:ext>
             </a:extLst>
           </p:cNvPr>
@@ -5514,7 +5464,7 @@
           <p:cNvPr id="7" name="">
             <a:extLst xmlns:a="http://schemas.openxmlformats.org/drawingml/2006/main">
               <a:ext uri="{FF2B5EF4-FFF2-40B4-BE49-F238E27FC236}">
-                <a16:creationId xmlns:a16="http://schemas.microsoft.com/office/drawing/2014/main" id="{AD784674-C112-4C68-884F-54630FFCB04F}"/>
+                <a16:creationId xmlns:a16="http://schemas.microsoft.com/office/drawing/2014/main" id="{D037560F-DF01-4DA9-A258-0C7B9D62C918}"/>
               </a:ext>
             </a:extLst>
           </p:cNvPr>
@@ -5564,7 +5514,7 @@
           <p:cNvPr id="8" name="">
             <a:extLst xmlns:a="http://schemas.openxmlformats.org/drawingml/2006/main">
               <a:ext uri="{FF2B5EF4-FFF2-40B4-BE49-F238E27FC236}">
-                <a16:creationId xmlns:a16="http://schemas.microsoft.com/office/drawing/2014/main" id="{5696626B-1B9A-4E38-9996-6831E6BE7B30}"/>
+                <a16:creationId xmlns:a16="http://schemas.microsoft.com/office/drawing/2014/main" id="{A4FAE60E-DA33-4D21-A086-508F19EA4058}"/>
               </a:ext>
             </a:extLst>
           </p:cNvPr>
@@ -5614,7 +5564,7 @@
           <p:cNvPr id="9" name="">
             <a:extLst xmlns:a="http://schemas.openxmlformats.org/drawingml/2006/main">
               <a:ext uri="{FF2B5EF4-FFF2-40B4-BE49-F238E27FC236}">
-                <a16:creationId xmlns:a16="http://schemas.microsoft.com/office/drawing/2014/main" id="{1E232D0A-F346-4EDA-A96E-84CF28C84C86}"/>
+                <a16:creationId xmlns:a16="http://schemas.microsoft.com/office/drawing/2014/main" id="{F561D74B-A36E-4C13-B040-79B5535EA70E}"/>
               </a:ext>
             </a:extLst>
           </p:cNvPr>
@@ -5664,7 +5614,7 @@
           <p:cNvPr id="10" name="">
             <a:extLst xmlns:a="http://schemas.openxmlformats.org/drawingml/2006/main">
               <a:ext uri="{FF2B5EF4-FFF2-40B4-BE49-F238E27FC236}">
-                <a16:creationId xmlns:a16="http://schemas.microsoft.com/office/drawing/2014/main" id="{D1E0DFE4-1036-4BB6-A5DE-4FDBCDE1CAF3}"/>
+                <a16:creationId xmlns:a16="http://schemas.microsoft.com/office/drawing/2014/main" id="{F38AFE03-07BE-42F7-8C6B-6C61FA6C0DF2}"/>
               </a:ext>
             </a:extLst>
           </p:cNvPr>
@@ -5714,7 +5664,7 @@
           <p:cNvPr id="11" name="">
             <a:extLst xmlns:a="http://schemas.openxmlformats.org/drawingml/2006/main">
               <a:ext uri="{FF2B5EF4-FFF2-40B4-BE49-F238E27FC236}">
-                <a16:creationId xmlns:a16="http://schemas.microsoft.com/office/drawing/2014/main" id="{AC8F3249-58A3-4AB5-A2E4-D605E8D80C07}"/>
+                <a16:creationId xmlns:a16="http://schemas.microsoft.com/office/drawing/2014/main" id="{7C15C74F-4137-45C4-B354-6FE2585C1AD5}"/>
               </a:ext>
             </a:extLst>
           </p:cNvPr>
@@ -5762,7 +5712,7 @@
     </p:spTree>
     <p:extLst>
       <p:ext uri="{BB962C8B-B14F-4D97-AF65-F5344CB8AC3E}">
-        <p14:creationId xmlns:p14="http://schemas.microsoft.com/office/powerpoint/2010/main" val="998169477"/>
+        <p14:creationId xmlns:p14="http://schemas.microsoft.com/office/powerpoint/2010/main" val="1783712166"/>
       </p:ext>
     </p:extLst>
   </p:cSld>
@@ -5793,7 +5743,7 @@
           <p:cNvPr id="9" name="">
             <a:extLst xmlns:a="http://schemas.openxmlformats.org/drawingml/2006/main">
               <a:ext uri="{FF2B5EF4-FFF2-40B4-BE49-F238E27FC236}">
-                <a16:creationId xmlns:a16="http://schemas.microsoft.com/office/drawing/2014/main" id="{80F5894F-5131-46F7-91F1-0C00A3681BE2}"/>
+                <a16:creationId xmlns:a16="http://schemas.microsoft.com/office/drawing/2014/main" id="{AD34BA47-CE24-45EA-ACA5-F72718419167}"/>
               </a:ext>
             </a:extLst>
           </p:cNvPr>
@@ -5843,7 +5793,7 @@
           <p:cNvPr id="2" name="">
             <a:extLst xmlns:a="http://schemas.openxmlformats.org/drawingml/2006/main">
               <a:ext uri="{FF2B5EF4-FFF2-40B4-BE49-F238E27FC236}">
-                <a16:creationId xmlns:a16="http://schemas.microsoft.com/office/drawing/2014/main" id="{846B80E5-9E21-4D4C-82F0-3A4036037912}"/>
+                <a16:creationId xmlns:a16="http://schemas.microsoft.com/office/drawing/2014/main" id="{5B0F4813-4052-427E-B4B4-54A0F19C16B3}"/>
               </a:ext>
             </a:extLst>
           </p:cNvPr>
@@ -5893,7 +5843,7 @@
           <p:cNvPr id="3" name="">
             <a:extLst xmlns:a="http://schemas.openxmlformats.org/drawingml/2006/main">
               <a:ext uri="{FF2B5EF4-FFF2-40B4-BE49-F238E27FC236}">
-                <a16:creationId xmlns:a16="http://schemas.microsoft.com/office/drawing/2014/main" id="{D6E3F474-BA41-4836-9119-2368AE4B636B}"/>
+                <a16:creationId xmlns:a16="http://schemas.microsoft.com/office/drawing/2014/main" id="{50BE40A2-F16C-4E9B-938C-C66B055368B8}"/>
               </a:ext>
             </a:extLst>
           </p:cNvPr>
@@ -5932,7 +5882,7 @@
           <p:nvPr/>
         </p:nvPicPr>
         <p:blipFill>
-          <a:blip xmlns:r="http://schemas.openxmlformats.org/officeDocument/2006/relationships" xmlns:a="http://schemas.openxmlformats.org/drawingml/2006/main" r:embed="Ref412272abe94d6b"/>
+          <a:blip xmlns:r="http://schemas.openxmlformats.org/officeDocument/2006/relationships" xmlns:a="http://schemas.openxmlformats.org/drawingml/2006/main" r:embed="R93b30e23c1444876"/>
           <a:stretch xmlns:a="http://schemas.openxmlformats.org/drawingml/2006/main"/>
         </p:blipFill>
         <p:spPr>
@@ -5950,7 +5900,7 @@
           <p:cNvPr id="5" name="">
             <a:extLst xmlns:a="http://schemas.openxmlformats.org/drawingml/2006/main">
               <a:ext uri="{FF2B5EF4-FFF2-40B4-BE49-F238E27FC236}">
-                <a16:creationId xmlns:a16="http://schemas.microsoft.com/office/drawing/2014/main" id="{2A59EC7B-C8E7-4154-9901-3398C0CA970B}"/>
+                <a16:creationId xmlns:a16="http://schemas.microsoft.com/office/drawing/2014/main" id="{425B79C7-BB4C-4E43-87FB-A7F8A1348FF4}"/>
               </a:ext>
             </a:extLst>
           </p:cNvPr>
@@ -6000,7 +5950,7 @@
           <p:cNvPr id="6" name="">
             <a:extLst xmlns:a="http://schemas.openxmlformats.org/drawingml/2006/main">
               <a:ext uri="{FF2B5EF4-FFF2-40B4-BE49-F238E27FC236}">
-                <a16:creationId xmlns:a16="http://schemas.microsoft.com/office/drawing/2014/main" id="{3E44DF2C-3346-4BE2-956C-B298DF0850E2}"/>
+                <a16:creationId xmlns:a16="http://schemas.microsoft.com/office/drawing/2014/main" id="{FD08FBB6-172F-497D-805E-73B299197DCB}"/>
               </a:ext>
             </a:extLst>
           </p:cNvPr>
@@ -6050,7 +6000,7 @@
           <p:cNvPr id="7" name="">
             <a:extLst xmlns:a="http://schemas.openxmlformats.org/drawingml/2006/main">
               <a:ext uri="{FF2B5EF4-FFF2-40B4-BE49-F238E27FC236}">
-                <a16:creationId xmlns:a16="http://schemas.microsoft.com/office/drawing/2014/main" id="{B9F8E16B-04C3-4B8E-861F-3C30CF056A3C}"/>
+                <a16:creationId xmlns:a16="http://schemas.microsoft.com/office/drawing/2014/main" id="{DDCB3123-3084-4FBF-A172-9714BB8AA28B}"/>
               </a:ext>
             </a:extLst>
           </p:cNvPr>
@@ -6100,7 +6050,7 @@
           <p:cNvPr id="8" name="">
             <a:extLst xmlns:a="http://schemas.openxmlformats.org/drawingml/2006/main">
               <a:ext uri="{FF2B5EF4-FFF2-40B4-BE49-F238E27FC236}">
-                <a16:creationId xmlns:a16="http://schemas.microsoft.com/office/drawing/2014/main" id="{C9FC36C5-9EB7-41AD-B5BB-DDA61C8EF0DC}"/>
+                <a16:creationId xmlns:a16="http://schemas.microsoft.com/office/drawing/2014/main" id="{68E3CB3B-BD33-441A-ADF5-E5BCCFB45869}"/>
               </a:ext>
             </a:extLst>
           </p:cNvPr>
@@ -6148,7 +6098,7 @@
     </p:spTree>
     <p:extLst>
       <p:ext uri="{BB962C8B-B14F-4D97-AF65-F5344CB8AC3E}">
-        <p14:creationId xmlns:p14="http://schemas.microsoft.com/office/powerpoint/2010/main" val="170264637"/>
+        <p14:creationId xmlns:p14="http://schemas.microsoft.com/office/powerpoint/2010/main" val="1536878427"/>
       </p:ext>
     </p:extLst>
   </p:cSld>
@@ -6179,7 +6129,7 @@
           <p:cNvPr id="27" name="">
             <a:extLst xmlns:a="http://schemas.openxmlformats.org/drawingml/2006/main">
               <a:ext uri="{FF2B5EF4-FFF2-40B4-BE49-F238E27FC236}">
-                <a16:creationId xmlns:a16="http://schemas.microsoft.com/office/drawing/2014/main" id="{3EE85317-04F6-4116-93DA-3FFE5143D331}"/>
+                <a16:creationId xmlns:a16="http://schemas.microsoft.com/office/drawing/2014/main" id="{61F03D19-B314-49C9-93B7-17D739F54B37}"/>
               </a:ext>
             </a:extLst>
           </p:cNvPr>
@@ -6229,7 +6179,7 @@
           <p:cNvPr id="2" name="">
             <a:extLst xmlns:a="http://schemas.openxmlformats.org/drawingml/2006/main">
               <a:ext uri="{FF2B5EF4-FFF2-40B4-BE49-F238E27FC236}">
-                <a16:creationId xmlns:a16="http://schemas.microsoft.com/office/drawing/2014/main" id="{9F9DEA1B-541B-4CE6-A378-0CBF0DD5A856}"/>
+                <a16:creationId xmlns:a16="http://schemas.microsoft.com/office/drawing/2014/main" id="{422DBAC9-FDE6-4FDE-B8D0-9A3FFBF85AC4}"/>
               </a:ext>
             </a:extLst>
           </p:cNvPr>
@@ -6279,7 +6229,7 @@
           <p:cNvPr id="3" name="">
             <a:extLst xmlns:a="http://schemas.openxmlformats.org/drawingml/2006/main">
               <a:ext uri="{FF2B5EF4-FFF2-40B4-BE49-F238E27FC236}">
-                <a16:creationId xmlns:a16="http://schemas.microsoft.com/office/drawing/2014/main" id="{7151633E-80A2-405B-8B97-A86CA62171FF}"/>
+                <a16:creationId xmlns:a16="http://schemas.microsoft.com/office/drawing/2014/main" id="{43BC88E1-0D73-4D03-9CAC-F3B531859556}"/>
               </a:ext>
             </a:extLst>
           </p:cNvPr>
@@ -6314,7 +6264,7 @@
           <p:cNvPr id="4" name="">
             <a:extLst xmlns:a="http://schemas.openxmlformats.org/drawingml/2006/main">
               <a:ext uri="{FF2B5EF4-FFF2-40B4-BE49-F238E27FC236}">
-                <a16:creationId xmlns:a16="http://schemas.microsoft.com/office/drawing/2014/main" id="{E918F2D8-774E-4C5D-945B-D823781B9837}"/>
+                <a16:creationId xmlns:a16="http://schemas.microsoft.com/office/drawing/2014/main" id="{222B10D5-AF3D-4827-A1AC-B1FBFF89CC7E}"/>
               </a:ext>
             </a:extLst>
           </p:cNvPr>
@@ -6364,7 +6314,7 @@
           <p:cNvPr id="5" name="">
             <a:extLst xmlns:a="http://schemas.openxmlformats.org/drawingml/2006/main">
               <a:ext uri="{FF2B5EF4-FFF2-40B4-BE49-F238E27FC236}">
-                <a16:creationId xmlns:a16="http://schemas.microsoft.com/office/drawing/2014/main" id="{0E9BFFDD-49C0-4203-8BC7-00969028AC00}"/>
+                <a16:creationId xmlns:a16="http://schemas.microsoft.com/office/drawing/2014/main" id="{58BB3263-32B0-4E80-AF90-F9B6A205F391}"/>
               </a:ext>
             </a:extLst>
           </p:cNvPr>
@@ -6414,7 +6364,7 @@
           <p:cNvPr id="6" name="">
             <a:extLst xmlns:a="http://schemas.openxmlformats.org/drawingml/2006/main">
               <a:ext uri="{FF2B5EF4-FFF2-40B4-BE49-F238E27FC236}">
-                <a16:creationId xmlns:a16="http://schemas.microsoft.com/office/drawing/2014/main" id="{B820E52D-ED10-4E03-A975-DBFF96C7226A}"/>
+                <a16:creationId xmlns:a16="http://schemas.microsoft.com/office/drawing/2014/main" id="{8A37FC77-050B-42B2-9D70-25BD66C6DF04}"/>
               </a:ext>
             </a:extLst>
           </p:cNvPr>
@@ -6464,7 +6414,7 @@
           <p:cNvPr id="7" name="">
             <a:extLst xmlns:a="http://schemas.openxmlformats.org/drawingml/2006/main">
               <a:ext uri="{FF2B5EF4-FFF2-40B4-BE49-F238E27FC236}">
-                <a16:creationId xmlns:a16="http://schemas.microsoft.com/office/drawing/2014/main" id="{19CF921B-28C8-44AC-BC85-6FD6076928C1}"/>
+                <a16:creationId xmlns:a16="http://schemas.microsoft.com/office/drawing/2014/main" id="{10F939C6-350E-4DD0-8DBC-0A14254C2D51}"/>
               </a:ext>
             </a:extLst>
           </p:cNvPr>
@@ -6499,7 +6449,7 @@
           <p:cNvPr id="8" name="">
             <a:extLst xmlns:a="http://schemas.openxmlformats.org/drawingml/2006/main">
               <a:ext uri="{FF2B5EF4-FFF2-40B4-BE49-F238E27FC236}">
-                <a16:creationId xmlns:a16="http://schemas.microsoft.com/office/drawing/2014/main" id="{6EE998F5-2400-4951-A644-AC2F66AE89D2}"/>
+                <a16:creationId xmlns:a16="http://schemas.microsoft.com/office/drawing/2014/main" id="{522D388B-FE0B-44F8-A3D2-A7622CAD89AC}"/>
               </a:ext>
             </a:extLst>
           </p:cNvPr>
@@ -6549,7 +6499,7 @@
           <p:cNvPr id="9" name="">
             <a:extLst xmlns:a="http://schemas.openxmlformats.org/drawingml/2006/main">
               <a:ext uri="{FF2B5EF4-FFF2-40B4-BE49-F238E27FC236}">
-                <a16:creationId xmlns:a16="http://schemas.microsoft.com/office/drawing/2014/main" id="{E75F76FB-6A4F-42CA-AEA3-84C3BDFA72BC}"/>
+                <a16:creationId xmlns:a16="http://schemas.microsoft.com/office/drawing/2014/main" id="{676812D0-C0A4-4237-8DDE-4304B1999C5F}"/>
               </a:ext>
             </a:extLst>
           </p:cNvPr>
@@ -6599,7 +6549,7 @@
           <p:cNvPr id="10" name="">
             <a:extLst xmlns:a="http://schemas.openxmlformats.org/drawingml/2006/main">
               <a:ext uri="{FF2B5EF4-FFF2-40B4-BE49-F238E27FC236}">
-                <a16:creationId xmlns:a16="http://schemas.microsoft.com/office/drawing/2014/main" id="{0248757A-DB28-4561-A1D6-F0D79881F2A6}"/>
+                <a16:creationId xmlns:a16="http://schemas.microsoft.com/office/drawing/2014/main" id="{83FD98FB-17CA-433A-9B12-3225E58B1C23}"/>
               </a:ext>
             </a:extLst>
           </p:cNvPr>
@@ -6649,7 +6599,7 @@
           <p:cNvPr id="11" name="">
             <a:extLst xmlns:a="http://schemas.openxmlformats.org/drawingml/2006/main">
               <a:ext uri="{FF2B5EF4-FFF2-40B4-BE49-F238E27FC236}">
-                <a16:creationId xmlns:a16="http://schemas.microsoft.com/office/drawing/2014/main" id="{A4DDD330-5DF7-4EA4-9D76-B075106F0E85}"/>
+                <a16:creationId xmlns:a16="http://schemas.microsoft.com/office/drawing/2014/main" id="{BF679420-27F7-44FD-8A9E-3C7812354433}"/>
               </a:ext>
             </a:extLst>
           </p:cNvPr>
@@ -6684,7 +6634,7 @@
           <p:cNvPr id="12" name="">
             <a:extLst xmlns:a="http://schemas.openxmlformats.org/drawingml/2006/main">
               <a:ext uri="{FF2B5EF4-FFF2-40B4-BE49-F238E27FC236}">
-                <a16:creationId xmlns:a16="http://schemas.microsoft.com/office/drawing/2014/main" id="{60132940-81CA-47DF-9385-425FFDACD504}"/>
+                <a16:creationId xmlns:a16="http://schemas.microsoft.com/office/drawing/2014/main" id="{84F5B24D-276A-4D7B-A395-99CA6762265E}"/>
               </a:ext>
             </a:extLst>
           </p:cNvPr>
@@ -6734,7 +6684,7 @@
           <p:cNvPr id="13" name="">
             <a:extLst xmlns:a="http://schemas.openxmlformats.org/drawingml/2006/main">
               <a:ext uri="{FF2B5EF4-FFF2-40B4-BE49-F238E27FC236}">
-                <a16:creationId xmlns:a16="http://schemas.microsoft.com/office/drawing/2014/main" id="{5D554875-5F1D-4960-9753-330273947C4A}"/>
+                <a16:creationId xmlns:a16="http://schemas.microsoft.com/office/drawing/2014/main" id="{975C0F49-D890-4035-BE6A-96170D42C97A}"/>
               </a:ext>
             </a:extLst>
           </p:cNvPr>
@@ -6784,7 +6734,7 @@
           <p:cNvPr id="14" name="">
             <a:extLst xmlns:a="http://schemas.openxmlformats.org/drawingml/2006/main">
               <a:ext uri="{FF2B5EF4-FFF2-40B4-BE49-F238E27FC236}">
-                <a16:creationId xmlns:a16="http://schemas.microsoft.com/office/drawing/2014/main" id="{5F665F7A-CC19-47A7-84B1-E596DDE5E7A3}"/>
+                <a16:creationId xmlns:a16="http://schemas.microsoft.com/office/drawing/2014/main" id="{21F43EB0-1BB2-4940-ACB3-BB21BFDC6FF8}"/>
               </a:ext>
             </a:extLst>
           </p:cNvPr>
@@ -6834,7 +6784,7 @@
           <p:cNvPr id="15" name="">
             <a:extLst xmlns:a="http://schemas.openxmlformats.org/drawingml/2006/main">
               <a:ext uri="{FF2B5EF4-FFF2-40B4-BE49-F238E27FC236}">
-                <a16:creationId xmlns:a16="http://schemas.microsoft.com/office/drawing/2014/main" id="{37D3B592-850C-4E80-844A-E4FB533B7AAD}"/>
+                <a16:creationId xmlns:a16="http://schemas.microsoft.com/office/drawing/2014/main" id="{5EB820F3-C7D8-4BCE-B52B-3DC1A09E028E}"/>
               </a:ext>
             </a:extLst>
           </p:cNvPr>
@@ -6869,7 +6819,7 @@
           <p:cNvPr id="16" name="">
             <a:extLst xmlns:a="http://schemas.openxmlformats.org/drawingml/2006/main">
               <a:ext uri="{FF2B5EF4-FFF2-40B4-BE49-F238E27FC236}">
-                <a16:creationId xmlns:a16="http://schemas.microsoft.com/office/drawing/2014/main" id="{3B0DBBDB-B571-4E9B-A74D-6200C3937EFE}"/>
+                <a16:creationId xmlns:a16="http://schemas.microsoft.com/office/drawing/2014/main" id="{D3DC714F-3CAA-4D27-8AE5-1AA2C1D4745D}"/>
               </a:ext>
             </a:extLst>
           </p:cNvPr>
@@ -6919,7 +6869,7 @@
           <p:cNvPr id="17" name="">
             <a:extLst xmlns:a="http://schemas.openxmlformats.org/drawingml/2006/main">
               <a:ext uri="{FF2B5EF4-FFF2-40B4-BE49-F238E27FC236}">
-                <a16:creationId xmlns:a16="http://schemas.microsoft.com/office/drawing/2014/main" id="{0D3F9C76-623A-40D0-B579-E8BC94D384E4}"/>
+                <a16:creationId xmlns:a16="http://schemas.microsoft.com/office/drawing/2014/main" id="{9096600A-8334-40EC-816A-F388A1541D62}"/>
               </a:ext>
             </a:extLst>
           </p:cNvPr>
@@ -6969,7 +6919,7 @@
           <p:cNvPr id="18" name="">
             <a:extLst xmlns:a="http://schemas.openxmlformats.org/drawingml/2006/main">
               <a:ext uri="{FF2B5EF4-FFF2-40B4-BE49-F238E27FC236}">
-                <a16:creationId xmlns:a16="http://schemas.microsoft.com/office/drawing/2014/main" id="{12E5A710-689F-4D32-AE20-B9E6EBF3DA73}"/>
+                <a16:creationId xmlns:a16="http://schemas.microsoft.com/office/drawing/2014/main" id="{2F754845-FB42-4D52-BBC5-4368763B264E}"/>
               </a:ext>
             </a:extLst>
           </p:cNvPr>
@@ -7019,7 +6969,7 @@
           <p:cNvPr id="19" name="">
             <a:extLst xmlns:a="http://schemas.openxmlformats.org/drawingml/2006/main">
               <a:ext uri="{FF2B5EF4-FFF2-40B4-BE49-F238E27FC236}">
-                <a16:creationId xmlns:a16="http://schemas.microsoft.com/office/drawing/2014/main" id="{24D053D8-723C-4C4E-9E6B-07F074FC4090}"/>
+                <a16:creationId xmlns:a16="http://schemas.microsoft.com/office/drawing/2014/main" id="{89ACCDB8-C66A-4B31-9C50-1951024BB6BA}"/>
               </a:ext>
             </a:extLst>
           </p:cNvPr>
@@ -7054,7 +7004,7 @@
           <p:cNvPr id="20" name="">
             <a:extLst xmlns:a="http://schemas.openxmlformats.org/drawingml/2006/main">
               <a:ext uri="{FF2B5EF4-FFF2-40B4-BE49-F238E27FC236}">
-                <a16:creationId xmlns:a16="http://schemas.microsoft.com/office/drawing/2014/main" id="{11D7581F-4374-4238-B2BA-419A2E80AC70}"/>
+                <a16:creationId xmlns:a16="http://schemas.microsoft.com/office/drawing/2014/main" id="{6CA90AF3-7EA5-4215-87ED-D257120CB4FE}"/>
               </a:ext>
             </a:extLst>
           </p:cNvPr>
@@ -7104,7 +7054,7 @@
           <p:cNvPr id="21" name="">
             <a:extLst xmlns:a="http://schemas.openxmlformats.org/drawingml/2006/main">
               <a:ext uri="{FF2B5EF4-FFF2-40B4-BE49-F238E27FC236}">
-                <a16:creationId xmlns:a16="http://schemas.microsoft.com/office/drawing/2014/main" id="{884DB8A4-B899-404A-B2C2-4D372D89AEC5}"/>
+                <a16:creationId xmlns:a16="http://schemas.microsoft.com/office/drawing/2014/main" id="{F4EDDA31-E0F5-4ECA-A01B-D7BCFE7C4D12}"/>
               </a:ext>
             </a:extLst>
           </p:cNvPr>
@@ -7154,7 +7104,7 @@
           <p:cNvPr id="22" name="">
             <a:extLst xmlns:a="http://schemas.openxmlformats.org/drawingml/2006/main">
               <a:ext uri="{FF2B5EF4-FFF2-40B4-BE49-F238E27FC236}">
-                <a16:creationId xmlns:a16="http://schemas.microsoft.com/office/drawing/2014/main" id="{2BB10AAA-D317-4FDE-9D2A-EBA2D5BFCC07}"/>
+                <a16:creationId xmlns:a16="http://schemas.microsoft.com/office/drawing/2014/main" id="{2767C2BD-42FF-4888-9BBB-EAD96C895477}"/>
               </a:ext>
             </a:extLst>
           </p:cNvPr>
@@ -7189,7 +7139,7 @@
           <p:cNvPr id="23" name="">
             <a:extLst xmlns:a="http://schemas.openxmlformats.org/drawingml/2006/main">
               <a:ext uri="{FF2B5EF4-FFF2-40B4-BE49-F238E27FC236}">
-                <a16:creationId xmlns:a16="http://schemas.microsoft.com/office/drawing/2014/main" id="{E7577C74-0F57-4E07-B242-5626D85C497E}"/>
+                <a16:creationId xmlns:a16="http://schemas.microsoft.com/office/drawing/2014/main" id="{839C8DDC-B4DA-4FDB-A4B3-93959ABE4A38}"/>
               </a:ext>
             </a:extLst>
           </p:cNvPr>
@@ -7239,7 +7189,7 @@
           <p:cNvPr id="24" name="">
             <a:extLst xmlns:a="http://schemas.openxmlformats.org/drawingml/2006/main">
               <a:ext uri="{FF2B5EF4-FFF2-40B4-BE49-F238E27FC236}">
-                <a16:creationId xmlns:a16="http://schemas.microsoft.com/office/drawing/2014/main" id="{4554A24C-2E4B-4A1B-869C-C2589BF225C1}"/>
+                <a16:creationId xmlns:a16="http://schemas.microsoft.com/office/drawing/2014/main" id="{0F060A64-FB81-41A5-9494-CE9171E5D55B}"/>
               </a:ext>
             </a:extLst>
           </p:cNvPr>
@@ -7289,7 +7239,7 @@
           <p:cNvPr id="25" name="">
             <a:extLst xmlns:a="http://schemas.openxmlformats.org/drawingml/2006/main">
               <a:ext uri="{FF2B5EF4-FFF2-40B4-BE49-F238E27FC236}">
-                <a16:creationId xmlns:a16="http://schemas.microsoft.com/office/drawing/2014/main" id="{9C964D50-B3C3-416D-BA42-29BA6A4F76C4}"/>
+                <a16:creationId xmlns:a16="http://schemas.microsoft.com/office/drawing/2014/main" id="{86C3D3FD-8B08-46D1-B7A2-E86B05EDF00C}"/>
               </a:ext>
             </a:extLst>
           </p:cNvPr>
@@ -7339,7 +7289,7 @@
           <p:cNvPr id="26" name="">
             <a:extLst xmlns:a="http://schemas.openxmlformats.org/drawingml/2006/main">
               <a:ext uri="{FF2B5EF4-FFF2-40B4-BE49-F238E27FC236}">
-                <a16:creationId xmlns:a16="http://schemas.microsoft.com/office/drawing/2014/main" id="{98B46ED2-5A57-4087-92BB-9C4D2AEEDD6C}"/>
+                <a16:creationId xmlns:a16="http://schemas.microsoft.com/office/drawing/2014/main" id="{FB1221F1-3248-47B5-B168-B0BA9978C2EB}"/>
               </a:ext>
             </a:extLst>
           </p:cNvPr>
@@ -7387,7 +7337,7 @@
     </p:spTree>
     <p:extLst>
       <p:ext uri="{BB962C8B-B14F-4D97-AF65-F5344CB8AC3E}">
-        <p14:creationId xmlns:p14="http://schemas.microsoft.com/office/powerpoint/2010/main" val="208989562"/>
+        <p14:creationId xmlns:p14="http://schemas.microsoft.com/office/powerpoint/2010/main" val="1514225622"/>
       </p:ext>
     </p:extLst>
   </p:cSld>

</xml_diff>

<commit_message>
Add profiled mechanism evidence to manager deck
</commit_message>
<xml_diff>
--- a/sglang_direct_kv/artifacts/slides/agent_aware_kv_movement_manager_deck.pptx
+++ b/sglang_direct_kv/artifacts/slides/agent_aware_kv_movement_manager_deck.pptx
@@ -2,21 +2,22 @@
 <file path=ppt/presentation.xml><?xml version="1.0" encoding="utf-8"?>
 <p:presentation xmlns:p="http://schemas.openxmlformats.org/presentationml/2006/main">
   <p:sldMasterIdLst>
-    <p:sldMasterId xmlns:r="http://schemas.openxmlformats.org/officeDocument/2006/relationships" id="2147483648" r:id="R19be7142173d40bb"/>
+    <p:sldMasterId xmlns:r="http://schemas.openxmlformats.org/officeDocument/2006/relationships" id="2147483648" r:id="R81f7908685dd4af7"/>
   </p:sldMasterIdLst>
   <p:notesMasterIdLst>
-    <p:notesMasterId xmlns:r="http://schemas.openxmlformats.org/officeDocument/2006/relationships" r:id="Rba21d89858f145ff"/>
+    <p:notesMasterId xmlns:r="http://schemas.openxmlformats.org/officeDocument/2006/relationships" r:id="R9bf995b93cff43a1"/>
   </p:notesMasterIdLst>
   <p:sldIdLst>
-    <p:sldId xmlns:r="http://schemas.openxmlformats.org/officeDocument/2006/relationships" id="256" r:id="Ra4670e6b3a7147e5"/>
-    <p:sldId xmlns:r="http://schemas.openxmlformats.org/officeDocument/2006/relationships" id="257" r:id="Rcb75cfb42c684b3c"/>
-    <p:sldId xmlns:r="http://schemas.openxmlformats.org/officeDocument/2006/relationships" id="258" r:id="R2e30584c14604f2f"/>
-    <p:sldId xmlns:r="http://schemas.openxmlformats.org/officeDocument/2006/relationships" id="259" r:id="R7ee322f34d4440df"/>
-    <p:sldId xmlns:r="http://schemas.openxmlformats.org/officeDocument/2006/relationships" id="260" r:id="R824a8ef9527341ce"/>
-    <p:sldId xmlns:r="http://schemas.openxmlformats.org/officeDocument/2006/relationships" id="261" r:id="Rad13eff0818a4233"/>
-    <p:sldId xmlns:r="http://schemas.openxmlformats.org/officeDocument/2006/relationships" id="262" r:id="Rdcd3ddad9e594b9d"/>
-    <p:sldId xmlns:r="http://schemas.openxmlformats.org/officeDocument/2006/relationships" id="263" r:id="Rc2b8ab27cb76421a"/>
-    <p:sldId xmlns:r="http://schemas.openxmlformats.org/officeDocument/2006/relationships" id="264" r:id="Re6c9d8d0764d4a11"/>
+    <p:sldId xmlns:r="http://schemas.openxmlformats.org/officeDocument/2006/relationships" id="256" r:id="R5043122217e246e0"/>
+    <p:sldId xmlns:r="http://schemas.openxmlformats.org/officeDocument/2006/relationships" id="257" r:id="R949be3ffd5af4b38"/>
+    <p:sldId xmlns:r="http://schemas.openxmlformats.org/officeDocument/2006/relationships" id="258" r:id="Reb3225402559474e"/>
+    <p:sldId xmlns:r="http://schemas.openxmlformats.org/officeDocument/2006/relationships" id="259" r:id="Rc204ca3e16054227"/>
+    <p:sldId xmlns:r="http://schemas.openxmlformats.org/officeDocument/2006/relationships" id="260" r:id="R0f7cd9bd96804f26"/>
+    <p:sldId xmlns:r="http://schemas.openxmlformats.org/officeDocument/2006/relationships" id="261" r:id="Rb861bc28d4d04e19"/>
+    <p:sldId xmlns:r="http://schemas.openxmlformats.org/officeDocument/2006/relationships" id="262" r:id="R14f4b2ec08204fa2"/>
+    <p:sldId xmlns:r="http://schemas.openxmlformats.org/officeDocument/2006/relationships" id="263" r:id="R63b994510f124db4"/>
+    <p:sldId xmlns:r="http://schemas.openxmlformats.org/officeDocument/2006/relationships" id="264" r:id="Rd2427f5a625c413a"/>
+    <p:sldId xmlns:r="http://schemas.openxmlformats.org/officeDocument/2006/relationships" id="265" r:id="Rd8de39e89037461c"/>
   </p:sldIdLst>
   <p:sldSz cx="12192000" cy="6858000"/>
   <p:notesSz cx="6858000" cy="9144000"/>
@@ -505,6 +506,101 @@
 </p:notes>
 </file>
 
+<file path=ppt/notesSlides/notesSlide10.xml><?xml version="1.0" encoding="utf-8"?>
+<p:notes xmlns:p="http://schemas.openxmlformats.org/presentationml/2006/main">
+  <p:cSld>
+    <p:spTree>
+      <p:nvGrpSpPr>
+        <p:cNvPr id="1" name=""/>
+        <p:cNvGrpSpPr/>
+        <p:nvPr/>
+      </p:nvGrpSpPr>
+      <p:grpSpPr>
+        <a:xfrm xmlns:a="http://schemas.openxmlformats.org/drawingml/2006/main"/>
+      </p:grpSpPr>
+      <p:sp>
+        <p:nvSpPr>
+          <p:cNvPr id="2" name="Slide Image Placeholder 1"/>
+          <p:cNvSpPr>
+            <a:spLocks xmlns:a="http://schemas.openxmlformats.org/drawingml/2006/main" noGrp="1"/>
+          </p:cNvSpPr>
+          <p:nvPr>
+            <p:ph type="sldImg" idx="0"/>
+          </p:nvPr>
+        </p:nvSpPr>
+        <p:spPr/>
+      </p:sp>
+      <p:sp>
+        <p:nvSpPr>
+          <p:cNvPr id="3" name="Notes Placeholder 2"/>
+          <p:cNvSpPr>
+            <a:spLocks xmlns:a="http://schemas.openxmlformats.org/drawingml/2006/main" noGrp="1"/>
+          </p:cNvSpPr>
+          <p:nvPr>
+            <p:ph type="body" idx="1"/>
+          </p:nvPr>
+        </p:nvSpPr>
+        <p:spPr/>
+        <p:txBody>
+          <a:bodyPr xmlns:a="http://schemas.openxmlformats.org/drawingml/2006/main"/>
+          <a:lstStyle xmlns:a="http://schemas.openxmlformats.org/drawingml/2006/main"/>
+          <a:p xmlns:a="http://schemas.openxmlformats.org/drawingml/2006/main">
+            <a:r>
+              <a:t>Closing slide. This translates observed software/runtime behavior into concrete hardware support candidates.</a:t>
+            </a:r>
+          </a:p>
+          <a:p xmlns:a="http://schemas.openxmlformats.org/drawingml/2006/main">
+            <a:r>
+              <a:t>Hardware ideas come from the project proposal: KV metadata, deadline-aware queues, priority-aware migration, residency protection, and telemetry.</a:t>
+            </a:r>
+          </a:p>
+          <a:p xmlns:a="http://schemas.openxmlformats.org/drawingml/2006/main">
+            <a:r>
+              <a:t/>
+            </a:r>
+          </a:p>
+          <a:p xmlns:a="http://schemas.openxmlformats.org/drawingml/2006/main">
+            <a:r>
+              <a:t>[Sources]</a:t>
+            </a:r>
+          </a:p>
+          <a:p xmlns:a="http://schemas.openxmlformats.org/drawingml/2006/main">
+            <a:r>
+              <a:t>Local report: /Users/oluwolejaiyeoba/Documents/GitHub/agentic_hardware/sglang_direct_kv/artifacts/results/latest_master_report.html</a:t>
+            </a:r>
+          </a:p>
+          <a:p xmlns:a="http://schemas.openxmlformats.org/drawingml/2006/main">
+            <a:r>
+              <a:t>Backup report: /Users/oluwolejaiyeoba/Documents/GitHub/agentic_hardware/backups/latest_master_report-1.html</a:t>
+            </a:r>
+          </a:p>
+        </p:txBody>
+      </p:sp>
+      <p:sp>
+        <p:nvSpPr>
+          <p:cNvPr id="4" name="Slide Number Placeholder 3"/>
+          <p:cNvSpPr>
+            <a:spLocks xmlns:a="http://schemas.openxmlformats.org/drawingml/2006/main" noGrp="1"/>
+          </p:cNvSpPr>
+          <p:nvPr>
+            <p:ph type="sldNum" idx="5"/>
+          </p:nvPr>
+        </p:nvSpPr>
+        <p:spPr/>
+        <p:txBody>
+          <a:bodyPr xmlns:a="http://schemas.openxmlformats.org/drawingml/2006/main"/>
+          <a:lstStyle xmlns:a="http://schemas.openxmlformats.org/drawingml/2006/main"/>
+          <a:p xmlns:a="http://schemas.openxmlformats.org/drawingml/2006/main"/>
+        </p:txBody>
+      </p:sp>
+    </p:spTree>
+  </p:cSld>
+  <p:clrMapOvr>
+    <a:masterClrMapping xmlns:a="http://schemas.openxmlformats.org/drawingml/2006/main"/>
+  </p:clrMapOvr>
+</p:notes>
+</file>
+
 <file path=ppt/notesSlides/notesSlide2.xml><?xml version="1.0" encoding="utf-8"?>
 <p:notes xmlns:p="http://schemas.openxmlformats.org/presentationml/2006/main">
   <p:cSld>
@@ -1020,12 +1116,17 @@
           <a:lstStyle xmlns:a="http://schemas.openxmlformats.org/drawingml/2006/main"/>
           <a:p xmlns:a="http://schemas.openxmlformats.org/drawingml/2006/main">
             <a:r>
-              <a:t>This is the aggregate evidence slide. The current controlled no-prefetch run reports 8 no-prefetch replay H2D gaps and 8 late H2D finishes.</a:t>
-            </a:r>
-          </a:p>
-          <a:p xmlns:a="http://schemas.openxmlformats.org/drawingml/2006/main">
-            <a:r>
-              <a:t>Measured claim source: Global Replay H2D Readiness table and dot plot in latest_master_report.html.</a:t>
+              <a:t>This slide uses the synthetic profiled mechanism timeline. It is not the clean performance run; it is useful for mechanism attribution.</a:t>
+            </a:r>
+          </a:p>
+          <a:p xmlns:a="http://schemas.openxmlformats.org/drawingml/2006/main">
+            <a:r>
+              <a:t>The report states: KV copy ready before replay in 0 / 6 sessions; profiler CUDA HtoD visible in 3 / 6 sessions; replay reloaded KV in 6 / 6 sessions.</a:t>
+            </a:r>
+          </a:p>
+          <a:p xmlns:a="http://schemas.openxmlformats.org/drawingml/2006/main">
+            <a:r>
+              <a:t>Manager takeaway: the software hint path can exist and still miss replay because the movement/readiness path is not deadline-enforced.</a:t>
             </a:r>
           </a:p>
           <a:p xmlns:a="http://schemas.openxmlformats.org/drawingml/2006/main">
@@ -1115,12 +1216,12 @@
           <a:lstStyle xmlns:a="http://schemas.openxmlformats.org/drawingml/2006/main"/>
           <a:p xmlns:a="http://schemas.openxmlformats.org/drawingml/2006/main">
             <a:r>
-              <a:t>This chart separates replay due, client submit, SGLang receive, scheduler queue/admit, H2D start, and H2D finish.</a:t>
-            </a:r>
-          </a:p>
-          <a:p xmlns:a="http://schemas.openxmlformats.org/drawingml/2006/main">
-            <a:r>
-              <a:t>The key manager takeaway: a hint-aware design should influence scheduling and priority, not merely request more copies.</a:t>
+              <a:t>This is the aggregate evidence slide. The current controlled no-prefetch run reports 8 no-prefetch replay H2D gaps and 8 late H2D finishes.</a:t>
+            </a:r>
+          </a:p>
+          <a:p xmlns:a="http://schemas.openxmlformats.org/drawingml/2006/main">
+            <a:r>
+              <a:t>Measured claim source: Global Replay H2D Readiness table and dot plot in latest_master_report.html.</a:t>
             </a:r>
           </a:p>
           <a:p xmlns:a="http://schemas.openxmlformats.org/drawingml/2006/main">
@@ -1210,12 +1311,12 @@
           <a:lstStyle xmlns:a="http://schemas.openxmlformats.org/drawingml/2006/main"/>
           <a:p xmlns:a="http://schemas.openxmlformats.org/drawingml/2006/main">
             <a:r>
-              <a:t>Closing slide. This translates observed software/runtime behavior into concrete hardware support candidates.</a:t>
-            </a:r>
-          </a:p>
-          <a:p xmlns:a="http://schemas.openxmlformats.org/drawingml/2006/main">
-            <a:r>
-              <a:t>Hardware ideas come from the project proposal: KV metadata, deadline-aware queues, priority-aware migration, residency protection, and telemetry.</a:t>
+              <a:t>This chart separates replay due, client submit, SGLang receive, scheduler queue/admit, H2D start, and H2D finish.</a:t>
+            </a:r>
+          </a:p>
+          <a:p xmlns:a="http://schemas.openxmlformats.org/drawingml/2006/main">
+            <a:r>
+              <a:t>The key manager takeaway: a hint-aware design should influence scheduling and priority, not merely request more copies.</a:t>
             </a:r>
           </a:p>
           <a:p xmlns:a="http://schemas.openxmlformats.org/drawingml/2006/main">
@@ -1303,7 +1404,7 @@
   </p:cSld>
   <p:clrMap bg1="lt1" tx1="dk1" bg2="lt2" tx2="dk2" accent1="accent1" accent2="accent2" accent3="accent3" accent4="accent4" accent5="accent5" accent6="accent6" hlink="hlink" folHlink="folHlink"/>
   <p:sldLayoutIdLst>
-    <p:sldLayoutId xmlns:r="http://schemas.openxmlformats.org/officeDocument/2006/relationships" id="2147483649" r:id="R719b5a8e665343a0"/>
+    <p:sldLayoutId xmlns:r="http://schemas.openxmlformats.org/officeDocument/2006/relationships" id="2147483649" r:id="Recf639b5bb7d478d"/>
   </p:sldLayoutIdLst>
   <p:txStyles>
     <p:titleStyle>
@@ -1854,7 +1955,7 @@
           <p:cNvPr id="16" name="">
             <a:extLst xmlns:a="http://schemas.openxmlformats.org/drawingml/2006/main">
               <a:ext uri="{FF2B5EF4-FFF2-40B4-BE49-F238E27FC236}">
-                <a16:creationId xmlns:a16="http://schemas.microsoft.com/office/drawing/2014/main" id="{89AB6631-AFEA-47DA-9BBC-FF6B8570C3F8}"/>
+                <a16:creationId xmlns:a16="http://schemas.microsoft.com/office/drawing/2014/main" id="{85F46643-F4F6-4A04-8CA7-1547CB28FE72}"/>
               </a:ext>
             </a:extLst>
           </p:cNvPr>
@@ -1904,7 +2005,7 @@
           <p:cNvPr id="2" name="">
             <a:extLst xmlns:a="http://schemas.openxmlformats.org/drawingml/2006/main">
               <a:ext uri="{FF2B5EF4-FFF2-40B4-BE49-F238E27FC236}">
-                <a16:creationId xmlns:a16="http://schemas.microsoft.com/office/drawing/2014/main" id="{CD2E1BA6-5ED2-4A7E-9869-DB6DEBE41C2B}"/>
+                <a16:creationId xmlns:a16="http://schemas.microsoft.com/office/drawing/2014/main" id="{A39D2D10-3AF2-4A10-AD6D-F6311B97AAD8}"/>
               </a:ext>
             </a:extLst>
           </p:cNvPr>
@@ -1954,7 +2055,7 @@
           <p:cNvPr id="3" name="">
             <a:extLst xmlns:a="http://schemas.openxmlformats.org/drawingml/2006/main">
               <a:ext uri="{FF2B5EF4-FFF2-40B4-BE49-F238E27FC236}">
-                <a16:creationId xmlns:a16="http://schemas.microsoft.com/office/drawing/2014/main" id="{3C0A07E2-34CF-4C22-B9FA-07890AC6AB8C}"/>
+                <a16:creationId xmlns:a16="http://schemas.microsoft.com/office/drawing/2014/main" id="{34055EDF-ECC8-4583-8871-0E6C64480FF3}"/>
               </a:ext>
             </a:extLst>
           </p:cNvPr>
@@ -1989,7 +2090,7 @@
           <p:cNvPr id="4" name="">
             <a:extLst xmlns:a="http://schemas.openxmlformats.org/drawingml/2006/main">
               <a:ext uri="{FF2B5EF4-FFF2-40B4-BE49-F238E27FC236}">
-                <a16:creationId xmlns:a16="http://schemas.microsoft.com/office/drawing/2014/main" id="{1648394F-91DB-45DA-BBAE-B60F8A965E42}"/>
+                <a16:creationId xmlns:a16="http://schemas.microsoft.com/office/drawing/2014/main" id="{32AC8851-0915-4322-8524-BEC697C18FC7}"/>
               </a:ext>
             </a:extLst>
           </p:cNvPr>
@@ -2039,7 +2140,7 @@
           <p:cNvPr id="5" name="">
             <a:extLst xmlns:a="http://schemas.openxmlformats.org/drawingml/2006/main">
               <a:ext uri="{FF2B5EF4-FFF2-40B4-BE49-F238E27FC236}">
-                <a16:creationId xmlns:a16="http://schemas.microsoft.com/office/drawing/2014/main" id="{C87513AA-AF0E-42F1-9E33-F49502313A2E}"/>
+                <a16:creationId xmlns:a16="http://schemas.microsoft.com/office/drawing/2014/main" id="{11C60858-B7DB-438F-9716-42CC9A9F4674}"/>
               </a:ext>
             </a:extLst>
           </p:cNvPr>
@@ -2089,7 +2190,7 @@
           <p:cNvPr id="6" name="">
             <a:extLst xmlns:a="http://schemas.openxmlformats.org/drawingml/2006/main">
               <a:ext uri="{FF2B5EF4-FFF2-40B4-BE49-F238E27FC236}">
-                <a16:creationId xmlns:a16="http://schemas.microsoft.com/office/drawing/2014/main" id="{EA340BD4-41AB-47F8-ABE6-C5B1A39DC980}"/>
+                <a16:creationId xmlns:a16="http://schemas.microsoft.com/office/drawing/2014/main" id="{1212EFB5-5A1D-477D-8B89-C3BBEFA111EE}"/>
               </a:ext>
             </a:extLst>
           </p:cNvPr>
@@ -2124,7 +2225,7 @@
           <p:cNvPr id="7" name="">
             <a:extLst xmlns:a="http://schemas.openxmlformats.org/drawingml/2006/main">
               <a:ext uri="{FF2B5EF4-FFF2-40B4-BE49-F238E27FC236}">
-                <a16:creationId xmlns:a16="http://schemas.microsoft.com/office/drawing/2014/main" id="{61675222-4D7B-4B73-A335-FBCBD2354C0F}"/>
+                <a16:creationId xmlns:a16="http://schemas.microsoft.com/office/drawing/2014/main" id="{4832C5F6-966E-490D-99F8-A6F96C637637}"/>
               </a:ext>
             </a:extLst>
           </p:cNvPr>
@@ -2174,7 +2275,7 @@
           <p:cNvPr id="8" name="">
             <a:extLst xmlns:a="http://schemas.openxmlformats.org/drawingml/2006/main">
               <a:ext uri="{FF2B5EF4-FFF2-40B4-BE49-F238E27FC236}">
-                <a16:creationId xmlns:a16="http://schemas.microsoft.com/office/drawing/2014/main" id="{894274B6-8C74-430D-81F2-BA691606E10E}"/>
+                <a16:creationId xmlns:a16="http://schemas.microsoft.com/office/drawing/2014/main" id="{F0DBDEF0-E7B0-4124-A1D6-01168DDD7C2B}"/>
               </a:ext>
             </a:extLst>
           </p:cNvPr>
@@ -2224,7 +2325,7 @@
           <p:cNvPr id="9" name="">
             <a:extLst xmlns:a="http://schemas.openxmlformats.org/drawingml/2006/main">
               <a:ext uri="{FF2B5EF4-FFF2-40B4-BE49-F238E27FC236}">
-                <a16:creationId xmlns:a16="http://schemas.microsoft.com/office/drawing/2014/main" id="{0C0CDA4E-B18E-4383-B251-648A79852200}"/>
+                <a16:creationId xmlns:a16="http://schemas.microsoft.com/office/drawing/2014/main" id="{02F32A8D-B537-4B1C-9175-93CB92306FCC}"/>
               </a:ext>
             </a:extLst>
           </p:cNvPr>
@@ -2259,7 +2360,7 @@
           <p:cNvPr id="10" name="">
             <a:extLst xmlns:a="http://schemas.openxmlformats.org/drawingml/2006/main">
               <a:ext uri="{FF2B5EF4-FFF2-40B4-BE49-F238E27FC236}">
-                <a16:creationId xmlns:a16="http://schemas.microsoft.com/office/drawing/2014/main" id="{5A85D7F3-3F78-4469-A17E-EF12464463E0}"/>
+                <a16:creationId xmlns:a16="http://schemas.microsoft.com/office/drawing/2014/main" id="{6F9DC534-FC1E-46B8-82B5-02B92F61016F}"/>
               </a:ext>
             </a:extLst>
           </p:cNvPr>
@@ -2309,7 +2410,7 @@
           <p:cNvPr id="11" name="">
             <a:extLst xmlns:a="http://schemas.openxmlformats.org/drawingml/2006/main">
               <a:ext uri="{FF2B5EF4-FFF2-40B4-BE49-F238E27FC236}">
-                <a16:creationId xmlns:a16="http://schemas.microsoft.com/office/drawing/2014/main" id="{117CBBF6-E44B-4D98-BE3D-040824E513AB}"/>
+                <a16:creationId xmlns:a16="http://schemas.microsoft.com/office/drawing/2014/main" id="{AF7CDDBA-61B5-4884-B435-1C4E6F5FAAD0}"/>
               </a:ext>
             </a:extLst>
           </p:cNvPr>
@@ -2359,7 +2460,7 @@
           <p:cNvPr id="12" name="">
             <a:extLst xmlns:a="http://schemas.openxmlformats.org/drawingml/2006/main">
               <a:ext uri="{FF2B5EF4-FFF2-40B4-BE49-F238E27FC236}">
-                <a16:creationId xmlns:a16="http://schemas.microsoft.com/office/drawing/2014/main" id="{993CC2AD-90AC-4059-8A8E-5ED70C879908}"/>
+                <a16:creationId xmlns:a16="http://schemas.microsoft.com/office/drawing/2014/main" id="{3A623E41-0542-4F36-934E-DC3C319DAA33}"/>
               </a:ext>
             </a:extLst>
           </p:cNvPr>
@@ -2394,7 +2495,7 @@
           <p:cNvPr id="13" name="">
             <a:extLst xmlns:a="http://schemas.openxmlformats.org/drawingml/2006/main">
               <a:ext uri="{FF2B5EF4-FFF2-40B4-BE49-F238E27FC236}">
-                <a16:creationId xmlns:a16="http://schemas.microsoft.com/office/drawing/2014/main" id="{3095EACB-17E5-4C38-8715-09651E39272E}"/>
+                <a16:creationId xmlns:a16="http://schemas.microsoft.com/office/drawing/2014/main" id="{7927A2F8-A5AB-451F-BC8B-293E4AB39C0E}"/>
               </a:ext>
             </a:extLst>
           </p:cNvPr>
@@ -2444,7 +2545,7 @@
           <p:cNvPr id="14" name="">
             <a:extLst xmlns:a="http://schemas.openxmlformats.org/drawingml/2006/main">
               <a:ext uri="{FF2B5EF4-FFF2-40B4-BE49-F238E27FC236}">
-                <a16:creationId xmlns:a16="http://schemas.microsoft.com/office/drawing/2014/main" id="{55C271DD-7013-4AC2-A618-FAFD564FFB5B}"/>
+                <a16:creationId xmlns:a16="http://schemas.microsoft.com/office/drawing/2014/main" id="{B4D9D0EE-B683-4B93-BA60-B95B916B4AEB}"/>
               </a:ext>
             </a:extLst>
           </p:cNvPr>
@@ -2494,7 +2595,7 @@
           <p:cNvPr id="15" name="">
             <a:extLst xmlns:a="http://schemas.openxmlformats.org/drawingml/2006/main">
               <a:ext uri="{FF2B5EF4-FFF2-40B4-BE49-F238E27FC236}">
-                <a16:creationId xmlns:a16="http://schemas.microsoft.com/office/drawing/2014/main" id="{2325E4FA-4CED-4BA2-996D-77F42AD2F933}"/>
+                <a16:creationId xmlns:a16="http://schemas.microsoft.com/office/drawing/2014/main" id="{310D2551-AA2F-4C09-B4C8-E721B8D386AB}"/>
               </a:ext>
             </a:extLst>
           </p:cNvPr>
@@ -2542,7 +2643,1246 @@
     </p:spTree>
     <p:extLst>
       <p:ext uri="{BB962C8B-B14F-4D97-AF65-F5344CB8AC3E}">
-        <p14:creationId xmlns:p14="http://schemas.microsoft.com/office/powerpoint/2010/main" val="8711797"/>
+        <p14:creationId xmlns:p14="http://schemas.microsoft.com/office/powerpoint/2010/main" val="1553111577"/>
+      </p:ext>
+    </p:extLst>
+  </p:cSld>
+</p:sld>
+</file>
+
+<file path=ppt/slides/slide10.xml><?xml version="1.0" encoding="utf-8"?>
+<p:sld xmlns:p="http://schemas.openxmlformats.org/presentationml/2006/main">
+  <p:cSld>
+    <p:bg>
+      <p:bgPr>
+        <a:solidFill xmlns:a="http://schemas.openxmlformats.org/drawingml/2006/main">
+          <a:srgbClr val="FFFFFF"/>
+        </a:solidFill>
+      </p:bgPr>
+    </p:bg>
+    <p:spTree>
+      <p:nvGrpSpPr>
+        <p:cNvPr id="1" name=""/>
+        <p:cNvGrpSpPr/>
+        <p:nvPr/>
+      </p:nvGrpSpPr>
+      <p:grpSpPr>
+        <a:xfrm xmlns:a="http://schemas.openxmlformats.org/drawingml/2006/main"/>
+      </p:grpSpPr>
+      <p:sp>
+        <p:nvSpPr>
+          <p:cNvPr id="27" name="">
+            <a:extLst xmlns:a="http://schemas.openxmlformats.org/drawingml/2006/main">
+              <a:ext uri="{FF2B5EF4-FFF2-40B4-BE49-F238E27FC236}">
+                <a16:creationId xmlns:a16="http://schemas.microsoft.com/office/drawing/2014/main" id="{66440635-592A-4EEC-B999-6B63790201B2}"/>
+              </a:ext>
+            </a:extLst>
+          </p:cNvPr>
+          <p:cNvSpPr>
+            <a:spLocks xmlns:a="http://schemas.openxmlformats.org/drawingml/2006/main" noGrp="1"/>
+          </p:cNvSpPr>
+          <p:nvPr/>
+        </p:nvSpPr>
+        <p:spPr>
+          <a:xfrm xmlns:a="http://schemas.openxmlformats.org/drawingml/2006/main">
+            <a:off x="400050" y="323850"/>
+            <a:ext cx="10668000" cy="800100"/>
+          </a:xfrm>
+          <a:prstGeom xmlns:a="http://schemas.openxmlformats.org/drawingml/2006/main" prst="rect">
+            <a:avLst/>
+          </a:prstGeom>
+          <a:noFill xmlns:a="http://schemas.openxmlformats.org/drawingml/2006/main"/>
+          <a:ln xmlns:a="http://schemas.openxmlformats.org/drawingml/2006/main" w="0">
+            <a:noFill/>
+            <a:prstDash val="solid"/>
+          </a:ln>
+        </p:spPr>
+        <p:txBody>
+          <a:bodyPr xmlns:a="http://schemas.openxmlformats.org/drawingml/2006/main" anchor="t"/>
+          <a:lstStyle xmlns:a="http://schemas.openxmlformats.org/drawingml/2006/main"/>
+          <a:p xmlns:a="http://schemas.openxmlformats.org/drawingml/2006/main">
+            <a:pPr algn="l">
+              <a:defRPr sz="2850" b="1">
+                <a:solidFill>
+                  <a:srgbClr val="0F172A"/>
+                </a:solidFill>
+              </a:defRPr>
+            </a:pPr>
+            <a:r>
+              <a:rPr sz="2850" b="1">
+                <a:solidFill>
+                  <a:srgbClr val="0F172A"/>
+                </a:solidFill>
+              </a:rPr>
+              <a:t>Hardware support can make hints enforceable</a:t>
+            </a:r>
+          </a:p>
+        </p:txBody>
+      </p:sp>
+      <p:sp>
+        <p:nvSpPr>
+          <p:cNvPr id="2" name="">
+            <a:extLst xmlns:a="http://schemas.openxmlformats.org/drawingml/2006/main">
+              <a:ext uri="{FF2B5EF4-FFF2-40B4-BE49-F238E27FC236}">
+                <a16:creationId xmlns:a16="http://schemas.microsoft.com/office/drawing/2014/main" id="{775D5695-BBCC-4521-AB34-4C410A0379B4}"/>
+              </a:ext>
+            </a:extLst>
+          </p:cNvPr>
+          <p:cNvSpPr>
+            <a:spLocks xmlns:a="http://schemas.openxmlformats.org/drawingml/2006/main" noGrp="1"/>
+          </p:cNvSpPr>
+          <p:nvPr/>
+        </p:nvSpPr>
+        <p:spPr>
+          <a:xfrm xmlns:a="http://schemas.openxmlformats.org/drawingml/2006/main">
+            <a:off x="419100" y="1028700"/>
+            <a:ext cx="9715500" cy="419100"/>
+          </a:xfrm>
+          <a:prstGeom xmlns:a="http://schemas.openxmlformats.org/drawingml/2006/main" prst="rect">
+            <a:avLst/>
+          </a:prstGeom>
+          <a:noFill xmlns:a="http://schemas.openxmlformats.org/drawingml/2006/main"/>
+          <a:ln xmlns:a="http://schemas.openxmlformats.org/drawingml/2006/main" w="0">
+            <a:noFill/>
+            <a:prstDash val="solid"/>
+          </a:ln>
+        </p:spPr>
+        <p:txBody>
+          <a:bodyPr xmlns:a="http://schemas.openxmlformats.org/drawingml/2006/main" anchor="t"/>
+          <a:lstStyle xmlns:a="http://schemas.openxmlformats.org/drawingml/2006/main"/>
+          <a:p xmlns:a="http://schemas.openxmlformats.org/drawingml/2006/main">
+            <a:pPr algn="l">
+              <a:defRPr sz="1350" b="0">
+                <a:solidFill>
+                  <a:srgbClr val="64748B"/>
+                </a:solidFill>
+              </a:defRPr>
+            </a:pPr>
+            <a:r>
+              <a:rPr sz="1350" b="0">
+                <a:solidFill>
+                  <a:srgbClr val="64748B"/>
+                </a:solidFill>
+              </a:rPr>
+              <a:t>The opportunity is to treat KV as deadline-sensitive memory, not generic bytes.</a:t>
+            </a:r>
+          </a:p>
+        </p:txBody>
+      </p:sp>
+      <p:sp>
+        <p:nvSpPr>
+          <p:cNvPr id="3" name="">
+            <a:extLst xmlns:a="http://schemas.openxmlformats.org/drawingml/2006/main">
+              <a:ext uri="{FF2B5EF4-FFF2-40B4-BE49-F238E27FC236}">
+                <a16:creationId xmlns:a16="http://schemas.microsoft.com/office/drawing/2014/main" id="{B919F1E8-595D-45ED-A9EF-2BBAEF6635C8}"/>
+              </a:ext>
+            </a:extLst>
+          </p:cNvPr>
+          <p:cNvSpPr>
+            <a:spLocks xmlns:a="http://schemas.openxmlformats.org/drawingml/2006/main" noGrp="1"/>
+          </p:cNvSpPr>
+          <p:nvPr/>
+        </p:nvSpPr>
+        <p:spPr>
+          <a:xfrm xmlns:a="http://schemas.openxmlformats.org/drawingml/2006/main">
+            <a:off x="552450" y="1962150"/>
+            <a:ext cx="1695450" cy="1695450"/>
+          </a:xfrm>
+          <a:prstGeom xmlns:a="http://schemas.openxmlformats.org/drawingml/2006/main" prst="roundRect">
+            <a:avLst>
+              <a:gd name="adj" fmla="val 3371"/>
+            </a:avLst>
+          </a:prstGeom>
+          <a:solidFill xmlns:a="http://schemas.openxmlformats.org/drawingml/2006/main">
+            <a:srgbClr val="EFF6FF"/>
+          </a:solidFill>
+          <a:ln xmlns:a="http://schemas.openxmlformats.org/drawingml/2006/main" w="9525">
+            <a:solidFill>
+              <a:srgbClr val="2563EB"/>
+            </a:solidFill>
+            <a:prstDash val="solid"/>
+          </a:ln>
+        </p:spPr>
+      </p:sp>
+      <p:sp>
+        <p:nvSpPr>
+          <p:cNvPr id="4" name="">
+            <a:extLst xmlns:a="http://schemas.openxmlformats.org/drawingml/2006/main">
+              <a:ext uri="{FF2B5EF4-FFF2-40B4-BE49-F238E27FC236}">
+                <a16:creationId xmlns:a16="http://schemas.microsoft.com/office/drawing/2014/main" id="{BC918451-9840-418E-A215-090B3A5301CB}"/>
+              </a:ext>
+            </a:extLst>
+          </p:cNvPr>
+          <p:cNvSpPr>
+            <a:spLocks xmlns:a="http://schemas.openxmlformats.org/drawingml/2006/main" noGrp="1"/>
+          </p:cNvSpPr>
+          <p:nvPr/>
+        </p:nvSpPr>
+        <p:spPr>
+          <a:xfrm xmlns:a="http://schemas.openxmlformats.org/drawingml/2006/main">
+            <a:off x="704850" y="2228850"/>
+            <a:ext cx="1390650" cy="323850"/>
+          </a:xfrm>
+          <a:prstGeom xmlns:a="http://schemas.openxmlformats.org/drawingml/2006/main" prst="rect">
+            <a:avLst/>
+          </a:prstGeom>
+          <a:noFill xmlns:a="http://schemas.openxmlformats.org/drawingml/2006/main"/>
+          <a:ln xmlns:a="http://schemas.openxmlformats.org/drawingml/2006/main" w="0">
+            <a:noFill/>
+            <a:prstDash val="solid"/>
+          </a:ln>
+        </p:spPr>
+        <p:txBody>
+          <a:bodyPr xmlns:a="http://schemas.openxmlformats.org/drawingml/2006/main" anchor="t"/>
+          <a:lstStyle xmlns:a="http://schemas.openxmlformats.org/drawingml/2006/main"/>
+          <a:p xmlns:a="http://schemas.openxmlformats.org/drawingml/2006/main">
+            <a:pPr algn="ctr">
+              <a:defRPr sz="1650" b="1">
+                <a:solidFill>
+                  <a:srgbClr val="0F172A"/>
+                </a:solidFill>
+              </a:defRPr>
+            </a:pPr>
+            <a:r>
+              <a:rPr sz="1650" b="1">
+                <a:solidFill>
+                  <a:srgbClr val="0F172A"/>
+                </a:solidFill>
+              </a:rPr>
+              <a:t>Runtime hint</a:t>
+            </a:r>
+          </a:p>
+        </p:txBody>
+      </p:sp>
+      <p:sp>
+        <p:nvSpPr>
+          <p:cNvPr id="5" name="">
+            <a:extLst xmlns:a="http://schemas.openxmlformats.org/drawingml/2006/main">
+              <a:ext uri="{FF2B5EF4-FFF2-40B4-BE49-F238E27FC236}">
+                <a16:creationId xmlns:a16="http://schemas.microsoft.com/office/drawing/2014/main" id="{5C14670C-522D-49B1-852B-3208D7C87FF2}"/>
+              </a:ext>
+            </a:extLst>
+          </p:cNvPr>
+          <p:cNvSpPr>
+            <a:spLocks xmlns:a="http://schemas.openxmlformats.org/drawingml/2006/main" noGrp="1"/>
+          </p:cNvSpPr>
+          <p:nvPr/>
+        </p:nvSpPr>
+        <p:spPr>
+          <a:xfrm xmlns:a="http://schemas.openxmlformats.org/drawingml/2006/main">
+            <a:off x="723900" y="2838450"/>
+            <a:ext cx="1352550" cy="533400"/>
+          </a:xfrm>
+          <a:prstGeom xmlns:a="http://schemas.openxmlformats.org/drawingml/2006/main" prst="rect">
+            <a:avLst/>
+          </a:prstGeom>
+          <a:noFill xmlns:a="http://schemas.openxmlformats.org/drawingml/2006/main"/>
+          <a:ln xmlns:a="http://schemas.openxmlformats.org/drawingml/2006/main" w="0">
+            <a:noFill/>
+            <a:prstDash val="solid"/>
+          </a:ln>
+        </p:spPr>
+        <p:txBody>
+          <a:bodyPr xmlns:a="http://schemas.openxmlformats.org/drawingml/2006/main" anchor="t"/>
+          <a:lstStyle xmlns:a="http://schemas.openxmlformats.org/drawingml/2006/main"/>
+          <a:p xmlns:a="http://schemas.openxmlformats.org/drawingml/2006/main">
+            <a:pPr algn="ctr">
+              <a:defRPr sz="1275" b="0">
+                <a:solidFill>
+                  <a:srgbClr val="334155"/>
+                </a:solidFill>
+              </a:defRPr>
+            </a:pPr>
+            <a:r>
+              <a:rPr sz="1275" b="0">
+                <a:solidFill>
+                  <a:srgbClr val="334155"/>
+                </a:solidFill>
+              </a:rPr>
+              <a:t>session, priority, deadline</a:t>
+            </a:r>
+          </a:p>
+        </p:txBody>
+      </p:sp>
+      <p:sp>
+        <p:nvSpPr>
+          <p:cNvPr id="6" name="">
+            <a:extLst xmlns:a="http://schemas.openxmlformats.org/drawingml/2006/main">
+              <a:ext uri="{FF2B5EF4-FFF2-40B4-BE49-F238E27FC236}">
+                <a16:creationId xmlns:a16="http://schemas.microsoft.com/office/drawing/2014/main" id="{ED09A8D7-54E5-4C23-89EA-B88811642562}"/>
+              </a:ext>
+            </a:extLst>
+          </p:cNvPr>
+          <p:cNvSpPr>
+            <a:spLocks xmlns:a="http://schemas.openxmlformats.org/drawingml/2006/main" noGrp="1"/>
+          </p:cNvSpPr>
+          <p:nvPr/>
+        </p:nvSpPr>
+        <p:spPr>
+          <a:xfrm xmlns:a="http://schemas.openxmlformats.org/drawingml/2006/main">
+            <a:off x="2305050" y="2552700"/>
+            <a:ext cx="476250" cy="476250"/>
+          </a:xfrm>
+          <a:prstGeom xmlns:a="http://schemas.openxmlformats.org/drawingml/2006/main" prst="rect">
+            <a:avLst/>
+          </a:prstGeom>
+          <a:noFill xmlns:a="http://schemas.openxmlformats.org/drawingml/2006/main"/>
+          <a:ln xmlns:a="http://schemas.openxmlformats.org/drawingml/2006/main" w="0">
+            <a:noFill/>
+            <a:prstDash val="solid"/>
+          </a:ln>
+        </p:spPr>
+        <p:txBody>
+          <a:bodyPr xmlns:a="http://schemas.openxmlformats.org/drawingml/2006/main" anchor="t"/>
+          <a:lstStyle xmlns:a="http://schemas.openxmlformats.org/drawingml/2006/main"/>
+          <a:p xmlns:a="http://schemas.openxmlformats.org/drawingml/2006/main">
+            <a:pPr algn="ctr">
+              <a:defRPr sz="2550" b="1">
+                <a:solidFill>
+                  <a:srgbClr val="64748B"/>
+                </a:solidFill>
+              </a:defRPr>
+            </a:pPr>
+            <a:r>
+              <a:rPr sz="2550" b="1">
+                <a:solidFill>
+                  <a:srgbClr val="64748B"/>
+                </a:solidFill>
+              </a:rPr>
+              <a:t>→</a:t>
+            </a:r>
+          </a:p>
+        </p:txBody>
+      </p:sp>
+      <p:sp>
+        <p:nvSpPr>
+          <p:cNvPr id="7" name="">
+            <a:extLst xmlns:a="http://schemas.openxmlformats.org/drawingml/2006/main">
+              <a:ext uri="{FF2B5EF4-FFF2-40B4-BE49-F238E27FC236}">
+                <a16:creationId xmlns:a16="http://schemas.microsoft.com/office/drawing/2014/main" id="{9AAB7A8C-8B1D-4A7A-93E9-049E17493353}"/>
+              </a:ext>
+            </a:extLst>
+          </p:cNvPr>
+          <p:cNvSpPr>
+            <a:spLocks xmlns:a="http://schemas.openxmlformats.org/drawingml/2006/main" noGrp="1"/>
+          </p:cNvSpPr>
+          <p:nvPr/>
+        </p:nvSpPr>
+        <p:spPr>
+          <a:xfrm xmlns:a="http://schemas.openxmlformats.org/drawingml/2006/main">
+            <a:off x="2857500" y="1962150"/>
+            <a:ext cx="1695450" cy="1695450"/>
+          </a:xfrm>
+          <a:prstGeom xmlns:a="http://schemas.openxmlformats.org/drawingml/2006/main" prst="roundRect">
+            <a:avLst>
+              <a:gd name="adj" fmla="val 3371"/>
+            </a:avLst>
+          </a:prstGeom>
+          <a:solidFill xmlns:a="http://schemas.openxmlformats.org/drawingml/2006/main">
+            <a:srgbClr val="F5F3FF"/>
+          </a:solidFill>
+          <a:ln xmlns:a="http://schemas.openxmlformats.org/drawingml/2006/main" w="9525">
+            <a:solidFill>
+              <a:srgbClr val="A855F7"/>
+            </a:solidFill>
+            <a:prstDash val="solid"/>
+          </a:ln>
+        </p:spPr>
+      </p:sp>
+      <p:sp>
+        <p:nvSpPr>
+          <p:cNvPr id="8" name="">
+            <a:extLst xmlns:a="http://schemas.openxmlformats.org/drawingml/2006/main">
+              <a:ext uri="{FF2B5EF4-FFF2-40B4-BE49-F238E27FC236}">
+                <a16:creationId xmlns:a16="http://schemas.microsoft.com/office/drawing/2014/main" id="{E41ABD46-71E0-4DB9-B747-77B06D5B3516}"/>
+              </a:ext>
+            </a:extLst>
+          </p:cNvPr>
+          <p:cNvSpPr>
+            <a:spLocks xmlns:a="http://schemas.openxmlformats.org/drawingml/2006/main" noGrp="1"/>
+          </p:cNvSpPr>
+          <p:nvPr/>
+        </p:nvSpPr>
+        <p:spPr>
+          <a:xfrm xmlns:a="http://schemas.openxmlformats.org/drawingml/2006/main">
+            <a:off x="3009900" y="2228850"/>
+            <a:ext cx="1390650" cy="323850"/>
+          </a:xfrm>
+          <a:prstGeom xmlns:a="http://schemas.openxmlformats.org/drawingml/2006/main" prst="rect">
+            <a:avLst/>
+          </a:prstGeom>
+          <a:noFill xmlns:a="http://schemas.openxmlformats.org/drawingml/2006/main"/>
+          <a:ln xmlns:a="http://schemas.openxmlformats.org/drawingml/2006/main" w="0">
+            <a:noFill/>
+            <a:prstDash val="solid"/>
+          </a:ln>
+        </p:spPr>
+        <p:txBody>
+          <a:bodyPr xmlns:a="http://schemas.openxmlformats.org/drawingml/2006/main" anchor="t"/>
+          <a:lstStyle xmlns:a="http://schemas.openxmlformats.org/drawingml/2006/main"/>
+          <a:p xmlns:a="http://schemas.openxmlformats.org/drawingml/2006/main">
+            <a:pPr algn="ctr">
+              <a:defRPr sz="1650" b="1">
+                <a:solidFill>
+                  <a:srgbClr val="0F172A"/>
+                </a:solidFill>
+              </a:defRPr>
+            </a:pPr>
+            <a:r>
+              <a:rPr sz="1650" b="1">
+                <a:solidFill>
+                  <a:srgbClr val="0F172A"/>
+                </a:solidFill>
+              </a:rPr>
+              <a:t>KV-aware queue</a:t>
+            </a:r>
+          </a:p>
+        </p:txBody>
+      </p:sp>
+      <p:sp>
+        <p:nvSpPr>
+          <p:cNvPr id="9" name="">
+            <a:extLst xmlns:a="http://schemas.openxmlformats.org/drawingml/2006/main">
+              <a:ext uri="{FF2B5EF4-FFF2-40B4-BE49-F238E27FC236}">
+                <a16:creationId xmlns:a16="http://schemas.microsoft.com/office/drawing/2014/main" id="{096A9AAE-E82C-4720-812A-0D4946B0FCEE}"/>
+              </a:ext>
+            </a:extLst>
+          </p:cNvPr>
+          <p:cNvSpPr>
+            <a:spLocks xmlns:a="http://schemas.openxmlformats.org/drawingml/2006/main" noGrp="1"/>
+          </p:cNvSpPr>
+          <p:nvPr/>
+        </p:nvSpPr>
+        <p:spPr>
+          <a:xfrm xmlns:a="http://schemas.openxmlformats.org/drawingml/2006/main">
+            <a:off x="3028950" y="2838450"/>
+            <a:ext cx="1352550" cy="533400"/>
+          </a:xfrm>
+          <a:prstGeom xmlns:a="http://schemas.openxmlformats.org/drawingml/2006/main" prst="rect">
+            <a:avLst/>
+          </a:prstGeom>
+          <a:noFill xmlns:a="http://schemas.openxmlformats.org/drawingml/2006/main"/>
+          <a:ln xmlns:a="http://schemas.openxmlformats.org/drawingml/2006/main" w="0">
+            <a:noFill/>
+            <a:prstDash val="solid"/>
+          </a:ln>
+        </p:spPr>
+        <p:txBody>
+          <a:bodyPr xmlns:a="http://schemas.openxmlformats.org/drawingml/2006/main" anchor="t"/>
+          <a:lstStyle xmlns:a="http://schemas.openxmlformats.org/drawingml/2006/main"/>
+          <a:p xmlns:a="http://schemas.openxmlformats.org/drawingml/2006/main">
+            <a:pPr algn="ctr">
+              <a:defRPr sz="1275" b="0">
+                <a:solidFill>
+                  <a:srgbClr val="334155"/>
+                </a:solidFill>
+              </a:defRPr>
+            </a:pPr>
+            <a:r>
+              <a:rPr sz="1275" b="0">
+                <a:solidFill>
+                  <a:srgbClr val="334155"/>
+                </a:solidFill>
+              </a:rPr>
+              <a:t>order urgent KV first</a:t>
+            </a:r>
+          </a:p>
+        </p:txBody>
+      </p:sp>
+      <p:sp>
+        <p:nvSpPr>
+          <p:cNvPr id="10" name="">
+            <a:extLst xmlns:a="http://schemas.openxmlformats.org/drawingml/2006/main">
+              <a:ext uri="{FF2B5EF4-FFF2-40B4-BE49-F238E27FC236}">
+                <a16:creationId xmlns:a16="http://schemas.microsoft.com/office/drawing/2014/main" id="{61160B5E-283D-4B39-9E26-86AF1A21E97E}"/>
+              </a:ext>
+            </a:extLst>
+          </p:cNvPr>
+          <p:cNvSpPr>
+            <a:spLocks xmlns:a="http://schemas.openxmlformats.org/drawingml/2006/main" noGrp="1"/>
+          </p:cNvSpPr>
+          <p:nvPr/>
+        </p:nvSpPr>
+        <p:spPr>
+          <a:xfrm xmlns:a="http://schemas.openxmlformats.org/drawingml/2006/main">
+            <a:off x="4610100" y="2552700"/>
+            <a:ext cx="476250" cy="476250"/>
+          </a:xfrm>
+          <a:prstGeom xmlns:a="http://schemas.openxmlformats.org/drawingml/2006/main" prst="rect">
+            <a:avLst/>
+          </a:prstGeom>
+          <a:noFill xmlns:a="http://schemas.openxmlformats.org/drawingml/2006/main"/>
+          <a:ln xmlns:a="http://schemas.openxmlformats.org/drawingml/2006/main" w="0">
+            <a:noFill/>
+            <a:prstDash val="solid"/>
+          </a:ln>
+        </p:spPr>
+        <p:txBody>
+          <a:bodyPr xmlns:a="http://schemas.openxmlformats.org/drawingml/2006/main" anchor="t"/>
+          <a:lstStyle xmlns:a="http://schemas.openxmlformats.org/drawingml/2006/main"/>
+          <a:p xmlns:a="http://schemas.openxmlformats.org/drawingml/2006/main">
+            <a:pPr algn="ctr">
+              <a:defRPr sz="2550" b="1">
+                <a:solidFill>
+                  <a:srgbClr val="64748B"/>
+                </a:solidFill>
+              </a:defRPr>
+            </a:pPr>
+            <a:r>
+              <a:rPr sz="2550" b="1">
+                <a:solidFill>
+                  <a:srgbClr val="64748B"/>
+                </a:solidFill>
+              </a:rPr>
+              <a:t>→</a:t>
+            </a:r>
+          </a:p>
+        </p:txBody>
+      </p:sp>
+      <p:sp>
+        <p:nvSpPr>
+          <p:cNvPr id="11" name="">
+            <a:extLst xmlns:a="http://schemas.openxmlformats.org/drawingml/2006/main">
+              <a:ext uri="{FF2B5EF4-FFF2-40B4-BE49-F238E27FC236}">
+                <a16:creationId xmlns:a16="http://schemas.microsoft.com/office/drawing/2014/main" id="{DEA0A620-1499-4C8C-9779-5B81C1E9B8D7}"/>
+              </a:ext>
+            </a:extLst>
+          </p:cNvPr>
+          <p:cNvSpPr>
+            <a:spLocks xmlns:a="http://schemas.openxmlformats.org/drawingml/2006/main" noGrp="1"/>
+          </p:cNvSpPr>
+          <p:nvPr/>
+        </p:nvSpPr>
+        <p:spPr>
+          <a:xfrm xmlns:a="http://schemas.openxmlformats.org/drawingml/2006/main">
+            <a:off x="5162550" y="1962150"/>
+            <a:ext cx="1695450" cy="1695450"/>
+          </a:xfrm>
+          <a:prstGeom xmlns:a="http://schemas.openxmlformats.org/drawingml/2006/main" prst="roundRect">
+            <a:avLst>
+              <a:gd name="adj" fmla="val 3371"/>
+            </a:avLst>
+          </a:prstGeom>
+          <a:solidFill xmlns:a="http://schemas.openxmlformats.org/drawingml/2006/main">
+            <a:srgbClr val="ECFEFF"/>
+          </a:solidFill>
+          <a:ln xmlns:a="http://schemas.openxmlformats.org/drawingml/2006/main" w="9525">
+            <a:solidFill>
+              <a:srgbClr val="06B6D4"/>
+            </a:solidFill>
+            <a:prstDash val="solid"/>
+          </a:ln>
+        </p:spPr>
+      </p:sp>
+      <p:sp>
+        <p:nvSpPr>
+          <p:cNvPr id="12" name="">
+            <a:extLst xmlns:a="http://schemas.openxmlformats.org/drawingml/2006/main">
+              <a:ext uri="{FF2B5EF4-FFF2-40B4-BE49-F238E27FC236}">
+                <a16:creationId xmlns:a16="http://schemas.microsoft.com/office/drawing/2014/main" id="{0E271240-12AD-4197-9874-59AD12A972F5}"/>
+              </a:ext>
+            </a:extLst>
+          </p:cNvPr>
+          <p:cNvSpPr>
+            <a:spLocks xmlns:a="http://schemas.openxmlformats.org/drawingml/2006/main" noGrp="1"/>
+          </p:cNvSpPr>
+          <p:nvPr/>
+        </p:nvSpPr>
+        <p:spPr>
+          <a:xfrm xmlns:a="http://schemas.openxmlformats.org/drawingml/2006/main">
+            <a:off x="5314950" y="2228850"/>
+            <a:ext cx="1390650" cy="323850"/>
+          </a:xfrm>
+          <a:prstGeom xmlns:a="http://schemas.openxmlformats.org/drawingml/2006/main" prst="rect">
+            <a:avLst/>
+          </a:prstGeom>
+          <a:noFill xmlns:a="http://schemas.openxmlformats.org/drawingml/2006/main"/>
+          <a:ln xmlns:a="http://schemas.openxmlformats.org/drawingml/2006/main" w="0">
+            <a:noFill/>
+            <a:prstDash val="solid"/>
+          </a:ln>
+        </p:spPr>
+        <p:txBody>
+          <a:bodyPr xmlns:a="http://schemas.openxmlformats.org/drawingml/2006/main" anchor="t"/>
+          <a:lstStyle xmlns:a="http://schemas.openxmlformats.org/drawingml/2006/main"/>
+          <a:p xmlns:a="http://schemas.openxmlformats.org/drawingml/2006/main">
+            <a:pPr algn="ctr">
+              <a:defRPr sz="1650" b="1">
+                <a:solidFill>
+                  <a:srgbClr val="0F172A"/>
+                </a:solidFill>
+              </a:defRPr>
+            </a:pPr>
+            <a:r>
+              <a:rPr sz="1650" b="1">
+                <a:solidFill>
+                  <a:srgbClr val="0F172A"/>
+                </a:solidFill>
+              </a:rPr>
+              <a:t>DMA / copy engine</a:t>
+            </a:r>
+          </a:p>
+        </p:txBody>
+      </p:sp>
+      <p:sp>
+        <p:nvSpPr>
+          <p:cNvPr id="13" name="">
+            <a:extLst xmlns:a="http://schemas.openxmlformats.org/drawingml/2006/main">
+              <a:ext uri="{FF2B5EF4-FFF2-40B4-BE49-F238E27FC236}">
+                <a16:creationId xmlns:a16="http://schemas.microsoft.com/office/drawing/2014/main" id="{1442192C-9A8F-4A32-881C-9D2D6FCB6197}"/>
+              </a:ext>
+            </a:extLst>
+          </p:cNvPr>
+          <p:cNvSpPr>
+            <a:spLocks xmlns:a="http://schemas.openxmlformats.org/drawingml/2006/main" noGrp="1"/>
+          </p:cNvSpPr>
+          <p:nvPr/>
+        </p:nvSpPr>
+        <p:spPr>
+          <a:xfrm xmlns:a="http://schemas.openxmlformats.org/drawingml/2006/main">
+            <a:off x="5334000" y="2838450"/>
+            <a:ext cx="1352550" cy="533400"/>
+          </a:xfrm>
+          <a:prstGeom xmlns:a="http://schemas.openxmlformats.org/drawingml/2006/main" prst="rect">
+            <a:avLst/>
+          </a:prstGeom>
+          <a:noFill xmlns:a="http://schemas.openxmlformats.org/drawingml/2006/main"/>
+          <a:ln xmlns:a="http://schemas.openxmlformats.org/drawingml/2006/main" w="0">
+            <a:noFill/>
+            <a:prstDash val="solid"/>
+          </a:ln>
+        </p:spPr>
+        <p:txBody>
+          <a:bodyPr xmlns:a="http://schemas.openxmlformats.org/drawingml/2006/main" anchor="t"/>
+          <a:lstStyle xmlns:a="http://schemas.openxmlformats.org/drawingml/2006/main"/>
+          <a:p xmlns:a="http://schemas.openxmlformats.org/drawingml/2006/main">
+            <a:pPr algn="ctr">
+              <a:defRPr sz="1275" b="0">
+                <a:solidFill>
+                  <a:srgbClr val="334155"/>
+                </a:solidFill>
+              </a:defRPr>
+            </a:pPr>
+            <a:r>
+              <a:rPr sz="1275" b="0">
+                <a:solidFill>
+                  <a:srgbClr val="334155"/>
+                </a:solidFill>
+              </a:rPr>
+              <a:t>throttle and prioritize</a:t>
+            </a:r>
+          </a:p>
+        </p:txBody>
+      </p:sp>
+      <p:sp>
+        <p:nvSpPr>
+          <p:cNvPr id="14" name="">
+            <a:extLst xmlns:a="http://schemas.openxmlformats.org/drawingml/2006/main">
+              <a:ext uri="{FF2B5EF4-FFF2-40B4-BE49-F238E27FC236}">
+                <a16:creationId xmlns:a16="http://schemas.microsoft.com/office/drawing/2014/main" id="{3010C93D-115D-416A-ACC6-E3A292715326}"/>
+              </a:ext>
+            </a:extLst>
+          </p:cNvPr>
+          <p:cNvSpPr>
+            <a:spLocks xmlns:a="http://schemas.openxmlformats.org/drawingml/2006/main" noGrp="1"/>
+          </p:cNvSpPr>
+          <p:nvPr/>
+        </p:nvSpPr>
+        <p:spPr>
+          <a:xfrm xmlns:a="http://schemas.openxmlformats.org/drawingml/2006/main">
+            <a:off x="6915150" y="2552700"/>
+            <a:ext cx="476250" cy="476250"/>
+          </a:xfrm>
+          <a:prstGeom xmlns:a="http://schemas.openxmlformats.org/drawingml/2006/main" prst="rect">
+            <a:avLst/>
+          </a:prstGeom>
+          <a:noFill xmlns:a="http://schemas.openxmlformats.org/drawingml/2006/main"/>
+          <a:ln xmlns:a="http://schemas.openxmlformats.org/drawingml/2006/main" w="0">
+            <a:noFill/>
+            <a:prstDash val="solid"/>
+          </a:ln>
+        </p:spPr>
+        <p:txBody>
+          <a:bodyPr xmlns:a="http://schemas.openxmlformats.org/drawingml/2006/main" anchor="t"/>
+          <a:lstStyle xmlns:a="http://schemas.openxmlformats.org/drawingml/2006/main"/>
+          <a:p xmlns:a="http://schemas.openxmlformats.org/drawingml/2006/main">
+            <a:pPr algn="ctr">
+              <a:defRPr sz="2550" b="1">
+                <a:solidFill>
+                  <a:srgbClr val="64748B"/>
+                </a:solidFill>
+              </a:defRPr>
+            </a:pPr>
+            <a:r>
+              <a:rPr sz="2550" b="1">
+                <a:solidFill>
+                  <a:srgbClr val="64748B"/>
+                </a:solidFill>
+              </a:rPr>
+              <a:t>→</a:t>
+            </a:r>
+          </a:p>
+        </p:txBody>
+      </p:sp>
+      <p:sp>
+        <p:nvSpPr>
+          <p:cNvPr id="15" name="">
+            <a:extLst xmlns:a="http://schemas.openxmlformats.org/drawingml/2006/main">
+              <a:ext uri="{FF2B5EF4-FFF2-40B4-BE49-F238E27FC236}">
+                <a16:creationId xmlns:a16="http://schemas.microsoft.com/office/drawing/2014/main" id="{D6D3D268-BEEF-4778-BD26-EFD53C4FB867}"/>
+              </a:ext>
+            </a:extLst>
+          </p:cNvPr>
+          <p:cNvSpPr>
+            <a:spLocks xmlns:a="http://schemas.openxmlformats.org/drawingml/2006/main" noGrp="1"/>
+          </p:cNvSpPr>
+          <p:nvPr/>
+        </p:nvSpPr>
+        <p:spPr>
+          <a:xfrm xmlns:a="http://schemas.openxmlformats.org/drawingml/2006/main">
+            <a:off x="7467600" y="1962150"/>
+            <a:ext cx="1695450" cy="1695450"/>
+          </a:xfrm>
+          <a:prstGeom xmlns:a="http://schemas.openxmlformats.org/drawingml/2006/main" prst="roundRect">
+            <a:avLst>
+              <a:gd name="adj" fmla="val 3371"/>
+            </a:avLst>
+          </a:prstGeom>
+          <a:solidFill xmlns:a="http://schemas.openxmlformats.org/drawingml/2006/main">
+            <a:srgbClr val="F0FDF4"/>
+          </a:solidFill>
+          <a:ln xmlns:a="http://schemas.openxmlformats.org/drawingml/2006/main" w="9525">
+            <a:solidFill>
+              <a:srgbClr val="16A34A"/>
+            </a:solidFill>
+            <a:prstDash val="solid"/>
+          </a:ln>
+        </p:spPr>
+      </p:sp>
+      <p:sp>
+        <p:nvSpPr>
+          <p:cNvPr id="16" name="">
+            <a:extLst xmlns:a="http://schemas.openxmlformats.org/drawingml/2006/main">
+              <a:ext uri="{FF2B5EF4-FFF2-40B4-BE49-F238E27FC236}">
+                <a16:creationId xmlns:a16="http://schemas.microsoft.com/office/drawing/2014/main" id="{2B5178BF-995A-4A29-80E0-D4F85A2FAFF9}"/>
+              </a:ext>
+            </a:extLst>
+          </p:cNvPr>
+          <p:cNvSpPr>
+            <a:spLocks xmlns:a="http://schemas.openxmlformats.org/drawingml/2006/main" noGrp="1"/>
+          </p:cNvSpPr>
+          <p:nvPr/>
+        </p:nvSpPr>
+        <p:spPr>
+          <a:xfrm xmlns:a="http://schemas.openxmlformats.org/drawingml/2006/main">
+            <a:off x="7620000" y="2228850"/>
+            <a:ext cx="1390650" cy="323850"/>
+          </a:xfrm>
+          <a:prstGeom xmlns:a="http://schemas.openxmlformats.org/drawingml/2006/main" prst="rect">
+            <a:avLst/>
+          </a:prstGeom>
+          <a:noFill xmlns:a="http://schemas.openxmlformats.org/drawingml/2006/main"/>
+          <a:ln xmlns:a="http://schemas.openxmlformats.org/drawingml/2006/main" w="0">
+            <a:noFill/>
+            <a:prstDash val="solid"/>
+          </a:ln>
+        </p:spPr>
+        <p:txBody>
+          <a:bodyPr xmlns:a="http://schemas.openxmlformats.org/drawingml/2006/main" anchor="t"/>
+          <a:lstStyle xmlns:a="http://schemas.openxmlformats.org/drawingml/2006/main"/>
+          <a:p xmlns:a="http://schemas.openxmlformats.org/drawingml/2006/main">
+            <a:pPr algn="ctr">
+              <a:defRPr sz="1650" b="1">
+                <a:solidFill>
+                  <a:srgbClr val="0F172A"/>
+                </a:solidFill>
+              </a:defRPr>
+            </a:pPr>
+            <a:r>
+              <a:rPr sz="1650" b="1">
+                <a:solidFill>
+                  <a:srgbClr val="0F172A"/>
+                </a:solidFill>
+              </a:rPr>
+              <a:t>Residency control</a:t>
+            </a:r>
+          </a:p>
+        </p:txBody>
+      </p:sp>
+      <p:sp>
+        <p:nvSpPr>
+          <p:cNvPr id="17" name="">
+            <a:extLst xmlns:a="http://schemas.openxmlformats.org/drawingml/2006/main">
+              <a:ext uri="{FF2B5EF4-FFF2-40B4-BE49-F238E27FC236}">
+                <a16:creationId xmlns:a16="http://schemas.microsoft.com/office/drawing/2014/main" id="{DADF1759-77D3-4754-A043-87D046C82E1B}"/>
+              </a:ext>
+            </a:extLst>
+          </p:cNvPr>
+          <p:cNvSpPr>
+            <a:spLocks xmlns:a="http://schemas.openxmlformats.org/drawingml/2006/main" noGrp="1"/>
+          </p:cNvSpPr>
+          <p:nvPr/>
+        </p:nvSpPr>
+        <p:spPr>
+          <a:xfrm xmlns:a="http://schemas.openxmlformats.org/drawingml/2006/main">
+            <a:off x="7639050" y="2838450"/>
+            <a:ext cx="1352550" cy="533400"/>
+          </a:xfrm>
+          <a:prstGeom xmlns:a="http://schemas.openxmlformats.org/drawingml/2006/main" prst="rect">
+            <a:avLst/>
+          </a:prstGeom>
+          <a:noFill xmlns:a="http://schemas.openxmlformats.org/drawingml/2006/main"/>
+          <a:ln xmlns:a="http://schemas.openxmlformats.org/drawingml/2006/main" w="0">
+            <a:noFill/>
+            <a:prstDash val="solid"/>
+          </a:ln>
+        </p:spPr>
+        <p:txBody>
+          <a:bodyPr xmlns:a="http://schemas.openxmlformats.org/drawingml/2006/main" anchor="t"/>
+          <a:lstStyle xmlns:a="http://schemas.openxmlformats.org/drawingml/2006/main"/>
+          <a:p xmlns:a="http://schemas.openxmlformats.org/drawingml/2006/main">
+            <a:pPr algn="ctr">
+              <a:defRPr sz="1275" b="0">
+                <a:solidFill>
+                  <a:srgbClr val="334155"/>
+                </a:solidFill>
+              </a:defRPr>
+            </a:pPr>
+            <a:r>
+              <a:rPr sz="1275" b="0">
+                <a:solidFill>
+                  <a:srgbClr val="334155"/>
+                </a:solidFill>
+              </a:rPr>
+              <a:t>protect useful KV</a:t>
+            </a:r>
+          </a:p>
+        </p:txBody>
+      </p:sp>
+      <p:sp>
+        <p:nvSpPr>
+          <p:cNvPr id="18" name="">
+            <a:extLst xmlns:a="http://schemas.openxmlformats.org/drawingml/2006/main">
+              <a:ext uri="{FF2B5EF4-FFF2-40B4-BE49-F238E27FC236}">
+                <a16:creationId xmlns:a16="http://schemas.microsoft.com/office/drawing/2014/main" id="{DC98FF0B-2B17-4F70-88FE-8304DEF05A22}"/>
+              </a:ext>
+            </a:extLst>
+          </p:cNvPr>
+          <p:cNvSpPr>
+            <a:spLocks xmlns:a="http://schemas.openxmlformats.org/drawingml/2006/main" noGrp="1"/>
+          </p:cNvSpPr>
+          <p:nvPr/>
+        </p:nvSpPr>
+        <p:spPr>
+          <a:xfrm xmlns:a="http://schemas.openxmlformats.org/drawingml/2006/main">
+            <a:off x="9220200" y="2552700"/>
+            <a:ext cx="476250" cy="476250"/>
+          </a:xfrm>
+          <a:prstGeom xmlns:a="http://schemas.openxmlformats.org/drawingml/2006/main" prst="rect">
+            <a:avLst/>
+          </a:prstGeom>
+          <a:noFill xmlns:a="http://schemas.openxmlformats.org/drawingml/2006/main"/>
+          <a:ln xmlns:a="http://schemas.openxmlformats.org/drawingml/2006/main" w="0">
+            <a:noFill/>
+            <a:prstDash val="solid"/>
+          </a:ln>
+        </p:spPr>
+        <p:txBody>
+          <a:bodyPr xmlns:a="http://schemas.openxmlformats.org/drawingml/2006/main" anchor="t"/>
+          <a:lstStyle xmlns:a="http://schemas.openxmlformats.org/drawingml/2006/main"/>
+          <a:p xmlns:a="http://schemas.openxmlformats.org/drawingml/2006/main">
+            <a:pPr algn="ctr">
+              <a:defRPr sz="2550" b="1">
+                <a:solidFill>
+                  <a:srgbClr val="64748B"/>
+                </a:solidFill>
+              </a:defRPr>
+            </a:pPr>
+            <a:r>
+              <a:rPr sz="2550" b="1">
+                <a:solidFill>
+                  <a:srgbClr val="64748B"/>
+                </a:solidFill>
+              </a:rPr>
+              <a:t>→</a:t>
+            </a:r>
+          </a:p>
+        </p:txBody>
+      </p:sp>
+      <p:sp>
+        <p:nvSpPr>
+          <p:cNvPr id="19" name="">
+            <a:extLst xmlns:a="http://schemas.openxmlformats.org/drawingml/2006/main">
+              <a:ext uri="{FF2B5EF4-FFF2-40B4-BE49-F238E27FC236}">
+                <a16:creationId xmlns:a16="http://schemas.microsoft.com/office/drawing/2014/main" id="{E66DFCA9-8FD9-449C-831F-CD33CEE05208}"/>
+              </a:ext>
+            </a:extLst>
+          </p:cNvPr>
+          <p:cNvSpPr>
+            <a:spLocks xmlns:a="http://schemas.openxmlformats.org/drawingml/2006/main" noGrp="1"/>
+          </p:cNvSpPr>
+          <p:nvPr/>
+        </p:nvSpPr>
+        <p:spPr>
+          <a:xfrm xmlns:a="http://schemas.openxmlformats.org/drawingml/2006/main">
+            <a:off x="9772650" y="1962150"/>
+            <a:ext cx="1695450" cy="1695450"/>
+          </a:xfrm>
+          <a:prstGeom xmlns:a="http://schemas.openxmlformats.org/drawingml/2006/main" prst="roundRect">
+            <a:avLst>
+              <a:gd name="adj" fmla="val 3371"/>
+            </a:avLst>
+          </a:prstGeom>
+          <a:solidFill xmlns:a="http://schemas.openxmlformats.org/drawingml/2006/main">
+            <a:srgbClr val="FFF7ED"/>
+          </a:solidFill>
+          <a:ln xmlns:a="http://schemas.openxmlformats.org/drawingml/2006/main" w="9525">
+            <a:solidFill>
+              <a:srgbClr val="F97316"/>
+            </a:solidFill>
+            <a:prstDash val="solid"/>
+          </a:ln>
+        </p:spPr>
+      </p:sp>
+      <p:sp>
+        <p:nvSpPr>
+          <p:cNvPr id="20" name="">
+            <a:extLst xmlns:a="http://schemas.openxmlformats.org/drawingml/2006/main">
+              <a:ext uri="{FF2B5EF4-FFF2-40B4-BE49-F238E27FC236}">
+                <a16:creationId xmlns:a16="http://schemas.microsoft.com/office/drawing/2014/main" id="{EDD22A59-6806-4DE5-AF11-5F338F6FE749}"/>
+              </a:ext>
+            </a:extLst>
+          </p:cNvPr>
+          <p:cNvSpPr>
+            <a:spLocks xmlns:a="http://schemas.openxmlformats.org/drawingml/2006/main" noGrp="1"/>
+          </p:cNvSpPr>
+          <p:nvPr/>
+        </p:nvSpPr>
+        <p:spPr>
+          <a:xfrm xmlns:a="http://schemas.openxmlformats.org/drawingml/2006/main">
+            <a:off x="9925050" y="2228850"/>
+            <a:ext cx="1390650" cy="323850"/>
+          </a:xfrm>
+          <a:prstGeom xmlns:a="http://schemas.openxmlformats.org/drawingml/2006/main" prst="rect">
+            <a:avLst/>
+          </a:prstGeom>
+          <a:noFill xmlns:a="http://schemas.openxmlformats.org/drawingml/2006/main"/>
+          <a:ln xmlns:a="http://schemas.openxmlformats.org/drawingml/2006/main" w="0">
+            <a:noFill/>
+            <a:prstDash val="solid"/>
+          </a:ln>
+        </p:spPr>
+        <p:txBody>
+          <a:bodyPr xmlns:a="http://schemas.openxmlformats.org/drawingml/2006/main" anchor="t"/>
+          <a:lstStyle xmlns:a="http://schemas.openxmlformats.org/drawingml/2006/main"/>
+          <a:p xmlns:a="http://schemas.openxmlformats.org/drawingml/2006/main">
+            <a:pPr algn="ctr">
+              <a:defRPr sz="1650" b="1">
+                <a:solidFill>
+                  <a:srgbClr val="0F172A"/>
+                </a:solidFill>
+              </a:defRPr>
+            </a:pPr>
+            <a:r>
+              <a:rPr sz="1650" b="1">
+                <a:solidFill>
+                  <a:srgbClr val="0F172A"/>
+                </a:solidFill>
+              </a:rPr>
+              <a:t>Telemetry</a:t>
+            </a:r>
+          </a:p>
+        </p:txBody>
+      </p:sp>
+      <p:sp>
+        <p:nvSpPr>
+          <p:cNvPr id="21" name="">
+            <a:extLst xmlns:a="http://schemas.openxmlformats.org/drawingml/2006/main">
+              <a:ext uri="{FF2B5EF4-FFF2-40B4-BE49-F238E27FC236}">
+                <a16:creationId xmlns:a16="http://schemas.microsoft.com/office/drawing/2014/main" id="{E32FC3B7-0FAE-46F3-AF72-228EF272B6FC}"/>
+              </a:ext>
+            </a:extLst>
+          </p:cNvPr>
+          <p:cNvSpPr>
+            <a:spLocks xmlns:a="http://schemas.openxmlformats.org/drawingml/2006/main" noGrp="1"/>
+          </p:cNvSpPr>
+          <p:nvPr/>
+        </p:nvSpPr>
+        <p:spPr>
+          <a:xfrm xmlns:a="http://schemas.openxmlformats.org/drawingml/2006/main">
+            <a:off x="9944100" y="2838450"/>
+            <a:ext cx="1352550" cy="533400"/>
+          </a:xfrm>
+          <a:prstGeom xmlns:a="http://schemas.openxmlformats.org/drawingml/2006/main" prst="rect">
+            <a:avLst/>
+          </a:prstGeom>
+          <a:noFill xmlns:a="http://schemas.openxmlformats.org/drawingml/2006/main"/>
+          <a:ln xmlns:a="http://schemas.openxmlformats.org/drawingml/2006/main" w="0">
+            <a:noFill/>
+            <a:prstDash val="solid"/>
+          </a:ln>
+        </p:spPr>
+        <p:txBody>
+          <a:bodyPr xmlns:a="http://schemas.openxmlformats.org/drawingml/2006/main" anchor="t"/>
+          <a:lstStyle xmlns:a="http://schemas.openxmlformats.org/drawingml/2006/main"/>
+          <a:p xmlns:a="http://schemas.openxmlformats.org/drawingml/2006/main">
+            <a:pPr algn="ctr">
+              <a:defRPr sz="1275" b="0">
+                <a:solidFill>
+                  <a:srgbClr val="334155"/>
+                </a:solidFill>
+              </a:defRPr>
+            </a:pPr>
+            <a:r>
+              <a:rPr sz="1275" b="0">
+                <a:solidFill>
+                  <a:srgbClr val="334155"/>
+                </a:solidFill>
+              </a:rPr>
+              <a:t>late / useful / wasted</a:t>
+            </a:r>
+          </a:p>
+        </p:txBody>
+      </p:sp>
+      <p:sp>
+        <p:nvSpPr>
+          <p:cNvPr id="22" name="">
+            <a:extLst xmlns:a="http://schemas.openxmlformats.org/drawingml/2006/main">
+              <a:ext uri="{FF2B5EF4-FFF2-40B4-BE49-F238E27FC236}">
+                <a16:creationId xmlns:a16="http://schemas.microsoft.com/office/drawing/2014/main" id="{BD658E17-8C90-4FF7-9B43-8CCD1DF156C1}"/>
+              </a:ext>
+            </a:extLst>
+          </p:cNvPr>
+          <p:cNvSpPr>
+            <a:spLocks xmlns:a="http://schemas.openxmlformats.org/drawingml/2006/main" noGrp="1"/>
+          </p:cNvSpPr>
+          <p:nvPr/>
+        </p:nvSpPr>
+        <p:spPr>
+          <a:xfrm xmlns:a="http://schemas.openxmlformats.org/drawingml/2006/main">
+            <a:off x="2000250" y="4514850"/>
+            <a:ext cx="8191500" cy="800100"/>
+          </a:xfrm>
+          <a:prstGeom xmlns:a="http://schemas.openxmlformats.org/drawingml/2006/main" prst="roundRect">
+            <a:avLst>
+              <a:gd name="adj" fmla="val 7143"/>
+            </a:avLst>
+          </a:prstGeom>
+          <a:solidFill xmlns:a="http://schemas.openxmlformats.org/drawingml/2006/main">
+            <a:srgbClr val="F8FAFC"/>
+          </a:solidFill>
+          <a:ln xmlns:a="http://schemas.openxmlformats.org/drawingml/2006/main" w="9525">
+            <a:solidFill>
+              <a:srgbClr val="CBD5E1"/>
+            </a:solidFill>
+            <a:prstDash val="solid"/>
+          </a:ln>
+        </p:spPr>
+      </p:sp>
+      <p:sp>
+        <p:nvSpPr>
+          <p:cNvPr id="23" name="">
+            <a:extLst xmlns:a="http://schemas.openxmlformats.org/drawingml/2006/main">
+              <a:ext uri="{FF2B5EF4-FFF2-40B4-BE49-F238E27FC236}">
+                <a16:creationId xmlns:a16="http://schemas.microsoft.com/office/drawing/2014/main" id="{484D4CAF-69BB-4328-B8B0-B6BC5C6425FE}"/>
+              </a:ext>
+            </a:extLst>
+          </p:cNvPr>
+          <p:cNvSpPr>
+            <a:spLocks xmlns:a="http://schemas.openxmlformats.org/drawingml/2006/main" noGrp="1"/>
+          </p:cNvSpPr>
+          <p:nvPr/>
+        </p:nvSpPr>
+        <p:spPr>
+          <a:xfrm xmlns:a="http://schemas.openxmlformats.org/drawingml/2006/main">
+            <a:off x="2247900" y="4743450"/>
+            <a:ext cx="2476500" cy="247650"/>
+          </a:xfrm>
+          <a:prstGeom xmlns:a="http://schemas.openxmlformats.org/drawingml/2006/main" prst="rect">
+            <a:avLst/>
+          </a:prstGeom>
+          <a:noFill xmlns:a="http://schemas.openxmlformats.org/drawingml/2006/main"/>
+          <a:ln xmlns:a="http://schemas.openxmlformats.org/drawingml/2006/main" w="0">
+            <a:noFill/>
+            <a:prstDash val="solid"/>
+          </a:ln>
+        </p:spPr>
+        <p:txBody>
+          <a:bodyPr xmlns:a="http://schemas.openxmlformats.org/drawingml/2006/main" anchor="t"/>
+          <a:lstStyle xmlns:a="http://schemas.openxmlformats.org/drawingml/2006/main"/>
+          <a:p xmlns:a="http://schemas.openxmlformats.org/drawingml/2006/main">
+            <a:pPr algn="l">
+              <a:defRPr sz="1650" b="1">
+                <a:solidFill>
+                  <a:srgbClr val="0F172A"/>
+                </a:solidFill>
+              </a:defRPr>
+            </a:pPr>
+            <a:r>
+              <a:rPr sz="1650" b="1">
+                <a:solidFill>
+                  <a:srgbClr val="0F172A"/>
+                </a:solidFill>
+              </a:rPr>
+              <a:t>Resulting research question</a:t>
+            </a:r>
+          </a:p>
+        </p:txBody>
+      </p:sp>
+      <p:sp>
+        <p:nvSpPr>
+          <p:cNvPr id="24" name="">
+            <a:extLst xmlns:a="http://schemas.openxmlformats.org/drawingml/2006/main">
+              <a:ext uri="{FF2B5EF4-FFF2-40B4-BE49-F238E27FC236}">
+                <a16:creationId xmlns:a16="http://schemas.microsoft.com/office/drawing/2014/main" id="{9193DF78-1B62-4618-9334-0768AD22B07E}"/>
+              </a:ext>
+            </a:extLst>
+          </p:cNvPr>
+          <p:cNvSpPr>
+            <a:spLocks xmlns:a="http://schemas.openxmlformats.org/drawingml/2006/main" noGrp="1"/>
+          </p:cNvSpPr>
+          <p:nvPr/>
+        </p:nvSpPr>
+        <p:spPr>
+          <a:xfrm xmlns:a="http://schemas.openxmlformats.org/drawingml/2006/main">
+            <a:off x="4953000" y="4686300"/>
+            <a:ext cx="4762500" cy="419100"/>
+          </a:xfrm>
+          <a:prstGeom xmlns:a="http://schemas.openxmlformats.org/drawingml/2006/main" prst="rect">
+            <a:avLst/>
+          </a:prstGeom>
+          <a:noFill xmlns:a="http://schemas.openxmlformats.org/drawingml/2006/main"/>
+          <a:ln xmlns:a="http://schemas.openxmlformats.org/drawingml/2006/main" w="0">
+            <a:noFill/>
+            <a:prstDash val="solid"/>
+          </a:ln>
+        </p:spPr>
+        <p:txBody>
+          <a:bodyPr xmlns:a="http://schemas.openxmlformats.org/drawingml/2006/main" anchor="t"/>
+          <a:lstStyle xmlns:a="http://schemas.openxmlformats.org/drawingml/2006/main"/>
+          <a:p xmlns:a="http://schemas.openxmlformats.org/drawingml/2006/main">
+            <a:pPr algn="l">
+              <a:defRPr sz="1425" b="0">
+                <a:solidFill>
+                  <a:srgbClr val="334155"/>
+                </a:solidFill>
+              </a:defRPr>
+            </a:pPr>
+            <a:r>
+              <a:rPr sz="1425" b="0">
+                <a:solidFill>
+                  <a:srgbClr val="334155"/>
+                </a:solidFill>
+              </a:rPr>
+              <a:t>How much replay latency and wasted movement can be avoided when KV movement has session context, priority, deadline, protection, and telemetry?</a:t>
+            </a:r>
+          </a:p>
+        </p:txBody>
+      </p:sp>
+      <p:sp>
+        <p:nvSpPr>
+          <p:cNvPr id="25" name="">
+            <a:extLst xmlns:a="http://schemas.openxmlformats.org/drawingml/2006/main">
+              <a:ext uri="{FF2B5EF4-FFF2-40B4-BE49-F238E27FC236}">
+                <a16:creationId xmlns:a16="http://schemas.microsoft.com/office/drawing/2014/main" id="{541AF021-097C-4ECC-8CE5-1D49324AC31C}"/>
+              </a:ext>
+            </a:extLst>
+          </p:cNvPr>
+          <p:cNvSpPr>
+            <a:spLocks xmlns:a="http://schemas.openxmlformats.org/drawingml/2006/main" noGrp="1"/>
+          </p:cNvSpPr>
+          <p:nvPr/>
+        </p:nvSpPr>
+        <p:spPr>
+          <a:xfrm xmlns:a="http://schemas.openxmlformats.org/drawingml/2006/main">
+            <a:off x="400050" y="6381750"/>
+            <a:ext cx="3429000" cy="228600"/>
+          </a:xfrm>
+          <a:prstGeom xmlns:a="http://schemas.openxmlformats.org/drawingml/2006/main" prst="rect">
+            <a:avLst/>
+          </a:prstGeom>
+          <a:noFill xmlns:a="http://schemas.openxmlformats.org/drawingml/2006/main"/>
+          <a:ln xmlns:a="http://schemas.openxmlformats.org/drawingml/2006/main" w="0">
+            <a:noFill/>
+            <a:prstDash val="solid"/>
+          </a:ln>
+        </p:spPr>
+        <p:txBody>
+          <a:bodyPr xmlns:a="http://schemas.openxmlformats.org/drawingml/2006/main" anchor="t"/>
+          <a:lstStyle xmlns:a="http://schemas.openxmlformats.org/drawingml/2006/main"/>
+          <a:p xmlns:a="http://schemas.openxmlformats.org/drawingml/2006/main">
+            <a:pPr algn="l">
+              <a:defRPr sz="975" b="0">
+                <a:solidFill>
+                  <a:srgbClr val="64748B"/>
+                </a:solidFill>
+              </a:defRPr>
+            </a:pPr>
+            <a:r>
+              <a:rPr sz="975" b="0">
+                <a:solidFill>
+                  <a:srgbClr val="64748B"/>
+                </a:solidFill>
+              </a:rPr>
+              <a:t>Agent-aware KV movement</a:t>
+            </a:r>
+          </a:p>
+        </p:txBody>
+      </p:sp>
+      <p:sp>
+        <p:nvSpPr>
+          <p:cNvPr id="26" name="">
+            <a:extLst xmlns:a="http://schemas.openxmlformats.org/drawingml/2006/main">
+              <a:ext uri="{FF2B5EF4-FFF2-40B4-BE49-F238E27FC236}">
+                <a16:creationId xmlns:a16="http://schemas.microsoft.com/office/drawing/2014/main" id="{C27257B0-D38C-44BA-BFBC-4EBF115ABA38}"/>
+              </a:ext>
+            </a:extLst>
+          </p:cNvPr>
+          <p:cNvSpPr>
+            <a:spLocks xmlns:a="http://schemas.openxmlformats.org/drawingml/2006/main" noGrp="1"/>
+          </p:cNvSpPr>
+          <p:nvPr/>
+        </p:nvSpPr>
+        <p:spPr>
+          <a:xfrm xmlns:a="http://schemas.openxmlformats.org/drawingml/2006/main">
+            <a:off x="11334750" y="6381750"/>
+            <a:ext cx="457200" cy="228600"/>
+          </a:xfrm>
+          <a:prstGeom xmlns:a="http://schemas.openxmlformats.org/drawingml/2006/main" prst="rect">
+            <a:avLst/>
+          </a:prstGeom>
+          <a:noFill xmlns:a="http://schemas.openxmlformats.org/drawingml/2006/main"/>
+          <a:ln xmlns:a="http://schemas.openxmlformats.org/drawingml/2006/main" w="0">
+            <a:noFill/>
+            <a:prstDash val="solid"/>
+          </a:ln>
+        </p:spPr>
+        <p:txBody>
+          <a:bodyPr xmlns:a="http://schemas.openxmlformats.org/drawingml/2006/main" anchor="t"/>
+          <a:lstStyle xmlns:a="http://schemas.openxmlformats.org/drawingml/2006/main"/>
+          <a:p xmlns:a="http://schemas.openxmlformats.org/drawingml/2006/main">
+            <a:pPr algn="r">
+              <a:defRPr sz="975" b="0">
+                <a:solidFill>
+                  <a:srgbClr val="64748B"/>
+                </a:solidFill>
+              </a:defRPr>
+            </a:pPr>
+            <a:r>
+              <a:rPr sz="975" b="0">
+                <a:solidFill>
+                  <a:srgbClr val="64748B"/>
+                </a:solidFill>
+              </a:rPr>
+              <a:t>10</a:t>
+            </a:r>
+          </a:p>
+        </p:txBody>
+      </p:sp>
+    </p:spTree>
+    <p:extLst>
+      <p:ext uri="{BB962C8B-B14F-4D97-AF65-F5344CB8AC3E}">
+        <p14:creationId xmlns:p14="http://schemas.microsoft.com/office/powerpoint/2010/main" val="1440689964"/>
       </p:ext>
     </p:extLst>
   </p:cSld>
@@ -2573,7 +3913,7 @@
           <p:cNvPr id="14" name="">
             <a:extLst xmlns:a="http://schemas.openxmlformats.org/drawingml/2006/main">
               <a:ext uri="{FF2B5EF4-FFF2-40B4-BE49-F238E27FC236}">
-                <a16:creationId xmlns:a16="http://schemas.microsoft.com/office/drawing/2014/main" id="{6CB27B2F-8040-4F21-961B-9500B53F2B95}"/>
+                <a16:creationId xmlns:a16="http://schemas.microsoft.com/office/drawing/2014/main" id="{40984737-2804-4F5C-8D6F-A7130D683613}"/>
               </a:ext>
             </a:extLst>
           </p:cNvPr>
@@ -2623,7 +3963,7 @@
           <p:cNvPr id="2" name="">
             <a:extLst xmlns:a="http://schemas.openxmlformats.org/drawingml/2006/main">
               <a:ext uri="{FF2B5EF4-FFF2-40B4-BE49-F238E27FC236}">
-                <a16:creationId xmlns:a16="http://schemas.microsoft.com/office/drawing/2014/main" id="{8BE0CD20-7C43-4401-83DB-44D5D4436DE0}"/>
+                <a16:creationId xmlns:a16="http://schemas.microsoft.com/office/drawing/2014/main" id="{32A9F450-C1E6-45BF-A8A7-BDCCD8676BE5}"/>
               </a:ext>
             </a:extLst>
           </p:cNvPr>
@@ -2673,7 +4013,7 @@
           <p:cNvPr id="3" name="">
             <a:extLst xmlns:a="http://schemas.openxmlformats.org/drawingml/2006/main">
               <a:ext uri="{FF2B5EF4-FFF2-40B4-BE49-F238E27FC236}">
-                <a16:creationId xmlns:a16="http://schemas.microsoft.com/office/drawing/2014/main" id="{5D7E99B7-5D14-40BA-B62E-DBFA0442E552}"/>
+                <a16:creationId xmlns:a16="http://schemas.microsoft.com/office/drawing/2014/main" id="{94607A23-EA65-4AEB-A8CE-175850697BFC}"/>
               </a:ext>
             </a:extLst>
           </p:cNvPr>
@@ -2712,7 +4052,7 @@
           <p:nvPr/>
         </p:nvPicPr>
         <p:blipFill>
-          <a:blip xmlns:r="http://schemas.openxmlformats.org/officeDocument/2006/relationships" xmlns:a="http://schemas.openxmlformats.org/drawingml/2006/main" r:embed="Ra2a90ef8e5c54102"/>
+          <a:blip xmlns:r="http://schemas.openxmlformats.org/officeDocument/2006/relationships" xmlns:a="http://schemas.openxmlformats.org/drawingml/2006/main" r:embed="R2c43e457889e46f4"/>
           <a:stretch xmlns:a="http://schemas.openxmlformats.org/drawingml/2006/main"/>
         </p:blipFill>
         <p:spPr>
@@ -2730,7 +4070,7 @@
           <p:cNvPr id="5" name="">
             <a:extLst xmlns:a="http://schemas.openxmlformats.org/drawingml/2006/main">
               <a:ext uri="{FF2B5EF4-FFF2-40B4-BE49-F238E27FC236}">
-                <a16:creationId xmlns:a16="http://schemas.microsoft.com/office/drawing/2014/main" id="{E61BC007-10AA-43D8-B0C3-84D773F62802}"/>
+                <a16:creationId xmlns:a16="http://schemas.microsoft.com/office/drawing/2014/main" id="{BC4FC63D-821B-4768-B73E-C928C535061F}"/>
               </a:ext>
             </a:extLst>
           </p:cNvPr>
@@ -2765,7 +4105,7 @@
           <p:cNvPr id="6" name="">
             <a:extLst xmlns:a="http://schemas.openxmlformats.org/drawingml/2006/main">
               <a:ext uri="{FF2B5EF4-FFF2-40B4-BE49-F238E27FC236}">
-                <a16:creationId xmlns:a16="http://schemas.microsoft.com/office/drawing/2014/main" id="{9EF09307-6CAE-46ED-8EAB-C36C590D6288}"/>
+                <a16:creationId xmlns:a16="http://schemas.microsoft.com/office/drawing/2014/main" id="{88F344BF-32B1-4A1C-953F-BC26A485B69A}"/>
               </a:ext>
             </a:extLst>
           </p:cNvPr>
@@ -2815,7 +4155,7 @@
           <p:cNvPr id="7" name="">
             <a:extLst xmlns:a="http://schemas.openxmlformats.org/drawingml/2006/main">
               <a:ext uri="{FF2B5EF4-FFF2-40B4-BE49-F238E27FC236}">
-                <a16:creationId xmlns:a16="http://schemas.microsoft.com/office/drawing/2014/main" id="{AF787D38-6392-4A06-B3A9-6986C0CA2148}"/>
+                <a16:creationId xmlns:a16="http://schemas.microsoft.com/office/drawing/2014/main" id="{86232BA6-D3FD-4002-9D6D-BAC26115EEBC}"/>
               </a:ext>
             </a:extLst>
           </p:cNvPr>
@@ -2865,7 +4205,7 @@
           <p:cNvPr id="8" name="">
             <a:extLst xmlns:a="http://schemas.openxmlformats.org/drawingml/2006/main">
               <a:ext uri="{FF2B5EF4-FFF2-40B4-BE49-F238E27FC236}">
-                <a16:creationId xmlns:a16="http://schemas.microsoft.com/office/drawing/2014/main" id="{172D2B5F-C810-4BE6-AAAB-B8A6A26685E1}"/>
+                <a16:creationId xmlns:a16="http://schemas.microsoft.com/office/drawing/2014/main" id="{C2633EB5-5D84-4E1E-9618-24461180B6EC}"/>
               </a:ext>
             </a:extLst>
           </p:cNvPr>
@@ -2900,7 +4240,7 @@
           <p:cNvPr id="9" name="">
             <a:extLst xmlns:a="http://schemas.openxmlformats.org/drawingml/2006/main">
               <a:ext uri="{FF2B5EF4-FFF2-40B4-BE49-F238E27FC236}">
-                <a16:creationId xmlns:a16="http://schemas.microsoft.com/office/drawing/2014/main" id="{C65CEB16-2BB3-4C23-8421-2B780C439C1B}"/>
+                <a16:creationId xmlns:a16="http://schemas.microsoft.com/office/drawing/2014/main" id="{730A4D98-E39D-4326-A0FA-2C86AB217588}"/>
               </a:ext>
             </a:extLst>
           </p:cNvPr>
@@ -2950,7 +4290,7 @@
           <p:cNvPr id="10" name="">
             <a:extLst xmlns:a="http://schemas.openxmlformats.org/drawingml/2006/main">
               <a:ext uri="{FF2B5EF4-FFF2-40B4-BE49-F238E27FC236}">
-                <a16:creationId xmlns:a16="http://schemas.microsoft.com/office/drawing/2014/main" id="{14AEDEF9-1183-4714-A9B2-3AABCBFA1917}"/>
+                <a16:creationId xmlns:a16="http://schemas.microsoft.com/office/drawing/2014/main" id="{8983C995-92D5-4767-A959-047139EEEF91}"/>
               </a:ext>
             </a:extLst>
           </p:cNvPr>
@@ -3000,7 +4340,7 @@
           <p:cNvPr id="11" name="">
             <a:extLst xmlns:a="http://schemas.openxmlformats.org/drawingml/2006/main">
               <a:ext uri="{FF2B5EF4-FFF2-40B4-BE49-F238E27FC236}">
-                <a16:creationId xmlns:a16="http://schemas.microsoft.com/office/drawing/2014/main" id="{496224DD-FCCD-48FA-9429-08C67D7CE35C}"/>
+                <a16:creationId xmlns:a16="http://schemas.microsoft.com/office/drawing/2014/main" id="{C92AF838-1D9C-4F9B-BAE3-61D8D61A2277}"/>
               </a:ext>
             </a:extLst>
           </p:cNvPr>
@@ -3050,7 +4390,7 @@
           <p:cNvPr id="12" name="">
             <a:extLst xmlns:a="http://schemas.openxmlformats.org/drawingml/2006/main">
               <a:ext uri="{FF2B5EF4-FFF2-40B4-BE49-F238E27FC236}">
-                <a16:creationId xmlns:a16="http://schemas.microsoft.com/office/drawing/2014/main" id="{25605FB8-6F0B-4027-B004-B6FD775B0E51}"/>
+                <a16:creationId xmlns:a16="http://schemas.microsoft.com/office/drawing/2014/main" id="{A7AC3A2F-A592-4CFD-8AC0-F20D19046F98}"/>
               </a:ext>
             </a:extLst>
           </p:cNvPr>
@@ -3100,7 +4440,7 @@
           <p:cNvPr id="13" name="">
             <a:extLst xmlns:a="http://schemas.openxmlformats.org/drawingml/2006/main">
               <a:ext uri="{FF2B5EF4-FFF2-40B4-BE49-F238E27FC236}">
-                <a16:creationId xmlns:a16="http://schemas.microsoft.com/office/drawing/2014/main" id="{9AC283EB-EEDD-4D3A-B0E1-F25EF72181D8}"/>
+                <a16:creationId xmlns:a16="http://schemas.microsoft.com/office/drawing/2014/main" id="{14B51456-28B4-4C39-831B-70344476944E}"/>
               </a:ext>
             </a:extLst>
           </p:cNvPr>
@@ -3148,7 +4488,7 @@
     </p:spTree>
     <p:extLst>
       <p:ext uri="{BB962C8B-B14F-4D97-AF65-F5344CB8AC3E}">
-        <p14:creationId xmlns:p14="http://schemas.microsoft.com/office/powerpoint/2010/main" val="551079583"/>
+        <p14:creationId xmlns:p14="http://schemas.microsoft.com/office/powerpoint/2010/main" val="1622963902"/>
       </p:ext>
     </p:extLst>
   </p:cSld>
@@ -3179,7 +4519,7 @@
           <p:cNvPr id="44" name="">
             <a:extLst xmlns:a="http://schemas.openxmlformats.org/drawingml/2006/main">
               <a:ext uri="{FF2B5EF4-FFF2-40B4-BE49-F238E27FC236}">
-                <a16:creationId xmlns:a16="http://schemas.microsoft.com/office/drawing/2014/main" id="{B9938FF0-0F20-4264-B181-F91D0D45DB02}"/>
+                <a16:creationId xmlns:a16="http://schemas.microsoft.com/office/drawing/2014/main" id="{EF8665A4-8A1F-41A2-8AE9-EC5292A66A6A}"/>
               </a:ext>
             </a:extLst>
           </p:cNvPr>
@@ -3229,7 +4569,7 @@
           <p:cNvPr id="2" name="">
             <a:extLst xmlns:a="http://schemas.openxmlformats.org/drawingml/2006/main">
               <a:ext uri="{FF2B5EF4-FFF2-40B4-BE49-F238E27FC236}">
-                <a16:creationId xmlns:a16="http://schemas.microsoft.com/office/drawing/2014/main" id="{666A5885-EC20-4295-9E23-FEF1A9CA0F42}"/>
+                <a16:creationId xmlns:a16="http://schemas.microsoft.com/office/drawing/2014/main" id="{7B82B209-E4B7-40FF-9CD4-63C3561263E1}"/>
               </a:ext>
             </a:extLst>
           </p:cNvPr>
@@ -3279,7 +4619,7 @@
           <p:cNvPr id="3" name="">
             <a:extLst xmlns:a="http://schemas.openxmlformats.org/drawingml/2006/main">
               <a:ext uri="{FF2B5EF4-FFF2-40B4-BE49-F238E27FC236}">
-                <a16:creationId xmlns:a16="http://schemas.microsoft.com/office/drawing/2014/main" id="{4252BA33-7C75-49ED-B351-BE8DF49C4285}"/>
+                <a16:creationId xmlns:a16="http://schemas.microsoft.com/office/drawing/2014/main" id="{BD930137-9889-414B-91E6-1E211626CCC7}"/>
               </a:ext>
             </a:extLst>
           </p:cNvPr>
@@ -3314,7 +4654,7 @@
           <p:cNvPr id="4" name="">
             <a:extLst xmlns:a="http://schemas.openxmlformats.org/drawingml/2006/main">
               <a:ext uri="{FF2B5EF4-FFF2-40B4-BE49-F238E27FC236}">
-                <a16:creationId xmlns:a16="http://schemas.microsoft.com/office/drawing/2014/main" id="{F98EBC35-3657-49C3-9C36-97F46493A0EC}"/>
+                <a16:creationId xmlns:a16="http://schemas.microsoft.com/office/drawing/2014/main" id="{E246D9F4-D0A7-4F73-B492-1ECCF97C904B}"/>
               </a:ext>
             </a:extLst>
           </p:cNvPr>
@@ -3381,7 +4721,7 @@
           <p:cNvPr id="5" name="">
             <a:extLst xmlns:a="http://schemas.openxmlformats.org/drawingml/2006/main">
               <a:ext uri="{FF2B5EF4-FFF2-40B4-BE49-F238E27FC236}">
-                <a16:creationId xmlns:a16="http://schemas.microsoft.com/office/drawing/2014/main" id="{53865425-AED9-4487-8238-03D950554468}"/>
+                <a16:creationId xmlns:a16="http://schemas.microsoft.com/office/drawing/2014/main" id="{6E3711EA-FFD8-48C5-9751-1CED0C0FB15D}"/>
               </a:ext>
             </a:extLst>
           </p:cNvPr>
@@ -3431,7 +4771,7 @@
           <p:cNvPr id="6" name="">
             <a:extLst xmlns:a="http://schemas.openxmlformats.org/drawingml/2006/main">
               <a:ext uri="{FF2B5EF4-FFF2-40B4-BE49-F238E27FC236}">
-                <a16:creationId xmlns:a16="http://schemas.microsoft.com/office/drawing/2014/main" id="{EA3BAC1B-2E40-454A-BD72-11C078AF958F}"/>
+                <a16:creationId xmlns:a16="http://schemas.microsoft.com/office/drawing/2014/main" id="{900975EA-B461-4630-9A72-AE9AE1496D15}"/>
               </a:ext>
             </a:extLst>
           </p:cNvPr>
@@ -3466,7 +4806,7 @@
           <p:cNvPr id="7" name="">
             <a:extLst xmlns:a="http://schemas.openxmlformats.org/drawingml/2006/main">
               <a:ext uri="{FF2B5EF4-FFF2-40B4-BE49-F238E27FC236}">
-                <a16:creationId xmlns:a16="http://schemas.microsoft.com/office/drawing/2014/main" id="{ECBF0D6F-AF21-49EE-8EF6-1F7BA4930291}"/>
+                <a16:creationId xmlns:a16="http://schemas.microsoft.com/office/drawing/2014/main" id="{FF4C8B94-0EBF-4FF0-B484-8B95ABC1CC0B}"/>
               </a:ext>
             </a:extLst>
           </p:cNvPr>
@@ -3533,7 +4873,7 @@
           <p:cNvPr id="8" name="">
             <a:extLst xmlns:a="http://schemas.openxmlformats.org/drawingml/2006/main">
               <a:ext uri="{FF2B5EF4-FFF2-40B4-BE49-F238E27FC236}">
-                <a16:creationId xmlns:a16="http://schemas.microsoft.com/office/drawing/2014/main" id="{742E2C10-0F4A-44A4-9850-DBD332945658}"/>
+                <a16:creationId xmlns:a16="http://schemas.microsoft.com/office/drawing/2014/main" id="{1EEDF11C-A031-45D2-ACC8-2607C5DE64CA}"/>
               </a:ext>
             </a:extLst>
           </p:cNvPr>
@@ -3583,7 +4923,7 @@
           <p:cNvPr id="9" name="">
             <a:extLst xmlns:a="http://schemas.openxmlformats.org/drawingml/2006/main">
               <a:ext uri="{FF2B5EF4-FFF2-40B4-BE49-F238E27FC236}">
-                <a16:creationId xmlns:a16="http://schemas.microsoft.com/office/drawing/2014/main" id="{6165527A-BBB6-46A6-AC5B-04F1BA7C7596}"/>
+                <a16:creationId xmlns:a16="http://schemas.microsoft.com/office/drawing/2014/main" id="{C1F9E7C9-0395-4D86-920F-8620B1FDF7C6}"/>
               </a:ext>
             </a:extLst>
           </p:cNvPr>
@@ -3618,7 +4958,7 @@
           <p:cNvPr id="10" name="">
             <a:extLst xmlns:a="http://schemas.openxmlformats.org/drawingml/2006/main">
               <a:ext uri="{FF2B5EF4-FFF2-40B4-BE49-F238E27FC236}">
-                <a16:creationId xmlns:a16="http://schemas.microsoft.com/office/drawing/2014/main" id="{35A642AE-6B86-4F6F-8B07-248D65E71965}"/>
+                <a16:creationId xmlns:a16="http://schemas.microsoft.com/office/drawing/2014/main" id="{78A1FE14-F8B7-49C0-B887-94FC0661A57A}"/>
               </a:ext>
             </a:extLst>
           </p:cNvPr>
@@ -3685,7 +5025,7 @@
           <p:cNvPr id="11" name="">
             <a:extLst xmlns:a="http://schemas.openxmlformats.org/drawingml/2006/main">
               <a:ext uri="{FF2B5EF4-FFF2-40B4-BE49-F238E27FC236}">
-                <a16:creationId xmlns:a16="http://schemas.microsoft.com/office/drawing/2014/main" id="{A8BCA6D7-D66F-4A12-826F-826A5497A6F0}"/>
+                <a16:creationId xmlns:a16="http://schemas.microsoft.com/office/drawing/2014/main" id="{B44567CF-497A-4EDF-93E6-C5AA4D1C2644}"/>
               </a:ext>
             </a:extLst>
           </p:cNvPr>
@@ -3735,7 +5075,7 @@
           <p:cNvPr id="12" name="">
             <a:extLst xmlns:a="http://schemas.openxmlformats.org/drawingml/2006/main">
               <a:ext uri="{FF2B5EF4-FFF2-40B4-BE49-F238E27FC236}">
-                <a16:creationId xmlns:a16="http://schemas.microsoft.com/office/drawing/2014/main" id="{9BECE95C-3025-4C7E-B35C-C10B68456BFA}"/>
+                <a16:creationId xmlns:a16="http://schemas.microsoft.com/office/drawing/2014/main" id="{3430779C-1C67-4490-B52C-75BEBD409A0A}"/>
               </a:ext>
             </a:extLst>
           </p:cNvPr>
@@ -3770,7 +5110,7 @@
           <p:cNvPr id="13" name="">
             <a:extLst xmlns:a="http://schemas.openxmlformats.org/drawingml/2006/main">
               <a:ext uri="{FF2B5EF4-FFF2-40B4-BE49-F238E27FC236}">
-                <a16:creationId xmlns:a16="http://schemas.microsoft.com/office/drawing/2014/main" id="{CCD669CF-D297-4A20-886F-683876E48792}"/>
+                <a16:creationId xmlns:a16="http://schemas.microsoft.com/office/drawing/2014/main" id="{846109AE-6081-46C1-8FD7-26D91229852B}"/>
               </a:ext>
             </a:extLst>
           </p:cNvPr>
@@ -3837,7 +5177,7 @@
           <p:cNvPr id="14" name="">
             <a:extLst xmlns:a="http://schemas.openxmlformats.org/drawingml/2006/main">
               <a:ext uri="{FF2B5EF4-FFF2-40B4-BE49-F238E27FC236}">
-                <a16:creationId xmlns:a16="http://schemas.microsoft.com/office/drawing/2014/main" id="{E5834862-26C5-4D5C-8088-D96A016D2ED4}"/>
+                <a16:creationId xmlns:a16="http://schemas.microsoft.com/office/drawing/2014/main" id="{9709B589-91E4-4CF5-B385-D7B1C00E1EA7}"/>
               </a:ext>
             </a:extLst>
           </p:cNvPr>
@@ -3887,7 +5227,7 @@
           <p:cNvPr id="15" name="">
             <a:extLst xmlns:a="http://schemas.openxmlformats.org/drawingml/2006/main">
               <a:ext uri="{FF2B5EF4-FFF2-40B4-BE49-F238E27FC236}">
-                <a16:creationId xmlns:a16="http://schemas.microsoft.com/office/drawing/2014/main" id="{88269B3C-EAA4-43B1-BC45-15875BF50027}"/>
+                <a16:creationId xmlns:a16="http://schemas.microsoft.com/office/drawing/2014/main" id="{AADC263F-24E2-464C-B234-077FED9BF253}"/>
               </a:ext>
             </a:extLst>
           </p:cNvPr>
@@ -3922,7 +5262,7 @@
           <p:cNvPr id="16" name="">
             <a:extLst xmlns:a="http://schemas.openxmlformats.org/drawingml/2006/main">
               <a:ext uri="{FF2B5EF4-FFF2-40B4-BE49-F238E27FC236}">
-                <a16:creationId xmlns:a16="http://schemas.microsoft.com/office/drawing/2014/main" id="{FE135ED4-EB5D-4FE4-B6FD-1D1456301317}"/>
+                <a16:creationId xmlns:a16="http://schemas.microsoft.com/office/drawing/2014/main" id="{F5A42442-B4F0-4A4A-BD67-AAF55CF9D5FC}"/>
               </a:ext>
             </a:extLst>
           </p:cNvPr>
@@ -3989,7 +5329,7 @@
           <p:cNvPr id="17" name="">
             <a:extLst xmlns:a="http://schemas.openxmlformats.org/drawingml/2006/main">
               <a:ext uri="{FF2B5EF4-FFF2-40B4-BE49-F238E27FC236}">
-                <a16:creationId xmlns:a16="http://schemas.microsoft.com/office/drawing/2014/main" id="{889DEB2C-E9D9-4E64-99A4-42CF436C86A9}"/>
+                <a16:creationId xmlns:a16="http://schemas.microsoft.com/office/drawing/2014/main" id="{12823D04-8CB7-4E4B-AE74-F2EF4526E5F0}"/>
               </a:ext>
             </a:extLst>
           </p:cNvPr>
@@ -4024,7 +5364,7 @@
           <p:cNvPr id="18" name="">
             <a:extLst xmlns:a="http://schemas.openxmlformats.org/drawingml/2006/main">
               <a:ext uri="{FF2B5EF4-FFF2-40B4-BE49-F238E27FC236}">
-                <a16:creationId xmlns:a16="http://schemas.microsoft.com/office/drawing/2014/main" id="{1065E258-09D9-47CE-A725-714AD2958B02}"/>
+                <a16:creationId xmlns:a16="http://schemas.microsoft.com/office/drawing/2014/main" id="{00D85002-2124-4B6E-8EF2-68436AAF3913}"/>
               </a:ext>
             </a:extLst>
           </p:cNvPr>
@@ -4074,7 +5414,7 @@
           <p:cNvPr id="19" name="">
             <a:extLst xmlns:a="http://schemas.openxmlformats.org/drawingml/2006/main">
               <a:ext uri="{FF2B5EF4-FFF2-40B4-BE49-F238E27FC236}">
-                <a16:creationId xmlns:a16="http://schemas.microsoft.com/office/drawing/2014/main" id="{8538A6C4-9B9D-43E4-B569-5B697E9A7D67}"/>
+                <a16:creationId xmlns:a16="http://schemas.microsoft.com/office/drawing/2014/main" id="{4EDB3108-7301-4BD0-898B-6937C4F36EC8}"/>
               </a:ext>
             </a:extLst>
           </p:cNvPr>
@@ -4124,7 +5464,7 @@
           <p:cNvPr id="20" name="">
             <a:extLst xmlns:a="http://schemas.openxmlformats.org/drawingml/2006/main">
               <a:ext uri="{FF2B5EF4-FFF2-40B4-BE49-F238E27FC236}">
-                <a16:creationId xmlns:a16="http://schemas.microsoft.com/office/drawing/2014/main" id="{61F94492-CC60-4B04-A783-33590DF5C96B}"/>
+                <a16:creationId xmlns:a16="http://schemas.microsoft.com/office/drawing/2014/main" id="{90DB8BA5-0C06-4EAE-80E9-BCB86D1CF17D}"/>
               </a:ext>
             </a:extLst>
           </p:cNvPr>
@@ -4159,7 +5499,7 @@
           <p:cNvPr id="21" name="">
             <a:extLst xmlns:a="http://schemas.openxmlformats.org/drawingml/2006/main">
               <a:ext uri="{FF2B5EF4-FFF2-40B4-BE49-F238E27FC236}">
-                <a16:creationId xmlns:a16="http://schemas.microsoft.com/office/drawing/2014/main" id="{54CE13CA-14BD-4ECB-A21B-BDD93603921A}"/>
+                <a16:creationId xmlns:a16="http://schemas.microsoft.com/office/drawing/2014/main" id="{93126720-994B-4833-AD4C-B49CE7294532}"/>
               </a:ext>
             </a:extLst>
           </p:cNvPr>
@@ -4209,7 +5549,7 @@
           <p:cNvPr id="22" name="">
             <a:extLst xmlns:a="http://schemas.openxmlformats.org/drawingml/2006/main">
               <a:ext uri="{FF2B5EF4-FFF2-40B4-BE49-F238E27FC236}">
-                <a16:creationId xmlns:a16="http://schemas.microsoft.com/office/drawing/2014/main" id="{6DC72D05-0552-45D2-8F90-69F7D878CFFC}"/>
+                <a16:creationId xmlns:a16="http://schemas.microsoft.com/office/drawing/2014/main" id="{A4203075-2C51-4A56-A279-C95B3C391611}"/>
               </a:ext>
             </a:extLst>
           </p:cNvPr>
@@ -4259,7 +5599,7 @@
           <p:cNvPr id="23" name="">
             <a:extLst xmlns:a="http://schemas.openxmlformats.org/drawingml/2006/main">
               <a:ext uri="{FF2B5EF4-FFF2-40B4-BE49-F238E27FC236}">
-                <a16:creationId xmlns:a16="http://schemas.microsoft.com/office/drawing/2014/main" id="{22F17FD1-088C-4ED1-B362-98C026E35639}"/>
+                <a16:creationId xmlns:a16="http://schemas.microsoft.com/office/drawing/2014/main" id="{990C3556-84E9-4869-8D49-C5E2A012D714}"/>
               </a:ext>
             </a:extLst>
           </p:cNvPr>
@@ -4294,7 +5634,7 @@
           <p:cNvPr id="24" name="">
             <a:extLst xmlns:a="http://schemas.openxmlformats.org/drawingml/2006/main">
               <a:ext uri="{FF2B5EF4-FFF2-40B4-BE49-F238E27FC236}">
-                <a16:creationId xmlns:a16="http://schemas.microsoft.com/office/drawing/2014/main" id="{FDD4CA0F-6156-469D-ACF1-5D1403B11CA8}"/>
+                <a16:creationId xmlns:a16="http://schemas.microsoft.com/office/drawing/2014/main" id="{909045E5-36D8-48AD-9C16-A6D656926AF5}"/>
               </a:ext>
             </a:extLst>
           </p:cNvPr>
@@ -4344,7 +5684,7 @@
           <p:cNvPr id="25" name="">
             <a:extLst xmlns:a="http://schemas.openxmlformats.org/drawingml/2006/main">
               <a:ext uri="{FF2B5EF4-FFF2-40B4-BE49-F238E27FC236}">
-                <a16:creationId xmlns:a16="http://schemas.microsoft.com/office/drawing/2014/main" id="{A2DC7A80-EAC3-4C1C-AA0B-D48325846CC8}"/>
+                <a16:creationId xmlns:a16="http://schemas.microsoft.com/office/drawing/2014/main" id="{0095C367-5847-4C83-9DA5-AD89BDC40112}"/>
               </a:ext>
             </a:extLst>
           </p:cNvPr>
@@ -4394,7 +5734,7 @@
           <p:cNvPr id="26" name="">
             <a:extLst xmlns:a="http://schemas.openxmlformats.org/drawingml/2006/main">
               <a:ext uri="{FF2B5EF4-FFF2-40B4-BE49-F238E27FC236}">
-                <a16:creationId xmlns:a16="http://schemas.microsoft.com/office/drawing/2014/main" id="{ADFFCE07-20A1-486F-BA59-05E53EC68E06}"/>
+                <a16:creationId xmlns:a16="http://schemas.microsoft.com/office/drawing/2014/main" id="{84784A40-F4E0-45EA-9798-9D69442DE958}"/>
               </a:ext>
             </a:extLst>
           </p:cNvPr>
@@ -4429,7 +5769,7 @@
           <p:cNvPr id="27" name="">
             <a:extLst xmlns:a="http://schemas.openxmlformats.org/drawingml/2006/main">
               <a:ext uri="{FF2B5EF4-FFF2-40B4-BE49-F238E27FC236}">
-                <a16:creationId xmlns:a16="http://schemas.microsoft.com/office/drawing/2014/main" id="{6D8C4E72-9451-447F-B294-9B40C02B25ED}"/>
+                <a16:creationId xmlns:a16="http://schemas.microsoft.com/office/drawing/2014/main" id="{153618BF-A8C1-4470-B4C0-E35D77B48A38}"/>
               </a:ext>
             </a:extLst>
           </p:cNvPr>
@@ -4479,7 +5819,7 @@
           <p:cNvPr id="28" name="">
             <a:extLst xmlns:a="http://schemas.openxmlformats.org/drawingml/2006/main">
               <a:ext uri="{FF2B5EF4-FFF2-40B4-BE49-F238E27FC236}">
-                <a16:creationId xmlns:a16="http://schemas.microsoft.com/office/drawing/2014/main" id="{405CA7D9-D69B-46F2-BFCF-88D57F1575A5}"/>
+                <a16:creationId xmlns:a16="http://schemas.microsoft.com/office/drawing/2014/main" id="{64BE7D69-4ABE-4791-8FD4-1DD66DD145B9}"/>
               </a:ext>
             </a:extLst>
           </p:cNvPr>
@@ -4529,7 +5869,7 @@
           <p:cNvPr id="29" name="">
             <a:extLst xmlns:a="http://schemas.openxmlformats.org/drawingml/2006/main">
               <a:ext uri="{FF2B5EF4-FFF2-40B4-BE49-F238E27FC236}">
-                <a16:creationId xmlns:a16="http://schemas.microsoft.com/office/drawing/2014/main" id="{41B97843-2DF7-4B6A-81F7-FAC3AC9540AA}"/>
+                <a16:creationId xmlns:a16="http://schemas.microsoft.com/office/drawing/2014/main" id="{8461D877-27C7-4781-BCBE-4ADA4A1E043A}"/>
               </a:ext>
             </a:extLst>
           </p:cNvPr>
@@ -4564,7 +5904,7 @@
           <p:cNvPr id="30" name="">
             <a:extLst xmlns:a="http://schemas.openxmlformats.org/drawingml/2006/main">
               <a:ext uri="{FF2B5EF4-FFF2-40B4-BE49-F238E27FC236}">
-                <a16:creationId xmlns:a16="http://schemas.microsoft.com/office/drawing/2014/main" id="{CC4BEF0F-D456-49B7-A2E6-4623A8C42998}"/>
+                <a16:creationId xmlns:a16="http://schemas.microsoft.com/office/drawing/2014/main" id="{390BF2CA-CFD9-4E5B-BDD6-95EC93F4E775}"/>
               </a:ext>
             </a:extLst>
           </p:cNvPr>
@@ -4614,7 +5954,7 @@
           <p:cNvPr id="31" name="">
             <a:extLst xmlns:a="http://schemas.openxmlformats.org/drawingml/2006/main">
               <a:ext uri="{FF2B5EF4-FFF2-40B4-BE49-F238E27FC236}">
-                <a16:creationId xmlns:a16="http://schemas.microsoft.com/office/drawing/2014/main" id="{A9754C85-FC10-4202-8CB1-A3E616119D44}"/>
+                <a16:creationId xmlns:a16="http://schemas.microsoft.com/office/drawing/2014/main" id="{2C47FED7-0FDA-40A5-968C-EF3524EE82BA}"/>
               </a:ext>
             </a:extLst>
           </p:cNvPr>
@@ -4664,7 +6004,7 @@
           <p:cNvPr id="32" name="">
             <a:extLst xmlns:a="http://schemas.openxmlformats.org/drawingml/2006/main">
               <a:ext uri="{FF2B5EF4-FFF2-40B4-BE49-F238E27FC236}">
-                <a16:creationId xmlns:a16="http://schemas.microsoft.com/office/drawing/2014/main" id="{A7F17BEC-E133-4646-95E0-0FCF8C2E7BAB}"/>
+                <a16:creationId xmlns:a16="http://schemas.microsoft.com/office/drawing/2014/main" id="{A0AE2487-355F-48ED-A54D-E6A9FB5ACC81}"/>
               </a:ext>
             </a:extLst>
           </p:cNvPr>
@@ -4699,7 +6039,7 @@
           <p:cNvPr id="33" name="">
             <a:extLst xmlns:a="http://schemas.openxmlformats.org/drawingml/2006/main">
               <a:ext uri="{FF2B5EF4-FFF2-40B4-BE49-F238E27FC236}">
-                <a16:creationId xmlns:a16="http://schemas.microsoft.com/office/drawing/2014/main" id="{350AD7A1-E70A-4B76-AE21-C3E1F6FD0BB1}"/>
+                <a16:creationId xmlns:a16="http://schemas.microsoft.com/office/drawing/2014/main" id="{F5FA3C2F-C829-4FCC-AE42-F29B1F3F4DA1}"/>
               </a:ext>
             </a:extLst>
           </p:cNvPr>
@@ -4749,7 +6089,7 @@
           <p:cNvPr id="34" name="">
             <a:extLst xmlns:a="http://schemas.openxmlformats.org/drawingml/2006/main">
               <a:ext uri="{FF2B5EF4-FFF2-40B4-BE49-F238E27FC236}">
-                <a16:creationId xmlns:a16="http://schemas.microsoft.com/office/drawing/2014/main" id="{244897F8-B1A4-41EA-8E6A-4451749CF97D}"/>
+                <a16:creationId xmlns:a16="http://schemas.microsoft.com/office/drawing/2014/main" id="{BB79FE45-059B-484B-B137-70F66B196C78}"/>
               </a:ext>
             </a:extLst>
           </p:cNvPr>
@@ -4799,7 +6139,7 @@
           <p:cNvPr id="35" name="">
             <a:extLst xmlns:a="http://schemas.openxmlformats.org/drawingml/2006/main">
               <a:ext uri="{FF2B5EF4-FFF2-40B4-BE49-F238E27FC236}">
-                <a16:creationId xmlns:a16="http://schemas.microsoft.com/office/drawing/2014/main" id="{5EFD6AC4-1235-417C-BAE7-66AFB43CCD03}"/>
+                <a16:creationId xmlns:a16="http://schemas.microsoft.com/office/drawing/2014/main" id="{636673F7-669C-486E-980D-7B0CD1989B59}"/>
               </a:ext>
             </a:extLst>
           </p:cNvPr>
@@ -4834,7 +6174,7 @@
           <p:cNvPr id="36" name="">
             <a:extLst xmlns:a="http://schemas.openxmlformats.org/drawingml/2006/main">
               <a:ext uri="{FF2B5EF4-FFF2-40B4-BE49-F238E27FC236}">
-                <a16:creationId xmlns:a16="http://schemas.microsoft.com/office/drawing/2014/main" id="{BE96BD14-DB99-4797-8699-56A7AB8440F0}"/>
+                <a16:creationId xmlns:a16="http://schemas.microsoft.com/office/drawing/2014/main" id="{1C90BBA7-C151-4B66-BDF1-DEFEEEA1C979}"/>
               </a:ext>
             </a:extLst>
           </p:cNvPr>
@@ -4884,7 +6224,7 @@
           <p:cNvPr id="37" name="">
             <a:extLst xmlns:a="http://schemas.openxmlformats.org/drawingml/2006/main">
               <a:ext uri="{FF2B5EF4-FFF2-40B4-BE49-F238E27FC236}">
-                <a16:creationId xmlns:a16="http://schemas.microsoft.com/office/drawing/2014/main" id="{E9E2EE5B-A33F-4D85-AF12-9285EF750602}"/>
+                <a16:creationId xmlns:a16="http://schemas.microsoft.com/office/drawing/2014/main" id="{53D36C85-6A9E-4ECC-BF4B-1159DEF7EB4F}"/>
               </a:ext>
             </a:extLst>
           </p:cNvPr>
@@ -4934,7 +6274,7 @@
           <p:cNvPr id="38" name="">
             <a:extLst xmlns:a="http://schemas.openxmlformats.org/drawingml/2006/main">
               <a:ext uri="{FF2B5EF4-FFF2-40B4-BE49-F238E27FC236}">
-                <a16:creationId xmlns:a16="http://schemas.microsoft.com/office/drawing/2014/main" id="{5CA26C4B-0846-4464-B08F-0938C1540D2D}"/>
+                <a16:creationId xmlns:a16="http://schemas.microsoft.com/office/drawing/2014/main" id="{4CBEAFFA-FD18-4F02-9BE7-3023F7A40D12}"/>
               </a:ext>
             </a:extLst>
           </p:cNvPr>
@@ -4969,7 +6309,7 @@
           <p:cNvPr id="39" name="">
             <a:extLst xmlns:a="http://schemas.openxmlformats.org/drawingml/2006/main">
               <a:ext uri="{FF2B5EF4-FFF2-40B4-BE49-F238E27FC236}">
-                <a16:creationId xmlns:a16="http://schemas.microsoft.com/office/drawing/2014/main" id="{A7DBFD87-09A0-47C7-8F31-7F56059BE18C}"/>
+                <a16:creationId xmlns:a16="http://schemas.microsoft.com/office/drawing/2014/main" id="{BDB9E5F6-1B47-4019-BDB0-E665E50694F7}"/>
               </a:ext>
             </a:extLst>
           </p:cNvPr>
@@ -5019,7 +6359,7 @@
           <p:cNvPr id="40" name="">
             <a:extLst xmlns:a="http://schemas.openxmlformats.org/drawingml/2006/main">
               <a:ext uri="{FF2B5EF4-FFF2-40B4-BE49-F238E27FC236}">
-                <a16:creationId xmlns:a16="http://schemas.microsoft.com/office/drawing/2014/main" id="{0FB1D28C-C353-4897-8692-216DEFFBE27C}"/>
+                <a16:creationId xmlns:a16="http://schemas.microsoft.com/office/drawing/2014/main" id="{BCD4693D-0B85-4852-9AE1-67100EC38E13}"/>
               </a:ext>
             </a:extLst>
           </p:cNvPr>
@@ -5069,7 +6409,7 @@
           <p:cNvPr id="41" name="">
             <a:extLst xmlns:a="http://schemas.openxmlformats.org/drawingml/2006/main">
               <a:ext uri="{FF2B5EF4-FFF2-40B4-BE49-F238E27FC236}">
-                <a16:creationId xmlns:a16="http://schemas.microsoft.com/office/drawing/2014/main" id="{B37AB779-6B5A-414A-9739-A84555C867D9}"/>
+                <a16:creationId xmlns:a16="http://schemas.microsoft.com/office/drawing/2014/main" id="{9D64CF76-FB15-4EC6-ADE6-D3C57FCB8512}"/>
               </a:ext>
             </a:extLst>
           </p:cNvPr>
@@ -5119,7 +6459,7 @@
           <p:cNvPr id="42" name="">
             <a:extLst xmlns:a="http://schemas.openxmlformats.org/drawingml/2006/main">
               <a:ext uri="{FF2B5EF4-FFF2-40B4-BE49-F238E27FC236}">
-                <a16:creationId xmlns:a16="http://schemas.microsoft.com/office/drawing/2014/main" id="{8016548A-B701-4197-843A-DDA7EA877897}"/>
+                <a16:creationId xmlns:a16="http://schemas.microsoft.com/office/drawing/2014/main" id="{F83092EF-C7D1-4DD4-AD04-403C45AF8AD3}"/>
               </a:ext>
             </a:extLst>
           </p:cNvPr>
@@ -5169,7 +6509,7 @@
           <p:cNvPr id="43" name="">
             <a:extLst xmlns:a="http://schemas.openxmlformats.org/drawingml/2006/main">
               <a:ext uri="{FF2B5EF4-FFF2-40B4-BE49-F238E27FC236}">
-                <a16:creationId xmlns:a16="http://schemas.microsoft.com/office/drawing/2014/main" id="{A8C76464-C988-4F8A-896B-8D2BD05EDF8E}"/>
+                <a16:creationId xmlns:a16="http://schemas.microsoft.com/office/drawing/2014/main" id="{72C50B5B-5D46-424D-9DCB-1041EC5CE587}"/>
               </a:ext>
             </a:extLst>
           </p:cNvPr>
@@ -5217,7 +6557,7 @@
     </p:spTree>
     <p:extLst>
       <p:ext uri="{BB962C8B-B14F-4D97-AF65-F5344CB8AC3E}">
-        <p14:creationId xmlns:p14="http://schemas.microsoft.com/office/powerpoint/2010/main" val="369989740"/>
+        <p14:creationId xmlns:p14="http://schemas.microsoft.com/office/powerpoint/2010/main" val="191738990"/>
       </p:ext>
     </p:extLst>
   </p:cSld>
@@ -5248,7 +6588,7 @@
           <p:cNvPr id="26" name="">
             <a:extLst xmlns:a="http://schemas.openxmlformats.org/drawingml/2006/main">
               <a:ext uri="{FF2B5EF4-FFF2-40B4-BE49-F238E27FC236}">
-                <a16:creationId xmlns:a16="http://schemas.microsoft.com/office/drawing/2014/main" id="{646684DD-B17D-41CA-9CEE-147E4AFC5947}"/>
+                <a16:creationId xmlns:a16="http://schemas.microsoft.com/office/drawing/2014/main" id="{FC9904DF-E872-4045-A561-59C33C009C8B}"/>
               </a:ext>
             </a:extLst>
           </p:cNvPr>
@@ -5298,7 +6638,7 @@
           <p:cNvPr id="2" name="">
             <a:extLst xmlns:a="http://schemas.openxmlformats.org/drawingml/2006/main">
               <a:ext uri="{FF2B5EF4-FFF2-40B4-BE49-F238E27FC236}">
-                <a16:creationId xmlns:a16="http://schemas.microsoft.com/office/drawing/2014/main" id="{7BE35B10-839A-44A6-A08D-9B594F750766}"/>
+                <a16:creationId xmlns:a16="http://schemas.microsoft.com/office/drawing/2014/main" id="{A56AB9AC-A3CB-4B18-BED9-CD9E80758276}"/>
               </a:ext>
             </a:extLst>
           </p:cNvPr>
@@ -5348,7 +6688,7 @@
           <p:cNvPr id="3" name="">
             <a:extLst xmlns:a="http://schemas.openxmlformats.org/drawingml/2006/main">
               <a:ext uri="{FF2B5EF4-FFF2-40B4-BE49-F238E27FC236}">
-                <a16:creationId xmlns:a16="http://schemas.microsoft.com/office/drawing/2014/main" id="{5BF69A02-3270-49F6-A368-B524D41D2AE5}"/>
+                <a16:creationId xmlns:a16="http://schemas.microsoft.com/office/drawing/2014/main" id="{5F4B55C9-65DA-4685-81A3-C27CDBD432C2}"/>
               </a:ext>
             </a:extLst>
           </p:cNvPr>
@@ -5383,7 +6723,7 @@
           <p:cNvPr id="4" name="">
             <a:extLst xmlns:a="http://schemas.openxmlformats.org/drawingml/2006/main">
               <a:ext uri="{FF2B5EF4-FFF2-40B4-BE49-F238E27FC236}">
-                <a16:creationId xmlns:a16="http://schemas.microsoft.com/office/drawing/2014/main" id="{542E02A1-093E-48E7-BEAC-31C429AB4169}"/>
+                <a16:creationId xmlns:a16="http://schemas.microsoft.com/office/drawing/2014/main" id="{93F0BB8C-C628-4F65-BE8F-1889250FF303}"/>
               </a:ext>
             </a:extLst>
           </p:cNvPr>
@@ -5433,7 +6773,7 @@
           <p:cNvPr id="5" name="">
             <a:extLst xmlns:a="http://schemas.openxmlformats.org/drawingml/2006/main">
               <a:ext uri="{FF2B5EF4-FFF2-40B4-BE49-F238E27FC236}">
-                <a16:creationId xmlns:a16="http://schemas.microsoft.com/office/drawing/2014/main" id="{D88B9067-A442-45ED-8A5E-5161725FA48C}"/>
+                <a16:creationId xmlns:a16="http://schemas.microsoft.com/office/drawing/2014/main" id="{0F6329F6-D543-4769-ACD9-8F3B99378530}"/>
               </a:ext>
             </a:extLst>
           </p:cNvPr>
@@ -5464,7 +6804,7 @@
           <p:cNvPr id="6" name="">
             <a:extLst xmlns:a="http://schemas.openxmlformats.org/drawingml/2006/main">
               <a:ext uri="{FF2B5EF4-FFF2-40B4-BE49-F238E27FC236}">
-                <a16:creationId xmlns:a16="http://schemas.microsoft.com/office/drawing/2014/main" id="{4C1E20FB-7845-41CC-9EE4-5546E377A9D1}"/>
+                <a16:creationId xmlns:a16="http://schemas.microsoft.com/office/drawing/2014/main" id="{8E8AC30A-8C12-4000-AB09-1C85346A041F}"/>
               </a:ext>
             </a:extLst>
           </p:cNvPr>
@@ -5514,7 +6854,7 @@
           <p:cNvPr id="7" name="">
             <a:extLst xmlns:a="http://schemas.openxmlformats.org/drawingml/2006/main">
               <a:ext uri="{FF2B5EF4-FFF2-40B4-BE49-F238E27FC236}">
-                <a16:creationId xmlns:a16="http://schemas.microsoft.com/office/drawing/2014/main" id="{581C252A-5319-4380-9B1F-2D482582AFC8}"/>
+                <a16:creationId xmlns:a16="http://schemas.microsoft.com/office/drawing/2014/main" id="{D540C6D3-4E7B-4110-86F9-DDF2E685B486}"/>
               </a:ext>
             </a:extLst>
           </p:cNvPr>
@@ -5545,7 +6885,7 @@
           <p:cNvPr id="8" name="">
             <a:extLst xmlns:a="http://schemas.openxmlformats.org/drawingml/2006/main">
               <a:ext uri="{FF2B5EF4-FFF2-40B4-BE49-F238E27FC236}">
-                <a16:creationId xmlns:a16="http://schemas.microsoft.com/office/drawing/2014/main" id="{2CFE2979-5975-4A8C-9CB2-D5DD59DFA1B0}"/>
+                <a16:creationId xmlns:a16="http://schemas.microsoft.com/office/drawing/2014/main" id="{C4D255D1-B9FB-4A5C-A046-259AF007BC25}"/>
               </a:ext>
             </a:extLst>
           </p:cNvPr>
@@ -5595,7 +6935,7 @@
           <p:cNvPr id="9" name="">
             <a:extLst xmlns:a="http://schemas.openxmlformats.org/drawingml/2006/main">
               <a:ext uri="{FF2B5EF4-FFF2-40B4-BE49-F238E27FC236}">
-                <a16:creationId xmlns:a16="http://schemas.microsoft.com/office/drawing/2014/main" id="{7B73D51C-CF48-458C-B7DC-949B7D9561C9}"/>
+                <a16:creationId xmlns:a16="http://schemas.microsoft.com/office/drawing/2014/main" id="{EE07DE1B-FD83-472C-9C54-7BFD8C2A2AE5}"/>
               </a:ext>
             </a:extLst>
           </p:cNvPr>
@@ -5626,7 +6966,7 @@
           <p:cNvPr id="10" name="">
             <a:extLst xmlns:a="http://schemas.openxmlformats.org/drawingml/2006/main">
               <a:ext uri="{FF2B5EF4-FFF2-40B4-BE49-F238E27FC236}">
-                <a16:creationId xmlns:a16="http://schemas.microsoft.com/office/drawing/2014/main" id="{6A7DF84F-942B-418C-986F-9879EF4E77FF}"/>
+                <a16:creationId xmlns:a16="http://schemas.microsoft.com/office/drawing/2014/main" id="{65864CE6-4F40-4B3B-9DCF-1989D3A55C2F}"/>
               </a:ext>
             </a:extLst>
           </p:cNvPr>
@@ -5676,7 +7016,7 @@
           <p:cNvPr id="11" name="">
             <a:extLst xmlns:a="http://schemas.openxmlformats.org/drawingml/2006/main">
               <a:ext uri="{FF2B5EF4-FFF2-40B4-BE49-F238E27FC236}">
-                <a16:creationId xmlns:a16="http://schemas.microsoft.com/office/drawing/2014/main" id="{1745A46A-0A53-4DCE-B958-E756CACE0B8B}"/>
+                <a16:creationId xmlns:a16="http://schemas.microsoft.com/office/drawing/2014/main" id="{A2A5A1B3-EF58-427A-A302-7488677A4CAC}"/>
               </a:ext>
             </a:extLst>
           </p:cNvPr>
@@ -5707,7 +7047,7 @@
           <p:cNvPr id="12" name="">
             <a:extLst xmlns:a="http://schemas.openxmlformats.org/drawingml/2006/main">
               <a:ext uri="{FF2B5EF4-FFF2-40B4-BE49-F238E27FC236}">
-                <a16:creationId xmlns:a16="http://schemas.microsoft.com/office/drawing/2014/main" id="{749C45ED-8CD3-4BAD-A51B-575D7C6D6711}"/>
+                <a16:creationId xmlns:a16="http://schemas.microsoft.com/office/drawing/2014/main" id="{0BDF1B09-1858-46A3-91CC-0696BDFDAD35}"/>
               </a:ext>
             </a:extLst>
           </p:cNvPr>
@@ -5757,7 +7097,7 @@
           <p:cNvPr id="13" name="">
             <a:extLst xmlns:a="http://schemas.openxmlformats.org/drawingml/2006/main">
               <a:ext uri="{FF2B5EF4-FFF2-40B4-BE49-F238E27FC236}">
-                <a16:creationId xmlns:a16="http://schemas.microsoft.com/office/drawing/2014/main" id="{64C7BEE5-73CD-45C1-A81A-8A3306B89692}"/>
+                <a16:creationId xmlns:a16="http://schemas.microsoft.com/office/drawing/2014/main" id="{EA0F9C3A-4953-4E69-839E-61F413213550}"/>
               </a:ext>
             </a:extLst>
           </p:cNvPr>
@@ -5807,7 +7147,7 @@
           <p:cNvPr id="14" name="">
             <a:extLst xmlns:a="http://schemas.openxmlformats.org/drawingml/2006/main">
               <a:ext uri="{FF2B5EF4-FFF2-40B4-BE49-F238E27FC236}">
-                <a16:creationId xmlns:a16="http://schemas.microsoft.com/office/drawing/2014/main" id="{EFEA93E8-754D-4930-A8F3-C17E32EC60C4}"/>
+                <a16:creationId xmlns:a16="http://schemas.microsoft.com/office/drawing/2014/main" id="{6DE10328-14AA-45F7-93F6-C7C579DD01CF}"/>
               </a:ext>
             </a:extLst>
           </p:cNvPr>
@@ -5842,7 +7182,7 @@
           <p:cNvPr id="15" name="">
             <a:extLst xmlns:a="http://schemas.openxmlformats.org/drawingml/2006/main">
               <a:ext uri="{FF2B5EF4-FFF2-40B4-BE49-F238E27FC236}">
-                <a16:creationId xmlns:a16="http://schemas.microsoft.com/office/drawing/2014/main" id="{3479463A-7096-480C-9D12-86C556D54384}"/>
+                <a16:creationId xmlns:a16="http://schemas.microsoft.com/office/drawing/2014/main" id="{85664607-2746-401F-9495-DF7B130A9A9B}"/>
               </a:ext>
             </a:extLst>
           </p:cNvPr>
@@ -5892,7 +7232,7 @@
           <p:cNvPr id="16" name="">
             <a:extLst xmlns:a="http://schemas.openxmlformats.org/drawingml/2006/main">
               <a:ext uri="{FF2B5EF4-FFF2-40B4-BE49-F238E27FC236}">
-                <a16:creationId xmlns:a16="http://schemas.microsoft.com/office/drawing/2014/main" id="{CB536808-FA20-492D-9F4A-6D6DFE2AB68A}"/>
+                <a16:creationId xmlns:a16="http://schemas.microsoft.com/office/drawing/2014/main" id="{B175B546-3EB1-47C9-9BE3-6ACB71470822}"/>
               </a:ext>
             </a:extLst>
           </p:cNvPr>
@@ -5923,7 +7263,7 @@
           <p:cNvPr id="17" name="">
             <a:extLst xmlns:a="http://schemas.openxmlformats.org/drawingml/2006/main">
               <a:ext uri="{FF2B5EF4-FFF2-40B4-BE49-F238E27FC236}">
-                <a16:creationId xmlns:a16="http://schemas.microsoft.com/office/drawing/2014/main" id="{67403ECC-6F6A-4ACF-8948-91C5C1C50847}"/>
+                <a16:creationId xmlns:a16="http://schemas.microsoft.com/office/drawing/2014/main" id="{9DA6C38D-A402-4C55-BAC2-CB4567160A4E}"/>
               </a:ext>
             </a:extLst>
           </p:cNvPr>
@@ -5973,7 +7313,7 @@
           <p:cNvPr id="18" name="">
             <a:extLst xmlns:a="http://schemas.openxmlformats.org/drawingml/2006/main">
               <a:ext uri="{FF2B5EF4-FFF2-40B4-BE49-F238E27FC236}">
-                <a16:creationId xmlns:a16="http://schemas.microsoft.com/office/drawing/2014/main" id="{5706EF25-E15F-4FB4-B811-772C2D797440}"/>
+                <a16:creationId xmlns:a16="http://schemas.microsoft.com/office/drawing/2014/main" id="{8E6D2637-CA3C-4CBB-A3BA-91448A4F9892}"/>
               </a:ext>
             </a:extLst>
           </p:cNvPr>
@@ -6004,7 +7344,7 @@
           <p:cNvPr id="19" name="">
             <a:extLst xmlns:a="http://schemas.openxmlformats.org/drawingml/2006/main">
               <a:ext uri="{FF2B5EF4-FFF2-40B4-BE49-F238E27FC236}">
-                <a16:creationId xmlns:a16="http://schemas.microsoft.com/office/drawing/2014/main" id="{91498836-E12D-4E21-9EB0-9B57AD99E1EA}"/>
+                <a16:creationId xmlns:a16="http://schemas.microsoft.com/office/drawing/2014/main" id="{6D4A5B4F-F585-4DD7-A281-967B03522D9D}"/>
               </a:ext>
             </a:extLst>
           </p:cNvPr>
@@ -6054,7 +7394,7 @@
           <p:cNvPr id="20" name="">
             <a:extLst xmlns:a="http://schemas.openxmlformats.org/drawingml/2006/main">
               <a:ext uri="{FF2B5EF4-FFF2-40B4-BE49-F238E27FC236}">
-                <a16:creationId xmlns:a16="http://schemas.microsoft.com/office/drawing/2014/main" id="{24DA658C-BDE2-4ED2-91CD-8985D0A4A44C}"/>
+                <a16:creationId xmlns:a16="http://schemas.microsoft.com/office/drawing/2014/main" id="{C96109B9-C728-459C-8471-3AA8370E8687}"/>
               </a:ext>
             </a:extLst>
           </p:cNvPr>
@@ -6085,7 +7425,7 @@
           <p:cNvPr id="21" name="">
             <a:extLst xmlns:a="http://schemas.openxmlformats.org/drawingml/2006/main">
               <a:ext uri="{FF2B5EF4-FFF2-40B4-BE49-F238E27FC236}">
-                <a16:creationId xmlns:a16="http://schemas.microsoft.com/office/drawing/2014/main" id="{3109D8DE-B82D-4B66-BEA5-D33F101DF0B9}"/>
+                <a16:creationId xmlns:a16="http://schemas.microsoft.com/office/drawing/2014/main" id="{F9682262-66E1-46F2-8B4D-7DB191D7D6C6}"/>
               </a:ext>
             </a:extLst>
           </p:cNvPr>
@@ -6135,7 +7475,7 @@
           <p:cNvPr id="22" name="">
             <a:extLst xmlns:a="http://schemas.openxmlformats.org/drawingml/2006/main">
               <a:ext uri="{FF2B5EF4-FFF2-40B4-BE49-F238E27FC236}">
-                <a16:creationId xmlns:a16="http://schemas.microsoft.com/office/drawing/2014/main" id="{3AFC8DFD-9737-4F56-B8BA-6813B1DAF62B}"/>
+                <a16:creationId xmlns:a16="http://schemas.microsoft.com/office/drawing/2014/main" id="{1D93A7D0-ED24-458B-AC6C-B4AC0F7C06C2}"/>
               </a:ext>
             </a:extLst>
           </p:cNvPr>
@@ -6166,7 +7506,7 @@
           <p:cNvPr id="23" name="">
             <a:extLst xmlns:a="http://schemas.openxmlformats.org/drawingml/2006/main">
               <a:ext uri="{FF2B5EF4-FFF2-40B4-BE49-F238E27FC236}">
-                <a16:creationId xmlns:a16="http://schemas.microsoft.com/office/drawing/2014/main" id="{16140D05-F4BE-47B2-88D3-3219B5C0BD50}"/>
+                <a16:creationId xmlns:a16="http://schemas.microsoft.com/office/drawing/2014/main" id="{8851CE3D-3CD3-48EC-A723-3EB79E938B3D}"/>
               </a:ext>
             </a:extLst>
           </p:cNvPr>
@@ -6216,7 +7556,7 @@
           <p:cNvPr id="24" name="">
             <a:extLst xmlns:a="http://schemas.openxmlformats.org/drawingml/2006/main">
               <a:ext uri="{FF2B5EF4-FFF2-40B4-BE49-F238E27FC236}">
-                <a16:creationId xmlns:a16="http://schemas.microsoft.com/office/drawing/2014/main" id="{F613DA12-8B36-4E88-BB0A-199A23649269}"/>
+                <a16:creationId xmlns:a16="http://schemas.microsoft.com/office/drawing/2014/main" id="{449C23BF-4ED4-42CE-BB79-0F8EE0A2EDE7}"/>
               </a:ext>
             </a:extLst>
           </p:cNvPr>
@@ -6266,7 +7606,7 @@
           <p:cNvPr id="25" name="">
             <a:extLst xmlns:a="http://schemas.openxmlformats.org/drawingml/2006/main">
               <a:ext uri="{FF2B5EF4-FFF2-40B4-BE49-F238E27FC236}">
-                <a16:creationId xmlns:a16="http://schemas.microsoft.com/office/drawing/2014/main" id="{A192BBB2-FB50-4264-8DF9-1BE806F27E57}"/>
+                <a16:creationId xmlns:a16="http://schemas.microsoft.com/office/drawing/2014/main" id="{0E14A752-2D97-46AF-A739-2274E50B8EAB}"/>
               </a:ext>
             </a:extLst>
           </p:cNvPr>
@@ -6314,7 +7654,7 @@
     </p:spTree>
     <p:extLst>
       <p:ext uri="{BB962C8B-B14F-4D97-AF65-F5344CB8AC3E}">
-        <p14:creationId xmlns:p14="http://schemas.microsoft.com/office/powerpoint/2010/main" val="1757269179"/>
+        <p14:creationId xmlns:p14="http://schemas.microsoft.com/office/powerpoint/2010/main" val="1169519708"/>
       </p:ext>
     </p:extLst>
   </p:cSld>
@@ -6345,7 +7685,7 @@
           <p:cNvPr id="8" name="">
             <a:extLst xmlns:a="http://schemas.openxmlformats.org/drawingml/2006/main">
               <a:ext uri="{FF2B5EF4-FFF2-40B4-BE49-F238E27FC236}">
-                <a16:creationId xmlns:a16="http://schemas.microsoft.com/office/drawing/2014/main" id="{54F3CE87-51EC-4277-82B3-968BEA504941}"/>
+                <a16:creationId xmlns:a16="http://schemas.microsoft.com/office/drawing/2014/main" id="{064E0F9E-2978-4805-8A99-42194A0191ED}"/>
               </a:ext>
             </a:extLst>
           </p:cNvPr>
@@ -6395,7 +7735,7 @@
           <p:cNvPr id="2" name="">
             <a:extLst xmlns:a="http://schemas.openxmlformats.org/drawingml/2006/main">
               <a:ext uri="{FF2B5EF4-FFF2-40B4-BE49-F238E27FC236}">
-                <a16:creationId xmlns:a16="http://schemas.microsoft.com/office/drawing/2014/main" id="{4FDC9E96-0B75-4292-AB48-CCF4331077CA}"/>
+                <a16:creationId xmlns:a16="http://schemas.microsoft.com/office/drawing/2014/main" id="{65345122-7962-4FEF-A84A-AEF2D086BF75}"/>
               </a:ext>
             </a:extLst>
           </p:cNvPr>
@@ -6445,7 +7785,7 @@
           <p:cNvPr id="3" name="">
             <a:extLst xmlns:a="http://schemas.openxmlformats.org/drawingml/2006/main">
               <a:ext uri="{FF2B5EF4-FFF2-40B4-BE49-F238E27FC236}">
-                <a16:creationId xmlns:a16="http://schemas.microsoft.com/office/drawing/2014/main" id="{AC93ED74-AEE4-4F44-9237-FDDC9C117B31}"/>
+                <a16:creationId xmlns:a16="http://schemas.microsoft.com/office/drawing/2014/main" id="{211862FF-9821-4999-B6EE-DE5A7F7B676D}"/>
               </a:ext>
             </a:extLst>
           </p:cNvPr>
@@ -6484,7 +7824,7 @@
           <p:nvPr/>
         </p:nvPicPr>
         <p:blipFill>
-          <a:blip xmlns:r="http://schemas.openxmlformats.org/officeDocument/2006/relationships" xmlns:a="http://schemas.openxmlformats.org/drawingml/2006/main" r:embed="Rfac2162f30804ea9"/>
+          <a:blip xmlns:r="http://schemas.openxmlformats.org/officeDocument/2006/relationships" xmlns:a="http://schemas.openxmlformats.org/drawingml/2006/main" r:embed="Ra60f92ac3142478a"/>
           <a:stretch xmlns:a="http://schemas.openxmlformats.org/drawingml/2006/main"/>
         </p:blipFill>
         <p:spPr>
@@ -6502,7 +7842,7 @@
           <p:cNvPr id="5" name="">
             <a:extLst xmlns:a="http://schemas.openxmlformats.org/drawingml/2006/main">
               <a:ext uri="{FF2B5EF4-FFF2-40B4-BE49-F238E27FC236}">
-                <a16:creationId xmlns:a16="http://schemas.microsoft.com/office/drawing/2014/main" id="{48E901A1-CC5A-4483-A730-EB6E0073EA84}"/>
+                <a16:creationId xmlns:a16="http://schemas.microsoft.com/office/drawing/2014/main" id="{3CA55B69-90C1-4D6A-95AC-BC1D51880B4F}"/>
               </a:ext>
             </a:extLst>
           </p:cNvPr>
@@ -6552,7 +7892,7 @@
           <p:cNvPr id="6" name="">
             <a:extLst xmlns:a="http://schemas.openxmlformats.org/drawingml/2006/main">
               <a:ext uri="{FF2B5EF4-FFF2-40B4-BE49-F238E27FC236}">
-                <a16:creationId xmlns:a16="http://schemas.microsoft.com/office/drawing/2014/main" id="{A2417F06-F3DB-4472-9509-5CC9E2B51728}"/>
+                <a16:creationId xmlns:a16="http://schemas.microsoft.com/office/drawing/2014/main" id="{4F4852C3-0125-4FCB-848D-A08A5D953547}"/>
               </a:ext>
             </a:extLst>
           </p:cNvPr>
@@ -6602,7 +7942,7 @@
           <p:cNvPr id="7" name="">
             <a:extLst xmlns:a="http://schemas.openxmlformats.org/drawingml/2006/main">
               <a:ext uri="{FF2B5EF4-FFF2-40B4-BE49-F238E27FC236}">
-                <a16:creationId xmlns:a16="http://schemas.microsoft.com/office/drawing/2014/main" id="{6FEB3ECD-9BCD-407D-9BC8-10C880D5621A}"/>
+                <a16:creationId xmlns:a16="http://schemas.microsoft.com/office/drawing/2014/main" id="{9F2F6E27-0464-4F0B-9055-B8DF8EDA32E3}"/>
               </a:ext>
             </a:extLst>
           </p:cNvPr>
@@ -6650,7 +7990,7 @@
     </p:spTree>
     <p:extLst>
       <p:ext uri="{BB962C8B-B14F-4D97-AF65-F5344CB8AC3E}">
-        <p14:creationId xmlns:p14="http://schemas.microsoft.com/office/powerpoint/2010/main" val="1900830495"/>
+        <p14:creationId xmlns:p14="http://schemas.microsoft.com/office/powerpoint/2010/main" val="387956659"/>
       </p:ext>
     </p:extLst>
   </p:cSld>
@@ -6681,7 +8021,7 @@
           <p:cNvPr id="16" name="">
             <a:extLst xmlns:a="http://schemas.openxmlformats.org/drawingml/2006/main">
               <a:ext uri="{FF2B5EF4-FFF2-40B4-BE49-F238E27FC236}">
-                <a16:creationId xmlns:a16="http://schemas.microsoft.com/office/drawing/2014/main" id="{E2D3BE00-4DD1-46E3-AD91-95B642BD463B}"/>
+                <a16:creationId xmlns:a16="http://schemas.microsoft.com/office/drawing/2014/main" id="{547E4C7B-A4A8-4569-A66F-28CC2434A6F3}"/>
               </a:ext>
             </a:extLst>
           </p:cNvPr>
@@ -6731,7 +8071,7 @@
           <p:cNvPr id="2" name="">
             <a:extLst xmlns:a="http://schemas.openxmlformats.org/drawingml/2006/main">
               <a:ext uri="{FF2B5EF4-FFF2-40B4-BE49-F238E27FC236}">
-                <a16:creationId xmlns:a16="http://schemas.microsoft.com/office/drawing/2014/main" id="{A4CEC726-DE17-48DB-BEFA-A2D16E07D88C}"/>
+                <a16:creationId xmlns:a16="http://schemas.microsoft.com/office/drawing/2014/main" id="{7B7A393E-CE68-49D4-9F0E-EA8C04916D77}"/>
               </a:ext>
             </a:extLst>
           </p:cNvPr>
@@ -6781,7 +8121,7 @@
           <p:cNvPr id="3" name="">
             <a:extLst xmlns:a="http://schemas.openxmlformats.org/drawingml/2006/main">
               <a:ext uri="{FF2B5EF4-FFF2-40B4-BE49-F238E27FC236}">
-                <a16:creationId xmlns:a16="http://schemas.microsoft.com/office/drawing/2014/main" id="{5ACB51C7-14FA-48FD-8775-4756525FA965}"/>
+                <a16:creationId xmlns:a16="http://schemas.microsoft.com/office/drawing/2014/main" id="{DC792BF2-6CB7-4A2B-99D0-3B906B1CCA4E}"/>
               </a:ext>
             </a:extLst>
           </p:cNvPr>
@@ -6820,7 +8160,7 @@
           <p:nvPr/>
         </p:nvPicPr>
         <p:blipFill>
-          <a:blip xmlns:r="http://schemas.openxmlformats.org/officeDocument/2006/relationships" xmlns:a="http://schemas.openxmlformats.org/drawingml/2006/main" r:embed="R0302a95fac6a4540"/>
+          <a:blip xmlns:r="http://schemas.openxmlformats.org/officeDocument/2006/relationships" xmlns:a="http://schemas.openxmlformats.org/drawingml/2006/main" r:embed="Rb6d142085d9b42ab"/>
           <a:stretch xmlns:a="http://schemas.openxmlformats.org/drawingml/2006/main"/>
         </p:blipFill>
         <p:spPr>
@@ -6838,7 +8178,7 @@
           <p:cNvPr id="5" name="">
             <a:extLst xmlns:a="http://schemas.openxmlformats.org/drawingml/2006/main">
               <a:ext uri="{FF2B5EF4-FFF2-40B4-BE49-F238E27FC236}">
-                <a16:creationId xmlns:a16="http://schemas.microsoft.com/office/drawing/2014/main" id="{EC94354D-3908-4943-9BA9-8B9465579C4B}"/>
+                <a16:creationId xmlns:a16="http://schemas.microsoft.com/office/drawing/2014/main" id="{05CB8AE5-5131-4AD4-B2EF-9E24EEEE37C4}"/>
               </a:ext>
             </a:extLst>
           </p:cNvPr>
@@ -6873,7 +8213,7 @@
           <p:cNvPr id="6" name="">
             <a:extLst xmlns:a="http://schemas.openxmlformats.org/drawingml/2006/main">
               <a:ext uri="{FF2B5EF4-FFF2-40B4-BE49-F238E27FC236}">
-                <a16:creationId xmlns:a16="http://schemas.microsoft.com/office/drawing/2014/main" id="{A8439B89-BC18-4A23-8B4B-6D774229F523}"/>
+                <a16:creationId xmlns:a16="http://schemas.microsoft.com/office/drawing/2014/main" id="{6359ED24-9912-4890-92AA-3DF7546EAA7D}"/>
               </a:ext>
             </a:extLst>
           </p:cNvPr>
@@ -6923,7 +8263,7 @@
           <p:cNvPr id="7" name="">
             <a:extLst xmlns:a="http://schemas.openxmlformats.org/drawingml/2006/main">
               <a:ext uri="{FF2B5EF4-FFF2-40B4-BE49-F238E27FC236}">
-                <a16:creationId xmlns:a16="http://schemas.microsoft.com/office/drawing/2014/main" id="{032F41C6-A6E9-4269-A5F5-2A34F08C5B55}"/>
+                <a16:creationId xmlns:a16="http://schemas.microsoft.com/office/drawing/2014/main" id="{8A7E27C9-65A6-4FC3-B283-FCD79A8C472D}"/>
               </a:ext>
             </a:extLst>
           </p:cNvPr>
@@ -6973,7 +8313,7 @@
           <p:cNvPr id="8" name="">
             <a:extLst xmlns:a="http://schemas.openxmlformats.org/drawingml/2006/main">
               <a:ext uri="{FF2B5EF4-FFF2-40B4-BE49-F238E27FC236}">
-                <a16:creationId xmlns:a16="http://schemas.microsoft.com/office/drawing/2014/main" id="{482042DA-551E-45B7-94E1-7B10492B43CF}"/>
+                <a16:creationId xmlns:a16="http://schemas.microsoft.com/office/drawing/2014/main" id="{6DF60C98-54B1-4FAF-AAF3-5150F35B0E16}"/>
               </a:ext>
             </a:extLst>
           </p:cNvPr>
@@ -7023,7 +8363,7 @@
           <p:cNvPr id="9" name="">
             <a:extLst xmlns:a="http://schemas.openxmlformats.org/drawingml/2006/main">
               <a:ext uri="{FF2B5EF4-FFF2-40B4-BE49-F238E27FC236}">
-                <a16:creationId xmlns:a16="http://schemas.microsoft.com/office/drawing/2014/main" id="{D7E65C6D-2B72-412A-B4BB-EA56ADEE250A}"/>
+                <a16:creationId xmlns:a16="http://schemas.microsoft.com/office/drawing/2014/main" id="{1919D814-B982-4DF7-A54D-8169F905CDF3}"/>
               </a:ext>
             </a:extLst>
           </p:cNvPr>
@@ -7058,7 +8398,7 @@
           <p:cNvPr id="10" name="">
             <a:extLst xmlns:a="http://schemas.openxmlformats.org/drawingml/2006/main">
               <a:ext uri="{FF2B5EF4-FFF2-40B4-BE49-F238E27FC236}">
-                <a16:creationId xmlns:a16="http://schemas.microsoft.com/office/drawing/2014/main" id="{2954A896-3C5D-4A55-A2DD-124F4F285F79}"/>
+                <a16:creationId xmlns:a16="http://schemas.microsoft.com/office/drawing/2014/main" id="{598FCF1A-44BB-4AB0-B3D7-D8D4ADC9E975}"/>
               </a:ext>
             </a:extLst>
           </p:cNvPr>
@@ -7108,7 +8448,7 @@
           <p:cNvPr id="11" name="">
             <a:extLst xmlns:a="http://schemas.openxmlformats.org/drawingml/2006/main">
               <a:ext uri="{FF2B5EF4-FFF2-40B4-BE49-F238E27FC236}">
-                <a16:creationId xmlns:a16="http://schemas.microsoft.com/office/drawing/2014/main" id="{F7166217-FF0B-4F1A-A440-2CE481CA1F30}"/>
+                <a16:creationId xmlns:a16="http://schemas.microsoft.com/office/drawing/2014/main" id="{1D21F941-8D67-49BB-BF57-979B2B831DFE}"/>
               </a:ext>
             </a:extLst>
           </p:cNvPr>
@@ -7158,7 +8498,7 @@
           <p:cNvPr id="12" name="">
             <a:extLst xmlns:a="http://schemas.openxmlformats.org/drawingml/2006/main">
               <a:ext uri="{FF2B5EF4-FFF2-40B4-BE49-F238E27FC236}">
-                <a16:creationId xmlns:a16="http://schemas.microsoft.com/office/drawing/2014/main" id="{DEC42A3A-304C-4902-96B6-66305CBD2913}"/>
+                <a16:creationId xmlns:a16="http://schemas.microsoft.com/office/drawing/2014/main" id="{B5295529-18D6-4E15-8626-C9C1B70DA4DA}"/>
               </a:ext>
             </a:extLst>
           </p:cNvPr>
@@ -7208,7 +8548,7 @@
           <p:cNvPr id="13" name="">
             <a:extLst xmlns:a="http://schemas.openxmlformats.org/drawingml/2006/main">
               <a:ext uri="{FF2B5EF4-FFF2-40B4-BE49-F238E27FC236}">
-                <a16:creationId xmlns:a16="http://schemas.microsoft.com/office/drawing/2014/main" id="{0AA22665-380D-4EEB-AA08-886F4009D3F9}"/>
+                <a16:creationId xmlns:a16="http://schemas.microsoft.com/office/drawing/2014/main" id="{0BF5292F-7FAC-4E8F-B45F-4AA1FDC55F96}"/>
               </a:ext>
             </a:extLst>
           </p:cNvPr>
@@ -7258,7 +8598,7 @@
           <p:cNvPr id="14" name="">
             <a:extLst xmlns:a="http://schemas.openxmlformats.org/drawingml/2006/main">
               <a:ext uri="{FF2B5EF4-FFF2-40B4-BE49-F238E27FC236}">
-                <a16:creationId xmlns:a16="http://schemas.microsoft.com/office/drawing/2014/main" id="{186E5304-69F0-4CC3-8E27-ED0AA9F83B72}"/>
+                <a16:creationId xmlns:a16="http://schemas.microsoft.com/office/drawing/2014/main" id="{F21CFDE2-0351-41F8-9FB4-D929694D5C7E}"/>
               </a:ext>
             </a:extLst>
           </p:cNvPr>
@@ -7308,7 +8648,7 @@
           <p:cNvPr id="15" name="">
             <a:extLst xmlns:a="http://schemas.openxmlformats.org/drawingml/2006/main">
               <a:ext uri="{FF2B5EF4-FFF2-40B4-BE49-F238E27FC236}">
-                <a16:creationId xmlns:a16="http://schemas.microsoft.com/office/drawing/2014/main" id="{A0E4E615-8C88-4F05-9A0B-5D0196305BEC}"/>
+                <a16:creationId xmlns:a16="http://schemas.microsoft.com/office/drawing/2014/main" id="{531F7D17-3789-49A6-8D03-DBE0C3099972}"/>
               </a:ext>
             </a:extLst>
           </p:cNvPr>
@@ -7356,7 +8696,7 @@
     </p:spTree>
     <p:extLst>
       <p:ext uri="{BB962C8B-B14F-4D97-AF65-F5344CB8AC3E}">
-        <p14:creationId xmlns:p14="http://schemas.microsoft.com/office/powerpoint/2010/main" val="1811837155"/>
+        <p14:creationId xmlns:p14="http://schemas.microsoft.com/office/powerpoint/2010/main" val="1166197037"/>
       </p:ext>
     </p:extLst>
   </p:cSld>
@@ -7384,10 +8724,10 @@
       </p:grpSpPr>
       <p:sp>
         <p:nvSpPr>
-          <p:cNvPr id="12" name="">
-            <a:extLst xmlns:a="http://schemas.openxmlformats.org/drawingml/2006/main">
-              <a:ext uri="{FF2B5EF4-FFF2-40B4-BE49-F238E27FC236}">
-                <a16:creationId xmlns:a16="http://schemas.microsoft.com/office/drawing/2014/main" id="{70AA618B-EF38-4F91-916B-41E6B3B042FF}"/>
+          <p:cNvPr id="19" name="">
+            <a:extLst xmlns:a="http://schemas.openxmlformats.org/drawingml/2006/main">
+              <a:ext uri="{FF2B5EF4-FFF2-40B4-BE49-F238E27FC236}">
+                <a16:creationId xmlns:a16="http://schemas.microsoft.com/office/drawing/2014/main" id="{8A4613DF-F9B4-4BFC-8D6D-B0DA39BE49E7}"/>
               </a:ext>
             </a:extLst>
           </p:cNvPr>
@@ -7427,7 +8767,7 @@
                   <a:srgbClr val="0F172A"/>
                 </a:solidFill>
               </a:rPr>
-              <a:t>Replay-side KV loads missed the deadline in this run</a:t>
+              <a:t>Mechanism traces show why prefetch misses</a:t>
             </a:r>
           </a:p>
         </p:txBody>
@@ -7437,7 +8777,7 @@
           <p:cNvPr id="2" name="">
             <a:extLst xmlns:a="http://schemas.openxmlformats.org/drawingml/2006/main">
               <a:ext uri="{FF2B5EF4-FFF2-40B4-BE49-F238E27FC236}">
-                <a16:creationId xmlns:a16="http://schemas.microsoft.com/office/drawing/2014/main" id="{FBAB8E2C-FD64-4D86-ADAE-EF18D8D8E24F}"/>
+                <a16:creationId xmlns:a16="http://schemas.microsoft.com/office/drawing/2014/main" id="{E199B795-95D7-4E93-85A6-D5A3C9C003DB}"/>
               </a:ext>
             </a:extLst>
           </p:cNvPr>
@@ -7477,7 +8817,7 @@
                   <a:srgbClr val="64748B"/>
                 </a:solidFill>
               </a:rPr>
-              <a:t>The aggregate view shows whether KV H2D finished before or after replay was due.</a:t>
+              <a:t>In the profiled synthetic run, the hint path existed, but KV copy/readiness still landed too late for replay.</a:t>
             </a:r>
           </a:p>
         </p:txBody>
@@ -7487,23 +8827,23 @@
           <p:cNvPr id="3" name="">
             <a:extLst xmlns:a="http://schemas.openxmlformats.org/drawingml/2006/main">
               <a:ext uri="{FF2B5EF4-FFF2-40B4-BE49-F238E27FC236}">
-                <a16:creationId xmlns:a16="http://schemas.microsoft.com/office/drawing/2014/main" id="{2E330626-E3C5-4A3A-ABC5-D106FA0805C4}"/>
-              </a:ext>
-            </a:extLst>
-          </p:cNvPr>
-          <p:cNvSpPr>
-            <a:spLocks xmlns:a="http://schemas.openxmlformats.org/drawingml/2006/main" noGrp="1"/>
-          </p:cNvSpPr>
-          <p:nvPr/>
-        </p:nvSpPr>
-        <p:spPr>
-          <a:xfrm xmlns:a="http://schemas.openxmlformats.org/drawingml/2006/main">
-            <a:off x="323850" y="1428750"/>
-            <a:ext cx="8724900" cy="3867150"/>
+                <a16:creationId xmlns:a16="http://schemas.microsoft.com/office/drawing/2014/main" id="{CC5A896C-106A-488E-9F35-4329E8164F93}"/>
+              </a:ext>
+            </a:extLst>
+          </p:cNvPr>
+          <p:cNvSpPr>
+            <a:spLocks xmlns:a="http://schemas.openxmlformats.org/drawingml/2006/main" noGrp="1"/>
+          </p:cNvSpPr>
+          <p:nvPr/>
+        </p:nvSpPr>
+        <p:spPr>
+          <a:xfrm xmlns:a="http://schemas.openxmlformats.org/drawingml/2006/main">
+            <a:off x="247650" y="1447800"/>
+            <a:ext cx="7677150" cy="3581400"/>
           </a:xfrm>
           <a:prstGeom xmlns:a="http://schemas.openxmlformats.org/drawingml/2006/main" prst="roundRect">
             <a:avLst>
-              <a:gd name="adj" fmla="val 1478"/>
+              <a:gd name="adj" fmla="val 1596"/>
             </a:avLst>
           </a:prstGeom>
           <a:solidFill xmlns:a="http://schemas.openxmlformats.org/drawingml/2006/main">
@@ -7519,20 +8859,20 @@
       </p:sp>
       <p:pic>
         <p:nvPicPr>
-          <p:cNvPr id="15" name=""/>
+          <p:cNvPr id="22" name=""/>
           <p:cNvPicPr>
             <a:picLocks xmlns:a="http://schemas.openxmlformats.org/drawingml/2006/main" noChangeAspect="1"/>
           </p:cNvPicPr>
           <p:nvPr/>
         </p:nvPicPr>
         <p:blipFill>
-          <a:blip xmlns:r="http://schemas.openxmlformats.org/officeDocument/2006/relationships" xmlns:a="http://schemas.openxmlformats.org/drawingml/2006/main" r:embed="R9be63e229c60453a"/>
+          <a:blip xmlns:r="http://schemas.openxmlformats.org/officeDocument/2006/relationships" xmlns:a="http://schemas.openxmlformats.org/drawingml/2006/main" r:embed="Raa64803f388a4bec"/>
           <a:stretch xmlns:a="http://schemas.openxmlformats.org/drawingml/2006/main"/>
         </p:blipFill>
         <p:spPr>
           <a:xfrm xmlns:a="http://schemas.openxmlformats.org/drawingml/2006/main">
-            <a:off x="400050" y="1795905"/>
-            <a:ext cx="8572500" cy="3132841"/>
+            <a:off x="323850" y="1858963"/>
+            <a:ext cx="7524750" cy="2759075"/>
           </a:xfrm>
           <a:prstGeom xmlns:a="http://schemas.openxmlformats.org/drawingml/2006/main" prst="rect">
             <a:avLst/>
@@ -7544,23 +8884,23 @@
           <p:cNvPr id="5" name="">
             <a:extLst xmlns:a="http://schemas.openxmlformats.org/drawingml/2006/main">
               <a:ext uri="{FF2B5EF4-FFF2-40B4-BE49-F238E27FC236}">
-                <a16:creationId xmlns:a16="http://schemas.microsoft.com/office/drawing/2014/main" id="{DCC59742-449F-4E22-B140-61B04664DADF}"/>
-              </a:ext>
-            </a:extLst>
-          </p:cNvPr>
-          <p:cNvSpPr>
-            <a:spLocks xmlns:a="http://schemas.openxmlformats.org/drawingml/2006/main" noGrp="1"/>
-          </p:cNvSpPr>
-          <p:nvPr/>
-        </p:nvSpPr>
-        <p:spPr>
-          <a:xfrm xmlns:a="http://schemas.openxmlformats.org/drawingml/2006/main">
-            <a:off x="9258300" y="1847850"/>
-            <a:ext cx="2095500" cy="1104900"/>
+                <a16:creationId xmlns:a16="http://schemas.microsoft.com/office/drawing/2014/main" id="{81FC3205-5B72-496C-8891-43F05149FC5D}"/>
+              </a:ext>
+            </a:extLst>
+          </p:cNvPr>
+          <p:cNvSpPr>
+            <a:spLocks xmlns:a="http://schemas.openxmlformats.org/drawingml/2006/main" noGrp="1"/>
+          </p:cNvSpPr>
+          <p:nvPr/>
+        </p:nvSpPr>
+        <p:spPr>
+          <a:xfrm xmlns:a="http://schemas.openxmlformats.org/drawingml/2006/main">
+            <a:off x="8191500" y="1619250"/>
+            <a:ext cx="3124200" cy="781050"/>
           </a:xfrm>
           <a:prstGeom xmlns:a="http://schemas.openxmlformats.org/drawingml/2006/main" prst="roundRect">
             <a:avLst>
-              <a:gd name="adj" fmla="val 5172"/>
+              <a:gd name="adj" fmla="val 7317"/>
             </a:avLst>
           </a:prstGeom>
           <a:solidFill xmlns:a="http://schemas.openxmlformats.org/drawingml/2006/main">
@@ -7579,19 +8919,19 @@
           <p:cNvPr id="6" name="">
             <a:extLst xmlns:a="http://schemas.openxmlformats.org/drawingml/2006/main">
               <a:ext uri="{FF2B5EF4-FFF2-40B4-BE49-F238E27FC236}">
-                <a16:creationId xmlns:a16="http://schemas.microsoft.com/office/drawing/2014/main" id="{13DF3E7E-B41F-41E9-BF57-716F50ED1C32}"/>
-              </a:ext>
-            </a:extLst>
-          </p:cNvPr>
-          <p:cNvSpPr>
-            <a:spLocks xmlns:a="http://schemas.openxmlformats.org/drawingml/2006/main" noGrp="1"/>
-          </p:cNvSpPr>
-          <p:nvPr/>
-        </p:nvSpPr>
-        <p:spPr>
-          <a:xfrm xmlns:a="http://schemas.openxmlformats.org/drawingml/2006/main">
-            <a:off x="9505950" y="2076450"/>
-            <a:ext cx="1600200" cy="476250"/>
+                <a16:creationId xmlns:a16="http://schemas.microsoft.com/office/drawing/2014/main" id="{7A690524-3B70-4D47-B64D-A1A40154F528}"/>
+              </a:ext>
+            </a:extLst>
+          </p:cNvPr>
+          <p:cNvSpPr>
+            <a:spLocks xmlns:a="http://schemas.openxmlformats.org/drawingml/2006/main" noGrp="1"/>
+          </p:cNvSpPr>
+          <p:nvPr/>
+        </p:nvSpPr>
+        <p:spPr>
+          <a:xfrm xmlns:a="http://schemas.openxmlformats.org/drawingml/2006/main">
+            <a:off x="8420100" y="1790700"/>
+            <a:ext cx="2667000" cy="323850"/>
           </a:xfrm>
           <a:prstGeom xmlns:a="http://schemas.openxmlformats.org/drawingml/2006/main" prst="rect">
             <a:avLst/>
@@ -7607,19 +8947,19 @@
           <a:lstStyle xmlns:a="http://schemas.openxmlformats.org/drawingml/2006/main"/>
           <a:p xmlns:a="http://schemas.openxmlformats.org/drawingml/2006/main">
             <a:pPr algn="ctr">
-              <a:defRPr sz="3600" b="1">
+              <a:defRPr sz="2550" b="1">
                 <a:solidFill>
                   <a:srgbClr val="B91C1C"/>
                 </a:solidFill>
               </a:defRPr>
             </a:pPr>
             <a:r>
-              <a:rPr sz="3600" b="1">
+              <a:rPr sz="2550" b="1">
                 <a:solidFill>
                   <a:srgbClr val="B91C1C"/>
                 </a:solidFill>
               </a:rPr>
-              <a:t>8 / 8</a:t>
+              <a:t>0 / 6</a:t>
             </a:r>
           </a:p>
         </p:txBody>
@@ -7629,19 +8969,339 @@
           <p:cNvPr id="7" name="">
             <a:extLst xmlns:a="http://schemas.openxmlformats.org/drawingml/2006/main">
               <a:ext uri="{FF2B5EF4-FFF2-40B4-BE49-F238E27FC236}">
-                <a16:creationId xmlns:a16="http://schemas.microsoft.com/office/drawing/2014/main" id="{83C52F6A-7360-457A-8440-FB39A167AA19}"/>
-              </a:ext>
-            </a:extLst>
-          </p:cNvPr>
-          <p:cNvSpPr>
-            <a:spLocks xmlns:a="http://schemas.openxmlformats.org/drawingml/2006/main" noGrp="1"/>
-          </p:cNvSpPr>
-          <p:nvPr/>
-        </p:nvSpPr>
-        <p:spPr>
-          <a:xfrm xmlns:a="http://schemas.openxmlformats.org/drawingml/2006/main">
-            <a:off x="9505950" y="2628900"/>
-            <a:ext cx="1600200" cy="266700"/>
+                <a16:creationId xmlns:a16="http://schemas.microsoft.com/office/drawing/2014/main" id="{E21206F9-DD38-4C31-8A60-F2B680E96ACA}"/>
+              </a:ext>
+            </a:extLst>
+          </p:cNvPr>
+          <p:cNvSpPr>
+            <a:spLocks xmlns:a="http://schemas.openxmlformats.org/drawingml/2006/main" noGrp="1"/>
+          </p:cNvSpPr>
+          <p:nvPr/>
+        </p:nvSpPr>
+        <p:spPr>
+          <a:xfrm xmlns:a="http://schemas.openxmlformats.org/drawingml/2006/main">
+            <a:off x="8420100" y="2152650"/>
+            <a:ext cx="2667000" cy="190500"/>
+          </a:xfrm>
+          <a:prstGeom xmlns:a="http://schemas.openxmlformats.org/drawingml/2006/main" prst="rect">
+            <a:avLst/>
+          </a:prstGeom>
+          <a:noFill xmlns:a="http://schemas.openxmlformats.org/drawingml/2006/main"/>
+          <a:ln xmlns:a="http://schemas.openxmlformats.org/drawingml/2006/main" w="0">
+            <a:noFill/>
+            <a:prstDash val="solid"/>
+          </a:ln>
+        </p:spPr>
+        <p:txBody>
+          <a:bodyPr xmlns:a="http://schemas.openxmlformats.org/drawingml/2006/main" anchor="t"/>
+          <a:lstStyle xmlns:a="http://schemas.openxmlformats.org/drawingml/2006/main"/>
+          <a:p xmlns:a="http://schemas.openxmlformats.org/drawingml/2006/main">
+            <a:pPr algn="ctr">
+              <a:defRPr sz="1200" b="0">
+                <a:solidFill>
+                  <a:srgbClr val="334155"/>
+                </a:solidFill>
+              </a:defRPr>
+            </a:pPr>
+            <a:r>
+              <a:rPr sz="1200" b="0">
+                <a:solidFill>
+                  <a:srgbClr val="334155"/>
+                </a:solidFill>
+              </a:rPr>
+              <a:t>ready before replay</a:t>
+            </a:r>
+          </a:p>
+        </p:txBody>
+      </p:sp>
+      <p:sp>
+        <p:nvSpPr>
+          <p:cNvPr id="8" name="">
+            <a:extLst xmlns:a="http://schemas.openxmlformats.org/drawingml/2006/main">
+              <a:ext uri="{FF2B5EF4-FFF2-40B4-BE49-F238E27FC236}">
+                <a16:creationId xmlns:a16="http://schemas.microsoft.com/office/drawing/2014/main" id="{1A22EED6-326F-4475-8BDB-8EA9AD5A7614}"/>
+              </a:ext>
+            </a:extLst>
+          </p:cNvPr>
+          <p:cNvSpPr>
+            <a:spLocks xmlns:a="http://schemas.openxmlformats.org/drawingml/2006/main" noGrp="1"/>
+          </p:cNvSpPr>
+          <p:nvPr/>
+        </p:nvSpPr>
+        <p:spPr>
+          <a:xfrm xmlns:a="http://schemas.openxmlformats.org/drawingml/2006/main">
+            <a:off x="8191500" y="2647950"/>
+            <a:ext cx="3124200" cy="781050"/>
+          </a:xfrm>
+          <a:prstGeom xmlns:a="http://schemas.openxmlformats.org/drawingml/2006/main" prst="roundRect">
+            <a:avLst>
+              <a:gd name="adj" fmla="val 7317"/>
+            </a:avLst>
+          </a:prstGeom>
+          <a:solidFill xmlns:a="http://schemas.openxmlformats.org/drawingml/2006/main">
+            <a:srgbClr val="ECFEFF"/>
+          </a:solidFill>
+          <a:ln xmlns:a="http://schemas.openxmlformats.org/drawingml/2006/main" w="9525">
+            <a:solidFill>
+              <a:srgbClr val="67E8F9"/>
+            </a:solidFill>
+            <a:prstDash val="solid"/>
+          </a:ln>
+        </p:spPr>
+      </p:sp>
+      <p:sp>
+        <p:nvSpPr>
+          <p:cNvPr id="9" name="">
+            <a:extLst xmlns:a="http://schemas.openxmlformats.org/drawingml/2006/main">
+              <a:ext uri="{FF2B5EF4-FFF2-40B4-BE49-F238E27FC236}">
+                <a16:creationId xmlns:a16="http://schemas.microsoft.com/office/drawing/2014/main" id="{FD088CC6-4BE6-4B45-B08A-F200B6B62AF7}"/>
+              </a:ext>
+            </a:extLst>
+          </p:cNvPr>
+          <p:cNvSpPr>
+            <a:spLocks xmlns:a="http://schemas.openxmlformats.org/drawingml/2006/main" noGrp="1"/>
+          </p:cNvSpPr>
+          <p:nvPr/>
+        </p:nvSpPr>
+        <p:spPr>
+          <a:xfrm xmlns:a="http://schemas.openxmlformats.org/drawingml/2006/main">
+            <a:off x="8420100" y="2819400"/>
+            <a:ext cx="2667000" cy="323850"/>
+          </a:xfrm>
+          <a:prstGeom xmlns:a="http://schemas.openxmlformats.org/drawingml/2006/main" prst="rect">
+            <a:avLst/>
+          </a:prstGeom>
+          <a:noFill xmlns:a="http://schemas.openxmlformats.org/drawingml/2006/main"/>
+          <a:ln xmlns:a="http://schemas.openxmlformats.org/drawingml/2006/main" w="0">
+            <a:noFill/>
+            <a:prstDash val="solid"/>
+          </a:ln>
+        </p:spPr>
+        <p:txBody>
+          <a:bodyPr xmlns:a="http://schemas.openxmlformats.org/drawingml/2006/main" anchor="t"/>
+          <a:lstStyle xmlns:a="http://schemas.openxmlformats.org/drawingml/2006/main"/>
+          <a:p xmlns:a="http://schemas.openxmlformats.org/drawingml/2006/main">
+            <a:pPr algn="ctr">
+              <a:defRPr sz="2550" b="1">
+                <a:solidFill>
+                  <a:srgbClr val="0E7490"/>
+                </a:solidFill>
+              </a:defRPr>
+            </a:pPr>
+            <a:r>
+              <a:rPr sz="2550" b="1">
+                <a:solidFill>
+                  <a:srgbClr val="0E7490"/>
+                </a:solidFill>
+              </a:rPr>
+              <a:t>3 / 6</a:t>
+            </a:r>
+          </a:p>
+        </p:txBody>
+      </p:sp>
+      <p:sp>
+        <p:nvSpPr>
+          <p:cNvPr id="10" name="">
+            <a:extLst xmlns:a="http://schemas.openxmlformats.org/drawingml/2006/main">
+              <a:ext uri="{FF2B5EF4-FFF2-40B4-BE49-F238E27FC236}">
+                <a16:creationId xmlns:a16="http://schemas.microsoft.com/office/drawing/2014/main" id="{9DEF483D-8906-48FE-93A5-21397BB8ECCD}"/>
+              </a:ext>
+            </a:extLst>
+          </p:cNvPr>
+          <p:cNvSpPr>
+            <a:spLocks xmlns:a="http://schemas.openxmlformats.org/drawingml/2006/main" noGrp="1"/>
+          </p:cNvSpPr>
+          <p:nvPr/>
+        </p:nvSpPr>
+        <p:spPr>
+          <a:xfrm xmlns:a="http://schemas.openxmlformats.org/drawingml/2006/main">
+            <a:off x="8420100" y="3181350"/>
+            <a:ext cx="2667000" cy="190500"/>
+          </a:xfrm>
+          <a:prstGeom xmlns:a="http://schemas.openxmlformats.org/drawingml/2006/main" prst="rect">
+            <a:avLst/>
+          </a:prstGeom>
+          <a:noFill xmlns:a="http://schemas.openxmlformats.org/drawingml/2006/main"/>
+          <a:ln xmlns:a="http://schemas.openxmlformats.org/drawingml/2006/main" w="0">
+            <a:noFill/>
+            <a:prstDash val="solid"/>
+          </a:ln>
+        </p:spPr>
+        <p:txBody>
+          <a:bodyPr xmlns:a="http://schemas.openxmlformats.org/drawingml/2006/main" anchor="t"/>
+          <a:lstStyle xmlns:a="http://schemas.openxmlformats.org/drawingml/2006/main"/>
+          <a:p xmlns:a="http://schemas.openxmlformats.org/drawingml/2006/main">
+            <a:pPr algn="ctr">
+              <a:defRPr sz="1200" b="0">
+                <a:solidFill>
+                  <a:srgbClr val="334155"/>
+                </a:solidFill>
+              </a:defRPr>
+            </a:pPr>
+            <a:r>
+              <a:rPr sz="1200" b="0">
+                <a:solidFill>
+                  <a:srgbClr val="334155"/>
+                </a:solidFill>
+              </a:rPr>
+              <a:t>visible CUDA HtoD</a:t>
+            </a:r>
+          </a:p>
+        </p:txBody>
+      </p:sp>
+      <p:sp>
+        <p:nvSpPr>
+          <p:cNvPr id="11" name="">
+            <a:extLst xmlns:a="http://schemas.openxmlformats.org/drawingml/2006/main">
+              <a:ext uri="{FF2B5EF4-FFF2-40B4-BE49-F238E27FC236}">
+                <a16:creationId xmlns:a16="http://schemas.microsoft.com/office/drawing/2014/main" id="{CCD68155-73C7-4AA9-9EDE-6180850749F3}"/>
+              </a:ext>
+            </a:extLst>
+          </p:cNvPr>
+          <p:cNvSpPr>
+            <a:spLocks xmlns:a="http://schemas.openxmlformats.org/drawingml/2006/main" noGrp="1"/>
+          </p:cNvSpPr>
+          <p:nvPr/>
+        </p:nvSpPr>
+        <p:spPr>
+          <a:xfrm xmlns:a="http://schemas.openxmlformats.org/drawingml/2006/main">
+            <a:off x="8191500" y="3676650"/>
+            <a:ext cx="3124200" cy="781050"/>
+          </a:xfrm>
+          <a:prstGeom xmlns:a="http://schemas.openxmlformats.org/drawingml/2006/main" prst="roundRect">
+            <a:avLst>
+              <a:gd name="adj" fmla="val 7317"/>
+            </a:avLst>
+          </a:prstGeom>
+          <a:solidFill xmlns:a="http://schemas.openxmlformats.org/drawingml/2006/main">
+            <a:srgbClr val="FFF7ED"/>
+          </a:solidFill>
+          <a:ln xmlns:a="http://schemas.openxmlformats.org/drawingml/2006/main" w="9525">
+            <a:solidFill>
+              <a:srgbClr val="FED7AA"/>
+            </a:solidFill>
+            <a:prstDash val="solid"/>
+          </a:ln>
+        </p:spPr>
+      </p:sp>
+      <p:sp>
+        <p:nvSpPr>
+          <p:cNvPr id="12" name="">
+            <a:extLst xmlns:a="http://schemas.openxmlformats.org/drawingml/2006/main">
+              <a:ext uri="{FF2B5EF4-FFF2-40B4-BE49-F238E27FC236}">
+                <a16:creationId xmlns:a16="http://schemas.microsoft.com/office/drawing/2014/main" id="{A4B80967-9A17-46B6-8512-BAD9CE769292}"/>
+              </a:ext>
+            </a:extLst>
+          </p:cNvPr>
+          <p:cNvSpPr>
+            <a:spLocks xmlns:a="http://schemas.openxmlformats.org/drawingml/2006/main" noGrp="1"/>
+          </p:cNvSpPr>
+          <p:nvPr/>
+        </p:nvSpPr>
+        <p:spPr>
+          <a:xfrm xmlns:a="http://schemas.openxmlformats.org/drawingml/2006/main">
+            <a:off x="8420100" y="3848100"/>
+            <a:ext cx="2667000" cy="323850"/>
+          </a:xfrm>
+          <a:prstGeom xmlns:a="http://schemas.openxmlformats.org/drawingml/2006/main" prst="rect">
+            <a:avLst/>
+          </a:prstGeom>
+          <a:noFill xmlns:a="http://schemas.openxmlformats.org/drawingml/2006/main"/>
+          <a:ln xmlns:a="http://schemas.openxmlformats.org/drawingml/2006/main" w="0">
+            <a:noFill/>
+            <a:prstDash val="solid"/>
+          </a:ln>
+        </p:spPr>
+        <p:txBody>
+          <a:bodyPr xmlns:a="http://schemas.openxmlformats.org/drawingml/2006/main" anchor="t"/>
+          <a:lstStyle xmlns:a="http://schemas.openxmlformats.org/drawingml/2006/main"/>
+          <a:p xmlns:a="http://schemas.openxmlformats.org/drawingml/2006/main">
+            <a:pPr algn="ctr">
+              <a:defRPr sz="2550" b="1">
+                <a:solidFill>
+                  <a:srgbClr val="C2410C"/>
+                </a:solidFill>
+              </a:defRPr>
+            </a:pPr>
+            <a:r>
+              <a:rPr sz="2550" b="1">
+                <a:solidFill>
+                  <a:srgbClr val="C2410C"/>
+                </a:solidFill>
+              </a:rPr>
+              <a:t>6 / 6</a:t>
+            </a:r>
+          </a:p>
+        </p:txBody>
+      </p:sp>
+      <p:sp>
+        <p:nvSpPr>
+          <p:cNvPr id="13" name="">
+            <a:extLst xmlns:a="http://schemas.openxmlformats.org/drawingml/2006/main">
+              <a:ext uri="{FF2B5EF4-FFF2-40B4-BE49-F238E27FC236}">
+                <a16:creationId xmlns:a16="http://schemas.microsoft.com/office/drawing/2014/main" id="{8875D84C-EA46-4D7C-8BA3-57F7BE6A5017}"/>
+              </a:ext>
+            </a:extLst>
+          </p:cNvPr>
+          <p:cNvSpPr>
+            <a:spLocks xmlns:a="http://schemas.openxmlformats.org/drawingml/2006/main" noGrp="1"/>
+          </p:cNvSpPr>
+          <p:nvPr/>
+        </p:nvSpPr>
+        <p:spPr>
+          <a:xfrm xmlns:a="http://schemas.openxmlformats.org/drawingml/2006/main">
+            <a:off x="8420100" y="4210050"/>
+            <a:ext cx="2667000" cy="190500"/>
+          </a:xfrm>
+          <a:prstGeom xmlns:a="http://schemas.openxmlformats.org/drawingml/2006/main" prst="rect">
+            <a:avLst/>
+          </a:prstGeom>
+          <a:noFill xmlns:a="http://schemas.openxmlformats.org/drawingml/2006/main"/>
+          <a:ln xmlns:a="http://schemas.openxmlformats.org/drawingml/2006/main" w="0">
+            <a:noFill/>
+            <a:prstDash val="solid"/>
+          </a:ln>
+        </p:spPr>
+        <p:txBody>
+          <a:bodyPr xmlns:a="http://schemas.openxmlformats.org/drawingml/2006/main" anchor="t"/>
+          <a:lstStyle xmlns:a="http://schemas.openxmlformats.org/drawingml/2006/main"/>
+          <a:p xmlns:a="http://schemas.openxmlformats.org/drawingml/2006/main">
+            <a:pPr algn="ctr">
+              <a:defRPr sz="1200" b="0">
+                <a:solidFill>
+                  <a:srgbClr val="334155"/>
+                </a:solidFill>
+              </a:defRPr>
+            </a:pPr>
+            <a:r>
+              <a:rPr sz="1200" b="0">
+                <a:solidFill>
+                  <a:srgbClr val="334155"/>
+                </a:solidFill>
+              </a:rPr>
+              <a:t>replay reloaded KV</a:t>
+            </a:r>
+          </a:p>
+        </p:txBody>
+      </p:sp>
+      <p:sp>
+        <p:nvSpPr>
+          <p:cNvPr id="14" name="">
+            <a:extLst xmlns:a="http://schemas.openxmlformats.org/drawingml/2006/main">
+              <a:ext uri="{FF2B5EF4-FFF2-40B4-BE49-F238E27FC236}">
+                <a16:creationId xmlns:a16="http://schemas.microsoft.com/office/drawing/2014/main" id="{1E45C44A-479D-40F4-A04D-B60E3DFF339E}"/>
+              </a:ext>
+            </a:extLst>
+          </p:cNvPr>
+          <p:cNvSpPr>
+            <a:spLocks xmlns:a="http://schemas.openxmlformats.org/drawingml/2006/main" noGrp="1"/>
+          </p:cNvSpPr>
+          <p:nvPr/>
+        </p:nvSpPr>
+        <p:spPr>
+          <a:xfrm xmlns:a="http://schemas.openxmlformats.org/drawingml/2006/main">
+            <a:off x="8134350" y="4686300"/>
+            <a:ext cx="3314700" cy="457200"/>
           </a:xfrm>
           <a:prstGeom xmlns:a="http://schemas.openxmlformats.org/drawingml/2006/main" prst="rect">
             <a:avLst/>
@@ -7669,67 +9329,67 @@
                   <a:srgbClr val="334155"/>
                 </a:solidFill>
               </a:rPr>
-              <a:t>H2D loads finished late</a:t>
-            </a:r>
-          </a:p>
-        </p:txBody>
-      </p:sp>
-      <p:sp>
-        <p:nvSpPr>
-          <p:cNvPr id="8" name="">
-            <a:extLst xmlns:a="http://schemas.openxmlformats.org/drawingml/2006/main">
-              <a:ext uri="{FF2B5EF4-FFF2-40B4-BE49-F238E27FC236}">
-                <a16:creationId xmlns:a16="http://schemas.microsoft.com/office/drawing/2014/main" id="{A344BDC2-22DD-4CF8-AAD0-491BE8AC87A9}"/>
-              </a:ext>
-            </a:extLst>
-          </p:cNvPr>
-          <p:cNvSpPr>
-            <a:spLocks xmlns:a="http://schemas.openxmlformats.org/drawingml/2006/main" noGrp="1"/>
-          </p:cNvSpPr>
-          <p:nvPr/>
-        </p:nvSpPr>
-        <p:spPr>
-          <a:xfrm xmlns:a="http://schemas.openxmlformats.org/drawingml/2006/main">
-            <a:off x="9258300" y="3524250"/>
-            <a:ext cx="2095500" cy="742950"/>
-          </a:xfrm>
-          <a:prstGeom xmlns:a="http://schemas.openxmlformats.org/drawingml/2006/main" prst="rect">
-            <a:avLst/>
-          </a:prstGeom>
-          <a:noFill xmlns:a="http://schemas.openxmlformats.org/drawingml/2006/main"/>
-          <a:ln xmlns:a="http://schemas.openxmlformats.org/drawingml/2006/main" w="0">
-            <a:noFill/>
-            <a:prstDash val="solid"/>
-          </a:ln>
-        </p:spPr>
-        <p:txBody>
-          <a:bodyPr xmlns:a="http://schemas.openxmlformats.org/drawingml/2006/main" anchor="t"/>
-          <a:lstStyle xmlns:a="http://schemas.openxmlformats.org/drawingml/2006/main"/>
-          <a:p xmlns:a="http://schemas.openxmlformats.org/drawingml/2006/main">
-            <a:pPr algn="l">
-              <a:defRPr sz="1575" b="0">
-                <a:solidFill>
-                  <a:srgbClr val="334155"/>
-                </a:solidFill>
-              </a:defRPr>
-            </a:pPr>
-            <a:r>
-              <a:rPr sz="1575" b="0">
-                <a:solidFill>
-                  <a:srgbClr val="334155"/>
-                </a:solidFill>
-              </a:rPr>
-              <a:t>All visible replay-side KV loads finished below the 0 ms deadline line.</a:t>
-            </a:r>
-          </a:p>
-        </p:txBody>
-      </p:sp>
-      <p:sp>
-        <p:nvSpPr>
-          <p:cNvPr id="9" name="">
-            <a:extLst xmlns:a="http://schemas.openxmlformats.org/drawingml/2006/main">
-              <a:ext uri="{FF2B5EF4-FFF2-40B4-BE49-F238E27FC236}">
-                <a16:creationId xmlns:a16="http://schemas.microsoft.com/office/drawing/2014/main" id="{570D357B-C522-4B23-8905-45AF27F1AC1A}"/>
+              <a:t>The semantic hint was present, but the normal movement path did not make residency/reuse predictable before replay.</a:t>
+            </a:r>
+          </a:p>
+        </p:txBody>
+      </p:sp>
+      <p:sp>
+        <p:nvSpPr>
+          <p:cNvPr id="15" name="">
+            <a:extLst xmlns:a="http://schemas.openxmlformats.org/drawingml/2006/main">
+              <a:ext uri="{FF2B5EF4-FFF2-40B4-BE49-F238E27FC236}">
+                <a16:creationId xmlns:a16="http://schemas.microsoft.com/office/drawing/2014/main" id="{38CA4649-E6AB-4C21-AA16-7B6F683879CF}"/>
+              </a:ext>
+            </a:extLst>
+          </p:cNvPr>
+          <p:cNvSpPr>
+            <a:spLocks xmlns:a="http://schemas.openxmlformats.org/drawingml/2006/main" noGrp="1"/>
+          </p:cNvSpPr>
+          <p:nvPr/>
+        </p:nvSpPr>
+        <p:spPr>
+          <a:xfrm xmlns:a="http://schemas.openxmlformats.org/drawingml/2006/main">
+            <a:off x="685800" y="5334000"/>
+            <a:ext cx="10191750" cy="228600"/>
+          </a:xfrm>
+          <a:prstGeom xmlns:a="http://schemas.openxmlformats.org/drawingml/2006/main" prst="rect">
+            <a:avLst/>
+          </a:prstGeom>
+          <a:noFill xmlns:a="http://schemas.openxmlformats.org/drawingml/2006/main"/>
+          <a:ln xmlns:a="http://schemas.openxmlformats.org/drawingml/2006/main" w="0">
+            <a:noFill/>
+            <a:prstDash val="solid"/>
+          </a:ln>
+        </p:spPr>
+        <p:txBody>
+          <a:bodyPr xmlns:a="http://schemas.openxmlformats.org/drawingml/2006/main" anchor="t"/>
+          <a:lstStyle xmlns:a="http://schemas.openxmlformats.org/drawingml/2006/main"/>
+          <a:p xmlns:a="http://schemas.openxmlformats.org/drawingml/2006/main">
+            <a:pPr algn="ctr">
+              <a:defRPr sz="1200" b="0">
+                <a:solidFill>
+                  <a:srgbClr val="64748B"/>
+                </a:solidFill>
+              </a:defRPr>
+            </a:pPr>
+            <a:r>
+              <a:rPr sz="1200" b="0">
+                <a:solidFill>
+                  <a:srgbClr val="64748B"/>
+                </a:solidFill>
+              </a:rPr>
+              <a:t>Preliminary mechanism evidence only: useful for copy-path attribution, not clean TTFT claims.</a:t>
+            </a:r>
+          </a:p>
+        </p:txBody>
+      </p:sp>
+      <p:sp>
+        <p:nvSpPr>
+          <p:cNvPr id="16" name="">
+            <a:extLst xmlns:a="http://schemas.openxmlformats.org/drawingml/2006/main">
+              <a:ext uri="{FF2B5EF4-FFF2-40B4-BE49-F238E27FC236}">
+                <a16:creationId xmlns:a16="http://schemas.microsoft.com/office/drawing/2014/main" id="{1BE4B4EC-FF02-4814-89B3-B6A54BC2BED2}"/>
               </a:ext>
             </a:extLst>
           </p:cNvPr>
@@ -7769,17 +9429,17 @@
                   <a:srgbClr val="64748B"/>
                 </a:solidFill>
               </a:rPr>
-              <a:t>Source: latest_master_report.html, Global Replay H2D Readiness</a:t>
-            </a:r>
-          </a:p>
-        </p:txBody>
-      </p:sp>
-      <p:sp>
-        <p:nvSpPr>
-          <p:cNvPr id="10" name="">
-            <a:extLst xmlns:a="http://schemas.openxmlformats.org/drawingml/2006/main">
-              <a:ext uri="{FF2B5EF4-FFF2-40B4-BE49-F238E27FC236}">
-                <a16:creationId xmlns:a16="http://schemas.microsoft.com/office/drawing/2014/main" id="{2F7503C8-5A98-44E2-A89C-F86A3B330A3B}"/>
+              <a:t>Source: latest_synthetic_master_report.html, Profiled Mechanism Timelines</a:t>
+            </a:r>
+          </a:p>
+        </p:txBody>
+      </p:sp>
+      <p:sp>
+        <p:nvSpPr>
+          <p:cNvPr id="17" name="">
+            <a:extLst xmlns:a="http://schemas.openxmlformats.org/drawingml/2006/main">
+              <a:ext uri="{FF2B5EF4-FFF2-40B4-BE49-F238E27FC236}">
+                <a16:creationId xmlns:a16="http://schemas.microsoft.com/office/drawing/2014/main" id="{89CB325D-25F2-44B5-B04F-257AC7448D35}"/>
               </a:ext>
             </a:extLst>
           </p:cNvPr>
@@ -7826,10 +9486,10 @@
       </p:sp>
       <p:sp>
         <p:nvSpPr>
-          <p:cNvPr id="11" name="">
-            <a:extLst xmlns:a="http://schemas.openxmlformats.org/drawingml/2006/main">
-              <a:ext uri="{FF2B5EF4-FFF2-40B4-BE49-F238E27FC236}">
-                <a16:creationId xmlns:a16="http://schemas.microsoft.com/office/drawing/2014/main" id="{EC3D20A8-B027-4867-811A-B3F41179943C}"/>
+          <p:cNvPr id="18" name="">
+            <a:extLst xmlns:a="http://schemas.openxmlformats.org/drawingml/2006/main">
+              <a:ext uri="{FF2B5EF4-FFF2-40B4-BE49-F238E27FC236}">
+                <a16:creationId xmlns:a16="http://schemas.microsoft.com/office/drawing/2014/main" id="{5CC25300-651E-48A4-B342-D499D85F4F46}"/>
               </a:ext>
             </a:extLst>
           </p:cNvPr>
@@ -7877,7 +9537,7 @@
     </p:spTree>
     <p:extLst>
       <p:ext uri="{BB962C8B-B14F-4D97-AF65-F5344CB8AC3E}">
-        <p14:creationId xmlns:p14="http://schemas.microsoft.com/office/powerpoint/2010/main" val="1589967240"/>
+        <p14:creationId xmlns:p14="http://schemas.microsoft.com/office/powerpoint/2010/main" val="1434002447"/>
       </p:ext>
     </p:extLst>
   </p:cSld>
@@ -7905,10 +9565,10 @@
       </p:grpSpPr>
       <p:sp>
         <p:nvSpPr>
-          <p:cNvPr id="9" name="">
-            <a:extLst xmlns:a="http://schemas.openxmlformats.org/drawingml/2006/main">
-              <a:ext uri="{FF2B5EF4-FFF2-40B4-BE49-F238E27FC236}">
-                <a16:creationId xmlns:a16="http://schemas.microsoft.com/office/drawing/2014/main" id="{431F8236-5F19-4701-9E52-DA82679C3C78}"/>
+          <p:cNvPr id="12" name="">
+            <a:extLst xmlns:a="http://schemas.openxmlformats.org/drawingml/2006/main">
+              <a:ext uri="{FF2B5EF4-FFF2-40B4-BE49-F238E27FC236}">
+                <a16:creationId xmlns:a16="http://schemas.microsoft.com/office/drawing/2014/main" id="{D5A1DE5F-EBB2-47BE-A8C7-27DA9990ED32}"/>
               </a:ext>
             </a:extLst>
           </p:cNvPr>
@@ -7948,7 +9608,7 @@
                   <a:srgbClr val="0F172A"/>
                 </a:solidFill>
               </a:rPr>
-              <a:t>The delay is not just copy time</a:t>
+              <a:t>Replay-side KV loads missed the deadline in this run</a:t>
             </a:r>
           </a:p>
         </p:txBody>
@@ -7958,7 +9618,7 @@
           <p:cNvPr id="2" name="">
             <a:extLst xmlns:a="http://schemas.openxmlformats.org/drawingml/2006/main">
               <a:ext uri="{FF2B5EF4-FFF2-40B4-BE49-F238E27FC236}">
-                <a16:creationId xmlns:a16="http://schemas.microsoft.com/office/drawing/2014/main" id="{3139F9F3-84F4-46C4-B05C-DE22630AD849}"/>
+                <a16:creationId xmlns:a16="http://schemas.microsoft.com/office/drawing/2014/main" id="{A273795D-DF79-41E2-BDAA-0796C1265DA0}"/>
               </a:ext>
             </a:extLst>
           </p:cNvPr>
@@ -7998,7 +9658,7 @@
                   <a:srgbClr val="64748B"/>
                 </a:solidFill>
               </a:rPr>
-              <a:t>The request enters normal software/runtime scheduling before visible KV H2D begins.</a:t>
+              <a:t>The aggregate view shows whether KV H2D finished before or after replay was due.</a:t>
             </a:r>
           </a:p>
         </p:txBody>
@@ -8008,23 +9668,23 @@
           <p:cNvPr id="3" name="">
             <a:extLst xmlns:a="http://schemas.openxmlformats.org/drawingml/2006/main">
               <a:ext uri="{FF2B5EF4-FFF2-40B4-BE49-F238E27FC236}">
-                <a16:creationId xmlns:a16="http://schemas.microsoft.com/office/drawing/2014/main" id="{F98BBA99-C6D7-4819-A4A4-936ACFB7EC53}"/>
-              </a:ext>
-            </a:extLst>
-          </p:cNvPr>
-          <p:cNvSpPr>
-            <a:spLocks xmlns:a="http://schemas.openxmlformats.org/drawingml/2006/main" noGrp="1"/>
-          </p:cNvSpPr>
-          <p:nvPr/>
-        </p:nvSpPr>
-        <p:spPr>
-          <a:xfrm xmlns:a="http://schemas.openxmlformats.org/drawingml/2006/main">
-            <a:off x="323850" y="1333500"/>
-            <a:ext cx="10820400" cy="4343400"/>
+                <a16:creationId xmlns:a16="http://schemas.microsoft.com/office/drawing/2014/main" id="{A24DF1CF-A9D4-43D7-A63E-86CB8F385CA4}"/>
+              </a:ext>
+            </a:extLst>
+          </p:cNvPr>
+          <p:cNvSpPr>
+            <a:spLocks xmlns:a="http://schemas.openxmlformats.org/drawingml/2006/main" noGrp="1"/>
+          </p:cNvSpPr>
+          <p:nvPr/>
+        </p:nvSpPr>
+        <p:spPr>
+          <a:xfrm xmlns:a="http://schemas.openxmlformats.org/drawingml/2006/main">
+            <a:off x="323850" y="1428750"/>
+            <a:ext cx="8724900" cy="3867150"/>
           </a:xfrm>
           <a:prstGeom xmlns:a="http://schemas.openxmlformats.org/drawingml/2006/main" prst="roundRect">
             <a:avLst>
-              <a:gd name="adj" fmla="val 1316"/>
+              <a:gd name="adj" fmla="val 1478"/>
             </a:avLst>
           </a:prstGeom>
           <a:solidFill xmlns:a="http://schemas.openxmlformats.org/drawingml/2006/main">
@@ -8040,20 +9700,20 @@
       </p:sp>
       <p:pic>
         <p:nvPicPr>
-          <p:cNvPr id="12" name=""/>
+          <p:cNvPr id="15" name=""/>
           <p:cNvPicPr>
             <a:picLocks xmlns:a="http://schemas.openxmlformats.org/drawingml/2006/main" noChangeAspect="1"/>
           </p:cNvPicPr>
           <p:nvPr/>
         </p:nvPicPr>
         <p:blipFill>
-          <a:blip xmlns:r="http://schemas.openxmlformats.org/officeDocument/2006/relationships" xmlns:a="http://schemas.openxmlformats.org/drawingml/2006/main" r:embed="R8c1aed6ad210448d"/>
+          <a:blip xmlns:r="http://schemas.openxmlformats.org/officeDocument/2006/relationships" xmlns:a="http://schemas.openxmlformats.org/drawingml/2006/main" r:embed="R48372ffadd9244e8"/>
           <a:stretch xmlns:a="http://schemas.openxmlformats.org/drawingml/2006/main"/>
         </p:blipFill>
         <p:spPr>
           <a:xfrm xmlns:a="http://schemas.openxmlformats.org/drawingml/2006/main">
-            <a:off x="1247835" y="1409700"/>
-            <a:ext cx="8972430" cy="4191000"/>
+            <a:off x="400050" y="1795905"/>
+            <a:ext cx="8572500" cy="3132841"/>
           </a:xfrm>
           <a:prstGeom xmlns:a="http://schemas.openxmlformats.org/drawingml/2006/main" prst="rect">
             <a:avLst/>
@@ -8065,19 +9725,154 @@
           <p:cNvPr id="5" name="">
             <a:extLst xmlns:a="http://schemas.openxmlformats.org/drawingml/2006/main">
               <a:ext uri="{FF2B5EF4-FFF2-40B4-BE49-F238E27FC236}">
-                <a16:creationId xmlns:a16="http://schemas.microsoft.com/office/drawing/2014/main" id="{F01342CA-81E0-4D4F-A653-267F08F4F658}"/>
-              </a:ext>
-            </a:extLst>
-          </p:cNvPr>
-          <p:cNvSpPr>
-            <a:spLocks xmlns:a="http://schemas.openxmlformats.org/drawingml/2006/main" noGrp="1"/>
-          </p:cNvSpPr>
-          <p:nvPr/>
-        </p:nvSpPr>
-        <p:spPr>
-          <a:xfrm xmlns:a="http://schemas.openxmlformats.org/drawingml/2006/main">
-            <a:off x="685800" y="5791200"/>
-            <a:ext cx="9906000" cy="228600"/>
+                <a16:creationId xmlns:a16="http://schemas.microsoft.com/office/drawing/2014/main" id="{C061D14D-3C11-47A1-8E65-522E591A9083}"/>
+              </a:ext>
+            </a:extLst>
+          </p:cNvPr>
+          <p:cNvSpPr>
+            <a:spLocks xmlns:a="http://schemas.openxmlformats.org/drawingml/2006/main" noGrp="1"/>
+          </p:cNvSpPr>
+          <p:nvPr/>
+        </p:nvSpPr>
+        <p:spPr>
+          <a:xfrm xmlns:a="http://schemas.openxmlformats.org/drawingml/2006/main">
+            <a:off x="9258300" y="1847850"/>
+            <a:ext cx="2095500" cy="1104900"/>
+          </a:xfrm>
+          <a:prstGeom xmlns:a="http://schemas.openxmlformats.org/drawingml/2006/main" prst="roundRect">
+            <a:avLst>
+              <a:gd name="adj" fmla="val 5172"/>
+            </a:avLst>
+          </a:prstGeom>
+          <a:solidFill xmlns:a="http://schemas.openxmlformats.org/drawingml/2006/main">
+            <a:srgbClr val="FEF2F2"/>
+          </a:solidFill>
+          <a:ln xmlns:a="http://schemas.openxmlformats.org/drawingml/2006/main" w="9525">
+            <a:solidFill>
+              <a:srgbClr val="FECACA"/>
+            </a:solidFill>
+            <a:prstDash val="solid"/>
+          </a:ln>
+        </p:spPr>
+      </p:sp>
+      <p:sp>
+        <p:nvSpPr>
+          <p:cNvPr id="6" name="">
+            <a:extLst xmlns:a="http://schemas.openxmlformats.org/drawingml/2006/main">
+              <a:ext uri="{FF2B5EF4-FFF2-40B4-BE49-F238E27FC236}">
+                <a16:creationId xmlns:a16="http://schemas.microsoft.com/office/drawing/2014/main" id="{CB00F1AF-4D34-490F-A0A5-9DC095CA6716}"/>
+              </a:ext>
+            </a:extLst>
+          </p:cNvPr>
+          <p:cNvSpPr>
+            <a:spLocks xmlns:a="http://schemas.openxmlformats.org/drawingml/2006/main" noGrp="1"/>
+          </p:cNvSpPr>
+          <p:nvPr/>
+        </p:nvSpPr>
+        <p:spPr>
+          <a:xfrm xmlns:a="http://schemas.openxmlformats.org/drawingml/2006/main">
+            <a:off x="9505950" y="2076450"/>
+            <a:ext cx="1600200" cy="476250"/>
+          </a:xfrm>
+          <a:prstGeom xmlns:a="http://schemas.openxmlformats.org/drawingml/2006/main" prst="rect">
+            <a:avLst/>
+          </a:prstGeom>
+          <a:noFill xmlns:a="http://schemas.openxmlformats.org/drawingml/2006/main"/>
+          <a:ln xmlns:a="http://schemas.openxmlformats.org/drawingml/2006/main" w="0">
+            <a:noFill/>
+            <a:prstDash val="solid"/>
+          </a:ln>
+        </p:spPr>
+        <p:txBody>
+          <a:bodyPr xmlns:a="http://schemas.openxmlformats.org/drawingml/2006/main" anchor="t"/>
+          <a:lstStyle xmlns:a="http://schemas.openxmlformats.org/drawingml/2006/main"/>
+          <a:p xmlns:a="http://schemas.openxmlformats.org/drawingml/2006/main">
+            <a:pPr algn="ctr">
+              <a:defRPr sz="3600" b="1">
+                <a:solidFill>
+                  <a:srgbClr val="B91C1C"/>
+                </a:solidFill>
+              </a:defRPr>
+            </a:pPr>
+            <a:r>
+              <a:rPr sz="3600" b="1">
+                <a:solidFill>
+                  <a:srgbClr val="B91C1C"/>
+                </a:solidFill>
+              </a:rPr>
+              <a:t>8 / 8</a:t>
+            </a:r>
+          </a:p>
+        </p:txBody>
+      </p:sp>
+      <p:sp>
+        <p:nvSpPr>
+          <p:cNvPr id="7" name="">
+            <a:extLst xmlns:a="http://schemas.openxmlformats.org/drawingml/2006/main">
+              <a:ext uri="{FF2B5EF4-FFF2-40B4-BE49-F238E27FC236}">
+                <a16:creationId xmlns:a16="http://schemas.microsoft.com/office/drawing/2014/main" id="{7F74B511-1B9E-4841-94D2-DBACEA63503A}"/>
+              </a:ext>
+            </a:extLst>
+          </p:cNvPr>
+          <p:cNvSpPr>
+            <a:spLocks xmlns:a="http://schemas.openxmlformats.org/drawingml/2006/main" noGrp="1"/>
+          </p:cNvSpPr>
+          <p:nvPr/>
+        </p:nvSpPr>
+        <p:spPr>
+          <a:xfrm xmlns:a="http://schemas.openxmlformats.org/drawingml/2006/main">
+            <a:off x="9505950" y="2628900"/>
+            <a:ext cx="1600200" cy="266700"/>
+          </a:xfrm>
+          <a:prstGeom xmlns:a="http://schemas.openxmlformats.org/drawingml/2006/main" prst="rect">
+            <a:avLst/>
+          </a:prstGeom>
+          <a:noFill xmlns:a="http://schemas.openxmlformats.org/drawingml/2006/main"/>
+          <a:ln xmlns:a="http://schemas.openxmlformats.org/drawingml/2006/main" w="0">
+            <a:noFill/>
+            <a:prstDash val="solid"/>
+          </a:ln>
+        </p:spPr>
+        <p:txBody>
+          <a:bodyPr xmlns:a="http://schemas.openxmlformats.org/drawingml/2006/main" anchor="t"/>
+          <a:lstStyle xmlns:a="http://schemas.openxmlformats.org/drawingml/2006/main"/>
+          <a:p xmlns:a="http://schemas.openxmlformats.org/drawingml/2006/main">
+            <a:pPr algn="ctr">
+              <a:defRPr sz="1275" b="0">
+                <a:solidFill>
+                  <a:srgbClr val="334155"/>
+                </a:solidFill>
+              </a:defRPr>
+            </a:pPr>
+            <a:r>
+              <a:rPr sz="1275" b="0">
+                <a:solidFill>
+                  <a:srgbClr val="334155"/>
+                </a:solidFill>
+              </a:rPr>
+              <a:t>H2D loads finished late</a:t>
+            </a:r>
+          </a:p>
+        </p:txBody>
+      </p:sp>
+      <p:sp>
+        <p:nvSpPr>
+          <p:cNvPr id="8" name="">
+            <a:extLst xmlns:a="http://schemas.openxmlformats.org/drawingml/2006/main">
+              <a:ext uri="{FF2B5EF4-FFF2-40B4-BE49-F238E27FC236}">
+                <a16:creationId xmlns:a16="http://schemas.microsoft.com/office/drawing/2014/main" id="{F191A9BD-D0E6-44BE-AD05-C608F17D0DB4}"/>
+              </a:ext>
+            </a:extLst>
+          </p:cNvPr>
+          <p:cNvSpPr>
+            <a:spLocks xmlns:a="http://schemas.openxmlformats.org/drawingml/2006/main" noGrp="1"/>
+          </p:cNvSpPr>
+          <p:nvPr/>
+        </p:nvSpPr>
+        <p:spPr>
+          <a:xfrm xmlns:a="http://schemas.openxmlformats.org/drawingml/2006/main">
+            <a:off x="9258300" y="3524250"/>
+            <a:ext cx="2095500" cy="742950"/>
           </a:xfrm>
           <a:prstGeom xmlns:a="http://schemas.openxmlformats.org/drawingml/2006/main" prst="rect">
             <a:avLst/>
@@ -8093,29 +9888,29 @@
           <a:lstStyle xmlns:a="http://schemas.openxmlformats.org/drawingml/2006/main"/>
           <a:p xmlns:a="http://schemas.openxmlformats.org/drawingml/2006/main">
             <a:pPr algn="l">
-              <a:defRPr sz="1275" b="0">
+              <a:defRPr sz="1575" b="0">
                 <a:solidFill>
                   <a:srgbClr val="334155"/>
                 </a:solidFill>
               </a:defRPr>
             </a:pPr>
             <a:r>
-              <a:rPr sz="1275" b="0">
+              <a:rPr sz="1575" b="0">
                 <a:solidFill>
                   <a:srgbClr val="334155"/>
                 </a:solidFill>
               </a:rPr>
-              <a:t>The stage markers separate submission, SGLang receive, scheduler queue/admit, and visible KV H2D movement.</a:t>
-            </a:r>
-          </a:p>
-        </p:txBody>
-      </p:sp>
-      <p:sp>
-        <p:nvSpPr>
-          <p:cNvPr id="6" name="">
-            <a:extLst xmlns:a="http://schemas.openxmlformats.org/drawingml/2006/main">
-              <a:ext uri="{FF2B5EF4-FFF2-40B4-BE49-F238E27FC236}">
-                <a16:creationId xmlns:a16="http://schemas.microsoft.com/office/drawing/2014/main" id="{940D003E-7BEE-4EC5-A130-939FD5C9AD61}"/>
+              <a:t>All visible replay-side KV loads finished below the 0 ms deadline line.</a:t>
+            </a:r>
+          </a:p>
+        </p:txBody>
+      </p:sp>
+      <p:sp>
+        <p:nvSpPr>
+          <p:cNvPr id="9" name="">
+            <a:extLst xmlns:a="http://schemas.openxmlformats.org/drawingml/2006/main">
+              <a:ext uri="{FF2B5EF4-FFF2-40B4-BE49-F238E27FC236}">
+                <a16:creationId xmlns:a16="http://schemas.microsoft.com/office/drawing/2014/main" id="{9E2CC8D2-F04E-44B5-97A2-0CD12CDF4131}"/>
               </a:ext>
             </a:extLst>
           </p:cNvPr>
@@ -8155,17 +9950,17 @@
                   <a:srgbClr val="64748B"/>
                 </a:solidFill>
               </a:rPr>
-              <a:t>Source: latest_master_report.html, Replay Queue Timeline vs H2D Start</a:t>
-            </a:r>
-          </a:p>
-        </p:txBody>
-      </p:sp>
-      <p:sp>
-        <p:nvSpPr>
-          <p:cNvPr id="7" name="">
-            <a:extLst xmlns:a="http://schemas.openxmlformats.org/drawingml/2006/main">
-              <a:ext uri="{FF2B5EF4-FFF2-40B4-BE49-F238E27FC236}">
-                <a16:creationId xmlns:a16="http://schemas.microsoft.com/office/drawing/2014/main" id="{72B9AC0E-AE27-4207-AA20-F5F9C3559210}"/>
+              <a:t>Source: latest_master_report.html, Global Replay H2D Readiness</a:t>
+            </a:r>
+          </a:p>
+        </p:txBody>
+      </p:sp>
+      <p:sp>
+        <p:nvSpPr>
+          <p:cNvPr id="10" name="">
+            <a:extLst xmlns:a="http://schemas.openxmlformats.org/drawingml/2006/main">
+              <a:ext uri="{FF2B5EF4-FFF2-40B4-BE49-F238E27FC236}">
+                <a16:creationId xmlns:a16="http://schemas.microsoft.com/office/drawing/2014/main" id="{7A1CC0CE-C2D7-4B3F-BE6F-67B3578AC330}"/>
               </a:ext>
             </a:extLst>
           </p:cNvPr>
@@ -8212,10 +10007,10 @@
       </p:sp>
       <p:sp>
         <p:nvSpPr>
-          <p:cNvPr id="8" name="">
-            <a:extLst xmlns:a="http://schemas.openxmlformats.org/drawingml/2006/main">
-              <a:ext uri="{FF2B5EF4-FFF2-40B4-BE49-F238E27FC236}">
-                <a16:creationId xmlns:a16="http://schemas.microsoft.com/office/drawing/2014/main" id="{15F71398-B653-4B92-91A1-FA5F8DCDC495}"/>
+          <p:cNvPr id="11" name="">
+            <a:extLst xmlns:a="http://schemas.openxmlformats.org/drawingml/2006/main">
+              <a:ext uri="{FF2B5EF4-FFF2-40B4-BE49-F238E27FC236}">
+                <a16:creationId xmlns:a16="http://schemas.microsoft.com/office/drawing/2014/main" id="{28822C22-DF86-44B2-BCB1-C8171CF456A0}"/>
               </a:ext>
             </a:extLst>
           </p:cNvPr>
@@ -8263,7 +10058,7 @@
     </p:spTree>
     <p:extLst>
       <p:ext uri="{BB962C8B-B14F-4D97-AF65-F5344CB8AC3E}">
-        <p14:creationId xmlns:p14="http://schemas.microsoft.com/office/powerpoint/2010/main" val="1447223750"/>
+        <p14:creationId xmlns:p14="http://schemas.microsoft.com/office/powerpoint/2010/main" val="2091445207"/>
       </p:ext>
     </p:extLst>
   </p:cSld>
@@ -8291,10 +10086,10 @@
       </p:grpSpPr>
       <p:sp>
         <p:nvSpPr>
-          <p:cNvPr id="27" name="">
-            <a:extLst xmlns:a="http://schemas.openxmlformats.org/drawingml/2006/main">
-              <a:ext uri="{FF2B5EF4-FFF2-40B4-BE49-F238E27FC236}">
-                <a16:creationId xmlns:a16="http://schemas.microsoft.com/office/drawing/2014/main" id="{2AD63010-72F3-43BC-874A-B4C35AFD7869}"/>
+          <p:cNvPr id="9" name="">
+            <a:extLst xmlns:a="http://schemas.openxmlformats.org/drawingml/2006/main">
+              <a:ext uri="{FF2B5EF4-FFF2-40B4-BE49-F238E27FC236}">
+                <a16:creationId xmlns:a16="http://schemas.microsoft.com/office/drawing/2014/main" id="{6CEF5D84-8BD8-4153-9201-B8605B844B10}"/>
               </a:ext>
             </a:extLst>
           </p:cNvPr>
@@ -8334,7 +10129,7 @@
                   <a:srgbClr val="0F172A"/>
                 </a:solidFill>
               </a:rPr>
-              <a:t>Hardware support can make hints enforceable</a:t>
+              <a:t>The delay is not just copy time</a:t>
             </a:r>
           </a:p>
         </p:txBody>
@@ -8344,7 +10139,7 @@
           <p:cNvPr id="2" name="">
             <a:extLst xmlns:a="http://schemas.openxmlformats.org/drawingml/2006/main">
               <a:ext uri="{FF2B5EF4-FFF2-40B4-BE49-F238E27FC236}">
-                <a16:creationId xmlns:a16="http://schemas.microsoft.com/office/drawing/2014/main" id="{BF388ED5-EC26-49D5-980F-3A91AAC602EA}"/>
+                <a16:creationId xmlns:a16="http://schemas.microsoft.com/office/drawing/2014/main" id="{5391E6EE-7B0E-4FA2-8310-C8BBEA91CE1C}"/>
               </a:ext>
             </a:extLst>
           </p:cNvPr>
@@ -8384,7 +10179,7 @@
                   <a:srgbClr val="64748B"/>
                 </a:solidFill>
               </a:rPr>
-              <a:t>The opportunity is to treat KV as deadline-sensitive memory, not generic bytes.</a:t>
+              <a:t>The request enters normal software/runtime scheduling before visible KV H2D begins.</a:t>
             </a:r>
           </a:p>
         </p:txBody>
@@ -8394,119 +10189,91 @@
           <p:cNvPr id="3" name="">
             <a:extLst xmlns:a="http://schemas.openxmlformats.org/drawingml/2006/main">
               <a:ext uri="{FF2B5EF4-FFF2-40B4-BE49-F238E27FC236}">
-                <a16:creationId xmlns:a16="http://schemas.microsoft.com/office/drawing/2014/main" id="{E0092D56-1D70-4C0D-9171-499148EB32D4}"/>
-              </a:ext>
-            </a:extLst>
-          </p:cNvPr>
-          <p:cNvSpPr>
-            <a:spLocks xmlns:a="http://schemas.openxmlformats.org/drawingml/2006/main" noGrp="1"/>
-          </p:cNvSpPr>
-          <p:nvPr/>
-        </p:nvSpPr>
-        <p:spPr>
-          <a:xfrm xmlns:a="http://schemas.openxmlformats.org/drawingml/2006/main">
-            <a:off x="552450" y="1962150"/>
-            <a:ext cx="1695450" cy="1695450"/>
+                <a16:creationId xmlns:a16="http://schemas.microsoft.com/office/drawing/2014/main" id="{A5A495FB-4327-499E-95E7-108260CD409D}"/>
+              </a:ext>
+            </a:extLst>
+          </p:cNvPr>
+          <p:cNvSpPr>
+            <a:spLocks xmlns:a="http://schemas.openxmlformats.org/drawingml/2006/main" noGrp="1"/>
+          </p:cNvSpPr>
+          <p:nvPr/>
+        </p:nvSpPr>
+        <p:spPr>
+          <a:xfrm xmlns:a="http://schemas.openxmlformats.org/drawingml/2006/main">
+            <a:off x="323850" y="1333500"/>
+            <a:ext cx="10820400" cy="4343400"/>
           </a:xfrm>
           <a:prstGeom xmlns:a="http://schemas.openxmlformats.org/drawingml/2006/main" prst="roundRect">
             <a:avLst>
-              <a:gd name="adj" fmla="val 3371"/>
+              <a:gd name="adj" fmla="val 1316"/>
             </a:avLst>
           </a:prstGeom>
           <a:solidFill xmlns:a="http://schemas.openxmlformats.org/drawingml/2006/main">
-            <a:srgbClr val="EFF6FF"/>
+            <a:srgbClr val="FFFFFF"/>
           </a:solidFill>
           <a:ln xmlns:a="http://schemas.openxmlformats.org/drawingml/2006/main" w="9525">
             <a:solidFill>
-              <a:srgbClr val="2563EB"/>
+              <a:srgbClr val="E5E7EB"/>
             </a:solidFill>
             <a:prstDash val="solid"/>
           </a:ln>
         </p:spPr>
       </p:sp>
-      <p:sp>
-        <p:nvSpPr>
-          <p:cNvPr id="4" name="">
-            <a:extLst xmlns:a="http://schemas.openxmlformats.org/drawingml/2006/main">
-              <a:ext uri="{FF2B5EF4-FFF2-40B4-BE49-F238E27FC236}">
-                <a16:creationId xmlns:a16="http://schemas.microsoft.com/office/drawing/2014/main" id="{FFA6716C-D257-4B7C-BE30-575D01AD6F3F}"/>
-              </a:ext>
-            </a:extLst>
-          </p:cNvPr>
-          <p:cNvSpPr>
-            <a:spLocks xmlns:a="http://schemas.openxmlformats.org/drawingml/2006/main" noGrp="1"/>
-          </p:cNvSpPr>
-          <p:nvPr/>
-        </p:nvSpPr>
-        <p:spPr>
-          <a:xfrm xmlns:a="http://schemas.openxmlformats.org/drawingml/2006/main">
-            <a:off x="704850" y="2228850"/>
-            <a:ext cx="1390650" cy="323850"/>
-          </a:xfrm>
-          <a:prstGeom xmlns:a="http://schemas.openxmlformats.org/drawingml/2006/main" prst="rect">
-            <a:avLst/>
-          </a:prstGeom>
-          <a:noFill xmlns:a="http://schemas.openxmlformats.org/drawingml/2006/main"/>
-          <a:ln xmlns:a="http://schemas.openxmlformats.org/drawingml/2006/main" w="0">
-            <a:noFill/>
-            <a:prstDash val="solid"/>
-          </a:ln>
-        </p:spPr>
-        <p:txBody>
-          <a:bodyPr xmlns:a="http://schemas.openxmlformats.org/drawingml/2006/main" anchor="t"/>
-          <a:lstStyle xmlns:a="http://schemas.openxmlformats.org/drawingml/2006/main"/>
-          <a:p xmlns:a="http://schemas.openxmlformats.org/drawingml/2006/main">
-            <a:pPr algn="ctr">
-              <a:defRPr sz="1650" b="1">
-                <a:solidFill>
-                  <a:srgbClr val="0F172A"/>
-                </a:solidFill>
-              </a:defRPr>
-            </a:pPr>
-            <a:r>
-              <a:rPr sz="1650" b="1">
-                <a:solidFill>
-                  <a:srgbClr val="0F172A"/>
-                </a:solidFill>
-              </a:rPr>
-              <a:t>Runtime hint</a:t>
-            </a:r>
-          </a:p>
-        </p:txBody>
-      </p:sp>
+      <p:pic>
+        <p:nvPicPr>
+          <p:cNvPr id="12" name=""/>
+          <p:cNvPicPr>
+            <a:picLocks xmlns:a="http://schemas.openxmlformats.org/drawingml/2006/main" noChangeAspect="1"/>
+          </p:cNvPicPr>
+          <p:nvPr/>
+        </p:nvPicPr>
+        <p:blipFill>
+          <a:blip xmlns:r="http://schemas.openxmlformats.org/officeDocument/2006/relationships" xmlns:a="http://schemas.openxmlformats.org/drawingml/2006/main" r:embed="R10ab5f9d2f2746c3"/>
+          <a:stretch xmlns:a="http://schemas.openxmlformats.org/drawingml/2006/main"/>
+        </p:blipFill>
+        <p:spPr>
+          <a:xfrm xmlns:a="http://schemas.openxmlformats.org/drawingml/2006/main">
+            <a:off x="1247835" y="1409700"/>
+            <a:ext cx="8972430" cy="4191000"/>
+          </a:xfrm>
+          <a:prstGeom xmlns:a="http://schemas.openxmlformats.org/drawingml/2006/main" prst="rect">
+            <a:avLst/>
+          </a:prstGeom>
+        </p:spPr>
+      </p:pic>
       <p:sp>
         <p:nvSpPr>
           <p:cNvPr id="5" name="">
             <a:extLst xmlns:a="http://schemas.openxmlformats.org/drawingml/2006/main">
               <a:ext uri="{FF2B5EF4-FFF2-40B4-BE49-F238E27FC236}">
-                <a16:creationId xmlns:a16="http://schemas.microsoft.com/office/drawing/2014/main" id="{8952EEFE-705B-4BF3-AD38-A155B63F8E00}"/>
-              </a:ext>
-            </a:extLst>
-          </p:cNvPr>
-          <p:cNvSpPr>
-            <a:spLocks xmlns:a="http://schemas.openxmlformats.org/drawingml/2006/main" noGrp="1"/>
-          </p:cNvSpPr>
-          <p:nvPr/>
-        </p:nvSpPr>
-        <p:spPr>
-          <a:xfrm xmlns:a="http://schemas.openxmlformats.org/drawingml/2006/main">
-            <a:off x="723900" y="2838450"/>
-            <a:ext cx="1352550" cy="533400"/>
-          </a:xfrm>
-          <a:prstGeom xmlns:a="http://schemas.openxmlformats.org/drawingml/2006/main" prst="rect">
-            <a:avLst/>
-          </a:prstGeom>
-          <a:noFill xmlns:a="http://schemas.openxmlformats.org/drawingml/2006/main"/>
-          <a:ln xmlns:a="http://schemas.openxmlformats.org/drawingml/2006/main" w="0">
-            <a:noFill/>
-            <a:prstDash val="solid"/>
-          </a:ln>
-        </p:spPr>
-        <p:txBody>
-          <a:bodyPr xmlns:a="http://schemas.openxmlformats.org/drawingml/2006/main" anchor="t"/>
-          <a:lstStyle xmlns:a="http://schemas.openxmlformats.org/drawingml/2006/main"/>
-          <a:p xmlns:a="http://schemas.openxmlformats.org/drawingml/2006/main">
-            <a:pPr algn="ctr">
+                <a16:creationId xmlns:a16="http://schemas.microsoft.com/office/drawing/2014/main" id="{FD004F01-8F39-4253-A54F-0C13C4E736FA}"/>
+              </a:ext>
+            </a:extLst>
+          </p:cNvPr>
+          <p:cNvSpPr>
+            <a:spLocks xmlns:a="http://schemas.openxmlformats.org/drawingml/2006/main" noGrp="1"/>
+          </p:cNvSpPr>
+          <p:nvPr/>
+        </p:nvSpPr>
+        <p:spPr>
+          <a:xfrm xmlns:a="http://schemas.openxmlformats.org/drawingml/2006/main">
+            <a:off x="685800" y="5791200"/>
+            <a:ext cx="9906000" cy="228600"/>
+          </a:xfrm>
+          <a:prstGeom xmlns:a="http://schemas.openxmlformats.org/drawingml/2006/main" prst="rect">
+            <a:avLst/>
+          </a:prstGeom>
+          <a:noFill xmlns:a="http://schemas.openxmlformats.org/drawingml/2006/main"/>
+          <a:ln xmlns:a="http://schemas.openxmlformats.org/drawingml/2006/main" w="0">
+            <a:noFill/>
+            <a:prstDash val="solid"/>
+          </a:ln>
+        </p:spPr>
+        <p:txBody>
+          <a:bodyPr xmlns:a="http://schemas.openxmlformats.org/drawingml/2006/main" anchor="t"/>
+          <a:lstStyle xmlns:a="http://schemas.openxmlformats.org/drawingml/2006/main"/>
+          <a:p xmlns:a="http://schemas.openxmlformats.org/drawingml/2006/main">
+            <a:pPr algn="l">
               <a:defRPr sz="1275" b="0">
                 <a:solidFill>
                   <a:srgbClr val="334155"/>
@@ -8519,7 +10286,7 @@
                   <a:srgbClr val="334155"/>
                 </a:solidFill>
               </a:rPr>
-              <a:t>session, priority, deadline</a:t>
+              <a:t>The stage markers separate submission, SGLang receive, scheduler queue/admit, and visible KV H2D movement.</a:t>
             </a:r>
           </a:p>
         </p:txBody>
@@ -8529,47 +10296,47 @@
           <p:cNvPr id="6" name="">
             <a:extLst xmlns:a="http://schemas.openxmlformats.org/drawingml/2006/main">
               <a:ext uri="{FF2B5EF4-FFF2-40B4-BE49-F238E27FC236}">
-                <a16:creationId xmlns:a16="http://schemas.microsoft.com/office/drawing/2014/main" id="{F2C79B21-6E3E-4DA4-B3C7-AB0E0B4C940D}"/>
-              </a:ext>
-            </a:extLst>
-          </p:cNvPr>
-          <p:cNvSpPr>
-            <a:spLocks xmlns:a="http://schemas.openxmlformats.org/drawingml/2006/main" noGrp="1"/>
-          </p:cNvSpPr>
-          <p:nvPr/>
-        </p:nvSpPr>
-        <p:spPr>
-          <a:xfrm xmlns:a="http://schemas.openxmlformats.org/drawingml/2006/main">
-            <a:off x="2305050" y="2552700"/>
-            <a:ext cx="476250" cy="476250"/>
-          </a:xfrm>
-          <a:prstGeom xmlns:a="http://schemas.openxmlformats.org/drawingml/2006/main" prst="rect">
-            <a:avLst/>
-          </a:prstGeom>
-          <a:noFill xmlns:a="http://schemas.openxmlformats.org/drawingml/2006/main"/>
-          <a:ln xmlns:a="http://schemas.openxmlformats.org/drawingml/2006/main" w="0">
-            <a:noFill/>
-            <a:prstDash val="solid"/>
-          </a:ln>
-        </p:spPr>
-        <p:txBody>
-          <a:bodyPr xmlns:a="http://schemas.openxmlformats.org/drawingml/2006/main" anchor="t"/>
-          <a:lstStyle xmlns:a="http://schemas.openxmlformats.org/drawingml/2006/main"/>
-          <a:p xmlns:a="http://schemas.openxmlformats.org/drawingml/2006/main">
-            <a:pPr algn="ctr">
-              <a:defRPr sz="2550" b="1">
-                <a:solidFill>
-                  <a:srgbClr val="64748B"/>
-                </a:solidFill>
-              </a:defRPr>
-            </a:pPr>
-            <a:r>
-              <a:rPr sz="2550" b="1">
-                <a:solidFill>
-                  <a:srgbClr val="64748B"/>
-                </a:solidFill>
-              </a:rPr>
-              <a:t>→</a:t>
+                <a16:creationId xmlns:a16="http://schemas.microsoft.com/office/drawing/2014/main" id="{DAF4585C-DAD1-4142-887B-94740EAE2140}"/>
+              </a:ext>
+            </a:extLst>
+          </p:cNvPr>
+          <p:cNvSpPr>
+            <a:spLocks xmlns:a="http://schemas.openxmlformats.org/drawingml/2006/main" noGrp="1"/>
+          </p:cNvSpPr>
+          <p:nvPr/>
+        </p:nvSpPr>
+        <p:spPr>
+          <a:xfrm xmlns:a="http://schemas.openxmlformats.org/drawingml/2006/main">
+            <a:off x="400050" y="6153150"/>
+            <a:ext cx="7810500" cy="190500"/>
+          </a:xfrm>
+          <a:prstGeom xmlns:a="http://schemas.openxmlformats.org/drawingml/2006/main" prst="rect">
+            <a:avLst/>
+          </a:prstGeom>
+          <a:noFill xmlns:a="http://schemas.openxmlformats.org/drawingml/2006/main"/>
+          <a:ln xmlns:a="http://schemas.openxmlformats.org/drawingml/2006/main" w="0">
+            <a:noFill/>
+            <a:prstDash val="solid"/>
+          </a:ln>
+        </p:spPr>
+        <p:txBody>
+          <a:bodyPr xmlns:a="http://schemas.openxmlformats.org/drawingml/2006/main" anchor="t"/>
+          <a:lstStyle xmlns:a="http://schemas.openxmlformats.org/drawingml/2006/main"/>
+          <a:p xmlns:a="http://schemas.openxmlformats.org/drawingml/2006/main">
+            <a:pPr algn="l">
+              <a:defRPr sz="825" b="0">
+                <a:solidFill>
+                  <a:srgbClr val="64748B"/>
+                </a:solidFill>
+              </a:defRPr>
+            </a:pPr>
+            <a:r>
+              <a:rPr sz="825" b="0">
+                <a:solidFill>
+                  <a:srgbClr val="64748B"/>
+                </a:solidFill>
+              </a:rPr>
+              <a:t>Source: latest_master_report.html, Replay Queue Timeline vs H2D Start</a:t>
             </a:r>
           </a:p>
         </p:txBody>
@@ -8579,832 +10346,7 @@
           <p:cNvPr id="7" name="">
             <a:extLst xmlns:a="http://schemas.openxmlformats.org/drawingml/2006/main">
               <a:ext uri="{FF2B5EF4-FFF2-40B4-BE49-F238E27FC236}">
-                <a16:creationId xmlns:a16="http://schemas.microsoft.com/office/drawing/2014/main" id="{072CDDCC-8365-4E38-812E-A3405E3F9F82}"/>
-              </a:ext>
-            </a:extLst>
-          </p:cNvPr>
-          <p:cNvSpPr>
-            <a:spLocks xmlns:a="http://schemas.openxmlformats.org/drawingml/2006/main" noGrp="1"/>
-          </p:cNvSpPr>
-          <p:nvPr/>
-        </p:nvSpPr>
-        <p:spPr>
-          <a:xfrm xmlns:a="http://schemas.openxmlformats.org/drawingml/2006/main">
-            <a:off x="2857500" y="1962150"/>
-            <a:ext cx="1695450" cy="1695450"/>
-          </a:xfrm>
-          <a:prstGeom xmlns:a="http://schemas.openxmlformats.org/drawingml/2006/main" prst="roundRect">
-            <a:avLst>
-              <a:gd name="adj" fmla="val 3371"/>
-            </a:avLst>
-          </a:prstGeom>
-          <a:solidFill xmlns:a="http://schemas.openxmlformats.org/drawingml/2006/main">
-            <a:srgbClr val="F5F3FF"/>
-          </a:solidFill>
-          <a:ln xmlns:a="http://schemas.openxmlformats.org/drawingml/2006/main" w="9525">
-            <a:solidFill>
-              <a:srgbClr val="A855F7"/>
-            </a:solidFill>
-            <a:prstDash val="solid"/>
-          </a:ln>
-        </p:spPr>
-      </p:sp>
-      <p:sp>
-        <p:nvSpPr>
-          <p:cNvPr id="8" name="">
-            <a:extLst xmlns:a="http://schemas.openxmlformats.org/drawingml/2006/main">
-              <a:ext uri="{FF2B5EF4-FFF2-40B4-BE49-F238E27FC236}">
-                <a16:creationId xmlns:a16="http://schemas.microsoft.com/office/drawing/2014/main" id="{521C4A3C-E8A9-48B7-8777-B7ACE410042B}"/>
-              </a:ext>
-            </a:extLst>
-          </p:cNvPr>
-          <p:cNvSpPr>
-            <a:spLocks xmlns:a="http://schemas.openxmlformats.org/drawingml/2006/main" noGrp="1"/>
-          </p:cNvSpPr>
-          <p:nvPr/>
-        </p:nvSpPr>
-        <p:spPr>
-          <a:xfrm xmlns:a="http://schemas.openxmlformats.org/drawingml/2006/main">
-            <a:off x="3009900" y="2228850"/>
-            <a:ext cx="1390650" cy="323850"/>
-          </a:xfrm>
-          <a:prstGeom xmlns:a="http://schemas.openxmlformats.org/drawingml/2006/main" prst="rect">
-            <a:avLst/>
-          </a:prstGeom>
-          <a:noFill xmlns:a="http://schemas.openxmlformats.org/drawingml/2006/main"/>
-          <a:ln xmlns:a="http://schemas.openxmlformats.org/drawingml/2006/main" w="0">
-            <a:noFill/>
-            <a:prstDash val="solid"/>
-          </a:ln>
-        </p:spPr>
-        <p:txBody>
-          <a:bodyPr xmlns:a="http://schemas.openxmlformats.org/drawingml/2006/main" anchor="t"/>
-          <a:lstStyle xmlns:a="http://schemas.openxmlformats.org/drawingml/2006/main"/>
-          <a:p xmlns:a="http://schemas.openxmlformats.org/drawingml/2006/main">
-            <a:pPr algn="ctr">
-              <a:defRPr sz="1650" b="1">
-                <a:solidFill>
-                  <a:srgbClr val="0F172A"/>
-                </a:solidFill>
-              </a:defRPr>
-            </a:pPr>
-            <a:r>
-              <a:rPr sz="1650" b="1">
-                <a:solidFill>
-                  <a:srgbClr val="0F172A"/>
-                </a:solidFill>
-              </a:rPr>
-              <a:t>KV-aware queue</a:t>
-            </a:r>
-          </a:p>
-        </p:txBody>
-      </p:sp>
-      <p:sp>
-        <p:nvSpPr>
-          <p:cNvPr id="9" name="">
-            <a:extLst xmlns:a="http://schemas.openxmlformats.org/drawingml/2006/main">
-              <a:ext uri="{FF2B5EF4-FFF2-40B4-BE49-F238E27FC236}">
-                <a16:creationId xmlns:a16="http://schemas.microsoft.com/office/drawing/2014/main" id="{CEDDC49B-9888-4BA0-8EF4-9C70F4297D43}"/>
-              </a:ext>
-            </a:extLst>
-          </p:cNvPr>
-          <p:cNvSpPr>
-            <a:spLocks xmlns:a="http://schemas.openxmlformats.org/drawingml/2006/main" noGrp="1"/>
-          </p:cNvSpPr>
-          <p:nvPr/>
-        </p:nvSpPr>
-        <p:spPr>
-          <a:xfrm xmlns:a="http://schemas.openxmlformats.org/drawingml/2006/main">
-            <a:off x="3028950" y="2838450"/>
-            <a:ext cx="1352550" cy="533400"/>
-          </a:xfrm>
-          <a:prstGeom xmlns:a="http://schemas.openxmlformats.org/drawingml/2006/main" prst="rect">
-            <a:avLst/>
-          </a:prstGeom>
-          <a:noFill xmlns:a="http://schemas.openxmlformats.org/drawingml/2006/main"/>
-          <a:ln xmlns:a="http://schemas.openxmlformats.org/drawingml/2006/main" w="0">
-            <a:noFill/>
-            <a:prstDash val="solid"/>
-          </a:ln>
-        </p:spPr>
-        <p:txBody>
-          <a:bodyPr xmlns:a="http://schemas.openxmlformats.org/drawingml/2006/main" anchor="t"/>
-          <a:lstStyle xmlns:a="http://schemas.openxmlformats.org/drawingml/2006/main"/>
-          <a:p xmlns:a="http://schemas.openxmlformats.org/drawingml/2006/main">
-            <a:pPr algn="ctr">
-              <a:defRPr sz="1275" b="0">
-                <a:solidFill>
-                  <a:srgbClr val="334155"/>
-                </a:solidFill>
-              </a:defRPr>
-            </a:pPr>
-            <a:r>
-              <a:rPr sz="1275" b="0">
-                <a:solidFill>
-                  <a:srgbClr val="334155"/>
-                </a:solidFill>
-              </a:rPr>
-              <a:t>order urgent KV first</a:t>
-            </a:r>
-          </a:p>
-        </p:txBody>
-      </p:sp>
-      <p:sp>
-        <p:nvSpPr>
-          <p:cNvPr id="10" name="">
-            <a:extLst xmlns:a="http://schemas.openxmlformats.org/drawingml/2006/main">
-              <a:ext uri="{FF2B5EF4-FFF2-40B4-BE49-F238E27FC236}">
-                <a16:creationId xmlns:a16="http://schemas.microsoft.com/office/drawing/2014/main" id="{7A943085-BFFD-4E65-B50A-35BA44D2D35F}"/>
-              </a:ext>
-            </a:extLst>
-          </p:cNvPr>
-          <p:cNvSpPr>
-            <a:spLocks xmlns:a="http://schemas.openxmlformats.org/drawingml/2006/main" noGrp="1"/>
-          </p:cNvSpPr>
-          <p:nvPr/>
-        </p:nvSpPr>
-        <p:spPr>
-          <a:xfrm xmlns:a="http://schemas.openxmlformats.org/drawingml/2006/main">
-            <a:off x="4610100" y="2552700"/>
-            <a:ext cx="476250" cy="476250"/>
-          </a:xfrm>
-          <a:prstGeom xmlns:a="http://schemas.openxmlformats.org/drawingml/2006/main" prst="rect">
-            <a:avLst/>
-          </a:prstGeom>
-          <a:noFill xmlns:a="http://schemas.openxmlformats.org/drawingml/2006/main"/>
-          <a:ln xmlns:a="http://schemas.openxmlformats.org/drawingml/2006/main" w="0">
-            <a:noFill/>
-            <a:prstDash val="solid"/>
-          </a:ln>
-        </p:spPr>
-        <p:txBody>
-          <a:bodyPr xmlns:a="http://schemas.openxmlformats.org/drawingml/2006/main" anchor="t"/>
-          <a:lstStyle xmlns:a="http://schemas.openxmlformats.org/drawingml/2006/main"/>
-          <a:p xmlns:a="http://schemas.openxmlformats.org/drawingml/2006/main">
-            <a:pPr algn="ctr">
-              <a:defRPr sz="2550" b="1">
-                <a:solidFill>
-                  <a:srgbClr val="64748B"/>
-                </a:solidFill>
-              </a:defRPr>
-            </a:pPr>
-            <a:r>
-              <a:rPr sz="2550" b="1">
-                <a:solidFill>
-                  <a:srgbClr val="64748B"/>
-                </a:solidFill>
-              </a:rPr>
-              <a:t>→</a:t>
-            </a:r>
-          </a:p>
-        </p:txBody>
-      </p:sp>
-      <p:sp>
-        <p:nvSpPr>
-          <p:cNvPr id="11" name="">
-            <a:extLst xmlns:a="http://schemas.openxmlformats.org/drawingml/2006/main">
-              <a:ext uri="{FF2B5EF4-FFF2-40B4-BE49-F238E27FC236}">
-                <a16:creationId xmlns:a16="http://schemas.microsoft.com/office/drawing/2014/main" id="{BCA44681-C801-4B02-AE19-1E6E116E3845}"/>
-              </a:ext>
-            </a:extLst>
-          </p:cNvPr>
-          <p:cNvSpPr>
-            <a:spLocks xmlns:a="http://schemas.openxmlformats.org/drawingml/2006/main" noGrp="1"/>
-          </p:cNvSpPr>
-          <p:nvPr/>
-        </p:nvSpPr>
-        <p:spPr>
-          <a:xfrm xmlns:a="http://schemas.openxmlformats.org/drawingml/2006/main">
-            <a:off x="5162550" y="1962150"/>
-            <a:ext cx="1695450" cy="1695450"/>
-          </a:xfrm>
-          <a:prstGeom xmlns:a="http://schemas.openxmlformats.org/drawingml/2006/main" prst="roundRect">
-            <a:avLst>
-              <a:gd name="adj" fmla="val 3371"/>
-            </a:avLst>
-          </a:prstGeom>
-          <a:solidFill xmlns:a="http://schemas.openxmlformats.org/drawingml/2006/main">
-            <a:srgbClr val="ECFEFF"/>
-          </a:solidFill>
-          <a:ln xmlns:a="http://schemas.openxmlformats.org/drawingml/2006/main" w="9525">
-            <a:solidFill>
-              <a:srgbClr val="06B6D4"/>
-            </a:solidFill>
-            <a:prstDash val="solid"/>
-          </a:ln>
-        </p:spPr>
-      </p:sp>
-      <p:sp>
-        <p:nvSpPr>
-          <p:cNvPr id="12" name="">
-            <a:extLst xmlns:a="http://schemas.openxmlformats.org/drawingml/2006/main">
-              <a:ext uri="{FF2B5EF4-FFF2-40B4-BE49-F238E27FC236}">
-                <a16:creationId xmlns:a16="http://schemas.microsoft.com/office/drawing/2014/main" id="{815A6AD4-39FF-4C1F-91AF-2B0BB446CFE9}"/>
-              </a:ext>
-            </a:extLst>
-          </p:cNvPr>
-          <p:cNvSpPr>
-            <a:spLocks xmlns:a="http://schemas.openxmlformats.org/drawingml/2006/main" noGrp="1"/>
-          </p:cNvSpPr>
-          <p:nvPr/>
-        </p:nvSpPr>
-        <p:spPr>
-          <a:xfrm xmlns:a="http://schemas.openxmlformats.org/drawingml/2006/main">
-            <a:off x="5314950" y="2228850"/>
-            <a:ext cx="1390650" cy="323850"/>
-          </a:xfrm>
-          <a:prstGeom xmlns:a="http://schemas.openxmlformats.org/drawingml/2006/main" prst="rect">
-            <a:avLst/>
-          </a:prstGeom>
-          <a:noFill xmlns:a="http://schemas.openxmlformats.org/drawingml/2006/main"/>
-          <a:ln xmlns:a="http://schemas.openxmlformats.org/drawingml/2006/main" w="0">
-            <a:noFill/>
-            <a:prstDash val="solid"/>
-          </a:ln>
-        </p:spPr>
-        <p:txBody>
-          <a:bodyPr xmlns:a="http://schemas.openxmlformats.org/drawingml/2006/main" anchor="t"/>
-          <a:lstStyle xmlns:a="http://schemas.openxmlformats.org/drawingml/2006/main"/>
-          <a:p xmlns:a="http://schemas.openxmlformats.org/drawingml/2006/main">
-            <a:pPr algn="ctr">
-              <a:defRPr sz="1650" b="1">
-                <a:solidFill>
-                  <a:srgbClr val="0F172A"/>
-                </a:solidFill>
-              </a:defRPr>
-            </a:pPr>
-            <a:r>
-              <a:rPr sz="1650" b="1">
-                <a:solidFill>
-                  <a:srgbClr val="0F172A"/>
-                </a:solidFill>
-              </a:rPr>
-              <a:t>DMA / copy engine</a:t>
-            </a:r>
-          </a:p>
-        </p:txBody>
-      </p:sp>
-      <p:sp>
-        <p:nvSpPr>
-          <p:cNvPr id="13" name="">
-            <a:extLst xmlns:a="http://schemas.openxmlformats.org/drawingml/2006/main">
-              <a:ext uri="{FF2B5EF4-FFF2-40B4-BE49-F238E27FC236}">
-                <a16:creationId xmlns:a16="http://schemas.microsoft.com/office/drawing/2014/main" id="{1FBAC9FC-5A16-4D00-BF0A-705157BA3A26}"/>
-              </a:ext>
-            </a:extLst>
-          </p:cNvPr>
-          <p:cNvSpPr>
-            <a:spLocks xmlns:a="http://schemas.openxmlformats.org/drawingml/2006/main" noGrp="1"/>
-          </p:cNvSpPr>
-          <p:nvPr/>
-        </p:nvSpPr>
-        <p:spPr>
-          <a:xfrm xmlns:a="http://schemas.openxmlformats.org/drawingml/2006/main">
-            <a:off x="5334000" y="2838450"/>
-            <a:ext cx="1352550" cy="533400"/>
-          </a:xfrm>
-          <a:prstGeom xmlns:a="http://schemas.openxmlformats.org/drawingml/2006/main" prst="rect">
-            <a:avLst/>
-          </a:prstGeom>
-          <a:noFill xmlns:a="http://schemas.openxmlformats.org/drawingml/2006/main"/>
-          <a:ln xmlns:a="http://schemas.openxmlformats.org/drawingml/2006/main" w="0">
-            <a:noFill/>
-            <a:prstDash val="solid"/>
-          </a:ln>
-        </p:spPr>
-        <p:txBody>
-          <a:bodyPr xmlns:a="http://schemas.openxmlformats.org/drawingml/2006/main" anchor="t"/>
-          <a:lstStyle xmlns:a="http://schemas.openxmlformats.org/drawingml/2006/main"/>
-          <a:p xmlns:a="http://schemas.openxmlformats.org/drawingml/2006/main">
-            <a:pPr algn="ctr">
-              <a:defRPr sz="1275" b="0">
-                <a:solidFill>
-                  <a:srgbClr val="334155"/>
-                </a:solidFill>
-              </a:defRPr>
-            </a:pPr>
-            <a:r>
-              <a:rPr sz="1275" b="0">
-                <a:solidFill>
-                  <a:srgbClr val="334155"/>
-                </a:solidFill>
-              </a:rPr>
-              <a:t>throttle and prioritize</a:t>
-            </a:r>
-          </a:p>
-        </p:txBody>
-      </p:sp>
-      <p:sp>
-        <p:nvSpPr>
-          <p:cNvPr id="14" name="">
-            <a:extLst xmlns:a="http://schemas.openxmlformats.org/drawingml/2006/main">
-              <a:ext uri="{FF2B5EF4-FFF2-40B4-BE49-F238E27FC236}">
-                <a16:creationId xmlns:a16="http://schemas.microsoft.com/office/drawing/2014/main" id="{2A6D27E1-ACD8-4452-9B41-B79EF6C0FC2A}"/>
-              </a:ext>
-            </a:extLst>
-          </p:cNvPr>
-          <p:cNvSpPr>
-            <a:spLocks xmlns:a="http://schemas.openxmlformats.org/drawingml/2006/main" noGrp="1"/>
-          </p:cNvSpPr>
-          <p:nvPr/>
-        </p:nvSpPr>
-        <p:spPr>
-          <a:xfrm xmlns:a="http://schemas.openxmlformats.org/drawingml/2006/main">
-            <a:off x="6915150" y="2552700"/>
-            <a:ext cx="476250" cy="476250"/>
-          </a:xfrm>
-          <a:prstGeom xmlns:a="http://schemas.openxmlformats.org/drawingml/2006/main" prst="rect">
-            <a:avLst/>
-          </a:prstGeom>
-          <a:noFill xmlns:a="http://schemas.openxmlformats.org/drawingml/2006/main"/>
-          <a:ln xmlns:a="http://schemas.openxmlformats.org/drawingml/2006/main" w="0">
-            <a:noFill/>
-            <a:prstDash val="solid"/>
-          </a:ln>
-        </p:spPr>
-        <p:txBody>
-          <a:bodyPr xmlns:a="http://schemas.openxmlformats.org/drawingml/2006/main" anchor="t"/>
-          <a:lstStyle xmlns:a="http://schemas.openxmlformats.org/drawingml/2006/main"/>
-          <a:p xmlns:a="http://schemas.openxmlformats.org/drawingml/2006/main">
-            <a:pPr algn="ctr">
-              <a:defRPr sz="2550" b="1">
-                <a:solidFill>
-                  <a:srgbClr val="64748B"/>
-                </a:solidFill>
-              </a:defRPr>
-            </a:pPr>
-            <a:r>
-              <a:rPr sz="2550" b="1">
-                <a:solidFill>
-                  <a:srgbClr val="64748B"/>
-                </a:solidFill>
-              </a:rPr>
-              <a:t>→</a:t>
-            </a:r>
-          </a:p>
-        </p:txBody>
-      </p:sp>
-      <p:sp>
-        <p:nvSpPr>
-          <p:cNvPr id="15" name="">
-            <a:extLst xmlns:a="http://schemas.openxmlformats.org/drawingml/2006/main">
-              <a:ext uri="{FF2B5EF4-FFF2-40B4-BE49-F238E27FC236}">
-                <a16:creationId xmlns:a16="http://schemas.microsoft.com/office/drawing/2014/main" id="{AB485DD5-B630-47AD-88A4-F9549735FCEC}"/>
-              </a:ext>
-            </a:extLst>
-          </p:cNvPr>
-          <p:cNvSpPr>
-            <a:spLocks xmlns:a="http://schemas.openxmlformats.org/drawingml/2006/main" noGrp="1"/>
-          </p:cNvSpPr>
-          <p:nvPr/>
-        </p:nvSpPr>
-        <p:spPr>
-          <a:xfrm xmlns:a="http://schemas.openxmlformats.org/drawingml/2006/main">
-            <a:off x="7467600" y="1962150"/>
-            <a:ext cx="1695450" cy="1695450"/>
-          </a:xfrm>
-          <a:prstGeom xmlns:a="http://schemas.openxmlformats.org/drawingml/2006/main" prst="roundRect">
-            <a:avLst>
-              <a:gd name="adj" fmla="val 3371"/>
-            </a:avLst>
-          </a:prstGeom>
-          <a:solidFill xmlns:a="http://schemas.openxmlformats.org/drawingml/2006/main">
-            <a:srgbClr val="F0FDF4"/>
-          </a:solidFill>
-          <a:ln xmlns:a="http://schemas.openxmlformats.org/drawingml/2006/main" w="9525">
-            <a:solidFill>
-              <a:srgbClr val="16A34A"/>
-            </a:solidFill>
-            <a:prstDash val="solid"/>
-          </a:ln>
-        </p:spPr>
-      </p:sp>
-      <p:sp>
-        <p:nvSpPr>
-          <p:cNvPr id="16" name="">
-            <a:extLst xmlns:a="http://schemas.openxmlformats.org/drawingml/2006/main">
-              <a:ext uri="{FF2B5EF4-FFF2-40B4-BE49-F238E27FC236}">
-                <a16:creationId xmlns:a16="http://schemas.microsoft.com/office/drawing/2014/main" id="{D89EA56F-C88E-4520-B75B-49894E4BC3CA}"/>
-              </a:ext>
-            </a:extLst>
-          </p:cNvPr>
-          <p:cNvSpPr>
-            <a:spLocks xmlns:a="http://schemas.openxmlformats.org/drawingml/2006/main" noGrp="1"/>
-          </p:cNvSpPr>
-          <p:nvPr/>
-        </p:nvSpPr>
-        <p:spPr>
-          <a:xfrm xmlns:a="http://schemas.openxmlformats.org/drawingml/2006/main">
-            <a:off x="7620000" y="2228850"/>
-            <a:ext cx="1390650" cy="323850"/>
-          </a:xfrm>
-          <a:prstGeom xmlns:a="http://schemas.openxmlformats.org/drawingml/2006/main" prst="rect">
-            <a:avLst/>
-          </a:prstGeom>
-          <a:noFill xmlns:a="http://schemas.openxmlformats.org/drawingml/2006/main"/>
-          <a:ln xmlns:a="http://schemas.openxmlformats.org/drawingml/2006/main" w="0">
-            <a:noFill/>
-            <a:prstDash val="solid"/>
-          </a:ln>
-        </p:spPr>
-        <p:txBody>
-          <a:bodyPr xmlns:a="http://schemas.openxmlformats.org/drawingml/2006/main" anchor="t"/>
-          <a:lstStyle xmlns:a="http://schemas.openxmlformats.org/drawingml/2006/main"/>
-          <a:p xmlns:a="http://schemas.openxmlformats.org/drawingml/2006/main">
-            <a:pPr algn="ctr">
-              <a:defRPr sz="1650" b="1">
-                <a:solidFill>
-                  <a:srgbClr val="0F172A"/>
-                </a:solidFill>
-              </a:defRPr>
-            </a:pPr>
-            <a:r>
-              <a:rPr sz="1650" b="1">
-                <a:solidFill>
-                  <a:srgbClr val="0F172A"/>
-                </a:solidFill>
-              </a:rPr>
-              <a:t>Residency control</a:t>
-            </a:r>
-          </a:p>
-        </p:txBody>
-      </p:sp>
-      <p:sp>
-        <p:nvSpPr>
-          <p:cNvPr id="17" name="">
-            <a:extLst xmlns:a="http://schemas.openxmlformats.org/drawingml/2006/main">
-              <a:ext uri="{FF2B5EF4-FFF2-40B4-BE49-F238E27FC236}">
-                <a16:creationId xmlns:a16="http://schemas.microsoft.com/office/drawing/2014/main" id="{EC379D16-E777-410C-A09D-A97E765A70F4}"/>
-              </a:ext>
-            </a:extLst>
-          </p:cNvPr>
-          <p:cNvSpPr>
-            <a:spLocks xmlns:a="http://schemas.openxmlformats.org/drawingml/2006/main" noGrp="1"/>
-          </p:cNvSpPr>
-          <p:nvPr/>
-        </p:nvSpPr>
-        <p:spPr>
-          <a:xfrm xmlns:a="http://schemas.openxmlformats.org/drawingml/2006/main">
-            <a:off x="7639050" y="2838450"/>
-            <a:ext cx="1352550" cy="533400"/>
-          </a:xfrm>
-          <a:prstGeom xmlns:a="http://schemas.openxmlformats.org/drawingml/2006/main" prst="rect">
-            <a:avLst/>
-          </a:prstGeom>
-          <a:noFill xmlns:a="http://schemas.openxmlformats.org/drawingml/2006/main"/>
-          <a:ln xmlns:a="http://schemas.openxmlformats.org/drawingml/2006/main" w="0">
-            <a:noFill/>
-            <a:prstDash val="solid"/>
-          </a:ln>
-        </p:spPr>
-        <p:txBody>
-          <a:bodyPr xmlns:a="http://schemas.openxmlformats.org/drawingml/2006/main" anchor="t"/>
-          <a:lstStyle xmlns:a="http://schemas.openxmlformats.org/drawingml/2006/main"/>
-          <a:p xmlns:a="http://schemas.openxmlformats.org/drawingml/2006/main">
-            <a:pPr algn="ctr">
-              <a:defRPr sz="1275" b="0">
-                <a:solidFill>
-                  <a:srgbClr val="334155"/>
-                </a:solidFill>
-              </a:defRPr>
-            </a:pPr>
-            <a:r>
-              <a:rPr sz="1275" b="0">
-                <a:solidFill>
-                  <a:srgbClr val="334155"/>
-                </a:solidFill>
-              </a:rPr>
-              <a:t>protect useful KV</a:t>
-            </a:r>
-          </a:p>
-        </p:txBody>
-      </p:sp>
-      <p:sp>
-        <p:nvSpPr>
-          <p:cNvPr id="18" name="">
-            <a:extLst xmlns:a="http://schemas.openxmlformats.org/drawingml/2006/main">
-              <a:ext uri="{FF2B5EF4-FFF2-40B4-BE49-F238E27FC236}">
-                <a16:creationId xmlns:a16="http://schemas.microsoft.com/office/drawing/2014/main" id="{C96EF447-5860-49BF-8461-2669CDE2134E}"/>
-              </a:ext>
-            </a:extLst>
-          </p:cNvPr>
-          <p:cNvSpPr>
-            <a:spLocks xmlns:a="http://schemas.openxmlformats.org/drawingml/2006/main" noGrp="1"/>
-          </p:cNvSpPr>
-          <p:nvPr/>
-        </p:nvSpPr>
-        <p:spPr>
-          <a:xfrm xmlns:a="http://schemas.openxmlformats.org/drawingml/2006/main">
-            <a:off x="9220200" y="2552700"/>
-            <a:ext cx="476250" cy="476250"/>
-          </a:xfrm>
-          <a:prstGeom xmlns:a="http://schemas.openxmlformats.org/drawingml/2006/main" prst="rect">
-            <a:avLst/>
-          </a:prstGeom>
-          <a:noFill xmlns:a="http://schemas.openxmlformats.org/drawingml/2006/main"/>
-          <a:ln xmlns:a="http://schemas.openxmlformats.org/drawingml/2006/main" w="0">
-            <a:noFill/>
-            <a:prstDash val="solid"/>
-          </a:ln>
-        </p:spPr>
-        <p:txBody>
-          <a:bodyPr xmlns:a="http://schemas.openxmlformats.org/drawingml/2006/main" anchor="t"/>
-          <a:lstStyle xmlns:a="http://schemas.openxmlformats.org/drawingml/2006/main"/>
-          <a:p xmlns:a="http://schemas.openxmlformats.org/drawingml/2006/main">
-            <a:pPr algn="ctr">
-              <a:defRPr sz="2550" b="1">
-                <a:solidFill>
-                  <a:srgbClr val="64748B"/>
-                </a:solidFill>
-              </a:defRPr>
-            </a:pPr>
-            <a:r>
-              <a:rPr sz="2550" b="1">
-                <a:solidFill>
-                  <a:srgbClr val="64748B"/>
-                </a:solidFill>
-              </a:rPr>
-              <a:t>→</a:t>
-            </a:r>
-          </a:p>
-        </p:txBody>
-      </p:sp>
-      <p:sp>
-        <p:nvSpPr>
-          <p:cNvPr id="19" name="">
-            <a:extLst xmlns:a="http://schemas.openxmlformats.org/drawingml/2006/main">
-              <a:ext uri="{FF2B5EF4-FFF2-40B4-BE49-F238E27FC236}">
-                <a16:creationId xmlns:a16="http://schemas.microsoft.com/office/drawing/2014/main" id="{51A0AA63-D822-4C25-BEC4-C669493AB867}"/>
-              </a:ext>
-            </a:extLst>
-          </p:cNvPr>
-          <p:cNvSpPr>
-            <a:spLocks xmlns:a="http://schemas.openxmlformats.org/drawingml/2006/main" noGrp="1"/>
-          </p:cNvSpPr>
-          <p:nvPr/>
-        </p:nvSpPr>
-        <p:spPr>
-          <a:xfrm xmlns:a="http://schemas.openxmlformats.org/drawingml/2006/main">
-            <a:off x="9772650" y="1962150"/>
-            <a:ext cx="1695450" cy="1695450"/>
-          </a:xfrm>
-          <a:prstGeom xmlns:a="http://schemas.openxmlformats.org/drawingml/2006/main" prst="roundRect">
-            <a:avLst>
-              <a:gd name="adj" fmla="val 3371"/>
-            </a:avLst>
-          </a:prstGeom>
-          <a:solidFill xmlns:a="http://schemas.openxmlformats.org/drawingml/2006/main">
-            <a:srgbClr val="FFF7ED"/>
-          </a:solidFill>
-          <a:ln xmlns:a="http://schemas.openxmlformats.org/drawingml/2006/main" w="9525">
-            <a:solidFill>
-              <a:srgbClr val="F97316"/>
-            </a:solidFill>
-            <a:prstDash val="solid"/>
-          </a:ln>
-        </p:spPr>
-      </p:sp>
-      <p:sp>
-        <p:nvSpPr>
-          <p:cNvPr id="20" name="">
-            <a:extLst xmlns:a="http://schemas.openxmlformats.org/drawingml/2006/main">
-              <a:ext uri="{FF2B5EF4-FFF2-40B4-BE49-F238E27FC236}">
-                <a16:creationId xmlns:a16="http://schemas.microsoft.com/office/drawing/2014/main" id="{F26F4CD2-582F-4BEC-A10B-8A85D0C6F639}"/>
-              </a:ext>
-            </a:extLst>
-          </p:cNvPr>
-          <p:cNvSpPr>
-            <a:spLocks xmlns:a="http://schemas.openxmlformats.org/drawingml/2006/main" noGrp="1"/>
-          </p:cNvSpPr>
-          <p:nvPr/>
-        </p:nvSpPr>
-        <p:spPr>
-          <a:xfrm xmlns:a="http://schemas.openxmlformats.org/drawingml/2006/main">
-            <a:off x="9925050" y="2228850"/>
-            <a:ext cx="1390650" cy="323850"/>
-          </a:xfrm>
-          <a:prstGeom xmlns:a="http://schemas.openxmlformats.org/drawingml/2006/main" prst="rect">
-            <a:avLst/>
-          </a:prstGeom>
-          <a:noFill xmlns:a="http://schemas.openxmlformats.org/drawingml/2006/main"/>
-          <a:ln xmlns:a="http://schemas.openxmlformats.org/drawingml/2006/main" w="0">
-            <a:noFill/>
-            <a:prstDash val="solid"/>
-          </a:ln>
-        </p:spPr>
-        <p:txBody>
-          <a:bodyPr xmlns:a="http://schemas.openxmlformats.org/drawingml/2006/main" anchor="t"/>
-          <a:lstStyle xmlns:a="http://schemas.openxmlformats.org/drawingml/2006/main"/>
-          <a:p xmlns:a="http://schemas.openxmlformats.org/drawingml/2006/main">
-            <a:pPr algn="ctr">
-              <a:defRPr sz="1650" b="1">
-                <a:solidFill>
-                  <a:srgbClr val="0F172A"/>
-                </a:solidFill>
-              </a:defRPr>
-            </a:pPr>
-            <a:r>
-              <a:rPr sz="1650" b="1">
-                <a:solidFill>
-                  <a:srgbClr val="0F172A"/>
-                </a:solidFill>
-              </a:rPr>
-              <a:t>Telemetry</a:t>
-            </a:r>
-          </a:p>
-        </p:txBody>
-      </p:sp>
-      <p:sp>
-        <p:nvSpPr>
-          <p:cNvPr id="21" name="">
-            <a:extLst xmlns:a="http://schemas.openxmlformats.org/drawingml/2006/main">
-              <a:ext uri="{FF2B5EF4-FFF2-40B4-BE49-F238E27FC236}">
-                <a16:creationId xmlns:a16="http://schemas.microsoft.com/office/drawing/2014/main" id="{63BA5230-1DD5-49A7-9603-3D058128A753}"/>
-              </a:ext>
-            </a:extLst>
-          </p:cNvPr>
-          <p:cNvSpPr>
-            <a:spLocks xmlns:a="http://schemas.openxmlformats.org/drawingml/2006/main" noGrp="1"/>
-          </p:cNvSpPr>
-          <p:nvPr/>
-        </p:nvSpPr>
-        <p:spPr>
-          <a:xfrm xmlns:a="http://schemas.openxmlformats.org/drawingml/2006/main">
-            <a:off x="9944100" y="2838450"/>
-            <a:ext cx="1352550" cy="533400"/>
-          </a:xfrm>
-          <a:prstGeom xmlns:a="http://schemas.openxmlformats.org/drawingml/2006/main" prst="rect">
-            <a:avLst/>
-          </a:prstGeom>
-          <a:noFill xmlns:a="http://schemas.openxmlformats.org/drawingml/2006/main"/>
-          <a:ln xmlns:a="http://schemas.openxmlformats.org/drawingml/2006/main" w="0">
-            <a:noFill/>
-            <a:prstDash val="solid"/>
-          </a:ln>
-        </p:spPr>
-        <p:txBody>
-          <a:bodyPr xmlns:a="http://schemas.openxmlformats.org/drawingml/2006/main" anchor="t"/>
-          <a:lstStyle xmlns:a="http://schemas.openxmlformats.org/drawingml/2006/main"/>
-          <a:p xmlns:a="http://schemas.openxmlformats.org/drawingml/2006/main">
-            <a:pPr algn="ctr">
-              <a:defRPr sz="1275" b="0">
-                <a:solidFill>
-                  <a:srgbClr val="334155"/>
-                </a:solidFill>
-              </a:defRPr>
-            </a:pPr>
-            <a:r>
-              <a:rPr sz="1275" b="0">
-                <a:solidFill>
-                  <a:srgbClr val="334155"/>
-                </a:solidFill>
-              </a:rPr>
-              <a:t>late / useful / wasted</a:t>
-            </a:r>
-          </a:p>
-        </p:txBody>
-      </p:sp>
-      <p:sp>
-        <p:nvSpPr>
-          <p:cNvPr id="22" name="">
-            <a:extLst xmlns:a="http://schemas.openxmlformats.org/drawingml/2006/main">
-              <a:ext uri="{FF2B5EF4-FFF2-40B4-BE49-F238E27FC236}">
-                <a16:creationId xmlns:a16="http://schemas.microsoft.com/office/drawing/2014/main" id="{92C74EE2-975A-4EA1-B681-BA97DC7E281E}"/>
-              </a:ext>
-            </a:extLst>
-          </p:cNvPr>
-          <p:cNvSpPr>
-            <a:spLocks xmlns:a="http://schemas.openxmlformats.org/drawingml/2006/main" noGrp="1"/>
-          </p:cNvSpPr>
-          <p:nvPr/>
-        </p:nvSpPr>
-        <p:spPr>
-          <a:xfrm xmlns:a="http://schemas.openxmlformats.org/drawingml/2006/main">
-            <a:off x="2000250" y="4514850"/>
-            <a:ext cx="8191500" cy="800100"/>
-          </a:xfrm>
-          <a:prstGeom xmlns:a="http://schemas.openxmlformats.org/drawingml/2006/main" prst="roundRect">
-            <a:avLst>
-              <a:gd name="adj" fmla="val 7143"/>
-            </a:avLst>
-          </a:prstGeom>
-          <a:solidFill xmlns:a="http://schemas.openxmlformats.org/drawingml/2006/main">
-            <a:srgbClr val="F8FAFC"/>
-          </a:solidFill>
-          <a:ln xmlns:a="http://schemas.openxmlformats.org/drawingml/2006/main" w="9525">
-            <a:solidFill>
-              <a:srgbClr val="CBD5E1"/>
-            </a:solidFill>
-            <a:prstDash val="solid"/>
-          </a:ln>
-        </p:spPr>
-      </p:sp>
-      <p:sp>
-        <p:nvSpPr>
-          <p:cNvPr id="23" name="">
-            <a:extLst xmlns:a="http://schemas.openxmlformats.org/drawingml/2006/main">
-              <a:ext uri="{FF2B5EF4-FFF2-40B4-BE49-F238E27FC236}">
-                <a16:creationId xmlns:a16="http://schemas.microsoft.com/office/drawing/2014/main" id="{B3FA8EC8-7CB9-4549-B017-929BA7A67E65}"/>
-              </a:ext>
-            </a:extLst>
-          </p:cNvPr>
-          <p:cNvSpPr>
-            <a:spLocks xmlns:a="http://schemas.openxmlformats.org/drawingml/2006/main" noGrp="1"/>
-          </p:cNvSpPr>
-          <p:nvPr/>
-        </p:nvSpPr>
-        <p:spPr>
-          <a:xfrm xmlns:a="http://schemas.openxmlformats.org/drawingml/2006/main">
-            <a:off x="2247900" y="4743450"/>
-            <a:ext cx="2476500" cy="247650"/>
-          </a:xfrm>
-          <a:prstGeom xmlns:a="http://schemas.openxmlformats.org/drawingml/2006/main" prst="rect">
-            <a:avLst/>
-          </a:prstGeom>
-          <a:noFill xmlns:a="http://schemas.openxmlformats.org/drawingml/2006/main"/>
-          <a:ln xmlns:a="http://schemas.openxmlformats.org/drawingml/2006/main" w="0">
-            <a:noFill/>
-            <a:prstDash val="solid"/>
-          </a:ln>
-        </p:spPr>
-        <p:txBody>
-          <a:bodyPr xmlns:a="http://schemas.openxmlformats.org/drawingml/2006/main" anchor="t"/>
-          <a:lstStyle xmlns:a="http://schemas.openxmlformats.org/drawingml/2006/main"/>
-          <a:p xmlns:a="http://schemas.openxmlformats.org/drawingml/2006/main">
-            <a:pPr algn="l">
-              <a:defRPr sz="1650" b="1">
-                <a:solidFill>
-                  <a:srgbClr val="0F172A"/>
-                </a:solidFill>
-              </a:defRPr>
-            </a:pPr>
-            <a:r>
-              <a:rPr sz="1650" b="1">
-                <a:solidFill>
-                  <a:srgbClr val="0F172A"/>
-                </a:solidFill>
-              </a:rPr>
-              <a:t>Resulting research question</a:t>
-            </a:r>
-          </a:p>
-        </p:txBody>
-      </p:sp>
-      <p:sp>
-        <p:nvSpPr>
-          <p:cNvPr id="24" name="">
-            <a:extLst xmlns:a="http://schemas.openxmlformats.org/drawingml/2006/main">
-              <a:ext uri="{FF2B5EF4-FFF2-40B4-BE49-F238E27FC236}">
-                <a16:creationId xmlns:a16="http://schemas.microsoft.com/office/drawing/2014/main" id="{8913022B-5B61-4A3E-9A1A-041A7FC87F85}"/>
-              </a:ext>
-            </a:extLst>
-          </p:cNvPr>
-          <p:cNvSpPr>
-            <a:spLocks xmlns:a="http://schemas.openxmlformats.org/drawingml/2006/main" noGrp="1"/>
-          </p:cNvSpPr>
-          <p:nvPr/>
-        </p:nvSpPr>
-        <p:spPr>
-          <a:xfrm xmlns:a="http://schemas.openxmlformats.org/drawingml/2006/main">
-            <a:off x="4953000" y="4686300"/>
-            <a:ext cx="4762500" cy="419100"/>
-          </a:xfrm>
-          <a:prstGeom xmlns:a="http://schemas.openxmlformats.org/drawingml/2006/main" prst="rect">
-            <a:avLst/>
-          </a:prstGeom>
-          <a:noFill xmlns:a="http://schemas.openxmlformats.org/drawingml/2006/main"/>
-          <a:ln xmlns:a="http://schemas.openxmlformats.org/drawingml/2006/main" w="0">
-            <a:noFill/>
-            <a:prstDash val="solid"/>
-          </a:ln>
-        </p:spPr>
-        <p:txBody>
-          <a:bodyPr xmlns:a="http://schemas.openxmlformats.org/drawingml/2006/main" anchor="t"/>
-          <a:lstStyle xmlns:a="http://schemas.openxmlformats.org/drawingml/2006/main"/>
-          <a:p xmlns:a="http://schemas.openxmlformats.org/drawingml/2006/main">
-            <a:pPr algn="l">
-              <a:defRPr sz="1425" b="0">
-                <a:solidFill>
-                  <a:srgbClr val="334155"/>
-                </a:solidFill>
-              </a:defRPr>
-            </a:pPr>
-            <a:r>
-              <a:rPr sz="1425" b="0">
-                <a:solidFill>
-                  <a:srgbClr val="334155"/>
-                </a:solidFill>
-              </a:rPr>
-              <a:t>How much replay latency and wasted movement can be avoided when KV movement has session context, priority, deadline, protection, and telemetry?</a:t>
-            </a:r>
-          </a:p>
-        </p:txBody>
-      </p:sp>
-      <p:sp>
-        <p:nvSpPr>
-          <p:cNvPr id="25" name="">
-            <a:extLst xmlns:a="http://schemas.openxmlformats.org/drawingml/2006/main">
-              <a:ext uri="{FF2B5EF4-FFF2-40B4-BE49-F238E27FC236}">
-                <a16:creationId xmlns:a16="http://schemas.microsoft.com/office/drawing/2014/main" id="{8DF687F8-FE0C-4D96-8896-0CE270921034}"/>
+                <a16:creationId xmlns:a16="http://schemas.microsoft.com/office/drawing/2014/main" id="{A279A9B1-D052-4683-B54C-6582090AF322}"/>
               </a:ext>
             </a:extLst>
           </p:cNvPr>
@@ -9451,10 +10393,10 @@
       </p:sp>
       <p:sp>
         <p:nvSpPr>
-          <p:cNvPr id="26" name="">
-            <a:extLst xmlns:a="http://schemas.openxmlformats.org/drawingml/2006/main">
-              <a:ext uri="{FF2B5EF4-FFF2-40B4-BE49-F238E27FC236}">
-                <a16:creationId xmlns:a16="http://schemas.microsoft.com/office/drawing/2014/main" id="{11FC1CEA-31E3-4096-96DD-7104301FBC81}"/>
+          <p:cNvPr id="8" name="">
+            <a:extLst xmlns:a="http://schemas.openxmlformats.org/drawingml/2006/main">
+              <a:ext uri="{FF2B5EF4-FFF2-40B4-BE49-F238E27FC236}">
+                <a16:creationId xmlns:a16="http://schemas.microsoft.com/office/drawing/2014/main" id="{7CEDB7B5-4C60-4A95-9365-197E644348AC}"/>
               </a:ext>
             </a:extLst>
           </p:cNvPr>
@@ -9502,7 +10444,7 @@
     </p:spTree>
     <p:extLst>
       <p:ext uri="{BB962C8B-B14F-4D97-AF65-F5344CB8AC3E}">
-        <p14:creationId xmlns:p14="http://schemas.microsoft.com/office/powerpoint/2010/main" val="14380816"/>
+        <p14:creationId xmlns:p14="http://schemas.microsoft.com/office/powerpoint/2010/main" val="1057135405"/>
       </p:ext>
     </p:extLst>
   </p:cSld>

</xml_diff>

<commit_message>
Add key findings slide to manager deck
</commit_message>
<xml_diff>
--- a/sglang_direct_kv/artifacts/slides/agent_aware_kv_movement_manager_deck.pptx
+++ b/sglang_direct_kv/artifacts/slides/agent_aware_kv_movement_manager_deck.pptx
@@ -2,22 +2,23 @@
 <file path=ppt/presentation.xml><?xml version="1.0" encoding="utf-8"?>
 <p:presentation xmlns:p="http://schemas.openxmlformats.org/presentationml/2006/main">
   <p:sldMasterIdLst>
-    <p:sldMasterId xmlns:r="http://schemas.openxmlformats.org/officeDocument/2006/relationships" id="2147483648" r:id="R81f7908685dd4af7"/>
+    <p:sldMasterId xmlns:r="http://schemas.openxmlformats.org/officeDocument/2006/relationships" id="2147483648" r:id="Redec65a8adea4648"/>
   </p:sldMasterIdLst>
   <p:notesMasterIdLst>
-    <p:notesMasterId xmlns:r="http://schemas.openxmlformats.org/officeDocument/2006/relationships" r:id="R9bf995b93cff43a1"/>
+    <p:notesMasterId xmlns:r="http://schemas.openxmlformats.org/officeDocument/2006/relationships" r:id="R5751310b4b6a4a24"/>
   </p:notesMasterIdLst>
   <p:sldIdLst>
-    <p:sldId xmlns:r="http://schemas.openxmlformats.org/officeDocument/2006/relationships" id="256" r:id="R5043122217e246e0"/>
-    <p:sldId xmlns:r="http://schemas.openxmlformats.org/officeDocument/2006/relationships" id="257" r:id="R949be3ffd5af4b38"/>
-    <p:sldId xmlns:r="http://schemas.openxmlformats.org/officeDocument/2006/relationships" id="258" r:id="Reb3225402559474e"/>
-    <p:sldId xmlns:r="http://schemas.openxmlformats.org/officeDocument/2006/relationships" id="259" r:id="Rc204ca3e16054227"/>
-    <p:sldId xmlns:r="http://schemas.openxmlformats.org/officeDocument/2006/relationships" id="260" r:id="R0f7cd9bd96804f26"/>
-    <p:sldId xmlns:r="http://schemas.openxmlformats.org/officeDocument/2006/relationships" id="261" r:id="Rb861bc28d4d04e19"/>
-    <p:sldId xmlns:r="http://schemas.openxmlformats.org/officeDocument/2006/relationships" id="262" r:id="R14f4b2ec08204fa2"/>
-    <p:sldId xmlns:r="http://schemas.openxmlformats.org/officeDocument/2006/relationships" id="263" r:id="R63b994510f124db4"/>
-    <p:sldId xmlns:r="http://schemas.openxmlformats.org/officeDocument/2006/relationships" id="264" r:id="Rd2427f5a625c413a"/>
-    <p:sldId xmlns:r="http://schemas.openxmlformats.org/officeDocument/2006/relationships" id="265" r:id="Rd8de39e89037461c"/>
+    <p:sldId xmlns:r="http://schemas.openxmlformats.org/officeDocument/2006/relationships" id="256" r:id="Rf93c1d25d19c43b1"/>
+    <p:sldId xmlns:r="http://schemas.openxmlformats.org/officeDocument/2006/relationships" id="257" r:id="R86b45fc1fb664aa8"/>
+    <p:sldId xmlns:r="http://schemas.openxmlformats.org/officeDocument/2006/relationships" id="258" r:id="Re37d71b1445d4472"/>
+    <p:sldId xmlns:r="http://schemas.openxmlformats.org/officeDocument/2006/relationships" id="259" r:id="Ra56e871d10224f91"/>
+    <p:sldId xmlns:r="http://schemas.openxmlformats.org/officeDocument/2006/relationships" id="260" r:id="R9a91cc9088ba41b5"/>
+    <p:sldId xmlns:r="http://schemas.openxmlformats.org/officeDocument/2006/relationships" id="261" r:id="R5cd1684a0d4f41b7"/>
+    <p:sldId xmlns:r="http://schemas.openxmlformats.org/officeDocument/2006/relationships" id="262" r:id="Re3fee97197584b71"/>
+    <p:sldId xmlns:r="http://schemas.openxmlformats.org/officeDocument/2006/relationships" id="263" r:id="R917b39da13fb4da7"/>
+    <p:sldId xmlns:r="http://schemas.openxmlformats.org/officeDocument/2006/relationships" id="264" r:id="R0f9480d59ad64571"/>
+    <p:sldId xmlns:r="http://schemas.openxmlformats.org/officeDocument/2006/relationships" id="265" r:id="R40b797a37fc74d0b"/>
+    <p:sldId xmlns:r="http://schemas.openxmlformats.org/officeDocument/2006/relationships" id="266" r:id="Rd8667c7be2864ccc"/>
   </p:sldIdLst>
   <p:sldSz cx="12192000" cy="6858000"/>
   <p:notesSz cx="6858000" cy="9144000"/>
@@ -546,6 +547,106 @@
           <a:lstStyle xmlns:a="http://schemas.openxmlformats.org/drawingml/2006/main"/>
           <a:p xmlns:a="http://schemas.openxmlformats.org/drawingml/2006/main">
             <a:r>
+              <a:t>This slide summarizes findings observed across the project so far.</a:t>
+            </a:r>
+          </a:p>
+          <a:p xmlns:a="http://schemas.openxmlformats.org/drawingml/2006/main">
+            <a:r>
+              <a:t>It connects the evidence slides to hardware implications: short tool gaps, late hints, scheduler/request-path delay, lost KV lifecycle, and replay-side H2D lateness.</a:t>
+            </a:r>
+          </a:p>
+          <a:p xmlns:a="http://schemas.openxmlformats.org/drawingml/2006/main">
+            <a:r>
+              <a:t>Manager takeaway: a smarter DMA path needs KV/session context and deadline enforcement, not only more bandwidth.</a:t>
+            </a:r>
+          </a:p>
+          <a:p xmlns:a="http://schemas.openxmlformats.org/drawingml/2006/main">
+            <a:r>
+              <a:t/>
+            </a:r>
+          </a:p>
+          <a:p xmlns:a="http://schemas.openxmlformats.org/drawingml/2006/main">
+            <a:r>
+              <a:t>[Sources]</a:t>
+            </a:r>
+          </a:p>
+          <a:p xmlns:a="http://schemas.openxmlformats.org/drawingml/2006/main">
+            <a:r>
+              <a:t>Local report: /Users/oluwolejaiyeoba/Documents/GitHub/agentic_hardware/sglang_direct_kv/artifacts/results/latest_master_report.html</a:t>
+            </a:r>
+          </a:p>
+          <a:p xmlns:a="http://schemas.openxmlformats.org/drawingml/2006/main">
+            <a:r>
+              <a:t>Backup report: /Users/oluwolejaiyeoba/Documents/GitHub/agentic_hardware/backups/latest_master_report-1.html</a:t>
+            </a:r>
+          </a:p>
+        </p:txBody>
+      </p:sp>
+      <p:sp>
+        <p:nvSpPr>
+          <p:cNvPr id="4" name="Slide Number Placeholder 3"/>
+          <p:cNvSpPr>
+            <a:spLocks xmlns:a="http://schemas.openxmlformats.org/drawingml/2006/main" noGrp="1"/>
+          </p:cNvSpPr>
+          <p:nvPr>
+            <p:ph type="sldNum" idx="5"/>
+          </p:nvPr>
+        </p:nvSpPr>
+        <p:spPr/>
+        <p:txBody>
+          <a:bodyPr xmlns:a="http://schemas.openxmlformats.org/drawingml/2006/main"/>
+          <a:lstStyle xmlns:a="http://schemas.openxmlformats.org/drawingml/2006/main"/>
+          <a:p xmlns:a="http://schemas.openxmlformats.org/drawingml/2006/main"/>
+        </p:txBody>
+      </p:sp>
+    </p:spTree>
+  </p:cSld>
+  <p:clrMapOvr>
+    <a:masterClrMapping xmlns:a="http://schemas.openxmlformats.org/drawingml/2006/main"/>
+  </p:clrMapOvr>
+</p:notes>
+</file>
+
+<file path=ppt/notesSlides/notesSlide11.xml><?xml version="1.0" encoding="utf-8"?>
+<p:notes xmlns:p="http://schemas.openxmlformats.org/presentationml/2006/main">
+  <p:cSld>
+    <p:spTree>
+      <p:nvGrpSpPr>
+        <p:cNvPr id="1" name=""/>
+        <p:cNvGrpSpPr/>
+        <p:nvPr/>
+      </p:nvGrpSpPr>
+      <p:grpSpPr>
+        <a:xfrm xmlns:a="http://schemas.openxmlformats.org/drawingml/2006/main"/>
+      </p:grpSpPr>
+      <p:sp>
+        <p:nvSpPr>
+          <p:cNvPr id="2" name="Slide Image Placeholder 1"/>
+          <p:cNvSpPr>
+            <a:spLocks xmlns:a="http://schemas.openxmlformats.org/drawingml/2006/main" noGrp="1"/>
+          </p:cNvSpPr>
+          <p:nvPr>
+            <p:ph type="sldImg" idx="0"/>
+          </p:nvPr>
+        </p:nvSpPr>
+        <p:spPr/>
+      </p:sp>
+      <p:sp>
+        <p:nvSpPr>
+          <p:cNvPr id="3" name="Notes Placeholder 2"/>
+          <p:cNvSpPr>
+            <a:spLocks xmlns:a="http://schemas.openxmlformats.org/drawingml/2006/main" noGrp="1"/>
+          </p:cNvSpPr>
+          <p:nvPr>
+            <p:ph type="body" idx="1"/>
+          </p:nvPr>
+        </p:nvSpPr>
+        <p:spPr/>
+        <p:txBody>
+          <a:bodyPr xmlns:a="http://schemas.openxmlformats.org/drawingml/2006/main"/>
+          <a:lstStyle xmlns:a="http://schemas.openxmlformats.org/drawingml/2006/main"/>
+          <a:p xmlns:a="http://schemas.openxmlformats.org/drawingml/2006/main">
+            <a:r>
               <a:t>Closing slide. This translates observed software/runtime behavior into concrete hardware support candidates.</a:t>
             </a:r>
           </a:p>
@@ -1404,7 +1505,7 @@
   </p:cSld>
   <p:clrMap bg1="lt1" tx1="dk1" bg2="lt2" tx2="dk2" accent1="accent1" accent2="accent2" accent3="accent3" accent4="accent4" accent5="accent5" accent6="accent6" hlink="hlink" folHlink="folHlink"/>
   <p:sldLayoutIdLst>
-    <p:sldLayoutId xmlns:r="http://schemas.openxmlformats.org/officeDocument/2006/relationships" id="2147483649" r:id="Recf639b5bb7d478d"/>
+    <p:sldLayoutId xmlns:r="http://schemas.openxmlformats.org/officeDocument/2006/relationships" id="2147483649" r:id="Re2203cba7e1f4be7"/>
   </p:sldLayoutIdLst>
   <p:txStyles>
     <p:titleStyle>
@@ -1955,7 +2056,7 @@
           <p:cNvPr id="16" name="">
             <a:extLst xmlns:a="http://schemas.openxmlformats.org/drawingml/2006/main">
               <a:ext uri="{FF2B5EF4-FFF2-40B4-BE49-F238E27FC236}">
-                <a16:creationId xmlns:a16="http://schemas.microsoft.com/office/drawing/2014/main" id="{85F46643-F4F6-4A04-8CA7-1547CB28FE72}"/>
+                <a16:creationId xmlns:a16="http://schemas.microsoft.com/office/drawing/2014/main" id="{419FA287-1B93-4547-B076-098D9A9E6E08}"/>
               </a:ext>
             </a:extLst>
           </p:cNvPr>
@@ -2005,7 +2106,7 @@
           <p:cNvPr id="2" name="">
             <a:extLst xmlns:a="http://schemas.openxmlformats.org/drawingml/2006/main">
               <a:ext uri="{FF2B5EF4-FFF2-40B4-BE49-F238E27FC236}">
-                <a16:creationId xmlns:a16="http://schemas.microsoft.com/office/drawing/2014/main" id="{A39D2D10-3AF2-4A10-AD6D-F6311B97AAD8}"/>
+                <a16:creationId xmlns:a16="http://schemas.microsoft.com/office/drawing/2014/main" id="{93960661-E137-4E25-B36F-BE1A243D9641}"/>
               </a:ext>
             </a:extLst>
           </p:cNvPr>
@@ -2055,7 +2156,7 @@
           <p:cNvPr id="3" name="">
             <a:extLst xmlns:a="http://schemas.openxmlformats.org/drawingml/2006/main">
               <a:ext uri="{FF2B5EF4-FFF2-40B4-BE49-F238E27FC236}">
-                <a16:creationId xmlns:a16="http://schemas.microsoft.com/office/drawing/2014/main" id="{34055EDF-ECC8-4583-8871-0E6C64480FF3}"/>
+                <a16:creationId xmlns:a16="http://schemas.microsoft.com/office/drawing/2014/main" id="{95F35314-1F49-4B1E-8057-9B8AC9AE8F56}"/>
               </a:ext>
             </a:extLst>
           </p:cNvPr>
@@ -2090,7 +2191,7 @@
           <p:cNvPr id="4" name="">
             <a:extLst xmlns:a="http://schemas.openxmlformats.org/drawingml/2006/main">
               <a:ext uri="{FF2B5EF4-FFF2-40B4-BE49-F238E27FC236}">
-                <a16:creationId xmlns:a16="http://schemas.microsoft.com/office/drawing/2014/main" id="{32AC8851-0915-4322-8524-BEC697C18FC7}"/>
+                <a16:creationId xmlns:a16="http://schemas.microsoft.com/office/drawing/2014/main" id="{9DC151AC-15E4-4A3D-9731-D15ED35D8EB5}"/>
               </a:ext>
             </a:extLst>
           </p:cNvPr>
@@ -2140,7 +2241,7 @@
           <p:cNvPr id="5" name="">
             <a:extLst xmlns:a="http://schemas.openxmlformats.org/drawingml/2006/main">
               <a:ext uri="{FF2B5EF4-FFF2-40B4-BE49-F238E27FC236}">
-                <a16:creationId xmlns:a16="http://schemas.microsoft.com/office/drawing/2014/main" id="{11C60858-B7DB-438F-9716-42CC9A9F4674}"/>
+                <a16:creationId xmlns:a16="http://schemas.microsoft.com/office/drawing/2014/main" id="{A42432D0-384C-4379-897C-E0F83EFF20E2}"/>
               </a:ext>
             </a:extLst>
           </p:cNvPr>
@@ -2190,7 +2291,7 @@
           <p:cNvPr id="6" name="">
             <a:extLst xmlns:a="http://schemas.openxmlformats.org/drawingml/2006/main">
               <a:ext uri="{FF2B5EF4-FFF2-40B4-BE49-F238E27FC236}">
-                <a16:creationId xmlns:a16="http://schemas.microsoft.com/office/drawing/2014/main" id="{1212EFB5-5A1D-477D-8B89-C3BBEFA111EE}"/>
+                <a16:creationId xmlns:a16="http://schemas.microsoft.com/office/drawing/2014/main" id="{B8B032E7-184B-4F31-A120-15F0C517854F}"/>
               </a:ext>
             </a:extLst>
           </p:cNvPr>
@@ -2225,7 +2326,7 @@
           <p:cNvPr id="7" name="">
             <a:extLst xmlns:a="http://schemas.openxmlformats.org/drawingml/2006/main">
               <a:ext uri="{FF2B5EF4-FFF2-40B4-BE49-F238E27FC236}">
-                <a16:creationId xmlns:a16="http://schemas.microsoft.com/office/drawing/2014/main" id="{4832C5F6-966E-490D-99F8-A6F96C637637}"/>
+                <a16:creationId xmlns:a16="http://schemas.microsoft.com/office/drawing/2014/main" id="{0BB5C5B5-B2D3-46DE-98F4-659F5AC44B90}"/>
               </a:ext>
             </a:extLst>
           </p:cNvPr>
@@ -2275,7 +2376,7 @@
           <p:cNvPr id="8" name="">
             <a:extLst xmlns:a="http://schemas.openxmlformats.org/drawingml/2006/main">
               <a:ext uri="{FF2B5EF4-FFF2-40B4-BE49-F238E27FC236}">
-                <a16:creationId xmlns:a16="http://schemas.microsoft.com/office/drawing/2014/main" id="{F0DBDEF0-E7B0-4124-A1D6-01168DDD7C2B}"/>
+                <a16:creationId xmlns:a16="http://schemas.microsoft.com/office/drawing/2014/main" id="{DAA21D4E-3919-4EA8-BED9-E0F3A1009172}"/>
               </a:ext>
             </a:extLst>
           </p:cNvPr>
@@ -2325,7 +2426,7 @@
           <p:cNvPr id="9" name="">
             <a:extLst xmlns:a="http://schemas.openxmlformats.org/drawingml/2006/main">
               <a:ext uri="{FF2B5EF4-FFF2-40B4-BE49-F238E27FC236}">
-                <a16:creationId xmlns:a16="http://schemas.microsoft.com/office/drawing/2014/main" id="{02F32A8D-B537-4B1C-9175-93CB92306FCC}"/>
+                <a16:creationId xmlns:a16="http://schemas.microsoft.com/office/drawing/2014/main" id="{B9209BF0-5016-4C14-A94E-4CF9DA096505}"/>
               </a:ext>
             </a:extLst>
           </p:cNvPr>
@@ -2360,7 +2461,7 @@
           <p:cNvPr id="10" name="">
             <a:extLst xmlns:a="http://schemas.openxmlformats.org/drawingml/2006/main">
               <a:ext uri="{FF2B5EF4-FFF2-40B4-BE49-F238E27FC236}">
-                <a16:creationId xmlns:a16="http://schemas.microsoft.com/office/drawing/2014/main" id="{6F9DC534-FC1E-46B8-82B5-02B92F61016F}"/>
+                <a16:creationId xmlns:a16="http://schemas.microsoft.com/office/drawing/2014/main" id="{AB00A238-5627-40E3-AA7A-F282626A07F1}"/>
               </a:ext>
             </a:extLst>
           </p:cNvPr>
@@ -2410,7 +2511,7 @@
           <p:cNvPr id="11" name="">
             <a:extLst xmlns:a="http://schemas.openxmlformats.org/drawingml/2006/main">
               <a:ext uri="{FF2B5EF4-FFF2-40B4-BE49-F238E27FC236}">
-                <a16:creationId xmlns:a16="http://schemas.microsoft.com/office/drawing/2014/main" id="{AF7CDDBA-61B5-4884-B435-1C4E6F5FAAD0}"/>
+                <a16:creationId xmlns:a16="http://schemas.microsoft.com/office/drawing/2014/main" id="{43F77D38-BE9F-44DD-8F69-E2E6CAE24DBA}"/>
               </a:ext>
             </a:extLst>
           </p:cNvPr>
@@ -2460,7 +2561,7 @@
           <p:cNvPr id="12" name="">
             <a:extLst xmlns:a="http://schemas.openxmlformats.org/drawingml/2006/main">
               <a:ext uri="{FF2B5EF4-FFF2-40B4-BE49-F238E27FC236}">
-                <a16:creationId xmlns:a16="http://schemas.microsoft.com/office/drawing/2014/main" id="{3A623E41-0542-4F36-934E-DC3C319DAA33}"/>
+                <a16:creationId xmlns:a16="http://schemas.microsoft.com/office/drawing/2014/main" id="{7F3C2120-C54B-4F03-A48F-088D4A4BCEDB}"/>
               </a:ext>
             </a:extLst>
           </p:cNvPr>
@@ -2495,7 +2596,7 @@
           <p:cNvPr id="13" name="">
             <a:extLst xmlns:a="http://schemas.openxmlformats.org/drawingml/2006/main">
               <a:ext uri="{FF2B5EF4-FFF2-40B4-BE49-F238E27FC236}">
-                <a16:creationId xmlns:a16="http://schemas.microsoft.com/office/drawing/2014/main" id="{7927A2F8-A5AB-451F-BC8B-293E4AB39C0E}"/>
+                <a16:creationId xmlns:a16="http://schemas.microsoft.com/office/drawing/2014/main" id="{7EE56297-B589-4C34-BB98-4EB0C3C099D4}"/>
               </a:ext>
             </a:extLst>
           </p:cNvPr>
@@ -2545,7 +2646,7 @@
           <p:cNvPr id="14" name="">
             <a:extLst xmlns:a="http://schemas.openxmlformats.org/drawingml/2006/main">
               <a:ext uri="{FF2B5EF4-FFF2-40B4-BE49-F238E27FC236}">
-                <a16:creationId xmlns:a16="http://schemas.microsoft.com/office/drawing/2014/main" id="{B4D9D0EE-B683-4B93-BA60-B95B916B4AEB}"/>
+                <a16:creationId xmlns:a16="http://schemas.microsoft.com/office/drawing/2014/main" id="{A4852671-FB36-473F-8639-079BB6CD731A}"/>
               </a:ext>
             </a:extLst>
           </p:cNvPr>
@@ -2595,7 +2696,7 @@
           <p:cNvPr id="15" name="">
             <a:extLst xmlns:a="http://schemas.openxmlformats.org/drawingml/2006/main">
               <a:ext uri="{FF2B5EF4-FFF2-40B4-BE49-F238E27FC236}">
-                <a16:creationId xmlns:a16="http://schemas.microsoft.com/office/drawing/2014/main" id="{310D2551-AA2F-4C09-B4C8-E721B8D386AB}"/>
+                <a16:creationId xmlns:a16="http://schemas.microsoft.com/office/drawing/2014/main" id="{F8F59266-5178-4C58-850C-9C8161C91024}"/>
               </a:ext>
             </a:extLst>
           </p:cNvPr>
@@ -2643,7 +2744,7 @@
     </p:spTree>
     <p:extLst>
       <p:ext uri="{BB962C8B-B14F-4D97-AF65-F5344CB8AC3E}">
-        <p14:creationId xmlns:p14="http://schemas.microsoft.com/office/powerpoint/2010/main" val="1553111577"/>
+        <p14:creationId xmlns:p14="http://schemas.microsoft.com/office/powerpoint/2010/main" val="1525316303"/>
       </p:ext>
     </p:extLst>
   </p:cSld>
@@ -2671,10 +2772,10 @@
       </p:grpSpPr>
       <p:sp>
         <p:nvSpPr>
-          <p:cNvPr id="27" name="">
-            <a:extLst xmlns:a="http://schemas.openxmlformats.org/drawingml/2006/main">
-              <a:ext uri="{FF2B5EF4-FFF2-40B4-BE49-F238E27FC236}">
-                <a16:creationId xmlns:a16="http://schemas.microsoft.com/office/drawing/2014/main" id="{66440635-592A-4EEC-B999-6B63790201B2}"/>
+          <p:cNvPr id="28" name="">
+            <a:extLst xmlns:a="http://schemas.openxmlformats.org/drawingml/2006/main">
+              <a:ext uri="{FF2B5EF4-FFF2-40B4-BE49-F238E27FC236}">
+                <a16:creationId xmlns:a16="http://schemas.microsoft.com/office/drawing/2014/main" id="{CFC3E667-0FFF-41E7-8122-4757F911C282}"/>
               </a:ext>
             </a:extLst>
           </p:cNvPr>
@@ -2714,7 +2815,7 @@
                   <a:srgbClr val="0F172A"/>
                 </a:solidFill>
               </a:rPr>
-              <a:t>Hardware support can make hints enforceable</a:t>
+              <a:t>Key findings make the hardware case</a:t>
             </a:r>
           </a:p>
         </p:txBody>
@@ -2724,7 +2825,7 @@
           <p:cNvPr id="2" name="">
             <a:extLst xmlns:a="http://schemas.openxmlformats.org/drawingml/2006/main">
               <a:ext uri="{FF2B5EF4-FFF2-40B4-BE49-F238E27FC236}">
-                <a16:creationId xmlns:a16="http://schemas.microsoft.com/office/drawing/2014/main" id="{775D5695-BBCC-4521-AB34-4C410A0379B4}"/>
+                <a16:creationId xmlns:a16="http://schemas.microsoft.com/office/drawing/2014/main" id="{A604714F-91AA-48B6-BE3E-FBDABB47E560}"/>
               </a:ext>
             </a:extLst>
           </p:cNvPr>
@@ -2764,6 +2865,1200 @@
                   <a:srgbClr val="64748B"/>
                 </a:solidFill>
               </a:rPr>
+              <a:t>The recurring pattern is not just missing bandwidth; it is missing context, deadlines, residency control, and telemetry.</a:t>
+            </a:r>
+          </a:p>
+        </p:txBody>
+      </p:sp>
+      <p:sp>
+        <p:nvSpPr>
+          <p:cNvPr id="3" name="">
+            <a:extLst xmlns:a="http://schemas.openxmlformats.org/drawingml/2006/main">
+              <a:ext uri="{FF2B5EF4-FFF2-40B4-BE49-F238E27FC236}">
+                <a16:creationId xmlns:a16="http://schemas.microsoft.com/office/drawing/2014/main" id="{477D2E00-72B9-4297-B770-CE6ECB30A734}"/>
+              </a:ext>
+            </a:extLst>
+          </p:cNvPr>
+          <p:cNvSpPr>
+            <a:spLocks xmlns:a="http://schemas.openxmlformats.org/drawingml/2006/main" noGrp="1"/>
+          </p:cNvSpPr>
+          <p:nvPr/>
+        </p:nvSpPr>
+        <p:spPr>
+          <a:xfrm xmlns:a="http://schemas.openxmlformats.org/drawingml/2006/main">
+            <a:off x="552450" y="1676400"/>
+            <a:ext cx="3333750" cy="1466850"/>
+          </a:xfrm>
+          <a:prstGeom xmlns:a="http://schemas.openxmlformats.org/drawingml/2006/main" prst="roundRect">
+            <a:avLst>
+              <a:gd name="adj" fmla="val 3896"/>
+            </a:avLst>
+          </a:prstGeom>
+          <a:solidFill xmlns:a="http://schemas.openxmlformats.org/drawingml/2006/main">
+            <a:srgbClr val="EFF6FF"/>
+          </a:solidFill>
+          <a:ln xmlns:a="http://schemas.openxmlformats.org/drawingml/2006/main" w="9525">
+            <a:solidFill>
+              <a:srgbClr val="BFDBFE"/>
+            </a:solidFill>
+            <a:prstDash val="solid"/>
+          </a:ln>
+        </p:spPr>
+      </p:sp>
+      <p:sp>
+        <p:nvSpPr>
+          <p:cNvPr id="4" name="">
+            <a:extLst xmlns:a="http://schemas.openxmlformats.org/drawingml/2006/main">
+              <a:ext uri="{FF2B5EF4-FFF2-40B4-BE49-F238E27FC236}">
+                <a16:creationId xmlns:a16="http://schemas.microsoft.com/office/drawing/2014/main" id="{F4EC5403-850A-42FE-9FC3-F51ABB409B5D}"/>
+              </a:ext>
+            </a:extLst>
+          </p:cNvPr>
+          <p:cNvSpPr>
+            <a:spLocks xmlns:a="http://schemas.openxmlformats.org/drawingml/2006/main" noGrp="1"/>
+          </p:cNvSpPr>
+          <p:nvPr/>
+        </p:nvSpPr>
+        <p:spPr>
+          <a:xfrm xmlns:a="http://schemas.openxmlformats.org/drawingml/2006/main">
+            <a:off x="552450" y="1676400"/>
+            <a:ext cx="66675" cy="1466850"/>
+          </a:xfrm>
+          <a:prstGeom xmlns:a="http://schemas.openxmlformats.org/drawingml/2006/main" prst="rect">
+            <a:avLst/>
+          </a:prstGeom>
+          <a:solidFill xmlns:a="http://schemas.openxmlformats.org/drawingml/2006/main">
+            <a:srgbClr val="2563EB"/>
+          </a:solidFill>
+          <a:ln xmlns:a="http://schemas.openxmlformats.org/drawingml/2006/main" w="0">
+            <a:noFill/>
+            <a:prstDash val="solid"/>
+          </a:ln>
+        </p:spPr>
+      </p:sp>
+      <p:sp>
+        <p:nvSpPr>
+          <p:cNvPr id="5" name="">
+            <a:extLst xmlns:a="http://schemas.openxmlformats.org/drawingml/2006/main">
+              <a:ext uri="{FF2B5EF4-FFF2-40B4-BE49-F238E27FC236}">
+                <a16:creationId xmlns:a16="http://schemas.microsoft.com/office/drawing/2014/main" id="{DE890471-6382-4D34-AC45-FBFE2784E417}"/>
+              </a:ext>
+            </a:extLst>
+          </p:cNvPr>
+          <p:cNvSpPr>
+            <a:spLocks xmlns:a="http://schemas.openxmlformats.org/drawingml/2006/main" noGrp="1"/>
+          </p:cNvSpPr>
+          <p:nvPr/>
+        </p:nvSpPr>
+        <p:spPr>
+          <a:xfrm xmlns:a="http://schemas.openxmlformats.org/drawingml/2006/main">
+            <a:off x="781050" y="1885950"/>
+            <a:ext cx="2933700" cy="476250"/>
+          </a:xfrm>
+          <a:prstGeom xmlns:a="http://schemas.openxmlformats.org/drawingml/2006/main" prst="rect">
+            <a:avLst/>
+          </a:prstGeom>
+          <a:noFill xmlns:a="http://schemas.openxmlformats.org/drawingml/2006/main"/>
+          <a:ln xmlns:a="http://schemas.openxmlformats.org/drawingml/2006/main" w="0">
+            <a:noFill/>
+            <a:prstDash val="solid"/>
+          </a:ln>
+        </p:spPr>
+        <p:txBody>
+          <a:bodyPr xmlns:a="http://schemas.openxmlformats.org/drawingml/2006/main" anchor="t"/>
+          <a:lstStyle xmlns:a="http://schemas.openxmlformats.org/drawingml/2006/main"/>
+          <a:p xmlns:a="http://schemas.openxmlformats.org/drawingml/2006/main">
+            <a:pPr algn="l">
+              <a:defRPr sz="1500" b="1">
+                <a:solidFill>
+                  <a:srgbClr val="0F172A"/>
+                </a:solidFill>
+              </a:defRPr>
+            </a:pPr>
+            <a:r>
+              <a:rPr sz="1500" b="1">
+                <a:solidFill>
+                  <a:srgbClr val="0F172A"/>
+                </a:solidFill>
+              </a:rPr>
+              <a:t>Agent gaps can be short</a:t>
+            </a:r>
+          </a:p>
+        </p:txBody>
+      </p:sp>
+      <p:sp>
+        <p:nvSpPr>
+          <p:cNvPr id="6" name="">
+            <a:extLst xmlns:a="http://schemas.openxmlformats.org/drawingml/2006/main">
+              <a:ext uri="{FF2B5EF4-FFF2-40B4-BE49-F238E27FC236}">
+                <a16:creationId xmlns:a16="http://schemas.microsoft.com/office/drawing/2014/main" id="{14CD1DA9-919A-438E-BE34-2F5C388972DB}"/>
+              </a:ext>
+            </a:extLst>
+          </p:cNvPr>
+          <p:cNvSpPr>
+            <a:spLocks xmlns:a="http://schemas.openxmlformats.org/drawingml/2006/main" noGrp="1"/>
+          </p:cNvSpPr>
+          <p:nvPr/>
+        </p:nvSpPr>
+        <p:spPr>
+          <a:xfrm xmlns:a="http://schemas.openxmlformats.org/drawingml/2006/main">
+            <a:off x="781050" y="2419350"/>
+            <a:ext cx="2933700" cy="552450"/>
+          </a:xfrm>
+          <a:prstGeom xmlns:a="http://schemas.openxmlformats.org/drawingml/2006/main" prst="rect">
+            <a:avLst/>
+          </a:prstGeom>
+          <a:noFill xmlns:a="http://schemas.openxmlformats.org/drawingml/2006/main"/>
+          <a:ln xmlns:a="http://schemas.openxmlformats.org/drawingml/2006/main" w="0">
+            <a:noFill/>
+            <a:prstDash val="solid"/>
+          </a:ln>
+        </p:spPr>
+        <p:txBody>
+          <a:bodyPr xmlns:a="http://schemas.openxmlformats.org/drawingml/2006/main" anchor="t"/>
+          <a:lstStyle xmlns:a="http://schemas.openxmlformats.org/drawingml/2006/main"/>
+          <a:p xmlns:a="http://schemas.openxmlformats.org/drawingml/2006/main">
+            <a:pPr algn="l">
+              <a:defRPr sz="1125" b="0">
+                <a:solidFill>
+                  <a:srgbClr val="334155"/>
+                </a:solidFill>
+              </a:defRPr>
+            </a:pPr>
+            <a:r>
+              <a:rPr sz="1125" b="0">
+                <a:solidFill>
+                  <a:srgbClr val="334155"/>
+                </a:solidFill>
+              </a:rPr>
+              <a:t>Real coding-agent tool gaps can be only tens of milliseconds, leaving little room for slow software paths.</a:t>
+            </a:r>
+          </a:p>
+        </p:txBody>
+      </p:sp>
+      <p:sp>
+        <p:nvSpPr>
+          <p:cNvPr id="7" name="">
+            <a:extLst xmlns:a="http://schemas.openxmlformats.org/drawingml/2006/main">
+              <a:ext uri="{FF2B5EF4-FFF2-40B4-BE49-F238E27FC236}">
+                <a16:creationId xmlns:a16="http://schemas.microsoft.com/office/drawing/2014/main" id="{98783914-BB9A-4EE1-9FD1-C7FC15B7DD54}"/>
+              </a:ext>
+            </a:extLst>
+          </p:cNvPr>
+          <p:cNvSpPr>
+            <a:spLocks xmlns:a="http://schemas.openxmlformats.org/drawingml/2006/main" noGrp="1"/>
+          </p:cNvSpPr>
+          <p:nvPr/>
+        </p:nvSpPr>
+        <p:spPr>
+          <a:xfrm xmlns:a="http://schemas.openxmlformats.org/drawingml/2006/main">
+            <a:off x="4438650" y="1676400"/>
+            <a:ext cx="3333750" cy="1466850"/>
+          </a:xfrm>
+          <a:prstGeom xmlns:a="http://schemas.openxmlformats.org/drawingml/2006/main" prst="roundRect">
+            <a:avLst>
+              <a:gd name="adj" fmla="val 3896"/>
+            </a:avLst>
+          </a:prstGeom>
+          <a:solidFill xmlns:a="http://schemas.openxmlformats.org/drawingml/2006/main">
+            <a:srgbClr val="F5F3FF"/>
+          </a:solidFill>
+          <a:ln xmlns:a="http://schemas.openxmlformats.org/drawingml/2006/main" w="9525">
+            <a:solidFill>
+              <a:srgbClr val="C4B5FD"/>
+            </a:solidFill>
+            <a:prstDash val="solid"/>
+          </a:ln>
+        </p:spPr>
+      </p:sp>
+      <p:sp>
+        <p:nvSpPr>
+          <p:cNvPr id="8" name="">
+            <a:extLst xmlns:a="http://schemas.openxmlformats.org/drawingml/2006/main">
+              <a:ext uri="{FF2B5EF4-FFF2-40B4-BE49-F238E27FC236}">
+                <a16:creationId xmlns:a16="http://schemas.microsoft.com/office/drawing/2014/main" id="{285C038E-7D54-4B24-9C48-7340CADEEC02}"/>
+              </a:ext>
+            </a:extLst>
+          </p:cNvPr>
+          <p:cNvSpPr>
+            <a:spLocks xmlns:a="http://schemas.openxmlformats.org/drawingml/2006/main" noGrp="1"/>
+          </p:cNvSpPr>
+          <p:nvPr/>
+        </p:nvSpPr>
+        <p:spPr>
+          <a:xfrm xmlns:a="http://schemas.openxmlformats.org/drawingml/2006/main">
+            <a:off x="4438650" y="1676400"/>
+            <a:ext cx="66675" cy="1466850"/>
+          </a:xfrm>
+          <a:prstGeom xmlns:a="http://schemas.openxmlformats.org/drawingml/2006/main" prst="rect">
+            <a:avLst/>
+          </a:prstGeom>
+          <a:solidFill xmlns:a="http://schemas.openxmlformats.org/drawingml/2006/main">
+            <a:srgbClr val="A855F7"/>
+          </a:solidFill>
+          <a:ln xmlns:a="http://schemas.openxmlformats.org/drawingml/2006/main" w="0">
+            <a:noFill/>
+            <a:prstDash val="solid"/>
+          </a:ln>
+        </p:spPr>
+      </p:sp>
+      <p:sp>
+        <p:nvSpPr>
+          <p:cNvPr id="9" name="">
+            <a:extLst xmlns:a="http://schemas.openxmlformats.org/drawingml/2006/main">
+              <a:ext uri="{FF2B5EF4-FFF2-40B4-BE49-F238E27FC236}">
+                <a16:creationId xmlns:a16="http://schemas.microsoft.com/office/drawing/2014/main" id="{5CFBB829-4CEA-4A0F-94F2-A5E8DF40A9E1}"/>
+              </a:ext>
+            </a:extLst>
+          </p:cNvPr>
+          <p:cNvSpPr>
+            <a:spLocks xmlns:a="http://schemas.openxmlformats.org/drawingml/2006/main" noGrp="1"/>
+          </p:cNvSpPr>
+          <p:nvPr/>
+        </p:nvSpPr>
+        <p:spPr>
+          <a:xfrm xmlns:a="http://schemas.openxmlformats.org/drawingml/2006/main">
+            <a:off x="4667250" y="1885950"/>
+            <a:ext cx="2933700" cy="476250"/>
+          </a:xfrm>
+          <a:prstGeom xmlns:a="http://schemas.openxmlformats.org/drawingml/2006/main" prst="rect">
+            <a:avLst/>
+          </a:prstGeom>
+          <a:noFill xmlns:a="http://schemas.openxmlformats.org/drawingml/2006/main"/>
+          <a:ln xmlns:a="http://schemas.openxmlformats.org/drawingml/2006/main" w="0">
+            <a:noFill/>
+            <a:prstDash val="solid"/>
+          </a:ln>
+        </p:spPr>
+        <p:txBody>
+          <a:bodyPr xmlns:a="http://schemas.openxmlformats.org/drawingml/2006/main" anchor="t"/>
+          <a:lstStyle xmlns:a="http://schemas.openxmlformats.org/drawingml/2006/main"/>
+          <a:p xmlns:a="http://schemas.openxmlformats.org/drawingml/2006/main">
+            <a:pPr algn="l">
+              <a:defRPr sz="1500" b="1">
+                <a:solidFill>
+                  <a:srgbClr val="0F172A"/>
+                </a:solidFill>
+              </a:defRPr>
+            </a:pPr>
+            <a:r>
+              <a:rPr sz="1500" b="1">
+                <a:solidFill>
+                  <a:srgbClr val="0F172A"/>
+                </a:solidFill>
+              </a:rPr>
+              <a:t>Correct hints can still be late</a:t>
+            </a:r>
+          </a:p>
+        </p:txBody>
+      </p:sp>
+      <p:sp>
+        <p:nvSpPr>
+          <p:cNvPr id="10" name="">
+            <a:extLst xmlns:a="http://schemas.openxmlformats.org/drawingml/2006/main">
+              <a:ext uri="{FF2B5EF4-FFF2-40B4-BE49-F238E27FC236}">
+                <a16:creationId xmlns:a16="http://schemas.microsoft.com/office/drawing/2014/main" id="{BC0EC8E2-BB2D-40F3-B127-9088BC28C524}"/>
+              </a:ext>
+            </a:extLst>
+          </p:cNvPr>
+          <p:cNvSpPr>
+            <a:spLocks xmlns:a="http://schemas.openxmlformats.org/drawingml/2006/main" noGrp="1"/>
+          </p:cNvSpPr>
+          <p:nvPr/>
+        </p:nvSpPr>
+        <p:spPr>
+          <a:xfrm xmlns:a="http://schemas.openxmlformats.org/drawingml/2006/main">
+            <a:off x="4667250" y="2419350"/>
+            <a:ext cx="2933700" cy="552450"/>
+          </a:xfrm>
+          <a:prstGeom xmlns:a="http://schemas.openxmlformats.org/drawingml/2006/main" prst="rect">
+            <a:avLst/>
+          </a:prstGeom>
+          <a:noFill xmlns:a="http://schemas.openxmlformats.org/drawingml/2006/main"/>
+          <a:ln xmlns:a="http://schemas.openxmlformats.org/drawingml/2006/main" w="0">
+            <a:noFill/>
+            <a:prstDash val="solid"/>
+          </a:ln>
+        </p:spPr>
+        <p:txBody>
+          <a:bodyPr xmlns:a="http://schemas.openxmlformats.org/drawingml/2006/main" anchor="t"/>
+          <a:lstStyle xmlns:a="http://schemas.openxmlformats.org/drawingml/2006/main"/>
+          <a:p xmlns:a="http://schemas.openxmlformats.org/drawingml/2006/main">
+            <a:pPr algn="l">
+              <a:defRPr sz="1125" b="0">
+                <a:solidFill>
+                  <a:srgbClr val="334155"/>
+                </a:solidFill>
+              </a:defRPr>
+            </a:pPr>
+            <a:r>
+              <a:rPr sz="1125" b="0">
+                <a:solidFill>
+                  <a:srgbClr val="334155"/>
+                </a:solidFill>
+              </a:rPr>
+              <a:t>The hint path can exist, but KV readiness can still miss replay deadlines in profiled traces.</a:t>
+            </a:r>
+          </a:p>
+        </p:txBody>
+      </p:sp>
+      <p:sp>
+        <p:nvSpPr>
+          <p:cNvPr id="11" name="">
+            <a:extLst xmlns:a="http://schemas.openxmlformats.org/drawingml/2006/main">
+              <a:ext uri="{FF2B5EF4-FFF2-40B4-BE49-F238E27FC236}">
+                <a16:creationId xmlns:a16="http://schemas.microsoft.com/office/drawing/2014/main" id="{B430D87C-9085-4CB3-883A-DEB6E68652BD}"/>
+              </a:ext>
+            </a:extLst>
+          </p:cNvPr>
+          <p:cNvSpPr>
+            <a:spLocks xmlns:a="http://schemas.openxmlformats.org/drawingml/2006/main" noGrp="1"/>
+          </p:cNvSpPr>
+          <p:nvPr/>
+        </p:nvSpPr>
+        <p:spPr>
+          <a:xfrm xmlns:a="http://schemas.openxmlformats.org/drawingml/2006/main">
+            <a:off x="8324850" y="1676400"/>
+            <a:ext cx="3333750" cy="1466850"/>
+          </a:xfrm>
+          <a:prstGeom xmlns:a="http://schemas.openxmlformats.org/drawingml/2006/main" prst="roundRect">
+            <a:avLst>
+              <a:gd name="adj" fmla="val 3896"/>
+            </a:avLst>
+          </a:prstGeom>
+          <a:solidFill xmlns:a="http://schemas.openxmlformats.org/drawingml/2006/main">
+            <a:srgbClr val="ECFEFF"/>
+          </a:solidFill>
+          <a:ln xmlns:a="http://schemas.openxmlformats.org/drawingml/2006/main" w="9525">
+            <a:solidFill>
+              <a:srgbClr val="67E8F9"/>
+            </a:solidFill>
+            <a:prstDash val="solid"/>
+          </a:ln>
+        </p:spPr>
+      </p:sp>
+      <p:sp>
+        <p:nvSpPr>
+          <p:cNvPr id="12" name="">
+            <a:extLst xmlns:a="http://schemas.openxmlformats.org/drawingml/2006/main">
+              <a:ext uri="{FF2B5EF4-FFF2-40B4-BE49-F238E27FC236}">
+                <a16:creationId xmlns:a16="http://schemas.microsoft.com/office/drawing/2014/main" id="{2A9A4B28-48D4-4CE2-82D5-6DACC9879CD5}"/>
+              </a:ext>
+            </a:extLst>
+          </p:cNvPr>
+          <p:cNvSpPr>
+            <a:spLocks xmlns:a="http://schemas.openxmlformats.org/drawingml/2006/main" noGrp="1"/>
+          </p:cNvSpPr>
+          <p:nvPr/>
+        </p:nvSpPr>
+        <p:spPr>
+          <a:xfrm xmlns:a="http://schemas.openxmlformats.org/drawingml/2006/main">
+            <a:off x="8324850" y="1676400"/>
+            <a:ext cx="66675" cy="1466850"/>
+          </a:xfrm>
+          <a:prstGeom xmlns:a="http://schemas.openxmlformats.org/drawingml/2006/main" prst="rect">
+            <a:avLst/>
+          </a:prstGeom>
+          <a:solidFill xmlns:a="http://schemas.openxmlformats.org/drawingml/2006/main">
+            <a:srgbClr val="06B6D4"/>
+          </a:solidFill>
+          <a:ln xmlns:a="http://schemas.openxmlformats.org/drawingml/2006/main" w="0">
+            <a:noFill/>
+            <a:prstDash val="solid"/>
+          </a:ln>
+        </p:spPr>
+      </p:sp>
+      <p:sp>
+        <p:nvSpPr>
+          <p:cNvPr id="13" name="">
+            <a:extLst xmlns:a="http://schemas.openxmlformats.org/drawingml/2006/main">
+              <a:ext uri="{FF2B5EF4-FFF2-40B4-BE49-F238E27FC236}">
+                <a16:creationId xmlns:a16="http://schemas.microsoft.com/office/drawing/2014/main" id="{86698DC2-8175-4277-83ED-B200D71C1405}"/>
+              </a:ext>
+            </a:extLst>
+          </p:cNvPr>
+          <p:cNvSpPr>
+            <a:spLocks xmlns:a="http://schemas.openxmlformats.org/drawingml/2006/main" noGrp="1"/>
+          </p:cNvSpPr>
+          <p:nvPr/>
+        </p:nvSpPr>
+        <p:spPr>
+          <a:xfrm xmlns:a="http://schemas.openxmlformats.org/drawingml/2006/main">
+            <a:off x="8553450" y="1885950"/>
+            <a:ext cx="2933700" cy="476250"/>
+          </a:xfrm>
+          <a:prstGeom xmlns:a="http://schemas.openxmlformats.org/drawingml/2006/main" prst="rect">
+            <a:avLst/>
+          </a:prstGeom>
+          <a:noFill xmlns:a="http://schemas.openxmlformats.org/drawingml/2006/main"/>
+          <a:ln xmlns:a="http://schemas.openxmlformats.org/drawingml/2006/main" w="0">
+            <a:noFill/>
+            <a:prstDash val="solid"/>
+          </a:ln>
+        </p:spPr>
+        <p:txBody>
+          <a:bodyPr xmlns:a="http://schemas.openxmlformats.org/drawingml/2006/main" anchor="t"/>
+          <a:lstStyle xmlns:a="http://schemas.openxmlformats.org/drawingml/2006/main"/>
+          <a:p xmlns:a="http://schemas.openxmlformats.org/drawingml/2006/main">
+            <a:pPr algn="l">
+              <a:defRPr sz="1500" b="1">
+                <a:solidFill>
+                  <a:srgbClr val="0F172A"/>
+                </a:solidFill>
+              </a:defRPr>
+            </a:pPr>
+            <a:r>
+              <a:rPr sz="1500" b="1">
+                <a:solidFill>
+                  <a:srgbClr val="0F172A"/>
+                </a:solidFill>
+              </a:rPr>
+              <a:t>Copy time is not the whole delay</a:t>
+            </a:r>
+          </a:p>
+        </p:txBody>
+      </p:sp>
+      <p:sp>
+        <p:nvSpPr>
+          <p:cNvPr id="14" name="">
+            <a:extLst xmlns:a="http://schemas.openxmlformats.org/drawingml/2006/main">
+              <a:ext uri="{FF2B5EF4-FFF2-40B4-BE49-F238E27FC236}">
+                <a16:creationId xmlns:a16="http://schemas.microsoft.com/office/drawing/2014/main" id="{F6EB3C76-EEA8-4CD5-8390-3AFC0EB934EB}"/>
+              </a:ext>
+            </a:extLst>
+          </p:cNvPr>
+          <p:cNvSpPr>
+            <a:spLocks xmlns:a="http://schemas.openxmlformats.org/drawingml/2006/main" noGrp="1"/>
+          </p:cNvSpPr>
+          <p:nvPr/>
+        </p:nvSpPr>
+        <p:spPr>
+          <a:xfrm xmlns:a="http://schemas.openxmlformats.org/drawingml/2006/main">
+            <a:off x="8553450" y="2419350"/>
+            <a:ext cx="2933700" cy="552450"/>
+          </a:xfrm>
+          <a:prstGeom xmlns:a="http://schemas.openxmlformats.org/drawingml/2006/main" prst="rect">
+            <a:avLst/>
+          </a:prstGeom>
+          <a:noFill xmlns:a="http://schemas.openxmlformats.org/drawingml/2006/main"/>
+          <a:ln xmlns:a="http://schemas.openxmlformats.org/drawingml/2006/main" w="0">
+            <a:noFill/>
+            <a:prstDash val="solid"/>
+          </a:ln>
+        </p:spPr>
+        <p:txBody>
+          <a:bodyPr xmlns:a="http://schemas.openxmlformats.org/drawingml/2006/main" anchor="t"/>
+          <a:lstStyle xmlns:a="http://schemas.openxmlformats.org/drawingml/2006/main"/>
+          <a:p xmlns:a="http://schemas.openxmlformats.org/drawingml/2006/main">
+            <a:pPr algn="l">
+              <a:defRPr sz="1125" b="0">
+                <a:solidFill>
+                  <a:srgbClr val="334155"/>
+                </a:solidFill>
+              </a:defRPr>
+            </a:pPr>
+            <a:r>
+              <a:rPr sz="1125" b="0">
+                <a:solidFill>
+                  <a:srgbClr val="334155"/>
+                </a:solidFill>
+              </a:rPr>
+              <a:t>Visible H2D copy can be short while end-to-end request/prefetch latency is much longer.</a:t>
+            </a:r>
+          </a:p>
+        </p:txBody>
+      </p:sp>
+      <p:sp>
+        <p:nvSpPr>
+          <p:cNvPr id="15" name="">
+            <a:extLst xmlns:a="http://schemas.openxmlformats.org/drawingml/2006/main">
+              <a:ext uri="{FF2B5EF4-FFF2-40B4-BE49-F238E27FC236}">
+                <a16:creationId xmlns:a16="http://schemas.microsoft.com/office/drawing/2014/main" id="{5BDAA012-A02D-4E6A-AB04-44160B48C85C}"/>
+              </a:ext>
+            </a:extLst>
+          </p:cNvPr>
+          <p:cNvSpPr>
+            <a:spLocks xmlns:a="http://schemas.openxmlformats.org/drawingml/2006/main" noGrp="1"/>
+          </p:cNvSpPr>
+          <p:nvPr/>
+        </p:nvSpPr>
+        <p:spPr>
+          <a:xfrm xmlns:a="http://schemas.openxmlformats.org/drawingml/2006/main">
+            <a:off x="1504950" y="3448050"/>
+            <a:ext cx="4095750" cy="1466850"/>
+          </a:xfrm>
+          <a:prstGeom xmlns:a="http://schemas.openxmlformats.org/drawingml/2006/main" prst="roundRect">
+            <a:avLst>
+              <a:gd name="adj" fmla="val 3896"/>
+            </a:avLst>
+          </a:prstGeom>
+          <a:solidFill xmlns:a="http://schemas.openxmlformats.org/drawingml/2006/main">
+            <a:srgbClr val="FFF7ED"/>
+          </a:solidFill>
+          <a:ln xmlns:a="http://schemas.openxmlformats.org/drawingml/2006/main" w="9525">
+            <a:solidFill>
+              <a:srgbClr val="FED7AA"/>
+            </a:solidFill>
+            <a:prstDash val="solid"/>
+          </a:ln>
+        </p:spPr>
+      </p:sp>
+      <p:sp>
+        <p:nvSpPr>
+          <p:cNvPr id="16" name="">
+            <a:extLst xmlns:a="http://schemas.openxmlformats.org/drawingml/2006/main">
+              <a:ext uri="{FF2B5EF4-FFF2-40B4-BE49-F238E27FC236}">
+                <a16:creationId xmlns:a16="http://schemas.microsoft.com/office/drawing/2014/main" id="{EC1B9260-9F0C-4B41-8D74-8A4C502276F3}"/>
+              </a:ext>
+            </a:extLst>
+          </p:cNvPr>
+          <p:cNvSpPr>
+            <a:spLocks xmlns:a="http://schemas.openxmlformats.org/drawingml/2006/main" noGrp="1"/>
+          </p:cNvSpPr>
+          <p:nvPr/>
+        </p:nvSpPr>
+        <p:spPr>
+          <a:xfrm xmlns:a="http://schemas.openxmlformats.org/drawingml/2006/main">
+            <a:off x="1504950" y="3448050"/>
+            <a:ext cx="66675" cy="1466850"/>
+          </a:xfrm>
+          <a:prstGeom xmlns:a="http://schemas.openxmlformats.org/drawingml/2006/main" prst="rect">
+            <a:avLst/>
+          </a:prstGeom>
+          <a:solidFill xmlns:a="http://schemas.openxmlformats.org/drawingml/2006/main">
+            <a:srgbClr val="C2410C"/>
+          </a:solidFill>
+          <a:ln xmlns:a="http://schemas.openxmlformats.org/drawingml/2006/main" w="0">
+            <a:noFill/>
+            <a:prstDash val="solid"/>
+          </a:ln>
+        </p:spPr>
+      </p:sp>
+      <p:sp>
+        <p:nvSpPr>
+          <p:cNvPr id="17" name="">
+            <a:extLst xmlns:a="http://schemas.openxmlformats.org/drawingml/2006/main">
+              <a:ext uri="{FF2B5EF4-FFF2-40B4-BE49-F238E27FC236}">
+                <a16:creationId xmlns:a16="http://schemas.microsoft.com/office/drawing/2014/main" id="{583FAA72-B3A4-45F1-932E-E579453E034D}"/>
+              </a:ext>
+            </a:extLst>
+          </p:cNvPr>
+          <p:cNvSpPr>
+            <a:spLocks xmlns:a="http://schemas.openxmlformats.org/drawingml/2006/main" noGrp="1"/>
+          </p:cNvSpPr>
+          <p:nvPr/>
+        </p:nvSpPr>
+        <p:spPr>
+          <a:xfrm xmlns:a="http://schemas.openxmlformats.org/drawingml/2006/main">
+            <a:off x="1733550" y="3657600"/>
+            <a:ext cx="3695700" cy="476250"/>
+          </a:xfrm>
+          <a:prstGeom xmlns:a="http://schemas.openxmlformats.org/drawingml/2006/main" prst="rect">
+            <a:avLst/>
+          </a:prstGeom>
+          <a:noFill xmlns:a="http://schemas.openxmlformats.org/drawingml/2006/main"/>
+          <a:ln xmlns:a="http://schemas.openxmlformats.org/drawingml/2006/main" w="0">
+            <a:noFill/>
+            <a:prstDash val="solid"/>
+          </a:ln>
+        </p:spPr>
+        <p:txBody>
+          <a:bodyPr xmlns:a="http://schemas.openxmlformats.org/drawingml/2006/main" anchor="t"/>
+          <a:lstStyle xmlns:a="http://schemas.openxmlformats.org/drawingml/2006/main"/>
+          <a:p xmlns:a="http://schemas.openxmlformats.org/drawingml/2006/main">
+            <a:pPr algn="l">
+              <a:defRPr sz="1500" b="1">
+                <a:solidFill>
+                  <a:srgbClr val="0F172A"/>
+                </a:solidFill>
+              </a:defRPr>
+            </a:pPr>
+            <a:r>
+              <a:rPr sz="1500" b="1">
+                <a:solidFill>
+                  <a:srgbClr val="0F172A"/>
+                </a:solidFill>
+              </a:rPr>
+              <a:t>KV can be lost before replay</a:t>
+            </a:r>
+          </a:p>
+        </p:txBody>
+      </p:sp>
+      <p:sp>
+        <p:nvSpPr>
+          <p:cNvPr id="18" name="">
+            <a:extLst xmlns:a="http://schemas.openxmlformats.org/drawingml/2006/main">
+              <a:ext uri="{FF2B5EF4-FFF2-40B4-BE49-F238E27FC236}">
+                <a16:creationId xmlns:a16="http://schemas.microsoft.com/office/drawing/2014/main" id="{C2A1C1C3-4EA7-4296-B0F4-0F742A763B10}"/>
+              </a:ext>
+            </a:extLst>
+          </p:cNvPr>
+          <p:cNvSpPr>
+            <a:spLocks xmlns:a="http://schemas.openxmlformats.org/drawingml/2006/main" noGrp="1"/>
+          </p:cNvSpPr>
+          <p:nvPr/>
+        </p:nvSpPr>
+        <p:spPr>
+          <a:xfrm xmlns:a="http://schemas.openxmlformats.org/drawingml/2006/main">
+            <a:off x="1733550" y="4191000"/>
+            <a:ext cx="3695700" cy="552450"/>
+          </a:xfrm>
+          <a:prstGeom xmlns:a="http://schemas.openxmlformats.org/drawingml/2006/main" prst="rect">
+            <a:avLst/>
+          </a:prstGeom>
+          <a:noFill xmlns:a="http://schemas.openxmlformats.org/drawingml/2006/main"/>
+          <a:ln xmlns:a="http://schemas.openxmlformats.org/drawingml/2006/main" w="0">
+            <a:noFill/>
+            <a:prstDash val="solid"/>
+          </a:ln>
+        </p:spPr>
+        <p:txBody>
+          <a:bodyPr xmlns:a="http://schemas.openxmlformats.org/drawingml/2006/main" anchor="t"/>
+          <a:lstStyle xmlns:a="http://schemas.openxmlformats.org/drawingml/2006/main"/>
+          <a:p xmlns:a="http://schemas.openxmlformats.org/drawingml/2006/main">
+            <a:pPr algn="l">
+              <a:defRPr sz="1125" b="0">
+                <a:solidFill>
+                  <a:srgbClr val="334155"/>
+                </a:solidFill>
+              </a:defRPr>
+            </a:pPr>
+            <a:r>
+              <a:rPr sz="1125" b="0">
+                <a:solidFill>
+                  <a:srgbClr val="334155"/>
+                </a:solidFill>
+              </a:rPr>
+              <a:t>Lifecycle traces show KV written to host, evicted from GPU, then sometimes evicted from host before replay.</a:t>
+            </a:r>
+          </a:p>
+        </p:txBody>
+      </p:sp>
+      <p:sp>
+        <p:nvSpPr>
+          <p:cNvPr id="19" name="">
+            <a:extLst xmlns:a="http://schemas.openxmlformats.org/drawingml/2006/main">
+              <a:ext uri="{FF2B5EF4-FFF2-40B4-BE49-F238E27FC236}">
+                <a16:creationId xmlns:a16="http://schemas.microsoft.com/office/drawing/2014/main" id="{128A8758-C404-4412-9F6C-5C1F77ED5FC4}"/>
+              </a:ext>
+            </a:extLst>
+          </p:cNvPr>
+          <p:cNvSpPr>
+            <a:spLocks xmlns:a="http://schemas.openxmlformats.org/drawingml/2006/main" noGrp="1"/>
+          </p:cNvSpPr>
+          <p:nvPr/>
+        </p:nvSpPr>
+        <p:spPr>
+          <a:xfrm xmlns:a="http://schemas.openxmlformats.org/drawingml/2006/main">
+            <a:off x="6591300" y="3448050"/>
+            <a:ext cx="4095750" cy="1466850"/>
+          </a:xfrm>
+          <a:prstGeom xmlns:a="http://schemas.openxmlformats.org/drawingml/2006/main" prst="roundRect">
+            <a:avLst>
+              <a:gd name="adj" fmla="val 3896"/>
+            </a:avLst>
+          </a:prstGeom>
+          <a:solidFill xmlns:a="http://schemas.openxmlformats.org/drawingml/2006/main">
+            <a:srgbClr val="FEF2F2"/>
+          </a:solidFill>
+          <a:ln xmlns:a="http://schemas.openxmlformats.org/drawingml/2006/main" w="9525">
+            <a:solidFill>
+              <a:srgbClr val="FECACA"/>
+            </a:solidFill>
+            <a:prstDash val="solid"/>
+          </a:ln>
+        </p:spPr>
+      </p:sp>
+      <p:sp>
+        <p:nvSpPr>
+          <p:cNvPr id="20" name="">
+            <a:extLst xmlns:a="http://schemas.openxmlformats.org/drawingml/2006/main">
+              <a:ext uri="{FF2B5EF4-FFF2-40B4-BE49-F238E27FC236}">
+                <a16:creationId xmlns:a16="http://schemas.microsoft.com/office/drawing/2014/main" id="{B3C75721-BC20-4175-8FD0-4D3EA7055122}"/>
+              </a:ext>
+            </a:extLst>
+          </p:cNvPr>
+          <p:cNvSpPr>
+            <a:spLocks xmlns:a="http://schemas.openxmlformats.org/drawingml/2006/main" noGrp="1"/>
+          </p:cNvSpPr>
+          <p:nvPr/>
+        </p:nvSpPr>
+        <p:spPr>
+          <a:xfrm xmlns:a="http://schemas.openxmlformats.org/drawingml/2006/main">
+            <a:off x="6591300" y="3448050"/>
+            <a:ext cx="66675" cy="1466850"/>
+          </a:xfrm>
+          <a:prstGeom xmlns:a="http://schemas.openxmlformats.org/drawingml/2006/main" prst="rect">
+            <a:avLst/>
+          </a:prstGeom>
+          <a:solidFill xmlns:a="http://schemas.openxmlformats.org/drawingml/2006/main">
+            <a:srgbClr val="B91C1C"/>
+          </a:solidFill>
+          <a:ln xmlns:a="http://schemas.openxmlformats.org/drawingml/2006/main" w="0">
+            <a:noFill/>
+            <a:prstDash val="solid"/>
+          </a:ln>
+        </p:spPr>
+      </p:sp>
+      <p:sp>
+        <p:nvSpPr>
+          <p:cNvPr id="21" name="">
+            <a:extLst xmlns:a="http://schemas.openxmlformats.org/drawingml/2006/main">
+              <a:ext uri="{FF2B5EF4-FFF2-40B4-BE49-F238E27FC236}">
+                <a16:creationId xmlns:a16="http://schemas.microsoft.com/office/drawing/2014/main" id="{C46F67E8-333A-48C5-A4E5-C6839F023971}"/>
+              </a:ext>
+            </a:extLst>
+          </p:cNvPr>
+          <p:cNvSpPr>
+            <a:spLocks xmlns:a="http://schemas.openxmlformats.org/drawingml/2006/main" noGrp="1"/>
+          </p:cNvSpPr>
+          <p:nvPr/>
+        </p:nvSpPr>
+        <p:spPr>
+          <a:xfrm xmlns:a="http://schemas.openxmlformats.org/drawingml/2006/main">
+            <a:off x="6819900" y="3657600"/>
+            <a:ext cx="3695700" cy="476250"/>
+          </a:xfrm>
+          <a:prstGeom xmlns:a="http://schemas.openxmlformats.org/drawingml/2006/main" prst="rect">
+            <a:avLst/>
+          </a:prstGeom>
+          <a:noFill xmlns:a="http://schemas.openxmlformats.org/drawingml/2006/main"/>
+          <a:ln xmlns:a="http://schemas.openxmlformats.org/drawingml/2006/main" w="0">
+            <a:noFill/>
+            <a:prstDash val="solid"/>
+          </a:ln>
+        </p:spPr>
+        <p:txBody>
+          <a:bodyPr xmlns:a="http://schemas.openxmlformats.org/drawingml/2006/main" anchor="t"/>
+          <a:lstStyle xmlns:a="http://schemas.openxmlformats.org/drawingml/2006/main"/>
+          <a:p xmlns:a="http://schemas.openxmlformats.org/drawingml/2006/main">
+            <a:pPr algn="l">
+              <a:defRPr sz="1500" b="1">
+                <a:solidFill>
+                  <a:srgbClr val="0F172A"/>
+                </a:solidFill>
+              </a:defRPr>
+            </a:pPr>
+            <a:r>
+              <a:rPr sz="1500" b="1">
+                <a:solidFill>
+                  <a:srgbClr val="0F172A"/>
+                </a:solidFill>
+              </a:rPr>
+              <a:t>Replay loads can miss the deadline</a:t>
+            </a:r>
+          </a:p>
+        </p:txBody>
+      </p:sp>
+      <p:sp>
+        <p:nvSpPr>
+          <p:cNvPr id="22" name="">
+            <a:extLst xmlns:a="http://schemas.openxmlformats.org/drawingml/2006/main">
+              <a:ext uri="{FF2B5EF4-FFF2-40B4-BE49-F238E27FC236}">
+                <a16:creationId xmlns:a16="http://schemas.microsoft.com/office/drawing/2014/main" id="{63919347-1838-4D9A-B847-25987F74239E}"/>
+              </a:ext>
+            </a:extLst>
+          </p:cNvPr>
+          <p:cNvSpPr>
+            <a:spLocks xmlns:a="http://schemas.openxmlformats.org/drawingml/2006/main" noGrp="1"/>
+          </p:cNvSpPr>
+          <p:nvPr/>
+        </p:nvSpPr>
+        <p:spPr>
+          <a:xfrm xmlns:a="http://schemas.openxmlformats.org/drawingml/2006/main">
+            <a:off x="6819900" y="4191000"/>
+            <a:ext cx="3695700" cy="552450"/>
+          </a:xfrm>
+          <a:prstGeom xmlns:a="http://schemas.openxmlformats.org/drawingml/2006/main" prst="rect">
+            <a:avLst/>
+          </a:prstGeom>
+          <a:noFill xmlns:a="http://schemas.openxmlformats.org/drawingml/2006/main"/>
+          <a:ln xmlns:a="http://schemas.openxmlformats.org/drawingml/2006/main" w="0">
+            <a:noFill/>
+            <a:prstDash val="solid"/>
+          </a:ln>
+        </p:spPr>
+        <p:txBody>
+          <a:bodyPr xmlns:a="http://schemas.openxmlformats.org/drawingml/2006/main" anchor="t"/>
+          <a:lstStyle xmlns:a="http://schemas.openxmlformats.org/drawingml/2006/main"/>
+          <a:p xmlns:a="http://schemas.openxmlformats.org/drawingml/2006/main">
+            <a:pPr algn="l">
+              <a:defRPr sz="1125" b="0">
+                <a:solidFill>
+                  <a:srgbClr val="334155"/>
+                </a:solidFill>
+              </a:defRPr>
+            </a:pPr>
+            <a:r>
+              <a:rPr sz="1125" b="0">
+                <a:solidFill>
+                  <a:srgbClr val="334155"/>
+                </a:solidFill>
+              </a:rPr>
+              <a:t>Replay-side H2D movement often starts or finishes after the agent already needed KV ready.</a:t>
+            </a:r>
+          </a:p>
+        </p:txBody>
+      </p:sp>
+      <p:sp>
+        <p:nvSpPr>
+          <p:cNvPr id="23" name="">
+            <a:extLst xmlns:a="http://schemas.openxmlformats.org/drawingml/2006/main">
+              <a:ext uri="{FF2B5EF4-FFF2-40B4-BE49-F238E27FC236}">
+                <a16:creationId xmlns:a16="http://schemas.microsoft.com/office/drawing/2014/main" id="{2518431A-585D-4CA3-81D5-6CD7834F3B57}"/>
+              </a:ext>
+            </a:extLst>
+          </p:cNvPr>
+          <p:cNvSpPr>
+            <a:spLocks xmlns:a="http://schemas.openxmlformats.org/drawingml/2006/main" noGrp="1"/>
+          </p:cNvSpPr>
+          <p:nvPr/>
+        </p:nvSpPr>
+        <p:spPr>
+          <a:xfrm xmlns:a="http://schemas.openxmlformats.org/drawingml/2006/main">
+            <a:off x="1809750" y="5257800"/>
+            <a:ext cx="8572500" cy="514350"/>
+          </a:xfrm>
+          <a:prstGeom xmlns:a="http://schemas.openxmlformats.org/drawingml/2006/main" prst="roundRect">
+            <a:avLst>
+              <a:gd name="adj" fmla="val 11111"/>
+            </a:avLst>
+          </a:prstGeom>
+          <a:solidFill xmlns:a="http://schemas.openxmlformats.org/drawingml/2006/main">
+            <a:srgbClr val="F8FAFC"/>
+          </a:solidFill>
+          <a:ln xmlns:a="http://schemas.openxmlformats.org/drawingml/2006/main" w="9525">
+            <a:solidFill>
+              <a:srgbClr val="CBD5E1"/>
+            </a:solidFill>
+            <a:prstDash val="solid"/>
+          </a:ln>
+        </p:spPr>
+      </p:sp>
+      <p:sp>
+        <p:nvSpPr>
+          <p:cNvPr id="24" name="">
+            <a:extLst xmlns:a="http://schemas.openxmlformats.org/drawingml/2006/main">
+              <a:ext uri="{FF2B5EF4-FFF2-40B4-BE49-F238E27FC236}">
+                <a16:creationId xmlns:a16="http://schemas.microsoft.com/office/drawing/2014/main" id="{C700FCBA-F89E-4CE9-B2FC-FFAFAD0ADAA1}"/>
+              </a:ext>
+            </a:extLst>
+          </p:cNvPr>
+          <p:cNvSpPr>
+            <a:spLocks xmlns:a="http://schemas.openxmlformats.org/drawingml/2006/main" noGrp="1"/>
+          </p:cNvSpPr>
+          <p:nvPr/>
+        </p:nvSpPr>
+        <p:spPr>
+          <a:xfrm xmlns:a="http://schemas.openxmlformats.org/drawingml/2006/main">
+            <a:off x="2133600" y="5410200"/>
+            <a:ext cx="7924800" cy="228600"/>
+          </a:xfrm>
+          <a:prstGeom xmlns:a="http://schemas.openxmlformats.org/drawingml/2006/main" prst="rect">
+            <a:avLst/>
+          </a:prstGeom>
+          <a:noFill xmlns:a="http://schemas.openxmlformats.org/drawingml/2006/main"/>
+          <a:ln xmlns:a="http://schemas.openxmlformats.org/drawingml/2006/main" w="0">
+            <a:noFill/>
+            <a:prstDash val="solid"/>
+          </a:ln>
+        </p:spPr>
+        <p:txBody>
+          <a:bodyPr xmlns:a="http://schemas.openxmlformats.org/drawingml/2006/main" anchor="t"/>
+          <a:lstStyle xmlns:a="http://schemas.openxmlformats.org/drawingml/2006/main"/>
+          <a:p xmlns:a="http://schemas.openxmlformats.org/drawingml/2006/main">
+            <a:pPr algn="ctr">
+              <a:defRPr sz="1350" b="1">
+                <a:solidFill>
+                  <a:srgbClr val="0F172A"/>
+                </a:solidFill>
+              </a:defRPr>
+            </a:pPr>
+            <a:r>
+              <a:rPr sz="1350" b="1">
+                <a:solidFill>
+                  <a:srgbClr val="0F172A"/>
+                </a:solidFill>
+              </a:rPr>
+              <a:t>Implication: smarter DMA needs KV/session metadata, deadline-aware scheduling, residency protection, and useful telemetry.</a:t>
+            </a:r>
+          </a:p>
+        </p:txBody>
+      </p:sp>
+      <p:sp>
+        <p:nvSpPr>
+          <p:cNvPr id="25" name="">
+            <a:extLst xmlns:a="http://schemas.openxmlformats.org/drawingml/2006/main">
+              <a:ext uri="{FF2B5EF4-FFF2-40B4-BE49-F238E27FC236}">
+                <a16:creationId xmlns:a16="http://schemas.microsoft.com/office/drawing/2014/main" id="{5C942F0D-7645-410C-94FD-9ED856FEACC4}"/>
+              </a:ext>
+            </a:extLst>
+          </p:cNvPr>
+          <p:cNvSpPr>
+            <a:spLocks xmlns:a="http://schemas.openxmlformats.org/drawingml/2006/main" noGrp="1"/>
+          </p:cNvSpPr>
+          <p:nvPr/>
+        </p:nvSpPr>
+        <p:spPr>
+          <a:xfrm xmlns:a="http://schemas.openxmlformats.org/drawingml/2006/main">
+            <a:off x="400050" y="6153150"/>
+            <a:ext cx="7810500" cy="190500"/>
+          </a:xfrm>
+          <a:prstGeom xmlns:a="http://schemas.openxmlformats.org/drawingml/2006/main" prst="rect">
+            <a:avLst/>
+          </a:prstGeom>
+          <a:noFill xmlns:a="http://schemas.openxmlformats.org/drawingml/2006/main"/>
+          <a:ln xmlns:a="http://schemas.openxmlformats.org/drawingml/2006/main" w="0">
+            <a:noFill/>
+            <a:prstDash val="solid"/>
+          </a:ln>
+        </p:spPr>
+        <p:txBody>
+          <a:bodyPr xmlns:a="http://schemas.openxmlformats.org/drawingml/2006/main" anchor="t"/>
+          <a:lstStyle xmlns:a="http://schemas.openxmlformats.org/drawingml/2006/main"/>
+          <a:p xmlns:a="http://schemas.openxmlformats.org/drawingml/2006/main">
+            <a:pPr algn="l">
+              <a:defRPr sz="825" b="0">
+                <a:solidFill>
+                  <a:srgbClr val="64748B"/>
+                </a:solidFill>
+              </a:defRPr>
+            </a:pPr>
+            <a:r>
+              <a:rPr sz="825" b="0">
+                <a:solidFill>
+                  <a:srgbClr val="64748B"/>
+                </a:solidFill>
+              </a:rPr>
+              <a:t>Source: project traces and latest master/synthetic report observations</a:t>
+            </a:r>
+          </a:p>
+        </p:txBody>
+      </p:sp>
+      <p:sp>
+        <p:nvSpPr>
+          <p:cNvPr id="26" name="">
+            <a:extLst xmlns:a="http://schemas.openxmlformats.org/drawingml/2006/main">
+              <a:ext uri="{FF2B5EF4-FFF2-40B4-BE49-F238E27FC236}">
+                <a16:creationId xmlns:a16="http://schemas.microsoft.com/office/drawing/2014/main" id="{82C8530E-6395-433C-B9E5-27DCC15BFD36}"/>
+              </a:ext>
+            </a:extLst>
+          </p:cNvPr>
+          <p:cNvSpPr>
+            <a:spLocks xmlns:a="http://schemas.openxmlformats.org/drawingml/2006/main" noGrp="1"/>
+          </p:cNvSpPr>
+          <p:nvPr/>
+        </p:nvSpPr>
+        <p:spPr>
+          <a:xfrm xmlns:a="http://schemas.openxmlformats.org/drawingml/2006/main">
+            <a:off x="400050" y="6381750"/>
+            <a:ext cx="3429000" cy="228600"/>
+          </a:xfrm>
+          <a:prstGeom xmlns:a="http://schemas.openxmlformats.org/drawingml/2006/main" prst="rect">
+            <a:avLst/>
+          </a:prstGeom>
+          <a:noFill xmlns:a="http://schemas.openxmlformats.org/drawingml/2006/main"/>
+          <a:ln xmlns:a="http://schemas.openxmlformats.org/drawingml/2006/main" w="0">
+            <a:noFill/>
+            <a:prstDash val="solid"/>
+          </a:ln>
+        </p:spPr>
+        <p:txBody>
+          <a:bodyPr xmlns:a="http://schemas.openxmlformats.org/drawingml/2006/main" anchor="t"/>
+          <a:lstStyle xmlns:a="http://schemas.openxmlformats.org/drawingml/2006/main"/>
+          <a:p xmlns:a="http://schemas.openxmlformats.org/drawingml/2006/main">
+            <a:pPr algn="l">
+              <a:defRPr sz="975" b="0">
+                <a:solidFill>
+                  <a:srgbClr val="64748B"/>
+                </a:solidFill>
+              </a:defRPr>
+            </a:pPr>
+            <a:r>
+              <a:rPr sz="975" b="0">
+                <a:solidFill>
+                  <a:srgbClr val="64748B"/>
+                </a:solidFill>
+              </a:rPr>
+              <a:t>Agent-aware KV movement</a:t>
+            </a:r>
+          </a:p>
+        </p:txBody>
+      </p:sp>
+      <p:sp>
+        <p:nvSpPr>
+          <p:cNvPr id="27" name="">
+            <a:extLst xmlns:a="http://schemas.openxmlformats.org/drawingml/2006/main">
+              <a:ext uri="{FF2B5EF4-FFF2-40B4-BE49-F238E27FC236}">
+                <a16:creationId xmlns:a16="http://schemas.microsoft.com/office/drawing/2014/main" id="{9CD4DBD8-E9D4-4D5F-AD3C-7A0FF9D2004C}"/>
+              </a:ext>
+            </a:extLst>
+          </p:cNvPr>
+          <p:cNvSpPr>
+            <a:spLocks xmlns:a="http://schemas.openxmlformats.org/drawingml/2006/main" noGrp="1"/>
+          </p:cNvSpPr>
+          <p:nvPr/>
+        </p:nvSpPr>
+        <p:spPr>
+          <a:xfrm xmlns:a="http://schemas.openxmlformats.org/drawingml/2006/main">
+            <a:off x="11334750" y="6381750"/>
+            <a:ext cx="457200" cy="228600"/>
+          </a:xfrm>
+          <a:prstGeom xmlns:a="http://schemas.openxmlformats.org/drawingml/2006/main" prst="rect">
+            <a:avLst/>
+          </a:prstGeom>
+          <a:noFill xmlns:a="http://schemas.openxmlformats.org/drawingml/2006/main"/>
+          <a:ln xmlns:a="http://schemas.openxmlformats.org/drawingml/2006/main" w="0">
+            <a:noFill/>
+            <a:prstDash val="solid"/>
+          </a:ln>
+        </p:spPr>
+        <p:txBody>
+          <a:bodyPr xmlns:a="http://schemas.openxmlformats.org/drawingml/2006/main" anchor="t"/>
+          <a:lstStyle xmlns:a="http://schemas.openxmlformats.org/drawingml/2006/main"/>
+          <a:p xmlns:a="http://schemas.openxmlformats.org/drawingml/2006/main">
+            <a:pPr algn="r">
+              <a:defRPr sz="975" b="0">
+                <a:solidFill>
+                  <a:srgbClr val="64748B"/>
+                </a:solidFill>
+              </a:defRPr>
+            </a:pPr>
+            <a:r>
+              <a:rPr sz="975" b="0">
+                <a:solidFill>
+                  <a:srgbClr val="64748B"/>
+                </a:solidFill>
+              </a:rPr>
+              <a:t>10</a:t>
+            </a:r>
+          </a:p>
+        </p:txBody>
+      </p:sp>
+    </p:spTree>
+    <p:extLst>
+      <p:ext uri="{BB962C8B-B14F-4D97-AF65-F5344CB8AC3E}">
+        <p14:creationId xmlns:p14="http://schemas.microsoft.com/office/powerpoint/2010/main" val="992531945"/>
+      </p:ext>
+    </p:extLst>
+  </p:cSld>
+</p:sld>
+</file>
+
+<file path=ppt/slides/slide11.xml><?xml version="1.0" encoding="utf-8"?>
+<p:sld xmlns:p="http://schemas.openxmlformats.org/presentationml/2006/main">
+  <p:cSld>
+    <p:bg>
+      <p:bgPr>
+        <a:solidFill xmlns:a="http://schemas.openxmlformats.org/drawingml/2006/main">
+          <a:srgbClr val="FFFFFF"/>
+        </a:solidFill>
+      </p:bgPr>
+    </p:bg>
+    <p:spTree>
+      <p:nvGrpSpPr>
+        <p:cNvPr id="1" name=""/>
+        <p:cNvGrpSpPr/>
+        <p:nvPr/>
+      </p:nvGrpSpPr>
+      <p:grpSpPr>
+        <a:xfrm xmlns:a="http://schemas.openxmlformats.org/drawingml/2006/main"/>
+      </p:grpSpPr>
+      <p:sp>
+        <p:nvSpPr>
+          <p:cNvPr id="27" name="">
+            <a:extLst xmlns:a="http://schemas.openxmlformats.org/drawingml/2006/main">
+              <a:ext uri="{FF2B5EF4-FFF2-40B4-BE49-F238E27FC236}">
+                <a16:creationId xmlns:a16="http://schemas.microsoft.com/office/drawing/2014/main" id="{B4D438DD-5867-4059-92AC-EAFBA1919051}"/>
+              </a:ext>
+            </a:extLst>
+          </p:cNvPr>
+          <p:cNvSpPr>
+            <a:spLocks xmlns:a="http://schemas.openxmlformats.org/drawingml/2006/main" noGrp="1"/>
+          </p:cNvSpPr>
+          <p:nvPr/>
+        </p:nvSpPr>
+        <p:spPr>
+          <a:xfrm xmlns:a="http://schemas.openxmlformats.org/drawingml/2006/main">
+            <a:off x="400050" y="323850"/>
+            <a:ext cx="10668000" cy="800100"/>
+          </a:xfrm>
+          <a:prstGeom xmlns:a="http://schemas.openxmlformats.org/drawingml/2006/main" prst="rect">
+            <a:avLst/>
+          </a:prstGeom>
+          <a:noFill xmlns:a="http://schemas.openxmlformats.org/drawingml/2006/main"/>
+          <a:ln xmlns:a="http://schemas.openxmlformats.org/drawingml/2006/main" w="0">
+            <a:noFill/>
+            <a:prstDash val="solid"/>
+          </a:ln>
+        </p:spPr>
+        <p:txBody>
+          <a:bodyPr xmlns:a="http://schemas.openxmlformats.org/drawingml/2006/main" anchor="t"/>
+          <a:lstStyle xmlns:a="http://schemas.openxmlformats.org/drawingml/2006/main"/>
+          <a:p xmlns:a="http://schemas.openxmlformats.org/drawingml/2006/main">
+            <a:pPr algn="l">
+              <a:defRPr sz="2850" b="1">
+                <a:solidFill>
+                  <a:srgbClr val="0F172A"/>
+                </a:solidFill>
+              </a:defRPr>
+            </a:pPr>
+            <a:r>
+              <a:rPr sz="2850" b="1">
+                <a:solidFill>
+                  <a:srgbClr val="0F172A"/>
+                </a:solidFill>
+              </a:rPr>
+              <a:t>Hardware support can make hints enforceable</a:t>
+            </a:r>
+          </a:p>
+        </p:txBody>
+      </p:sp>
+      <p:sp>
+        <p:nvSpPr>
+          <p:cNvPr id="2" name="">
+            <a:extLst xmlns:a="http://schemas.openxmlformats.org/drawingml/2006/main">
+              <a:ext uri="{FF2B5EF4-FFF2-40B4-BE49-F238E27FC236}">
+                <a16:creationId xmlns:a16="http://schemas.microsoft.com/office/drawing/2014/main" id="{135DF2C0-378A-4909-8877-0397C35027EB}"/>
+              </a:ext>
+            </a:extLst>
+          </p:cNvPr>
+          <p:cNvSpPr>
+            <a:spLocks xmlns:a="http://schemas.openxmlformats.org/drawingml/2006/main" noGrp="1"/>
+          </p:cNvSpPr>
+          <p:nvPr/>
+        </p:nvSpPr>
+        <p:spPr>
+          <a:xfrm xmlns:a="http://schemas.openxmlformats.org/drawingml/2006/main">
+            <a:off x="419100" y="1028700"/>
+            <a:ext cx="9715500" cy="419100"/>
+          </a:xfrm>
+          <a:prstGeom xmlns:a="http://schemas.openxmlformats.org/drawingml/2006/main" prst="rect">
+            <a:avLst/>
+          </a:prstGeom>
+          <a:noFill xmlns:a="http://schemas.openxmlformats.org/drawingml/2006/main"/>
+          <a:ln xmlns:a="http://schemas.openxmlformats.org/drawingml/2006/main" w="0">
+            <a:noFill/>
+            <a:prstDash val="solid"/>
+          </a:ln>
+        </p:spPr>
+        <p:txBody>
+          <a:bodyPr xmlns:a="http://schemas.openxmlformats.org/drawingml/2006/main" anchor="t"/>
+          <a:lstStyle xmlns:a="http://schemas.openxmlformats.org/drawingml/2006/main"/>
+          <a:p xmlns:a="http://schemas.openxmlformats.org/drawingml/2006/main">
+            <a:pPr algn="l">
+              <a:defRPr sz="1350" b="0">
+                <a:solidFill>
+                  <a:srgbClr val="64748B"/>
+                </a:solidFill>
+              </a:defRPr>
+            </a:pPr>
+            <a:r>
+              <a:rPr sz="1350" b="0">
+                <a:solidFill>
+                  <a:srgbClr val="64748B"/>
+                </a:solidFill>
+              </a:rPr>
               <a:t>The opportunity is to treat KV as deadline-sensitive memory, not generic bytes.</a:t>
             </a:r>
           </a:p>
@@ -2774,7 +4069,7 @@
           <p:cNvPr id="3" name="">
             <a:extLst xmlns:a="http://schemas.openxmlformats.org/drawingml/2006/main">
               <a:ext uri="{FF2B5EF4-FFF2-40B4-BE49-F238E27FC236}">
-                <a16:creationId xmlns:a16="http://schemas.microsoft.com/office/drawing/2014/main" id="{B919F1E8-595D-45ED-A9EF-2BBAEF6635C8}"/>
+                <a16:creationId xmlns:a16="http://schemas.microsoft.com/office/drawing/2014/main" id="{B69CA1E6-5AFF-4113-8922-A3D9ED6E4DE8}"/>
               </a:ext>
             </a:extLst>
           </p:cNvPr>
@@ -2809,7 +4104,7 @@
           <p:cNvPr id="4" name="">
             <a:extLst xmlns:a="http://schemas.openxmlformats.org/drawingml/2006/main">
               <a:ext uri="{FF2B5EF4-FFF2-40B4-BE49-F238E27FC236}">
-                <a16:creationId xmlns:a16="http://schemas.microsoft.com/office/drawing/2014/main" id="{BC918451-9840-418E-A215-090B3A5301CB}"/>
+                <a16:creationId xmlns:a16="http://schemas.microsoft.com/office/drawing/2014/main" id="{0903FB5C-E56D-4BBA-A60C-C9F271963CC7}"/>
               </a:ext>
             </a:extLst>
           </p:cNvPr>
@@ -2859,7 +4154,7 @@
           <p:cNvPr id="5" name="">
             <a:extLst xmlns:a="http://schemas.openxmlformats.org/drawingml/2006/main">
               <a:ext uri="{FF2B5EF4-FFF2-40B4-BE49-F238E27FC236}">
-                <a16:creationId xmlns:a16="http://schemas.microsoft.com/office/drawing/2014/main" id="{5C14670C-522D-49B1-852B-3208D7C87FF2}"/>
+                <a16:creationId xmlns:a16="http://schemas.microsoft.com/office/drawing/2014/main" id="{2F09291D-119E-45AC-9BF5-1F13E5D7798E}"/>
               </a:ext>
             </a:extLst>
           </p:cNvPr>
@@ -2909,7 +4204,7 @@
           <p:cNvPr id="6" name="">
             <a:extLst xmlns:a="http://schemas.openxmlformats.org/drawingml/2006/main">
               <a:ext uri="{FF2B5EF4-FFF2-40B4-BE49-F238E27FC236}">
-                <a16:creationId xmlns:a16="http://schemas.microsoft.com/office/drawing/2014/main" id="{ED09A8D7-54E5-4C23-89EA-B88811642562}"/>
+                <a16:creationId xmlns:a16="http://schemas.microsoft.com/office/drawing/2014/main" id="{402A50E2-B611-4286-B3A3-EC3CD844E139}"/>
               </a:ext>
             </a:extLst>
           </p:cNvPr>
@@ -2959,7 +4254,7 @@
           <p:cNvPr id="7" name="">
             <a:extLst xmlns:a="http://schemas.openxmlformats.org/drawingml/2006/main">
               <a:ext uri="{FF2B5EF4-FFF2-40B4-BE49-F238E27FC236}">
-                <a16:creationId xmlns:a16="http://schemas.microsoft.com/office/drawing/2014/main" id="{9AAB7A8C-8B1D-4A7A-93E9-049E17493353}"/>
+                <a16:creationId xmlns:a16="http://schemas.microsoft.com/office/drawing/2014/main" id="{754E0EB6-59F3-407B-8A0B-48C080FD3314}"/>
               </a:ext>
             </a:extLst>
           </p:cNvPr>
@@ -2994,7 +4289,7 @@
           <p:cNvPr id="8" name="">
             <a:extLst xmlns:a="http://schemas.openxmlformats.org/drawingml/2006/main">
               <a:ext uri="{FF2B5EF4-FFF2-40B4-BE49-F238E27FC236}">
-                <a16:creationId xmlns:a16="http://schemas.microsoft.com/office/drawing/2014/main" id="{E41ABD46-71E0-4DB9-B747-77B06D5B3516}"/>
+                <a16:creationId xmlns:a16="http://schemas.microsoft.com/office/drawing/2014/main" id="{D3BA9781-8888-4E39-A6F5-0251214760E0}"/>
               </a:ext>
             </a:extLst>
           </p:cNvPr>
@@ -3044,7 +4339,7 @@
           <p:cNvPr id="9" name="">
             <a:extLst xmlns:a="http://schemas.openxmlformats.org/drawingml/2006/main">
               <a:ext uri="{FF2B5EF4-FFF2-40B4-BE49-F238E27FC236}">
-                <a16:creationId xmlns:a16="http://schemas.microsoft.com/office/drawing/2014/main" id="{096A9AAE-E82C-4720-812A-0D4946B0FCEE}"/>
+                <a16:creationId xmlns:a16="http://schemas.microsoft.com/office/drawing/2014/main" id="{7D31D6A5-590C-4B3D-BAFE-C5FFB91D8D74}"/>
               </a:ext>
             </a:extLst>
           </p:cNvPr>
@@ -3094,7 +4389,7 @@
           <p:cNvPr id="10" name="">
             <a:extLst xmlns:a="http://schemas.openxmlformats.org/drawingml/2006/main">
               <a:ext uri="{FF2B5EF4-FFF2-40B4-BE49-F238E27FC236}">
-                <a16:creationId xmlns:a16="http://schemas.microsoft.com/office/drawing/2014/main" id="{61160B5E-283D-4B39-9E26-86AF1A21E97E}"/>
+                <a16:creationId xmlns:a16="http://schemas.microsoft.com/office/drawing/2014/main" id="{C27FC1DA-90AF-4F56-902F-97683ECEB117}"/>
               </a:ext>
             </a:extLst>
           </p:cNvPr>
@@ -3144,7 +4439,7 @@
           <p:cNvPr id="11" name="">
             <a:extLst xmlns:a="http://schemas.openxmlformats.org/drawingml/2006/main">
               <a:ext uri="{FF2B5EF4-FFF2-40B4-BE49-F238E27FC236}">
-                <a16:creationId xmlns:a16="http://schemas.microsoft.com/office/drawing/2014/main" id="{DEA0A620-1499-4C8C-9779-5B81C1E9B8D7}"/>
+                <a16:creationId xmlns:a16="http://schemas.microsoft.com/office/drawing/2014/main" id="{0ED5B989-C1AC-4026-8F4F-BCD893B91FDD}"/>
               </a:ext>
             </a:extLst>
           </p:cNvPr>
@@ -3179,7 +4474,7 @@
           <p:cNvPr id="12" name="">
             <a:extLst xmlns:a="http://schemas.openxmlformats.org/drawingml/2006/main">
               <a:ext uri="{FF2B5EF4-FFF2-40B4-BE49-F238E27FC236}">
-                <a16:creationId xmlns:a16="http://schemas.microsoft.com/office/drawing/2014/main" id="{0E271240-12AD-4197-9874-59AD12A972F5}"/>
+                <a16:creationId xmlns:a16="http://schemas.microsoft.com/office/drawing/2014/main" id="{98421532-E4E5-472C-B5F1-A96794EA36DE}"/>
               </a:ext>
             </a:extLst>
           </p:cNvPr>
@@ -3229,7 +4524,7 @@
           <p:cNvPr id="13" name="">
             <a:extLst xmlns:a="http://schemas.openxmlformats.org/drawingml/2006/main">
               <a:ext uri="{FF2B5EF4-FFF2-40B4-BE49-F238E27FC236}">
-                <a16:creationId xmlns:a16="http://schemas.microsoft.com/office/drawing/2014/main" id="{1442192C-9A8F-4A32-881C-9D2D6FCB6197}"/>
+                <a16:creationId xmlns:a16="http://schemas.microsoft.com/office/drawing/2014/main" id="{4244315C-8B4D-4875-9760-245C5EF0218D}"/>
               </a:ext>
             </a:extLst>
           </p:cNvPr>
@@ -3279,7 +4574,7 @@
           <p:cNvPr id="14" name="">
             <a:extLst xmlns:a="http://schemas.openxmlformats.org/drawingml/2006/main">
               <a:ext uri="{FF2B5EF4-FFF2-40B4-BE49-F238E27FC236}">
-                <a16:creationId xmlns:a16="http://schemas.microsoft.com/office/drawing/2014/main" id="{3010C93D-115D-416A-ACC6-E3A292715326}"/>
+                <a16:creationId xmlns:a16="http://schemas.microsoft.com/office/drawing/2014/main" id="{FC24EC58-335B-4BD9-B8E2-46B93F0028A6}"/>
               </a:ext>
             </a:extLst>
           </p:cNvPr>
@@ -3329,7 +4624,7 @@
           <p:cNvPr id="15" name="">
             <a:extLst xmlns:a="http://schemas.openxmlformats.org/drawingml/2006/main">
               <a:ext uri="{FF2B5EF4-FFF2-40B4-BE49-F238E27FC236}">
-                <a16:creationId xmlns:a16="http://schemas.microsoft.com/office/drawing/2014/main" id="{D6D3D268-BEEF-4778-BD26-EFD53C4FB867}"/>
+                <a16:creationId xmlns:a16="http://schemas.microsoft.com/office/drawing/2014/main" id="{C89898BD-6F09-4D43-AE05-352DA79EB8C3}"/>
               </a:ext>
             </a:extLst>
           </p:cNvPr>
@@ -3364,7 +4659,7 @@
           <p:cNvPr id="16" name="">
             <a:extLst xmlns:a="http://schemas.openxmlformats.org/drawingml/2006/main">
               <a:ext uri="{FF2B5EF4-FFF2-40B4-BE49-F238E27FC236}">
-                <a16:creationId xmlns:a16="http://schemas.microsoft.com/office/drawing/2014/main" id="{2B5178BF-995A-4A29-80E0-D4F85A2FAFF9}"/>
+                <a16:creationId xmlns:a16="http://schemas.microsoft.com/office/drawing/2014/main" id="{6E37C455-E33F-4D46-940A-31AEE575EB0C}"/>
               </a:ext>
             </a:extLst>
           </p:cNvPr>
@@ -3414,7 +4709,7 @@
           <p:cNvPr id="17" name="">
             <a:extLst xmlns:a="http://schemas.openxmlformats.org/drawingml/2006/main">
               <a:ext uri="{FF2B5EF4-FFF2-40B4-BE49-F238E27FC236}">
-                <a16:creationId xmlns:a16="http://schemas.microsoft.com/office/drawing/2014/main" id="{DADF1759-77D3-4754-A043-87D046C82E1B}"/>
+                <a16:creationId xmlns:a16="http://schemas.microsoft.com/office/drawing/2014/main" id="{431B839C-ECAD-4519-870E-F4A698FF9CF9}"/>
               </a:ext>
             </a:extLst>
           </p:cNvPr>
@@ -3464,7 +4759,7 @@
           <p:cNvPr id="18" name="">
             <a:extLst xmlns:a="http://schemas.openxmlformats.org/drawingml/2006/main">
               <a:ext uri="{FF2B5EF4-FFF2-40B4-BE49-F238E27FC236}">
-                <a16:creationId xmlns:a16="http://schemas.microsoft.com/office/drawing/2014/main" id="{DC98FF0B-2B17-4F70-88FE-8304DEF05A22}"/>
+                <a16:creationId xmlns:a16="http://schemas.microsoft.com/office/drawing/2014/main" id="{14E7CE19-8101-49D3-A043-C32ADB7F3FCE}"/>
               </a:ext>
             </a:extLst>
           </p:cNvPr>
@@ -3514,7 +4809,7 @@
           <p:cNvPr id="19" name="">
             <a:extLst xmlns:a="http://schemas.openxmlformats.org/drawingml/2006/main">
               <a:ext uri="{FF2B5EF4-FFF2-40B4-BE49-F238E27FC236}">
-                <a16:creationId xmlns:a16="http://schemas.microsoft.com/office/drawing/2014/main" id="{E66DFCA9-8FD9-449C-831F-CD33CEE05208}"/>
+                <a16:creationId xmlns:a16="http://schemas.microsoft.com/office/drawing/2014/main" id="{7A36D4B5-7E5F-49D1-B57E-2FF8A4DBC14A}"/>
               </a:ext>
             </a:extLst>
           </p:cNvPr>
@@ -3549,7 +4844,7 @@
           <p:cNvPr id="20" name="">
             <a:extLst xmlns:a="http://schemas.openxmlformats.org/drawingml/2006/main">
               <a:ext uri="{FF2B5EF4-FFF2-40B4-BE49-F238E27FC236}">
-                <a16:creationId xmlns:a16="http://schemas.microsoft.com/office/drawing/2014/main" id="{EDD22A59-6806-4DE5-AF11-5F338F6FE749}"/>
+                <a16:creationId xmlns:a16="http://schemas.microsoft.com/office/drawing/2014/main" id="{F32B4C1D-02A3-4683-B33C-AE53816527CE}"/>
               </a:ext>
             </a:extLst>
           </p:cNvPr>
@@ -3599,7 +4894,7 @@
           <p:cNvPr id="21" name="">
             <a:extLst xmlns:a="http://schemas.openxmlformats.org/drawingml/2006/main">
               <a:ext uri="{FF2B5EF4-FFF2-40B4-BE49-F238E27FC236}">
-                <a16:creationId xmlns:a16="http://schemas.microsoft.com/office/drawing/2014/main" id="{E32FC3B7-0FAE-46F3-AF72-228EF272B6FC}"/>
+                <a16:creationId xmlns:a16="http://schemas.microsoft.com/office/drawing/2014/main" id="{CBE5EFB3-EE0C-4058-A7C6-F2F7D9AD25EC}"/>
               </a:ext>
             </a:extLst>
           </p:cNvPr>
@@ -3649,7 +4944,7 @@
           <p:cNvPr id="22" name="">
             <a:extLst xmlns:a="http://schemas.openxmlformats.org/drawingml/2006/main">
               <a:ext uri="{FF2B5EF4-FFF2-40B4-BE49-F238E27FC236}">
-                <a16:creationId xmlns:a16="http://schemas.microsoft.com/office/drawing/2014/main" id="{BD658E17-8C90-4FF7-9B43-8CCD1DF156C1}"/>
+                <a16:creationId xmlns:a16="http://schemas.microsoft.com/office/drawing/2014/main" id="{D25D699C-52B7-4B0A-BAB9-B0A5CD902748}"/>
               </a:ext>
             </a:extLst>
           </p:cNvPr>
@@ -3684,7 +4979,7 @@
           <p:cNvPr id="23" name="">
             <a:extLst xmlns:a="http://schemas.openxmlformats.org/drawingml/2006/main">
               <a:ext uri="{FF2B5EF4-FFF2-40B4-BE49-F238E27FC236}">
-                <a16:creationId xmlns:a16="http://schemas.microsoft.com/office/drawing/2014/main" id="{484D4CAF-69BB-4328-B8B0-B6BC5C6425FE}"/>
+                <a16:creationId xmlns:a16="http://schemas.microsoft.com/office/drawing/2014/main" id="{94D50774-64CF-4228-8500-20A380EF8EC0}"/>
               </a:ext>
             </a:extLst>
           </p:cNvPr>
@@ -3734,7 +5029,7 @@
           <p:cNvPr id="24" name="">
             <a:extLst xmlns:a="http://schemas.openxmlformats.org/drawingml/2006/main">
               <a:ext uri="{FF2B5EF4-FFF2-40B4-BE49-F238E27FC236}">
-                <a16:creationId xmlns:a16="http://schemas.microsoft.com/office/drawing/2014/main" id="{9193DF78-1B62-4618-9334-0768AD22B07E}"/>
+                <a16:creationId xmlns:a16="http://schemas.microsoft.com/office/drawing/2014/main" id="{94065F4F-411E-4623-8922-7C8DE483CF3B}"/>
               </a:ext>
             </a:extLst>
           </p:cNvPr>
@@ -3784,7 +5079,7 @@
           <p:cNvPr id="25" name="">
             <a:extLst xmlns:a="http://schemas.openxmlformats.org/drawingml/2006/main">
               <a:ext uri="{FF2B5EF4-FFF2-40B4-BE49-F238E27FC236}">
-                <a16:creationId xmlns:a16="http://schemas.microsoft.com/office/drawing/2014/main" id="{541AF021-097C-4ECC-8CE5-1D49324AC31C}"/>
+                <a16:creationId xmlns:a16="http://schemas.microsoft.com/office/drawing/2014/main" id="{423F398F-3919-4D49-80A0-FFCBC0783096}"/>
               </a:ext>
             </a:extLst>
           </p:cNvPr>
@@ -3834,7 +5129,7 @@
           <p:cNvPr id="26" name="">
             <a:extLst xmlns:a="http://schemas.openxmlformats.org/drawingml/2006/main">
               <a:ext uri="{FF2B5EF4-FFF2-40B4-BE49-F238E27FC236}">
-                <a16:creationId xmlns:a16="http://schemas.microsoft.com/office/drawing/2014/main" id="{C27257B0-D38C-44BA-BFBC-4EBF115ABA38}"/>
+                <a16:creationId xmlns:a16="http://schemas.microsoft.com/office/drawing/2014/main" id="{9CB8A09B-B7D0-4544-8304-506AFD00F09E}"/>
               </a:ext>
             </a:extLst>
           </p:cNvPr>
@@ -3874,7 +5169,7 @@
                   <a:srgbClr val="64748B"/>
                 </a:solidFill>
               </a:rPr>
-              <a:t>10</a:t>
+              <a:t>11</a:t>
             </a:r>
           </a:p>
         </p:txBody>
@@ -3882,7 +5177,7 @@
     </p:spTree>
     <p:extLst>
       <p:ext uri="{BB962C8B-B14F-4D97-AF65-F5344CB8AC3E}">
-        <p14:creationId xmlns:p14="http://schemas.microsoft.com/office/powerpoint/2010/main" val="1440689964"/>
+        <p14:creationId xmlns:p14="http://schemas.microsoft.com/office/powerpoint/2010/main" val="1006525070"/>
       </p:ext>
     </p:extLst>
   </p:cSld>
@@ -3913,7 +5208,7 @@
           <p:cNvPr id="14" name="">
             <a:extLst xmlns:a="http://schemas.openxmlformats.org/drawingml/2006/main">
               <a:ext uri="{FF2B5EF4-FFF2-40B4-BE49-F238E27FC236}">
-                <a16:creationId xmlns:a16="http://schemas.microsoft.com/office/drawing/2014/main" id="{40984737-2804-4F5C-8D6F-A7130D683613}"/>
+                <a16:creationId xmlns:a16="http://schemas.microsoft.com/office/drawing/2014/main" id="{456C125E-CFA9-4E94-9033-E1275FD00BAA}"/>
               </a:ext>
             </a:extLst>
           </p:cNvPr>
@@ -3963,7 +5258,7 @@
           <p:cNvPr id="2" name="">
             <a:extLst xmlns:a="http://schemas.openxmlformats.org/drawingml/2006/main">
               <a:ext uri="{FF2B5EF4-FFF2-40B4-BE49-F238E27FC236}">
-                <a16:creationId xmlns:a16="http://schemas.microsoft.com/office/drawing/2014/main" id="{32A9F450-C1E6-45BF-A8A7-BDCCD8676BE5}"/>
+                <a16:creationId xmlns:a16="http://schemas.microsoft.com/office/drawing/2014/main" id="{8E7A96EE-0F75-4FD1-8056-A16F52052304}"/>
               </a:ext>
             </a:extLst>
           </p:cNvPr>
@@ -4013,7 +5308,7 @@
           <p:cNvPr id="3" name="">
             <a:extLst xmlns:a="http://schemas.openxmlformats.org/drawingml/2006/main">
               <a:ext uri="{FF2B5EF4-FFF2-40B4-BE49-F238E27FC236}">
-                <a16:creationId xmlns:a16="http://schemas.microsoft.com/office/drawing/2014/main" id="{94607A23-EA65-4AEB-A8CE-175850697BFC}"/>
+                <a16:creationId xmlns:a16="http://schemas.microsoft.com/office/drawing/2014/main" id="{F3B7F689-AA0F-4FCE-B8C1-7A6B4384B8DB}"/>
               </a:ext>
             </a:extLst>
           </p:cNvPr>
@@ -4052,7 +5347,7 @@
           <p:nvPr/>
         </p:nvPicPr>
         <p:blipFill>
-          <a:blip xmlns:r="http://schemas.openxmlformats.org/officeDocument/2006/relationships" xmlns:a="http://schemas.openxmlformats.org/drawingml/2006/main" r:embed="R2c43e457889e46f4"/>
+          <a:blip xmlns:r="http://schemas.openxmlformats.org/officeDocument/2006/relationships" xmlns:a="http://schemas.openxmlformats.org/drawingml/2006/main" r:embed="R22d98f0133724c22"/>
           <a:stretch xmlns:a="http://schemas.openxmlformats.org/drawingml/2006/main"/>
         </p:blipFill>
         <p:spPr>
@@ -4070,7 +5365,7 @@
           <p:cNvPr id="5" name="">
             <a:extLst xmlns:a="http://schemas.openxmlformats.org/drawingml/2006/main">
               <a:ext uri="{FF2B5EF4-FFF2-40B4-BE49-F238E27FC236}">
-                <a16:creationId xmlns:a16="http://schemas.microsoft.com/office/drawing/2014/main" id="{BC4FC63D-821B-4768-B73E-C928C535061F}"/>
+                <a16:creationId xmlns:a16="http://schemas.microsoft.com/office/drawing/2014/main" id="{20F4A1EB-FCFF-4142-826D-425B3E83E44F}"/>
               </a:ext>
             </a:extLst>
           </p:cNvPr>
@@ -4105,7 +5400,7 @@
           <p:cNvPr id="6" name="">
             <a:extLst xmlns:a="http://schemas.openxmlformats.org/drawingml/2006/main">
               <a:ext uri="{FF2B5EF4-FFF2-40B4-BE49-F238E27FC236}">
-                <a16:creationId xmlns:a16="http://schemas.microsoft.com/office/drawing/2014/main" id="{88F344BF-32B1-4A1C-953F-BC26A485B69A}"/>
+                <a16:creationId xmlns:a16="http://schemas.microsoft.com/office/drawing/2014/main" id="{B50322F1-E9E0-4F53-8B6A-956EE8493103}"/>
               </a:ext>
             </a:extLst>
           </p:cNvPr>
@@ -4155,7 +5450,7 @@
           <p:cNvPr id="7" name="">
             <a:extLst xmlns:a="http://schemas.openxmlformats.org/drawingml/2006/main">
               <a:ext uri="{FF2B5EF4-FFF2-40B4-BE49-F238E27FC236}">
-                <a16:creationId xmlns:a16="http://schemas.microsoft.com/office/drawing/2014/main" id="{86232BA6-D3FD-4002-9D6D-BAC26115EEBC}"/>
+                <a16:creationId xmlns:a16="http://schemas.microsoft.com/office/drawing/2014/main" id="{F037026E-8FEE-4C7E-A872-20694153C51E}"/>
               </a:ext>
             </a:extLst>
           </p:cNvPr>
@@ -4205,7 +5500,7 @@
           <p:cNvPr id="8" name="">
             <a:extLst xmlns:a="http://schemas.openxmlformats.org/drawingml/2006/main">
               <a:ext uri="{FF2B5EF4-FFF2-40B4-BE49-F238E27FC236}">
-                <a16:creationId xmlns:a16="http://schemas.microsoft.com/office/drawing/2014/main" id="{C2633EB5-5D84-4E1E-9618-24461180B6EC}"/>
+                <a16:creationId xmlns:a16="http://schemas.microsoft.com/office/drawing/2014/main" id="{93B05141-627F-4798-93BF-18118E8A077C}"/>
               </a:ext>
             </a:extLst>
           </p:cNvPr>
@@ -4240,7 +5535,7 @@
           <p:cNvPr id="9" name="">
             <a:extLst xmlns:a="http://schemas.openxmlformats.org/drawingml/2006/main">
               <a:ext uri="{FF2B5EF4-FFF2-40B4-BE49-F238E27FC236}">
-                <a16:creationId xmlns:a16="http://schemas.microsoft.com/office/drawing/2014/main" id="{730A4D98-E39D-4326-A0FA-2C86AB217588}"/>
+                <a16:creationId xmlns:a16="http://schemas.microsoft.com/office/drawing/2014/main" id="{1F2B60C9-1D2D-4165-98F6-7F26DC785F8B}"/>
               </a:ext>
             </a:extLst>
           </p:cNvPr>
@@ -4290,7 +5585,7 @@
           <p:cNvPr id="10" name="">
             <a:extLst xmlns:a="http://schemas.openxmlformats.org/drawingml/2006/main">
               <a:ext uri="{FF2B5EF4-FFF2-40B4-BE49-F238E27FC236}">
-                <a16:creationId xmlns:a16="http://schemas.microsoft.com/office/drawing/2014/main" id="{8983C995-92D5-4767-A959-047139EEEF91}"/>
+                <a16:creationId xmlns:a16="http://schemas.microsoft.com/office/drawing/2014/main" id="{1247DCD4-AF7B-4F5E-8890-DA45AE548019}"/>
               </a:ext>
             </a:extLst>
           </p:cNvPr>
@@ -4340,7 +5635,7 @@
           <p:cNvPr id="11" name="">
             <a:extLst xmlns:a="http://schemas.openxmlformats.org/drawingml/2006/main">
               <a:ext uri="{FF2B5EF4-FFF2-40B4-BE49-F238E27FC236}">
-                <a16:creationId xmlns:a16="http://schemas.microsoft.com/office/drawing/2014/main" id="{C92AF838-1D9C-4F9B-BAE3-61D8D61A2277}"/>
+                <a16:creationId xmlns:a16="http://schemas.microsoft.com/office/drawing/2014/main" id="{98313591-67C0-4FE4-9445-5939A47FCE4E}"/>
               </a:ext>
             </a:extLst>
           </p:cNvPr>
@@ -4390,7 +5685,7 @@
           <p:cNvPr id="12" name="">
             <a:extLst xmlns:a="http://schemas.openxmlformats.org/drawingml/2006/main">
               <a:ext uri="{FF2B5EF4-FFF2-40B4-BE49-F238E27FC236}">
-                <a16:creationId xmlns:a16="http://schemas.microsoft.com/office/drawing/2014/main" id="{A7AC3A2F-A592-4CFD-8AC0-F20D19046F98}"/>
+                <a16:creationId xmlns:a16="http://schemas.microsoft.com/office/drawing/2014/main" id="{E4692B7C-5587-4231-AB47-847B62C12152}"/>
               </a:ext>
             </a:extLst>
           </p:cNvPr>
@@ -4440,7 +5735,7 @@
           <p:cNvPr id="13" name="">
             <a:extLst xmlns:a="http://schemas.openxmlformats.org/drawingml/2006/main">
               <a:ext uri="{FF2B5EF4-FFF2-40B4-BE49-F238E27FC236}">
-                <a16:creationId xmlns:a16="http://schemas.microsoft.com/office/drawing/2014/main" id="{14B51456-28B4-4C39-831B-70344476944E}"/>
+                <a16:creationId xmlns:a16="http://schemas.microsoft.com/office/drawing/2014/main" id="{4B2933B7-7A7D-47B1-A67E-FEFD860A2404}"/>
               </a:ext>
             </a:extLst>
           </p:cNvPr>
@@ -4488,7 +5783,7 @@
     </p:spTree>
     <p:extLst>
       <p:ext uri="{BB962C8B-B14F-4D97-AF65-F5344CB8AC3E}">
-        <p14:creationId xmlns:p14="http://schemas.microsoft.com/office/powerpoint/2010/main" val="1622963902"/>
+        <p14:creationId xmlns:p14="http://schemas.microsoft.com/office/powerpoint/2010/main" val="1158222287"/>
       </p:ext>
     </p:extLst>
   </p:cSld>
@@ -4519,7 +5814,7 @@
           <p:cNvPr id="44" name="">
             <a:extLst xmlns:a="http://schemas.openxmlformats.org/drawingml/2006/main">
               <a:ext uri="{FF2B5EF4-FFF2-40B4-BE49-F238E27FC236}">
-                <a16:creationId xmlns:a16="http://schemas.microsoft.com/office/drawing/2014/main" id="{EF8665A4-8A1F-41A2-8AE9-EC5292A66A6A}"/>
+                <a16:creationId xmlns:a16="http://schemas.microsoft.com/office/drawing/2014/main" id="{5D76668C-DE85-4AAE-A4B7-F895E830E27E}"/>
               </a:ext>
             </a:extLst>
           </p:cNvPr>
@@ -4569,7 +5864,7 @@
           <p:cNvPr id="2" name="">
             <a:extLst xmlns:a="http://schemas.openxmlformats.org/drawingml/2006/main">
               <a:ext uri="{FF2B5EF4-FFF2-40B4-BE49-F238E27FC236}">
-                <a16:creationId xmlns:a16="http://schemas.microsoft.com/office/drawing/2014/main" id="{7B82B209-E4B7-40FF-9CD4-63C3561263E1}"/>
+                <a16:creationId xmlns:a16="http://schemas.microsoft.com/office/drawing/2014/main" id="{01B7B60F-19C1-4F63-BD30-2F158CBF7BB9}"/>
               </a:ext>
             </a:extLst>
           </p:cNvPr>
@@ -4619,7 +5914,7 @@
           <p:cNvPr id="3" name="">
             <a:extLst xmlns:a="http://schemas.openxmlformats.org/drawingml/2006/main">
               <a:ext uri="{FF2B5EF4-FFF2-40B4-BE49-F238E27FC236}">
-                <a16:creationId xmlns:a16="http://schemas.microsoft.com/office/drawing/2014/main" id="{BD930137-9889-414B-91E6-1E211626CCC7}"/>
+                <a16:creationId xmlns:a16="http://schemas.microsoft.com/office/drawing/2014/main" id="{B3C1B354-4E7D-46C1-BCDE-42E08F8C4E20}"/>
               </a:ext>
             </a:extLst>
           </p:cNvPr>
@@ -4654,7 +5949,7 @@
           <p:cNvPr id="4" name="">
             <a:extLst xmlns:a="http://schemas.openxmlformats.org/drawingml/2006/main">
               <a:ext uri="{FF2B5EF4-FFF2-40B4-BE49-F238E27FC236}">
-                <a16:creationId xmlns:a16="http://schemas.microsoft.com/office/drawing/2014/main" id="{E246D9F4-D0A7-4F73-B492-1ECCF97C904B}"/>
+                <a16:creationId xmlns:a16="http://schemas.microsoft.com/office/drawing/2014/main" id="{D6A78837-70DE-4325-A3D4-5FD759CEB171}"/>
               </a:ext>
             </a:extLst>
           </p:cNvPr>
@@ -4721,7 +6016,7 @@
           <p:cNvPr id="5" name="">
             <a:extLst xmlns:a="http://schemas.openxmlformats.org/drawingml/2006/main">
               <a:ext uri="{FF2B5EF4-FFF2-40B4-BE49-F238E27FC236}">
-                <a16:creationId xmlns:a16="http://schemas.microsoft.com/office/drawing/2014/main" id="{6E3711EA-FFD8-48C5-9751-1CED0C0FB15D}"/>
+                <a16:creationId xmlns:a16="http://schemas.microsoft.com/office/drawing/2014/main" id="{CB275716-2FE3-49CB-85B9-6CBBB1F723F0}"/>
               </a:ext>
             </a:extLst>
           </p:cNvPr>
@@ -4771,7 +6066,7 @@
           <p:cNvPr id="6" name="">
             <a:extLst xmlns:a="http://schemas.openxmlformats.org/drawingml/2006/main">
               <a:ext uri="{FF2B5EF4-FFF2-40B4-BE49-F238E27FC236}">
-                <a16:creationId xmlns:a16="http://schemas.microsoft.com/office/drawing/2014/main" id="{900975EA-B461-4630-9A72-AE9AE1496D15}"/>
+                <a16:creationId xmlns:a16="http://schemas.microsoft.com/office/drawing/2014/main" id="{DF8AEE1B-08EA-4B7E-AB42-72A215EB5BD4}"/>
               </a:ext>
             </a:extLst>
           </p:cNvPr>
@@ -4806,7 +6101,7 @@
           <p:cNvPr id="7" name="">
             <a:extLst xmlns:a="http://schemas.openxmlformats.org/drawingml/2006/main">
               <a:ext uri="{FF2B5EF4-FFF2-40B4-BE49-F238E27FC236}">
-                <a16:creationId xmlns:a16="http://schemas.microsoft.com/office/drawing/2014/main" id="{FF4C8B94-0EBF-4FF0-B484-8B95ABC1CC0B}"/>
+                <a16:creationId xmlns:a16="http://schemas.microsoft.com/office/drawing/2014/main" id="{2FA1B7DC-6C25-44E4-A135-A484F0AFDED2}"/>
               </a:ext>
             </a:extLst>
           </p:cNvPr>
@@ -4873,7 +6168,7 @@
           <p:cNvPr id="8" name="">
             <a:extLst xmlns:a="http://schemas.openxmlformats.org/drawingml/2006/main">
               <a:ext uri="{FF2B5EF4-FFF2-40B4-BE49-F238E27FC236}">
-                <a16:creationId xmlns:a16="http://schemas.microsoft.com/office/drawing/2014/main" id="{1EEDF11C-A031-45D2-ACC8-2607C5DE64CA}"/>
+                <a16:creationId xmlns:a16="http://schemas.microsoft.com/office/drawing/2014/main" id="{711EF777-17A7-452B-AB71-A68556732159}"/>
               </a:ext>
             </a:extLst>
           </p:cNvPr>
@@ -4923,7 +6218,7 @@
           <p:cNvPr id="9" name="">
             <a:extLst xmlns:a="http://schemas.openxmlformats.org/drawingml/2006/main">
               <a:ext uri="{FF2B5EF4-FFF2-40B4-BE49-F238E27FC236}">
-                <a16:creationId xmlns:a16="http://schemas.microsoft.com/office/drawing/2014/main" id="{C1F9E7C9-0395-4D86-920F-8620B1FDF7C6}"/>
+                <a16:creationId xmlns:a16="http://schemas.microsoft.com/office/drawing/2014/main" id="{AF8C8EF3-2879-4C48-8B31-3B98314E3E8B}"/>
               </a:ext>
             </a:extLst>
           </p:cNvPr>
@@ -4958,7 +6253,7 @@
           <p:cNvPr id="10" name="">
             <a:extLst xmlns:a="http://schemas.openxmlformats.org/drawingml/2006/main">
               <a:ext uri="{FF2B5EF4-FFF2-40B4-BE49-F238E27FC236}">
-                <a16:creationId xmlns:a16="http://schemas.microsoft.com/office/drawing/2014/main" id="{78A1FE14-F8B7-49C0-B887-94FC0661A57A}"/>
+                <a16:creationId xmlns:a16="http://schemas.microsoft.com/office/drawing/2014/main" id="{91A913B0-E03B-462C-8F0E-D182D6CC2055}"/>
               </a:ext>
             </a:extLst>
           </p:cNvPr>
@@ -5025,7 +6320,7 @@
           <p:cNvPr id="11" name="">
             <a:extLst xmlns:a="http://schemas.openxmlformats.org/drawingml/2006/main">
               <a:ext uri="{FF2B5EF4-FFF2-40B4-BE49-F238E27FC236}">
-                <a16:creationId xmlns:a16="http://schemas.microsoft.com/office/drawing/2014/main" id="{B44567CF-497A-4EDF-93E6-C5AA4D1C2644}"/>
+                <a16:creationId xmlns:a16="http://schemas.microsoft.com/office/drawing/2014/main" id="{80DD1B9A-4357-4472-845B-05F5F933D2C0}"/>
               </a:ext>
             </a:extLst>
           </p:cNvPr>
@@ -5075,7 +6370,7 @@
           <p:cNvPr id="12" name="">
             <a:extLst xmlns:a="http://schemas.openxmlformats.org/drawingml/2006/main">
               <a:ext uri="{FF2B5EF4-FFF2-40B4-BE49-F238E27FC236}">
-                <a16:creationId xmlns:a16="http://schemas.microsoft.com/office/drawing/2014/main" id="{3430779C-1C67-4490-B52C-75BEBD409A0A}"/>
+                <a16:creationId xmlns:a16="http://schemas.microsoft.com/office/drawing/2014/main" id="{D43A8042-3B7B-47CF-B8F4-CA92B631B50F}"/>
               </a:ext>
             </a:extLst>
           </p:cNvPr>
@@ -5110,7 +6405,7 @@
           <p:cNvPr id="13" name="">
             <a:extLst xmlns:a="http://schemas.openxmlformats.org/drawingml/2006/main">
               <a:ext uri="{FF2B5EF4-FFF2-40B4-BE49-F238E27FC236}">
-                <a16:creationId xmlns:a16="http://schemas.microsoft.com/office/drawing/2014/main" id="{846109AE-6081-46C1-8FD7-26D91229852B}"/>
+                <a16:creationId xmlns:a16="http://schemas.microsoft.com/office/drawing/2014/main" id="{78EED882-3252-401B-B6F1-DFB069EDF770}"/>
               </a:ext>
             </a:extLst>
           </p:cNvPr>
@@ -5177,7 +6472,7 @@
           <p:cNvPr id="14" name="">
             <a:extLst xmlns:a="http://schemas.openxmlformats.org/drawingml/2006/main">
               <a:ext uri="{FF2B5EF4-FFF2-40B4-BE49-F238E27FC236}">
-                <a16:creationId xmlns:a16="http://schemas.microsoft.com/office/drawing/2014/main" id="{9709B589-91E4-4CF5-B385-D7B1C00E1EA7}"/>
+                <a16:creationId xmlns:a16="http://schemas.microsoft.com/office/drawing/2014/main" id="{49911DA4-F8F9-4825-940F-2C3EFF421446}"/>
               </a:ext>
             </a:extLst>
           </p:cNvPr>
@@ -5227,7 +6522,7 @@
           <p:cNvPr id="15" name="">
             <a:extLst xmlns:a="http://schemas.openxmlformats.org/drawingml/2006/main">
               <a:ext uri="{FF2B5EF4-FFF2-40B4-BE49-F238E27FC236}">
-                <a16:creationId xmlns:a16="http://schemas.microsoft.com/office/drawing/2014/main" id="{AADC263F-24E2-464C-B234-077FED9BF253}"/>
+                <a16:creationId xmlns:a16="http://schemas.microsoft.com/office/drawing/2014/main" id="{22DAF0E8-D2B1-45AF-BF61-26261587C590}"/>
               </a:ext>
             </a:extLst>
           </p:cNvPr>
@@ -5262,7 +6557,7 @@
           <p:cNvPr id="16" name="">
             <a:extLst xmlns:a="http://schemas.openxmlformats.org/drawingml/2006/main">
               <a:ext uri="{FF2B5EF4-FFF2-40B4-BE49-F238E27FC236}">
-                <a16:creationId xmlns:a16="http://schemas.microsoft.com/office/drawing/2014/main" id="{F5A42442-B4F0-4A4A-BD67-AAF55CF9D5FC}"/>
+                <a16:creationId xmlns:a16="http://schemas.microsoft.com/office/drawing/2014/main" id="{7DCC1C11-80D9-4664-BC8B-5CC4FCC223EA}"/>
               </a:ext>
             </a:extLst>
           </p:cNvPr>
@@ -5329,7 +6624,7 @@
           <p:cNvPr id="17" name="">
             <a:extLst xmlns:a="http://schemas.openxmlformats.org/drawingml/2006/main">
               <a:ext uri="{FF2B5EF4-FFF2-40B4-BE49-F238E27FC236}">
-                <a16:creationId xmlns:a16="http://schemas.microsoft.com/office/drawing/2014/main" id="{12823D04-8CB7-4E4B-AE74-F2EF4526E5F0}"/>
+                <a16:creationId xmlns:a16="http://schemas.microsoft.com/office/drawing/2014/main" id="{4CE6824F-D9FD-4999-89D0-FBD2BDA9B8CE}"/>
               </a:ext>
             </a:extLst>
           </p:cNvPr>
@@ -5364,7 +6659,7 @@
           <p:cNvPr id="18" name="">
             <a:extLst xmlns:a="http://schemas.openxmlformats.org/drawingml/2006/main">
               <a:ext uri="{FF2B5EF4-FFF2-40B4-BE49-F238E27FC236}">
-                <a16:creationId xmlns:a16="http://schemas.microsoft.com/office/drawing/2014/main" id="{00D85002-2124-4B6E-8EF2-68436AAF3913}"/>
+                <a16:creationId xmlns:a16="http://schemas.microsoft.com/office/drawing/2014/main" id="{63172E0B-B5D7-4C0F-8A95-E7215FE7CA55}"/>
               </a:ext>
             </a:extLst>
           </p:cNvPr>
@@ -5414,7 +6709,7 @@
           <p:cNvPr id="19" name="">
             <a:extLst xmlns:a="http://schemas.openxmlformats.org/drawingml/2006/main">
               <a:ext uri="{FF2B5EF4-FFF2-40B4-BE49-F238E27FC236}">
-                <a16:creationId xmlns:a16="http://schemas.microsoft.com/office/drawing/2014/main" id="{4EDB3108-7301-4BD0-898B-6937C4F36EC8}"/>
+                <a16:creationId xmlns:a16="http://schemas.microsoft.com/office/drawing/2014/main" id="{D214B62A-CE92-4824-ACB6-0D5D657E6933}"/>
               </a:ext>
             </a:extLst>
           </p:cNvPr>
@@ -5464,7 +6759,7 @@
           <p:cNvPr id="20" name="">
             <a:extLst xmlns:a="http://schemas.openxmlformats.org/drawingml/2006/main">
               <a:ext uri="{FF2B5EF4-FFF2-40B4-BE49-F238E27FC236}">
-                <a16:creationId xmlns:a16="http://schemas.microsoft.com/office/drawing/2014/main" id="{90DB8BA5-0C06-4EAE-80E9-BCB86D1CF17D}"/>
+                <a16:creationId xmlns:a16="http://schemas.microsoft.com/office/drawing/2014/main" id="{D77BBA88-8E58-48EA-86BF-6044FAC55F72}"/>
               </a:ext>
             </a:extLst>
           </p:cNvPr>
@@ -5499,7 +6794,7 @@
           <p:cNvPr id="21" name="">
             <a:extLst xmlns:a="http://schemas.openxmlformats.org/drawingml/2006/main">
               <a:ext uri="{FF2B5EF4-FFF2-40B4-BE49-F238E27FC236}">
-                <a16:creationId xmlns:a16="http://schemas.microsoft.com/office/drawing/2014/main" id="{93126720-994B-4833-AD4C-B49CE7294532}"/>
+                <a16:creationId xmlns:a16="http://schemas.microsoft.com/office/drawing/2014/main" id="{8EE3806C-14E5-4ABD-A6EE-230C625A0F97}"/>
               </a:ext>
             </a:extLst>
           </p:cNvPr>
@@ -5549,7 +6844,7 @@
           <p:cNvPr id="22" name="">
             <a:extLst xmlns:a="http://schemas.openxmlformats.org/drawingml/2006/main">
               <a:ext uri="{FF2B5EF4-FFF2-40B4-BE49-F238E27FC236}">
-                <a16:creationId xmlns:a16="http://schemas.microsoft.com/office/drawing/2014/main" id="{A4203075-2C51-4A56-A279-C95B3C391611}"/>
+                <a16:creationId xmlns:a16="http://schemas.microsoft.com/office/drawing/2014/main" id="{D2506BDE-D690-41B4-AAE8-C84D8D6B40E3}"/>
               </a:ext>
             </a:extLst>
           </p:cNvPr>
@@ -5599,7 +6894,7 @@
           <p:cNvPr id="23" name="">
             <a:extLst xmlns:a="http://schemas.openxmlformats.org/drawingml/2006/main">
               <a:ext uri="{FF2B5EF4-FFF2-40B4-BE49-F238E27FC236}">
-                <a16:creationId xmlns:a16="http://schemas.microsoft.com/office/drawing/2014/main" id="{990C3556-84E9-4869-8D49-C5E2A012D714}"/>
+                <a16:creationId xmlns:a16="http://schemas.microsoft.com/office/drawing/2014/main" id="{9CCC2AF3-0EF1-44CA-B718-9F81283757B7}"/>
               </a:ext>
             </a:extLst>
           </p:cNvPr>
@@ -5634,7 +6929,7 @@
           <p:cNvPr id="24" name="">
             <a:extLst xmlns:a="http://schemas.openxmlformats.org/drawingml/2006/main">
               <a:ext uri="{FF2B5EF4-FFF2-40B4-BE49-F238E27FC236}">
-                <a16:creationId xmlns:a16="http://schemas.microsoft.com/office/drawing/2014/main" id="{909045E5-36D8-48AD-9C16-A6D656926AF5}"/>
+                <a16:creationId xmlns:a16="http://schemas.microsoft.com/office/drawing/2014/main" id="{FAF9D5E7-296A-41D1-9400-60A2C12BB9D0}"/>
               </a:ext>
             </a:extLst>
           </p:cNvPr>
@@ -5684,7 +6979,7 @@
           <p:cNvPr id="25" name="">
             <a:extLst xmlns:a="http://schemas.openxmlformats.org/drawingml/2006/main">
               <a:ext uri="{FF2B5EF4-FFF2-40B4-BE49-F238E27FC236}">
-                <a16:creationId xmlns:a16="http://schemas.microsoft.com/office/drawing/2014/main" id="{0095C367-5847-4C83-9DA5-AD89BDC40112}"/>
+                <a16:creationId xmlns:a16="http://schemas.microsoft.com/office/drawing/2014/main" id="{A91B2E25-0224-4BEE-9220-3983AFBD5860}"/>
               </a:ext>
             </a:extLst>
           </p:cNvPr>
@@ -5734,7 +7029,7 @@
           <p:cNvPr id="26" name="">
             <a:extLst xmlns:a="http://schemas.openxmlformats.org/drawingml/2006/main">
               <a:ext uri="{FF2B5EF4-FFF2-40B4-BE49-F238E27FC236}">
-                <a16:creationId xmlns:a16="http://schemas.microsoft.com/office/drawing/2014/main" id="{84784A40-F4E0-45EA-9798-9D69442DE958}"/>
+                <a16:creationId xmlns:a16="http://schemas.microsoft.com/office/drawing/2014/main" id="{B7A10C7D-29C4-4566-8A81-343126E16C38}"/>
               </a:ext>
             </a:extLst>
           </p:cNvPr>
@@ -5769,7 +7064,7 @@
           <p:cNvPr id="27" name="">
             <a:extLst xmlns:a="http://schemas.openxmlformats.org/drawingml/2006/main">
               <a:ext uri="{FF2B5EF4-FFF2-40B4-BE49-F238E27FC236}">
-                <a16:creationId xmlns:a16="http://schemas.microsoft.com/office/drawing/2014/main" id="{153618BF-A8C1-4470-B4C0-E35D77B48A38}"/>
+                <a16:creationId xmlns:a16="http://schemas.microsoft.com/office/drawing/2014/main" id="{4A0E9200-E724-4A40-8E19-8DCD591F8BAE}"/>
               </a:ext>
             </a:extLst>
           </p:cNvPr>
@@ -5819,7 +7114,7 @@
           <p:cNvPr id="28" name="">
             <a:extLst xmlns:a="http://schemas.openxmlformats.org/drawingml/2006/main">
               <a:ext uri="{FF2B5EF4-FFF2-40B4-BE49-F238E27FC236}">
-                <a16:creationId xmlns:a16="http://schemas.microsoft.com/office/drawing/2014/main" id="{64BE7D69-4ABE-4791-8FD4-1DD66DD145B9}"/>
+                <a16:creationId xmlns:a16="http://schemas.microsoft.com/office/drawing/2014/main" id="{BBCE0D59-36C7-4F7B-8D96-512502F33AAD}"/>
               </a:ext>
             </a:extLst>
           </p:cNvPr>
@@ -5869,7 +7164,7 @@
           <p:cNvPr id="29" name="">
             <a:extLst xmlns:a="http://schemas.openxmlformats.org/drawingml/2006/main">
               <a:ext uri="{FF2B5EF4-FFF2-40B4-BE49-F238E27FC236}">
-                <a16:creationId xmlns:a16="http://schemas.microsoft.com/office/drawing/2014/main" id="{8461D877-27C7-4781-BCBE-4ADA4A1E043A}"/>
+                <a16:creationId xmlns:a16="http://schemas.microsoft.com/office/drawing/2014/main" id="{DD8BB145-8065-4ACB-9589-3B72194F091A}"/>
               </a:ext>
             </a:extLst>
           </p:cNvPr>
@@ -5904,7 +7199,7 @@
           <p:cNvPr id="30" name="">
             <a:extLst xmlns:a="http://schemas.openxmlformats.org/drawingml/2006/main">
               <a:ext uri="{FF2B5EF4-FFF2-40B4-BE49-F238E27FC236}">
-                <a16:creationId xmlns:a16="http://schemas.microsoft.com/office/drawing/2014/main" id="{390BF2CA-CFD9-4E5B-BDD6-95EC93F4E775}"/>
+                <a16:creationId xmlns:a16="http://schemas.microsoft.com/office/drawing/2014/main" id="{1D5E322D-4E77-483A-9775-1058BE82596F}"/>
               </a:ext>
             </a:extLst>
           </p:cNvPr>
@@ -5954,7 +7249,7 @@
           <p:cNvPr id="31" name="">
             <a:extLst xmlns:a="http://schemas.openxmlformats.org/drawingml/2006/main">
               <a:ext uri="{FF2B5EF4-FFF2-40B4-BE49-F238E27FC236}">
-                <a16:creationId xmlns:a16="http://schemas.microsoft.com/office/drawing/2014/main" id="{2C47FED7-0FDA-40A5-968C-EF3524EE82BA}"/>
+                <a16:creationId xmlns:a16="http://schemas.microsoft.com/office/drawing/2014/main" id="{297C8B62-39BD-46FB-B2CA-5589F126F4BA}"/>
               </a:ext>
             </a:extLst>
           </p:cNvPr>
@@ -6004,7 +7299,7 @@
           <p:cNvPr id="32" name="">
             <a:extLst xmlns:a="http://schemas.openxmlformats.org/drawingml/2006/main">
               <a:ext uri="{FF2B5EF4-FFF2-40B4-BE49-F238E27FC236}">
-                <a16:creationId xmlns:a16="http://schemas.microsoft.com/office/drawing/2014/main" id="{A0AE2487-355F-48ED-A54D-E6A9FB5ACC81}"/>
+                <a16:creationId xmlns:a16="http://schemas.microsoft.com/office/drawing/2014/main" id="{A8B1EF20-752C-4036-8B01-9A12D5CC8F59}"/>
               </a:ext>
             </a:extLst>
           </p:cNvPr>
@@ -6039,7 +7334,7 @@
           <p:cNvPr id="33" name="">
             <a:extLst xmlns:a="http://schemas.openxmlformats.org/drawingml/2006/main">
               <a:ext uri="{FF2B5EF4-FFF2-40B4-BE49-F238E27FC236}">
-                <a16:creationId xmlns:a16="http://schemas.microsoft.com/office/drawing/2014/main" id="{F5FA3C2F-C829-4FCC-AE42-F29B1F3F4DA1}"/>
+                <a16:creationId xmlns:a16="http://schemas.microsoft.com/office/drawing/2014/main" id="{BFC22588-0C36-4B1D-BFC5-02B5D2C0F5C1}"/>
               </a:ext>
             </a:extLst>
           </p:cNvPr>
@@ -6089,7 +7384,7 @@
           <p:cNvPr id="34" name="">
             <a:extLst xmlns:a="http://schemas.openxmlformats.org/drawingml/2006/main">
               <a:ext uri="{FF2B5EF4-FFF2-40B4-BE49-F238E27FC236}">
-                <a16:creationId xmlns:a16="http://schemas.microsoft.com/office/drawing/2014/main" id="{BB79FE45-059B-484B-B137-70F66B196C78}"/>
+                <a16:creationId xmlns:a16="http://schemas.microsoft.com/office/drawing/2014/main" id="{2A19B398-9432-43BF-8860-3B44EDED0559}"/>
               </a:ext>
             </a:extLst>
           </p:cNvPr>
@@ -6139,7 +7434,7 @@
           <p:cNvPr id="35" name="">
             <a:extLst xmlns:a="http://schemas.openxmlformats.org/drawingml/2006/main">
               <a:ext uri="{FF2B5EF4-FFF2-40B4-BE49-F238E27FC236}">
-                <a16:creationId xmlns:a16="http://schemas.microsoft.com/office/drawing/2014/main" id="{636673F7-669C-486E-980D-7B0CD1989B59}"/>
+                <a16:creationId xmlns:a16="http://schemas.microsoft.com/office/drawing/2014/main" id="{09437138-7BE3-4608-97E0-4074355190C0}"/>
               </a:ext>
             </a:extLst>
           </p:cNvPr>
@@ -6174,7 +7469,7 @@
           <p:cNvPr id="36" name="">
             <a:extLst xmlns:a="http://schemas.openxmlformats.org/drawingml/2006/main">
               <a:ext uri="{FF2B5EF4-FFF2-40B4-BE49-F238E27FC236}">
-                <a16:creationId xmlns:a16="http://schemas.microsoft.com/office/drawing/2014/main" id="{1C90BBA7-C151-4B66-BDF1-DEFEEEA1C979}"/>
+                <a16:creationId xmlns:a16="http://schemas.microsoft.com/office/drawing/2014/main" id="{C1E6A6B1-EC17-4CCC-B944-0F10B6E57B42}"/>
               </a:ext>
             </a:extLst>
           </p:cNvPr>
@@ -6224,7 +7519,7 @@
           <p:cNvPr id="37" name="">
             <a:extLst xmlns:a="http://schemas.openxmlformats.org/drawingml/2006/main">
               <a:ext uri="{FF2B5EF4-FFF2-40B4-BE49-F238E27FC236}">
-                <a16:creationId xmlns:a16="http://schemas.microsoft.com/office/drawing/2014/main" id="{53D36C85-6A9E-4ECC-BF4B-1159DEF7EB4F}"/>
+                <a16:creationId xmlns:a16="http://schemas.microsoft.com/office/drawing/2014/main" id="{9F04F906-178A-4E85-8463-A3EBAD7C29DF}"/>
               </a:ext>
             </a:extLst>
           </p:cNvPr>
@@ -6274,7 +7569,7 @@
           <p:cNvPr id="38" name="">
             <a:extLst xmlns:a="http://schemas.openxmlformats.org/drawingml/2006/main">
               <a:ext uri="{FF2B5EF4-FFF2-40B4-BE49-F238E27FC236}">
-                <a16:creationId xmlns:a16="http://schemas.microsoft.com/office/drawing/2014/main" id="{4CBEAFFA-FD18-4F02-9BE7-3023F7A40D12}"/>
+                <a16:creationId xmlns:a16="http://schemas.microsoft.com/office/drawing/2014/main" id="{8AC64079-9D19-4EFC-80E5-DE028C22C33E}"/>
               </a:ext>
             </a:extLst>
           </p:cNvPr>
@@ -6309,7 +7604,7 @@
           <p:cNvPr id="39" name="">
             <a:extLst xmlns:a="http://schemas.openxmlformats.org/drawingml/2006/main">
               <a:ext uri="{FF2B5EF4-FFF2-40B4-BE49-F238E27FC236}">
-                <a16:creationId xmlns:a16="http://schemas.microsoft.com/office/drawing/2014/main" id="{BDB9E5F6-1B47-4019-BDB0-E665E50694F7}"/>
+                <a16:creationId xmlns:a16="http://schemas.microsoft.com/office/drawing/2014/main" id="{A90BCC01-5B9A-4A6D-A232-BCE1EE716BB5}"/>
               </a:ext>
             </a:extLst>
           </p:cNvPr>
@@ -6359,7 +7654,7 @@
           <p:cNvPr id="40" name="">
             <a:extLst xmlns:a="http://schemas.openxmlformats.org/drawingml/2006/main">
               <a:ext uri="{FF2B5EF4-FFF2-40B4-BE49-F238E27FC236}">
-                <a16:creationId xmlns:a16="http://schemas.microsoft.com/office/drawing/2014/main" id="{BCD4693D-0B85-4852-9AE1-67100EC38E13}"/>
+                <a16:creationId xmlns:a16="http://schemas.microsoft.com/office/drawing/2014/main" id="{D70B7FB8-AB0F-4845-A1A3-5B83408D94E2}"/>
               </a:ext>
             </a:extLst>
           </p:cNvPr>
@@ -6409,7 +7704,7 @@
           <p:cNvPr id="41" name="">
             <a:extLst xmlns:a="http://schemas.openxmlformats.org/drawingml/2006/main">
               <a:ext uri="{FF2B5EF4-FFF2-40B4-BE49-F238E27FC236}">
-                <a16:creationId xmlns:a16="http://schemas.microsoft.com/office/drawing/2014/main" id="{9D64CF76-FB15-4EC6-ADE6-D3C57FCB8512}"/>
+                <a16:creationId xmlns:a16="http://schemas.microsoft.com/office/drawing/2014/main" id="{7B1F3AC4-0F56-4A98-8C5F-B3C0C620DDE1}"/>
               </a:ext>
             </a:extLst>
           </p:cNvPr>
@@ -6459,7 +7754,7 @@
           <p:cNvPr id="42" name="">
             <a:extLst xmlns:a="http://schemas.openxmlformats.org/drawingml/2006/main">
               <a:ext uri="{FF2B5EF4-FFF2-40B4-BE49-F238E27FC236}">
-                <a16:creationId xmlns:a16="http://schemas.microsoft.com/office/drawing/2014/main" id="{F83092EF-C7D1-4DD4-AD04-403C45AF8AD3}"/>
+                <a16:creationId xmlns:a16="http://schemas.microsoft.com/office/drawing/2014/main" id="{DA640CEE-D46F-4360-A0B5-4FC8FBD42A24}"/>
               </a:ext>
             </a:extLst>
           </p:cNvPr>
@@ -6509,7 +7804,7 @@
           <p:cNvPr id="43" name="">
             <a:extLst xmlns:a="http://schemas.openxmlformats.org/drawingml/2006/main">
               <a:ext uri="{FF2B5EF4-FFF2-40B4-BE49-F238E27FC236}">
-                <a16:creationId xmlns:a16="http://schemas.microsoft.com/office/drawing/2014/main" id="{72C50B5B-5D46-424D-9DCB-1041EC5CE587}"/>
+                <a16:creationId xmlns:a16="http://schemas.microsoft.com/office/drawing/2014/main" id="{FDA669F1-FFD5-4FC6-ABB8-6D3AF770FCE5}"/>
               </a:ext>
             </a:extLst>
           </p:cNvPr>
@@ -6557,7 +7852,7 @@
     </p:spTree>
     <p:extLst>
       <p:ext uri="{BB962C8B-B14F-4D97-AF65-F5344CB8AC3E}">
-        <p14:creationId xmlns:p14="http://schemas.microsoft.com/office/powerpoint/2010/main" val="191738990"/>
+        <p14:creationId xmlns:p14="http://schemas.microsoft.com/office/powerpoint/2010/main" val="607571319"/>
       </p:ext>
     </p:extLst>
   </p:cSld>
@@ -6588,7 +7883,7 @@
           <p:cNvPr id="26" name="">
             <a:extLst xmlns:a="http://schemas.openxmlformats.org/drawingml/2006/main">
               <a:ext uri="{FF2B5EF4-FFF2-40B4-BE49-F238E27FC236}">
-                <a16:creationId xmlns:a16="http://schemas.microsoft.com/office/drawing/2014/main" id="{FC9904DF-E872-4045-A561-59C33C009C8B}"/>
+                <a16:creationId xmlns:a16="http://schemas.microsoft.com/office/drawing/2014/main" id="{43B133D8-36FC-41E2-9A95-30B9F70BBDEF}"/>
               </a:ext>
             </a:extLst>
           </p:cNvPr>
@@ -6638,7 +7933,7 @@
           <p:cNvPr id="2" name="">
             <a:extLst xmlns:a="http://schemas.openxmlformats.org/drawingml/2006/main">
               <a:ext uri="{FF2B5EF4-FFF2-40B4-BE49-F238E27FC236}">
-                <a16:creationId xmlns:a16="http://schemas.microsoft.com/office/drawing/2014/main" id="{A56AB9AC-A3CB-4B18-BED9-CD9E80758276}"/>
+                <a16:creationId xmlns:a16="http://schemas.microsoft.com/office/drawing/2014/main" id="{56C7D7D2-EB65-4398-B221-613AB92EB068}"/>
               </a:ext>
             </a:extLst>
           </p:cNvPr>
@@ -6688,7 +7983,7 @@
           <p:cNvPr id="3" name="">
             <a:extLst xmlns:a="http://schemas.openxmlformats.org/drawingml/2006/main">
               <a:ext uri="{FF2B5EF4-FFF2-40B4-BE49-F238E27FC236}">
-                <a16:creationId xmlns:a16="http://schemas.microsoft.com/office/drawing/2014/main" id="{5F4B55C9-65DA-4685-81A3-C27CDBD432C2}"/>
+                <a16:creationId xmlns:a16="http://schemas.microsoft.com/office/drawing/2014/main" id="{FF4FAD7E-08BC-4BCF-BAE1-8F2D3806C409}"/>
               </a:ext>
             </a:extLst>
           </p:cNvPr>
@@ -6723,7 +8018,7 @@
           <p:cNvPr id="4" name="">
             <a:extLst xmlns:a="http://schemas.openxmlformats.org/drawingml/2006/main">
               <a:ext uri="{FF2B5EF4-FFF2-40B4-BE49-F238E27FC236}">
-                <a16:creationId xmlns:a16="http://schemas.microsoft.com/office/drawing/2014/main" id="{93F0BB8C-C628-4F65-BE8F-1889250FF303}"/>
+                <a16:creationId xmlns:a16="http://schemas.microsoft.com/office/drawing/2014/main" id="{6284BA9F-915A-49BF-93D1-CEAC0692ED66}"/>
               </a:ext>
             </a:extLst>
           </p:cNvPr>
@@ -6773,7 +8068,7 @@
           <p:cNvPr id="5" name="">
             <a:extLst xmlns:a="http://schemas.openxmlformats.org/drawingml/2006/main">
               <a:ext uri="{FF2B5EF4-FFF2-40B4-BE49-F238E27FC236}">
-                <a16:creationId xmlns:a16="http://schemas.microsoft.com/office/drawing/2014/main" id="{0F6329F6-D543-4769-ACD9-8F3B99378530}"/>
+                <a16:creationId xmlns:a16="http://schemas.microsoft.com/office/drawing/2014/main" id="{7BA0716D-08AD-4DAF-A736-66D45C018D47}"/>
               </a:ext>
             </a:extLst>
           </p:cNvPr>
@@ -6804,7 +8099,7 @@
           <p:cNvPr id="6" name="">
             <a:extLst xmlns:a="http://schemas.openxmlformats.org/drawingml/2006/main">
               <a:ext uri="{FF2B5EF4-FFF2-40B4-BE49-F238E27FC236}">
-                <a16:creationId xmlns:a16="http://schemas.microsoft.com/office/drawing/2014/main" id="{8E8AC30A-8C12-4000-AB09-1C85346A041F}"/>
+                <a16:creationId xmlns:a16="http://schemas.microsoft.com/office/drawing/2014/main" id="{DFE81315-318D-43AC-A6DA-769523898FEB}"/>
               </a:ext>
             </a:extLst>
           </p:cNvPr>
@@ -6854,7 +8149,7 @@
           <p:cNvPr id="7" name="">
             <a:extLst xmlns:a="http://schemas.openxmlformats.org/drawingml/2006/main">
               <a:ext uri="{FF2B5EF4-FFF2-40B4-BE49-F238E27FC236}">
-                <a16:creationId xmlns:a16="http://schemas.microsoft.com/office/drawing/2014/main" id="{D540C6D3-4E7B-4110-86F9-DDF2E685B486}"/>
+                <a16:creationId xmlns:a16="http://schemas.microsoft.com/office/drawing/2014/main" id="{2CB513AF-5075-4586-8CEE-68D185DF134A}"/>
               </a:ext>
             </a:extLst>
           </p:cNvPr>
@@ -6885,7 +8180,7 @@
           <p:cNvPr id="8" name="">
             <a:extLst xmlns:a="http://schemas.openxmlformats.org/drawingml/2006/main">
               <a:ext uri="{FF2B5EF4-FFF2-40B4-BE49-F238E27FC236}">
-                <a16:creationId xmlns:a16="http://schemas.microsoft.com/office/drawing/2014/main" id="{C4D255D1-B9FB-4A5C-A046-259AF007BC25}"/>
+                <a16:creationId xmlns:a16="http://schemas.microsoft.com/office/drawing/2014/main" id="{7DC3254C-767F-4361-BD88-5C472F8BE027}"/>
               </a:ext>
             </a:extLst>
           </p:cNvPr>
@@ -6935,7 +8230,7 @@
           <p:cNvPr id="9" name="">
             <a:extLst xmlns:a="http://schemas.openxmlformats.org/drawingml/2006/main">
               <a:ext uri="{FF2B5EF4-FFF2-40B4-BE49-F238E27FC236}">
-                <a16:creationId xmlns:a16="http://schemas.microsoft.com/office/drawing/2014/main" id="{EE07DE1B-FD83-472C-9C54-7BFD8C2A2AE5}"/>
+                <a16:creationId xmlns:a16="http://schemas.microsoft.com/office/drawing/2014/main" id="{D0AE9A68-C86E-4A42-8EA8-4158FB3606FC}"/>
               </a:ext>
             </a:extLst>
           </p:cNvPr>
@@ -6966,7 +8261,7 @@
           <p:cNvPr id="10" name="">
             <a:extLst xmlns:a="http://schemas.openxmlformats.org/drawingml/2006/main">
               <a:ext uri="{FF2B5EF4-FFF2-40B4-BE49-F238E27FC236}">
-                <a16:creationId xmlns:a16="http://schemas.microsoft.com/office/drawing/2014/main" id="{65864CE6-4F40-4B3B-9DCF-1989D3A55C2F}"/>
+                <a16:creationId xmlns:a16="http://schemas.microsoft.com/office/drawing/2014/main" id="{B8FA3165-95C7-452F-AF68-B071B8B345A8}"/>
               </a:ext>
             </a:extLst>
           </p:cNvPr>
@@ -7016,7 +8311,7 @@
           <p:cNvPr id="11" name="">
             <a:extLst xmlns:a="http://schemas.openxmlformats.org/drawingml/2006/main">
               <a:ext uri="{FF2B5EF4-FFF2-40B4-BE49-F238E27FC236}">
-                <a16:creationId xmlns:a16="http://schemas.microsoft.com/office/drawing/2014/main" id="{A2A5A1B3-EF58-427A-A302-7488677A4CAC}"/>
+                <a16:creationId xmlns:a16="http://schemas.microsoft.com/office/drawing/2014/main" id="{8F1B2C55-920F-4198-BDBF-7A434E5A6478}"/>
               </a:ext>
             </a:extLst>
           </p:cNvPr>
@@ -7047,7 +8342,7 @@
           <p:cNvPr id="12" name="">
             <a:extLst xmlns:a="http://schemas.openxmlformats.org/drawingml/2006/main">
               <a:ext uri="{FF2B5EF4-FFF2-40B4-BE49-F238E27FC236}">
-                <a16:creationId xmlns:a16="http://schemas.microsoft.com/office/drawing/2014/main" id="{0BDF1B09-1858-46A3-91CC-0696BDFDAD35}"/>
+                <a16:creationId xmlns:a16="http://schemas.microsoft.com/office/drawing/2014/main" id="{303B1280-49D0-4236-847F-65F97891353E}"/>
               </a:ext>
             </a:extLst>
           </p:cNvPr>
@@ -7097,7 +8392,7 @@
           <p:cNvPr id="13" name="">
             <a:extLst xmlns:a="http://schemas.openxmlformats.org/drawingml/2006/main">
               <a:ext uri="{FF2B5EF4-FFF2-40B4-BE49-F238E27FC236}">
-                <a16:creationId xmlns:a16="http://schemas.microsoft.com/office/drawing/2014/main" id="{EA0F9C3A-4953-4E69-839E-61F413213550}"/>
+                <a16:creationId xmlns:a16="http://schemas.microsoft.com/office/drawing/2014/main" id="{F862CA72-161E-4011-92CE-86C96CDBA670}"/>
               </a:ext>
             </a:extLst>
           </p:cNvPr>
@@ -7147,7 +8442,7 @@
           <p:cNvPr id="14" name="">
             <a:extLst xmlns:a="http://schemas.openxmlformats.org/drawingml/2006/main">
               <a:ext uri="{FF2B5EF4-FFF2-40B4-BE49-F238E27FC236}">
-                <a16:creationId xmlns:a16="http://schemas.microsoft.com/office/drawing/2014/main" id="{6DE10328-14AA-45F7-93F6-C7C579DD01CF}"/>
+                <a16:creationId xmlns:a16="http://schemas.microsoft.com/office/drawing/2014/main" id="{97CC03F3-C3C2-43F1-BBE1-48046526646B}"/>
               </a:ext>
             </a:extLst>
           </p:cNvPr>
@@ -7182,7 +8477,7 @@
           <p:cNvPr id="15" name="">
             <a:extLst xmlns:a="http://schemas.openxmlformats.org/drawingml/2006/main">
               <a:ext uri="{FF2B5EF4-FFF2-40B4-BE49-F238E27FC236}">
-                <a16:creationId xmlns:a16="http://schemas.microsoft.com/office/drawing/2014/main" id="{85664607-2746-401F-9495-DF7B130A9A9B}"/>
+                <a16:creationId xmlns:a16="http://schemas.microsoft.com/office/drawing/2014/main" id="{5A3875DD-33B5-4BDE-B1DC-631ECB12E139}"/>
               </a:ext>
             </a:extLst>
           </p:cNvPr>
@@ -7232,7 +8527,7 @@
           <p:cNvPr id="16" name="">
             <a:extLst xmlns:a="http://schemas.openxmlformats.org/drawingml/2006/main">
               <a:ext uri="{FF2B5EF4-FFF2-40B4-BE49-F238E27FC236}">
-                <a16:creationId xmlns:a16="http://schemas.microsoft.com/office/drawing/2014/main" id="{B175B546-3EB1-47C9-9BE3-6ACB71470822}"/>
+                <a16:creationId xmlns:a16="http://schemas.microsoft.com/office/drawing/2014/main" id="{78F08C0D-B270-40FF-9360-8E8A5F9C568A}"/>
               </a:ext>
             </a:extLst>
           </p:cNvPr>
@@ -7263,7 +8558,7 @@
           <p:cNvPr id="17" name="">
             <a:extLst xmlns:a="http://schemas.openxmlformats.org/drawingml/2006/main">
               <a:ext uri="{FF2B5EF4-FFF2-40B4-BE49-F238E27FC236}">
-                <a16:creationId xmlns:a16="http://schemas.microsoft.com/office/drawing/2014/main" id="{9DA6C38D-A402-4C55-BAC2-CB4567160A4E}"/>
+                <a16:creationId xmlns:a16="http://schemas.microsoft.com/office/drawing/2014/main" id="{58BB8879-846C-4096-9BB5-417CE7F66B24}"/>
               </a:ext>
             </a:extLst>
           </p:cNvPr>
@@ -7313,7 +8608,7 @@
           <p:cNvPr id="18" name="">
             <a:extLst xmlns:a="http://schemas.openxmlformats.org/drawingml/2006/main">
               <a:ext uri="{FF2B5EF4-FFF2-40B4-BE49-F238E27FC236}">
-                <a16:creationId xmlns:a16="http://schemas.microsoft.com/office/drawing/2014/main" id="{8E6D2637-CA3C-4CBB-A3BA-91448A4F9892}"/>
+                <a16:creationId xmlns:a16="http://schemas.microsoft.com/office/drawing/2014/main" id="{55FF0281-08A3-4CCE-9676-9056E55837CA}"/>
               </a:ext>
             </a:extLst>
           </p:cNvPr>
@@ -7344,7 +8639,7 @@
           <p:cNvPr id="19" name="">
             <a:extLst xmlns:a="http://schemas.openxmlformats.org/drawingml/2006/main">
               <a:ext uri="{FF2B5EF4-FFF2-40B4-BE49-F238E27FC236}">
-                <a16:creationId xmlns:a16="http://schemas.microsoft.com/office/drawing/2014/main" id="{6D4A5B4F-F585-4DD7-A281-967B03522D9D}"/>
+                <a16:creationId xmlns:a16="http://schemas.microsoft.com/office/drawing/2014/main" id="{5A69BB1B-67C0-407C-8CC8-FA418D0B5F49}"/>
               </a:ext>
             </a:extLst>
           </p:cNvPr>
@@ -7394,7 +8689,7 @@
           <p:cNvPr id="20" name="">
             <a:extLst xmlns:a="http://schemas.openxmlformats.org/drawingml/2006/main">
               <a:ext uri="{FF2B5EF4-FFF2-40B4-BE49-F238E27FC236}">
-                <a16:creationId xmlns:a16="http://schemas.microsoft.com/office/drawing/2014/main" id="{C96109B9-C728-459C-8471-3AA8370E8687}"/>
+                <a16:creationId xmlns:a16="http://schemas.microsoft.com/office/drawing/2014/main" id="{F49B8BE5-08C5-483E-AD85-1EF8671BBA39}"/>
               </a:ext>
             </a:extLst>
           </p:cNvPr>
@@ -7425,7 +8720,7 @@
           <p:cNvPr id="21" name="">
             <a:extLst xmlns:a="http://schemas.openxmlformats.org/drawingml/2006/main">
               <a:ext uri="{FF2B5EF4-FFF2-40B4-BE49-F238E27FC236}">
-                <a16:creationId xmlns:a16="http://schemas.microsoft.com/office/drawing/2014/main" id="{F9682262-66E1-46F2-8B4D-7DB191D7D6C6}"/>
+                <a16:creationId xmlns:a16="http://schemas.microsoft.com/office/drawing/2014/main" id="{58AD7F28-6970-45A6-A405-ADF5E0AA3C7D}"/>
               </a:ext>
             </a:extLst>
           </p:cNvPr>
@@ -7475,7 +8770,7 @@
           <p:cNvPr id="22" name="">
             <a:extLst xmlns:a="http://schemas.openxmlformats.org/drawingml/2006/main">
               <a:ext uri="{FF2B5EF4-FFF2-40B4-BE49-F238E27FC236}">
-                <a16:creationId xmlns:a16="http://schemas.microsoft.com/office/drawing/2014/main" id="{1D93A7D0-ED24-458B-AC6C-B4AC0F7C06C2}"/>
+                <a16:creationId xmlns:a16="http://schemas.microsoft.com/office/drawing/2014/main" id="{11484F66-F65E-4EF9-90B6-9F0F4E22E35F}"/>
               </a:ext>
             </a:extLst>
           </p:cNvPr>
@@ -7506,7 +8801,7 @@
           <p:cNvPr id="23" name="">
             <a:extLst xmlns:a="http://schemas.openxmlformats.org/drawingml/2006/main">
               <a:ext uri="{FF2B5EF4-FFF2-40B4-BE49-F238E27FC236}">
-                <a16:creationId xmlns:a16="http://schemas.microsoft.com/office/drawing/2014/main" id="{8851CE3D-3CD3-48EC-A723-3EB79E938B3D}"/>
+                <a16:creationId xmlns:a16="http://schemas.microsoft.com/office/drawing/2014/main" id="{4675F407-ACED-4F53-88DC-C0E8AF21D0B7}"/>
               </a:ext>
             </a:extLst>
           </p:cNvPr>
@@ -7556,7 +8851,7 @@
           <p:cNvPr id="24" name="">
             <a:extLst xmlns:a="http://schemas.openxmlformats.org/drawingml/2006/main">
               <a:ext uri="{FF2B5EF4-FFF2-40B4-BE49-F238E27FC236}">
-                <a16:creationId xmlns:a16="http://schemas.microsoft.com/office/drawing/2014/main" id="{449C23BF-4ED4-42CE-BB79-0F8EE0A2EDE7}"/>
+                <a16:creationId xmlns:a16="http://schemas.microsoft.com/office/drawing/2014/main" id="{88B70E44-9E47-4FFA-92A4-970EE5B5261B}"/>
               </a:ext>
             </a:extLst>
           </p:cNvPr>
@@ -7606,7 +8901,7 @@
           <p:cNvPr id="25" name="">
             <a:extLst xmlns:a="http://schemas.openxmlformats.org/drawingml/2006/main">
               <a:ext uri="{FF2B5EF4-FFF2-40B4-BE49-F238E27FC236}">
-                <a16:creationId xmlns:a16="http://schemas.microsoft.com/office/drawing/2014/main" id="{0E14A752-2D97-46AF-A739-2274E50B8EAB}"/>
+                <a16:creationId xmlns:a16="http://schemas.microsoft.com/office/drawing/2014/main" id="{D92D41CC-74EC-4F4D-987B-E0EDB6515A5E}"/>
               </a:ext>
             </a:extLst>
           </p:cNvPr>
@@ -7654,7 +8949,7 @@
     </p:spTree>
     <p:extLst>
       <p:ext uri="{BB962C8B-B14F-4D97-AF65-F5344CB8AC3E}">
-        <p14:creationId xmlns:p14="http://schemas.microsoft.com/office/powerpoint/2010/main" val="1169519708"/>
+        <p14:creationId xmlns:p14="http://schemas.microsoft.com/office/powerpoint/2010/main" val="1921973542"/>
       </p:ext>
     </p:extLst>
   </p:cSld>
@@ -7685,7 +8980,7 @@
           <p:cNvPr id="8" name="">
             <a:extLst xmlns:a="http://schemas.openxmlformats.org/drawingml/2006/main">
               <a:ext uri="{FF2B5EF4-FFF2-40B4-BE49-F238E27FC236}">
-                <a16:creationId xmlns:a16="http://schemas.microsoft.com/office/drawing/2014/main" id="{064E0F9E-2978-4805-8A99-42194A0191ED}"/>
+                <a16:creationId xmlns:a16="http://schemas.microsoft.com/office/drawing/2014/main" id="{15C032E1-64FF-4FF7-A2EC-5631FAEDE309}"/>
               </a:ext>
             </a:extLst>
           </p:cNvPr>
@@ -7735,7 +9030,7 @@
           <p:cNvPr id="2" name="">
             <a:extLst xmlns:a="http://schemas.openxmlformats.org/drawingml/2006/main">
               <a:ext uri="{FF2B5EF4-FFF2-40B4-BE49-F238E27FC236}">
-                <a16:creationId xmlns:a16="http://schemas.microsoft.com/office/drawing/2014/main" id="{65345122-7962-4FEF-A84A-AEF2D086BF75}"/>
+                <a16:creationId xmlns:a16="http://schemas.microsoft.com/office/drawing/2014/main" id="{AD2BE603-D614-44B4-8068-05D4C85CEA53}"/>
               </a:ext>
             </a:extLst>
           </p:cNvPr>
@@ -7785,7 +9080,7 @@
           <p:cNvPr id="3" name="">
             <a:extLst xmlns:a="http://schemas.openxmlformats.org/drawingml/2006/main">
               <a:ext uri="{FF2B5EF4-FFF2-40B4-BE49-F238E27FC236}">
-                <a16:creationId xmlns:a16="http://schemas.microsoft.com/office/drawing/2014/main" id="{211862FF-9821-4999-B6EE-DE5A7F7B676D}"/>
+                <a16:creationId xmlns:a16="http://schemas.microsoft.com/office/drawing/2014/main" id="{A0B23157-8A3E-40C0-9CF9-0321EE5C4B5E}"/>
               </a:ext>
             </a:extLst>
           </p:cNvPr>
@@ -7824,7 +9119,7 @@
           <p:nvPr/>
         </p:nvPicPr>
         <p:blipFill>
-          <a:blip xmlns:r="http://schemas.openxmlformats.org/officeDocument/2006/relationships" xmlns:a="http://schemas.openxmlformats.org/drawingml/2006/main" r:embed="Ra60f92ac3142478a"/>
+          <a:blip xmlns:r="http://schemas.openxmlformats.org/officeDocument/2006/relationships" xmlns:a="http://schemas.openxmlformats.org/drawingml/2006/main" r:embed="Rf6f1a72317b649e8"/>
           <a:stretch xmlns:a="http://schemas.openxmlformats.org/drawingml/2006/main"/>
         </p:blipFill>
         <p:spPr>
@@ -7842,7 +9137,7 @@
           <p:cNvPr id="5" name="">
             <a:extLst xmlns:a="http://schemas.openxmlformats.org/drawingml/2006/main">
               <a:ext uri="{FF2B5EF4-FFF2-40B4-BE49-F238E27FC236}">
-                <a16:creationId xmlns:a16="http://schemas.microsoft.com/office/drawing/2014/main" id="{3CA55B69-90C1-4D6A-95AC-BC1D51880B4F}"/>
+                <a16:creationId xmlns:a16="http://schemas.microsoft.com/office/drawing/2014/main" id="{0C95FAF7-1A8F-4AED-B42E-99A8D1FC08CF}"/>
               </a:ext>
             </a:extLst>
           </p:cNvPr>
@@ -7892,7 +9187,7 @@
           <p:cNvPr id="6" name="">
             <a:extLst xmlns:a="http://schemas.openxmlformats.org/drawingml/2006/main">
               <a:ext uri="{FF2B5EF4-FFF2-40B4-BE49-F238E27FC236}">
-                <a16:creationId xmlns:a16="http://schemas.microsoft.com/office/drawing/2014/main" id="{4F4852C3-0125-4FCB-848D-A08A5D953547}"/>
+                <a16:creationId xmlns:a16="http://schemas.microsoft.com/office/drawing/2014/main" id="{C9EA2A8B-F625-4231-9A31-A90C894FCD1D}"/>
               </a:ext>
             </a:extLst>
           </p:cNvPr>
@@ -7942,7 +9237,7 @@
           <p:cNvPr id="7" name="">
             <a:extLst xmlns:a="http://schemas.openxmlformats.org/drawingml/2006/main">
               <a:ext uri="{FF2B5EF4-FFF2-40B4-BE49-F238E27FC236}">
-                <a16:creationId xmlns:a16="http://schemas.microsoft.com/office/drawing/2014/main" id="{9F2F6E27-0464-4F0B-9055-B8DF8EDA32E3}"/>
+                <a16:creationId xmlns:a16="http://schemas.microsoft.com/office/drawing/2014/main" id="{49CB5D53-F1CF-48C5-B053-9170DBE60679}"/>
               </a:ext>
             </a:extLst>
           </p:cNvPr>
@@ -7990,7 +9285,7 @@
     </p:spTree>
     <p:extLst>
       <p:ext uri="{BB962C8B-B14F-4D97-AF65-F5344CB8AC3E}">
-        <p14:creationId xmlns:p14="http://schemas.microsoft.com/office/powerpoint/2010/main" val="387956659"/>
+        <p14:creationId xmlns:p14="http://schemas.microsoft.com/office/powerpoint/2010/main" val="1089820716"/>
       </p:ext>
     </p:extLst>
   </p:cSld>
@@ -8021,7 +9316,7 @@
           <p:cNvPr id="16" name="">
             <a:extLst xmlns:a="http://schemas.openxmlformats.org/drawingml/2006/main">
               <a:ext uri="{FF2B5EF4-FFF2-40B4-BE49-F238E27FC236}">
-                <a16:creationId xmlns:a16="http://schemas.microsoft.com/office/drawing/2014/main" id="{547E4C7B-A4A8-4569-A66F-28CC2434A6F3}"/>
+                <a16:creationId xmlns:a16="http://schemas.microsoft.com/office/drawing/2014/main" id="{18C9C0CB-F7A7-4BE9-ACB0-1C702AA840AC}"/>
               </a:ext>
             </a:extLst>
           </p:cNvPr>
@@ -8071,7 +9366,7 @@
           <p:cNvPr id="2" name="">
             <a:extLst xmlns:a="http://schemas.openxmlformats.org/drawingml/2006/main">
               <a:ext uri="{FF2B5EF4-FFF2-40B4-BE49-F238E27FC236}">
-                <a16:creationId xmlns:a16="http://schemas.microsoft.com/office/drawing/2014/main" id="{7B7A393E-CE68-49D4-9F0E-EA8C04916D77}"/>
+                <a16:creationId xmlns:a16="http://schemas.microsoft.com/office/drawing/2014/main" id="{CD065499-DFED-430E-9547-474C4B961A42}"/>
               </a:ext>
             </a:extLst>
           </p:cNvPr>
@@ -8121,7 +9416,7 @@
           <p:cNvPr id="3" name="">
             <a:extLst xmlns:a="http://schemas.openxmlformats.org/drawingml/2006/main">
               <a:ext uri="{FF2B5EF4-FFF2-40B4-BE49-F238E27FC236}">
-                <a16:creationId xmlns:a16="http://schemas.microsoft.com/office/drawing/2014/main" id="{DC792BF2-6CB7-4A2B-99D0-3B906B1CCA4E}"/>
+                <a16:creationId xmlns:a16="http://schemas.microsoft.com/office/drawing/2014/main" id="{DA7CE27A-A994-41E8-A353-ADAC8AE6EA19}"/>
               </a:ext>
             </a:extLst>
           </p:cNvPr>
@@ -8160,7 +9455,7 @@
           <p:nvPr/>
         </p:nvPicPr>
         <p:blipFill>
-          <a:blip xmlns:r="http://schemas.openxmlformats.org/officeDocument/2006/relationships" xmlns:a="http://schemas.openxmlformats.org/drawingml/2006/main" r:embed="Rb6d142085d9b42ab"/>
+          <a:blip xmlns:r="http://schemas.openxmlformats.org/officeDocument/2006/relationships" xmlns:a="http://schemas.openxmlformats.org/drawingml/2006/main" r:embed="Rd2befd4d13e64aa4"/>
           <a:stretch xmlns:a="http://schemas.openxmlformats.org/drawingml/2006/main"/>
         </p:blipFill>
         <p:spPr>
@@ -8178,7 +9473,7 @@
           <p:cNvPr id="5" name="">
             <a:extLst xmlns:a="http://schemas.openxmlformats.org/drawingml/2006/main">
               <a:ext uri="{FF2B5EF4-FFF2-40B4-BE49-F238E27FC236}">
-                <a16:creationId xmlns:a16="http://schemas.microsoft.com/office/drawing/2014/main" id="{05CB8AE5-5131-4AD4-B2EF-9E24EEEE37C4}"/>
+                <a16:creationId xmlns:a16="http://schemas.microsoft.com/office/drawing/2014/main" id="{318EB209-A8D6-49A4-ABF0-9D0681C257FB}"/>
               </a:ext>
             </a:extLst>
           </p:cNvPr>
@@ -8213,7 +9508,7 @@
           <p:cNvPr id="6" name="">
             <a:extLst xmlns:a="http://schemas.openxmlformats.org/drawingml/2006/main">
               <a:ext uri="{FF2B5EF4-FFF2-40B4-BE49-F238E27FC236}">
-                <a16:creationId xmlns:a16="http://schemas.microsoft.com/office/drawing/2014/main" id="{6359ED24-9912-4890-92AA-3DF7546EAA7D}"/>
+                <a16:creationId xmlns:a16="http://schemas.microsoft.com/office/drawing/2014/main" id="{9D3C770C-A96A-474E-B2A6-0BC1708AC562}"/>
               </a:ext>
             </a:extLst>
           </p:cNvPr>
@@ -8263,7 +9558,7 @@
           <p:cNvPr id="7" name="">
             <a:extLst xmlns:a="http://schemas.openxmlformats.org/drawingml/2006/main">
               <a:ext uri="{FF2B5EF4-FFF2-40B4-BE49-F238E27FC236}">
-                <a16:creationId xmlns:a16="http://schemas.microsoft.com/office/drawing/2014/main" id="{8A7E27C9-65A6-4FC3-B283-FCD79A8C472D}"/>
+                <a16:creationId xmlns:a16="http://schemas.microsoft.com/office/drawing/2014/main" id="{F679ECA5-0E89-47A0-A0E1-0935EB07995F}"/>
               </a:ext>
             </a:extLst>
           </p:cNvPr>
@@ -8313,7 +9608,7 @@
           <p:cNvPr id="8" name="">
             <a:extLst xmlns:a="http://schemas.openxmlformats.org/drawingml/2006/main">
               <a:ext uri="{FF2B5EF4-FFF2-40B4-BE49-F238E27FC236}">
-                <a16:creationId xmlns:a16="http://schemas.microsoft.com/office/drawing/2014/main" id="{6DF60C98-54B1-4FAF-AAF3-5150F35B0E16}"/>
+                <a16:creationId xmlns:a16="http://schemas.microsoft.com/office/drawing/2014/main" id="{4C7571D6-00C8-4618-8C9A-684196BAE708}"/>
               </a:ext>
             </a:extLst>
           </p:cNvPr>
@@ -8363,7 +9658,7 @@
           <p:cNvPr id="9" name="">
             <a:extLst xmlns:a="http://schemas.openxmlformats.org/drawingml/2006/main">
               <a:ext uri="{FF2B5EF4-FFF2-40B4-BE49-F238E27FC236}">
-                <a16:creationId xmlns:a16="http://schemas.microsoft.com/office/drawing/2014/main" id="{1919D814-B982-4DF7-A54D-8169F905CDF3}"/>
+                <a16:creationId xmlns:a16="http://schemas.microsoft.com/office/drawing/2014/main" id="{BBD0D283-6E61-4C14-8D1E-BF66CA354F97}"/>
               </a:ext>
             </a:extLst>
           </p:cNvPr>
@@ -8398,7 +9693,7 @@
           <p:cNvPr id="10" name="">
             <a:extLst xmlns:a="http://schemas.openxmlformats.org/drawingml/2006/main">
               <a:ext uri="{FF2B5EF4-FFF2-40B4-BE49-F238E27FC236}">
-                <a16:creationId xmlns:a16="http://schemas.microsoft.com/office/drawing/2014/main" id="{598FCF1A-44BB-4AB0-B3D7-D8D4ADC9E975}"/>
+                <a16:creationId xmlns:a16="http://schemas.microsoft.com/office/drawing/2014/main" id="{8EB1FBEA-1B74-453F-998B-A7217DD2AADC}"/>
               </a:ext>
             </a:extLst>
           </p:cNvPr>
@@ -8448,7 +9743,7 @@
           <p:cNvPr id="11" name="">
             <a:extLst xmlns:a="http://schemas.openxmlformats.org/drawingml/2006/main">
               <a:ext uri="{FF2B5EF4-FFF2-40B4-BE49-F238E27FC236}">
-                <a16:creationId xmlns:a16="http://schemas.microsoft.com/office/drawing/2014/main" id="{1D21F941-8D67-49BB-BF57-979B2B831DFE}"/>
+                <a16:creationId xmlns:a16="http://schemas.microsoft.com/office/drawing/2014/main" id="{8B69C191-CF0D-479F-A0E3-BAF40514DFF8}"/>
               </a:ext>
             </a:extLst>
           </p:cNvPr>
@@ -8498,7 +9793,7 @@
           <p:cNvPr id="12" name="">
             <a:extLst xmlns:a="http://schemas.openxmlformats.org/drawingml/2006/main">
               <a:ext uri="{FF2B5EF4-FFF2-40B4-BE49-F238E27FC236}">
-                <a16:creationId xmlns:a16="http://schemas.microsoft.com/office/drawing/2014/main" id="{B5295529-18D6-4E15-8626-C9C1B70DA4DA}"/>
+                <a16:creationId xmlns:a16="http://schemas.microsoft.com/office/drawing/2014/main" id="{BC24C7C3-B06C-4DCB-AF18-92BB5AFA83C4}"/>
               </a:ext>
             </a:extLst>
           </p:cNvPr>
@@ -8548,7 +9843,7 @@
           <p:cNvPr id="13" name="">
             <a:extLst xmlns:a="http://schemas.openxmlformats.org/drawingml/2006/main">
               <a:ext uri="{FF2B5EF4-FFF2-40B4-BE49-F238E27FC236}">
-                <a16:creationId xmlns:a16="http://schemas.microsoft.com/office/drawing/2014/main" id="{0BF5292F-7FAC-4E8F-B45F-4AA1FDC55F96}"/>
+                <a16:creationId xmlns:a16="http://schemas.microsoft.com/office/drawing/2014/main" id="{BB8A9760-8712-432D-944C-9AA402984734}"/>
               </a:ext>
             </a:extLst>
           </p:cNvPr>
@@ -8598,7 +9893,7 @@
           <p:cNvPr id="14" name="">
             <a:extLst xmlns:a="http://schemas.openxmlformats.org/drawingml/2006/main">
               <a:ext uri="{FF2B5EF4-FFF2-40B4-BE49-F238E27FC236}">
-                <a16:creationId xmlns:a16="http://schemas.microsoft.com/office/drawing/2014/main" id="{F21CFDE2-0351-41F8-9FB4-D929694D5C7E}"/>
+                <a16:creationId xmlns:a16="http://schemas.microsoft.com/office/drawing/2014/main" id="{CE4B4A13-B36E-4EC3-9A7A-18288BEC6DA4}"/>
               </a:ext>
             </a:extLst>
           </p:cNvPr>
@@ -8648,7 +9943,7 @@
           <p:cNvPr id="15" name="">
             <a:extLst xmlns:a="http://schemas.openxmlformats.org/drawingml/2006/main">
               <a:ext uri="{FF2B5EF4-FFF2-40B4-BE49-F238E27FC236}">
-                <a16:creationId xmlns:a16="http://schemas.microsoft.com/office/drawing/2014/main" id="{531F7D17-3789-49A6-8D03-DBE0C3099972}"/>
+                <a16:creationId xmlns:a16="http://schemas.microsoft.com/office/drawing/2014/main" id="{3D5DA55F-FBD2-4963-82B6-87EFD35E261A}"/>
               </a:ext>
             </a:extLst>
           </p:cNvPr>
@@ -8696,7 +9991,7 @@
     </p:spTree>
     <p:extLst>
       <p:ext uri="{BB962C8B-B14F-4D97-AF65-F5344CB8AC3E}">
-        <p14:creationId xmlns:p14="http://schemas.microsoft.com/office/powerpoint/2010/main" val="1166197037"/>
+        <p14:creationId xmlns:p14="http://schemas.microsoft.com/office/powerpoint/2010/main" val="1972104334"/>
       </p:ext>
     </p:extLst>
   </p:cSld>
@@ -8727,7 +10022,7 @@
           <p:cNvPr id="19" name="">
             <a:extLst xmlns:a="http://schemas.openxmlformats.org/drawingml/2006/main">
               <a:ext uri="{FF2B5EF4-FFF2-40B4-BE49-F238E27FC236}">
-                <a16:creationId xmlns:a16="http://schemas.microsoft.com/office/drawing/2014/main" id="{8A4613DF-F9B4-4BFC-8D6D-B0DA39BE49E7}"/>
+                <a16:creationId xmlns:a16="http://schemas.microsoft.com/office/drawing/2014/main" id="{26666CC0-26A8-4AB1-B521-4069E3B45A1C}"/>
               </a:ext>
             </a:extLst>
           </p:cNvPr>
@@ -8777,7 +10072,7 @@
           <p:cNvPr id="2" name="">
             <a:extLst xmlns:a="http://schemas.openxmlformats.org/drawingml/2006/main">
               <a:ext uri="{FF2B5EF4-FFF2-40B4-BE49-F238E27FC236}">
-                <a16:creationId xmlns:a16="http://schemas.microsoft.com/office/drawing/2014/main" id="{E199B795-95D7-4E93-85A6-D5A3C9C003DB}"/>
+                <a16:creationId xmlns:a16="http://schemas.microsoft.com/office/drawing/2014/main" id="{FD442541-361D-4DAD-B60B-0D944BC75F8D}"/>
               </a:ext>
             </a:extLst>
           </p:cNvPr>
@@ -8827,7 +10122,7 @@
           <p:cNvPr id="3" name="">
             <a:extLst xmlns:a="http://schemas.openxmlformats.org/drawingml/2006/main">
               <a:ext uri="{FF2B5EF4-FFF2-40B4-BE49-F238E27FC236}">
-                <a16:creationId xmlns:a16="http://schemas.microsoft.com/office/drawing/2014/main" id="{CC5A896C-106A-488E-9F35-4329E8164F93}"/>
+                <a16:creationId xmlns:a16="http://schemas.microsoft.com/office/drawing/2014/main" id="{308A0188-0627-4041-B1BC-13289A91E5A6}"/>
               </a:ext>
             </a:extLst>
           </p:cNvPr>
@@ -8866,7 +10161,7 @@
           <p:nvPr/>
         </p:nvPicPr>
         <p:blipFill>
-          <a:blip xmlns:r="http://schemas.openxmlformats.org/officeDocument/2006/relationships" xmlns:a="http://schemas.openxmlformats.org/drawingml/2006/main" r:embed="Raa64803f388a4bec"/>
+          <a:blip xmlns:r="http://schemas.openxmlformats.org/officeDocument/2006/relationships" xmlns:a="http://schemas.openxmlformats.org/drawingml/2006/main" r:embed="Rde40053323ef4c98"/>
           <a:stretch xmlns:a="http://schemas.openxmlformats.org/drawingml/2006/main"/>
         </p:blipFill>
         <p:spPr>
@@ -8884,7 +10179,7 @@
           <p:cNvPr id="5" name="">
             <a:extLst xmlns:a="http://schemas.openxmlformats.org/drawingml/2006/main">
               <a:ext uri="{FF2B5EF4-FFF2-40B4-BE49-F238E27FC236}">
-                <a16:creationId xmlns:a16="http://schemas.microsoft.com/office/drawing/2014/main" id="{81FC3205-5B72-496C-8891-43F05149FC5D}"/>
+                <a16:creationId xmlns:a16="http://schemas.microsoft.com/office/drawing/2014/main" id="{A03E889E-AAB2-4ACC-B5AA-B2DEDCBB915A}"/>
               </a:ext>
             </a:extLst>
           </p:cNvPr>
@@ -8919,7 +10214,7 @@
           <p:cNvPr id="6" name="">
             <a:extLst xmlns:a="http://schemas.openxmlformats.org/drawingml/2006/main">
               <a:ext uri="{FF2B5EF4-FFF2-40B4-BE49-F238E27FC236}">
-                <a16:creationId xmlns:a16="http://schemas.microsoft.com/office/drawing/2014/main" id="{7A690524-3B70-4D47-B64D-A1A40154F528}"/>
+                <a16:creationId xmlns:a16="http://schemas.microsoft.com/office/drawing/2014/main" id="{DBDEA58E-EE76-4D7B-8FDD-6B8DAB743500}"/>
               </a:ext>
             </a:extLst>
           </p:cNvPr>
@@ -8969,7 +10264,7 @@
           <p:cNvPr id="7" name="">
             <a:extLst xmlns:a="http://schemas.openxmlformats.org/drawingml/2006/main">
               <a:ext uri="{FF2B5EF4-FFF2-40B4-BE49-F238E27FC236}">
-                <a16:creationId xmlns:a16="http://schemas.microsoft.com/office/drawing/2014/main" id="{E21206F9-DD38-4C31-8A60-F2B680E96ACA}"/>
+                <a16:creationId xmlns:a16="http://schemas.microsoft.com/office/drawing/2014/main" id="{8EE01444-5B72-4C5D-B91D-1A17B8CE2570}"/>
               </a:ext>
             </a:extLst>
           </p:cNvPr>
@@ -9019,7 +10314,7 @@
           <p:cNvPr id="8" name="">
             <a:extLst xmlns:a="http://schemas.openxmlformats.org/drawingml/2006/main">
               <a:ext uri="{FF2B5EF4-FFF2-40B4-BE49-F238E27FC236}">
-                <a16:creationId xmlns:a16="http://schemas.microsoft.com/office/drawing/2014/main" id="{1A22EED6-326F-4475-8BDB-8EA9AD5A7614}"/>
+                <a16:creationId xmlns:a16="http://schemas.microsoft.com/office/drawing/2014/main" id="{1184EAFA-293F-41E8-925A-A5835C5D1F63}"/>
               </a:ext>
             </a:extLst>
           </p:cNvPr>
@@ -9054,7 +10349,7 @@
           <p:cNvPr id="9" name="">
             <a:extLst xmlns:a="http://schemas.openxmlformats.org/drawingml/2006/main">
               <a:ext uri="{FF2B5EF4-FFF2-40B4-BE49-F238E27FC236}">
-                <a16:creationId xmlns:a16="http://schemas.microsoft.com/office/drawing/2014/main" id="{FD088CC6-4BE6-4B45-B08A-F200B6B62AF7}"/>
+                <a16:creationId xmlns:a16="http://schemas.microsoft.com/office/drawing/2014/main" id="{7FBF1629-2085-4B16-AD96-9E0F9A483F43}"/>
               </a:ext>
             </a:extLst>
           </p:cNvPr>
@@ -9104,7 +10399,7 @@
           <p:cNvPr id="10" name="">
             <a:extLst xmlns:a="http://schemas.openxmlformats.org/drawingml/2006/main">
               <a:ext uri="{FF2B5EF4-FFF2-40B4-BE49-F238E27FC236}">
-                <a16:creationId xmlns:a16="http://schemas.microsoft.com/office/drawing/2014/main" id="{9DEF483D-8906-48FE-93A5-21397BB8ECCD}"/>
+                <a16:creationId xmlns:a16="http://schemas.microsoft.com/office/drawing/2014/main" id="{D24D4B37-0DD8-45A6-A10D-9F4C33C4DB56}"/>
               </a:ext>
             </a:extLst>
           </p:cNvPr>
@@ -9154,7 +10449,7 @@
           <p:cNvPr id="11" name="">
             <a:extLst xmlns:a="http://schemas.openxmlformats.org/drawingml/2006/main">
               <a:ext uri="{FF2B5EF4-FFF2-40B4-BE49-F238E27FC236}">
-                <a16:creationId xmlns:a16="http://schemas.microsoft.com/office/drawing/2014/main" id="{CCD68155-73C7-4AA9-9EDE-6180850749F3}"/>
+                <a16:creationId xmlns:a16="http://schemas.microsoft.com/office/drawing/2014/main" id="{DB52334E-FD14-48C5-86F7-C80709B0A90A}"/>
               </a:ext>
             </a:extLst>
           </p:cNvPr>
@@ -9189,7 +10484,7 @@
           <p:cNvPr id="12" name="">
             <a:extLst xmlns:a="http://schemas.openxmlformats.org/drawingml/2006/main">
               <a:ext uri="{FF2B5EF4-FFF2-40B4-BE49-F238E27FC236}">
-                <a16:creationId xmlns:a16="http://schemas.microsoft.com/office/drawing/2014/main" id="{A4B80967-9A17-46B6-8512-BAD9CE769292}"/>
+                <a16:creationId xmlns:a16="http://schemas.microsoft.com/office/drawing/2014/main" id="{64C9E881-8B90-4543-8055-FBE53AED8A77}"/>
               </a:ext>
             </a:extLst>
           </p:cNvPr>
@@ -9239,7 +10534,7 @@
           <p:cNvPr id="13" name="">
             <a:extLst xmlns:a="http://schemas.openxmlformats.org/drawingml/2006/main">
               <a:ext uri="{FF2B5EF4-FFF2-40B4-BE49-F238E27FC236}">
-                <a16:creationId xmlns:a16="http://schemas.microsoft.com/office/drawing/2014/main" id="{8875D84C-EA46-4D7C-8BA3-57F7BE6A5017}"/>
+                <a16:creationId xmlns:a16="http://schemas.microsoft.com/office/drawing/2014/main" id="{168BB3AB-97C5-4234-ACCF-7BB4AA46F9E1}"/>
               </a:ext>
             </a:extLst>
           </p:cNvPr>
@@ -9289,7 +10584,7 @@
           <p:cNvPr id="14" name="">
             <a:extLst xmlns:a="http://schemas.openxmlformats.org/drawingml/2006/main">
               <a:ext uri="{FF2B5EF4-FFF2-40B4-BE49-F238E27FC236}">
-                <a16:creationId xmlns:a16="http://schemas.microsoft.com/office/drawing/2014/main" id="{1E45C44A-479D-40F4-A04D-B60E3DFF339E}"/>
+                <a16:creationId xmlns:a16="http://schemas.microsoft.com/office/drawing/2014/main" id="{E61FBC2D-62F6-4838-9992-656E6522C25A}"/>
               </a:ext>
             </a:extLst>
           </p:cNvPr>
@@ -9339,7 +10634,7 @@
           <p:cNvPr id="15" name="">
             <a:extLst xmlns:a="http://schemas.openxmlformats.org/drawingml/2006/main">
               <a:ext uri="{FF2B5EF4-FFF2-40B4-BE49-F238E27FC236}">
-                <a16:creationId xmlns:a16="http://schemas.microsoft.com/office/drawing/2014/main" id="{38CA4649-E6AB-4C21-AA16-7B6F683879CF}"/>
+                <a16:creationId xmlns:a16="http://schemas.microsoft.com/office/drawing/2014/main" id="{64818A14-D399-4193-9409-3B51A7718540}"/>
               </a:ext>
             </a:extLst>
           </p:cNvPr>
@@ -9389,7 +10684,7 @@
           <p:cNvPr id="16" name="">
             <a:extLst xmlns:a="http://schemas.openxmlformats.org/drawingml/2006/main">
               <a:ext uri="{FF2B5EF4-FFF2-40B4-BE49-F238E27FC236}">
-                <a16:creationId xmlns:a16="http://schemas.microsoft.com/office/drawing/2014/main" id="{1BE4B4EC-FF02-4814-89B3-B6A54BC2BED2}"/>
+                <a16:creationId xmlns:a16="http://schemas.microsoft.com/office/drawing/2014/main" id="{2FAB6770-DBC7-4FBE-9392-4EFE8BCF2BE5}"/>
               </a:ext>
             </a:extLst>
           </p:cNvPr>
@@ -9439,7 +10734,7 @@
           <p:cNvPr id="17" name="">
             <a:extLst xmlns:a="http://schemas.openxmlformats.org/drawingml/2006/main">
               <a:ext uri="{FF2B5EF4-FFF2-40B4-BE49-F238E27FC236}">
-                <a16:creationId xmlns:a16="http://schemas.microsoft.com/office/drawing/2014/main" id="{89CB325D-25F2-44B5-B04F-257AC7448D35}"/>
+                <a16:creationId xmlns:a16="http://schemas.microsoft.com/office/drawing/2014/main" id="{F485A3B4-6C7D-4E37-90D2-F475A271727F}"/>
               </a:ext>
             </a:extLst>
           </p:cNvPr>
@@ -9489,7 +10784,7 @@
           <p:cNvPr id="18" name="">
             <a:extLst xmlns:a="http://schemas.openxmlformats.org/drawingml/2006/main">
               <a:ext uri="{FF2B5EF4-FFF2-40B4-BE49-F238E27FC236}">
-                <a16:creationId xmlns:a16="http://schemas.microsoft.com/office/drawing/2014/main" id="{5CC25300-651E-48A4-B342-D499D85F4F46}"/>
+                <a16:creationId xmlns:a16="http://schemas.microsoft.com/office/drawing/2014/main" id="{7678EEED-E6DE-4748-989D-8755A3CA1178}"/>
               </a:ext>
             </a:extLst>
           </p:cNvPr>
@@ -9537,7 +10832,7 @@
     </p:spTree>
     <p:extLst>
       <p:ext uri="{BB962C8B-B14F-4D97-AF65-F5344CB8AC3E}">
-        <p14:creationId xmlns:p14="http://schemas.microsoft.com/office/powerpoint/2010/main" val="1434002447"/>
+        <p14:creationId xmlns:p14="http://schemas.microsoft.com/office/powerpoint/2010/main" val="509575254"/>
       </p:ext>
     </p:extLst>
   </p:cSld>
@@ -9568,7 +10863,7 @@
           <p:cNvPr id="12" name="">
             <a:extLst xmlns:a="http://schemas.openxmlformats.org/drawingml/2006/main">
               <a:ext uri="{FF2B5EF4-FFF2-40B4-BE49-F238E27FC236}">
-                <a16:creationId xmlns:a16="http://schemas.microsoft.com/office/drawing/2014/main" id="{D5A1DE5F-EBB2-47BE-A8C7-27DA9990ED32}"/>
+                <a16:creationId xmlns:a16="http://schemas.microsoft.com/office/drawing/2014/main" id="{79194F76-77AD-4342-B858-270E225A04A8}"/>
               </a:ext>
             </a:extLst>
           </p:cNvPr>
@@ -9618,7 +10913,7 @@
           <p:cNvPr id="2" name="">
             <a:extLst xmlns:a="http://schemas.openxmlformats.org/drawingml/2006/main">
               <a:ext uri="{FF2B5EF4-FFF2-40B4-BE49-F238E27FC236}">
-                <a16:creationId xmlns:a16="http://schemas.microsoft.com/office/drawing/2014/main" id="{A273795D-DF79-41E2-BDAA-0796C1265DA0}"/>
+                <a16:creationId xmlns:a16="http://schemas.microsoft.com/office/drawing/2014/main" id="{DD1C6A58-34BB-4C5B-8C71-A9C831010083}"/>
               </a:ext>
             </a:extLst>
           </p:cNvPr>
@@ -9668,7 +10963,7 @@
           <p:cNvPr id="3" name="">
             <a:extLst xmlns:a="http://schemas.openxmlformats.org/drawingml/2006/main">
               <a:ext uri="{FF2B5EF4-FFF2-40B4-BE49-F238E27FC236}">
-                <a16:creationId xmlns:a16="http://schemas.microsoft.com/office/drawing/2014/main" id="{A24DF1CF-A9D4-43D7-A63E-86CB8F385CA4}"/>
+                <a16:creationId xmlns:a16="http://schemas.microsoft.com/office/drawing/2014/main" id="{F0CF3DE8-8F26-4499-B8CE-504FA17BAA64}"/>
               </a:ext>
             </a:extLst>
           </p:cNvPr>
@@ -9707,7 +11002,7 @@
           <p:nvPr/>
         </p:nvPicPr>
         <p:blipFill>
-          <a:blip xmlns:r="http://schemas.openxmlformats.org/officeDocument/2006/relationships" xmlns:a="http://schemas.openxmlformats.org/drawingml/2006/main" r:embed="R48372ffadd9244e8"/>
+          <a:blip xmlns:r="http://schemas.openxmlformats.org/officeDocument/2006/relationships" xmlns:a="http://schemas.openxmlformats.org/drawingml/2006/main" r:embed="Rda1081e51bce4e35"/>
           <a:stretch xmlns:a="http://schemas.openxmlformats.org/drawingml/2006/main"/>
         </p:blipFill>
         <p:spPr>
@@ -9725,7 +11020,7 @@
           <p:cNvPr id="5" name="">
             <a:extLst xmlns:a="http://schemas.openxmlformats.org/drawingml/2006/main">
               <a:ext uri="{FF2B5EF4-FFF2-40B4-BE49-F238E27FC236}">
-                <a16:creationId xmlns:a16="http://schemas.microsoft.com/office/drawing/2014/main" id="{C061D14D-3C11-47A1-8E65-522E591A9083}"/>
+                <a16:creationId xmlns:a16="http://schemas.microsoft.com/office/drawing/2014/main" id="{1ECE577B-78CA-4EF9-86BA-BB1F087B87D7}"/>
               </a:ext>
             </a:extLst>
           </p:cNvPr>
@@ -9760,7 +11055,7 @@
           <p:cNvPr id="6" name="">
             <a:extLst xmlns:a="http://schemas.openxmlformats.org/drawingml/2006/main">
               <a:ext uri="{FF2B5EF4-FFF2-40B4-BE49-F238E27FC236}">
-                <a16:creationId xmlns:a16="http://schemas.microsoft.com/office/drawing/2014/main" id="{CB00F1AF-4D34-490F-A0A5-9DC095CA6716}"/>
+                <a16:creationId xmlns:a16="http://schemas.microsoft.com/office/drawing/2014/main" id="{8AC471BC-39AD-4370-AAA6-CDF8538A297C}"/>
               </a:ext>
             </a:extLst>
           </p:cNvPr>
@@ -9810,7 +11105,7 @@
           <p:cNvPr id="7" name="">
             <a:extLst xmlns:a="http://schemas.openxmlformats.org/drawingml/2006/main">
               <a:ext uri="{FF2B5EF4-FFF2-40B4-BE49-F238E27FC236}">
-                <a16:creationId xmlns:a16="http://schemas.microsoft.com/office/drawing/2014/main" id="{7F74B511-1B9E-4841-94D2-DBACEA63503A}"/>
+                <a16:creationId xmlns:a16="http://schemas.microsoft.com/office/drawing/2014/main" id="{6E25B398-9407-490F-811E-8259D8560D59}"/>
               </a:ext>
             </a:extLst>
           </p:cNvPr>
@@ -9860,7 +11155,7 @@
           <p:cNvPr id="8" name="">
             <a:extLst xmlns:a="http://schemas.openxmlformats.org/drawingml/2006/main">
               <a:ext uri="{FF2B5EF4-FFF2-40B4-BE49-F238E27FC236}">
-                <a16:creationId xmlns:a16="http://schemas.microsoft.com/office/drawing/2014/main" id="{F191A9BD-D0E6-44BE-AD05-C608F17D0DB4}"/>
+                <a16:creationId xmlns:a16="http://schemas.microsoft.com/office/drawing/2014/main" id="{68CA7BA5-8D96-4B3A-AD77-482E697A99F6}"/>
               </a:ext>
             </a:extLst>
           </p:cNvPr>
@@ -9910,7 +11205,7 @@
           <p:cNvPr id="9" name="">
             <a:extLst xmlns:a="http://schemas.openxmlformats.org/drawingml/2006/main">
               <a:ext uri="{FF2B5EF4-FFF2-40B4-BE49-F238E27FC236}">
-                <a16:creationId xmlns:a16="http://schemas.microsoft.com/office/drawing/2014/main" id="{9E2CC8D2-F04E-44B5-97A2-0CD12CDF4131}"/>
+                <a16:creationId xmlns:a16="http://schemas.microsoft.com/office/drawing/2014/main" id="{7A9A247B-CB14-480C-AE67-B1C85B258A57}"/>
               </a:ext>
             </a:extLst>
           </p:cNvPr>
@@ -9960,7 +11255,7 @@
           <p:cNvPr id="10" name="">
             <a:extLst xmlns:a="http://schemas.openxmlformats.org/drawingml/2006/main">
               <a:ext uri="{FF2B5EF4-FFF2-40B4-BE49-F238E27FC236}">
-                <a16:creationId xmlns:a16="http://schemas.microsoft.com/office/drawing/2014/main" id="{7A1CC0CE-C2D7-4B3F-BE6F-67B3578AC330}"/>
+                <a16:creationId xmlns:a16="http://schemas.microsoft.com/office/drawing/2014/main" id="{E772A7EC-2088-4785-B9BE-F51B041009D7}"/>
               </a:ext>
             </a:extLst>
           </p:cNvPr>
@@ -10010,7 +11305,7 @@
           <p:cNvPr id="11" name="">
             <a:extLst xmlns:a="http://schemas.openxmlformats.org/drawingml/2006/main">
               <a:ext uri="{FF2B5EF4-FFF2-40B4-BE49-F238E27FC236}">
-                <a16:creationId xmlns:a16="http://schemas.microsoft.com/office/drawing/2014/main" id="{28822C22-DF86-44B2-BCB1-C8171CF456A0}"/>
+                <a16:creationId xmlns:a16="http://schemas.microsoft.com/office/drawing/2014/main" id="{34E8F0D2-726D-4F0A-A523-02E78F2B8670}"/>
               </a:ext>
             </a:extLst>
           </p:cNvPr>
@@ -10058,7 +11353,7 @@
     </p:spTree>
     <p:extLst>
       <p:ext uri="{BB962C8B-B14F-4D97-AF65-F5344CB8AC3E}">
-        <p14:creationId xmlns:p14="http://schemas.microsoft.com/office/powerpoint/2010/main" val="2091445207"/>
+        <p14:creationId xmlns:p14="http://schemas.microsoft.com/office/powerpoint/2010/main" val="150420166"/>
       </p:ext>
     </p:extLst>
   </p:cSld>
@@ -10089,7 +11384,7 @@
           <p:cNvPr id="9" name="">
             <a:extLst xmlns:a="http://schemas.openxmlformats.org/drawingml/2006/main">
               <a:ext uri="{FF2B5EF4-FFF2-40B4-BE49-F238E27FC236}">
-                <a16:creationId xmlns:a16="http://schemas.microsoft.com/office/drawing/2014/main" id="{6CEF5D84-8BD8-4153-9201-B8605B844B10}"/>
+                <a16:creationId xmlns:a16="http://schemas.microsoft.com/office/drawing/2014/main" id="{2A74A09F-8021-450B-8059-AF8C0D7D7660}"/>
               </a:ext>
             </a:extLst>
           </p:cNvPr>
@@ -10139,7 +11434,7 @@
           <p:cNvPr id="2" name="">
             <a:extLst xmlns:a="http://schemas.openxmlformats.org/drawingml/2006/main">
               <a:ext uri="{FF2B5EF4-FFF2-40B4-BE49-F238E27FC236}">
-                <a16:creationId xmlns:a16="http://schemas.microsoft.com/office/drawing/2014/main" id="{5391E6EE-7B0E-4FA2-8310-C8BBEA91CE1C}"/>
+                <a16:creationId xmlns:a16="http://schemas.microsoft.com/office/drawing/2014/main" id="{274952F3-E7BD-49C8-ADDF-2121E07DA1A7}"/>
               </a:ext>
             </a:extLst>
           </p:cNvPr>
@@ -10189,7 +11484,7 @@
           <p:cNvPr id="3" name="">
             <a:extLst xmlns:a="http://schemas.openxmlformats.org/drawingml/2006/main">
               <a:ext uri="{FF2B5EF4-FFF2-40B4-BE49-F238E27FC236}">
-                <a16:creationId xmlns:a16="http://schemas.microsoft.com/office/drawing/2014/main" id="{A5A495FB-4327-499E-95E7-108260CD409D}"/>
+                <a16:creationId xmlns:a16="http://schemas.microsoft.com/office/drawing/2014/main" id="{D71116E9-2D31-4DA7-B2B6-53BF419056DD}"/>
               </a:ext>
             </a:extLst>
           </p:cNvPr>
@@ -10228,7 +11523,7 @@
           <p:nvPr/>
         </p:nvPicPr>
         <p:blipFill>
-          <a:blip xmlns:r="http://schemas.openxmlformats.org/officeDocument/2006/relationships" xmlns:a="http://schemas.openxmlformats.org/drawingml/2006/main" r:embed="R10ab5f9d2f2746c3"/>
+          <a:blip xmlns:r="http://schemas.openxmlformats.org/officeDocument/2006/relationships" xmlns:a="http://schemas.openxmlformats.org/drawingml/2006/main" r:embed="R21c512cc05b8451b"/>
           <a:stretch xmlns:a="http://schemas.openxmlformats.org/drawingml/2006/main"/>
         </p:blipFill>
         <p:spPr>
@@ -10246,7 +11541,7 @@
           <p:cNvPr id="5" name="">
             <a:extLst xmlns:a="http://schemas.openxmlformats.org/drawingml/2006/main">
               <a:ext uri="{FF2B5EF4-FFF2-40B4-BE49-F238E27FC236}">
-                <a16:creationId xmlns:a16="http://schemas.microsoft.com/office/drawing/2014/main" id="{FD004F01-8F39-4253-A54F-0C13C4E736FA}"/>
+                <a16:creationId xmlns:a16="http://schemas.microsoft.com/office/drawing/2014/main" id="{C18B1B06-F23E-4B4E-98A7-B650F50984B6}"/>
               </a:ext>
             </a:extLst>
           </p:cNvPr>
@@ -10296,7 +11591,7 @@
           <p:cNvPr id="6" name="">
             <a:extLst xmlns:a="http://schemas.openxmlformats.org/drawingml/2006/main">
               <a:ext uri="{FF2B5EF4-FFF2-40B4-BE49-F238E27FC236}">
-                <a16:creationId xmlns:a16="http://schemas.microsoft.com/office/drawing/2014/main" id="{DAF4585C-DAD1-4142-887B-94740EAE2140}"/>
+                <a16:creationId xmlns:a16="http://schemas.microsoft.com/office/drawing/2014/main" id="{392A2D30-A93C-4FCC-9CBA-59E1614FAC07}"/>
               </a:ext>
             </a:extLst>
           </p:cNvPr>
@@ -10346,7 +11641,7 @@
           <p:cNvPr id="7" name="">
             <a:extLst xmlns:a="http://schemas.openxmlformats.org/drawingml/2006/main">
               <a:ext uri="{FF2B5EF4-FFF2-40B4-BE49-F238E27FC236}">
-                <a16:creationId xmlns:a16="http://schemas.microsoft.com/office/drawing/2014/main" id="{A279A9B1-D052-4683-B54C-6582090AF322}"/>
+                <a16:creationId xmlns:a16="http://schemas.microsoft.com/office/drawing/2014/main" id="{C8345FAC-194F-46F4-88F8-FB5FA4A421BF}"/>
               </a:ext>
             </a:extLst>
           </p:cNvPr>
@@ -10396,7 +11691,7 @@
           <p:cNvPr id="8" name="">
             <a:extLst xmlns:a="http://schemas.openxmlformats.org/drawingml/2006/main">
               <a:ext uri="{FF2B5EF4-FFF2-40B4-BE49-F238E27FC236}">
-                <a16:creationId xmlns:a16="http://schemas.microsoft.com/office/drawing/2014/main" id="{7CEDB7B5-4C60-4A95-9365-197E644348AC}"/>
+                <a16:creationId xmlns:a16="http://schemas.microsoft.com/office/drawing/2014/main" id="{4EC1F2A0-D8CF-441D-8808-84F7D8004C4B}"/>
               </a:ext>
             </a:extLst>
           </p:cNvPr>
@@ -10444,7 +11739,7 @@
     </p:spTree>
     <p:extLst>
       <p:ext uri="{BB962C8B-B14F-4D97-AF65-F5344CB8AC3E}">
-        <p14:creationId xmlns:p14="http://schemas.microsoft.com/office/powerpoint/2010/main" val="1057135405"/>
+        <p14:creationId xmlns:p14="http://schemas.microsoft.com/office/powerpoint/2010/main" val="1197714083"/>
       </p:ext>
     </p:extLst>
   </p:cSld>

</xml_diff>

<commit_message>
Simplify experiment testbed setup slide
</commit_message>
<xml_diff>
--- a/sglang_direct_kv/artifacts/slides/agent_aware_kv_movement_manager_deck.pptx
+++ b/sglang_direct_kv/artifacts/slides/agent_aware_kv_movement_manager_deck.pptx
@@ -2,23 +2,23 @@
 <file path=ppt/presentation.xml><?xml version="1.0" encoding="utf-8"?>
 <p:presentation xmlns:p="http://schemas.openxmlformats.org/presentationml/2006/main">
   <p:sldMasterIdLst>
-    <p:sldMasterId xmlns:r="http://schemas.openxmlformats.org/officeDocument/2006/relationships" id="2147483648" r:id="Redec65a8adea4648"/>
+    <p:sldMasterId xmlns:r="http://schemas.openxmlformats.org/officeDocument/2006/relationships" id="2147483648" r:id="R45000e4ad3794bcb"/>
   </p:sldMasterIdLst>
   <p:notesMasterIdLst>
-    <p:notesMasterId xmlns:r="http://schemas.openxmlformats.org/officeDocument/2006/relationships" r:id="R5751310b4b6a4a24"/>
+    <p:notesMasterId xmlns:r="http://schemas.openxmlformats.org/officeDocument/2006/relationships" r:id="Raa6dd049190c4e0d"/>
   </p:notesMasterIdLst>
   <p:sldIdLst>
-    <p:sldId xmlns:r="http://schemas.openxmlformats.org/officeDocument/2006/relationships" id="256" r:id="Rf93c1d25d19c43b1"/>
-    <p:sldId xmlns:r="http://schemas.openxmlformats.org/officeDocument/2006/relationships" id="257" r:id="R86b45fc1fb664aa8"/>
-    <p:sldId xmlns:r="http://schemas.openxmlformats.org/officeDocument/2006/relationships" id="258" r:id="Re37d71b1445d4472"/>
-    <p:sldId xmlns:r="http://schemas.openxmlformats.org/officeDocument/2006/relationships" id="259" r:id="Ra56e871d10224f91"/>
-    <p:sldId xmlns:r="http://schemas.openxmlformats.org/officeDocument/2006/relationships" id="260" r:id="R9a91cc9088ba41b5"/>
-    <p:sldId xmlns:r="http://schemas.openxmlformats.org/officeDocument/2006/relationships" id="261" r:id="R5cd1684a0d4f41b7"/>
-    <p:sldId xmlns:r="http://schemas.openxmlformats.org/officeDocument/2006/relationships" id="262" r:id="Re3fee97197584b71"/>
-    <p:sldId xmlns:r="http://schemas.openxmlformats.org/officeDocument/2006/relationships" id="263" r:id="R917b39da13fb4da7"/>
-    <p:sldId xmlns:r="http://schemas.openxmlformats.org/officeDocument/2006/relationships" id="264" r:id="R0f9480d59ad64571"/>
-    <p:sldId xmlns:r="http://schemas.openxmlformats.org/officeDocument/2006/relationships" id="265" r:id="R40b797a37fc74d0b"/>
-    <p:sldId xmlns:r="http://schemas.openxmlformats.org/officeDocument/2006/relationships" id="266" r:id="Rd8667c7be2864ccc"/>
+    <p:sldId xmlns:r="http://schemas.openxmlformats.org/officeDocument/2006/relationships" id="256" r:id="Rfaefc26859454b40"/>
+    <p:sldId xmlns:r="http://schemas.openxmlformats.org/officeDocument/2006/relationships" id="257" r:id="Raa8f17dc28e84c4b"/>
+    <p:sldId xmlns:r="http://schemas.openxmlformats.org/officeDocument/2006/relationships" id="258" r:id="R21b20d109ee74e2b"/>
+    <p:sldId xmlns:r="http://schemas.openxmlformats.org/officeDocument/2006/relationships" id="259" r:id="R8ee0412ca49b4362"/>
+    <p:sldId xmlns:r="http://schemas.openxmlformats.org/officeDocument/2006/relationships" id="260" r:id="R6347202f948c4353"/>
+    <p:sldId xmlns:r="http://schemas.openxmlformats.org/officeDocument/2006/relationships" id="261" r:id="R67702fa69c38430b"/>
+    <p:sldId xmlns:r="http://schemas.openxmlformats.org/officeDocument/2006/relationships" id="262" r:id="Re47c7237bc2e4826"/>
+    <p:sldId xmlns:r="http://schemas.openxmlformats.org/officeDocument/2006/relationships" id="263" r:id="Ree47d708630b4570"/>
+    <p:sldId xmlns:r="http://schemas.openxmlformats.org/officeDocument/2006/relationships" id="264" r:id="R297110dabe1f4138"/>
+    <p:sldId xmlns:r="http://schemas.openxmlformats.org/officeDocument/2006/relationships" id="265" r:id="R530ec569cb324125"/>
+    <p:sldId xmlns:r="http://schemas.openxmlformats.org/officeDocument/2006/relationships" id="266" r:id="R978d11244a7e408a"/>
   </p:sldIdLst>
   <p:sldSz cx="12192000" cy="6858000"/>
   <p:notesSz cx="6858000" cy="9144000"/>
@@ -837,12 +837,12 @@
           <a:lstStyle xmlns:a="http://schemas.openxmlformats.org/drawingml/2006/main"/>
           <a:p xmlns:a="http://schemas.openxmlformats.org/drawingml/2006/main">
             <a:r>
-              <a:t>This slide summarizes the concrete prototype setup used for the current manager report.</a:t>
-            </a:r>
-          </a:p>
-          <a:p xmlns:a="http://schemas.openxmlformats.org/drawingml/2006/main">
-            <a:r>
-              <a:t>Hardware/runtime values are from the latest master report setup section and the project run configuration: Qwen2.5-Coder-7B, A10G-class single GPU, 24 GB GDDR6 GPU memory, 16 GB HiCache host KV shelf, context length 32768, max total tokens 12288, mem fraction static 0.72, tensor parallel size 1.</a:t>
+              <a:t>This slide intentionally keeps the testbed setup simple: real software-engineering traces flow into DeepAgents and then into SGLang.</a:t>
+            </a:r>
+          </a:p>
+          <a:p xmlns:a="http://schemas.openxmlformats.org/drawingml/2006/main">
+            <a:r>
+              <a:t>Detailed hardware/runtime values are not shown on this slide to keep the experiment components clear.</a:t>
             </a:r>
           </a:p>
           <a:p xmlns:a="http://schemas.openxmlformats.org/drawingml/2006/main">
@@ -1505,7 +1505,7 @@
   </p:cSld>
   <p:clrMap bg1="lt1" tx1="dk1" bg2="lt2" tx2="dk2" accent1="accent1" accent2="accent2" accent3="accent3" accent4="accent4" accent5="accent5" accent6="accent6" hlink="hlink" folHlink="folHlink"/>
   <p:sldLayoutIdLst>
-    <p:sldLayoutId xmlns:r="http://schemas.openxmlformats.org/officeDocument/2006/relationships" id="2147483649" r:id="Re2203cba7e1f4be7"/>
+    <p:sldLayoutId xmlns:r="http://schemas.openxmlformats.org/officeDocument/2006/relationships" id="2147483649" r:id="Ree1eba763f4e46de"/>
   </p:sldLayoutIdLst>
   <p:txStyles>
     <p:titleStyle>
@@ -2056,7 +2056,7 @@
           <p:cNvPr id="16" name="">
             <a:extLst xmlns:a="http://schemas.openxmlformats.org/drawingml/2006/main">
               <a:ext uri="{FF2B5EF4-FFF2-40B4-BE49-F238E27FC236}">
-                <a16:creationId xmlns:a16="http://schemas.microsoft.com/office/drawing/2014/main" id="{419FA287-1B93-4547-B076-098D9A9E6E08}"/>
+                <a16:creationId xmlns:a16="http://schemas.microsoft.com/office/drawing/2014/main" id="{2987F92D-DB40-4AA6-908A-5E822A65D2B3}"/>
               </a:ext>
             </a:extLst>
           </p:cNvPr>
@@ -2106,7 +2106,7 @@
           <p:cNvPr id="2" name="">
             <a:extLst xmlns:a="http://schemas.openxmlformats.org/drawingml/2006/main">
               <a:ext uri="{FF2B5EF4-FFF2-40B4-BE49-F238E27FC236}">
-                <a16:creationId xmlns:a16="http://schemas.microsoft.com/office/drawing/2014/main" id="{93960661-E137-4E25-B36F-BE1A243D9641}"/>
+                <a16:creationId xmlns:a16="http://schemas.microsoft.com/office/drawing/2014/main" id="{D183278D-0C18-4EF1-8E93-F1858F496396}"/>
               </a:ext>
             </a:extLst>
           </p:cNvPr>
@@ -2156,7 +2156,7 @@
           <p:cNvPr id="3" name="">
             <a:extLst xmlns:a="http://schemas.openxmlformats.org/drawingml/2006/main">
               <a:ext uri="{FF2B5EF4-FFF2-40B4-BE49-F238E27FC236}">
-                <a16:creationId xmlns:a16="http://schemas.microsoft.com/office/drawing/2014/main" id="{95F35314-1F49-4B1E-8057-9B8AC9AE8F56}"/>
+                <a16:creationId xmlns:a16="http://schemas.microsoft.com/office/drawing/2014/main" id="{F262E1E0-779E-4145-9381-FCA88BA0D7CF}"/>
               </a:ext>
             </a:extLst>
           </p:cNvPr>
@@ -2191,7 +2191,7 @@
           <p:cNvPr id="4" name="">
             <a:extLst xmlns:a="http://schemas.openxmlformats.org/drawingml/2006/main">
               <a:ext uri="{FF2B5EF4-FFF2-40B4-BE49-F238E27FC236}">
-                <a16:creationId xmlns:a16="http://schemas.microsoft.com/office/drawing/2014/main" id="{9DC151AC-15E4-4A3D-9731-D15ED35D8EB5}"/>
+                <a16:creationId xmlns:a16="http://schemas.microsoft.com/office/drawing/2014/main" id="{A457F92E-3EE8-44B7-B68D-188065357ABB}"/>
               </a:ext>
             </a:extLst>
           </p:cNvPr>
@@ -2241,7 +2241,7 @@
           <p:cNvPr id="5" name="">
             <a:extLst xmlns:a="http://schemas.openxmlformats.org/drawingml/2006/main">
               <a:ext uri="{FF2B5EF4-FFF2-40B4-BE49-F238E27FC236}">
-                <a16:creationId xmlns:a16="http://schemas.microsoft.com/office/drawing/2014/main" id="{A42432D0-384C-4379-897C-E0F83EFF20E2}"/>
+                <a16:creationId xmlns:a16="http://schemas.microsoft.com/office/drawing/2014/main" id="{175E444D-324C-4FF4-833F-9DC32C6D60D3}"/>
               </a:ext>
             </a:extLst>
           </p:cNvPr>
@@ -2291,7 +2291,7 @@
           <p:cNvPr id="6" name="">
             <a:extLst xmlns:a="http://schemas.openxmlformats.org/drawingml/2006/main">
               <a:ext uri="{FF2B5EF4-FFF2-40B4-BE49-F238E27FC236}">
-                <a16:creationId xmlns:a16="http://schemas.microsoft.com/office/drawing/2014/main" id="{B8B032E7-184B-4F31-A120-15F0C517854F}"/>
+                <a16:creationId xmlns:a16="http://schemas.microsoft.com/office/drawing/2014/main" id="{B973C7E7-BE2B-4CD8-BAD4-9EBBA5A5F22E}"/>
               </a:ext>
             </a:extLst>
           </p:cNvPr>
@@ -2326,7 +2326,7 @@
           <p:cNvPr id="7" name="">
             <a:extLst xmlns:a="http://schemas.openxmlformats.org/drawingml/2006/main">
               <a:ext uri="{FF2B5EF4-FFF2-40B4-BE49-F238E27FC236}">
-                <a16:creationId xmlns:a16="http://schemas.microsoft.com/office/drawing/2014/main" id="{0BB5C5B5-B2D3-46DE-98F4-659F5AC44B90}"/>
+                <a16:creationId xmlns:a16="http://schemas.microsoft.com/office/drawing/2014/main" id="{607C164D-5C3C-47EA-9F45-737A86E7C081}"/>
               </a:ext>
             </a:extLst>
           </p:cNvPr>
@@ -2376,7 +2376,7 @@
           <p:cNvPr id="8" name="">
             <a:extLst xmlns:a="http://schemas.openxmlformats.org/drawingml/2006/main">
               <a:ext uri="{FF2B5EF4-FFF2-40B4-BE49-F238E27FC236}">
-                <a16:creationId xmlns:a16="http://schemas.microsoft.com/office/drawing/2014/main" id="{DAA21D4E-3919-4EA8-BED9-E0F3A1009172}"/>
+                <a16:creationId xmlns:a16="http://schemas.microsoft.com/office/drawing/2014/main" id="{E9932ADB-9685-4490-A22F-45CE24397180}"/>
               </a:ext>
             </a:extLst>
           </p:cNvPr>
@@ -2426,7 +2426,7 @@
           <p:cNvPr id="9" name="">
             <a:extLst xmlns:a="http://schemas.openxmlformats.org/drawingml/2006/main">
               <a:ext uri="{FF2B5EF4-FFF2-40B4-BE49-F238E27FC236}">
-                <a16:creationId xmlns:a16="http://schemas.microsoft.com/office/drawing/2014/main" id="{B9209BF0-5016-4C14-A94E-4CF9DA096505}"/>
+                <a16:creationId xmlns:a16="http://schemas.microsoft.com/office/drawing/2014/main" id="{BEB23E09-599A-4887-A0A4-96B0CC4E7973}"/>
               </a:ext>
             </a:extLst>
           </p:cNvPr>
@@ -2461,7 +2461,7 @@
           <p:cNvPr id="10" name="">
             <a:extLst xmlns:a="http://schemas.openxmlformats.org/drawingml/2006/main">
               <a:ext uri="{FF2B5EF4-FFF2-40B4-BE49-F238E27FC236}">
-                <a16:creationId xmlns:a16="http://schemas.microsoft.com/office/drawing/2014/main" id="{AB00A238-5627-40E3-AA7A-F282626A07F1}"/>
+                <a16:creationId xmlns:a16="http://schemas.microsoft.com/office/drawing/2014/main" id="{98F4558D-F384-4847-A690-2F06E897079B}"/>
               </a:ext>
             </a:extLst>
           </p:cNvPr>
@@ -2511,7 +2511,7 @@
           <p:cNvPr id="11" name="">
             <a:extLst xmlns:a="http://schemas.openxmlformats.org/drawingml/2006/main">
               <a:ext uri="{FF2B5EF4-FFF2-40B4-BE49-F238E27FC236}">
-                <a16:creationId xmlns:a16="http://schemas.microsoft.com/office/drawing/2014/main" id="{43F77D38-BE9F-44DD-8F69-E2E6CAE24DBA}"/>
+                <a16:creationId xmlns:a16="http://schemas.microsoft.com/office/drawing/2014/main" id="{6B3AEEC7-3DA8-4B8A-B9F4-637D4CF5B097}"/>
               </a:ext>
             </a:extLst>
           </p:cNvPr>
@@ -2561,7 +2561,7 @@
           <p:cNvPr id="12" name="">
             <a:extLst xmlns:a="http://schemas.openxmlformats.org/drawingml/2006/main">
               <a:ext uri="{FF2B5EF4-FFF2-40B4-BE49-F238E27FC236}">
-                <a16:creationId xmlns:a16="http://schemas.microsoft.com/office/drawing/2014/main" id="{7F3C2120-C54B-4F03-A48F-088D4A4BCEDB}"/>
+                <a16:creationId xmlns:a16="http://schemas.microsoft.com/office/drawing/2014/main" id="{7E216146-EA62-429F-9635-BD3D3D9350BF}"/>
               </a:ext>
             </a:extLst>
           </p:cNvPr>
@@ -2596,7 +2596,7 @@
           <p:cNvPr id="13" name="">
             <a:extLst xmlns:a="http://schemas.openxmlformats.org/drawingml/2006/main">
               <a:ext uri="{FF2B5EF4-FFF2-40B4-BE49-F238E27FC236}">
-                <a16:creationId xmlns:a16="http://schemas.microsoft.com/office/drawing/2014/main" id="{7EE56297-B589-4C34-BB98-4EB0C3C099D4}"/>
+                <a16:creationId xmlns:a16="http://schemas.microsoft.com/office/drawing/2014/main" id="{16D681A5-F09C-42AF-85FF-313C2B3DF23F}"/>
               </a:ext>
             </a:extLst>
           </p:cNvPr>
@@ -2646,7 +2646,7 @@
           <p:cNvPr id="14" name="">
             <a:extLst xmlns:a="http://schemas.openxmlformats.org/drawingml/2006/main">
               <a:ext uri="{FF2B5EF4-FFF2-40B4-BE49-F238E27FC236}">
-                <a16:creationId xmlns:a16="http://schemas.microsoft.com/office/drawing/2014/main" id="{A4852671-FB36-473F-8639-079BB6CD731A}"/>
+                <a16:creationId xmlns:a16="http://schemas.microsoft.com/office/drawing/2014/main" id="{2D49094C-910E-4862-8ED9-8D2CBA129ABC}"/>
               </a:ext>
             </a:extLst>
           </p:cNvPr>
@@ -2696,7 +2696,7 @@
           <p:cNvPr id="15" name="">
             <a:extLst xmlns:a="http://schemas.openxmlformats.org/drawingml/2006/main">
               <a:ext uri="{FF2B5EF4-FFF2-40B4-BE49-F238E27FC236}">
-                <a16:creationId xmlns:a16="http://schemas.microsoft.com/office/drawing/2014/main" id="{F8F59266-5178-4C58-850C-9C8161C91024}"/>
+                <a16:creationId xmlns:a16="http://schemas.microsoft.com/office/drawing/2014/main" id="{2B69CBF8-61AF-4B48-94DD-8F6A8C6B7902}"/>
               </a:ext>
             </a:extLst>
           </p:cNvPr>
@@ -2744,7 +2744,7 @@
     </p:spTree>
     <p:extLst>
       <p:ext uri="{BB962C8B-B14F-4D97-AF65-F5344CB8AC3E}">
-        <p14:creationId xmlns:p14="http://schemas.microsoft.com/office/powerpoint/2010/main" val="1525316303"/>
+        <p14:creationId xmlns:p14="http://schemas.microsoft.com/office/powerpoint/2010/main" val="415295932"/>
       </p:ext>
     </p:extLst>
   </p:cSld>
@@ -2775,7 +2775,7 @@
           <p:cNvPr id="28" name="">
             <a:extLst xmlns:a="http://schemas.openxmlformats.org/drawingml/2006/main">
               <a:ext uri="{FF2B5EF4-FFF2-40B4-BE49-F238E27FC236}">
-                <a16:creationId xmlns:a16="http://schemas.microsoft.com/office/drawing/2014/main" id="{CFC3E667-0FFF-41E7-8122-4757F911C282}"/>
+                <a16:creationId xmlns:a16="http://schemas.microsoft.com/office/drawing/2014/main" id="{5055E84E-DAFF-48FE-92A9-6E7BB2D957C8}"/>
               </a:ext>
             </a:extLst>
           </p:cNvPr>
@@ -2825,7 +2825,7 @@
           <p:cNvPr id="2" name="">
             <a:extLst xmlns:a="http://schemas.openxmlformats.org/drawingml/2006/main">
               <a:ext uri="{FF2B5EF4-FFF2-40B4-BE49-F238E27FC236}">
-                <a16:creationId xmlns:a16="http://schemas.microsoft.com/office/drawing/2014/main" id="{A604714F-91AA-48B6-BE3E-FBDABB47E560}"/>
+                <a16:creationId xmlns:a16="http://schemas.microsoft.com/office/drawing/2014/main" id="{C3EE8DA9-B42C-43BE-804D-25D12FA4568B}"/>
               </a:ext>
             </a:extLst>
           </p:cNvPr>
@@ -2875,7 +2875,7 @@
           <p:cNvPr id="3" name="">
             <a:extLst xmlns:a="http://schemas.openxmlformats.org/drawingml/2006/main">
               <a:ext uri="{FF2B5EF4-FFF2-40B4-BE49-F238E27FC236}">
-                <a16:creationId xmlns:a16="http://schemas.microsoft.com/office/drawing/2014/main" id="{477D2E00-72B9-4297-B770-CE6ECB30A734}"/>
+                <a16:creationId xmlns:a16="http://schemas.microsoft.com/office/drawing/2014/main" id="{105A6898-DE15-4A0F-B134-DC679F330FF9}"/>
               </a:ext>
             </a:extLst>
           </p:cNvPr>
@@ -2910,7 +2910,7 @@
           <p:cNvPr id="4" name="">
             <a:extLst xmlns:a="http://schemas.openxmlformats.org/drawingml/2006/main">
               <a:ext uri="{FF2B5EF4-FFF2-40B4-BE49-F238E27FC236}">
-                <a16:creationId xmlns:a16="http://schemas.microsoft.com/office/drawing/2014/main" id="{F4EC5403-850A-42FE-9FC3-F51ABB409B5D}"/>
+                <a16:creationId xmlns:a16="http://schemas.microsoft.com/office/drawing/2014/main" id="{07E49C5B-D7B3-4C23-B2F9-BF06231F4500}"/>
               </a:ext>
             </a:extLst>
           </p:cNvPr>
@@ -2941,7 +2941,7 @@
           <p:cNvPr id="5" name="">
             <a:extLst xmlns:a="http://schemas.openxmlformats.org/drawingml/2006/main">
               <a:ext uri="{FF2B5EF4-FFF2-40B4-BE49-F238E27FC236}">
-                <a16:creationId xmlns:a16="http://schemas.microsoft.com/office/drawing/2014/main" id="{DE890471-6382-4D34-AC45-FBFE2784E417}"/>
+                <a16:creationId xmlns:a16="http://schemas.microsoft.com/office/drawing/2014/main" id="{487B0E09-CABB-437F-8E13-C52D4D77DF97}"/>
               </a:ext>
             </a:extLst>
           </p:cNvPr>
@@ -2991,7 +2991,7 @@
           <p:cNvPr id="6" name="">
             <a:extLst xmlns:a="http://schemas.openxmlformats.org/drawingml/2006/main">
               <a:ext uri="{FF2B5EF4-FFF2-40B4-BE49-F238E27FC236}">
-                <a16:creationId xmlns:a16="http://schemas.microsoft.com/office/drawing/2014/main" id="{14CD1DA9-919A-438E-BE34-2F5C388972DB}"/>
+                <a16:creationId xmlns:a16="http://schemas.microsoft.com/office/drawing/2014/main" id="{4A8C2018-0F08-4EFE-9285-B587DED749D0}"/>
               </a:ext>
             </a:extLst>
           </p:cNvPr>
@@ -3041,7 +3041,7 @@
           <p:cNvPr id="7" name="">
             <a:extLst xmlns:a="http://schemas.openxmlformats.org/drawingml/2006/main">
               <a:ext uri="{FF2B5EF4-FFF2-40B4-BE49-F238E27FC236}">
-                <a16:creationId xmlns:a16="http://schemas.microsoft.com/office/drawing/2014/main" id="{98783914-BB9A-4EE1-9FD1-C7FC15B7DD54}"/>
+                <a16:creationId xmlns:a16="http://schemas.microsoft.com/office/drawing/2014/main" id="{E2C1F1B7-3BCC-4563-B5BD-177AC04C1D7C}"/>
               </a:ext>
             </a:extLst>
           </p:cNvPr>
@@ -3076,7 +3076,7 @@
           <p:cNvPr id="8" name="">
             <a:extLst xmlns:a="http://schemas.openxmlformats.org/drawingml/2006/main">
               <a:ext uri="{FF2B5EF4-FFF2-40B4-BE49-F238E27FC236}">
-                <a16:creationId xmlns:a16="http://schemas.microsoft.com/office/drawing/2014/main" id="{285C038E-7D54-4B24-9C48-7340CADEEC02}"/>
+                <a16:creationId xmlns:a16="http://schemas.microsoft.com/office/drawing/2014/main" id="{57F436FA-6D50-463D-937E-208DA8E7FB72}"/>
               </a:ext>
             </a:extLst>
           </p:cNvPr>
@@ -3107,7 +3107,7 @@
           <p:cNvPr id="9" name="">
             <a:extLst xmlns:a="http://schemas.openxmlformats.org/drawingml/2006/main">
               <a:ext uri="{FF2B5EF4-FFF2-40B4-BE49-F238E27FC236}">
-                <a16:creationId xmlns:a16="http://schemas.microsoft.com/office/drawing/2014/main" id="{5CFBB829-4CEA-4A0F-94F2-A5E8DF40A9E1}"/>
+                <a16:creationId xmlns:a16="http://schemas.microsoft.com/office/drawing/2014/main" id="{76397905-654D-4D97-8291-003344D7ED32}"/>
               </a:ext>
             </a:extLst>
           </p:cNvPr>
@@ -3157,7 +3157,7 @@
           <p:cNvPr id="10" name="">
             <a:extLst xmlns:a="http://schemas.openxmlformats.org/drawingml/2006/main">
               <a:ext uri="{FF2B5EF4-FFF2-40B4-BE49-F238E27FC236}">
-                <a16:creationId xmlns:a16="http://schemas.microsoft.com/office/drawing/2014/main" id="{BC0EC8E2-BB2D-40F3-B127-9088BC28C524}"/>
+                <a16:creationId xmlns:a16="http://schemas.microsoft.com/office/drawing/2014/main" id="{55238B65-11EC-4C85-8220-D1D320F89401}"/>
               </a:ext>
             </a:extLst>
           </p:cNvPr>
@@ -3207,7 +3207,7 @@
           <p:cNvPr id="11" name="">
             <a:extLst xmlns:a="http://schemas.openxmlformats.org/drawingml/2006/main">
               <a:ext uri="{FF2B5EF4-FFF2-40B4-BE49-F238E27FC236}">
-                <a16:creationId xmlns:a16="http://schemas.microsoft.com/office/drawing/2014/main" id="{B430D87C-9085-4CB3-883A-DEB6E68652BD}"/>
+                <a16:creationId xmlns:a16="http://schemas.microsoft.com/office/drawing/2014/main" id="{A9C3833E-F37A-45D1-984A-DB27DDF49C4B}"/>
               </a:ext>
             </a:extLst>
           </p:cNvPr>
@@ -3242,7 +3242,7 @@
           <p:cNvPr id="12" name="">
             <a:extLst xmlns:a="http://schemas.openxmlformats.org/drawingml/2006/main">
               <a:ext uri="{FF2B5EF4-FFF2-40B4-BE49-F238E27FC236}">
-                <a16:creationId xmlns:a16="http://schemas.microsoft.com/office/drawing/2014/main" id="{2A9A4B28-48D4-4CE2-82D5-6DACC9879CD5}"/>
+                <a16:creationId xmlns:a16="http://schemas.microsoft.com/office/drawing/2014/main" id="{6B969611-A85C-4B48-8BBB-DD20B9D7A5E4}"/>
               </a:ext>
             </a:extLst>
           </p:cNvPr>
@@ -3273,7 +3273,7 @@
           <p:cNvPr id="13" name="">
             <a:extLst xmlns:a="http://schemas.openxmlformats.org/drawingml/2006/main">
               <a:ext uri="{FF2B5EF4-FFF2-40B4-BE49-F238E27FC236}">
-                <a16:creationId xmlns:a16="http://schemas.microsoft.com/office/drawing/2014/main" id="{86698DC2-8175-4277-83ED-B200D71C1405}"/>
+                <a16:creationId xmlns:a16="http://schemas.microsoft.com/office/drawing/2014/main" id="{60690128-11FF-49E1-8ED7-50D4AAC6F43E}"/>
               </a:ext>
             </a:extLst>
           </p:cNvPr>
@@ -3323,7 +3323,7 @@
           <p:cNvPr id="14" name="">
             <a:extLst xmlns:a="http://schemas.openxmlformats.org/drawingml/2006/main">
               <a:ext uri="{FF2B5EF4-FFF2-40B4-BE49-F238E27FC236}">
-                <a16:creationId xmlns:a16="http://schemas.microsoft.com/office/drawing/2014/main" id="{F6EB3C76-EEA8-4CD5-8390-3AFC0EB934EB}"/>
+                <a16:creationId xmlns:a16="http://schemas.microsoft.com/office/drawing/2014/main" id="{50B6F3A9-4176-4A32-A862-29BE428ED4E7}"/>
               </a:ext>
             </a:extLst>
           </p:cNvPr>
@@ -3373,7 +3373,7 @@
           <p:cNvPr id="15" name="">
             <a:extLst xmlns:a="http://schemas.openxmlformats.org/drawingml/2006/main">
               <a:ext uri="{FF2B5EF4-FFF2-40B4-BE49-F238E27FC236}">
-                <a16:creationId xmlns:a16="http://schemas.microsoft.com/office/drawing/2014/main" id="{5BDAA012-A02D-4E6A-AB04-44160B48C85C}"/>
+                <a16:creationId xmlns:a16="http://schemas.microsoft.com/office/drawing/2014/main" id="{8C6B3C82-AA00-429F-9D8A-5ED1E0698A30}"/>
               </a:ext>
             </a:extLst>
           </p:cNvPr>
@@ -3408,7 +3408,7 @@
           <p:cNvPr id="16" name="">
             <a:extLst xmlns:a="http://schemas.openxmlformats.org/drawingml/2006/main">
               <a:ext uri="{FF2B5EF4-FFF2-40B4-BE49-F238E27FC236}">
-                <a16:creationId xmlns:a16="http://schemas.microsoft.com/office/drawing/2014/main" id="{EC1B9260-9F0C-4B41-8D74-8A4C502276F3}"/>
+                <a16:creationId xmlns:a16="http://schemas.microsoft.com/office/drawing/2014/main" id="{3C12ACDC-99CB-481C-80F5-983A5E219DC7}"/>
               </a:ext>
             </a:extLst>
           </p:cNvPr>
@@ -3439,7 +3439,7 @@
           <p:cNvPr id="17" name="">
             <a:extLst xmlns:a="http://schemas.openxmlformats.org/drawingml/2006/main">
               <a:ext uri="{FF2B5EF4-FFF2-40B4-BE49-F238E27FC236}">
-                <a16:creationId xmlns:a16="http://schemas.microsoft.com/office/drawing/2014/main" id="{583FAA72-B3A4-45F1-932E-E579453E034D}"/>
+                <a16:creationId xmlns:a16="http://schemas.microsoft.com/office/drawing/2014/main" id="{168A548C-9DE9-4D30-BD2E-82CF33CFA173}"/>
               </a:ext>
             </a:extLst>
           </p:cNvPr>
@@ -3489,7 +3489,7 @@
           <p:cNvPr id="18" name="">
             <a:extLst xmlns:a="http://schemas.openxmlformats.org/drawingml/2006/main">
               <a:ext uri="{FF2B5EF4-FFF2-40B4-BE49-F238E27FC236}">
-                <a16:creationId xmlns:a16="http://schemas.microsoft.com/office/drawing/2014/main" id="{C2A1C1C3-4EA7-4296-B0F4-0F742A763B10}"/>
+                <a16:creationId xmlns:a16="http://schemas.microsoft.com/office/drawing/2014/main" id="{5146A486-4DB4-4686-ACA7-85E1AB6E8507}"/>
               </a:ext>
             </a:extLst>
           </p:cNvPr>
@@ -3539,7 +3539,7 @@
           <p:cNvPr id="19" name="">
             <a:extLst xmlns:a="http://schemas.openxmlformats.org/drawingml/2006/main">
               <a:ext uri="{FF2B5EF4-FFF2-40B4-BE49-F238E27FC236}">
-                <a16:creationId xmlns:a16="http://schemas.microsoft.com/office/drawing/2014/main" id="{128A8758-C404-4412-9F6C-5C1F77ED5FC4}"/>
+                <a16:creationId xmlns:a16="http://schemas.microsoft.com/office/drawing/2014/main" id="{9ED82A97-A801-4C9A-A44D-0ED58D1E728C}"/>
               </a:ext>
             </a:extLst>
           </p:cNvPr>
@@ -3574,7 +3574,7 @@
           <p:cNvPr id="20" name="">
             <a:extLst xmlns:a="http://schemas.openxmlformats.org/drawingml/2006/main">
               <a:ext uri="{FF2B5EF4-FFF2-40B4-BE49-F238E27FC236}">
-                <a16:creationId xmlns:a16="http://schemas.microsoft.com/office/drawing/2014/main" id="{B3C75721-BC20-4175-8FD0-4D3EA7055122}"/>
+                <a16:creationId xmlns:a16="http://schemas.microsoft.com/office/drawing/2014/main" id="{3A4FC0EE-FE73-4B29-9F0D-F18624BFAC32}"/>
               </a:ext>
             </a:extLst>
           </p:cNvPr>
@@ -3605,7 +3605,7 @@
           <p:cNvPr id="21" name="">
             <a:extLst xmlns:a="http://schemas.openxmlformats.org/drawingml/2006/main">
               <a:ext uri="{FF2B5EF4-FFF2-40B4-BE49-F238E27FC236}">
-                <a16:creationId xmlns:a16="http://schemas.microsoft.com/office/drawing/2014/main" id="{C46F67E8-333A-48C5-A4E5-C6839F023971}"/>
+                <a16:creationId xmlns:a16="http://schemas.microsoft.com/office/drawing/2014/main" id="{65970081-BAAE-4CB8-B726-CF6C4D231F2E}"/>
               </a:ext>
             </a:extLst>
           </p:cNvPr>
@@ -3655,7 +3655,7 @@
           <p:cNvPr id="22" name="">
             <a:extLst xmlns:a="http://schemas.openxmlformats.org/drawingml/2006/main">
               <a:ext uri="{FF2B5EF4-FFF2-40B4-BE49-F238E27FC236}">
-                <a16:creationId xmlns:a16="http://schemas.microsoft.com/office/drawing/2014/main" id="{63919347-1838-4D9A-B847-25987F74239E}"/>
+                <a16:creationId xmlns:a16="http://schemas.microsoft.com/office/drawing/2014/main" id="{D050352D-3219-480D-A7D7-E6142467C89F}"/>
               </a:ext>
             </a:extLst>
           </p:cNvPr>
@@ -3705,7 +3705,7 @@
           <p:cNvPr id="23" name="">
             <a:extLst xmlns:a="http://schemas.openxmlformats.org/drawingml/2006/main">
               <a:ext uri="{FF2B5EF4-FFF2-40B4-BE49-F238E27FC236}">
-                <a16:creationId xmlns:a16="http://schemas.microsoft.com/office/drawing/2014/main" id="{2518431A-585D-4CA3-81D5-6CD7834F3B57}"/>
+                <a16:creationId xmlns:a16="http://schemas.microsoft.com/office/drawing/2014/main" id="{7F4B8FDC-4453-4989-A649-EFC5806DE859}"/>
               </a:ext>
             </a:extLst>
           </p:cNvPr>
@@ -3740,7 +3740,7 @@
           <p:cNvPr id="24" name="">
             <a:extLst xmlns:a="http://schemas.openxmlformats.org/drawingml/2006/main">
               <a:ext uri="{FF2B5EF4-FFF2-40B4-BE49-F238E27FC236}">
-                <a16:creationId xmlns:a16="http://schemas.microsoft.com/office/drawing/2014/main" id="{C700FCBA-F89E-4CE9-B2FC-FFAFAD0ADAA1}"/>
+                <a16:creationId xmlns:a16="http://schemas.microsoft.com/office/drawing/2014/main" id="{1462C91E-F6BF-41AC-9B10-4EC22204AD98}"/>
               </a:ext>
             </a:extLst>
           </p:cNvPr>
@@ -3790,7 +3790,7 @@
           <p:cNvPr id="25" name="">
             <a:extLst xmlns:a="http://schemas.openxmlformats.org/drawingml/2006/main">
               <a:ext uri="{FF2B5EF4-FFF2-40B4-BE49-F238E27FC236}">
-                <a16:creationId xmlns:a16="http://schemas.microsoft.com/office/drawing/2014/main" id="{5C942F0D-7645-410C-94FD-9ED856FEACC4}"/>
+                <a16:creationId xmlns:a16="http://schemas.microsoft.com/office/drawing/2014/main" id="{CEC1D895-EA4B-4A38-B4E1-087872B7C296}"/>
               </a:ext>
             </a:extLst>
           </p:cNvPr>
@@ -3840,7 +3840,7 @@
           <p:cNvPr id="26" name="">
             <a:extLst xmlns:a="http://schemas.openxmlformats.org/drawingml/2006/main">
               <a:ext uri="{FF2B5EF4-FFF2-40B4-BE49-F238E27FC236}">
-                <a16:creationId xmlns:a16="http://schemas.microsoft.com/office/drawing/2014/main" id="{82C8530E-6395-433C-B9E5-27DCC15BFD36}"/>
+                <a16:creationId xmlns:a16="http://schemas.microsoft.com/office/drawing/2014/main" id="{A8539BF1-A005-4F97-90F7-85BC05E06BE2}"/>
               </a:ext>
             </a:extLst>
           </p:cNvPr>
@@ -3890,7 +3890,7 @@
           <p:cNvPr id="27" name="">
             <a:extLst xmlns:a="http://schemas.openxmlformats.org/drawingml/2006/main">
               <a:ext uri="{FF2B5EF4-FFF2-40B4-BE49-F238E27FC236}">
-                <a16:creationId xmlns:a16="http://schemas.microsoft.com/office/drawing/2014/main" id="{9CD4DBD8-E9D4-4D5F-AD3C-7A0FF9D2004C}"/>
+                <a16:creationId xmlns:a16="http://schemas.microsoft.com/office/drawing/2014/main" id="{1B7F3815-2023-4895-B13D-8BBE1AFE645D}"/>
               </a:ext>
             </a:extLst>
           </p:cNvPr>
@@ -3938,7 +3938,7 @@
     </p:spTree>
     <p:extLst>
       <p:ext uri="{BB962C8B-B14F-4D97-AF65-F5344CB8AC3E}">
-        <p14:creationId xmlns:p14="http://schemas.microsoft.com/office/powerpoint/2010/main" val="992531945"/>
+        <p14:creationId xmlns:p14="http://schemas.microsoft.com/office/powerpoint/2010/main" val="2140973703"/>
       </p:ext>
     </p:extLst>
   </p:cSld>
@@ -3969,7 +3969,7 @@
           <p:cNvPr id="27" name="">
             <a:extLst xmlns:a="http://schemas.openxmlformats.org/drawingml/2006/main">
               <a:ext uri="{FF2B5EF4-FFF2-40B4-BE49-F238E27FC236}">
-                <a16:creationId xmlns:a16="http://schemas.microsoft.com/office/drawing/2014/main" id="{B4D438DD-5867-4059-92AC-EAFBA1919051}"/>
+                <a16:creationId xmlns:a16="http://schemas.microsoft.com/office/drawing/2014/main" id="{3965953B-6AF3-4517-BE3F-145669879961}"/>
               </a:ext>
             </a:extLst>
           </p:cNvPr>
@@ -4019,7 +4019,7 @@
           <p:cNvPr id="2" name="">
             <a:extLst xmlns:a="http://schemas.openxmlformats.org/drawingml/2006/main">
               <a:ext uri="{FF2B5EF4-FFF2-40B4-BE49-F238E27FC236}">
-                <a16:creationId xmlns:a16="http://schemas.microsoft.com/office/drawing/2014/main" id="{135DF2C0-378A-4909-8877-0397C35027EB}"/>
+                <a16:creationId xmlns:a16="http://schemas.microsoft.com/office/drawing/2014/main" id="{3E99E580-723A-40F6-90FD-B66ECF5CA047}"/>
               </a:ext>
             </a:extLst>
           </p:cNvPr>
@@ -4069,7 +4069,7 @@
           <p:cNvPr id="3" name="">
             <a:extLst xmlns:a="http://schemas.openxmlformats.org/drawingml/2006/main">
               <a:ext uri="{FF2B5EF4-FFF2-40B4-BE49-F238E27FC236}">
-                <a16:creationId xmlns:a16="http://schemas.microsoft.com/office/drawing/2014/main" id="{B69CA1E6-5AFF-4113-8922-A3D9ED6E4DE8}"/>
+                <a16:creationId xmlns:a16="http://schemas.microsoft.com/office/drawing/2014/main" id="{2AFD71DF-7962-4B49-942C-1BDC5526B2CC}"/>
               </a:ext>
             </a:extLst>
           </p:cNvPr>
@@ -4104,7 +4104,7 @@
           <p:cNvPr id="4" name="">
             <a:extLst xmlns:a="http://schemas.openxmlformats.org/drawingml/2006/main">
               <a:ext uri="{FF2B5EF4-FFF2-40B4-BE49-F238E27FC236}">
-                <a16:creationId xmlns:a16="http://schemas.microsoft.com/office/drawing/2014/main" id="{0903FB5C-E56D-4BBA-A60C-C9F271963CC7}"/>
+                <a16:creationId xmlns:a16="http://schemas.microsoft.com/office/drawing/2014/main" id="{C8D93A99-D050-47BA-8DDF-3B0DCD177CAD}"/>
               </a:ext>
             </a:extLst>
           </p:cNvPr>
@@ -4154,7 +4154,7 @@
           <p:cNvPr id="5" name="">
             <a:extLst xmlns:a="http://schemas.openxmlformats.org/drawingml/2006/main">
               <a:ext uri="{FF2B5EF4-FFF2-40B4-BE49-F238E27FC236}">
-                <a16:creationId xmlns:a16="http://schemas.microsoft.com/office/drawing/2014/main" id="{2F09291D-119E-45AC-9BF5-1F13E5D7798E}"/>
+                <a16:creationId xmlns:a16="http://schemas.microsoft.com/office/drawing/2014/main" id="{E65EBDC7-AED3-4893-AE5E-18AEB368186D}"/>
               </a:ext>
             </a:extLst>
           </p:cNvPr>
@@ -4204,7 +4204,7 @@
           <p:cNvPr id="6" name="">
             <a:extLst xmlns:a="http://schemas.openxmlformats.org/drawingml/2006/main">
               <a:ext uri="{FF2B5EF4-FFF2-40B4-BE49-F238E27FC236}">
-                <a16:creationId xmlns:a16="http://schemas.microsoft.com/office/drawing/2014/main" id="{402A50E2-B611-4286-B3A3-EC3CD844E139}"/>
+                <a16:creationId xmlns:a16="http://schemas.microsoft.com/office/drawing/2014/main" id="{2A1A6110-DC07-45E6-88BD-7FB8D97E6A9C}"/>
               </a:ext>
             </a:extLst>
           </p:cNvPr>
@@ -4254,7 +4254,7 @@
           <p:cNvPr id="7" name="">
             <a:extLst xmlns:a="http://schemas.openxmlformats.org/drawingml/2006/main">
               <a:ext uri="{FF2B5EF4-FFF2-40B4-BE49-F238E27FC236}">
-                <a16:creationId xmlns:a16="http://schemas.microsoft.com/office/drawing/2014/main" id="{754E0EB6-59F3-407B-8A0B-48C080FD3314}"/>
+                <a16:creationId xmlns:a16="http://schemas.microsoft.com/office/drawing/2014/main" id="{294D5AEB-FFD3-4071-A228-1A84305D497E}"/>
               </a:ext>
             </a:extLst>
           </p:cNvPr>
@@ -4289,7 +4289,7 @@
           <p:cNvPr id="8" name="">
             <a:extLst xmlns:a="http://schemas.openxmlformats.org/drawingml/2006/main">
               <a:ext uri="{FF2B5EF4-FFF2-40B4-BE49-F238E27FC236}">
-                <a16:creationId xmlns:a16="http://schemas.microsoft.com/office/drawing/2014/main" id="{D3BA9781-8888-4E39-A6F5-0251214760E0}"/>
+                <a16:creationId xmlns:a16="http://schemas.microsoft.com/office/drawing/2014/main" id="{F09C67A2-0915-483A-8CEA-E2731084D99C}"/>
               </a:ext>
             </a:extLst>
           </p:cNvPr>
@@ -4339,7 +4339,7 @@
           <p:cNvPr id="9" name="">
             <a:extLst xmlns:a="http://schemas.openxmlformats.org/drawingml/2006/main">
               <a:ext uri="{FF2B5EF4-FFF2-40B4-BE49-F238E27FC236}">
-                <a16:creationId xmlns:a16="http://schemas.microsoft.com/office/drawing/2014/main" id="{7D31D6A5-590C-4B3D-BAFE-C5FFB91D8D74}"/>
+                <a16:creationId xmlns:a16="http://schemas.microsoft.com/office/drawing/2014/main" id="{B9081164-85DF-4CFE-9B9B-B764F51A5154}"/>
               </a:ext>
             </a:extLst>
           </p:cNvPr>
@@ -4389,7 +4389,7 @@
           <p:cNvPr id="10" name="">
             <a:extLst xmlns:a="http://schemas.openxmlformats.org/drawingml/2006/main">
               <a:ext uri="{FF2B5EF4-FFF2-40B4-BE49-F238E27FC236}">
-                <a16:creationId xmlns:a16="http://schemas.microsoft.com/office/drawing/2014/main" id="{C27FC1DA-90AF-4F56-902F-97683ECEB117}"/>
+                <a16:creationId xmlns:a16="http://schemas.microsoft.com/office/drawing/2014/main" id="{C239E0F3-0D93-4CF4-9670-3A1F47067325}"/>
               </a:ext>
             </a:extLst>
           </p:cNvPr>
@@ -4439,7 +4439,7 @@
           <p:cNvPr id="11" name="">
             <a:extLst xmlns:a="http://schemas.openxmlformats.org/drawingml/2006/main">
               <a:ext uri="{FF2B5EF4-FFF2-40B4-BE49-F238E27FC236}">
-                <a16:creationId xmlns:a16="http://schemas.microsoft.com/office/drawing/2014/main" id="{0ED5B989-C1AC-4026-8F4F-BCD893B91FDD}"/>
+                <a16:creationId xmlns:a16="http://schemas.microsoft.com/office/drawing/2014/main" id="{5B9DDE3C-45E4-4457-9C2F-30797E098C9D}"/>
               </a:ext>
             </a:extLst>
           </p:cNvPr>
@@ -4474,7 +4474,7 @@
           <p:cNvPr id="12" name="">
             <a:extLst xmlns:a="http://schemas.openxmlformats.org/drawingml/2006/main">
               <a:ext uri="{FF2B5EF4-FFF2-40B4-BE49-F238E27FC236}">
-                <a16:creationId xmlns:a16="http://schemas.microsoft.com/office/drawing/2014/main" id="{98421532-E4E5-472C-B5F1-A96794EA36DE}"/>
+                <a16:creationId xmlns:a16="http://schemas.microsoft.com/office/drawing/2014/main" id="{295B6D78-11E9-4150-B3F2-CC643F59200F}"/>
               </a:ext>
             </a:extLst>
           </p:cNvPr>
@@ -4524,7 +4524,7 @@
           <p:cNvPr id="13" name="">
             <a:extLst xmlns:a="http://schemas.openxmlformats.org/drawingml/2006/main">
               <a:ext uri="{FF2B5EF4-FFF2-40B4-BE49-F238E27FC236}">
-                <a16:creationId xmlns:a16="http://schemas.microsoft.com/office/drawing/2014/main" id="{4244315C-8B4D-4875-9760-245C5EF0218D}"/>
+                <a16:creationId xmlns:a16="http://schemas.microsoft.com/office/drawing/2014/main" id="{918A0619-933C-4907-8250-827491304B28}"/>
               </a:ext>
             </a:extLst>
           </p:cNvPr>
@@ -4574,7 +4574,7 @@
           <p:cNvPr id="14" name="">
             <a:extLst xmlns:a="http://schemas.openxmlformats.org/drawingml/2006/main">
               <a:ext uri="{FF2B5EF4-FFF2-40B4-BE49-F238E27FC236}">
-                <a16:creationId xmlns:a16="http://schemas.microsoft.com/office/drawing/2014/main" id="{FC24EC58-335B-4BD9-B8E2-46B93F0028A6}"/>
+                <a16:creationId xmlns:a16="http://schemas.microsoft.com/office/drawing/2014/main" id="{8296BFA6-8245-4CE1-8A39-E253356FA52A}"/>
               </a:ext>
             </a:extLst>
           </p:cNvPr>
@@ -4624,7 +4624,7 @@
           <p:cNvPr id="15" name="">
             <a:extLst xmlns:a="http://schemas.openxmlformats.org/drawingml/2006/main">
               <a:ext uri="{FF2B5EF4-FFF2-40B4-BE49-F238E27FC236}">
-                <a16:creationId xmlns:a16="http://schemas.microsoft.com/office/drawing/2014/main" id="{C89898BD-6F09-4D43-AE05-352DA79EB8C3}"/>
+                <a16:creationId xmlns:a16="http://schemas.microsoft.com/office/drawing/2014/main" id="{6941993F-A81C-4C94-A479-D72FAC1270BF}"/>
               </a:ext>
             </a:extLst>
           </p:cNvPr>
@@ -4659,7 +4659,7 @@
           <p:cNvPr id="16" name="">
             <a:extLst xmlns:a="http://schemas.openxmlformats.org/drawingml/2006/main">
               <a:ext uri="{FF2B5EF4-FFF2-40B4-BE49-F238E27FC236}">
-                <a16:creationId xmlns:a16="http://schemas.microsoft.com/office/drawing/2014/main" id="{6E37C455-E33F-4D46-940A-31AEE575EB0C}"/>
+                <a16:creationId xmlns:a16="http://schemas.microsoft.com/office/drawing/2014/main" id="{CBB4C2DC-BDB4-4B3A-A857-0C4ACA8B6FE9}"/>
               </a:ext>
             </a:extLst>
           </p:cNvPr>
@@ -4709,7 +4709,7 @@
           <p:cNvPr id="17" name="">
             <a:extLst xmlns:a="http://schemas.openxmlformats.org/drawingml/2006/main">
               <a:ext uri="{FF2B5EF4-FFF2-40B4-BE49-F238E27FC236}">
-                <a16:creationId xmlns:a16="http://schemas.microsoft.com/office/drawing/2014/main" id="{431B839C-ECAD-4519-870E-F4A698FF9CF9}"/>
+                <a16:creationId xmlns:a16="http://schemas.microsoft.com/office/drawing/2014/main" id="{B34B788E-B6A6-46A7-B340-1FBA93D58FC2}"/>
               </a:ext>
             </a:extLst>
           </p:cNvPr>
@@ -4759,7 +4759,7 @@
           <p:cNvPr id="18" name="">
             <a:extLst xmlns:a="http://schemas.openxmlformats.org/drawingml/2006/main">
               <a:ext uri="{FF2B5EF4-FFF2-40B4-BE49-F238E27FC236}">
-                <a16:creationId xmlns:a16="http://schemas.microsoft.com/office/drawing/2014/main" id="{14E7CE19-8101-49D3-A043-C32ADB7F3FCE}"/>
+                <a16:creationId xmlns:a16="http://schemas.microsoft.com/office/drawing/2014/main" id="{18342C36-A309-4ED8-B8F4-6353EA01A33A}"/>
               </a:ext>
             </a:extLst>
           </p:cNvPr>
@@ -4809,7 +4809,7 @@
           <p:cNvPr id="19" name="">
             <a:extLst xmlns:a="http://schemas.openxmlformats.org/drawingml/2006/main">
               <a:ext uri="{FF2B5EF4-FFF2-40B4-BE49-F238E27FC236}">
-                <a16:creationId xmlns:a16="http://schemas.microsoft.com/office/drawing/2014/main" id="{7A36D4B5-7E5F-49D1-B57E-2FF8A4DBC14A}"/>
+                <a16:creationId xmlns:a16="http://schemas.microsoft.com/office/drawing/2014/main" id="{072C1F2C-8B44-4BED-8B14-3CCDB972036C}"/>
               </a:ext>
             </a:extLst>
           </p:cNvPr>
@@ -4844,7 +4844,7 @@
           <p:cNvPr id="20" name="">
             <a:extLst xmlns:a="http://schemas.openxmlformats.org/drawingml/2006/main">
               <a:ext uri="{FF2B5EF4-FFF2-40B4-BE49-F238E27FC236}">
-                <a16:creationId xmlns:a16="http://schemas.microsoft.com/office/drawing/2014/main" id="{F32B4C1D-02A3-4683-B33C-AE53816527CE}"/>
+                <a16:creationId xmlns:a16="http://schemas.microsoft.com/office/drawing/2014/main" id="{1E52F16F-0B50-4CC4-B5A1-5E6E896F8BAD}"/>
               </a:ext>
             </a:extLst>
           </p:cNvPr>
@@ -4894,7 +4894,7 @@
           <p:cNvPr id="21" name="">
             <a:extLst xmlns:a="http://schemas.openxmlformats.org/drawingml/2006/main">
               <a:ext uri="{FF2B5EF4-FFF2-40B4-BE49-F238E27FC236}">
-                <a16:creationId xmlns:a16="http://schemas.microsoft.com/office/drawing/2014/main" id="{CBE5EFB3-EE0C-4058-A7C6-F2F7D9AD25EC}"/>
+                <a16:creationId xmlns:a16="http://schemas.microsoft.com/office/drawing/2014/main" id="{951F7856-1542-43FE-9E38-C8B2EB36A491}"/>
               </a:ext>
             </a:extLst>
           </p:cNvPr>
@@ -4944,7 +4944,7 @@
           <p:cNvPr id="22" name="">
             <a:extLst xmlns:a="http://schemas.openxmlformats.org/drawingml/2006/main">
               <a:ext uri="{FF2B5EF4-FFF2-40B4-BE49-F238E27FC236}">
-                <a16:creationId xmlns:a16="http://schemas.microsoft.com/office/drawing/2014/main" id="{D25D699C-52B7-4B0A-BAB9-B0A5CD902748}"/>
+                <a16:creationId xmlns:a16="http://schemas.microsoft.com/office/drawing/2014/main" id="{63889E1B-E5A0-4F23-85BE-905BE01004ED}"/>
               </a:ext>
             </a:extLst>
           </p:cNvPr>
@@ -4979,7 +4979,7 @@
           <p:cNvPr id="23" name="">
             <a:extLst xmlns:a="http://schemas.openxmlformats.org/drawingml/2006/main">
               <a:ext uri="{FF2B5EF4-FFF2-40B4-BE49-F238E27FC236}">
-                <a16:creationId xmlns:a16="http://schemas.microsoft.com/office/drawing/2014/main" id="{94D50774-64CF-4228-8500-20A380EF8EC0}"/>
+                <a16:creationId xmlns:a16="http://schemas.microsoft.com/office/drawing/2014/main" id="{AD68BEE7-FDE6-47A8-9C4E-0AFD83EAEF30}"/>
               </a:ext>
             </a:extLst>
           </p:cNvPr>
@@ -5029,7 +5029,7 @@
           <p:cNvPr id="24" name="">
             <a:extLst xmlns:a="http://schemas.openxmlformats.org/drawingml/2006/main">
               <a:ext uri="{FF2B5EF4-FFF2-40B4-BE49-F238E27FC236}">
-                <a16:creationId xmlns:a16="http://schemas.microsoft.com/office/drawing/2014/main" id="{94065F4F-411E-4623-8922-7C8DE483CF3B}"/>
+                <a16:creationId xmlns:a16="http://schemas.microsoft.com/office/drawing/2014/main" id="{8972BB09-19AD-4616-A1C1-0C71BF6873CA}"/>
               </a:ext>
             </a:extLst>
           </p:cNvPr>
@@ -5079,7 +5079,7 @@
           <p:cNvPr id="25" name="">
             <a:extLst xmlns:a="http://schemas.openxmlformats.org/drawingml/2006/main">
               <a:ext uri="{FF2B5EF4-FFF2-40B4-BE49-F238E27FC236}">
-                <a16:creationId xmlns:a16="http://schemas.microsoft.com/office/drawing/2014/main" id="{423F398F-3919-4D49-80A0-FFCBC0783096}"/>
+                <a16:creationId xmlns:a16="http://schemas.microsoft.com/office/drawing/2014/main" id="{4A218EB2-8918-457E-8930-ED6111AE5399}"/>
               </a:ext>
             </a:extLst>
           </p:cNvPr>
@@ -5129,7 +5129,7 @@
           <p:cNvPr id="26" name="">
             <a:extLst xmlns:a="http://schemas.openxmlformats.org/drawingml/2006/main">
               <a:ext uri="{FF2B5EF4-FFF2-40B4-BE49-F238E27FC236}">
-                <a16:creationId xmlns:a16="http://schemas.microsoft.com/office/drawing/2014/main" id="{9CB8A09B-B7D0-4544-8304-506AFD00F09E}"/>
+                <a16:creationId xmlns:a16="http://schemas.microsoft.com/office/drawing/2014/main" id="{B0AE04BC-4E3A-40F7-A0F2-ECDE9AC535F5}"/>
               </a:ext>
             </a:extLst>
           </p:cNvPr>
@@ -5177,7 +5177,7 @@
     </p:spTree>
     <p:extLst>
       <p:ext uri="{BB962C8B-B14F-4D97-AF65-F5344CB8AC3E}">
-        <p14:creationId xmlns:p14="http://schemas.microsoft.com/office/powerpoint/2010/main" val="1006525070"/>
+        <p14:creationId xmlns:p14="http://schemas.microsoft.com/office/powerpoint/2010/main" val="1508190767"/>
       </p:ext>
     </p:extLst>
   </p:cSld>
@@ -5208,7 +5208,7 @@
           <p:cNvPr id="14" name="">
             <a:extLst xmlns:a="http://schemas.openxmlformats.org/drawingml/2006/main">
               <a:ext uri="{FF2B5EF4-FFF2-40B4-BE49-F238E27FC236}">
-                <a16:creationId xmlns:a16="http://schemas.microsoft.com/office/drawing/2014/main" id="{456C125E-CFA9-4E94-9033-E1275FD00BAA}"/>
+                <a16:creationId xmlns:a16="http://schemas.microsoft.com/office/drawing/2014/main" id="{122AE74C-4678-43CB-8323-7BC334708732}"/>
               </a:ext>
             </a:extLst>
           </p:cNvPr>
@@ -5258,7 +5258,7 @@
           <p:cNvPr id="2" name="">
             <a:extLst xmlns:a="http://schemas.openxmlformats.org/drawingml/2006/main">
               <a:ext uri="{FF2B5EF4-FFF2-40B4-BE49-F238E27FC236}">
-                <a16:creationId xmlns:a16="http://schemas.microsoft.com/office/drawing/2014/main" id="{8E7A96EE-0F75-4FD1-8056-A16F52052304}"/>
+                <a16:creationId xmlns:a16="http://schemas.microsoft.com/office/drawing/2014/main" id="{8CF3F7CC-4EC7-44DC-96F4-C0191E94391C}"/>
               </a:ext>
             </a:extLst>
           </p:cNvPr>
@@ -5308,7 +5308,7 @@
           <p:cNvPr id="3" name="">
             <a:extLst xmlns:a="http://schemas.openxmlformats.org/drawingml/2006/main">
               <a:ext uri="{FF2B5EF4-FFF2-40B4-BE49-F238E27FC236}">
-                <a16:creationId xmlns:a16="http://schemas.microsoft.com/office/drawing/2014/main" id="{F3B7F689-AA0F-4FCE-B8C1-7A6B4384B8DB}"/>
+                <a16:creationId xmlns:a16="http://schemas.microsoft.com/office/drawing/2014/main" id="{EC998F15-526A-4726-AFA3-123506ABA380}"/>
               </a:ext>
             </a:extLst>
           </p:cNvPr>
@@ -5347,7 +5347,7 @@
           <p:nvPr/>
         </p:nvPicPr>
         <p:blipFill>
-          <a:blip xmlns:r="http://schemas.openxmlformats.org/officeDocument/2006/relationships" xmlns:a="http://schemas.openxmlformats.org/drawingml/2006/main" r:embed="R22d98f0133724c22"/>
+          <a:blip xmlns:r="http://schemas.openxmlformats.org/officeDocument/2006/relationships" xmlns:a="http://schemas.openxmlformats.org/drawingml/2006/main" r:embed="R247ae4f82fac4aca"/>
           <a:stretch xmlns:a="http://schemas.openxmlformats.org/drawingml/2006/main"/>
         </p:blipFill>
         <p:spPr>
@@ -5365,7 +5365,7 @@
           <p:cNvPr id="5" name="">
             <a:extLst xmlns:a="http://schemas.openxmlformats.org/drawingml/2006/main">
               <a:ext uri="{FF2B5EF4-FFF2-40B4-BE49-F238E27FC236}">
-                <a16:creationId xmlns:a16="http://schemas.microsoft.com/office/drawing/2014/main" id="{20F4A1EB-FCFF-4142-826D-425B3E83E44F}"/>
+                <a16:creationId xmlns:a16="http://schemas.microsoft.com/office/drawing/2014/main" id="{605F64C3-AD29-4108-90C6-7C9C941134C7}"/>
               </a:ext>
             </a:extLst>
           </p:cNvPr>
@@ -5400,7 +5400,7 @@
           <p:cNvPr id="6" name="">
             <a:extLst xmlns:a="http://schemas.openxmlformats.org/drawingml/2006/main">
               <a:ext uri="{FF2B5EF4-FFF2-40B4-BE49-F238E27FC236}">
-                <a16:creationId xmlns:a16="http://schemas.microsoft.com/office/drawing/2014/main" id="{B50322F1-E9E0-4F53-8B6A-956EE8493103}"/>
+                <a16:creationId xmlns:a16="http://schemas.microsoft.com/office/drawing/2014/main" id="{AE13499B-7634-4BC5-95F3-91AC003DD403}"/>
               </a:ext>
             </a:extLst>
           </p:cNvPr>
@@ -5450,7 +5450,7 @@
           <p:cNvPr id="7" name="">
             <a:extLst xmlns:a="http://schemas.openxmlformats.org/drawingml/2006/main">
               <a:ext uri="{FF2B5EF4-FFF2-40B4-BE49-F238E27FC236}">
-                <a16:creationId xmlns:a16="http://schemas.microsoft.com/office/drawing/2014/main" id="{F037026E-8FEE-4C7E-A872-20694153C51E}"/>
+                <a16:creationId xmlns:a16="http://schemas.microsoft.com/office/drawing/2014/main" id="{F2593916-1B68-4F5D-A928-0577B3AE7131}"/>
               </a:ext>
             </a:extLst>
           </p:cNvPr>
@@ -5500,7 +5500,7 @@
           <p:cNvPr id="8" name="">
             <a:extLst xmlns:a="http://schemas.openxmlformats.org/drawingml/2006/main">
               <a:ext uri="{FF2B5EF4-FFF2-40B4-BE49-F238E27FC236}">
-                <a16:creationId xmlns:a16="http://schemas.microsoft.com/office/drawing/2014/main" id="{93B05141-627F-4798-93BF-18118E8A077C}"/>
+                <a16:creationId xmlns:a16="http://schemas.microsoft.com/office/drawing/2014/main" id="{31E3E785-3763-4100-962A-63E66851FAFB}"/>
               </a:ext>
             </a:extLst>
           </p:cNvPr>
@@ -5535,7 +5535,7 @@
           <p:cNvPr id="9" name="">
             <a:extLst xmlns:a="http://schemas.openxmlformats.org/drawingml/2006/main">
               <a:ext uri="{FF2B5EF4-FFF2-40B4-BE49-F238E27FC236}">
-                <a16:creationId xmlns:a16="http://schemas.microsoft.com/office/drawing/2014/main" id="{1F2B60C9-1D2D-4165-98F6-7F26DC785F8B}"/>
+                <a16:creationId xmlns:a16="http://schemas.microsoft.com/office/drawing/2014/main" id="{16133E4F-5277-4781-A76E-3A4F5F559784}"/>
               </a:ext>
             </a:extLst>
           </p:cNvPr>
@@ -5585,7 +5585,7 @@
           <p:cNvPr id="10" name="">
             <a:extLst xmlns:a="http://schemas.openxmlformats.org/drawingml/2006/main">
               <a:ext uri="{FF2B5EF4-FFF2-40B4-BE49-F238E27FC236}">
-                <a16:creationId xmlns:a16="http://schemas.microsoft.com/office/drawing/2014/main" id="{1247DCD4-AF7B-4F5E-8890-DA45AE548019}"/>
+                <a16:creationId xmlns:a16="http://schemas.microsoft.com/office/drawing/2014/main" id="{DBBC22DE-CEFC-4E54-995E-A302B092A06A}"/>
               </a:ext>
             </a:extLst>
           </p:cNvPr>
@@ -5635,7 +5635,7 @@
           <p:cNvPr id="11" name="">
             <a:extLst xmlns:a="http://schemas.openxmlformats.org/drawingml/2006/main">
               <a:ext uri="{FF2B5EF4-FFF2-40B4-BE49-F238E27FC236}">
-                <a16:creationId xmlns:a16="http://schemas.microsoft.com/office/drawing/2014/main" id="{98313591-67C0-4FE4-9445-5939A47FCE4E}"/>
+                <a16:creationId xmlns:a16="http://schemas.microsoft.com/office/drawing/2014/main" id="{CFCF7DCC-D1B4-4A5A-BDD4-0CD47FB5273E}"/>
               </a:ext>
             </a:extLst>
           </p:cNvPr>
@@ -5685,7 +5685,7 @@
           <p:cNvPr id="12" name="">
             <a:extLst xmlns:a="http://schemas.openxmlformats.org/drawingml/2006/main">
               <a:ext uri="{FF2B5EF4-FFF2-40B4-BE49-F238E27FC236}">
-                <a16:creationId xmlns:a16="http://schemas.microsoft.com/office/drawing/2014/main" id="{E4692B7C-5587-4231-AB47-847B62C12152}"/>
+                <a16:creationId xmlns:a16="http://schemas.microsoft.com/office/drawing/2014/main" id="{A087F5A8-1F15-480C-A956-CCE384A53627}"/>
               </a:ext>
             </a:extLst>
           </p:cNvPr>
@@ -5735,7 +5735,7 @@
           <p:cNvPr id="13" name="">
             <a:extLst xmlns:a="http://schemas.openxmlformats.org/drawingml/2006/main">
               <a:ext uri="{FF2B5EF4-FFF2-40B4-BE49-F238E27FC236}">
-                <a16:creationId xmlns:a16="http://schemas.microsoft.com/office/drawing/2014/main" id="{4B2933B7-7A7D-47B1-A67E-FEFD860A2404}"/>
+                <a16:creationId xmlns:a16="http://schemas.microsoft.com/office/drawing/2014/main" id="{01127284-94D0-4D96-927D-0537BEE953AD}"/>
               </a:ext>
             </a:extLst>
           </p:cNvPr>
@@ -5783,7 +5783,7 @@
     </p:spTree>
     <p:extLst>
       <p:ext uri="{BB962C8B-B14F-4D97-AF65-F5344CB8AC3E}">
-        <p14:creationId xmlns:p14="http://schemas.microsoft.com/office/powerpoint/2010/main" val="1158222287"/>
+        <p14:creationId xmlns:p14="http://schemas.microsoft.com/office/powerpoint/2010/main" val="2004430829"/>
       </p:ext>
     </p:extLst>
   </p:cSld>
@@ -5811,10 +5811,10 @@
       </p:grpSpPr>
       <p:sp>
         <p:nvSpPr>
-          <p:cNvPr id="44" name="">
-            <a:extLst xmlns:a="http://schemas.openxmlformats.org/drawingml/2006/main">
-              <a:ext uri="{FF2B5EF4-FFF2-40B4-BE49-F238E27FC236}">
-                <a16:creationId xmlns:a16="http://schemas.microsoft.com/office/drawing/2014/main" id="{5D76668C-DE85-4AAE-A4B7-F895E830E27E}"/>
+          <p:cNvPr id="14" name="">
+            <a:extLst xmlns:a="http://schemas.openxmlformats.org/drawingml/2006/main">
+              <a:ext uri="{FF2B5EF4-FFF2-40B4-BE49-F238E27FC236}">
+                <a16:creationId xmlns:a16="http://schemas.microsoft.com/office/drawing/2014/main" id="{8BC2481D-72DC-4C97-AEFE-67C3D9CDE632}"/>
               </a:ext>
             </a:extLst>
           </p:cNvPr>
@@ -5854,7 +5854,7 @@
                   <a:srgbClr val="0F172A"/>
                 </a:solidFill>
               </a:rPr>
-              <a:t>The prototype runs real prompts through SGLang</a:t>
+              <a:t>Experiment Testbed Setup</a:t>
             </a:r>
           </a:p>
         </p:txBody>
@@ -5864,7 +5864,7 @@
           <p:cNvPr id="2" name="">
             <a:extLst xmlns:a="http://schemas.openxmlformats.org/drawingml/2006/main">
               <a:ext uri="{FF2B5EF4-FFF2-40B4-BE49-F238E27FC236}">
-                <a16:creationId xmlns:a16="http://schemas.microsoft.com/office/drawing/2014/main" id="{01B7B60F-19C1-4F63-BD30-2F158CBF7BB9}"/>
+                <a16:creationId xmlns:a16="http://schemas.microsoft.com/office/drawing/2014/main" id="{41283567-321F-4957-B5B9-B606A18400D4}"/>
               </a:ext>
             </a:extLst>
           </p:cNvPr>
@@ -5904,7 +5904,7 @@
                   <a:srgbClr val="64748B"/>
                 </a:solidFill>
               </a:rPr>
-              <a:t>Concrete setup behind the charts: traffic source, serving stack, one GPU, model, and host-side KV cache.</a:t>
+              <a:t>Real software-engineering traces flow through DeepAgents into SGLang, where we observe tool gaps, replay requests, and KV behavior.</a:t>
             </a:r>
           </a:p>
         </p:txBody>
@@ -5914,175 +5914,23 @@
           <p:cNvPr id="3" name="">
             <a:extLst xmlns:a="http://schemas.openxmlformats.org/drawingml/2006/main">
               <a:ext uri="{FF2B5EF4-FFF2-40B4-BE49-F238E27FC236}">
-                <a16:creationId xmlns:a16="http://schemas.microsoft.com/office/drawing/2014/main" id="{B3C1B354-4E7D-46C1-BCDE-42E08F8C4E20}"/>
-              </a:ext>
-            </a:extLst>
-          </p:cNvPr>
-          <p:cNvSpPr>
-            <a:spLocks xmlns:a="http://schemas.openxmlformats.org/drawingml/2006/main" noGrp="1"/>
-          </p:cNvSpPr>
-          <p:nvPr/>
-        </p:nvSpPr>
-        <p:spPr>
-          <a:xfrm xmlns:a="http://schemas.openxmlformats.org/drawingml/2006/main">
-            <a:off x="514350" y="1752600"/>
-            <a:ext cx="1695450" cy="914400"/>
+                <a16:creationId xmlns:a16="http://schemas.microsoft.com/office/drawing/2014/main" id="{715E521E-542F-4291-A220-F1989FA38635}"/>
+              </a:ext>
+            </a:extLst>
+          </p:cNvPr>
+          <p:cNvSpPr>
+            <a:spLocks xmlns:a="http://schemas.openxmlformats.org/drawingml/2006/main" noGrp="1"/>
+          </p:cNvSpPr>
+          <p:nvPr/>
+        </p:nvSpPr>
+        <p:spPr>
+          <a:xfrm xmlns:a="http://schemas.openxmlformats.org/drawingml/2006/main">
+            <a:off x="1504950" y="2247900"/>
+            <a:ext cx="2095500" cy="1123950"/>
           </a:xfrm>
           <a:prstGeom xmlns:a="http://schemas.openxmlformats.org/drawingml/2006/main" prst="roundRect">
             <a:avLst>
-              <a:gd name="adj" fmla="val 6250"/>
-            </a:avLst>
-          </a:prstGeom>
-          <a:solidFill xmlns:a="http://schemas.openxmlformats.org/drawingml/2006/main">
-            <a:srgbClr val="F8FAFC"/>
-          </a:solidFill>
-          <a:ln xmlns:a="http://schemas.openxmlformats.org/drawingml/2006/main" w="9525">
-            <a:solidFill>
-              <a:srgbClr val="CBD5E1"/>
-            </a:solidFill>
-            <a:prstDash val="solid"/>
-          </a:ln>
-        </p:spPr>
-      </p:sp>
-      <p:sp>
-        <p:nvSpPr>
-          <p:cNvPr id="4" name="">
-            <a:extLst xmlns:a="http://schemas.openxmlformats.org/drawingml/2006/main">
-              <a:ext uri="{FF2B5EF4-FFF2-40B4-BE49-F238E27FC236}">
-                <a16:creationId xmlns:a16="http://schemas.microsoft.com/office/drawing/2014/main" id="{D6A78837-70DE-4325-A3D4-5FD759CEB171}"/>
-              </a:ext>
-            </a:extLst>
-          </p:cNvPr>
-          <p:cNvSpPr>
-            <a:spLocks xmlns:a="http://schemas.openxmlformats.org/drawingml/2006/main" noGrp="1"/>
-          </p:cNvSpPr>
-          <p:nvPr/>
-        </p:nvSpPr>
-        <p:spPr>
-          <a:xfrm xmlns:a="http://schemas.openxmlformats.org/drawingml/2006/main">
-            <a:off x="647700" y="1895475"/>
-            <a:ext cx="1428750" cy="723900"/>
-          </a:xfrm>
-          <a:prstGeom xmlns:a="http://schemas.openxmlformats.org/drawingml/2006/main" prst="rect">
-            <a:avLst/>
-          </a:prstGeom>
-          <a:noFill xmlns:a="http://schemas.openxmlformats.org/drawingml/2006/main"/>
-          <a:ln xmlns:a="http://schemas.openxmlformats.org/drawingml/2006/main" w="0">
-            <a:noFill/>
-            <a:prstDash val="solid"/>
-          </a:ln>
-        </p:spPr>
-        <p:txBody>
-          <a:bodyPr xmlns:a="http://schemas.openxmlformats.org/drawingml/2006/main" anchor="ctr"/>
-          <a:lstStyle xmlns:a="http://schemas.openxmlformats.org/drawingml/2006/main"/>
-          <a:p xmlns:a="http://schemas.openxmlformats.org/drawingml/2006/main">
-            <a:pPr algn="ctr">
-              <a:defRPr sz="1500" b="1">
-                <a:solidFill>
-                  <a:srgbClr val="0F172A"/>
-                </a:solidFill>
-              </a:defRPr>
-            </a:pPr>
-            <a:r>
-              <a:rPr sz="1500" b="1">
-                <a:solidFill>
-                  <a:srgbClr val="0F172A"/>
-                </a:solidFill>
-              </a:rPr>
-              <a:t>Synthetic</a:t>
-            </a:r>
-          </a:p>
-          <a:p xmlns:a="http://schemas.openxmlformats.org/drawingml/2006/main">
-            <a:pPr algn="ctr">
-              <a:defRPr sz="1500" b="1">
-                <a:solidFill>
-                  <a:srgbClr val="0F172A"/>
-                </a:solidFill>
-              </a:defRPr>
-            </a:pPr>
-            <a:r>
-              <a:rPr sz="1500" b="1">
-                <a:solidFill>
-                  <a:srgbClr val="0F172A"/>
-                </a:solidFill>
-              </a:rPr>
-              <a:t>request generator</a:t>
-            </a:r>
-          </a:p>
-        </p:txBody>
-      </p:sp>
-      <p:sp>
-        <p:nvSpPr>
-          <p:cNvPr id="5" name="">
-            <a:extLst xmlns:a="http://schemas.openxmlformats.org/drawingml/2006/main">
-              <a:ext uri="{FF2B5EF4-FFF2-40B4-BE49-F238E27FC236}">
-                <a16:creationId xmlns:a16="http://schemas.microsoft.com/office/drawing/2014/main" id="{CB275716-2FE3-49CB-85B9-6CBBB1F723F0}"/>
-              </a:ext>
-            </a:extLst>
-          </p:cNvPr>
-          <p:cNvSpPr>
-            <a:spLocks xmlns:a="http://schemas.openxmlformats.org/drawingml/2006/main" noGrp="1"/>
-          </p:cNvSpPr>
-          <p:nvPr/>
-        </p:nvSpPr>
-        <p:spPr>
-          <a:xfrm xmlns:a="http://schemas.openxmlformats.org/drawingml/2006/main">
-            <a:off x="2286000" y="2038350"/>
-            <a:ext cx="381000" cy="342900"/>
-          </a:xfrm>
-          <a:prstGeom xmlns:a="http://schemas.openxmlformats.org/drawingml/2006/main" prst="rect">
-            <a:avLst/>
-          </a:prstGeom>
-          <a:noFill xmlns:a="http://schemas.openxmlformats.org/drawingml/2006/main"/>
-          <a:ln xmlns:a="http://schemas.openxmlformats.org/drawingml/2006/main" w="0">
-            <a:noFill/>
-            <a:prstDash val="solid"/>
-          </a:ln>
-        </p:spPr>
-        <p:txBody>
-          <a:bodyPr xmlns:a="http://schemas.openxmlformats.org/drawingml/2006/main" anchor="t"/>
-          <a:lstStyle xmlns:a="http://schemas.openxmlformats.org/drawingml/2006/main"/>
-          <a:p xmlns:a="http://schemas.openxmlformats.org/drawingml/2006/main">
-            <a:pPr algn="ctr">
-              <a:defRPr sz="2250" b="1">
-                <a:solidFill>
-                  <a:srgbClr val="64748B"/>
-                </a:solidFill>
-              </a:defRPr>
-            </a:pPr>
-            <a:r>
-              <a:rPr sz="2250" b="1">
-                <a:solidFill>
-                  <a:srgbClr val="64748B"/>
-                </a:solidFill>
-              </a:rPr>
-              <a:t>→</a:t>
-            </a:r>
-          </a:p>
-        </p:txBody>
-      </p:sp>
-      <p:sp>
-        <p:nvSpPr>
-          <p:cNvPr id="6" name="">
-            <a:extLst xmlns:a="http://schemas.openxmlformats.org/drawingml/2006/main">
-              <a:ext uri="{FF2B5EF4-FFF2-40B4-BE49-F238E27FC236}">
-                <a16:creationId xmlns:a16="http://schemas.microsoft.com/office/drawing/2014/main" id="{DF8AEE1B-08EA-4B7E-AB42-72A215EB5BD4}"/>
-              </a:ext>
-            </a:extLst>
-          </p:cNvPr>
-          <p:cNvSpPr>
-            <a:spLocks xmlns:a="http://schemas.openxmlformats.org/drawingml/2006/main" noGrp="1"/>
-          </p:cNvSpPr>
-          <p:nvPr/>
-        </p:nvSpPr>
-        <p:spPr>
-          <a:xfrm xmlns:a="http://schemas.openxmlformats.org/drawingml/2006/main">
-            <a:off x="2724150" y="1752600"/>
-            <a:ext cx="1695450" cy="914400"/>
-          </a:xfrm>
-          <a:prstGeom xmlns:a="http://schemas.openxmlformats.org/drawingml/2006/main" prst="roundRect">
-            <a:avLst>
-              <a:gd name="adj" fmla="val 6250"/>
+              <a:gd name="adj" fmla="val 5085"/>
             </a:avLst>
           </a:prstGeom>
           <a:solidFill xmlns:a="http://schemas.openxmlformats.org/drawingml/2006/main">
@@ -6098,22 +5946,22 @@
       </p:sp>
       <p:sp>
         <p:nvSpPr>
-          <p:cNvPr id="7" name="">
-            <a:extLst xmlns:a="http://schemas.openxmlformats.org/drawingml/2006/main">
-              <a:ext uri="{FF2B5EF4-FFF2-40B4-BE49-F238E27FC236}">
-                <a16:creationId xmlns:a16="http://schemas.microsoft.com/office/drawing/2014/main" id="{2FA1B7DC-6C25-44E4-A135-A484F0AFDED2}"/>
-              </a:ext>
-            </a:extLst>
-          </p:cNvPr>
-          <p:cNvSpPr>
-            <a:spLocks xmlns:a="http://schemas.openxmlformats.org/drawingml/2006/main" noGrp="1"/>
-          </p:cNvSpPr>
-          <p:nvPr/>
-        </p:nvSpPr>
-        <p:spPr>
-          <a:xfrm xmlns:a="http://schemas.openxmlformats.org/drawingml/2006/main">
-            <a:off x="2857500" y="1895475"/>
-            <a:ext cx="1428750" cy="723900"/>
+          <p:cNvPr id="4" name="">
+            <a:extLst xmlns:a="http://schemas.openxmlformats.org/drawingml/2006/main">
+              <a:ext uri="{FF2B5EF4-FFF2-40B4-BE49-F238E27FC236}">
+                <a16:creationId xmlns:a16="http://schemas.microsoft.com/office/drawing/2014/main" id="{D4760415-2DAE-495A-8464-6A96C5BF371B}"/>
+              </a:ext>
+            </a:extLst>
+          </p:cNvPr>
+          <p:cNvSpPr>
+            <a:spLocks xmlns:a="http://schemas.openxmlformats.org/drawingml/2006/main" noGrp="1"/>
+          </p:cNvSpPr>
+          <p:nvPr/>
+        </p:nvSpPr>
+        <p:spPr>
+          <a:xfrm xmlns:a="http://schemas.openxmlformats.org/drawingml/2006/main">
+            <a:off x="1638300" y="2390775"/>
+            <a:ext cx="1828800" cy="933450"/>
           </a:xfrm>
           <a:prstGeom xmlns:a="http://schemas.openxmlformats.org/drawingml/2006/main" prst="rect">
             <a:avLst/>
@@ -6141,7 +5989,7 @@
                   <a:srgbClr val="0F172A"/>
                 </a:solidFill>
               </a:rPr>
-              <a:t>SWE-bench /</a:t>
+              <a:t>SWE-bench</a:t>
             </a:r>
           </a:p>
           <a:p xmlns:a="http://schemas.openxmlformats.org/drawingml/2006/main">
@@ -6158,29 +6006,29 @@
                   <a:srgbClr val="0F172A"/>
                 </a:solidFill>
               </a:rPr>
-              <a:t>DeepAgents traces</a:t>
-            </a:r>
-          </a:p>
-        </p:txBody>
-      </p:sp>
-      <p:sp>
-        <p:nvSpPr>
-          <p:cNvPr id="8" name="">
-            <a:extLst xmlns:a="http://schemas.openxmlformats.org/drawingml/2006/main">
-              <a:ext uri="{FF2B5EF4-FFF2-40B4-BE49-F238E27FC236}">
-                <a16:creationId xmlns:a16="http://schemas.microsoft.com/office/drawing/2014/main" id="{711EF777-17A7-452B-AB71-A68556732159}"/>
-              </a:ext>
-            </a:extLst>
-          </p:cNvPr>
-          <p:cNvSpPr>
-            <a:spLocks xmlns:a="http://schemas.openxmlformats.org/drawingml/2006/main" noGrp="1"/>
-          </p:cNvSpPr>
-          <p:nvPr/>
-        </p:nvSpPr>
-        <p:spPr>
-          <a:xfrm xmlns:a="http://schemas.openxmlformats.org/drawingml/2006/main">
-            <a:off x="4495800" y="2038350"/>
-            <a:ext cx="381000" cy="342900"/>
+              <a:t>traces</a:t>
+            </a:r>
+          </a:p>
+        </p:txBody>
+      </p:sp>
+      <p:sp>
+        <p:nvSpPr>
+          <p:cNvPr id="5" name="">
+            <a:extLst xmlns:a="http://schemas.openxmlformats.org/drawingml/2006/main">
+              <a:ext uri="{FF2B5EF4-FFF2-40B4-BE49-F238E27FC236}">
+                <a16:creationId xmlns:a16="http://schemas.microsoft.com/office/drawing/2014/main" id="{A0852961-F3FA-4C50-BDA5-EC0F67B93F89}"/>
+              </a:ext>
+            </a:extLst>
+          </p:cNvPr>
+          <p:cNvSpPr>
+            <a:spLocks xmlns:a="http://schemas.openxmlformats.org/drawingml/2006/main" noGrp="1"/>
+          </p:cNvSpPr>
+          <p:nvPr/>
+        </p:nvSpPr>
+        <p:spPr>
+          <a:xfrm xmlns:a="http://schemas.openxmlformats.org/drawingml/2006/main">
+            <a:off x="3848100" y="2609850"/>
+            <a:ext cx="742950" cy="419100"/>
           </a:xfrm>
           <a:prstGeom xmlns:a="http://schemas.openxmlformats.org/drawingml/2006/main" prst="rect">
             <a:avLst/>
@@ -6196,14 +6044,14 @@
           <a:lstStyle xmlns:a="http://schemas.openxmlformats.org/drawingml/2006/main"/>
           <a:p xmlns:a="http://schemas.openxmlformats.org/drawingml/2006/main">
             <a:pPr algn="ctr">
-              <a:defRPr sz="2250" b="1">
+              <a:defRPr sz="2850" b="1">
                 <a:solidFill>
                   <a:srgbClr val="64748B"/>
                 </a:solidFill>
               </a:defRPr>
             </a:pPr>
             <a:r>
-              <a:rPr sz="2250" b="1">
+              <a:rPr sz="2850" b="1">
                 <a:solidFill>
                   <a:srgbClr val="64748B"/>
                 </a:solidFill>
@@ -6215,26 +6063,26 @@
       </p:sp>
       <p:sp>
         <p:nvSpPr>
-          <p:cNvPr id="9" name="">
-            <a:extLst xmlns:a="http://schemas.openxmlformats.org/drawingml/2006/main">
-              <a:ext uri="{FF2B5EF4-FFF2-40B4-BE49-F238E27FC236}">
-                <a16:creationId xmlns:a16="http://schemas.microsoft.com/office/drawing/2014/main" id="{AF8C8EF3-2879-4C48-8B31-3B98314E3E8B}"/>
-              </a:ext>
-            </a:extLst>
-          </p:cNvPr>
-          <p:cNvSpPr>
-            <a:spLocks xmlns:a="http://schemas.openxmlformats.org/drawingml/2006/main" noGrp="1"/>
-          </p:cNvSpPr>
-          <p:nvPr/>
-        </p:nvSpPr>
-        <p:spPr>
-          <a:xfrm xmlns:a="http://schemas.openxmlformats.org/drawingml/2006/main">
-            <a:off x="4933950" y="1752600"/>
-            <a:ext cx="1695450" cy="914400"/>
+          <p:cNvPr id="6" name="">
+            <a:extLst xmlns:a="http://schemas.openxmlformats.org/drawingml/2006/main">
+              <a:ext uri="{FF2B5EF4-FFF2-40B4-BE49-F238E27FC236}">
+                <a16:creationId xmlns:a16="http://schemas.microsoft.com/office/drawing/2014/main" id="{01F13798-9667-47AF-B21D-FA7F7C610151}"/>
+              </a:ext>
+            </a:extLst>
+          </p:cNvPr>
+          <p:cNvSpPr>
+            <a:spLocks xmlns:a="http://schemas.openxmlformats.org/drawingml/2006/main" noGrp="1"/>
+          </p:cNvSpPr>
+          <p:nvPr/>
+        </p:nvSpPr>
+        <p:spPr>
+          <a:xfrm xmlns:a="http://schemas.openxmlformats.org/drawingml/2006/main">
+            <a:off x="5048250" y="2247900"/>
+            <a:ext cx="2095500" cy="1123950"/>
           </a:xfrm>
           <a:prstGeom xmlns:a="http://schemas.openxmlformats.org/drawingml/2006/main" prst="roundRect">
             <a:avLst>
-              <a:gd name="adj" fmla="val 6250"/>
+              <a:gd name="adj" fmla="val 5085"/>
             </a:avLst>
           </a:prstGeom>
           <a:solidFill xmlns:a="http://schemas.openxmlformats.org/drawingml/2006/main">
@@ -6250,22 +6098,22 @@
       </p:sp>
       <p:sp>
         <p:nvSpPr>
-          <p:cNvPr id="10" name="">
-            <a:extLst xmlns:a="http://schemas.openxmlformats.org/drawingml/2006/main">
-              <a:ext uri="{FF2B5EF4-FFF2-40B4-BE49-F238E27FC236}">
-                <a16:creationId xmlns:a16="http://schemas.microsoft.com/office/drawing/2014/main" id="{91A913B0-E03B-462C-8F0E-D182D6CC2055}"/>
-              </a:ext>
-            </a:extLst>
-          </p:cNvPr>
-          <p:cNvSpPr>
-            <a:spLocks xmlns:a="http://schemas.openxmlformats.org/drawingml/2006/main" noGrp="1"/>
-          </p:cNvSpPr>
-          <p:nvPr/>
-        </p:nvSpPr>
-        <p:spPr>
-          <a:xfrm xmlns:a="http://schemas.openxmlformats.org/drawingml/2006/main">
-            <a:off x="5067300" y="1895475"/>
-            <a:ext cx="1428750" cy="723900"/>
+          <p:cNvPr id="7" name="">
+            <a:extLst xmlns:a="http://schemas.openxmlformats.org/drawingml/2006/main">
+              <a:ext uri="{FF2B5EF4-FFF2-40B4-BE49-F238E27FC236}">
+                <a16:creationId xmlns:a16="http://schemas.microsoft.com/office/drawing/2014/main" id="{A6A063CC-0EAF-4FA0-8132-F0D892463971}"/>
+              </a:ext>
+            </a:extLst>
+          </p:cNvPr>
+          <p:cNvSpPr>
+            <a:spLocks xmlns:a="http://schemas.openxmlformats.org/drawingml/2006/main" noGrp="1"/>
+          </p:cNvSpPr>
+          <p:nvPr/>
+        </p:nvSpPr>
+        <p:spPr>
+          <a:xfrm xmlns:a="http://schemas.openxmlformats.org/drawingml/2006/main">
+            <a:off x="5181600" y="2390775"/>
+            <a:ext cx="1828800" cy="933450"/>
           </a:xfrm>
           <a:prstGeom xmlns:a="http://schemas.openxmlformats.org/drawingml/2006/main" prst="rect">
             <a:avLst/>
@@ -6293,69 +6141,52 @@
                   <a:srgbClr val="0F172A"/>
                 </a:solidFill>
               </a:rPr>
-              <a:t>SGLang</a:t>
-            </a:r>
-          </a:p>
+              <a:t>DeepAgents</a:t>
+            </a:r>
+          </a:p>
+        </p:txBody>
+      </p:sp>
+      <p:sp>
+        <p:nvSpPr>
+          <p:cNvPr id="8" name="">
+            <a:extLst xmlns:a="http://schemas.openxmlformats.org/drawingml/2006/main">
+              <a:ext uri="{FF2B5EF4-FFF2-40B4-BE49-F238E27FC236}">
+                <a16:creationId xmlns:a16="http://schemas.microsoft.com/office/drawing/2014/main" id="{50D597CD-399B-4695-8D67-E41962D8C628}"/>
+              </a:ext>
+            </a:extLst>
+          </p:cNvPr>
+          <p:cNvSpPr>
+            <a:spLocks xmlns:a="http://schemas.openxmlformats.org/drawingml/2006/main" noGrp="1"/>
+          </p:cNvSpPr>
+          <p:nvPr/>
+        </p:nvSpPr>
+        <p:spPr>
+          <a:xfrm xmlns:a="http://schemas.openxmlformats.org/drawingml/2006/main">
+            <a:off x="7391400" y="2609850"/>
+            <a:ext cx="742950" cy="419100"/>
+          </a:xfrm>
+          <a:prstGeom xmlns:a="http://schemas.openxmlformats.org/drawingml/2006/main" prst="rect">
+            <a:avLst/>
+          </a:prstGeom>
+          <a:noFill xmlns:a="http://schemas.openxmlformats.org/drawingml/2006/main"/>
+          <a:ln xmlns:a="http://schemas.openxmlformats.org/drawingml/2006/main" w="0">
+            <a:noFill/>
+            <a:prstDash val="solid"/>
+          </a:ln>
+        </p:spPr>
+        <p:txBody>
+          <a:bodyPr xmlns:a="http://schemas.openxmlformats.org/drawingml/2006/main" anchor="t"/>
+          <a:lstStyle xmlns:a="http://schemas.openxmlformats.org/drawingml/2006/main"/>
           <a:p xmlns:a="http://schemas.openxmlformats.org/drawingml/2006/main">
             <a:pPr algn="ctr">
-              <a:defRPr sz="1500" b="1">
-                <a:solidFill>
-                  <a:srgbClr val="0F172A"/>
-                </a:solidFill>
-              </a:defRPr>
-            </a:pPr>
-            <a:r>
-              <a:rPr sz="1500" b="1">
-                <a:solidFill>
-                  <a:srgbClr val="0F172A"/>
-                </a:solidFill>
-              </a:rPr>
-              <a:t>OpenAI server</a:t>
-            </a:r>
-          </a:p>
-        </p:txBody>
-      </p:sp>
-      <p:sp>
-        <p:nvSpPr>
-          <p:cNvPr id="11" name="">
-            <a:extLst xmlns:a="http://schemas.openxmlformats.org/drawingml/2006/main">
-              <a:ext uri="{FF2B5EF4-FFF2-40B4-BE49-F238E27FC236}">
-                <a16:creationId xmlns:a16="http://schemas.microsoft.com/office/drawing/2014/main" id="{80DD1B9A-4357-4472-845B-05F5F933D2C0}"/>
-              </a:ext>
-            </a:extLst>
-          </p:cNvPr>
-          <p:cNvSpPr>
-            <a:spLocks xmlns:a="http://schemas.openxmlformats.org/drawingml/2006/main" noGrp="1"/>
-          </p:cNvSpPr>
-          <p:nvPr/>
-        </p:nvSpPr>
-        <p:spPr>
-          <a:xfrm xmlns:a="http://schemas.openxmlformats.org/drawingml/2006/main">
-            <a:off x="6705600" y="2038350"/>
-            <a:ext cx="381000" cy="342900"/>
-          </a:xfrm>
-          <a:prstGeom xmlns:a="http://schemas.openxmlformats.org/drawingml/2006/main" prst="rect">
-            <a:avLst/>
-          </a:prstGeom>
-          <a:noFill xmlns:a="http://schemas.openxmlformats.org/drawingml/2006/main"/>
-          <a:ln xmlns:a="http://schemas.openxmlformats.org/drawingml/2006/main" w="0">
-            <a:noFill/>
-            <a:prstDash val="solid"/>
-          </a:ln>
-        </p:spPr>
-        <p:txBody>
-          <a:bodyPr xmlns:a="http://schemas.openxmlformats.org/drawingml/2006/main" anchor="t"/>
-          <a:lstStyle xmlns:a="http://schemas.openxmlformats.org/drawingml/2006/main"/>
-          <a:p xmlns:a="http://schemas.openxmlformats.org/drawingml/2006/main">
-            <a:pPr algn="ctr">
-              <a:defRPr sz="2250" b="1">
+              <a:defRPr sz="2850" b="1">
                 <a:solidFill>
                   <a:srgbClr val="64748B"/>
                 </a:solidFill>
               </a:defRPr>
             </a:pPr>
             <a:r>
-              <a:rPr sz="2250" b="1">
+              <a:rPr sz="2850" b="1">
                 <a:solidFill>
                   <a:srgbClr val="64748B"/>
                 </a:solidFill>
@@ -6367,26 +6198,26 @@
       </p:sp>
       <p:sp>
         <p:nvSpPr>
-          <p:cNvPr id="12" name="">
-            <a:extLst xmlns:a="http://schemas.openxmlformats.org/drawingml/2006/main">
-              <a:ext uri="{FF2B5EF4-FFF2-40B4-BE49-F238E27FC236}">
-                <a16:creationId xmlns:a16="http://schemas.microsoft.com/office/drawing/2014/main" id="{D43A8042-3B7B-47CF-B8F4-CA92B631B50F}"/>
-              </a:ext>
-            </a:extLst>
-          </p:cNvPr>
-          <p:cNvSpPr>
-            <a:spLocks xmlns:a="http://schemas.openxmlformats.org/drawingml/2006/main" noGrp="1"/>
-          </p:cNvSpPr>
-          <p:nvPr/>
-        </p:nvSpPr>
-        <p:spPr>
-          <a:xfrm xmlns:a="http://schemas.openxmlformats.org/drawingml/2006/main">
-            <a:off x="7143750" y="1752600"/>
-            <a:ext cx="1695450" cy="914400"/>
+          <p:cNvPr id="9" name="">
+            <a:extLst xmlns:a="http://schemas.openxmlformats.org/drawingml/2006/main">
+              <a:ext uri="{FF2B5EF4-FFF2-40B4-BE49-F238E27FC236}">
+                <a16:creationId xmlns:a16="http://schemas.microsoft.com/office/drawing/2014/main" id="{D52E4171-1596-443A-9067-991BB0DE5483}"/>
+              </a:ext>
+            </a:extLst>
+          </p:cNvPr>
+          <p:cNvSpPr>
+            <a:spLocks xmlns:a="http://schemas.openxmlformats.org/drawingml/2006/main" noGrp="1"/>
+          </p:cNvSpPr>
+          <p:nvPr/>
+        </p:nvSpPr>
+        <p:spPr>
+          <a:xfrm xmlns:a="http://schemas.openxmlformats.org/drawingml/2006/main">
+            <a:off x="8591550" y="2247900"/>
+            <a:ext cx="2095500" cy="1123950"/>
           </a:xfrm>
           <a:prstGeom xmlns:a="http://schemas.openxmlformats.org/drawingml/2006/main" prst="roundRect">
             <a:avLst>
-              <a:gd name="adj" fmla="val 6250"/>
+              <a:gd name="adj" fmla="val 5085"/>
             </a:avLst>
           </a:prstGeom>
           <a:solidFill xmlns:a="http://schemas.openxmlformats.org/drawingml/2006/main">
@@ -6402,22 +6233,22 @@
       </p:sp>
       <p:sp>
         <p:nvSpPr>
-          <p:cNvPr id="13" name="">
-            <a:extLst xmlns:a="http://schemas.openxmlformats.org/drawingml/2006/main">
-              <a:ext uri="{FF2B5EF4-FFF2-40B4-BE49-F238E27FC236}">
-                <a16:creationId xmlns:a16="http://schemas.microsoft.com/office/drawing/2014/main" id="{78EED882-3252-401B-B6F1-DFB069EDF770}"/>
-              </a:ext>
-            </a:extLst>
-          </p:cNvPr>
-          <p:cNvSpPr>
-            <a:spLocks xmlns:a="http://schemas.openxmlformats.org/drawingml/2006/main" noGrp="1"/>
-          </p:cNvSpPr>
-          <p:nvPr/>
-        </p:nvSpPr>
-        <p:spPr>
-          <a:xfrm xmlns:a="http://schemas.openxmlformats.org/drawingml/2006/main">
-            <a:off x="7277100" y="1895475"/>
-            <a:ext cx="1428750" cy="723900"/>
+          <p:cNvPr id="10" name="">
+            <a:extLst xmlns:a="http://schemas.openxmlformats.org/drawingml/2006/main">
+              <a:ext uri="{FF2B5EF4-FFF2-40B4-BE49-F238E27FC236}">
+                <a16:creationId xmlns:a16="http://schemas.microsoft.com/office/drawing/2014/main" id="{AC94E36E-192F-4531-9EC1-B2FE454A9836}"/>
+              </a:ext>
+            </a:extLst>
+          </p:cNvPr>
+          <p:cNvSpPr>
+            <a:spLocks xmlns:a="http://schemas.openxmlformats.org/drawingml/2006/main" noGrp="1"/>
+          </p:cNvSpPr>
+          <p:nvPr/>
+        </p:nvSpPr>
+        <p:spPr>
+          <a:xfrm xmlns:a="http://schemas.openxmlformats.org/drawingml/2006/main">
+            <a:off x="8724900" y="2390775"/>
+            <a:ext cx="1828800" cy="933450"/>
           </a:xfrm>
           <a:prstGeom xmlns:a="http://schemas.openxmlformats.org/drawingml/2006/main" prst="rect">
             <a:avLst/>
@@ -6445,7 +6276,7 @@
                   <a:srgbClr val="0F172A"/>
                 </a:solidFill>
               </a:rPr>
-              <a:t>Qwen Coder</a:t>
+              <a:t>SGLang</a:t>
             </a:r>
           </a:p>
           <a:p xmlns:a="http://schemas.openxmlformats.org/drawingml/2006/main">
@@ -6462,1249 +6293,17 @@
                   <a:srgbClr val="0F172A"/>
                 </a:solidFill>
               </a:rPr>
-              <a:t>7B Instruct</a:t>
-            </a:r>
-          </a:p>
-        </p:txBody>
-      </p:sp>
-      <p:sp>
-        <p:nvSpPr>
-          <p:cNvPr id="14" name="">
-            <a:extLst xmlns:a="http://schemas.openxmlformats.org/drawingml/2006/main">
-              <a:ext uri="{FF2B5EF4-FFF2-40B4-BE49-F238E27FC236}">
-                <a16:creationId xmlns:a16="http://schemas.microsoft.com/office/drawing/2014/main" id="{49911DA4-F8F9-4825-940F-2C3EFF421446}"/>
-              </a:ext>
-            </a:extLst>
-          </p:cNvPr>
-          <p:cNvSpPr>
-            <a:spLocks xmlns:a="http://schemas.openxmlformats.org/drawingml/2006/main" noGrp="1"/>
-          </p:cNvSpPr>
-          <p:nvPr/>
-        </p:nvSpPr>
-        <p:spPr>
-          <a:xfrm xmlns:a="http://schemas.openxmlformats.org/drawingml/2006/main">
-            <a:off x="8915400" y="2038350"/>
-            <a:ext cx="381000" cy="342900"/>
-          </a:xfrm>
-          <a:prstGeom xmlns:a="http://schemas.openxmlformats.org/drawingml/2006/main" prst="rect">
-            <a:avLst/>
-          </a:prstGeom>
-          <a:noFill xmlns:a="http://schemas.openxmlformats.org/drawingml/2006/main"/>
-          <a:ln xmlns:a="http://schemas.openxmlformats.org/drawingml/2006/main" w="0">
-            <a:noFill/>
-            <a:prstDash val="solid"/>
-          </a:ln>
-        </p:spPr>
-        <p:txBody>
-          <a:bodyPr xmlns:a="http://schemas.openxmlformats.org/drawingml/2006/main" anchor="t"/>
-          <a:lstStyle xmlns:a="http://schemas.openxmlformats.org/drawingml/2006/main"/>
-          <a:p xmlns:a="http://schemas.openxmlformats.org/drawingml/2006/main">
-            <a:pPr algn="ctr">
-              <a:defRPr sz="2250" b="1">
-                <a:solidFill>
-                  <a:srgbClr val="64748B"/>
-                </a:solidFill>
-              </a:defRPr>
-            </a:pPr>
-            <a:r>
-              <a:rPr sz="2250" b="1">
-                <a:solidFill>
-                  <a:srgbClr val="64748B"/>
-                </a:solidFill>
-              </a:rPr>
-              <a:t>→</a:t>
-            </a:r>
-          </a:p>
-        </p:txBody>
-      </p:sp>
-      <p:sp>
-        <p:nvSpPr>
-          <p:cNvPr id="15" name="">
-            <a:extLst xmlns:a="http://schemas.openxmlformats.org/drawingml/2006/main">
-              <a:ext uri="{FF2B5EF4-FFF2-40B4-BE49-F238E27FC236}">
-                <a16:creationId xmlns:a16="http://schemas.microsoft.com/office/drawing/2014/main" id="{22DAF0E8-D2B1-45AF-BF61-26261587C590}"/>
-              </a:ext>
-            </a:extLst>
-          </p:cNvPr>
-          <p:cNvSpPr>
-            <a:spLocks xmlns:a="http://schemas.openxmlformats.org/drawingml/2006/main" noGrp="1"/>
-          </p:cNvSpPr>
-          <p:nvPr/>
-        </p:nvSpPr>
-        <p:spPr>
-          <a:xfrm xmlns:a="http://schemas.openxmlformats.org/drawingml/2006/main">
-            <a:off x="9353550" y="1752600"/>
-            <a:ext cx="1695450" cy="914400"/>
-          </a:xfrm>
-          <a:prstGeom xmlns:a="http://schemas.openxmlformats.org/drawingml/2006/main" prst="roundRect">
-            <a:avLst>
-              <a:gd name="adj" fmla="val 6250"/>
-            </a:avLst>
-          </a:prstGeom>
-          <a:solidFill xmlns:a="http://schemas.openxmlformats.org/drawingml/2006/main">
-            <a:srgbClr val="F0FDF4"/>
-          </a:solidFill>
-          <a:ln xmlns:a="http://schemas.openxmlformats.org/drawingml/2006/main" w="9525">
-            <a:solidFill>
-              <a:srgbClr val="86EFAC"/>
-            </a:solidFill>
-            <a:prstDash val="solid"/>
-          </a:ln>
-        </p:spPr>
-      </p:sp>
-      <p:sp>
-        <p:nvSpPr>
-          <p:cNvPr id="16" name="">
-            <a:extLst xmlns:a="http://schemas.openxmlformats.org/drawingml/2006/main">
-              <a:ext uri="{FF2B5EF4-FFF2-40B4-BE49-F238E27FC236}">
-                <a16:creationId xmlns:a16="http://schemas.microsoft.com/office/drawing/2014/main" id="{7DCC1C11-80D9-4664-BC8B-5CC4FCC223EA}"/>
-              </a:ext>
-            </a:extLst>
-          </p:cNvPr>
-          <p:cNvSpPr>
-            <a:spLocks xmlns:a="http://schemas.openxmlformats.org/drawingml/2006/main" noGrp="1"/>
-          </p:cNvSpPr>
-          <p:nvPr/>
-        </p:nvSpPr>
-        <p:spPr>
-          <a:xfrm xmlns:a="http://schemas.openxmlformats.org/drawingml/2006/main">
-            <a:off x="9486900" y="1895475"/>
-            <a:ext cx="1428750" cy="723900"/>
-          </a:xfrm>
-          <a:prstGeom xmlns:a="http://schemas.openxmlformats.org/drawingml/2006/main" prst="rect">
-            <a:avLst/>
-          </a:prstGeom>
-          <a:noFill xmlns:a="http://schemas.openxmlformats.org/drawingml/2006/main"/>
-          <a:ln xmlns:a="http://schemas.openxmlformats.org/drawingml/2006/main" w="0">
-            <a:noFill/>
-            <a:prstDash val="solid"/>
-          </a:ln>
-        </p:spPr>
-        <p:txBody>
-          <a:bodyPr xmlns:a="http://schemas.openxmlformats.org/drawingml/2006/main" anchor="ctr"/>
-          <a:lstStyle xmlns:a="http://schemas.openxmlformats.org/drawingml/2006/main"/>
-          <a:p xmlns:a="http://schemas.openxmlformats.org/drawingml/2006/main">
-            <a:pPr algn="ctr">
-              <a:defRPr sz="1500" b="1">
-                <a:solidFill>
-                  <a:srgbClr val="0F172A"/>
-                </a:solidFill>
-              </a:defRPr>
-            </a:pPr>
-            <a:r>
-              <a:rPr sz="1500" b="1">
-                <a:solidFill>
-                  <a:srgbClr val="0F172A"/>
-                </a:solidFill>
-              </a:rPr>
-              <a:t>GPU KV cache</a:t>
-            </a:r>
-          </a:p>
-          <a:p xmlns:a="http://schemas.openxmlformats.org/drawingml/2006/main">
-            <a:pPr algn="ctr">
-              <a:defRPr sz="1500" b="1">
-                <a:solidFill>
-                  <a:srgbClr val="0F172A"/>
-                </a:solidFill>
-              </a:defRPr>
-            </a:pPr>
-            <a:r>
-              <a:rPr sz="1500" b="1">
-                <a:solidFill>
-                  <a:srgbClr val="0F172A"/>
-                </a:solidFill>
-              </a:rPr>
-              <a:t>+ HiCache</a:t>
-            </a:r>
-          </a:p>
-        </p:txBody>
-      </p:sp>
-      <p:sp>
-        <p:nvSpPr>
-          <p:cNvPr id="17" name="">
-            <a:extLst xmlns:a="http://schemas.openxmlformats.org/drawingml/2006/main">
-              <a:ext uri="{FF2B5EF4-FFF2-40B4-BE49-F238E27FC236}">
-                <a16:creationId xmlns:a16="http://schemas.microsoft.com/office/drawing/2014/main" id="{4CE6824F-D9FD-4999-89D0-FBD2BDA9B8CE}"/>
-              </a:ext>
-            </a:extLst>
-          </p:cNvPr>
-          <p:cNvSpPr>
-            <a:spLocks xmlns:a="http://schemas.openxmlformats.org/drawingml/2006/main" noGrp="1"/>
-          </p:cNvSpPr>
-          <p:nvPr/>
-        </p:nvSpPr>
-        <p:spPr>
-          <a:xfrm xmlns:a="http://schemas.openxmlformats.org/drawingml/2006/main">
-            <a:off x="666750" y="3390900"/>
-            <a:ext cx="2343150" cy="895350"/>
-          </a:xfrm>
-          <a:prstGeom xmlns:a="http://schemas.openxmlformats.org/drawingml/2006/main" prst="roundRect">
-            <a:avLst>
-              <a:gd name="adj" fmla="val 6383"/>
-            </a:avLst>
-          </a:prstGeom>
-          <a:solidFill xmlns:a="http://schemas.openxmlformats.org/drawingml/2006/main">
-            <a:srgbClr val="F8FAFC"/>
-          </a:solidFill>
-          <a:ln xmlns:a="http://schemas.openxmlformats.org/drawingml/2006/main" w="9525">
-            <a:solidFill>
-              <a:srgbClr val="CBD5E1"/>
-            </a:solidFill>
-            <a:prstDash val="solid"/>
-          </a:ln>
-        </p:spPr>
-      </p:sp>
-      <p:sp>
-        <p:nvSpPr>
-          <p:cNvPr id="18" name="">
-            <a:extLst xmlns:a="http://schemas.openxmlformats.org/drawingml/2006/main">
-              <a:ext uri="{FF2B5EF4-FFF2-40B4-BE49-F238E27FC236}">
-                <a16:creationId xmlns:a16="http://schemas.microsoft.com/office/drawing/2014/main" id="{63172E0B-B5D7-4C0F-8A95-E7215FE7CA55}"/>
-              </a:ext>
-            </a:extLst>
-          </p:cNvPr>
-          <p:cNvSpPr>
-            <a:spLocks xmlns:a="http://schemas.openxmlformats.org/drawingml/2006/main" noGrp="1"/>
-          </p:cNvSpPr>
-          <p:nvPr/>
-        </p:nvSpPr>
-        <p:spPr>
-          <a:xfrm xmlns:a="http://schemas.openxmlformats.org/drawingml/2006/main">
-            <a:off x="819150" y="3524250"/>
-            <a:ext cx="2038350" cy="209550"/>
-          </a:xfrm>
-          <a:prstGeom xmlns:a="http://schemas.openxmlformats.org/drawingml/2006/main" prst="rect">
-            <a:avLst/>
-          </a:prstGeom>
-          <a:noFill xmlns:a="http://schemas.openxmlformats.org/drawingml/2006/main"/>
-          <a:ln xmlns:a="http://schemas.openxmlformats.org/drawingml/2006/main" w="0">
-            <a:noFill/>
-            <a:prstDash val="solid"/>
-          </a:ln>
-        </p:spPr>
-        <p:txBody>
-          <a:bodyPr xmlns:a="http://schemas.openxmlformats.org/drawingml/2006/main" anchor="t"/>
-          <a:lstStyle xmlns:a="http://schemas.openxmlformats.org/drawingml/2006/main"/>
-          <a:p xmlns:a="http://schemas.openxmlformats.org/drawingml/2006/main">
-            <a:pPr algn="l">
-              <a:defRPr sz="1125" b="1">
-                <a:solidFill>
-                  <a:srgbClr val="64748B"/>
-                </a:solidFill>
-              </a:defRPr>
-            </a:pPr>
-            <a:r>
-              <a:rPr sz="1125" b="1">
-                <a:solidFill>
-                  <a:srgbClr val="64748B"/>
-                </a:solidFill>
-              </a:rPr>
-              <a:t>GPU</a:t>
-            </a:r>
-          </a:p>
-        </p:txBody>
-      </p:sp>
-      <p:sp>
-        <p:nvSpPr>
-          <p:cNvPr id="19" name="">
-            <a:extLst xmlns:a="http://schemas.openxmlformats.org/drawingml/2006/main">
-              <a:ext uri="{FF2B5EF4-FFF2-40B4-BE49-F238E27FC236}">
-                <a16:creationId xmlns:a16="http://schemas.microsoft.com/office/drawing/2014/main" id="{D214B62A-CE92-4824-ACB6-0D5D657E6933}"/>
-              </a:ext>
-            </a:extLst>
-          </p:cNvPr>
-          <p:cNvSpPr>
-            <a:spLocks xmlns:a="http://schemas.openxmlformats.org/drawingml/2006/main" noGrp="1"/>
-          </p:cNvSpPr>
-          <p:nvPr/>
-        </p:nvSpPr>
-        <p:spPr>
-          <a:xfrm xmlns:a="http://schemas.openxmlformats.org/drawingml/2006/main">
-            <a:off x="819150" y="3790950"/>
-            <a:ext cx="2038350" cy="400050"/>
-          </a:xfrm>
-          <a:prstGeom xmlns:a="http://schemas.openxmlformats.org/drawingml/2006/main" prst="rect">
-            <a:avLst/>
-          </a:prstGeom>
-          <a:noFill xmlns:a="http://schemas.openxmlformats.org/drawingml/2006/main"/>
-          <a:ln xmlns:a="http://schemas.openxmlformats.org/drawingml/2006/main" w="0">
-            <a:noFill/>
-            <a:prstDash val="solid"/>
-          </a:ln>
-        </p:spPr>
-        <p:txBody>
-          <a:bodyPr xmlns:a="http://schemas.openxmlformats.org/drawingml/2006/main" anchor="t"/>
-          <a:lstStyle xmlns:a="http://schemas.openxmlformats.org/drawingml/2006/main"/>
-          <a:p xmlns:a="http://schemas.openxmlformats.org/drawingml/2006/main">
-            <a:pPr algn="l">
-              <a:defRPr sz="1575" b="1">
-                <a:solidFill>
-                  <a:srgbClr val="0F172A"/>
-                </a:solidFill>
-              </a:defRPr>
-            </a:pPr>
-            <a:r>
-              <a:rPr sz="1575" b="1">
-                <a:solidFill>
-                  <a:srgbClr val="0F172A"/>
-                </a:solidFill>
-              </a:rPr>
-              <a:t>NVIDIA A10G class</a:t>
-            </a:r>
-          </a:p>
-        </p:txBody>
-      </p:sp>
-      <p:sp>
-        <p:nvSpPr>
-          <p:cNvPr id="20" name="">
-            <a:extLst xmlns:a="http://schemas.openxmlformats.org/drawingml/2006/main">
-              <a:ext uri="{FF2B5EF4-FFF2-40B4-BE49-F238E27FC236}">
-                <a16:creationId xmlns:a16="http://schemas.microsoft.com/office/drawing/2014/main" id="{D77BBA88-8E58-48EA-86BF-6044FAC55F72}"/>
-              </a:ext>
-            </a:extLst>
-          </p:cNvPr>
-          <p:cNvSpPr>
-            <a:spLocks xmlns:a="http://schemas.openxmlformats.org/drawingml/2006/main" noGrp="1"/>
-          </p:cNvSpPr>
-          <p:nvPr/>
-        </p:nvSpPr>
-        <p:spPr>
-          <a:xfrm xmlns:a="http://schemas.openxmlformats.org/drawingml/2006/main">
-            <a:off x="3238500" y="3390900"/>
-            <a:ext cx="2343150" cy="895350"/>
-          </a:xfrm>
-          <a:prstGeom xmlns:a="http://schemas.openxmlformats.org/drawingml/2006/main" prst="roundRect">
-            <a:avLst>
-              <a:gd name="adj" fmla="val 6383"/>
-            </a:avLst>
-          </a:prstGeom>
-          <a:solidFill xmlns:a="http://schemas.openxmlformats.org/drawingml/2006/main">
-            <a:srgbClr val="F8FAFC"/>
-          </a:solidFill>
-          <a:ln xmlns:a="http://schemas.openxmlformats.org/drawingml/2006/main" w="9525">
-            <a:solidFill>
-              <a:srgbClr val="CBD5E1"/>
-            </a:solidFill>
-            <a:prstDash val="solid"/>
-          </a:ln>
-        </p:spPr>
-      </p:sp>
-      <p:sp>
-        <p:nvSpPr>
-          <p:cNvPr id="21" name="">
-            <a:extLst xmlns:a="http://schemas.openxmlformats.org/drawingml/2006/main">
-              <a:ext uri="{FF2B5EF4-FFF2-40B4-BE49-F238E27FC236}">
-                <a16:creationId xmlns:a16="http://schemas.microsoft.com/office/drawing/2014/main" id="{8EE3806C-14E5-4ABD-A6EE-230C625A0F97}"/>
-              </a:ext>
-            </a:extLst>
-          </p:cNvPr>
-          <p:cNvSpPr>
-            <a:spLocks xmlns:a="http://schemas.openxmlformats.org/drawingml/2006/main" noGrp="1"/>
-          </p:cNvSpPr>
-          <p:nvPr/>
-        </p:nvSpPr>
-        <p:spPr>
-          <a:xfrm xmlns:a="http://schemas.openxmlformats.org/drawingml/2006/main">
-            <a:off x="3390900" y="3524250"/>
-            <a:ext cx="2038350" cy="209550"/>
-          </a:xfrm>
-          <a:prstGeom xmlns:a="http://schemas.openxmlformats.org/drawingml/2006/main" prst="rect">
-            <a:avLst/>
-          </a:prstGeom>
-          <a:noFill xmlns:a="http://schemas.openxmlformats.org/drawingml/2006/main"/>
-          <a:ln xmlns:a="http://schemas.openxmlformats.org/drawingml/2006/main" w="0">
-            <a:noFill/>
-            <a:prstDash val="solid"/>
-          </a:ln>
-        </p:spPr>
-        <p:txBody>
-          <a:bodyPr xmlns:a="http://schemas.openxmlformats.org/drawingml/2006/main" anchor="t"/>
-          <a:lstStyle xmlns:a="http://schemas.openxmlformats.org/drawingml/2006/main"/>
-          <a:p xmlns:a="http://schemas.openxmlformats.org/drawingml/2006/main">
-            <a:pPr algn="l">
-              <a:defRPr sz="1125" b="1">
-                <a:solidFill>
-                  <a:srgbClr val="64748B"/>
-                </a:solidFill>
-              </a:defRPr>
-            </a:pPr>
-            <a:r>
-              <a:rPr sz="1125" b="1">
-                <a:solidFill>
-                  <a:srgbClr val="64748B"/>
-                </a:solidFill>
-              </a:rPr>
-              <a:t>GPU memory</a:t>
-            </a:r>
-          </a:p>
-        </p:txBody>
-      </p:sp>
-      <p:sp>
-        <p:nvSpPr>
-          <p:cNvPr id="22" name="">
-            <a:extLst xmlns:a="http://schemas.openxmlformats.org/drawingml/2006/main">
-              <a:ext uri="{FF2B5EF4-FFF2-40B4-BE49-F238E27FC236}">
-                <a16:creationId xmlns:a16="http://schemas.microsoft.com/office/drawing/2014/main" id="{D2506BDE-D690-41B4-AAE8-C84D8D6B40E3}"/>
-              </a:ext>
-            </a:extLst>
-          </p:cNvPr>
-          <p:cNvSpPr>
-            <a:spLocks xmlns:a="http://schemas.openxmlformats.org/drawingml/2006/main" noGrp="1"/>
-          </p:cNvSpPr>
-          <p:nvPr/>
-        </p:nvSpPr>
-        <p:spPr>
-          <a:xfrm xmlns:a="http://schemas.openxmlformats.org/drawingml/2006/main">
-            <a:off x="3390900" y="3790950"/>
-            <a:ext cx="2038350" cy="400050"/>
-          </a:xfrm>
-          <a:prstGeom xmlns:a="http://schemas.openxmlformats.org/drawingml/2006/main" prst="rect">
-            <a:avLst/>
-          </a:prstGeom>
-          <a:noFill xmlns:a="http://schemas.openxmlformats.org/drawingml/2006/main"/>
-          <a:ln xmlns:a="http://schemas.openxmlformats.org/drawingml/2006/main" w="0">
-            <a:noFill/>
-            <a:prstDash val="solid"/>
-          </a:ln>
-        </p:spPr>
-        <p:txBody>
-          <a:bodyPr xmlns:a="http://schemas.openxmlformats.org/drawingml/2006/main" anchor="t"/>
-          <a:lstStyle xmlns:a="http://schemas.openxmlformats.org/drawingml/2006/main"/>
-          <a:p xmlns:a="http://schemas.openxmlformats.org/drawingml/2006/main">
-            <a:pPr algn="l">
-              <a:defRPr sz="1575" b="1">
-                <a:solidFill>
-                  <a:srgbClr val="0F172A"/>
-                </a:solidFill>
-              </a:defRPr>
-            </a:pPr>
-            <a:r>
-              <a:rPr sz="1575" b="1">
-                <a:solidFill>
-                  <a:srgbClr val="0F172A"/>
-                </a:solidFill>
-              </a:rPr>
-              <a:t>24 GB GDDR6</a:t>
-            </a:r>
-          </a:p>
-        </p:txBody>
-      </p:sp>
-      <p:sp>
-        <p:nvSpPr>
-          <p:cNvPr id="23" name="">
-            <a:extLst xmlns:a="http://schemas.openxmlformats.org/drawingml/2006/main">
-              <a:ext uri="{FF2B5EF4-FFF2-40B4-BE49-F238E27FC236}">
-                <a16:creationId xmlns:a16="http://schemas.microsoft.com/office/drawing/2014/main" id="{9CCC2AF3-0EF1-44CA-B718-9F81283757B7}"/>
-              </a:ext>
-            </a:extLst>
-          </p:cNvPr>
-          <p:cNvSpPr>
-            <a:spLocks xmlns:a="http://schemas.openxmlformats.org/drawingml/2006/main" noGrp="1"/>
-          </p:cNvSpPr>
-          <p:nvPr/>
-        </p:nvSpPr>
-        <p:spPr>
-          <a:xfrm xmlns:a="http://schemas.openxmlformats.org/drawingml/2006/main">
-            <a:off x="5810250" y="3390900"/>
-            <a:ext cx="2343150" cy="895350"/>
-          </a:xfrm>
-          <a:prstGeom xmlns:a="http://schemas.openxmlformats.org/drawingml/2006/main" prst="roundRect">
-            <a:avLst>
-              <a:gd name="adj" fmla="val 6383"/>
-            </a:avLst>
-          </a:prstGeom>
-          <a:solidFill xmlns:a="http://schemas.openxmlformats.org/drawingml/2006/main">
-            <a:srgbClr val="FFF7ED"/>
-          </a:solidFill>
-          <a:ln xmlns:a="http://schemas.openxmlformats.org/drawingml/2006/main" w="9525">
-            <a:solidFill>
-              <a:srgbClr val="FED7AA"/>
-            </a:solidFill>
-            <a:prstDash val="solid"/>
-          </a:ln>
-        </p:spPr>
-      </p:sp>
-      <p:sp>
-        <p:nvSpPr>
-          <p:cNvPr id="24" name="">
-            <a:extLst xmlns:a="http://schemas.openxmlformats.org/drawingml/2006/main">
-              <a:ext uri="{FF2B5EF4-FFF2-40B4-BE49-F238E27FC236}">
-                <a16:creationId xmlns:a16="http://schemas.microsoft.com/office/drawing/2014/main" id="{FAF9D5E7-296A-41D1-9400-60A2C12BB9D0}"/>
-              </a:ext>
-            </a:extLst>
-          </p:cNvPr>
-          <p:cNvSpPr>
-            <a:spLocks xmlns:a="http://schemas.openxmlformats.org/drawingml/2006/main" noGrp="1"/>
-          </p:cNvSpPr>
-          <p:nvPr/>
-        </p:nvSpPr>
-        <p:spPr>
-          <a:xfrm xmlns:a="http://schemas.openxmlformats.org/drawingml/2006/main">
-            <a:off x="5962650" y="3524250"/>
-            <a:ext cx="2038350" cy="209550"/>
-          </a:xfrm>
-          <a:prstGeom xmlns:a="http://schemas.openxmlformats.org/drawingml/2006/main" prst="rect">
-            <a:avLst/>
-          </a:prstGeom>
-          <a:noFill xmlns:a="http://schemas.openxmlformats.org/drawingml/2006/main"/>
-          <a:ln xmlns:a="http://schemas.openxmlformats.org/drawingml/2006/main" w="0">
-            <a:noFill/>
-            <a:prstDash val="solid"/>
-          </a:ln>
-        </p:spPr>
-        <p:txBody>
-          <a:bodyPr xmlns:a="http://schemas.openxmlformats.org/drawingml/2006/main" anchor="t"/>
-          <a:lstStyle xmlns:a="http://schemas.openxmlformats.org/drawingml/2006/main"/>
-          <a:p xmlns:a="http://schemas.openxmlformats.org/drawingml/2006/main">
-            <a:pPr algn="l">
-              <a:defRPr sz="1125" b="1">
-                <a:solidFill>
-                  <a:srgbClr val="64748B"/>
-                </a:solidFill>
-              </a:defRPr>
-            </a:pPr>
-            <a:r>
-              <a:rPr sz="1125" b="1">
-                <a:solidFill>
-                  <a:srgbClr val="64748B"/>
-                </a:solidFill>
-              </a:rPr>
-              <a:t>HiCache host KV shelf</a:t>
-            </a:r>
-          </a:p>
-        </p:txBody>
-      </p:sp>
-      <p:sp>
-        <p:nvSpPr>
-          <p:cNvPr id="25" name="">
-            <a:extLst xmlns:a="http://schemas.openxmlformats.org/drawingml/2006/main">
-              <a:ext uri="{FF2B5EF4-FFF2-40B4-BE49-F238E27FC236}">
-                <a16:creationId xmlns:a16="http://schemas.microsoft.com/office/drawing/2014/main" id="{A91B2E25-0224-4BEE-9220-3983AFBD5860}"/>
-              </a:ext>
-            </a:extLst>
-          </p:cNvPr>
-          <p:cNvSpPr>
-            <a:spLocks xmlns:a="http://schemas.openxmlformats.org/drawingml/2006/main" noGrp="1"/>
-          </p:cNvSpPr>
-          <p:nvPr/>
-        </p:nvSpPr>
-        <p:spPr>
-          <a:xfrm xmlns:a="http://schemas.openxmlformats.org/drawingml/2006/main">
-            <a:off x="5962650" y="3790950"/>
-            <a:ext cx="2038350" cy="400050"/>
-          </a:xfrm>
-          <a:prstGeom xmlns:a="http://schemas.openxmlformats.org/drawingml/2006/main" prst="rect">
-            <a:avLst/>
-          </a:prstGeom>
-          <a:noFill xmlns:a="http://schemas.openxmlformats.org/drawingml/2006/main"/>
-          <a:ln xmlns:a="http://schemas.openxmlformats.org/drawingml/2006/main" w="0">
-            <a:noFill/>
-            <a:prstDash val="solid"/>
-          </a:ln>
-        </p:spPr>
-        <p:txBody>
-          <a:bodyPr xmlns:a="http://schemas.openxmlformats.org/drawingml/2006/main" anchor="t"/>
-          <a:lstStyle xmlns:a="http://schemas.openxmlformats.org/drawingml/2006/main"/>
-          <a:p xmlns:a="http://schemas.openxmlformats.org/drawingml/2006/main">
-            <a:pPr algn="l">
-              <a:defRPr sz="1575" b="1">
-                <a:solidFill>
-                  <a:srgbClr val="0F172A"/>
-                </a:solidFill>
-              </a:defRPr>
-            </a:pPr>
-            <a:r>
-              <a:rPr sz="1575" b="1">
-                <a:solidFill>
-                  <a:srgbClr val="0F172A"/>
-                </a:solidFill>
-              </a:rPr>
-              <a:t>16 GB configured</a:t>
-            </a:r>
-          </a:p>
-        </p:txBody>
-      </p:sp>
-      <p:sp>
-        <p:nvSpPr>
-          <p:cNvPr id="26" name="">
-            <a:extLst xmlns:a="http://schemas.openxmlformats.org/drawingml/2006/main">
-              <a:ext uri="{FF2B5EF4-FFF2-40B4-BE49-F238E27FC236}">
-                <a16:creationId xmlns:a16="http://schemas.microsoft.com/office/drawing/2014/main" id="{B7A10C7D-29C4-4566-8A81-343126E16C38}"/>
-              </a:ext>
-            </a:extLst>
-          </p:cNvPr>
-          <p:cNvSpPr>
-            <a:spLocks xmlns:a="http://schemas.openxmlformats.org/drawingml/2006/main" noGrp="1"/>
-          </p:cNvSpPr>
-          <p:nvPr/>
-        </p:nvSpPr>
-        <p:spPr>
-          <a:xfrm xmlns:a="http://schemas.openxmlformats.org/drawingml/2006/main">
-            <a:off x="8382000" y="3390900"/>
-            <a:ext cx="2343150" cy="895350"/>
-          </a:xfrm>
-          <a:prstGeom xmlns:a="http://schemas.openxmlformats.org/drawingml/2006/main" prst="roundRect">
-            <a:avLst>
-              <a:gd name="adj" fmla="val 6383"/>
-            </a:avLst>
-          </a:prstGeom>
-          <a:solidFill xmlns:a="http://schemas.openxmlformats.org/drawingml/2006/main">
-            <a:srgbClr val="F8FAFC"/>
-          </a:solidFill>
-          <a:ln xmlns:a="http://schemas.openxmlformats.org/drawingml/2006/main" w="9525">
-            <a:solidFill>
-              <a:srgbClr val="CBD5E1"/>
-            </a:solidFill>
-            <a:prstDash val="solid"/>
-          </a:ln>
-        </p:spPr>
-      </p:sp>
-      <p:sp>
-        <p:nvSpPr>
-          <p:cNvPr id="27" name="">
-            <a:extLst xmlns:a="http://schemas.openxmlformats.org/drawingml/2006/main">
-              <a:ext uri="{FF2B5EF4-FFF2-40B4-BE49-F238E27FC236}">
-                <a16:creationId xmlns:a16="http://schemas.microsoft.com/office/drawing/2014/main" id="{4A0E9200-E724-4A40-8E19-8DCD591F8BAE}"/>
-              </a:ext>
-            </a:extLst>
-          </p:cNvPr>
-          <p:cNvSpPr>
-            <a:spLocks xmlns:a="http://schemas.openxmlformats.org/drawingml/2006/main" noGrp="1"/>
-          </p:cNvSpPr>
-          <p:nvPr/>
-        </p:nvSpPr>
-        <p:spPr>
-          <a:xfrm xmlns:a="http://schemas.openxmlformats.org/drawingml/2006/main">
-            <a:off x="8534400" y="3524250"/>
-            <a:ext cx="2038350" cy="209550"/>
-          </a:xfrm>
-          <a:prstGeom xmlns:a="http://schemas.openxmlformats.org/drawingml/2006/main" prst="rect">
-            <a:avLst/>
-          </a:prstGeom>
-          <a:noFill xmlns:a="http://schemas.openxmlformats.org/drawingml/2006/main"/>
-          <a:ln xmlns:a="http://schemas.openxmlformats.org/drawingml/2006/main" w="0">
-            <a:noFill/>
-            <a:prstDash val="solid"/>
-          </a:ln>
-        </p:spPr>
-        <p:txBody>
-          <a:bodyPr xmlns:a="http://schemas.openxmlformats.org/drawingml/2006/main" anchor="t"/>
-          <a:lstStyle xmlns:a="http://schemas.openxmlformats.org/drawingml/2006/main"/>
-          <a:p xmlns:a="http://schemas.openxmlformats.org/drawingml/2006/main">
-            <a:pPr algn="l">
-              <a:defRPr sz="1125" b="1">
-                <a:solidFill>
-                  <a:srgbClr val="64748B"/>
-                </a:solidFill>
-              </a:defRPr>
-            </a:pPr>
-            <a:r>
-              <a:rPr sz="1125" b="1">
-                <a:solidFill>
-                  <a:srgbClr val="64748B"/>
-                </a:solidFill>
-              </a:rPr>
-              <a:t>Context length</a:t>
-            </a:r>
-          </a:p>
-        </p:txBody>
-      </p:sp>
-      <p:sp>
-        <p:nvSpPr>
-          <p:cNvPr id="28" name="">
-            <a:extLst xmlns:a="http://schemas.openxmlformats.org/drawingml/2006/main">
-              <a:ext uri="{FF2B5EF4-FFF2-40B4-BE49-F238E27FC236}">
-                <a16:creationId xmlns:a16="http://schemas.microsoft.com/office/drawing/2014/main" id="{BBCE0D59-36C7-4F7B-8D96-512502F33AAD}"/>
-              </a:ext>
-            </a:extLst>
-          </p:cNvPr>
-          <p:cNvSpPr>
-            <a:spLocks xmlns:a="http://schemas.openxmlformats.org/drawingml/2006/main" noGrp="1"/>
-          </p:cNvSpPr>
-          <p:nvPr/>
-        </p:nvSpPr>
-        <p:spPr>
-          <a:xfrm xmlns:a="http://schemas.openxmlformats.org/drawingml/2006/main">
-            <a:off x="8534400" y="3790950"/>
-            <a:ext cx="2038350" cy="400050"/>
-          </a:xfrm>
-          <a:prstGeom xmlns:a="http://schemas.openxmlformats.org/drawingml/2006/main" prst="rect">
-            <a:avLst/>
-          </a:prstGeom>
-          <a:noFill xmlns:a="http://schemas.openxmlformats.org/drawingml/2006/main"/>
-          <a:ln xmlns:a="http://schemas.openxmlformats.org/drawingml/2006/main" w="0">
-            <a:noFill/>
-            <a:prstDash val="solid"/>
-          </a:ln>
-        </p:spPr>
-        <p:txBody>
-          <a:bodyPr xmlns:a="http://schemas.openxmlformats.org/drawingml/2006/main" anchor="t"/>
-          <a:lstStyle xmlns:a="http://schemas.openxmlformats.org/drawingml/2006/main"/>
-          <a:p xmlns:a="http://schemas.openxmlformats.org/drawingml/2006/main">
-            <a:pPr algn="l">
-              <a:defRPr sz="1575" b="1">
-                <a:solidFill>
-                  <a:srgbClr val="0F172A"/>
-                </a:solidFill>
-              </a:defRPr>
-            </a:pPr>
-            <a:r>
-              <a:rPr sz="1575" b="1">
-                <a:solidFill>
-                  <a:srgbClr val="0F172A"/>
-                </a:solidFill>
-              </a:rPr>
-              <a:t>32,768 tokens</a:t>
-            </a:r>
-          </a:p>
-        </p:txBody>
-      </p:sp>
-      <p:sp>
-        <p:nvSpPr>
-          <p:cNvPr id="29" name="">
-            <a:extLst xmlns:a="http://schemas.openxmlformats.org/drawingml/2006/main">
-              <a:ext uri="{FF2B5EF4-FFF2-40B4-BE49-F238E27FC236}">
-                <a16:creationId xmlns:a16="http://schemas.microsoft.com/office/drawing/2014/main" id="{DD8BB145-8065-4ACB-9589-3B72194F091A}"/>
-              </a:ext>
-            </a:extLst>
-          </p:cNvPr>
-          <p:cNvSpPr>
-            <a:spLocks xmlns:a="http://schemas.openxmlformats.org/drawingml/2006/main" noGrp="1"/>
-          </p:cNvSpPr>
-          <p:nvPr/>
-        </p:nvSpPr>
-        <p:spPr>
-          <a:xfrm xmlns:a="http://schemas.openxmlformats.org/drawingml/2006/main">
-            <a:off x="666750" y="4572000"/>
-            <a:ext cx="2343150" cy="895350"/>
-          </a:xfrm>
-          <a:prstGeom xmlns:a="http://schemas.openxmlformats.org/drawingml/2006/main" prst="roundRect">
-            <a:avLst>
-              <a:gd name="adj" fmla="val 6383"/>
-            </a:avLst>
-          </a:prstGeom>
-          <a:solidFill xmlns:a="http://schemas.openxmlformats.org/drawingml/2006/main">
-            <a:srgbClr val="F8FAFC"/>
-          </a:solidFill>
-          <a:ln xmlns:a="http://schemas.openxmlformats.org/drawingml/2006/main" w="9525">
-            <a:solidFill>
-              <a:srgbClr val="CBD5E1"/>
-            </a:solidFill>
-            <a:prstDash val="solid"/>
-          </a:ln>
-        </p:spPr>
-      </p:sp>
-      <p:sp>
-        <p:nvSpPr>
-          <p:cNvPr id="30" name="">
-            <a:extLst xmlns:a="http://schemas.openxmlformats.org/drawingml/2006/main">
-              <a:ext uri="{FF2B5EF4-FFF2-40B4-BE49-F238E27FC236}">
-                <a16:creationId xmlns:a16="http://schemas.microsoft.com/office/drawing/2014/main" id="{1D5E322D-4E77-483A-9775-1058BE82596F}"/>
-              </a:ext>
-            </a:extLst>
-          </p:cNvPr>
-          <p:cNvSpPr>
-            <a:spLocks xmlns:a="http://schemas.openxmlformats.org/drawingml/2006/main" noGrp="1"/>
-          </p:cNvSpPr>
-          <p:nvPr/>
-        </p:nvSpPr>
-        <p:spPr>
-          <a:xfrm xmlns:a="http://schemas.openxmlformats.org/drawingml/2006/main">
-            <a:off x="819150" y="4705350"/>
-            <a:ext cx="2038350" cy="209550"/>
-          </a:xfrm>
-          <a:prstGeom xmlns:a="http://schemas.openxmlformats.org/drawingml/2006/main" prst="rect">
-            <a:avLst/>
-          </a:prstGeom>
-          <a:noFill xmlns:a="http://schemas.openxmlformats.org/drawingml/2006/main"/>
-          <a:ln xmlns:a="http://schemas.openxmlformats.org/drawingml/2006/main" w="0">
-            <a:noFill/>
-            <a:prstDash val="solid"/>
-          </a:ln>
-        </p:spPr>
-        <p:txBody>
-          <a:bodyPr xmlns:a="http://schemas.openxmlformats.org/drawingml/2006/main" anchor="t"/>
-          <a:lstStyle xmlns:a="http://schemas.openxmlformats.org/drawingml/2006/main"/>
-          <a:p xmlns:a="http://schemas.openxmlformats.org/drawingml/2006/main">
-            <a:pPr algn="l">
-              <a:defRPr sz="1125" b="1">
-                <a:solidFill>
-                  <a:srgbClr val="64748B"/>
-                </a:solidFill>
-              </a:defRPr>
-            </a:pPr>
-            <a:r>
-              <a:rPr sz="1125" b="1">
-                <a:solidFill>
-                  <a:srgbClr val="64748B"/>
-                </a:solidFill>
-              </a:rPr>
-              <a:t>Max total tokens</a:t>
-            </a:r>
-          </a:p>
-        </p:txBody>
-      </p:sp>
-      <p:sp>
-        <p:nvSpPr>
-          <p:cNvPr id="31" name="">
-            <a:extLst xmlns:a="http://schemas.openxmlformats.org/drawingml/2006/main">
-              <a:ext uri="{FF2B5EF4-FFF2-40B4-BE49-F238E27FC236}">
-                <a16:creationId xmlns:a16="http://schemas.microsoft.com/office/drawing/2014/main" id="{297C8B62-39BD-46FB-B2CA-5589F126F4BA}"/>
-              </a:ext>
-            </a:extLst>
-          </p:cNvPr>
-          <p:cNvSpPr>
-            <a:spLocks xmlns:a="http://schemas.openxmlformats.org/drawingml/2006/main" noGrp="1"/>
-          </p:cNvSpPr>
-          <p:nvPr/>
-        </p:nvSpPr>
-        <p:spPr>
-          <a:xfrm xmlns:a="http://schemas.openxmlformats.org/drawingml/2006/main">
-            <a:off x="819150" y="4972050"/>
-            <a:ext cx="2038350" cy="400050"/>
-          </a:xfrm>
-          <a:prstGeom xmlns:a="http://schemas.openxmlformats.org/drawingml/2006/main" prst="rect">
-            <a:avLst/>
-          </a:prstGeom>
-          <a:noFill xmlns:a="http://schemas.openxmlformats.org/drawingml/2006/main"/>
-          <a:ln xmlns:a="http://schemas.openxmlformats.org/drawingml/2006/main" w="0">
-            <a:noFill/>
-            <a:prstDash val="solid"/>
-          </a:ln>
-        </p:spPr>
-        <p:txBody>
-          <a:bodyPr xmlns:a="http://schemas.openxmlformats.org/drawingml/2006/main" anchor="t"/>
-          <a:lstStyle xmlns:a="http://schemas.openxmlformats.org/drawingml/2006/main"/>
-          <a:p xmlns:a="http://schemas.openxmlformats.org/drawingml/2006/main">
-            <a:pPr algn="l">
-              <a:defRPr sz="1575" b="1">
-                <a:solidFill>
-                  <a:srgbClr val="0F172A"/>
-                </a:solidFill>
-              </a:defRPr>
-            </a:pPr>
-            <a:r>
-              <a:rPr sz="1575" b="1">
-                <a:solidFill>
-                  <a:srgbClr val="0F172A"/>
-                </a:solidFill>
-              </a:rPr>
-              <a:t>12,288</a:t>
-            </a:r>
-          </a:p>
-        </p:txBody>
-      </p:sp>
-      <p:sp>
-        <p:nvSpPr>
-          <p:cNvPr id="32" name="">
-            <a:extLst xmlns:a="http://schemas.openxmlformats.org/drawingml/2006/main">
-              <a:ext uri="{FF2B5EF4-FFF2-40B4-BE49-F238E27FC236}">
-                <a16:creationId xmlns:a16="http://schemas.microsoft.com/office/drawing/2014/main" id="{A8B1EF20-752C-4036-8B01-9A12D5CC8F59}"/>
-              </a:ext>
-            </a:extLst>
-          </p:cNvPr>
-          <p:cNvSpPr>
-            <a:spLocks xmlns:a="http://schemas.openxmlformats.org/drawingml/2006/main" noGrp="1"/>
-          </p:cNvSpPr>
-          <p:nvPr/>
-        </p:nvSpPr>
-        <p:spPr>
-          <a:xfrm xmlns:a="http://schemas.openxmlformats.org/drawingml/2006/main">
-            <a:off x="3238500" y="4572000"/>
-            <a:ext cx="2343150" cy="895350"/>
-          </a:xfrm>
-          <a:prstGeom xmlns:a="http://schemas.openxmlformats.org/drawingml/2006/main" prst="roundRect">
-            <a:avLst>
-              <a:gd name="adj" fmla="val 6383"/>
-            </a:avLst>
-          </a:prstGeom>
-          <a:solidFill xmlns:a="http://schemas.openxmlformats.org/drawingml/2006/main">
-            <a:srgbClr val="F8FAFC"/>
-          </a:solidFill>
-          <a:ln xmlns:a="http://schemas.openxmlformats.org/drawingml/2006/main" w="9525">
-            <a:solidFill>
-              <a:srgbClr val="CBD5E1"/>
-            </a:solidFill>
-            <a:prstDash val="solid"/>
-          </a:ln>
-        </p:spPr>
-      </p:sp>
-      <p:sp>
-        <p:nvSpPr>
-          <p:cNvPr id="33" name="">
-            <a:extLst xmlns:a="http://schemas.openxmlformats.org/drawingml/2006/main">
-              <a:ext uri="{FF2B5EF4-FFF2-40B4-BE49-F238E27FC236}">
-                <a16:creationId xmlns:a16="http://schemas.microsoft.com/office/drawing/2014/main" id="{BFC22588-0C36-4B1D-BFC5-02B5D2C0F5C1}"/>
-              </a:ext>
-            </a:extLst>
-          </p:cNvPr>
-          <p:cNvSpPr>
-            <a:spLocks xmlns:a="http://schemas.openxmlformats.org/drawingml/2006/main" noGrp="1"/>
-          </p:cNvSpPr>
-          <p:nvPr/>
-        </p:nvSpPr>
-        <p:spPr>
-          <a:xfrm xmlns:a="http://schemas.openxmlformats.org/drawingml/2006/main">
-            <a:off x="3390900" y="4705350"/>
-            <a:ext cx="2038350" cy="209550"/>
-          </a:xfrm>
-          <a:prstGeom xmlns:a="http://schemas.openxmlformats.org/drawingml/2006/main" prst="rect">
-            <a:avLst/>
-          </a:prstGeom>
-          <a:noFill xmlns:a="http://schemas.openxmlformats.org/drawingml/2006/main"/>
-          <a:ln xmlns:a="http://schemas.openxmlformats.org/drawingml/2006/main" w="0">
-            <a:noFill/>
-            <a:prstDash val="solid"/>
-          </a:ln>
-        </p:spPr>
-        <p:txBody>
-          <a:bodyPr xmlns:a="http://schemas.openxmlformats.org/drawingml/2006/main" anchor="t"/>
-          <a:lstStyle xmlns:a="http://schemas.openxmlformats.org/drawingml/2006/main"/>
-          <a:p xmlns:a="http://schemas.openxmlformats.org/drawingml/2006/main">
-            <a:pPr algn="l">
-              <a:defRPr sz="1125" b="1">
-                <a:solidFill>
-                  <a:srgbClr val="64748B"/>
-                </a:solidFill>
-              </a:defRPr>
-            </a:pPr>
-            <a:r>
-              <a:rPr sz="1125" b="1">
-                <a:solidFill>
-                  <a:srgbClr val="64748B"/>
-                </a:solidFill>
-              </a:rPr>
-              <a:t>Memory fraction static</a:t>
-            </a:r>
-          </a:p>
-        </p:txBody>
-      </p:sp>
-      <p:sp>
-        <p:nvSpPr>
-          <p:cNvPr id="34" name="">
-            <a:extLst xmlns:a="http://schemas.openxmlformats.org/drawingml/2006/main">
-              <a:ext uri="{FF2B5EF4-FFF2-40B4-BE49-F238E27FC236}">
-                <a16:creationId xmlns:a16="http://schemas.microsoft.com/office/drawing/2014/main" id="{2A19B398-9432-43BF-8860-3B44EDED0559}"/>
-              </a:ext>
-            </a:extLst>
-          </p:cNvPr>
-          <p:cNvSpPr>
-            <a:spLocks xmlns:a="http://schemas.openxmlformats.org/drawingml/2006/main" noGrp="1"/>
-          </p:cNvSpPr>
-          <p:nvPr/>
-        </p:nvSpPr>
-        <p:spPr>
-          <a:xfrm xmlns:a="http://schemas.openxmlformats.org/drawingml/2006/main">
-            <a:off x="3390900" y="4972050"/>
-            <a:ext cx="2038350" cy="400050"/>
-          </a:xfrm>
-          <a:prstGeom xmlns:a="http://schemas.openxmlformats.org/drawingml/2006/main" prst="rect">
-            <a:avLst/>
-          </a:prstGeom>
-          <a:noFill xmlns:a="http://schemas.openxmlformats.org/drawingml/2006/main"/>
-          <a:ln xmlns:a="http://schemas.openxmlformats.org/drawingml/2006/main" w="0">
-            <a:noFill/>
-            <a:prstDash val="solid"/>
-          </a:ln>
-        </p:spPr>
-        <p:txBody>
-          <a:bodyPr xmlns:a="http://schemas.openxmlformats.org/drawingml/2006/main" anchor="t"/>
-          <a:lstStyle xmlns:a="http://schemas.openxmlformats.org/drawingml/2006/main"/>
-          <a:p xmlns:a="http://schemas.openxmlformats.org/drawingml/2006/main">
-            <a:pPr algn="l">
-              <a:defRPr sz="1575" b="1">
-                <a:solidFill>
-                  <a:srgbClr val="0F172A"/>
-                </a:solidFill>
-              </a:defRPr>
-            </a:pPr>
-            <a:r>
-              <a:rPr sz="1575" b="1">
-                <a:solidFill>
-                  <a:srgbClr val="0F172A"/>
-                </a:solidFill>
-              </a:rPr>
-              <a:t>0.72</a:t>
-            </a:r>
-          </a:p>
-        </p:txBody>
-      </p:sp>
-      <p:sp>
-        <p:nvSpPr>
-          <p:cNvPr id="35" name="">
-            <a:extLst xmlns:a="http://schemas.openxmlformats.org/drawingml/2006/main">
-              <a:ext uri="{FF2B5EF4-FFF2-40B4-BE49-F238E27FC236}">
-                <a16:creationId xmlns:a16="http://schemas.microsoft.com/office/drawing/2014/main" id="{09437138-7BE3-4608-97E0-4074355190C0}"/>
-              </a:ext>
-            </a:extLst>
-          </p:cNvPr>
-          <p:cNvSpPr>
-            <a:spLocks xmlns:a="http://schemas.openxmlformats.org/drawingml/2006/main" noGrp="1"/>
-          </p:cNvSpPr>
-          <p:nvPr/>
-        </p:nvSpPr>
-        <p:spPr>
-          <a:xfrm xmlns:a="http://schemas.openxmlformats.org/drawingml/2006/main">
-            <a:off x="5810250" y="4572000"/>
-            <a:ext cx="2343150" cy="895350"/>
-          </a:xfrm>
-          <a:prstGeom xmlns:a="http://schemas.openxmlformats.org/drawingml/2006/main" prst="roundRect">
-            <a:avLst>
-              <a:gd name="adj" fmla="val 6383"/>
-            </a:avLst>
-          </a:prstGeom>
-          <a:solidFill xmlns:a="http://schemas.openxmlformats.org/drawingml/2006/main">
-            <a:srgbClr val="F8FAFC"/>
-          </a:solidFill>
-          <a:ln xmlns:a="http://schemas.openxmlformats.org/drawingml/2006/main" w="9525">
-            <a:solidFill>
-              <a:srgbClr val="CBD5E1"/>
-            </a:solidFill>
-            <a:prstDash val="solid"/>
-          </a:ln>
-        </p:spPr>
-      </p:sp>
-      <p:sp>
-        <p:nvSpPr>
-          <p:cNvPr id="36" name="">
-            <a:extLst xmlns:a="http://schemas.openxmlformats.org/drawingml/2006/main">
-              <a:ext uri="{FF2B5EF4-FFF2-40B4-BE49-F238E27FC236}">
-                <a16:creationId xmlns:a16="http://schemas.microsoft.com/office/drawing/2014/main" id="{C1E6A6B1-EC17-4CCC-B944-0F10B6E57B42}"/>
-              </a:ext>
-            </a:extLst>
-          </p:cNvPr>
-          <p:cNvSpPr>
-            <a:spLocks xmlns:a="http://schemas.openxmlformats.org/drawingml/2006/main" noGrp="1"/>
-          </p:cNvSpPr>
-          <p:nvPr/>
-        </p:nvSpPr>
-        <p:spPr>
-          <a:xfrm xmlns:a="http://schemas.openxmlformats.org/drawingml/2006/main">
-            <a:off x="5962650" y="4705350"/>
-            <a:ext cx="2038350" cy="209550"/>
-          </a:xfrm>
-          <a:prstGeom xmlns:a="http://schemas.openxmlformats.org/drawingml/2006/main" prst="rect">
-            <a:avLst/>
-          </a:prstGeom>
-          <a:noFill xmlns:a="http://schemas.openxmlformats.org/drawingml/2006/main"/>
-          <a:ln xmlns:a="http://schemas.openxmlformats.org/drawingml/2006/main" w="0">
-            <a:noFill/>
-            <a:prstDash val="solid"/>
-          </a:ln>
-        </p:spPr>
-        <p:txBody>
-          <a:bodyPr xmlns:a="http://schemas.openxmlformats.org/drawingml/2006/main" anchor="t"/>
-          <a:lstStyle xmlns:a="http://schemas.openxmlformats.org/drawingml/2006/main"/>
-          <a:p xmlns:a="http://schemas.openxmlformats.org/drawingml/2006/main">
-            <a:pPr algn="l">
-              <a:defRPr sz="1125" b="1">
-                <a:solidFill>
-                  <a:srgbClr val="64748B"/>
-                </a:solidFill>
-              </a:defRPr>
-            </a:pPr>
-            <a:r>
-              <a:rPr sz="1125" b="1">
-                <a:solidFill>
-                  <a:srgbClr val="64748B"/>
-                </a:solidFill>
-              </a:rPr>
-              <a:t>Tensor parallel</a:t>
-            </a:r>
-          </a:p>
-        </p:txBody>
-      </p:sp>
-      <p:sp>
-        <p:nvSpPr>
-          <p:cNvPr id="37" name="">
-            <a:extLst xmlns:a="http://schemas.openxmlformats.org/drawingml/2006/main">
-              <a:ext uri="{FF2B5EF4-FFF2-40B4-BE49-F238E27FC236}">
-                <a16:creationId xmlns:a16="http://schemas.microsoft.com/office/drawing/2014/main" id="{9F04F906-178A-4E85-8463-A3EBAD7C29DF}"/>
-              </a:ext>
-            </a:extLst>
-          </p:cNvPr>
-          <p:cNvSpPr>
-            <a:spLocks xmlns:a="http://schemas.openxmlformats.org/drawingml/2006/main" noGrp="1"/>
-          </p:cNvSpPr>
-          <p:nvPr/>
-        </p:nvSpPr>
-        <p:spPr>
-          <a:xfrm xmlns:a="http://schemas.openxmlformats.org/drawingml/2006/main">
-            <a:off x="5962650" y="4972050"/>
-            <a:ext cx="2038350" cy="400050"/>
-          </a:xfrm>
-          <a:prstGeom xmlns:a="http://schemas.openxmlformats.org/drawingml/2006/main" prst="rect">
-            <a:avLst/>
-          </a:prstGeom>
-          <a:noFill xmlns:a="http://schemas.openxmlformats.org/drawingml/2006/main"/>
-          <a:ln xmlns:a="http://schemas.openxmlformats.org/drawingml/2006/main" w="0">
-            <a:noFill/>
-            <a:prstDash val="solid"/>
-          </a:ln>
-        </p:spPr>
-        <p:txBody>
-          <a:bodyPr xmlns:a="http://schemas.openxmlformats.org/drawingml/2006/main" anchor="t"/>
-          <a:lstStyle xmlns:a="http://schemas.openxmlformats.org/drawingml/2006/main"/>
-          <a:p xmlns:a="http://schemas.openxmlformats.org/drawingml/2006/main">
-            <a:pPr algn="l">
-              <a:defRPr sz="1575" b="1">
-                <a:solidFill>
-                  <a:srgbClr val="0F172A"/>
-                </a:solidFill>
-              </a:defRPr>
-            </a:pPr>
-            <a:r>
-              <a:rPr sz="1575" b="1">
-                <a:solidFill>
-                  <a:srgbClr val="0F172A"/>
-                </a:solidFill>
-              </a:rPr>
-              <a:t>TP = 1</a:t>
-            </a:r>
-          </a:p>
-        </p:txBody>
-      </p:sp>
-      <p:sp>
-        <p:nvSpPr>
-          <p:cNvPr id="38" name="">
-            <a:extLst xmlns:a="http://schemas.openxmlformats.org/drawingml/2006/main">
-              <a:ext uri="{FF2B5EF4-FFF2-40B4-BE49-F238E27FC236}">
-                <a16:creationId xmlns:a16="http://schemas.microsoft.com/office/drawing/2014/main" id="{8AC64079-9D19-4EFC-80E5-DE028C22C33E}"/>
-              </a:ext>
-            </a:extLst>
-          </p:cNvPr>
-          <p:cNvSpPr>
-            <a:spLocks xmlns:a="http://schemas.openxmlformats.org/drawingml/2006/main" noGrp="1"/>
-          </p:cNvSpPr>
-          <p:nvPr/>
-        </p:nvSpPr>
-        <p:spPr>
-          <a:xfrm xmlns:a="http://schemas.openxmlformats.org/drawingml/2006/main">
-            <a:off x="8382000" y="4572000"/>
-            <a:ext cx="2343150" cy="895350"/>
-          </a:xfrm>
-          <a:prstGeom xmlns:a="http://schemas.openxmlformats.org/drawingml/2006/main" prst="roundRect">
-            <a:avLst>
-              <a:gd name="adj" fmla="val 6383"/>
-            </a:avLst>
-          </a:prstGeom>
-          <a:solidFill xmlns:a="http://schemas.openxmlformats.org/drawingml/2006/main">
-            <a:srgbClr val="FFF7ED"/>
-          </a:solidFill>
-          <a:ln xmlns:a="http://schemas.openxmlformats.org/drawingml/2006/main" w="9525">
-            <a:solidFill>
-              <a:srgbClr val="FED7AA"/>
-            </a:solidFill>
-            <a:prstDash val="solid"/>
-          </a:ln>
-        </p:spPr>
-      </p:sp>
-      <p:sp>
-        <p:nvSpPr>
-          <p:cNvPr id="39" name="">
-            <a:extLst xmlns:a="http://schemas.openxmlformats.org/drawingml/2006/main">
-              <a:ext uri="{FF2B5EF4-FFF2-40B4-BE49-F238E27FC236}">
-                <a16:creationId xmlns:a16="http://schemas.microsoft.com/office/drawing/2014/main" id="{A90BCC01-5B9A-4A6D-A232-BCE1EE716BB5}"/>
-              </a:ext>
-            </a:extLst>
-          </p:cNvPr>
-          <p:cNvSpPr>
-            <a:spLocks xmlns:a="http://schemas.openxmlformats.org/drawingml/2006/main" noGrp="1"/>
-          </p:cNvSpPr>
-          <p:nvPr/>
-        </p:nvSpPr>
-        <p:spPr>
-          <a:xfrm xmlns:a="http://schemas.openxmlformats.org/drawingml/2006/main">
-            <a:off x="8534400" y="4705350"/>
-            <a:ext cx="2038350" cy="209550"/>
-          </a:xfrm>
-          <a:prstGeom xmlns:a="http://schemas.openxmlformats.org/drawingml/2006/main" prst="rect">
-            <a:avLst/>
-          </a:prstGeom>
-          <a:noFill xmlns:a="http://schemas.openxmlformats.org/drawingml/2006/main"/>
-          <a:ln xmlns:a="http://schemas.openxmlformats.org/drawingml/2006/main" w="0">
-            <a:noFill/>
-            <a:prstDash val="solid"/>
-          </a:ln>
-        </p:spPr>
-        <p:txBody>
-          <a:bodyPr xmlns:a="http://schemas.openxmlformats.org/drawingml/2006/main" anchor="t"/>
-          <a:lstStyle xmlns:a="http://schemas.openxmlformats.org/drawingml/2006/main"/>
-          <a:p xmlns:a="http://schemas.openxmlformats.org/drawingml/2006/main">
-            <a:pPr algn="l">
-              <a:defRPr sz="1125" b="1">
-                <a:solidFill>
-                  <a:srgbClr val="64748B"/>
-                </a:solidFill>
-              </a:defRPr>
-            </a:pPr>
-            <a:r>
-              <a:rPr sz="1125" b="1">
-                <a:solidFill>
-                  <a:srgbClr val="64748B"/>
-                </a:solidFill>
-              </a:rPr>
-              <a:t>HiCache policy</a:t>
-            </a:r>
-          </a:p>
-        </p:txBody>
-      </p:sp>
-      <p:sp>
-        <p:nvSpPr>
-          <p:cNvPr id="40" name="">
-            <a:extLst xmlns:a="http://schemas.openxmlformats.org/drawingml/2006/main">
-              <a:ext uri="{FF2B5EF4-FFF2-40B4-BE49-F238E27FC236}">
-                <a16:creationId xmlns:a16="http://schemas.microsoft.com/office/drawing/2014/main" id="{D70B7FB8-AB0F-4845-A1A3-5B83408D94E2}"/>
-              </a:ext>
-            </a:extLst>
-          </p:cNvPr>
-          <p:cNvSpPr>
-            <a:spLocks xmlns:a="http://schemas.openxmlformats.org/drawingml/2006/main" noGrp="1"/>
-          </p:cNvSpPr>
-          <p:nvPr/>
-        </p:nvSpPr>
-        <p:spPr>
-          <a:xfrm xmlns:a="http://schemas.openxmlformats.org/drawingml/2006/main">
-            <a:off x="8534400" y="4972050"/>
-            <a:ext cx="2038350" cy="400050"/>
-          </a:xfrm>
-          <a:prstGeom xmlns:a="http://schemas.openxmlformats.org/drawingml/2006/main" prst="rect">
-            <a:avLst/>
-          </a:prstGeom>
-          <a:noFill xmlns:a="http://schemas.openxmlformats.org/drawingml/2006/main"/>
-          <a:ln xmlns:a="http://schemas.openxmlformats.org/drawingml/2006/main" w="0">
-            <a:noFill/>
-            <a:prstDash val="solid"/>
-          </a:ln>
-        </p:spPr>
-        <p:txBody>
-          <a:bodyPr xmlns:a="http://schemas.openxmlformats.org/drawingml/2006/main" anchor="t"/>
-          <a:lstStyle xmlns:a="http://schemas.openxmlformats.org/drawingml/2006/main"/>
-          <a:p xmlns:a="http://schemas.openxmlformats.org/drawingml/2006/main">
-            <a:pPr algn="l">
-              <a:defRPr sz="1350" b="1">
-                <a:solidFill>
-                  <a:srgbClr val="0F172A"/>
-                </a:solidFill>
-              </a:defRPr>
-            </a:pPr>
-            <a:r>
-              <a:rPr sz="1350" b="1">
-                <a:solidFill>
-                  <a:srgbClr val="0F172A"/>
-                </a:solidFill>
-              </a:rPr>
-              <a:t>direct + write-through</a:t>
-            </a:r>
-          </a:p>
-        </p:txBody>
-      </p:sp>
-      <p:sp>
-        <p:nvSpPr>
-          <p:cNvPr id="41" name="">
-            <a:extLst xmlns:a="http://schemas.openxmlformats.org/drawingml/2006/main">
-              <a:ext uri="{FF2B5EF4-FFF2-40B4-BE49-F238E27FC236}">
-                <a16:creationId xmlns:a16="http://schemas.microsoft.com/office/drawing/2014/main" id="{7B1F3AC4-0F56-4A98-8C5F-B3C0C620DDE1}"/>
+              <a:t>server</a:t>
+            </a:r>
+          </a:p>
+        </p:txBody>
+      </p:sp>
+      <p:sp>
+        <p:nvSpPr>
+          <p:cNvPr id="11" name="">
+            <a:extLst xmlns:a="http://schemas.openxmlformats.org/drawingml/2006/main">
+              <a:ext uri="{FF2B5EF4-FFF2-40B4-BE49-F238E27FC236}">
+                <a16:creationId xmlns:a16="http://schemas.microsoft.com/office/drawing/2014/main" id="{0F7942B0-E335-4763-A512-E904DE04BF82}"/>
               </a:ext>
             </a:extLst>
           </p:cNvPr>
@@ -7744,17 +6343,17 @@
                   <a:srgbClr val="64748B"/>
                 </a:solidFill>
               </a:rPr>
-              <a:t>Source: latest_master_report.html setup section and run configuration</a:t>
-            </a:r>
-          </a:p>
-        </p:txBody>
-      </p:sp>
-      <p:sp>
-        <p:nvSpPr>
-          <p:cNvPr id="42" name="">
-            <a:extLst xmlns:a="http://schemas.openxmlformats.org/drawingml/2006/main">
-              <a:ext uri="{FF2B5EF4-FFF2-40B4-BE49-F238E27FC236}">
-                <a16:creationId xmlns:a16="http://schemas.microsoft.com/office/drawing/2014/main" id="{DA640CEE-D46F-4360-A0B5-4FC8FBD42A24}"/>
+              <a:t>Source: latest_master_report.html, Experiment Setup And Manager Summary</a:t>
+            </a:r>
+          </a:p>
+        </p:txBody>
+      </p:sp>
+      <p:sp>
+        <p:nvSpPr>
+          <p:cNvPr id="12" name="">
+            <a:extLst xmlns:a="http://schemas.openxmlformats.org/drawingml/2006/main">
+              <a:ext uri="{FF2B5EF4-FFF2-40B4-BE49-F238E27FC236}">
+                <a16:creationId xmlns:a16="http://schemas.microsoft.com/office/drawing/2014/main" id="{A7DBC3B8-CDD7-4667-947B-B803B8D6B65C}"/>
               </a:ext>
             </a:extLst>
           </p:cNvPr>
@@ -7801,10 +6400,10 @@
       </p:sp>
       <p:sp>
         <p:nvSpPr>
-          <p:cNvPr id="43" name="">
-            <a:extLst xmlns:a="http://schemas.openxmlformats.org/drawingml/2006/main">
-              <a:ext uri="{FF2B5EF4-FFF2-40B4-BE49-F238E27FC236}">
-                <a16:creationId xmlns:a16="http://schemas.microsoft.com/office/drawing/2014/main" id="{FDA669F1-FFD5-4FC6-ABB8-6D3AF770FCE5}"/>
+          <p:cNvPr id="13" name="">
+            <a:extLst xmlns:a="http://schemas.openxmlformats.org/drawingml/2006/main">
+              <a:ext uri="{FF2B5EF4-FFF2-40B4-BE49-F238E27FC236}">
+                <a16:creationId xmlns:a16="http://schemas.microsoft.com/office/drawing/2014/main" id="{86FD3DE0-660A-4AC3-B2D8-3414F3D00F49}"/>
               </a:ext>
             </a:extLst>
           </p:cNvPr>
@@ -7852,7 +6451,7 @@
     </p:spTree>
     <p:extLst>
       <p:ext uri="{BB962C8B-B14F-4D97-AF65-F5344CB8AC3E}">
-        <p14:creationId xmlns:p14="http://schemas.microsoft.com/office/powerpoint/2010/main" val="607571319"/>
+        <p14:creationId xmlns:p14="http://schemas.microsoft.com/office/powerpoint/2010/main" val="520072162"/>
       </p:ext>
     </p:extLst>
   </p:cSld>
@@ -7883,7 +6482,7 @@
           <p:cNvPr id="26" name="">
             <a:extLst xmlns:a="http://schemas.openxmlformats.org/drawingml/2006/main">
               <a:ext uri="{FF2B5EF4-FFF2-40B4-BE49-F238E27FC236}">
-                <a16:creationId xmlns:a16="http://schemas.microsoft.com/office/drawing/2014/main" id="{43B133D8-36FC-41E2-9A95-30B9F70BBDEF}"/>
+                <a16:creationId xmlns:a16="http://schemas.microsoft.com/office/drawing/2014/main" id="{FF944E50-CB2B-4C24-B56B-F6E8CFAE32F0}"/>
               </a:ext>
             </a:extLst>
           </p:cNvPr>
@@ -7933,7 +6532,7 @@
           <p:cNvPr id="2" name="">
             <a:extLst xmlns:a="http://schemas.openxmlformats.org/drawingml/2006/main">
               <a:ext uri="{FF2B5EF4-FFF2-40B4-BE49-F238E27FC236}">
-                <a16:creationId xmlns:a16="http://schemas.microsoft.com/office/drawing/2014/main" id="{56C7D7D2-EB65-4398-B221-613AB92EB068}"/>
+                <a16:creationId xmlns:a16="http://schemas.microsoft.com/office/drawing/2014/main" id="{EAF90778-4130-4522-8E99-72BFD4B0ACAB}"/>
               </a:ext>
             </a:extLst>
           </p:cNvPr>
@@ -7983,7 +6582,7 @@
           <p:cNvPr id="3" name="">
             <a:extLst xmlns:a="http://schemas.openxmlformats.org/drawingml/2006/main">
               <a:ext uri="{FF2B5EF4-FFF2-40B4-BE49-F238E27FC236}">
-                <a16:creationId xmlns:a16="http://schemas.microsoft.com/office/drawing/2014/main" id="{FF4FAD7E-08BC-4BCF-BAE1-8F2D3806C409}"/>
+                <a16:creationId xmlns:a16="http://schemas.microsoft.com/office/drawing/2014/main" id="{AC9F4BCA-F928-4220-BEDC-D5CBA1CF50C6}"/>
               </a:ext>
             </a:extLst>
           </p:cNvPr>
@@ -8018,7 +6617,7 @@
           <p:cNvPr id="4" name="">
             <a:extLst xmlns:a="http://schemas.openxmlformats.org/drawingml/2006/main">
               <a:ext uri="{FF2B5EF4-FFF2-40B4-BE49-F238E27FC236}">
-                <a16:creationId xmlns:a16="http://schemas.microsoft.com/office/drawing/2014/main" id="{6284BA9F-915A-49BF-93D1-CEAC0692ED66}"/>
+                <a16:creationId xmlns:a16="http://schemas.microsoft.com/office/drawing/2014/main" id="{0419A695-4F67-4F86-9F67-52A3904C4BEF}"/>
               </a:ext>
             </a:extLst>
           </p:cNvPr>
@@ -8068,7 +6667,7 @@
           <p:cNvPr id="5" name="">
             <a:extLst xmlns:a="http://schemas.openxmlformats.org/drawingml/2006/main">
               <a:ext uri="{FF2B5EF4-FFF2-40B4-BE49-F238E27FC236}">
-                <a16:creationId xmlns:a16="http://schemas.microsoft.com/office/drawing/2014/main" id="{7BA0716D-08AD-4DAF-A736-66D45C018D47}"/>
+                <a16:creationId xmlns:a16="http://schemas.microsoft.com/office/drawing/2014/main" id="{90002F90-8781-432D-B568-70D637BF48D2}"/>
               </a:ext>
             </a:extLst>
           </p:cNvPr>
@@ -8099,7 +6698,7 @@
           <p:cNvPr id="6" name="">
             <a:extLst xmlns:a="http://schemas.openxmlformats.org/drawingml/2006/main">
               <a:ext uri="{FF2B5EF4-FFF2-40B4-BE49-F238E27FC236}">
-                <a16:creationId xmlns:a16="http://schemas.microsoft.com/office/drawing/2014/main" id="{DFE81315-318D-43AC-A6DA-769523898FEB}"/>
+                <a16:creationId xmlns:a16="http://schemas.microsoft.com/office/drawing/2014/main" id="{9BD870E9-0EE6-433F-BE42-CE43072233F9}"/>
               </a:ext>
             </a:extLst>
           </p:cNvPr>
@@ -8149,7 +6748,7 @@
           <p:cNvPr id="7" name="">
             <a:extLst xmlns:a="http://schemas.openxmlformats.org/drawingml/2006/main">
               <a:ext uri="{FF2B5EF4-FFF2-40B4-BE49-F238E27FC236}">
-                <a16:creationId xmlns:a16="http://schemas.microsoft.com/office/drawing/2014/main" id="{2CB513AF-5075-4586-8CEE-68D185DF134A}"/>
+                <a16:creationId xmlns:a16="http://schemas.microsoft.com/office/drawing/2014/main" id="{DA43180D-0EE3-41B0-BEBB-1D2378D11562}"/>
               </a:ext>
             </a:extLst>
           </p:cNvPr>
@@ -8180,7 +6779,7 @@
           <p:cNvPr id="8" name="">
             <a:extLst xmlns:a="http://schemas.openxmlformats.org/drawingml/2006/main">
               <a:ext uri="{FF2B5EF4-FFF2-40B4-BE49-F238E27FC236}">
-                <a16:creationId xmlns:a16="http://schemas.microsoft.com/office/drawing/2014/main" id="{7DC3254C-767F-4361-BD88-5C472F8BE027}"/>
+                <a16:creationId xmlns:a16="http://schemas.microsoft.com/office/drawing/2014/main" id="{99A651CD-2377-4FD7-A938-CD2FC1C1F66F}"/>
               </a:ext>
             </a:extLst>
           </p:cNvPr>
@@ -8230,7 +6829,7 @@
           <p:cNvPr id="9" name="">
             <a:extLst xmlns:a="http://schemas.openxmlformats.org/drawingml/2006/main">
               <a:ext uri="{FF2B5EF4-FFF2-40B4-BE49-F238E27FC236}">
-                <a16:creationId xmlns:a16="http://schemas.microsoft.com/office/drawing/2014/main" id="{D0AE9A68-C86E-4A42-8EA8-4158FB3606FC}"/>
+                <a16:creationId xmlns:a16="http://schemas.microsoft.com/office/drawing/2014/main" id="{A5699B7D-4895-4324-839E-B157B26596A0}"/>
               </a:ext>
             </a:extLst>
           </p:cNvPr>
@@ -8261,7 +6860,7 @@
           <p:cNvPr id="10" name="">
             <a:extLst xmlns:a="http://schemas.openxmlformats.org/drawingml/2006/main">
               <a:ext uri="{FF2B5EF4-FFF2-40B4-BE49-F238E27FC236}">
-                <a16:creationId xmlns:a16="http://schemas.microsoft.com/office/drawing/2014/main" id="{B8FA3165-95C7-452F-AF68-B071B8B345A8}"/>
+                <a16:creationId xmlns:a16="http://schemas.microsoft.com/office/drawing/2014/main" id="{9201B88B-7283-46B5-9A41-8D863AC0B3AB}"/>
               </a:ext>
             </a:extLst>
           </p:cNvPr>
@@ -8311,7 +6910,7 @@
           <p:cNvPr id="11" name="">
             <a:extLst xmlns:a="http://schemas.openxmlformats.org/drawingml/2006/main">
               <a:ext uri="{FF2B5EF4-FFF2-40B4-BE49-F238E27FC236}">
-                <a16:creationId xmlns:a16="http://schemas.microsoft.com/office/drawing/2014/main" id="{8F1B2C55-920F-4198-BDBF-7A434E5A6478}"/>
+                <a16:creationId xmlns:a16="http://schemas.microsoft.com/office/drawing/2014/main" id="{EF7E450D-259A-4D0E-A5FF-5A16A20E30BA}"/>
               </a:ext>
             </a:extLst>
           </p:cNvPr>
@@ -8342,7 +6941,7 @@
           <p:cNvPr id="12" name="">
             <a:extLst xmlns:a="http://schemas.openxmlformats.org/drawingml/2006/main">
               <a:ext uri="{FF2B5EF4-FFF2-40B4-BE49-F238E27FC236}">
-                <a16:creationId xmlns:a16="http://schemas.microsoft.com/office/drawing/2014/main" id="{303B1280-49D0-4236-847F-65F97891353E}"/>
+                <a16:creationId xmlns:a16="http://schemas.microsoft.com/office/drawing/2014/main" id="{354E9B81-A648-4F16-87FC-4E06FE2939EB}"/>
               </a:ext>
             </a:extLst>
           </p:cNvPr>
@@ -8392,7 +6991,7 @@
           <p:cNvPr id="13" name="">
             <a:extLst xmlns:a="http://schemas.openxmlformats.org/drawingml/2006/main">
               <a:ext uri="{FF2B5EF4-FFF2-40B4-BE49-F238E27FC236}">
-                <a16:creationId xmlns:a16="http://schemas.microsoft.com/office/drawing/2014/main" id="{F862CA72-161E-4011-92CE-86C96CDBA670}"/>
+                <a16:creationId xmlns:a16="http://schemas.microsoft.com/office/drawing/2014/main" id="{7F81AD45-9020-472A-8718-FFC8735A78E3}"/>
               </a:ext>
             </a:extLst>
           </p:cNvPr>
@@ -8442,7 +7041,7 @@
           <p:cNvPr id="14" name="">
             <a:extLst xmlns:a="http://schemas.openxmlformats.org/drawingml/2006/main">
               <a:ext uri="{FF2B5EF4-FFF2-40B4-BE49-F238E27FC236}">
-                <a16:creationId xmlns:a16="http://schemas.microsoft.com/office/drawing/2014/main" id="{97CC03F3-C3C2-43F1-BBE1-48046526646B}"/>
+                <a16:creationId xmlns:a16="http://schemas.microsoft.com/office/drawing/2014/main" id="{0BCDB1AD-53A4-47A2-B0D3-ED862C010D95}"/>
               </a:ext>
             </a:extLst>
           </p:cNvPr>
@@ -8477,7 +7076,7 @@
           <p:cNvPr id="15" name="">
             <a:extLst xmlns:a="http://schemas.openxmlformats.org/drawingml/2006/main">
               <a:ext uri="{FF2B5EF4-FFF2-40B4-BE49-F238E27FC236}">
-                <a16:creationId xmlns:a16="http://schemas.microsoft.com/office/drawing/2014/main" id="{5A3875DD-33B5-4BDE-B1DC-631ECB12E139}"/>
+                <a16:creationId xmlns:a16="http://schemas.microsoft.com/office/drawing/2014/main" id="{8FEB0E11-A01C-4401-9C3D-1D80D105F03D}"/>
               </a:ext>
             </a:extLst>
           </p:cNvPr>
@@ -8527,7 +7126,7 @@
           <p:cNvPr id="16" name="">
             <a:extLst xmlns:a="http://schemas.openxmlformats.org/drawingml/2006/main">
               <a:ext uri="{FF2B5EF4-FFF2-40B4-BE49-F238E27FC236}">
-                <a16:creationId xmlns:a16="http://schemas.microsoft.com/office/drawing/2014/main" id="{78F08C0D-B270-40FF-9360-8E8A5F9C568A}"/>
+                <a16:creationId xmlns:a16="http://schemas.microsoft.com/office/drawing/2014/main" id="{4F6C9403-4839-42D2-A1B9-92AA08C825B7}"/>
               </a:ext>
             </a:extLst>
           </p:cNvPr>
@@ -8558,7 +7157,7 @@
           <p:cNvPr id="17" name="">
             <a:extLst xmlns:a="http://schemas.openxmlformats.org/drawingml/2006/main">
               <a:ext uri="{FF2B5EF4-FFF2-40B4-BE49-F238E27FC236}">
-                <a16:creationId xmlns:a16="http://schemas.microsoft.com/office/drawing/2014/main" id="{58BB8879-846C-4096-9BB5-417CE7F66B24}"/>
+                <a16:creationId xmlns:a16="http://schemas.microsoft.com/office/drawing/2014/main" id="{B2183E7D-BAF5-464C-B628-73503964ED1C}"/>
               </a:ext>
             </a:extLst>
           </p:cNvPr>
@@ -8608,7 +7207,7 @@
           <p:cNvPr id="18" name="">
             <a:extLst xmlns:a="http://schemas.openxmlformats.org/drawingml/2006/main">
               <a:ext uri="{FF2B5EF4-FFF2-40B4-BE49-F238E27FC236}">
-                <a16:creationId xmlns:a16="http://schemas.microsoft.com/office/drawing/2014/main" id="{55FF0281-08A3-4CCE-9676-9056E55837CA}"/>
+                <a16:creationId xmlns:a16="http://schemas.microsoft.com/office/drawing/2014/main" id="{99B1C59B-1E4E-4CD2-B9E3-4C1339D01E31}"/>
               </a:ext>
             </a:extLst>
           </p:cNvPr>
@@ -8639,7 +7238,7 @@
           <p:cNvPr id="19" name="">
             <a:extLst xmlns:a="http://schemas.openxmlformats.org/drawingml/2006/main">
               <a:ext uri="{FF2B5EF4-FFF2-40B4-BE49-F238E27FC236}">
-                <a16:creationId xmlns:a16="http://schemas.microsoft.com/office/drawing/2014/main" id="{5A69BB1B-67C0-407C-8CC8-FA418D0B5F49}"/>
+                <a16:creationId xmlns:a16="http://schemas.microsoft.com/office/drawing/2014/main" id="{F6A2BAA8-DA29-471A-AF3E-3FCE3903EEF9}"/>
               </a:ext>
             </a:extLst>
           </p:cNvPr>
@@ -8689,7 +7288,7 @@
           <p:cNvPr id="20" name="">
             <a:extLst xmlns:a="http://schemas.openxmlformats.org/drawingml/2006/main">
               <a:ext uri="{FF2B5EF4-FFF2-40B4-BE49-F238E27FC236}">
-                <a16:creationId xmlns:a16="http://schemas.microsoft.com/office/drawing/2014/main" id="{F49B8BE5-08C5-483E-AD85-1EF8671BBA39}"/>
+                <a16:creationId xmlns:a16="http://schemas.microsoft.com/office/drawing/2014/main" id="{496BCE7D-9406-46F9-9AFA-DD765737D5B4}"/>
               </a:ext>
             </a:extLst>
           </p:cNvPr>
@@ -8720,7 +7319,7 @@
           <p:cNvPr id="21" name="">
             <a:extLst xmlns:a="http://schemas.openxmlformats.org/drawingml/2006/main">
               <a:ext uri="{FF2B5EF4-FFF2-40B4-BE49-F238E27FC236}">
-                <a16:creationId xmlns:a16="http://schemas.microsoft.com/office/drawing/2014/main" id="{58AD7F28-6970-45A6-A405-ADF5E0AA3C7D}"/>
+                <a16:creationId xmlns:a16="http://schemas.microsoft.com/office/drawing/2014/main" id="{9F3D2E4E-8589-4EDC-A51C-5B4F59DB88CF}"/>
               </a:ext>
             </a:extLst>
           </p:cNvPr>
@@ -8770,7 +7369,7 @@
           <p:cNvPr id="22" name="">
             <a:extLst xmlns:a="http://schemas.openxmlformats.org/drawingml/2006/main">
               <a:ext uri="{FF2B5EF4-FFF2-40B4-BE49-F238E27FC236}">
-                <a16:creationId xmlns:a16="http://schemas.microsoft.com/office/drawing/2014/main" id="{11484F66-F65E-4EF9-90B6-9F0F4E22E35F}"/>
+                <a16:creationId xmlns:a16="http://schemas.microsoft.com/office/drawing/2014/main" id="{22CB5DCE-86F0-4C24-8412-BD1BE9ECFA61}"/>
               </a:ext>
             </a:extLst>
           </p:cNvPr>
@@ -8801,7 +7400,7 @@
           <p:cNvPr id="23" name="">
             <a:extLst xmlns:a="http://schemas.openxmlformats.org/drawingml/2006/main">
               <a:ext uri="{FF2B5EF4-FFF2-40B4-BE49-F238E27FC236}">
-                <a16:creationId xmlns:a16="http://schemas.microsoft.com/office/drawing/2014/main" id="{4675F407-ACED-4F53-88DC-C0E8AF21D0B7}"/>
+                <a16:creationId xmlns:a16="http://schemas.microsoft.com/office/drawing/2014/main" id="{6F69B058-D91C-4637-9436-F1FF3F0D3810}"/>
               </a:ext>
             </a:extLst>
           </p:cNvPr>
@@ -8851,7 +7450,7 @@
           <p:cNvPr id="24" name="">
             <a:extLst xmlns:a="http://schemas.openxmlformats.org/drawingml/2006/main">
               <a:ext uri="{FF2B5EF4-FFF2-40B4-BE49-F238E27FC236}">
-                <a16:creationId xmlns:a16="http://schemas.microsoft.com/office/drawing/2014/main" id="{88B70E44-9E47-4FFA-92A4-970EE5B5261B}"/>
+                <a16:creationId xmlns:a16="http://schemas.microsoft.com/office/drawing/2014/main" id="{1D1646C6-935D-4114-928E-9731AC769993}"/>
               </a:ext>
             </a:extLst>
           </p:cNvPr>
@@ -8901,7 +7500,7 @@
           <p:cNvPr id="25" name="">
             <a:extLst xmlns:a="http://schemas.openxmlformats.org/drawingml/2006/main">
               <a:ext uri="{FF2B5EF4-FFF2-40B4-BE49-F238E27FC236}">
-                <a16:creationId xmlns:a16="http://schemas.microsoft.com/office/drawing/2014/main" id="{D92D41CC-74EC-4F4D-987B-E0EDB6515A5E}"/>
+                <a16:creationId xmlns:a16="http://schemas.microsoft.com/office/drawing/2014/main" id="{6A0FBB1D-0755-438D-90E5-5ACCDD9FDA18}"/>
               </a:ext>
             </a:extLst>
           </p:cNvPr>
@@ -8949,7 +7548,7 @@
     </p:spTree>
     <p:extLst>
       <p:ext uri="{BB962C8B-B14F-4D97-AF65-F5344CB8AC3E}">
-        <p14:creationId xmlns:p14="http://schemas.microsoft.com/office/powerpoint/2010/main" val="1921973542"/>
+        <p14:creationId xmlns:p14="http://schemas.microsoft.com/office/powerpoint/2010/main" val="652562334"/>
       </p:ext>
     </p:extLst>
   </p:cSld>
@@ -8980,7 +7579,7 @@
           <p:cNvPr id="8" name="">
             <a:extLst xmlns:a="http://schemas.openxmlformats.org/drawingml/2006/main">
               <a:ext uri="{FF2B5EF4-FFF2-40B4-BE49-F238E27FC236}">
-                <a16:creationId xmlns:a16="http://schemas.microsoft.com/office/drawing/2014/main" id="{15C032E1-64FF-4FF7-A2EC-5631FAEDE309}"/>
+                <a16:creationId xmlns:a16="http://schemas.microsoft.com/office/drawing/2014/main" id="{198D01FD-846A-43BF-AE81-696FB16EE130}"/>
               </a:ext>
             </a:extLst>
           </p:cNvPr>
@@ -9030,7 +7629,7 @@
           <p:cNvPr id="2" name="">
             <a:extLst xmlns:a="http://schemas.openxmlformats.org/drawingml/2006/main">
               <a:ext uri="{FF2B5EF4-FFF2-40B4-BE49-F238E27FC236}">
-                <a16:creationId xmlns:a16="http://schemas.microsoft.com/office/drawing/2014/main" id="{AD2BE603-D614-44B4-8068-05D4C85CEA53}"/>
+                <a16:creationId xmlns:a16="http://schemas.microsoft.com/office/drawing/2014/main" id="{E55D17CE-A4E4-462B-8868-FF0690AA75A4}"/>
               </a:ext>
             </a:extLst>
           </p:cNvPr>
@@ -9080,7 +7679,7 @@
           <p:cNvPr id="3" name="">
             <a:extLst xmlns:a="http://schemas.openxmlformats.org/drawingml/2006/main">
               <a:ext uri="{FF2B5EF4-FFF2-40B4-BE49-F238E27FC236}">
-                <a16:creationId xmlns:a16="http://schemas.microsoft.com/office/drawing/2014/main" id="{A0B23157-8A3E-40C0-9CF9-0321EE5C4B5E}"/>
+                <a16:creationId xmlns:a16="http://schemas.microsoft.com/office/drawing/2014/main" id="{9594D784-E9A8-4D23-B8C7-8712094BD5A1}"/>
               </a:ext>
             </a:extLst>
           </p:cNvPr>
@@ -9119,7 +7718,7 @@
           <p:nvPr/>
         </p:nvPicPr>
         <p:blipFill>
-          <a:blip xmlns:r="http://schemas.openxmlformats.org/officeDocument/2006/relationships" xmlns:a="http://schemas.openxmlformats.org/drawingml/2006/main" r:embed="Rf6f1a72317b649e8"/>
+          <a:blip xmlns:r="http://schemas.openxmlformats.org/officeDocument/2006/relationships" xmlns:a="http://schemas.openxmlformats.org/drawingml/2006/main" r:embed="R5d31d76e677f42a1"/>
           <a:stretch xmlns:a="http://schemas.openxmlformats.org/drawingml/2006/main"/>
         </p:blipFill>
         <p:spPr>
@@ -9137,7 +7736,7 @@
           <p:cNvPr id="5" name="">
             <a:extLst xmlns:a="http://schemas.openxmlformats.org/drawingml/2006/main">
               <a:ext uri="{FF2B5EF4-FFF2-40B4-BE49-F238E27FC236}">
-                <a16:creationId xmlns:a16="http://schemas.microsoft.com/office/drawing/2014/main" id="{0C95FAF7-1A8F-4AED-B42E-99A8D1FC08CF}"/>
+                <a16:creationId xmlns:a16="http://schemas.microsoft.com/office/drawing/2014/main" id="{94F4B900-1A43-4D7D-B9A1-ECD1F46E7815}"/>
               </a:ext>
             </a:extLst>
           </p:cNvPr>
@@ -9187,7 +7786,7 @@
           <p:cNvPr id="6" name="">
             <a:extLst xmlns:a="http://schemas.openxmlformats.org/drawingml/2006/main">
               <a:ext uri="{FF2B5EF4-FFF2-40B4-BE49-F238E27FC236}">
-                <a16:creationId xmlns:a16="http://schemas.microsoft.com/office/drawing/2014/main" id="{C9EA2A8B-F625-4231-9A31-A90C894FCD1D}"/>
+                <a16:creationId xmlns:a16="http://schemas.microsoft.com/office/drawing/2014/main" id="{0FB17993-EF78-45E3-9B75-3AE0619856FC}"/>
               </a:ext>
             </a:extLst>
           </p:cNvPr>
@@ -9237,7 +7836,7 @@
           <p:cNvPr id="7" name="">
             <a:extLst xmlns:a="http://schemas.openxmlformats.org/drawingml/2006/main">
               <a:ext uri="{FF2B5EF4-FFF2-40B4-BE49-F238E27FC236}">
-                <a16:creationId xmlns:a16="http://schemas.microsoft.com/office/drawing/2014/main" id="{49CB5D53-F1CF-48C5-B053-9170DBE60679}"/>
+                <a16:creationId xmlns:a16="http://schemas.microsoft.com/office/drawing/2014/main" id="{10AFF26E-49FC-4389-8CC6-2A34EA2FBCF4}"/>
               </a:ext>
             </a:extLst>
           </p:cNvPr>
@@ -9285,7 +7884,7 @@
     </p:spTree>
     <p:extLst>
       <p:ext uri="{BB962C8B-B14F-4D97-AF65-F5344CB8AC3E}">
-        <p14:creationId xmlns:p14="http://schemas.microsoft.com/office/powerpoint/2010/main" val="1089820716"/>
+        <p14:creationId xmlns:p14="http://schemas.microsoft.com/office/powerpoint/2010/main" val="2137336462"/>
       </p:ext>
     </p:extLst>
   </p:cSld>
@@ -9316,7 +7915,7 @@
           <p:cNvPr id="16" name="">
             <a:extLst xmlns:a="http://schemas.openxmlformats.org/drawingml/2006/main">
               <a:ext uri="{FF2B5EF4-FFF2-40B4-BE49-F238E27FC236}">
-                <a16:creationId xmlns:a16="http://schemas.microsoft.com/office/drawing/2014/main" id="{18C9C0CB-F7A7-4BE9-ACB0-1C702AA840AC}"/>
+                <a16:creationId xmlns:a16="http://schemas.microsoft.com/office/drawing/2014/main" id="{F7D4C8B6-67C2-4AD1-911A-4B1085B2CE86}"/>
               </a:ext>
             </a:extLst>
           </p:cNvPr>
@@ -9366,7 +7965,7 @@
           <p:cNvPr id="2" name="">
             <a:extLst xmlns:a="http://schemas.openxmlformats.org/drawingml/2006/main">
               <a:ext uri="{FF2B5EF4-FFF2-40B4-BE49-F238E27FC236}">
-                <a16:creationId xmlns:a16="http://schemas.microsoft.com/office/drawing/2014/main" id="{CD065499-DFED-430E-9547-474C4B961A42}"/>
+                <a16:creationId xmlns:a16="http://schemas.microsoft.com/office/drawing/2014/main" id="{9BE30A09-D3BB-4AC5-A0C5-8B312A441218}"/>
               </a:ext>
             </a:extLst>
           </p:cNvPr>
@@ -9416,7 +8015,7 @@
           <p:cNvPr id="3" name="">
             <a:extLst xmlns:a="http://schemas.openxmlformats.org/drawingml/2006/main">
               <a:ext uri="{FF2B5EF4-FFF2-40B4-BE49-F238E27FC236}">
-                <a16:creationId xmlns:a16="http://schemas.microsoft.com/office/drawing/2014/main" id="{DA7CE27A-A994-41E8-A353-ADAC8AE6EA19}"/>
+                <a16:creationId xmlns:a16="http://schemas.microsoft.com/office/drawing/2014/main" id="{970D3739-3191-4C0C-8211-7BA90F546505}"/>
               </a:ext>
             </a:extLst>
           </p:cNvPr>
@@ -9455,7 +8054,7 @@
           <p:nvPr/>
         </p:nvPicPr>
         <p:blipFill>
-          <a:blip xmlns:r="http://schemas.openxmlformats.org/officeDocument/2006/relationships" xmlns:a="http://schemas.openxmlformats.org/drawingml/2006/main" r:embed="Rd2befd4d13e64aa4"/>
+          <a:blip xmlns:r="http://schemas.openxmlformats.org/officeDocument/2006/relationships" xmlns:a="http://schemas.openxmlformats.org/drawingml/2006/main" r:embed="Re452a7c0f9424912"/>
           <a:stretch xmlns:a="http://schemas.openxmlformats.org/drawingml/2006/main"/>
         </p:blipFill>
         <p:spPr>
@@ -9473,7 +8072,7 @@
           <p:cNvPr id="5" name="">
             <a:extLst xmlns:a="http://schemas.openxmlformats.org/drawingml/2006/main">
               <a:ext uri="{FF2B5EF4-FFF2-40B4-BE49-F238E27FC236}">
-                <a16:creationId xmlns:a16="http://schemas.microsoft.com/office/drawing/2014/main" id="{318EB209-A8D6-49A4-ABF0-9D0681C257FB}"/>
+                <a16:creationId xmlns:a16="http://schemas.microsoft.com/office/drawing/2014/main" id="{014F19D1-433B-4864-9E52-C998E9F04E1E}"/>
               </a:ext>
             </a:extLst>
           </p:cNvPr>
@@ -9508,7 +8107,7 @@
           <p:cNvPr id="6" name="">
             <a:extLst xmlns:a="http://schemas.openxmlformats.org/drawingml/2006/main">
               <a:ext uri="{FF2B5EF4-FFF2-40B4-BE49-F238E27FC236}">
-                <a16:creationId xmlns:a16="http://schemas.microsoft.com/office/drawing/2014/main" id="{9D3C770C-A96A-474E-B2A6-0BC1708AC562}"/>
+                <a16:creationId xmlns:a16="http://schemas.microsoft.com/office/drawing/2014/main" id="{ADF3197A-D663-4F9F-BA11-020B55C3A0E3}"/>
               </a:ext>
             </a:extLst>
           </p:cNvPr>
@@ -9558,7 +8157,7 @@
           <p:cNvPr id="7" name="">
             <a:extLst xmlns:a="http://schemas.openxmlformats.org/drawingml/2006/main">
               <a:ext uri="{FF2B5EF4-FFF2-40B4-BE49-F238E27FC236}">
-                <a16:creationId xmlns:a16="http://schemas.microsoft.com/office/drawing/2014/main" id="{F679ECA5-0E89-47A0-A0E1-0935EB07995F}"/>
+                <a16:creationId xmlns:a16="http://schemas.microsoft.com/office/drawing/2014/main" id="{DE618CA2-E8F6-4354-86BB-B86B50EFFCCF}"/>
               </a:ext>
             </a:extLst>
           </p:cNvPr>
@@ -9608,7 +8207,7 @@
           <p:cNvPr id="8" name="">
             <a:extLst xmlns:a="http://schemas.openxmlformats.org/drawingml/2006/main">
               <a:ext uri="{FF2B5EF4-FFF2-40B4-BE49-F238E27FC236}">
-                <a16:creationId xmlns:a16="http://schemas.microsoft.com/office/drawing/2014/main" id="{4C7571D6-00C8-4618-8C9A-684196BAE708}"/>
+                <a16:creationId xmlns:a16="http://schemas.microsoft.com/office/drawing/2014/main" id="{754E9E81-14E3-44C0-A4A0-D26C9533BC6E}"/>
               </a:ext>
             </a:extLst>
           </p:cNvPr>
@@ -9658,7 +8257,7 @@
           <p:cNvPr id="9" name="">
             <a:extLst xmlns:a="http://schemas.openxmlformats.org/drawingml/2006/main">
               <a:ext uri="{FF2B5EF4-FFF2-40B4-BE49-F238E27FC236}">
-                <a16:creationId xmlns:a16="http://schemas.microsoft.com/office/drawing/2014/main" id="{BBD0D283-6E61-4C14-8D1E-BF66CA354F97}"/>
+                <a16:creationId xmlns:a16="http://schemas.microsoft.com/office/drawing/2014/main" id="{6143551E-54DD-443F-95B6-C60936CD7066}"/>
               </a:ext>
             </a:extLst>
           </p:cNvPr>
@@ -9693,7 +8292,7 @@
           <p:cNvPr id="10" name="">
             <a:extLst xmlns:a="http://schemas.openxmlformats.org/drawingml/2006/main">
               <a:ext uri="{FF2B5EF4-FFF2-40B4-BE49-F238E27FC236}">
-                <a16:creationId xmlns:a16="http://schemas.microsoft.com/office/drawing/2014/main" id="{8EB1FBEA-1B74-453F-998B-A7217DD2AADC}"/>
+                <a16:creationId xmlns:a16="http://schemas.microsoft.com/office/drawing/2014/main" id="{432EBC68-506B-454F-93F4-15E15A30EE02}"/>
               </a:ext>
             </a:extLst>
           </p:cNvPr>
@@ -9743,7 +8342,7 @@
           <p:cNvPr id="11" name="">
             <a:extLst xmlns:a="http://schemas.openxmlformats.org/drawingml/2006/main">
               <a:ext uri="{FF2B5EF4-FFF2-40B4-BE49-F238E27FC236}">
-                <a16:creationId xmlns:a16="http://schemas.microsoft.com/office/drawing/2014/main" id="{8B69C191-CF0D-479F-A0E3-BAF40514DFF8}"/>
+                <a16:creationId xmlns:a16="http://schemas.microsoft.com/office/drawing/2014/main" id="{AFF776D2-031F-4E43-B489-D3D4E5AEDA37}"/>
               </a:ext>
             </a:extLst>
           </p:cNvPr>
@@ -9793,7 +8392,7 @@
           <p:cNvPr id="12" name="">
             <a:extLst xmlns:a="http://schemas.openxmlformats.org/drawingml/2006/main">
               <a:ext uri="{FF2B5EF4-FFF2-40B4-BE49-F238E27FC236}">
-                <a16:creationId xmlns:a16="http://schemas.microsoft.com/office/drawing/2014/main" id="{BC24C7C3-B06C-4DCB-AF18-92BB5AFA83C4}"/>
+                <a16:creationId xmlns:a16="http://schemas.microsoft.com/office/drawing/2014/main" id="{1781E2E0-741A-4754-83D3-BAD992458D48}"/>
               </a:ext>
             </a:extLst>
           </p:cNvPr>
@@ -9843,7 +8442,7 @@
           <p:cNvPr id="13" name="">
             <a:extLst xmlns:a="http://schemas.openxmlformats.org/drawingml/2006/main">
               <a:ext uri="{FF2B5EF4-FFF2-40B4-BE49-F238E27FC236}">
-                <a16:creationId xmlns:a16="http://schemas.microsoft.com/office/drawing/2014/main" id="{BB8A9760-8712-432D-944C-9AA402984734}"/>
+                <a16:creationId xmlns:a16="http://schemas.microsoft.com/office/drawing/2014/main" id="{BFA7857B-E1E7-416A-A1C9-CA370250C43D}"/>
               </a:ext>
             </a:extLst>
           </p:cNvPr>
@@ -9893,7 +8492,7 @@
           <p:cNvPr id="14" name="">
             <a:extLst xmlns:a="http://schemas.openxmlformats.org/drawingml/2006/main">
               <a:ext uri="{FF2B5EF4-FFF2-40B4-BE49-F238E27FC236}">
-                <a16:creationId xmlns:a16="http://schemas.microsoft.com/office/drawing/2014/main" id="{CE4B4A13-B36E-4EC3-9A7A-18288BEC6DA4}"/>
+                <a16:creationId xmlns:a16="http://schemas.microsoft.com/office/drawing/2014/main" id="{B9235771-3F7A-4D4C-BE7F-FCAA26C9ABE5}"/>
               </a:ext>
             </a:extLst>
           </p:cNvPr>
@@ -9943,7 +8542,7 @@
           <p:cNvPr id="15" name="">
             <a:extLst xmlns:a="http://schemas.openxmlformats.org/drawingml/2006/main">
               <a:ext uri="{FF2B5EF4-FFF2-40B4-BE49-F238E27FC236}">
-                <a16:creationId xmlns:a16="http://schemas.microsoft.com/office/drawing/2014/main" id="{3D5DA55F-FBD2-4963-82B6-87EFD35E261A}"/>
+                <a16:creationId xmlns:a16="http://schemas.microsoft.com/office/drawing/2014/main" id="{AD84FF07-7947-4F0D-A7DC-ACE33B4EAFDB}"/>
               </a:ext>
             </a:extLst>
           </p:cNvPr>
@@ -9991,7 +8590,7 @@
     </p:spTree>
     <p:extLst>
       <p:ext uri="{BB962C8B-B14F-4D97-AF65-F5344CB8AC3E}">
-        <p14:creationId xmlns:p14="http://schemas.microsoft.com/office/powerpoint/2010/main" val="1972104334"/>
+        <p14:creationId xmlns:p14="http://schemas.microsoft.com/office/powerpoint/2010/main" val="1045197519"/>
       </p:ext>
     </p:extLst>
   </p:cSld>
@@ -10022,7 +8621,7 @@
           <p:cNvPr id="19" name="">
             <a:extLst xmlns:a="http://schemas.openxmlformats.org/drawingml/2006/main">
               <a:ext uri="{FF2B5EF4-FFF2-40B4-BE49-F238E27FC236}">
-                <a16:creationId xmlns:a16="http://schemas.microsoft.com/office/drawing/2014/main" id="{26666CC0-26A8-4AB1-B521-4069E3B45A1C}"/>
+                <a16:creationId xmlns:a16="http://schemas.microsoft.com/office/drawing/2014/main" id="{0D845DA4-148B-4D0C-90FB-FEE19D4AD764}"/>
               </a:ext>
             </a:extLst>
           </p:cNvPr>
@@ -10072,7 +8671,7 @@
           <p:cNvPr id="2" name="">
             <a:extLst xmlns:a="http://schemas.openxmlformats.org/drawingml/2006/main">
               <a:ext uri="{FF2B5EF4-FFF2-40B4-BE49-F238E27FC236}">
-                <a16:creationId xmlns:a16="http://schemas.microsoft.com/office/drawing/2014/main" id="{FD442541-361D-4DAD-B60B-0D944BC75F8D}"/>
+                <a16:creationId xmlns:a16="http://schemas.microsoft.com/office/drawing/2014/main" id="{FDE919A2-57A1-4766-9DB3-DC904F4D9636}"/>
               </a:ext>
             </a:extLst>
           </p:cNvPr>
@@ -10122,7 +8721,7 @@
           <p:cNvPr id="3" name="">
             <a:extLst xmlns:a="http://schemas.openxmlformats.org/drawingml/2006/main">
               <a:ext uri="{FF2B5EF4-FFF2-40B4-BE49-F238E27FC236}">
-                <a16:creationId xmlns:a16="http://schemas.microsoft.com/office/drawing/2014/main" id="{308A0188-0627-4041-B1BC-13289A91E5A6}"/>
+                <a16:creationId xmlns:a16="http://schemas.microsoft.com/office/drawing/2014/main" id="{B9DF4960-0991-4E5A-86B4-E92AAB8A1BDC}"/>
               </a:ext>
             </a:extLst>
           </p:cNvPr>
@@ -10161,7 +8760,7 @@
           <p:nvPr/>
         </p:nvPicPr>
         <p:blipFill>
-          <a:blip xmlns:r="http://schemas.openxmlformats.org/officeDocument/2006/relationships" xmlns:a="http://schemas.openxmlformats.org/drawingml/2006/main" r:embed="Rde40053323ef4c98"/>
+          <a:blip xmlns:r="http://schemas.openxmlformats.org/officeDocument/2006/relationships" xmlns:a="http://schemas.openxmlformats.org/drawingml/2006/main" r:embed="Rc50aff526565449b"/>
           <a:stretch xmlns:a="http://schemas.openxmlformats.org/drawingml/2006/main"/>
         </p:blipFill>
         <p:spPr>
@@ -10179,7 +8778,7 @@
           <p:cNvPr id="5" name="">
             <a:extLst xmlns:a="http://schemas.openxmlformats.org/drawingml/2006/main">
               <a:ext uri="{FF2B5EF4-FFF2-40B4-BE49-F238E27FC236}">
-                <a16:creationId xmlns:a16="http://schemas.microsoft.com/office/drawing/2014/main" id="{A03E889E-AAB2-4ACC-B5AA-B2DEDCBB915A}"/>
+                <a16:creationId xmlns:a16="http://schemas.microsoft.com/office/drawing/2014/main" id="{393DA3FD-8B61-4F06-9DBB-E815E174164B}"/>
               </a:ext>
             </a:extLst>
           </p:cNvPr>
@@ -10214,7 +8813,7 @@
           <p:cNvPr id="6" name="">
             <a:extLst xmlns:a="http://schemas.openxmlformats.org/drawingml/2006/main">
               <a:ext uri="{FF2B5EF4-FFF2-40B4-BE49-F238E27FC236}">
-                <a16:creationId xmlns:a16="http://schemas.microsoft.com/office/drawing/2014/main" id="{DBDEA58E-EE76-4D7B-8FDD-6B8DAB743500}"/>
+                <a16:creationId xmlns:a16="http://schemas.microsoft.com/office/drawing/2014/main" id="{9ECAE5B1-F98C-479C-A53A-99AEBD856245}"/>
               </a:ext>
             </a:extLst>
           </p:cNvPr>
@@ -10264,7 +8863,7 @@
           <p:cNvPr id="7" name="">
             <a:extLst xmlns:a="http://schemas.openxmlformats.org/drawingml/2006/main">
               <a:ext uri="{FF2B5EF4-FFF2-40B4-BE49-F238E27FC236}">
-                <a16:creationId xmlns:a16="http://schemas.microsoft.com/office/drawing/2014/main" id="{8EE01444-5B72-4C5D-B91D-1A17B8CE2570}"/>
+                <a16:creationId xmlns:a16="http://schemas.microsoft.com/office/drawing/2014/main" id="{55AFA5AE-63B1-4862-BDD9-1F5C285A5761}"/>
               </a:ext>
             </a:extLst>
           </p:cNvPr>
@@ -10314,7 +8913,7 @@
           <p:cNvPr id="8" name="">
             <a:extLst xmlns:a="http://schemas.openxmlformats.org/drawingml/2006/main">
               <a:ext uri="{FF2B5EF4-FFF2-40B4-BE49-F238E27FC236}">
-                <a16:creationId xmlns:a16="http://schemas.microsoft.com/office/drawing/2014/main" id="{1184EAFA-293F-41E8-925A-A5835C5D1F63}"/>
+                <a16:creationId xmlns:a16="http://schemas.microsoft.com/office/drawing/2014/main" id="{DADD0649-733C-437E-8E47-62EE077AF1B4}"/>
               </a:ext>
             </a:extLst>
           </p:cNvPr>
@@ -10349,7 +8948,7 @@
           <p:cNvPr id="9" name="">
             <a:extLst xmlns:a="http://schemas.openxmlformats.org/drawingml/2006/main">
               <a:ext uri="{FF2B5EF4-FFF2-40B4-BE49-F238E27FC236}">
-                <a16:creationId xmlns:a16="http://schemas.microsoft.com/office/drawing/2014/main" id="{7FBF1629-2085-4B16-AD96-9E0F9A483F43}"/>
+                <a16:creationId xmlns:a16="http://schemas.microsoft.com/office/drawing/2014/main" id="{D7AFBFC5-432C-496F-BACB-6F286E9365F6}"/>
               </a:ext>
             </a:extLst>
           </p:cNvPr>
@@ -10399,7 +8998,7 @@
           <p:cNvPr id="10" name="">
             <a:extLst xmlns:a="http://schemas.openxmlformats.org/drawingml/2006/main">
               <a:ext uri="{FF2B5EF4-FFF2-40B4-BE49-F238E27FC236}">
-                <a16:creationId xmlns:a16="http://schemas.microsoft.com/office/drawing/2014/main" id="{D24D4B37-0DD8-45A6-A10D-9F4C33C4DB56}"/>
+                <a16:creationId xmlns:a16="http://schemas.microsoft.com/office/drawing/2014/main" id="{A76320F1-5D09-43D3-9816-35CE6F472206}"/>
               </a:ext>
             </a:extLst>
           </p:cNvPr>
@@ -10449,7 +9048,7 @@
           <p:cNvPr id="11" name="">
             <a:extLst xmlns:a="http://schemas.openxmlformats.org/drawingml/2006/main">
               <a:ext uri="{FF2B5EF4-FFF2-40B4-BE49-F238E27FC236}">
-                <a16:creationId xmlns:a16="http://schemas.microsoft.com/office/drawing/2014/main" id="{DB52334E-FD14-48C5-86F7-C80709B0A90A}"/>
+                <a16:creationId xmlns:a16="http://schemas.microsoft.com/office/drawing/2014/main" id="{BB1EB466-5804-43DB-9FB5-2E7E24D09E09}"/>
               </a:ext>
             </a:extLst>
           </p:cNvPr>
@@ -10484,7 +9083,7 @@
           <p:cNvPr id="12" name="">
             <a:extLst xmlns:a="http://schemas.openxmlformats.org/drawingml/2006/main">
               <a:ext uri="{FF2B5EF4-FFF2-40B4-BE49-F238E27FC236}">
-                <a16:creationId xmlns:a16="http://schemas.microsoft.com/office/drawing/2014/main" id="{64C9E881-8B90-4543-8055-FBE53AED8A77}"/>
+                <a16:creationId xmlns:a16="http://schemas.microsoft.com/office/drawing/2014/main" id="{B3611D42-1283-4EF1-B7EA-44690F310E93}"/>
               </a:ext>
             </a:extLst>
           </p:cNvPr>
@@ -10534,7 +9133,7 @@
           <p:cNvPr id="13" name="">
             <a:extLst xmlns:a="http://schemas.openxmlformats.org/drawingml/2006/main">
               <a:ext uri="{FF2B5EF4-FFF2-40B4-BE49-F238E27FC236}">
-                <a16:creationId xmlns:a16="http://schemas.microsoft.com/office/drawing/2014/main" id="{168BB3AB-97C5-4234-ACCF-7BB4AA46F9E1}"/>
+                <a16:creationId xmlns:a16="http://schemas.microsoft.com/office/drawing/2014/main" id="{B7858114-13B0-4F4E-928F-6442B4F40DA0}"/>
               </a:ext>
             </a:extLst>
           </p:cNvPr>
@@ -10584,7 +9183,7 @@
           <p:cNvPr id="14" name="">
             <a:extLst xmlns:a="http://schemas.openxmlformats.org/drawingml/2006/main">
               <a:ext uri="{FF2B5EF4-FFF2-40B4-BE49-F238E27FC236}">
-                <a16:creationId xmlns:a16="http://schemas.microsoft.com/office/drawing/2014/main" id="{E61FBC2D-62F6-4838-9992-656E6522C25A}"/>
+                <a16:creationId xmlns:a16="http://schemas.microsoft.com/office/drawing/2014/main" id="{5FD22651-102B-4C94-A592-681B935B3EDB}"/>
               </a:ext>
             </a:extLst>
           </p:cNvPr>
@@ -10634,7 +9233,7 @@
           <p:cNvPr id="15" name="">
             <a:extLst xmlns:a="http://schemas.openxmlformats.org/drawingml/2006/main">
               <a:ext uri="{FF2B5EF4-FFF2-40B4-BE49-F238E27FC236}">
-                <a16:creationId xmlns:a16="http://schemas.microsoft.com/office/drawing/2014/main" id="{64818A14-D399-4193-9409-3B51A7718540}"/>
+                <a16:creationId xmlns:a16="http://schemas.microsoft.com/office/drawing/2014/main" id="{43F40970-FE58-420E-9837-2C8CFED0E192}"/>
               </a:ext>
             </a:extLst>
           </p:cNvPr>
@@ -10684,7 +9283,7 @@
           <p:cNvPr id="16" name="">
             <a:extLst xmlns:a="http://schemas.openxmlformats.org/drawingml/2006/main">
               <a:ext uri="{FF2B5EF4-FFF2-40B4-BE49-F238E27FC236}">
-                <a16:creationId xmlns:a16="http://schemas.microsoft.com/office/drawing/2014/main" id="{2FAB6770-DBC7-4FBE-9392-4EFE8BCF2BE5}"/>
+                <a16:creationId xmlns:a16="http://schemas.microsoft.com/office/drawing/2014/main" id="{2C08B88A-D5AA-4E8B-9400-C43CE95210A2}"/>
               </a:ext>
             </a:extLst>
           </p:cNvPr>
@@ -10734,7 +9333,7 @@
           <p:cNvPr id="17" name="">
             <a:extLst xmlns:a="http://schemas.openxmlformats.org/drawingml/2006/main">
               <a:ext uri="{FF2B5EF4-FFF2-40B4-BE49-F238E27FC236}">
-                <a16:creationId xmlns:a16="http://schemas.microsoft.com/office/drawing/2014/main" id="{F485A3B4-6C7D-4E37-90D2-F475A271727F}"/>
+                <a16:creationId xmlns:a16="http://schemas.microsoft.com/office/drawing/2014/main" id="{581A6BC5-30DA-4821-A9C5-6265FABCD3E8}"/>
               </a:ext>
             </a:extLst>
           </p:cNvPr>
@@ -10784,7 +9383,7 @@
           <p:cNvPr id="18" name="">
             <a:extLst xmlns:a="http://schemas.openxmlformats.org/drawingml/2006/main">
               <a:ext uri="{FF2B5EF4-FFF2-40B4-BE49-F238E27FC236}">
-                <a16:creationId xmlns:a16="http://schemas.microsoft.com/office/drawing/2014/main" id="{7678EEED-E6DE-4748-989D-8755A3CA1178}"/>
+                <a16:creationId xmlns:a16="http://schemas.microsoft.com/office/drawing/2014/main" id="{DD0D32F0-4E02-4AAB-A8FD-513239DAFBB6}"/>
               </a:ext>
             </a:extLst>
           </p:cNvPr>
@@ -10832,7 +9431,7 @@
     </p:spTree>
     <p:extLst>
       <p:ext uri="{BB962C8B-B14F-4D97-AF65-F5344CB8AC3E}">
-        <p14:creationId xmlns:p14="http://schemas.microsoft.com/office/powerpoint/2010/main" val="509575254"/>
+        <p14:creationId xmlns:p14="http://schemas.microsoft.com/office/powerpoint/2010/main" val="855042535"/>
       </p:ext>
     </p:extLst>
   </p:cSld>
@@ -10863,7 +9462,7 @@
           <p:cNvPr id="12" name="">
             <a:extLst xmlns:a="http://schemas.openxmlformats.org/drawingml/2006/main">
               <a:ext uri="{FF2B5EF4-FFF2-40B4-BE49-F238E27FC236}">
-                <a16:creationId xmlns:a16="http://schemas.microsoft.com/office/drawing/2014/main" id="{79194F76-77AD-4342-B858-270E225A04A8}"/>
+                <a16:creationId xmlns:a16="http://schemas.microsoft.com/office/drawing/2014/main" id="{43A15A61-C203-4F91-A698-DEFADA9814DE}"/>
               </a:ext>
             </a:extLst>
           </p:cNvPr>
@@ -10913,7 +9512,7 @@
           <p:cNvPr id="2" name="">
             <a:extLst xmlns:a="http://schemas.openxmlformats.org/drawingml/2006/main">
               <a:ext uri="{FF2B5EF4-FFF2-40B4-BE49-F238E27FC236}">
-                <a16:creationId xmlns:a16="http://schemas.microsoft.com/office/drawing/2014/main" id="{DD1C6A58-34BB-4C5B-8C71-A9C831010083}"/>
+                <a16:creationId xmlns:a16="http://schemas.microsoft.com/office/drawing/2014/main" id="{FBB70B49-D383-4BD0-8B44-0EC074E67526}"/>
               </a:ext>
             </a:extLst>
           </p:cNvPr>
@@ -10963,7 +9562,7 @@
           <p:cNvPr id="3" name="">
             <a:extLst xmlns:a="http://schemas.openxmlformats.org/drawingml/2006/main">
               <a:ext uri="{FF2B5EF4-FFF2-40B4-BE49-F238E27FC236}">
-                <a16:creationId xmlns:a16="http://schemas.microsoft.com/office/drawing/2014/main" id="{F0CF3DE8-8F26-4499-B8CE-504FA17BAA64}"/>
+                <a16:creationId xmlns:a16="http://schemas.microsoft.com/office/drawing/2014/main" id="{6FF4E5F6-4D8B-4557-A488-525B56A38F29}"/>
               </a:ext>
             </a:extLst>
           </p:cNvPr>
@@ -11002,7 +9601,7 @@
           <p:nvPr/>
         </p:nvPicPr>
         <p:blipFill>
-          <a:blip xmlns:r="http://schemas.openxmlformats.org/officeDocument/2006/relationships" xmlns:a="http://schemas.openxmlformats.org/drawingml/2006/main" r:embed="Rda1081e51bce4e35"/>
+          <a:blip xmlns:r="http://schemas.openxmlformats.org/officeDocument/2006/relationships" xmlns:a="http://schemas.openxmlformats.org/drawingml/2006/main" r:embed="R414dc66eda4f488f"/>
           <a:stretch xmlns:a="http://schemas.openxmlformats.org/drawingml/2006/main"/>
         </p:blipFill>
         <p:spPr>
@@ -11020,7 +9619,7 @@
           <p:cNvPr id="5" name="">
             <a:extLst xmlns:a="http://schemas.openxmlformats.org/drawingml/2006/main">
               <a:ext uri="{FF2B5EF4-FFF2-40B4-BE49-F238E27FC236}">
-                <a16:creationId xmlns:a16="http://schemas.microsoft.com/office/drawing/2014/main" id="{1ECE577B-78CA-4EF9-86BA-BB1F087B87D7}"/>
+                <a16:creationId xmlns:a16="http://schemas.microsoft.com/office/drawing/2014/main" id="{F080900F-EE16-4EF7-AB9F-9823444022B5}"/>
               </a:ext>
             </a:extLst>
           </p:cNvPr>
@@ -11055,7 +9654,7 @@
           <p:cNvPr id="6" name="">
             <a:extLst xmlns:a="http://schemas.openxmlformats.org/drawingml/2006/main">
               <a:ext uri="{FF2B5EF4-FFF2-40B4-BE49-F238E27FC236}">
-                <a16:creationId xmlns:a16="http://schemas.microsoft.com/office/drawing/2014/main" id="{8AC471BC-39AD-4370-AAA6-CDF8538A297C}"/>
+                <a16:creationId xmlns:a16="http://schemas.microsoft.com/office/drawing/2014/main" id="{7F2168A0-CD47-4F3C-B09D-CE2EF7A25848}"/>
               </a:ext>
             </a:extLst>
           </p:cNvPr>
@@ -11105,7 +9704,7 @@
           <p:cNvPr id="7" name="">
             <a:extLst xmlns:a="http://schemas.openxmlformats.org/drawingml/2006/main">
               <a:ext uri="{FF2B5EF4-FFF2-40B4-BE49-F238E27FC236}">
-                <a16:creationId xmlns:a16="http://schemas.microsoft.com/office/drawing/2014/main" id="{6E25B398-9407-490F-811E-8259D8560D59}"/>
+                <a16:creationId xmlns:a16="http://schemas.microsoft.com/office/drawing/2014/main" id="{F2C60DAB-0D38-4E4D-BEA2-258A21F8F246}"/>
               </a:ext>
             </a:extLst>
           </p:cNvPr>
@@ -11155,7 +9754,7 @@
           <p:cNvPr id="8" name="">
             <a:extLst xmlns:a="http://schemas.openxmlformats.org/drawingml/2006/main">
               <a:ext uri="{FF2B5EF4-FFF2-40B4-BE49-F238E27FC236}">
-                <a16:creationId xmlns:a16="http://schemas.microsoft.com/office/drawing/2014/main" id="{68CA7BA5-8D96-4B3A-AD77-482E697A99F6}"/>
+                <a16:creationId xmlns:a16="http://schemas.microsoft.com/office/drawing/2014/main" id="{C79D9AF6-77B3-41FD-821D-C8599C8BF0CB}"/>
               </a:ext>
             </a:extLst>
           </p:cNvPr>
@@ -11205,7 +9804,7 @@
           <p:cNvPr id="9" name="">
             <a:extLst xmlns:a="http://schemas.openxmlformats.org/drawingml/2006/main">
               <a:ext uri="{FF2B5EF4-FFF2-40B4-BE49-F238E27FC236}">
-                <a16:creationId xmlns:a16="http://schemas.microsoft.com/office/drawing/2014/main" id="{7A9A247B-CB14-480C-AE67-B1C85B258A57}"/>
+                <a16:creationId xmlns:a16="http://schemas.microsoft.com/office/drawing/2014/main" id="{12A5B779-5148-4152-A00C-AAB6DF1612EE}"/>
               </a:ext>
             </a:extLst>
           </p:cNvPr>
@@ -11255,7 +9854,7 @@
           <p:cNvPr id="10" name="">
             <a:extLst xmlns:a="http://schemas.openxmlformats.org/drawingml/2006/main">
               <a:ext uri="{FF2B5EF4-FFF2-40B4-BE49-F238E27FC236}">
-                <a16:creationId xmlns:a16="http://schemas.microsoft.com/office/drawing/2014/main" id="{E772A7EC-2088-4785-B9BE-F51B041009D7}"/>
+                <a16:creationId xmlns:a16="http://schemas.microsoft.com/office/drawing/2014/main" id="{A339867D-5116-4151-9C66-90BC9EEC5860}"/>
               </a:ext>
             </a:extLst>
           </p:cNvPr>
@@ -11305,7 +9904,7 @@
           <p:cNvPr id="11" name="">
             <a:extLst xmlns:a="http://schemas.openxmlformats.org/drawingml/2006/main">
               <a:ext uri="{FF2B5EF4-FFF2-40B4-BE49-F238E27FC236}">
-                <a16:creationId xmlns:a16="http://schemas.microsoft.com/office/drawing/2014/main" id="{34E8F0D2-726D-4F0A-A523-02E78F2B8670}"/>
+                <a16:creationId xmlns:a16="http://schemas.microsoft.com/office/drawing/2014/main" id="{57F364A6-CD19-4BF9-9FD1-FB0BE6230DED}"/>
               </a:ext>
             </a:extLst>
           </p:cNvPr>
@@ -11353,7 +9952,7 @@
     </p:spTree>
     <p:extLst>
       <p:ext uri="{BB962C8B-B14F-4D97-AF65-F5344CB8AC3E}">
-        <p14:creationId xmlns:p14="http://schemas.microsoft.com/office/powerpoint/2010/main" val="150420166"/>
+        <p14:creationId xmlns:p14="http://schemas.microsoft.com/office/powerpoint/2010/main" val="175379469"/>
       </p:ext>
     </p:extLst>
   </p:cSld>
@@ -11384,7 +9983,7 @@
           <p:cNvPr id="9" name="">
             <a:extLst xmlns:a="http://schemas.openxmlformats.org/drawingml/2006/main">
               <a:ext uri="{FF2B5EF4-FFF2-40B4-BE49-F238E27FC236}">
-                <a16:creationId xmlns:a16="http://schemas.microsoft.com/office/drawing/2014/main" id="{2A74A09F-8021-450B-8059-AF8C0D7D7660}"/>
+                <a16:creationId xmlns:a16="http://schemas.microsoft.com/office/drawing/2014/main" id="{927CCEDF-BF71-4CF2-90E9-63ED0A2766E2}"/>
               </a:ext>
             </a:extLst>
           </p:cNvPr>
@@ -11434,7 +10033,7 @@
           <p:cNvPr id="2" name="">
             <a:extLst xmlns:a="http://schemas.openxmlformats.org/drawingml/2006/main">
               <a:ext uri="{FF2B5EF4-FFF2-40B4-BE49-F238E27FC236}">
-                <a16:creationId xmlns:a16="http://schemas.microsoft.com/office/drawing/2014/main" id="{274952F3-E7BD-49C8-ADDF-2121E07DA1A7}"/>
+                <a16:creationId xmlns:a16="http://schemas.microsoft.com/office/drawing/2014/main" id="{324B422D-7EB4-4971-A334-678CC2F68794}"/>
               </a:ext>
             </a:extLst>
           </p:cNvPr>
@@ -11484,7 +10083,7 @@
           <p:cNvPr id="3" name="">
             <a:extLst xmlns:a="http://schemas.openxmlformats.org/drawingml/2006/main">
               <a:ext uri="{FF2B5EF4-FFF2-40B4-BE49-F238E27FC236}">
-                <a16:creationId xmlns:a16="http://schemas.microsoft.com/office/drawing/2014/main" id="{D71116E9-2D31-4DA7-B2B6-53BF419056DD}"/>
+                <a16:creationId xmlns:a16="http://schemas.microsoft.com/office/drawing/2014/main" id="{93895754-C86B-49C3-819F-101E8F7C8A46}"/>
               </a:ext>
             </a:extLst>
           </p:cNvPr>
@@ -11523,7 +10122,7 @@
           <p:nvPr/>
         </p:nvPicPr>
         <p:blipFill>
-          <a:blip xmlns:r="http://schemas.openxmlformats.org/officeDocument/2006/relationships" xmlns:a="http://schemas.openxmlformats.org/drawingml/2006/main" r:embed="R21c512cc05b8451b"/>
+          <a:blip xmlns:r="http://schemas.openxmlformats.org/officeDocument/2006/relationships" xmlns:a="http://schemas.openxmlformats.org/drawingml/2006/main" r:embed="Rb980cbeea3f84c70"/>
           <a:stretch xmlns:a="http://schemas.openxmlformats.org/drawingml/2006/main"/>
         </p:blipFill>
         <p:spPr>
@@ -11541,7 +10140,7 @@
           <p:cNvPr id="5" name="">
             <a:extLst xmlns:a="http://schemas.openxmlformats.org/drawingml/2006/main">
               <a:ext uri="{FF2B5EF4-FFF2-40B4-BE49-F238E27FC236}">
-                <a16:creationId xmlns:a16="http://schemas.microsoft.com/office/drawing/2014/main" id="{C18B1B06-F23E-4B4E-98A7-B650F50984B6}"/>
+                <a16:creationId xmlns:a16="http://schemas.microsoft.com/office/drawing/2014/main" id="{0BFE29CA-36A7-40BE-8F1B-28CF051FF307}"/>
               </a:ext>
             </a:extLst>
           </p:cNvPr>
@@ -11591,7 +10190,7 @@
           <p:cNvPr id="6" name="">
             <a:extLst xmlns:a="http://schemas.openxmlformats.org/drawingml/2006/main">
               <a:ext uri="{FF2B5EF4-FFF2-40B4-BE49-F238E27FC236}">
-                <a16:creationId xmlns:a16="http://schemas.microsoft.com/office/drawing/2014/main" id="{392A2D30-A93C-4FCC-9CBA-59E1614FAC07}"/>
+                <a16:creationId xmlns:a16="http://schemas.microsoft.com/office/drawing/2014/main" id="{E53BFD32-D62D-4B31-9FC4-57EB425895B3}"/>
               </a:ext>
             </a:extLst>
           </p:cNvPr>
@@ -11641,7 +10240,7 @@
           <p:cNvPr id="7" name="">
             <a:extLst xmlns:a="http://schemas.openxmlformats.org/drawingml/2006/main">
               <a:ext uri="{FF2B5EF4-FFF2-40B4-BE49-F238E27FC236}">
-                <a16:creationId xmlns:a16="http://schemas.microsoft.com/office/drawing/2014/main" id="{C8345FAC-194F-46F4-88F8-FB5FA4A421BF}"/>
+                <a16:creationId xmlns:a16="http://schemas.microsoft.com/office/drawing/2014/main" id="{17A978C7-1BEE-49CC-B6BB-F8911A312B42}"/>
               </a:ext>
             </a:extLst>
           </p:cNvPr>
@@ -11691,7 +10290,7 @@
           <p:cNvPr id="8" name="">
             <a:extLst xmlns:a="http://schemas.openxmlformats.org/drawingml/2006/main">
               <a:ext uri="{FF2B5EF4-FFF2-40B4-BE49-F238E27FC236}">
-                <a16:creationId xmlns:a16="http://schemas.microsoft.com/office/drawing/2014/main" id="{4EC1F2A0-D8CF-441D-8808-84F7D8004C4B}"/>
+                <a16:creationId xmlns:a16="http://schemas.microsoft.com/office/drawing/2014/main" id="{85C32EB3-7C6F-4B6A-918D-6D4169D828F8}"/>
               </a:ext>
             </a:extLst>
           </p:cNvPr>
@@ -11739,7 +10338,7 @@
     </p:spTree>
     <p:extLst>
       <p:ext uri="{BB962C8B-B14F-4D97-AF65-F5344CB8AC3E}">
-        <p14:creationId xmlns:p14="http://schemas.microsoft.com/office/powerpoint/2010/main" val="1197714083"/>
+        <p14:creationId xmlns:p14="http://schemas.microsoft.com/office/powerpoint/2010/main" val="832540945"/>
       </p:ext>
     </p:extLst>
   </p:cSld>

</xml_diff>

<commit_message>
Polish manager deck with impact slide
</commit_message>
<xml_diff>
--- a/sglang_direct_kv/artifacts/slides/agent_aware_kv_movement_manager_deck.pptx
+++ b/sglang_direct_kv/artifacts/slides/agent_aware_kv_movement_manager_deck.pptx
@@ -2,23 +2,24 @@
 <file path=ppt/presentation.xml><?xml version="1.0" encoding="utf-8"?>
 <p:presentation xmlns:p="http://schemas.openxmlformats.org/presentationml/2006/main">
   <p:sldMasterIdLst>
-    <p:sldMasterId xmlns:r="http://schemas.openxmlformats.org/officeDocument/2006/relationships" id="2147483648" r:id="R20d915324bde41b1"/>
+    <p:sldMasterId xmlns:r="http://schemas.openxmlformats.org/officeDocument/2006/relationships" id="2147483648" r:id="R899d768b3d5f448e"/>
   </p:sldMasterIdLst>
   <p:notesMasterIdLst>
-    <p:notesMasterId xmlns:r="http://schemas.openxmlformats.org/officeDocument/2006/relationships" r:id="R23c17bbc80db48dc"/>
+    <p:notesMasterId xmlns:r="http://schemas.openxmlformats.org/officeDocument/2006/relationships" r:id="R8e3a05492f824db5"/>
   </p:notesMasterIdLst>
   <p:sldIdLst>
-    <p:sldId xmlns:r="http://schemas.openxmlformats.org/officeDocument/2006/relationships" id="256" r:id="R2ded201f67b74c16"/>
-    <p:sldId xmlns:r="http://schemas.openxmlformats.org/officeDocument/2006/relationships" id="257" r:id="R12083c949ea94ecb"/>
-    <p:sldId xmlns:r="http://schemas.openxmlformats.org/officeDocument/2006/relationships" id="258" r:id="R6efc19409d574b75"/>
-    <p:sldId xmlns:r="http://schemas.openxmlformats.org/officeDocument/2006/relationships" id="259" r:id="R823ab8db15bd4f59"/>
-    <p:sldId xmlns:r="http://schemas.openxmlformats.org/officeDocument/2006/relationships" id="260" r:id="R7afacd1f905d4341"/>
-    <p:sldId xmlns:r="http://schemas.openxmlformats.org/officeDocument/2006/relationships" id="261" r:id="R3585b33b42f7429c"/>
-    <p:sldId xmlns:r="http://schemas.openxmlformats.org/officeDocument/2006/relationships" id="262" r:id="Rf177a4c70d4d4d06"/>
-    <p:sldId xmlns:r="http://schemas.openxmlformats.org/officeDocument/2006/relationships" id="263" r:id="Rc813268d0b9a49a6"/>
-    <p:sldId xmlns:r="http://schemas.openxmlformats.org/officeDocument/2006/relationships" id="264" r:id="Rb7243a3b6898417d"/>
-    <p:sldId xmlns:r="http://schemas.openxmlformats.org/officeDocument/2006/relationships" id="265" r:id="Rc7b207a74b4d4405"/>
-    <p:sldId xmlns:r="http://schemas.openxmlformats.org/officeDocument/2006/relationships" id="266" r:id="Ree81fbcebe3641db"/>
+    <p:sldId xmlns:r="http://schemas.openxmlformats.org/officeDocument/2006/relationships" id="256" r:id="Rd377b6085a8a40c8"/>
+    <p:sldId xmlns:r="http://schemas.openxmlformats.org/officeDocument/2006/relationships" id="257" r:id="R433929d20de746ae"/>
+    <p:sldId xmlns:r="http://schemas.openxmlformats.org/officeDocument/2006/relationships" id="258" r:id="R8cd0295ac3e649c9"/>
+    <p:sldId xmlns:r="http://schemas.openxmlformats.org/officeDocument/2006/relationships" id="259" r:id="R468f87e0b6a24835"/>
+    <p:sldId xmlns:r="http://schemas.openxmlformats.org/officeDocument/2006/relationships" id="260" r:id="R07edb9ecb3394432"/>
+    <p:sldId xmlns:r="http://schemas.openxmlformats.org/officeDocument/2006/relationships" id="261" r:id="R691e92a9768f4be2"/>
+    <p:sldId xmlns:r="http://schemas.openxmlformats.org/officeDocument/2006/relationships" id="262" r:id="R344f558b43f64ed4"/>
+    <p:sldId xmlns:r="http://schemas.openxmlformats.org/officeDocument/2006/relationships" id="263" r:id="R1b3732fe2589427a"/>
+    <p:sldId xmlns:r="http://schemas.openxmlformats.org/officeDocument/2006/relationships" id="264" r:id="R791187716dc0457a"/>
+    <p:sldId xmlns:r="http://schemas.openxmlformats.org/officeDocument/2006/relationships" id="265" r:id="R9de39528184c4195"/>
+    <p:sldId xmlns:r="http://schemas.openxmlformats.org/officeDocument/2006/relationships" id="266" r:id="R15f6bf842f224442"/>
+    <p:sldId xmlns:r="http://schemas.openxmlformats.org/officeDocument/2006/relationships" id="267" r:id="Rbf0e08b5fa924679"/>
   </p:sldIdLst>
   <p:sldSz cx="12192000" cy="6858000"/>
   <p:notesSz cx="6858000" cy="9144000"/>
@@ -652,6 +653,111 @@
           <a:lstStyle xmlns:a="http://schemas.openxmlformats.org/drawingml/2006/main"/>
           <a:p xmlns:a="http://schemas.openxmlformats.org/drawingml/2006/main">
             <a:r>
+              <a:t>This slide intentionally frames benefits as ballpark expectations and research targets.</a:t>
+            </a:r>
+          </a:p>
+          <a:p xmlns:a="http://schemas.openxmlformats.org/drawingml/2006/main">
+            <a:r>
+              <a:t>The user previously asked for impact statements like 20% lower latency. Keep claims conservative until clean manager-grade measurements are available.</a:t>
+            </a:r>
+          </a:p>
+          <a:p xmlns:a="http://schemas.openxmlformats.org/drawingml/2006/main">
+            <a:r>
+              <a:t>Potential benefit ranges are internal proposal estimates based on observed late prefetch/replay H2D patterns and expected gains from deadline-aware KV movement.</a:t>
+            </a:r>
+          </a:p>
+          <a:p xmlns:a="http://schemas.openxmlformats.org/drawingml/2006/main">
+            <a:r>
+              <a:t/>
+            </a:r>
+          </a:p>
+          <a:p xmlns:a="http://schemas.openxmlformats.org/drawingml/2006/main">
+            <a:r>
+              <a:t>[Sources]</a:t>
+            </a:r>
+          </a:p>
+          <a:p xmlns:a="http://schemas.openxmlformats.org/drawingml/2006/main">
+            <a:r>
+              <a:t>Local report: /Users/oluwolejaiyeoba/Documents/GitHub/agentic_hardware/sglang_direct_kv/artifacts/results/latest_master_report.html</a:t>
+            </a:r>
+          </a:p>
+          <a:p xmlns:a="http://schemas.openxmlformats.org/drawingml/2006/main">
+            <a:r>
+              <a:t>Synthetic report: /Users/oluwolejaiyeoba/Documents/GitHub/agentic_hardware/sglang_direct_kv/artifacts/results/latest_synthetic_master_report.html</a:t>
+            </a:r>
+          </a:p>
+          <a:p xmlns:a="http://schemas.openxmlformats.org/drawingml/2006/main">
+            <a:r>
+              <a:t>Backup report: /Users/oluwolejaiyeoba/Documents/GitHub/agentic_hardware/backups/latest_master_report-1.html</a:t>
+            </a:r>
+          </a:p>
+        </p:txBody>
+      </p:sp>
+      <p:sp>
+        <p:nvSpPr>
+          <p:cNvPr id="4" name="Slide Number Placeholder 3"/>
+          <p:cNvSpPr>
+            <a:spLocks xmlns:a="http://schemas.openxmlformats.org/drawingml/2006/main" noGrp="1"/>
+          </p:cNvSpPr>
+          <p:nvPr>
+            <p:ph type="sldNum" idx="5"/>
+          </p:nvPr>
+        </p:nvSpPr>
+        <p:spPr/>
+        <p:txBody>
+          <a:bodyPr xmlns:a="http://schemas.openxmlformats.org/drawingml/2006/main"/>
+          <a:lstStyle xmlns:a="http://schemas.openxmlformats.org/drawingml/2006/main"/>
+          <a:p xmlns:a="http://schemas.openxmlformats.org/drawingml/2006/main"/>
+        </p:txBody>
+      </p:sp>
+    </p:spTree>
+  </p:cSld>
+  <p:clrMapOvr>
+    <a:masterClrMapping xmlns:a="http://schemas.openxmlformats.org/drawingml/2006/main"/>
+  </p:clrMapOvr>
+</p:notes>
+</file>
+
+<file path=ppt/notesSlides/notesSlide12.xml><?xml version="1.0" encoding="utf-8"?>
+<p:notes xmlns:p="http://schemas.openxmlformats.org/presentationml/2006/main">
+  <p:cSld>
+    <p:spTree>
+      <p:nvGrpSpPr>
+        <p:cNvPr id="1" name=""/>
+        <p:cNvGrpSpPr/>
+        <p:nvPr/>
+      </p:nvGrpSpPr>
+      <p:grpSpPr>
+        <a:xfrm xmlns:a="http://schemas.openxmlformats.org/drawingml/2006/main"/>
+      </p:grpSpPr>
+      <p:sp>
+        <p:nvSpPr>
+          <p:cNvPr id="2" name="Slide Image Placeholder 1"/>
+          <p:cNvSpPr>
+            <a:spLocks xmlns:a="http://schemas.openxmlformats.org/drawingml/2006/main" noGrp="1"/>
+          </p:cNvSpPr>
+          <p:nvPr>
+            <p:ph type="sldImg" idx="0"/>
+          </p:nvPr>
+        </p:nvSpPr>
+        <p:spPr/>
+      </p:sp>
+      <p:sp>
+        <p:nvSpPr>
+          <p:cNvPr id="3" name="Notes Placeholder 2"/>
+          <p:cNvSpPr>
+            <a:spLocks xmlns:a="http://schemas.openxmlformats.org/drawingml/2006/main" noGrp="1"/>
+          </p:cNvSpPr>
+          <p:nvPr>
+            <p:ph type="body" idx="1"/>
+          </p:nvPr>
+        </p:nvSpPr>
+        <p:spPr/>
+        <p:txBody>
+          <a:bodyPr xmlns:a="http://schemas.openxmlformats.org/drawingml/2006/main"/>
+          <a:lstStyle xmlns:a="http://schemas.openxmlformats.org/drawingml/2006/main"/>
+          <a:p xmlns:a="http://schemas.openxmlformats.org/drawingml/2006/main">
+            <a:r>
               <a:t>Closing slide. Translate the evidence into concrete hardware support candidates.</a:t>
             </a:r>
           </a:p>
@@ -1550,7 +1656,7 @@
   </p:cSld>
   <p:clrMap bg1="lt1" tx1="dk1" bg2="lt2" tx2="dk2" accent1="accent1" accent2="accent2" accent3="accent3" accent4="accent4" accent5="accent5" accent6="accent6" hlink="hlink" folHlink="folHlink"/>
   <p:sldLayoutIdLst>
-    <p:sldLayoutId xmlns:r="http://schemas.openxmlformats.org/officeDocument/2006/relationships" id="2147483649" r:id="R7a586a2ea674487b"/>
+    <p:sldLayoutId xmlns:r="http://schemas.openxmlformats.org/officeDocument/2006/relationships" id="2147483649" r:id="R9dd8673576d7441a"/>
   </p:sldLayoutIdLst>
   <p:txStyles>
     <p:titleStyle>
@@ -2101,7 +2207,7 @@
           <p:cNvPr id="12" name="">
             <a:extLst xmlns:a="http://schemas.openxmlformats.org/drawingml/2006/main">
               <a:ext uri="{FF2B5EF4-FFF2-40B4-BE49-F238E27FC236}">
-                <a16:creationId xmlns:a16="http://schemas.microsoft.com/office/drawing/2014/main" id="{3FC7523C-C444-4A2A-9304-79D6F1A41B0F}"/>
+                <a16:creationId xmlns:a16="http://schemas.microsoft.com/office/drawing/2014/main" id="{6543091D-7A1B-427B-9CB4-3A4591A94195}"/>
               </a:ext>
             </a:extLst>
           </p:cNvPr>
@@ -2151,7 +2257,7 @@
           <p:cNvPr id="2" name="">
             <a:extLst xmlns:a="http://schemas.openxmlformats.org/drawingml/2006/main">
               <a:ext uri="{FF2B5EF4-FFF2-40B4-BE49-F238E27FC236}">
-                <a16:creationId xmlns:a16="http://schemas.microsoft.com/office/drawing/2014/main" id="{B946B008-5047-4094-9B15-09B1B243DFBF}"/>
+                <a16:creationId xmlns:a16="http://schemas.microsoft.com/office/drawing/2014/main" id="{C4925A30-F28D-4A6B-BA2D-33FE19F2E34D}"/>
               </a:ext>
             </a:extLst>
           </p:cNvPr>
@@ -2201,7 +2307,7 @@
           <p:cNvPr id="3" name="">
             <a:extLst xmlns:a="http://schemas.openxmlformats.org/drawingml/2006/main">
               <a:ext uri="{FF2B5EF4-FFF2-40B4-BE49-F238E27FC236}">
-                <a16:creationId xmlns:a16="http://schemas.microsoft.com/office/drawing/2014/main" id="{9CA5556B-4CE9-4C15-A4C0-35FA6CB8E76C}"/>
+                <a16:creationId xmlns:a16="http://schemas.microsoft.com/office/drawing/2014/main" id="{F64297CF-480E-4B19-9A68-B2605682614E}"/>
               </a:ext>
             </a:extLst>
           </p:cNvPr>
@@ -2232,7 +2338,7 @@
           <p:cNvPr id="4" name="">
             <a:extLst xmlns:a="http://schemas.openxmlformats.org/drawingml/2006/main">
               <a:ext uri="{FF2B5EF4-FFF2-40B4-BE49-F238E27FC236}">
-                <a16:creationId xmlns:a16="http://schemas.microsoft.com/office/drawing/2014/main" id="{99A9D1E8-D606-4B1E-9C5C-6C498D5963E2}"/>
+                <a16:creationId xmlns:a16="http://schemas.microsoft.com/office/drawing/2014/main" id="{A9BD2C76-8565-4C6F-BF64-8C98D033D2E1}"/>
               </a:ext>
             </a:extLst>
           </p:cNvPr>
@@ -2282,7 +2388,7 @@
           <p:cNvPr id="5" name="">
             <a:extLst xmlns:a="http://schemas.openxmlformats.org/drawingml/2006/main">
               <a:ext uri="{FF2B5EF4-FFF2-40B4-BE49-F238E27FC236}">
-                <a16:creationId xmlns:a16="http://schemas.microsoft.com/office/drawing/2014/main" id="{48CE3191-F12E-4145-9661-7CC772D26E35}"/>
+                <a16:creationId xmlns:a16="http://schemas.microsoft.com/office/drawing/2014/main" id="{86B6D4D9-C071-4588-A0CB-37F3B93C48E0}"/>
               </a:ext>
             </a:extLst>
           </p:cNvPr>
@@ -2332,7 +2438,7 @@
           <p:cNvPr id="6" name="">
             <a:extLst xmlns:a="http://schemas.openxmlformats.org/drawingml/2006/main">
               <a:ext uri="{FF2B5EF4-FFF2-40B4-BE49-F238E27FC236}">
-                <a16:creationId xmlns:a16="http://schemas.microsoft.com/office/drawing/2014/main" id="{5091F809-8919-408F-9994-D8D322103088}"/>
+                <a16:creationId xmlns:a16="http://schemas.microsoft.com/office/drawing/2014/main" id="{E357A409-BDE7-44C3-87DB-064C08F832F2}"/>
               </a:ext>
             </a:extLst>
           </p:cNvPr>
@@ -2382,7 +2488,7 @@
           <p:cNvPr id="7" name="">
             <a:extLst xmlns:a="http://schemas.openxmlformats.org/drawingml/2006/main">
               <a:ext uri="{FF2B5EF4-FFF2-40B4-BE49-F238E27FC236}">
-                <a16:creationId xmlns:a16="http://schemas.microsoft.com/office/drawing/2014/main" id="{D2FA7529-45F5-44A2-B171-AA9E2E2BEB8C}"/>
+                <a16:creationId xmlns:a16="http://schemas.microsoft.com/office/drawing/2014/main" id="{C884BB1D-B896-46D3-9B02-0865E912AF12}"/>
               </a:ext>
             </a:extLst>
           </p:cNvPr>
@@ -2432,7 +2538,7 @@
           <p:cNvPr id="8" name="">
             <a:extLst xmlns:a="http://schemas.openxmlformats.org/drawingml/2006/main">
               <a:ext uri="{FF2B5EF4-FFF2-40B4-BE49-F238E27FC236}">
-                <a16:creationId xmlns:a16="http://schemas.microsoft.com/office/drawing/2014/main" id="{6FF5949B-0D9E-4816-828B-B814B90B1C1A}"/>
+                <a16:creationId xmlns:a16="http://schemas.microsoft.com/office/drawing/2014/main" id="{ED16BFC6-8729-4EFC-A995-1EFFC8A31624}"/>
               </a:ext>
             </a:extLst>
           </p:cNvPr>
@@ -2482,7 +2588,7 @@
           <p:cNvPr id="9" name="">
             <a:extLst xmlns:a="http://schemas.openxmlformats.org/drawingml/2006/main">
               <a:ext uri="{FF2B5EF4-FFF2-40B4-BE49-F238E27FC236}">
-                <a16:creationId xmlns:a16="http://schemas.microsoft.com/office/drawing/2014/main" id="{B19FC95B-2A6C-4626-9720-E6C1AE845201}"/>
+                <a16:creationId xmlns:a16="http://schemas.microsoft.com/office/drawing/2014/main" id="{057277D4-975A-446B-B44E-BD31CEE330E0}"/>
               </a:ext>
             </a:extLst>
           </p:cNvPr>
@@ -2532,7 +2638,7 @@
           <p:cNvPr id="10" name="">
             <a:extLst xmlns:a="http://schemas.openxmlformats.org/drawingml/2006/main">
               <a:ext uri="{FF2B5EF4-FFF2-40B4-BE49-F238E27FC236}">
-                <a16:creationId xmlns:a16="http://schemas.microsoft.com/office/drawing/2014/main" id="{AD0898B3-EED3-424B-9B04-9720CAB78AF9}"/>
+                <a16:creationId xmlns:a16="http://schemas.microsoft.com/office/drawing/2014/main" id="{F490E093-38BA-4121-8B63-6550B5F0EFE4}"/>
               </a:ext>
             </a:extLst>
           </p:cNvPr>
@@ -2582,7 +2688,7 @@
           <p:cNvPr id="11" name="">
             <a:extLst xmlns:a="http://schemas.openxmlformats.org/drawingml/2006/main">
               <a:ext uri="{FF2B5EF4-FFF2-40B4-BE49-F238E27FC236}">
-                <a16:creationId xmlns:a16="http://schemas.microsoft.com/office/drawing/2014/main" id="{FF683914-53E2-4ECA-A7C0-D38A2FE0CFF0}"/>
+                <a16:creationId xmlns:a16="http://schemas.microsoft.com/office/drawing/2014/main" id="{69D55FF7-F253-4A5D-B199-8A6FA18BD5E7}"/>
               </a:ext>
             </a:extLst>
           </p:cNvPr>
@@ -2630,7 +2736,7 @@
     </p:spTree>
     <p:extLst>
       <p:ext uri="{BB962C8B-B14F-4D97-AF65-F5344CB8AC3E}">
-        <p14:creationId xmlns:p14="http://schemas.microsoft.com/office/powerpoint/2010/main" val="699505266"/>
+        <p14:creationId xmlns:p14="http://schemas.microsoft.com/office/powerpoint/2010/main" val="1139630840"/>
       </p:ext>
     </p:extLst>
   </p:cSld>
@@ -2658,10 +2764,10 @@
       </p:grpSpPr>
       <p:sp>
         <p:nvSpPr>
-          <p:cNvPr id="18" name="">
-            <a:extLst xmlns:a="http://schemas.openxmlformats.org/drawingml/2006/main">
-              <a:ext uri="{FF2B5EF4-FFF2-40B4-BE49-F238E27FC236}">
-                <a16:creationId xmlns:a16="http://schemas.microsoft.com/office/drawing/2014/main" id="{91DB210A-25A4-4A0B-B0BD-8B4EC1F32DED}"/>
+          <p:cNvPr id="17" name="">
+            <a:extLst xmlns:a="http://schemas.openxmlformats.org/drawingml/2006/main">
+              <a:ext uri="{FF2B5EF4-FFF2-40B4-BE49-F238E27FC236}">
+                <a16:creationId xmlns:a16="http://schemas.microsoft.com/office/drawing/2014/main" id="{AD530860-9A8A-4888-B38D-E331E671FED7}"/>
               </a:ext>
             </a:extLst>
           </p:cNvPr>
@@ -2711,7 +2817,7 @@
           <p:cNvPr id="2" name="">
             <a:extLst xmlns:a="http://schemas.openxmlformats.org/drawingml/2006/main">
               <a:ext uri="{FF2B5EF4-FFF2-40B4-BE49-F238E27FC236}">
-                <a16:creationId xmlns:a16="http://schemas.microsoft.com/office/drawing/2014/main" id="{8F8840B8-F83C-4E9D-9179-D214E307826C}"/>
+                <a16:creationId xmlns:a16="http://schemas.microsoft.com/office/drawing/2014/main" id="{308F1D59-09FE-4477-A218-8681AD2C8542}"/>
               </a:ext>
             </a:extLst>
           </p:cNvPr>
@@ -2761,7 +2867,7 @@
           <p:cNvPr id="3" name="">
             <a:extLst xmlns:a="http://schemas.openxmlformats.org/drawingml/2006/main">
               <a:ext uri="{FF2B5EF4-FFF2-40B4-BE49-F238E27FC236}">
-                <a16:creationId xmlns:a16="http://schemas.microsoft.com/office/drawing/2014/main" id="{60E9ADB8-108A-4F0F-83FC-3452331C4160}"/>
+                <a16:creationId xmlns:a16="http://schemas.microsoft.com/office/drawing/2014/main" id="{21463CB0-08ED-4506-8BB0-A9EDC311B992}"/>
               </a:ext>
             </a:extLst>
           </p:cNvPr>
@@ -2811,7 +2917,7 @@
           <p:cNvPr id="4" name="">
             <a:extLst xmlns:a="http://schemas.openxmlformats.org/drawingml/2006/main">
               <a:ext uri="{FF2B5EF4-FFF2-40B4-BE49-F238E27FC236}">
-                <a16:creationId xmlns:a16="http://schemas.microsoft.com/office/drawing/2014/main" id="{C214AFFD-9E48-406A-A2B4-75164C2C3128}"/>
+                <a16:creationId xmlns:a16="http://schemas.microsoft.com/office/drawing/2014/main" id="{F9AA8060-D775-462E-AE4D-5E12C3A6341A}"/>
               </a:ext>
             </a:extLst>
           </p:cNvPr>
@@ -2861,7 +2967,7 @@
           <p:cNvPr id="5" name="">
             <a:extLst xmlns:a="http://schemas.openxmlformats.org/drawingml/2006/main">
               <a:ext uri="{FF2B5EF4-FFF2-40B4-BE49-F238E27FC236}">
-                <a16:creationId xmlns:a16="http://schemas.microsoft.com/office/drawing/2014/main" id="{D6AF8C16-DDC8-402E-A57C-0DDDAFACF6D3}"/>
+                <a16:creationId xmlns:a16="http://schemas.microsoft.com/office/drawing/2014/main" id="{6CD8B445-BF2E-45C2-810D-1201CED09F3A}"/>
               </a:ext>
             </a:extLst>
           </p:cNvPr>
@@ -2911,7 +3017,7 @@
           <p:cNvPr id="6" name="">
             <a:extLst xmlns:a="http://schemas.openxmlformats.org/drawingml/2006/main">
               <a:ext uri="{FF2B5EF4-FFF2-40B4-BE49-F238E27FC236}">
-                <a16:creationId xmlns:a16="http://schemas.microsoft.com/office/drawing/2014/main" id="{29EB4331-0504-4C90-BF64-467C24DA9AFA}"/>
+                <a16:creationId xmlns:a16="http://schemas.microsoft.com/office/drawing/2014/main" id="{55567DCC-79FB-499C-975B-63F2B1EB8C38}"/>
               </a:ext>
             </a:extLst>
           </p:cNvPr>
@@ -2961,7 +3067,7 @@
           <p:cNvPr id="7" name="">
             <a:extLst xmlns:a="http://schemas.openxmlformats.org/drawingml/2006/main">
               <a:ext uri="{FF2B5EF4-FFF2-40B4-BE49-F238E27FC236}">
-                <a16:creationId xmlns:a16="http://schemas.microsoft.com/office/drawing/2014/main" id="{F8B4BF22-6434-47C7-8846-D1A02281E390}"/>
+                <a16:creationId xmlns:a16="http://schemas.microsoft.com/office/drawing/2014/main" id="{11E7F8D9-EA30-4FD6-BB26-60702350C0F0}"/>
               </a:ext>
             </a:extLst>
           </p:cNvPr>
@@ -3011,7 +3117,7 @@
           <p:cNvPr id="8" name="">
             <a:extLst xmlns:a="http://schemas.openxmlformats.org/drawingml/2006/main">
               <a:ext uri="{FF2B5EF4-FFF2-40B4-BE49-F238E27FC236}">
-                <a16:creationId xmlns:a16="http://schemas.microsoft.com/office/drawing/2014/main" id="{94EEF04E-8104-46C4-A3B2-370FACB885B2}"/>
+                <a16:creationId xmlns:a16="http://schemas.microsoft.com/office/drawing/2014/main" id="{43CAEB04-AFD6-4004-B47F-915F949BAD1D}"/>
               </a:ext>
             </a:extLst>
           </p:cNvPr>
@@ -3061,7 +3167,7 @@
           <p:cNvPr id="9" name="">
             <a:extLst xmlns:a="http://schemas.openxmlformats.org/drawingml/2006/main">
               <a:ext uri="{FF2B5EF4-FFF2-40B4-BE49-F238E27FC236}">
-                <a16:creationId xmlns:a16="http://schemas.microsoft.com/office/drawing/2014/main" id="{86FA9148-DFA0-4AFB-A6C9-AFE416943730}"/>
+                <a16:creationId xmlns:a16="http://schemas.microsoft.com/office/drawing/2014/main" id="{F49A0774-6B8F-47DC-A254-E2343962B4D6}"/>
               </a:ext>
             </a:extLst>
           </p:cNvPr>
@@ -3111,7 +3217,7 @@
           <p:cNvPr id="10" name="">
             <a:extLst xmlns:a="http://schemas.openxmlformats.org/drawingml/2006/main">
               <a:ext uri="{FF2B5EF4-FFF2-40B4-BE49-F238E27FC236}">
-                <a16:creationId xmlns:a16="http://schemas.microsoft.com/office/drawing/2014/main" id="{D7E1BDAA-0E8F-4173-A340-1C568F864035}"/>
+                <a16:creationId xmlns:a16="http://schemas.microsoft.com/office/drawing/2014/main" id="{F38F8FE4-B4C6-4CFD-B527-6B4112274950}"/>
               </a:ext>
             </a:extLst>
           </p:cNvPr>
@@ -3161,7 +3267,7 @@
           <p:cNvPr id="11" name="">
             <a:extLst xmlns:a="http://schemas.openxmlformats.org/drawingml/2006/main">
               <a:ext uri="{FF2B5EF4-FFF2-40B4-BE49-F238E27FC236}">
-                <a16:creationId xmlns:a16="http://schemas.microsoft.com/office/drawing/2014/main" id="{E9A2D6CF-9D2F-43B2-AD43-9EE2B8C735FC}"/>
+                <a16:creationId xmlns:a16="http://schemas.microsoft.com/office/drawing/2014/main" id="{377DDC15-10FE-4D52-9E1B-AE16CD8A0071}"/>
               </a:ext>
             </a:extLst>
           </p:cNvPr>
@@ -3211,7 +3317,7 @@
           <p:cNvPr id="12" name="">
             <a:extLst xmlns:a="http://schemas.openxmlformats.org/drawingml/2006/main">
               <a:ext uri="{FF2B5EF4-FFF2-40B4-BE49-F238E27FC236}">
-                <a16:creationId xmlns:a16="http://schemas.microsoft.com/office/drawing/2014/main" id="{4BECB439-7726-4097-A75E-D6F16F3CCACD}"/>
+                <a16:creationId xmlns:a16="http://schemas.microsoft.com/office/drawing/2014/main" id="{C59EF465-7C4A-42EA-8AF0-9EC02FEC243D}"/>
               </a:ext>
             </a:extLst>
           </p:cNvPr>
@@ -3261,7 +3367,7 @@
           <p:cNvPr id="13" name="">
             <a:extLst xmlns:a="http://schemas.openxmlformats.org/drawingml/2006/main">
               <a:ext uri="{FF2B5EF4-FFF2-40B4-BE49-F238E27FC236}">
-                <a16:creationId xmlns:a16="http://schemas.microsoft.com/office/drawing/2014/main" id="{783577F5-4417-4D74-A8BA-851C772D5081}"/>
+                <a16:creationId xmlns:a16="http://schemas.microsoft.com/office/drawing/2014/main" id="{F4C51755-B5FD-475B-A3B4-9A05CB6DC516}"/>
               </a:ext>
             </a:extLst>
           </p:cNvPr>
@@ -3292,7 +3398,7 @@
           <p:cNvPr id="14" name="">
             <a:extLst xmlns:a="http://schemas.openxmlformats.org/drawingml/2006/main">
               <a:ext uri="{FF2B5EF4-FFF2-40B4-BE49-F238E27FC236}">
-                <a16:creationId xmlns:a16="http://schemas.microsoft.com/office/drawing/2014/main" id="{FBEABC84-4FAF-4258-A5B9-F78B0F8329AE}"/>
+                <a16:creationId xmlns:a16="http://schemas.microsoft.com/office/drawing/2014/main" id="{9CD41DA1-610C-40E8-91BC-C8C0ED4AE028}"/>
               </a:ext>
             </a:extLst>
           </p:cNvPr>
@@ -3342,57 +3448,7 @@
           <p:cNvPr id="15" name="">
             <a:extLst xmlns:a="http://schemas.openxmlformats.org/drawingml/2006/main">
               <a:ext uri="{FF2B5EF4-FFF2-40B4-BE49-F238E27FC236}">
-                <a16:creationId xmlns:a16="http://schemas.microsoft.com/office/drawing/2014/main" id="{32515FE4-0725-4A39-AAAF-04466838967F}"/>
-              </a:ext>
-            </a:extLst>
-          </p:cNvPr>
-          <p:cNvSpPr>
-            <a:spLocks xmlns:a="http://schemas.openxmlformats.org/drawingml/2006/main" noGrp="1"/>
-          </p:cNvSpPr>
-          <p:nvPr/>
-        </p:nvSpPr>
-        <p:spPr>
-          <a:xfrm xmlns:a="http://schemas.openxmlformats.org/drawingml/2006/main">
-            <a:off x="419100" y="6134100"/>
-            <a:ext cx="9334500" cy="190500"/>
-          </a:xfrm>
-          <a:prstGeom xmlns:a="http://schemas.openxmlformats.org/drawingml/2006/main" prst="rect">
-            <a:avLst/>
-          </a:prstGeom>
-          <a:noFill xmlns:a="http://schemas.openxmlformats.org/drawingml/2006/main"/>
-          <a:ln xmlns:a="http://schemas.openxmlformats.org/drawingml/2006/main" w="0">
-            <a:noFill/>
-            <a:prstDash val="solid"/>
-          </a:ln>
-        </p:spPr>
-        <p:txBody>
-          <a:bodyPr xmlns:a="http://schemas.openxmlformats.org/drawingml/2006/main" anchor="t"/>
-          <a:lstStyle xmlns:a="http://schemas.openxmlformats.org/drawingml/2006/main"/>
-          <a:p xmlns:a="http://schemas.openxmlformats.org/drawingml/2006/main">
-            <a:pPr algn="l">
-              <a:defRPr sz="825" b="0">
-                <a:solidFill>
-                  <a:srgbClr val="64748B"/>
-                </a:solidFill>
-              </a:defRPr>
-            </a:pPr>
-            <a:r>
-              <a:rPr sz="825" b="0">
-                <a:solidFill>
-                  <a:srgbClr val="64748B"/>
-                </a:solidFill>
-              </a:rPr>
-              <a:t>Source: project traces and latest master/synthetic report observations</a:t>
-            </a:r>
-          </a:p>
-        </p:txBody>
-      </p:sp>
-      <p:sp>
-        <p:nvSpPr>
-          <p:cNvPr id="16" name="">
-            <a:extLst xmlns:a="http://schemas.openxmlformats.org/drawingml/2006/main">
-              <a:ext uri="{FF2B5EF4-FFF2-40B4-BE49-F238E27FC236}">
-                <a16:creationId xmlns:a16="http://schemas.microsoft.com/office/drawing/2014/main" id="{425BDFD2-0FD2-43BA-9675-F762D8DD7511}"/>
+                <a16:creationId xmlns:a16="http://schemas.microsoft.com/office/drawing/2014/main" id="{24FFF9B2-D60F-4260-81DD-43CEAE7CA20B}"/>
               </a:ext>
             </a:extLst>
           </p:cNvPr>
@@ -3439,10 +3495,10 @@
       </p:sp>
       <p:sp>
         <p:nvSpPr>
-          <p:cNvPr id="17" name="">
-            <a:extLst xmlns:a="http://schemas.openxmlformats.org/drawingml/2006/main">
-              <a:ext uri="{FF2B5EF4-FFF2-40B4-BE49-F238E27FC236}">
-                <a16:creationId xmlns:a16="http://schemas.microsoft.com/office/drawing/2014/main" id="{027D9A8B-6529-41A8-B248-9D0F3813A1DB}"/>
+          <p:cNvPr id="16" name="">
+            <a:extLst xmlns:a="http://schemas.openxmlformats.org/drawingml/2006/main">
+              <a:ext uri="{FF2B5EF4-FFF2-40B4-BE49-F238E27FC236}">
+                <a16:creationId xmlns:a16="http://schemas.microsoft.com/office/drawing/2014/main" id="{EDC70FB8-D435-40B8-9E7F-CED5FDD8F262}"/>
               </a:ext>
             </a:extLst>
           </p:cNvPr>
@@ -3490,7 +3546,7 @@
     </p:spTree>
     <p:extLst>
       <p:ext uri="{BB962C8B-B14F-4D97-AF65-F5344CB8AC3E}">
-        <p14:creationId xmlns:p14="http://schemas.microsoft.com/office/powerpoint/2010/main" val="1565412291"/>
+        <p14:creationId xmlns:p14="http://schemas.microsoft.com/office/powerpoint/2010/main" val="1065304262"/>
       </p:ext>
     </p:extLst>
   </p:cSld>
@@ -3518,10 +3574,10 @@
       </p:grpSpPr>
       <p:sp>
         <p:nvSpPr>
-          <p:cNvPr id="15" name="">
-            <a:extLst xmlns:a="http://schemas.openxmlformats.org/drawingml/2006/main">
-              <a:ext uri="{FF2B5EF4-FFF2-40B4-BE49-F238E27FC236}">
-                <a16:creationId xmlns:a16="http://schemas.microsoft.com/office/drawing/2014/main" id="{1E6937AA-7ED1-4955-8D89-6CF767309345}"/>
+          <p:cNvPr id="17" name="">
+            <a:extLst xmlns:a="http://schemas.openxmlformats.org/drawingml/2006/main">
+              <a:ext uri="{FF2B5EF4-FFF2-40B4-BE49-F238E27FC236}">
+                <a16:creationId xmlns:a16="http://schemas.microsoft.com/office/drawing/2014/main" id="{A17E71E8-B245-4850-A7AF-52DCE50A47FB}"/>
               </a:ext>
             </a:extLst>
           </p:cNvPr>
@@ -3561,7 +3617,7 @@
                   <a:srgbClr val="0F172A"/>
                 </a:solidFill>
               </a:rPr>
-              <a:t>Hardware support can make hints enforceable</a:t>
+              <a:t>Potential hardware impact</a:t>
             </a:r>
           </a:p>
         </p:txBody>
@@ -3571,7 +3627,7 @@
           <p:cNvPr id="2" name="">
             <a:extLst xmlns:a="http://schemas.openxmlformats.org/drawingml/2006/main">
               <a:ext uri="{FF2B5EF4-FFF2-40B4-BE49-F238E27FC236}">
-                <a16:creationId xmlns:a16="http://schemas.microsoft.com/office/drawing/2014/main" id="{F54E1413-BCCA-4924-A78D-124D95775034}"/>
+                <a16:creationId xmlns:a16="http://schemas.microsoft.com/office/drawing/2014/main" id="{087D382F-2747-4FE1-A2A0-A65681099C3D}"/>
               </a:ext>
             </a:extLst>
           </p:cNvPr>
@@ -3611,7 +3667,7 @@
                   <a:srgbClr val="64748B"/>
                 </a:solidFill>
               </a:rPr>
-              <a:t>Treat KV as deadline-sensitive memory, not generic bytes.</a:t>
+              <a:t>These are ballpark research targets for tool-heavy agent workloads, not final measured claims.</a:t>
             </a:r>
           </a:p>
         </p:txBody>
@@ -3621,18 +3677,18 @@
           <p:cNvPr id="3" name="">
             <a:extLst xmlns:a="http://schemas.openxmlformats.org/drawingml/2006/main">
               <a:ext uri="{FF2B5EF4-FFF2-40B4-BE49-F238E27FC236}">
-                <a16:creationId xmlns:a16="http://schemas.microsoft.com/office/drawing/2014/main" id="{77CBAB5D-07DF-40A3-A6AE-76CFCEAA1821}"/>
-              </a:ext>
-            </a:extLst>
-          </p:cNvPr>
-          <p:cNvSpPr>
-            <a:spLocks xmlns:a="http://schemas.openxmlformats.org/drawingml/2006/main" noGrp="1"/>
-          </p:cNvSpPr>
-          <p:nvPr/>
-        </p:nvSpPr>
-        <p:spPr>
-          <a:xfrm xmlns:a="http://schemas.openxmlformats.org/drawingml/2006/main">
-            <a:off x="857250" y="1676400"/>
+                <a16:creationId xmlns:a16="http://schemas.microsoft.com/office/drawing/2014/main" id="{663BB759-66EF-4679-B1A9-1C036C6C1EB7}"/>
+              </a:ext>
+            </a:extLst>
+          </p:cNvPr>
+          <p:cNvSpPr>
+            <a:spLocks xmlns:a="http://schemas.openxmlformats.org/drawingml/2006/main" noGrp="1"/>
+          </p:cNvSpPr>
+          <p:nvPr/>
+        </p:nvSpPr>
+        <p:spPr>
+          <a:xfrm xmlns:a="http://schemas.openxmlformats.org/drawingml/2006/main">
+            <a:off x="876300" y="1562100"/>
             <a:ext cx="190500" cy="304800"/>
           </a:xfrm>
           <a:prstGeom xmlns:a="http://schemas.openxmlformats.org/drawingml/2006/main" prst="rect">
@@ -3671,19 +3727,19 @@
           <p:cNvPr id="4" name="">
             <a:extLst xmlns:a="http://schemas.openxmlformats.org/drawingml/2006/main">
               <a:ext uri="{FF2B5EF4-FFF2-40B4-BE49-F238E27FC236}">
-                <a16:creationId xmlns:a16="http://schemas.microsoft.com/office/drawing/2014/main" id="{D66BF7F1-9F5A-44F6-A824-8B0FA9A0E69A}"/>
-              </a:ext>
-            </a:extLst>
-          </p:cNvPr>
-          <p:cNvSpPr>
-            <a:spLocks xmlns:a="http://schemas.openxmlformats.org/drawingml/2006/main" noGrp="1"/>
-          </p:cNvSpPr>
-          <p:nvPr/>
-        </p:nvSpPr>
-        <p:spPr>
-          <a:xfrm xmlns:a="http://schemas.openxmlformats.org/drawingml/2006/main">
-            <a:off x="1143000" y="1695450"/>
-            <a:ext cx="9715500" cy="552450"/>
+                <a16:creationId xmlns:a16="http://schemas.microsoft.com/office/drawing/2014/main" id="{1A1E89B1-B4F3-437B-B60D-684E2E3757BA}"/>
+              </a:ext>
+            </a:extLst>
+          </p:cNvPr>
+          <p:cNvSpPr>
+            <a:spLocks xmlns:a="http://schemas.openxmlformats.org/drawingml/2006/main" noGrp="1"/>
+          </p:cNvSpPr>
+          <p:nvPr/>
+        </p:nvSpPr>
+        <p:spPr>
+          <a:xfrm xmlns:a="http://schemas.openxmlformats.org/drawingml/2006/main">
+            <a:off x="1162050" y="1581150"/>
+            <a:ext cx="9715500" cy="514350"/>
           </a:xfrm>
           <a:prstGeom xmlns:a="http://schemas.openxmlformats.org/drawingml/2006/main" prst="rect">
             <a:avLst/>
@@ -3711,7 +3767,7 @@
                   <a:srgbClr val="334155"/>
                 </a:solidFill>
               </a:rPr>
-              <a:t>KV page/session metadata: which agent owns this KV and how urgent is it?</a:t>
+              <a:t>10-30% lower post-tool replay latency when urgent KV is ready before replay.</a:t>
             </a:r>
           </a:p>
         </p:txBody>
@@ -3721,18 +3777,18 @@
           <p:cNvPr id="5" name="">
             <a:extLst xmlns:a="http://schemas.openxmlformats.org/drawingml/2006/main">
               <a:ext uri="{FF2B5EF4-FFF2-40B4-BE49-F238E27FC236}">
-                <a16:creationId xmlns:a16="http://schemas.microsoft.com/office/drawing/2014/main" id="{BF3088F7-E772-4344-8BFD-7DF675114801}"/>
-              </a:ext>
-            </a:extLst>
-          </p:cNvPr>
-          <p:cNvSpPr>
-            <a:spLocks xmlns:a="http://schemas.openxmlformats.org/drawingml/2006/main" noGrp="1"/>
-          </p:cNvSpPr>
-          <p:nvPr/>
-        </p:nvSpPr>
-        <p:spPr>
-          <a:xfrm xmlns:a="http://schemas.openxmlformats.org/drawingml/2006/main">
-            <a:off x="857250" y="2362200"/>
+                <a16:creationId xmlns:a16="http://schemas.microsoft.com/office/drawing/2014/main" id="{846EA34F-5FD7-42D3-9E0D-761201685738}"/>
+              </a:ext>
+            </a:extLst>
+          </p:cNvPr>
+          <p:cNvSpPr>
+            <a:spLocks xmlns:a="http://schemas.openxmlformats.org/drawingml/2006/main" noGrp="1"/>
+          </p:cNvSpPr>
+          <p:nvPr/>
+        </p:nvSpPr>
+        <p:spPr>
+          <a:xfrm xmlns:a="http://schemas.openxmlformats.org/drawingml/2006/main">
+            <a:off x="876300" y="2247900"/>
             <a:ext cx="190500" cy="304800"/>
           </a:xfrm>
           <a:prstGeom xmlns:a="http://schemas.openxmlformats.org/drawingml/2006/main" prst="rect">
@@ -3771,19 +3827,19 @@
           <p:cNvPr id="6" name="">
             <a:extLst xmlns:a="http://schemas.openxmlformats.org/drawingml/2006/main">
               <a:ext uri="{FF2B5EF4-FFF2-40B4-BE49-F238E27FC236}">
-                <a16:creationId xmlns:a16="http://schemas.microsoft.com/office/drawing/2014/main" id="{F3707825-552E-4DA5-BBA7-6EDE7E0AB5E7}"/>
-              </a:ext>
-            </a:extLst>
-          </p:cNvPr>
-          <p:cNvSpPr>
-            <a:spLocks xmlns:a="http://schemas.openxmlformats.org/drawingml/2006/main" noGrp="1"/>
-          </p:cNvSpPr>
-          <p:nvPr/>
-        </p:nvSpPr>
-        <p:spPr>
-          <a:xfrm xmlns:a="http://schemas.openxmlformats.org/drawingml/2006/main">
-            <a:off x="1143000" y="2381250"/>
-            <a:ext cx="9715500" cy="552450"/>
+                <a16:creationId xmlns:a16="http://schemas.microsoft.com/office/drawing/2014/main" id="{BF975120-3ECA-4B75-98F1-F38341BFB05E}"/>
+              </a:ext>
+            </a:extLst>
+          </p:cNvPr>
+          <p:cNvSpPr>
+            <a:spLocks xmlns:a="http://schemas.openxmlformats.org/drawingml/2006/main" noGrp="1"/>
+          </p:cNvSpPr>
+          <p:nvPr/>
+        </p:nvSpPr>
+        <p:spPr>
+          <a:xfrm xmlns:a="http://schemas.openxmlformats.org/drawingml/2006/main">
+            <a:off x="1162050" y="2266950"/>
+            <a:ext cx="9715500" cy="514350"/>
           </a:xfrm>
           <a:prstGeom xmlns:a="http://schemas.openxmlformats.org/drawingml/2006/main" prst="rect">
             <a:avLst/>
@@ -3811,7 +3867,7 @@
                   <a:srgbClr val="334155"/>
                 </a:solidFill>
               </a:rPr>
-              <a:t>Deadline-aware migration queue: move urgent KV before less urgent traffic.</a:t>
+              <a:t>20-50% fewer late KV reloads with deadline-aware movement scheduling.</a:t>
             </a:r>
           </a:p>
         </p:txBody>
@@ -3821,18 +3877,18 @@
           <p:cNvPr id="7" name="">
             <a:extLst xmlns:a="http://schemas.openxmlformats.org/drawingml/2006/main">
               <a:ext uri="{FF2B5EF4-FFF2-40B4-BE49-F238E27FC236}">
-                <a16:creationId xmlns:a16="http://schemas.microsoft.com/office/drawing/2014/main" id="{8943B917-1048-4752-AE70-A539A21A15B3}"/>
-              </a:ext>
-            </a:extLst>
-          </p:cNvPr>
-          <p:cNvSpPr>
-            <a:spLocks xmlns:a="http://schemas.openxmlformats.org/drawingml/2006/main" noGrp="1"/>
-          </p:cNvSpPr>
-          <p:nvPr/>
-        </p:nvSpPr>
-        <p:spPr>
-          <a:xfrm xmlns:a="http://schemas.openxmlformats.org/drawingml/2006/main">
-            <a:off x="857250" y="3048000"/>
+                <a16:creationId xmlns:a16="http://schemas.microsoft.com/office/drawing/2014/main" id="{057E3B91-29B2-48BC-AB82-048B49F42177}"/>
+              </a:ext>
+            </a:extLst>
+          </p:cNvPr>
+          <p:cNvSpPr>
+            <a:spLocks xmlns:a="http://schemas.openxmlformats.org/drawingml/2006/main" noGrp="1"/>
+          </p:cNvSpPr>
+          <p:nvPr/>
+        </p:nvSpPr>
+        <p:spPr>
+          <a:xfrm xmlns:a="http://schemas.openxmlformats.org/drawingml/2006/main">
+            <a:off x="876300" y="2933700"/>
             <a:ext cx="190500" cy="304800"/>
           </a:xfrm>
           <a:prstGeom xmlns:a="http://schemas.openxmlformats.org/drawingml/2006/main" prst="rect">
@@ -3851,6 +3907,206 @@
             <a:pPr algn="l">
               <a:defRPr sz="2025" b="1">
                 <a:solidFill>
+                  <a:srgbClr val="DC2626"/>
+                </a:solidFill>
+              </a:defRPr>
+            </a:pPr>
+            <a:r>
+              <a:rPr sz="2025" b="1">
+                <a:solidFill>
+                  <a:srgbClr val="DC2626"/>
+                </a:solidFill>
+              </a:rPr>
+              <a:t>•</a:t>
+            </a:r>
+          </a:p>
+        </p:txBody>
+      </p:sp>
+      <p:sp>
+        <p:nvSpPr>
+          <p:cNvPr id="8" name="">
+            <a:extLst xmlns:a="http://schemas.openxmlformats.org/drawingml/2006/main">
+              <a:ext uri="{FF2B5EF4-FFF2-40B4-BE49-F238E27FC236}">
+                <a16:creationId xmlns:a16="http://schemas.microsoft.com/office/drawing/2014/main" id="{C9847812-B562-4EC3-9B77-B24497214908}"/>
+              </a:ext>
+            </a:extLst>
+          </p:cNvPr>
+          <p:cNvSpPr>
+            <a:spLocks xmlns:a="http://schemas.openxmlformats.org/drawingml/2006/main" noGrp="1"/>
+          </p:cNvSpPr>
+          <p:nvPr/>
+        </p:nvSpPr>
+        <p:spPr>
+          <a:xfrm xmlns:a="http://schemas.openxmlformats.org/drawingml/2006/main">
+            <a:off x="1162050" y="2952750"/>
+            <a:ext cx="9715500" cy="514350"/>
+          </a:xfrm>
+          <a:prstGeom xmlns:a="http://schemas.openxmlformats.org/drawingml/2006/main" prst="rect">
+            <a:avLst/>
+          </a:prstGeom>
+          <a:noFill xmlns:a="http://schemas.openxmlformats.org/drawingml/2006/main"/>
+          <a:ln xmlns:a="http://schemas.openxmlformats.org/drawingml/2006/main" w="0">
+            <a:noFill/>
+            <a:prstDash val="solid"/>
+          </a:ln>
+        </p:spPr>
+        <p:txBody>
+          <a:bodyPr xmlns:a="http://schemas.openxmlformats.org/drawingml/2006/main" anchor="t"/>
+          <a:lstStyle xmlns:a="http://schemas.openxmlformats.org/drawingml/2006/main"/>
+          <a:p xmlns:a="http://schemas.openxmlformats.org/drawingml/2006/main">
+            <a:pPr algn="l">
+              <a:defRPr sz="1875" b="0">
+                <a:solidFill>
+                  <a:srgbClr val="334155"/>
+                </a:solidFill>
+              </a:defRPr>
+            </a:pPr>
+            <a:r>
+              <a:rPr sz="1875" b="0">
+                <a:solidFill>
+                  <a:srgbClr val="334155"/>
+                </a:solidFill>
+              </a:rPr>
+              <a:t>Lower tail latency by prioritizing soon-resuming agent sessions.</a:t>
+            </a:r>
+          </a:p>
+        </p:txBody>
+      </p:sp>
+      <p:sp>
+        <p:nvSpPr>
+          <p:cNvPr id="9" name="">
+            <a:extLst xmlns:a="http://schemas.openxmlformats.org/drawingml/2006/main">
+              <a:ext uri="{FF2B5EF4-FFF2-40B4-BE49-F238E27FC236}">
+                <a16:creationId xmlns:a16="http://schemas.microsoft.com/office/drawing/2014/main" id="{5CDC1431-3E15-4D87-8FF1-EAF8903922B8}"/>
+              </a:ext>
+            </a:extLst>
+          </p:cNvPr>
+          <p:cNvSpPr>
+            <a:spLocks xmlns:a="http://schemas.openxmlformats.org/drawingml/2006/main" noGrp="1"/>
+          </p:cNvSpPr>
+          <p:nvPr/>
+        </p:nvSpPr>
+        <p:spPr>
+          <a:xfrm xmlns:a="http://schemas.openxmlformats.org/drawingml/2006/main">
+            <a:off x="876300" y="3619500"/>
+            <a:ext cx="190500" cy="304800"/>
+          </a:xfrm>
+          <a:prstGeom xmlns:a="http://schemas.openxmlformats.org/drawingml/2006/main" prst="rect">
+            <a:avLst/>
+          </a:prstGeom>
+          <a:noFill xmlns:a="http://schemas.openxmlformats.org/drawingml/2006/main"/>
+          <a:ln xmlns:a="http://schemas.openxmlformats.org/drawingml/2006/main" w="0">
+            <a:noFill/>
+            <a:prstDash val="solid"/>
+          </a:ln>
+        </p:spPr>
+        <p:txBody>
+          <a:bodyPr xmlns:a="http://schemas.openxmlformats.org/drawingml/2006/main" anchor="t"/>
+          <a:lstStyle xmlns:a="http://schemas.openxmlformats.org/drawingml/2006/main"/>
+          <a:p xmlns:a="http://schemas.openxmlformats.org/drawingml/2006/main">
+            <a:pPr algn="l">
+              <a:defRPr sz="2025" b="1">
+                <a:solidFill>
+                  <a:srgbClr val="0891B2"/>
+                </a:solidFill>
+              </a:defRPr>
+            </a:pPr>
+            <a:r>
+              <a:rPr sz="2025" b="1">
+                <a:solidFill>
+                  <a:srgbClr val="0891B2"/>
+                </a:solidFill>
+              </a:rPr>
+              <a:t>•</a:t>
+            </a:r>
+          </a:p>
+        </p:txBody>
+      </p:sp>
+      <p:sp>
+        <p:nvSpPr>
+          <p:cNvPr id="10" name="">
+            <a:extLst xmlns:a="http://schemas.openxmlformats.org/drawingml/2006/main">
+              <a:ext uri="{FF2B5EF4-FFF2-40B4-BE49-F238E27FC236}">
+                <a16:creationId xmlns:a16="http://schemas.microsoft.com/office/drawing/2014/main" id="{32167948-09C3-40B4-96AA-2E9B806C6247}"/>
+              </a:ext>
+            </a:extLst>
+          </p:cNvPr>
+          <p:cNvSpPr>
+            <a:spLocks xmlns:a="http://schemas.openxmlformats.org/drawingml/2006/main" noGrp="1"/>
+          </p:cNvSpPr>
+          <p:nvPr/>
+        </p:nvSpPr>
+        <p:spPr>
+          <a:xfrm xmlns:a="http://schemas.openxmlformats.org/drawingml/2006/main">
+            <a:off x="1162050" y="3638550"/>
+            <a:ext cx="9715500" cy="514350"/>
+          </a:xfrm>
+          <a:prstGeom xmlns:a="http://schemas.openxmlformats.org/drawingml/2006/main" prst="rect">
+            <a:avLst/>
+          </a:prstGeom>
+          <a:noFill xmlns:a="http://schemas.openxmlformats.org/drawingml/2006/main"/>
+          <a:ln xmlns:a="http://schemas.openxmlformats.org/drawingml/2006/main" w="0">
+            <a:noFill/>
+            <a:prstDash val="solid"/>
+          </a:ln>
+        </p:spPr>
+        <p:txBody>
+          <a:bodyPr xmlns:a="http://schemas.openxmlformats.org/drawingml/2006/main" anchor="t"/>
+          <a:lstStyle xmlns:a="http://schemas.openxmlformats.org/drawingml/2006/main"/>
+          <a:p xmlns:a="http://schemas.openxmlformats.org/drawingml/2006/main">
+            <a:pPr algn="l">
+              <a:defRPr sz="1875" b="0">
+                <a:solidFill>
+                  <a:srgbClr val="334155"/>
+                </a:solidFill>
+              </a:defRPr>
+            </a:pPr>
+            <a:r>
+              <a:rPr sz="1875" b="0">
+                <a:solidFill>
+                  <a:srgbClr val="334155"/>
+                </a:solidFill>
+              </a:rPr>
+              <a:t>Less wasted bandwidth by avoiding too-early or evicted-before-use prefetch.</a:t>
+            </a:r>
+          </a:p>
+        </p:txBody>
+      </p:sp>
+      <p:sp>
+        <p:nvSpPr>
+          <p:cNvPr id="11" name="">
+            <a:extLst xmlns:a="http://schemas.openxmlformats.org/drawingml/2006/main">
+              <a:ext uri="{FF2B5EF4-FFF2-40B4-BE49-F238E27FC236}">
+                <a16:creationId xmlns:a16="http://schemas.microsoft.com/office/drawing/2014/main" id="{EEEA7C81-0285-467E-9749-DFCABDAA451A}"/>
+              </a:ext>
+            </a:extLst>
+          </p:cNvPr>
+          <p:cNvSpPr>
+            <a:spLocks xmlns:a="http://schemas.openxmlformats.org/drawingml/2006/main" noGrp="1"/>
+          </p:cNvSpPr>
+          <p:nvPr/>
+        </p:nvSpPr>
+        <p:spPr>
+          <a:xfrm xmlns:a="http://schemas.openxmlformats.org/drawingml/2006/main">
+            <a:off x="876300" y="4305300"/>
+            <a:ext cx="190500" cy="304800"/>
+          </a:xfrm>
+          <a:prstGeom xmlns:a="http://schemas.openxmlformats.org/drawingml/2006/main" prst="rect">
+            <a:avLst/>
+          </a:prstGeom>
+          <a:noFill xmlns:a="http://schemas.openxmlformats.org/drawingml/2006/main"/>
+          <a:ln xmlns:a="http://schemas.openxmlformats.org/drawingml/2006/main" w="0">
+            <a:noFill/>
+            <a:prstDash val="solid"/>
+          </a:ln>
+        </p:spPr>
+        <p:txBody>
+          <a:bodyPr xmlns:a="http://schemas.openxmlformats.org/drawingml/2006/main" anchor="t"/>
+          <a:lstStyle xmlns:a="http://schemas.openxmlformats.org/drawingml/2006/main"/>
+          <a:p xmlns:a="http://schemas.openxmlformats.org/drawingml/2006/main">
+            <a:pPr algn="l">
+              <a:defRPr sz="2025" b="1">
+                <a:solidFill>
                   <a:srgbClr val="16A34A"/>
                 </a:solidFill>
               </a:defRPr>
@@ -3868,22 +4124,22 @@
       </p:sp>
       <p:sp>
         <p:nvSpPr>
-          <p:cNvPr id="8" name="">
-            <a:extLst xmlns:a="http://schemas.openxmlformats.org/drawingml/2006/main">
-              <a:ext uri="{FF2B5EF4-FFF2-40B4-BE49-F238E27FC236}">
-                <a16:creationId xmlns:a16="http://schemas.microsoft.com/office/drawing/2014/main" id="{3C9A5F95-4B9F-4DD3-95CA-5A0830830D50}"/>
-              </a:ext>
-            </a:extLst>
-          </p:cNvPr>
-          <p:cNvSpPr>
-            <a:spLocks xmlns:a="http://schemas.openxmlformats.org/drawingml/2006/main" noGrp="1"/>
-          </p:cNvSpPr>
-          <p:nvPr/>
-        </p:nvSpPr>
-        <p:spPr>
-          <a:xfrm xmlns:a="http://schemas.openxmlformats.org/drawingml/2006/main">
-            <a:off x="1143000" y="3067050"/>
-            <a:ext cx="9715500" cy="552450"/>
+          <p:cNvPr id="12" name="">
+            <a:extLst xmlns:a="http://schemas.openxmlformats.org/drawingml/2006/main">
+              <a:ext uri="{FF2B5EF4-FFF2-40B4-BE49-F238E27FC236}">
+                <a16:creationId xmlns:a16="http://schemas.microsoft.com/office/drawing/2014/main" id="{06BA6338-6ABB-4F87-A225-A0A8FFE33F96}"/>
+              </a:ext>
+            </a:extLst>
+          </p:cNvPr>
+          <p:cNvSpPr>
+            <a:spLocks xmlns:a="http://schemas.openxmlformats.org/drawingml/2006/main" noGrp="1"/>
+          </p:cNvSpPr>
+          <p:nvPr/>
+        </p:nvSpPr>
+        <p:spPr>
+          <a:xfrm xmlns:a="http://schemas.openxmlformats.org/drawingml/2006/main">
+            <a:off x="1162050" y="4324350"/>
+            <a:ext cx="9715500" cy="514350"/>
           </a:xfrm>
           <a:prstGeom xmlns:a="http://schemas.openxmlformats.org/drawingml/2006/main" prst="rect">
             <a:avLst/>
@@ -3911,128 +4167,28 @@
                   <a:srgbClr val="334155"/>
                 </a:solidFill>
               </a:rPr>
-              <a:t>Residency protection: keep useful prefetched KV from being evicted too early.</a:t>
-            </a:r>
-          </a:p>
-        </p:txBody>
-      </p:sp>
-      <p:sp>
-        <p:nvSpPr>
-          <p:cNvPr id="9" name="">
-            <a:extLst xmlns:a="http://schemas.openxmlformats.org/drawingml/2006/main">
-              <a:ext uri="{FF2B5EF4-FFF2-40B4-BE49-F238E27FC236}">
-                <a16:creationId xmlns:a16="http://schemas.microsoft.com/office/drawing/2014/main" id="{76E21428-B143-46A2-88DE-76783CBAAC94}"/>
-              </a:ext>
-            </a:extLst>
-          </p:cNvPr>
-          <p:cNvSpPr>
-            <a:spLocks xmlns:a="http://schemas.openxmlformats.org/drawingml/2006/main" noGrp="1"/>
-          </p:cNvSpPr>
-          <p:nvPr/>
-        </p:nvSpPr>
-        <p:spPr>
-          <a:xfrm xmlns:a="http://schemas.openxmlformats.org/drawingml/2006/main">
-            <a:off x="857250" y="3733800"/>
-            <a:ext cx="190500" cy="304800"/>
-          </a:xfrm>
-          <a:prstGeom xmlns:a="http://schemas.openxmlformats.org/drawingml/2006/main" prst="rect">
-            <a:avLst/>
-          </a:prstGeom>
-          <a:noFill xmlns:a="http://schemas.openxmlformats.org/drawingml/2006/main"/>
-          <a:ln xmlns:a="http://schemas.openxmlformats.org/drawingml/2006/main" w="0">
-            <a:noFill/>
-            <a:prstDash val="solid"/>
-          </a:ln>
-        </p:spPr>
-        <p:txBody>
-          <a:bodyPr xmlns:a="http://schemas.openxmlformats.org/drawingml/2006/main" anchor="t"/>
-          <a:lstStyle xmlns:a="http://schemas.openxmlformats.org/drawingml/2006/main"/>
-          <a:p xmlns:a="http://schemas.openxmlformats.org/drawingml/2006/main">
-            <a:pPr algn="l">
-              <a:defRPr sz="2025" b="1">
-                <a:solidFill>
-                  <a:srgbClr val="0891B2"/>
-                </a:solidFill>
-              </a:defRPr>
-            </a:pPr>
-            <a:r>
-              <a:rPr sz="2025" b="1">
-                <a:solidFill>
-                  <a:srgbClr val="0891B2"/>
-                </a:solidFill>
-              </a:rPr>
-              <a:t>•</a:t>
-            </a:r>
-          </a:p>
-        </p:txBody>
-      </p:sp>
-      <p:sp>
-        <p:nvSpPr>
-          <p:cNvPr id="10" name="">
-            <a:extLst xmlns:a="http://schemas.openxmlformats.org/drawingml/2006/main">
-              <a:ext uri="{FF2B5EF4-FFF2-40B4-BE49-F238E27FC236}">
-                <a16:creationId xmlns:a16="http://schemas.microsoft.com/office/drawing/2014/main" id="{A368743A-D401-435C-9F1A-2FE1B385E614}"/>
-              </a:ext>
-            </a:extLst>
-          </p:cNvPr>
-          <p:cNvSpPr>
-            <a:spLocks xmlns:a="http://schemas.openxmlformats.org/drawingml/2006/main" noGrp="1"/>
-          </p:cNvSpPr>
-          <p:nvPr/>
-        </p:nvSpPr>
-        <p:spPr>
-          <a:xfrm xmlns:a="http://schemas.openxmlformats.org/drawingml/2006/main">
-            <a:off x="1143000" y="3752850"/>
-            <a:ext cx="9715500" cy="552450"/>
-          </a:xfrm>
-          <a:prstGeom xmlns:a="http://schemas.openxmlformats.org/drawingml/2006/main" prst="rect">
-            <a:avLst/>
-          </a:prstGeom>
-          <a:noFill xmlns:a="http://schemas.openxmlformats.org/drawingml/2006/main"/>
-          <a:ln xmlns:a="http://schemas.openxmlformats.org/drawingml/2006/main" w="0">
-            <a:noFill/>
-            <a:prstDash val="solid"/>
-          </a:ln>
-        </p:spPr>
-        <p:txBody>
-          <a:bodyPr xmlns:a="http://schemas.openxmlformats.org/drawingml/2006/main" anchor="t"/>
-          <a:lstStyle xmlns:a="http://schemas.openxmlformats.org/drawingml/2006/main"/>
-          <a:p xmlns:a="http://schemas.openxmlformats.org/drawingml/2006/main">
-            <a:pPr algn="l">
-              <a:defRPr sz="1875" b="0">
-                <a:solidFill>
-                  <a:srgbClr val="334155"/>
-                </a:solidFill>
-              </a:defRPr>
-            </a:pPr>
-            <a:r>
-              <a:rPr sz="1875" b="0">
-                <a:solidFill>
-                  <a:srgbClr val="334155"/>
-                </a:solidFill>
-              </a:rPr>
-              <a:t>Telemetry: count useful, late, wasted, and evicted-before-use movement.</a:t>
-            </a:r>
-          </a:p>
-        </p:txBody>
-      </p:sp>
-      <p:sp>
-        <p:nvSpPr>
-          <p:cNvPr id="11" name="">
-            <a:extLst xmlns:a="http://schemas.openxmlformats.org/drawingml/2006/main">
-              <a:ext uri="{FF2B5EF4-FFF2-40B4-BE49-F238E27FC236}">
-                <a16:creationId xmlns:a16="http://schemas.microsoft.com/office/drawing/2014/main" id="{EFEA2AE4-BD7F-4E37-B459-90B6B44105BC}"/>
-              </a:ext>
-            </a:extLst>
-          </p:cNvPr>
-          <p:cNvSpPr>
-            <a:spLocks xmlns:a="http://schemas.openxmlformats.org/drawingml/2006/main" noGrp="1"/>
-          </p:cNvSpPr>
-          <p:nvPr/>
-        </p:nvSpPr>
-        <p:spPr>
-          <a:xfrm xmlns:a="http://schemas.openxmlformats.org/drawingml/2006/main">
-            <a:off x="419100" y="5257800"/>
+              <a:t>Better effective HBM use through KV-aware residency and eviction choices.</a:t>
+            </a:r>
+          </a:p>
+        </p:txBody>
+      </p:sp>
+      <p:sp>
+        <p:nvSpPr>
+          <p:cNvPr id="13" name="">
+            <a:extLst xmlns:a="http://schemas.openxmlformats.org/drawingml/2006/main">
+              <a:ext uri="{FF2B5EF4-FFF2-40B4-BE49-F238E27FC236}">
+                <a16:creationId xmlns:a16="http://schemas.microsoft.com/office/drawing/2014/main" id="{3FA7312E-F183-431F-8F93-5DAE042BA5FB}"/>
+              </a:ext>
+            </a:extLst>
+          </p:cNvPr>
+          <p:cNvSpPr>
+            <a:spLocks xmlns:a="http://schemas.openxmlformats.org/drawingml/2006/main" noGrp="1"/>
+          </p:cNvSpPr>
+          <p:nvPr/>
+        </p:nvSpPr>
+        <p:spPr>
+          <a:xfrm xmlns:a="http://schemas.openxmlformats.org/drawingml/2006/main">
+            <a:off x="419100" y="5429250"/>
             <a:ext cx="11353800" cy="11430"/>
           </a:xfrm>
           <a:prstGeom xmlns:a="http://schemas.openxmlformats.org/drawingml/2006/main" prst="rect">
@@ -4049,22 +4205,22 @@
       </p:sp>
       <p:sp>
         <p:nvSpPr>
-          <p:cNvPr id="12" name="">
-            <a:extLst xmlns:a="http://schemas.openxmlformats.org/drawingml/2006/main">
-              <a:ext uri="{FF2B5EF4-FFF2-40B4-BE49-F238E27FC236}">
-                <a16:creationId xmlns:a16="http://schemas.microsoft.com/office/drawing/2014/main" id="{6DF91589-E793-4FA2-AD35-6D03A61B6932}"/>
-              </a:ext>
-            </a:extLst>
-          </p:cNvPr>
-          <p:cNvSpPr>
-            <a:spLocks xmlns:a="http://schemas.openxmlformats.org/drawingml/2006/main" noGrp="1"/>
-          </p:cNvSpPr>
-          <p:nvPr/>
-        </p:nvSpPr>
-        <p:spPr>
-          <a:xfrm xmlns:a="http://schemas.openxmlformats.org/drawingml/2006/main">
-            <a:off x="857250" y="5524500"/>
-            <a:ext cx="10191750" cy="476250"/>
+          <p:cNvPr id="14" name="">
+            <a:extLst xmlns:a="http://schemas.openxmlformats.org/drawingml/2006/main">
+              <a:ext uri="{FF2B5EF4-FFF2-40B4-BE49-F238E27FC236}">
+                <a16:creationId xmlns:a16="http://schemas.microsoft.com/office/drawing/2014/main" id="{639028E8-520B-4226-A2C0-8FAA493F2E8D}"/>
+              </a:ext>
+            </a:extLst>
+          </p:cNvPr>
+          <p:cNvSpPr>
+            <a:spLocks xmlns:a="http://schemas.openxmlformats.org/drawingml/2006/main" noGrp="1"/>
+          </p:cNvSpPr>
+          <p:nvPr/>
+        </p:nvSpPr>
+        <p:spPr>
+          <a:xfrm xmlns:a="http://schemas.openxmlformats.org/drawingml/2006/main">
+            <a:off x="876300" y="5657850"/>
+            <a:ext cx="9906000" cy="285750"/>
           </a:xfrm>
           <a:prstGeom xmlns:a="http://schemas.openxmlformats.org/drawingml/2006/main" prst="rect">
             <a:avLst/>
@@ -4080,29 +4236,29 @@
           <a:lstStyle xmlns:a="http://schemas.openxmlformats.org/drawingml/2006/main"/>
           <a:p xmlns:a="http://schemas.openxmlformats.org/drawingml/2006/main">
             <a:pPr algn="ctr">
-              <a:defRPr sz="1575" b="1">
+              <a:defRPr sz="1725" b="1">
                 <a:solidFill>
                   <a:srgbClr val="0F172A"/>
                 </a:solidFill>
               </a:defRPr>
             </a:pPr>
             <a:r>
-              <a:rPr sz="1575" b="1">
+              <a:rPr sz="1725" b="1">
                 <a:solidFill>
                   <a:srgbClr val="0F172A"/>
                 </a:solidFill>
               </a:rPr>
-              <a:t>Research question: how much replay latency and wasted movement can be avoided when KV movement has session context, priority, deadline, protection, and telemetry?</a:t>
-            </a:r>
-          </a:p>
-        </p:txBody>
-      </p:sp>
-      <p:sp>
-        <p:nvSpPr>
-          <p:cNvPr id="13" name="">
-            <a:extLst xmlns:a="http://schemas.openxmlformats.org/drawingml/2006/main">
-              <a:ext uri="{FF2B5EF4-FFF2-40B4-BE49-F238E27FC236}">
-                <a16:creationId xmlns:a16="http://schemas.microsoft.com/office/drawing/2014/main" id="{95978198-DB2C-4E0D-9A3D-1C740208B01F}"/>
+              <a:t>The prototype is designed to turn these targets into measured numbers.</a:t>
+            </a:r>
+          </a:p>
+        </p:txBody>
+      </p:sp>
+      <p:sp>
+        <p:nvSpPr>
+          <p:cNvPr id="15" name="">
+            <a:extLst xmlns:a="http://schemas.openxmlformats.org/drawingml/2006/main">
+              <a:ext uri="{FF2B5EF4-FFF2-40B4-BE49-F238E27FC236}">
+                <a16:creationId xmlns:a16="http://schemas.microsoft.com/office/drawing/2014/main" id="{3E425FD8-A71B-4051-BB24-F53DC7532F82}"/>
               </a:ext>
             </a:extLst>
           </p:cNvPr>
@@ -4149,10 +4305,10 @@
       </p:sp>
       <p:sp>
         <p:nvSpPr>
-          <p:cNvPr id="14" name="">
-            <a:extLst xmlns:a="http://schemas.openxmlformats.org/drawingml/2006/main">
-              <a:ext uri="{FF2B5EF4-FFF2-40B4-BE49-F238E27FC236}">
-                <a16:creationId xmlns:a16="http://schemas.microsoft.com/office/drawing/2014/main" id="{97F36FA5-D15F-4C9D-8554-C215CC38C810}"/>
+          <p:cNvPr id="16" name="">
+            <a:extLst xmlns:a="http://schemas.openxmlformats.org/drawingml/2006/main">
+              <a:ext uri="{FF2B5EF4-FFF2-40B4-BE49-F238E27FC236}">
+                <a16:creationId xmlns:a16="http://schemas.microsoft.com/office/drawing/2014/main" id="{69CB595C-9341-49C6-8E80-D836A1C5C1D8}"/>
               </a:ext>
             </a:extLst>
           </p:cNvPr>
@@ -4200,7 +4356,717 @@
     </p:spTree>
     <p:extLst>
       <p:ext uri="{BB962C8B-B14F-4D97-AF65-F5344CB8AC3E}">
-        <p14:creationId xmlns:p14="http://schemas.microsoft.com/office/powerpoint/2010/main" val="679460108"/>
+        <p14:creationId xmlns:p14="http://schemas.microsoft.com/office/powerpoint/2010/main" val="1432180523"/>
+      </p:ext>
+    </p:extLst>
+  </p:cSld>
+</p:sld>
+</file>
+
+<file path=ppt/slides/slide12.xml><?xml version="1.0" encoding="utf-8"?>
+<p:sld xmlns:p="http://schemas.openxmlformats.org/presentationml/2006/main">
+  <p:cSld>
+    <p:bg>
+      <p:bgPr>
+        <a:solidFill xmlns:a="http://schemas.openxmlformats.org/drawingml/2006/main">
+          <a:srgbClr val="FFFFFF"/>
+        </a:solidFill>
+      </p:bgPr>
+    </p:bg>
+    <p:spTree>
+      <p:nvGrpSpPr>
+        <p:cNvPr id="1" name=""/>
+        <p:cNvGrpSpPr/>
+        <p:nvPr/>
+      </p:nvGrpSpPr>
+      <p:grpSpPr>
+        <a:xfrm xmlns:a="http://schemas.openxmlformats.org/drawingml/2006/main"/>
+      </p:grpSpPr>
+      <p:sp>
+        <p:nvSpPr>
+          <p:cNvPr id="15" name="">
+            <a:extLst xmlns:a="http://schemas.openxmlformats.org/drawingml/2006/main">
+              <a:ext uri="{FF2B5EF4-FFF2-40B4-BE49-F238E27FC236}">
+                <a16:creationId xmlns:a16="http://schemas.microsoft.com/office/drawing/2014/main" id="{C6B4CE2F-9957-46EE-AA82-73CDE40669C9}"/>
+              </a:ext>
+            </a:extLst>
+          </p:cNvPr>
+          <p:cNvSpPr>
+            <a:spLocks xmlns:a="http://schemas.openxmlformats.org/drawingml/2006/main" noGrp="1"/>
+          </p:cNvSpPr>
+          <p:nvPr/>
+        </p:nvSpPr>
+        <p:spPr>
+          <a:xfrm xmlns:a="http://schemas.openxmlformats.org/drawingml/2006/main">
+            <a:off x="419100" y="323850"/>
+            <a:ext cx="10744200" cy="552450"/>
+          </a:xfrm>
+          <a:prstGeom xmlns:a="http://schemas.openxmlformats.org/drawingml/2006/main" prst="rect">
+            <a:avLst/>
+          </a:prstGeom>
+          <a:noFill xmlns:a="http://schemas.openxmlformats.org/drawingml/2006/main"/>
+          <a:ln xmlns:a="http://schemas.openxmlformats.org/drawingml/2006/main" w="0">
+            <a:noFill/>
+            <a:prstDash val="solid"/>
+          </a:ln>
+        </p:spPr>
+        <p:txBody>
+          <a:bodyPr xmlns:a="http://schemas.openxmlformats.org/drawingml/2006/main" anchor="t"/>
+          <a:lstStyle xmlns:a="http://schemas.openxmlformats.org/drawingml/2006/main"/>
+          <a:p xmlns:a="http://schemas.openxmlformats.org/drawingml/2006/main">
+            <a:pPr algn="l">
+              <a:defRPr sz="2925" b="1">
+                <a:solidFill>
+                  <a:srgbClr val="0F172A"/>
+                </a:solidFill>
+              </a:defRPr>
+            </a:pPr>
+            <a:r>
+              <a:rPr sz="2925" b="1">
+                <a:solidFill>
+                  <a:srgbClr val="0F172A"/>
+                </a:solidFill>
+              </a:rPr>
+              <a:t>Hardware support can make hints enforceable</a:t>
+            </a:r>
+          </a:p>
+        </p:txBody>
+      </p:sp>
+      <p:sp>
+        <p:nvSpPr>
+          <p:cNvPr id="2" name="">
+            <a:extLst xmlns:a="http://schemas.openxmlformats.org/drawingml/2006/main">
+              <a:ext uri="{FF2B5EF4-FFF2-40B4-BE49-F238E27FC236}">
+                <a16:creationId xmlns:a16="http://schemas.microsoft.com/office/drawing/2014/main" id="{C8BA4646-951F-4A26-B02C-3536C023CBBC}"/>
+              </a:ext>
+            </a:extLst>
+          </p:cNvPr>
+          <p:cNvSpPr>
+            <a:spLocks xmlns:a="http://schemas.openxmlformats.org/drawingml/2006/main" noGrp="1"/>
+          </p:cNvSpPr>
+          <p:nvPr/>
+        </p:nvSpPr>
+        <p:spPr>
+          <a:xfrm xmlns:a="http://schemas.openxmlformats.org/drawingml/2006/main">
+            <a:off x="438150" y="914400"/>
+            <a:ext cx="10477500" cy="457200"/>
+          </a:xfrm>
+          <a:prstGeom xmlns:a="http://schemas.openxmlformats.org/drawingml/2006/main" prst="rect">
+            <a:avLst/>
+          </a:prstGeom>
+          <a:noFill xmlns:a="http://schemas.openxmlformats.org/drawingml/2006/main"/>
+          <a:ln xmlns:a="http://schemas.openxmlformats.org/drawingml/2006/main" w="0">
+            <a:noFill/>
+            <a:prstDash val="solid"/>
+          </a:ln>
+        </p:spPr>
+        <p:txBody>
+          <a:bodyPr xmlns:a="http://schemas.openxmlformats.org/drawingml/2006/main" anchor="t"/>
+          <a:lstStyle xmlns:a="http://schemas.openxmlformats.org/drawingml/2006/main"/>
+          <a:p xmlns:a="http://schemas.openxmlformats.org/drawingml/2006/main">
+            <a:pPr algn="l">
+              <a:defRPr sz="1500" b="0">
+                <a:solidFill>
+                  <a:srgbClr val="64748B"/>
+                </a:solidFill>
+              </a:defRPr>
+            </a:pPr>
+            <a:r>
+              <a:rPr sz="1500" b="0">
+                <a:solidFill>
+                  <a:srgbClr val="64748B"/>
+                </a:solidFill>
+              </a:rPr>
+              <a:t>Treat KV as deadline-sensitive memory, not generic bytes.</a:t>
+            </a:r>
+          </a:p>
+        </p:txBody>
+      </p:sp>
+      <p:sp>
+        <p:nvSpPr>
+          <p:cNvPr id="3" name="">
+            <a:extLst xmlns:a="http://schemas.openxmlformats.org/drawingml/2006/main">
+              <a:ext uri="{FF2B5EF4-FFF2-40B4-BE49-F238E27FC236}">
+                <a16:creationId xmlns:a16="http://schemas.microsoft.com/office/drawing/2014/main" id="{4F4852DE-D899-4EFF-B849-F84FD246E05F}"/>
+              </a:ext>
+            </a:extLst>
+          </p:cNvPr>
+          <p:cNvSpPr>
+            <a:spLocks xmlns:a="http://schemas.openxmlformats.org/drawingml/2006/main" noGrp="1"/>
+          </p:cNvSpPr>
+          <p:nvPr/>
+        </p:nvSpPr>
+        <p:spPr>
+          <a:xfrm xmlns:a="http://schemas.openxmlformats.org/drawingml/2006/main">
+            <a:off x="857250" y="1676400"/>
+            <a:ext cx="190500" cy="304800"/>
+          </a:xfrm>
+          <a:prstGeom xmlns:a="http://schemas.openxmlformats.org/drawingml/2006/main" prst="rect">
+            <a:avLst/>
+          </a:prstGeom>
+          <a:noFill xmlns:a="http://schemas.openxmlformats.org/drawingml/2006/main"/>
+          <a:ln xmlns:a="http://schemas.openxmlformats.org/drawingml/2006/main" w="0">
+            <a:noFill/>
+            <a:prstDash val="solid"/>
+          </a:ln>
+        </p:spPr>
+        <p:txBody>
+          <a:bodyPr xmlns:a="http://schemas.openxmlformats.org/drawingml/2006/main" anchor="t"/>
+          <a:lstStyle xmlns:a="http://schemas.openxmlformats.org/drawingml/2006/main"/>
+          <a:p xmlns:a="http://schemas.openxmlformats.org/drawingml/2006/main">
+            <a:pPr algn="l">
+              <a:defRPr sz="2025" b="1">
+                <a:solidFill>
+                  <a:srgbClr val="2563EB"/>
+                </a:solidFill>
+              </a:defRPr>
+            </a:pPr>
+            <a:r>
+              <a:rPr sz="2025" b="1">
+                <a:solidFill>
+                  <a:srgbClr val="2563EB"/>
+                </a:solidFill>
+              </a:rPr>
+              <a:t>•</a:t>
+            </a:r>
+          </a:p>
+        </p:txBody>
+      </p:sp>
+      <p:sp>
+        <p:nvSpPr>
+          <p:cNvPr id="4" name="">
+            <a:extLst xmlns:a="http://schemas.openxmlformats.org/drawingml/2006/main">
+              <a:ext uri="{FF2B5EF4-FFF2-40B4-BE49-F238E27FC236}">
+                <a16:creationId xmlns:a16="http://schemas.microsoft.com/office/drawing/2014/main" id="{876932F4-7DEA-4FCA-9CAA-2DEE3ECE5417}"/>
+              </a:ext>
+            </a:extLst>
+          </p:cNvPr>
+          <p:cNvSpPr>
+            <a:spLocks xmlns:a="http://schemas.openxmlformats.org/drawingml/2006/main" noGrp="1"/>
+          </p:cNvSpPr>
+          <p:nvPr/>
+        </p:nvSpPr>
+        <p:spPr>
+          <a:xfrm xmlns:a="http://schemas.openxmlformats.org/drawingml/2006/main">
+            <a:off x="1143000" y="1695450"/>
+            <a:ext cx="9715500" cy="552450"/>
+          </a:xfrm>
+          <a:prstGeom xmlns:a="http://schemas.openxmlformats.org/drawingml/2006/main" prst="rect">
+            <a:avLst/>
+          </a:prstGeom>
+          <a:noFill xmlns:a="http://schemas.openxmlformats.org/drawingml/2006/main"/>
+          <a:ln xmlns:a="http://schemas.openxmlformats.org/drawingml/2006/main" w="0">
+            <a:noFill/>
+            <a:prstDash val="solid"/>
+          </a:ln>
+        </p:spPr>
+        <p:txBody>
+          <a:bodyPr xmlns:a="http://schemas.openxmlformats.org/drawingml/2006/main" anchor="t"/>
+          <a:lstStyle xmlns:a="http://schemas.openxmlformats.org/drawingml/2006/main"/>
+          <a:p xmlns:a="http://schemas.openxmlformats.org/drawingml/2006/main">
+            <a:pPr algn="l">
+              <a:defRPr sz="1875" b="0">
+                <a:solidFill>
+                  <a:srgbClr val="334155"/>
+                </a:solidFill>
+              </a:defRPr>
+            </a:pPr>
+            <a:r>
+              <a:rPr sz="1875" b="0">
+                <a:solidFill>
+                  <a:srgbClr val="334155"/>
+                </a:solidFill>
+              </a:rPr>
+              <a:t>KV page/session metadata: which agent owns this KV and how urgent is it?</a:t>
+            </a:r>
+          </a:p>
+        </p:txBody>
+      </p:sp>
+      <p:sp>
+        <p:nvSpPr>
+          <p:cNvPr id="5" name="">
+            <a:extLst xmlns:a="http://schemas.openxmlformats.org/drawingml/2006/main">
+              <a:ext uri="{FF2B5EF4-FFF2-40B4-BE49-F238E27FC236}">
+                <a16:creationId xmlns:a16="http://schemas.microsoft.com/office/drawing/2014/main" id="{D8973758-DDDC-40E4-AD2E-0A0ADB4641B0}"/>
+              </a:ext>
+            </a:extLst>
+          </p:cNvPr>
+          <p:cNvSpPr>
+            <a:spLocks xmlns:a="http://schemas.openxmlformats.org/drawingml/2006/main" noGrp="1"/>
+          </p:cNvSpPr>
+          <p:nvPr/>
+        </p:nvSpPr>
+        <p:spPr>
+          <a:xfrm xmlns:a="http://schemas.openxmlformats.org/drawingml/2006/main">
+            <a:off x="857250" y="2362200"/>
+            <a:ext cx="190500" cy="304800"/>
+          </a:xfrm>
+          <a:prstGeom xmlns:a="http://schemas.openxmlformats.org/drawingml/2006/main" prst="rect">
+            <a:avLst/>
+          </a:prstGeom>
+          <a:noFill xmlns:a="http://schemas.openxmlformats.org/drawingml/2006/main"/>
+          <a:ln xmlns:a="http://schemas.openxmlformats.org/drawingml/2006/main" w="0">
+            <a:noFill/>
+            <a:prstDash val="solid"/>
+          </a:ln>
+        </p:spPr>
+        <p:txBody>
+          <a:bodyPr xmlns:a="http://schemas.openxmlformats.org/drawingml/2006/main" anchor="t"/>
+          <a:lstStyle xmlns:a="http://schemas.openxmlformats.org/drawingml/2006/main"/>
+          <a:p xmlns:a="http://schemas.openxmlformats.org/drawingml/2006/main">
+            <a:pPr algn="l">
+              <a:defRPr sz="2025" b="1">
+                <a:solidFill>
+                  <a:srgbClr val="9333EA"/>
+                </a:solidFill>
+              </a:defRPr>
+            </a:pPr>
+            <a:r>
+              <a:rPr sz="2025" b="1">
+                <a:solidFill>
+                  <a:srgbClr val="9333EA"/>
+                </a:solidFill>
+              </a:rPr>
+              <a:t>•</a:t>
+            </a:r>
+          </a:p>
+        </p:txBody>
+      </p:sp>
+      <p:sp>
+        <p:nvSpPr>
+          <p:cNvPr id="6" name="">
+            <a:extLst xmlns:a="http://schemas.openxmlformats.org/drawingml/2006/main">
+              <a:ext uri="{FF2B5EF4-FFF2-40B4-BE49-F238E27FC236}">
+                <a16:creationId xmlns:a16="http://schemas.microsoft.com/office/drawing/2014/main" id="{F3879348-7A93-40D8-BE6A-74DD062F7D68}"/>
+              </a:ext>
+            </a:extLst>
+          </p:cNvPr>
+          <p:cNvSpPr>
+            <a:spLocks xmlns:a="http://schemas.openxmlformats.org/drawingml/2006/main" noGrp="1"/>
+          </p:cNvSpPr>
+          <p:nvPr/>
+        </p:nvSpPr>
+        <p:spPr>
+          <a:xfrm xmlns:a="http://schemas.openxmlformats.org/drawingml/2006/main">
+            <a:off x="1143000" y="2381250"/>
+            <a:ext cx="9715500" cy="552450"/>
+          </a:xfrm>
+          <a:prstGeom xmlns:a="http://schemas.openxmlformats.org/drawingml/2006/main" prst="rect">
+            <a:avLst/>
+          </a:prstGeom>
+          <a:noFill xmlns:a="http://schemas.openxmlformats.org/drawingml/2006/main"/>
+          <a:ln xmlns:a="http://schemas.openxmlformats.org/drawingml/2006/main" w="0">
+            <a:noFill/>
+            <a:prstDash val="solid"/>
+          </a:ln>
+        </p:spPr>
+        <p:txBody>
+          <a:bodyPr xmlns:a="http://schemas.openxmlformats.org/drawingml/2006/main" anchor="t"/>
+          <a:lstStyle xmlns:a="http://schemas.openxmlformats.org/drawingml/2006/main"/>
+          <a:p xmlns:a="http://schemas.openxmlformats.org/drawingml/2006/main">
+            <a:pPr algn="l">
+              <a:defRPr sz="1875" b="0">
+                <a:solidFill>
+                  <a:srgbClr val="334155"/>
+                </a:solidFill>
+              </a:defRPr>
+            </a:pPr>
+            <a:r>
+              <a:rPr sz="1875" b="0">
+                <a:solidFill>
+                  <a:srgbClr val="334155"/>
+                </a:solidFill>
+              </a:rPr>
+              <a:t>Deadline-aware migration queue: move urgent KV before less urgent traffic.</a:t>
+            </a:r>
+          </a:p>
+        </p:txBody>
+      </p:sp>
+      <p:sp>
+        <p:nvSpPr>
+          <p:cNvPr id="7" name="">
+            <a:extLst xmlns:a="http://schemas.openxmlformats.org/drawingml/2006/main">
+              <a:ext uri="{FF2B5EF4-FFF2-40B4-BE49-F238E27FC236}">
+                <a16:creationId xmlns:a16="http://schemas.microsoft.com/office/drawing/2014/main" id="{430CA2DD-3F4B-4152-83B5-E3D468BCC102}"/>
+              </a:ext>
+            </a:extLst>
+          </p:cNvPr>
+          <p:cNvSpPr>
+            <a:spLocks xmlns:a="http://schemas.openxmlformats.org/drawingml/2006/main" noGrp="1"/>
+          </p:cNvSpPr>
+          <p:nvPr/>
+        </p:nvSpPr>
+        <p:spPr>
+          <a:xfrm xmlns:a="http://schemas.openxmlformats.org/drawingml/2006/main">
+            <a:off x="857250" y="3048000"/>
+            <a:ext cx="190500" cy="304800"/>
+          </a:xfrm>
+          <a:prstGeom xmlns:a="http://schemas.openxmlformats.org/drawingml/2006/main" prst="rect">
+            <a:avLst/>
+          </a:prstGeom>
+          <a:noFill xmlns:a="http://schemas.openxmlformats.org/drawingml/2006/main"/>
+          <a:ln xmlns:a="http://schemas.openxmlformats.org/drawingml/2006/main" w="0">
+            <a:noFill/>
+            <a:prstDash val="solid"/>
+          </a:ln>
+        </p:spPr>
+        <p:txBody>
+          <a:bodyPr xmlns:a="http://schemas.openxmlformats.org/drawingml/2006/main" anchor="t"/>
+          <a:lstStyle xmlns:a="http://schemas.openxmlformats.org/drawingml/2006/main"/>
+          <a:p xmlns:a="http://schemas.openxmlformats.org/drawingml/2006/main">
+            <a:pPr algn="l">
+              <a:defRPr sz="2025" b="1">
+                <a:solidFill>
+                  <a:srgbClr val="16A34A"/>
+                </a:solidFill>
+              </a:defRPr>
+            </a:pPr>
+            <a:r>
+              <a:rPr sz="2025" b="1">
+                <a:solidFill>
+                  <a:srgbClr val="16A34A"/>
+                </a:solidFill>
+              </a:rPr>
+              <a:t>•</a:t>
+            </a:r>
+          </a:p>
+        </p:txBody>
+      </p:sp>
+      <p:sp>
+        <p:nvSpPr>
+          <p:cNvPr id="8" name="">
+            <a:extLst xmlns:a="http://schemas.openxmlformats.org/drawingml/2006/main">
+              <a:ext uri="{FF2B5EF4-FFF2-40B4-BE49-F238E27FC236}">
+                <a16:creationId xmlns:a16="http://schemas.microsoft.com/office/drawing/2014/main" id="{B8185251-AD8C-43E0-AAD5-FF1AF03A930D}"/>
+              </a:ext>
+            </a:extLst>
+          </p:cNvPr>
+          <p:cNvSpPr>
+            <a:spLocks xmlns:a="http://schemas.openxmlformats.org/drawingml/2006/main" noGrp="1"/>
+          </p:cNvSpPr>
+          <p:nvPr/>
+        </p:nvSpPr>
+        <p:spPr>
+          <a:xfrm xmlns:a="http://schemas.openxmlformats.org/drawingml/2006/main">
+            <a:off x="1143000" y="3067050"/>
+            <a:ext cx="9715500" cy="552450"/>
+          </a:xfrm>
+          <a:prstGeom xmlns:a="http://schemas.openxmlformats.org/drawingml/2006/main" prst="rect">
+            <a:avLst/>
+          </a:prstGeom>
+          <a:noFill xmlns:a="http://schemas.openxmlformats.org/drawingml/2006/main"/>
+          <a:ln xmlns:a="http://schemas.openxmlformats.org/drawingml/2006/main" w="0">
+            <a:noFill/>
+            <a:prstDash val="solid"/>
+          </a:ln>
+        </p:spPr>
+        <p:txBody>
+          <a:bodyPr xmlns:a="http://schemas.openxmlformats.org/drawingml/2006/main" anchor="t"/>
+          <a:lstStyle xmlns:a="http://schemas.openxmlformats.org/drawingml/2006/main"/>
+          <a:p xmlns:a="http://schemas.openxmlformats.org/drawingml/2006/main">
+            <a:pPr algn="l">
+              <a:defRPr sz="1875" b="0">
+                <a:solidFill>
+                  <a:srgbClr val="334155"/>
+                </a:solidFill>
+              </a:defRPr>
+            </a:pPr>
+            <a:r>
+              <a:rPr sz="1875" b="0">
+                <a:solidFill>
+                  <a:srgbClr val="334155"/>
+                </a:solidFill>
+              </a:rPr>
+              <a:t>Residency protection: keep useful prefetched KV from being evicted too early.</a:t>
+            </a:r>
+          </a:p>
+        </p:txBody>
+      </p:sp>
+      <p:sp>
+        <p:nvSpPr>
+          <p:cNvPr id="9" name="">
+            <a:extLst xmlns:a="http://schemas.openxmlformats.org/drawingml/2006/main">
+              <a:ext uri="{FF2B5EF4-FFF2-40B4-BE49-F238E27FC236}">
+                <a16:creationId xmlns:a16="http://schemas.microsoft.com/office/drawing/2014/main" id="{C9823D08-C122-4D61-8DD8-7C3F73109D73}"/>
+              </a:ext>
+            </a:extLst>
+          </p:cNvPr>
+          <p:cNvSpPr>
+            <a:spLocks xmlns:a="http://schemas.openxmlformats.org/drawingml/2006/main" noGrp="1"/>
+          </p:cNvSpPr>
+          <p:nvPr/>
+        </p:nvSpPr>
+        <p:spPr>
+          <a:xfrm xmlns:a="http://schemas.openxmlformats.org/drawingml/2006/main">
+            <a:off x="857250" y="3733800"/>
+            <a:ext cx="190500" cy="304800"/>
+          </a:xfrm>
+          <a:prstGeom xmlns:a="http://schemas.openxmlformats.org/drawingml/2006/main" prst="rect">
+            <a:avLst/>
+          </a:prstGeom>
+          <a:noFill xmlns:a="http://schemas.openxmlformats.org/drawingml/2006/main"/>
+          <a:ln xmlns:a="http://schemas.openxmlformats.org/drawingml/2006/main" w="0">
+            <a:noFill/>
+            <a:prstDash val="solid"/>
+          </a:ln>
+        </p:spPr>
+        <p:txBody>
+          <a:bodyPr xmlns:a="http://schemas.openxmlformats.org/drawingml/2006/main" anchor="t"/>
+          <a:lstStyle xmlns:a="http://schemas.openxmlformats.org/drawingml/2006/main"/>
+          <a:p xmlns:a="http://schemas.openxmlformats.org/drawingml/2006/main">
+            <a:pPr algn="l">
+              <a:defRPr sz="2025" b="1">
+                <a:solidFill>
+                  <a:srgbClr val="0891B2"/>
+                </a:solidFill>
+              </a:defRPr>
+            </a:pPr>
+            <a:r>
+              <a:rPr sz="2025" b="1">
+                <a:solidFill>
+                  <a:srgbClr val="0891B2"/>
+                </a:solidFill>
+              </a:rPr>
+              <a:t>•</a:t>
+            </a:r>
+          </a:p>
+        </p:txBody>
+      </p:sp>
+      <p:sp>
+        <p:nvSpPr>
+          <p:cNvPr id="10" name="">
+            <a:extLst xmlns:a="http://schemas.openxmlformats.org/drawingml/2006/main">
+              <a:ext uri="{FF2B5EF4-FFF2-40B4-BE49-F238E27FC236}">
+                <a16:creationId xmlns:a16="http://schemas.microsoft.com/office/drawing/2014/main" id="{8E3E0687-7278-4F44-BAD8-FC78975C012E}"/>
+              </a:ext>
+            </a:extLst>
+          </p:cNvPr>
+          <p:cNvSpPr>
+            <a:spLocks xmlns:a="http://schemas.openxmlformats.org/drawingml/2006/main" noGrp="1"/>
+          </p:cNvSpPr>
+          <p:nvPr/>
+        </p:nvSpPr>
+        <p:spPr>
+          <a:xfrm xmlns:a="http://schemas.openxmlformats.org/drawingml/2006/main">
+            <a:off x="1143000" y="3752850"/>
+            <a:ext cx="9715500" cy="552450"/>
+          </a:xfrm>
+          <a:prstGeom xmlns:a="http://schemas.openxmlformats.org/drawingml/2006/main" prst="rect">
+            <a:avLst/>
+          </a:prstGeom>
+          <a:noFill xmlns:a="http://schemas.openxmlformats.org/drawingml/2006/main"/>
+          <a:ln xmlns:a="http://schemas.openxmlformats.org/drawingml/2006/main" w="0">
+            <a:noFill/>
+            <a:prstDash val="solid"/>
+          </a:ln>
+        </p:spPr>
+        <p:txBody>
+          <a:bodyPr xmlns:a="http://schemas.openxmlformats.org/drawingml/2006/main" anchor="t"/>
+          <a:lstStyle xmlns:a="http://schemas.openxmlformats.org/drawingml/2006/main"/>
+          <a:p xmlns:a="http://schemas.openxmlformats.org/drawingml/2006/main">
+            <a:pPr algn="l">
+              <a:defRPr sz="1875" b="0">
+                <a:solidFill>
+                  <a:srgbClr val="334155"/>
+                </a:solidFill>
+              </a:defRPr>
+            </a:pPr>
+            <a:r>
+              <a:rPr sz="1875" b="0">
+                <a:solidFill>
+                  <a:srgbClr val="334155"/>
+                </a:solidFill>
+              </a:rPr>
+              <a:t>Telemetry: count useful, late, wasted, and evicted-before-use movement.</a:t>
+            </a:r>
+          </a:p>
+        </p:txBody>
+      </p:sp>
+      <p:sp>
+        <p:nvSpPr>
+          <p:cNvPr id="11" name="">
+            <a:extLst xmlns:a="http://schemas.openxmlformats.org/drawingml/2006/main">
+              <a:ext uri="{FF2B5EF4-FFF2-40B4-BE49-F238E27FC236}">
+                <a16:creationId xmlns:a16="http://schemas.microsoft.com/office/drawing/2014/main" id="{D5403DF6-E996-4CB5-BE90-7C7B3ECDB7D4}"/>
+              </a:ext>
+            </a:extLst>
+          </p:cNvPr>
+          <p:cNvSpPr>
+            <a:spLocks xmlns:a="http://schemas.openxmlformats.org/drawingml/2006/main" noGrp="1"/>
+          </p:cNvSpPr>
+          <p:nvPr/>
+        </p:nvSpPr>
+        <p:spPr>
+          <a:xfrm xmlns:a="http://schemas.openxmlformats.org/drawingml/2006/main">
+            <a:off x="419100" y="5257800"/>
+            <a:ext cx="11353800" cy="11430"/>
+          </a:xfrm>
+          <a:prstGeom xmlns:a="http://schemas.openxmlformats.org/drawingml/2006/main" prst="rect">
+            <a:avLst/>
+          </a:prstGeom>
+          <a:solidFill xmlns:a="http://schemas.openxmlformats.org/drawingml/2006/main">
+            <a:srgbClr val="CBD5E1"/>
+          </a:solidFill>
+          <a:ln xmlns:a="http://schemas.openxmlformats.org/drawingml/2006/main" w="0">
+            <a:noFill/>
+            <a:prstDash val="solid"/>
+          </a:ln>
+        </p:spPr>
+      </p:sp>
+      <p:sp>
+        <p:nvSpPr>
+          <p:cNvPr id="12" name="">
+            <a:extLst xmlns:a="http://schemas.openxmlformats.org/drawingml/2006/main">
+              <a:ext uri="{FF2B5EF4-FFF2-40B4-BE49-F238E27FC236}">
+                <a16:creationId xmlns:a16="http://schemas.microsoft.com/office/drawing/2014/main" id="{9CE9AFF2-BA4B-47AF-90D9-938EBB0CD3D0}"/>
+              </a:ext>
+            </a:extLst>
+          </p:cNvPr>
+          <p:cNvSpPr>
+            <a:spLocks xmlns:a="http://schemas.openxmlformats.org/drawingml/2006/main" noGrp="1"/>
+          </p:cNvSpPr>
+          <p:nvPr/>
+        </p:nvSpPr>
+        <p:spPr>
+          <a:xfrm xmlns:a="http://schemas.openxmlformats.org/drawingml/2006/main">
+            <a:off x="857250" y="5524500"/>
+            <a:ext cx="10191750" cy="476250"/>
+          </a:xfrm>
+          <a:prstGeom xmlns:a="http://schemas.openxmlformats.org/drawingml/2006/main" prst="rect">
+            <a:avLst/>
+          </a:prstGeom>
+          <a:noFill xmlns:a="http://schemas.openxmlformats.org/drawingml/2006/main"/>
+          <a:ln xmlns:a="http://schemas.openxmlformats.org/drawingml/2006/main" w="0">
+            <a:noFill/>
+            <a:prstDash val="solid"/>
+          </a:ln>
+        </p:spPr>
+        <p:txBody>
+          <a:bodyPr xmlns:a="http://schemas.openxmlformats.org/drawingml/2006/main" anchor="t"/>
+          <a:lstStyle xmlns:a="http://schemas.openxmlformats.org/drawingml/2006/main"/>
+          <a:p xmlns:a="http://schemas.openxmlformats.org/drawingml/2006/main">
+            <a:pPr algn="ctr">
+              <a:defRPr sz="1575" b="1">
+                <a:solidFill>
+                  <a:srgbClr val="0F172A"/>
+                </a:solidFill>
+              </a:defRPr>
+            </a:pPr>
+            <a:r>
+              <a:rPr sz="1575" b="1">
+                <a:solidFill>
+                  <a:srgbClr val="0F172A"/>
+                </a:solidFill>
+              </a:rPr>
+              <a:t>Research question: how much replay latency and wasted movement can be avoided when KV movement has session context, priority, deadline, protection, and telemetry?</a:t>
+            </a:r>
+          </a:p>
+        </p:txBody>
+      </p:sp>
+      <p:sp>
+        <p:nvSpPr>
+          <p:cNvPr id="13" name="">
+            <a:extLst xmlns:a="http://schemas.openxmlformats.org/drawingml/2006/main">
+              <a:ext uri="{FF2B5EF4-FFF2-40B4-BE49-F238E27FC236}">
+                <a16:creationId xmlns:a16="http://schemas.microsoft.com/office/drawing/2014/main" id="{881D0C17-6E5D-4173-9986-E3CAADF83BF4}"/>
+              </a:ext>
+            </a:extLst>
+          </p:cNvPr>
+          <p:cNvSpPr>
+            <a:spLocks xmlns:a="http://schemas.openxmlformats.org/drawingml/2006/main" noGrp="1"/>
+          </p:cNvSpPr>
+          <p:nvPr/>
+        </p:nvSpPr>
+        <p:spPr>
+          <a:xfrm xmlns:a="http://schemas.openxmlformats.org/drawingml/2006/main">
+            <a:off x="419100" y="6400800"/>
+            <a:ext cx="3619500" cy="209550"/>
+          </a:xfrm>
+          <a:prstGeom xmlns:a="http://schemas.openxmlformats.org/drawingml/2006/main" prst="rect">
+            <a:avLst/>
+          </a:prstGeom>
+          <a:noFill xmlns:a="http://schemas.openxmlformats.org/drawingml/2006/main"/>
+          <a:ln xmlns:a="http://schemas.openxmlformats.org/drawingml/2006/main" w="0">
+            <a:noFill/>
+            <a:prstDash val="solid"/>
+          </a:ln>
+        </p:spPr>
+        <p:txBody>
+          <a:bodyPr xmlns:a="http://schemas.openxmlformats.org/drawingml/2006/main" anchor="t"/>
+          <a:lstStyle xmlns:a="http://schemas.openxmlformats.org/drawingml/2006/main"/>
+          <a:p xmlns:a="http://schemas.openxmlformats.org/drawingml/2006/main">
+            <a:pPr algn="l">
+              <a:defRPr sz="975" b="0">
+                <a:solidFill>
+                  <a:srgbClr val="64748B"/>
+                </a:solidFill>
+              </a:defRPr>
+            </a:pPr>
+            <a:r>
+              <a:rPr sz="975" b="0">
+                <a:solidFill>
+                  <a:srgbClr val="64748B"/>
+                </a:solidFill>
+              </a:rPr>
+              <a:t>Agent-aware KV movement</a:t>
+            </a:r>
+          </a:p>
+        </p:txBody>
+      </p:sp>
+      <p:sp>
+        <p:nvSpPr>
+          <p:cNvPr id="14" name="">
+            <a:extLst xmlns:a="http://schemas.openxmlformats.org/drawingml/2006/main">
+              <a:ext uri="{FF2B5EF4-FFF2-40B4-BE49-F238E27FC236}">
+                <a16:creationId xmlns:a16="http://schemas.microsoft.com/office/drawing/2014/main" id="{90CD33D0-6E80-4F97-A505-3981B2AA1F69}"/>
+              </a:ext>
+            </a:extLst>
+          </p:cNvPr>
+          <p:cNvSpPr>
+            <a:spLocks xmlns:a="http://schemas.openxmlformats.org/drawingml/2006/main" noGrp="1"/>
+          </p:cNvSpPr>
+          <p:nvPr/>
+        </p:nvSpPr>
+        <p:spPr>
+          <a:xfrm xmlns:a="http://schemas.openxmlformats.org/drawingml/2006/main">
+            <a:off x="11315700" y="6400800"/>
+            <a:ext cx="438150" cy="209550"/>
+          </a:xfrm>
+          <a:prstGeom xmlns:a="http://schemas.openxmlformats.org/drawingml/2006/main" prst="rect">
+            <a:avLst/>
+          </a:prstGeom>
+          <a:noFill xmlns:a="http://schemas.openxmlformats.org/drawingml/2006/main"/>
+          <a:ln xmlns:a="http://schemas.openxmlformats.org/drawingml/2006/main" w="0">
+            <a:noFill/>
+            <a:prstDash val="solid"/>
+          </a:ln>
+        </p:spPr>
+        <p:txBody>
+          <a:bodyPr xmlns:a="http://schemas.openxmlformats.org/drawingml/2006/main" anchor="t"/>
+          <a:lstStyle xmlns:a="http://schemas.openxmlformats.org/drawingml/2006/main"/>
+          <a:p xmlns:a="http://schemas.openxmlformats.org/drawingml/2006/main">
+            <a:pPr algn="r">
+              <a:defRPr sz="975" b="0">
+                <a:solidFill>
+                  <a:srgbClr val="64748B"/>
+                </a:solidFill>
+              </a:defRPr>
+            </a:pPr>
+            <a:r>
+              <a:rPr sz="975" b="0">
+                <a:solidFill>
+                  <a:srgbClr val="64748B"/>
+                </a:solidFill>
+              </a:rPr>
+              <a:t>12</a:t>
+            </a:r>
+          </a:p>
+        </p:txBody>
+      </p:sp>
+    </p:spTree>
+    <p:extLst>
+      <p:ext uri="{BB962C8B-B14F-4D97-AF65-F5344CB8AC3E}">
+        <p14:creationId xmlns:p14="http://schemas.microsoft.com/office/powerpoint/2010/main" val="1981364023"/>
       </p:ext>
     </p:extLst>
   </p:cSld>
@@ -4228,10 +5094,10 @@
       </p:grpSpPr>
       <p:sp>
         <p:nvSpPr>
-          <p:cNvPr id="13" name="">
-            <a:extLst xmlns:a="http://schemas.openxmlformats.org/drawingml/2006/main">
-              <a:ext uri="{FF2B5EF4-FFF2-40B4-BE49-F238E27FC236}">
-                <a16:creationId xmlns:a16="http://schemas.microsoft.com/office/drawing/2014/main" id="{AC00B649-4EEA-491C-AF89-EFEF0E9BBB48}"/>
+          <p:cNvPr id="12" name="">
+            <a:extLst xmlns:a="http://schemas.openxmlformats.org/drawingml/2006/main">
+              <a:ext uri="{FF2B5EF4-FFF2-40B4-BE49-F238E27FC236}">
+                <a16:creationId xmlns:a16="http://schemas.microsoft.com/office/drawing/2014/main" id="{3CC51281-9FDC-4EB3-A6AD-CB29F39716F7}"/>
               </a:ext>
             </a:extLst>
           </p:cNvPr>
@@ -4281,7 +5147,7 @@
           <p:cNvPr id="2" name="">
             <a:extLst xmlns:a="http://schemas.openxmlformats.org/drawingml/2006/main">
               <a:ext uri="{FF2B5EF4-FFF2-40B4-BE49-F238E27FC236}">
-                <a16:creationId xmlns:a16="http://schemas.microsoft.com/office/drawing/2014/main" id="{8C5BB232-A6D5-4BB1-8B61-3219285FE92F}"/>
+                <a16:creationId xmlns:a16="http://schemas.microsoft.com/office/drawing/2014/main" id="{77788F02-BA0B-42A4-BBA0-A84F91360122}"/>
               </a:ext>
             </a:extLst>
           </p:cNvPr>
@@ -4331,7 +5197,7 @@
           <p:cNvPr id="3" name="">
             <a:extLst xmlns:a="http://schemas.openxmlformats.org/drawingml/2006/main">
               <a:ext uri="{FF2B5EF4-FFF2-40B4-BE49-F238E27FC236}">
-                <a16:creationId xmlns:a16="http://schemas.microsoft.com/office/drawing/2014/main" id="{476A1B60-7F4F-4922-96B5-AF12CC974761}"/>
+                <a16:creationId xmlns:a16="http://schemas.microsoft.com/office/drawing/2014/main" id="{06BCC0E1-994C-46E5-B2D1-5406224A279E}"/>
               </a:ext>
             </a:extLst>
           </p:cNvPr>
@@ -4381,7 +5247,7 @@
           <p:cNvPr id="4" name="">
             <a:extLst xmlns:a="http://schemas.openxmlformats.org/drawingml/2006/main">
               <a:ext uri="{FF2B5EF4-FFF2-40B4-BE49-F238E27FC236}">
-                <a16:creationId xmlns:a16="http://schemas.microsoft.com/office/drawing/2014/main" id="{BC91FB7A-BAEE-46E9-A5AB-3FBEE5D52AF2}"/>
+                <a16:creationId xmlns:a16="http://schemas.microsoft.com/office/drawing/2014/main" id="{3A8D7A4D-E741-41D4-88F7-F835002EEA6A}"/>
               </a:ext>
             </a:extLst>
           </p:cNvPr>
@@ -4431,7 +5297,7 @@
           <p:cNvPr id="5" name="">
             <a:extLst xmlns:a="http://schemas.openxmlformats.org/drawingml/2006/main">
               <a:ext uri="{FF2B5EF4-FFF2-40B4-BE49-F238E27FC236}">
-                <a16:creationId xmlns:a16="http://schemas.microsoft.com/office/drawing/2014/main" id="{503A79E9-7B85-47A6-83DA-57C3614EAECB}"/>
+                <a16:creationId xmlns:a16="http://schemas.microsoft.com/office/drawing/2014/main" id="{F795BF95-1DD1-4FD3-813D-018E3B474233}"/>
               </a:ext>
             </a:extLst>
           </p:cNvPr>
@@ -4481,7 +5347,7 @@
           <p:cNvPr id="6" name="">
             <a:extLst xmlns:a="http://schemas.openxmlformats.org/drawingml/2006/main">
               <a:ext uri="{FF2B5EF4-FFF2-40B4-BE49-F238E27FC236}">
-                <a16:creationId xmlns:a16="http://schemas.microsoft.com/office/drawing/2014/main" id="{46873607-86FE-443D-8E81-B01E70D4D110}"/>
+                <a16:creationId xmlns:a16="http://schemas.microsoft.com/office/drawing/2014/main" id="{A069A48E-8AEF-469A-A9F7-26D88F519D00}"/>
               </a:ext>
             </a:extLst>
           </p:cNvPr>
@@ -4531,7 +5397,7 @@
           <p:cNvPr id="7" name="">
             <a:extLst xmlns:a="http://schemas.openxmlformats.org/drawingml/2006/main">
               <a:ext uri="{FF2B5EF4-FFF2-40B4-BE49-F238E27FC236}">
-                <a16:creationId xmlns:a16="http://schemas.microsoft.com/office/drawing/2014/main" id="{A7FC6744-CA37-44F3-8CB0-FCD4BEF97038}"/>
+                <a16:creationId xmlns:a16="http://schemas.microsoft.com/office/drawing/2014/main" id="{C28CAFFC-707C-47D2-A352-04E31B47BA68}"/>
               </a:ext>
             </a:extLst>
           </p:cNvPr>
@@ -4581,7 +5447,7 @@
           <p:cNvPr id="8" name="">
             <a:extLst xmlns:a="http://schemas.openxmlformats.org/drawingml/2006/main">
               <a:ext uri="{FF2B5EF4-FFF2-40B4-BE49-F238E27FC236}">
-                <a16:creationId xmlns:a16="http://schemas.microsoft.com/office/drawing/2014/main" id="{82706FF2-4D96-4B33-8B8C-DF39760D3454}"/>
+                <a16:creationId xmlns:a16="http://schemas.microsoft.com/office/drawing/2014/main" id="{DDA21EFB-4FEF-44C8-896E-D4508A461359}"/>
               </a:ext>
             </a:extLst>
           </p:cNvPr>
@@ -4631,7 +5497,7 @@
           <p:cNvPr id="9" name="">
             <a:extLst xmlns:a="http://schemas.openxmlformats.org/drawingml/2006/main">
               <a:ext uri="{FF2B5EF4-FFF2-40B4-BE49-F238E27FC236}">
-                <a16:creationId xmlns:a16="http://schemas.microsoft.com/office/drawing/2014/main" id="{D9CD3F7B-D472-48D3-BF44-22339B9ABC23}"/>
+                <a16:creationId xmlns:a16="http://schemas.microsoft.com/office/drawing/2014/main" id="{29F4ABF6-EFF9-4EBE-B185-B6CD56CACCE3}"/>
               </a:ext>
             </a:extLst>
           </p:cNvPr>
@@ -4681,57 +5547,7 @@
           <p:cNvPr id="10" name="">
             <a:extLst xmlns:a="http://schemas.openxmlformats.org/drawingml/2006/main">
               <a:ext uri="{FF2B5EF4-FFF2-40B4-BE49-F238E27FC236}">
-                <a16:creationId xmlns:a16="http://schemas.microsoft.com/office/drawing/2014/main" id="{699F9EB5-6011-48B4-A48D-59E35635334E}"/>
-              </a:ext>
-            </a:extLst>
-          </p:cNvPr>
-          <p:cNvSpPr>
-            <a:spLocks xmlns:a="http://schemas.openxmlformats.org/drawingml/2006/main" noGrp="1"/>
-          </p:cNvSpPr>
-          <p:nvPr/>
-        </p:nvSpPr>
-        <p:spPr>
-          <a:xfrm xmlns:a="http://schemas.openxmlformats.org/drawingml/2006/main">
-            <a:off x="419100" y="6134100"/>
-            <a:ext cx="9334500" cy="190500"/>
-          </a:xfrm>
-          <a:prstGeom xmlns:a="http://schemas.openxmlformats.org/drawingml/2006/main" prst="rect">
-            <a:avLst/>
-          </a:prstGeom>
-          <a:noFill xmlns:a="http://schemas.openxmlformats.org/drawingml/2006/main"/>
-          <a:ln xmlns:a="http://schemas.openxmlformats.org/drawingml/2006/main" w="0">
-            <a:noFill/>
-            <a:prstDash val="solid"/>
-          </a:ln>
-        </p:spPr>
-        <p:txBody>
-          <a:bodyPr xmlns:a="http://schemas.openxmlformats.org/drawingml/2006/main" anchor="t"/>
-          <a:lstStyle xmlns:a="http://schemas.openxmlformats.org/drawingml/2006/main"/>
-          <a:p xmlns:a="http://schemas.openxmlformats.org/drawingml/2006/main">
-            <a:pPr algn="l">
-              <a:defRPr sz="825" b="0">
-                <a:solidFill>
-                  <a:srgbClr val="64748B"/>
-                </a:solidFill>
-              </a:defRPr>
-            </a:pPr>
-            <a:r>
-              <a:rPr sz="825" b="0">
-                <a:solidFill>
-                  <a:srgbClr val="64748B"/>
-                </a:solidFill>
-              </a:rPr>
-              <a:t>Source: latest_master_report.html, Experiment Setup And Manager Summary</a:t>
-            </a:r>
-          </a:p>
-        </p:txBody>
-      </p:sp>
-      <p:sp>
-        <p:nvSpPr>
-          <p:cNvPr id="11" name="">
-            <a:extLst xmlns:a="http://schemas.openxmlformats.org/drawingml/2006/main">
-              <a:ext uri="{FF2B5EF4-FFF2-40B4-BE49-F238E27FC236}">
-                <a16:creationId xmlns:a16="http://schemas.microsoft.com/office/drawing/2014/main" id="{48E4EE69-D57A-47DD-B5A2-F77D6185A98F}"/>
+                <a16:creationId xmlns:a16="http://schemas.microsoft.com/office/drawing/2014/main" id="{6827A1CF-FB0F-4EF9-9AAC-F6A29927364B}"/>
               </a:ext>
             </a:extLst>
           </p:cNvPr>
@@ -4778,10 +5594,10 @@
       </p:sp>
       <p:sp>
         <p:nvSpPr>
-          <p:cNvPr id="12" name="">
-            <a:extLst xmlns:a="http://schemas.openxmlformats.org/drawingml/2006/main">
-              <a:ext uri="{FF2B5EF4-FFF2-40B4-BE49-F238E27FC236}">
-                <a16:creationId xmlns:a16="http://schemas.microsoft.com/office/drawing/2014/main" id="{413920CA-C0E7-4ECA-8AA9-0290A0F00BF2}"/>
+          <p:cNvPr id="11" name="">
+            <a:extLst xmlns:a="http://schemas.openxmlformats.org/drawingml/2006/main">
+              <a:ext uri="{FF2B5EF4-FFF2-40B4-BE49-F238E27FC236}">
+                <a16:creationId xmlns:a16="http://schemas.microsoft.com/office/drawing/2014/main" id="{3FB59C64-BE46-458E-A085-895460376B36}"/>
               </a:ext>
             </a:extLst>
           </p:cNvPr>
@@ -4829,7 +5645,7 @@
     </p:spTree>
     <p:extLst>
       <p:ext uri="{BB962C8B-B14F-4D97-AF65-F5344CB8AC3E}">
-        <p14:creationId xmlns:p14="http://schemas.microsoft.com/office/powerpoint/2010/main" val="613856396"/>
+        <p14:creationId xmlns:p14="http://schemas.microsoft.com/office/powerpoint/2010/main" val="1019548047"/>
       </p:ext>
     </p:extLst>
   </p:cSld>
@@ -4857,10 +5673,10 @@
       </p:grpSpPr>
       <p:sp>
         <p:nvSpPr>
-          <p:cNvPr id="13" name="">
-            <a:extLst xmlns:a="http://schemas.openxmlformats.org/drawingml/2006/main">
-              <a:ext uri="{FF2B5EF4-FFF2-40B4-BE49-F238E27FC236}">
-                <a16:creationId xmlns:a16="http://schemas.microsoft.com/office/drawing/2014/main" id="{05EDAAFC-CE44-4CFA-8FC9-677E089F3E4A}"/>
+          <p:cNvPr id="22" name="">
+            <a:extLst xmlns:a="http://schemas.openxmlformats.org/drawingml/2006/main">
+              <a:ext uri="{FF2B5EF4-FFF2-40B4-BE49-F238E27FC236}">
+                <a16:creationId xmlns:a16="http://schemas.microsoft.com/office/drawing/2014/main" id="{6E2861C9-5F68-4128-BD76-9EC7AC6606CD}"/>
               </a:ext>
             </a:extLst>
           </p:cNvPr>
@@ -4910,7 +5726,7 @@
           <p:cNvPr id="2" name="">
             <a:extLst xmlns:a="http://schemas.openxmlformats.org/drawingml/2006/main">
               <a:ext uri="{FF2B5EF4-FFF2-40B4-BE49-F238E27FC236}">
-                <a16:creationId xmlns:a16="http://schemas.microsoft.com/office/drawing/2014/main" id="{43EAC5A1-B0CF-4C03-8AD0-A21504DE2B3D}"/>
+                <a16:creationId xmlns:a16="http://schemas.microsoft.com/office/drawing/2014/main" id="{15A5BA03-E95A-4F99-8439-A2B34E6C270A}"/>
               </a:ext>
             </a:extLst>
           </p:cNvPr>
@@ -4960,19 +5776,54 @@
           <p:cNvPr id="3" name="">
             <a:extLst xmlns:a="http://schemas.openxmlformats.org/drawingml/2006/main">
               <a:ext uri="{FF2B5EF4-FFF2-40B4-BE49-F238E27FC236}">
-                <a16:creationId xmlns:a16="http://schemas.microsoft.com/office/drawing/2014/main" id="{E68E1F2B-9AA2-4AB5-8853-D687978F43F4}"/>
-              </a:ext>
-            </a:extLst>
-          </p:cNvPr>
-          <p:cNvSpPr>
-            <a:spLocks xmlns:a="http://schemas.openxmlformats.org/drawingml/2006/main" noGrp="1"/>
-          </p:cNvSpPr>
-          <p:nvPr/>
-        </p:nvSpPr>
-        <p:spPr>
-          <a:xfrm xmlns:a="http://schemas.openxmlformats.org/drawingml/2006/main">
-            <a:off x="762000" y="2305050"/>
-            <a:ext cx="10668000" cy="742950"/>
+                <a16:creationId xmlns:a16="http://schemas.microsoft.com/office/drawing/2014/main" id="{452F4E55-BB3C-4086-BE0F-3B687FD7C425}"/>
+              </a:ext>
+            </a:extLst>
+          </p:cNvPr>
+          <p:cNvSpPr>
+            <a:spLocks xmlns:a="http://schemas.openxmlformats.org/drawingml/2006/main" noGrp="1"/>
+          </p:cNvSpPr>
+          <p:nvPr/>
+        </p:nvSpPr>
+        <p:spPr>
+          <a:xfrm xmlns:a="http://schemas.openxmlformats.org/drawingml/2006/main">
+            <a:off x="723900" y="1943100"/>
+            <a:ext cx="2243138" cy="990600"/>
+          </a:xfrm>
+          <a:prstGeom xmlns:a="http://schemas.openxmlformats.org/drawingml/2006/main" prst="roundRect">
+            <a:avLst>
+              <a:gd name="adj" fmla="val 5769"/>
+            </a:avLst>
+          </a:prstGeom>
+          <a:solidFill xmlns:a="http://schemas.openxmlformats.org/drawingml/2006/main">
+            <a:srgbClr val="FFFFFF"/>
+          </a:solidFill>
+          <a:ln xmlns:a="http://schemas.openxmlformats.org/drawingml/2006/main" w="13335">
+            <a:solidFill>
+              <a:srgbClr val="2563EB"/>
+            </a:solidFill>
+            <a:prstDash val="solid"/>
+          </a:ln>
+        </p:spPr>
+      </p:sp>
+      <p:sp>
+        <p:nvSpPr>
+          <p:cNvPr id="4" name="">
+            <a:extLst xmlns:a="http://schemas.openxmlformats.org/drawingml/2006/main">
+              <a:ext uri="{FF2B5EF4-FFF2-40B4-BE49-F238E27FC236}">
+                <a16:creationId xmlns:a16="http://schemas.microsoft.com/office/drawing/2014/main" id="{45FA16C7-E80E-40C2-8912-6A8FFD9A6938}"/>
+              </a:ext>
+            </a:extLst>
+          </p:cNvPr>
+          <p:cNvSpPr>
+            <a:spLocks xmlns:a="http://schemas.openxmlformats.org/drawingml/2006/main" noGrp="1"/>
+          </p:cNvSpPr>
+          <p:nvPr/>
+        </p:nvSpPr>
+        <p:spPr>
+          <a:xfrm xmlns:a="http://schemas.openxmlformats.org/drawingml/2006/main">
+            <a:off x="857250" y="2114550"/>
+            <a:ext cx="1976438" cy="723900"/>
           </a:xfrm>
           <a:prstGeom xmlns:a="http://schemas.openxmlformats.org/drawingml/2006/main" prst="rect">
             <a:avLst/>
@@ -4988,29 +5839,502 @@
           <a:lstStyle xmlns:a="http://schemas.openxmlformats.org/drawingml/2006/main"/>
           <a:p xmlns:a="http://schemas.openxmlformats.org/drawingml/2006/main">
             <a:pPr algn="ctr">
-              <a:defRPr sz="2850" b="1">
+              <a:defRPr sz="1575" b="1">
                 <a:solidFill>
                   <a:srgbClr val="0F172A"/>
                 </a:solidFill>
               </a:defRPr>
             </a:pPr>
             <a:r>
-              <a:rPr sz="2850" b="1">
+              <a:rPr sz="1575" b="1">
                 <a:solidFill>
                   <a:srgbClr val="0F172A"/>
                 </a:solidFill>
               </a:rPr>
-              <a:t>SWE-bench traces   →   DeepAgents   →   SGLang server</a:t>
-            </a:r>
-          </a:p>
-        </p:txBody>
-      </p:sp>
-      <p:sp>
-        <p:nvSpPr>
-          <p:cNvPr id="4" name="">
-            <a:extLst xmlns:a="http://schemas.openxmlformats.org/drawingml/2006/main">
-              <a:ext uri="{FF2B5EF4-FFF2-40B4-BE49-F238E27FC236}">
-                <a16:creationId xmlns:a16="http://schemas.microsoft.com/office/drawing/2014/main" id="{50CB75DE-AA18-4B18-B705-6FD0A3FE626D}"/>
+              <a:t>SWE-bench</a:t>
+            </a:r>
+          </a:p>
+          <a:p xmlns:a="http://schemas.openxmlformats.org/drawingml/2006/main">
+            <a:pPr algn="ctr">
+              <a:defRPr sz="1575" b="1">
+                <a:solidFill>
+                  <a:srgbClr val="0F172A"/>
+                </a:solidFill>
+              </a:defRPr>
+            </a:pPr>
+            <a:r>
+              <a:rPr sz="1575" b="1">
+                <a:solidFill>
+                  <a:srgbClr val="0F172A"/>
+                </a:solidFill>
+              </a:rPr>
+              <a:t>traces</a:t>
+            </a:r>
+          </a:p>
+        </p:txBody>
+      </p:sp>
+      <p:sp>
+        <p:nvSpPr>
+          <p:cNvPr id="5" name="">
+            <a:extLst xmlns:a="http://schemas.openxmlformats.org/drawingml/2006/main">
+              <a:ext uri="{FF2B5EF4-FFF2-40B4-BE49-F238E27FC236}">
+                <a16:creationId xmlns:a16="http://schemas.microsoft.com/office/drawing/2014/main" id="{E7BFF767-C121-499C-A5B0-0F2C9F7B8F03}"/>
+              </a:ext>
+            </a:extLst>
+          </p:cNvPr>
+          <p:cNvSpPr>
+            <a:spLocks xmlns:a="http://schemas.openxmlformats.org/drawingml/2006/main" noGrp="1"/>
+          </p:cNvSpPr>
+          <p:nvPr/>
+        </p:nvSpPr>
+        <p:spPr>
+          <a:xfrm xmlns:a="http://schemas.openxmlformats.org/drawingml/2006/main">
+            <a:off x="3043238" y="2209800"/>
+            <a:ext cx="438150" cy="381000"/>
+          </a:xfrm>
+          <a:prstGeom xmlns:a="http://schemas.openxmlformats.org/drawingml/2006/main" prst="rect">
+            <a:avLst/>
+          </a:prstGeom>
+          <a:noFill xmlns:a="http://schemas.openxmlformats.org/drawingml/2006/main"/>
+          <a:ln xmlns:a="http://schemas.openxmlformats.org/drawingml/2006/main" w="0">
+            <a:noFill/>
+            <a:prstDash val="solid"/>
+          </a:ln>
+        </p:spPr>
+        <p:txBody>
+          <a:bodyPr xmlns:a="http://schemas.openxmlformats.org/drawingml/2006/main" anchor="t"/>
+          <a:lstStyle xmlns:a="http://schemas.openxmlformats.org/drawingml/2006/main"/>
+          <a:p xmlns:a="http://schemas.openxmlformats.org/drawingml/2006/main">
+            <a:pPr algn="ctr">
+              <a:defRPr sz="2250" b="1">
+                <a:solidFill>
+                  <a:srgbClr val="64748B"/>
+                </a:solidFill>
+              </a:defRPr>
+            </a:pPr>
+            <a:r>
+              <a:rPr sz="2250" b="1">
+                <a:solidFill>
+                  <a:srgbClr val="64748B"/>
+                </a:solidFill>
+              </a:rPr>
+              <a:t>→</a:t>
+            </a:r>
+          </a:p>
+        </p:txBody>
+      </p:sp>
+      <p:sp>
+        <p:nvSpPr>
+          <p:cNvPr id="6" name="">
+            <a:extLst xmlns:a="http://schemas.openxmlformats.org/drawingml/2006/main">
+              <a:ext uri="{FF2B5EF4-FFF2-40B4-BE49-F238E27FC236}">
+                <a16:creationId xmlns:a16="http://schemas.microsoft.com/office/drawing/2014/main" id="{86629657-3D34-446B-AAC4-ACDFA24BF8C2}"/>
+              </a:ext>
+            </a:extLst>
+          </p:cNvPr>
+          <p:cNvSpPr>
+            <a:spLocks xmlns:a="http://schemas.openxmlformats.org/drawingml/2006/main" noGrp="1"/>
+          </p:cNvSpPr>
+          <p:nvPr/>
+        </p:nvSpPr>
+        <p:spPr>
+          <a:xfrm xmlns:a="http://schemas.openxmlformats.org/drawingml/2006/main">
+            <a:off x="3557588" y="1943100"/>
+            <a:ext cx="2243138" cy="990600"/>
+          </a:xfrm>
+          <a:prstGeom xmlns:a="http://schemas.openxmlformats.org/drawingml/2006/main" prst="roundRect">
+            <a:avLst>
+              <a:gd name="adj" fmla="val 5769"/>
+            </a:avLst>
+          </a:prstGeom>
+          <a:solidFill xmlns:a="http://schemas.openxmlformats.org/drawingml/2006/main">
+            <a:srgbClr val="FFFFFF"/>
+          </a:solidFill>
+          <a:ln xmlns:a="http://schemas.openxmlformats.org/drawingml/2006/main" w="13335">
+            <a:solidFill>
+              <a:srgbClr val="9333EA"/>
+            </a:solidFill>
+            <a:prstDash val="solid"/>
+          </a:ln>
+        </p:spPr>
+      </p:sp>
+      <p:sp>
+        <p:nvSpPr>
+          <p:cNvPr id="7" name="">
+            <a:extLst xmlns:a="http://schemas.openxmlformats.org/drawingml/2006/main">
+              <a:ext uri="{FF2B5EF4-FFF2-40B4-BE49-F238E27FC236}">
+                <a16:creationId xmlns:a16="http://schemas.microsoft.com/office/drawing/2014/main" id="{AB166912-B3FA-485F-85F6-9187A48BC734}"/>
+              </a:ext>
+            </a:extLst>
+          </p:cNvPr>
+          <p:cNvSpPr>
+            <a:spLocks xmlns:a="http://schemas.openxmlformats.org/drawingml/2006/main" noGrp="1"/>
+          </p:cNvSpPr>
+          <p:nvPr/>
+        </p:nvSpPr>
+        <p:spPr>
+          <a:xfrm xmlns:a="http://schemas.openxmlformats.org/drawingml/2006/main">
+            <a:off x="3690938" y="2114550"/>
+            <a:ext cx="1976438" cy="723900"/>
+          </a:xfrm>
+          <a:prstGeom xmlns:a="http://schemas.openxmlformats.org/drawingml/2006/main" prst="rect">
+            <a:avLst/>
+          </a:prstGeom>
+          <a:noFill xmlns:a="http://schemas.openxmlformats.org/drawingml/2006/main"/>
+          <a:ln xmlns:a="http://schemas.openxmlformats.org/drawingml/2006/main" w="0">
+            <a:noFill/>
+            <a:prstDash val="solid"/>
+          </a:ln>
+        </p:spPr>
+        <p:txBody>
+          <a:bodyPr xmlns:a="http://schemas.openxmlformats.org/drawingml/2006/main" anchor="ctr"/>
+          <a:lstStyle xmlns:a="http://schemas.openxmlformats.org/drawingml/2006/main"/>
+          <a:p xmlns:a="http://schemas.openxmlformats.org/drawingml/2006/main">
+            <a:pPr algn="ctr">
+              <a:defRPr sz="1575" b="1">
+                <a:solidFill>
+                  <a:srgbClr val="0F172A"/>
+                </a:solidFill>
+              </a:defRPr>
+            </a:pPr>
+            <a:r>
+              <a:rPr sz="1575" b="1">
+                <a:solidFill>
+                  <a:srgbClr val="0F172A"/>
+                </a:solidFill>
+              </a:rPr>
+              <a:t>DeepAgents</a:t>
+            </a:r>
+          </a:p>
+          <a:p xmlns:a="http://schemas.openxmlformats.org/drawingml/2006/main">
+            <a:pPr algn="ctr">
+              <a:defRPr sz="1575" b="1">
+                <a:solidFill>
+                  <a:srgbClr val="0F172A"/>
+                </a:solidFill>
+              </a:defRPr>
+            </a:pPr>
+            <a:r>
+              <a:rPr sz="1575" b="1">
+                <a:solidFill>
+                  <a:srgbClr val="0F172A"/>
+                </a:solidFill>
+              </a:rPr>
+              <a:t>tool loop</a:t>
+            </a:r>
+          </a:p>
+        </p:txBody>
+      </p:sp>
+      <p:sp>
+        <p:nvSpPr>
+          <p:cNvPr id="8" name="">
+            <a:extLst xmlns:a="http://schemas.openxmlformats.org/drawingml/2006/main">
+              <a:ext uri="{FF2B5EF4-FFF2-40B4-BE49-F238E27FC236}">
+                <a16:creationId xmlns:a16="http://schemas.microsoft.com/office/drawing/2014/main" id="{5CE23B28-612A-4B97-B4AA-15C0ADB97876}"/>
+              </a:ext>
+            </a:extLst>
+          </p:cNvPr>
+          <p:cNvSpPr>
+            <a:spLocks xmlns:a="http://schemas.openxmlformats.org/drawingml/2006/main" noGrp="1"/>
+          </p:cNvSpPr>
+          <p:nvPr/>
+        </p:nvSpPr>
+        <p:spPr>
+          <a:xfrm xmlns:a="http://schemas.openxmlformats.org/drawingml/2006/main">
+            <a:off x="5876925" y="2209800"/>
+            <a:ext cx="438150" cy="381000"/>
+          </a:xfrm>
+          <a:prstGeom xmlns:a="http://schemas.openxmlformats.org/drawingml/2006/main" prst="rect">
+            <a:avLst/>
+          </a:prstGeom>
+          <a:noFill xmlns:a="http://schemas.openxmlformats.org/drawingml/2006/main"/>
+          <a:ln xmlns:a="http://schemas.openxmlformats.org/drawingml/2006/main" w="0">
+            <a:noFill/>
+            <a:prstDash val="solid"/>
+          </a:ln>
+        </p:spPr>
+        <p:txBody>
+          <a:bodyPr xmlns:a="http://schemas.openxmlformats.org/drawingml/2006/main" anchor="t"/>
+          <a:lstStyle xmlns:a="http://schemas.openxmlformats.org/drawingml/2006/main"/>
+          <a:p xmlns:a="http://schemas.openxmlformats.org/drawingml/2006/main">
+            <a:pPr algn="ctr">
+              <a:defRPr sz="2250" b="1">
+                <a:solidFill>
+                  <a:srgbClr val="64748B"/>
+                </a:solidFill>
+              </a:defRPr>
+            </a:pPr>
+            <a:r>
+              <a:rPr sz="2250" b="1">
+                <a:solidFill>
+                  <a:srgbClr val="64748B"/>
+                </a:solidFill>
+              </a:rPr>
+              <a:t>→</a:t>
+            </a:r>
+          </a:p>
+        </p:txBody>
+      </p:sp>
+      <p:sp>
+        <p:nvSpPr>
+          <p:cNvPr id="9" name="">
+            <a:extLst xmlns:a="http://schemas.openxmlformats.org/drawingml/2006/main">
+              <a:ext uri="{FF2B5EF4-FFF2-40B4-BE49-F238E27FC236}">
+                <a16:creationId xmlns:a16="http://schemas.microsoft.com/office/drawing/2014/main" id="{6C039FF1-5160-490A-B103-8AD45E04CD30}"/>
+              </a:ext>
+            </a:extLst>
+          </p:cNvPr>
+          <p:cNvSpPr>
+            <a:spLocks xmlns:a="http://schemas.openxmlformats.org/drawingml/2006/main" noGrp="1"/>
+          </p:cNvSpPr>
+          <p:nvPr/>
+        </p:nvSpPr>
+        <p:spPr>
+          <a:xfrm xmlns:a="http://schemas.openxmlformats.org/drawingml/2006/main">
+            <a:off x="6391275" y="1943100"/>
+            <a:ext cx="2243138" cy="990600"/>
+          </a:xfrm>
+          <a:prstGeom xmlns:a="http://schemas.openxmlformats.org/drawingml/2006/main" prst="roundRect">
+            <a:avLst>
+              <a:gd name="adj" fmla="val 5769"/>
+            </a:avLst>
+          </a:prstGeom>
+          <a:solidFill xmlns:a="http://schemas.openxmlformats.org/drawingml/2006/main">
+            <a:srgbClr val="FFFFFF"/>
+          </a:solidFill>
+          <a:ln xmlns:a="http://schemas.openxmlformats.org/drawingml/2006/main" w="13335">
+            <a:solidFill>
+              <a:srgbClr val="0891B2"/>
+            </a:solidFill>
+            <a:prstDash val="solid"/>
+          </a:ln>
+        </p:spPr>
+      </p:sp>
+      <p:sp>
+        <p:nvSpPr>
+          <p:cNvPr id="10" name="">
+            <a:extLst xmlns:a="http://schemas.openxmlformats.org/drawingml/2006/main">
+              <a:ext uri="{FF2B5EF4-FFF2-40B4-BE49-F238E27FC236}">
+                <a16:creationId xmlns:a16="http://schemas.microsoft.com/office/drawing/2014/main" id="{3A00ED5F-8A3D-456E-8D8F-F22B2BA98435}"/>
+              </a:ext>
+            </a:extLst>
+          </p:cNvPr>
+          <p:cNvSpPr>
+            <a:spLocks xmlns:a="http://schemas.openxmlformats.org/drawingml/2006/main" noGrp="1"/>
+          </p:cNvSpPr>
+          <p:nvPr/>
+        </p:nvSpPr>
+        <p:spPr>
+          <a:xfrm xmlns:a="http://schemas.openxmlformats.org/drawingml/2006/main">
+            <a:off x="6524625" y="2114550"/>
+            <a:ext cx="1976438" cy="723900"/>
+          </a:xfrm>
+          <a:prstGeom xmlns:a="http://schemas.openxmlformats.org/drawingml/2006/main" prst="rect">
+            <a:avLst/>
+          </a:prstGeom>
+          <a:noFill xmlns:a="http://schemas.openxmlformats.org/drawingml/2006/main"/>
+          <a:ln xmlns:a="http://schemas.openxmlformats.org/drawingml/2006/main" w="0">
+            <a:noFill/>
+            <a:prstDash val="solid"/>
+          </a:ln>
+        </p:spPr>
+        <p:txBody>
+          <a:bodyPr xmlns:a="http://schemas.openxmlformats.org/drawingml/2006/main" anchor="ctr"/>
+          <a:lstStyle xmlns:a="http://schemas.openxmlformats.org/drawingml/2006/main"/>
+          <a:p xmlns:a="http://schemas.openxmlformats.org/drawingml/2006/main">
+            <a:pPr algn="ctr">
+              <a:defRPr sz="1575" b="1">
+                <a:solidFill>
+                  <a:srgbClr val="0F172A"/>
+                </a:solidFill>
+              </a:defRPr>
+            </a:pPr>
+            <a:r>
+              <a:rPr sz="1575" b="1">
+                <a:solidFill>
+                  <a:srgbClr val="0F172A"/>
+                </a:solidFill>
+              </a:rPr>
+              <a:t>SGLang</a:t>
+            </a:r>
+          </a:p>
+          <a:p xmlns:a="http://schemas.openxmlformats.org/drawingml/2006/main">
+            <a:pPr algn="ctr">
+              <a:defRPr sz="1575" b="1">
+                <a:solidFill>
+                  <a:srgbClr val="0F172A"/>
+                </a:solidFill>
+              </a:defRPr>
+            </a:pPr>
+            <a:r>
+              <a:rPr sz="1575" b="1">
+                <a:solidFill>
+                  <a:srgbClr val="0F172A"/>
+                </a:solidFill>
+              </a:rPr>
+              <a:t>server</a:t>
+            </a:r>
+          </a:p>
+        </p:txBody>
+      </p:sp>
+      <p:sp>
+        <p:nvSpPr>
+          <p:cNvPr id="11" name="">
+            <a:extLst xmlns:a="http://schemas.openxmlformats.org/drawingml/2006/main">
+              <a:ext uri="{FF2B5EF4-FFF2-40B4-BE49-F238E27FC236}">
+                <a16:creationId xmlns:a16="http://schemas.microsoft.com/office/drawing/2014/main" id="{62B0B214-E01D-4FC3-87E2-CD60B6D88A2A}"/>
+              </a:ext>
+            </a:extLst>
+          </p:cNvPr>
+          <p:cNvSpPr>
+            <a:spLocks xmlns:a="http://schemas.openxmlformats.org/drawingml/2006/main" noGrp="1"/>
+          </p:cNvSpPr>
+          <p:nvPr/>
+        </p:nvSpPr>
+        <p:spPr>
+          <a:xfrm xmlns:a="http://schemas.openxmlformats.org/drawingml/2006/main">
+            <a:off x="8710613" y="2209800"/>
+            <a:ext cx="438150" cy="381000"/>
+          </a:xfrm>
+          <a:prstGeom xmlns:a="http://schemas.openxmlformats.org/drawingml/2006/main" prst="rect">
+            <a:avLst/>
+          </a:prstGeom>
+          <a:noFill xmlns:a="http://schemas.openxmlformats.org/drawingml/2006/main"/>
+          <a:ln xmlns:a="http://schemas.openxmlformats.org/drawingml/2006/main" w="0">
+            <a:noFill/>
+            <a:prstDash val="solid"/>
+          </a:ln>
+        </p:spPr>
+        <p:txBody>
+          <a:bodyPr xmlns:a="http://schemas.openxmlformats.org/drawingml/2006/main" anchor="t"/>
+          <a:lstStyle xmlns:a="http://schemas.openxmlformats.org/drawingml/2006/main"/>
+          <a:p xmlns:a="http://schemas.openxmlformats.org/drawingml/2006/main">
+            <a:pPr algn="ctr">
+              <a:defRPr sz="2250" b="1">
+                <a:solidFill>
+                  <a:srgbClr val="64748B"/>
+                </a:solidFill>
+              </a:defRPr>
+            </a:pPr>
+            <a:r>
+              <a:rPr sz="2250" b="1">
+                <a:solidFill>
+                  <a:srgbClr val="64748B"/>
+                </a:solidFill>
+              </a:rPr>
+              <a:t>→</a:t>
+            </a:r>
+          </a:p>
+        </p:txBody>
+      </p:sp>
+      <p:sp>
+        <p:nvSpPr>
+          <p:cNvPr id="12" name="">
+            <a:extLst xmlns:a="http://schemas.openxmlformats.org/drawingml/2006/main">
+              <a:ext uri="{FF2B5EF4-FFF2-40B4-BE49-F238E27FC236}">
+                <a16:creationId xmlns:a16="http://schemas.microsoft.com/office/drawing/2014/main" id="{02A621AD-77DE-4207-A5B2-FC6900DC5B68}"/>
+              </a:ext>
+            </a:extLst>
+          </p:cNvPr>
+          <p:cNvSpPr>
+            <a:spLocks xmlns:a="http://schemas.openxmlformats.org/drawingml/2006/main" noGrp="1"/>
+          </p:cNvSpPr>
+          <p:nvPr/>
+        </p:nvSpPr>
+        <p:spPr>
+          <a:xfrm xmlns:a="http://schemas.openxmlformats.org/drawingml/2006/main">
+            <a:off x="9224963" y="1943100"/>
+            <a:ext cx="2243138" cy="990600"/>
+          </a:xfrm>
+          <a:prstGeom xmlns:a="http://schemas.openxmlformats.org/drawingml/2006/main" prst="roundRect">
+            <a:avLst>
+              <a:gd name="adj" fmla="val 5769"/>
+            </a:avLst>
+          </a:prstGeom>
+          <a:solidFill xmlns:a="http://schemas.openxmlformats.org/drawingml/2006/main">
+            <a:srgbClr val="FFFFFF"/>
+          </a:solidFill>
+          <a:ln xmlns:a="http://schemas.openxmlformats.org/drawingml/2006/main" w="13335">
+            <a:solidFill>
+              <a:srgbClr val="16A34A"/>
+            </a:solidFill>
+            <a:prstDash val="solid"/>
+          </a:ln>
+        </p:spPr>
+      </p:sp>
+      <p:sp>
+        <p:nvSpPr>
+          <p:cNvPr id="13" name="">
+            <a:extLst xmlns:a="http://schemas.openxmlformats.org/drawingml/2006/main">
+              <a:ext uri="{FF2B5EF4-FFF2-40B4-BE49-F238E27FC236}">
+                <a16:creationId xmlns:a16="http://schemas.microsoft.com/office/drawing/2014/main" id="{BFA7153B-1621-411E-8EC6-EB84C6AA76FA}"/>
+              </a:ext>
+            </a:extLst>
+          </p:cNvPr>
+          <p:cNvSpPr>
+            <a:spLocks xmlns:a="http://schemas.openxmlformats.org/drawingml/2006/main" noGrp="1"/>
+          </p:cNvSpPr>
+          <p:nvPr/>
+        </p:nvSpPr>
+        <p:spPr>
+          <a:xfrm xmlns:a="http://schemas.openxmlformats.org/drawingml/2006/main">
+            <a:off x="9358313" y="2114550"/>
+            <a:ext cx="1976438" cy="723900"/>
+          </a:xfrm>
+          <a:prstGeom xmlns:a="http://schemas.openxmlformats.org/drawingml/2006/main" prst="rect">
+            <a:avLst/>
+          </a:prstGeom>
+          <a:noFill xmlns:a="http://schemas.openxmlformats.org/drawingml/2006/main"/>
+          <a:ln xmlns:a="http://schemas.openxmlformats.org/drawingml/2006/main" w="0">
+            <a:noFill/>
+            <a:prstDash val="solid"/>
+          </a:ln>
+        </p:spPr>
+        <p:txBody>
+          <a:bodyPr xmlns:a="http://schemas.openxmlformats.org/drawingml/2006/main" anchor="ctr"/>
+          <a:lstStyle xmlns:a="http://schemas.openxmlformats.org/drawingml/2006/main"/>
+          <a:p xmlns:a="http://schemas.openxmlformats.org/drawingml/2006/main">
+            <a:pPr algn="ctr">
+              <a:defRPr sz="1575" b="1">
+                <a:solidFill>
+                  <a:srgbClr val="0F172A"/>
+                </a:solidFill>
+              </a:defRPr>
+            </a:pPr>
+            <a:r>
+              <a:rPr sz="1575" b="1">
+                <a:solidFill>
+                  <a:srgbClr val="0F172A"/>
+                </a:solidFill>
+              </a:rPr>
+              <a:t>KV/cache</a:t>
+            </a:r>
+          </a:p>
+          <a:p xmlns:a="http://schemas.openxmlformats.org/drawingml/2006/main">
+            <a:pPr algn="ctr">
+              <a:defRPr sz="1575" b="1">
+                <a:solidFill>
+                  <a:srgbClr val="0F172A"/>
+                </a:solidFill>
+              </a:defRPr>
+            </a:pPr>
+            <a:r>
+              <a:rPr sz="1575" b="1">
+                <a:solidFill>
+                  <a:srgbClr val="0F172A"/>
+                </a:solidFill>
+              </a:rPr>
+              <a:t>observations</a:t>
+            </a:r>
+          </a:p>
+        </p:txBody>
+      </p:sp>
+      <p:sp>
+        <p:nvSpPr>
+          <p:cNvPr id="14" name="">
+            <a:extLst xmlns:a="http://schemas.openxmlformats.org/drawingml/2006/main">
+              <a:ext uri="{FF2B5EF4-FFF2-40B4-BE49-F238E27FC236}">
+                <a16:creationId xmlns:a16="http://schemas.microsoft.com/office/drawing/2014/main" id="{1CE69650-A07F-42A3-AAB3-E7476934334C}"/>
               </a:ext>
             </a:extLst>
           </p:cNvPr>
@@ -5057,10 +6381,10 @@
       </p:sp>
       <p:sp>
         <p:nvSpPr>
-          <p:cNvPr id="5" name="">
-            <a:extLst xmlns:a="http://schemas.openxmlformats.org/drawingml/2006/main">
-              <a:ext uri="{FF2B5EF4-FFF2-40B4-BE49-F238E27FC236}">
-                <a16:creationId xmlns:a16="http://schemas.microsoft.com/office/drawing/2014/main" id="{202EF722-959F-4DC1-8360-1E7F09320084}"/>
+          <p:cNvPr id="15" name="">
+            <a:extLst xmlns:a="http://schemas.openxmlformats.org/drawingml/2006/main">
+              <a:ext uri="{FF2B5EF4-FFF2-40B4-BE49-F238E27FC236}">
+                <a16:creationId xmlns:a16="http://schemas.microsoft.com/office/drawing/2014/main" id="{769B8775-7239-468C-BC8C-30EA013C673A}"/>
               </a:ext>
             </a:extLst>
           </p:cNvPr>
@@ -5107,10 +6431,10 @@
       </p:sp>
       <p:sp>
         <p:nvSpPr>
-          <p:cNvPr id="6" name="">
-            <a:extLst xmlns:a="http://schemas.openxmlformats.org/drawingml/2006/main">
-              <a:ext uri="{FF2B5EF4-FFF2-40B4-BE49-F238E27FC236}">
-                <a16:creationId xmlns:a16="http://schemas.microsoft.com/office/drawing/2014/main" id="{1CD470D2-EE85-427E-8D04-25E372D8F78E}"/>
+          <p:cNvPr id="16" name="">
+            <a:extLst xmlns:a="http://schemas.openxmlformats.org/drawingml/2006/main">
+              <a:ext uri="{FF2B5EF4-FFF2-40B4-BE49-F238E27FC236}">
+                <a16:creationId xmlns:a16="http://schemas.microsoft.com/office/drawing/2014/main" id="{D4A4DCE5-1AA5-4946-81B6-821CBA8086F8}"/>
               </a:ext>
             </a:extLst>
           </p:cNvPr>
@@ -5157,10 +6481,10 @@
       </p:sp>
       <p:sp>
         <p:nvSpPr>
-          <p:cNvPr id="7" name="">
-            <a:extLst xmlns:a="http://schemas.openxmlformats.org/drawingml/2006/main">
-              <a:ext uri="{FF2B5EF4-FFF2-40B4-BE49-F238E27FC236}">
-                <a16:creationId xmlns:a16="http://schemas.microsoft.com/office/drawing/2014/main" id="{8ED1FCD4-46F3-45F7-A1E5-56EEE1CE5D7E}"/>
+          <p:cNvPr id="17" name="">
+            <a:extLst xmlns:a="http://schemas.openxmlformats.org/drawingml/2006/main">
+              <a:ext uri="{FF2B5EF4-FFF2-40B4-BE49-F238E27FC236}">
+                <a16:creationId xmlns:a16="http://schemas.microsoft.com/office/drawing/2014/main" id="{9A0DBE37-6841-4BE1-A936-542800883184}"/>
               </a:ext>
             </a:extLst>
           </p:cNvPr>
@@ -5207,10 +6531,10 @@
       </p:sp>
       <p:sp>
         <p:nvSpPr>
-          <p:cNvPr id="8" name="">
-            <a:extLst xmlns:a="http://schemas.openxmlformats.org/drawingml/2006/main">
-              <a:ext uri="{FF2B5EF4-FFF2-40B4-BE49-F238E27FC236}">
-                <a16:creationId xmlns:a16="http://schemas.microsoft.com/office/drawing/2014/main" id="{1C0270AB-E1B5-49BD-86FE-8295FFFA73A9}"/>
+          <p:cNvPr id="18" name="">
+            <a:extLst xmlns:a="http://schemas.openxmlformats.org/drawingml/2006/main">
+              <a:ext uri="{FF2B5EF4-FFF2-40B4-BE49-F238E27FC236}">
+                <a16:creationId xmlns:a16="http://schemas.microsoft.com/office/drawing/2014/main" id="{20166A04-AED4-47B7-8CDA-261624265F1F}"/>
               </a:ext>
             </a:extLst>
           </p:cNvPr>
@@ -5257,10 +6581,10 @@
       </p:sp>
       <p:sp>
         <p:nvSpPr>
-          <p:cNvPr id="9" name="">
-            <a:extLst xmlns:a="http://schemas.openxmlformats.org/drawingml/2006/main">
-              <a:ext uri="{FF2B5EF4-FFF2-40B4-BE49-F238E27FC236}">
-                <a16:creationId xmlns:a16="http://schemas.microsoft.com/office/drawing/2014/main" id="{CA9E6E5B-1FA3-4E60-A346-F23CF8F02A8E}"/>
+          <p:cNvPr id="19" name="">
+            <a:extLst xmlns:a="http://schemas.openxmlformats.org/drawingml/2006/main">
+              <a:ext uri="{FF2B5EF4-FFF2-40B4-BE49-F238E27FC236}">
+                <a16:creationId xmlns:a16="http://schemas.microsoft.com/office/drawing/2014/main" id="{099EBF12-1743-4795-902E-D1BFDE271BC4}"/>
               </a:ext>
             </a:extLst>
           </p:cNvPr>
@@ -5307,60 +6631,10 @@
       </p:sp>
       <p:sp>
         <p:nvSpPr>
-          <p:cNvPr id="10" name="">
-            <a:extLst xmlns:a="http://schemas.openxmlformats.org/drawingml/2006/main">
-              <a:ext uri="{FF2B5EF4-FFF2-40B4-BE49-F238E27FC236}">
-                <a16:creationId xmlns:a16="http://schemas.microsoft.com/office/drawing/2014/main" id="{E885C58E-DAF6-4453-B345-82AD8347C59F}"/>
-              </a:ext>
-            </a:extLst>
-          </p:cNvPr>
-          <p:cNvSpPr>
-            <a:spLocks xmlns:a="http://schemas.openxmlformats.org/drawingml/2006/main" noGrp="1"/>
-          </p:cNvSpPr>
-          <p:nvPr/>
-        </p:nvSpPr>
-        <p:spPr>
-          <a:xfrm xmlns:a="http://schemas.openxmlformats.org/drawingml/2006/main">
-            <a:off x="419100" y="6134100"/>
-            <a:ext cx="9334500" cy="190500"/>
-          </a:xfrm>
-          <a:prstGeom xmlns:a="http://schemas.openxmlformats.org/drawingml/2006/main" prst="rect">
-            <a:avLst/>
-          </a:prstGeom>
-          <a:noFill xmlns:a="http://schemas.openxmlformats.org/drawingml/2006/main"/>
-          <a:ln xmlns:a="http://schemas.openxmlformats.org/drawingml/2006/main" w="0">
-            <a:noFill/>
-            <a:prstDash val="solid"/>
-          </a:ln>
-        </p:spPr>
-        <p:txBody>
-          <a:bodyPr xmlns:a="http://schemas.openxmlformats.org/drawingml/2006/main" anchor="t"/>
-          <a:lstStyle xmlns:a="http://schemas.openxmlformats.org/drawingml/2006/main"/>
-          <a:p xmlns:a="http://schemas.openxmlformats.org/drawingml/2006/main">
-            <a:pPr algn="l">
-              <a:defRPr sz="825" b="0">
-                <a:solidFill>
-                  <a:srgbClr val="64748B"/>
-                </a:solidFill>
-              </a:defRPr>
-            </a:pPr>
-            <a:r>
-              <a:rPr sz="825" b="0">
-                <a:solidFill>
-                  <a:srgbClr val="64748B"/>
-                </a:solidFill>
-              </a:rPr>
-              <a:t>Source: latest_master_report.html, Experiment Setup And Manager Summary</a:t>
-            </a:r>
-          </a:p>
-        </p:txBody>
-      </p:sp>
-      <p:sp>
-        <p:nvSpPr>
-          <p:cNvPr id="11" name="">
-            <a:extLst xmlns:a="http://schemas.openxmlformats.org/drawingml/2006/main">
-              <a:ext uri="{FF2B5EF4-FFF2-40B4-BE49-F238E27FC236}">
-                <a16:creationId xmlns:a16="http://schemas.microsoft.com/office/drawing/2014/main" id="{517562BF-BBF6-4EB0-B9C6-8131BEDFA783}"/>
+          <p:cNvPr id="20" name="">
+            <a:extLst xmlns:a="http://schemas.openxmlformats.org/drawingml/2006/main">
+              <a:ext uri="{FF2B5EF4-FFF2-40B4-BE49-F238E27FC236}">
+                <a16:creationId xmlns:a16="http://schemas.microsoft.com/office/drawing/2014/main" id="{981A80A2-C487-4B63-9C4D-7D904D482F79}"/>
               </a:ext>
             </a:extLst>
           </p:cNvPr>
@@ -5407,10 +6681,10 @@
       </p:sp>
       <p:sp>
         <p:nvSpPr>
-          <p:cNvPr id="12" name="">
-            <a:extLst xmlns:a="http://schemas.openxmlformats.org/drawingml/2006/main">
-              <a:ext uri="{FF2B5EF4-FFF2-40B4-BE49-F238E27FC236}">
-                <a16:creationId xmlns:a16="http://schemas.microsoft.com/office/drawing/2014/main" id="{2EF5F4C4-0603-4322-AA0A-C0E42B3132ED}"/>
+          <p:cNvPr id="21" name="">
+            <a:extLst xmlns:a="http://schemas.openxmlformats.org/drawingml/2006/main">
+              <a:ext uri="{FF2B5EF4-FFF2-40B4-BE49-F238E27FC236}">
+                <a16:creationId xmlns:a16="http://schemas.microsoft.com/office/drawing/2014/main" id="{D056856B-4BFC-4185-9753-5BAF5B6C2901}"/>
               </a:ext>
             </a:extLst>
           </p:cNvPr>
@@ -5458,7 +6732,7 @@
     </p:spTree>
     <p:extLst>
       <p:ext uri="{BB962C8B-B14F-4D97-AF65-F5344CB8AC3E}">
-        <p14:creationId xmlns:p14="http://schemas.microsoft.com/office/powerpoint/2010/main" val="298855737"/>
+        <p14:creationId xmlns:p14="http://schemas.microsoft.com/office/powerpoint/2010/main" val="947024270"/>
       </p:ext>
     </p:extLst>
   </p:cSld>
@@ -5489,7 +6763,7 @@
           <p:cNvPr id="15" name="">
             <a:extLst xmlns:a="http://schemas.openxmlformats.org/drawingml/2006/main">
               <a:ext uri="{FF2B5EF4-FFF2-40B4-BE49-F238E27FC236}">
-                <a16:creationId xmlns:a16="http://schemas.microsoft.com/office/drawing/2014/main" id="{D099DDF8-60CF-4C85-BFA6-0F5C13C5EA10}"/>
+                <a16:creationId xmlns:a16="http://schemas.microsoft.com/office/drawing/2014/main" id="{524C366F-CE34-4B3F-BC1B-846FBF9F6DAF}"/>
               </a:ext>
             </a:extLst>
           </p:cNvPr>
@@ -5539,7 +6813,7 @@
           <p:cNvPr id="2" name="">
             <a:extLst xmlns:a="http://schemas.openxmlformats.org/drawingml/2006/main">
               <a:ext uri="{FF2B5EF4-FFF2-40B4-BE49-F238E27FC236}">
-                <a16:creationId xmlns:a16="http://schemas.microsoft.com/office/drawing/2014/main" id="{70667946-6A2F-431A-977A-61EBB9C5457A}"/>
+                <a16:creationId xmlns:a16="http://schemas.microsoft.com/office/drawing/2014/main" id="{72D34990-8603-47AD-B834-F6FFF0E85801}"/>
               </a:ext>
             </a:extLst>
           </p:cNvPr>
@@ -5589,7 +6863,7 @@
           <p:cNvPr id="3" name="">
             <a:extLst xmlns:a="http://schemas.openxmlformats.org/drawingml/2006/main">
               <a:ext uri="{FF2B5EF4-FFF2-40B4-BE49-F238E27FC236}">
-                <a16:creationId xmlns:a16="http://schemas.microsoft.com/office/drawing/2014/main" id="{115AACE9-0180-494D-9A5A-1219A9521611}"/>
+                <a16:creationId xmlns:a16="http://schemas.microsoft.com/office/drawing/2014/main" id="{BF82FFEC-E09D-4E79-A7FE-FB0F268B5E6C}"/>
               </a:ext>
             </a:extLst>
           </p:cNvPr>
@@ -5639,7 +6913,7 @@
           <p:cNvPr id="4" name="">
             <a:extLst xmlns:a="http://schemas.openxmlformats.org/drawingml/2006/main">
               <a:ext uri="{FF2B5EF4-FFF2-40B4-BE49-F238E27FC236}">
-                <a16:creationId xmlns:a16="http://schemas.microsoft.com/office/drawing/2014/main" id="{2433E807-025F-4070-9E82-C074E53C7829}"/>
+                <a16:creationId xmlns:a16="http://schemas.microsoft.com/office/drawing/2014/main" id="{7FB36E10-396B-4B33-84B3-8908C105A955}"/>
               </a:ext>
             </a:extLst>
           </p:cNvPr>
@@ -5689,7 +6963,7 @@
           <p:cNvPr id="5" name="">
             <a:extLst xmlns:a="http://schemas.openxmlformats.org/drawingml/2006/main">
               <a:ext uri="{FF2B5EF4-FFF2-40B4-BE49-F238E27FC236}">
-                <a16:creationId xmlns:a16="http://schemas.microsoft.com/office/drawing/2014/main" id="{819522EE-90BB-4DF7-8571-8E0AA958BE77}"/>
+                <a16:creationId xmlns:a16="http://schemas.microsoft.com/office/drawing/2014/main" id="{A5AA46D2-C52D-48F8-A886-934E031EA098}"/>
               </a:ext>
             </a:extLst>
           </p:cNvPr>
@@ -5739,7 +7013,7 @@
           <p:cNvPr id="6" name="">
             <a:extLst xmlns:a="http://schemas.openxmlformats.org/drawingml/2006/main">
               <a:ext uri="{FF2B5EF4-FFF2-40B4-BE49-F238E27FC236}">
-                <a16:creationId xmlns:a16="http://schemas.microsoft.com/office/drawing/2014/main" id="{636F7F6D-1324-410F-B65B-BB76ECA12C99}"/>
+                <a16:creationId xmlns:a16="http://schemas.microsoft.com/office/drawing/2014/main" id="{6357B22D-0BEA-4F41-91F6-BA4715F638F4}"/>
               </a:ext>
             </a:extLst>
           </p:cNvPr>
@@ -5789,7 +7063,7 @@
           <p:cNvPr id="7" name="">
             <a:extLst xmlns:a="http://schemas.openxmlformats.org/drawingml/2006/main">
               <a:ext uri="{FF2B5EF4-FFF2-40B4-BE49-F238E27FC236}">
-                <a16:creationId xmlns:a16="http://schemas.microsoft.com/office/drawing/2014/main" id="{C897D364-AB65-45A0-A1B0-7C7984F43972}"/>
+                <a16:creationId xmlns:a16="http://schemas.microsoft.com/office/drawing/2014/main" id="{373F2FF0-CF6D-4230-8C8A-FAEFFBC8A25D}"/>
               </a:ext>
             </a:extLst>
           </p:cNvPr>
@@ -5839,7 +7113,7 @@
           <p:cNvPr id="8" name="">
             <a:extLst xmlns:a="http://schemas.openxmlformats.org/drawingml/2006/main">
               <a:ext uri="{FF2B5EF4-FFF2-40B4-BE49-F238E27FC236}">
-                <a16:creationId xmlns:a16="http://schemas.microsoft.com/office/drawing/2014/main" id="{3CA6797C-F5A9-443B-9444-9289BCE3C3B0}"/>
+                <a16:creationId xmlns:a16="http://schemas.microsoft.com/office/drawing/2014/main" id="{C4F57CD4-10E9-429F-AAA0-5A533F4D1EA6}"/>
               </a:ext>
             </a:extLst>
           </p:cNvPr>
@@ -5889,7 +7163,7 @@
           <p:cNvPr id="9" name="">
             <a:extLst xmlns:a="http://schemas.openxmlformats.org/drawingml/2006/main">
               <a:ext uri="{FF2B5EF4-FFF2-40B4-BE49-F238E27FC236}">
-                <a16:creationId xmlns:a16="http://schemas.microsoft.com/office/drawing/2014/main" id="{293519CA-F7BF-48AD-9664-82CA7777D070}"/>
+                <a16:creationId xmlns:a16="http://schemas.microsoft.com/office/drawing/2014/main" id="{563921B5-8403-478E-BE4B-4629E8C858BB}"/>
               </a:ext>
             </a:extLst>
           </p:cNvPr>
@@ -5939,7 +7213,7 @@
           <p:cNvPr id="10" name="">
             <a:extLst xmlns:a="http://schemas.openxmlformats.org/drawingml/2006/main">
               <a:ext uri="{FF2B5EF4-FFF2-40B4-BE49-F238E27FC236}">
-                <a16:creationId xmlns:a16="http://schemas.microsoft.com/office/drawing/2014/main" id="{6011E1E7-459A-4DD1-AC1A-FB2AAFF0B60A}"/>
+                <a16:creationId xmlns:a16="http://schemas.microsoft.com/office/drawing/2014/main" id="{3810DEF7-2B6A-4E7C-809C-432AAAA7813C}"/>
               </a:ext>
             </a:extLst>
           </p:cNvPr>
@@ -5989,7 +7263,7 @@
           <p:cNvPr id="11" name="">
             <a:extLst xmlns:a="http://schemas.openxmlformats.org/drawingml/2006/main">
               <a:ext uri="{FF2B5EF4-FFF2-40B4-BE49-F238E27FC236}">
-                <a16:creationId xmlns:a16="http://schemas.microsoft.com/office/drawing/2014/main" id="{FB361BDA-069E-4988-B0ED-DFC5FE8F42A6}"/>
+                <a16:creationId xmlns:a16="http://schemas.microsoft.com/office/drawing/2014/main" id="{242C3F51-AA1F-493A-9044-FAA2B74E2689}"/>
               </a:ext>
             </a:extLst>
           </p:cNvPr>
@@ -6020,7 +7294,7 @@
           <p:cNvPr id="12" name="">
             <a:extLst xmlns:a="http://schemas.openxmlformats.org/drawingml/2006/main">
               <a:ext uri="{FF2B5EF4-FFF2-40B4-BE49-F238E27FC236}">
-                <a16:creationId xmlns:a16="http://schemas.microsoft.com/office/drawing/2014/main" id="{F8C9B73D-7DED-4749-8665-2272A1B38EBD}"/>
+                <a16:creationId xmlns:a16="http://schemas.microsoft.com/office/drawing/2014/main" id="{732F0D12-41B6-4C47-904A-2FD2F5A03FD1}"/>
               </a:ext>
             </a:extLst>
           </p:cNvPr>
@@ -6070,7 +7344,7 @@
           <p:cNvPr id="13" name="">
             <a:extLst xmlns:a="http://schemas.openxmlformats.org/drawingml/2006/main">
               <a:ext uri="{FF2B5EF4-FFF2-40B4-BE49-F238E27FC236}">
-                <a16:creationId xmlns:a16="http://schemas.microsoft.com/office/drawing/2014/main" id="{CFD6BF6D-FB11-4F89-8169-008EA63F339A}"/>
+                <a16:creationId xmlns:a16="http://schemas.microsoft.com/office/drawing/2014/main" id="{CEBFF4B2-7058-45AD-898D-581F11F2FCCC}"/>
               </a:ext>
             </a:extLst>
           </p:cNvPr>
@@ -6120,7 +7394,7 @@
           <p:cNvPr id="14" name="">
             <a:extLst xmlns:a="http://schemas.openxmlformats.org/drawingml/2006/main">
               <a:ext uri="{FF2B5EF4-FFF2-40B4-BE49-F238E27FC236}">
-                <a16:creationId xmlns:a16="http://schemas.microsoft.com/office/drawing/2014/main" id="{7F02B8AA-56F2-47A3-A2C2-BAADF9A5EDBB}"/>
+                <a16:creationId xmlns:a16="http://schemas.microsoft.com/office/drawing/2014/main" id="{C9244580-1673-41A2-96EA-656ED2EAFACE}"/>
               </a:ext>
             </a:extLst>
           </p:cNvPr>
@@ -6168,7 +7442,7 @@
     </p:spTree>
     <p:extLst>
       <p:ext uri="{BB962C8B-B14F-4D97-AF65-F5344CB8AC3E}">
-        <p14:creationId xmlns:p14="http://schemas.microsoft.com/office/powerpoint/2010/main" val="1889608842"/>
+        <p14:creationId xmlns:p14="http://schemas.microsoft.com/office/powerpoint/2010/main" val="707378012"/>
       </p:ext>
     </p:extLst>
   </p:cSld>
@@ -6196,10 +7470,10 @@
       </p:grpSpPr>
       <p:sp>
         <p:nvSpPr>
-          <p:cNvPr id="7" name="">
-            <a:extLst xmlns:a="http://schemas.openxmlformats.org/drawingml/2006/main">
-              <a:ext uri="{FF2B5EF4-FFF2-40B4-BE49-F238E27FC236}">
-                <a16:creationId xmlns:a16="http://schemas.microsoft.com/office/drawing/2014/main" id="{AA6ADB8B-BF7F-4205-9884-3C6AE8326CB1}"/>
+          <p:cNvPr id="6" name="">
+            <a:extLst xmlns:a="http://schemas.openxmlformats.org/drawingml/2006/main">
+              <a:ext uri="{FF2B5EF4-FFF2-40B4-BE49-F238E27FC236}">
+                <a16:creationId xmlns:a16="http://schemas.microsoft.com/office/drawing/2014/main" id="{B5CB5E58-3C5B-472C-9ACA-A57E00A07C2D}"/>
               </a:ext>
             </a:extLst>
           </p:cNvPr>
@@ -6249,7 +7523,7 @@
           <p:cNvPr id="2" name="">
             <a:extLst xmlns:a="http://schemas.openxmlformats.org/drawingml/2006/main">
               <a:ext uri="{FF2B5EF4-FFF2-40B4-BE49-F238E27FC236}">
-                <a16:creationId xmlns:a16="http://schemas.microsoft.com/office/drawing/2014/main" id="{92CC7DF5-9151-46B1-987C-8CFC254D946B}"/>
+                <a16:creationId xmlns:a16="http://schemas.microsoft.com/office/drawing/2014/main" id="{4C9280EB-B5F4-440A-A393-702204B0EBC1}"/>
               </a:ext>
             </a:extLst>
           </p:cNvPr>
@@ -6296,14 +7570,14 @@
       </p:sp>
       <p:pic>
         <p:nvPicPr>
-          <p:cNvPr id="9" name=""/>
+          <p:cNvPr id="8" name=""/>
           <p:cNvPicPr>
             <a:picLocks xmlns:a="http://schemas.openxmlformats.org/drawingml/2006/main" noChangeAspect="1"/>
           </p:cNvPicPr>
           <p:nvPr/>
         </p:nvPicPr>
         <p:blipFill>
-          <a:blip xmlns:r="http://schemas.openxmlformats.org/officeDocument/2006/relationships" xmlns:a="http://schemas.openxmlformats.org/drawingml/2006/main" r:embed="R565f879706f4468b"/>
+          <a:blip xmlns:r="http://schemas.openxmlformats.org/officeDocument/2006/relationships" xmlns:a="http://schemas.openxmlformats.org/drawingml/2006/main" r:embed="R4d822850def849d2"/>
           <a:stretch xmlns:a="http://schemas.openxmlformats.org/drawingml/2006/main"/>
         </p:blipFill>
         <p:spPr>
@@ -6321,57 +7595,7 @@
           <p:cNvPr id="4" name="">
             <a:extLst xmlns:a="http://schemas.openxmlformats.org/drawingml/2006/main">
               <a:ext uri="{FF2B5EF4-FFF2-40B4-BE49-F238E27FC236}">
-                <a16:creationId xmlns:a16="http://schemas.microsoft.com/office/drawing/2014/main" id="{8D765EE8-68FC-41F1-9957-982CCF9C1897}"/>
-              </a:ext>
-            </a:extLst>
-          </p:cNvPr>
-          <p:cNvSpPr>
-            <a:spLocks xmlns:a="http://schemas.openxmlformats.org/drawingml/2006/main" noGrp="1"/>
-          </p:cNvSpPr>
-          <p:nvPr/>
-        </p:nvSpPr>
-        <p:spPr>
-          <a:xfrm xmlns:a="http://schemas.openxmlformats.org/drawingml/2006/main">
-            <a:off x="419100" y="6134100"/>
-            <a:ext cx="9334500" cy="190500"/>
-          </a:xfrm>
-          <a:prstGeom xmlns:a="http://schemas.openxmlformats.org/drawingml/2006/main" prst="rect">
-            <a:avLst/>
-          </a:prstGeom>
-          <a:noFill xmlns:a="http://schemas.openxmlformats.org/drawingml/2006/main"/>
-          <a:ln xmlns:a="http://schemas.openxmlformats.org/drawingml/2006/main" w="0">
-            <a:noFill/>
-            <a:prstDash val="solid"/>
-          </a:ln>
-        </p:spPr>
-        <p:txBody>
-          <a:bodyPr xmlns:a="http://schemas.openxmlformats.org/drawingml/2006/main" anchor="t"/>
-          <a:lstStyle xmlns:a="http://schemas.openxmlformats.org/drawingml/2006/main"/>
-          <a:p xmlns:a="http://schemas.openxmlformats.org/drawingml/2006/main">
-            <a:pPr algn="l">
-              <a:defRPr sz="825" b="0">
-                <a:solidFill>
-                  <a:srgbClr val="64748B"/>
-                </a:solidFill>
-              </a:defRPr>
-            </a:pPr>
-            <a:r>
-              <a:rPr sz="825" b="0">
-                <a:solidFill>
-                  <a:srgbClr val="64748B"/>
-                </a:solidFill>
-              </a:rPr>
-              <a:t>Source: latest_master_report.html controlled run</a:t>
-            </a:r>
-          </a:p>
-        </p:txBody>
-      </p:sp>
-      <p:sp>
-        <p:nvSpPr>
-          <p:cNvPr id="5" name="">
-            <a:extLst xmlns:a="http://schemas.openxmlformats.org/drawingml/2006/main">
-              <a:ext uri="{FF2B5EF4-FFF2-40B4-BE49-F238E27FC236}">
-                <a16:creationId xmlns:a16="http://schemas.microsoft.com/office/drawing/2014/main" id="{F3D8D844-35EF-43D1-84E7-32F43F8FDB99}"/>
+                <a16:creationId xmlns:a16="http://schemas.microsoft.com/office/drawing/2014/main" id="{79FC21EA-CBAC-40DB-A312-903064AD1514}"/>
               </a:ext>
             </a:extLst>
           </p:cNvPr>
@@ -6418,10 +7642,10 @@
       </p:sp>
       <p:sp>
         <p:nvSpPr>
-          <p:cNvPr id="6" name="">
-            <a:extLst xmlns:a="http://schemas.openxmlformats.org/drawingml/2006/main">
-              <a:ext uri="{FF2B5EF4-FFF2-40B4-BE49-F238E27FC236}">
-                <a16:creationId xmlns:a16="http://schemas.microsoft.com/office/drawing/2014/main" id="{D0DE714B-E1C8-4B4E-A17E-8A240EE16738}"/>
+          <p:cNvPr id="5" name="">
+            <a:extLst xmlns:a="http://schemas.openxmlformats.org/drawingml/2006/main">
+              <a:ext uri="{FF2B5EF4-FFF2-40B4-BE49-F238E27FC236}">
+                <a16:creationId xmlns:a16="http://schemas.microsoft.com/office/drawing/2014/main" id="{A24A752F-DCA2-4B27-A6BA-82ED24E2307E}"/>
               </a:ext>
             </a:extLst>
           </p:cNvPr>
@@ -6469,7 +7693,7 @@
     </p:spTree>
     <p:extLst>
       <p:ext uri="{BB962C8B-B14F-4D97-AF65-F5344CB8AC3E}">
-        <p14:creationId xmlns:p14="http://schemas.microsoft.com/office/powerpoint/2010/main" val="311302887"/>
+        <p14:creationId xmlns:p14="http://schemas.microsoft.com/office/powerpoint/2010/main" val="1958997452"/>
       </p:ext>
     </p:extLst>
   </p:cSld>
@@ -6497,10 +7721,10 @@
       </p:grpSpPr>
       <p:sp>
         <p:nvSpPr>
-          <p:cNvPr id="12" name="">
-            <a:extLst xmlns:a="http://schemas.openxmlformats.org/drawingml/2006/main">
-              <a:ext uri="{FF2B5EF4-FFF2-40B4-BE49-F238E27FC236}">
-                <a16:creationId xmlns:a16="http://schemas.microsoft.com/office/drawing/2014/main" id="{3FC0132B-666E-41B8-AE90-0001F6A8337E}"/>
+          <p:cNvPr id="11" name="">
+            <a:extLst xmlns:a="http://schemas.openxmlformats.org/drawingml/2006/main">
+              <a:ext uri="{FF2B5EF4-FFF2-40B4-BE49-F238E27FC236}">
+                <a16:creationId xmlns:a16="http://schemas.microsoft.com/office/drawing/2014/main" id="{D07AE9E6-FCF5-49DE-99D6-31697F858267}"/>
               </a:ext>
             </a:extLst>
           </p:cNvPr>
@@ -6550,7 +7774,7 @@
           <p:cNvPr id="2" name="">
             <a:extLst xmlns:a="http://schemas.openxmlformats.org/drawingml/2006/main">
               <a:ext uri="{FF2B5EF4-FFF2-40B4-BE49-F238E27FC236}">
-                <a16:creationId xmlns:a16="http://schemas.microsoft.com/office/drawing/2014/main" id="{EFC3ADBA-4CDA-4EF1-8F2C-27CDB77E6C2F}"/>
+                <a16:creationId xmlns:a16="http://schemas.microsoft.com/office/drawing/2014/main" id="{7B253396-F255-40C2-A080-F191CE4428DF}"/>
               </a:ext>
             </a:extLst>
           </p:cNvPr>
@@ -6597,14 +7821,14 @@
       </p:sp>
       <p:pic>
         <p:nvPicPr>
-          <p:cNvPr id="14" name=""/>
+          <p:cNvPr id="13" name=""/>
           <p:cNvPicPr>
             <a:picLocks xmlns:a="http://schemas.openxmlformats.org/drawingml/2006/main" noChangeAspect="1"/>
           </p:cNvPicPr>
           <p:nvPr/>
         </p:nvPicPr>
         <p:blipFill>
-          <a:blip xmlns:r="http://schemas.openxmlformats.org/officeDocument/2006/relationships" xmlns:a="http://schemas.openxmlformats.org/drawingml/2006/main" r:embed="R24591ba0485e4c12"/>
+          <a:blip xmlns:r="http://schemas.openxmlformats.org/officeDocument/2006/relationships" xmlns:a="http://schemas.openxmlformats.org/drawingml/2006/main" r:embed="R3816c416c0ff44a5"/>
           <a:stretch xmlns:a="http://schemas.openxmlformats.org/drawingml/2006/main"/>
         </p:blipFill>
         <p:spPr>
@@ -6622,7 +7846,7 @@
           <p:cNvPr id="4" name="">
             <a:extLst xmlns:a="http://schemas.openxmlformats.org/drawingml/2006/main">
               <a:ext uri="{FF2B5EF4-FFF2-40B4-BE49-F238E27FC236}">
-                <a16:creationId xmlns:a16="http://schemas.microsoft.com/office/drawing/2014/main" id="{CF1A9AA5-0DDE-4C36-9AA4-0187BC1E8ADF}"/>
+                <a16:creationId xmlns:a16="http://schemas.microsoft.com/office/drawing/2014/main" id="{62337011-70F9-4A83-A098-84C858B104AF}"/>
               </a:ext>
             </a:extLst>
           </p:cNvPr>
@@ -6672,7 +7896,7 @@
           <p:cNvPr id="5" name="">
             <a:extLst xmlns:a="http://schemas.openxmlformats.org/drawingml/2006/main">
               <a:ext uri="{FF2B5EF4-FFF2-40B4-BE49-F238E27FC236}">
-                <a16:creationId xmlns:a16="http://schemas.microsoft.com/office/drawing/2014/main" id="{848A6E7C-524A-48B1-8A51-0C144F860AB5}"/>
+                <a16:creationId xmlns:a16="http://schemas.microsoft.com/office/drawing/2014/main" id="{203A934D-CF43-4741-89AF-82B72C328D51}"/>
               </a:ext>
             </a:extLst>
           </p:cNvPr>
@@ -6722,7 +7946,7 @@
           <p:cNvPr id="6" name="">
             <a:extLst xmlns:a="http://schemas.openxmlformats.org/drawingml/2006/main">
               <a:ext uri="{FF2B5EF4-FFF2-40B4-BE49-F238E27FC236}">
-                <a16:creationId xmlns:a16="http://schemas.microsoft.com/office/drawing/2014/main" id="{013A0A67-1C5E-4FEA-9E77-BFEFAE3BF47E}"/>
+                <a16:creationId xmlns:a16="http://schemas.microsoft.com/office/drawing/2014/main" id="{A379AC97-7B92-4FD1-BDDA-D28DE6C322F1}"/>
               </a:ext>
             </a:extLst>
           </p:cNvPr>
@@ -6772,7 +7996,7 @@
           <p:cNvPr id="7" name="">
             <a:extLst xmlns:a="http://schemas.openxmlformats.org/drawingml/2006/main">
               <a:ext uri="{FF2B5EF4-FFF2-40B4-BE49-F238E27FC236}">
-                <a16:creationId xmlns:a16="http://schemas.microsoft.com/office/drawing/2014/main" id="{748D1B02-9906-45B2-BF03-DC4A61673860}"/>
+                <a16:creationId xmlns:a16="http://schemas.microsoft.com/office/drawing/2014/main" id="{DA8DACC9-3D78-42CF-BBB2-B3337AEF9F23}"/>
               </a:ext>
             </a:extLst>
           </p:cNvPr>
@@ -6822,7 +8046,7 @@
           <p:cNvPr id="8" name="">
             <a:extLst xmlns:a="http://schemas.openxmlformats.org/drawingml/2006/main">
               <a:ext uri="{FF2B5EF4-FFF2-40B4-BE49-F238E27FC236}">
-                <a16:creationId xmlns:a16="http://schemas.microsoft.com/office/drawing/2014/main" id="{311822C4-208E-421B-B595-5ED32BAA710C}"/>
+                <a16:creationId xmlns:a16="http://schemas.microsoft.com/office/drawing/2014/main" id="{9ACFAB0A-D81C-4078-8027-E6DB1E3255A3}"/>
               </a:ext>
             </a:extLst>
           </p:cNvPr>
@@ -6872,57 +8096,7 @@
           <p:cNvPr id="9" name="">
             <a:extLst xmlns:a="http://schemas.openxmlformats.org/drawingml/2006/main">
               <a:ext uri="{FF2B5EF4-FFF2-40B4-BE49-F238E27FC236}">
-                <a16:creationId xmlns:a16="http://schemas.microsoft.com/office/drawing/2014/main" id="{18C51214-E419-4520-AD58-230FE6A3110C}"/>
-              </a:ext>
-            </a:extLst>
-          </p:cNvPr>
-          <p:cNvSpPr>
-            <a:spLocks xmlns:a="http://schemas.openxmlformats.org/drawingml/2006/main" noGrp="1"/>
-          </p:cNvSpPr>
-          <p:nvPr/>
-        </p:nvSpPr>
-        <p:spPr>
-          <a:xfrm xmlns:a="http://schemas.openxmlformats.org/drawingml/2006/main">
-            <a:off x="419100" y="6134100"/>
-            <a:ext cx="9334500" cy="190500"/>
-          </a:xfrm>
-          <a:prstGeom xmlns:a="http://schemas.openxmlformats.org/drawingml/2006/main" prst="rect">
-            <a:avLst/>
-          </a:prstGeom>
-          <a:noFill xmlns:a="http://schemas.openxmlformats.org/drawingml/2006/main"/>
-          <a:ln xmlns:a="http://schemas.openxmlformats.org/drawingml/2006/main" w="0">
-            <a:noFill/>
-            <a:prstDash val="solid"/>
-          </a:ln>
-        </p:spPr>
-        <p:txBody>
-          <a:bodyPr xmlns:a="http://schemas.openxmlformats.org/drawingml/2006/main" anchor="t"/>
-          <a:lstStyle xmlns:a="http://schemas.openxmlformats.org/drawingml/2006/main"/>
-          <a:p xmlns:a="http://schemas.openxmlformats.org/drawingml/2006/main">
-            <a:pPr algn="l">
-              <a:defRPr sz="825" b="0">
-                <a:solidFill>
-                  <a:srgbClr val="64748B"/>
-                </a:solidFill>
-              </a:defRPr>
-            </a:pPr>
-            <a:r>
-              <a:rPr sz="825" b="0">
-                <a:solidFill>
-                  <a:srgbClr val="64748B"/>
-                </a:solidFill>
-              </a:rPr>
-              <a:t>Source: backups/latest_master_report-1.html, Global Prefetch Margin</a:t>
-            </a:r>
-          </a:p>
-        </p:txBody>
-      </p:sp>
-      <p:sp>
-        <p:nvSpPr>
-          <p:cNvPr id="10" name="">
-            <a:extLst xmlns:a="http://schemas.openxmlformats.org/drawingml/2006/main">
-              <a:ext uri="{FF2B5EF4-FFF2-40B4-BE49-F238E27FC236}">
-                <a16:creationId xmlns:a16="http://schemas.microsoft.com/office/drawing/2014/main" id="{4AF83E6B-D6CD-4A42-B140-2BB89D61D0AE}"/>
+                <a16:creationId xmlns:a16="http://schemas.microsoft.com/office/drawing/2014/main" id="{D43398B7-02AB-420B-8AA7-369313BE8BA5}"/>
               </a:ext>
             </a:extLst>
           </p:cNvPr>
@@ -6969,10 +8143,10 @@
       </p:sp>
       <p:sp>
         <p:nvSpPr>
-          <p:cNvPr id="11" name="">
-            <a:extLst xmlns:a="http://schemas.openxmlformats.org/drawingml/2006/main">
-              <a:ext uri="{FF2B5EF4-FFF2-40B4-BE49-F238E27FC236}">
-                <a16:creationId xmlns:a16="http://schemas.microsoft.com/office/drawing/2014/main" id="{4993B0F6-F3B9-41B2-89C9-50DE7DA60BDE}"/>
+          <p:cNvPr id="10" name="">
+            <a:extLst xmlns:a="http://schemas.openxmlformats.org/drawingml/2006/main">
+              <a:ext uri="{FF2B5EF4-FFF2-40B4-BE49-F238E27FC236}">
+                <a16:creationId xmlns:a16="http://schemas.microsoft.com/office/drawing/2014/main" id="{268EEEF1-9E52-4174-A570-532EA29BC559}"/>
               </a:ext>
             </a:extLst>
           </p:cNvPr>
@@ -7020,7 +8194,7 @@
     </p:spTree>
     <p:extLst>
       <p:ext uri="{BB962C8B-B14F-4D97-AF65-F5344CB8AC3E}">
-        <p14:creationId xmlns:p14="http://schemas.microsoft.com/office/powerpoint/2010/main" val="634894223"/>
+        <p14:creationId xmlns:p14="http://schemas.microsoft.com/office/powerpoint/2010/main" val="1775054189"/>
       </p:ext>
     </p:extLst>
   </p:cSld>
@@ -7048,10 +8222,10 @@
       </p:grpSpPr>
       <p:sp>
         <p:nvSpPr>
-          <p:cNvPr id="14" name="">
-            <a:extLst xmlns:a="http://schemas.openxmlformats.org/drawingml/2006/main">
-              <a:ext uri="{FF2B5EF4-FFF2-40B4-BE49-F238E27FC236}">
-                <a16:creationId xmlns:a16="http://schemas.microsoft.com/office/drawing/2014/main" id="{E52AC5A3-099D-4479-A2FE-6A3DADCFC8F5}"/>
+          <p:cNvPr id="13" name="">
+            <a:extLst xmlns:a="http://schemas.openxmlformats.org/drawingml/2006/main">
+              <a:ext uri="{FF2B5EF4-FFF2-40B4-BE49-F238E27FC236}">
+                <a16:creationId xmlns:a16="http://schemas.microsoft.com/office/drawing/2014/main" id="{4671A170-8086-4D84-91D4-3F93A38573E5}"/>
               </a:ext>
             </a:extLst>
           </p:cNvPr>
@@ -7101,7 +8275,7 @@
           <p:cNvPr id="2" name="">
             <a:extLst xmlns:a="http://schemas.openxmlformats.org/drawingml/2006/main">
               <a:ext uri="{FF2B5EF4-FFF2-40B4-BE49-F238E27FC236}">
-                <a16:creationId xmlns:a16="http://schemas.microsoft.com/office/drawing/2014/main" id="{D43B8401-94AE-4D00-B1DF-C6087598D019}"/>
+                <a16:creationId xmlns:a16="http://schemas.microsoft.com/office/drawing/2014/main" id="{ACC0E34C-0653-49CD-9088-69E254D0C467}"/>
               </a:ext>
             </a:extLst>
           </p:cNvPr>
@@ -7148,14 +8322,14 @@
       </p:sp>
       <p:pic>
         <p:nvPicPr>
-          <p:cNvPr id="16" name=""/>
+          <p:cNvPr id="15" name=""/>
           <p:cNvPicPr>
             <a:picLocks xmlns:a="http://schemas.openxmlformats.org/drawingml/2006/main" noChangeAspect="1"/>
           </p:cNvPicPr>
           <p:nvPr/>
         </p:nvPicPr>
         <p:blipFill>
-          <a:blip xmlns:r="http://schemas.openxmlformats.org/officeDocument/2006/relationships" xmlns:a="http://schemas.openxmlformats.org/drawingml/2006/main" r:embed="Rd58270b99d6c4dc2"/>
+          <a:blip xmlns:r="http://schemas.openxmlformats.org/officeDocument/2006/relationships" xmlns:a="http://schemas.openxmlformats.org/drawingml/2006/main" r:embed="R6d4e49561f5243b2"/>
           <a:stretch xmlns:a="http://schemas.openxmlformats.org/drawingml/2006/main"/>
         </p:blipFill>
         <p:spPr>
@@ -7173,7 +8347,7 @@
           <p:cNvPr id="4" name="">
             <a:extLst xmlns:a="http://schemas.openxmlformats.org/drawingml/2006/main">
               <a:ext uri="{FF2B5EF4-FFF2-40B4-BE49-F238E27FC236}">
-                <a16:creationId xmlns:a16="http://schemas.microsoft.com/office/drawing/2014/main" id="{26C6B26E-A11C-4BC9-877A-A28A77371905}"/>
+                <a16:creationId xmlns:a16="http://schemas.microsoft.com/office/drawing/2014/main" id="{5026578A-6205-45FD-8088-710F876E010A}"/>
               </a:ext>
             </a:extLst>
           </p:cNvPr>
@@ -7223,7 +8397,7 @@
           <p:cNvPr id="5" name="">
             <a:extLst xmlns:a="http://schemas.openxmlformats.org/drawingml/2006/main">
               <a:ext uri="{FF2B5EF4-FFF2-40B4-BE49-F238E27FC236}">
-                <a16:creationId xmlns:a16="http://schemas.microsoft.com/office/drawing/2014/main" id="{B2888244-4713-49F1-8656-3C5D109888A0}"/>
+                <a16:creationId xmlns:a16="http://schemas.microsoft.com/office/drawing/2014/main" id="{8CFA7176-08C7-457C-99B0-0BC628541755}"/>
               </a:ext>
             </a:extLst>
           </p:cNvPr>
@@ -7273,7 +8447,7 @@
           <p:cNvPr id="6" name="">
             <a:extLst xmlns:a="http://schemas.openxmlformats.org/drawingml/2006/main">
               <a:ext uri="{FF2B5EF4-FFF2-40B4-BE49-F238E27FC236}">
-                <a16:creationId xmlns:a16="http://schemas.microsoft.com/office/drawing/2014/main" id="{EA71AAE6-909E-4143-834D-FA7F7F62F1FB}"/>
+                <a16:creationId xmlns:a16="http://schemas.microsoft.com/office/drawing/2014/main" id="{5B711EB1-F118-4D44-97E6-B13DAA85E356}"/>
               </a:ext>
             </a:extLst>
           </p:cNvPr>
@@ -7323,7 +8497,7 @@
           <p:cNvPr id="7" name="">
             <a:extLst xmlns:a="http://schemas.openxmlformats.org/drawingml/2006/main">
               <a:ext uri="{FF2B5EF4-FFF2-40B4-BE49-F238E27FC236}">
-                <a16:creationId xmlns:a16="http://schemas.microsoft.com/office/drawing/2014/main" id="{199F74D3-DD9E-452B-BD78-670830EE90AB}"/>
+                <a16:creationId xmlns:a16="http://schemas.microsoft.com/office/drawing/2014/main" id="{AA77F951-DF73-4EAA-BB56-D7530FF70DB6}"/>
               </a:ext>
             </a:extLst>
           </p:cNvPr>
@@ -7373,7 +8547,7 @@
           <p:cNvPr id="8" name="">
             <a:extLst xmlns:a="http://schemas.openxmlformats.org/drawingml/2006/main">
               <a:ext uri="{FF2B5EF4-FFF2-40B4-BE49-F238E27FC236}">
-                <a16:creationId xmlns:a16="http://schemas.microsoft.com/office/drawing/2014/main" id="{07DA02E2-F1D1-4B93-8D77-2CCF373A0434}"/>
+                <a16:creationId xmlns:a16="http://schemas.microsoft.com/office/drawing/2014/main" id="{E4C78BA4-AA07-491F-AEF3-D686E937DB57}"/>
               </a:ext>
             </a:extLst>
           </p:cNvPr>
@@ -7423,7 +8597,7 @@
           <p:cNvPr id="9" name="">
             <a:extLst xmlns:a="http://schemas.openxmlformats.org/drawingml/2006/main">
               <a:ext uri="{FF2B5EF4-FFF2-40B4-BE49-F238E27FC236}">
-                <a16:creationId xmlns:a16="http://schemas.microsoft.com/office/drawing/2014/main" id="{1E38723F-D7C7-4ABA-A9A3-78DA4D999543}"/>
+                <a16:creationId xmlns:a16="http://schemas.microsoft.com/office/drawing/2014/main" id="{A312E9B3-2F65-4B10-AA52-1B8814544951}"/>
               </a:ext>
             </a:extLst>
           </p:cNvPr>
@@ -7473,7 +8647,7 @@
           <p:cNvPr id="10" name="">
             <a:extLst xmlns:a="http://schemas.openxmlformats.org/drawingml/2006/main">
               <a:ext uri="{FF2B5EF4-FFF2-40B4-BE49-F238E27FC236}">
-                <a16:creationId xmlns:a16="http://schemas.microsoft.com/office/drawing/2014/main" id="{68BCDC75-535F-46F4-AC56-DC0A9EA4330E}"/>
+                <a16:creationId xmlns:a16="http://schemas.microsoft.com/office/drawing/2014/main" id="{AAB88C3C-53AF-498C-A113-1EBF66F3A819}"/>
               </a:ext>
             </a:extLst>
           </p:cNvPr>
@@ -7523,57 +8697,7 @@
           <p:cNvPr id="11" name="">
             <a:extLst xmlns:a="http://schemas.openxmlformats.org/drawingml/2006/main">
               <a:ext uri="{FF2B5EF4-FFF2-40B4-BE49-F238E27FC236}">
-                <a16:creationId xmlns:a16="http://schemas.microsoft.com/office/drawing/2014/main" id="{BD86E477-539D-4193-B6DB-5D8AC28D1573}"/>
-              </a:ext>
-            </a:extLst>
-          </p:cNvPr>
-          <p:cNvSpPr>
-            <a:spLocks xmlns:a="http://schemas.openxmlformats.org/drawingml/2006/main" noGrp="1"/>
-          </p:cNvSpPr>
-          <p:nvPr/>
-        </p:nvSpPr>
-        <p:spPr>
-          <a:xfrm xmlns:a="http://schemas.openxmlformats.org/drawingml/2006/main">
-            <a:off x="419100" y="6134100"/>
-            <a:ext cx="9334500" cy="190500"/>
-          </a:xfrm>
-          <a:prstGeom xmlns:a="http://schemas.openxmlformats.org/drawingml/2006/main" prst="rect">
-            <a:avLst/>
-          </a:prstGeom>
-          <a:noFill xmlns:a="http://schemas.openxmlformats.org/drawingml/2006/main"/>
-          <a:ln xmlns:a="http://schemas.openxmlformats.org/drawingml/2006/main" w="0">
-            <a:noFill/>
-            <a:prstDash val="solid"/>
-          </a:ln>
-        </p:spPr>
-        <p:txBody>
-          <a:bodyPr xmlns:a="http://schemas.openxmlformats.org/drawingml/2006/main" anchor="t"/>
-          <a:lstStyle xmlns:a="http://schemas.openxmlformats.org/drawingml/2006/main"/>
-          <a:p xmlns:a="http://schemas.openxmlformats.org/drawingml/2006/main">
-            <a:pPr algn="l">
-              <a:defRPr sz="825" b="0">
-                <a:solidFill>
-                  <a:srgbClr val="64748B"/>
-                </a:solidFill>
-              </a:defRPr>
-            </a:pPr>
-            <a:r>
-              <a:rPr sz="825" b="0">
-                <a:solidFill>
-                  <a:srgbClr val="64748B"/>
-                </a:solidFill>
-              </a:rPr>
-              <a:t>Source: latest_synthetic_master_report.html, Profiled Mechanism Timelines</a:t>
-            </a:r>
-          </a:p>
-        </p:txBody>
-      </p:sp>
-      <p:sp>
-        <p:nvSpPr>
-          <p:cNvPr id="12" name="">
-            <a:extLst xmlns:a="http://schemas.openxmlformats.org/drawingml/2006/main">
-              <a:ext uri="{FF2B5EF4-FFF2-40B4-BE49-F238E27FC236}">
-                <a16:creationId xmlns:a16="http://schemas.microsoft.com/office/drawing/2014/main" id="{33E7ABCD-2E72-4D61-8725-F18FF0ACAED2}"/>
+                <a16:creationId xmlns:a16="http://schemas.microsoft.com/office/drawing/2014/main" id="{95551343-5FE7-4061-92A0-68ABEDEBA00C}"/>
               </a:ext>
             </a:extLst>
           </p:cNvPr>
@@ -7620,10 +8744,10 @@
       </p:sp>
       <p:sp>
         <p:nvSpPr>
-          <p:cNvPr id="13" name="">
-            <a:extLst xmlns:a="http://schemas.openxmlformats.org/drawingml/2006/main">
-              <a:ext uri="{FF2B5EF4-FFF2-40B4-BE49-F238E27FC236}">
-                <a16:creationId xmlns:a16="http://schemas.microsoft.com/office/drawing/2014/main" id="{3F53CB0F-5CD2-491E-B6EC-9414B3F88A91}"/>
+          <p:cNvPr id="12" name="">
+            <a:extLst xmlns:a="http://schemas.openxmlformats.org/drawingml/2006/main">
+              <a:ext uri="{FF2B5EF4-FFF2-40B4-BE49-F238E27FC236}">
+                <a16:creationId xmlns:a16="http://schemas.microsoft.com/office/drawing/2014/main" id="{D0315A68-5F28-40A5-B14F-58BF2D2C9489}"/>
               </a:ext>
             </a:extLst>
           </p:cNvPr>
@@ -7671,7 +8795,7 @@
     </p:spTree>
     <p:extLst>
       <p:ext uri="{BB962C8B-B14F-4D97-AF65-F5344CB8AC3E}">
-        <p14:creationId xmlns:p14="http://schemas.microsoft.com/office/powerpoint/2010/main" val="495323221"/>
+        <p14:creationId xmlns:p14="http://schemas.microsoft.com/office/powerpoint/2010/main" val="1313210021"/>
       </p:ext>
     </p:extLst>
   </p:cSld>
@@ -7699,10 +8823,10 @@
       </p:grpSpPr>
       <p:sp>
         <p:nvSpPr>
-          <p:cNvPr id="10" name="">
-            <a:extLst xmlns:a="http://schemas.openxmlformats.org/drawingml/2006/main">
-              <a:ext uri="{FF2B5EF4-FFF2-40B4-BE49-F238E27FC236}">
-                <a16:creationId xmlns:a16="http://schemas.microsoft.com/office/drawing/2014/main" id="{9CD6CF57-5097-4588-B06F-E2BB3EFB325D}"/>
+          <p:cNvPr id="9" name="">
+            <a:extLst xmlns:a="http://schemas.openxmlformats.org/drawingml/2006/main">
+              <a:ext uri="{FF2B5EF4-FFF2-40B4-BE49-F238E27FC236}">
+                <a16:creationId xmlns:a16="http://schemas.microsoft.com/office/drawing/2014/main" id="{638350B1-C921-4273-800F-FE317B8F737C}"/>
               </a:ext>
             </a:extLst>
           </p:cNvPr>
@@ -7752,7 +8876,7 @@
           <p:cNvPr id="2" name="">
             <a:extLst xmlns:a="http://schemas.openxmlformats.org/drawingml/2006/main">
               <a:ext uri="{FF2B5EF4-FFF2-40B4-BE49-F238E27FC236}">
-                <a16:creationId xmlns:a16="http://schemas.microsoft.com/office/drawing/2014/main" id="{A54A5F45-A011-403D-BECA-D44565F93797}"/>
+                <a16:creationId xmlns:a16="http://schemas.microsoft.com/office/drawing/2014/main" id="{0D47E67F-B8E7-402A-84D6-C1BD43A319F3}"/>
               </a:ext>
             </a:extLst>
           </p:cNvPr>
@@ -7799,14 +8923,14 @@
       </p:sp>
       <p:pic>
         <p:nvPicPr>
-          <p:cNvPr id="12" name=""/>
+          <p:cNvPr id="11" name=""/>
           <p:cNvPicPr>
             <a:picLocks xmlns:a="http://schemas.openxmlformats.org/drawingml/2006/main" noChangeAspect="1"/>
           </p:cNvPicPr>
           <p:nvPr/>
         </p:nvPicPr>
         <p:blipFill>
-          <a:blip xmlns:r="http://schemas.openxmlformats.org/officeDocument/2006/relationships" xmlns:a="http://schemas.openxmlformats.org/drawingml/2006/main" r:embed="R4ec59d47238145f7"/>
+          <a:blip xmlns:r="http://schemas.openxmlformats.org/officeDocument/2006/relationships" xmlns:a="http://schemas.openxmlformats.org/drawingml/2006/main" r:embed="Rdd230e803e5d48ff"/>
           <a:stretch xmlns:a="http://schemas.openxmlformats.org/drawingml/2006/main"/>
         </p:blipFill>
         <p:spPr>
@@ -7824,7 +8948,7 @@
           <p:cNvPr id="4" name="">
             <a:extLst xmlns:a="http://schemas.openxmlformats.org/drawingml/2006/main">
               <a:ext uri="{FF2B5EF4-FFF2-40B4-BE49-F238E27FC236}">
-                <a16:creationId xmlns:a16="http://schemas.microsoft.com/office/drawing/2014/main" id="{901DCE38-BB11-418B-81BC-B09F88E986CC}"/>
+                <a16:creationId xmlns:a16="http://schemas.microsoft.com/office/drawing/2014/main" id="{6642B4B8-E3C2-4BD8-A14D-F83A0864728D}"/>
               </a:ext>
             </a:extLst>
           </p:cNvPr>
@@ -7874,7 +8998,7 @@
           <p:cNvPr id="5" name="">
             <a:extLst xmlns:a="http://schemas.openxmlformats.org/drawingml/2006/main">
               <a:ext uri="{FF2B5EF4-FFF2-40B4-BE49-F238E27FC236}">
-                <a16:creationId xmlns:a16="http://schemas.microsoft.com/office/drawing/2014/main" id="{51D3FBAA-DC3E-4F60-A445-852B85F5DBB5}"/>
+                <a16:creationId xmlns:a16="http://schemas.microsoft.com/office/drawing/2014/main" id="{BA86C5EA-D7FA-4704-86A6-E77E853BB62C}"/>
               </a:ext>
             </a:extLst>
           </p:cNvPr>
@@ -7924,7 +9048,7 @@
           <p:cNvPr id="6" name="">
             <a:extLst xmlns:a="http://schemas.openxmlformats.org/drawingml/2006/main">
               <a:ext uri="{FF2B5EF4-FFF2-40B4-BE49-F238E27FC236}">
-                <a16:creationId xmlns:a16="http://schemas.microsoft.com/office/drawing/2014/main" id="{1D98EAD6-FBBF-48C9-8BE0-0785C8578F21}"/>
+                <a16:creationId xmlns:a16="http://schemas.microsoft.com/office/drawing/2014/main" id="{723B0C4F-DA4B-4B58-ADE8-DB0C5FEF92EE}"/>
               </a:ext>
             </a:extLst>
           </p:cNvPr>
@@ -7974,57 +9098,7 @@
           <p:cNvPr id="7" name="">
             <a:extLst xmlns:a="http://schemas.openxmlformats.org/drawingml/2006/main">
               <a:ext uri="{FF2B5EF4-FFF2-40B4-BE49-F238E27FC236}">
-                <a16:creationId xmlns:a16="http://schemas.microsoft.com/office/drawing/2014/main" id="{F427FC2D-0DA2-48DD-90C8-6FAD78727591}"/>
-              </a:ext>
-            </a:extLst>
-          </p:cNvPr>
-          <p:cNvSpPr>
-            <a:spLocks xmlns:a="http://schemas.openxmlformats.org/drawingml/2006/main" noGrp="1"/>
-          </p:cNvSpPr>
-          <p:nvPr/>
-        </p:nvSpPr>
-        <p:spPr>
-          <a:xfrm xmlns:a="http://schemas.openxmlformats.org/drawingml/2006/main">
-            <a:off x="419100" y="6134100"/>
-            <a:ext cx="9334500" cy="190500"/>
-          </a:xfrm>
-          <a:prstGeom xmlns:a="http://schemas.openxmlformats.org/drawingml/2006/main" prst="rect">
-            <a:avLst/>
-          </a:prstGeom>
-          <a:noFill xmlns:a="http://schemas.openxmlformats.org/drawingml/2006/main"/>
-          <a:ln xmlns:a="http://schemas.openxmlformats.org/drawingml/2006/main" w="0">
-            <a:noFill/>
-            <a:prstDash val="solid"/>
-          </a:ln>
-        </p:spPr>
-        <p:txBody>
-          <a:bodyPr xmlns:a="http://schemas.openxmlformats.org/drawingml/2006/main" anchor="t"/>
-          <a:lstStyle xmlns:a="http://schemas.openxmlformats.org/drawingml/2006/main"/>
-          <a:p xmlns:a="http://schemas.openxmlformats.org/drawingml/2006/main">
-            <a:pPr algn="l">
-              <a:defRPr sz="825" b="0">
-                <a:solidFill>
-                  <a:srgbClr val="64748B"/>
-                </a:solidFill>
-              </a:defRPr>
-            </a:pPr>
-            <a:r>
-              <a:rPr sz="825" b="0">
-                <a:solidFill>
-                  <a:srgbClr val="64748B"/>
-                </a:solidFill>
-              </a:rPr>
-              <a:t>Source: latest_master_report.html, Global Replay H2D Readiness</a:t>
-            </a:r>
-          </a:p>
-        </p:txBody>
-      </p:sp>
-      <p:sp>
-        <p:nvSpPr>
-          <p:cNvPr id="8" name="">
-            <a:extLst xmlns:a="http://schemas.openxmlformats.org/drawingml/2006/main">
-              <a:ext uri="{FF2B5EF4-FFF2-40B4-BE49-F238E27FC236}">
-                <a16:creationId xmlns:a16="http://schemas.microsoft.com/office/drawing/2014/main" id="{AD64974A-8884-4235-9FC6-FE074C101044}"/>
+                <a16:creationId xmlns:a16="http://schemas.microsoft.com/office/drawing/2014/main" id="{A794DE88-BC86-41C8-87C6-EE32E60BD0B6}"/>
               </a:ext>
             </a:extLst>
           </p:cNvPr>
@@ -8071,10 +9145,10 @@
       </p:sp>
       <p:sp>
         <p:nvSpPr>
-          <p:cNvPr id="9" name="">
-            <a:extLst xmlns:a="http://schemas.openxmlformats.org/drawingml/2006/main">
-              <a:ext uri="{FF2B5EF4-FFF2-40B4-BE49-F238E27FC236}">
-                <a16:creationId xmlns:a16="http://schemas.microsoft.com/office/drawing/2014/main" id="{D21CAAFA-6549-4677-A5CB-40F8BBF561F9}"/>
+          <p:cNvPr id="8" name="">
+            <a:extLst xmlns:a="http://schemas.openxmlformats.org/drawingml/2006/main">
+              <a:ext uri="{FF2B5EF4-FFF2-40B4-BE49-F238E27FC236}">
+                <a16:creationId xmlns:a16="http://schemas.microsoft.com/office/drawing/2014/main" id="{C513AFAF-5FD3-45DD-9AA5-FA799B02F730}"/>
               </a:ext>
             </a:extLst>
           </p:cNvPr>
@@ -8122,7 +9196,7 @@
     </p:spTree>
     <p:extLst>
       <p:ext uri="{BB962C8B-B14F-4D97-AF65-F5344CB8AC3E}">
-        <p14:creationId xmlns:p14="http://schemas.microsoft.com/office/powerpoint/2010/main" val="1279703527"/>
+        <p14:creationId xmlns:p14="http://schemas.microsoft.com/office/powerpoint/2010/main" val="538688526"/>
       </p:ext>
     </p:extLst>
   </p:cSld>
@@ -8150,10 +9224,10 @@
       </p:grpSpPr>
       <p:sp>
         <p:nvSpPr>
-          <p:cNvPr id="8" name="">
-            <a:extLst xmlns:a="http://schemas.openxmlformats.org/drawingml/2006/main">
-              <a:ext uri="{FF2B5EF4-FFF2-40B4-BE49-F238E27FC236}">
-                <a16:creationId xmlns:a16="http://schemas.microsoft.com/office/drawing/2014/main" id="{134F0EFD-3F4E-43E0-9D59-23675673DC99}"/>
+          <p:cNvPr id="7" name="">
+            <a:extLst xmlns:a="http://schemas.openxmlformats.org/drawingml/2006/main">
+              <a:ext uri="{FF2B5EF4-FFF2-40B4-BE49-F238E27FC236}">
+                <a16:creationId xmlns:a16="http://schemas.microsoft.com/office/drawing/2014/main" id="{3EB62C9B-136D-455C-A49E-0FBAB85BC759}"/>
               </a:ext>
             </a:extLst>
           </p:cNvPr>
@@ -8203,7 +9277,7 @@
           <p:cNvPr id="2" name="">
             <a:extLst xmlns:a="http://schemas.openxmlformats.org/drawingml/2006/main">
               <a:ext uri="{FF2B5EF4-FFF2-40B4-BE49-F238E27FC236}">
-                <a16:creationId xmlns:a16="http://schemas.microsoft.com/office/drawing/2014/main" id="{E745B048-AAC8-4B7B-9050-EF260B05F7C2}"/>
+                <a16:creationId xmlns:a16="http://schemas.microsoft.com/office/drawing/2014/main" id="{C342B356-7711-4D18-A52C-FA85DE8C070B}"/>
               </a:ext>
             </a:extLst>
           </p:cNvPr>
@@ -8250,14 +9324,14 @@
       </p:sp>
       <p:pic>
         <p:nvPicPr>
-          <p:cNvPr id="10" name=""/>
+          <p:cNvPr id="9" name=""/>
           <p:cNvPicPr>
             <a:picLocks xmlns:a="http://schemas.openxmlformats.org/drawingml/2006/main" noChangeAspect="1"/>
           </p:cNvPicPr>
           <p:nvPr/>
         </p:nvPicPr>
         <p:blipFill>
-          <a:blip xmlns:r="http://schemas.openxmlformats.org/officeDocument/2006/relationships" xmlns:a="http://schemas.openxmlformats.org/drawingml/2006/main" r:embed="R977fd1f6a7364997"/>
+          <a:blip xmlns:r="http://schemas.openxmlformats.org/officeDocument/2006/relationships" xmlns:a="http://schemas.openxmlformats.org/drawingml/2006/main" r:embed="Rbb2cf4b31cc24e52"/>
           <a:stretch xmlns:a="http://schemas.openxmlformats.org/drawingml/2006/main"/>
         </p:blipFill>
         <p:spPr>
@@ -8275,7 +9349,7 @@
           <p:cNvPr id="4" name="">
             <a:extLst xmlns:a="http://schemas.openxmlformats.org/drawingml/2006/main">
               <a:ext uri="{FF2B5EF4-FFF2-40B4-BE49-F238E27FC236}">
-                <a16:creationId xmlns:a16="http://schemas.microsoft.com/office/drawing/2014/main" id="{097CE6D9-A3D5-458E-A829-BEA6DEC46415}"/>
+                <a16:creationId xmlns:a16="http://schemas.microsoft.com/office/drawing/2014/main" id="{9D23379E-A04A-43FB-9077-CA8E00D442A7}"/>
               </a:ext>
             </a:extLst>
           </p:cNvPr>
@@ -8325,57 +9399,7 @@
           <p:cNvPr id="5" name="">
             <a:extLst xmlns:a="http://schemas.openxmlformats.org/drawingml/2006/main">
               <a:ext uri="{FF2B5EF4-FFF2-40B4-BE49-F238E27FC236}">
-                <a16:creationId xmlns:a16="http://schemas.microsoft.com/office/drawing/2014/main" id="{22C6B8DD-0F70-4486-8AB9-50A539CBE3AA}"/>
-              </a:ext>
-            </a:extLst>
-          </p:cNvPr>
-          <p:cNvSpPr>
-            <a:spLocks xmlns:a="http://schemas.openxmlformats.org/drawingml/2006/main" noGrp="1"/>
-          </p:cNvSpPr>
-          <p:nvPr/>
-        </p:nvSpPr>
-        <p:spPr>
-          <a:xfrm xmlns:a="http://schemas.openxmlformats.org/drawingml/2006/main">
-            <a:off x="419100" y="6134100"/>
-            <a:ext cx="9334500" cy="190500"/>
-          </a:xfrm>
-          <a:prstGeom xmlns:a="http://schemas.openxmlformats.org/drawingml/2006/main" prst="rect">
-            <a:avLst/>
-          </a:prstGeom>
-          <a:noFill xmlns:a="http://schemas.openxmlformats.org/drawingml/2006/main"/>
-          <a:ln xmlns:a="http://schemas.openxmlformats.org/drawingml/2006/main" w="0">
-            <a:noFill/>
-            <a:prstDash val="solid"/>
-          </a:ln>
-        </p:spPr>
-        <p:txBody>
-          <a:bodyPr xmlns:a="http://schemas.openxmlformats.org/drawingml/2006/main" anchor="t"/>
-          <a:lstStyle xmlns:a="http://schemas.openxmlformats.org/drawingml/2006/main"/>
-          <a:p xmlns:a="http://schemas.openxmlformats.org/drawingml/2006/main">
-            <a:pPr algn="l">
-              <a:defRPr sz="825" b="0">
-                <a:solidFill>
-                  <a:srgbClr val="64748B"/>
-                </a:solidFill>
-              </a:defRPr>
-            </a:pPr>
-            <a:r>
-              <a:rPr sz="825" b="0">
-                <a:solidFill>
-                  <a:srgbClr val="64748B"/>
-                </a:solidFill>
-              </a:rPr>
-              <a:t>Source: latest_master_report.html, Replay Queue Timeline vs H2D Start</a:t>
-            </a:r>
-          </a:p>
-        </p:txBody>
-      </p:sp>
-      <p:sp>
-        <p:nvSpPr>
-          <p:cNvPr id="6" name="">
-            <a:extLst xmlns:a="http://schemas.openxmlformats.org/drawingml/2006/main">
-              <a:ext uri="{FF2B5EF4-FFF2-40B4-BE49-F238E27FC236}">
-                <a16:creationId xmlns:a16="http://schemas.microsoft.com/office/drawing/2014/main" id="{1C2DE477-474A-4C1B-973D-607C96324F39}"/>
+                <a16:creationId xmlns:a16="http://schemas.microsoft.com/office/drawing/2014/main" id="{8AF46321-33DF-4A20-A14F-C4E300BF72CB}"/>
               </a:ext>
             </a:extLst>
           </p:cNvPr>
@@ -8422,10 +9446,10 @@
       </p:sp>
       <p:sp>
         <p:nvSpPr>
-          <p:cNvPr id="7" name="">
-            <a:extLst xmlns:a="http://schemas.openxmlformats.org/drawingml/2006/main">
-              <a:ext uri="{FF2B5EF4-FFF2-40B4-BE49-F238E27FC236}">
-                <a16:creationId xmlns:a16="http://schemas.microsoft.com/office/drawing/2014/main" id="{A0CE2C64-972B-47FB-9D40-0D7449633744}"/>
+          <p:cNvPr id="6" name="">
+            <a:extLst xmlns:a="http://schemas.openxmlformats.org/drawingml/2006/main">
+              <a:ext uri="{FF2B5EF4-FFF2-40B4-BE49-F238E27FC236}">
+                <a16:creationId xmlns:a16="http://schemas.microsoft.com/office/drawing/2014/main" id="{B4A8BDEF-C57D-45CC-9279-0B3E18A652D8}"/>
               </a:ext>
             </a:extLst>
           </p:cNvPr>
@@ -8473,7 +9497,7 @@
     </p:spTree>
     <p:extLst>
       <p:ext uri="{BB962C8B-B14F-4D97-AF65-F5344CB8AC3E}">
-        <p14:creationId xmlns:p14="http://schemas.microsoft.com/office/powerpoint/2010/main" val="1934301508"/>
+        <p14:creationId xmlns:p14="http://schemas.microsoft.com/office/powerpoint/2010/main" val="2080746787"/>
       </p:ext>
     </p:extLst>
   </p:cSld>

</xml_diff>

<commit_message>
Make replay bottleneck slide more readable
</commit_message>
<xml_diff>
--- a/sglang_direct_kv/artifacts/slides/agent_aware_kv_movement_manager_deck.pptx
+++ b/sglang_direct_kv/artifacts/slides/agent_aware_kv_movement_manager_deck.pptx
@@ -2,24 +2,24 @@
 <file path=ppt/presentation.xml><?xml version="1.0" encoding="utf-8"?>
 <p:presentation xmlns:p="http://schemas.openxmlformats.org/presentationml/2006/main">
   <p:sldMasterIdLst>
-    <p:sldMasterId xmlns:r="http://schemas.openxmlformats.org/officeDocument/2006/relationships" id="2147483648" r:id="R899d768b3d5f448e"/>
+    <p:sldMasterId xmlns:r="http://schemas.openxmlformats.org/officeDocument/2006/relationships" id="2147483648" r:id="R660986d3031a4505"/>
   </p:sldMasterIdLst>
   <p:notesMasterIdLst>
-    <p:notesMasterId xmlns:r="http://schemas.openxmlformats.org/officeDocument/2006/relationships" r:id="R8e3a05492f824db5"/>
+    <p:notesMasterId xmlns:r="http://schemas.openxmlformats.org/officeDocument/2006/relationships" r:id="Ra51744c5f07b4732"/>
   </p:notesMasterIdLst>
   <p:sldIdLst>
-    <p:sldId xmlns:r="http://schemas.openxmlformats.org/officeDocument/2006/relationships" id="256" r:id="Rd377b6085a8a40c8"/>
-    <p:sldId xmlns:r="http://schemas.openxmlformats.org/officeDocument/2006/relationships" id="257" r:id="R433929d20de746ae"/>
-    <p:sldId xmlns:r="http://schemas.openxmlformats.org/officeDocument/2006/relationships" id="258" r:id="R8cd0295ac3e649c9"/>
-    <p:sldId xmlns:r="http://schemas.openxmlformats.org/officeDocument/2006/relationships" id="259" r:id="R468f87e0b6a24835"/>
-    <p:sldId xmlns:r="http://schemas.openxmlformats.org/officeDocument/2006/relationships" id="260" r:id="R07edb9ecb3394432"/>
-    <p:sldId xmlns:r="http://schemas.openxmlformats.org/officeDocument/2006/relationships" id="261" r:id="R691e92a9768f4be2"/>
-    <p:sldId xmlns:r="http://schemas.openxmlformats.org/officeDocument/2006/relationships" id="262" r:id="R344f558b43f64ed4"/>
-    <p:sldId xmlns:r="http://schemas.openxmlformats.org/officeDocument/2006/relationships" id="263" r:id="R1b3732fe2589427a"/>
-    <p:sldId xmlns:r="http://schemas.openxmlformats.org/officeDocument/2006/relationships" id="264" r:id="R791187716dc0457a"/>
-    <p:sldId xmlns:r="http://schemas.openxmlformats.org/officeDocument/2006/relationships" id="265" r:id="R9de39528184c4195"/>
-    <p:sldId xmlns:r="http://schemas.openxmlformats.org/officeDocument/2006/relationships" id="266" r:id="R15f6bf842f224442"/>
-    <p:sldId xmlns:r="http://schemas.openxmlformats.org/officeDocument/2006/relationships" id="267" r:id="Rbf0e08b5fa924679"/>
+    <p:sldId xmlns:r="http://schemas.openxmlformats.org/officeDocument/2006/relationships" id="256" r:id="R443a9f967aac40bd"/>
+    <p:sldId xmlns:r="http://schemas.openxmlformats.org/officeDocument/2006/relationships" id="257" r:id="R1dc4f6dd977f4c1b"/>
+    <p:sldId xmlns:r="http://schemas.openxmlformats.org/officeDocument/2006/relationships" id="258" r:id="R33f3c6b7c3f74d09"/>
+    <p:sldId xmlns:r="http://schemas.openxmlformats.org/officeDocument/2006/relationships" id="259" r:id="Rf99a4d9ced3f40f2"/>
+    <p:sldId xmlns:r="http://schemas.openxmlformats.org/officeDocument/2006/relationships" id="260" r:id="R2f260ac653d1447f"/>
+    <p:sldId xmlns:r="http://schemas.openxmlformats.org/officeDocument/2006/relationships" id="261" r:id="Rc22b3acfbc024586"/>
+    <p:sldId xmlns:r="http://schemas.openxmlformats.org/officeDocument/2006/relationships" id="262" r:id="R2bdd170283fa4b86"/>
+    <p:sldId xmlns:r="http://schemas.openxmlformats.org/officeDocument/2006/relationships" id="263" r:id="R4b1662d392464e78"/>
+    <p:sldId xmlns:r="http://schemas.openxmlformats.org/officeDocument/2006/relationships" id="264" r:id="Raca4ed3f82e94266"/>
+    <p:sldId xmlns:r="http://schemas.openxmlformats.org/officeDocument/2006/relationships" id="265" r:id="R400cf00b9c95400f"/>
+    <p:sldId xmlns:r="http://schemas.openxmlformats.org/officeDocument/2006/relationships" id="266" r:id="Ra1b74e46bcd54c28"/>
+    <p:sldId xmlns:r="http://schemas.openxmlformats.org/officeDocument/2006/relationships" id="267" r:id="Rc89e3ac1aa7c45a0"/>
   </p:sldIdLst>
   <p:sldSz cx="12192000" cy="6858000"/>
   <p:notesSz cx="6858000" cy="9144000"/>
@@ -1158,12 +1158,17 @@
           <a:lstStyle xmlns:a="http://schemas.openxmlformats.org/drawingml/2006/main"/>
           <a:p xmlns:a="http://schemas.openxmlformats.org/drawingml/2006/main">
             <a:r>
-              <a:t>This is the main timeline slide. It should remain chart-dominant.</a:t>
-            </a:r>
-          </a:p>
-          <a:p xmlns:a="http://schemas.openxmlformats.org/drawingml/2006/main">
-            <a:r>
-              <a:t>The chart shows initial model turn, tool wait, replay path, H2D, recompute, prefill, and decode.</a:t>
+              <a:t>This is the main timeline slide. It now shows a readable crop of G00 through G03 instead of compressing all rows.</a:t>
+            </a:r>
+          </a:p>
+          <a:p xmlns:a="http://schemas.openxmlformats.org/drawingml/2006/main">
+            <a:r>
+              <a:t>The cropped chart shows initial model turn, tool wait, replay path, H2D, recompute, prefill, and decode.</a:t>
+            </a:r>
+          </a:p>
+          <a:p xmlns:a="http://schemas.openxmlformats.org/drawingml/2006/main">
+            <a:r>
+              <a:t>The full timeline remains available in latest_master_report.html.</a:t>
             </a:r>
           </a:p>
           <a:p xmlns:a="http://schemas.openxmlformats.org/drawingml/2006/main">
@@ -1656,7 +1661,7 @@
   </p:cSld>
   <p:clrMap bg1="lt1" tx1="dk1" bg2="lt2" tx2="dk2" accent1="accent1" accent2="accent2" accent3="accent3" accent4="accent4" accent5="accent5" accent6="accent6" hlink="hlink" folHlink="folHlink"/>
   <p:sldLayoutIdLst>
-    <p:sldLayoutId xmlns:r="http://schemas.openxmlformats.org/officeDocument/2006/relationships" id="2147483649" r:id="R9dd8673576d7441a"/>
+    <p:sldLayoutId xmlns:r="http://schemas.openxmlformats.org/officeDocument/2006/relationships" id="2147483649" r:id="Ree7888e845a14412"/>
   </p:sldLayoutIdLst>
   <p:txStyles>
     <p:titleStyle>
@@ -2207,7 +2212,7 @@
           <p:cNvPr id="12" name="">
             <a:extLst xmlns:a="http://schemas.openxmlformats.org/drawingml/2006/main">
               <a:ext uri="{FF2B5EF4-FFF2-40B4-BE49-F238E27FC236}">
-                <a16:creationId xmlns:a16="http://schemas.microsoft.com/office/drawing/2014/main" id="{6543091D-7A1B-427B-9CB4-3A4591A94195}"/>
+                <a16:creationId xmlns:a16="http://schemas.microsoft.com/office/drawing/2014/main" id="{9C2DE161-E611-4262-B733-5CD158F3DBBA}"/>
               </a:ext>
             </a:extLst>
           </p:cNvPr>
@@ -2257,7 +2262,7 @@
           <p:cNvPr id="2" name="">
             <a:extLst xmlns:a="http://schemas.openxmlformats.org/drawingml/2006/main">
               <a:ext uri="{FF2B5EF4-FFF2-40B4-BE49-F238E27FC236}">
-                <a16:creationId xmlns:a16="http://schemas.microsoft.com/office/drawing/2014/main" id="{C4925A30-F28D-4A6B-BA2D-33FE19F2E34D}"/>
+                <a16:creationId xmlns:a16="http://schemas.microsoft.com/office/drawing/2014/main" id="{45C3661D-E131-402E-AAAA-2FCE11314ED8}"/>
               </a:ext>
             </a:extLst>
           </p:cNvPr>
@@ -2307,7 +2312,7 @@
           <p:cNvPr id="3" name="">
             <a:extLst xmlns:a="http://schemas.openxmlformats.org/drawingml/2006/main">
               <a:ext uri="{FF2B5EF4-FFF2-40B4-BE49-F238E27FC236}">
-                <a16:creationId xmlns:a16="http://schemas.microsoft.com/office/drawing/2014/main" id="{F64297CF-480E-4B19-9A68-B2605682614E}"/>
+                <a16:creationId xmlns:a16="http://schemas.microsoft.com/office/drawing/2014/main" id="{FA2DD041-0C3E-4D53-A976-60EEEA027435}"/>
               </a:ext>
             </a:extLst>
           </p:cNvPr>
@@ -2338,7 +2343,7 @@
           <p:cNvPr id="4" name="">
             <a:extLst xmlns:a="http://schemas.openxmlformats.org/drawingml/2006/main">
               <a:ext uri="{FF2B5EF4-FFF2-40B4-BE49-F238E27FC236}">
-                <a16:creationId xmlns:a16="http://schemas.microsoft.com/office/drawing/2014/main" id="{A9BD2C76-8565-4C6F-BF64-8C98D033D2E1}"/>
+                <a16:creationId xmlns:a16="http://schemas.microsoft.com/office/drawing/2014/main" id="{0B21E43B-A4BB-4400-A440-10315E075255}"/>
               </a:ext>
             </a:extLst>
           </p:cNvPr>
@@ -2388,7 +2393,7 @@
           <p:cNvPr id="5" name="">
             <a:extLst xmlns:a="http://schemas.openxmlformats.org/drawingml/2006/main">
               <a:ext uri="{FF2B5EF4-FFF2-40B4-BE49-F238E27FC236}">
-                <a16:creationId xmlns:a16="http://schemas.microsoft.com/office/drawing/2014/main" id="{86B6D4D9-C071-4588-A0CB-37F3B93C48E0}"/>
+                <a16:creationId xmlns:a16="http://schemas.microsoft.com/office/drawing/2014/main" id="{5AD7DF86-6114-4CEE-8AC2-AA1DFF95FFAF}"/>
               </a:ext>
             </a:extLst>
           </p:cNvPr>
@@ -2438,7 +2443,7 @@
           <p:cNvPr id="6" name="">
             <a:extLst xmlns:a="http://schemas.openxmlformats.org/drawingml/2006/main">
               <a:ext uri="{FF2B5EF4-FFF2-40B4-BE49-F238E27FC236}">
-                <a16:creationId xmlns:a16="http://schemas.microsoft.com/office/drawing/2014/main" id="{E357A409-BDE7-44C3-87DB-064C08F832F2}"/>
+                <a16:creationId xmlns:a16="http://schemas.microsoft.com/office/drawing/2014/main" id="{C31B95AA-5D08-4016-8AA5-D0F32AA91D21}"/>
               </a:ext>
             </a:extLst>
           </p:cNvPr>
@@ -2488,7 +2493,7 @@
           <p:cNvPr id="7" name="">
             <a:extLst xmlns:a="http://schemas.openxmlformats.org/drawingml/2006/main">
               <a:ext uri="{FF2B5EF4-FFF2-40B4-BE49-F238E27FC236}">
-                <a16:creationId xmlns:a16="http://schemas.microsoft.com/office/drawing/2014/main" id="{C884BB1D-B896-46D3-9B02-0865E912AF12}"/>
+                <a16:creationId xmlns:a16="http://schemas.microsoft.com/office/drawing/2014/main" id="{AA973700-6C77-475C-8C91-56EAF055F9ED}"/>
               </a:ext>
             </a:extLst>
           </p:cNvPr>
@@ -2538,7 +2543,7 @@
           <p:cNvPr id="8" name="">
             <a:extLst xmlns:a="http://schemas.openxmlformats.org/drawingml/2006/main">
               <a:ext uri="{FF2B5EF4-FFF2-40B4-BE49-F238E27FC236}">
-                <a16:creationId xmlns:a16="http://schemas.microsoft.com/office/drawing/2014/main" id="{ED16BFC6-8729-4EFC-A995-1EFFC8A31624}"/>
+                <a16:creationId xmlns:a16="http://schemas.microsoft.com/office/drawing/2014/main" id="{06599A79-558A-47B7-B45B-F500320C8955}"/>
               </a:ext>
             </a:extLst>
           </p:cNvPr>
@@ -2588,7 +2593,7 @@
           <p:cNvPr id="9" name="">
             <a:extLst xmlns:a="http://schemas.openxmlformats.org/drawingml/2006/main">
               <a:ext uri="{FF2B5EF4-FFF2-40B4-BE49-F238E27FC236}">
-                <a16:creationId xmlns:a16="http://schemas.microsoft.com/office/drawing/2014/main" id="{057277D4-975A-446B-B44E-BD31CEE330E0}"/>
+                <a16:creationId xmlns:a16="http://schemas.microsoft.com/office/drawing/2014/main" id="{F699F22B-59F9-4ECA-A615-8AD5A3D08770}"/>
               </a:ext>
             </a:extLst>
           </p:cNvPr>
@@ -2638,7 +2643,7 @@
           <p:cNvPr id="10" name="">
             <a:extLst xmlns:a="http://schemas.openxmlformats.org/drawingml/2006/main">
               <a:ext uri="{FF2B5EF4-FFF2-40B4-BE49-F238E27FC236}">
-                <a16:creationId xmlns:a16="http://schemas.microsoft.com/office/drawing/2014/main" id="{F490E093-38BA-4121-8B63-6550B5F0EFE4}"/>
+                <a16:creationId xmlns:a16="http://schemas.microsoft.com/office/drawing/2014/main" id="{E9993F09-C781-4902-B1F0-4A50EFE91EBA}"/>
               </a:ext>
             </a:extLst>
           </p:cNvPr>
@@ -2688,7 +2693,7 @@
           <p:cNvPr id="11" name="">
             <a:extLst xmlns:a="http://schemas.openxmlformats.org/drawingml/2006/main">
               <a:ext uri="{FF2B5EF4-FFF2-40B4-BE49-F238E27FC236}">
-                <a16:creationId xmlns:a16="http://schemas.microsoft.com/office/drawing/2014/main" id="{69D55FF7-F253-4A5D-B199-8A6FA18BD5E7}"/>
+                <a16:creationId xmlns:a16="http://schemas.microsoft.com/office/drawing/2014/main" id="{F818A59E-BDB3-40AF-A166-0184570D9656}"/>
               </a:ext>
             </a:extLst>
           </p:cNvPr>
@@ -2736,7 +2741,7 @@
     </p:spTree>
     <p:extLst>
       <p:ext uri="{BB962C8B-B14F-4D97-AF65-F5344CB8AC3E}">
-        <p14:creationId xmlns:p14="http://schemas.microsoft.com/office/powerpoint/2010/main" val="1139630840"/>
+        <p14:creationId xmlns:p14="http://schemas.microsoft.com/office/powerpoint/2010/main" val="519333489"/>
       </p:ext>
     </p:extLst>
   </p:cSld>
@@ -2767,7 +2772,7 @@
           <p:cNvPr id="17" name="">
             <a:extLst xmlns:a="http://schemas.openxmlformats.org/drawingml/2006/main">
               <a:ext uri="{FF2B5EF4-FFF2-40B4-BE49-F238E27FC236}">
-                <a16:creationId xmlns:a16="http://schemas.microsoft.com/office/drawing/2014/main" id="{AD530860-9A8A-4888-B38D-E331E671FED7}"/>
+                <a16:creationId xmlns:a16="http://schemas.microsoft.com/office/drawing/2014/main" id="{399E9D64-0F62-496F-9093-33F4E55317B8}"/>
               </a:ext>
             </a:extLst>
           </p:cNvPr>
@@ -2817,7 +2822,7 @@
           <p:cNvPr id="2" name="">
             <a:extLst xmlns:a="http://schemas.openxmlformats.org/drawingml/2006/main">
               <a:ext uri="{FF2B5EF4-FFF2-40B4-BE49-F238E27FC236}">
-                <a16:creationId xmlns:a16="http://schemas.microsoft.com/office/drawing/2014/main" id="{308F1D59-09FE-4477-A218-8681AD2C8542}"/>
+                <a16:creationId xmlns:a16="http://schemas.microsoft.com/office/drawing/2014/main" id="{F147E563-6D64-459C-B06F-490ADD969CE9}"/>
               </a:ext>
             </a:extLst>
           </p:cNvPr>
@@ -2867,7 +2872,7 @@
           <p:cNvPr id="3" name="">
             <a:extLst xmlns:a="http://schemas.openxmlformats.org/drawingml/2006/main">
               <a:ext uri="{FF2B5EF4-FFF2-40B4-BE49-F238E27FC236}">
-                <a16:creationId xmlns:a16="http://schemas.microsoft.com/office/drawing/2014/main" id="{21463CB0-08ED-4506-8BB0-A9EDC311B992}"/>
+                <a16:creationId xmlns:a16="http://schemas.microsoft.com/office/drawing/2014/main" id="{B5698D55-8C1D-435B-8317-8D88145A6970}"/>
               </a:ext>
             </a:extLst>
           </p:cNvPr>
@@ -2917,7 +2922,7 @@
           <p:cNvPr id="4" name="">
             <a:extLst xmlns:a="http://schemas.openxmlformats.org/drawingml/2006/main">
               <a:ext uri="{FF2B5EF4-FFF2-40B4-BE49-F238E27FC236}">
-                <a16:creationId xmlns:a16="http://schemas.microsoft.com/office/drawing/2014/main" id="{F9AA8060-D775-462E-AE4D-5E12C3A6341A}"/>
+                <a16:creationId xmlns:a16="http://schemas.microsoft.com/office/drawing/2014/main" id="{549D50B5-D731-49E2-A29A-FD104178E50C}"/>
               </a:ext>
             </a:extLst>
           </p:cNvPr>
@@ -2967,7 +2972,7 @@
           <p:cNvPr id="5" name="">
             <a:extLst xmlns:a="http://schemas.openxmlformats.org/drawingml/2006/main">
               <a:ext uri="{FF2B5EF4-FFF2-40B4-BE49-F238E27FC236}">
-                <a16:creationId xmlns:a16="http://schemas.microsoft.com/office/drawing/2014/main" id="{6CD8B445-BF2E-45C2-810D-1201CED09F3A}"/>
+                <a16:creationId xmlns:a16="http://schemas.microsoft.com/office/drawing/2014/main" id="{C85E57E6-3A09-440B-94B8-2F189545D09E}"/>
               </a:ext>
             </a:extLst>
           </p:cNvPr>
@@ -3017,7 +3022,7 @@
           <p:cNvPr id="6" name="">
             <a:extLst xmlns:a="http://schemas.openxmlformats.org/drawingml/2006/main">
               <a:ext uri="{FF2B5EF4-FFF2-40B4-BE49-F238E27FC236}">
-                <a16:creationId xmlns:a16="http://schemas.microsoft.com/office/drawing/2014/main" id="{55567DCC-79FB-499C-975B-63F2B1EB8C38}"/>
+                <a16:creationId xmlns:a16="http://schemas.microsoft.com/office/drawing/2014/main" id="{81FB160B-3FAC-4EF7-88AF-E78084A66B8C}"/>
               </a:ext>
             </a:extLst>
           </p:cNvPr>
@@ -3067,7 +3072,7 @@
           <p:cNvPr id="7" name="">
             <a:extLst xmlns:a="http://schemas.openxmlformats.org/drawingml/2006/main">
               <a:ext uri="{FF2B5EF4-FFF2-40B4-BE49-F238E27FC236}">
-                <a16:creationId xmlns:a16="http://schemas.microsoft.com/office/drawing/2014/main" id="{11E7F8D9-EA30-4FD6-BB26-60702350C0F0}"/>
+                <a16:creationId xmlns:a16="http://schemas.microsoft.com/office/drawing/2014/main" id="{88DD0CB8-CF0A-4FB1-86EF-861DFA275B91}"/>
               </a:ext>
             </a:extLst>
           </p:cNvPr>
@@ -3117,7 +3122,7 @@
           <p:cNvPr id="8" name="">
             <a:extLst xmlns:a="http://schemas.openxmlformats.org/drawingml/2006/main">
               <a:ext uri="{FF2B5EF4-FFF2-40B4-BE49-F238E27FC236}">
-                <a16:creationId xmlns:a16="http://schemas.microsoft.com/office/drawing/2014/main" id="{43CAEB04-AFD6-4004-B47F-915F949BAD1D}"/>
+                <a16:creationId xmlns:a16="http://schemas.microsoft.com/office/drawing/2014/main" id="{27089430-C1B8-414B-BAE7-7DA1AFE1A0A8}"/>
               </a:ext>
             </a:extLst>
           </p:cNvPr>
@@ -3167,7 +3172,7 @@
           <p:cNvPr id="9" name="">
             <a:extLst xmlns:a="http://schemas.openxmlformats.org/drawingml/2006/main">
               <a:ext uri="{FF2B5EF4-FFF2-40B4-BE49-F238E27FC236}">
-                <a16:creationId xmlns:a16="http://schemas.microsoft.com/office/drawing/2014/main" id="{F49A0774-6B8F-47DC-A254-E2343962B4D6}"/>
+                <a16:creationId xmlns:a16="http://schemas.microsoft.com/office/drawing/2014/main" id="{8139AACC-046A-40E1-9C50-C8CAF7D74DC0}"/>
               </a:ext>
             </a:extLst>
           </p:cNvPr>
@@ -3217,7 +3222,7 @@
           <p:cNvPr id="10" name="">
             <a:extLst xmlns:a="http://schemas.openxmlformats.org/drawingml/2006/main">
               <a:ext uri="{FF2B5EF4-FFF2-40B4-BE49-F238E27FC236}">
-                <a16:creationId xmlns:a16="http://schemas.microsoft.com/office/drawing/2014/main" id="{F38F8FE4-B4C6-4CFD-B527-6B4112274950}"/>
+                <a16:creationId xmlns:a16="http://schemas.microsoft.com/office/drawing/2014/main" id="{F477F21D-6823-4103-B4BA-69EA42C30168}"/>
               </a:ext>
             </a:extLst>
           </p:cNvPr>
@@ -3267,7 +3272,7 @@
           <p:cNvPr id="11" name="">
             <a:extLst xmlns:a="http://schemas.openxmlformats.org/drawingml/2006/main">
               <a:ext uri="{FF2B5EF4-FFF2-40B4-BE49-F238E27FC236}">
-                <a16:creationId xmlns:a16="http://schemas.microsoft.com/office/drawing/2014/main" id="{377DDC15-10FE-4D52-9E1B-AE16CD8A0071}"/>
+                <a16:creationId xmlns:a16="http://schemas.microsoft.com/office/drawing/2014/main" id="{D810BB76-BC0A-47D9-8F83-25823BCCDD54}"/>
               </a:ext>
             </a:extLst>
           </p:cNvPr>
@@ -3317,7 +3322,7 @@
           <p:cNvPr id="12" name="">
             <a:extLst xmlns:a="http://schemas.openxmlformats.org/drawingml/2006/main">
               <a:ext uri="{FF2B5EF4-FFF2-40B4-BE49-F238E27FC236}">
-                <a16:creationId xmlns:a16="http://schemas.microsoft.com/office/drawing/2014/main" id="{C59EF465-7C4A-42EA-8AF0-9EC02FEC243D}"/>
+                <a16:creationId xmlns:a16="http://schemas.microsoft.com/office/drawing/2014/main" id="{7B30856C-F232-43F4-B994-851BEFB7A1B9}"/>
               </a:ext>
             </a:extLst>
           </p:cNvPr>
@@ -3367,7 +3372,7 @@
           <p:cNvPr id="13" name="">
             <a:extLst xmlns:a="http://schemas.openxmlformats.org/drawingml/2006/main">
               <a:ext uri="{FF2B5EF4-FFF2-40B4-BE49-F238E27FC236}">
-                <a16:creationId xmlns:a16="http://schemas.microsoft.com/office/drawing/2014/main" id="{F4C51755-B5FD-475B-A3B4-9A05CB6DC516}"/>
+                <a16:creationId xmlns:a16="http://schemas.microsoft.com/office/drawing/2014/main" id="{7CCC884A-F5FB-43F4-963B-CE9C74CEFB20}"/>
               </a:ext>
             </a:extLst>
           </p:cNvPr>
@@ -3398,7 +3403,7 @@
           <p:cNvPr id="14" name="">
             <a:extLst xmlns:a="http://schemas.openxmlformats.org/drawingml/2006/main">
               <a:ext uri="{FF2B5EF4-FFF2-40B4-BE49-F238E27FC236}">
-                <a16:creationId xmlns:a16="http://schemas.microsoft.com/office/drawing/2014/main" id="{9CD41DA1-610C-40E8-91BC-C8C0ED4AE028}"/>
+                <a16:creationId xmlns:a16="http://schemas.microsoft.com/office/drawing/2014/main" id="{BF8A7BBB-C244-4A92-A266-6D02BD69E2A0}"/>
               </a:ext>
             </a:extLst>
           </p:cNvPr>
@@ -3448,7 +3453,7 @@
           <p:cNvPr id="15" name="">
             <a:extLst xmlns:a="http://schemas.openxmlformats.org/drawingml/2006/main">
               <a:ext uri="{FF2B5EF4-FFF2-40B4-BE49-F238E27FC236}">
-                <a16:creationId xmlns:a16="http://schemas.microsoft.com/office/drawing/2014/main" id="{24FFF9B2-D60F-4260-81DD-43CEAE7CA20B}"/>
+                <a16:creationId xmlns:a16="http://schemas.microsoft.com/office/drawing/2014/main" id="{F77AB9F1-0129-451E-96CC-0D352A5CC40E}"/>
               </a:ext>
             </a:extLst>
           </p:cNvPr>
@@ -3498,7 +3503,7 @@
           <p:cNvPr id="16" name="">
             <a:extLst xmlns:a="http://schemas.openxmlformats.org/drawingml/2006/main">
               <a:ext uri="{FF2B5EF4-FFF2-40B4-BE49-F238E27FC236}">
-                <a16:creationId xmlns:a16="http://schemas.microsoft.com/office/drawing/2014/main" id="{EDC70FB8-D435-40B8-9E7F-CED5FDD8F262}"/>
+                <a16:creationId xmlns:a16="http://schemas.microsoft.com/office/drawing/2014/main" id="{2026B7DC-C6FB-4BC1-913B-98D6583289C7}"/>
               </a:ext>
             </a:extLst>
           </p:cNvPr>
@@ -3546,7 +3551,7 @@
     </p:spTree>
     <p:extLst>
       <p:ext uri="{BB962C8B-B14F-4D97-AF65-F5344CB8AC3E}">
-        <p14:creationId xmlns:p14="http://schemas.microsoft.com/office/powerpoint/2010/main" val="1065304262"/>
+        <p14:creationId xmlns:p14="http://schemas.microsoft.com/office/powerpoint/2010/main" val="1716994904"/>
       </p:ext>
     </p:extLst>
   </p:cSld>
@@ -3577,7 +3582,7 @@
           <p:cNvPr id="17" name="">
             <a:extLst xmlns:a="http://schemas.openxmlformats.org/drawingml/2006/main">
               <a:ext uri="{FF2B5EF4-FFF2-40B4-BE49-F238E27FC236}">
-                <a16:creationId xmlns:a16="http://schemas.microsoft.com/office/drawing/2014/main" id="{A17E71E8-B245-4850-A7AF-52DCE50A47FB}"/>
+                <a16:creationId xmlns:a16="http://schemas.microsoft.com/office/drawing/2014/main" id="{0915752A-C7B1-4DFA-92A7-DEFCC40F3E48}"/>
               </a:ext>
             </a:extLst>
           </p:cNvPr>
@@ -3627,7 +3632,7 @@
           <p:cNvPr id="2" name="">
             <a:extLst xmlns:a="http://schemas.openxmlformats.org/drawingml/2006/main">
               <a:ext uri="{FF2B5EF4-FFF2-40B4-BE49-F238E27FC236}">
-                <a16:creationId xmlns:a16="http://schemas.microsoft.com/office/drawing/2014/main" id="{087D382F-2747-4FE1-A2A0-A65681099C3D}"/>
+                <a16:creationId xmlns:a16="http://schemas.microsoft.com/office/drawing/2014/main" id="{998AD203-C032-4D04-82DF-A11A4629DD0E}"/>
               </a:ext>
             </a:extLst>
           </p:cNvPr>
@@ -3677,7 +3682,7 @@
           <p:cNvPr id="3" name="">
             <a:extLst xmlns:a="http://schemas.openxmlformats.org/drawingml/2006/main">
               <a:ext uri="{FF2B5EF4-FFF2-40B4-BE49-F238E27FC236}">
-                <a16:creationId xmlns:a16="http://schemas.microsoft.com/office/drawing/2014/main" id="{663BB759-66EF-4679-B1A9-1C036C6C1EB7}"/>
+                <a16:creationId xmlns:a16="http://schemas.microsoft.com/office/drawing/2014/main" id="{3AFAFCA3-9EF8-4E69-B854-219BFE1367B8}"/>
               </a:ext>
             </a:extLst>
           </p:cNvPr>
@@ -3727,7 +3732,7 @@
           <p:cNvPr id="4" name="">
             <a:extLst xmlns:a="http://schemas.openxmlformats.org/drawingml/2006/main">
               <a:ext uri="{FF2B5EF4-FFF2-40B4-BE49-F238E27FC236}">
-                <a16:creationId xmlns:a16="http://schemas.microsoft.com/office/drawing/2014/main" id="{1A1E89B1-B4F3-437B-B60D-684E2E3757BA}"/>
+                <a16:creationId xmlns:a16="http://schemas.microsoft.com/office/drawing/2014/main" id="{69F336FE-CDD9-4133-966A-E9A0AD09D280}"/>
               </a:ext>
             </a:extLst>
           </p:cNvPr>
@@ -3777,7 +3782,7 @@
           <p:cNvPr id="5" name="">
             <a:extLst xmlns:a="http://schemas.openxmlformats.org/drawingml/2006/main">
               <a:ext uri="{FF2B5EF4-FFF2-40B4-BE49-F238E27FC236}">
-                <a16:creationId xmlns:a16="http://schemas.microsoft.com/office/drawing/2014/main" id="{846EA34F-5FD7-42D3-9E0D-761201685738}"/>
+                <a16:creationId xmlns:a16="http://schemas.microsoft.com/office/drawing/2014/main" id="{A48ED84E-FB21-4227-870A-F00D16C80DD8}"/>
               </a:ext>
             </a:extLst>
           </p:cNvPr>
@@ -3827,7 +3832,7 @@
           <p:cNvPr id="6" name="">
             <a:extLst xmlns:a="http://schemas.openxmlformats.org/drawingml/2006/main">
               <a:ext uri="{FF2B5EF4-FFF2-40B4-BE49-F238E27FC236}">
-                <a16:creationId xmlns:a16="http://schemas.microsoft.com/office/drawing/2014/main" id="{BF975120-3ECA-4B75-98F1-F38341BFB05E}"/>
+                <a16:creationId xmlns:a16="http://schemas.microsoft.com/office/drawing/2014/main" id="{2D9B5E78-CD7F-4A97-B493-118F5B2FF0FD}"/>
               </a:ext>
             </a:extLst>
           </p:cNvPr>
@@ -3877,7 +3882,7 @@
           <p:cNvPr id="7" name="">
             <a:extLst xmlns:a="http://schemas.openxmlformats.org/drawingml/2006/main">
               <a:ext uri="{FF2B5EF4-FFF2-40B4-BE49-F238E27FC236}">
-                <a16:creationId xmlns:a16="http://schemas.microsoft.com/office/drawing/2014/main" id="{057E3B91-29B2-48BC-AB82-048B49F42177}"/>
+                <a16:creationId xmlns:a16="http://schemas.microsoft.com/office/drawing/2014/main" id="{C04281E1-C78E-4ADD-AF9A-47E5E5E2A7A6}"/>
               </a:ext>
             </a:extLst>
           </p:cNvPr>
@@ -3927,7 +3932,7 @@
           <p:cNvPr id="8" name="">
             <a:extLst xmlns:a="http://schemas.openxmlformats.org/drawingml/2006/main">
               <a:ext uri="{FF2B5EF4-FFF2-40B4-BE49-F238E27FC236}">
-                <a16:creationId xmlns:a16="http://schemas.microsoft.com/office/drawing/2014/main" id="{C9847812-B562-4EC3-9B77-B24497214908}"/>
+                <a16:creationId xmlns:a16="http://schemas.microsoft.com/office/drawing/2014/main" id="{4A98A2F2-11A8-4698-92CD-87C5C8C85B08}"/>
               </a:ext>
             </a:extLst>
           </p:cNvPr>
@@ -3977,7 +3982,7 @@
           <p:cNvPr id="9" name="">
             <a:extLst xmlns:a="http://schemas.openxmlformats.org/drawingml/2006/main">
               <a:ext uri="{FF2B5EF4-FFF2-40B4-BE49-F238E27FC236}">
-                <a16:creationId xmlns:a16="http://schemas.microsoft.com/office/drawing/2014/main" id="{5CDC1431-3E15-4D87-8FF1-EAF8903922B8}"/>
+                <a16:creationId xmlns:a16="http://schemas.microsoft.com/office/drawing/2014/main" id="{8F38DFD5-1B17-4D4F-BC77-6F39BFD670E8}"/>
               </a:ext>
             </a:extLst>
           </p:cNvPr>
@@ -4027,7 +4032,7 @@
           <p:cNvPr id="10" name="">
             <a:extLst xmlns:a="http://schemas.openxmlformats.org/drawingml/2006/main">
               <a:ext uri="{FF2B5EF4-FFF2-40B4-BE49-F238E27FC236}">
-                <a16:creationId xmlns:a16="http://schemas.microsoft.com/office/drawing/2014/main" id="{32167948-09C3-40B4-96AA-2E9B806C6247}"/>
+                <a16:creationId xmlns:a16="http://schemas.microsoft.com/office/drawing/2014/main" id="{36B49A24-00E6-450A-B223-24B8C5ED0D7D}"/>
               </a:ext>
             </a:extLst>
           </p:cNvPr>
@@ -4077,7 +4082,7 @@
           <p:cNvPr id="11" name="">
             <a:extLst xmlns:a="http://schemas.openxmlformats.org/drawingml/2006/main">
               <a:ext uri="{FF2B5EF4-FFF2-40B4-BE49-F238E27FC236}">
-                <a16:creationId xmlns:a16="http://schemas.microsoft.com/office/drawing/2014/main" id="{EEEA7C81-0285-467E-9749-DFCABDAA451A}"/>
+                <a16:creationId xmlns:a16="http://schemas.microsoft.com/office/drawing/2014/main" id="{32057DBB-7140-45F3-83C9-FB1737AE3659}"/>
               </a:ext>
             </a:extLst>
           </p:cNvPr>
@@ -4127,7 +4132,7 @@
           <p:cNvPr id="12" name="">
             <a:extLst xmlns:a="http://schemas.openxmlformats.org/drawingml/2006/main">
               <a:ext uri="{FF2B5EF4-FFF2-40B4-BE49-F238E27FC236}">
-                <a16:creationId xmlns:a16="http://schemas.microsoft.com/office/drawing/2014/main" id="{06BA6338-6ABB-4F87-A225-A0A8FFE33F96}"/>
+                <a16:creationId xmlns:a16="http://schemas.microsoft.com/office/drawing/2014/main" id="{691E0B30-6C14-4A18-8F42-CACC3ADBD9FB}"/>
               </a:ext>
             </a:extLst>
           </p:cNvPr>
@@ -4177,7 +4182,7 @@
           <p:cNvPr id="13" name="">
             <a:extLst xmlns:a="http://schemas.openxmlformats.org/drawingml/2006/main">
               <a:ext uri="{FF2B5EF4-FFF2-40B4-BE49-F238E27FC236}">
-                <a16:creationId xmlns:a16="http://schemas.microsoft.com/office/drawing/2014/main" id="{3FA7312E-F183-431F-8F93-5DAE042BA5FB}"/>
+                <a16:creationId xmlns:a16="http://schemas.microsoft.com/office/drawing/2014/main" id="{A2ACDE22-E435-4A47-BA79-CBC4C3F57866}"/>
               </a:ext>
             </a:extLst>
           </p:cNvPr>
@@ -4208,7 +4213,7 @@
           <p:cNvPr id="14" name="">
             <a:extLst xmlns:a="http://schemas.openxmlformats.org/drawingml/2006/main">
               <a:ext uri="{FF2B5EF4-FFF2-40B4-BE49-F238E27FC236}">
-                <a16:creationId xmlns:a16="http://schemas.microsoft.com/office/drawing/2014/main" id="{639028E8-520B-4226-A2C0-8FAA493F2E8D}"/>
+                <a16:creationId xmlns:a16="http://schemas.microsoft.com/office/drawing/2014/main" id="{9597EAE0-7FDC-47BD-94C4-F6CB41DE4630}"/>
               </a:ext>
             </a:extLst>
           </p:cNvPr>
@@ -4258,7 +4263,7 @@
           <p:cNvPr id="15" name="">
             <a:extLst xmlns:a="http://schemas.openxmlformats.org/drawingml/2006/main">
               <a:ext uri="{FF2B5EF4-FFF2-40B4-BE49-F238E27FC236}">
-                <a16:creationId xmlns:a16="http://schemas.microsoft.com/office/drawing/2014/main" id="{3E425FD8-A71B-4051-BB24-F53DC7532F82}"/>
+                <a16:creationId xmlns:a16="http://schemas.microsoft.com/office/drawing/2014/main" id="{8B3A3CF0-42FB-43DD-B389-E173B458016D}"/>
               </a:ext>
             </a:extLst>
           </p:cNvPr>
@@ -4308,7 +4313,7 @@
           <p:cNvPr id="16" name="">
             <a:extLst xmlns:a="http://schemas.openxmlformats.org/drawingml/2006/main">
               <a:ext uri="{FF2B5EF4-FFF2-40B4-BE49-F238E27FC236}">
-                <a16:creationId xmlns:a16="http://schemas.microsoft.com/office/drawing/2014/main" id="{69CB595C-9341-49C6-8E80-D836A1C5C1D8}"/>
+                <a16:creationId xmlns:a16="http://schemas.microsoft.com/office/drawing/2014/main" id="{9C7A32DF-6E6B-404A-8EF7-5B46E89D1D04}"/>
               </a:ext>
             </a:extLst>
           </p:cNvPr>
@@ -4356,7 +4361,7 @@
     </p:spTree>
     <p:extLst>
       <p:ext uri="{BB962C8B-B14F-4D97-AF65-F5344CB8AC3E}">
-        <p14:creationId xmlns:p14="http://schemas.microsoft.com/office/powerpoint/2010/main" val="1432180523"/>
+        <p14:creationId xmlns:p14="http://schemas.microsoft.com/office/powerpoint/2010/main" val="938142167"/>
       </p:ext>
     </p:extLst>
   </p:cSld>
@@ -4387,7 +4392,7 @@
           <p:cNvPr id="15" name="">
             <a:extLst xmlns:a="http://schemas.openxmlformats.org/drawingml/2006/main">
               <a:ext uri="{FF2B5EF4-FFF2-40B4-BE49-F238E27FC236}">
-                <a16:creationId xmlns:a16="http://schemas.microsoft.com/office/drawing/2014/main" id="{C6B4CE2F-9957-46EE-AA82-73CDE40669C9}"/>
+                <a16:creationId xmlns:a16="http://schemas.microsoft.com/office/drawing/2014/main" id="{6BB8D00A-E042-4CBF-8313-94F867FEEF9B}"/>
               </a:ext>
             </a:extLst>
           </p:cNvPr>
@@ -4437,7 +4442,7 @@
           <p:cNvPr id="2" name="">
             <a:extLst xmlns:a="http://schemas.openxmlformats.org/drawingml/2006/main">
               <a:ext uri="{FF2B5EF4-FFF2-40B4-BE49-F238E27FC236}">
-                <a16:creationId xmlns:a16="http://schemas.microsoft.com/office/drawing/2014/main" id="{C8BA4646-951F-4A26-B02C-3536C023CBBC}"/>
+                <a16:creationId xmlns:a16="http://schemas.microsoft.com/office/drawing/2014/main" id="{5010AEC4-16AC-4473-AD5D-4505F23E14DA}"/>
               </a:ext>
             </a:extLst>
           </p:cNvPr>
@@ -4487,7 +4492,7 @@
           <p:cNvPr id="3" name="">
             <a:extLst xmlns:a="http://schemas.openxmlformats.org/drawingml/2006/main">
               <a:ext uri="{FF2B5EF4-FFF2-40B4-BE49-F238E27FC236}">
-                <a16:creationId xmlns:a16="http://schemas.microsoft.com/office/drawing/2014/main" id="{4F4852DE-D899-4EFF-B849-F84FD246E05F}"/>
+                <a16:creationId xmlns:a16="http://schemas.microsoft.com/office/drawing/2014/main" id="{C7E432A2-2282-452E-9130-FCB89C98F303}"/>
               </a:ext>
             </a:extLst>
           </p:cNvPr>
@@ -4537,7 +4542,7 @@
           <p:cNvPr id="4" name="">
             <a:extLst xmlns:a="http://schemas.openxmlformats.org/drawingml/2006/main">
               <a:ext uri="{FF2B5EF4-FFF2-40B4-BE49-F238E27FC236}">
-                <a16:creationId xmlns:a16="http://schemas.microsoft.com/office/drawing/2014/main" id="{876932F4-7DEA-4FCA-9CAA-2DEE3ECE5417}"/>
+                <a16:creationId xmlns:a16="http://schemas.microsoft.com/office/drawing/2014/main" id="{38CA6EEE-E75D-4F26-ACB4-5BF45656AD8F}"/>
               </a:ext>
             </a:extLst>
           </p:cNvPr>
@@ -4587,7 +4592,7 @@
           <p:cNvPr id="5" name="">
             <a:extLst xmlns:a="http://schemas.openxmlformats.org/drawingml/2006/main">
               <a:ext uri="{FF2B5EF4-FFF2-40B4-BE49-F238E27FC236}">
-                <a16:creationId xmlns:a16="http://schemas.microsoft.com/office/drawing/2014/main" id="{D8973758-DDDC-40E4-AD2E-0A0ADB4641B0}"/>
+                <a16:creationId xmlns:a16="http://schemas.microsoft.com/office/drawing/2014/main" id="{39C2A197-DF65-48E1-A608-824465534BAE}"/>
               </a:ext>
             </a:extLst>
           </p:cNvPr>
@@ -4637,7 +4642,7 @@
           <p:cNvPr id="6" name="">
             <a:extLst xmlns:a="http://schemas.openxmlformats.org/drawingml/2006/main">
               <a:ext uri="{FF2B5EF4-FFF2-40B4-BE49-F238E27FC236}">
-                <a16:creationId xmlns:a16="http://schemas.microsoft.com/office/drawing/2014/main" id="{F3879348-7A93-40D8-BE6A-74DD062F7D68}"/>
+                <a16:creationId xmlns:a16="http://schemas.microsoft.com/office/drawing/2014/main" id="{53F43964-E35C-4881-AAF1-3B047B1DF6F8}"/>
               </a:ext>
             </a:extLst>
           </p:cNvPr>
@@ -4687,7 +4692,7 @@
           <p:cNvPr id="7" name="">
             <a:extLst xmlns:a="http://schemas.openxmlformats.org/drawingml/2006/main">
               <a:ext uri="{FF2B5EF4-FFF2-40B4-BE49-F238E27FC236}">
-                <a16:creationId xmlns:a16="http://schemas.microsoft.com/office/drawing/2014/main" id="{430CA2DD-3F4B-4152-83B5-E3D468BCC102}"/>
+                <a16:creationId xmlns:a16="http://schemas.microsoft.com/office/drawing/2014/main" id="{7FD36D02-A0F7-4056-845A-419218182DF2}"/>
               </a:ext>
             </a:extLst>
           </p:cNvPr>
@@ -4737,7 +4742,7 @@
           <p:cNvPr id="8" name="">
             <a:extLst xmlns:a="http://schemas.openxmlformats.org/drawingml/2006/main">
               <a:ext uri="{FF2B5EF4-FFF2-40B4-BE49-F238E27FC236}">
-                <a16:creationId xmlns:a16="http://schemas.microsoft.com/office/drawing/2014/main" id="{B8185251-AD8C-43E0-AAD5-FF1AF03A930D}"/>
+                <a16:creationId xmlns:a16="http://schemas.microsoft.com/office/drawing/2014/main" id="{869F8FC6-2572-4156-8D70-1A137464D9CC}"/>
               </a:ext>
             </a:extLst>
           </p:cNvPr>
@@ -4787,7 +4792,7 @@
           <p:cNvPr id="9" name="">
             <a:extLst xmlns:a="http://schemas.openxmlformats.org/drawingml/2006/main">
               <a:ext uri="{FF2B5EF4-FFF2-40B4-BE49-F238E27FC236}">
-                <a16:creationId xmlns:a16="http://schemas.microsoft.com/office/drawing/2014/main" id="{C9823D08-C122-4D61-8DD8-7C3F73109D73}"/>
+                <a16:creationId xmlns:a16="http://schemas.microsoft.com/office/drawing/2014/main" id="{F05F8CC5-C174-42B2-867E-10128B930290}"/>
               </a:ext>
             </a:extLst>
           </p:cNvPr>
@@ -4837,7 +4842,7 @@
           <p:cNvPr id="10" name="">
             <a:extLst xmlns:a="http://schemas.openxmlformats.org/drawingml/2006/main">
               <a:ext uri="{FF2B5EF4-FFF2-40B4-BE49-F238E27FC236}">
-                <a16:creationId xmlns:a16="http://schemas.microsoft.com/office/drawing/2014/main" id="{8E3E0687-7278-4F44-BAD8-FC78975C012E}"/>
+                <a16:creationId xmlns:a16="http://schemas.microsoft.com/office/drawing/2014/main" id="{F67B6D55-B6D3-4D78-B9B8-B58D7A317D19}"/>
               </a:ext>
             </a:extLst>
           </p:cNvPr>
@@ -4887,7 +4892,7 @@
           <p:cNvPr id="11" name="">
             <a:extLst xmlns:a="http://schemas.openxmlformats.org/drawingml/2006/main">
               <a:ext uri="{FF2B5EF4-FFF2-40B4-BE49-F238E27FC236}">
-                <a16:creationId xmlns:a16="http://schemas.microsoft.com/office/drawing/2014/main" id="{D5403DF6-E996-4CB5-BE90-7C7B3ECDB7D4}"/>
+                <a16:creationId xmlns:a16="http://schemas.microsoft.com/office/drawing/2014/main" id="{003716AF-2CC5-406D-9910-9A4D95003E05}"/>
               </a:ext>
             </a:extLst>
           </p:cNvPr>
@@ -4918,7 +4923,7 @@
           <p:cNvPr id="12" name="">
             <a:extLst xmlns:a="http://schemas.openxmlformats.org/drawingml/2006/main">
               <a:ext uri="{FF2B5EF4-FFF2-40B4-BE49-F238E27FC236}">
-                <a16:creationId xmlns:a16="http://schemas.microsoft.com/office/drawing/2014/main" id="{9CE9AFF2-BA4B-47AF-90D9-938EBB0CD3D0}"/>
+                <a16:creationId xmlns:a16="http://schemas.microsoft.com/office/drawing/2014/main" id="{BB56CCAB-31D5-4522-BB4A-89112E42E592}"/>
               </a:ext>
             </a:extLst>
           </p:cNvPr>
@@ -4968,7 +4973,7 @@
           <p:cNvPr id="13" name="">
             <a:extLst xmlns:a="http://schemas.openxmlformats.org/drawingml/2006/main">
               <a:ext uri="{FF2B5EF4-FFF2-40B4-BE49-F238E27FC236}">
-                <a16:creationId xmlns:a16="http://schemas.microsoft.com/office/drawing/2014/main" id="{881D0C17-6E5D-4173-9986-E3CAADF83BF4}"/>
+                <a16:creationId xmlns:a16="http://schemas.microsoft.com/office/drawing/2014/main" id="{FA6B60C7-F77F-41E7-B148-2349E4D8BEB7}"/>
               </a:ext>
             </a:extLst>
           </p:cNvPr>
@@ -5018,7 +5023,7 @@
           <p:cNvPr id="14" name="">
             <a:extLst xmlns:a="http://schemas.openxmlformats.org/drawingml/2006/main">
               <a:ext uri="{FF2B5EF4-FFF2-40B4-BE49-F238E27FC236}">
-                <a16:creationId xmlns:a16="http://schemas.microsoft.com/office/drawing/2014/main" id="{90CD33D0-6E80-4F97-A505-3981B2AA1F69}"/>
+                <a16:creationId xmlns:a16="http://schemas.microsoft.com/office/drawing/2014/main" id="{FEE829BC-C365-4AF3-BA29-69293093ABD6}"/>
               </a:ext>
             </a:extLst>
           </p:cNvPr>
@@ -5066,7 +5071,7 @@
     </p:spTree>
     <p:extLst>
       <p:ext uri="{BB962C8B-B14F-4D97-AF65-F5344CB8AC3E}">
-        <p14:creationId xmlns:p14="http://schemas.microsoft.com/office/powerpoint/2010/main" val="1981364023"/>
+        <p14:creationId xmlns:p14="http://schemas.microsoft.com/office/powerpoint/2010/main" val="908985294"/>
       </p:ext>
     </p:extLst>
   </p:cSld>
@@ -5097,7 +5102,7 @@
           <p:cNvPr id="12" name="">
             <a:extLst xmlns:a="http://schemas.openxmlformats.org/drawingml/2006/main">
               <a:ext uri="{FF2B5EF4-FFF2-40B4-BE49-F238E27FC236}">
-                <a16:creationId xmlns:a16="http://schemas.microsoft.com/office/drawing/2014/main" id="{3CC51281-9FDC-4EB3-A6AD-CB29F39716F7}"/>
+                <a16:creationId xmlns:a16="http://schemas.microsoft.com/office/drawing/2014/main" id="{0214A903-4877-4D6F-B48E-3A86B4C4572C}"/>
               </a:ext>
             </a:extLst>
           </p:cNvPr>
@@ -5147,7 +5152,7 @@
           <p:cNvPr id="2" name="">
             <a:extLst xmlns:a="http://schemas.openxmlformats.org/drawingml/2006/main">
               <a:ext uri="{FF2B5EF4-FFF2-40B4-BE49-F238E27FC236}">
-                <a16:creationId xmlns:a16="http://schemas.microsoft.com/office/drawing/2014/main" id="{77788F02-BA0B-42A4-BBA0-A84F91360122}"/>
+                <a16:creationId xmlns:a16="http://schemas.microsoft.com/office/drawing/2014/main" id="{B819FBBA-F596-4F7B-9888-36243BF89721}"/>
               </a:ext>
             </a:extLst>
           </p:cNvPr>
@@ -5197,7 +5202,7 @@
           <p:cNvPr id="3" name="">
             <a:extLst xmlns:a="http://schemas.openxmlformats.org/drawingml/2006/main">
               <a:ext uri="{FF2B5EF4-FFF2-40B4-BE49-F238E27FC236}">
-                <a16:creationId xmlns:a16="http://schemas.microsoft.com/office/drawing/2014/main" id="{06BCC0E1-994C-46E5-B2D1-5406224A279E}"/>
+                <a16:creationId xmlns:a16="http://schemas.microsoft.com/office/drawing/2014/main" id="{71576250-220D-44DD-9572-8C3216639949}"/>
               </a:ext>
             </a:extLst>
           </p:cNvPr>
@@ -5247,7 +5252,7 @@
           <p:cNvPr id="4" name="">
             <a:extLst xmlns:a="http://schemas.openxmlformats.org/drawingml/2006/main">
               <a:ext uri="{FF2B5EF4-FFF2-40B4-BE49-F238E27FC236}">
-                <a16:creationId xmlns:a16="http://schemas.microsoft.com/office/drawing/2014/main" id="{3A8D7A4D-E741-41D4-88F7-F835002EEA6A}"/>
+                <a16:creationId xmlns:a16="http://schemas.microsoft.com/office/drawing/2014/main" id="{86D7D8BF-7C48-4630-9784-973D204EBBEE}"/>
               </a:ext>
             </a:extLst>
           </p:cNvPr>
@@ -5297,7 +5302,7 @@
           <p:cNvPr id="5" name="">
             <a:extLst xmlns:a="http://schemas.openxmlformats.org/drawingml/2006/main">
               <a:ext uri="{FF2B5EF4-FFF2-40B4-BE49-F238E27FC236}">
-                <a16:creationId xmlns:a16="http://schemas.microsoft.com/office/drawing/2014/main" id="{F795BF95-1DD1-4FD3-813D-018E3B474233}"/>
+                <a16:creationId xmlns:a16="http://schemas.microsoft.com/office/drawing/2014/main" id="{93D95A12-1A23-4D53-BCC5-914C93D0DDF6}"/>
               </a:ext>
             </a:extLst>
           </p:cNvPr>
@@ -5347,7 +5352,7 @@
           <p:cNvPr id="6" name="">
             <a:extLst xmlns:a="http://schemas.openxmlformats.org/drawingml/2006/main">
               <a:ext uri="{FF2B5EF4-FFF2-40B4-BE49-F238E27FC236}">
-                <a16:creationId xmlns:a16="http://schemas.microsoft.com/office/drawing/2014/main" id="{A069A48E-8AEF-469A-A9F7-26D88F519D00}"/>
+                <a16:creationId xmlns:a16="http://schemas.microsoft.com/office/drawing/2014/main" id="{1DD8B41A-D374-4232-BE34-36A74B338545}"/>
               </a:ext>
             </a:extLst>
           </p:cNvPr>
@@ -5397,7 +5402,7 @@
           <p:cNvPr id="7" name="">
             <a:extLst xmlns:a="http://schemas.openxmlformats.org/drawingml/2006/main">
               <a:ext uri="{FF2B5EF4-FFF2-40B4-BE49-F238E27FC236}">
-                <a16:creationId xmlns:a16="http://schemas.microsoft.com/office/drawing/2014/main" id="{C28CAFFC-707C-47D2-A352-04E31B47BA68}"/>
+                <a16:creationId xmlns:a16="http://schemas.microsoft.com/office/drawing/2014/main" id="{F8DD4EA7-68BB-411C-AA8E-6863FE206F50}"/>
               </a:ext>
             </a:extLst>
           </p:cNvPr>
@@ -5447,7 +5452,7 @@
           <p:cNvPr id="8" name="">
             <a:extLst xmlns:a="http://schemas.openxmlformats.org/drawingml/2006/main">
               <a:ext uri="{FF2B5EF4-FFF2-40B4-BE49-F238E27FC236}">
-                <a16:creationId xmlns:a16="http://schemas.microsoft.com/office/drawing/2014/main" id="{DDA21EFB-4FEF-44C8-896E-D4508A461359}"/>
+                <a16:creationId xmlns:a16="http://schemas.microsoft.com/office/drawing/2014/main" id="{1C8D5E37-BA82-4188-B455-0E8C2DCA8947}"/>
               </a:ext>
             </a:extLst>
           </p:cNvPr>
@@ -5497,7 +5502,7 @@
           <p:cNvPr id="9" name="">
             <a:extLst xmlns:a="http://schemas.openxmlformats.org/drawingml/2006/main">
               <a:ext uri="{FF2B5EF4-FFF2-40B4-BE49-F238E27FC236}">
-                <a16:creationId xmlns:a16="http://schemas.microsoft.com/office/drawing/2014/main" id="{29F4ABF6-EFF9-4EBE-B185-B6CD56CACCE3}"/>
+                <a16:creationId xmlns:a16="http://schemas.microsoft.com/office/drawing/2014/main" id="{C55A4190-5409-428D-AE3B-9535F4AD1DDE}"/>
               </a:ext>
             </a:extLst>
           </p:cNvPr>
@@ -5547,7 +5552,7 @@
           <p:cNvPr id="10" name="">
             <a:extLst xmlns:a="http://schemas.openxmlformats.org/drawingml/2006/main">
               <a:ext uri="{FF2B5EF4-FFF2-40B4-BE49-F238E27FC236}">
-                <a16:creationId xmlns:a16="http://schemas.microsoft.com/office/drawing/2014/main" id="{6827A1CF-FB0F-4EF9-9AAC-F6A29927364B}"/>
+                <a16:creationId xmlns:a16="http://schemas.microsoft.com/office/drawing/2014/main" id="{9F911AD4-54DA-4BDB-A27E-01FD73237203}"/>
               </a:ext>
             </a:extLst>
           </p:cNvPr>
@@ -5597,7 +5602,7 @@
           <p:cNvPr id="11" name="">
             <a:extLst xmlns:a="http://schemas.openxmlformats.org/drawingml/2006/main">
               <a:ext uri="{FF2B5EF4-FFF2-40B4-BE49-F238E27FC236}">
-                <a16:creationId xmlns:a16="http://schemas.microsoft.com/office/drawing/2014/main" id="{3FB59C64-BE46-458E-A085-895460376B36}"/>
+                <a16:creationId xmlns:a16="http://schemas.microsoft.com/office/drawing/2014/main" id="{9495BC32-3E64-4ABB-88B1-01724A8C9824}"/>
               </a:ext>
             </a:extLst>
           </p:cNvPr>
@@ -5645,7 +5650,7 @@
     </p:spTree>
     <p:extLst>
       <p:ext uri="{BB962C8B-B14F-4D97-AF65-F5344CB8AC3E}">
-        <p14:creationId xmlns:p14="http://schemas.microsoft.com/office/powerpoint/2010/main" val="1019548047"/>
+        <p14:creationId xmlns:p14="http://schemas.microsoft.com/office/powerpoint/2010/main" val="1245650642"/>
       </p:ext>
     </p:extLst>
   </p:cSld>
@@ -5676,7 +5681,7 @@
           <p:cNvPr id="22" name="">
             <a:extLst xmlns:a="http://schemas.openxmlformats.org/drawingml/2006/main">
               <a:ext uri="{FF2B5EF4-FFF2-40B4-BE49-F238E27FC236}">
-                <a16:creationId xmlns:a16="http://schemas.microsoft.com/office/drawing/2014/main" id="{6E2861C9-5F68-4128-BD76-9EC7AC6606CD}"/>
+                <a16:creationId xmlns:a16="http://schemas.microsoft.com/office/drawing/2014/main" id="{10312D3C-5AC6-4EA9-A794-91A6A7F2FCB9}"/>
               </a:ext>
             </a:extLst>
           </p:cNvPr>
@@ -5726,7 +5731,7 @@
           <p:cNvPr id="2" name="">
             <a:extLst xmlns:a="http://schemas.openxmlformats.org/drawingml/2006/main">
               <a:ext uri="{FF2B5EF4-FFF2-40B4-BE49-F238E27FC236}">
-                <a16:creationId xmlns:a16="http://schemas.microsoft.com/office/drawing/2014/main" id="{15A5BA03-E95A-4F99-8439-A2B34E6C270A}"/>
+                <a16:creationId xmlns:a16="http://schemas.microsoft.com/office/drawing/2014/main" id="{8A0548C2-5826-488D-B1F1-22BD71C878F3}"/>
               </a:ext>
             </a:extLst>
           </p:cNvPr>
@@ -5776,7 +5781,7 @@
           <p:cNvPr id="3" name="">
             <a:extLst xmlns:a="http://schemas.openxmlformats.org/drawingml/2006/main">
               <a:ext uri="{FF2B5EF4-FFF2-40B4-BE49-F238E27FC236}">
-                <a16:creationId xmlns:a16="http://schemas.microsoft.com/office/drawing/2014/main" id="{452F4E55-BB3C-4086-BE0F-3B687FD7C425}"/>
+                <a16:creationId xmlns:a16="http://schemas.microsoft.com/office/drawing/2014/main" id="{7A583227-C72C-4870-A4AB-26A7F0325A69}"/>
               </a:ext>
             </a:extLst>
           </p:cNvPr>
@@ -5811,7 +5816,7 @@
           <p:cNvPr id="4" name="">
             <a:extLst xmlns:a="http://schemas.openxmlformats.org/drawingml/2006/main">
               <a:ext uri="{FF2B5EF4-FFF2-40B4-BE49-F238E27FC236}">
-                <a16:creationId xmlns:a16="http://schemas.microsoft.com/office/drawing/2014/main" id="{45FA16C7-E80E-40C2-8912-6A8FFD9A6938}"/>
+                <a16:creationId xmlns:a16="http://schemas.microsoft.com/office/drawing/2014/main" id="{69124CE2-0E7A-414A-A43F-BF80FC76B928}"/>
               </a:ext>
             </a:extLst>
           </p:cNvPr>
@@ -5878,7 +5883,7 @@
           <p:cNvPr id="5" name="">
             <a:extLst xmlns:a="http://schemas.openxmlformats.org/drawingml/2006/main">
               <a:ext uri="{FF2B5EF4-FFF2-40B4-BE49-F238E27FC236}">
-                <a16:creationId xmlns:a16="http://schemas.microsoft.com/office/drawing/2014/main" id="{E7BFF767-C121-499C-A5B0-0F2C9F7B8F03}"/>
+                <a16:creationId xmlns:a16="http://schemas.microsoft.com/office/drawing/2014/main" id="{4EE85025-0FC7-4A73-B66D-04BB04A845C9}"/>
               </a:ext>
             </a:extLst>
           </p:cNvPr>
@@ -5928,7 +5933,7 @@
           <p:cNvPr id="6" name="">
             <a:extLst xmlns:a="http://schemas.openxmlformats.org/drawingml/2006/main">
               <a:ext uri="{FF2B5EF4-FFF2-40B4-BE49-F238E27FC236}">
-                <a16:creationId xmlns:a16="http://schemas.microsoft.com/office/drawing/2014/main" id="{86629657-3D34-446B-AAC4-ACDFA24BF8C2}"/>
+                <a16:creationId xmlns:a16="http://schemas.microsoft.com/office/drawing/2014/main" id="{692CB88B-26EC-4AD0-BAFA-CB670F9FF2E2}"/>
               </a:ext>
             </a:extLst>
           </p:cNvPr>
@@ -5963,7 +5968,7 @@
           <p:cNvPr id="7" name="">
             <a:extLst xmlns:a="http://schemas.openxmlformats.org/drawingml/2006/main">
               <a:ext uri="{FF2B5EF4-FFF2-40B4-BE49-F238E27FC236}">
-                <a16:creationId xmlns:a16="http://schemas.microsoft.com/office/drawing/2014/main" id="{AB166912-B3FA-485F-85F6-9187A48BC734}"/>
+                <a16:creationId xmlns:a16="http://schemas.microsoft.com/office/drawing/2014/main" id="{EB4C16F5-0B5D-49C1-9EC6-7476A982D203}"/>
               </a:ext>
             </a:extLst>
           </p:cNvPr>
@@ -6030,7 +6035,7 @@
           <p:cNvPr id="8" name="">
             <a:extLst xmlns:a="http://schemas.openxmlformats.org/drawingml/2006/main">
               <a:ext uri="{FF2B5EF4-FFF2-40B4-BE49-F238E27FC236}">
-                <a16:creationId xmlns:a16="http://schemas.microsoft.com/office/drawing/2014/main" id="{5CE23B28-612A-4B97-B4AA-15C0ADB97876}"/>
+                <a16:creationId xmlns:a16="http://schemas.microsoft.com/office/drawing/2014/main" id="{F5E5B23B-9916-4E8D-9843-A0259640B12E}"/>
               </a:ext>
             </a:extLst>
           </p:cNvPr>
@@ -6080,7 +6085,7 @@
           <p:cNvPr id="9" name="">
             <a:extLst xmlns:a="http://schemas.openxmlformats.org/drawingml/2006/main">
               <a:ext uri="{FF2B5EF4-FFF2-40B4-BE49-F238E27FC236}">
-                <a16:creationId xmlns:a16="http://schemas.microsoft.com/office/drawing/2014/main" id="{6C039FF1-5160-490A-B103-8AD45E04CD30}"/>
+                <a16:creationId xmlns:a16="http://schemas.microsoft.com/office/drawing/2014/main" id="{82D3EA5A-DD27-4A2F-B366-FCCF188D0B4B}"/>
               </a:ext>
             </a:extLst>
           </p:cNvPr>
@@ -6115,7 +6120,7 @@
           <p:cNvPr id="10" name="">
             <a:extLst xmlns:a="http://schemas.openxmlformats.org/drawingml/2006/main">
               <a:ext uri="{FF2B5EF4-FFF2-40B4-BE49-F238E27FC236}">
-                <a16:creationId xmlns:a16="http://schemas.microsoft.com/office/drawing/2014/main" id="{3A00ED5F-8A3D-456E-8D8F-F22B2BA98435}"/>
+                <a16:creationId xmlns:a16="http://schemas.microsoft.com/office/drawing/2014/main" id="{D0C8E1C4-3538-47AE-BB0A-DE056346D7BC}"/>
               </a:ext>
             </a:extLst>
           </p:cNvPr>
@@ -6182,7 +6187,7 @@
           <p:cNvPr id="11" name="">
             <a:extLst xmlns:a="http://schemas.openxmlformats.org/drawingml/2006/main">
               <a:ext uri="{FF2B5EF4-FFF2-40B4-BE49-F238E27FC236}">
-                <a16:creationId xmlns:a16="http://schemas.microsoft.com/office/drawing/2014/main" id="{62B0B214-E01D-4FC3-87E2-CD60B6D88A2A}"/>
+                <a16:creationId xmlns:a16="http://schemas.microsoft.com/office/drawing/2014/main" id="{63A4743A-4513-4439-B640-682651DA02D6}"/>
               </a:ext>
             </a:extLst>
           </p:cNvPr>
@@ -6232,7 +6237,7 @@
           <p:cNvPr id="12" name="">
             <a:extLst xmlns:a="http://schemas.openxmlformats.org/drawingml/2006/main">
               <a:ext uri="{FF2B5EF4-FFF2-40B4-BE49-F238E27FC236}">
-                <a16:creationId xmlns:a16="http://schemas.microsoft.com/office/drawing/2014/main" id="{02A621AD-77DE-4207-A5B2-FC6900DC5B68}"/>
+                <a16:creationId xmlns:a16="http://schemas.microsoft.com/office/drawing/2014/main" id="{08048A5B-619F-47D3-A115-91629D1A45CA}"/>
               </a:ext>
             </a:extLst>
           </p:cNvPr>
@@ -6267,7 +6272,7 @@
           <p:cNvPr id="13" name="">
             <a:extLst xmlns:a="http://schemas.openxmlformats.org/drawingml/2006/main">
               <a:ext uri="{FF2B5EF4-FFF2-40B4-BE49-F238E27FC236}">
-                <a16:creationId xmlns:a16="http://schemas.microsoft.com/office/drawing/2014/main" id="{BFA7153B-1621-411E-8EC6-EB84C6AA76FA}"/>
+                <a16:creationId xmlns:a16="http://schemas.microsoft.com/office/drawing/2014/main" id="{ABCB61B2-1A7B-4D7A-8B12-21E5CB1179A0}"/>
               </a:ext>
             </a:extLst>
           </p:cNvPr>
@@ -6334,7 +6339,7 @@
           <p:cNvPr id="14" name="">
             <a:extLst xmlns:a="http://schemas.openxmlformats.org/drawingml/2006/main">
               <a:ext uri="{FF2B5EF4-FFF2-40B4-BE49-F238E27FC236}">
-                <a16:creationId xmlns:a16="http://schemas.microsoft.com/office/drawing/2014/main" id="{1CE69650-A07F-42A3-AAB3-E7476934334C}"/>
+                <a16:creationId xmlns:a16="http://schemas.microsoft.com/office/drawing/2014/main" id="{219E9940-5C9E-4EC6-A69A-827CE649F03D}"/>
               </a:ext>
             </a:extLst>
           </p:cNvPr>
@@ -6384,7 +6389,7 @@
           <p:cNvPr id="15" name="">
             <a:extLst xmlns:a="http://schemas.openxmlformats.org/drawingml/2006/main">
               <a:ext uri="{FF2B5EF4-FFF2-40B4-BE49-F238E27FC236}">
-                <a16:creationId xmlns:a16="http://schemas.microsoft.com/office/drawing/2014/main" id="{769B8775-7239-468C-BC8C-30EA013C673A}"/>
+                <a16:creationId xmlns:a16="http://schemas.microsoft.com/office/drawing/2014/main" id="{BDA228D9-52A0-48FF-825A-DAE3A8B68D5A}"/>
               </a:ext>
             </a:extLst>
           </p:cNvPr>
@@ -6434,7 +6439,7 @@
           <p:cNvPr id="16" name="">
             <a:extLst xmlns:a="http://schemas.openxmlformats.org/drawingml/2006/main">
               <a:ext uri="{FF2B5EF4-FFF2-40B4-BE49-F238E27FC236}">
-                <a16:creationId xmlns:a16="http://schemas.microsoft.com/office/drawing/2014/main" id="{D4A4DCE5-1AA5-4946-81B6-821CBA8086F8}"/>
+                <a16:creationId xmlns:a16="http://schemas.microsoft.com/office/drawing/2014/main" id="{949173BC-1186-4C49-BB7D-CEBE71A14DDB}"/>
               </a:ext>
             </a:extLst>
           </p:cNvPr>
@@ -6484,7 +6489,7 @@
           <p:cNvPr id="17" name="">
             <a:extLst xmlns:a="http://schemas.openxmlformats.org/drawingml/2006/main">
               <a:ext uri="{FF2B5EF4-FFF2-40B4-BE49-F238E27FC236}">
-                <a16:creationId xmlns:a16="http://schemas.microsoft.com/office/drawing/2014/main" id="{9A0DBE37-6841-4BE1-A936-542800883184}"/>
+                <a16:creationId xmlns:a16="http://schemas.microsoft.com/office/drawing/2014/main" id="{5A4BF536-1780-484A-A81D-22D33B90F6BB}"/>
               </a:ext>
             </a:extLst>
           </p:cNvPr>
@@ -6534,7 +6539,7 @@
           <p:cNvPr id="18" name="">
             <a:extLst xmlns:a="http://schemas.openxmlformats.org/drawingml/2006/main">
               <a:ext uri="{FF2B5EF4-FFF2-40B4-BE49-F238E27FC236}">
-                <a16:creationId xmlns:a16="http://schemas.microsoft.com/office/drawing/2014/main" id="{20166A04-AED4-47B7-8CDA-261624265F1F}"/>
+                <a16:creationId xmlns:a16="http://schemas.microsoft.com/office/drawing/2014/main" id="{40CBD32F-9C76-4090-967E-7EDBEF52065A}"/>
               </a:ext>
             </a:extLst>
           </p:cNvPr>
@@ -6584,7 +6589,7 @@
           <p:cNvPr id="19" name="">
             <a:extLst xmlns:a="http://schemas.openxmlformats.org/drawingml/2006/main">
               <a:ext uri="{FF2B5EF4-FFF2-40B4-BE49-F238E27FC236}">
-                <a16:creationId xmlns:a16="http://schemas.microsoft.com/office/drawing/2014/main" id="{099EBF12-1743-4795-902E-D1BFDE271BC4}"/>
+                <a16:creationId xmlns:a16="http://schemas.microsoft.com/office/drawing/2014/main" id="{E9EA22CF-9461-43DA-91A6-B06223394848}"/>
               </a:ext>
             </a:extLst>
           </p:cNvPr>
@@ -6634,7 +6639,7 @@
           <p:cNvPr id="20" name="">
             <a:extLst xmlns:a="http://schemas.openxmlformats.org/drawingml/2006/main">
               <a:ext uri="{FF2B5EF4-FFF2-40B4-BE49-F238E27FC236}">
-                <a16:creationId xmlns:a16="http://schemas.microsoft.com/office/drawing/2014/main" id="{981A80A2-C487-4B63-9C4D-7D904D482F79}"/>
+                <a16:creationId xmlns:a16="http://schemas.microsoft.com/office/drawing/2014/main" id="{006F0B6F-A4AC-4B8C-BE59-4AC5DB49798F}"/>
               </a:ext>
             </a:extLst>
           </p:cNvPr>
@@ -6684,7 +6689,7 @@
           <p:cNvPr id="21" name="">
             <a:extLst xmlns:a="http://schemas.openxmlformats.org/drawingml/2006/main">
               <a:ext uri="{FF2B5EF4-FFF2-40B4-BE49-F238E27FC236}">
-                <a16:creationId xmlns:a16="http://schemas.microsoft.com/office/drawing/2014/main" id="{D056856B-4BFC-4185-9753-5BAF5B6C2901}"/>
+                <a16:creationId xmlns:a16="http://schemas.microsoft.com/office/drawing/2014/main" id="{E3C72460-7EC8-44DB-941A-68EADBE160B2}"/>
               </a:ext>
             </a:extLst>
           </p:cNvPr>
@@ -6732,7 +6737,7 @@
     </p:spTree>
     <p:extLst>
       <p:ext uri="{BB962C8B-B14F-4D97-AF65-F5344CB8AC3E}">
-        <p14:creationId xmlns:p14="http://schemas.microsoft.com/office/powerpoint/2010/main" val="947024270"/>
+        <p14:creationId xmlns:p14="http://schemas.microsoft.com/office/powerpoint/2010/main" val="876670144"/>
       </p:ext>
     </p:extLst>
   </p:cSld>
@@ -6763,7 +6768,7 @@
           <p:cNvPr id="15" name="">
             <a:extLst xmlns:a="http://schemas.openxmlformats.org/drawingml/2006/main">
               <a:ext uri="{FF2B5EF4-FFF2-40B4-BE49-F238E27FC236}">
-                <a16:creationId xmlns:a16="http://schemas.microsoft.com/office/drawing/2014/main" id="{524C366F-CE34-4B3F-BC1B-846FBF9F6DAF}"/>
+                <a16:creationId xmlns:a16="http://schemas.microsoft.com/office/drawing/2014/main" id="{F4B4F162-5588-4747-8482-69912614F0A4}"/>
               </a:ext>
             </a:extLst>
           </p:cNvPr>
@@ -6813,7 +6818,7 @@
           <p:cNvPr id="2" name="">
             <a:extLst xmlns:a="http://schemas.openxmlformats.org/drawingml/2006/main">
               <a:ext uri="{FF2B5EF4-FFF2-40B4-BE49-F238E27FC236}">
-                <a16:creationId xmlns:a16="http://schemas.microsoft.com/office/drawing/2014/main" id="{72D34990-8603-47AD-B834-F6FFF0E85801}"/>
+                <a16:creationId xmlns:a16="http://schemas.microsoft.com/office/drawing/2014/main" id="{1D37321D-0146-43BC-9810-69227E71B285}"/>
               </a:ext>
             </a:extLst>
           </p:cNvPr>
@@ -6863,7 +6868,7 @@
           <p:cNvPr id="3" name="">
             <a:extLst xmlns:a="http://schemas.openxmlformats.org/drawingml/2006/main">
               <a:ext uri="{FF2B5EF4-FFF2-40B4-BE49-F238E27FC236}">
-                <a16:creationId xmlns:a16="http://schemas.microsoft.com/office/drawing/2014/main" id="{BF82FFEC-E09D-4E79-A7FE-FB0F268B5E6C}"/>
+                <a16:creationId xmlns:a16="http://schemas.microsoft.com/office/drawing/2014/main" id="{6B1B5FF6-3F06-48E8-BDA3-7AD4C68441E3}"/>
               </a:ext>
             </a:extLst>
           </p:cNvPr>
@@ -6913,7 +6918,7 @@
           <p:cNvPr id="4" name="">
             <a:extLst xmlns:a="http://schemas.openxmlformats.org/drawingml/2006/main">
               <a:ext uri="{FF2B5EF4-FFF2-40B4-BE49-F238E27FC236}">
-                <a16:creationId xmlns:a16="http://schemas.microsoft.com/office/drawing/2014/main" id="{7FB36E10-396B-4B33-84B3-8908C105A955}"/>
+                <a16:creationId xmlns:a16="http://schemas.microsoft.com/office/drawing/2014/main" id="{BD10B93F-C08B-4DFE-A887-A602EB3BF485}"/>
               </a:ext>
             </a:extLst>
           </p:cNvPr>
@@ -6963,7 +6968,7 @@
           <p:cNvPr id="5" name="">
             <a:extLst xmlns:a="http://schemas.openxmlformats.org/drawingml/2006/main">
               <a:ext uri="{FF2B5EF4-FFF2-40B4-BE49-F238E27FC236}">
-                <a16:creationId xmlns:a16="http://schemas.microsoft.com/office/drawing/2014/main" id="{A5AA46D2-C52D-48F8-A886-934E031EA098}"/>
+                <a16:creationId xmlns:a16="http://schemas.microsoft.com/office/drawing/2014/main" id="{2F09F9F7-049B-42FD-939A-D3E36FF201D5}"/>
               </a:ext>
             </a:extLst>
           </p:cNvPr>
@@ -7013,7 +7018,7 @@
           <p:cNvPr id="6" name="">
             <a:extLst xmlns:a="http://schemas.openxmlformats.org/drawingml/2006/main">
               <a:ext uri="{FF2B5EF4-FFF2-40B4-BE49-F238E27FC236}">
-                <a16:creationId xmlns:a16="http://schemas.microsoft.com/office/drawing/2014/main" id="{6357B22D-0BEA-4F41-91F6-BA4715F638F4}"/>
+                <a16:creationId xmlns:a16="http://schemas.microsoft.com/office/drawing/2014/main" id="{22A3F2E9-CCFE-458D-9EA0-BC00465BE40E}"/>
               </a:ext>
             </a:extLst>
           </p:cNvPr>
@@ -7063,7 +7068,7 @@
           <p:cNvPr id="7" name="">
             <a:extLst xmlns:a="http://schemas.openxmlformats.org/drawingml/2006/main">
               <a:ext uri="{FF2B5EF4-FFF2-40B4-BE49-F238E27FC236}">
-                <a16:creationId xmlns:a16="http://schemas.microsoft.com/office/drawing/2014/main" id="{373F2FF0-CF6D-4230-8C8A-FAEFFBC8A25D}"/>
+                <a16:creationId xmlns:a16="http://schemas.microsoft.com/office/drawing/2014/main" id="{A3EA0753-2EA4-4627-A5B2-C5D4F0CBA521}"/>
               </a:ext>
             </a:extLst>
           </p:cNvPr>
@@ -7113,7 +7118,7 @@
           <p:cNvPr id="8" name="">
             <a:extLst xmlns:a="http://schemas.openxmlformats.org/drawingml/2006/main">
               <a:ext uri="{FF2B5EF4-FFF2-40B4-BE49-F238E27FC236}">
-                <a16:creationId xmlns:a16="http://schemas.microsoft.com/office/drawing/2014/main" id="{C4F57CD4-10E9-429F-AAA0-5A533F4D1EA6}"/>
+                <a16:creationId xmlns:a16="http://schemas.microsoft.com/office/drawing/2014/main" id="{A347428D-9091-456E-85B7-7D321637F945}"/>
               </a:ext>
             </a:extLst>
           </p:cNvPr>
@@ -7163,7 +7168,7 @@
           <p:cNvPr id="9" name="">
             <a:extLst xmlns:a="http://schemas.openxmlformats.org/drawingml/2006/main">
               <a:ext uri="{FF2B5EF4-FFF2-40B4-BE49-F238E27FC236}">
-                <a16:creationId xmlns:a16="http://schemas.microsoft.com/office/drawing/2014/main" id="{563921B5-8403-478E-BE4B-4629E8C858BB}"/>
+                <a16:creationId xmlns:a16="http://schemas.microsoft.com/office/drawing/2014/main" id="{DCCE03A7-0BB6-42F1-BDEA-5DA59B6FAC18}"/>
               </a:ext>
             </a:extLst>
           </p:cNvPr>
@@ -7213,7 +7218,7 @@
           <p:cNvPr id="10" name="">
             <a:extLst xmlns:a="http://schemas.openxmlformats.org/drawingml/2006/main">
               <a:ext uri="{FF2B5EF4-FFF2-40B4-BE49-F238E27FC236}">
-                <a16:creationId xmlns:a16="http://schemas.microsoft.com/office/drawing/2014/main" id="{3810DEF7-2B6A-4E7C-809C-432AAAA7813C}"/>
+                <a16:creationId xmlns:a16="http://schemas.microsoft.com/office/drawing/2014/main" id="{A6AC3CFC-2A88-437A-8C51-013816955484}"/>
               </a:ext>
             </a:extLst>
           </p:cNvPr>
@@ -7263,7 +7268,7 @@
           <p:cNvPr id="11" name="">
             <a:extLst xmlns:a="http://schemas.openxmlformats.org/drawingml/2006/main">
               <a:ext uri="{FF2B5EF4-FFF2-40B4-BE49-F238E27FC236}">
-                <a16:creationId xmlns:a16="http://schemas.microsoft.com/office/drawing/2014/main" id="{242C3F51-AA1F-493A-9044-FAA2B74E2689}"/>
+                <a16:creationId xmlns:a16="http://schemas.microsoft.com/office/drawing/2014/main" id="{B8A0E14F-7B79-4746-9CFE-925D40906446}"/>
               </a:ext>
             </a:extLst>
           </p:cNvPr>
@@ -7294,7 +7299,7 @@
           <p:cNvPr id="12" name="">
             <a:extLst xmlns:a="http://schemas.openxmlformats.org/drawingml/2006/main">
               <a:ext uri="{FF2B5EF4-FFF2-40B4-BE49-F238E27FC236}">
-                <a16:creationId xmlns:a16="http://schemas.microsoft.com/office/drawing/2014/main" id="{732F0D12-41B6-4C47-904A-2FD2F5A03FD1}"/>
+                <a16:creationId xmlns:a16="http://schemas.microsoft.com/office/drawing/2014/main" id="{B4BBA6D2-CA23-4266-9A78-3BC96E4E8E21}"/>
               </a:ext>
             </a:extLst>
           </p:cNvPr>
@@ -7344,7 +7349,7 @@
           <p:cNvPr id="13" name="">
             <a:extLst xmlns:a="http://schemas.openxmlformats.org/drawingml/2006/main">
               <a:ext uri="{FF2B5EF4-FFF2-40B4-BE49-F238E27FC236}">
-                <a16:creationId xmlns:a16="http://schemas.microsoft.com/office/drawing/2014/main" id="{CEBFF4B2-7058-45AD-898D-581F11F2FCCC}"/>
+                <a16:creationId xmlns:a16="http://schemas.microsoft.com/office/drawing/2014/main" id="{8A998F70-F113-477D-A5E9-5F2007229FB3}"/>
               </a:ext>
             </a:extLst>
           </p:cNvPr>
@@ -7394,7 +7399,7 @@
           <p:cNvPr id="14" name="">
             <a:extLst xmlns:a="http://schemas.openxmlformats.org/drawingml/2006/main">
               <a:ext uri="{FF2B5EF4-FFF2-40B4-BE49-F238E27FC236}">
-                <a16:creationId xmlns:a16="http://schemas.microsoft.com/office/drawing/2014/main" id="{C9244580-1673-41A2-96EA-656ED2EAFACE}"/>
+                <a16:creationId xmlns:a16="http://schemas.microsoft.com/office/drawing/2014/main" id="{09B5FA8D-3BCA-4566-BAB7-B720F8DA3FDF}"/>
               </a:ext>
             </a:extLst>
           </p:cNvPr>
@@ -7442,7 +7447,7 @@
     </p:spTree>
     <p:extLst>
       <p:ext uri="{BB962C8B-B14F-4D97-AF65-F5344CB8AC3E}">
-        <p14:creationId xmlns:p14="http://schemas.microsoft.com/office/powerpoint/2010/main" val="707378012"/>
+        <p14:creationId xmlns:p14="http://schemas.microsoft.com/office/powerpoint/2010/main" val="427654349"/>
       </p:ext>
     </p:extLst>
   </p:cSld>
@@ -7470,10 +7475,10 @@
       </p:grpSpPr>
       <p:sp>
         <p:nvSpPr>
-          <p:cNvPr id="6" name="">
-            <a:extLst xmlns:a="http://schemas.openxmlformats.org/drawingml/2006/main">
-              <a:ext uri="{FF2B5EF4-FFF2-40B4-BE49-F238E27FC236}">
-                <a16:creationId xmlns:a16="http://schemas.microsoft.com/office/drawing/2014/main" id="{B5CB5E58-3C5B-472C-9ACA-A57E00A07C2D}"/>
+          <p:cNvPr id="7" name="">
+            <a:extLst xmlns:a="http://schemas.openxmlformats.org/drawingml/2006/main">
+              <a:ext uri="{FF2B5EF4-FFF2-40B4-BE49-F238E27FC236}">
+                <a16:creationId xmlns:a16="http://schemas.microsoft.com/office/drawing/2014/main" id="{A09C2A0C-D04D-48FD-A7AA-AE83D36D0BDE}"/>
               </a:ext>
             </a:extLst>
           </p:cNvPr>
@@ -7523,7 +7528,7 @@
           <p:cNvPr id="2" name="">
             <a:extLst xmlns:a="http://schemas.openxmlformats.org/drawingml/2006/main">
               <a:ext uri="{FF2B5EF4-FFF2-40B4-BE49-F238E27FC236}">
-                <a16:creationId xmlns:a16="http://schemas.microsoft.com/office/drawing/2014/main" id="{4C9280EB-B5F4-440A-A393-702204B0EBC1}"/>
+                <a16:creationId xmlns:a16="http://schemas.microsoft.com/office/drawing/2014/main" id="{8F04FD3D-74BF-42A8-9A7C-6899816AE0AC}"/>
               </a:ext>
             </a:extLst>
           </p:cNvPr>
@@ -7563,27 +7568,27 @@
                   <a:srgbClr val="64748B"/>
                 </a:solidFill>
               </a:rPr>
-              <a:t>The timeline shows where replay spends time before the first useful token.</a:t>
+              <a:t>Each row is one tool-gap replay; the replay path shows where time goes before the first token.</a:t>
             </a:r>
           </a:p>
         </p:txBody>
       </p:sp>
       <p:pic>
         <p:nvPicPr>
-          <p:cNvPr id="8" name=""/>
+          <p:cNvPr id="9" name=""/>
           <p:cNvPicPr>
             <a:picLocks xmlns:a="http://schemas.openxmlformats.org/drawingml/2006/main" noChangeAspect="1"/>
           </p:cNvPicPr>
           <p:nvPr/>
         </p:nvPicPr>
         <p:blipFill>
-          <a:blip xmlns:r="http://schemas.openxmlformats.org/officeDocument/2006/relationships" xmlns:a="http://schemas.openxmlformats.org/drawingml/2006/main" r:embed="R4d822850def849d2"/>
+          <a:blip xmlns:r="http://schemas.openxmlformats.org/officeDocument/2006/relationships" xmlns:a="http://schemas.openxmlformats.org/drawingml/2006/main" r:embed="R4150a337e9ec487f"/>
           <a:stretch xmlns:a="http://schemas.openxmlformats.org/drawingml/2006/main"/>
         </p:blipFill>
         <p:spPr>
           <a:xfrm xmlns:a="http://schemas.openxmlformats.org/drawingml/2006/main">
-            <a:off x="468276" y="1295400"/>
-            <a:ext cx="11255448" cy="4629150"/>
+            <a:off x="1024101" y="1295400"/>
+            <a:ext cx="10143798" cy="4171950"/>
           </a:xfrm>
           <a:prstGeom xmlns:a="http://schemas.openxmlformats.org/drawingml/2006/main" prst="rect">
             <a:avLst/>
@@ -7595,7 +7600,57 @@
           <p:cNvPr id="4" name="">
             <a:extLst xmlns:a="http://schemas.openxmlformats.org/drawingml/2006/main">
               <a:ext uri="{FF2B5EF4-FFF2-40B4-BE49-F238E27FC236}">
-                <a16:creationId xmlns:a16="http://schemas.microsoft.com/office/drawing/2014/main" id="{79FC21EA-CBAC-40DB-A312-903064AD1514}"/>
+                <a16:creationId xmlns:a16="http://schemas.microsoft.com/office/drawing/2014/main" id="{4E637304-7CF4-413F-838E-706688D7508E}"/>
+              </a:ext>
+            </a:extLst>
+          </p:cNvPr>
+          <p:cNvSpPr>
+            <a:spLocks xmlns:a="http://schemas.openxmlformats.org/drawingml/2006/main" noGrp="1"/>
+          </p:cNvSpPr>
+          <p:nvPr/>
+        </p:nvSpPr>
+        <p:spPr>
+          <a:xfrm xmlns:a="http://schemas.openxmlformats.org/drawingml/2006/main">
+            <a:off x="952500" y="5619750"/>
+            <a:ext cx="10287000" cy="266700"/>
+          </a:xfrm>
+          <a:prstGeom xmlns:a="http://schemas.openxmlformats.org/drawingml/2006/main" prst="rect">
+            <a:avLst/>
+          </a:prstGeom>
+          <a:noFill xmlns:a="http://schemas.openxmlformats.org/drawingml/2006/main"/>
+          <a:ln xmlns:a="http://schemas.openxmlformats.org/drawingml/2006/main" w="0">
+            <a:noFill/>
+            <a:prstDash val="solid"/>
+          </a:ln>
+        </p:spPr>
+        <p:txBody>
+          <a:bodyPr xmlns:a="http://schemas.openxmlformats.org/drawingml/2006/main" anchor="t"/>
+          <a:lstStyle xmlns:a="http://schemas.openxmlformats.org/drawingml/2006/main"/>
+          <a:p xmlns:a="http://schemas.openxmlformats.org/drawingml/2006/main">
+            <a:pPr algn="ctr">
+              <a:defRPr sz="1725" b="1">
+                <a:solidFill>
+                  <a:srgbClr val="64748B"/>
+                </a:solidFill>
+              </a:defRPr>
+            </a:pPr>
+            <a:r>
+              <a:rPr sz="1725" b="1">
+                <a:solidFill>
+                  <a:srgbClr val="64748B"/>
+                </a:solidFill>
+              </a:rPr>
+              <a:t>... more replay gaps observed in the full report</a:t>
+            </a:r>
+          </a:p>
+        </p:txBody>
+      </p:sp>
+      <p:sp>
+        <p:nvSpPr>
+          <p:cNvPr id="5" name="">
+            <a:extLst xmlns:a="http://schemas.openxmlformats.org/drawingml/2006/main">
+              <a:ext uri="{FF2B5EF4-FFF2-40B4-BE49-F238E27FC236}">
+                <a16:creationId xmlns:a16="http://schemas.microsoft.com/office/drawing/2014/main" id="{B03724F4-B3F8-4BC8-83FA-CA2CB8F7709E}"/>
               </a:ext>
             </a:extLst>
           </p:cNvPr>
@@ -7642,10 +7697,10 @@
       </p:sp>
       <p:sp>
         <p:nvSpPr>
-          <p:cNvPr id="5" name="">
-            <a:extLst xmlns:a="http://schemas.openxmlformats.org/drawingml/2006/main">
-              <a:ext uri="{FF2B5EF4-FFF2-40B4-BE49-F238E27FC236}">
-                <a16:creationId xmlns:a16="http://schemas.microsoft.com/office/drawing/2014/main" id="{A24A752F-DCA2-4B27-A6BA-82ED24E2307E}"/>
+          <p:cNvPr id="6" name="">
+            <a:extLst xmlns:a="http://schemas.openxmlformats.org/drawingml/2006/main">
+              <a:ext uri="{FF2B5EF4-FFF2-40B4-BE49-F238E27FC236}">
+                <a16:creationId xmlns:a16="http://schemas.microsoft.com/office/drawing/2014/main" id="{EDC63988-5859-43FA-A553-4F1311019966}"/>
               </a:ext>
             </a:extLst>
           </p:cNvPr>
@@ -7693,7 +7748,7 @@
     </p:spTree>
     <p:extLst>
       <p:ext uri="{BB962C8B-B14F-4D97-AF65-F5344CB8AC3E}">
-        <p14:creationId xmlns:p14="http://schemas.microsoft.com/office/powerpoint/2010/main" val="1958997452"/>
+        <p14:creationId xmlns:p14="http://schemas.microsoft.com/office/powerpoint/2010/main" val="653779735"/>
       </p:ext>
     </p:extLst>
   </p:cSld>
@@ -7724,7 +7779,7 @@
           <p:cNvPr id="11" name="">
             <a:extLst xmlns:a="http://schemas.openxmlformats.org/drawingml/2006/main">
               <a:ext uri="{FF2B5EF4-FFF2-40B4-BE49-F238E27FC236}">
-                <a16:creationId xmlns:a16="http://schemas.microsoft.com/office/drawing/2014/main" id="{D07AE9E6-FCF5-49DE-99D6-31697F858267}"/>
+                <a16:creationId xmlns:a16="http://schemas.microsoft.com/office/drawing/2014/main" id="{FB11BD36-A475-4CAF-B2DD-DEFFC67DBDF6}"/>
               </a:ext>
             </a:extLst>
           </p:cNvPr>
@@ -7774,7 +7829,7 @@
           <p:cNvPr id="2" name="">
             <a:extLst xmlns:a="http://schemas.openxmlformats.org/drawingml/2006/main">
               <a:ext uri="{FF2B5EF4-FFF2-40B4-BE49-F238E27FC236}">
-                <a16:creationId xmlns:a16="http://schemas.microsoft.com/office/drawing/2014/main" id="{7B253396-F255-40C2-A080-F191CE4428DF}"/>
+                <a16:creationId xmlns:a16="http://schemas.microsoft.com/office/drawing/2014/main" id="{AE5E1168-66AE-4BDD-92C9-C454CA9E5B7E}"/>
               </a:ext>
             </a:extLst>
           </p:cNvPr>
@@ -7828,7 +7883,7 @@
           <p:nvPr/>
         </p:nvPicPr>
         <p:blipFill>
-          <a:blip xmlns:r="http://schemas.openxmlformats.org/officeDocument/2006/relationships" xmlns:a="http://schemas.openxmlformats.org/drawingml/2006/main" r:embed="R3816c416c0ff44a5"/>
+          <a:blip xmlns:r="http://schemas.openxmlformats.org/officeDocument/2006/relationships" xmlns:a="http://schemas.openxmlformats.org/drawingml/2006/main" r:embed="R7d60b54b0d0747a6"/>
           <a:stretch xmlns:a="http://schemas.openxmlformats.org/drawingml/2006/main"/>
         </p:blipFill>
         <p:spPr>
@@ -7846,7 +7901,7 @@
           <p:cNvPr id="4" name="">
             <a:extLst xmlns:a="http://schemas.openxmlformats.org/drawingml/2006/main">
               <a:ext uri="{FF2B5EF4-FFF2-40B4-BE49-F238E27FC236}">
-                <a16:creationId xmlns:a16="http://schemas.microsoft.com/office/drawing/2014/main" id="{62337011-70F9-4A83-A098-84C858B104AF}"/>
+                <a16:creationId xmlns:a16="http://schemas.microsoft.com/office/drawing/2014/main" id="{4ADED076-709E-4095-8904-CF0D751BE6F5}"/>
               </a:ext>
             </a:extLst>
           </p:cNvPr>
@@ -7896,7 +7951,7 @@
           <p:cNvPr id="5" name="">
             <a:extLst xmlns:a="http://schemas.openxmlformats.org/drawingml/2006/main">
               <a:ext uri="{FF2B5EF4-FFF2-40B4-BE49-F238E27FC236}">
-                <a16:creationId xmlns:a16="http://schemas.microsoft.com/office/drawing/2014/main" id="{203A934D-CF43-4741-89AF-82B72C328D51}"/>
+                <a16:creationId xmlns:a16="http://schemas.microsoft.com/office/drawing/2014/main" id="{C646962C-FF02-4B20-B553-C1ED9D25CD09}"/>
               </a:ext>
             </a:extLst>
           </p:cNvPr>
@@ -7946,7 +8001,7 @@
           <p:cNvPr id="6" name="">
             <a:extLst xmlns:a="http://schemas.openxmlformats.org/drawingml/2006/main">
               <a:ext uri="{FF2B5EF4-FFF2-40B4-BE49-F238E27FC236}">
-                <a16:creationId xmlns:a16="http://schemas.microsoft.com/office/drawing/2014/main" id="{A379AC97-7B92-4FD1-BDDA-D28DE6C322F1}"/>
+                <a16:creationId xmlns:a16="http://schemas.microsoft.com/office/drawing/2014/main" id="{909897E7-54F6-4416-87F1-064332E448EE}"/>
               </a:ext>
             </a:extLst>
           </p:cNvPr>
@@ -7996,7 +8051,7 @@
           <p:cNvPr id="7" name="">
             <a:extLst xmlns:a="http://schemas.openxmlformats.org/drawingml/2006/main">
               <a:ext uri="{FF2B5EF4-FFF2-40B4-BE49-F238E27FC236}">
-                <a16:creationId xmlns:a16="http://schemas.microsoft.com/office/drawing/2014/main" id="{DA8DACC9-3D78-42CF-BBB2-B3337AEF9F23}"/>
+                <a16:creationId xmlns:a16="http://schemas.microsoft.com/office/drawing/2014/main" id="{47BB8C4A-89D1-4CDA-B399-30109A90E2C2}"/>
               </a:ext>
             </a:extLst>
           </p:cNvPr>
@@ -8046,7 +8101,7 @@
           <p:cNvPr id="8" name="">
             <a:extLst xmlns:a="http://schemas.openxmlformats.org/drawingml/2006/main">
               <a:ext uri="{FF2B5EF4-FFF2-40B4-BE49-F238E27FC236}">
-                <a16:creationId xmlns:a16="http://schemas.microsoft.com/office/drawing/2014/main" id="{9ACFAB0A-D81C-4078-8027-E6DB1E3255A3}"/>
+                <a16:creationId xmlns:a16="http://schemas.microsoft.com/office/drawing/2014/main" id="{774D1A36-1F59-4A90-94E9-98443A1E5A1D}"/>
               </a:ext>
             </a:extLst>
           </p:cNvPr>
@@ -8096,7 +8151,7 @@
           <p:cNvPr id="9" name="">
             <a:extLst xmlns:a="http://schemas.openxmlformats.org/drawingml/2006/main">
               <a:ext uri="{FF2B5EF4-FFF2-40B4-BE49-F238E27FC236}">
-                <a16:creationId xmlns:a16="http://schemas.microsoft.com/office/drawing/2014/main" id="{D43398B7-02AB-420B-8AA7-369313BE8BA5}"/>
+                <a16:creationId xmlns:a16="http://schemas.microsoft.com/office/drawing/2014/main" id="{F2249596-BDD9-4FA5-90DF-D3F0DD443725}"/>
               </a:ext>
             </a:extLst>
           </p:cNvPr>
@@ -8146,7 +8201,7 @@
           <p:cNvPr id="10" name="">
             <a:extLst xmlns:a="http://schemas.openxmlformats.org/drawingml/2006/main">
               <a:ext uri="{FF2B5EF4-FFF2-40B4-BE49-F238E27FC236}">
-                <a16:creationId xmlns:a16="http://schemas.microsoft.com/office/drawing/2014/main" id="{268EEEF1-9E52-4174-A570-532EA29BC559}"/>
+                <a16:creationId xmlns:a16="http://schemas.microsoft.com/office/drawing/2014/main" id="{8625E1F9-F113-42C8-A344-1865570C9E6B}"/>
               </a:ext>
             </a:extLst>
           </p:cNvPr>
@@ -8194,7 +8249,7 @@
     </p:spTree>
     <p:extLst>
       <p:ext uri="{BB962C8B-B14F-4D97-AF65-F5344CB8AC3E}">
-        <p14:creationId xmlns:p14="http://schemas.microsoft.com/office/powerpoint/2010/main" val="1775054189"/>
+        <p14:creationId xmlns:p14="http://schemas.microsoft.com/office/powerpoint/2010/main" val="512601409"/>
       </p:ext>
     </p:extLst>
   </p:cSld>
@@ -8225,7 +8280,7 @@
           <p:cNvPr id="13" name="">
             <a:extLst xmlns:a="http://schemas.openxmlformats.org/drawingml/2006/main">
               <a:ext uri="{FF2B5EF4-FFF2-40B4-BE49-F238E27FC236}">
-                <a16:creationId xmlns:a16="http://schemas.microsoft.com/office/drawing/2014/main" id="{4671A170-8086-4D84-91D4-3F93A38573E5}"/>
+                <a16:creationId xmlns:a16="http://schemas.microsoft.com/office/drawing/2014/main" id="{8192C54A-6898-4329-A70E-FC180B335280}"/>
               </a:ext>
             </a:extLst>
           </p:cNvPr>
@@ -8275,7 +8330,7 @@
           <p:cNvPr id="2" name="">
             <a:extLst xmlns:a="http://schemas.openxmlformats.org/drawingml/2006/main">
               <a:ext uri="{FF2B5EF4-FFF2-40B4-BE49-F238E27FC236}">
-                <a16:creationId xmlns:a16="http://schemas.microsoft.com/office/drawing/2014/main" id="{ACC0E34C-0653-49CD-9088-69E254D0C467}"/>
+                <a16:creationId xmlns:a16="http://schemas.microsoft.com/office/drawing/2014/main" id="{D791AAE8-0A74-4585-9813-9BB9E1D97AEE}"/>
               </a:ext>
             </a:extLst>
           </p:cNvPr>
@@ -8329,7 +8384,7 @@
           <p:nvPr/>
         </p:nvPicPr>
         <p:blipFill>
-          <a:blip xmlns:r="http://schemas.openxmlformats.org/officeDocument/2006/relationships" xmlns:a="http://schemas.openxmlformats.org/drawingml/2006/main" r:embed="R6d4e49561f5243b2"/>
+          <a:blip xmlns:r="http://schemas.openxmlformats.org/officeDocument/2006/relationships" xmlns:a="http://schemas.openxmlformats.org/drawingml/2006/main" r:embed="R67a320ad8d814d10"/>
           <a:stretch xmlns:a="http://schemas.openxmlformats.org/drawingml/2006/main"/>
         </p:blipFill>
         <p:spPr>
@@ -8347,7 +8402,7 @@
           <p:cNvPr id="4" name="">
             <a:extLst xmlns:a="http://schemas.openxmlformats.org/drawingml/2006/main">
               <a:ext uri="{FF2B5EF4-FFF2-40B4-BE49-F238E27FC236}">
-                <a16:creationId xmlns:a16="http://schemas.microsoft.com/office/drawing/2014/main" id="{5026578A-6205-45FD-8088-710F876E010A}"/>
+                <a16:creationId xmlns:a16="http://schemas.microsoft.com/office/drawing/2014/main" id="{CD2250E6-D362-42CA-BCBC-1F6135D12609}"/>
               </a:ext>
             </a:extLst>
           </p:cNvPr>
@@ -8397,7 +8452,7 @@
           <p:cNvPr id="5" name="">
             <a:extLst xmlns:a="http://schemas.openxmlformats.org/drawingml/2006/main">
               <a:ext uri="{FF2B5EF4-FFF2-40B4-BE49-F238E27FC236}">
-                <a16:creationId xmlns:a16="http://schemas.microsoft.com/office/drawing/2014/main" id="{8CFA7176-08C7-457C-99B0-0BC628541755}"/>
+                <a16:creationId xmlns:a16="http://schemas.microsoft.com/office/drawing/2014/main" id="{A706E735-D169-48C8-8E8C-F7609764713C}"/>
               </a:ext>
             </a:extLst>
           </p:cNvPr>
@@ -8447,7 +8502,7 @@
           <p:cNvPr id="6" name="">
             <a:extLst xmlns:a="http://schemas.openxmlformats.org/drawingml/2006/main">
               <a:ext uri="{FF2B5EF4-FFF2-40B4-BE49-F238E27FC236}">
-                <a16:creationId xmlns:a16="http://schemas.microsoft.com/office/drawing/2014/main" id="{5B711EB1-F118-4D44-97E6-B13DAA85E356}"/>
+                <a16:creationId xmlns:a16="http://schemas.microsoft.com/office/drawing/2014/main" id="{6EFA9B0D-FC89-42C6-B365-5C75450D1EE9}"/>
               </a:ext>
             </a:extLst>
           </p:cNvPr>
@@ -8497,7 +8552,7 @@
           <p:cNvPr id="7" name="">
             <a:extLst xmlns:a="http://schemas.openxmlformats.org/drawingml/2006/main">
               <a:ext uri="{FF2B5EF4-FFF2-40B4-BE49-F238E27FC236}">
-                <a16:creationId xmlns:a16="http://schemas.microsoft.com/office/drawing/2014/main" id="{AA77F951-DF73-4EAA-BB56-D7530FF70DB6}"/>
+                <a16:creationId xmlns:a16="http://schemas.microsoft.com/office/drawing/2014/main" id="{F81CC9E7-5855-46BD-867D-EF8737D81938}"/>
               </a:ext>
             </a:extLst>
           </p:cNvPr>
@@ -8547,7 +8602,7 @@
           <p:cNvPr id="8" name="">
             <a:extLst xmlns:a="http://schemas.openxmlformats.org/drawingml/2006/main">
               <a:ext uri="{FF2B5EF4-FFF2-40B4-BE49-F238E27FC236}">
-                <a16:creationId xmlns:a16="http://schemas.microsoft.com/office/drawing/2014/main" id="{E4C78BA4-AA07-491F-AEF3-D686E937DB57}"/>
+                <a16:creationId xmlns:a16="http://schemas.microsoft.com/office/drawing/2014/main" id="{6D695476-62F0-44D7-8C13-CE5F346D2882}"/>
               </a:ext>
             </a:extLst>
           </p:cNvPr>
@@ -8597,7 +8652,7 @@
           <p:cNvPr id="9" name="">
             <a:extLst xmlns:a="http://schemas.openxmlformats.org/drawingml/2006/main">
               <a:ext uri="{FF2B5EF4-FFF2-40B4-BE49-F238E27FC236}">
-                <a16:creationId xmlns:a16="http://schemas.microsoft.com/office/drawing/2014/main" id="{A312E9B3-2F65-4B10-AA52-1B8814544951}"/>
+                <a16:creationId xmlns:a16="http://schemas.microsoft.com/office/drawing/2014/main" id="{9FDF1C9B-C680-4C49-9EFB-C48530A3AE90}"/>
               </a:ext>
             </a:extLst>
           </p:cNvPr>
@@ -8647,7 +8702,7 @@
           <p:cNvPr id="10" name="">
             <a:extLst xmlns:a="http://schemas.openxmlformats.org/drawingml/2006/main">
               <a:ext uri="{FF2B5EF4-FFF2-40B4-BE49-F238E27FC236}">
-                <a16:creationId xmlns:a16="http://schemas.microsoft.com/office/drawing/2014/main" id="{AAB88C3C-53AF-498C-A113-1EBF66F3A819}"/>
+                <a16:creationId xmlns:a16="http://schemas.microsoft.com/office/drawing/2014/main" id="{7EE69568-803B-4B3B-93BA-61848935F87F}"/>
               </a:ext>
             </a:extLst>
           </p:cNvPr>
@@ -8697,7 +8752,7 @@
           <p:cNvPr id="11" name="">
             <a:extLst xmlns:a="http://schemas.openxmlformats.org/drawingml/2006/main">
               <a:ext uri="{FF2B5EF4-FFF2-40B4-BE49-F238E27FC236}">
-                <a16:creationId xmlns:a16="http://schemas.microsoft.com/office/drawing/2014/main" id="{95551343-5FE7-4061-92A0-68ABEDEBA00C}"/>
+                <a16:creationId xmlns:a16="http://schemas.microsoft.com/office/drawing/2014/main" id="{1D51C70C-ED81-4D60-9754-D8FBC4E00040}"/>
               </a:ext>
             </a:extLst>
           </p:cNvPr>
@@ -8747,7 +8802,7 @@
           <p:cNvPr id="12" name="">
             <a:extLst xmlns:a="http://schemas.openxmlformats.org/drawingml/2006/main">
               <a:ext uri="{FF2B5EF4-FFF2-40B4-BE49-F238E27FC236}">
-                <a16:creationId xmlns:a16="http://schemas.microsoft.com/office/drawing/2014/main" id="{D0315A68-5F28-40A5-B14F-58BF2D2C9489}"/>
+                <a16:creationId xmlns:a16="http://schemas.microsoft.com/office/drawing/2014/main" id="{2EDFE697-5744-404A-8834-B8171F56C19F}"/>
               </a:ext>
             </a:extLst>
           </p:cNvPr>
@@ -8795,7 +8850,7 @@
     </p:spTree>
     <p:extLst>
       <p:ext uri="{BB962C8B-B14F-4D97-AF65-F5344CB8AC3E}">
-        <p14:creationId xmlns:p14="http://schemas.microsoft.com/office/powerpoint/2010/main" val="1313210021"/>
+        <p14:creationId xmlns:p14="http://schemas.microsoft.com/office/powerpoint/2010/main" val="1383535827"/>
       </p:ext>
     </p:extLst>
   </p:cSld>
@@ -8826,7 +8881,7 @@
           <p:cNvPr id="9" name="">
             <a:extLst xmlns:a="http://schemas.openxmlformats.org/drawingml/2006/main">
               <a:ext uri="{FF2B5EF4-FFF2-40B4-BE49-F238E27FC236}">
-                <a16:creationId xmlns:a16="http://schemas.microsoft.com/office/drawing/2014/main" id="{638350B1-C921-4273-800F-FE317B8F737C}"/>
+                <a16:creationId xmlns:a16="http://schemas.microsoft.com/office/drawing/2014/main" id="{7797D703-B8FB-4033-9EC2-71E63ACD7D27}"/>
               </a:ext>
             </a:extLst>
           </p:cNvPr>
@@ -8876,7 +8931,7 @@
           <p:cNvPr id="2" name="">
             <a:extLst xmlns:a="http://schemas.openxmlformats.org/drawingml/2006/main">
               <a:ext uri="{FF2B5EF4-FFF2-40B4-BE49-F238E27FC236}">
-                <a16:creationId xmlns:a16="http://schemas.microsoft.com/office/drawing/2014/main" id="{0D47E67F-B8E7-402A-84D6-C1BD43A319F3}"/>
+                <a16:creationId xmlns:a16="http://schemas.microsoft.com/office/drawing/2014/main" id="{85344845-725D-4644-BE59-6C4D3E4D0641}"/>
               </a:ext>
             </a:extLst>
           </p:cNvPr>
@@ -8930,7 +8985,7 @@
           <p:nvPr/>
         </p:nvPicPr>
         <p:blipFill>
-          <a:blip xmlns:r="http://schemas.openxmlformats.org/officeDocument/2006/relationships" xmlns:a="http://schemas.openxmlformats.org/drawingml/2006/main" r:embed="Rdd230e803e5d48ff"/>
+          <a:blip xmlns:r="http://schemas.openxmlformats.org/officeDocument/2006/relationships" xmlns:a="http://schemas.openxmlformats.org/drawingml/2006/main" r:embed="Rf5da76c6325b4799"/>
           <a:stretch xmlns:a="http://schemas.openxmlformats.org/drawingml/2006/main"/>
         </p:blipFill>
         <p:spPr>
@@ -8948,7 +9003,7 @@
           <p:cNvPr id="4" name="">
             <a:extLst xmlns:a="http://schemas.openxmlformats.org/drawingml/2006/main">
               <a:ext uri="{FF2B5EF4-FFF2-40B4-BE49-F238E27FC236}">
-                <a16:creationId xmlns:a16="http://schemas.microsoft.com/office/drawing/2014/main" id="{6642B4B8-E3C2-4BD8-A14D-F83A0864728D}"/>
+                <a16:creationId xmlns:a16="http://schemas.microsoft.com/office/drawing/2014/main" id="{492A8882-634D-4AFC-BEE1-DD00A256903C}"/>
               </a:ext>
             </a:extLst>
           </p:cNvPr>
@@ -8998,7 +9053,7 @@
           <p:cNvPr id="5" name="">
             <a:extLst xmlns:a="http://schemas.openxmlformats.org/drawingml/2006/main">
               <a:ext uri="{FF2B5EF4-FFF2-40B4-BE49-F238E27FC236}">
-                <a16:creationId xmlns:a16="http://schemas.microsoft.com/office/drawing/2014/main" id="{BA86C5EA-D7FA-4704-86A6-E77E853BB62C}"/>
+                <a16:creationId xmlns:a16="http://schemas.microsoft.com/office/drawing/2014/main" id="{FCCE234D-12B7-4E98-A285-74E31BF82ECE}"/>
               </a:ext>
             </a:extLst>
           </p:cNvPr>
@@ -9048,7 +9103,7 @@
           <p:cNvPr id="6" name="">
             <a:extLst xmlns:a="http://schemas.openxmlformats.org/drawingml/2006/main">
               <a:ext uri="{FF2B5EF4-FFF2-40B4-BE49-F238E27FC236}">
-                <a16:creationId xmlns:a16="http://schemas.microsoft.com/office/drawing/2014/main" id="{723B0C4F-DA4B-4B58-ADE8-DB0C5FEF92EE}"/>
+                <a16:creationId xmlns:a16="http://schemas.microsoft.com/office/drawing/2014/main" id="{0C867DED-AAFB-4941-9541-48A203367148}"/>
               </a:ext>
             </a:extLst>
           </p:cNvPr>
@@ -9098,7 +9153,7 @@
           <p:cNvPr id="7" name="">
             <a:extLst xmlns:a="http://schemas.openxmlformats.org/drawingml/2006/main">
               <a:ext uri="{FF2B5EF4-FFF2-40B4-BE49-F238E27FC236}">
-                <a16:creationId xmlns:a16="http://schemas.microsoft.com/office/drawing/2014/main" id="{A794DE88-BC86-41C8-87C6-EE32E60BD0B6}"/>
+                <a16:creationId xmlns:a16="http://schemas.microsoft.com/office/drawing/2014/main" id="{248DBFF0-43F9-4A41-AD0E-5548FE748641}"/>
               </a:ext>
             </a:extLst>
           </p:cNvPr>
@@ -9148,7 +9203,7 @@
           <p:cNvPr id="8" name="">
             <a:extLst xmlns:a="http://schemas.openxmlformats.org/drawingml/2006/main">
               <a:ext uri="{FF2B5EF4-FFF2-40B4-BE49-F238E27FC236}">
-                <a16:creationId xmlns:a16="http://schemas.microsoft.com/office/drawing/2014/main" id="{C513AFAF-5FD3-45DD-9AA5-FA799B02F730}"/>
+                <a16:creationId xmlns:a16="http://schemas.microsoft.com/office/drawing/2014/main" id="{B8D2C932-C29E-4DC8-955C-2C6DFB6B55CC}"/>
               </a:ext>
             </a:extLst>
           </p:cNvPr>
@@ -9196,7 +9251,7 @@
     </p:spTree>
     <p:extLst>
       <p:ext uri="{BB962C8B-B14F-4D97-AF65-F5344CB8AC3E}">
-        <p14:creationId xmlns:p14="http://schemas.microsoft.com/office/powerpoint/2010/main" val="538688526"/>
+        <p14:creationId xmlns:p14="http://schemas.microsoft.com/office/powerpoint/2010/main" val="1890699639"/>
       </p:ext>
     </p:extLst>
   </p:cSld>
@@ -9227,7 +9282,7 @@
           <p:cNvPr id="7" name="">
             <a:extLst xmlns:a="http://schemas.openxmlformats.org/drawingml/2006/main">
               <a:ext uri="{FF2B5EF4-FFF2-40B4-BE49-F238E27FC236}">
-                <a16:creationId xmlns:a16="http://schemas.microsoft.com/office/drawing/2014/main" id="{3EB62C9B-136D-455C-A49E-0FBAB85BC759}"/>
+                <a16:creationId xmlns:a16="http://schemas.microsoft.com/office/drawing/2014/main" id="{2DC40D5E-8534-4652-8003-699C26D67F89}"/>
               </a:ext>
             </a:extLst>
           </p:cNvPr>
@@ -9277,7 +9332,7 @@
           <p:cNvPr id="2" name="">
             <a:extLst xmlns:a="http://schemas.openxmlformats.org/drawingml/2006/main">
               <a:ext uri="{FF2B5EF4-FFF2-40B4-BE49-F238E27FC236}">
-                <a16:creationId xmlns:a16="http://schemas.microsoft.com/office/drawing/2014/main" id="{C342B356-7711-4D18-A52C-FA85DE8C070B}"/>
+                <a16:creationId xmlns:a16="http://schemas.microsoft.com/office/drawing/2014/main" id="{207C936F-7DAD-4600-8BDA-6561AF89598E}"/>
               </a:ext>
             </a:extLst>
           </p:cNvPr>
@@ -9331,7 +9386,7 @@
           <p:nvPr/>
         </p:nvPicPr>
         <p:blipFill>
-          <a:blip xmlns:r="http://schemas.openxmlformats.org/officeDocument/2006/relationships" xmlns:a="http://schemas.openxmlformats.org/drawingml/2006/main" r:embed="Rbb2cf4b31cc24e52"/>
+          <a:blip xmlns:r="http://schemas.openxmlformats.org/officeDocument/2006/relationships" xmlns:a="http://schemas.openxmlformats.org/drawingml/2006/main" r:embed="Rd0b858a0a6e24cbf"/>
           <a:stretch xmlns:a="http://schemas.openxmlformats.org/drawingml/2006/main"/>
         </p:blipFill>
         <p:spPr>
@@ -9349,7 +9404,7 @@
           <p:cNvPr id="4" name="">
             <a:extLst xmlns:a="http://schemas.openxmlformats.org/drawingml/2006/main">
               <a:ext uri="{FF2B5EF4-FFF2-40B4-BE49-F238E27FC236}">
-                <a16:creationId xmlns:a16="http://schemas.microsoft.com/office/drawing/2014/main" id="{9D23379E-A04A-43FB-9077-CA8E00D442A7}"/>
+                <a16:creationId xmlns:a16="http://schemas.microsoft.com/office/drawing/2014/main" id="{FA586958-AC4D-471D-8DAD-470CB9B1BE70}"/>
               </a:ext>
             </a:extLst>
           </p:cNvPr>
@@ -9399,7 +9454,7 @@
           <p:cNvPr id="5" name="">
             <a:extLst xmlns:a="http://schemas.openxmlformats.org/drawingml/2006/main">
               <a:ext uri="{FF2B5EF4-FFF2-40B4-BE49-F238E27FC236}">
-                <a16:creationId xmlns:a16="http://schemas.microsoft.com/office/drawing/2014/main" id="{8AF46321-33DF-4A20-A14F-C4E300BF72CB}"/>
+                <a16:creationId xmlns:a16="http://schemas.microsoft.com/office/drawing/2014/main" id="{4E7D5F67-6A27-49E7-BB73-F04E173E7FBB}"/>
               </a:ext>
             </a:extLst>
           </p:cNvPr>
@@ -9449,7 +9504,7 @@
           <p:cNvPr id="6" name="">
             <a:extLst xmlns:a="http://schemas.openxmlformats.org/drawingml/2006/main">
               <a:ext uri="{FF2B5EF4-FFF2-40B4-BE49-F238E27FC236}">
-                <a16:creationId xmlns:a16="http://schemas.microsoft.com/office/drawing/2014/main" id="{B4A8BDEF-C57D-45CC-9279-0B3E18A652D8}"/>
+                <a16:creationId xmlns:a16="http://schemas.microsoft.com/office/drawing/2014/main" id="{C7E6B456-54D0-418B-8B77-5DFC5DD61B83}"/>
               </a:ext>
             </a:extLst>
           </p:cNvPr>
@@ -9497,7 +9552,7 @@
     </p:spTree>
     <p:extLst>
       <p:ext uri="{BB962C8B-B14F-4D97-AF65-F5344CB8AC3E}">
-        <p14:creationId xmlns:p14="http://schemas.microsoft.com/office/powerpoint/2010/main" val="2080746787"/>
+        <p14:creationId xmlns:p14="http://schemas.microsoft.com/office/powerpoint/2010/main" val="977719600"/>
       </p:ext>
     </p:extLst>
   </p:cSld>

</xml_diff>

<commit_message>
Strengthen hardware impact slide rationale
</commit_message>
<xml_diff>
--- a/sglang_direct_kv/artifacts/slides/agent_aware_kv_movement_manager_deck.pptx
+++ b/sglang_direct_kv/artifacts/slides/agent_aware_kv_movement_manager_deck.pptx
@@ -2,24 +2,24 @@
 <file path=ppt/presentation.xml><?xml version="1.0" encoding="utf-8"?>
 <p:presentation xmlns:p="http://schemas.openxmlformats.org/presentationml/2006/main">
   <p:sldMasterIdLst>
-    <p:sldMasterId xmlns:r="http://schemas.openxmlformats.org/officeDocument/2006/relationships" id="2147483648" r:id="R660986d3031a4505"/>
+    <p:sldMasterId xmlns:r="http://schemas.openxmlformats.org/officeDocument/2006/relationships" id="2147483648" r:id="R40d3942bad664423"/>
   </p:sldMasterIdLst>
   <p:notesMasterIdLst>
-    <p:notesMasterId xmlns:r="http://schemas.openxmlformats.org/officeDocument/2006/relationships" r:id="Ra51744c5f07b4732"/>
+    <p:notesMasterId xmlns:r="http://schemas.openxmlformats.org/officeDocument/2006/relationships" r:id="R4d113a97877a4b1a"/>
   </p:notesMasterIdLst>
   <p:sldIdLst>
-    <p:sldId xmlns:r="http://schemas.openxmlformats.org/officeDocument/2006/relationships" id="256" r:id="R443a9f967aac40bd"/>
-    <p:sldId xmlns:r="http://schemas.openxmlformats.org/officeDocument/2006/relationships" id="257" r:id="R1dc4f6dd977f4c1b"/>
-    <p:sldId xmlns:r="http://schemas.openxmlformats.org/officeDocument/2006/relationships" id="258" r:id="R33f3c6b7c3f74d09"/>
-    <p:sldId xmlns:r="http://schemas.openxmlformats.org/officeDocument/2006/relationships" id="259" r:id="Rf99a4d9ced3f40f2"/>
-    <p:sldId xmlns:r="http://schemas.openxmlformats.org/officeDocument/2006/relationships" id="260" r:id="R2f260ac653d1447f"/>
-    <p:sldId xmlns:r="http://schemas.openxmlformats.org/officeDocument/2006/relationships" id="261" r:id="Rc22b3acfbc024586"/>
-    <p:sldId xmlns:r="http://schemas.openxmlformats.org/officeDocument/2006/relationships" id="262" r:id="R2bdd170283fa4b86"/>
-    <p:sldId xmlns:r="http://schemas.openxmlformats.org/officeDocument/2006/relationships" id="263" r:id="R4b1662d392464e78"/>
-    <p:sldId xmlns:r="http://schemas.openxmlformats.org/officeDocument/2006/relationships" id="264" r:id="Raca4ed3f82e94266"/>
-    <p:sldId xmlns:r="http://schemas.openxmlformats.org/officeDocument/2006/relationships" id="265" r:id="R400cf00b9c95400f"/>
-    <p:sldId xmlns:r="http://schemas.openxmlformats.org/officeDocument/2006/relationships" id="266" r:id="Ra1b74e46bcd54c28"/>
-    <p:sldId xmlns:r="http://schemas.openxmlformats.org/officeDocument/2006/relationships" id="267" r:id="Rc89e3ac1aa7c45a0"/>
+    <p:sldId xmlns:r="http://schemas.openxmlformats.org/officeDocument/2006/relationships" id="256" r:id="R5dcec6d074154950"/>
+    <p:sldId xmlns:r="http://schemas.openxmlformats.org/officeDocument/2006/relationships" id="257" r:id="R06ca5600d27144bf"/>
+    <p:sldId xmlns:r="http://schemas.openxmlformats.org/officeDocument/2006/relationships" id="258" r:id="R1365626a08f14d75"/>
+    <p:sldId xmlns:r="http://schemas.openxmlformats.org/officeDocument/2006/relationships" id="259" r:id="Rbc12651a76144b9e"/>
+    <p:sldId xmlns:r="http://schemas.openxmlformats.org/officeDocument/2006/relationships" id="260" r:id="R92ef069b993c46fe"/>
+    <p:sldId xmlns:r="http://schemas.openxmlformats.org/officeDocument/2006/relationships" id="261" r:id="Re24b14165cef44e6"/>
+    <p:sldId xmlns:r="http://schemas.openxmlformats.org/officeDocument/2006/relationships" id="262" r:id="R75712280d49944ed"/>
+    <p:sldId xmlns:r="http://schemas.openxmlformats.org/officeDocument/2006/relationships" id="263" r:id="R4e08a2964863474b"/>
+    <p:sldId xmlns:r="http://schemas.openxmlformats.org/officeDocument/2006/relationships" id="264" r:id="R428e6f7cdb654358"/>
+    <p:sldId xmlns:r="http://schemas.openxmlformats.org/officeDocument/2006/relationships" id="265" r:id="Rd8aa53cf8f614e1f"/>
+    <p:sldId xmlns:r="http://schemas.openxmlformats.org/officeDocument/2006/relationships" id="266" r:id="R3443f83985f44ee5"/>
+    <p:sldId xmlns:r="http://schemas.openxmlformats.org/officeDocument/2006/relationships" id="267" r:id="R0143f6f7023d4dd2"/>
   </p:sldIdLst>
   <p:sldSz cx="12192000" cy="6858000"/>
   <p:notesSz cx="6858000" cy="9144000"/>
@@ -658,7 +658,17 @@
           </a:p>
           <a:p xmlns:a="http://schemas.openxmlformats.org/drawingml/2006/main">
             <a:r>
-              <a:t>The user previously asked for impact statements like 20% lower latency. Keep claims conservative until clean manager-grade measurements are available.</a:t>
+              <a:t>The table ties each benefit estimate to an observed mechanism: late replay H2D, recompute after KV loss, late hint completion, and wasted prefetch.</a:t>
+            </a:r>
+          </a:p>
+          <a:p xmlns:a="http://schemas.openxmlformats.org/drawingml/2006/main">
+            <a:r>
+              <a:t>Low-end gains are plausible when KV is already mostly resident and only small stalls remain.</a:t>
+            </a:r>
+          </a:p>
+          <a:p xmlns:a="http://schemas.openxmlformats.org/drawingml/2006/main">
+            <a:r>
+              <a:t>High-end gains are plausible when contexts are long, cache pressure is high, and replay falls back to H2D reload or recompute.</a:t>
             </a:r>
           </a:p>
           <a:p xmlns:a="http://schemas.openxmlformats.org/drawingml/2006/main">
@@ -1661,7 +1671,7 @@
   </p:cSld>
   <p:clrMap bg1="lt1" tx1="dk1" bg2="lt2" tx2="dk2" accent1="accent1" accent2="accent2" accent3="accent3" accent4="accent4" accent5="accent5" accent6="accent6" hlink="hlink" folHlink="folHlink"/>
   <p:sldLayoutIdLst>
-    <p:sldLayoutId xmlns:r="http://schemas.openxmlformats.org/officeDocument/2006/relationships" id="2147483649" r:id="Ree7888e845a14412"/>
+    <p:sldLayoutId xmlns:r="http://schemas.openxmlformats.org/officeDocument/2006/relationships" id="2147483649" r:id="R58678bbb0051414a"/>
   </p:sldLayoutIdLst>
   <p:txStyles>
     <p:titleStyle>
@@ -2212,7 +2222,7 @@
           <p:cNvPr id="12" name="">
             <a:extLst xmlns:a="http://schemas.openxmlformats.org/drawingml/2006/main">
               <a:ext uri="{FF2B5EF4-FFF2-40B4-BE49-F238E27FC236}">
-                <a16:creationId xmlns:a16="http://schemas.microsoft.com/office/drawing/2014/main" id="{9C2DE161-E611-4262-B733-5CD158F3DBBA}"/>
+                <a16:creationId xmlns:a16="http://schemas.microsoft.com/office/drawing/2014/main" id="{2BE8AC51-12DF-490F-B70B-0D599428BA7E}"/>
               </a:ext>
             </a:extLst>
           </p:cNvPr>
@@ -2262,7 +2272,7 @@
           <p:cNvPr id="2" name="">
             <a:extLst xmlns:a="http://schemas.openxmlformats.org/drawingml/2006/main">
               <a:ext uri="{FF2B5EF4-FFF2-40B4-BE49-F238E27FC236}">
-                <a16:creationId xmlns:a16="http://schemas.microsoft.com/office/drawing/2014/main" id="{45C3661D-E131-402E-AAAA-2FCE11314ED8}"/>
+                <a16:creationId xmlns:a16="http://schemas.microsoft.com/office/drawing/2014/main" id="{4A36DC6C-D510-428A-9767-5E5944A41475}"/>
               </a:ext>
             </a:extLst>
           </p:cNvPr>
@@ -2312,7 +2322,7 @@
           <p:cNvPr id="3" name="">
             <a:extLst xmlns:a="http://schemas.openxmlformats.org/drawingml/2006/main">
               <a:ext uri="{FF2B5EF4-FFF2-40B4-BE49-F238E27FC236}">
-                <a16:creationId xmlns:a16="http://schemas.microsoft.com/office/drawing/2014/main" id="{FA2DD041-0C3E-4D53-A976-60EEEA027435}"/>
+                <a16:creationId xmlns:a16="http://schemas.microsoft.com/office/drawing/2014/main" id="{0D4EE2CF-12A0-4A99-907E-273C1D33B94F}"/>
               </a:ext>
             </a:extLst>
           </p:cNvPr>
@@ -2343,7 +2353,7 @@
           <p:cNvPr id="4" name="">
             <a:extLst xmlns:a="http://schemas.openxmlformats.org/drawingml/2006/main">
               <a:ext uri="{FF2B5EF4-FFF2-40B4-BE49-F238E27FC236}">
-                <a16:creationId xmlns:a16="http://schemas.microsoft.com/office/drawing/2014/main" id="{0B21E43B-A4BB-4400-A440-10315E075255}"/>
+                <a16:creationId xmlns:a16="http://schemas.microsoft.com/office/drawing/2014/main" id="{AFDF0CBA-F550-4283-9D1D-99B526B7529F}"/>
               </a:ext>
             </a:extLst>
           </p:cNvPr>
@@ -2393,7 +2403,7 @@
           <p:cNvPr id="5" name="">
             <a:extLst xmlns:a="http://schemas.openxmlformats.org/drawingml/2006/main">
               <a:ext uri="{FF2B5EF4-FFF2-40B4-BE49-F238E27FC236}">
-                <a16:creationId xmlns:a16="http://schemas.microsoft.com/office/drawing/2014/main" id="{5AD7DF86-6114-4CEE-8AC2-AA1DFF95FFAF}"/>
+                <a16:creationId xmlns:a16="http://schemas.microsoft.com/office/drawing/2014/main" id="{6F98A2D3-3AB4-442D-B4DE-EFAFE4A4A861}"/>
               </a:ext>
             </a:extLst>
           </p:cNvPr>
@@ -2443,7 +2453,7 @@
           <p:cNvPr id="6" name="">
             <a:extLst xmlns:a="http://schemas.openxmlformats.org/drawingml/2006/main">
               <a:ext uri="{FF2B5EF4-FFF2-40B4-BE49-F238E27FC236}">
-                <a16:creationId xmlns:a16="http://schemas.microsoft.com/office/drawing/2014/main" id="{C31B95AA-5D08-4016-8AA5-D0F32AA91D21}"/>
+                <a16:creationId xmlns:a16="http://schemas.microsoft.com/office/drawing/2014/main" id="{F9E8F69B-E58E-4A44-8786-F99964D252E9}"/>
               </a:ext>
             </a:extLst>
           </p:cNvPr>
@@ -2493,7 +2503,7 @@
           <p:cNvPr id="7" name="">
             <a:extLst xmlns:a="http://schemas.openxmlformats.org/drawingml/2006/main">
               <a:ext uri="{FF2B5EF4-FFF2-40B4-BE49-F238E27FC236}">
-                <a16:creationId xmlns:a16="http://schemas.microsoft.com/office/drawing/2014/main" id="{AA973700-6C77-475C-8C91-56EAF055F9ED}"/>
+                <a16:creationId xmlns:a16="http://schemas.microsoft.com/office/drawing/2014/main" id="{1979369D-7927-4796-9A72-5E0E95732E4B}"/>
               </a:ext>
             </a:extLst>
           </p:cNvPr>
@@ -2543,7 +2553,7 @@
           <p:cNvPr id="8" name="">
             <a:extLst xmlns:a="http://schemas.openxmlformats.org/drawingml/2006/main">
               <a:ext uri="{FF2B5EF4-FFF2-40B4-BE49-F238E27FC236}">
-                <a16:creationId xmlns:a16="http://schemas.microsoft.com/office/drawing/2014/main" id="{06599A79-558A-47B7-B45B-F500320C8955}"/>
+                <a16:creationId xmlns:a16="http://schemas.microsoft.com/office/drawing/2014/main" id="{86BD44E5-C814-4771-847F-EC61D2E96C03}"/>
               </a:ext>
             </a:extLst>
           </p:cNvPr>
@@ -2593,7 +2603,7 @@
           <p:cNvPr id="9" name="">
             <a:extLst xmlns:a="http://schemas.openxmlformats.org/drawingml/2006/main">
               <a:ext uri="{FF2B5EF4-FFF2-40B4-BE49-F238E27FC236}">
-                <a16:creationId xmlns:a16="http://schemas.microsoft.com/office/drawing/2014/main" id="{F699F22B-59F9-4ECA-A615-8AD5A3D08770}"/>
+                <a16:creationId xmlns:a16="http://schemas.microsoft.com/office/drawing/2014/main" id="{84569A75-B9E3-41A0-B4B9-B0A3783D816E}"/>
               </a:ext>
             </a:extLst>
           </p:cNvPr>
@@ -2643,7 +2653,7 @@
           <p:cNvPr id="10" name="">
             <a:extLst xmlns:a="http://schemas.openxmlformats.org/drawingml/2006/main">
               <a:ext uri="{FF2B5EF4-FFF2-40B4-BE49-F238E27FC236}">
-                <a16:creationId xmlns:a16="http://schemas.microsoft.com/office/drawing/2014/main" id="{E9993F09-C781-4902-B1F0-4A50EFE91EBA}"/>
+                <a16:creationId xmlns:a16="http://schemas.microsoft.com/office/drawing/2014/main" id="{846158E8-77EE-4599-87D5-186387181BAD}"/>
               </a:ext>
             </a:extLst>
           </p:cNvPr>
@@ -2693,7 +2703,7 @@
           <p:cNvPr id="11" name="">
             <a:extLst xmlns:a="http://schemas.openxmlformats.org/drawingml/2006/main">
               <a:ext uri="{FF2B5EF4-FFF2-40B4-BE49-F238E27FC236}">
-                <a16:creationId xmlns:a16="http://schemas.microsoft.com/office/drawing/2014/main" id="{F818A59E-BDB3-40AF-A166-0184570D9656}"/>
+                <a16:creationId xmlns:a16="http://schemas.microsoft.com/office/drawing/2014/main" id="{1662F6F2-F813-493F-BB83-1B8958ED0252}"/>
               </a:ext>
             </a:extLst>
           </p:cNvPr>
@@ -2741,7 +2751,7 @@
     </p:spTree>
     <p:extLst>
       <p:ext uri="{BB962C8B-B14F-4D97-AF65-F5344CB8AC3E}">
-        <p14:creationId xmlns:p14="http://schemas.microsoft.com/office/powerpoint/2010/main" val="519333489"/>
+        <p14:creationId xmlns:p14="http://schemas.microsoft.com/office/powerpoint/2010/main" val="779423332"/>
       </p:ext>
     </p:extLst>
   </p:cSld>
@@ -2772,7 +2782,7 @@
           <p:cNvPr id="17" name="">
             <a:extLst xmlns:a="http://schemas.openxmlformats.org/drawingml/2006/main">
               <a:ext uri="{FF2B5EF4-FFF2-40B4-BE49-F238E27FC236}">
-                <a16:creationId xmlns:a16="http://schemas.microsoft.com/office/drawing/2014/main" id="{399E9D64-0F62-496F-9093-33F4E55317B8}"/>
+                <a16:creationId xmlns:a16="http://schemas.microsoft.com/office/drawing/2014/main" id="{0909186F-299F-4F0A-A072-48757DBCAE02}"/>
               </a:ext>
             </a:extLst>
           </p:cNvPr>
@@ -2822,7 +2832,7 @@
           <p:cNvPr id="2" name="">
             <a:extLst xmlns:a="http://schemas.openxmlformats.org/drawingml/2006/main">
               <a:ext uri="{FF2B5EF4-FFF2-40B4-BE49-F238E27FC236}">
-                <a16:creationId xmlns:a16="http://schemas.microsoft.com/office/drawing/2014/main" id="{F147E563-6D64-459C-B06F-490ADD969CE9}"/>
+                <a16:creationId xmlns:a16="http://schemas.microsoft.com/office/drawing/2014/main" id="{4A88393E-98CD-458C-B2C0-2798CF88B3E7}"/>
               </a:ext>
             </a:extLst>
           </p:cNvPr>
@@ -2872,7 +2882,7 @@
           <p:cNvPr id="3" name="">
             <a:extLst xmlns:a="http://schemas.openxmlformats.org/drawingml/2006/main">
               <a:ext uri="{FF2B5EF4-FFF2-40B4-BE49-F238E27FC236}">
-                <a16:creationId xmlns:a16="http://schemas.microsoft.com/office/drawing/2014/main" id="{B5698D55-8C1D-435B-8317-8D88145A6970}"/>
+                <a16:creationId xmlns:a16="http://schemas.microsoft.com/office/drawing/2014/main" id="{EF11D1F2-7F96-4791-BDE8-9640A48C7A8B}"/>
               </a:ext>
             </a:extLst>
           </p:cNvPr>
@@ -2922,7 +2932,7 @@
           <p:cNvPr id="4" name="">
             <a:extLst xmlns:a="http://schemas.openxmlformats.org/drawingml/2006/main">
               <a:ext uri="{FF2B5EF4-FFF2-40B4-BE49-F238E27FC236}">
-                <a16:creationId xmlns:a16="http://schemas.microsoft.com/office/drawing/2014/main" id="{549D50B5-D731-49E2-A29A-FD104178E50C}"/>
+                <a16:creationId xmlns:a16="http://schemas.microsoft.com/office/drawing/2014/main" id="{587D8C23-1119-41C4-8145-1C0AE95A5B78}"/>
               </a:ext>
             </a:extLst>
           </p:cNvPr>
@@ -2972,7 +2982,7 @@
           <p:cNvPr id="5" name="">
             <a:extLst xmlns:a="http://schemas.openxmlformats.org/drawingml/2006/main">
               <a:ext uri="{FF2B5EF4-FFF2-40B4-BE49-F238E27FC236}">
-                <a16:creationId xmlns:a16="http://schemas.microsoft.com/office/drawing/2014/main" id="{C85E57E6-3A09-440B-94B8-2F189545D09E}"/>
+                <a16:creationId xmlns:a16="http://schemas.microsoft.com/office/drawing/2014/main" id="{1C9EB440-8330-4926-9E2E-C476D03A967E}"/>
               </a:ext>
             </a:extLst>
           </p:cNvPr>
@@ -3022,7 +3032,7 @@
           <p:cNvPr id="6" name="">
             <a:extLst xmlns:a="http://schemas.openxmlformats.org/drawingml/2006/main">
               <a:ext uri="{FF2B5EF4-FFF2-40B4-BE49-F238E27FC236}">
-                <a16:creationId xmlns:a16="http://schemas.microsoft.com/office/drawing/2014/main" id="{81FB160B-3FAC-4EF7-88AF-E78084A66B8C}"/>
+                <a16:creationId xmlns:a16="http://schemas.microsoft.com/office/drawing/2014/main" id="{5D4AC944-59FC-4FAF-98A8-5C0D93B32F81}"/>
               </a:ext>
             </a:extLst>
           </p:cNvPr>
@@ -3072,7 +3082,7 @@
           <p:cNvPr id="7" name="">
             <a:extLst xmlns:a="http://schemas.openxmlformats.org/drawingml/2006/main">
               <a:ext uri="{FF2B5EF4-FFF2-40B4-BE49-F238E27FC236}">
-                <a16:creationId xmlns:a16="http://schemas.microsoft.com/office/drawing/2014/main" id="{88DD0CB8-CF0A-4FB1-86EF-861DFA275B91}"/>
+                <a16:creationId xmlns:a16="http://schemas.microsoft.com/office/drawing/2014/main" id="{8D98494F-EFE6-4668-B8A8-AA63DE8FD7CD}"/>
               </a:ext>
             </a:extLst>
           </p:cNvPr>
@@ -3122,7 +3132,7 @@
           <p:cNvPr id="8" name="">
             <a:extLst xmlns:a="http://schemas.openxmlformats.org/drawingml/2006/main">
               <a:ext uri="{FF2B5EF4-FFF2-40B4-BE49-F238E27FC236}">
-                <a16:creationId xmlns:a16="http://schemas.microsoft.com/office/drawing/2014/main" id="{27089430-C1B8-414B-BAE7-7DA1AFE1A0A8}"/>
+                <a16:creationId xmlns:a16="http://schemas.microsoft.com/office/drawing/2014/main" id="{62A54583-B8AC-4007-AFFA-D144C98A5DC7}"/>
               </a:ext>
             </a:extLst>
           </p:cNvPr>
@@ -3172,7 +3182,7 @@
           <p:cNvPr id="9" name="">
             <a:extLst xmlns:a="http://schemas.openxmlformats.org/drawingml/2006/main">
               <a:ext uri="{FF2B5EF4-FFF2-40B4-BE49-F238E27FC236}">
-                <a16:creationId xmlns:a16="http://schemas.microsoft.com/office/drawing/2014/main" id="{8139AACC-046A-40E1-9C50-C8CAF7D74DC0}"/>
+                <a16:creationId xmlns:a16="http://schemas.microsoft.com/office/drawing/2014/main" id="{6418B938-7E7C-4B95-A8CD-1580DC5167CC}"/>
               </a:ext>
             </a:extLst>
           </p:cNvPr>
@@ -3222,7 +3232,7 @@
           <p:cNvPr id="10" name="">
             <a:extLst xmlns:a="http://schemas.openxmlformats.org/drawingml/2006/main">
               <a:ext uri="{FF2B5EF4-FFF2-40B4-BE49-F238E27FC236}">
-                <a16:creationId xmlns:a16="http://schemas.microsoft.com/office/drawing/2014/main" id="{F477F21D-6823-4103-B4BA-69EA42C30168}"/>
+                <a16:creationId xmlns:a16="http://schemas.microsoft.com/office/drawing/2014/main" id="{64CE8A19-588D-485C-8D1D-974BB44CF09B}"/>
               </a:ext>
             </a:extLst>
           </p:cNvPr>
@@ -3272,7 +3282,7 @@
           <p:cNvPr id="11" name="">
             <a:extLst xmlns:a="http://schemas.openxmlformats.org/drawingml/2006/main">
               <a:ext uri="{FF2B5EF4-FFF2-40B4-BE49-F238E27FC236}">
-                <a16:creationId xmlns:a16="http://schemas.microsoft.com/office/drawing/2014/main" id="{D810BB76-BC0A-47D9-8F83-25823BCCDD54}"/>
+                <a16:creationId xmlns:a16="http://schemas.microsoft.com/office/drawing/2014/main" id="{16F47999-2E50-4376-8CB3-782293C942C3}"/>
               </a:ext>
             </a:extLst>
           </p:cNvPr>
@@ -3322,7 +3332,7 @@
           <p:cNvPr id="12" name="">
             <a:extLst xmlns:a="http://schemas.openxmlformats.org/drawingml/2006/main">
               <a:ext uri="{FF2B5EF4-FFF2-40B4-BE49-F238E27FC236}">
-                <a16:creationId xmlns:a16="http://schemas.microsoft.com/office/drawing/2014/main" id="{7B30856C-F232-43F4-B994-851BEFB7A1B9}"/>
+                <a16:creationId xmlns:a16="http://schemas.microsoft.com/office/drawing/2014/main" id="{35D53424-E5EF-495F-A691-A7D970DC5AF9}"/>
               </a:ext>
             </a:extLst>
           </p:cNvPr>
@@ -3372,7 +3382,7 @@
           <p:cNvPr id="13" name="">
             <a:extLst xmlns:a="http://schemas.openxmlformats.org/drawingml/2006/main">
               <a:ext uri="{FF2B5EF4-FFF2-40B4-BE49-F238E27FC236}">
-                <a16:creationId xmlns:a16="http://schemas.microsoft.com/office/drawing/2014/main" id="{7CCC884A-F5FB-43F4-963B-CE9C74CEFB20}"/>
+                <a16:creationId xmlns:a16="http://schemas.microsoft.com/office/drawing/2014/main" id="{E40A1E29-39A0-4831-8297-2F8A6782D6FA}"/>
               </a:ext>
             </a:extLst>
           </p:cNvPr>
@@ -3403,7 +3413,7 @@
           <p:cNvPr id="14" name="">
             <a:extLst xmlns:a="http://schemas.openxmlformats.org/drawingml/2006/main">
               <a:ext uri="{FF2B5EF4-FFF2-40B4-BE49-F238E27FC236}">
-                <a16:creationId xmlns:a16="http://schemas.microsoft.com/office/drawing/2014/main" id="{BF8A7BBB-C244-4A92-A266-6D02BD69E2A0}"/>
+                <a16:creationId xmlns:a16="http://schemas.microsoft.com/office/drawing/2014/main" id="{5BB5ED05-9F3B-4725-8A99-CF91D7E31A2C}"/>
               </a:ext>
             </a:extLst>
           </p:cNvPr>
@@ -3453,7 +3463,7 @@
           <p:cNvPr id="15" name="">
             <a:extLst xmlns:a="http://schemas.openxmlformats.org/drawingml/2006/main">
               <a:ext uri="{FF2B5EF4-FFF2-40B4-BE49-F238E27FC236}">
-                <a16:creationId xmlns:a16="http://schemas.microsoft.com/office/drawing/2014/main" id="{F77AB9F1-0129-451E-96CC-0D352A5CC40E}"/>
+                <a16:creationId xmlns:a16="http://schemas.microsoft.com/office/drawing/2014/main" id="{7E5EDB16-C868-4D2D-AC11-42D4459C0F43}"/>
               </a:ext>
             </a:extLst>
           </p:cNvPr>
@@ -3503,7 +3513,7 @@
           <p:cNvPr id="16" name="">
             <a:extLst xmlns:a="http://schemas.openxmlformats.org/drawingml/2006/main">
               <a:ext uri="{FF2B5EF4-FFF2-40B4-BE49-F238E27FC236}">
-                <a16:creationId xmlns:a16="http://schemas.microsoft.com/office/drawing/2014/main" id="{2026B7DC-C6FB-4BC1-913B-98D6583289C7}"/>
+                <a16:creationId xmlns:a16="http://schemas.microsoft.com/office/drawing/2014/main" id="{C363CAAA-A22F-452D-9262-ED1DE289DDA3}"/>
               </a:ext>
             </a:extLst>
           </p:cNvPr>
@@ -3551,7 +3561,7 @@
     </p:spTree>
     <p:extLst>
       <p:ext uri="{BB962C8B-B14F-4D97-AF65-F5344CB8AC3E}">
-        <p14:creationId xmlns:p14="http://schemas.microsoft.com/office/powerpoint/2010/main" val="1716994904"/>
+        <p14:creationId xmlns:p14="http://schemas.microsoft.com/office/powerpoint/2010/main" val="406075102"/>
       </p:ext>
     </p:extLst>
   </p:cSld>
@@ -3579,10 +3589,10 @@
       </p:grpSpPr>
       <p:sp>
         <p:nvSpPr>
-          <p:cNvPr id="17" name="">
-            <a:extLst xmlns:a="http://schemas.openxmlformats.org/drawingml/2006/main">
-              <a:ext uri="{FF2B5EF4-FFF2-40B4-BE49-F238E27FC236}">
-                <a16:creationId xmlns:a16="http://schemas.microsoft.com/office/drawing/2014/main" id="{0915752A-C7B1-4DFA-92A7-DEFCC40F3E48}"/>
+          <p:cNvPr id="44" name="">
+            <a:extLst xmlns:a="http://schemas.openxmlformats.org/drawingml/2006/main">
+              <a:ext uri="{FF2B5EF4-FFF2-40B4-BE49-F238E27FC236}">
+                <a16:creationId xmlns:a16="http://schemas.microsoft.com/office/drawing/2014/main" id="{C9BEB51E-4CE4-4925-A706-CA51504F6AF4}"/>
               </a:ext>
             </a:extLst>
           </p:cNvPr>
@@ -3632,7 +3642,7 @@
           <p:cNvPr id="2" name="">
             <a:extLst xmlns:a="http://schemas.openxmlformats.org/drawingml/2006/main">
               <a:ext uri="{FF2B5EF4-FFF2-40B4-BE49-F238E27FC236}">
-                <a16:creationId xmlns:a16="http://schemas.microsoft.com/office/drawing/2014/main" id="{998AD203-C032-4D04-82DF-A11A4629DD0E}"/>
+                <a16:creationId xmlns:a16="http://schemas.microsoft.com/office/drawing/2014/main" id="{B1A445DC-2DBE-41D6-A284-D4D5B4322341}"/>
               </a:ext>
             </a:extLst>
           </p:cNvPr>
@@ -3672,7 +3682,7 @@
                   <a:srgbClr val="64748B"/>
                 </a:solidFill>
               </a:rPr>
-              <a:t>These are ballpark research targets for tool-heavy agent workloads, not final measured claims.</a:t>
+              <a:t>The ranges are tied to observed failure modes, not standalone guesses.</a:t>
             </a:r>
           </a:p>
         </p:txBody>
@@ -3682,549 +3692,1782 @@
           <p:cNvPr id="3" name="">
             <a:extLst xmlns:a="http://schemas.openxmlformats.org/drawingml/2006/main">
               <a:ext uri="{FF2B5EF4-FFF2-40B4-BE49-F238E27FC236}">
-                <a16:creationId xmlns:a16="http://schemas.microsoft.com/office/drawing/2014/main" id="{3AFAFCA3-9EF8-4E69-B854-219BFE1367B8}"/>
-              </a:ext>
-            </a:extLst>
-          </p:cNvPr>
-          <p:cNvSpPr>
-            <a:spLocks xmlns:a="http://schemas.openxmlformats.org/drawingml/2006/main" noGrp="1"/>
-          </p:cNvSpPr>
-          <p:nvPr/>
-        </p:nvSpPr>
-        <p:spPr>
-          <a:xfrm xmlns:a="http://schemas.openxmlformats.org/drawingml/2006/main">
-            <a:off x="876300" y="1562100"/>
-            <a:ext cx="190500" cy="304800"/>
-          </a:xfrm>
-          <a:prstGeom xmlns:a="http://schemas.openxmlformats.org/drawingml/2006/main" prst="rect">
-            <a:avLst/>
-          </a:prstGeom>
-          <a:noFill xmlns:a="http://schemas.openxmlformats.org/drawingml/2006/main"/>
-          <a:ln xmlns:a="http://schemas.openxmlformats.org/drawingml/2006/main" w="0">
-            <a:noFill/>
-            <a:prstDash val="solid"/>
-          </a:ln>
-        </p:spPr>
-        <p:txBody>
-          <a:bodyPr xmlns:a="http://schemas.openxmlformats.org/drawingml/2006/main" anchor="t"/>
-          <a:lstStyle xmlns:a="http://schemas.openxmlformats.org/drawingml/2006/main"/>
-          <a:p xmlns:a="http://schemas.openxmlformats.org/drawingml/2006/main">
-            <a:pPr algn="l">
-              <a:defRPr sz="2025" b="1">
+                <a16:creationId xmlns:a16="http://schemas.microsoft.com/office/drawing/2014/main" id="{0A48BA8D-68CD-4B54-8A58-7F59B86751C8}"/>
+              </a:ext>
+            </a:extLst>
+          </p:cNvPr>
+          <p:cNvSpPr>
+            <a:spLocks xmlns:a="http://schemas.openxmlformats.org/drawingml/2006/main" noGrp="1"/>
+          </p:cNvSpPr>
+          <p:nvPr/>
+        </p:nvSpPr>
+        <p:spPr>
+          <a:xfrm xmlns:a="http://schemas.openxmlformats.org/drawingml/2006/main">
+            <a:off x="514350" y="1485900"/>
+            <a:ext cx="10906125" cy="381000"/>
+          </a:xfrm>
+          <a:prstGeom xmlns:a="http://schemas.openxmlformats.org/drawingml/2006/main" prst="rect">
+            <a:avLst/>
+          </a:prstGeom>
+          <a:solidFill xmlns:a="http://schemas.openxmlformats.org/drawingml/2006/main">
+            <a:srgbClr val="EEF2FF"/>
+          </a:solidFill>
+          <a:ln xmlns:a="http://schemas.openxmlformats.org/drawingml/2006/main" w="9525">
+            <a:solidFill>
+              <a:srgbClr val="CBD5E1"/>
+            </a:solidFill>
+            <a:prstDash val="solid"/>
+          </a:ln>
+        </p:spPr>
+      </p:sp>
+      <p:sp>
+        <p:nvSpPr>
+          <p:cNvPr id="4" name="">
+            <a:extLst xmlns:a="http://schemas.openxmlformats.org/drawingml/2006/main">
+              <a:ext uri="{FF2B5EF4-FFF2-40B4-BE49-F238E27FC236}">
+                <a16:creationId xmlns:a16="http://schemas.microsoft.com/office/drawing/2014/main" id="{4C8DC447-E395-4491-90E9-1C5688383ED3}"/>
+              </a:ext>
+            </a:extLst>
+          </p:cNvPr>
+          <p:cNvSpPr>
+            <a:spLocks xmlns:a="http://schemas.openxmlformats.org/drawingml/2006/main" noGrp="1"/>
+          </p:cNvSpPr>
+          <p:nvPr/>
+        </p:nvSpPr>
+        <p:spPr>
+          <a:xfrm xmlns:a="http://schemas.openxmlformats.org/drawingml/2006/main">
+            <a:off x="600075" y="1581150"/>
+            <a:ext cx="2305050" cy="266700"/>
+          </a:xfrm>
+          <a:prstGeom xmlns:a="http://schemas.openxmlformats.org/drawingml/2006/main" prst="rect">
+            <a:avLst/>
+          </a:prstGeom>
+          <a:noFill xmlns:a="http://schemas.openxmlformats.org/drawingml/2006/main"/>
+          <a:ln xmlns:a="http://schemas.openxmlformats.org/drawingml/2006/main" w="0">
+            <a:noFill/>
+            <a:prstDash val="solid"/>
+          </a:ln>
+        </p:spPr>
+        <p:txBody>
+          <a:bodyPr xmlns:a="http://schemas.openxmlformats.org/drawingml/2006/main" anchor="ctr"/>
+          <a:lstStyle xmlns:a="http://schemas.openxmlformats.org/drawingml/2006/main"/>
+          <a:p xmlns:a="http://schemas.openxmlformats.org/drawingml/2006/main">
+            <a:pPr algn="l">
+              <a:defRPr sz="1125" b="1">
+                <a:solidFill>
+                  <a:srgbClr val="0F172A"/>
+                </a:solidFill>
+              </a:defRPr>
+            </a:pPr>
+            <a:r>
+              <a:rPr sz="1125" b="1">
+                <a:solidFill>
+                  <a:srgbClr val="0F172A"/>
+                </a:solidFill>
+              </a:rPr>
+              <a:t>Observed in our traces</a:t>
+            </a:r>
+          </a:p>
+        </p:txBody>
+      </p:sp>
+      <p:sp>
+        <p:nvSpPr>
+          <p:cNvPr id="5" name="">
+            <a:extLst xmlns:a="http://schemas.openxmlformats.org/drawingml/2006/main">
+              <a:ext uri="{FF2B5EF4-FFF2-40B4-BE49-F238E27FC236}">
+                <a16:creationId xmlns:a16="http://schemas.microsoft.com/office/drawing/2014/main" id="{D21E7E54-B614-4473-94B6-BD3460361472}"/>
+              </a:ext>
+            </a:extLst>
+          </p:cNvPr>
+          <p:cNvSpPr>
+            <a:spLocks xmlns:a="http://schemas.openxmlformats.org/drawingml/2006/main" noGrp="1"/>
+          </p:cNvSpPr>
+          <p:nvPr/>
+        </p:nvSpPr>
+        <p:spPr>
+          <a:xfrm xmlns:a="http://schemas.openxmlformats.org/drawingml/2006/main">
+            <a:off x="3076575" y="1581150"/>
+            <a:ext cx="2209800" cy="266700"/>
+          </a:xfrm>
+          <a:prstGeom xmlns:a="http://schemas.openxmlformats.org/drawingml/2006/main" prst="rect">
+            <a:avLst/>
+          </a:prstGeom>
+          <a:noFill xmlns:a="http://schemas.openxmlformats.org/drawingml/2006/main"/>
+          <a:ln xmlns:a="http://schemas.openxmlformats.org/drawingml/2006/main" w="0">
+            <a:noFill/>
+            <a:prstDash val="solid"/>
+          </a:ln>
+        </p:spPr>
+        <p:txBody>
+          <a:bodyPr xmlns:a="http://schemas.openxmlformats.org/drawingml/2006/main" anchor="ctr"/>
+          <a:lstStyle xmlns:a="http://schemas.openxmlformats.org/drawingml/2006/main"/>
+          <a:p xmlns:a="http://schemas.openxmlformats.org/drawingml/2006/main">
+            <a:pPr algn="l">
+              <a:defRPr sz="1125" b="1">
+                <a:solidFill>
+                  <a:srgbClr val="0F172A"/>
+                </a:solidFill>
+              </a:defRPr>
+            </a:pPr>
+            <a:r>
+              <a:rPr sz="1125" b="1">
+                <a:solidFill>
+                  <a:srgbClr val="0F172A"/>
+                </a:solidFill>
+              </a:rPr>
+              <a:t>Hardware assist</a:t>
+            </a:r>
+          </a:p>
+        </p:txBody>
+      </p:sp>
+      <p:sp>
+        <p:nvSpPr>
+          <p:cNvPr id="6" name="">
+            <a:extLst xmlns:a="http://schemas.openxmlformats.org/drawingml/2006/main">
+              <a:ext uri="{FF2B5EF4-FFF2-40B4-BE49-F238E27FC236}">
+                <a16:creationId xmlns:a16="http://schemas.microsoft.com/office/drawing/2014/main" id="{518E3EE8-E58D-4ED8-9281-F896CBD46A86}"/>
+              </a:ext>
+            </a:extLst>
+          </p:cNvPr>
+          <p:cNvSpPr>
+            <a:spLocks xmlns:a="http://schemas.openxmlformats.org/drawingml/2006/main" noGrp="1"/>
+          </p:cNvSpPr>
+          <p:nvPr/>
+        </p:nvSpPr>
+        <p:spPr>
+          <a:xfrm xmlns:a="http://schemas.openxmlformats.org/drawingml/2006/main">
+            <a:off x="5457825" y="1581150"/>
+            <a:ext cx="3495675" cy="266700"/>
+          </a:xfrm>
+          <a:prstGeom xmlns:a="http://schemas.openxmlformats.org/drawingml/2006/main" prst="rect">
+            <a:avLst/>
+          </a:prstGeom>
+          <a:noFill xmlns:a="http://schemas.openxmlformats.org/drawingml/2006/main"/>
+          <a:ln xmlns:a="http://schemas.openxmlformats.org/drawingml/2006/main" w="0">
+            <a:noFill/>
+            <a:prstDash val="solid"/>
+          </a:ln>
+        </p:spPr>
+        <p:txBody>
+          <a:bodyPr xmlns:a="http://schemas.openxmlformats.org/drawingml/2006/main" anchor="ctr"/>
+          <a:lstStyle xmlns:a="http://schemas.openxmlformats.org/drawingml/2006/main"/>
+          <a:p xmlns:a="http://schemas.openxmlformats.org/drawingml/2006/main">
+            <a:pPr algn="l">
+              <a:defRPr sz="1125" b="1">
+                <a:solidFill>
+                  <a:srgbClr val="0F172A"/>
+                </a:solidFill>
+              </a:defRPr>
+            </a:pPr>
+            <a:r>
+              <a:rPr sz="1125" b="1">
+                <a:solidFill>
+                  <a:srgbClr val="0F172A"/>
+                </a:solidFill>
+              </a:rPr>
+              <a:t>Why it moves the number</a:t>
+            </a:r>
+          </a:p>
+        </p:txBody>
+      </p:sp>
+      <p:sp>
+        <p:nvSpPr>
+          <p:cNvPr id="7" name="">
+            <a:extLst xmlns:a="http://schemas.openxmlformats.org/drawingml/2006/main">
+              <a:ext uri="{FF2B5EF4-FFF2-40B4-BE49-F238E27FC236}">
+                <a16:creationId xmlns:a16="http://schemas.microsoft.com/office/drawing/2014/main" id="{CBB1DB0F-2035-40EC-8998-93FF00840625}"/>
+              </a:ext>
+            </a:extLst>
+          </p:cNvPr>
+          <p:cNvSpPr>
+            <a:spLocks xmlns:a="http://schemas.openxmlformats.org/drawingml/2006/main" noGrp="1"/>
+          </p:cNvSpPr>
+          <p:nvPr/>
+        </p:nvSpPr>
+        <p:spPr>
+          <a:xfrm xmlns:a="http://schemas.openxmlformats.org/drawingml/2006/main">
+            <a:off x="9124950" y="1581150"/>
+            <a:ext cx="2209800" cy="266700"/>
+          </a:xfrm>
+          <a:prstGeom xmlns:a="http://schemas.openxmlformats.org/drawingml/2006/main" prst="rect">
+            <a:avLst/>
+          </a:prstGeom>
+          <a:noFill xmlns:a="http://schemas.openxmlformats.org/drawingml/2006/main"/>
+          <a:ln xmlns:a="http://schemas.openxmlformats.org/drawingml/2006/main" w="0">
+            <a:noFill/>
+            <a:prstDash val="solid"/>
+          </a:ln>
+        </p:spPr>
+        <p:txBody>
+          <a:bodyPr xmlns:a="http://schemas.openxmlformats.org/drawingml/2006/main" anchor="ctr"/>
+          <a:lstStyle xmlns:a="http://schemas.openxmlformats.org/drawingml/2006/main"/>
+          <a:p xmlns:a="http://schemas.openxmlformats.org/drawingml/2006/main">
+            <a:pPr algn="l">
+              <a:defRPr sz="1125" b="1">
+                <a:solidFill>
+                  <a:srgbClr val="0F172A"/>
+                </a:solidFill>
+              </a:defRPr>
+            </a:pPr>
+            <a:r>
+              <a:rPr sz="1125" b="1">
+                <a:solidFill>
+                  <a:srgbClr val="0F172A"/>
+                </a:solidFill>
+              </a:rPr>
+              <a:t>Target impact</a:t>
+            </a:r>
+          </a:p>
+        </p:txBody>
+      </p:sp>
+      <p:sp>
+        <p:nvSpPr>
+          <p:cNvPr id="8" name="">
+            <a:extLst xmlns:a="http://schemas.openxmlformats.org/drawingml/2006/main">
+              <a:ext uri="{FF2B5EF4-FFF2-40B4-BE49-F238E27FC236}">
+                <a16:creationId xmlns:a16="http://schemas.microsoft.com/office/drawing/2014/main" id="{E5134F14-23A3-4FE0-AC4D-9D95E91E94FD}"/>
+              </a:ext>
+            </a:extLst>
+          </p:cNvPr>
+          <p:cNvSpPr>
+            <a:spLocks xmlns:a="http://schemas.openxmlformats.org/drawingml/2006/main" noGrp="1"/>
+          </p:cNvSpPr>
+          <p:nvPr/>
+        </p:nvSpPr>
+        <p:spPr>
+          <a:xfrm xmlns:a="http://schemas.openxmlformats.org/drawingml/2006/main">
+            <a:off x="514350" y="1866900"/>
+            <a:ext cx="10906125" cy="628650"/>
+          </a:xfrm>
+          <a:prstGeom xmlns:a="http://schemas.openxmlformats.org/drawingml/2006/main" prst="rect">
+            <a:avLst/>
+          </a:prstGeom>
+          <a:solidFill xmlns:a="http://schemas.openxmlformats.org/drawingml/2006/main">
+            <a:srgbClr val="FFFFFF"/>
+          </a:solidFill>
+          <a:ln xmlns:a="http://schemas.openxmlformats.org/drawingml/2006/main" w="7620">
+            <a:solidFill>
+              <a:srgbClr val="CBD5E1"/>
+            </a:solidFill>
+            <a:prstDash val="solid"/>
+          </a:ln>
+        </p:spPr>
+      </p:sp>
+      <p:sp>
+        <p:nvSpPr>
+          <p:cNvPr id="9" name="">
+            <a:extLst xmlns:a="http://schemas.openxmlformats.org/drawingml/2006/main">
+              <a:ext uri="{FF2B5EF4-FFF2-40B4-BE49-F238E27FC236}">
+                <a16:creationId xmlns:a16="http://schemas.microsoft.com/office/drawing/2014/main" id="{ABFB8220-236F-45CB-8D7B-2082AA85C7C6}"/>
+              </a:ext>
+            </a:extLst>
+          </p:cNvPr>
+          <p:cNvSpPr>
+            <a:spLocks xmlns:a="http://schemas.openxmlformats.org/drawingml/2006/main" noGrp="1"/>
+          </p:cNvSpPr>
+          <p:nvPr/>
+        </p:nvSpPr>
+        <p:spPr>
+          <a:xfrm xmlns:a="http://schemas.openxmlformats.org/drawingml/2006/main">
+            <a:off x="600075" y="1952625"/>
+            <a:ext cx="2305050" cy="495300"/>
+          </a:xfrm>
+          <a:prstGeom xmlns:a="http://schemas.openxmlformats.org/drawingml/2006/main" prst="rect">
+            <a:avLst/>
+          </a:prstGeom>
+          <a:noFill xmlns:a="http://schemas.openxmlformats.org/drawingml/2006/main"/>
+          <a:ln xmlns:a="http://schemas.openxmlformats.org/drawingml/2006/main" w="0">
+            <a:noFill/>
+            <a:prstDash val="solid"/>
+          </a:ln>
+        </p:spPr>
+        <p:txBody>
+          <a:bodyPr xmlns:a="http://schemas.openxmlformats.org/drawingml/2006/main" anchor="ctr"/>
+          <a:lstStyle xmlns:a="http://schemas.openxmlformats.org/drawingml/2006/main"/>
+          <a:p xmlns:a="http://schemas.openxmlformats.org/drawingml/2006/main">
+            <a:pPr algn="l">
+              <a:defRPr sz="1125" b="1">
+                <a:solidFill>
+                  <a:srgbClr val="DC2626"/>
+                </a:solidFill>
+              </a:defRPr>
+            </a:pPr>
+            <a:r>
+              <a:rPr sz="1125" b="1">
+                <a:solidFill>
+                  <a:srgbClr val="DC2626"/>
+                </a:solidFill>
+              </a:rPr>
+              <a:t>Late replay H2D</a:t>
+            </a:r>
+          </a:p>
+        </p:txBody>
+      </p:sp>
+      <p:sp>
+        <p:nvSpPr>
+          <p:cNvPr id="10" name="">
+            <a:extLst xmlns:a="http://schemas.openxmlformats.org/drawingml/2006/main">
+              <a:ext uri="{FF2B5EF4-FFF2-40B4-BE49-F238E27FC236}">
+                <a16:creationId xmlns:a16="http://schemas.microsoft.com/office/drawing/2014/main" id="{1B944896-6C53-472E-8BE5-94614E9E7C17}"/>
+              </a:ext>
+            </a:extLst>
+          </p:cNvPr>
+          <p:cNvSpPr>
+            <a:spLocks xmlns:a="http://schemas.openxmlformats.org/drawingml/2006/main" noGrp="1"/>
+          </p:cNvSpPr>
+          <p:nvPr/>
+        </p:nvSpPr>
+        <p:spPr>
+          <a:xfrm xmlns:a="http://schemas.openxmlformats.org/drawingml/2006/main">
+            <a:off x="3076575" y="1952625"/>
+            <a:ext cx="2209800" cy="495300"/>
+          </a:xfrm>
+          <a:prstGeom xmlns:a="http://schemas.openxmlformats.org/drawingml/2006/main" prst="rect">
+            <a:avLst/>
+          </a:prstGeom>
+          <a:noFill xmlns:a="http://schemas.openxmlformats.org/drawingml/2006/main"/>
+          <a:ln xmlns:a="http://schemas.openxmlformats.org/drawingml/2006/main" w="0">
+            <a:noFill/>
+            <a:prstDash val="solid"/>
+          </a:ln>
+        </p:spPr>
+        <p:txBody>
+          <a:bodyPr xmlns:a="http://schemas.openxmlformats.org/drawingml/2006/main" anchor="ctr"/>
+          <a:lstStyle xmlns:a="http://schemas.openxmlformats.org/drawingml/2006/main"/>
+          <a:p xmlns:a="http://schemas.openxmlformats.org/drawingml/2006/main">
+            <a:pPr algn="l">
+              <a:defRPr sz="1125" b="0">
+                <a:solidFill>
+                  <a:srgbClr val="334155"/>
+                </a:solidFill>
+              </a:defRPr>
+            </a:pPr>
+            <a:r>
+              <a:rPr sz="1125" b="0">
+                <a:solidFill>
+                  <a:srgbClr val="334155"/>
+                </a:solidFill>
+              </a:rPr>
+              <a:t>deadline-aware KV queue</a:t>
+            </a:r>
+          </a:p>
+        </p:txBody>
+      </p:sp>
+      <p:sp>
+        <p:nvSpPr>
+          <p:cNvPr id="11" name="">
+            <a:extLst xmlns:a="http://schemas.openxmlformats.org/drawingml/2006/main">
+              <a:ext uri="{FF2B5EF4-FFF2-40B4-BE49-F238E27FC236}">
+                <a16:creationId xmlns:a16="http://schemas.microsoft.com/office/drawing/2014/main" id="{4A95457C-6754-4E7C-A608-230CC9DAA33E}"/>
+              </a:ext>
+            </a:extLst>
+          </p:cNvPr>
+          <p:cNvSpPr>
+            <a:spLocks xmlns:a="http://schemas.openxmlformats.org/drawingml/2006/main" noGrp="1"/>
+          </p:cNvSpPr>
+          <p:nvPr/>
+        </p:nvSpPr>
+        <p:spPr>
+          <a:xfrm xmlns:a="http://schemas.openxmlformats.org/drawingml/2006/main">
+            <a:off x="5457825" y="1952625"/>
+            <a:ext cx="3495675" cy="495300"/>
+          </a:xfrm>
+          <a:prstGeom xmlns:a="http://schemas.openxmlformats.org/drawingml/2006/main" prst="rect">
+            <a:avLst/>
+          </a:prstGeom>
+          <a:noFill xmlns:a="http://schemas.openxmlformats.org/drawingml/2006/main"/>
+          <a:ln xmlns:a="http://schemas.openxmlformats.org/drawingml/2006/main" w="0">
+            <a:noFill/>
+            <a:prstDash val="solid"/>
+          </a:ln>
+        </p:spPr>
+        <p:txBody>
+          <a:bodyPr xmlns:a="http://schemas.openxmlformats.org/drawingml/2006/main" anchor="ctr"/>
+          <a:lstStyle xmlns:a="http://schemas.openxmlformats.org/drawingml/2006/main"/>
+          <a:p xmlns:a="http://schemas.openxmlformats.org/drawingml/2006/main">
+            <a:pPr algn="l">
+              <a:defRPr sz="1125" b="0">
+                <a:solidFill>
+                  <a:srgbClr val="334155"/>
+                </a:solidFill>
+              </a:defRPr>
+            </a:pPr>
+            <a:r>
+              <a:rPr sz="1125" b="0">
+                <a:solidFill>
+                  <a:srgbClr val="334155"/>
+                </a:solidFill>
+              </a:rPr>
+              <a:t>cuts time spent waiting for urgent KV</a:t>
+            </a:r>
+          </a:p>
+        </p:txBody>
+      </p:sp>
+      <p:sp>
+        <p:nvSpPr>
+          <p:cNvPr id="12" name="">
+            <a:extLst xmlns:a="http://schemas.openxmlformats.org/drawingml/2006/main">
+              <a:ext uri="{FF2B5EF4-FFF2-40B4-BE49-F238E27FC236}">
+                <a16:creationId xmlns:a16="http://schemas.microsoft.com/office/drawing/2014/main" id="{C88DF3DE-418F-4A38-A1AF-6D82D9AE12C3}"/>
+              </a:ext>
+            </a:extLst>
+          </p:cNvPr>
+          <p:cNvSpPr>
+            <a:spLocks xmlns:a="http://schemas.openxmlformats.org/drawingml/2006/main" noGrp="1"/>
+          </p:cNvSpPr>
+          <p:nvPr/>
+        </p:nvSpPr>
+        <p:spPr>
+          <a:xfrm xmlns:a="http://schemas.openxmlformats.org/drawingml/2006/main">
+            <a:off x="9124950" y="1952625"/>
+            <a:ext cx="2209800" cy="495300"/>
+          </a:xfrm>
+          <a:prstGeom xmlns:a="http://schemas.openxmlformats.org/drawingml/2006/main" prst="rect">
+            <a:avLst/>
+          </a:prstGeom>
+          <a:noFill xmlns:a="http://schemas.openxmlformats.org/drawingml/2006/main"/>
+          <a:ln xmlns:a="http://schemas.openxmlformats.org/drawingml/2006/main" w="0">
+            <a:noFill/>
+            <a:prstDash val="solid"/>
+          </a:ln>
+        </p:spPr>
+        <p:txBody>
+          <a:bodyPr xmlns:a="http://schemas.openxmlformats.org/drawingml/2006/main" anchor="ctr"/>
+          <a:lstStyle xmlns:a="http://schemas.openxmlformats.org/drawingml/2006/main"/>
+          <a:p xmlns:a="http://schemas.openxmlformats.org/drawingml/2006/main">
+            <a:pPr algn="l">
+              <a:defRPr sz="1125" b="1">
                 <a:solidFill>
                   <a:srgbClr val="2563EB"/>
                 </a:solidFill>
               </a:defRPr>
             </a:pPr>
             <a:r>
-              <a:rPr sz="2025" b="1">
+              <a:rPr sz="1125" b="1">
                 <a:solidFill>
                   <a:srgbClr val="2563EB"/>
                 </a:solidFill>
               </a:rPr>
-              <a:t>•</a:t>
-            </a:r>
-          </a:p>
-        </p:txBody>
-      </p:sp>
-      <p:sp>
-        <p:nvSpPr>
-          <p:cNvPr id="4" name="">
-            <a:extLst xmlns:a="http://schemas.openxmlformats.org/drawingml/2006/main">
-              <a:ext uri="{FF2B5EF4-FFF2-40B4-BE49-F238E27FC236}">
-                <a16:creationId xmlns:a16="http://schemas.microsoft.com/office/drawing/2014/main" id="{69F336FE-CDD9-4133-966A-E9A0AD09D280}"/>
-              </a:ext>
-            </a:extLst>
-          </p:cNvPr>
-          <p:cNvSpPr>
-            <a:spLocks xmlns:a="http://schemas.openxmlformats.org/drawingml/2006/main" noGrp="1"/>
-          </p:cNvSpPr>
-          <p:nvPr/>
-        </p:nvSpPr>
-        <p:spPr>
-          <a:xfrm xmlns:a="http://schemas.openxmlformats.org/drawingml/2006/main">
-            <a:off x="1162050" y="1581150"/>
-            <a:ext cx="9715500" cy="514350"/>
-          </a:xfrm>
-          <a:prstGeom xmlns:a="http://schemas.openxmlformats.org/drawingml/2006/main" prst="rect">
-            <a:avLst/>
-          </a:prstGeom>
-          <a:noFill xmlns:a="http://schemas.openxmlformats.org/drawingml/2006/main"/>
-          <a:ln xmlns:a="http://schemas.openxmlformats.org/drawingml/2006/main" w="0">
-            <a:noFill/>
-            <a:prstDash val="solid"/>
-          </a:ln>
-        </p:spPr>
-        <p:txBody>
-          <a:bodyPr xmlns:a="http://schemas.openxmlformats.org/drawingml/2006/main" anchor="t"/>
-          <a:lstStyle xmlns:a="http://schemas.openxmlformats.org/drawingml/2006/main"/>
-          <a:p xmlns:a="http://schemas.openxmlformats.org/drawingml/2006/main">
-            <a:pPr algn="l">
-              <a:defRPr sz="1875" b="0">
+              <a:t>10-20% replay latency</a:t>
+            </a:r>
+          </a:p>
+        </p:txBody>
+      </p:sp>
+      <p:sp>
+        <p:nvSpPr>
+          <p:cNvPr id="13" name="">
+            <a:extLst xmlns:a="http://schemas.openxmlformats.org/drawingml/2006/main">
+              <a:ext uri="{FF2B5EF4-FFF2-40B4-BE49-F238E27FC236}">
+                <a16:creationId xmlns:a16="http://schemas.microsoft.com/office/drawing/2014/main" id="{43F9E836-9FA0-46AA-91A1-343DB91D5A2A}"/>
+              </a:ext>
+            </a:extLst>
+          </p:cNvPr>
+          <p:cNvSpPr>
+            <a:spLocks xmlns:a="http://schemas.openxmlformats.org/drawingml/2006/main" noGrp="1"/>
+          </p:cNvSpPr>
+          <p:nvPr/>
+        </p:nvSpPr>
+        <p:spPr>
+          <a:xfrm xmlns:a="http://schemas.openxmlformats.org/drawingml/2006/main">
+            <a:off x="514350" y="2495550"/>
+            <a:ext cx="10906125" cy="628650"/>
+          </a:xfrm>
+          <a:prstGeom xmlns:a="http://schemas.openxmlformats.org/drawingml/2006/main" prst="rect">
+            <a:avLst/>
+          </a:prstGeom>
+          <a:solidFill xmlns:a="http://schemas.openxmlformats.org/drawingml/2006/main">
+            <a:srgbClr val="F8FAFC"/>
+          </a:solidFill>
+          <a:ln xmlns:a="http://schemas.openxmlformats.org/drawingml/2006/main" w="7620">
+            <a:solidFill>
+              <a:srgbClr val="CBD5E1"/>
+            </a:solidFill>
+            <a:prstDash val="solid"/>
+          </a:ln>
+        </p:spPr>
+      </p:sp>
+      <p:sp>
+        <p:nvSpPr>
+          <p:cNvPr id="14" name="">
+            <a:extLst xmlns:a="http://schemas.openxmlformats.org/drawingml/2006/main">
+              <a:ext uri="{FF2B5EF4-FFF2-40B4-BE49-F238E27FC236}">
+                <a16:creationId xmlns:a16="http://schemas.microsoft.com/office/drawing/2014/main" id="{400E382B-1EBA-4A9D-A7FF-85068CC0DFDD}"/>
+              </a:ext>
+            </a:extLst>
+          </p:cNvPr>
+          <p:cNvSpPr>
+            <a:spLocks xmlns:a="http://schemas.openxmlformats.org/drawingml/2006/main" noGrp="1"/>
+          </p:cNvSpPr>
+          <p:nvPr/>
+        </p:nvSpPr>
+        <p:spPr>
+          <a:xfrm xmlns:a="http://schemas.openxmlformats.org/drawingml/2006/main">
+            <a:off x="600075" y="2581275"/>
+            <a:ext cx="2305050" cy="495300"/>
+          </a:xfrm>
+          <a:prstGeom xmlns:a="http://schemas.openxmlformats.org/drawingml/2006/main" prst="rect">
+            <a:avLst/>
+          </a:prstGeom>
+          <a:noFill xmlns:a="http://schemas.openxmlformats.org/drawingml/2006/main"/>
+          <a:ln xmlns:a="http://schemas.openxmlformats.org/drawingml/2006/main" w="0">
+            <a:noFill/>
+            <a:prstDash val="solid"/>
+          </a:ln>
+        </p:spPr>
+        <p:txBody>
+          <a:bodyPr xmlns:a="http://schemas.openxmlformats.org/drawingml/2006/main" anchor="ctr"/>
+          <a:lstStyle xmlns:a="http://schemas.openxmlformats.org/drawingml/2006/main"/>
+          <a:p xmlns:a="http://schemas.openxmlformats.org/drawingml/2006/main">
+            <a:pPr algn="l">
+              <a:defRPr sz="1125" b="1">
+                <a:solidFill>
+                  <a:srgbClr val="CA8A04"/>
+                </a:solidFill>
+              </a:defRPr>
+            </a:pPr>
+            <a:r>
+              <a:rPr sz="1125" b="1">
+                <a:solidFill>
+                  <a:srgbClr val="CA8A04"/>
+                </a:solidFill>
+              </a:rPr>
+              <a:t>Replay recomputes old prefix</a:t>
+            </a:r>
+          </a:p>
+        </p:txBody>
+      </p:sp>
+      <p:sp>
+        <p:nvSpPr>
+          <p:cNvPr id="15" name="">
+            <a:extLst xmlns:a="http://schemas.openxmlformats.org/drawingml/2006/main">
+              <a:ext uri="{FF2B5EF4-FFF2-40B4-BE49-F238E27FC236}">
+                <a16:creationId xmlns:a16="http://schemas.microsoft.com/office/drawing/2014/main" id="{019C9FE1-AD6D-44E9-B7BE-A52810251BD3}"/>
+              </a:ext>
+            </a:extLst>
+          </p:cNvPr>
+          <p:cNvSpPr>
+            <a:spLocks xmlns:a="http://schemas.openxmlformats.org/drawingml/2006/main" noGrp="1"/>
+          </p:cNvSpPr>
+          <p:nvPr/>
+        </p:nvSpPr>
+        <p:spPr>
+          <a:xfrm xmlns:a="http://schemas.openxmlformats.org/drawingml/2006/main">
+            <a:off x="3076575" y="2581275"/>
+            <a:ext cx="2209800" cy="495300"/>
+          </a:xfrm>
+          <a:prstGeom xmlns:a="http://schemas.openxmlformats.org/drawingml/2006/main" prst="rect">
+            <a:avLst/>
+          </a:prstGeom>
+          <a:noFill xmlns:a="http://schemas.openxmlformats.org/drawingml/2006/main"/>
+          <a:ln xmlns:a="http://schemas.openxmlformats.org/drawingml/2006/main" w="0">
+            <a:noFill/>
+            <a:prstDash val="solid"/>
+          </a:ln>
+        </p:spPr>
+        <p:txBody>
+          <a:bodyPr xmlns:a="http://schemas.openxmlformats.org/drawingml/2006/main" anchor="ctr"/>
+          <a:lstStyle xmlns:a="http://schemas.openxmlformats.org/drawingml/2006/main"/>
+          <a:p xmlns:a="http://schemas.openxmlformats.org/drawingml/2006/main">
+            <a:pPr algn="l">
+              <a:defRPr sz="1125" b="0">
                 <a:solidFill>
                   <a:srgbClr val="334155"/>
                 </a:solidFill>
               </a:defRPr>
             </a:pPr>
             <a:r>
-              <a:rPr sz="1875" b="0">
+              <a:rPr sz="1125" b="0">
                 <a:solidFill>
                   <a:srgbClr val="334155"/>
                 </a:solidFill>
               </a:rPr>
-              <a:t>10-30% lower post-tool replay latency when urgent KV is ready before replay.</a:t>
-            </a:r>
-          </a:p>
-        </p:txBody>
-      </p:sp>
-      <p:sp>
-        <p:nvSpPr>
-          <p:cNvPr id="5" name="">
-            <a:extLst xmlns:a="http://schemas.openxmlformats.org/drawingml/2006/main">
-              <a:ext uri="{FF2B5EF4-FFF2-40B4-BE49-F238E27FC236}">
-                <a16:creationId xmlns:a16="http://schemas.microsoft.com/office/drawing/2014/main" id="{A48ED84E-FB21-4227-870A-F00D16C80DD8}"/>
-              </a:ext>
-            </a:extLst>
-          </p:cNvPr>
-          <p:cNvSpPr>
-            <a:spLocks xmlns:a="http://schemas.openxmlformats.org/drawingml/2006/main" noGrp="1"/>
-          </p:cNvSpPr>
-          <p:nvPr/>
-        </p:nvSpPr>
-        <p:spPr>
-          <a:xfrm xmlns:a="http://schemas.openxmlformats.org/drawingml/2006/main">
-            <a:off x="876300" y="2247900"/>
-            <a:ext cx="190500" cy="304800"/>
-          </a:xfrm>
-          <a:prstGeom xmlns:a="http://schemas.openxmlformats.org/drawingml/2006/main" prst="rect">
-            <a:avLst/>
-          </a:prstGeom>
-          <a:noFill xmlns:a="http://schemas.openxmlformats.org/drawingml/2006/main"/>
-          <a:ln xmlns:a="http://schemas.openxmlformats.org/drawingml/2006/main" w="0">
-            <a:noFill/>
-            <a:prstDash val="solid"/>
-          </a:ln>
-        </p:spPr>
-        <p:txBody>
-          <a:bodyPr xmlns:a="http://schemas.openxmlformats.org/drawingml/2006/main" anchor="t"/>
-          <a:lstStyle xmlns:a="http://schemas.openxmlformats.org/drawingml/2006/main"/>
-          <a:p xmlns:a="http://schemas.openxmlformats.org/drawingml/2006/main">
-            <a:pPr algn="l">
-              <a:defRPr sz="2025" b="1">
+              <a:t>residency protection</a:t>
+            </a:r>
+          </a:p>
+        </p:txBody>
+      </p:sp>
+      <p:sp>
+        <p:nvSpPr>
+          <p:cNvPr id="16" name="">
+            <a:extLst xmlns:a="http://schemas.openxmlformats.org/drawingml/2006/main">
+              <a:ext uri="{FF2B5EF4-FFF2-40B4-BE49-F238E27FC236}">
+                <a16:creationId xmlns:a16="http://schemas.microsoft.com/office/drawing/2014/main" id="{423FA0F1-FB27-4EB9-9ACE-6CAAFF4DC8BA}"/>
+              </a:ext>
+            </a:extLst>
+          </p:cNvPr>
+          <p:cNvSpPr>
+            <a:spLocks xmlns:a="http://schemas.openxmlformats.org/drawingml/2006/main" noGrp="1"/>
+          </p:cNvSpPr>
+          <p:nvPr/>
+        </p:nvSpPr>
+        <p:spPr>
+          <a:xfrm xmlns:a="http://schemas.openxmlformats.org/drawingml/2006/main">
+            <a:off x="5457825" y="2581275"/>
+            <a:ext cx="3495675" cy="495300"/>
+          </a:xfrm>
+          <a:prstGeom xmlns:a="http://schemas.openxmlformats.org/drawingml/2006/main" prst="rect">
+            <a:avLst/>
+          </a:prstGeom>
+          <a:noFill xmlns:a="http://schemas.openxmlformats.org/drawingml/2006/main"/>
+          <a:ln xmlns:a="http://schemas.openxmlformats.org/drawingml/2006/main" w="0">
+            <a:noFill/>
+            <a:prstDash val="solid"/>
+          </a:ln>
+        </p:spPr>
+        <p:txBody>
+          <a:bodyPr xmlns:a="http://schemas.openxmlformats.org/drawingml/2006/main" anchor="ctr"/>
+          <a:lstStyle xmlns:a="http://schemas.openxmlformats.org/drawingml/2006/main"/>
+          <a:p xmlns:a="http://schemas.openxmlformats.org/drawingml/2006/main">
+            <a:pPr algn="l">
+              <a:defRPr sz="1125" b="0">
+                <a:solidFill>
+                  <a:srgbClr val="334155"/>
+                </a:solidFill>
+              </a:defRPr>
+            </a:pPr>
+            <a:r>
+              <a:rPr sz="1125" b="0">
+                <a:solidFill>
+                  <a:srgbClr val="334155"/>
+                </a:solidFill>
+              </a:rPr>
+              <a:t>keeps useful KV available until reuse</a:t>
+            </a:r>
+          </a:p>
+        </p:txBody>
+      </p:sp>
+      <p:sp>
+        <p:nvSpPr>
+          <p:cNvPr id="17" name="">
+            <a:extLst xmlns:a="http://schemas.openxmlformats.org/drawingml/2006/main">
+              <a:ext uri="{FF2B5EF4-FFF2-40B4-BE49-F238E27FC236}">
+                <a16:creationId xmlns:a16="http://schemas.microsoft.com/office/drawing/2014/main" id="{789C0981-73BC-436E-B1C4-253CFD5A5FD1}"/>
+              </a:ext>
+            </a:extLst>
+          </p:cNvPr>
+          <p:cNvSpPr>
+            <a:spLocks xmlns:a="http://schemas.openxmlformats.org/drawingml/2006/main" noGrp="1"/>
+          </p:cNvSpPr>
+          <p:nvPr/>
+        </p:nvSpPr>
+        <p:spPr>
+          <a:xfrm xmlns:a="http://schemas.openxmlformats.org/drawingml/2006/main">
+            <a:off x="9124950" y="2581275"/>
+            <a:ext cx="2209800" cy="495300"/>
+          </a:xfrm>
+          <a:prstGeom xmlns:a="http://schemas.openxmlformats.org/drawingml/2006/main" prst="rect">
+            <a:avLst/>
+          </a:prstGeom>
+          <a:noFill xmlns:a="http://schemas.openxmlformats.org/drawingml/2006/main"/>
+          <a:ln xmlns:a="http://schemas.openxmlformats.org/drawingml/2006/main" w="0">
+            <a:noFill/>
+            <a:prstDash val="solid"/>
+          </a:ln>
+        </p:spPr>
+        <p:txBody>
+          <a:bodyPr xmlns:a="http://schemas.openxmlformats.org/drawingml/2006/main" anchor="ctr"/>
+          <a:lstStyle xmlns:a="http://schemas.openxmlformats.org/drawingml/2006/main"/>
+          <a:p xmlns:a="http://schemas.openxmlformats.org/drawingml/2006/main">
+            <a:pPr algn="l">
+              <a:defRPr sz="1125" b="1">
                 <a:solidFill>
                   <a:srgbClr val="9333EA"/>
                 </a:solidFill>
               </a:defRPr>
             </a:pPr>
             <a:r>
-              <a:rPr sz="2025" b="1">
+              <a:rPr sz="1125" b="1">
                 <a:solidFill>
                   <a:srgbClr val="9333EA"/>
                 </a:solidFill>
               </a:rPr>
-              <a:t>•</a:t>
-            </a:r>
-          </a:p>
-        </p:txBody>
-      </p:sp>
-      <p:sp>
-        <p:nvSpPr>
-          <p:cNvPr id="6" name="">
-            <a:extLst xmlns:a="http://schemas.openxmlformats.org/drawingml/2006/main">
-              <a:ext uri="{FF2B5EF4-FFF2-40B4-BE49-F238E27FC236}">
-                <a16:creationId xmlns:a16="http://schemas.microsoft.com/office/drawing/2014/main" id="{2D9B5E78-CD7F-4A97-B493-118F5B2FF0FD}"/>
-              </a:ext>
-            </a:extLst>
-          </p:cNvPr>
-          <p:cNvSpPr>
-            <a:spLocks xmlns:a="http://schemas.openxmlformats.org/drawingml/2006/main" noGrp="1"/>
-          </p:cNvSpPr>
-          <p:nvPr/>
-        </p:nvSpPr>
-        <p:spPr>
-          <a:xfrm xmlns:a="http://schemas.openxmlformats.org/drawingml/2006/main">
-            <a:off x="1162050" y="2266950"/>
-            <a:ext cx="9715500" cy="514350"/>
-          </a:xfrm>
-          <a:prstGeom xmlns:a="http://schemas.openxmlformats.org/drawingml/2006/main" prst="rect">
-            <a:avLst/>
-          </a:prstGeom>
-          <a:noFill xmlns:a="http://schemas.openxmlformats.org/drawingml/2006/main"/>
-          <a:ln xmlns:a="http://schemas.openxmlformats.org/drawingml/2006/main" w="0">
-            <a:noFill/>
-            <a:prstDash val="solid"/>
-          </a:ln>
-        </p:spPr>
-        <p:txBody>
-          <a:bodyPr xmlns:a="http://schemas.openxmlformats.org/drawingml/2006/main" anchor="t"/>
-          <a:lstStyle xmlns:a="http://schemas.openxmlformats.org/drawingml/2006/main"/>
-          <a:p xmlns:a="http://schemas.openxmlformats.org/drawingml/2006/main">
-            <a:pPr algn="l">
-              <a:defRPr sz="1875" b="0">
+              <a:t>up to 20-30%</a:t>
+            </a:r>
+          </a:p>
+        </p:txBody>
+      </p:sp>
+      <p:sp>
+        <p:nvSpPr>
+          <p:cNvPr id="18" name="">
+            <a:extLst xmlns:a="http://schemas.openxmlformats.org/drawingml/2006/main">
+              <a:ext uri="{FF2B5EF4-FFF2-40B4-BE49-F238E27FC236}">
+                <a16:creationId xmlns:a16="http://schemas.microsoft.com/office/drawing/2014/main" id="{9D9381C7-ABE4-47AC-B032-DEBE03B10F85}"/>
+              </a:ext>
+            </a:extLst>
+          </p:cNvPr>
+          <p:cNvSpPr>
+            <a:spLocks xmlns:a="http://schemas.openxmlformats.org/drawingml/2006/main" noGrp="1"/>
+          </p:cNvSpPr>
+          <p:nvPr/>
+        </p:nvSpPr>
+        <p:spPr>
+          <a:xfrm xmlns:a="http://schemas.openxmlformats.org/drawingml/2006/main">
+            <a:off x="514350" y="3124200"/>
+            <a:ext cx="10906125" cy="628650"/>
+          </a:xfrm>
+          <a:prstGeom xmlns:a="http://schemas.openxmlformats.org/drawingml/2006/main" prst="rect">
+            <a:avLst/>
+          </a:prstGeom>
+          <a:solidFill xmlns:a="http://schemas.openxmlformats.org/drawingml/2006/main">
+            <a:srgbClr val="FFFFFF"/>
+          </a:solidFill>
+          <a:ln xmlns:a="http://schemas.openxmlformats.org/drawingml/2006/main" w="7620">
+            <a:solidFill>
+              <a:srgbClr val="CBD5E1"/>
+            </a:solidFill>
+            <a:prstDash val="solid"/>
+          </a:ln>
+        </p:spPr>
+      </p:sp>
+      <p:sp>
+        <p:nvSpPr>
+          <p:cNvPr id="19" name="">
+            <a:extLst xmlns:a="http://schemas.openxmlformats.org/drawingml/2006/main">
+              <a:ext uri="{FF2B5EF4-FFF2-40B4-BE49-F238E27FC236}">
+                <a16:creationId xmlns:a16="http://schemas.microsoft.com/office/drawing/2014/main" id="{A6172B88-46C9-4964-B18A-29D3E3AC4579}"/>
+              </a:ext>
+            </a:extLst>
+          </p:cNvPr>
+          <p:cNvSpPr>
+            <a:spLocks xmlns:a="http://schemas.openxmlformats.org/drawingml/2006/main" noGrp="1"/>
+          </p:cNvSpPr>
+          <p:nvPr/>
+        </p:nvSpPr>
+        <p:spPr>
+          <a:xfrm xmlns:a="http://schemas.openxmlformats.org/drawingml/2006/main">
+            <a:off x="600075" y="3209925"/>
+            <a:ext cx="2305050" cy="495300"/>
+          </a:xfrm>
+          <a:prstGeom xmlns:a="http://schemas.openxmlformats.org/drawingml/2006/main" prst="rect">
+            <a:avLst/>
+          </a:prstGeom>
+          <a:noFill xmlns:a="http://schemas.openxmlformats.org/drawingml/2006/main"/>
+          <a:ln xmlns:a="http://schemas.openxmlformats.org/drawingml/2006/main" w="0">
+            <a:noFill/>
+            <a:prstDash val="solid"/>
+          </a:ln>
+        </p:spPr>
+        <p:txBody>
+          <a:bodyPr xmlns:a="http://schemas.openxmlformats.org/drawingml/2006/main" anchor="ctr"/>
+          <a:lstStyle xmlns:a="http://schemas.openxmlformats.org/drawingml/2006/main"/>
+          <a:p xmlns:a="http://schemas.openxmlformats.org/drawingml/2006/main">
+            <a:pPr algn="l">
+              <a:defRPr sz="1125" b="1">
+                <a:solidFill>
+                  <a:srgbClr val="9333EA"/>
+                </a:solidFill>
+              </a:defRPr>
+            </a:pPr>
+            <a:r>
+              <a:rPr sz="1125" b="1">
+                <a:solidFill>
+                  <a:srgbClr val="9333EA"/>
+                </a:solidFill>
+              </a:rPr>
+              <a:t>Hints finish after deadline</a:t>
+            </a:r>
+          </a:p>
+        </p:txBody>
+      </p:sp>
+      <p:sp>
+        <p:nvSpPr>
+          <p:cNvPr id="20" name="">
+            <a:extLst xmlns:a="http://schemas.openxmlformats.org/drawingml/2006/main">
+              <a:ext uri="{FF2B5EF4-FFF2-40B4-BE49-F238E27FC236}">
+                <a16:creationId xmlns:a16="http://schemas.microsoft.com/office/drawing/2014/main" id="{A9418E71-4CE4-4075-8DD0-8FBB88D3C6E2}"/>
+              </a:ext>
+            </a:extLst>
+          </p:cNvPr>
+          <p:cNvSpPr>
+            <a:spLocks xmlns:a="http://schemas.openxmlformats.org/drawingml/2006/main" noGrp="1"/>
+          </p:cNvSpPr>
+          <p:nvPr/>
+        </p:nvSpPr>
+        <p:spPr>
+          <a:xfrm xmlns:a="http://schemas.openxmlformats.org/drawingml/2006/main">
+            <a:off x="3076575" y="3209925"/>
+            <a:ext cx="2209800" cy="495300"/>
+          </a:xfrm>
+          <a:prstGeom xmlns:a="http://schemas.openxmlformats.org/drawingml/2006/main" prst="rect">
+            <a:avLst/>
+          </a:prstGeom>
+          <a:noFill xmlns:a="http://schemas.openxmlformats.org/drawingml/2006/main"/>
+          <a:ln xmlns:a="http://schemas.openxmlformats.org/drawingml/2006/main" w="0">
+            <a:noFill/>
+            <a:prstDash val="solid"/>
+          </a:ln>
+        </p:spPr>
+        <p:txBody>
+          <a:bodyPr xmlns:a="http://schemas.openxmlformats.org/drawingml/2006/main" anchor="ctr"/>
+          <a:lstStyle xmlns:a="http://schemas.openxmlformats.org/drawingml/2006/main"/>
+          <a:p xmlns:a="http://schemas.openxmlformats.org/drawingml/2006/main">
+            <a:pPr algn="l">
+              <a:defRPr sz="1125" b="0">
                 <a:solidFill>
                   <a:srgbClr val="334155"/>
                 </a:solidFill>
               </a:defRPr>
             </a:pPr>
             <a:r>
-              <a:rPr sz="1875" b="0">
+              <a:rPr sz="1125" b="0">
                 <a:solidFill>
                   <a:srgbClr val="334155"/>
                 </a:solidFill>
               </a:rPr>
-              <a:t>20-50% fewer late KV reloads with deadline-aware movement scheduling.</a:t>
-            </a:r>
-          </a:p>
-        </p:txBody>
-      </p:sp>
-      <p:sp>
-        <p:nvSpPr>
-          <p:cNvPr id="7" name="">
-            <a:extLst xmlns:a="http://schemas.openxmlformats.org/drawingml/2006/main">
-              <a:ext uri="{FF2B5EF4-FFF2-40B4-BE49-F238E27FC236}">
-                <a16:creationId xmlns:a16="http://schemas.microsoft.com/office/drawing/2014/main" id="{C04281E1-C78E-4ADD-AF9A-47E5E5E2A7A6}"/>
-              </a:ext>
-            </a:extLst>
-          </p:cNvPr>
-          <p:cNvSpPr>
-            <a:spLocks xmlns:a="http://schemas.openxmlformats.org/drawingml/2006/main" noGrp="1"/>
-          </p:cNvSpPr>
-          <p:nvPr/>
-        </p:nvSpPr>
-        <p:spPr>
-          <a:xfrm xmlns:a="http://schemas.openxmlformats.org/drawingml/2006/main">
-            <a:off x="876300" y="2933700"/>
-            <a:ext cx="190500" cy="304800"/>
-          </a:xfrm>
-          <a:prstGeom xmlns:a="http://schemas.openxmlformats.org/drawingml/2006/main" prst="rect">
-            <a:avLst/>
-          </a:prstGeom>
-          <a:noFill xmlns:a="http://schemas.openxmlformats.org/drawingml/2006/main"/>
-          <a:ln xmlns:a="http://schemas.openxmlformats.org/drawingml/2006/main" w="0">
-            <a:noFill/>
-            <a:prstDash val="solid"/>
-          </a:ln>
-        </p:spPr>
-        <p:txBody>
-          <a:bodyPr xmlns:a="http://schemas.openxmlformats.org/drawingml/2006/main" anchor="t"/>
-          <a:lstStyle xmlns:a="http://schemas.openxmlformats.org/drawingml/2006/main"/>
-          <a:p xmlns:a="http://schemas.openxmlformats.org/drawingml/2006/main">
-            <a:pPr algn="l">
-              <a:defRPr sz="2025" b="1">
+              <a:t>session priority metadata</a:t>
+            </a:r>
+          </a:p>
+        </p:txBody>
+      </p:sp>
+      <p:sp>
+        <p:nvSpPr>
+          <p:cNvPr id="21" name="">
+            <a:extLst xmlns:a="http://schemas.openxmlformats.org/drawingml/2006/main">
+              <a:ext uri="{FF2B5EF4-FFF2-40B4-BE49-F238E27FC236}">
+                <a16:creationId xmlns:a16="http://schemas.microsoft.com/office/drawing/2014/main" id="{85C97FC5-629A-478E-9073-4F40CCF9B670}"/>
+              </a:ext>
+            </a:extLst>
+          </p:cNvPr>
+          <p:cNvSpPr>
+            <a:spLocks xmlns:a="http://schemas.openxmlformats.org/drawingml/2006/main" noGrp="1"/>
+          </p:cNvSpPr>
+          <p:nvPr/>
+        </p:nvSpPr>
+        <p:spPr>
+          <a:xfrm xmlns:a="http://schemas.openxmlformats.org/drawingml/2006/main">
+            <a:off x="5457825" y="3209925"/>
+            <a:ext cx="3495675" cy="495300"/>
+          </a:xfrm>
+          <a:prstGeom xmlns:a="http://schemas.openxmlformats.org/drawingml/2006/main" prst="rect">
+            <a:avLst/>
+          </a:prstGeom>
+          <a:noFill xmlns:a="http://schemas.openxmlformats.org/drawingml/2006/main"/>
+          <a:ln xmlns:a="http://schemas.openxmlformats.org/drawingml/2006/main" w="0">
+            <a:noFill/>
+            <a:prstDash val="solid"/>
+          </a:ln>
+        </p:spPr>
+        <p:txBody>
+          <a:bodyPr xmlns:a="http://schemas.openxmlformats.org/drawingml/2006/main" anchor="ctr"/>
+          <a:lstStyle xmlns:a="http://schemas.openxmlformats.org/drawingml/2006/main"/>
+          <a:p xmlns:a="http://schemas.openxmlformats.org/drawingml/2006/main">
+            <a:pPr algn="l">
+              <a:defRPr sz="1125" b="0">
+                <a:solidFill>
+                  <a:srgbClr val="334155"/>
+                </a:solidFill>
+              </a:defRPr>
+            </a:pPr>
+            <a:r>
+              <a:rPr sz="1125" b="0">
+                <a:solidFill>
+                  <a:srgbClr val="334155"/>
+                </a:solidFill>
+              </a:rPr>
+              <a:t>lets urgent agents preempt low-value movement</a:t>
+            </a:r>
+          </a:p>
+        </p:txBody>
+      </p:sp>
+      <p:sp>
+        <p:nvSpPr>
+          <p:cNvPr id="22" name="">
+            <a:extLst xmlns:a="http://schemas.openxmlformats.org/drawingml/2006/main">
+              <a:ext uri="{FF2B5EF4-FFF2-40B4-BE49-F238E27FC236}">
+                <a16:creationId xmlns:a16="http://schemas.microsoft.com/office/drawing/2014/main" id="{293005FE-C61F-4419-BFE7-7A9789E0CCDC}"/>
+              </a:ext>
+            </a:extLst>
+          </p:cNvPr>
+          <p:cNvSpPr>
+            <a:spLocks xmlns:a="http://schemas.openxmlformats.org/drawingml/2006/main" noGrp="1"/>
+          </p:cNvSpPr>
+          <p:nvPr/>
+        </p:nvSpPr>
+        <p:spPr>
+          <a:xfrm xmlns:a="http://schemas.openxmlformats.org/drawingml/2006/main">
+            <a:off x="9124950" y="3209925"/>
+            <a:ext cx="2209800" cy="495300"/>
+          </a:xfrm>
+          <a:prstGeom xmlns:a="http://schemas.openxmlformats.org/drawingml/2006/main" prst="rect">
+            <a:avLst/>
+          </a:prstGeom>
+          <a:noFill xmlns:a="http://schemas.openxmlformats.org/drawingml/2006/main"/>
+          <a:ln xmlns:a="http://schemas.openxmlformats.org/drawingml/2006/main" w="0">
+            <a:noFill/>
+            <a:prstDash val="solid"/>
+          </a:ln>
+        </p:spPr>
+        <p:txBody>
+          <a:bodyPr xmlns:a="http://schemas.openxmlformats.org/drawingml/2006/main" anchor="ctr"/>
+          <a:lstStyle xmlns:a="http://schemas.openxmlformats.org/drawingml/2006/main"/>
+          <a:p xmlns:a="http://schemas.openxmlformats.org/drawingml/2006/main">
+            <a:pPr algn="l">
+              <a:defRPr sz="1125" b="1">
+                <a:solidFill>
+                  <a:srgbClr val="16A34A"/>
+                </a:solidFill>
+              </a:defRPr>
+            </a:pPr>
+            <a:r>
+              <a:rPr sz="1125" b="1">
+                <a:solidFill>
+                  <a:srgbClr val="16A34A"/>
+                </a:solidFill>
+              </a:rPr>
+              <a:t>20-50% fewer late reloads</a:t>
+            </a:r>
+          </a:p>
+        </p:txBody>
+      </p:sp>
+      <p:sp>
+        <p:nvSpPr>
+          <p:cNvPr id="23" name="">
+            <a:extLst xmlns:a="http://schemas.openxmlformats.org/drawingml/2006/main">
+              <a:ext uri="{FF2B5EF4-FFF2-40B4-BE49-F238E27FC236}">
+                <a16:creationId xmlns:a16="http://schemas.microsoft.com/office/drawing/2014/main" id="{60531866-68C7-47EF-B369-094086949282}"/>
+              </a:ext>
+            </a:extLst>
+          </p:cNvPr>
+          <p:cNvSpPr>
+            <a:spLocks xmlns:a="http://schemas.openxmlformats.org/drawingml/2006/main" noGrp="1"/>
+          </p:cNvSpPr>
+          <p:nvPr/>
+        </p:nvSpPr>
+        <p:spPr>
+          <a:xfrm xmlns:a="http://schemas.openxmlformats.org/drawingml/2006/main">
+            <a:off x="514350" y="3752850"/>
+            <a:ext cx="10906125" cy="628650"/>
+          </a:xfrm>
+          <a:prstGeom xmlns:a="http://schemas.openxmlformats.org/drawingml/2006/main" prst="rect">
+            <a:avLst/>
+          </a:prstGeom>
+          <a:solidFill xmlns:a="http://schemas.openxmlformats.org/drawingml/2006/main">
+            <a:srgbClr val="F8FAFC"/>
+          </a:solidFill>
+          <a:ln xmlns:a="http://schemas.openxmlformats.org/drawingml/2006/main" w="7620">
+            <a:solidFill>
+              <a:srgbClr val="CBD5E1"/>
+            </a:solidFill>
+            <a:prstDash val="solid"/>
+          </a:ln>
+        </p:spPr>
+      </p:sp>
+      <p:sp>
+        <p:nvSpPr>
+          <p:cNvPr id="24" name="">
+            <a:extLst xmlns:a="http://schemas.openxmlformats.org/drawingml/2006/main">
+              <a:ext uri="{FF2B5EF4-FFF2-40B4-BE49-F238E27FC236}">
+                <a16:creationId xmlns:a16="http://schemas.microsoft.com/office/drawing/2014/main" id="{3B0F4BC0-95FC-4922-AADB-B914F2CD58D1}"/>
+              </a:ext>
+            </a:extLst>
+          </p:cNvPr>
+          <p:cNvSpPr>
+            <a:spLocks xmlns:a="http://schemas.openxmlformats.org/drawingml/2006/main" noGrp="1"/>
+          </p:cNvSpPr>
+          <p:nvPr/>
+        </p:nvSpPr>
+        <p:spPr>
+          <a:xfrm xmlns:a="http://schemas.openxmlformats.org/drawingml/2006/main">
+            <a:off x="600075" y="3838575"/>
+            <a:ext cx="2305050" cy="495300"/>
+          </a:xfrm>
+          <a:prstGeom xmlns:a="http://schemas.openxmlformats.org/drawingml/2006/main" prst="rect">
+            <a:avLst/>
+          </a:prstGeom>
+          <a:noFill xmlns:a="http://schemas.openxmlformats.org/drawingml/2006/main"/>
+          <a:ln xmlns:a="http://schemas.openxmlformats.org/drawingml/2006/main" w="0">
+            <a:noFill/>
+            <a:prstDash val="solid"/>
+          </a:ln>
+        </p:spPr>
+        <p:txBody>
+          <a:bodyPr xmlns:a="http://schemas.openxmlformats.org/drawingml/2006/main" anchor="ctr"/>
+          <a:lstStyle xmlns:a="http://schemas.openxmlformats.org/drawingml/2006/main"/>
+          <a:p xmlns:a="http://schemas.openxmlformats.org/drawingml/2006/main">
+            <a:pPr algn="l">
+              <a:defRPr sz="1125" b="1">
+                <a:solidFill>
+                  <a:srgbClr val="0891B2"/>
+                </a:solidFill>
+              </a:defRPr>
+            </a:pPr>
+            <a:r>
+              <a:rPr sz="1125" b="1">
+                <a:solidFill>
+                  <a:srgbClr val="0891B2"/>
+                </a:solidFill>
+              </a:rPr>
+              <a:t>Useful prefetch is wasted</a:t>
+            </a:r>
+          </a:p>
+        </p:txBody>
+      </p:sp>
+      <p:sp>
+        <p:nvSpPr>
+          <p:cNvPr id="25" name="">
+            <a:extLst xmlns:a="http://schemas.openxmlformats.org/drawingml/2006/main">
+              <a:ext uri="{FF2B5EF4-FFF2-40B4-BE49-F238E27FC236}">
+                <a16:creationId xmlns:a16="http://schemas.microsoft.com/office/drawing/2014/main" id="{E338A250-3F34-41EB-95BE-DB3AEABF20AC}"/>
+              </a:ext>
+            </a:extLst>
+          </p:cNvPr>
+          <p:cNvSpPr>
+            <a:spLocks xmlns:a="http://schemas.openxmlformats.org/drawingml/2006/main" noGrp="1"/>
+          </p:cNvSpPr>
+          <p:nvPr/>
+        </p:nvSpPr>
+        <p:spPr>
+          <a:xfrm xmlns:a="http://schemas.openxmlformats.org/drawingml/2006/main">
+            <a:off x="3076575" y="3838575"/>
+            <a:ext cx="2209800" cy="495300"/>
+          </a:xfrm>
+          <a:prstGeom xmlns:a="http://schemas.openxmlformats.org/drawingml/2006/main" prst="rect">
+            <a:avLst/>
+          </a:prstGeom>
+          <a:noFill xmlns:a="http://schemas.openxmlformats.org/drawingml/2006/main"/>
+          <a:ln xmlns:a="http://schemas.openxmlformats.org/drawingml/2006/main" w="0">
+            <a:noFill/>
+            <a:prstDash val="solid"/>
+          </a:ln>
+        </p:spPr>
+        <p:txBody>
+          <a:bodyPr xmlns:a="http://schemas.openxmlformats.org/drawingml/2006/main" anchor="ctr"/>
+          <a:lstStyle xmlns:a="http://schemas.openxmlformats.org/drawingml/2006/main"/>
+          <a:p xmlns:a="http://schemas.openxmlformats.org/drawingml/2006/main">
+            <a:pPr algn="l">
+              <a:defRPr sz="1125" b="0">
+                <a:solidFill>
+                  <a:srgbClr val="334155"/>
+                </a:solidFill>
+              </a:defRPr>
+            </a:pPr>
+            <a:r>
+              <a:rPr sz="1125" b="0">
+                <a:solidFill>
+                  <a:srgbClr val="334155"/>
+                </a:solidFill>
+              </a:rPr>
+              <a:t>KV-aware telemetry</a:t>
+            </a:r>
+          </a:p>
+        </p:txBody>
+      </p:sp>
+      <p:sp>
+        <p:nvSpPr>
+          <p:cNvPr id="26" name="">
+            <a:extLst xmlns:a="http://schemas.openxmlformats.org/drawingml/2006/main">
+              <a:ext uri="{FF2B5EF4-FFF2-40B4-BE49-F238E27FC236}">
+                <a16:creationId xmlns:a16="http://schemas.microsoft.com/office/drawing/2014/main" id="{DBEEC0E7-FA74-4B64-9821-799B51DC5FE8}"/>
+              </a:ext>
+            </a:extLst>
+          </p:cNvPr>
+          <p:cNvSpPr>
+            <a:spLocks xmlns:a="http://schemas.openxmlformats.org/drawingml/2006/main" noGrp="1"/>
+          </p:cNvSpPr>
+          <p:nvPr/>
+        </p:nvSpPr>
+        <p:spPr>
+          <a:xfrm xmlns:a="http://schemas.openxmlformats.org/drawingml/2006/main">
+            <a:off x="5457825" y="3838575"/>
+            <a:ext cx="3495675" cy="495300"/>
+          </a:xfrm>
+          <a:prstGeom xmlns:a="http://schemas.openxmlformats.org/drawingml/2006/main" prst="rect">
+            <a:avLst/>
+          </a:prstGeom>
+          <a:noFill xmlns:a="http://schemas.openxmlformats.org/drawingml/2006/main"/>
+          <a:ln xmlns:a="http://schemas.openxmlformats.org/drawingml/2006/main" w="0">
+            <a:noFill/>
+            <a:prstDash val="solid"/>
+          </a:ln>
+        </p:spPr>
+        <p:txBody>
+          <a:bodyPr xmlns:a="http://schemas.openxmlformats.org/drawingml/2006/main" anchor="ctr"/>
+          <a:lstStyle xmlns:a="http://schemas.openxmlformats.org/drawingml/2006/main"/>
+          <a:p xmlns:a="http://schemas.openxmlformats.org/drawingml/2006/main">
+            <a:pPr algn="l">
+              <a:defRPr sz="1125" b="0">
+                <a:solidFill>
+                  <a:srgbClr val="334155"/>
+                </a:solidFill>
+              </a:defRPr>
+            </a:pPr>
+            <a:r>
+              <a:rPr sz="1125" b="0">
+                <a:solidFill>
+                  <a:srgbClr val="334155"/>
+                </a:solidFill>
+              </a:rPr>
+              <a:t>detects late, wasted, and evicted-before-use KV</a:t>
+            </a:r>
+          </a:p>
+        </p:txBody>
+      </p:sp>
+      <p:sp>
+        <p:nvSpPr>
+          <p:cNvPr id="27" name="">
+            <a:extLst xmlns:a="http://schemas.openxmlformats.org/drawingml/2006/main">
+              <a:ext uri="{FF2B5EF4-FFF2-40B4-BE49-F238E27FC236}">
+                <a16:creationId xmlns:a16="http://schemas.microsoft.com/office/drawing/2014/main" id="{84D1EA7E-03F6-4715-8325-C6E0DA1F4F53}"/>
+              </a:ext>
+            </a:extLst>
+          </p:cNvPr>
+          <p:cNvSpPr>
+            <a:spLocks xmlns:a="http://schemas.openxmlformats.org/drawingml/2006/main" noGrp="1"/>
+          </p:cNvSpPr>
+          <p:nvPr/>
+        </p:nvSpPr>
+        <p:spPr>
+          <a:xfrm xmlns:a="http://schemas.openxmlformats.org/drawingml/2006/main">
+            <a:off x="9124950" y="3838575"/>
+            <a:ext cx="2209800" cy="495300"/>
+          </a:xfrm>
+          <a:prstGeom xmlns:a="http://schemas.openxmlformats.org/drawingml/2006/main" prst="rect">
+            <a:avLst/>
+          </a:prstGeom>
+          <a:noFill xmlns:a="http://schemas.openxmlformats.org/drawingml/2006/main"/>
+          <a:ln xmlns:a="http://schemas.openxmlformats.org/drawingml/2006/main" w="0">
+            <a:noFill/>
+            <a:prstDash val="solid"/>
+          </a:ln>
+        </p:spPr>
+        <p:txBody>
+          <a:bodyPr xmlns:a="http://schemas.openxmlformats.org/drawingml/2006/main" anchor="ctr"/>
+          <a:lstStyle xmlns:a="http://schemas.openxmlformats.org/drawingml/2006/main"/>
+          <a:p xmlns:a="http://schemas.openxmlformats.org/drawingml/2006/main">
+            <a:pPr algn="l">
+              <a:defRPr sz="1125" b="1">
+                <a:solidFill>
+                  <a:srgbClr val="0891B2"/>
+                </a:solidFill>
+              </a:defRPr>
+            </a:pPr>
+            <a:r>
+              <a:rPr sz="1125" b="1">
+                <a:solidFill>
+                  <a:srgbClr val="0891B2"/>
+                </a:solidFill>
+              </a:rPr>
+              <a:t>less bandwidth waste</a:t>
+            </a:r>
+          </a:p>
+        </p:txBody>
+      </p:sp>
+      <p:sp>
+        <p:nvSpPr>
+          <p:cNvPr id="28" name="">
+            <a:extLst xmlns:a="http://schemas.openxmlformats.org/drawingml/2006/main">
+              <a:ext uri="{FF2B5EF4-FFF2-40B4-BE49-F238E27FC236}">
+                <a16:creationId xmlns:a16="http://schemas.microsoft.com/office/drawing/2014/main" id="{6B1E9538-3885-4B5E-A4F9-760C0697A257}"/>
+              </a:ext>
+            </a:extLst>
+          </p:cNvPr>
+          <p:cNvSpPr>
+            <a:spLocks xmlns:a="http://schemas.openxmlformats.org/drawingml/2006/main" noGrp="1"/>
+          </p:cNvSpPr>
+          <p:nvPr/>
+        </p:nvSpPr>
+        <p:spPr>
+          <a:xfrm xmlns:a="http://schemas.openxmlformats.org/drawingml/2006/main">
+            <a:off x="609600" y="4591050"/>
+            <a:ext cx="2381250" cy="266700"/>
+          </a:xfrm>
+          <a:prstGeom xmlns:a="http://schemas.openxmlformats.org/drawingml/2006/main" prst="rect">
+            <a:avLst/>
+          </a:prstGeom>
+          <a:noFill xmlns:a="http://schemas.openxmlformats.org/drawingml/2006/main"/>
+          <a:ln xmlns:a="http://schemas.openxmlformats.org/drawingml/2006/main" w="0">
+            <a:noFill/>
+            <a:prstDash val="solid"/>
+          </a:ln>
+        </p:spPr>
+        <p:txBody>
+          <a:bodyPr xmlns:a="http://schemas.openxmlformats.org/drawingml/2006/main" anchor="t"/>
+          <a:lstStyle xmlns:a="http://schemas.openxmlformats.org/drawingml/2006/main"/>
+          <a:p xmlns:a="http://schemas.openxmlformats.org/drawingml/2006/main">
+            <a:pPr algn="l">
+              <a:defRPr sz="1500" b="1">
+                <a:solidFill>
+                  <a:srgbClr val="0F172A"/>
+                </a:solidFill>
+              </a:defRPr>
+            </a:pPr>
+            <a:r>
+              <a:rPr sz="1500" b="1">
+                <a:solidFill>
+                  <a:srgbClr val="0F172A"/>
+                </a:solidFill>
+              </a:rPr>
+              <a:t>Range rationale</a:t>
+            </a:r>
+          </a:p>
+        </p:txBody>
+      </p:sp>
+      <p:sp>
+        <p:nvSpPr>
+          <p:cNvPr id="29" name="">
+            <a:extLst xmlns:a="http://schemas.openxmlformats.org/drawingml/2006/main">
+              <a:ext uri="{FF2B5EF4-FFF2-40B4-BE49-F238E27FC236}">
+                <a16:creationId xmlns:a16="http://schemas.microsoft.com/office/drawing/2014/main" id="{6B852242-037E-4AD6-BD2A-1709DD5294EB}"/>
+              </a:ext>
+            </a:extLst>
+          </p:cNvPr>
+          <p:cNvSpPr>
+            <a:spLocks xmlns:a="http://schemas.openxmlformats.org/drawingml/2006/main" noGrp="1"/>
+          </p:cNvSpPr>
+          <p:nvPr/>
+        </p:nvSpPr>
+        <p:spPr>
+          <a:xfrm xmlns:a="http://schemas.openxmlformats.org/drawingml/2006/main">
+            <a:off x="609600" y="4857750"/>
+            <a:ext cx="10668000" cy="323850"/>
+          </a:xfrm>
+          <a:prstGeom xmlns:a="http://schemas.openxmlformats.org/drawingml/2006/main" prst="rect">
+            <a:avLst/>
+          </a:prstGeom>
+          <a:solidFill xmlns:a="http://schemas.openxmlformats.org/drawingml/2006/main">
+            <a:srgbClr val="F1F5F9"/>
+          </a:solidFill>
+          <a:ln xmlns:a="http://schemas.openxmlformats.org/drawingml/2006/main" w="9525">
+            <a:solidFill>
+              <a:srgbClr val="CBD5E1"/>
+            </a:solidFill>
+            <a:prstDash val="solid"/>
+          </a:ln>
+        </p:spPr>
+      </p:sp>
+      <p:sp>
+        <p:nvSpPr>
+          <p:cNvPr id="30" name="">
+            <a:extLst xmlns:a="http://schemas.openxmlformats.org/drawingml/2006/main">
+              <a:ext uri="{FF2B5EF4-FFF2-40B4-BE49-F238E27FC236}">
+                <a16:creationId xmlns:a16="http://schemas.microsoft.com/office/drawing/2014/main" id="{FAD62488-C574-4F7A-8D30-CACAA71337DF}"/>
+              </a:ext>
+            </a:extLst>
+          </p:cNvPr>
+          <p:cNvSpPr>
+            <a:spLocks xmlns:a="http://schemas.openxmlformats.org/drawingml/2006/main" noGrp="1"/>
+          </p:cNvSpPr>
+          <p:nvPr/>
+        </p:nvSpPr>
+        <p:spPr>
+          <a:xfrm xmlns:a="http://schemas.openxmlformats.org/drawingml/2006/main">
+            <a:off x="695325" y="4953000"/>
+            <a:ext cx="2019300" cy="209550"/>
+          </a:xfrm>
+          <a:prstGeom xmlns:a="http://schemas.openxmlformats.org/drawingml/2006/main" prst="rect">
+            <a:avLst/>
+          </a:prstGeom>
+          <a:noFill xmlns:a="http://schemas.openxmlformats.org/drawingml/2006/main"/>
+          <a:ln xmlns:a="http://schemas.openxmlformats.org/drawingml/2006/main" w="0">
+            <a:noFill/>
+            <a:prstDash val="solid"/>
+          </a:ln>
+        </p:spPr>
+        <p:txBody>
+          <a:bodyPr xmlns:a="http://schemas.openxmlformats.org/drawingml/2006/main" anchor="ctr"/>
+          <a:lstStyle xmlns:a="http://schemas.openxmlformats.org/drawingml/2006/main"/>
+          <a:p xmlns:a="http://schemas.openxmlformats.org/drawingml/2006/main">
+            <a:pPr algn="l">
+              <a:defRPr sz="1050" b="1">
+                <a:solidFill>
+                  <a:srgbClr val="0F172A"/>
+                </a:solidFill>
+              </a:defRPr>
+            </a:pPr>
+            <a:r>
+              <a:rPr sz="1050" b="1">
+                <a:solidFill>
+                  <a:srgbClr val="0F172A"/>
+                </a:solidFill>
+              </a:rPr>
+              <a:t>Range</a:t>
+            </a:r>
+          </a:p>
+        </p:txBody>
+      </p:sp>
+      <p:sp>
+        <p:nvSpPr>
+          <p:cNvPr id="31" name="">
+            <a:extLst xmlns:a="http://schemas.openxmlformats.org/drawingml/2006/main">
+              <a:ext uri="{FF2B5EF4-FFF2-40B4-BE49-F238E27FC236}">
+                <a16:creationId xmlns:a16="http://schemas.microsoft.com/office/drawing/2014/main" id="{E3355BC7-3D95-42D0-85AC-F85F37A39D60}"/>
+              </a:ext>
+            </a:extLst>
+          </p:cNvPr>
+          <p:cNvSpPr>
+            <a:spLocks xmlns:a="http://schemas.openxmlformats.org/drawingml/2006/main" noGrp="1"/>
+          </p:cNvSpPr>
+          <p:nvPr/>
+        </p:nvSpPr>
+        <p:spPr>
+          <a:xfrm xmlns:a="http://schemas.openxmlformats.org/drawingml/2006/main">
+            <a:off x="2886075" y="4953000"/>
+            <a:ext cx="4591050" cy="209550"/>
+          </a:xfrm>
+          <a:prstGeom xmlns:a="http://schemas.openxmlformats.org/drawingml/2006/main" prst="rect">
+            <a:avLst/>
+          </a:prstGeom>
+          <a:noFill xmlns:a="http://schemas.openxmlformats.org/drawingml/2006/main"/>
+          <a:ln xmlns:a="http://schemas.openxmlformats.org/drawingml/2006/main" w="0">
+            <a:noFill/>
+            <a:prstDash val="solid"/>
+          </a:ln>
+        </p:spPr>
+        <p:txBody>
+          <a:bodyPr xmlns:a="http://schemas.openxmlformats.org/drawingml/2006/main" anchor="ctr"/>
+          <a:lstStyle xmlns:a="http://schemas.openxmlformats.org/drawingml/2006/main"/>
+          <a:p xmlns:a="http://schemas.openxmlformats.org/drawingml/2006/main">
+            <a:pPr algn="l">
+              <a:defRPr sz="1050" b="1">
+                <a:solidFill>
+                  <a:srgbClr val="0F172A"/>
+                </a:solidFill>
+              </a:defRPr>
+            </a:pPr>
+            <a:r>
+              <a:rPr sz="1050" b="1">
+                <a:solidFill>
+                  <a:srgbClr val="0F172A"/>
+                </a:solidFill>
+              </a:rPr>
+              <a:t>When it applies</a:t>
+            </a:r>
+          </a:p>
+        </p:txBody>
+      </p:sp>
+      <p:sp>
+        <p:nvSpPr>
+          <p:cNvPr id="32" name="">
+            <a:extLst xmlns:a="http://schemas.openxmlformats.org/drawingml/2006/main">
+              <a:ext uri="{FF2B5EF4-FFF2-40B4-BE49-F238E27FC236}">
+                <a16:creationId xmlns:a16="http://schemas.microsoft.com/office/drawing/2014/main" id="{36C27F19-E49F-4D71-8229-6BCF30BA4766}"/>
+              </a:ext>
+            </a:extLst>
+          </p:cNvPr>
+          <p:cNvSpPr>
+            <a:spLocks xmlns:a="http://schemas.openxmlformats.org/drawingml/2006/main" noGrp="1"/>
+          </p:cNvSpPr>
+          <p:nvPr/>
+        </p:nvSpPr>
+        <p:spPr>
+          <a:xfrm xmlns:a="http://schemas.openxmlformats.org/drawingml/2006/main">
+            <a:off x="7648575" y="4953000"/>
+            <a:ext cx="3543300" cy="209550"/>
+          </a:xfrm>
+          <a:prstGeom xmlns:a="http://schemas.openxmlformats.org/drawingml/2006/main" prst="rect">
+            <a:avLst/>
+          </a:prstGeom>
+          <a:noFill xmlns:a="http://schemas.openxmlformats.org/drawingml/2006/main"/>
+          <a:ln xmlns:a="http://schemas.openxmlformats.org/drawingml/2006/main" w="0">
+            <a:noFill/>
+            <a:prstDash val="solid"/>
+          </a:ln>
+        </p:spPr>
+        <p:txBody>
+          <a:bodyPr xmlns:a="http://schemas.openxmlformats.org/drawingml/2006/main" anchor="ctr"/>
+          <a:lstStyle xmlns:a="http://schemas.openxmlformats.org/drawingml/2006/main"/>
+          <a:p xmlns:a="http://schemas.openxmlformats.org/drawingml/2006/main">
+            <a:pPr algn="l">
+              <a:defRPr sz="1050" b="1">
+                <a:solidFill>
+                  <a:srgbClr val="0F172A"/>
+                </a:solidFill>
+              </a:defRPr>
+            </a:pPr>
+            <a:r>
+              <a:rPr sz="1050" b="1">
+                <a:solidFill>
+                  <a:srgbClr val="0F172A"/>
+                </a:solidFill>
+              </a:rPr>
+              <a:t>Reason</a:t>
+            </a:r>
+          </a:p>
+        </p:txBody>
+      </p:sp>
+      <p:sp>
+        <p:nvSpPr>
+          <p:cNvPr id="33" name="">
+            <a:extLst xmlns:a="http://schemas.openxmlformats.org/drawingml/2006/main">
+              <a:ext uri="{FF2B5EF4-FFF2-40B4-BE49-F238E27FC236}">
+                <a16:creationId xmlns:a16="http://schemas.microsoft.com/office/drawing/2014/main" id="{ABF17381-88CB-45DA-961D-470E12EF03FE}"/>
+              </a:ext>
+            </a:extLst>
+          </p:cNvPr>
+          <p:cNvSpPr>
+            <a:spLocks xmlns:a="http://schemas.openxmlformats.org/drawingml/2006/main" noGrp="1"/>
+          </p:cNvSpPr>
+          <p:nvPr/>
+        </p:nvSpPr>
+        <p:spPr>
+          <a:xfrm xmlns:a="http://schemas.openxmlformats.org/drawingml/2006/main">
+            <a:off x="609600" y="5181600"/>
+            <a:ext cx="10668000" cy="361950"/>
+          </a:xfrm>
+          <a:prstGeom xmlns:a="http://schemas.openxmlformats.org/drawingml/2006/main" prst="rect">
+            <a:avLst/>
+          </a:prstGeom>
+          <a:solidFill xmlns:a="http://schemas.openxmlformats.org/drawingml/2006/main">
+            <a:srgbClr val="FFFFFF"/>
+          </a:solidFill>
+          <a:ln xmlns:a="http://schemas.openxmlformats.org/drawingml/2006/main" w="7620">
+            <a:solidFill>
+              <a:srgbClr val="CBD5E1"/>
+            </a:solidFill>
+            <a:prstDash val="solid"/>
+          </a:ln>
+        </p:spPr>
+      </p:sp>
+      <p:sp>
+        <p:nvSpPr>
+          <p:cNvPr id="34" name="">
+            <a:extLst xmlns:a="http://schemas.openxmlformats.org/drawingml/2006/main">
+              <a:ext uri="{FF2B5EF4-FFF2-40B4-BE49-F238E27FC236}">
+                <a16:creationId xmlns:a16="http://schemas.microsoft.com/office/drawing/2014/main" id="{D3E75873-5A83-40D1-B44B-E350B69E6671}"/>
+              </a:ext>
+            </a:extLst>
+          </p:cNvPr>
+          <p:cNvSpPr>
+            <a:spLocks xmlns:a="http://schemas.openxmlformats.org/drawingml/2006/main" noGrp="1"/>
+          </p:cNvSpPr>
+          <p:nvPr/>
+        </p:nvSpPr>
+        <p:spPr>
+          <a:xfrm xmlns:a="http://schemas.openxmlformats.org/drawingml/2006/main">
+            <a:off x="695325" y="5267325"/>
+            <a:ext cx="2019300" cy="228600"/>
+          </a:xfrm>
+          <a:prstGeom xmlns:a="http://schemas.openxmlformats.org/drawingml/2006/main" prst="rect">
+            <a:avLst/>
+          </a:prstGeom>
+          <a:noFill xmlns:a="http://schemas.openxmlformats.org/drawingml/2006/main"/>
+          <a:ln xmlns:a="http://schemas.openxmlformats.org/drawingml/2006/main" w="0">
+            <a:noFill/>
+            <a:prstDash val="solid"/>
+          </a:ln>
+        </p:spPr>
+        <p:txBody>
+          <a:bodyPr xmlns:a="http://schemas.openxmlformats.org/drawingml/2006/main" anchor="ctr"/>
+          <a:lstStyle xmlns:a="http://schemas.openxmlformats.org/drawingml/2006/main"/>
+          <a:p xmlns:a="http://schemas.openxmlformats.org/drawingml/2006/main">
+            <a:pPr algn="l">
+              <a:defRPr sz="1050" b="1">
+                <a:solidFill>
+                  <a:srgbClr val="2563EB"/>
+                </a:solidFill>
+              </a:defRPr>
+            </a:pPr>
+            <a:r>
+              <a:rPr sz="1050" b="1">
+                <a:solidFill>
+                  <a:srgbClr val="2563EB"/>
+                </a:solidFill>
+              </a:rPr>
+              <a:t>Low end: 10-15%</a:t>
+            </a:r>
+          </a:p>
+        </p:txBody>
+      </p:sp>
+      <p:sp>
+        <p:nvSpPr>
+          <p:cNvPr id="35" name="">
+            <a:extLst xmlns:a="http://schemas.openxmlformats.org/drawingml/2006/main">
+              <a:ext uri="{FF2B5EF4-FFF2-40B4-BE49-F238E27FC236}">
+                <a16:creationId xmlns:a16="http://schemas.microsoft.com/office/drawing/2014/main" id="{98E28E80-1178-4D29-8307-3B099EED6F78}"/>
+              </a:ext>
+            </a:extLst>
+          </p:cNvPr>
+          <p:cNvSpPr>
+            <a:spLocks xmlns:a="http://schemas.openxmlformats.org/drawingml/2006/main" noGrp="1"/>
+          </p:cNvSpPr>
+          <p:nvPr/>
+        </p:nvSpPr>
+        <p:spPr>
+          <a:xfrm xmlns:a="http://schemas.openxmlformats.org/drawingml/2006/main">
+            <a:off x="2886075" y="5267325"/>
+            <a:ext cx="4591050" cy="228600"/>
+          </a:xfrm>
+          <a:prstGeom xmlns:a="http://schemas.openxmlformats.org/drawingml/2006/main" prst="rect">
+            <a:avLst/>
+          </a:prstGeom>
+          <a:noFill xmlns:a="http://schemas.openxmlformats.org/drawingml/2006/main"/>
+          <a:ln xmlns:a="http://schemas.openxmlformats.org/drawingml/2006/main" w="0">
+            <a:noFill/>
+            <a:prstDash val="solid"/>
+          </a:ln>
+        </p:spPr>
+        <p:txBody>
+          <a:bodyPr xmlns:a="http://schemas.openxmlformats.org/drawingml/2006/main" anchor="ctr"/>
+          <a:lstStyle xmlns:a="http://schemas.openxmlformats.org/drawingml/2006/main"/>
+          <a:p xmlns:a="http://schemas.openxmlformats.org/drawingml/2006/main">
+            <a:pPr algn="l">
+              <a:defRPr sz="1050" b="0">
+                <a:solidFill>
+                  <a:srgbClr val="334155"/>
+                </a:solidFill>
+              </a:defRPr>
+            </a:pPr>
+            <a:r>
+              <a:rPr sz="1050" b="0">
+                <a:solidFill>
+                  <a:srgbClr val="334155"/>
+                </a:solidFill>
+              </a:rPr>
+              <a:t>KV is mostly hot, contexts are short, or pressure is light.</a:t>
+            </a:r>
+          </a:p>
+        </p:txBody>
+      </p:sp>
+      <p:sp>
+        <p:nvSpPr>
+          <p:cNvPr id="36" name="">
+            <a:extLst xmlns:a="http://schemas.openxmlformats.org/drawingml/2006/main">
+              <a:ext uri="{FF2B5EF4-FFF2-40B4-BE49-F238E27FC236}">
+                <a16:creationId xmlns:a16="http://schemas.microsoft.com/office/drawing/2014/main" id="{ECBAF44D-5376-4FB1-A561-1C97E755FC10}"/>
+              </a:ext>
+            </a:extLst>
+          </p:cNvPr>
+          <p:cNvSpPr>
+            <a:spLocks xmlns:a="http://schemas.openxmlformats.org/drawingml/2006/main" noGrp="1"/>
+          </p:cNvSpPr>
+          <p:nvPr/>
+        </p:nvSpPr>
+        <p:spPr>
+          <a:xfrm xmlns:a="http://schemas.openxmlformats.org/drawingml/2006/main">
+            <a:off x="7648575" y="5267325"/>
+            <a:ext cx="3543300" cy="228600"/>
+          </a:xfrm>
+          <a:prstGeom xmlns:a="http://schemas.openxmlformats.org/drawingml/2006/main" prst="rect">
+            <a:avLst/>
+          </a:prstGeom>
+          <a:noFill xmlns:a="http://schemas.openxmlformats.org/drawingml/2006/main"/>
+          <a:ln xmlns:a="http://schemas.openxmlformats.org/drawingml/2006/main" w="0">
+            <a:noFill/>
+            <a:prstDash val="solid"/>
+          </a:ln>
+        </p:spPr>
+        <p:txBody>
+          <a:bodyPr xmlns:a="http://schemas.openxmlformats.org/drawingml/2006/main" anchor="ctr"/>
+          <a:lstStyle xmlns:a="http://schemas.openxmlformats.org/drawingml/2006/main"/>
+          <a:p xmlns:a="http://schemas.openxmlformats.org/drawingml/2006/main">
+            <a:pPr algn="l">
+              <a:defRPr sz="1050" b="0">
+                <a:solidFill>
+                  <a:srgbClr val="334155"/>
+                </a:solidFill>
+              </a:defRPr>
+            </a:pPr>
+            <a:r>
+              <a:rPr sz="1050" b="0">
+                <a:solidFill>
+                  <a:srgbClr val="334155"/>
+                </a:solidFill>
+              </a:rPr>
+              <a:t>Hardware mainly removes small replay stalls.</a:t>
+            </a:r>
+          </a:p>
+        </p:txBody>
+      </p:sp>
+      <p:sp>
+        <p:nvSpPr>
+          <p:cNvPr id="37" name="">
+            <a:extLst xmlns:a="http://schemas.openxmlformats.org/drawingml/2006/main">
+              <a:ext uri="{FF2B5EF4-FFF2-40B4-BE49-F238E27FC236}">
+                <a16:creationId xmlns:a16="http://schemas.microsoft.com/office/drawing/2014/main" id="{6BDE23D1-365B-492D-9889-F8706AD0A995}"/>
+              </a:ext>
+            </a:extLst>
+          </p:cNvPr>
+          <p:cNvSpPr>
+            <a:spLocks xmlns:a="http://schemas.openxmlformats.org/drawingml/2006/main" noGrp="1"/>
+          </p:cNvSpPr>
+          <p:nvPr/>
+        </p:nvSpPr>
+        <p:spPr>
+          <a:xfrm xmlns:a="http://schemas.openxmlformats.org/drawingml/2006/main">
+            <a:off x="609600" y="5543550"/>
+            <a:ext cx="10668000" cy="361950"/>
+          </a:xfrm>
+          <a:prstGeom xmlns:a="http://schemas.openxmlformats.org/drawingml/2006/main" prst="rect">
+            <a:avLst/>
+          </a:prstGeom>
+          <a:solidFill xmlns:a="http://schemas.openxmlformats.org/drawingml/2006/main">
+            <a:srgbClr val="F8FAFC"/>
+          </a:solidFill>
+          <a:ln xmlns:a="http://schemas.openxmlformats.org/drawingml/2006/main" w="7620">
+            <a:solidFill>
+              <a:srgbClr val="CBD5E1"/>
+            </a:solidFill>
+            <a:prstDash val="solid"/>
+          </a:ln>
+        </p:spPr>
+      </p:sp>
+      <p:sp>
+        <p:nvSpPr>
+          <p:cNvPr id="38" name="">
+            <a:extLst xmlns:a="http://schemas.openxmlformats.org/drawingml/2006/main">
+              <a:ext uri="{FF2B5EF4-FFF2-40B4-BE49-F238E27FC236}">
+                <a16:creationId xmlns:a16="http://schemas.microsoft.com/office/drawing/2014/main" id="{7BE61C62-835F-4575-83E8-B04EB02CCF05}"/>
+              </a:ext>
+            </a:extLst>
+          </p:cNvPr>
+          <p:cNvSpPr>
+            <a:spLocks xmlns:a="http://schemas.openxmlformats.org/drawingml/2006/main" noGrp="1"/>
+          </p:cNvSpPr>
+          <p:nvPr/>
+        </p:nvSpPr>
+        <p:spPr>
+          <a:xfrm xmlns:a="http://schemas.openxmlformats.org/drawingml/2006/main">
+            <a:off x="695325" y="5629275"/>
+            <a:ext cx="2019300" cy="228600"/>
+          </a:xfrm>
+          <a:prstGeom xmlns:a="http://schemas.openxmlformats.org/drawingml/2006/main" prst="rect">
+            <a:avLst/>
+          </a:prstGeom>
+          <a:noFill xmlns:a="http://schemas.openxmlformats.org/drawingml/2006/main"/>
+          <a:ln xmlns:a="http://schemas.openxmlformats.org/drawingml/2006/main" w="0">
+            <a:noFill/>
+            <a:prstDash val="solid"/>
+          </a:ln>
+        </p:spPr>
+        <p:txBody>
+          <a:bodyPr xmlns:a="http://schemas.openxmlformats.org/drawingml/2006/main" anchor="ctr"/>
+          <a:lstStyle xmlns:a="http://schemas.openxmlformats.org/drawingml/2006/main"/>
+          <a:p xmlns:a="http://schemas.openxmlformats.org/drawingml/2006/main">
+            <a:pPr algn="l">
+              <a:defRPr sz="1050" b="1">
                 <a:solidFill>
                   <a:srgbClr val="DC2626"/>
                 </a:solidFill>
               </a:defRPr>
             </a:pPr>
             <a:r>
-              <a:rPr sz="2025" b="1">
+              <a:rPr sz="1050" b="1">
                 <a:solidFill>
                   <a:srgbClr val="DC2626"/>
                 </a:solidFill>
               </a:rPr>
-              <a:t>•</a:t>
-            </a:r>
-          </a:p>
-        </p:txBody>
-      </p:sp>
-      <p:sp>
-        <p:nvSpPr>
-          <p:cNvPr id="8" name="">
-            <a:extLst xmlns:a="http://schemas.openxmlformats.org/drawingml/2006/main">
-              <a:ext uri="{FF2B5EF4-FFF2-40B4-BE49-F238E27FC236}">
-                <a16:creationId xmlns:a16="http://schemas.microsoft.com/office/drawing/2014/main" id="{4A98A2F2-11A8-4698-92CD-87C5C8C85B08}"/>
-              </a:ext>
-            </a:extLst>
-          </p:cNvPr>
-          <p:cNvSpPr>
-            <a:spLocks xmlns:a="http://schemas.openxmlformats.org/drawingml/2006/main" noGrp="1"/>
-          </p:cNvSpPr>
-          <p:nvPr/>
-        </p:nvSpPr>
-        <p:spPr>
-          <a:xfrm xmlns:a="http://schemas.openxmlformats.org/drawingml/2006/main">
-            <a:off x="1162050" y="2952750"/>
-            <a:ext cx="9715500" cy="514350"/>
-          </a:xfrm>
-          <a:prstGeom xmlns:a="http://schemas.openxmlformats.org/drawingml/2006/main" prst="rect">
-            <a:avLst/>
-          </a:prstGeom>
-          <a:noFill xmlns:a="http://schemas.openxmlformats.org/drawingml/2006/main"/>
-          <a:ln xmlns:a="http://schemas.openxmlformats.org/drawingml/2006/main" w="0">
-            <a:noFill/>
-            <a:prstDash val="solid"/>
-          </a:ln>
-        </p:spPr>
-        <p:txBody>
-          <a:bodyPr xmlns:a="http://schemas.openxmlformats.org/drawingml/2006/main" anchor="t"/>
-          <a:lstStyle xmlns:a="http://schemas.openxmlformats.org/drawingml/2006/main"/>
-          <a:p xmlns:a="http://schemas.openxmlformats.org/drawingml/2006/main">
-            <a:pPr algn="l">
-              <a:defRPr sz="1875" b="0">
+              <a:t>High end: 25-30%+</a:t>
+            </a:r>
+          </a:p>
+        </p:txBody>
+      </p:sp>
+      <p:sp>
+        <p:nvSpPr>
+          <p:cNvPr id="39" name="">
+            <a:extLst xmlns:a="http://schemas.openxmlformats.org/drawingml/2006/main">
+              <a:ext uri="{FF2B5EF4-FFF2-40B4-BE49-F238E27FC236}">
+                <a16:creationId xmlns:a16="http://schemas.microsoft.com/office/drawing/2014/main" id="{2C6C85F1-3AC8-4547-8C0B-2C9FCCF65336}"/>
+              </a:ext>
+            </a:extLst>
+          </p:cNvPr>
+          <p:cNvSpPr>
+            <a:spLocks xmlns:a="http://schemas.openxmlformats.org/drawingml/2006/main" noGrp="1"/>
+          </p:cNvSpPr>
+          <p:nvPr/>
+        </p:nvSpPr>
+        <p:spPr>
+          <a:xfrm xmlns:a="http://schemas.openxmlformats.org/drawingml/2006/main">
+            <a:off x="2886075" y="5629275"/>
+            <a:ext cx="4591050" cy="228600"/>
+          </a:xfrm>
+          <a:prstGeom xmlns:a="http://schemas.openxmlformats.org/drawingml/2006/main" prst="rect">
+            <a:avLst/>
+          </a:prstGeom>
+          <a:noFill xmlns:a="http://schemas.openxmlformats.org/drawingml/2006/main"/>
+          <a:ln xmlns:a="http://schemas.openxmlformats.org/drawingml/2006/main" w="0">
+            <a:noFill/>
+            <a:prstDash val="solid"/>
+          </a:ln>
+        </p:spPr>
+        <p:txBody>
+          <a:bodyPr xmlns:a="http://schemas.openxmlformats.org/drawingml/2006/main" anchor="ctr"/>
+          <a:lstStyle xmlns:a="http://schemas.openxmlformats.org/drawingml/2006/main"/>
+          <a:p xmlns:a="http://schemas.openxmlformats.org/drawingml/2006/main">
+            <a:pPr algn="l">
+              <a:defRPr sz="1050" b="0">
                 <a:solidFill>
                   <a:srgbClr val="334155"/>
                 </a:solidFill>
               </a:defRPr>
             </a:pPr>
             <a:r>
-              <a:rPr sz="1875" b="0">
+              <a:rPr sz="1050" b="0">
                 <a:solidFill>
                   <a:srgbClr val="334155"/>
                 </a:solidFill>
               </a:rPr>
-              <a:t>Lower tail latency by prioritizing soon-resuming agent sessions.</a:t>
-            </a:r>
-          </a:p>
-        </p:txBody>
-      </p:sp>
-      <p:sp>
-        <p:nvSpPr>
-          <p:cNvPr id="9" name="">
-            <a:extLst xmlns:a="http://schemas.openxmlformats.org/drawingml/2006/main">
-              <a:ext uri="{FF2B5EF4-FFF2-40B4-BE49-F238E27FC236}">
-                <a16:creationId xmlns:a16="http://schemas.microsoft.com/office/drawing/2014/main" id="{8F38DFD5-1B17-4D4F-BC77-6F39BFD670E8}"/>
-              </a:ext>
-            </a:extLst>
-          </p:cNvPr>
-          <p:cNvSpPr>
-            <a:spLocks xmlns:a="http://schemas.openxmlformats.org/drawingml/2006/main" noGrp="1"/>
-          </p:cNvSpPr>
-          <p:nvPr/>
-        </p:nvSpPr>
-        <p:spPr>
-          <a:xfrm xmlns:a="http://schemas.openxmlformats.org/drawingml/2006/main">
-            <a:off x="876300" y="3619500"/>
-            <a:ext cx="190500" cy="304800"/>
-          </a:xfrm>
-          <a:prstGeom xmlns:a="http://schemas.openxmlformats.org/drawingml/2006/main" prst="rect">
-            <a:avLst/>
-          </a:prstGeom>
-          <a:noFill xmlns:a="http://schemas.openxmlformats.org/drawingml/2006/main"/>
-          <a:ln xmlns:a="http://schemas.openxmlformats.org/drawingml/2006/main" w="0">
-            <a:noFill/>
-            <a:prstDash val="solid"/>
-          </a:ln>
-        </p:spPr>
-        <p:txBody>
-          <a:bodyPr xmlns:a="http://schemas.openxmlformats.org/drawingml/2006/main" anchor="t"/>
-          <a:lstStyle xmlns:a="http://schemas.openxmlformats.org/drawingml/2006/main"/>
-          <a:p xmlns:a="http://schemas.openxmlformats.org/drawingml/2006/main">
-            <a:pPr algn="l">
-              <a:defRPr sz="2025" b="1">
-                <a:solidFill>
-                  <a:srgbClr val="0891B2"/>
-                </a:solidFill>
-              </a:defRPr>
-            </a:pPr>
-            <a:r>
-              <a:rPr sz="2025" b="1">
-                <a:solidFill>
-                  <a:srgbClr val="0891B2"/>
-                </a:solidFill>
-              </a:rPr>
-              <a:t>•</a:t>
-            </a:r>
-          </a:p>
-        </p:txBody>
-      </p:sp>
-      <p:sp>
-        <p:nvSpPr>
-          <p:cNvPr id="10" name="">
-            <a:extLst xmlns:a="http://schemas.openxmlformats.org/drawingml/2006/main">
-              <a:ext uri="{FF2B5EF4-FFF2-40B4-BE49-F238E27FC236}">
-                <a16:creationId xmlns:a16="http://schemas.microsoft.com/office/drawing/2014/main" id="{36B49A24-00E6-450A-B223-24B8C5ED0D7D}"/>
-              </a:ext>
-            </a:extLst>
-          </p:cNvPr>
-          <p:cNvSpPr>
-            <a:spLocks xmlns:a="http://schemas.openxmlformats.org/drawingml/2006/main" noGrp="1"/>
-          </p:cNvSpPr>
-          <p:nvPr/>
-        </p:nvSpPr>
-        <p:spPr>
-          <a:xfrm xmlns:a="http://schemas.openxmlformats.org/drawingml/2006/main">
-            <a:off x="1162050" y="3638550"/>
-            <a:ext cx="9715500" cy="514350"/>
-          </a:xfrm>
-          <a:prstGeom xmlns:a="http://schemas.openxmlformats.org/drawingml/2006/main" prst="rect">
-            <a:avLst/>
-          </a:prstGeom>
-          <a:noFill xmlns:a="http://schemas.openxmlformats.org/drawingml/2006/main"/>
-          <a:ln xmlns:a="http://schemas.openxmlformats.org/drawingml/2006/main" w="0">
-            <a:noFill/>
-            <a:prstDash val="solid"/>
-          </a:ln>
-        </p:spPr>
-        <p:txBody>
-          <a:bodyPr xmlns:a="http://schemas.openxmlformats.org/drawingml/2006/main" anchor="t"/>
-          <a:lstStyle xmlns:a="http://schemas.openxmlformats.org/drawingml/2006/main"/>
-          <a:p xmlns:a="http://schemas.openxmlformats.org/drawingml/2006/main">
-            <a:pPr algn="l">
-              <a:defRPr sz="1875" b="0">
+              <a:t>Long contexts, high pressure, frequent offload/reload, or recompute.</a:t>
+            </a:r>
+          </a:p>
+        </p:txBody>
+      </p:sp>
+      <p:sp>
+        <p:nvSpPr>
+          <p:cNvPr id="40" name="">
+            <a:extLst xmlns:a="http://schemas.openxmlformats.org/drawingml/2006/main">
+              <a:ext uri="{FF2B5EF4-FFF2-40B4-BE49-F238E27FC236}">
+                <a16:creationId xmlns:a16="http://schemas.microsoft.com/office/drawing/2014/main" id="{71048D73-7EBF-4C8B-ACB3-6EF2DB3F1FB8}"/>
+              </a:ext>
+            </a:extLst>
+          </p:cNvPr>
+          <p:cNvSpPr>
+            <a:spLocks xmlns:a="http://schemas.openxmlformats.org/drawingml/2006/main" noGrp="1"/>
+          </p:cNvSpPr>
+          <p:nvPr/>
+        </p:nvSpPr>
+        <p:spPr>
+          <a:xfrm xmlns:a="http://schemas.openxmlformats.org/drawingml/2006/main">
+            <a:off x="7648575" y="5629275"/>
+            <a:ext cx="3543300" cy="228600"/>
+          </a:xfrm>
+          <a:prstGeom xmlns:a="http://schemas.openxmlformats.org/drawingml/2006/main" prst="rect">
+            <a:avLst/>
+          </a:prstGeom>
+          <a:noFill xmlns:a="http://schemas.openxmlformats.org/drawingml/2006/main"/>
+          <a:ln xmlns:a="http://schemas.openxmlformats.org/drawingml/2006/main" w="0">
+            <a:noFill/>
+            <a:prstDash val="solid"/>
+          </a:ln>
+        </p:spPr>
+        <p:txBody>
+          <a:bodyPr xmlns:a="http://schemas.openxmlformats.org/drawingml/2006/main" anchor="ctr"/>
+          <a:lstStyle xmlns:a="http://schemas.openxmlformats.org/drawingml/2006/main"/>
+          <a:p xmlns:a="http://schemas.openxmlformats.org/drawingml/2006/main">
+            <a:pPr algn="l">
+              <a:defRPr sz="1050" b="0">
                 <a:solidFill>
                   <a:srgbClr val="334155"/>
                 </a:solidFill>
               </a:defRPr>
             </a:pPr>
             <a:r>
-              <a:rPr sz="1875" b="0">
+              <a:rPr sz="1050" b="0">
                 <a:solidFill>
                   <a:srgbClr val="334155"/>
                 </a:solidFill>
               </a:rPr>
-              <a:t>Less wasted bandwidth by avoiding too-early or evicted-before-use prefetch.</a:t>
-            </a:r>
-          </a:p>
-        </p:txBody>
-      </p:sp>
-      <p:sp>
-        <p:nvSpPr>
-          <p:cNvPr id="11" name="">
-            <a:extLst xmlns:a="http://schemas.openxmlformats.org/drawingml/2006/main">
-              <a:ext uri="{FF2B5EF4-FFF2-40B4-BE49-F238E27FC236}">
-                <a16:creationId xmlns:a16="http://schemas.microsoft.com/office/drawing/2014/main" id="{32057DBB-7140-45F3-83C9-FB1737AE3659}"/>
-              </a:ext>
-            </a:extLst>
-          </p:cNvPr>
-          <p:cNvSpPr>
-            <a:spLocks xmlns:a="http://schemas.openxmlformats.org/drawingml/2006/main" noGrp="1"/>
-          </p:cNvSpPr>
-          <p:nvPr/>
-        </p:nvSpPr>
-        <p:spPr>
-          <a:xfrm xmlns:a="http://schemas.openxmlformats.org/drawingml/2006/main">
-            <a:off x="876300" y="4305300"/>
-            <a:ext cx="190500" cy="304800"/>
-          </a:xfrm>
-          <a:prstGeom xmlns:a="http://schemas.openxmlformats.org/drawingml/2006/main" prst="rect">
-            <a:avLst/>
-          </a:prstGeom>
-          <a:noFill xmlns:a="http://schemas.openxmlformats.org/drawingml/2006/main"/>
-          <a:ln xmlns:a="http://schemas.openxmlformats.org/drawingml/2006/main" w="0">
-            <a:noFill/>
-            <a:prstDash val="solid"/>
-          </a:ln>
-        </p:spPr>
-        <p:txBody>
-          <a:bodyPr xmlns:a="http://schemas.openxmlformats.org/drawingml/2006/main" anchor="t"/>
-          <a:lstStyle xmlns:a="http://schemas.openxmlformats.org/drawingml/2006/main"/>
-          <a:p xmlns:a="http://schemas.openxmlformats.org/drawingml/2006/main">
-            <a:pPr algn="l">
-              <a:defRPr sz="2025" b="1">
-                <a:solidFill>
-                  <a:srgbClr val="16A34A"/>
-                </a:solidFill>
-              </a:defRPr>
-            </a:pPr>
-            <a:r>
-              <a:rPr sz="2025" b="1">
-                <a:solidFill>
-                  <a:srgbClr val="16A34A"/>
-                </a:solidFill>
-              </a:rPr>
-              <a:t>•</a:t>
-            </a:r>
-          </a:p>
-        </p:txBody>
-      </p:sp>
-      <p:sp>
-        <p:nvSpPr>
-          <p:cNvPr id="12" name="">
-            <a:extLst xmlns:a="http://schemas.openxmlformats.org/drawingml/2006/main">
-              <a:ext uri="{FF2B5EF4-FFF2-40B4-BE49-F238E27FC236}">
-                <a16:creationId xmlns:a16="http://schemas.microsoft.com/office/drawing/2014/main" id="{691E0B30-6C14-4A18-8F42-CACC3ADBD9FB}"/>
-              </a:ext>
-            </a:extLst>
-          </p:cNvPr>
-          <p:cNvSpPr>
-            <a:spLocks xmlns:a="http://schemas.openxmlformats.org/drawingml/2006/main" noGrp="1"/>
-          </p:cNvSpPr>
-          <p:nvPr/>
-        </p:nvSpPr>
-        <p:spPr>
-          <a:xfrm xmlns:a="http://schemas.openxmlformats.org/drawingml/2006/main">
-            <a:off x="1162050" y="4324350"/>
-            <a:ext cx="9715500" cy="514350"/>
-          </a:xfrm>
-          <a:prstGeom xmlns:a="http://schemas.openxmlformats.org/drawingml/2006/main" prst="rect">
-            <a:avLst/>
-          </a:prstGeom>
-          <a:noFill xmlns:a="http://schemas.openxmlformats.org/drawingml/2006/main"/>
-          <a:ln xmlns:a="http://schemas.openxmlformats.org/drawingml/2006/main" w="0">
-            <a:noFill/>
-            <a:prstDash val="solid"/>
-          </a:ln>
-        </p:spPr>
-        <p:txBody>
-          <a:bodyPr xmlns:a="http://schemas.openxmlformats.org/drawingml/2006/main" anchor="t"/>
-          <a:lstStyle xmlns:a="http://schemas.openxmlformats.org/drawingml/2006/main"/>
-          <a:p xmlns:a="http://schemas.openxmlformats.org/drawingml/2006/main">
-            <a:pPr algn="l">
-              <a:defRPr sz="1875" b="0">
-                <a:solidFill>
-                  <a:srgbClr val="334155"/>
-                </a:solidFill>
-              </a:defRPr>
-            </a:pPr>
-            <a:r>
-              <a:rPr sz="1875" b="0">
-                <a:solidFill>
-                  <a:srgbClr val="334155"/>
-                </a:solidFill>
-              </a:rPr>
-              <a:t>Better effective HBM use through KV-aware residency and eviction choices.</a:t>
-            </a:r>
-          </a:p>
-        </p:txBody>
-      </p:sp>
-      <p:sp>
-        <p:nvSpPr>
-          <p:cNvPr id="13" name="">
-            <a:extLst xmlns:a="http://schemas.openxmlformats.org/drawingml/2006/main">
-              <a:ext uri="{FF2B5EF4-FFF2-40B4-BE49-F238E27FC236}">
-                <a16:creationId xmlns:a16="http://schemas.microsoft.com/office/drawing/2014/main" id="{A2ACDE22-E435-4A47-BA79-CBC4C3F57866}"/>
-              </a:ext>
-            </a:extLst>
-          </p:cNvPr>
-          <p:cNvSpPr>
-            <a:spLocks xmlns:a="http://schemas.openxmlformats.org/drawingml/2006/main" noGrp="1"/>
-          </p:cNvSpPr>
-          <p:nvPr/>
-        </p:nvSpPr>
-        <p:spPr>
-          <a:xfrm xmlns:a="http://schemas.openxmlformats.org/drawingml/2006/main">
-            <a:off x="419100" y="5429250"/>
-            <a:ext cx="11353800" cy="11430"/>
-          </a:xfrm>
-          <a:prstGeom xmlns:a="http://schemas.openxmlformats.org/drawingml/2006/main" prst="rect">
-            <a:avLst/>
-          </a:prstGeom>
-          <a:solidFill xmlns:a="http://schemas.openxmlformats.org/drawingml/2006/main">
-            <a:srgbClr val="CBD5E1"/>
-          </a:solidFill>
-          <a:ln xmlns:a="http://schemas.openxmlformats.org/drawingml/2006/main" w="0">
-            <a:noFill/>
-            <a:prstDash val="solid"/>
-          </a:ln>
-        </p:spPr>
-      </p:sp>
-      <p:sp>
-        <p:nvSpPr>
-          <p:cNvPr id="14" name="">
-            <a:extLst xmlns:a="http://schemas.openxmlformats.org/drawingml/2006/main">
-              <a:ext uri="{FF2B5EF4-FFF2-40B4-BE49-F238E27FC236}">
-                <a16:creationId xmlns:a16="http://schemas.microsoft.com/office/drawing/2014/main" id="{9597EAE0-7FDC-47BD-94C4-F6CB41DE4630}"/>
-              </a:ext>
-            </a:extLst>
-          </p:cNvPr>
-          <p:cNvSpPr>
-            <a:spLocks xmlns:a="http://schemas.openxmlformats.org/drawingml/2006/main" noGrp="1"/>
-          </p:cNvSpPr>
-          <p:nvPr/>
-        </p:nvSpPr>
-        <p:spPr>
-          <a:xfrm xmlns:a="http://schemas.openxmlformats.org/drawingml/2006/main">
-            <a:off x="876300" y="5657850"/>
+              <a:t>Hardware avoids the expensive replay path.</a:t>
+            </a:r>
+          </a:p>
+        </p:txBody>
+      </p:sp>
+      <p:sp>
+        <p:nvSpPr>
+          <p:cNvPr id="41" name="">
+            <a:extLst xmlns:a="http://schemas.openxmlformats.org/drawingml/2006/main">
+              <a:ext uri="{FF2B5EF4-FFF2-40B4-BE49-F238E27FC236}">
+                <a16:creationId xmlns:a16="http://schemas.microsoft.com/office/drawing/2014/main" id="{3D16E2E6-695B-427B-A2BA-D569A2270624}"/>
+              </a:ext>
+            </a:extLst>
+          </p:cNvPr>
+          <p:cNvSpPr>
+            <a:spLocks xmlns:a="http://schemas.openxmlformats.org/drawingml/2006/main" noGrp="1"/>
+          </p:cNvSpPr>
+          <p:nvPr/>
+        </p:nvSpPr>
+        <p:spPr>
+          <a:xfrm xmlns:a="http://schemas.openxmlformats.org/drawingml/2006/main">
+            <a:off x="876300" y="6029325"/>
             <a:ext cx="9906000" cy="285750"/>
           </a:xfrm>
           <a:prstGeom xmlns:a="http://schemas.openxmlformats.org/drawingml/2006/main" prst="rect">
@@ -4241,29 +5484,29 @@
           <a:lstStyle xmlns:a="http://schemas.openxmlformats.org/drawingml/2006/main"/>
           <a:p xmlns:a="http://schemas.openxmlformats.org/drawingml/2006/main">
             <a:pPr algn="ctr">
-              <a:defRPr sz="1725" b="1">
+              <a:defRPr sz="1425" b="1">
                 <a:solidFill>
                   <a:srgbClr val="0F172A"/>
                 </a:solidFill>
               </a:defRPr>
             </a:pPr>
             <a:r>
-              <a:rPr sz="1725" b="1">
+              <a:rPr sz="1425" b="1">
                 <a:solidFill>
                   <a:srgbClr val="0F172A"/>
                 </a:solidFill>
               </a:rPr>
-              <a:t>The prototype is designed to turn these targets into measured numbers.</a:t>
-            </a:r>
-          </a:p>
-        </p:txBody>
-      </p:sp>
-      <p:sp>
-        <p:nvSpPr>
-          <p:cNvPr id="15" name="">
-            <a:extLst xmlns:a="http://schemas.openxmlformats.org/drawingml/2006/main">
-              <a:ext uri="{FF2B5EF4-FFF2-40B4-BE49-F238E27FC236}">
-                <a16:creationId xmlns:a16="http://schemas.microsoft.com/office/drawing/2014/main" id="{8B3A3CF0-42FB-43DD-B389-E173B458016D}"/>
+              <a:t>Framing: these are conservative research targets; the prototype is meant to turn them into measured numbers.</a:t>
+            </a:r>
+          </a:p>
+        </p:txBody>
+      </p:sp>
+      <p:sp>
+        <p:nvSpPr>
+          <p:cNvPr id="42" name="">
+            <a:extLst xmlns:a="http://schemas.openxmlformats.org/drawingml/2006/main">
+              <a:ext uri="{FF2B5EF4-FFF2-40B4-BE49-F238E27FC236}">
+                <a16:creationId xmlns:a16="http://schemas.microsoft.com/office/drawing/2014/main" id="{83F94061-1833-4185-B3F0-29FA684265A9}"/>
               </a:ext>
             </a:extLst>
           </p:cNvPr>
@@ -4310,10 +5553,10 @@
       </p:sp>
       <p:sp>
         <p:nvSpPr>
-          <p:cNvPr id="16" name="">
-            <a:extLst xmlns:a="http://schemas.openxmlformats.org/drawingml/2006/main">
-              <a:ext uri="{FF2B5EF4-FFF2-40B4-BE49-F238E27FC236}">
-                <a16:creationId xmlns:a16="http://schemas.microsoft.com/office/drawing/2014/main" id="{9C7A32DF-6E6B-404A-8EF7-5B46E89D1D04}"/>
+          <p:cNvPr id="43" name="">
+            <a:extLst xmlns:a="http://schemas.openxmlformats.org/drawingml/2006/main">
+              <a:ext uri="{FF2B5EF4-FFF2-40B4-BE49-F238E27FC236}">
+                <a16:creationId xmlns:a16="http://schemas.microsoft.com/office/drawing/2014/main" id="{A8B5DDA3-30C9-494B-8E37-79B3106E508F}"/>
               </a:ext>
             </a:extLst>
           </p:cNvPr>
@@ -4361,7 +5604,7 @@
     </p:spTree>
     <p:extLst>
       <p:ext uri="{BB962C8B-B14F-4D97-AF65-F5344CB8AC3E}">
-        <p14:creationId xmlns:p14="http://schemas.microsoft.com/office/powerpoint/2010/main" val="938142167"/>
+        <p14:creationId xmlns:p14="http://schemas.microsoft.com/office/powerpoint/2010/main" val="496324710"/>
       </p:ext>
     </p:extLst>
   </p:cSld>
@@ -4392,7 +5635,7 @@
           <p:cNvPr id="15" name="">
             <a:extLst xmlns:a="http://schemas.openxmlformats.org/drawingml/2006/main">
               <a:ext uri="{FF2B5EF4-FFF2-40B4-BE49-F238E27FC236}">
-                <a16:creationId xmlns:a16="http://schemas.microsoft.com/office/drawing/2014/main" id="{6BB8D00A-E042-4CBF-8313-94F867FEEF9B}"/>
+                <a16:creationId xmlns:a16="http://schemas.microsoft.com/office/drawing/2014/main" id="{57FF6920-A6BF-4A4F-A963-9BC9D42DBA0B}"/>
               </a:ext>
             </a:extLst>
           </p:cNvPr>
@@ -4442,7 +5685,7 @@
           <p:cNvPr id="2" name="">
             <a:extLst xmlns:a="http://schemas.openxmlformats.org/drawingml/2006/main">
               <a:ext uri="{FF2B5EF4-FFF2-40B4-BE49-F238E27FC236}">
-                <a16:creationId xmlns:a16="http://schemas.microsoft.com/office/drawing/2014/main" id="{5010AEC4-16AC-4473-AD5D-4505F23E14DA}"/>
+                <a16:creationId xmlns:a16="http://schemas.microsoft.com/office/drawing/2014/main" id="{22C3FB72-7F7D-45CA-8CAA-EB17BB02B42D}"/>
               </a:ext>
             </a:extLst>
           </p:cNvPr>
@@ -4492,7 +5735,7 @@
           <p:cNvPr id="3" name="">
             <a:extLst xmlns:a="http://schemas.openxmlformats.org/drawingml/2006/main">
               <a:ext uri="{FF2B5EF4-FFF2-40B4-BE49-F238E27FC236}">
-                <a16:creationId xmlns:a16="http://schemas.microsoft.com/office/drawing/2014/main" id="{C7E432A2-2282-452E-9130-FCB89C98F303}"/>
+                <a16:creationId xmlns:a16="http://schemas.microsoft.com/office/drawing/2014/main" id="{F29F3426-107A-49BA-8F95-2B2111188A12}"/>
               </a:ext>
             </a:extLst>
           </p:cNvPr>
@@ -4542,7 +5785,7 @@
           <p:cNvPr id="4" name="">
             <a:extLst xmlns:a="http://schemas.openxmlformats.org/drawingml/2006/main">
               <a:ext uri="{FF2B5EF4-FFF2-40B4-BE49-F238E27FC236}">
-                <a16:creationId xmlns:a16="http://schemas.microsoft.com/office/drawing/2014/main" id="{38CA6EEE-E75D-4F26-ACB4-5BF45656AD8F}"/>
+                <a16:creationId xmlns:a16="http://schemas.microsoft.com/office/drawing/2014/main" id="{B67F276E-06E0-477E-934A-47FC1F0E55B3}"/>
               </a:ext>
             </a:extLst>
           </p:cNvPr>
@@ -4592,7 +5835,7 @@
           <p:cNvPr id="5" name="">
             <a:extLst xmlns:a="http://schemas.openxmlformats.org/drawingml/2006/main">
               <a:ext uri="{FF2B5EF4-FFF2-40B4-BE49-F238E27FC236}">
-                <a16:creationId xmlns:a16="http://schemas.microsoft.com/office/drawing/2014/main" id="{39C2A197-DF65-48E1-A608-824465534BAE}"/>
+                <a16:creationId xmlns:a16="http://schemas.microsoft.com/office/drawing/2014/main" id="{D14FFE8F-4AFE-4F53-B466-CBBFF05FA262}"/>
               </a:ext>
             </a:extLst>
           </p:cNvPr>
@@ -4642,7 +5885,7 @@
           <p:cNvPr id="6" name="">
             <a:extLst xmlns:a="http://schemas.openxmlformats.org/drawingml/2006/main">
               <a:ext uri="{FF2B5EF4-FFF2-40B4-BE49-F238E27FC236}">
-                <a16:creationId xmlns:a16="http://schemas.microsoft.com/office/drawing/2014/main" id="{53F43964-E35C-4881-AAF1-3B047B1DF6F8}"/>
+                <a16:creationId xmlns:a16="http://schemas.microsoft.com/office/drawing/2014/main" id="{6B4750E0-9356-4DDE-8CA9-5CA794160CD0}"/>
               </a:ext>
             </a:extLst>
           </p:cNvPr>
@@ -4692,7 +5935,7 @@
           <p:cNvPr id="7" name="">
             <a:extLst xmlns:a="http://schemas.openxmlformats.org/drawingml/2006/main">
               <a:ext uri="{FF2B5EF4-FFF2-40B4-BE49-F238E27FC236}">
-                <a16:creationId xmlns:a16="http://schemas.microsoft.com/office/drawing/2014/main" id="{7FD36D02-A0F7-4056-845A-419218182DF2}"/>
+                <a16:creationId xmlns:a16="http://schemas.microsoft.com/office/drawing/2014/main" id="{8A347B0F-D736-4503-A755-E0212033ADAB}"/>
               </a:ext>
             </a:extLst>
           </p:cNvPr>
@@ -4742,7 +5985,7 @@
           <p:cNvPr id="8" name="">
             <a:extLst xmlns:a="http://schemas.openxmlformats.org/drawingml/2006/main">
               <a:ext uri="{FF2B5EF4-FFF2-40B4-BE49-F238E27FC236}">
-                <a16:creationId xmlns:a16="http://schemas.microsoft.com/office/drawing/2014/main" id="{869F8FC6-2572-4156-8D70-1A137464D9CC}"/>
+                <a16:creationId xmlns:a16="http://schemas.microsoft.com/office/drawing/2014/main" id="{38052B10-C9F3-4995-91D9-C5CE375822E6}"/>
               </a:ext>
             </a:extLst>
           </p:cNvPr>
@@ -4792,7 +6035,7 @@
           <p:cNvPr id="9" name="">
             <a:extLst xmlns:a="http://schemas.openxmlformats.org/drawingml/2006/main">
               <a:ext uri="{FF2B5EF4-FFF2-40B4-BE49-F238E27FC236}">
-                <a16:creationId xmlns:a16="http://schemas.microsoft.com/office/drawing/2014/main" id="{F05F8CC5-C174-42B2-867E-10128B930290}"/>
+                <a16:creationId xmlns:a16="http://schemas.microsoft.com/office/drawing/2014/main" id="{CA153E0A-45DA-483C-8DBA-3DB57AC72815}"/>
               </a:ext>
             </a:extLst>
           </p:cNvPr>
@@ -4842,7 +6085,7 @@
           <p:cNvPr id="10" name="">
             <a:extLst xmlns:a="http://schemas.openxmlformats.org/drawingml/2006/main">
               <a:ext uri="{FF2B5EF4-FFF2-40B4-BE49-F238E27FC236}">
-                <a16:creationId xmlns:a16="http://schemas.microsoft.com/office/drawing/2014/main" id="{F67B6D55-B6D3-4D78-B9B8-B58D7A317D19}"/>
+                <a16:creationId xmlns:a16="http://schemas.microsoft.com/office/drawing/2014/main" id="{CAB8B715-1E09-44EB-9423-980AF2C0C312}"/>
               </a:ext>
             </a:extLst>
           </p:cNvPr>
@@ -4892,7 +6135,7 @@
           <p:cNvPr id="11" name="">
             <a:extLst xmlns:a="http://schemas.openxmlformats.org/drawingml/2006/main">
               <a:ext uri="{FF2B5EF4-FFF2-40B4-BE49-F238E27FC236}">
-                <a16:creationId xmlns:a16="http://schemas.microsoft.com/office/drawing/2014/main" id="{003716AF-2CC5-406D-9910-9A4D95003E05}"/>
+                <a16:creationId xmlns:a16="http://schemas.microsoft.com/office/drawing/2014/main" id="{9A5644F5-9A20-467E-A72B-9016BD4CC8FA}"/>
               </a:ext>
             </a:extLst>
           </p:cNvPr>
@@ -4923,7 +6166,7 @@
           <p:cNvPr id="12" name="">
             <a:extLst xmlns:a="http://schemas.openxmlformats.org/drawingml/2006/main">
               <a:ext uri="{FF2B5EF4-FFF2-40B4-BE49-F238E27FC236}">
-                <a16:creationId xmlns:a16="http://schemas.microsoft.com/office/drawing/2014/main" id="{BB56CCAB-31D5-4522-BB4A-89112E42E592}"/>
+                <a16:creationId xmlns:a16="http://schemas.microsoft.com/office/drawing/2014/main" id="{6AB716F4-E1D2-433A-B8D1-38767E4E5E34}"/>
               </a:ext>
             </a:extLst>
           </p:cNvPr>
@@ -4973,7 +6216,7 @@
           <p:cNvPr id="13" name="">
             <a:extLst xmlns:a="http://schemas.openxmlformats.org/drawingml/2006/main">
               <a:ext uri="{FF2B5EF4-FFF2-40B4-BE49-F238E27FC236}">
-                <a16:creationId xmlns:a16="http://schemas.microsoft.com/office/drawing/2014/main" id="{FA6B60C7-F77F-41E7-B148-2349E4D8BEB7}"/>
+                <a16:creationId xmlns:a16="http://schemas.microsoft.com/office/drawing/2014/main" id="{65472C9F-39F7-42E3-A5CE-645F885A1B37}"/>
               </a:ext>
             </a:extLst>
           </p:cNvPr>
@@ -5023,7 +6266,7 @@
           <p:cNvPr id="14" name="">
             <a:extLst xmlns:a="http://schemas.openxmlformats.org/drawingml/2006/main">
               <a:ext uri="{FF2B5EF4-FFF2-40B4-BE49-F238E27FC236}">
-                <a16:creationId xmlns:a16="http://schemas.microsoft.com/office/drawing/2014/main" id="{FEE829BC-C365-4AF3-BA29-69293093ABD6}"/>
+                <a16:creationId xmlns:a16="http://schemas.microsoft.com/office/drawing/2014/main" id="{9318CD37-BC14-4927-AE5A-6B94EC7F3BFA}"/>
               </a:ext>
             </a:extLst>
           </p:cNvPr>
@@ -5071,7 +6314,7 @@
     </p:spTree>
     <p:extLst>
       <p:ext uri="{BB962C8B-B14F-4D97-AF65-F5344CB8AC3E}">
-        <p14:creationId xmlns:p14="http://schemas.microsoft.com/office/powerpoint/2010/main" val="908985294"/>
+        <p14:creationId xmlns:p14="http://schemas.microsoft.com/office/powerpoint/2010/main" val="1254036893"/>
       </p:ext>
     </p:extLst>
   </p:cSld>
@@ -5102,7 +6345,7 @@
           <p:cNvPr id="12" name="">
             <a:extLst xmlns:a="http://schemas.openxmlformats.org/drawingml/2006/main">
               <a:ext uri="{FF2B5EF4-FFF2-40B4-BE49-F238E27FC236}">
-                <a16:creationId xmlns:a16="http://schemas.microsoft.com/office/drawing/2014/main" id="{0214A903-4877-4D6F-B48E-3A86B4C4572C}"/>
+                <a16:creationId xmlns:a16="http://schemas.microsoft.com/office/drawing/2014/main" id="{B8032C68-68D8-4E50-9C99-15ACDF549D4B}"/>
               </a:ext>
             </a:extLst>
           </p:cNvPr>
@@ -5152,7 +6395,7 @@
           <p:cNvPr id="2" name="">
             <a:extLst xmlns:a="http://schemas.openxmlformats.org/drawingml/2006/main">
               <a:ext uri="{FF2B5EF4-FFF2-40B4-BE49-F238E27FC236}">
-                <a16:creationId xmlns:a16="http://schemas.microsoft.com/office/drawing/2014/main" id="{B819FBBA-F596-4F7B-9888-36243BF89721}"/>
+                <a16:creationId xmlns:a16="http://schemas.microsoft.com/office/drawing/2014/main" id="{7D159159-C98C-4037-80B6-758E50588C20}"/>
               </a:ext>
             </a:extLst>
           </p:cNvPr>
@@ -5202,7 +6445,7 @@
           <p:cNvPr id="3" name="">
             <a:extLst xmlns:a="http://schemas.openxmlformats.org/drawingml/2006/main">
               <a:ext uri="{FF2B5EF4-FFF2-40B4-BE49-F238E27FC236}">
-                <a16:creationId xmlns:a16="http://schemas.microsoft.com/office/drawing/2014/main" id="{71576250-220D-44DD-9572-8C3216639949}"/>
+                <a16:creationId xmlns:a16="http://schemas.microsoft.com/office/drawing/2014/main" id="{F5AC69A0-D315-4264-A736-A12809F64593}"/>
               </a:ext>
             </a:extLst>
           </p:cNvPr>
@@ -5252,7 +6495,7 @@
           <p:cNvPr id="4" name="">
             <a:extLst xmlns:a="http://schemas.openxmlformats.org/drawingml/2006/main">
               <a:ext uri="{FF2B5EF4-FFF2-40B4-BE49-F238E27FC236}">
-                <a16:creationId xmlns:a16="http://schemas.microsoft.com/office/drawing/2014/main" id="{86D7D8BF-7C48-4630-9784-973D204EBBEE}"/>
+                <a16:creationId xmlns:a16="http://schemas.microsoft.com/office/drawing/2014/main" id="{FF16EFAB-93F6-4E59-BA78-7FDD2F720A99}"/>
               </a:ext>
             </a:extLst>
           </p:cNvPr>
@@ -5302,7 +6545,7 @@
           <p:cNvPr id="5" name="">
             <a:extLst xmlns:a="http://schemas.openxmlformats.org/drawingml/2006/main">
               <a:ext uri="{FF2B5EF4-FFF2-40B4-BE49-F238E27FC236}">
-                <a16:creationId xmlns:a16="http://schemas.microsoft.com/office/drawing/2014/main" id="{93D95A12-1A23-4D53-BCC5-914C93D0DDF6}"/>
+                <a16:creationId xmlns:a16="http://schemas.microsoft.com/office/drawing/2014/main" id="{29EA0E5D-ECA5-4093-9736-0CE354546050}"/>
               </a:ext>
             </a:extLst>
           </p:cNvPr>
@@ -5352,7 +6595,7 @@
           <p:cNvPr id="6" name="">
             <a:extLst xmlns:a="http://schemas.openxmlformats.org/drawingml/2006/main">
               <a:ext uri="{FF2B5EF4-FFF2-40B4-BE49-F238E27FC236}">
-                <a16:creationId xmlns:a16="http://schemas.microsoft.com/office/drawing/2014/main" id="{1DD8B41A-D374-4232-BE34-36A74B338545}"/>
+                <a16:creationId xmlns:a16="http://schemas.microsoft.com/office/drawing/2014/main" id="{1C52FF47-2DCF-4F70-B466-7DD95BE1A772}"/>
               </a:ext>
             </a:extLst>
           </p:cNvPr>
@@ -5402,7 +6645,7 @@
           <p:cNvPr id="7" name="">
             <a:extLst xmlns:a="http://schemas.openxmlformats.org/drawingml/2006/main">
               <a:ext uri="{FF2B5EF4-FFF2-40B4-BE49-F238E27FC236}">
-                <a16:creationId xmlns:a16="http://schemas.microsoft.com/office/drawing/2014/main" id="{F8DD4EA7-68BB-411C-AA8E-6863FE206F50}"/>
+                <a16:creationId xmlns:a16="http://schemas.microsoft.com/office/drawing/2014/main" id="{E7523849-E8A3-47D8-A752-ABBD87847193}"/>
               </a:ext>
             </a:extLst>
           </p:cNvPr>
@@ -5452,7 +6695,7 @@
           <p:cNvPr id="8" name="">
             <a:extLst xmlns:a="http://schemas.openxmlformats.org/drawingml/2006/main">
               <a:ext uri="{FF2B5EF4-FFF2-40B4-BE49-F238E27FC236}">
-                <a16:creationId xmlns:a16="http://schemas.microsoft.com/office/drawing/2014/main" id="{1C8D5E37-BA82-4188-B455-0E8C2DCA8947}"/>
+                <a16:creationId xmlns:a16="http://schemas.microsoft.com/office/drawing/2014/main" id="{9719DDCB-3290-4CB9-88FC-470C3CEF3EED}"/>
               </a:ext>
             </a:extLst>
           </p:cNvPr>
@@ -5502,7 +6745,7 @@
           <p:cNvPr id="9" name="">
             <a:extLst xmlns:a="http://schemas.openxmlformats.org/drawingml/2006/main">
               <a:ext uri="{FF2B5EF4-FFF2-40B4-BE49-F238E27FC236}">
-                <a16:creationId xmlns:a16="http://schemas.microsoft.com/office/drawing/2014/main" id="{C55A4190-5409-428D-AE3B-9535F4AD1DDE}"/>
+                <a16:creationId xmlns:a16="http://schemas.microsoft.com/office/drawing/2014/main" id="{6AAAF10B-62CF-450C-B501-27E3C23856C0}"/>
               </a:ext>
             </a:extLst>
           </p:cNvPr>
@@ -5552,7 +6795,7 @@
           <p:cNvPr id="10" name="">
             <a:extLst xmlns:a="http://schemas.openxmlformats.org/drawingml/2006/main">
               <a:ext uri="{FF2B5EF4-FFF2-40B4-BE49-F238E27FC236}">
-                <a16:creationId xmlns:a16="http://schemas.microsoft.com/office/drawing/2014/main" id="{9F911AD4-54DA-4BDB-A27E-01FD73237203}"/>
+                <a16:creationId xmlns:a16="http://schemas.microsoft.com/office/drawing/2014/main" id="{241BE25E-8A1B-4E3C-9E66-9831F905403D}"/>
               </a:ext>
             </a:extLst>
           </p:cNvPr>
@@ -5602,7 +6845,7 @@
           <p:cNvPr id="11" name="">
             <a:extLst xmlns:a="http://schemas.openxmlformats.org/drawingml/2006/main">
               <a:ext uri="{FF2B5EF4-FFF2-40B4-BE49-F238E27FC236}">
-                <a16:creationId xmlns:a16="http://schemas.microsoft.com/office/drawing/2014/main" id="{9495BC32-3E64-4ABB-88B1-01724A8C9824}"/>
+                <a16:creationId xmlns:a16="http://schemas.microsoft.com/office/drawing/2014/main" id="{0654C8BF-1FB4-45F6-BF0C-5B83AD32AC81}"/>
               </a:ext>
             </a:extLst>
           </p:cNvPr>
@@ -5650,7 +6893,7 @@
     </p:spTree>
     <p:extLst>
       <p:ext uri="{BB962C8B-B14F-4D97-AF65-F5344CB8AC3E}">
-        <p14:creationId xmlns:p14="http://schemas.microsoft.com/office/powerpoint/2010/main" val="1245650642"/>
+        <p14:creationId xmlns:p14="http://schemas.microsoft.com/office/powerpoint/2010/main" val="1258909754"/>
       </p:ext>
     </p:extLst>
   </p:cSld>
@@ -5681,7 +6924,7 @@
           <p:cNvPr id="22" name="">
             <a:extLst xmlns:a="http://schemas.openxmlformats.org/drawingml/2006/main">
               <a:ext uri="{FF2B5EF4-FFF2-40B4-BE49-F238E27FC236}">
-                <a16:creationId xmlns:a16="http://schemas.microsoft.com/office/drawing/2014/main" id="{10312D3C-5AC6-4EA9-A794-91A6A7F2FCB9}"/>
+                <a16:creationId xmlns:a16="http://schemas.microsoft.com/office/drawing/2014/main" id="{58C8B68F-261E-48B8-B1C2-257B1A54212B}"/>
               </a:ext>
             </a:extLst>
           </p:cNvPr>
@@ -5731,7 +6974,7 @@
           <p:cNvPr id="2" name="">
             <a:extLst xmlns:a="http://schemas.openxmlformats.org/drawingml/2006/main">
               <a:ext uri="{FF2B5EF4-FFF2-40B4-BE49-F238E27FC236}">
-                <a16:creationId xmlns:a16="http://schemas.microsoft.com/office/drawing/2014/main" id="{8A0548C2-5826-488D-B1F1-22BD71C878F3}"/>
+                <a16:creationId xmlns:a16="http://schemas.microsoft.com/office/drawing/2014/main" id="{D4595595-CA61-49A5-813A-99BE2BB12F96}"/>
               </a:ext>
             </a:extLst>
           </p:cNvPr>
@@ -5781,7 +7024,7 @@
           <p:cNvPr id="3" name="">
             <a:extLst xmlns:a="http://schemas.openxmlformats.org/drawingml/2006/main">
               <a:ext uri="{FF2B5EF4-FFF2-40B4-BE49-F238E27FC236}">
-                <a16:creationId xmlns:a16="http://schemas.microsoft.com/office/drawing/2014/main" id="{7A583227-C72C-4870-A4AB-26A7F0325A69}"/>
+                <a16:creationId xmlns:a16="http://schemas.microsoft.com/office/drawing/2014/main" id="{CACF41CA-D2AD-472C-AB46-1A499C7C17A2}"/>
               </a:ext>
             </a:extLst>
           </p:cNvPr>
@@ -5816,7 +7059,7 @@
           <p:cNvPr id="4" name="">
             <a:extLst xmlns:a="http://schemas.openxmlformats.org/drawingml/2006/main">
               <a:ext uri="{FF2B5EF4-FFF2-40B4-BE49-F238E27FC236}">
-                <a16:creationId xmlns:a16="http://schemas.microsoft.com/office/drawing/2014/main" id="{69124CE2-0E7A-414A-A43F-BF80FC76B928}"/>
+                <a16:creationId xmlns:a16="http://schemas.microsoft.com/office/drawing/2014/main" id="{1E61DC6F-666F-42DB-99DB-280732054B98}"/>
               </a:ext>
             </a:extLst>
           </p:cNvPr>
@@ -5883,7 +7126,7 @@
           <p:cNvPr id="5" name="">
             <a:extLst xmlns:a="http://schemas.openxmlformats.org/drawingml/2006/main">
               <a:ext uri="{FF2B5EF4-FFF2-40B4-BE49-F238E27FC236}">
-                <a16:creationId xmlns:a16="http://schemas.microsoft.com/office/drawing/2014/main" id="{4EE85025-0FC7-4A73-B66D-04BB04A845C9}"/>
+                <a16:creationId xmlns:a16="http://schemas.microsoft.com/office/drawing/2014/main" id="{D76F8753-24D0-4CA2-AA06-EBDCB4D652BE}"/>
               </a:ext>
             </a:extLst>
           </p:cNvPr>
@@ -5933,7 +7176,7 @@
           <p:cNvPr id="6" name="">
             <a:extLst xmlns:a="http://schemas.openxmlformats.org/drawingml/2006/main">
               <a:ext uri="{FF2B5EF4-FFF2-40B4-BE49-F238E27FC236}">
-                <a16:creationId xmlns:a16="http://schemas.microsoft.com/office/drawing/2014/main" id="{692CB88B-26EC-4AD0-BAFA-CB670F9FF2E2}"/>
+                <a16:creationId xmlns:a16="http://schemas.microsoft.com/office/drawing/2014/main" id="{88ED699D-3AF6-4906-82E5-5140B21FE4AA}"/>
               </a:ext>
             </a:extLst>
           </p:cNvPr>
@@ -5968,7 +7211,7 @@
           <p:cNvPr id="7" name="">
             <a:extLst xmlns:a="http://schemas.openxmlformats.org/drawingml/2006/main">
               <a:ext uri="{FF2B5EF4-FFF2-40B4-BE49-F238E27FC236}">
-                <a16:creationId xmlns:a16="http://schemas.microsoft.com/office/drawing/2014/main" id="{EB4C16F5-0B5D-49C1-9EC6-7476A982D203}"/>
+                <a16:creationId xmlns:a16="http://schemas.microsoft.com/office/drawing/2014/main" id="{4A4D3AD1-3A7F-4797-9F46-1EB04CB4BE6E}"/>
               </a:ext>
             </a:extLst>
           </p:cNvPr>
@@ -6035,7 +7278,7 @@
           <p:cNvPr id="8" name="">
             <a:extLst xmlns:a="http://schemas.openxmlformats.org/drawingml/2006/main">
               <a:ext uri="{FF2B5EF4-FFF2-40B4-BE49-F238E27FC236}">
-                <a16:creationId xmlns:a16="http://schemas.microsoft.com/office/drawing/2014/main" id="{F5E5B23B-9916-4E8D-9843-A0259640B12E}"/>
+                <a16:creationId xmlns:a16="http://schemas.microsoft.com/office/drawing/2014/main" id="{FAD6A26B-2D54-4ED4-8AA1-2AA078C8F0AA}"/>
               </a:ext>
             </a:extLst>
           </p:cNvPr>
@@ -6085,7 +7328,7 @@
           <p:cNvPr id="9" name="">
             <a:extLst xmlns:a="http://schemas.openxmlformats.org/drawingml/2006/main">
               <a:ext uri="{FF2B5EF4-FFF2-40B4-BE49-F238E27FC236}">
-                <a16:creationId xmlns:a16="http://schemas.microsoft.com/office/drawing/2014/main" id="{82D3EA5A-DD27-4A2F-B366-FCCF188D0B4B}"/>
+                <a16:creationId xmlns:a16="http://schemas.microsoft.com/office/drawing/2014/main" id="{CB38301F-CF08-4907-9249-3FD3048C3270}"/>
               </a:ext>
             </a:extLst>
           </p:cNvPr>
@@ -6120,7 +7363,7 @@
           <p:cNvPr id="10" name="">
             <a:extLst xmlns:a="http://schemas.openxmlformats.org/drawingml/2006/main">
               <a:ext uri="{FF2B5EF4-FFF2-40B4-BE49-F238E27FC236}">
-                <a16:creationId xmlns:a16="http://schemas.microsoft.com/office/drawing/2014/main" id="{D0C8E1C4-3538-47AE-BB0A-DE056346D7BC}"/>
+                <a16:creationId xmlns:a16="http://schemas.microsoft.com/office/drawing/2014/main" id="{0B183D6D-AE2F-4961-B1E2-0BCBF2C63E94}"/>
               </a:ext>
             </a:extLst>
           </p:cNvPr>
@@ -6187,7 +7430,7 @@
           <p:cNvPr id="11" name="">
             <a:extLst xmlns:a="http://schemas.openxmlformats.org/drawingml/2006/main">
               <a:ext uri="{FF2B5EF4-FFF2-40B4-BE49-F238E27FC236}">
-                <a16:creationId xmlns:a16="http://schemas.microsoft.com/office/drawing/2014/main" id="{63A4743A-4513-4439-B640-682651DA02D6}"/>
+                <a16:creationId xmlns:a16="http://schemas.microsoft.com/office/drawing/2014/main" id="{6AEA85BB-478D-4ECC-88CE-653DC4F40D8C}"/>
               </a:ext>
             </a:extLst>
           </p:cNvPr>
@@ -6237,7 +7480,7 @@
           <p:cNvPr id="12" name="">
             <a:extLst xmlns:a="http://schemas.openxmlformats.org/drawingml/2006/main">
               <a:ext uri="{FF2B5EF4-FFF2-40B4-BE49-F238E27FC236}">
-                <a16:creationId xmlns:a16="http://schemas.microsoft.com/office/drawing/2014/main" id="{08048A5B-619F-47D3-A115-91629D1A45CA}"/>
+                <a16:creationId xmlns:a16="http://schemas.microsoft.com/office/drawing/2014/main" id="{268FFA50-31C1-40A3-8C92-0B995F5CE0CE}"/>
               </a:ext>
             </a:extLst>
           </p:cNvPr>
@@ -6272,7 +7515,7 @@
           <p:cNvPr id="13" name="">
             <a:extLst xmlns:a="http://schemas.openxmlformats.org/drawingml/2006/main">
               <a:ext uri="{FF2B5EF4-FFF2-40B4-BE49-F238E27FC236}">
-                <a16:creationId xmlns:a16="http://schemas.microsoft.com/office/drawing/2014/main" id="{ABCB61B2-1A7B-4D7A-8B12-21E5CB1179A0}"/>
+                <a16:creationId xmlns:a16="http://schemas.microsoft.com/office/drawing/2014/main" id="{AF86E3E3-11C7-41E1-A9FF-00C2AD55BAFF}"/>
               </a:ext>
             </a:extLst>
           </p:cNvPr>
@@ -6339,7 +7582,7 @@
           <p:cNvPr id="14" name="">
             <a:extLst xmlns:a="http://schemas.openxmlformats.org/drawingml/2006/main">
               <a:ext uri="{FF2B5EF4-FFF2-40B4-BE49-F238E27FC236}">
-                <a16:creationId xmlns:a16="http://schemas.microsoft.com/office/drawing/2014/main" id="{219E9940-5C9E-4EC6-A69A-827CE649F03D}"/>
+                <a16:creationId xmlns:a16="http://schemas.microsoft.com/office/drawing/2014/main" id="{D0BA1036-B8C6-4767-B710-F1BBB980F267}"/>
               </a:ext>
             </a:extLst>
           </p:cNvPr>
@@ -6389,7 +7632,7 @@
           <p:cNvPr id="15" name="">
             <a:extLst xmlns:a="http://schemas.openxmlformats.org/drawingml/2006/main">
               <a:ext uri="{FF2B5EF4-FFF2-40B4-BE49-F238E27FC236}">
-                <a16:creationId xmlns:a16="http://schemas.microsoft.com/office/drawing/2014/main" id="{BDA228D9-52A0-48FF-825A-DAE3A8B68D5A}"/>
+                <a16:creationId xmlns:a16="http://schemas.microsoft.com/office/drawing/2014/main" id="{4ACC93DD-B8DF-4914-B627-F3D4D0CD4FFA}"/>
               </a:ext>
             </a:extLst>
           </p:cNvPr>
@@ -6439,7 +7682,7 @@
           <p:cNvPr id="16" name="">
             <a:extLst xmlns:a="http://schemas.openxmlformats.org/drawingml/2006/main">
               <a:ext uri="{FF2B5EF4-FFF2-40B4-BE49-F238E27FC236}">
-                <a16:creationId xmlns:a16="http://schemas.microsoft.com/office/drawing/2014/main" id="{949173BC-1186-4C49-BB7D-CEBE71A14DDB}"/>
+                <a16:creationId xmlns:a16="http://schemas.microsoft.com/office/drawing/2014/main" id="{3B9EDF85-5D83-424A-960F-B2D793EF8EA4}"/>
               </a:ext>
             </a:extLst>
           </p:cNvPr>
@@ -6489,7 +7732,7 @@
           <p:cNvPr id="17" name="">
             <a:extLst xmlns:a="http://schemas.openxmlformats.org/drawingml/2006/main">
               <a:ext uri="{FF2B5EF4-FFF2-40B4-BE49-F238E27FC236}">
-                <a16:creationId xmlns:a16="http://schemas.microsoft.com/office/drawing/2014/main" id="{5A4BF536-1780-484A-A81D-22D33B90F6BB}"/>
+                <a16:creationId xmlns:a16="http://schemas.microsoft.com/office/drawing/2014/main" id="{C59F22D1-9137-43DC-9200-1AE4145E96D7}"/>
               </a:ext>
             </a:extLst>
           </p:cNvPr>
@@ -6539,7 +7782,7 @@
           <p:cNvPr id="18" name="">
             <a:extLst xmlns:a="http://schemas.openxmlformats.org/drawingml/2006/main">
               <a:ext uri="{FF2B5EF4-FFF2-40B4-BE49-F238E27FC236}">
-                <a16:creationId xmlns:a16="http://schemas.microsoft.com/office/drawing/2014/main" id="{40CBD32F-9C76-4090-967E-7EDBEF52065A}"/>
+                <a16:creationId xmlns:a16="http://schemas.microsoft.com/office/drawing/2014/main" id="{433AADAD-D5F9-4EA1-8B39-8B1F7C47E2BA}"/>
               </a:ext>
             </a:extLst>
           </p:cNvPr>
@@ -6589,7 +7832,7 @@
           <p:cNvPr id="19" name="">
             <a:extLst xmlns:a="http://schemas.openxmlformats.org/drawingml/2006/main">
               <a:ext uri="{FF2B5EF4-FFF2-40B4-BE49-F238E27FC236}">
-                <a16:creationId xmlns:a16="http://schemas.microsoft.com/office/drawing/2014/main" id="{E9EA22CF-9461-43DA-91A6-B06223394848}"/>
+                <a16:creationId xmlns:a16="http://schemas.microsoft.com/office/drawing/2014/main" id="{3B93C9A2-D2F6-4CB3-8FC4-6904602EA6BA}"/>
               </a:ext>
             </a:extLst>
           </p:cNvPr>
@@ -6639,7 +7882,7 @@
           <p:cNvPr id="20" name="">
             <a:extLst xmlns:a="http://schemas.openxmlformats.org/drawingml/2006/main">
               <a:ext uri="{FF2B5EF4-FFF2-40B4-BE49-F238E27FC236}">
-                <a16:creationId xmlns:a16="http://schemas.microsoft.com/office/drawing/2014/main" id="{006F0B6F-A4AC-4B8C-BE59-4AC5DB49798F}"/>
+                <a16:creationId xmlns:a16="http://schemas.microsoft.com/office/drawing/2014/main" id="{6872D377-1DB9-4B96-BAA5-7B07590C6AF7}"/>
               </a:ext>
             </a:extLst>
           </p:cNvPr>
@@ -6689,7 +7932,7 @@
           <p:cNvPr id="21" name="">
             <a:extLst xmlns:a="http://schemas.openxmlformats.org/drawingml/2006/main">
               <a:ext uri="{FF2B5EF4-FFF2-40B4-BE49-F238E27FC236}">
-                <a16:creationId xmlns:a16="http://schemas.microsoft.com/office/drawing/2014/main" id="{E3C72460-7EC8-44DB-941A-68EADBE160B2}"/>
+                <a16:creationId xmlns:a16="http://schemas.microsoft.com/office/drawing/2014/main" id="{45F6FF87-08F6-4483-B464-35BC1D98FBA7}"/>
               </a:ext>
             </a:extLst>
           </p:cNvPr>
@@ -6737,7 +7980,7 @@
     </p:spTree>
     <p:extLst>
       <p:ext uri="{BB962C8B-B14F-4D97-AF65-F5344CB8AC3E}">
-        <p14:creationId xmlns:p14="http://schemas.microsoft.com/office/powerpoint/2010/main" val="876670144"/>
+        <p14:creationId xmlns:p14="http://schemas.microsoft.com/office/powerpoint/2010/main" val="337880034"/>
       </p:ext>
     </p:extLst>
   </p:cSld>
@@ -6768,7 +8011,7 @@
           <p:cNvPr id="15" name="">
             <a:extLst xmlns:a="http://schemas.openxmlformats.org/drawingml/2006/main">
               <a:ext uri="{FF2B5EF4-FFF2-40B4-BE49-F238E27FC236}">
-                <a16:creationId xmlns:a16="http://schemas.microsoft.com/office/drawing/2014/main" id="{F4B4F162-5588-4747-8482-69912614F0A4}"/>
+                <a16:creationId xmlns:a16="http://schemas.microsoft.com/office/drawing/2014/main" id="{09A504ED-D1F0-4BCF-AAD4-3E2433BAEC4D}"/>
               </a:ext>
             </a:extLst>
           </p:cNvPr>
@@ -6818,7 +8061,7 @@
           <p:cNvPr id="2" name="">
             <a:extLst xmlns:a="http://schemas.openxmlformats.org/drawingml/2006/main">
               <a:ext uri="{FF2B5EF4-FFF2-40B4-BE49-F238E27FC236}">
-                <a16:creationId xmlns:a16="http://schemas.microsoft.com/office/drawing/2014/main" id="{1D37321D-0146-43BC-9810-69227E71B285}"/>
+                <a16:creationId xmlns:a16="http://schemas.microsoft.com/office/drawing/2014/main" id="{68B2278D-3BC7-4413-B38F-F10586ED9345}"/>
               </a:ext>
             </a:extLst>
           </p:cNvPr>
@@ -6868,7 +8111,7 @@
           <p:cNvPr id="3" name="">
             <a:extLst xmlns:a="http://schemas.openxmlformats.org/drawingml/2006/main">
               <a:ext uri="{FF2B5EF4-FFF2-40B4-BE49-F238E27FC236}">
-                <a16:creationId xmlns:a16="http://schemas.microsoft.com/office/drawing/2014/main" id="{6B1B5FF6-3F06-48E8-BDA3-7AD4C68441E3}"/>
+                <a16:creationId xmlns:a16="http://schemas.microsoft.com/office/drawing/2014/main" id="{0785AB17-1DF2-4113-90B6-C9E7F1307098}"/>
               </a:ext>
             </a:extLst>
           </p:cNvPr>
@@ -6918,7 +8161,7 @@
           <p:cNvPr id="4" name="">
             <a:extLst xmlns:a="http://schemas.openxmlformats.org/drawingml/2006/main">
               <a:ext uri="{FF2B5EF4-FFF2-40B4-BE49-F238E27FC236}">
-                <a16:creationId xmlns:a16="http://schemas.microsoft.com/office/drawing/2014/main" id="{BD10B93F-C08B-4DFE-A887-A602EB3BF485}"/>
+                <a16:creationId xmlns:a16="http://schemas.microsoft.com/office/drawing/2014/main" id="{E432BAD8-991A-44ED-9DA3-2457524271A3}"/>
               </a:ext>
             </a:extLst>
           </p:cNvPr>
@@ -6968,7 +8211,7 @@
           <p:cNvPr id="5" name="">
             <a:extLst xmlns:a="http://schemas.openxmlformats.org/drawingml/2006/main">
               <a:ext uri="{FF2B5EF4-FFF2-40B4-BE49-F238E27FC236}">
-                <a16:creationId xmlns:a16="http://schemas.microsoft.com/office/drawing/2014/main" id="{2F09F9F7-049B-42FD-939A-D3E36FF201D5}"/>
+                <a16:creationId xmlns:a16="http://schemas.microsoft.com/office/drawing/2014/main" id="{A9BFD9E2-0872-4DFA-ADDF-E50B1B7A7EAE}"/>
               </a:ext>
             </a:extLst>
           </p:cNvPr>
@@ -7018,7 +8261,7 @@
           <p:cNvPr id="6" name="">
             <a:extLst xmlns:a="http://schemas.openxmlformats.org/drawingml/2006/main">
               <a:ext uri="{FF2B5EF4-FFF2-40B4-BE49-F238E27FC236}">
-                <a16:creationId xmlns:a16="http://schemas.microsoft.com/office/drawing/2014/main" id="{22A3F2E9-CCFE-458D-9EA0-BC00465BE40E}"/>
+                <a16:creationId xmlns:a16="http://schemas.microsoft.com/office/drawing/2014/main" id="{459E9D6B-371A-4ACF-9A21-4E0323D4F274}"/>
               </a:ext>
             </a:extLst>
           </p:cNvPr>
@@ -7068,7 +8311,7 @@
           <p:cNvPr id="7" name="">
             <a:extLst xmlns:a="http://schemas.openxmlformats.org/drawingml/2006/main">
               <a:ext uri="{FF2B5EF4-FFF2-40B4-BE49-F238E27FC236}">
-                <a16:creationId xmlns:a16="http://schemas.microsoft.com/office/drawing/2014/main" id="{A3EA0753-2EA4-4627-A5B2-C5D4F0CBA521}"/>
+                <a16:creationId xmlns:a16="http://schemas.microsoft.com/office/drawing/2014/main" id="{82D8BDE3-CC5B-410A-88B7-403020489D38}"/>
               </a:ext>
             </a:extLst>
           </p:cNvPr>
@@ -7118,7 +8361,7 @@
           <p:cNvPr id="8" name="">
             <a:extLst xmlns:a="http://schemas.openxmlformats.org/drawingml/2006/main">
               <a:ext uri="{FF2B5EF4-FFF2-40B4-BE49-F238E27FC236}">
-                <a16:creationId xmlns:a16="http://schemas.microsoft.com/office/drawing/2014/main" id="{A347428D-9091-456E-85B7-7D321637F945}"/>
+                <a16:creationId xmlns:a16="http://schemas.microsoft.com/office/drawing/2014/main" id="{F166C464-1515-4A80-9E7E-5203316C4B94}"/>
               </a:ext>
             </a:extLst>
           </p:cNvPr>
@@ -7168,7 +8411,7 @@
           <p:cNvPr id="9" name="">
             <a:extLst xmlns:a="http://schemas.openxmlformats.org/drawingml/2006/main">
               <a:ext uri="{FF2B5EF4-FFF2-40B4-BE49-F238E27FC236}">
-                <a16:creationId xmlns:a16="http://schemas.microsoft.com/office/drawing/2014/main" id="{DCCE03A7-0BB6-42F1-BDEA-5DA59B6FAC18}"/>
+                <a16:creationId xmlns:a16="http://schemas.microsoft.com/office/drawing/2014/main" id="{6DE31DEF-8F63-49CB-8455-C14319ACE546}"/>
               </a:ext>
             </a:extLst>
           </p:cNvPr>
@@ -7218,7 +8461,7 @@
           <p:cNvPr id="10" name="">
             <a:extLst xmlns:a="http://schemas.openxmlformats.org/drawingml/2006/main">
               <a:ext uri="{FF2B5EF4-FFF2-40B4-BE49-F238E27FC236}">
-                <a16:creationId xmlns:a16="http://schemas.microsoft.com/office/drawing/2014/main" id="{A6AC3CFC-2A88-437A-8C51-013816955484}"/>
+                <a16:creationId xmlns:a16="http://schemas.microsoft.com/office/drawing/2014/main" id="{C4677FBF-2706-4758-83AB-7306E4790457}"/>
               </a:ext>
             </a:extLst>
           </p:cNvPr>
@@ -7268,7 +8511,7 @@
           <p:cNvPr id="11" name="">
             <a:extLst xmlns:a="http://schemas.openxmlformats.org/drawingml/2006/main">
               <a:ext uri="{FF2B5EF4-FFF2-40B4-BE49-F238E27FC236}">
-                <a16:creationId xmlns:a16="http://schemas.microsoft.com/office/drawing/2014/main" id="{B8A0E14F-7B79-4746-9CFE-925D40906446}"/>
+                <a16:creationId xmlns:a16="http://schemas.microsoft.com/office/drawing/2014/main" id="{2354027A-D097-4DA0-BDDF-23100CD5061A}"/>
               </a:ext>
             </a:extLst>
           </p:cNvPr>
@@ -7299,7 +8542,7 @@
           <p:cNvPr id="12" name="">
             <a:extLst xmlns:a="http://schemas.openxmlformats.org/drawingml/2006/main">
               <a:ext uri="{FF2B5EF4-FFF2-40B4-BE49-F238E27FC236}">
-                <a16:creationId xmlns:a16="http://schemas.microsoft.com/office/drawing/2014/main" id="{B4BBA6D2-CA23-4266-9A78-3BC96E4E8E21}"/>
+                <a16:creationId xmlns:a16="http://schemas.microsoft.com/office/drawing/2014/main" id="{96B9E938-6151-4C16-993D-80075D6C130C}"/>
               </a:ext>
             </a:extLst>
           </p:cNvPr>
@@ -7349,7 +8592,7 @@
           <p:cNvPr id="13" name="">
             <a:extLst xmlns:a="http://schemas.openxmlformats.org/drawingml/2006/main">
               <a:ext uri="{FF2B5EF4-FFF2-40B4-BE49-F238E27FC236}">
-                <a16:creationId xmlns:a16="http://schemas.microsoft.com/office/drawing/2014/main" id="{8A998F70-F113-477D-A5E9-5F2007229FB3}"/>
+                <a16:creationId xmlns:a16="http://schemas.microsoft.com/office/drawing/2014/main" id="{C4E9F532-5FC9-483D-A0A8-0A691F375FB1}"/>
               </a:ext>
             </a:extLst>
           </p:cNvPr>
@@ -7399,7 +8642,7 @@
           <p:cNvPr id="14" name="">
             <a:extLst xmlns:a="http://schemas.openxmlformats.org/drawingml/2006/main">
               <a:ext uri="{FF2B5EF4-FFF2-40B4-BE49-F238E27FC236}">
-                <a16:creationId xmlns:a16="http://schemas.microsoft.com/office/drawing/2014/main" id="{09B5FA8D-3BCA-4566-BAB7-B720F8DA3FDF}"/>
+                <a16:creationId xmlns:a16="http://schemas.microsoft.com/office/drawing/2014/main" id="{A9C268DE-EF80-462C-A3B1-9ADF1D5B714E}"/>
               </a:ext>
             </a:extLst>
           </p:cNvPr>
@@ -7447,7 +8690,7 @@
     </p:spTree>
     <p:extLst>
       <p:ext uri="{BB962C8B-B14F-4D97-AF65-F5344CB8AC3E}">
-        <p14:creationId xmlns:p14="http://schemas.microsoft.com/office/powerpoint/2010/main" val="427654349"/>
+        <p14:creationId xmlns:p14="http://schemas.microsoft.com/office/powerpoint/2010/main" val="843098074"/>
       </p:ext>
     </p:extLst>
   </p:cSld>
@@ -7478,7 +8721,7 @@
           <p:cNvPr id="7" name="">
             <a:extLst xmlns:a="http://schemas.openxmlformats.org/drawingml/2006/main">
               <a:ext uri="{FF2B5EF4-FFF2-40B4-BE49-F238E27FC236}">
-                <a16:creationId xmlns:a16="http://schemas.microsoft.com/office/drawing/2014/main" id="{A09C2A0C-D04D-48FD-A7AA-AE83D36D0BDE}"/>
+                <a16:creationId xmlns:a16="http://schemas.microsoft.com/office/drawing/2014/main" id="{F6EB642C-5B29-40CF-91F5-8791F9E735E5}"/>
               </a:ext>
             </a:extLst>
           </p:cNvPr>
@@ -7528,7 +8771,7 @@
           <p:cNvPr id="2" name="">
             <a:extLst xmlns:a="http://schemas.openxmlformats.org/drawingml/2006/main">
               <a:ext uri="{FF2B5EF4-FFF2-40B4-BE49-F238E27FC236}">
-                <a16:creationId xmlns:a16="http://schemas.microsoft.com/office/drawing/2014/main" id="{8F04FD3D-74BF-42A8-9A7C-6899816AE0AC}"/>
+                <a16:creationId xmlns:a16="http://schemas.microsoft.com/office/drawing/2014/main" id="{3989FB80-91BE-49E4-B8D2-9F52CB063719}"/>
               </a:ext>
             </a:extLst>
           </p:cNvPr>
@@ -7582,7 +8825,7 @@
           <p:nvPr/>
         </p:nvPicPr>
         <p:blipFill>
-          <a:blip xmlns:r="http://schemas.openxmlformats.org/officeDocument/2006/relationships" xmlns:a="http://schemas.openxmlformats.org/drawingml/2006/main" r:embed="R4150a337e9ec487f"/>
+          <a:blip xmlns:r="http://schemas.openxmlformats.org/officeDocument/2006/relationships" xmlns:a="http://schemas.openxmlformats.org/drawingml/2006/main" r:embed="Rd1675278ea7a4416"/>
           <a:stretch xmlns:a="http://schemas.openxmlformats.org/drawingml/2006/main"/>
         </p:blipFill>
         <p:spPr>
@@ -7600,7 +8843,7 @@
           <p:cNvPr id="4" name="">
             <a:extLst xmlns:a="http://schemas.openxmlformats.org/drawingml/2006/main">
               <a:ext uri="{FF2B5EF4-FFF2-40B4-BE49-F238E27FC236}">
-                <a16:creationId xmlns:a16="http://schemas.microsoft.com/office/drawing/2014/main" id="{4E637304-7CF4-413F-838E-706688D7508E}"/>
+                <a16:creationId xmlns:a16="http://schemas.microsoft.com/office/drawing/2014/main" id="{73D9F1E0-4CDF-4EC7-BD83-D07F50E0B7F4}"/>
               </a:ext>
             </a:extLst>
           </p:cNvPr>
@@ -7650,7 +8893,7 @@
           <p:cNvPr id="5" name="">
             <a:extLst xmlns:a="http://schemas.openxmlformats.org/drawingml/2006/main">
               <a:ext uri="{FF2B5EF4-FFF2-40B4-BE49-F238E27FC236}">
-                <a16:creationId xmlns:a16="http://schemas.microsoft.com/office/drawing/2014/main" id="{B03724F4-B3F8-4BC8-83FA-CA2CB8F7709E}"/>
+                <a16:creationId xmlns:a16="http://schemas.microsoft.com/office/drawing/2014/main" id="{4ED53949-7F52-4E29-B9F0-42C42A3FC374}"/>
               </a:ext>
             </a:extLst>
           </p:cNvPr>
@@ -7700,7 +8943,7 @@
           <p:cNvPr id="6" name="">
             <a:extLst xmlns:a="http://schemas.openxmlformats.org/drawingml/2006/main">
               <a:ext uri="{FF2B5EF4-FFF2-40B4-BE49-F238E27FC236}">
-                <a16:creationId xmlns:a16="http://schemas.microsoft.com/office/drawing/2014/main" id="{EDC63988-5859-43FA-A553-4F1311019966}"/>
+                <a16:creationId xmlns:a16="http://schemas.microsoft.com/office/drawing/2014/main" id="{883CD310-6664-44B5-8937-5E779FDB9C15}"/>
               </a:ext>
             </a:extLst>
           </p:cNvPr>
@@ -7748,7 +8991,7 @@
     </p:spTree>
     <p:extLst>
       <p:ext uri="{BB962C8B-B14F-4D97-AF65-F5344CB8AC3E}">
-        <p14:creationId xmlns:p14="http://schemas.microsoft.com/office/powerpoint/2010/main" val="653779735"/>
+        <p14:creationId xmlns:p14="http://schemas.microsoft.com/office/powerpoint/2010/main" val="910095904"/>
       </p:ext>
     </p:extLst>
   </p:cSld>
@@ -7779,7 +9022,7 @@
           <p:cNvPr id="11" name="">
             <a:extLst xmlns:a="http://schemas.openxmlformats.org/drawingml/2006/main">
               <a:ext uri="{FF2B5EF4-FFF2-40B4-BE49-F238E27FC236}">
-                <a16:creationId xmlns:a16="http://schemas.microsoft.com/office/drawing/2014/main" id="{FB11BD36-A475-4CAF-B2DD-DEFFC67DBDF6}"/>
+                <a16:creationId xmlns:a16="http://schemas.microsoft.com/office/drawing/2014/main" id="{45DEDB76-9A0B-45B9-8BC7-92B842B99444}"/>
               </a:ext>
             </a:extLst>
           </p:cNvPr>
@@ -7829,7 +9072,7 @@
           <p:cNvPr id="2" name="">
             <a:extLst xmlns:a="http://schemas.openxmlformats.org/drawingml/2006/main">
               <a:ext uri="{FF2B5EF4-FFF2-40B4-BE49-F238E27FC236}">
-                <a16:creationId xmlns:a16="http://schemas.microsoft.com/office/drawing/2014/main" id="{AE5E1168-66AE-4BDD-92C9-C454CA9E5B7E}"/>
+                <a16:creationId xmlns:a16="http://schemas.microsoft.com/office/drawing/2014/main" id="{7B312CE4-0653-4CC1-A011-C38E24005B80}"/>
               </a:ext>
             </a:extLst>
           </p:cNvPr>
@@ -7883,7 +9126,7 @@
           <p:nvPr/>
         </p:nvPicPr>
         <p:blipFill>
-          <a:blip xmlns:r="http://schemas.openxmlformats.org/officeDocument/2006/relationships" xmlns:a="http://schemas.openxmlformats.org/drawingml/2006/main" r:embed="R7d60b54b0d0747a6"/>
+          <a:blip xmlns:r="http://schemas.openxmlformats.org/officeDocument/2006/relationships" xmlns:a="http://schemas.openxmlformats.org/drawingml/2006/main" r:embed="R7d62aa19976848e3"/>
           <a:stretch xmlns:a="http://schemas.openxmlformats.org/drawingml/2006/main"/>
         </p:blipFill>
         <p:spPr>
@@ -7901,7 +9144,7 @@
           <p:cNvPr id="4" name="">
             <a:extLst xmlns:a="http://schemas.openxmlformats.org/drawingml/2006/main">
               <a:ext uri="{FF2B5EF4-FFF2-40B4-BE49-F238E27FC236}">
-                <a16:creationId xmlns:a16="http://schemas.microsoft.com/office/drawing/2014/main" id="{4ADED076-709E-4095-8904-CF0D751BE6F5}"/>
+                <a16:creationId xmlns:a16="http://schemas.microsoft.com/office/drawing/2014/main" id="{B77D43B4-1A83-4397-B653-ED6B82C973E0}"/>
               </a:ext>
             </a:extLst>
           </p:cNvPr>
@@ -7951,7 +9194,7 @@
           <p:cNvPr id="5" name="">
             <a:extLst xmlns:a="http://schemas.openxmlformats.org/drawingml/2006/main">
               <a:ext uri="{FF2B5EF4-FFF2-40B4-BE49-F238E27FC236}">
-                <a16:creationId xmlns:a16="http://schemas.microsoft.com/office/drawing/2014/main" id="{C646962C-FF02-4B20-B553-C1ED9D25CD09}"/>
+                <a16:creationId xmlns:a16="http://schemas.microsoft.com/office/drawing/2014/main" id="{61F16353-F6C2-4940-9355-2E598FAF0EA8}"/>
               </a:ext>
             </a:extLst>
           </p:cNvPr>
@@ -8001,7 +9244,7 @@
           <p:cNvPr id="6" name="">
             <a:extLst xmlns:a="http://schemas.openxmlformats.org/drawingml/2006/main">
               <a:ext uri="{FF2B5EF4-FFF2-40B4-BE49-F238E27FC236}">
-                <a16:creationId xmlns:a16="http://schemas.microsoft.com/office/drawing/2014/main" id="{909897E7-54F6-4416-87F1-064332E448EE}"/>
+                <a16:creationId xmlns:a16="http://schemas.microsoft.com/office/drawing/2014/main" id="{7869CA2A-555D-433E-8A14-ADE2ABB3D093}"/>
               </a:ext>
             </a:extLst>
           </p:cNvPr>
@@ -8051,7 +9294,7 @@
           <p:cNvPr id="7" name="">
             <a:extLst xmlns:a="http://schemas.openxmlformats.org/drawingml/2006/main">
               <a:ext uri="{FF2B5EF4-FFF2-40B4-BE49-F238E27FC236}">
-                <a16:creationId xmlns:a16="http://schemas.microsoft.com/office/drawing/2014/main" id="{47BB8C4A-89D1-4CDA-B399-30109A90E2C2}"/>
+                <a16:creationId xmlns:a16="http://schemas.microsoft.com/office/drawing/2014/main" id="{1E778660-C82E-476E-8143-BA4F27F2B49C}"/>
               </a:ext>
             </a:extLst>
           </p:cNvPr>
@@ -8101,7 +9344,7 @@
           <p:cNvPr id="8" name="">
             <a:extLst xmlns:a="http://schemas.openxmlformats.org/drawingml/2006/main">
               <a:ext uri="{FF2B5EF4-FFF2-40B4-BE49-F238E27FC236}">
-                <a16:creationId xmlns:a16="http://schemas.microsoft.com/office/drawing/2014/main" id="{774D1A36-1F59-4A90-94E9-98443A1E5A1D}"/>
+                <a16:creationId xmlns:a16="http://schemas.microsoft.com/office/drawing/2014/main" id="{7FF06F40-DCFB-4687-B1AA-A347499496AF}"/>
               </a:ext>
             </a:extLst>
           </p:cNvPr>
@@ -8151,7 +9394,7 @@
           <p:cNvPr id="9" name="">
             <a:extLst xmlns:a="http://schemas.openxmlformats.org/drawingml/2006/main">
               <a:ext uri="{FF2B5EF4-FFF2-40B4-BE49-F238E27FC236}">
-                <a16:creationId xmlns:a16="http://schemas.microsoft.com/office/drawing/2014/main" id="{F2249596-BDD9-4FA5-90DF-D3F0DD443725}"/>
+                <a16:creationId xmlns:a16="http://schemas.microsoft.com/office/drawing/2014/main" id="{24A5E46C-95D7-49ED-93F4-9DD6C4E0640F}"/>
               </a:ext>
             </a:extLst>
           </p:cNvPr>
@@ -8201,7 +9444,7 @@
           <p:cNvPr id="10" name="">
             <a:extLst xmlns:a="http://schemas.openxmlformats.org/drawingml/2006/main">
               <a:ext uri="{FF2B5EF4-FFF2-40B4-BE49-F238E27FC236}">
-                <a16:creationId xmlns:a16="http://schemas.microsoft.com/office/drawing/2014/main" id="{8625E1F9-F113-42C8-A344-1865570C9E6B}"/>
+                <a16:creationId xmlns:a16="http://schemas.microsoft.com/office/drawing/2014/main" id="{3828E3EF-5D5C-4C46-BCFA-0E96C935ECF9}"/>
               </a:ext>
             </a:extLst>
           </p:cNvPr>
@@ -8249,7 +9492,7 @@
     </p:spTree>
     <p:extLst>
       <p:ext uri="{BB962C8B-B14F-4D97-AF65-F5344CB8AC3E}">
-        <p14:creationId xmlns:p14="http://schemas.microsoft.com/office/powerpoint/2010/main" val="512601409"/>
+        <p14:creationId xmlns:p14="http://schemas.microsoft.com/office/powerpoint/2010/main" val="1079977351"/>
       </p:ext>
     </p:extLst>
   </p:cSld>
@@ -8280,7 +9523,7 @@
           <p:cNvPr id="13" name="">
             <a:extLst xmlns:a="http://schemas.openxmlformats.org/drawingml/2006/main">
               <a:ext uri="{FF2B5EF4-FFF2-40B4-BE49-F238E27FC236}">
-                <a16:creationId xmlns:a16="http://schemas.microsoft.com/office/drawing/2014/main" id="{8192C54A-6898-4329-A70E-FC180B335280}"/>
+                <a16:creationId xmlns:a16="http://schemas.microsoft.com/office/drawing/2014/main" id="{420A89CC-69AD-497C-AF8D-FA5079C6EE06}"/>
               </a:ext>
             </a:extLst>
           </p:cNvPr>
@@ -8330,7 +9573,7 @@
           <p:cNvPr id="2" name="">
             <a:extLst xmlns:a="http://schemas.openxmlformats.org/drawingml/2006/main">
               <a:ext uri="{FF2B5EF4-FFF2-40B4-BE49-F238E27FC236}">
-                <a16:creationId xmlns:a16="http://schemas.microsoft.com/office/drawing/2014/main" id="{D791AAE8-0A74-4585-9813-9BB9E1D97AEE}"/>
+                <a16:creationId xmlns:a16="http://schemas.microsoft.com/office/drawing/2014/main" id="{E469EF6B-D2DB-433F-B7D1-59EE7517313E}"/>
               </a:ext>
             </a:extLst>
           </p:cNvPr>
@@ -8384,7 +9627,7 @@
           <p:nvPr/>
         </p:nvPicPr>
         <p:blipFill>
-          <a:blip xmlns:r="http://schemas.openxmlformats.org/officeDocument/2006/relationships" xmlns:a="http://schemas.openxmlformats.org/drawingml/2006/main" r:embed="R67a320ad8d814d10"/>
+          <a:blip xmlns:r="http://schemas.openxmlformats.org/officeDocument/2006/relationships" xmlns:a="http://schemas.openxmlformats.org/drawingml/2006/main" r:embed="Rffc454e21491477a"/>
           <a:stretch xmlns:a="http://schemas.openxmlformats.org/drawingml/2006/main"/>
         </p:blipFill>
         <p:spPr>
@@ -8402,7 +9645,7 @@
           <p:cNvPr id="4" name="">
             <a:extLst xmlns:a="http://schemas.openxmlformats.org/drawingml/2006/main">
               <a:ext uri="{FF2B5EF4-FFF2-40B4-BE49-F238E27FC236}">
-                <a16:creationId xmlns:a16="http://schemas.microsoft.com/office/drawing/2014/main" id="{CD2250E6-D362-42CA-BCBC-1F6135D12609}"/>
+                <a16:creationId xmlns:a16="http://schemas.microsoft.com/office/drawing/2014/main" id="{5822D81E-5978-483F-BB48-2944842FD18F}"/>
               </a:ext>
             </a:extLst>
           </p:cNvPr>
@@ -8452,7 +9695,7 @@
           <p:cNvPr id="5" name="">
             <a:extLst xmlns:a="http://schemas.openxmlformats.org/drawingml/2006/main">
               <a:ext uri="{FF2B5EF4-FFF2-40B4-BE49-F238E27FC236}">
-                <a16:creationId xmlns:a16="http://schemas.microsoft.com/office/drawing/2014/main" id="{A706E735-D169-48C8-8E8C-F7609764713C}"/>
+                <a16:creationId xmlns:a16="http://schemas.microsoft.com/office/drawing/2014/main" id="{F296E73F-2FC1-4D37-828C-0165FB21803F}"/>
               </a:ext>
             </a:extLst>
           </p:cNvPr>
@@ -8502,7 +9745,7 @@
           <p:cNvPr id="6" name="">
             <a:extLst xmlns:a="http://schemas.openxmlformats.org/drawingml/2006/main">
               <a:ext uri="{FF2B5EF4-FFF2-40B4-BE49-F238E27FC236}">
-                <a16:creationId xmlns:a16="http://schemas.microsoft.com/office/drawing/2014/main" id="{6EFA9B0D-FC89-42C6-B365-5C75450D1EE9}"/>
+                <a16:creationId xmlns:a16="http://schemas.microsoft.com/office/drawing/2014/main" id="{77C01BB6-9C5E-4401-95D9-864684348BA0}"/>
               </a:ext>
             </a:extLst>
           </p:cNvPr>
@@ -8552,7 +9795,7 @@
           <p:cNvPr id="7" name="">
             <a:extLst xmlns:a="http://schemas.openxmlformats.org/drawingml/2006/main">
               <a:ext uri="{FF2B5EF4-FFF2-40B4-BE49-F238E27FC236}">
-                <a16:creationId xmlns:a16="http://schemas.microsoft.com/office/drawing/2014/main" id="{F81CC9E7-5855-46BD-867D-EF8737D81938}"/>
+                <a16:creationId xmlns:a16="http://schemas.microsoft.com/office/drawing/2014/main" id="{50724CF8-DC14-4C4E-87A1-94E2FC01C63B}"/>
               </a:ext>
             </a:extLst>
           </p:cNvPr>
@@ -8602,7 +9845,7 @@
           <p:cNvPr id="8" name="">
             <a:extLst xmlns:a="http://schemas.openxmlformats.org/drawingml/2006/main">
               <a:ext uri="{FF2B5EF4-FFF2-40B4-BE49-F238E27FC236}">
-                <a16:creationId xmlns:a16="http://schemas.microsoft.com/office/drawing/2014/main" id="{6D695476-62F0-44D7-8C13-CE5F346D2882}"/>
+                <a16:creationId xmlns:a16="http://schemas.microsoft.com/office/drawing/2014/main" id="{BC8BB289-4DDE-46E7-8352-B627B59EDE62}"/>
               </a:ext>
             </a:extLst>
           </p:cNvPr>
@@ -8652,7 +9895,7 @@
           <p:cNvPr id="9" name="">
             <a:extLst xmlns:a="http://schemas.openxmlformats.org/drawingml/2006/main">
               <a:ext uri="{FF2B5EF4-FFF2-40B4-BE49-F238E27FC236}">
-                <a16:creationId xmlns:a16="http://schemas.microsoft.com/office/drawing/2014/main" id="{9FDF1C9B-C680-4C49-9EFB-C48530A3AE90}"/>
+                <a16:creationId xmlns:a16="http://schemas.microsoft.com/office/drawing/2014/main" id="{BB975225-ED79-4E81-A012-E44E2FE233AA}"/>
               </a:ext>
             </a:extLst>
           </p:cNvPr>
@@ -8702,7 +9945,7 @@
           <p:cNvPr id="10" name="">
             <a:extLst xmlns:a="http://schemas.openxmlformats.org/drawingml/2006/main">
               <a:ext uri="{FF2B5EF4-FFF2-40B4-BE49-F238E27FC236}">
-                <a16:creationId xmlns:a16="http://schemas.microsoft.com/office/drawing/2014/main" id="{7EE69568-803B-4B3B-93BA-61848935F87F}"/>
+                <a16:creationId xmlns:a16="http://schemas.microsoft.com/office/drawing/2014/main" id="{C938E1E5-7678-4BE5-AFF4-5E9D406E2010}"/>
               </a:ext>
             </a:extLst>
           </p:cNvPr>
@@ -8752,7 +9995,7 @@
           <p:cNvPr id="11" name="">
             <a:extLst xmlns:a="http://schemas.openxmlformats.org/drawingml/2006/main">
               <a:ext uri="{FF2B5EF4-FFF2-40B4-BE49-F238E27FC236}">
-                <a16:creationId xmlns:a16="http://schemas.microsoft.com/office/drawing/2014/main" id="{1D51C70C-ED81-4D60-9754-D8FBC4E00040}"/>
+                <a16:creationId xmlns:a16="http://schemas.microsoft.com/office/drawing/2014/main" id="{844740DF-B636-460D-97C1-AD4E8E63F06A}"/>
               </a:ext>
             </a:extLst>
           </p:cNvPr>
@@ -8802,7 +10045,7 @@
           <p:cNvPr id="12" name="">
             <a:extLst xmlns:a="http://schemas.openxmlformats.org/drawingml/2006/main">
               <a:ext uri="{FF2B5EF4-FFF2-40B4-BE49-F238E27FC236}">
-                <a16:creationId xmlns:a16="http://schemas.microsoft.com/office/drawing/2014/main" id="{2EDFE697-5744-404A-8834-B8171F56C19F}"/>
+                <a16:creationId xmlns:a16="http://schemas.microsoft.com/office/drawing/2014/main" id="{1F1A2E76-8942-4151-BF81-4A93E85AFEEF}"/>
               </a:ext>
             </a:extLst>
           </p:cNvPr>
@@ -8850,7 +10093,7 @@
     </p:spTree>
     <p:extLst>
       <p:ext uri="{BB962C8B-B14F-4D97-AF65-F5344CB8AC3E}">
-        <p14:creationId xmlns:p14="http://schemas.microsoft.com/office/powerpoint/2010/main" val="1383535827"/>
+        <p14:creationId xmlns:p14="http://schemas.microsoft.com/office/powerpoint/2010/main" val="1528600922"/>
       </p:ext>
     </p:extLst>
   </p:cSld>
@@ -8881,7 +10124,7 @@
           <p:cNvPr id="9" name="">
             <a:extLst xmlns:a="http://schemas.openxmlformats.org/drawingml/2006/main">
               <a:ext uri="{FF2B5EF4-FFF2-40B4-BE49-F238E27FC236}">
-                <a16:creationId xmlns:a16="http://schemas.microsoft.com/office/drawing/2014/main" id="{7797D703-B8FB-4033-9EC2-71E63ACD7D27}"/>
+                <a16:creationId xmlns:a16="http://schemas.microsoft.com/office/drawing/2014/main" id="{5DF5D210-C04A-45D1-A4AA-45D8A764DC74}"/>
               </a:ext>
             </a:extLst>
           </p:cNvPr>
@@ -8931,7 +10174,7 @@
           <p:cNvPr id="2" name="">
             <a:extLst xmlns:a="http://schemas.openxmlformats.org/drawingml/2006/main">
               <a:ext uri="{FF2B5EF4-FFF2-40B4-BE49-F238E27FC236}">
-                <a16:creationId xmlns:a16="http://schemas.microsoft.com/office/drawing/2014/main" id="{85344845-725D-4644-BE59-6C4D3E4D0641}"/>
+                <a16:creationId xmlns:a16="http://schemas.microsoft.com/office/drawing/2014/main" id="{FE4FFDE3-75E1-46D0-833B-0E3869F3D7C3}"/>
               </a:ext>
             </a:extLst>
           </p:cNvPr>
@@ -8985,7 +10228,7 @@
           <p:nvPr/>
         </p:nvPicPr>
         <p:blipFill>
-          <a:blip xmlns:r="http://schemas.openxmlformats.org/officeDocument/2006/relationships" xmlns:a="http://schemas.openxmlformats.org/drawingml/2006/main" r:embed="Rf5da76c6325b4799"/>
+          <a:blip xmlns:r="http://schemas.openxmlformats.org/officeDocument/2006/relationships" xmlns:a="http://schemas.openxmlformats.org/drawingml/2006/main" r:embed="R83551dee1ca24116"/>
           <a:stretch xmlns:a="http://schemas.openxmlformats.org/drawingml/2006/main"/>
         </p:blipFill>
         <p:spPr>
@@ -9003,7 +10246,7 @@
           <p:cNvPr id="4" name="">
             <a:extLst xmlns:a="http://schemas.openxmlformats.org/drawingml/2006/main">
               <a:ext uri="{FF2B5EF4-FFF2-40B4-BE49-F238E27FC236}">
-                <a16:creationId xmlns:a16="http://schemas.microsoft.com/office/drawing/2014/main" id="{492A8882-634D-4AFC-BEE1-DD00A256903C}"/>
+                <a16:creationId xmlns:a16="http://schemas.microsoft.com/office/drawing/2014/main" id="{4FCF7857-70C1-4435-A928-1B258A0FACE1}"/>
               </a:ext>
             </a:extLst>
           </p:cNvPr>
@@ -9053,7 +10296,7 @@
           <p:cNvPr id="5" name="">
             <a:extLst xmlns:a="http://schemas.openxmlformats.org/drawingml/2006/main">
               <a:ext uri="{FF2B5EF4-FFF2-40B4-BE49-F238E27FC236}">
-                <a16:creationId xmlns:a16="http://schemas.microsoft.com/office/drawing/2014/main" id="{FCCE234D-12B7-4E98-A285-74E31BF82ECE}"/>
+                <a16:creationId xmlns:a16="http://schemas.microsoft.com/office/drawing/2014/main" id="{D41D5194-78B9-49F7-A082-7971DF82B795}"/>
               </a:ext>
             </a:extLst>
           </p:cNvPr>
@@ -9103,7 +10346,7 @@
           <p:cNvPr id="6" name="">
             <a:extLst xmlns:a="http://schemas.openxmlformats.org/drawingml/2006/main">
               <a:ext uri="{FF2B5EF4-FFF2-40B4-BE49-F238E27FC236}">
-                <a16:creationId xmlns:a16="http://schemas.microsoft.com/office/drawing/2014/main" id="{0C867DED-AAFB-4941-9541-48A203367148}"/>
+                <a16:creationId xmlns:a16="http://schemas.microsoft.com/office/drawing/2014/main" id="{DF79C20E-972E-4653-8879-34F973531F4E}"/>
               </a:ext>
             </a:extLst>
           </p:cNvPr>
@@ -9153,7 +10396,7 @@
           <p:cNvPr id="7" name="">
             <a:extLst xmlns:a="http://schemas.openxmlformats.org/drawingml/2006/main">
               <a:ext uri="{FF2B5EF4-FFF2-40B4-BE49-F238E27FC236}">
-                <a16:creationId xmlns:a16="http://schemas.microsoft.com/office/drawing/2014/main" id="{248DBFF0-43F9-4A41-AD0E-5548FE748641}"/>
+                <a16:creationId xmlns:a16="http://schemas.microsoft.com/office/drawing/2014/main" id="{6ED84EEA-141E-4C1B-ABF4-4594CB70F98C}"/>
               </a:ext>
             </a:extLst>
           </p:cNvPr>
@@ -9203,7 +10446,7 @@
           <p:cNvPr id="8" name="">
             <a:extLst xmlns:a="http://schemas.openxmlformats.org/drawingml/2006/main">
               <a:ext uri="{FF2B5EF4-FFF2-40B4-BE49-F238E27FC236}">
-                <a16:creationId xmlns:a16="http://schemas.microsoft.com/office/drawing/2014/main" id="{B8D2C932-C29E-4DC8-955C-2C6DFB6B55CC}"/>
+                <a16:creationId xmlns:a16="http://schemas.microsoft.com/office/drawing/2014/main" id="{FBA3D3DB-73F5-4D97-9477-CD7B8666EC2D}"/>
               </a:ext>
             </a:extLst>
           </p:cNvPr>
@@ -9251,7 +10494,7 @@
     </p:spTree>
     <p:extLst>
       <p:ext uri="{BB962C8B-B14F-4D97-AF65-F5344CB8AC3E}">
-        <p14:creationId xmlns:p14="http://schemas.microsoft.com/office/powerpoint/2010/main" val="1890699639"/>
+        <p14:creationId xmlns:p14="http://schemas.microsoft.com/office/powerpoint/2010/main" val="1106869428"/>
       </p:ext>
     </p:extLst>
   </p:cSld>
@@ -9282,7 +10525,7 @@
           <p:cNvPr id="7" name="">
             <a:extLst xmlns:a="http://schemas.openxmlformats.org/drawingml/2006/main">
               <a:ext uri="{FF2B5EF4-FFF2-40B4-BE49-F238E27FC236}">
-                <a16:creationId xmlns:a16="http://schemas.microsoft.com/office/drawing/2014/main" id="{2DC40D5E-8534-4652-8003-699C26D67F89}"/>
+                <a16:creationId xmlns:a16="http://schemas.microsoft.com/office/drawing/2014/main" id="{CDBEF49C-69B0-4F0E-951C-27ECBDB7FE28}"/>
               </a:ext>
             </a:extLst>
           </p:cNvPr>
@@ -9332,7 +10575,7 @@
           <p:cNvPr id="2" name="">
             <a:extLst xmlns:a="http://schemas.openxmlformats.org/drawingml/2006/main">
               <a:ext uri="{FF2B5EF4-FFF2-40B4-BE49-F238E27FC236}">
-                <a16:creationId xmlns:a16="http://schemas.microsoft.com/office/drawing/2014/main" id="{207C936F-7DAD-4600-8BDA-6561AF89598E}"/>
+                <a16:creationId xmlns:a16="http://schemas.microsoft.com/office/drawing/2014/main" id="{F48DE9FB-5859-4DE0-AC11-C626FF7B7073}"/>
               </a:ext>
             </a:extLst>
           </p:cNvPr>
@@ -9386,7 +10629,7 @@
           <p:nvPr/>
         </p:nvPicPr>
         <p:blipFill>
-          <a:blip xmlns:r="http://schemas.openxmlformats.org/officeDocument/2006/relationships" xmlns:a="http://schemas.openxmlformats.org/drawingml/2006/main" r:embed="Rd0b858a0a6e24cbf"/>
+          <a:blip xmlns:r="http://schemas.openxmlformats.org/officeDocument/2006/relationships" xmlns:a="http://schemas.openxmlformats.org/drawingml/2006/main" r:embed="R12ea939e569f430e"/>
           <a:stretch xmlns:a="http://schemas.openxmlformats.org/drawingml/2006/main"/>
         </p:blipFill>
         <p:spPr>
@@ -9404,7 +10647,7 @@
           <p:cNvPr id="4" name="">
             <a:extLst xmlns:a="http://schemas.openxmlformats.org/drawingml/2006/main">
               <a:ext uri="{FF2B5EF4-FFF2-40B4-BE49-F238E27FC236}">
-                <a16:creationId xmlns:a16="http://schemas.microsoft.com/office/drawing/2014/main" id="{FA586958-AC4D-471D-8DAD-470CB9B1BE70}"/>
+                <a16:creationId xmlns:a16="http://schemas.microsoft.com/office/drawing/2014/main" id="{F9361A23-936D-4741-9FCB-14880B88186F}"/>
               </a:ext>
             </a:extLst>
           </p:cNvPr>
@@ -9454,7 +10697,7 @@
           <p:cNvPr id="5" name="">
             <a:extLst xmlns:a="http://schemas.openxmlformats.org/drawingml/2006/main">
               <a:ext uri="{FF2B5EF4-FFF2-40B4-BE49-F238E27FC236}">
-                <a16:creationId xmlns:a16="http://schemas.microsoft.com/office/drawing/2014/main" id="{4E7D5F67-6A27-49E7-BB73-F04E173E7FBB}"/>
+                <a16:creationId xmlns:a16="http://schemas.microsoft.com/office/drawing/2014/main" id="{C6547F55-D01C-4F76-8864-D776F41855EE}"/>
               </a:ext>
             </a:extLst>
           </p:cNvPr>
@@ -9504,7 +10747,7 @@
           <p:cNvPr id="6" name="">
             <a:extLst xmlns:a="http://schemas.openxmlformats.org/drawingml/2006/main">
               <a:ext uri="{FF2B5EF4-FFF2-40B4-BE49-F238E27FC236}">
-                <a16:creationId xmlns:a16="http://schemas.microsoft.com/office/drawing/2014/main" id="{C7E6B456-54D0-418B-8B77-5DFC5DD61B83}"/>
+                <a16:creationId xmlns:a16="http://schemas.microsoft.com/office/drawing/2014/main" id="{9F4613CE-FDCF-4F2D-9FD0-28DC6C1321DC}"/>
               </a:ext>
             </a:extLst>
           </p:cNvPr>
@@ -9552,7 +10795,7 @@
     </p:spTree>
     <p:extLst>
       <p:ext uri="{BB962C8B-B14F-4D97-AF65-F5344CB8AC3E}">
-        <p14:creationId xmlns:p14="http://schemas.microsoft.com/office/powerpoint/2010/main" val="977719600"/>
+        <p14:creationId xmlns:p14="http://schemas.microsoft.com/office/powerpoint/2010/main" val="914692184"/>
       </p:ext>
     </p:extLst>
   </p:cSld>

</xml_diff>

<commit_message>
Simplify hardware impact slide for managers
</commit_message>
<xml_diff>
--- a/sglang_direct_kv/artifacts/slides/agent_aware_kv_movement_manager_deck.pptx
+++ b/sglang_direct_kv/artifacts/slides/agent_aware_kv_movement_manager_deck.pptx
@@ -2,24 +2,24 @@
 <file path=ppt/presentation.xml><?xml version="1.0" encoding="utf-8"?>
 <p:presentation xmlns:p="http://schemas.openxmlformats.org/presentationml/2006/main">
   <p:sldMasterIdLst>
-    <p:sldMasterId xmlns:r="http://schemas.openxmlformats.org/officeDocument/2006/relationships" id="2147483648" r:id="R40d3942bad664423"/>
+    <p:sldMasterId xmlns:r="http://schemas.openxmlformats.org/officeDocument/2006/relationships" id="2147483648" r:id="Rdd19941f25ac4c9f"/>
   </p:sldMasterIdLst>
   <p:notesMasterIdLst>
-    <p:notesMasterId xmlns:r="http://schemas.openxmlformats.org/officeDocument/2006/relationships" r:id="R4d113a97877a4b1a"/>
+    <p:notesMasterId xmlns:r="http://schemas.openxmlformats.org/officeDocument/2006/relationships" r:id="R3b9ab355ed5148dd"/>
   </p:notesMasterIdLst>
   <p:sldIdLst>
-    <p:sldId xmlns:r="http://schemas.openxmlformats.org/officeDocument/2006/relationships" id="256" r:id="R5dcec6d074154950"/>
-    <p:sldId xmlns:r="http://schemas.openxmlformats.org/officeDocument/2006/relationships" id="257" r:id="R06ca5600d27144bf"/>
-    <p:sldId xmlns:r="http://schemas.openxmlformats.org/officeDocument/2006/relationships" id="258" r:id="R1365626a08f14d75"/>
-    <p:sldId xmlns:r="http://schemas.openxmlformats.org/officeDocument/2006/relationships" id="259" r:id="Rbc12651a76144b9e"/>
-    <p:sldId xmlns:r="http://schemas.openxmlformats.org/officeDocument/2006/relationships" id="260" r:id="R92ef069b993c46fe"/>
-    <p:sldId xmlns:r="http://schemas.openxmlformats.org/officeDocument/2006/relationships" id="261" r:id="Re24b14165cef44e6"/>
-    <p:sldId xmlns:r="http://schemas.openxmlformats.org/officeDocument/2006/relationships" id="262" r:id="R75712280d49944ed"/>
-    <p:sldId xmlns:r="http://schemas.openxmlformats.org/officeDocument/2006/relationships" id="263" r:id="R4e08a2964863474b"/>
-    <p:sldId xmlns:r="http://schemas.openxmlformats.org/officeDocument/2006/relationships" id="264" r:id="R428e6f7cdb654358"/>
-    <p:sldId xmlns:r="http://schemas.openxmlformats.org/officeDocument/2006/relationships" id="265" r:id="Rd8aa53cf8f614e1f"/>
-    <p:sldId xmlns:r="http://schemas.openxmlformats.org/officeDocument/2006/relationships" id="266" r:id="R3443f83985f44ee5"/>
-    <p:sldId xmlns:r="http://schemas.openxmlformats.org/officeDocument/2006/relationships" id="267" r:id="R0143f6f7023d4dd2"/>
+    <p:sldId xmlns:r="http://schemas.openxmlformats.org/officeDocument/2006/relationships" id="256" r:id="R3747018f52a847ed"/>
+    <p:sldId xmlns:r="http://schemas.openxmlformats.org/officeDocument/2006/relationships" id="257" r:id="R10fb33f07ceb472a"/>
+    <p:sldId xmlns:r="http://schemas.openxmlformats.org/officeDocument/2006/relationships" id="258" r:id="R1ff5d80340db4d44"/>
+    <p:sldId xmlns:r="http://schemas.openxmlformats.org/officeDocument/2006/relationships" id="259" r:id="R4b61aa6434d84c08"/>
+    <p:sldId xmlns:r="http://schemas.openxmlformats.org/officeDocument/2006/relationships" id="260" r:id="R1e9c2c7fe8b641bd"/>
+    <p:sldId xmlns:r="http://schemas.openxmlformats.org/officeDocument/2006/relationships" id="261" r:id="Rbe6f11dc51634325"/>
+    <p:sldId xmlns:r="http://schemas.openxmlformats.org/officeDocument/2006/relationships" id="262" r:id="R0256c9fd73004179"/>
+    <p:sldId xmlns:r="http://schemas.openxmlformats.org/officeDocument/2006/relationships" id="263" r:id="Ra8f0a96523904ac3"/>
+    <p:sldId xmlns:r="http://schemas.openxmlformats.org/officeDocument/2006/relationships" id="264" r:id="R309071f66e354c5b"/>
+    <p:sldId xmlns:r="http://schemas.openxmlformats.org/officeDocument/2006/relationships" id="265" r:id="R30f277db03c14201"/>
+    <p:sldId xmlns:r="http://schemas.openxmlformats.org/officeDocument/2006/relationships" id="266" r:id="R4e067635c6524ff7"/>
+    <p:sldId xmlns:r="http://schemas.openxmlformats.org/officeDocument/2006/relationships" id="267" r:id="Ra1672ae8f55b4568"/>
   </p:sldIdLst>
   <p:sldSz cx="12192000" cy="6858000"/>
   <p:notesSz cx="6858000" cy="9144000"/>
@@ -653,27 +653,27 @@
           <a:lstStyle xmlns:a="http://schemas.openxmlformats.org/drawingml/2006/main"/>
           <a:p xmlns:a="http://schemas.openxmlformats.org/drawingml/2006/main">
             <a:r>
-              <a:t>This slide intentionally frames benefits as ballpark expectations and research targets.</a:t>
-            </a:r>
-          </a:p>
-          <a:p xmlns:a="http://schemas.openxmlformats.org/drawingml/2006/main">
-            <a:r>
-              <a:t>The table ties each benefit estimate to an observed mechanism: late replay H2D, recompute after KV loss, late hint completion, and wasted prefetch.</a:t>
-            </a:r>
-          </a:p>
-          <a:p xmlns:a="http://schemas.openxmlformats.org/drawingml/2006/main">
-            <a:r>
-              <a:t>Low-end gains are plausible when KV is already mostly resident and only small stalls remain.</a:t>
-            </a:r>
-          </a:p>
-          <a:p xmlns:a="http://schemas.openxmlformats.org/drawingml/2006/main">
-            <a:r>
-              <a:t>High-end gains are plausible when contexts are long, cache pressure is high, and replay falls back to H2D reload or recompute.</a:t>
-            </a:r>
-          </a:p>
-          <a:p xmlns:a="http://schemas.openxmlformats.org/drawingml/2006/main">
-            <a:r>
-              <a:t>Potential benefit ranges are internal proposal estimates based on observed late prefetch/replay H2D patterns and expected gains from deadline-aware KV movement.</a:t>
+              <a:t>This slide intentionally avoids internal terms such as H2D and replay-prefill on the visible canvas.</a:t>
+            </a:r>
+          </a:p>
+          <a:p xmlns:a="http://schemas.openxmlformats.org/drawingml/2006/main">
+            <a:r>
+              <a:t>Translate for technical discussion: faster agent resume corresponds to lowering post-tool replay latency when KV is ready earlier.</a:t>
+            </a:r>
+          </a:p>
+          <a:p xmlns:a="http://schemas.openxmlformats.org/drawingml/2006/main">
+            <a:r>
+              <a:t>Fewer wasted memory movements corresponds to reducing late prefetches, evicted-before-use KV, and redundant reloads.</a:t>
+            </a:r>
+          </a:p>
+          <a:p xmlns:a="http://schemas.openxmlformats.org/drawingml/2006/main">
+            <a:r>
+              <a:t>More predictable tail latency corresponds to reducing p95/p99 stalls caused by context-agnostic memory scheduling.</a:t>
+            </a:r>
+          </a:p>
+          <a:p xmlns:a="http://schemas.openxmlformats.org/drawingml/2006/main">
+            <a:r>
+              <a:t>Potential benefit ranges are conservative internal proposal targets based on observed late prefetch/replay H2D patterns and expected gains from deadline-aware KV movement.</a:t>
             </a:r>
           </a:p>
           <a:p xmlns:a="http://schemas.openxmlformats.org/drawingml/2006/main">
@@ -1671,7 +1671,7 @@
   </p:cSld>
   <p:clrMap bg1="lt1" tx1="dk1" bg2="lt2" tx2="dk2" accent1="accent1" accent2="accent2" accent3="accent3" accent4="accent4" accent5="accent5" accent6="accent6" hlink="hlink" folHlink="folHlink"/>
   <p:sldLayoutIdLst>
-    <p:sldLayoutId xmlns:r="http://schemas.openxmlformats.org/officeDocument/2006/relationships" id="2147483649" r:id="R58678bbb0051414a"/>
+    <p:sldLayoutId xmlns:r="http://schemas.openxmlformats.org/officeDocument/2006/relationships" id="2147483649" r:id="Re294e6d64ab644ea"/>
   </p:sldLayoutIdLst>
   <p:txStyles>
     <p:titleStyle>
@@ -2222,7 +2222,7 @@
           <p:cNvPr id="12" name="">
             <a:extLst xmlns:a="http://schemas.openxmlformats.org/drawingml/2006/main">
               <a:ext uri="{FF2B5EF4-FFF2-40B4-BE49-F238E27FC236}">
-                <a16:creationId xmlns:a16="http://schemas.microsoft.com/office/drawing/2014/main" id="{2BE8AC51-12DF-490F-B70B-0D599428BA7E}"/>
+                <a16:creationId xmlns:a16="http://schemas.microsoft.com/office/drawing/2014/main" id="{F999D096-759A-4CF7-80BC-AEEC8EDCD149}"/>
               </a:ext>
             </a:extLst>
           </p:cNvPr>
@@ -2272,7 +2272,7 @@
           <p:cNvPr id="2" name="">
             <a:extLst xmlns:a="http://schemas.openxmlformats.org/drawingml/2006/main">
               <a:ext uri="{FF2B5EF4-FFF2-40B4-BE49-F238E27FC236}">
-                <a16:creationId xmlns:a16="http://schemas.microsoft.com/office/drawing/2014/main" id="{4A36DC6C-D510-428A-9767-5E5944A41475}"/>
+                <a16:creationId xmlns:a16="http://schemas.microsoft.com/office/drawing/2014/main" id="{D64462A8-A55B-4784-8D10-DFAEFC955DC2}"/>
               </a:ext>
             </a:extLst>
           </p:cNvPr>
@@ -2322,7 +2322,7 @@
           <p:cNvPr id="3" name="">
             <a:extLst xmlns:a="http://schemas.openxmlformats.org/drawingml/2006/main">
               <a:ext uri="{FF2B5EF4-FFF2-40B4-BE49-F238E27FC236}">
-                <a16:creationId xmlns:a16="http://schemas.microsoft.com/office/drawing/2014/main" id="{0D4EE2CF-12A0-4A99-907E-273C1D33B94F}"/>
+                <a16:creationId xmlns:a16="http://schemas.microsoft.com/office/drawing/2014/main" id="{551B11E0-FF31-4E0B-8F1B-D266111653E9}"/>
               </a:ext>
             </a:extLst>
           </p:cNvPr>
@@ -2353,7 +2353,7 @@
           <p:cNvPr id="4" name="">
             <a:extLst xmlns:a="http://schemas.openxmlformats.org/drawingml/2006/main">
               <a:ext uri="{FF2B5EF4-FFF2-40B4-BE49-F238E27FC236}">
-                <a16:creationId xmlns:a16="http://schemas.microsoft.com/office/drawing/2014/main" id="{AFDF0CBA-F550-4283-9D1D-99B526B7529F}"/>
+                <a16:creationId xmlns:a16="http://schemas.microsoft.com/office/drawing/2014/main" id="{86EBA2A1-B361-410A-8182-8067D38FF181}"/>
               </a:ext>
             </a:extLst>
           </p:cNvPr>
@@ -2403,7 +2403,7 @@
           <p:cNvPr id="5" name="">
             <a:extLst xmlns:a="http://schemas.openxmlformats.org/drawingml/2006/main">
               <a:ext uri="{FF2B5EF4-FFF2-40B4-BE49-F238E27FC236}">
-                <a16:creationId xmlns:a16="http://schemas.microsoft.com/office/drawing/2014/main" id="{6F98A2D3-3AB4-442D-B4DE-EFAFE4A4A861}"/>
+                <a16:creationId xmlns:a16="http://schemas.microsoft.com/office/drawing/2014/main" id="{B1693AB9-A175-4515-84EC-B4231DD9F598}"/>
               </a:ext>
             </a:extLst>
           </p:cNvPr>
@@ -2453,7 +2453,7 @@
           <p:cNvPr id="6" name="">
             <a:extLst xmlns:a="http://schemas.openxmlformats.org/drawingml/2006/main">
               <a:ext uri="{FF2B5EF4-FFF2-40B4-BE49-F238E27FC236}">
-                <a16:creationId xmlns:a16="http://schemas.microsoft.com/office/drawing/2014/main" id="{F9E8F69B-E58E-4A44-8786-F99964D252E9}"/>
+                <a16:creationId xmlns:a16="http://schemas.microsoft.com/office/drawing/2014/main" id="{0436163B-6727-4BB7-A387-3D9853679692}"/>
               </a:ext>
             </a:extLst>
           </p:cNvPr>
@@ -2503,7 +2503,7 @@
           <p:cNvPr id="7" name="">
             <a:extLst xmlns:a="http://schemas.openxmlformats.org/drawingml/2006/main">
               <a:ext uri="{FF2B5EF4-FFF2-40B4-BE49-F238E27FC236}">
-                <a16:creationId xmlns:a16="http://schemas.microsoft.com/office/drawing/2014/main" id="{1979369D-7927-4796-9A72-5E0E95732E4B}"/>
+                <a16:creationId xmlns:a16="http://schemas.microsoft.com/office/drawing/2014/main" id="{4EB4A988-1C85-4C5E-B8B5-76DE39C0EB13}"/>
               </a:ext>
             </a:extLst>
           </p:cNvPr>
@@ -2553,7 +2553,7 @@
           <p:cNvPr id="8" name="">
             <a:extLst xmlns:a="http://schemas.openxmlformats.org/drawingml/2006/main">
               <a:ext uri="{FF2B5EF4-FFF2-40B4-BE49-F238E27FC236}">
-                <a16:creationId xmlns:a16="http://schemas.microsoft.com/office/drawing/2014/main" id="{86BD44E5-C814-4771-847F-EC61D2E96C03}"/>
+                <a16:creationId xmlns:a16="http://schemas.microsoft.com/office/drawing/2014/main" id="{771150D8-8CF0-4A3E-9E97-E0D8FC4948FE}"/>
               </a:ext>
             </a:extLst>
           </p:cNvPr>
@@ -2603,7 +2603,7 @@
           <p:cNvPr id="9" name="">
             <a:extLst xmlns:a="http://schemas.openxmlformats.org/drawingml/2006/main">
               <a:ext uri="{FF2B5EF4-FFF2-40B4-BE49-F238E27FC236}">
-                <a16:creationId xmlns:a16="http://schemas.microsoft.com/office/drawing/2014/main" id="{84569A75-B9E3-41A0-B4B9-B0A3783D816E}"/>
+                <a16:creationId xmlns:a16="http://schemas.microsoft.com/office/drawing/2014/main" id="{19049D14-8459-44DA-8F7B-7464BB3D6058}"/>
               </a:ext>
             </a:extLst>
           </p:cNvPr>
@@ -2653,7 +2653,7 @@
           <p:cNvPr id="10" name="">
             <a:extLst xmlns:a="http://schemas.openxmlformats.org/drawingml/2006/main">
               <a:ext uri="{FF2B5EF4-FFF2-40B4-BE49-F238E27FC236}">
-                <a16:creationId xmlns:a16="http://schemas.microsoft.com/office/drawing/2014/main" id="{846158E8-77EE-4599-87D5-186387181BAD}"/>
+                <a16:creationId xmlns:a16="http://schemas.microsoft.com/office/drawing/2014/main" id="{5ED37489-5E99-4C6A-B836-2681A11EE898}"/>
               </a:ext>
             </a:extLst>
           </p:cNvPr>
@@ -2703,7 +2703,7 @@
           <p:cNvPr id="11" name="">
             <a:extLst xmlns:a="http://schemas.openxmlformats.org/drawingml/2006/main">
               <a:ext uri="{FF2B5EF4-FFF2-40B4-BE49-F238E27FC236}">
-                <a16:creationId xmlns:a16="http://schemas.microsoft.com/office/drawing/2014/main" id="{1662F6F2-F813-493F-BB83-1B8958ED0252}"/>
+                <a16:creationId xmlns:a16="http://schemas.microsoft.com/office/drawing/2014/main" id="{034DCA3F-84B8-4721-8ECA-05EB7D57D81E}"/>
               </a:ext>
             </a:extLst>
           </p:cNvPr>
@@ -2751,7 +2751,7 @@
     </p:spTree>
     <p:extLst>
       <p:ext uri="{BB962C8B-B14F-4D97-AF65-F5344CB8AC3E}">
-        <p14:creationId xmlns:p14="http://schemas.microsoft.com/office/powerpoint/2010/main" val="779423332"/>
+        <p14:creationId xmlns:p14="http://schemas.microsoft.com/office/powerpoint/2010/main" val="919480083"/>
       </p:ext>
     </p:extLst>
   </p:cSld>
@@ -2782,7 +2782,7 @@
           <p:cNvPr id="17" name="">
             <a:extLst xmlns:a="http://schemas.openxmlformats.org/drawingml/2006/main">
               <a:ext uri="{FF2B5EF4-FFF2-40B4-BE49-F238E27FC236}">
-                <a16:creationId xmlns:a16="http://schemas.microsoft.com/office/drawing/2014/main" id="{0909186F-299F-4F0A-A072-48757DBCAE02}"/>
+                <a16:creationId xmlns:a16="http://schemas.microsoft.com/office/drawing/2014/main" id="{A58CD9DE-7C59-4F93-AE45-D91BB5A7451F}"/>
               </a:ext>
             </a:extLst>
           </p:cNvPr>
@@ -2832,7 +2832,7 @@
           <p:cNvPr id="2" name="">
             <a:extLst xmlns:a="http://schemas.openxmlformats.org/drawingml/2006/main">
               <a:ext uri="{FF2B5EF4-FFF2-40B4-BE49-F238E27FC236}">
-                <a16:creationId xmlns:a16="http://schemas.microsoft.com/office/drawing/2014/main" id="{4A88393E-98CD-458C-B2C0-2798CF88B3E7}"/>
+                <a16:creationId xmlns:a16="http://schemas.microsoft.com/office/drawing/2014/main" id="{8AC5B8B2-5A48-4A1E-92A2-1962CE762B25}"/>
               </a:ext>
             </a:extLst>
           </p:cNvPr>
@@ -2882,7 +2882,7 @@
           <p:cNvPr id="3" name="">
             <a:extLst xmlns:a="http://schemas.openxmlformats.org/drawingml/2006/main">
               <a:ext uri="{FF2B5EF4-FFF2-40B4-BE49-F238E27FC236}">
-                <a16:creationId xmlns:a16="http://schemas.microsoft.com/office/drawing/2014/main" id="{EF11D1F2-7F96-4791-BDE8-9640A48C7A8B}"/>
+                <a16:creationId xmlns:a16="http://schemas.microsoft.com/office/drawing/2014/main" id="{AABBCCF7-70F7-4EF6-A01F-3A831DC23DD6}"/>
               </a:ext>
             </a:extLst>
           </p:cNvPr>
@@ -2932,7 +2932,7 @@
           <p:cNvPr id="4" name="">
             <a:extLst xmlns:a="http://schemas.openxmlformats.org/drawingml/2006/main">
               <a:ext uri="{FF2B5EF4-FFF2-40B4-BE49-F238E27FC236}">
-                <a16:creationId xmlns:a16="http://schemas.microsoft.com/office/drawing/2014/main" id="{587D8C23-1119-41C4-8145-1C0AE95A5B78}"/>
+                <a16:creationId xmlns:a16="http://schemas.microsoft.com/office/drawing/2014/main" id="{F1B23511-75DF-467F-9087-119AFF50FA38}"/>
               </a:ext>
             </a:extLst>
           </p:cNvPr>
@@ -2982,7 +2982,7 @@
           <p:cNvPr id="5" name="">
             <a:extLst xmlns:a="http://schemas.openxmlformats.org/drawingml/2006/main">
               <a:ext uri="{FF2B5EF4-FFF2-40B4-BE49-F238E27FC236}">
-                <a16:creationId xmlns:a16="http://schemas.microsoft.com/office/drawing/2014/main" id="{1C9EB440-8330-4926-9E2E-C476D03A967E}"/>
+                <a16:creationId xmlns:a16="http://schemas.microsoft.com/office/drawing/2014/main" id="{06A3EC39-6CA7-4A35-8214-93C22DF1D211}"/>
               </a:ext>
             </a:extLst>
           </p:cNvPr>
@@ -3032,7 +3032,7 @@
           <p:cNvPr id="6" name="">
             <a:extLst xmlns:a="http://schemas.openxmlformats.org/drawingml/2006/main">
               <a:ext uri="{FF2B5EF4-FFF2-40B4-BE49-F238E27FC236}">
-                <a16:creationId xmlns:a16="http://schemas.microsoft.com/office/drawing/2014/main" id="{5D4AC944-59FC-4FAF-98A8-5C0D93B32F81}"/>
+                <a16:creationId xmlns:a16="http://schemas.microsoft.com/office/drawing/2014/main" id="{75412647-D8B8-4CF0-8957-515A58D453A2}"/>
               </a:ext>
             </a:extLst>
           </p:cNvPr>
@@ -3082,7 +3082,7 @@
           <p:cNvPr id="7" name="">
             <a:extLst xmlns:a="http://schemas.openxmlformats.org/drawingml/2006/main">
               <a:ext uri="{FF2B5EF4-FFF2-40B4-BE49-F238E27FC236}">
-                <a16:creationId xmlns:a16="http://schemas.microsoft.com/office/drawing/2014/main" id="{8D98494F-EFE6-4668-B8A8-AA63DE8FD7CD}"/>
+                <a16:creationId xmlns:a16="http://schemas.microsoft.com/office/drawing/2014/main" id="{4F28DCCB-43CF-482D-9FC4-AC0292C6FCBF}"/>
               </a:ext>
             </a:extLst>
           </p:cNvPr>
@@ -3132,7 +3132,7 @@
           <p:cNvPr id="8" name="">
             <a:extLst xmlns:a="http://schemas.openxmlformats.org/drawingml/2006/main">
               <a:ext uri="{FF2B5EF4-FFF2-40B4-BE49-F238E27FC236}">
-                <a16:creationId xmlns:a16="http://schemas.microsoft.com/office/drawing/2014/main" id="{62A54583-B8AC-4007-AFFA-D144C98A5DC7}"/>
+                <a16:creationId xmlns:a16="http://schemas.microsoft.com/office/drawing/2014/main" id="{2B421B0F-2E07-4406-B27F-5003B5EE01A8}"/>
               </a:ext>
             </a:extLst>
           </p:cNvPr>
@@ -3182,7 +3182,7 @@
           <p:cNvPr id="9" name="">
             <a:extLst xmlns:a="http://schemas.openxmlformats.org/drawingml/2006/main">
               <a:ext uri="{FF2B5EF4-FFF2-40B4-BE49-F238E27FC236}">
-                <a16:creationId xmlns:a16="http://schemas.microsoft.com/office/drawing/2014/main" id="{6418B938-7E7C-4B95-A8CD-1580DC5167CC}"/>
+                <a16:creationId xmlns:a16="http://schemas.microsoft.com/office/drawing/2014/main" id="{10AC94F0-21D7-49CF-8511-B6F052F0B9A0}"/>
               </a:ext>
             </a:extLst>
           </p:cNvPr>
@@ -3232,7 +3232,7 @@
           <p:cNvPr id="10" name="">
             <a:extLst xmlns:a="http://schemas.openxmlformats.org/drawingml/2006/main">
               <a:ext uri="{FF2B5EF4-FFF2-40B4-BE49-F238E27FC236}">
-                <a16:creationId xmlns:a16="http://schemas.microsoft.com/office/drawing/2014/main" id="{64CE8A19-588D-485C-8D1D-974BB44CF09B}"/>
+                <a16:creationId xmlns:a16="http://schemas.microsoft.com/office/drawing/2014/main" id="{CAF8F4E6-F19C-431A-B1EB-029082E95DF2}"/>
               </a:ext>
             </a:extLst>
           </p:cNvPr>
@@ -3282,7 +3282,7 @@
           <p:cNvPr id="11" name="">
             <a:extLst xmlns:a="http://schemas.openxmlformats.org/drawingml/2006/main">
               <a:ext uri="{FF2B5EF4-FFF2-40B4-BE49-F238E27FC236}">
-                <a16:creationId xmlns:a16="http://schemas.microsoft.com/office/drawing/2014/main" id="{16F47999-2E50-4376-8CB3-782293C942C3}"/>
+                <a16:creationId xmlns:a16="http://schemas.microsoft.com/office/drawing/2014/main" id="{AD871F86-7098-45EE-B2E4-EA7D79CB99B0}"/>
               </a:ext>
             </a:extLst>
           </p:cNvPr>
@@ -3332,7 +3332,7 @@
           <p:cNvPr id="12" name="">
             <a:extLst xmlns:a="http://schemas.openxmlformats.org/drawingml/2006/main">
               <a:ext uri="{FF2B5EF4-FFF2-40B4-BE49-F238E27FC236}">
-                <a16:creationId xmlns:a16="http://schemas.microsoft.com/office/drawing/2014/main" id="{35D53424-E5EF-495F-A691-A7D970DC5AF9}"/>
+                <a16:creationId xmlns:a16="http://schemas.microsoft.com/office/drawing/2014/main" id="{D8F91BBE-0ACC-4C87-A921-462948210056}"/>
               </a:ext>
             </a:extLst>
           </p:cNvPr>
@@ -3382,7 +3382,7 @@
           <p:cNvPr id="13" name="">
             <a:extLst xmlns:a="http://schemas.openxmlformats.org/drawingml/2006/main">
               <a:ext uri="{FF2B5EF4-FFF2-40B4-BE49-F238E27FC236}">
-                <a16:creationId xmlns:a16="http://schemas.microsoft.com/office/drawing/2014/main" id="{E40A1E29-39A0-4831-8297-2F8A6782D6FA}"/>
+                <a16:creationId xmlns:a16="http://schemas.microsoft.com/office/drawing/2014/main" id="{786513C9-A431-4695-8AE7-851F7F9CB91B}"/>
               </a:ext>
             </a:extLst>
           </p:cNvPr>
@@ -3413,7 +3413,7 @@
           <p:cNvPr id="14" name="">
             <a:extLst xmlns:a="http://schemas.openxmlformats.org/drawingml/2006/main">
               <a:ext uri="{FF2B5EF4-FFF2-40B4-BE49-F238E27FC236}">
-                <a16:creationId xmlns:a16="http://schemas.microsoft.com/office/drawing/2014/main" id="{5BB5ED05-9F3B-4725-8A99-CF91D7E31A2C}"/>
+                <a16:creationId xmlns:a16="http://schemas.microsoft.com/office/drawing/2014/main" id="{537E4755-2015-45BF-B890-323D8ED931D8}"/>
               </a:ext>
             </a:extLst>
           </p:cNvPr>
@@ -3463,7 +3463,7 @@
           <p:cNvPr id="15" name="">
             <a:extLst xmlns:a="http://schemas.openxmlformats.org/drawingml/2006/main">
               <a:ext uri="{FF2B5EF4-FFF2-40B4-BE49-F238E27FC236}">
-                <a16:creationId xmlns:a16="http://schemas.microsoft.com/office/drawing/2014/main" id="{7E5EDB16-C868-4D2D-AC11-42D4459C0F43}"/>
+                <a16:creationId xmlns:a16="http://schemas.microsoft.com/office/drawing/2014/main" id="{91B6AC60-DF40-43FA-8CF3-B3D6EDFB7885}"/>
               </a:ext>
             </a:extLst>
           </p:cNvPr>
@@ -3513,7 +3513,7 @@
           <p:cNvPr id="16" name="">
             <a:extLst xmlns:a="http://schemas.openxmlformats.org/drawingml/2006/main">
               <a:ext uri="{FF2B5EF4-FFF2-40B4-BE49-F238E27FC236}">
-                <a16:creationId xmlns:a16="http://schemas.microsoft.com/office/drawing/2014/main" id="{C363CAAA-A22F-452D-9262-ED1DE289DDA3}"/>
+                <a16:creationId xmlns:a16="http://schemas.microsoft.com/office/drawing/2014/main" id="{3439C747-162C-4542-B2E9-D51832D83C12}"/>
               </a:ext>
             </a:extLst>
           </p:cNvPr>
@@ -3561,7 +3561,7 @@
     </p:spTree>
     <p:extLst>
       <p:ext uri="{BB962C8B-B14F-4D97-AF65-F5344CB8AC3E}">
-        <p14:creationId xmlns:p14="http://schemas.microsoft.com/office/powerpoint/2010/main" val="406075102"/>
+        <p14:creationId xmlns:p14="http://schemas.microsoft.com/office/powerpoint/2010/main" val="1851075174"/>
       </p:ext>
     </p:extLst>
   </p:cSld>
@@ -3589,10 +3589,10 @@
       </p:grpSpPr>
       <p:sp>
         <p:nvSpPr>
-          <p:cNvPr id="44" name="">
-            <a:extLst xmlns:a="http://schemas.openxmlformats.org/drawingml/2006/main">
-              <a:ext uri="{FF2B5EF4-FFF2-40B4-BE49-F238E27FC236}">
-                <a16:creationId xmlns:a16="http://schemas.microsoft.com/office/drawing/2014/main" id="{C9BEB51E-4CE4-4925-A706-CA51504F6AF4}"/>
+          <p:cNvPr id="22" name="">
+            <a:extLst xmlns:a="http://schemas.openxmlformats.org/drawingml/2006/main">
+              <a:ext uri="{FF2B5EF4-FFF2-40B4-BE49-F238E27FC236}">
+                <a16:creationId xmlns:a16="http://schemas.microsoft.com/office/drawing/2014/main" id="{3AECBB62-54C9-4112-85B4-18ACEE28F499}"/>
               </a:ext>
             </a:extLst>
           </p:cNvPr>
@@ -3642,7 +3642,7 @@
           <p:cNvPr id="2" name="">
             <a:extLst xmlns:a="http://schemas.openxmlformats.org/drawingml/2006/main">
               <a:ext uri="{FF2B5EF4-FFF2-40B4-BE49-F238E27FC236}">
-                <a16:creationId xmlns:a16="http://schemas.microsoft.com/office/drawing/2014/main" id="{B1A445DC-2DBE-41D6-A284-D4D5B4322341}"/>
+                <a16:creationId xmlns:a16="http://schemas.microsoft.com/office/drawing/2014/main" id="{A8BD059F-89E3-46CA-8FDF-0AE0708D9BBC}"/>
               </a:ext>
             </a:extLst>
           </p:cNvPr>
@@ -3682,7 +3682,7 @@
                   <a:srgbClr val="64748B"/>
                 </a:solidFill>
               </a:rPr>
-              <a:t>The ranges are tied to observed failure modes, not standalone guesses.</a:t>
+              <a:t>Simple targets for tool-heavy coding-agent workloads.</a:t>
             </a:r>
           </a:p>
         </p:txBody>
@@ -3692,779 +3692,790 @@
           <p:cNvPr id="3" name="">
             <a:extLst xmlns:a="http://schemas.openxmlformats.org/drawingml/2006/main">
               <a:ext uri="{FF2B5EF4-FFF2-40B4-BE49-F238E27FC236}">
-                <a16:creationId xmlns:a16="http://schemas.microsoft.com/office/drawing/2014/main" id="{0A48BA8D-68CD-4B54-8A58-7F59B86751C8}"/>
-              </a:ext>
-            </a:extLst>
-          </p:cNvPr>
-          <p:cNvSpPr>
-            <a:spLocks xmlns:a="http://schemas.openxmlformats.org/drawingml/2006/main" noGrp="1"/>
-          </p:cNvSpPr>
-          <p:nvPr/>
-        </p:nvSpPr>
-        <p:spPr>
-          <a:xfrm xmlns:a="http://schemas.openxmlformats.org/drawingml/2006/main">
-            <a:off x="514350" y="1485900"/>
-            <a:ext cx="10906125" cy="381000"/>
+                <a16:creationId xmlns:a16="http://schemas.microsoft.com/office/drawing/2014/main" id="{FC8D48C4-AD5D-4499-BD26-90907D0B8874}"/>
+              </a:ext>
+            </a:extLst>
+          </p:cNvPr>
+          <p:cNvSpPr>
+            <a:spLocks xmlns:a="http://schemas.openxmlformats.org/drawingml/2006/main" noGrp="1"/>
+          </p:cNvSpPr>
+          <p:nvPr/>
+        </p:nvSpPr>
+        <p:spPr>
+          <a:xfrm xmlns:a="http://schemas.openxmlformats.org/drawingml/2006/main">
+            <a:off x="685800" y="1562100"/>
+            <a:ext cx="533400" cy="342900"/>
+          </a:xfrm>
+          <a:prstGeom xmlns:a="http://schemas.openxmlformats.org/drawingml/2006/main" prst="rect">
+            <a:avLst/>
+          </a:prstGeom>
+          <a:noFill xmlns:a="http://schemas.openxmlformats.org/drawingml/2006/main"/>
+          <a:ln xmlns:a="http://schemas.openxmlformats.org/drawingml/2006/main" w="0">
+            <a:noFill/>
+            <a:prstDash val="solid"/>
+          </a:ln>
+        </p:spPr>
+        <p:txBody>
+          <a:bodyPr xmlns:a="http://schemas.openxmlformats.org/drawingml/2006/main" anchor="t"/>
+          <a:lstStyle xmlns:a="http://schemas.openxmlformats.org/drawingml/2006/main"/>
+          <a:p xmlns:a="http://schemas.openxmlformats.org/drawingml/2006/main">
+            <a:pPr algn="l">
+              <a:defRPr sz="1875" b="1">
+                <a:solidFill>
+                  <a:srgbClr val="2563EB"/>
+                </a:solidFill>
+              </a:defRPr>
+            </a:pPr>
+            <a:r>
+              <a:rPr sz="1875" b="1">
+                <a:solidFill>
+                  <a:srgbClr val="2563EB"/>
+                </a:solidFill>
+              </a:rPr>
+              <a:t>1.</a:t>
+            </a:r>
+          </a:p>
+        </p:txBody>
+      </p:sp>
+      <p:sp>
+        <p:nvSpPr>
+          <p:cNvPr id="4" name="">
+            <a:extLst xmlns:a="http://schemas.openxmlformats.org/drawingml/2006/main">
+              <a:ext uri="{FF2B5EF4-FFF2-40B4-BE49-F238E27FC236}">
+                <a16:creationId xmlns:a16="http://schemas.microsoft.com/office/drawing/2014/main" id="{92375BAA-E69E-449F-B345-2CA90298BD8B}"/>
+              </a:ext>
+            </a:extLst>
+          </p:cNvPr>
+          <p:cNvSpPr>
+            <a:spLocks xmlns:a="http://schemas.openxmlformats.org/drawingml/2006/main" noGrp="1"/>
+          </p:cNvSpPr>
+          <p:nvPr/>
+        </p:nvSpPr>
+        <p:spPr>
+          <a:xfrm xmlns:a="http://schemas.openxmlformats.org/drawingml/2006/main">
+            <a:off x="1123950" y="1562100"/>
+            <a:ext cx="5334000" cy="323850"/>
+          </a:xfrm>
+          <a:prstGeom xmlns:a="http://schemas.openxmlformats.org/drawingml/2006/main" prst="rect">
+            <a:avLst/>
+          </a:prstGeom>
+          <a:noFill xmlns:a="http://schemas.openxmlformats.org/drawingml/2006/main"/>
+          <a:ln xmlns:a="http://schemas.openxmlformats.org/drawingml/2006/main" w="0">
+            <a:noFill/>
+            <a:prstDash val="solid"/>
+          </a:ln>
+        </p:spPr>
+        <p:txBody>
+          <a:bodyPr xmlns:a="http://schemas.openxmlformats.org/drawingml/2006/main" anchor="t"/>
+          <a:lstStyle xmlns:a="http://schemas.openxmlformats.org/drawingml/2006/main"/>
+          <a:p xmlns:a="http://schemas.openxmlformats.org/drawingml/2006/main">
+            <a:pPr algn="l">
+              <a:defRPr sz="1875" b="1">
+                <a:solidFill>
+                  <a:srgbClr val="0F172A"/>
+                </a:solidFill>
+              </a:defRPr>
+            </a:pPr>
+            <a:r>
+              <a:rPr sz="1875" b="1">
+                <a:solidFill>
+                  <a:srgbClr val="0F172A"/>
+                </a:solidFill>
+              </a:rPr>
+              <a:t>Faster agent resume after tools</a:t>
+            </a:r>
+          </a:p>
+        </p:txBody>
+      </p:sp>
+      <p:sp>
+        <p:nvSpPr>
+          <p:cNvPr id="5" name="">
+            <a:extLst xmlns:a="http://schemas.openxmlformats.org/drawingml/2006/main">
+              <a:ext uri="{FF2B5EF4-FFF2-40B4-BE49-F238E27FC236}">
+                <a16:creationId xmlns:a16="http://schemas.microsoft.com/office/drawing/2014/main" id="{F8AAA9C0-5E92-40EE-A0BE-D0ED8DBB3696}"/>
+              </a:ext>
+            </a:extLst>
+          </p:cNvPr>
+          <p:cNvSpPr>
+            <a:spLocks xmlns:a="http://schemas.openxmlformats.org/drawingml/2006/main" noGrp="1"/>
+          </p:cNvSpPr>
+          <p:nvPr/>
+        </p:nvSpPr>
+        <p:spPr>
+          <a:xfrm xmlns:a="http://schemas.openxmlformats.org/drawingml/2006/main">
+            <a:off x="1123950" y="1924050"/>
+            <a:ext cx="6572250" cy="285750"/>
+          </a:xfrm>
+          <a:prstGeom xmlns:a="http://schemas.openxmlformats.org/drawingml/2006/main" prst="rect">
+            <a:avLst/>
+          </a:prstGeom>
+          <a:noFill xmlns:a="http://schemas.openxmlformats.org/drawingml/2006/main"/>
+          <a:ln xmlns:a="http://schemas.openxmlformats.org/drawingml/2006/main" w="0">
+            <a:noFill/>
+            <a:prstDash val="solid"/>
+          </a:ln>
+        </p:spPr>
+        <p:txBody>
+          <a:bodyPr xmlns:a="http://schemas.openxmlformats.org/drawingml/2006/main" anchor="t"/>
+          <a:lstStyle xmlns:a="http://schemas.openxmlformats.org/drawingml/2006/main"/>
+          <a:p xmlns:a="http://schemas.openxmlformats.org/drawingml/2006/main">
+            <a:pPr algn="l">
+              <a:defRPr sz="1575" b="1">
+                <a:solidFill>
+                  <a:srgbClr val="2563EB"/>
+                </a:solidFill>
+              </a:defRPr>
+            </a:pPr>
+            <a:r>
+              <a:rPr sz="1575" b="1">
+                <a:solidFill>
+                  <a:srgbClr val="2563EB"/>
+                </a:solidFill>
+              </a:rPr>
+              <a:t>Target: 10-30% lower post-tool latency</a:t>
+            </a:r>
+          </a:p>
+        </p:txBody>
+      </p:sp>
+      <p:sp>
+        <p:nvSpPr>
+          <p:cNvPr id="6" name="">
+            <a:extLst xmlns:a="http://schemas.openxmlformats.org/drawingml/2006/main">
+              <a:ext uri="{FF2B5EF4-FFF2-40B4-BE49-F238E27FC236}">
+                <a16:creationId xmlns:a16="http://schemas.microsoft.com/office/drawing/2014/main" id="{D85D6261-142F-4D85-8F5C-CB594E66A20F}"/>
+              </a:ext>
+            </a:extLst>
+          </p:cNvPr>
+          <p:cNvSpPr>
+            <a:spLocks xmlns:a="http://schemas.openxmlformats.org/drawingml/2006/main" noGrp="1"/>
+          </p:cNvSpPr>
+          <p:nvPr/>
+        </p:nvSpPr>
+        <p:spPr>
+          <a:xfrm xmlns:a="http://schemas.openxmlformats.org/drawingml/2006/main">
+            <a:off x="1123950" y="2247900"/>
+            <a:ext cx="9334500" cy="428625"/>
+          </a:xfrm>
+          <a:prstGeom xmlns:a="http://schemas.openxmlformats.org/drawingml/2006/main" prst="rect">
+            <a:avLst/>
+          </a:prstGeom>
+          <a:noFill xmlns:a="http://schemas.openxmlformats.org/drawingml/2006/main"/>
+          <a:ln xmlns:a="http://schemas.openxmlformats.org/drawingml/2006/main" w="0">
+            <a:noFill/>
+            <a:prstDash val="solid"/>
+          </a:ln>
+        </p:spPr>
+        <p:txBody>
+          <a:bodyPr xmlns:a="http://schemas.openxmlformats.org/drawingml/2006/main" anchor="t"/>
+          <a:lstStyle xmlns:a="http://schemas.openxmlformats.org/drawingml/2006/main"/>
+          <a:p xmlns:a="http://schemas.openxmlformats.org/drawingml/2006/main">
+            <a:pPr algn="l">
+              <a:defRPr sz="1350" b="0">
+                <a:solidFill>
+                  <a:srgbClr val="334155"/>
+                </a:solidFill>
+              </a:defRPr>
+            </a:pPr>
+            <a:r>
+              <a:rPr sz="1350" b="0">
+                <a:solidFill>
+                  <a:srgbClr val="334155"/>
+                </a:solidFill>
+              </a:rPr>
+              <a:t>Why: our traces show the next model turn can wait because useful KV is not ready when the agent resumes.</a:t>
+            </a:r>
+          </a:p>
+        </p:txBody>
+      </p:sp>
+      <p:sp>
+        <p:nvSpPr>
+          <p:cNvPr id="7" name="">
+            <a:extLst xmlns:a="http://schemas.openxmlformats.org/drawingml/2006/main">
+              <a:ext uri="{FF2B5EF4-FFF2-40B4-BE49-F238E27FC236}">
+                <a16:creationId xmlns:a16="http://schemas.microsoft.com/office/drawing/2014/main" id="{8B8BF92F-D1B6-4284-9DC4-58D74208D3B1}"/>
+              </a:ext>
+            </a:extLst>
+          </p:cNvPr>
+          <p:cNvSpPr>
+            <a:spLocks xmlns:a="http://schemas.openxmlformats.org/drawingml/2006/main" noGrp="1"/>
+          </p:cNvSpPr>
+          <p:nvPr/>
+        </p:nvSpPr>
+        <p:spPr>
+          <a:xfrm xmlns:a="http://schemas.openxmlformats.org/drawingml/2006/main">
+            <a:off x="419100" y="2647950"/>
+            <a:ext cx="11353800" cy="11430"/>
           </a:xfrm>
           <a:prstGeom xmlns:a="http://schemas.openxmlformats.org/drawingml/2006/main" prst="rect">
             <a:avLst/>
           </a:prstGeom>
           <a:solidFill xmlns:a="http://schemas.openxmlformats.org/drawingml/2006/main">
-            <a:srgbClr val="EEF2FF"/>
+            <a:srgbClr val="E2E8F0"/>
           </a:solidFill>
-          <a:ln xmlns:a="http://schemas.openxmlformats.org/drawingml/2006/main" w="9525">
-            <a:solidFill>
-              <a:srgbClr val="CBD5E1"/>
-            </a:solidFill>
-            <a:prstDash val="solid"/>
-          </a:ln>
-        </p:spPr>
-      </p:sp>
-      <p:sp>
-        <p:nvSpPr>
-          <p:cNvPr id="4" name="">
-            <a:extLst xmlns:a="http://schemas.openxmlformats.org/drawingml/2006/main">
-              <a:ext uri="{FF2B5EF4-FFF2-40B4-BE49-F238E27FC236}">
-                <a16:creationId xmlns:a16="http://schemas.microsoft.com/office/drawing/2014/main" id="{4C8DC447-E395-4491-90E9-1C5688383ED3}"/>
-              </a:ext>
-            </a:extLst>
-          </p:cNvPr>
-          <p:cNvSpPr>
-            <a:spLocks xmlns:a="http://schemas.openxmlformats.org/drawingml/2006/main" noGrp="1"/>
-          </p:cNvSpPr>
-          <p:nvPr/>
-        </p:nvSpPr>
-        <p:spPr>
-          <a:xfrm xmlns:a="http://schemas.openxmlformats.org/drawingml/2006/main">
-            <a:off x="600075" y="1581150"/>
-            <a:ext cx="2305050" cy="266700"/>
-          </a:xfrm>
-          <a:prstGeom xmlns:a="http://schemas.openxmlformats.org/drawingml/2006/main" prst="rect">
-            <a:avLst/>
-          </a:prstGeom>
-          <a:noFill xmlns:a="http://schemas.openxmlformats.org/drawingml/2006/main"/>
-          <a:ln xmlns:a="http://schemas.openxmlformats.org/drawingml/2006/main" w="0">
-            <a:noFill/>
-            <a:prstDash val="solid"/>
-          </a:ln>
-        </p:spPr>
-        <p:txBody>
-          <a:bodyPr xmlns:a="http://schemas.openxmlformats.org/drawingml/2006/main" anchor="ctr"/>
-          <a:lstStyle xmlns:a="http://schemas.openxmlformats.org/drawingml/2006/main"/>
-          <a:p xmlns:a="http://schemas.openxmlformats.org/drawingml/2006/main">
-            <a:pPr algn="l">
-              <a:defRPr sz="1125" b="1">
+          <a:ln xmlns:a="http://schemas.openxmlformats.org/drawingml/2006/main" w="0">
+            <a:noFill/>
+            <a:prstDash val="solid"/>
+          </a:ln>
+        </p:spPr>
+      </p:sp>
+      <p:sp>
+        <p:nvSpPr>
+          <p:cNvPr id="8" name="">
+            <a:extLst xmlns:a="http://schemas.openxmlformats.org/drawingml/2006/main">
+              <a:ext uri="{FF2B5EF4-FFF2-40B4-BE49-F238E27FC236}">
+                <a16:creationId xmlns:a16="http://schemas.microsoft.com/office/drawing/2014/main" id="{1C48B3DF-63EE-4DD2-B3D5-587D861B78B4}"/>
+              </a:ext>
+            </a:extLst>
+          </p:cNvPr>
+          <p:cNvSpPr>
+            <a:spLocks xmlns:a="http://schemas.openxmlformats.org/drawingml/2006/main" noGrp="1"/>
+          </p:cNvSpPr>
+          <p:nvPr/>
+        </p:nvSpPr>
+        <p:spPr>
+          <a:xfrm xmlns:a="http://schemas.openxmlformats.org/drawingml/2006/main">
+            <a:off x="685800" y="2781300"/>
+            <a:ext cx="533400" cy="342900"/>
+          </a:xfrm>
+          <a:prstGeom xmlns:a="http://schemas.openxmlformats.org/drawingml/2006/main" prst="rect">
+            <a:avLst/>
+          </a:prstGeom>
+          <a:noFill xmlns:a="http://schemas.openxmlformats.org/drawingml/2006/main"/>
+          <a:ln xmlns:a="http://schemas.openxmlformats.org/drawingml/2006/main" w="0">
+            <a:noFill/>
+            <a:prstDash val="solid"/>
+          </a:ln>
+        </p:spPr>
+        <p:txBody>
+          <a:bodyPr xmlns:a="http://schemas.openxmlformats.org/drawingml/2006/main" anchor="t"/>
+          <a:lstStyle xmlns:a="http://schemas.openxmlformats.org/drawingml/2006/main"/>
+          <a:p xmlns:a="http://schemas.openxmlformats.org/drawingml/2006/main">
+            <a:pPr algn="l">
+              <a:defRPr sz="1875" b="1">
+                <a:solidFill>
+                  <a:srgbClr val="9333EA"/>
+                </a:solidFill>
+              </a:defRPr>
+            </a:pPr>
+            <a:r>
+              <a:rPr sz="1875" b="1">
+                <a:solidFill>
+                  <a:srgbClr val="9333EA"/>
+                </a:solidFill>
+              </a:rPr>
+              <a:t>2.</a:t>
+            </a:r>
+          </a:p>
+        </p:txBody>
+      </p:sp>
+      <p:sp>
+        <p:nvSpPr>
+          <p:cNvPr id="9" name="">
+            <a:extLst xmlns:a="http://schemas.openxmlformats.org/drawingml/2006/main">
+              <a:ext uri="{FF2B5EF4-FFF2-40B4-BE49-F238E27FC236}">
+                <a16:creationId xmlns:a16="http://schemas.microsoft.com/office/drawing/2014/main" id="{67BDA0E0-DE61-4427-B6E0-E69EAEF32AEE}"/>
+              </a:ext>
+            </a:extLst>
+          </p:cNvPr>
+          <p:cNvSpPr>
+            <a:spLocks xmlns:a="http://schemas.openxmlformats.org/drawingml/2006/main" noGrp="1"/>
+          </p:cNvSpPr>
+          <p:nvPr/>
+        </p:nvSpPr>
+        <p:spPr>
+          <a:xfrm xmlns:a="http://schemas.openxmlformats.org/drawingml/2006/main">
+            <a:off x="1123950" y="2781300"/>
+            <a:ext cx="5334000" cy="323850"/>
+          </a:xfrm>
+          <a:prstGeom xmlns:a="http://schemas.openxmlformats.org/drawingml/2006/main" prst="rect">
+            <a:avLst/>
+          </a:prstGeom>
+          <a:noFill xmlns:a="http://schemas.openxmlformats.org/drawingml/2006/main"/>
+          <a:ln xmlns:a="http://schemas.openxmlformats.org/drawingml/2006/main" w="0">
+            <a:noFill/>
+            <a:prstDash val="solid"/>
+          </a:ln>
+        </p:spPr>
+        <p:txBody>
+          <a:bodyPr xmlns:a="http://schemas.openxmlformats.org/drawingml/2006/main" anchor="t"/>
+          <a:lstStyle xmlns:a="http://schemas.openxmlformats.org/drawingml/2006/main"/>
+          <a:p xmlns:a="http://schemas.openxmlformats.org/drawingml/2006/main">
+            <a:pPr algn="l">
+              <a:defRPr sz="1875" b="1">
                 <a:solidFill>
                   <a:srgbClr val="0F172A"/>
                 </a:solidFill>
               </a:defRPr>
             </a:pPr>
             <a:r>
-              <a:rPr sz="1125" b="1">
+              <a:rPr sz="1875" b="1">
                 <a:solidFill>
                   <a:srgbClr val="0F172A"/>
                 </a:solidFill>
               </a:rPr>
-              <a:t>Observed in our traces</a:t>
-            </a:r>
-          </a:p>
-        </p:txBody>
-      </p:sp>
-      <p:sp>
-        <p:nvSpPr>
-          <p:cNvPr id="5" name="">
-            <a:extLst xmlns:a="http://schemas.openxmlformats.org/drawingml/2006/main">
-              <a:ext uri="{FF2B5EF4-FFF2-40B4-BE49-F238E27FC236}">
-                <a16:creationId xmlns:a16="http://schemas.microsoft.com/office/drawing/2014/main" id="{D21E7E54-B614-4473-94B6-BD3460361472}"/>
-              </a:ext>
-            </a:extLst>
-          </p:cNvPr>
-          <p:cNvSpPr>
-            <a:spLocks xmlns:a="http://schemas.openxmlformats.org/drawingml/2006/main" noGrp="1"/>
-          </p:cNvSpPr>
-          <p:nvPr/>
-        </p:nvSpPr>
-        <p:spPr>
-          <a:xfrm xmlns:a="http://schemas.openxmlformats.org/drawingml/2006/main">
-            <a:off x="3076575" y="1581150"/>
-            <a:ext cx="2209800" cy="266700"/>
-          </a:xfrm>
-          <a:prstGeom xmlns:a="http://schemas.openxmlformats.org/drawingml/2006/main" prst="rect">
-            <a:avLst/>
-          </a:prstGeom>
-          <a:noFill xmlns:a="http://schemas.openxmlformats.org/drawingml/2006/main"/>
-          <a:ln xmlns:a="http://schemas.openxmlformats.org/drawingml/2006/main" w="0">
-            <a:noFill/>
-            <a:prstDash val="solid"/>
-          </a:ln>
-        </p:spPr>
-        <p:txBody>
-          <a:bodyPr xmlns:a="http://schemas.openxmlformats.org/drawingml/2006/main" anchor="ctr"/>
-          <a:lstStyle xmlns:a="http://schemas.openxmlformats.org/drawingml/2006/main"/>
-          <a:p xmlns:a="http://schemas.openxmlformats.org/drawingml/2006/main">
-            <a:pPr algn="l">
-              <a:defRPr sz="1125" b="1">
+              <a:t>Fewer wasted memory movements</a:t>
+            </a:r>
+          </a:p>
+        </p:txBody>
+      </p:sp>
+      <p:sp>
+        <p:nvSpPr>
+          <p:cNvPr id="10" name="">
+            <a:extLst xmlns:a="http://schemas.openxmlformats.org/drawingml/2006/main">
+              <a:ext uri="{FF2B5EF4-FFF2-40B4-BE49-F238E27FC236}">
+                <a16:creationId xmlns:a16="http://schemas.microsoft.com/office/drawing/2014/main" id="{33CADE34-C19B-49C0-BFDC-58254C6C91AC}"/>
+              </a:ext>
+            </a:extLst>
+          </p:cNvPr>
+          <p:cNvSpPr>
+            <a:spLocks xmlns:a="http://schemas.openxmlformats.org/drawingml/2006/main" noGrp="1"/>
+          </p:cNvSpPr>
+          <p:nvPr/>
+        </p:nvSpPr>
+        <p:spPr>
+          <a:xfrm xmlns:a="http://schemas.openxmlformats.org/drawingml/2006/main">
+            <a:off x="1123950" y="3143250"/>
+            <a:ext cx="6572250" cy="285750"/>
+          </a:xfrm>
+          <a:prstGeom xmlns:a="http://schemas.openxmlformats.org/drawingml/2006/main" prst="rect">
+            <a:avLst/>
+          </a:prstGeom>
+          <a:noFill xmlns:a="http://schemas.openxmlformats.org/drawingml/2006/main"/>
+          <a:ln xmlns:a="http://schemas.openxmlformats.org/drawingml/2006/main" w="0">
+            <a:noFill/>
+            <a:prstDash val="solid"/>
+          </a:ln>
+        </p:spPr>
+        <p:txBody>
+          <a:bodyPr xmlns:a="http://schemas.openxmlformats.org/drawingml/2006/main" anchor="t"/>
+          <a:lstStyle xmlns:a="http://schemas.openxmlformats.org/drawingml/2006/main"/>
+          <a:p xmlns:a="http://schemas.openxmlformats.org/drawingml/2006/main">
+            <a:pPr algn="l">
+              <a:defRPr sz="1575" b="1">
+                <a:solidFill>
+                  <a:srgbClr val="9333EA"/>
+                </a:solidFill>
+              </a:defRPr>
+            </a:pPr>
+            <a:r>
+              <a:rPr sz="1575" b="1">
+                <a:solidFill>
+                  <a:srgbClr val="9333EA"/>
+                </a:solidFill>
+              </a:rPr>
+              <a:t>Target: 20-50% fewer late or wasted KV reloads</a:t>
+            </a:r>
+          </a:p>
+        </p:txBody>
+      </p:sp>
+      <p:sp>
+        <p:nvSpPr>
+          <p:cNvPr id="11" name="">
+            <a:extLst xmlns:a="http://schemas.openxmlformats.org/drawingml/2006/main">
+              <a:ext uri="{FF2B5EF4-FFF2-40B4-BE49-F238E27FC236}">
+                <a16:creationId xmlns:a16="http://schemas.microsoft.com/office/drawing/2014/main" id="{9A58081A-E0D2-4F1F-AE26-AE1DE0D62AE4}"/>
+              </a:ext>
+            </a:extLst>
+          </p:cNvPr>
+          <p:cNvSpPr>
+            <a:spLocks xmlns:a="http://schemas.openxmlformats.org/drawingml/2006/main" noGrp="1"/>
+          </p:cNvSpPr>
+          <p:nvPr/>
+        </p:nvSpPr>
+        <p:spPr>
+          <a:xfrm xmlns:a="http://schemas.openxmlformats.org/drawingml/2006/main">
+            <a:off x="1123950" y="3467100"/>
+            <a:ext cx="9334500" cy="428625"/>
+          </a:xfrm>
+          <a:prstGeom xmlns:a="http://schemas.openxmlformats.org/drawingml/2006/main" prst="rect">
+            <a:avLst/>
+          </a:prstGeom>
+          <a:noFill xmlns:a="http://schemas.openxmlformats.org/drawingml/2006/main"/>
+          <a:ln xmlns:a="http://schemas.openxmlformats.org/drawingml/2006/main" w="0">
+            <a:noFill/>
+            <a:prstDash val="solid"/>
+          </a:ln>
+        </p:spPr>
+        <p:txBody>
+          <a:bodyPr xmlns:a="http://schemas.openxmlformats.org/drawingml/2006/main" anchor="t"/>
+          <a:lstStyle xmlns:a="http://schemas.openxmlformats.org/drawingml/2006/main"/>
+          <a:p xmlns:a="http://schemas.openxmlformats.org/drawingml/2006/main">
+            <a:pPr algn="l">
+              <a:defRPr sz="1350" b="0">
+                <a:solidFill>
+                  <a:srgbClr val="334155"/>
+                </a:solidFill>
+              </a:defRPr>
+            </a:pPr>
+            <a:r>
+              <a:rPr sz="1350" b="0">
+                <a:solidFill>
+                  <a:srgbClr val="334155"/>
+                </a:solidFill>
+              </a:rPr>
+              <a:t>Why: memory movement can finish too late, or useful KV can be moved but not reused in time.</a:t>
+            </a:r>
+          </a:p>
+        </p:txBody>
+      </p:sp>
+      <p:sp>
+        <p:nvSpPr>
+          <p:cNvPr id="12" name="">
+            <a:extLst xmlns:a="http://schemas.openxmlformats.org/drawingml/2006/main">
+              <a:ext uri="{FF2B5EF4-FFF2-40B4-BE49-F238E27FC236}">
+                <a16:creationId xmlns:a16="http://schemas.microsoft.com/office/drawing/2014/main" id="{9A81C263-E4DC-4DF9-8D0F-C2C074E796F6}"/>
+              </a:ext>
+            </a:extLst>
+          </p:cNvPr>
+          <p:cNvSpPr>
+            <a:spLocks xmlns:a="http://schemas.openxmlformats.org/drawingml/2006/main" noGrp="1"/>
+          </p:cNvSpPr>
+          <p:nvPr/>
+        </p:nvSpPr>
+        <p:spPr>
+          <a:xfrm xmlns:a="http://schemas.openxmlformats.org/drawingml/2006/main">
+            <a:off x="419100" y="3867150"/>
+            <a:ext cx="11353800" cy="11430"/>
+          </a:xfrm>
+          <a:prstGeom xmlns:a="http://schemas.openxmlformats.org/drawingml/2006/main" prst="rect">
+            <a:avLst/>
+          </a:prstGeom>
+          <a:solidFill xmlns:a="http://schemas.openxmlformats.org/drawingml/2006/main">
+            <a:srgbClr val="E2E8F0"/>
+          </a:solidFill>
+          <a:ln xmlns:a="http://schemas.openxmlformats.org/drawingml/2006/main" w="0">
+            <a:noFill/>
+            <a:prstDash val="solid"/>
+          </a:ln>
+        </p:spPr>
+      </p:sp>
+      <p:sp>
+        <p:nvSpPr>
+          <p:cNvPr id="13" name="">
+            <a:extLst xmlns:a="http://schemas.openxmlformats.org/drawingml/2006/main">
+              <a:ext uri="{FF2B5EF4-FFF2-40B4-BE49-F238E27FC236}">
+                <a16:creationId xmlns:a16="http://schemas.microsoft.com/office/drawing/2014/main" id="{D2ECB64A-A1C4-4C79-B216-F24A8600962D}"/>
+              </a:ext>
+            </a:extLst>
+          </p:cNvPr>
+          <p:cNvSpPr>
+            <a:spLocks xmlns:a="http://schemas.openxmlformats.org/drawingml/2006/main" noGrp="1"/>
+          </p:cNvSpPr>
+          <p:nvPr/>
+        </p:nvSpPr>
+        <p:spPr>
+          <a:xfrm xmlns:a="http://schemas.openxmlformats.org/drawingml/2006/main">
+            <a:off x="685800" y="4000500"/>
+            <a:ext cx="533400" cy="342900"/>
+          </a:xfrm>
+          <a:prstGeom xmlns:a="http://schemas.openxmlformats.org/drawingml/2006/main" prst="rect">
+            <a:avLst/>
+          </a:prstGeom>
+          <a:noFill xmlns:a="http://schemas.openxmlformats.org/drawingml/2006/main"/>
+          <a:ln xmlns:a="http://schemas.openxmlformats.org/drawingml/2006/main" w="0">
+            <a:noFill/>
+            <a:prstDash val="solid"/>
+          </a:ln>
+        </p:spPr>
+        <p:txBody>
+          <a:bodyPr xmlns:a="http://schemas.openxmlformats.org/drawingml/2006/main" anchor="t"/>
+          <a:lstStyle xmlns:a="http://schemas.openxmlformats.org/drawingml/2006/main"/>
+          <a:p xmlns:a="http://schemas.openxmlformats.org/drawingml/2006/main">
+            <a:pPr algn="l">
+              <a:defRPr sz="1875" b="1">
+                <a:solidFill>
+                  <a:srgbClr val="16A34A"/>
+                </a:solidFill>
+              </a:defRPr>
+            </a:pPr>
+            <a:r>
+              <a:rPr sz="1875" b="1">
+                <a:solidFill>
+                  <a:srgbClr val="16A34A"/>
+                </a:solidFill>
+              </a:rPr>
+              <a:t>3.</a:t>
+            </a:r>
+          </a:p>
+        </p:txBody>
+      </p:sp>
+      <p:sp>
+        <p:nvSpPr>
+          <p:cNvPr id="14" name="">
+            <a:extLst xmlns:a="http://schemas.openxmlformats.org/drawingml/2006/main">
+              <a:ext uri="{FF2B5EF4-FFF2-40B4-BE49-F238E27FC236}">
+                <a16:creationId xmlns:a16="http://schemas.microsoft.com/office/drawing/2014/main" id="{09F01511-E20C-4C52-BF81-0E93F2EAE940}"/>
+              </a:ext>
+            </a:extLst>
+          </p:cNvPr>
+          <p:cNvSpPr>
+            <a:spLocks xmlns:a="http://schemas.openxmlformats.org/drawingml/2006/main" noGrp="1"/>
+          </p:cNvSpPr>
+          <p:nvPr/>
+        </p:nvSpPr>
+        <p:spPr>
+          <a:xfrm xmlns:a="http://schemas.openxmlformats.org/drawingml/2006/main">
+            <a:off x="1123950" y="4000500"/>
+            <a:ext cx="5334000" cy="323850"/>
+          </a:xfrm>
+          <a:prstGeom xmlns:a="http://schemas.openxmlformats.org/drawingml/2006/main" prst="rect">
+            <a:avLst/>
+          </a:prstGeom>
+          <a:noFill xmlns:a="http://schemas.openxmlformats.org/drawingml/2006/main"/>
+          <a:ln xmlns:a="http://schemas.openxmlformats.org/drawingml/2006/main" w="0">
+            <a:noFill/>
+            <a:prstDash val="solid"/>
+          </a:ln>
+        </p:spPr>
+        <p:txBody>
+          <a:bodyPr xmlns:a="http://schemas.openxmlformats.org/drawingml/2006/main" anchor="t"/>
+          <a:lstStyle xmlns:a="http://schemas.openxmlformats.org/drawingml/2006/main"/>
+          <a:p xmlns:a="http://schemas.openxmlformats.org/drawingml/2006/main">
+            <a:pPr algn="l">
+              <a:defRPr sz="1875" b="1">
                 <a:solidFill>
                   <a:srgbClr val="0F172A"/>
                 </a:solidFill>
               </a:defRPr>
             </a:pPr>
             <a:r>
-              <a:rPr sz="1125" b="1">
+              <a:rPr sz="1875" b="1">
                 <a:solidFill>
                   <a:srgbClr val="0F172A"/>
                 </a:solidFill>
               </a:rPr>
-              <a:t>Hardware assist</a:t>
-            </a:r>
-          </a:p>
-        </p:txBody>
-      </p:sp>
-      <p:sp>
-        <p:nvSpPr>
-          <p:cNvPr id="6" name="">
-            <a:extLst xmlns:a="http://schemas.openxmlformats.org/drawingml/2006/main">
-              <a:ext uri="{FF2B5EF4-FFF2-40B4-BE49-F238E27FC236}">
-                <a16:creationId xmlns:a16="http://schemas.microsoft.com/office/drawing/2014/main" id="{518E3EE8-E58D-4ED8-9281-F896CBD46A86}"/>
-              </a:ext>
-            </a:extLst>
-          </p:cNvPr>
-          <p:cNvSpPr>
-            <a:spLocks xmlns:a="http://schemas.openxmlformats.org/drawingml/2006/main" noGrp="1"/>
-          </p:cNvSpPr>
-          <p:nvPr/>
-        </p:nvSpPr>
-        <p:spPr>
-          <a:xfrm xmlns:a="http://schemas.openxmlformats.org/drawingml/2006/main">
-            <a:off x="5457825" y="1581150"/>
-            <a:ext cx="3495675" cy="266700"/>
-          </a:xfrm>
-          <a:prstGeom xmlns:a="http://schemas.openxmlformats.org/drawingml/2006/main" prst="rect">
-            <a:avLst/>
-          </a:prstGeom>
-          <a:noFill xmlns:a="http://schemas.openxmlformats.org/drawingml/2006/main"/>
-          <a:ln xmlns:a="http://schemas.openxmlformats.org/drawingml/2006/main" w="0">
-            <a:noFill/>
-            <a:prstDash val="solid"/>
-          </a:ln>
-        </p:spPr>
-        <p:txBody>
-          <a:bodyPr xmlns:a="http://schemas.openxmlformats.org/drawingml/2006/main" anchor="ctr"/>
-          <a:lstStyle xmlns:a="http://schemas.openxmlformats.org/drawingml/2006/main"/>
-          <a:p xmlns:a="http://schemas.openxmlformats.org/drawingml/2006/main">
-            <a:pPr algn="l">
-              <a:defRPr sz="1125" b="1">
+              <a:t>More predictable tail latency</a:t>
+            </a:r>
+          </a:p>
+        </p:txBody>
+      </p:sp>
+      <p:sp>
+        <p:nvSpPr>
+          <p:cNvPr id="15" name="">
+            <a:extLst xmlns:a="http://schemas.openxmlformats.org/drawingml/2006/main">
+              <a:ext uri="{FF2B5EF4-FFF2-40B4-BE49-F238E27FC236}">
+                <a16:creationId xmlns:a16="http://schemas.microsoft.com/office/drawing/2014/main" id="{E99FB8C6-D4C0-4E88-A0A2-5C436EEF1FB0}"/>
+              </a:ext>
+            </a:extLst>
+          </p:cNvPr>
+          <p:cNvSpPr>
+            <a:spLocks xmlns:a="http://schemas.openxmlformats.org/drawingml/2006/main" noGrp="1"/>
+          </p:cNvSpPr>
+          <p:nvPr/>
+        </p:nvSpPr>
+        <p:spPr>
+          <a:xfrm xmlns:a="http://schemas.openxmlformats.org/drawingml/2006/main">
+            <a:off x="1123950" y="4362450"/>
+            <a:ext cx="6572250" cy="285750"/>
+          </a:xfrm>
+          <a:prstGeom xmlns:a="http://schemas.openxmlformats.org/drawingml/2006/main" prst="rect">
+            <a:avLst/>
+          </a:prstGeom>
+          <a:noFill xmlns:a="http://schemas.openxmlformats.org/drawingml/2006/main"/>
+          <a:ln xmlns:a="http://schemas.openxmlformats.org/drawingml/2006/main" w="0">
+            <a:noFill/>
+            <a:prstDash val="solid"/>
+          </a:ln>
+        </p:spPr>
+        <p:txBody>
+          <a:bodyPr xmlns:a="http://schemas.openxmlformats.org/drawingml/2006/main" anchor="t"/>
+          <a:lstStyle xmlns:a="http://schemas.openxmlformats.org/drawingml/2006/main"/>
+          <a:p xmlns:a="http://schemas.openxmlformats.org/drawingml/2006/main">
+            <a:pPr algn="l">
+              <a:defRPr sz="1575" b="1">
+                <a:solidFill>
+                  <a:srgbClr val="16A34A"/>
+                </a:solidFill>
+              </a:defRPr>
+            </a:pPr>
+            <a:r>
+              <a:rPr sz="1575" b="1">
+                <a:solidFill>
+                  <a:srgbClr val="16A34A"/>
+                </a:solidFill>
+              </a:rPr>
+              <a:t>Target: lower p95/p99 agent-resume stalls</a:t>
+            </a:r>
+          </a:p>
+        </p:txBody>
+      </p:sp>
+      <p:sp>
+        <p:nvSpPr>
+          <p:cNvPr id="16" name="">
+            <a:extLst xmlns:a="http://schemas.openxmlformats.org/drawingml/2006/main">
+              <a:ext uri="{FF2B5EF4-FFF2-40B4-BE49-F238E27FC236}">
+                <a16:creationId xmlns:a16="http://schemas.microsoft.com/office/drawing/2014/main" id="{C865F086-731A-4783-80E8-3893553F584F}"/>
+              </a:ext>
+            </a:extLst>
+          </p:cNvPr>
+          <p:cNvSpPr>
+            <a:spLocks xmlns:a="http://schemas.openxmlformats.org/drawingml/2006/main" noGrp="1"/>
+          </p:cNvSpPr>
+          <p:nvPr/>
+        </p:nvSpPr>
+        <p:spPr>
+          <a:xfrm xmlns:a="http://schemas.openxmlformats.org/drawingml/2006/main">
+            <a:off x="1123950" y="4686300"/>
+            <a:ext cx="9334500" cy="428625"/>
+          </a:xfrm>
+          <a:prstGeom xmlns:a="http://schemas.openxmlformats.org/drawingml/2006/main" prst="rect">
+            <a:avLst/>
+          </a:prstGeom>
+          <a:noFill xmlns:a="http://schemas.openxmlformats.org/drawingml/2006/main"/>
+          <a:ln xmlns:a="http://schemas.openxmlformats.org/drawingml/2006/main" w="0">
+            <a:noFill/>
+            <a:prstDash val="solid"/>
+          </a:ln>
+        </p:spPr>
+        <p:txBody>
+          <a:bodyPr xmlns:a="http://schemas.openxmlformats.org/drawingml/2006/main" anchor="t"/>
+          <a:lstStyle xmlns:a="http://schemas.openxmlformats.org/drawingml/2006/main"/>
+          <a:p xmlns:a="http://schemas.openxmlformats.org/drawingml/2006/main">
+            <a:pPr algn="l">
+              <a:defRPr sz="1350" b="0">
+                <a:solidFill>
+                  <a:srgbClr val="334155"/>
+                </a:solidFill>
+              </a:defRPr>
+            </a:pPr>
+            <a:r>
+              <a:rPr sz="1350" b="0">
+                <a:solidFill>
+                  <a:srgbClr val="334155"/>
+                </a:solidFill>
+              </a:rPr>
+              <a:t>Why: urgent agent KV currently competes with ordinary memory traffic without deadline or priority context.</a:t>
+            </a:r>
+          </a:p>
+        </p:txBody>
+      </p:sp>
+      <p:sp>
+        <p:nvSpPr>
+          <p:cNvPr id="17" name="">
+            <a:extLst xmlns:a="http://schemas.openxmlformats.org/drawingml/2006/main">
+              <a:ext uri="{FF2B5EF4-FFF2-40B4-BE49-F238E27FC236}">
+                <a16:creationId xmlns:a16="http://schemas.microsoft.com/office/drawing/2014/main" id="{B7CCE12D-B2F8-4E75-BB7A-A8157236C3B1}"/>
+              </a:ext>
+            </a:extLst>
+          </p:cNvPr>
+          <p:cNvSpPr>
+            <a:spLocks xmlns:a="http://schemas.openxmlformats.org/drawingml/2006/main" noGrp="1"/>
+          </p:cNvSpPr>
+          <p:nvPr/>
+        </p:nvSpPr>
+        <p:spPr>
+          <a:xfrm xmlns:a="http://schemas.openxmlformats.org/drawingml/2006/main">
+            <a:off x="419100" y="5334000"/>
+            <a:ext cx="11353800" cy="11430"/>
+          </a:xfrm>
+          <a:prstGeom xmlns:a="http://schemas.openxmlformats.org/drawingml/2006/main" prst="rect">
+            <a:avLst/>
+          </a:prstGeom>
+          <a:solidFill xmlns:a="http://schemas.openxmlformats.org/drawingml/2006/main">
+            <a:srgbClr val="CBD5E1"/>
+          </a:solidFill>
+          <a:ln xmlns:a="http://schemas.openxmlformats.org/drawingml/2006/main" w="0">
+            <a:noFill/>
+            <a:prstDash val="solid"/>
+          </a:ln>
+        </p:spPr>
+      </p:sp>
+      <p:sp>
+        <p:nvSpPr>
+          <p:cNvPr id="18" name="">
+            <a:extLst xmlns:a="http://schemas.openxmlformats.org/drawingml/2006/main">
+              <a:ext uri="{FF2B5EF4-FFF2-40B4-BE49-F238E27FC236}">
+                <a16:creationId xmlns:a16="http://schemas.microsoft.com/office/drawing/2014/main" id="{6C6CDA8D-8973-4D17-862E-551A0640D0F4}"/>
+              </a:ext>
+            </a:extLst>
+          </p:cNvPr>
+          <p:cNvSpPr>
+            <a:spLocks xmlns:a="http://schemas.openxmlformats.org/drawingml/2006/main" noGrp="1"/>
+          </p:cNvSpPr>
+          <p:nvPr/>
+        </p:nvSpPr>
+        <p:spPr>
+          <a:xfrm xmlns:a="http://schemas.openxmlformats.org/drawingml/2006/main">
+            <a:off x="876300" y="5562600"/>
+            <a:ext cx="2952750" cy="266700"/>
+          </a:xfrm>
+          <a:prstGeom xmlns:a="http://schemas.openxmlformats.org/drawingml/2006/main" prst="rect">
+            <a:avLst/>
+          </a:prstGeom>
+          <a:noFill xmlns:a="http://schemas.openxmlformats.org/drawingml/2006/main"/>
+          <a:ln xmlns:a="http://schemas.openxmlformats.org/drawingml/2006/main" w="0">
+            <a:noFill/>
+            <a:prstDash val="solid"/>
+          </a:ln>
+        </p:spPr>
+        <p:txBody>
+          <a:bodyPr xmlns:a="http://schemas.openxmlformats.org/drawingml/2006/main" anchor="t"/>
+          <a:lstStyle xmlns:a="http://schemas.openxmlformats.org/drawingml/2006/main"/>
+          <a:p xmlns:a="http://schemas.openxmlformats.org/drawingml/2006/main">
+            <a:pPr algn="l">
+              <a:defRPr sz="1500" b="1">
                 <a:solidFill>
                   <a:srgbClr val="0F172A"/>
                 </a:solidFill>
               </a:defRPr>
             </a:pPr>
             <a:r>
-              <a:rPr sz="1125" b="1">
+              <a:rPr sz="1500" b="1">
                 <a:solidFill>
                   <a:srgbClr val="0F172A"/>
                 </a:solidFill>
               </a:rPr>
-              <a:t>Why it moves the number</a:t>
-            </a:r>
-          </a:p>
-        </p:txBody>
-      </p:sp>
-      <p:sp>
-        <p:nvSpPr>
-          <p:cNvPr id="7" name="">
-            <a:extLst xmlns:a="http://schemas.openxmlformats.org/drawingml/2006/main">
-              <a:ext uri="{FF2B5EF4-FFF2-40B4-BE49-F238E27FC236}">
-                <a16:creationId xmlns:a16="http://schemas.microsoft.com/office/drawing/2014/main" id="{CBB1DB0F-2035-40EC-8998-93FF00840625}"/>
-              </a:ext>
-            </a:extLst>
-          </p:cNvPr>
-          <p:cNvSpPr>
-            <a:spLocks xmlns:a="http://schemas.openxmlformats.org/drawingml/2006/main" noGrp="1"/>
-          </p:cNvSpPr>
-          <p:nvPr/>
-        </p:nvSpPr>
-        <p:spPr>
-          <a:xfrm xmlns:a="http://schemas.openxmlformats.org/drawingml/2006/main">
-            <a:off x="9124950" y="1581150"/>
-            <a:ext cx="2209800" cy="266700"/>
-          </a:xfrm>
-          <a:prstGeom xmlns:a="http://schemas.openxmlformats.org/drawingml/2006/main" prst="rect">
-            <a:avLst/>
-          </a:prstGeom>
-          <a:noFill xmlns:a="http://schemas.openxmlformats.org/drawingml/2006/main"/>
-          <a:ln xmlns:a="http://schemas.openxmlformats.org/drawingml/2006/main" w="0">
-            <a:noFill/>
-            <a:prstDash val="solid"/>
-          </a:ln>
-        </p:spPr>
-        <p:txBody>
-          <a:bodyPr xmlns:a="http://schemas.openxmlformats.org/drawingml/2006/main" anchor="ctr"/>
-          <a:lstStyle xmlns:a="http://schemas.openxmlformats.org/drawingml/2006/main"/>
-          <a:p xmlns:a="http://schemas.openxmlformats.org/drawingml/2006/main">
-            <a:pPr algn="l">
-              <a:defRPr sz="1125" b="1">
+              <a:t>Hardware support to test</a:t>
+            </a:r>
+          </a:p>
+        </p:txBody>
+      </p:sp>
+      <p:sp>
+        <p:nvSpPr>
+          <p:cNvPr id="19" name="">
+            <a:extLst xmlns:a="http://schemas.openxmlformats.org/drawingml/2006/main">
+              <a:ext uri="{FF2B5EF4-FFF2-40B4-BE49-F238E27FC236}">
+                <a16:creationId xmlns:a16="http://schemas.microsoft.com/office/drawing/2014/main" id="{5FD3D6B7-A0E6-4078-9750-92005DA716AF}"/>
+              </a:ext>
+            </a:extLst>
+          </p:cNvPr>
+          <p:cNvSpPr>
+            <a:spLocks xmlns:a="http://schemas.openxmlformats.org/drawingml/2006/main" noGrp="1"/>
+          </p:cNvSpPr>
+          <p:nvPr/>
+        </p:nvSpPr>
+        <p:spPr>
+          <a:xfrm xmlns:a="http://schemas.openxmlformats.org/drawingml/2006/main">
+            <a:off x="876300" y="5867400"/>
+            <a:ext cx="9810750" cy="342900"/>
+          </a:xfrm>
+          <a:prstGeom xmlns:a="http://schemas.openxmlformats.org/drawingml/2006/main" prst="rect">
+            <a:avLst/>
+          </a:prstGeom>
+          <a:noFill xmlns:a="http://schemas.openxmlformats.org/drawingml/2006/main"/>
+          <a:ln xmlns:a="http://schemas.openxmlformats.org/drawingml/2006/main" w="0">
+            <a:noFill/>
+            <a:prstDash val="solid"/>
+          </a:ln>
+        </p:spPr>
+        <p:txBody>
+          <a:bodyPr xmlns:a="http://schemas.openxmlformats.org/drawingml/2006/main" anchor="t"/>
+          <a:lstStyle xmlns:a="http://schemas.openxmlformats.org/drawingml/2006/main"/>
+          <a:p xmlns:a="http://schemas.openxmlformats.org/drawingml/2006/main">
+            <a:pPr algn="l">
+              <a:defRPr sz="1425" b="1">
                 <a:solidFill>
                   <a:srgbClr val="0F172A"/>
                 </a:solidFill>
               </a:defRPr>
             </a:pPr>
             <a:r>
-              <a:rPr sz="1125" b="1">
+              <a:rPr sz="1425" b="1">
                 <a:solidFill>
                   <a:srgbClr val="0F172A"/>
                 </a:solidFill>
               </a:rPr>
-              <a:t>Target impact</a:t>
-            </a:r>
-          </a:p>
-        </p:txBody>
-      </p:sp>
-      <p:sp>
-        <p:nvSpPr>
-          <p:cNvPr id="8" name="">
-            <a:extLst xmlns:a="http://schemas.openxmlformats.org/drawingml/2006/main">
-              <a:ext uri="{FF2B5EF4-FFF2-40B4-BE49-F238E27FC236}">
-                <a16:creationId xmlns:a16="http://schemas.microsoft.com/office/drawing/2014/main" id="{E5134F14-23A3-4FE0-AC4D-9D95E91E94FD}"/>
-              </a:ext>
-            </a:extLst>
-          </p:cNvPr>
-          <p:cNvSpPr>
-            <a:spLocks xmlns:a="http://schemas.openxmlformats.org/drawingml/2006/main" noGrp="1"/>
-          </p:cNvSpPr>
-          <p:nvPr/>
-        </p:nvSpPr>
-        <p:spPr>
-          <a:xfrm xmlns:a="http://schemas.openxmlformats.org/drawingml/2006/main">
-            <a:off x="514350" y="1866900"/>
-            <a:ext cx="10906125" cy="628650"/>
-          </a:xfrm>
-          <a:prstGeom xmlns:a="http://schemas.openxmlformats.org/drawingml/2006/main" prst="rect">
-            <a:avLst/>
-          </a:prstGeom>
-          <a:solidFill xmlns:a="http://schemas.openxmlformats.org/drawingml/2006/main">
-            <a:srgbClr val="FFFFFF"/>
-          </a:solidFill>
-          <a:ln xmlns:a="http://schemas.openxmlformats.org/drawingml/2006/main" w="7620">
-            <a:solidFill>
-              <a:srgbClr val="CBD5E1"/>
-            </a:solidFill>
-            <a:prstDash val="solid"/>
-          </a:ln>
-        </p:spPr>
-      </p:sp>
-      <p:sp>
-        <p:nvSpPr>
-          <p:cNvPr id="9" name="">
-            <a:extLst xmlns:a="http://schemas.openxmlformats.org/drawingml/2006/main">
-              <a:ext uri="{FF2B5EF4-FFF2-40B4-BE49-F238E27FC236}">
-                <a16:creationId xmlns:a16="http://schemas.microsoft.com/office/drawing/2014/main" id="{ABFB8220-236F-45CB-8D7B-2082AA85C7C6}"/>
-              </a:ext>
-            </a:extLst>
-          </p:cNvPr>
-          <p:cNvSpPr>
-            <a:spLocks xmlns:a="http://schemas.openxmlformats.org/drawingml/2006/main" noGrp="1"/>
-          </p:cNvSpPr>
-          <p:nvPr/>
-        </p:nvSpPr>
-        <p:spPr>
-          <a:xfrm xmlns:a="http://schemas.openxmlformats.org/drawingml/2006/main">
-            <a:off x="600075" y="1952625"/>
-            <a:ext cx="2305050" cy="495300"/>
-          </a:xfrm>
-          <a:prstGeom xmlns:a="http://schemas.openxmlformats.org/drawingml/2006/main" prst="rect">
-            <a:avLst/>
-          </a:prstGeom>
-          <a:noFill xmlns:a="http://schemas.openxmlformats.org/drawingml/2006/main"/>
-          <a:ln xmlns:a="http://schemas.openxmlformats.org/drawingml/2006/main" w="0">
-            <a:noFill/>
-            <a:prstDash val="solid"/>
-          </a:ln>
-        </p:spPr>
-        <p:txBody>
-          <a:bodyPr xmlns:a="http://schemas.openxmlformats.org/drawingml/2006/main" anchor="ctr"/>
-          <a:lstStyle xmlns:a="http://schemas.openxmlformats.org/drawingml/2006/main"/>
-          <a:p xmlns:a="http://schemas.openxmlformats.org/drawingml/2006/main">
-            <a:pPr algn="l">
-              <a:defRPr sz="1125" b="1">
-                <a:solidFill>
-                  <a:srgbClr val="DC2626"/>
-                </a:solidFill>
-              </a:defRPr>
-            </a:pPr>
-            <a:r>
-              <a:rPr sz="1125" b="1">
-                <a:solidFill>
-                  <a:srgbClr val="DC2626"/>
-                </a:solidFill>
-              </a:rPr>
-              <a:t>Late replay H2D</a:t>
-            </a:r>
-          </a:p>
-        </p:txBody>
-      </p:sp>
-      <p:sp>
-        <p:nvSpPr>
-          <p:cNvPr id="10" name="">
-            <a:extLst xmlns:a="http://schemas.openxmlformats.org/drawingml/2006/main">
-              <a:ext uri="{FF2B5EF4-FFF2-40B4-BE49-F238E27FC236}">
-                <a16:creationId xmlns:a16="http://schemas.microsoft.com/office/drawing/2014/main" id="{1B944896-6C53-472E-8BE5-94614E9E7C17}"/>
-              </a:ext>
-            </a:extLst>
-          </p:cNvPr>
-          <p:cNvSpPr>
-            <a:spLocks xmlns:a="http://schemas.openxmlformats.org/drawingml/2006/main" noGrp="1"/>
-          </p:cNvSpPr>
-          <p:nvPr/>
-        </p:nvSpPr>
-        <p:spPr>
-          <a:xfrm xmlns:a="http://schemas.openxmlformats.org/drawingml/2006/main">
-            <a:off x="3076575" y="1952625"/>
-            <a:ext cx="2209800" cy="495300"/>
-          </a:xfrm>
-          <a:prstGeom xmlns:a="http://schemas.openxmlformats.org/drawingml/2006/main" prst="rect">
-            <a:avLst/>
-          </a:prstGeom>
-          <a:noFill xmlns:a="http://schemas.openxmlformats.org/drawingml/2006/main"/>
-          <a:ln xmlns:a="http://schemas.openxmlformats.org/drawingml/2006/main" w="0">
-            <a:noFill/>
-            <a:prstDash val="solid"/>
-          </a:ln>
-        </p:spPr>
-        <p:txBody>
-          <a:bodyPr xmlns:a="http://schemas.openxmlformats.org/drawingml/2006/main" anchor="ctr"/>
-          <a:lstStyle xmlns:a="http://schemas.openxmlformats.org/drawingml/2006/main"/>
-          <a:p xmlns:a="http://schemas.openxmlformats.org/drawingml/2006/main">
-            <a:pPr algn="l">
-              <a:defRPr sz="1125" b="0">
-                <a:solidFill>
-                  <a:srgbClr val="334155"/>
-                </a:solidFill>
-              </a:defRPr>
-            </a:pPr>
-            <a:r>
-              <a:rPr sz="1125" b="0">
-                <a:solidFill>
-                  <a:srgbClr val="334155"/>
-                </a:solidFill>
-              </a:rPr>
-              <a:t>deadline-aware KV queue</a:t>
-            </a:r>
-          </a:p>
-        </p:txBody>
-      </p:sp>
-      <p:sp>
-        <p:nvSpPr>
-          <p:cNvPr id="11" name="">
-            <a:extLst xmlns:a="http://schemas.openxmlformats.org/drawingml/2006/main">
-              <a:ext uri="{FF2B5EF4-FFF2-40B4-BE49-F238E27FC236}">
-                <a16:creationId xmlns:a16="http://schemas.microsoft.com/office/drawing/2014/main" id="{4A95457C-6754-4E7C-A608-230CC9DAA33E}"/>
-              </a:ext>
-            </a:extLst>
-          </p:cNvPr>
-          <p:cNvSpPr>
-            <a:spLocks xmlns:a="http://schemas.openxmlformats.org/drawingml/2006/main" noGrp="1"/>
-          </p:cNvSpPr>
-          <p:nvPr/>
-        </p:nvSpPr>
-        <p:spPr>
-          <a:xfrm xmlns:a="http://schemas.openxmlformats.org/drawingml/2006/main">
-            <a:off x="5457825" y="1952625"/>
-            <a:ext cx="3495675" cy="495300"/>
-          </a:xfrm>
-          <a:prstGeom xmlns:a="http://schemas.openxmlformats.org/drawingml/2006/main" prst="rect">
-            <a:avLst/>
-          </a:prstGeom>
-          <a:noFill xmlns:a="http://schemas.openxmlformats.org/drawingml/2006/main"/>
-          <a:ln xmlns:a="http://schemas.openxmlformats.org/drawingml/2006/main" w="0">
-            <a:noFill/>
-            <a:prstDash val="solid"/>
-          </a:ln>
-        </p:spPr>
-        <p:txBody>
-          <a:bodyPr xmlns:a="http://schemas.openxmlformats.org/drawingml/2006/main" anchor="ctr"/>
-          <a:lstStyle xmlns:a="http://schemas.openxmlformats.org/drawingml/2006/main"/>
-          <a:p xmlns:a="http://schemas.openxmlformats.org/drawingml/2006/main">
-            <a:pPr algn="l">
-              <a:defRPr sz="1125" b="0">
-                <a:solidFill>
-                  <a:srgbClr val="334155"/>
-                </a:solidFill>
-              </a:defRPr>
-            </a:pPr>
-            <a:r>
-              <a:rPr sz="1125" b="0">
-                <a:solidFill>
-                  <a:srgbClr val="334155"/>
-                </a:solidFill>
-              </a:rPr>
-              <a:t>cuts time spent waiting for urgent KV</a:t>
-            </a:r>
-          </a:p>
-        </p:txBody>
-      </p:sp>
-      <p:sp>
-        <p:nvSpPr>
-          <p:cNvPr id="12" name="">
-            <a:extLst xmlns:a="http://schemas.openxmlformats.org/drawingml/2006/main">
-              <a:ext uri="{FF2B5EF4-FFF2-40B4-BE49-F238E27FC236}">
-                <a16:creationId xmlns:a16="http://schemas.microsoft.com/office/drawing/2014/main" id="{C88DF3DE-418F-4A38-A1AF-6D82D9AE12C3}"/>
-              </a:ext>
-            </a:extLst>
-          </p:cNvPr>
-          <p:cNvSpPr>
-            <a:spLocks xmlns:a="http://schemas.openxmlformats.org/drawingml/2006/main" noGrp="1"/>
-          </p:cNvSpPr>
-          <p:nvPr/>
-        </p:nvSpPr>
-        <p:spPr>
-          <a:xfrm xmlns:a="http://schemas.openxmlformats.org/drawingml/2006/main">
-            <a:off x="9124950" y="1952625"/>
-            <a:ext cx="2209800" cy="495300"/>
-          </a:xfrm>
-          <a:prstGeom xmlns:a="http://schemas.openxmlformats.org/drawingml/2006/main" prst="rect">
-            <a:avLst/>
-          </a:prstGeom>
-          <a:noFill xmlns:a="http://schemas.openxmlformats.org/drawingml/2006/main"/>
-          <a:ln xmlns:a="http://schemas.openxmlformats.org/drawingml/2006/main" w="0">
-            <a:noFill/>
-            <a:prstDash val="solid"/>
-          </a:ln>
-        </p:spPr>
-        <p:txBody>
-          <a:bodyPr xmlns:a="http://schemas.openxmlformats.org/drawingml/2006/main" anchor="ctr"/>
-          <a:lstStyle xmlns:a="http://schemas.openxmlformats.org/drawingml/2006/main"/>
-          <a:p xmlns:a="http://schemas.openxmlformats.org/drawingml/2006/main">
-            <a:pPr algn="l">
-              <a:defRPr sz="1125" b="1">
-                <a:solidFill>
-                  <a:srgbClr val="2563EB"/>
-                </a:solidFill>
-              </a:defRPr>
-            </a:pPr>
-            <a:r>
-              <a:rPr sz="1125" b="1">
-                <a:solidFill>
-                  <a:srgbClr val="2563EB"/>
-                </a:solidFill>
-              </a:rPr>
-              <a:t>10-20% replay latency</a:t>
-            </a:r>
-          </a:p>
-        </p:txBody>
-      </p:sp>
-      <p:sp>
-        <p:nvSpPr>
-          <p:cNvPr id="13" name="">
-            <a:extLst xmlns:a="http://schemas.openxmlformats.org/drawingml/2006/main">
-              <a:ext uri="{FF2B5EF4-FFF2-40B4-BE49-F238E27FC236}">
-                <a16:creationId xmlns:a16="http://schemas.microsoft.com/office/drawing/2014/main" id="{43F9E836-9FA0-46AA-91A1-343DB91D5A2A}"/>
-              </a:ext>
-            </a:extLst>
-          </p:cNvPr>
-          <p:cNvSpPr>
-            <a:spLocks xmlns:a="http://schemas.openxmlformats.org/drawingml/2006/main" noGrp="1"/>
-          </p:cNvSpPr>
-          <p:nvPr/>
-        </p:nvSpPr>
-        <p:spPr>
-          <a:xfrm xmlns:a="http://schemas.openxmlformats.org/drawingml/2006/main">
-            <a:off x="514350" y="2495550"/>
-            <a:ext cx="10906125" cy="628650"/>
-          </a:xfrm>
-          <a:prstGeom xmlns:a="http://schemas.openxmlformats.org/drawingml/2006/main" prst="rect">
-            <a:avLst/>
-          </a:prstGeom>
-          <a:solidFill xmlns:a="http://schemas.openxmlformats.org/drawingml/2006/main">
-            <a:srgbClr val="F8FAFC"/>
-          </a:solidFill>
-          <a:ln xmlns:a="http://schemas.openxmlformats.org/drawingml/2006/main" w="7620">
-            <a:solidFill>
-              <a:srgbClr val="CBD5E1"/>
-            </a:solidFill>
-            <a:prstDash val="solid"/>
-          </a:ln>
-        </p:spPr>
-      </p:sp>
-      <p:sp>
-        <p:nvSpPr>
-          <p:cNvPr id="14" name="">
-            <a:extLst xmlns:a="http://schemas.openxmlformats.org/drawingml/2006/main">
-              <a:ext uri="{FF2B5EF4-FFF2-40B4-BE49-F238E27FC236}">
-                <a16:creationId xmlns:a16="http://schemas.microsoft.com/office/drawing/2014/main" id="{400E382B-1EBA-4A9D-A7FF-85068CC0DFDD}"/>
-              </a:ext>
-            </a:extLst>
-          </p:cNvPr>
-          <p:cNvSpPr>
-            <a:spLocks xmlns:a="http://schemas.openxmlformats.org/drawingml/2006/main" noGrp="1"/>
-          </p:cNvSpPr>
-          <p:nvPr/>
-        </p:nvSpPr>
-        <p:spPr>
-          <a:xfrm xmlns:a="http://schemas.openxmlformats.org/drawingml/2006/main">
-            <a:off x="600075" y="2581275"/>
-            <a:ext cx="2305050" cy="495300"/>
-          </a:xfrm>
-          <a:prstGeom xmlns:a="http://schemas.openxmlformats.org/drawingml/2006/main" prst="rect">
-            <a:avLst/>
-          </a:prstGeom>
-          <a:noFill xmlns:a="http://schemas.openxmlformats.org/drawingml/2006/main"/>
-          <a:ln xmlns:a="http://schemas.openxmlformats.org/drawingml/2006/main" w="0">
-            <a:noFill/>
-            <a:prstDash val="solid"/>
-          </a:ln>
-        </p:spPr>
-        <p:txBody>
-          <a:bodyPr xmlns:a="http://schemas.openxmlformats.org/drawingml/2006/main" anchor="ctr"/>
-          <a:lstStyle xmlns:a="http://schemas.openxmlformats.org/drawingml/2006/main"/>
-          <a:p xmlns:a="http://schemas.openxmlformats.org/drawingml/2006/main">
-            <a:pPr algn="l">
-              <a:defRPr sz="1125" b="1">
-                <a:solidFill>
-                  <a:srgbClr val="CA8A04"/>
-                </a:solidFill>
-              </a:defRPr>
-            </a:pPr>
-            <a:r>
-              <a:rPr sz="1125" b="1">
-                <a:solidFill>
-                  <a:srgbClr val="CA8A04"/>
-                </a:solidFill>
-              </a:rPr>
-              <a:t>Replay recomputes old prefix</a:t>
-            </a:r>
-          </a:p>
-        </p:txBody>
-      </p:sp>
-      <p:sp>
-        <p:nvSpPr>
-          <p:cNvPr id="15" name="">
-            <a:extLst xmlns:a="http://schemas.openxmlformats.org/drawingml/2006/main">
-              <a:ext uri="{FF2B5EF4-FFF2-40B4-BE49-F238E27FC236}">
-                <a16:creationId xmlns:a16="http://schemas.microsoft.com/office/drawing/2014/main" id="{019C9FE1-AD6D-44E9-B7BE-A52810251BD3}"/>
-              </a:ext>
-            </a:extLst>
-          </p:cNvPr>
-          <p:cNvSpPr>
-            <a:spLocks xmlns:a="http://schemas.openxmlformats.org/drawingml/2006/main" noGrp="1"/>
-          </p:cNvSpPr>
-          <p:nvPr/>
-        </p:nvSpPr>
-        <p:spPr>
-          <a:xfrm xmlns:a="http://schemas.openxmlformats.org/drawingml/2006/main">
-            <a:off x="3076575" y="2581275"/>
-            <a:ext cx="2209800" cy="495300"/>
-          </a:xfrm>
-          <a:prstGeom xmlns:a="http://schemas.openxmlformats.org/drawingml/2006/main" prst="rect">
-            <a:avLst/>
-          </a:prstGeom>
-          <a:noFill xmlns:a="http://schemas.openxmlformats.org/drawingml/2006/main"/>
-          <a:ln xmlns:a="http://schemas.openxmlformats.org/drawingml/2006/main" w="0">
-            <a:noFill/>
-            <a:prstDash val="solid"/>
-          </a:ln>
-        </p:spPr>
-        <p:txBody>
-          <a:bodyPr xmlns:a="http://schemas.openxmlformats.org/drawingml/2006/main" anchor="ctr"/>
-          <a:lstStyle xmlns:a="http://schemas.openxmlformats.org/drawingml/2006/main"/>
-          <a:p xmlns:a="http://schemas.openxmlformats.org/drawingml/2006/main">
-            <a:pPr algn="l">
-              <a:defRPr sz="1125" b="0">
-                <a:solidFill>
-                  <a:srgbClr val="334155"/>
-                </a:solidFill>
-              </a:defRPr>
-            </a:pPr>
-            <a:r>
-              <a:rPr sz="1125" b="0">
-                <a:solidFill>
-                  <a:srgbClr val="334155"/>
-                </a:solidFill>
-              </a:rPr>
-              <a:t>residency protection</a:t>
-            </a:r>
-          </a:p>
-        </p:txBody>
-      </p:sp>
-      <p:sp>
-        <p:nvSpPr>
-          <p:cNvPr id="16" name="">
-            <a:extLst xmlns:a="http://schemas.openxmlformats.org/drawingml/2006/main">
-              <a:ext uri="{FF2B5EF4-FFF2-40B4-BE49-F238E27FC236}">
-                <a16:creationId xmlns:a16="http://schemas.microsoft.com/office/drawing/2014/main" id="{423FA0F1-FB27-4EB9-9ACE-6CAAFF4DC8BA}"/>
-              </a:ext>
-            </a:extLst>
-          </p:cNvPr>
-          <p:cNvSpPr>
-            <a:spLocks xmlns:a="http://schemas.openxmlformats.org/drawingml/2006/main" noGrp="1"/>
-          </p:cNvSpPr>
-          <p:nvPr/>
-        </p:nvSpPr>
-        <p:spPr>
-          <a:xfrm xmlns:a="http://schemas.openxmlformats.org/drawingml/2006/main">
-            <a:off x="5457825" y="2581275"/>
-            <a:ext cx="3495675" cy="495300"/>
-          </a:xfrm>
-          <a:prstGeom xmlns:a="http://schemas.openxmlformats.org/drawingml/2006/main" prst="rect">
-            <a:avLst/>
-          </a:prstGeom>
-          <a:noFill xmlns:a="http://schemas.openxmlformats.org/drawingml/2006/main"/>
-          <a:ln xmlns:a="http://schemas.openxmlformats.org/drawingml/2006/main" w="0">
-            <a:noFill/>
-            <a:prstDash val="solid"/>
-          </a:ln>
-        </p:spPr>
-        <p:txBody>
-          <a:bodyPr xmlns:a="http://schemas.openxmlformats.org/drawingml/2006/main" anchor="ctr"/>
-          <a:lstStyle xmlns:a="http://schemas.openxmlformats.org/drawingml/2006/main"/>
-          <a:p xmlns:a="http://schemas.openxmlformats.org/drawingml/2006/main">
-            <a:pPr algn="l">
-              <a:defRPr sz="1125" b="0">
-                <a:solidFill>
-                  <a:srgbClr val="334155"/>
-                </a:solidFill>
-              </a:defRPr>
-            </a:pPr>
-            <a:r>
-              <a:rPr sz="1125" b="0">
-                <a:solidFill>
-                  <a:srgbClr val="334155"/>
-                </a:solidFill>
-              </a:rPr>
-              <a:t>keeps useful KV available until reuse</a:t>
-            </a:r>
-          </a:p>
-        </p:txBody>
-      </p:sp>
-      <p:sp>
-        <p:nvSpPr>
-          <p:cNvPr id="17" name="">
-            <a:extLst xmlns:a="http://schemas.openxmlformats.org/drawingml/2006/main">
-              <a:ext uri="{FF2B5EF4-FFF2-40B4-BE49-F238E27FC236}">
-                <a16:creationId xmlns:a16="http://schemas.microsoft.com/office/drawing/2014/main" id="{789C0981-73BC-436E-B1C4-253CFD5A5FD1}"/>
-              </a:ext>
-            </a:extLst>
-          </p:cNvPr>
-          <p:cNvSpPr>
-            <a:spLocks xmlns:a="http://schemas.openxmlformats.org/drawingml/2006/main" noGrp="1"/>
-          </p:cNvSpPr>
-          <p:nvPr/>
-        </p:nvSpPr>
-        <p:spPr>
-          <a:xfrm xmlns:a="http://schemas.openxmlformats.org/drawingml/2006/main">
-            <a:off x="9124950" y="2581275"/>
-            <a:ext cx="2209800" cy="495300"/>
-          </a:xfrm>
-          <a:prstGeom xmlns:a="http://schemas.openxmlformats.org/drawingml/2006/main" prst="rect">
-            <a:avLst/>
-          </a:prstGeom>
-          <a:noFill xmlns:a="http://schemas.openxmlformats.org/drawingml/2006/main"/>
-          <a:ln xmlns:a="http://schemas.openxmlformats.org/drawingml/2006/main" w="0">
-            <a:noFill/>
-            <a:prstDash val="solid"/>
-          </a:ln>
-        </p:spPr>
-        <p:txBody>
-          <a:bodyPr xmlns:a="http://schemas.openxmlformats.org/drawingml/2006/main" anchor="ctr"/>
-          <a:lstStyle xmlns:a="http://schemas.openxmlformats.org/drawingml/2006/main"/>
-          <a:p xmlns:a="http://schemas.openxmlformats.org/drawingml/2006/main">
-            <a:pPr algn="l">
-              <a:defRPr sz="1125" b="1">
-                <a:solidFill>
-                  <a:srgbClr val="9333EA"/>
-                </a:solidFill>
-              </a:defRPr>
-            </a:pPr>
-            <a:r>
-              <a:rPr sz="1125" b="1">
-                <a:solidFill>
-                  <a:srgbClr val="9333EA"/>
-                </a:solidFill>
-              </a:rPr>
-              <a:t>up to 20-30%</a:t>
-            </a:r>
-          </a:p>
-        </p:txBody>
-      </p:sp>
-      <p:sp>
-        <p:nvSpPr>
-          <p:cNvPr id="18" name="">
-            <a:extLst xmlns:a="http://schemas.openxmlformats.org/drawingml/2006/main">
-              <a:ext uri="{FF2B5EF4-FFF2-40B4-BE49-F238E27FC236}">
-                <a16:creationId xmlns:a16="http://schemas.microsoft.com/office/drawing/2014/main" id="{9D9381C7-ABE4-47AC-B032-DEBE03B10F85}"/>
-              </a:ext>
-            </a:extLst>
-          </p:cNvPr>
-          <p:cNvSpPr>
-            <a:spLocks xmlns:a="http://schemas.openxmlformats.org/drawingml/2006/main" noGrp="1"/>
-          </p:cNvSpPr>
-          <p:nvPr/>
-        </p:nvSpPr>
-        <p:spPr>
-          <a:xfrm xmlns:a="http://schemas.openxmlformats.org/drawingml/2006/main">
-            <a:off x="514350" y="3124200"/>
-            <a:ext cx="10906125" cy="628650"/>
-          </a:xfrm>
-          <a:prstGeom xmlns:a="http://schemas.openxmlformats.org/drawingml/2006/main" prst="rect">
-            <a:avLst/>
-          </a:prstGeom>
-          <a:solidFill xmlns:a="http://schemas.openxmlformats.org/drawingml/2006/main">
-            <a:srgbClr val="FFFFFF"/>
-          </a:solidFill>
-          <a:ln xmlns:a="http://schemas.openxmlformats.org/drawingml/2006/main" w="7620">
-            <a:solidFill>
-              <a:srgbClr val="CBD5E1"/>
-            </a:solidFill>
-            <a:prstDash val="solid"/>
-          </a:ln>
-        </p:spPr>
-      </p:sp>
-      <p:sp>
-        <p:nvSpPr>
-          <p:cNvPr id="19" name="">
-            <a:extLst xmlns:a="http://schemas.openxmlformats.org/drawingml/2006/main">
-              <a:ext uri="{FF2B5EF4-FFF2-40B4-BE49-F238E27FC236}">
-                <a16:creationId xmlns:a16="http://schemas.microsoft.com/office/drawing/2014/main" id="{A6172B88-46C9-4964-B18A-29D3E3AC4579}"/>
-              </a:ext>
-            </a:extLst>
-          </p:cNvPr>
-          <p:cNvSpPr>
-            <a:spLocks xmlns:a="http://schemas.openxmlformats.org/drawingml/2006/main" noGrp="1"/>
-          </p:cNvSpPr>
-          <p:nvPr/>
-        </p:nvSpPr>
-        <p:spPr>
-          <a:xfrm xmlns:a="http://schemas.openxmlformats.org/drawingml/2006/main">
-            <a:off x="600075" y="3209925"/>
-            <a:ext cx="2305050" cy="495300"/>
-          </a:xfrm>
-          <a:prstGeom xmlns:a="http://schemas.openxmlformats.org/drawingml/2006/main" prst="rect">
-            <a:avLst/>
-          </a:prstGeom>
-          <a:noFill xmlns:a="http://schemas.openxmlformats.org/drawingml/2006/main"/>
-          <a:ln xmlns:a="http://schemas.openxmlformats.org/drawingml/2006/main" w="0">
-            <a:noFill/>
-            <a:prstDash val="solid"/>
-          </a:ln>
-        </p:spPr>
-        <p:txBody>
-          <a:bodyPr xmlns:a="http://schemas.openxmlformats.org/drawingml/2006/main" anchor="ctr"/>
-          <a:lstStyle xmlns:a="http://schemas.openxmlformats.org/drawingml/2006/main"/>
-          <a:p xmlns:a="http://schemas.openxmlformats.org/drawingml/2006/main">
-            <a:pPr algn="l">
-              <a:defRPr sz="1125" b="1">
-                <a:solidFill>
-                  <a:srgbClr val="9333EA"/>
-                </a:solidFill>
-              </a:defRPr>
-            </a:pPr>
-            <a:r>
-              <a:rPr sz="1125" b="1">
-                <a:solidFill>
-                  <a:srgbClr val="9333EA"/>
-                </a:solidFill>
-              </a:rPr>
-              <a:t>Hints finish after deadline</a:t>
+              <a:t>KV/session metadata, deadline-aware movement queues, temporary KV protection, and useful/late/wasted telemetry.</a:t>
             </a:r>
           </a:p>
         </p:txBody>
@@ -4474,1039 +4485,7 @@
           <p:cNvPr id="20" name="">
             <a:extLst xmlns:a="http://schemas.openxmlformats.org/drawingml/2006/main">
               <a:ext uri="{FF2B5EF4-FFF2-40B4-BE49-F238E27FC236}">
-                <a16:creationId xmlns:a16="http://schemas.microsoft.com/office/drawing/2014/main" id="{A9418E71-4CE4-4075-8DD0-8FBB88D3C6E2}"/>
-              </a:ext>
-            </a:extLst>
-          </p:cNvPr>
-          <p:cNvSpPr>
-            <a:spLocks xmlns:a="http://schemas.openxmlformats.org/drawingml/2006/main" noGrp="1"/>
-          </p:cNvSpPr>
-          <p:nvPr/>
-        </p:nvSpPr>
-        <p:spPr>
-          <a:xfrm xmlns:a="http://schemas.openxmlformats.org/drawingml/2006/main">
-            <a:off x="3076575" y="3209925"/>
-            <a:ext cx="2209800" cy="495300"/>
-          </a:xfrm>
-          <a:prstGeom xmlns:a="http://schemas.openxmlformats.org/drawingml/2006/main" prst="rect">
-            <a:avLst/>
-          </a:prstGeom>
-          <a:noFill xmlns:a="http://schemas.openxmlformats.org/drawingml/2006/main"/>
-          <a:ln xmlns:a="http://schemas.openxmlformats.org/drawingml/2006/main" w="0">
-            <a:noFill/>
-            <a:prstDash val="solid"/>
-          </a:ln>
-        </p:spPr>
-        <p:txBody>
-          <a:bodyPr xmlns:a="http://schemas.openxmlformats.org/drawingml/2006/main" anchor="ctr"/>
-          <a:lstStyle xmlns:a="http://schemas.openxmlformats.org/drawingml/2006/main"/>
-          <a:p xmlns:a="http://schemas.openxmlformats.org/drawingml/2006/main">
-            <a:pPr algn="l">
-              <a:defRPr sz="1125" b="0">
-                <a:solidFill>
-                  <a:srgbClr val="334155"/>
-                </a:solidFill>
-              </a:defRPr>
-            </a:pPr>
-            <a:r>
-              <a:rPr sz="1125" b="0">
-                <a:solidFill>
-                  <a:srgbClr val="334155"/>
-                </a:solidFill>
-              </a:rPr>
-              <a:t>session priority metadata</a:t>
-            </a:r>
-          </a:p>
-        </p:txBody>
-      </p:sp>
-      <p:sp>
-        <p:nvSpPr>
-          <p:cNvPr id="21" name="">
-            <a:extLst xmlns:a="http://schemas.openxmlformats.org/drawingml/2006/main">
-              <a:ext uri="{FF2B5EF4-FFF2-40B4-BE49-F238E27FC236}">
-                <a16:creationId xmlns:a16="http://schemas.microsoft.com/office/drawing/2014/main" id="{85C97FC5-629A-478E-9073-4F40CCF9B670}"/>
-              </a:ext>
-            </a:extLst>
-          </p:cNvPr>
-          <p:cNvSpPr>
-            <a:spLocks xmlns:a="http://schemas.openxmlformats.org/drawingml/2006/main" noGrp="1"/>
-          </p:cNvSpPr>
-          <p:nvPr/>
-        </p:nvSpPr>
-        <p:spPr>
-          <a:xfrm xmlns:a="http://schemas.openxmlformats.org/drawingml/2006/main">
-            <a:off x="5457825" y="3209925"/>
-            <a:ext cx="3495675" cy="495300"/>
-          </a:xfrm>
-          <a:prstGeom xmlns:a="http://schemas.openxmlformats.org/drawingml/2006/main" prst="rect">
-            <a:avLst/>
-          </a:prstGeom>
-          <a:noFill xmlns:a="http://schemas.openxmlformats.org/drawingml/2006/main"/>
-          <a:ln xmlns:a="http://schemas.openxmlformats.org/drawingml/2006/main" w="0">
-            <a:noFill/>
-            <a:prstDash val="solid"/>
-          </a:ln>
-        </p:spPr>
-        <p:txBody>
-          <a:bodyPr xmlns:a="http://schemas.openxmlformats.org/drawingml/2006/main" anchor="ctr"/>
-          <a:lstStyle xmlns:a="http://schemas.openxmlformats.org/drawingml/2006/main"/>
-          <a:p xmlns:a="http://schemas.openxmlformats.org/drawingml/2006/main">
-            <a:pPr algn="l">
-              <a:defRPr sz="1125" b="0">
-                <a:solidFill>
-                  <a:srgbClr val="334155"/>
-                </a:solidFill>
-              </a:defRPr>
-            </a:pPr>
-            <a:r>
-              <a:rPr sz="1125" b="0">
-                <a:solidFill>
-                  <a:srgbClr val="334155"/>
-                </a:solidFill>
-              </a:rPr>
-              <a:t>lets urgent agents preempt low-value movement</a:t>
-            </a:r>
-          </a:p>
-        </p:txBody>
-      </p:sp>
-      <p:sp>
-        <p:nvSpPr>
-          <p:cNvPr id="22" name="">
-            <a:extLst xmlns:a="http://schemas.openxmlformats.org/drawingml/2006/main">
-              <a:ext uri="{FF2B5EF4-FFF2-40B4-BE49-F238E27FC236}">
-                <a16:creationId xmlns:a16="http://schemas.microsoft.com/office/drawing/2014/main" id="{293005FE-C61F-4419-BFE7-7A9789E0CCDC}"/>
-              </a:ext>
-            </a:extLst>
-          </p:cNvPr>
-          <p:cNvSpPr>
-            <a:spLocks xmlns:a="http://schemas.openxmlformats.org/drawingml/2006/main" noGrp="1"/>
-          </p:cNvSpPr>
-          <p:nvPr/>
-        </p:nvSpPr>
-        <p:spPr>
-          <a:xfrm xmlns:a="http://schemas.openxmlformats.org/drawingml/2006/main">
-            <a:off x="9124950" y="3209925"/>
-            <a:ext cx="2209800" cy="495300"/>
-          </a:xfrm>
-          <a:prstGeom xmlns:a="http://schemas.openxmlformats.org/drawingml/2006/main" prst="rect">
-            <a:avLst/>
-          </a:prstGeom>
-          <a:noFill xmlns:a="http://schemas.openxmlformats.org/drawingml/2006/main"/>
-          <a:ln xmlns:a="http://schemas.openxmlformats.org/drawingml/2006/main" w="0">
-            <a:noFill/>
-            <a:prstDash val="solid"/>
-          </a:ln>
-        </p:spPr>
-        <p:txBody>
-          <a:bodyPr xmlns:a="http://schemas.openxmlformats.org/drawingml/2006/main" anchor="ctr"/>
-          <a:lstStyle xmlns:a="http://schemas.openxmlformats.org/drawingml/2006/main"/>
-          <a:p xmlns:a="http://schemas.openxmlformats.org/drawingml/2006/main">
-            <a:pPr algn="l">
-              <a:defRPr sz="1125" b="1">
-                <a:solidFill>
-                  <a:srgbClr val="16A34A"/>
-                </a:solidFill>
-              </a:defRPr>
-            </a:pPr>
-            <a:r>
-              <a:rPr sz="1125" b="1">
-                <a:solidFill>
-                  <a:srgbClr val="16A34A"/>
-                </a:solidFill>
-              </a:rPr>
-              <a:t>20-50% fewer late reloads</a:t>
-            </a:r>
-          </a:p>
-        </p:txBody>
-      </p:sp>
-      <p:sp>
-        <p:nvSpPr>
-          <p:cNvPr id="23" name="">
-            <a:extLst xmlns:a="http://schemas.openxmlformats.org/drawingml/2006/main">
-              <a:ext uri="{FF2B5EF4-FFF2-40B4-BE49-F238E27FC236}">
-                <a16:creationId xmlns:a16="http://schemas.microsoft.com/office/drawing/2014/main" id="{60531866-68C7-47EF-B369-094086949282}"/>
-              </a:ext>
-            </a:extLst>
-          </p:cNvPr>
-          <p:cNvSpPr>
-            <a:spLocks xmlns:a="http://schemas.openxmlformats.org/drawingml/2006/main" noGrp="1"/>
-          </p:cNvSpPr>
-          <p:nvPr/>
-        </p:nvSpPr>
-        <p:spPr>
-          <a:xfrm xmlns:a="http://schemas.openxmlformats.org/drawingml/2006/main">
-            <a:off x="514350" y="3752850"/>
-            <a:ext cx="10906125" cy="628650"/>
-          </a:xfrm>
-          <a:prstGeom xmlns:a="http://schemas.openxmlformats.org/drawingml/2006/main" prst="rect">
-            <a:avLst/>
-          </a:prstGeom>
-          <a:solidFill xmlns:a="http://schemas.openxmlformats.org/drawingml/2006/main">
-            <a:srgbClr val="F8FAFC"/>
-          </a:solidFill>
-          <a:ln xmlns:a="http://schemas.openxmlformats.org/drawingml/2006/main" w="7620">
-            <a:solidFill>
-              <a:srgbClr val="CBD5E1"/>
-            </a:solidFill>
-            <a:prstDash val="solid"/>
-          </a:ln>
-        </p:spPr>
-      </p:sp>
-      <p:sp>
-        <p:nvSpPr>
-          <p:cNvPr id="24" name="">
-            <a:extLst xmlns:a="http://schemas.openxmlformats.org/drawingml/2006/main">
-              <a:ext uri="{FF2B5EF4-FFF2-40B4-BE49-F238E27FC236}">
-                <a16:creationId xmlns:a16="http://schemas.microsoft.com/office/drawing/2014/main" id="{3B0F4BC0-95FC-4922-AADB-B914F2CD58D1}"/>
-              </a:ext>
-            </a:extLst>
-          </p:cNvPr>
-          <p:cNvSpPr>
-            <a:spLocks xmlns:a="http://schemas.openxmlformats.org/drawingml/2006/main" noGrp="1"/>
-          </p:cNvSpPr>
-          <p:nvPr/>
-        </p:nvSpPr>
-        <p:spPr>
-          <a:xfrm xmlns:a="http://schemas.openxmlformats.org/drawingml/2006/main">
-            <a:off x="600075" y="3838575"/>
-            <a:ext cx="2305050" cy="495300"/>
-          </a:xfrm>
-          <a:prstGeom xmlns:a="http://schemas.openxmlformats.org/drawingml/2006/main" prst="rect">
-            <a:avLst/>
-          </a:prstGeom>
-          <a:noFill xmlns:a="http://schemas.openxmlformats.org/drawingml/2006/main"/>
-          <a:ln xmlns:a="http://schemas.openxmlformats.org/drawingml/2006/main" w="0">
-            <a:noFill/>
-            <a:prstDash val="solid"/>
-          </a:ln>
-        </p:spPr>
-        <p:txBody>
-          <a:bodyPr xmlns:a="http://schemas.openxmlformats.org/drawingml/2006/main" anchor="ctr"/>
-          <a:lstStyle xmlns:a="http://schemas.openxmlformats.org/drawingml/2006/main"/>
-          <a:p xmlns:a="http://schemas.openxmlformats.org/drawingml/2006/main">
-            <a:pPr algn="l">
-              <a:defRPr sz="1125" b="1">
-                <a:solidFill>
-                  <a:srgbClr val="0891B2"/>
-                </a:solidFill>
-              </a:defRPr>
-            </a:pPr>
-            <a:r>
-              <a:rPr sz="1125" b="1">
-                <a:solidFill>
-                  <a:srgbClr val="0891B2"/>
-                </a:solidFill>
-              </a:rPr>
-              <a:t>Useful prefetch is wasted</a:t>
-            </a:r>
-          </a:p>
-        </p:txBody>
-      </p:sp>
-      <p:sp>
-        <p:nvSpPr>
-          <p:cNvPr id="25" name="">
-            <a:extLst xmlns:a="http://schemas.openxmlformats.org/drawingml/2006/main">
-              <a:ext uri="{FF2B5EF4-FFF2-40B4-BE49-F238E27FC236}">
-                <a16:creationId xmlns:a16="http://schemas.microsoft.com/office/drawing/2014/main" id="{E338A250-3F34-41EB-95BE-DB3AEABF20AC}"/>
-              </a:ext>
-            </a:extLst>
-          </p:cNvPr>
-          <p:cNvSpPr>
-            <a:spLocks xmlns:a="http://schemas.openxmlformats.org/drawingml/2006/main" noGrp="1"/>
-          </p:cNvSpPr>
-          <p:nvPr/>
-        </p:nvSpPr>
-        <p:spPr>
-          <a:xfrm xmlns:a="http://schemas.openxmlformats.org/drawingml/2006/main">
-            <a:off x="3076575" y="3838575"/>
-            <a:ext cx="2209800" cy="495300"/>
-          </a:xfrm>
-          <a:prstGeom xmlns:a="http://schemas.openxmlformats.org/drawingml/2006/main" prst="rect">
-            <a:avLst/>
-          </a:prstGeom>
-          <a:noFill xmlns:a="http://schemas.openxmlformats.org/drawingml/2006/main"/>
-          <a:ln xmlns:a="http://schemas.openxmlformats.org/drawingml/2006/main" w="0">
-            <a:noFill/>
-            <a:prstDash val="solid"/>
-          </a:ln>
-        </p:spPr>
-        <p:txBody>
-          <a:bodyPr xmlns:a="http://schemas.openxmlformats.org/drawingml/2006/main" anchor="ctr"/>
-          <a:lstStyle xmlns:a="http://schemas.openxmlformats.org/drawingml/2006/main"/>
-          <a:p xmlns:a="http://schemas.openxmlformats.org/drawingml/2006/main">
-            <a:pPr algn="l">
-              <a:defRPr sz="1125" b="0">
-                <a:solidFill>
-                  <a:srgbClr val="334155"/>
-                </a:solidFill>
-              </a:defRPr>
-            </a:pPr>
-            <a:r>
-              <a:rPr sz="1125" b="0">
-                <a:solidFill>
-                  <a:srgbClr val="334155"/>
-                </a:solidFill>
-              </a:rPr>
-              <a:t>KV-aware telemetry</a:t>
-            </a:r>
-          </a:p>
-        </p:txBody>
-      </p:sp>
-      <p:sp>
-        <p:nvSpPr>
-          <p:cNvPr id="26" name="">
-            <a:extLst xmlns:a="http://schemas.openxmlformats.org/drawingml/2006/main">
-              <a:ext uri="{FF2B5EF4-FFF2-40B4-BE49-F238E27FC236}">
-                <a16:creationId xmlns:a16="http://schemas.microsoft.com/office/drawing/2014/main" id="{DBEEC0E7-FA74-4B64-9821-799B51DC5FE8}"/>
-              </a:ext>
-            </a:extLst>
-          </p:cNvPr>
-          <p:cNvSpPr>
-            <a:spLocks xmlns:a="http://schemas.openxmlformats.org/drawingml/2006/main" noGrp="1"/>
-          </p:cNvSpPr>
-          <p:nvPr/>
-        </p:nvSpPr>
-        <p:spPr>
-          <a:xfrm xmlns:a="http://schemas.openxmlformats.org/drawingml/2006/main">
-            <a:off x="5457825" y="3838575"/>
-            <a:ext cx="3495675" cy="495300"/>
-          </a:xfrm>
-          <a:prstGeom xmlns:a="http://schemas.openxmlformats.org/drawingml/2006/main" prst="rect">
-            <a:avLst/>
-          </a:prstGeom>
-          <a:noFill xmlns:a="http://schemas.openxmlformats.org/drawingml/2006/main"/>
-          <a:ln xmlns:a="http://schemas.openxmlformats.org/drawingml/2006/main" w="0">
-            <a:noFill/>
-            <a:prstDash val="solid"/>
-          </a:ln>
-        </p:spPr>
-        <p:txBody>
-          <a:bodyPr xmlns:a="http://schemas.openxmlformats.org/drawingml/2006/main" anchor="ctr"/>
-          <a:lstStyle xmlns:a="http://schemas.openxmlformats.org/drawingml/2006/main"/>
-          <a:p xmlns:a="http://schemas.openxmlformats.org/drawingml/2006/main">
-            <a:pPr algn="l">
-              <a:defRPr sz="1125" b="0">
-                <a:solidFill>
-                  <a:srgbClr val="334155"/>
-                </a:solidFill>
-              </a:defRPr>
-            </a:pPr>
-            <a:r>
-              <a:rPr sz="1125" b="0">
-                <a:solidFill>
-                  <a:srgbClr val="334155"/>
-                </a:solidFill>
-              </a:rPr>
-              <a:t>detects late, wasted, and evicted-before-use KV</a:t>
-            </a:r>
-          </a:p>
-        </p:txBody>
-      </p:sp>
-      <p:sp>
-        <p:nvSpPr>
-          <p:cNvPr id="27" name="">
-            <a:extLst xmlns:a="http://schemas.openxmlformats.org/drawingml/2006/main">
-              <a:ext uri="{FF2B5EF4-FFF2-40B4-BE49-F238E27FC236}">
-                <a16:creationId xmlns:a16="http://schemas.microsoft.com/office/drawing/2014/main" id="{84D1EA7E-03F6-4715-8325-C6E0DA1F4F53}"/>
-              </a:ext>
-            </a:extLst>
-          </p:cNvPr>
-          <p:cNvSpPr>
-            <a:spLocks xmlns:a="http://schemas.openxmlformats.org/drawingml/2006/main" noGrp="1"/>
-          </p:cNvSpPr>
-          <p:nvPr/>
-        </p:nvSpPr>
-        <p:spPr>
-          <a:xfrm xmlns:a="http://schemas.openxmlformats.org/drawingml/2006/main">
-            <a:off x="9124950" y="3838575"/>
-            <a:ext cx="2209800" cy="495300"/>
-          </a:xfrm>
-          <a:prstGeom xmlns:a="http://schemas.openxmlformats.org/drawingml/2006/main" prst="rect">
-            <a:avLst/>
-          </a:prstGeom>
-          <a:noFill xmlns:a="http://schemas.openxmlformats.org/drawingml/2006/main"/>
-          <a:ln xmlns:a="http://schemas.openxmlformats.org/drawingml/2006/main" w="0">
-            <a:noFill/>
-            <a:prstDash val="solid"/>
-          </a:ln>
-        </p:spPr>
-        <p:txBody>
-          <a:bodyPr xmlns:a="http://schemas.openxmlformats.org/drawingml/2006/main" anchor="ctr"/>
-          <a:lstStyle xmlns:a="http://schemas.openxmlformats.org/drawingml/2006/main"/>
-          <a:p xmlns:a="http://schemas.openxmlformats.org/drawingml/2006/main">
-            <a:pPr algn="l">
-              <a:defRPr sz="1125" b="1">
-                <a:solidFill>
-                  <a:srgbClr val="0891B2"/>
-                </a:solidFill>
-              </a:defRPr>
-            </a:pPr>
-            <a:r>
-              <a:rPr sz="1125" b="1">
-                <a:solidFill>
-                  <a:srgbClr val="0891B2"/>
-                </a:solidFill>
-              </a:rPr>
-              <a:t>less bandwidth waste</a:t>
-            </a:r>
-          </a:p>
-        </p:txBody>
-      </p:sp>
-      <p:sp>
-        <p:nvSpPr>
-          <p:cNvPr id="28" name="">
-            <a:extLst xmlns:a="http://schemas.openxmlformats.org/drawingml/2006/main">
-              <a:ext uri="{FF2B5EF4-FFF2-40B4-BE49-F238E27FC236}">
-                <a16:creationId xmlns:a16="http://schemas.microsoft.com/office/drawing/2014/main" id="{6B1E9538-3885-4B5E-A4F9-760C0697A257}"/>
-              </a:ext>
-            </a:extLst>
-          </p:cNvPr>
-          <p:cNvSpPr>
-            <a:spLocks xmlns:a="http://schemas.openxmlformats.org/drawingml/2006/main" noGrp="1"/>
-          </p:cNvSpPr>
-          <p:nvPr/>
-        </p:nvSpPr>
-        <p:spPr>
-          <a:xfrm xmlns:a="http://schemas.openxmlformats.org/drawingml/2006/main">
-            <a:off x="609600" y="4591050"/>
-            <a:ext cx="2381250" cy="266700"/>
-          </a:xfrm>
-          <a:prstGeom xmlns:a="http://schemas.openxmlformats.org/drawingml/2006/main" prst="rect">
-            <a:avLst/>
-          </a:prstGeom>
-          <a:noFill xmlns:a="http://schemas.openxmlformats.org/drawingml/2006/main"/>
-          <a:ln xmlns:a="http://schemas.openxmlformats.org/drawingml/2006/main" w="0">
-            <a:noFill/>
-            <a:prstDash val="solid"/>
-          </a:ln>
-        </p:spPr>
-        <p:txBody>
-          <a:bodyPr xmlns:a="http://schemas.openxmlformats.org/drawingml/2006/main" anchor="t"/>
-          <a:lstStyle xmlns:a="http://schemas.openxmlformats.org/drawingml/2006/main"/>
-          <a:p xmlns:a="http://schemas.openxmlformats.org/drawingml/2006/main">
-            <a:pPr algn="l">
-              <a:defRPr sz="1500" b="1">
-                <a:solidFill>
-                  <a:srgbClr val="0F172A"/>
-                </a:solidFill>
-              </a:defRPr>
-            </a:pPr>
-            <a:r>
-              <a:rPr sz="1500" b="1">
-                <a:solidFill>
-                  <a:srgbClr val="0F172A"/>
-                </a:solidFill>
-              </a:rPr>
-              <a:t>Range rationale</a:t>
-            </a:r>
-          </a:p>
-        </p:txBody>
-      </p:sp>
-      <p:sp>
-        <p:nvSpPr>
-          <p:cNvPr id="29" name="">
-            <a:extLst xmlns:a="http://schemas.openxmlformats.org/drawingml/2006/main">
-              <a:ext uri="{FF2B5EF4-FFF2-40B4-BE49-F238E27FC236}">
-                <a16:creationId xmlns:a16="http://schemas.microsoft.com/office/drawing/2014/main" id="{6B852242-037E-4AD6-BD2A-1709DD5294EB}"/>
-              </a:ext>
-            </a:extLst>
-          </p:cNvPr>
-          <p:cNvSpPr>
-            <a:spLocks xmlns:a="http://schemas.openxmlformats.org/drawingml/2006/main" noGrp="1"/>
-          </p:cNvSpPr>
-          <p:nvPr/>
-        </p:nvSpPr>
-        <p:spPr>
-          <a:xfrm xmlns:a="http://schemas.openxmlformats.org/drawingml/2006/main">
-            <a:off x="609600" y="4857750"/>
-            <a:ext cx="10668000" cy="323850"/>
-          </a:xfrm>
-          <a:prstGeom xmlns:a="http://schemas.openxmlformats.org/drawingml/2006/main" prst="rect">
-            <a:avLst/>
-          </a:prstGeom>
-          <a:solidFill xmlns:a="http://schemas.openxmlformats.org/drawingml/2006/main">
-            <a:srgbClr val="F1F5F9"/>
-          </a:solidFill>
-          <a:ln xmlns:a="http://schemas.openxmlformats.org/drawingml/2006/main" w="9525">
-            <a:solidFill>
-              <a:srgbClr val="CBD5E1"/>
-            </a:solidFill>
-            <a:prstDash val="solid"/>
-          </a:ln>
-        </p:spPr>
-      </p:sp>
-      <p:sp>
-        <p:nvSpPr>
-          <p:cNvPr id="30" name="">
-            <a:extLst xmlns:a="http://schemas.openxmlformats.org/drawingml/2006/main">
-              <a:ext uri="{FF2B5EF4-FFF2-40B4-BE49-F238E27FC236}">
-                <a16:creationId xmlns:a16="http://schemas.microsoft.com/office/drawing/2014/main" id="{FAD62488-C574-4F7A-8D30-CACAA71337DF}"/>
-              </a:ext>
-            </a:extLst>
-          </p:cNvPr>
-          <p:cNvSpPr>
-            <a:spLocks xmlns:a="http://schemas.openxmlformats.org/drawingml/2006/main" noGrp="1"/>
-          </p:cNvSpPr>
-          <p:nvPr/>
-        </p:nvSpPr>
-        <p:spPr>
-          <a:xfrm xmlns:a="http://schemas.openxmlformats.org/drawingml/2006/main">
-            <a:off x="695325" y="4953000"/>
-            <a:ext cx="2019300" cy="209550"/>
-          </a:xfrm>
-          <a:prstGeom xmlns:a="http://schemas.openxmlformats.org/drawingml/2006/main" prst="rect">
-            <a:avLst/>
-          </a:prstGeom>
-          <a:noFill xmlns:a="http://schemas.openxmlformats.org/drawingml/2006/main"/>
-          <a:ln xmlns:a="http://schemas.openxmlformats.org/drawingml/2006/main" w="0">
-            <a:noFill/>
-            <a:prstDash val="solid"/>
-          </a:ln>
-        </p:spPr>
-        <p:txBody>
-          <a:bodyPr xmlns:a="http://schemas.openxmlformats.org/drawingml/2006/main" anchor="ctr"/>
-          <a:lstStyle xmlns:a="http://schemas.openxmlformats.org/drawingml/2006/main"/>
-          <a:p xmlns:a="http://schemas.openxmlformats.org/drawingml/2006/main">
-            <a:pPr algn="l">
-              <a:defRPr sz="1050" b="1">
-                <a:solidFill>
-                  <a:srgbClr val="0F172A"/>
-                </a:solidFill>
-              </a:defRPr>
-            </a:pPr>
-            <a:r>
-              <a:rPr sz="1050" b="1">
-                <a:solidFill>
-                  <a:srgbClr val="0F172A"/>
-                </a:solidFill>
-              </a:rPr>
-              <a:t>Range</a:t>
-            </a:r>
-          </a:p>
-        </p:txBody>
-      </p:sp>
-      <p:sp>
-        <p:nvSpPr>
-          <p:cNvPr id="31" name="">
-            <a:extLst xmlns:a="http://schemas.openxmlformats.org/drawingml/2006/main">
-              <a:ext uri="{FF2B5EF4-FFF2-40B4-BE49-F238E27FC236}">
-                <a16:creationId xmlns:a16="http://schemas.microsoft.com/office/drawing/2014/main" id="{E3355BC7-3D95-42D0-85AC-F85F37A39D60}"/>
-              </a:ext>
-            </a:extLst>
-          </p:cNvPr>
-          <p:cNvSpPr>
-            <a:spLocks xmlns:a="http://schemas.openxmlformats.org/drawingml/2006/main" noGrp="1"/>
-          </p:cNvSpPr>
-          <p:nvPr/>
-        </p:nvSpPr>
-        <p:spPr>
-          <a:xfrm xmlns:a="http://schemas.openxmlformats.org/drawingml/2006/main">
-            <a:off x="2886075" y="4953000"/>
-            <a:ext cx="4591050" cy="209550"/>
-          </a:xfrm>
-          <a:prstGeom xmlns:a="http://schemas.openxmlformats.org/drawingml/2006/main" prst="rect">
-            <a:avLst/>
-          </a:prstGeom>
-          <a:noFill xmlns:a="http://schemas.openxmlformats.org/drawingml/2006/main"/>
-          <a:ln xmlns:a="http://schemas.openxmlformats.org/drawingml/2006/main" w="0">
-            <a:noFill/>
-            <a:prstDash val="solid"/>
-          </a:ln>
-        </p:spPr>
-        <p:txBody>
-          <a:bodyPr xmlns:a="http://schemas.openxmlformats.org/drawingml/2006/main" anchor="ctr"/>
-          <a:lstStyle xmlns:a="http://schemas.openxmlformats.org/drawingml/2006/main"/>
-          <a:p xmlns:a="http://schemas.openxmlformats.org/drawingml/2006/main">
-            <a:pPr algn="l">
-              <a:defRPr sz="1050" b="1">
-                <a:solidFill>
-                  <a:srgbClr val="0F172A"/>
-                </a:solidFill>
-              </a:defRPr>
-            </a:pPr>
-            <a:r>
-              <a:rPr sz="1050" b="1">
-                <a:solidFill>
-                  <a:srgbClr val="0F172A"/>
-                </a:solidFill>
-              </a:rPr>
-              <a:t>When it applies</a:t>
-            </a:r>
-          </a:p>
-        </p:txBody>
-      </p:sp>
-      <p:sp>
-        <p:nvSpPr>
-          <p:cNvPr id="32" name="">
-            <a:extLst xmlns:a="http://schemas.openxmlformats.org/drawingml/2006/main">
-              <a:ext uri="{FF2B5EF4-FFF2-40B4-BE49-F238E27FC236}">
-                <a16:creationId xmlns:a16="http://schemas.microsoft.com/office/drawing/2014/main" id="{36C27F19-E49F-4D71-8229-6BCF30BA4766}"/>
-              </a:ext>
-            </a:extLst>
-          </p:cNvPr>
-          <p:cNvSpPr>
-            <a:spLocks xmlns:a="http://schemas.openxmlformats.org/drawingml/2006/main" noGrp="1"/>
-          </p:cNvSpPr>
-          <p:nvPr/>
-        </p:nvSpPr>
-        <p:spPr>
-          <a:xfrm xmlns:a="http://schemas.openxmlformats.org/drawingml/2006/main">
-            <a:off x="7648575" y="4953000"/>
-            <a:ext cx="3543300" cy="209550"/>
-          </a:xfrm>
-          <a:prstGeom xmlns:a="http://schemas.openxmlformats.org/drawingml/2006/main" prst="rect">
-            <a:avLst/>
-          </a:prstGeom>
-          <a:noFill xmlns:a="http://schemas.openxmlformats.org/drawingml/2006/main"/>
-          <a:ln xmlns:a="http://schemas.openxmlformats.org/drawingml/2006/main" w="0">
-            <a:noFill/>
-            <a:prstDash val="solid"/>
-          </a:ln>
-        </p:spPr>
-        <p:txBody>
-          <a:bodyPr xmlns:a="http://schemas.openxmlformats.org/drawingml/2006/main" anchor="ctr"/>
-          <a:lstStyle xmlns:a="http://schemas.openxmlformats.org/drawingml/2006/main"/>
-          <a:p xmlns:a="http://schemas.openxmlformats.org/drawingml/2006/main">
-            <a:pPr algn="l">
-              <a:defRPr sz="1050" b="1">
-                <a:solidFill>
-                  <a:srgbClr val="0F172A"/>
-                </a:solidFill>
-              </a:defRPr>
-            </a:pPr>
-            <a:r>
-              <a:rPr sz="1050" b="1">
-                <a:solidFill>
-                  <a:srgbClr val="0F172A"/>
-                </a:solidFill>
-              </a:rPr>
-              <a:t>Reason</a:t>
-            </a:r>
-          </a:p>
-        </p:txBody>
-      </p:sp>
-      <p:sp>
-        <p:nvSpPr>
-          <p:cNvPr id="33" name="">
-            <a:extLst xmlns:a="http://schemas.openxmlformats.org/drawingml/2006/main">
-              <a:ext uri="{FF2B5EF4-FFF2-40B4-BE49-F238E27FC236}">
-                <a16:creationId xmlns:a16="http://schemas.microsoft.com/office/drawing/2014/main" id="{ABF17381-88CB-45DA-961D-470E12EF03FE}"/>
-              </a:ext>
-            </a:extLst>
-          </p:cNvPr>
-          <p:cNvSpPr>
-            <a:spLocks xmlns:a="http://schemas.openxmlformats.org/drawingml/2006/main" noGrp="1"/>
-          </p:cNvSpPr>
-          <p:nvPr/>
-        </p:nvSpPr>
-        <p:spPr>
-          <a:xfrm xmlns:a="http://schemas.openxmlformats.org/drawingml/2006/main">
-            <a:off x="609600" y="5181600"/>
-            <a:ext cx="10668000" cy="361950"/>
-          </a:xfrm>
-          <a:prstGeom xmlns:a="http://schemas.openxmlformats.org/drawingml/2006/main" prst="rect">
-            <a:avLst/>
-          </a:prstGeom>
-          <a:solidFill xmlns:a="http://schemas.openxmlformats.org/drawingml/2006/main">
-            <a:srgbClr val="FFFFFF"/>
-          </a:solidFill>
-          <a:ln xmlns:a="http://schemas.openxmlformats.org/drawingml/2006/main" w="7620">
-            <a:solidFill>
-              <a:srgbClr val="CBD5E1"/>
-            </a:solidFill>
-            <a:prstDash val="solid"/>
-          </a:ln>
-        </p:spPr>
-      </p:sp>
-      <p:sp>
-        <p:nvSpPr>
-          <p:cNvPr id="34" name="">
-            <a:extLst xmlns:a="http://schemas.openxmlformats.org/drawingml/2006/main">
-              <a:ext uri="{FF2B5EF4-FFF2-40B4-BE49-F238E27FC236}">
-                <a16:creationId xmlns:a16="http://schemas.microsoft.com/office/drawing/2014/main" id="{D3E75873-5A83-40D1-B44B-E350B69E6671}"/>
-              </a:ext>
-            </a:extLst>
-          </p:cNvPr>
-          <p:cNvSpPr>
-            <a:spLocks xmlns:a="http://schemas.openxmlformats.org/drawingml/2006/main" noGrp="1"/>
-          </p:cNvSpPr>
-          <p:nvPr/>
-        </p:nvSpPr>
-        <p:spPr>
-          <a:xfrm xmlns:a="http://schemas.openxmlformats.org/drawingml/2006/main">
-            <a:off x="695325" y="5267325"/>
-            <a:ext cx="2019300" cy="228600"/>
-          </a:xfrm>
-          <a:prstGeom xmlns:a="http://schemas.openxmlformats.org/drawingml/2006/main" prst="rect">
-            <a:avLst/>
-          </a:prstGeom>
-          <a:noFill xmlns:a="http://schemas.openxmlformats.org/drawingml/2006/main"/>
-          <a:ln xmlns:a="http://schemas.openxmlformats.org/drawingml/2006/main" w="0">
-            <a:noFill/>
-            <a:prstDash val="solid"/>
-          </a:ln>
-        </p:spPr>
-        <p:txBody>
-          <a:bodyPr xmlns:a="http://schemas.openxmlformats.org/drawingml/2006/main" anchor="ctr"/>
-          <a:lstStyle xmlns:a="http://schemas.openxmlformats.org/drawingml/2006/main"/>
-          <a:p xmlns:a="http://schemas.openxmlformats.org/drawingml/2006/main">
-            <a:pPr algn="l">
-              <a:defRPr sz="1050" b="1">
-                <a:solidFill>
-                  <a:srgbClr val="2563EB"/>
-                </a:solidFill>
-              </a:defRPr>
-            </a:pPr>
-            <a:r>
-              <a:rPr sz="1050" b="1">
-                <a:solidFill>
-                  <a:srgbClr val="2563EB"/>
-                </a:solidFill>
-              </a:rPr>
-              <a:t>Low end: 10-15%</a:t>
-            </a:r>
-          </a:p>
-        </p:txBody>
-      </p:sp>
-      <p:sp>
-        <p:nvSpPr>
-          <p:cNvPr id="35" name="">
-            <a:extLst xmlns:a="http://schemas.openxmlformats.org/drawingml/2006/main">
-              <a:ext uri="{FF2B5EF4-FFF2-40B4-BE49-F238E27FC236}">
-                <a16:creationId xmlns:a16="http://schemas.microsoft.com/office/drawing/2014/main" id="{98E28E80-1178-4D29-8307-3B099EED6F78}"/>
-              </a:ext>
-            </a:extLst>
-          </p:cNvPr>
-          <p:cNvSpPr>
-            <a:spLocks xmlns:a="http://schemas.openxmlformats.org/drawingml/2006/main" noGrp="1"/>
-          </p:cNvSpPr>
-          <p:nvPr/>
-        </p:nvSpPr>
-        <p:spPr>
-          <a:xfrm xmlns:a="http://schemas.openxmlformats.org/drawingml/2006/main">
-            <a:off x="2886075" y="5267325"/>
-            <a:ext cx="4591050" cy="228600"/>
-          </a:xfrm>
-          <a:prstGeom xmlns:a="http://schemas.openxmlformats.org/drawingml/2006/main" prst="rect">
-            <a:avLst/>
-          </a:prstGeom>
-          <a:noFill xmlns:a="http://schemas.openxmlformats.org/drawingml/2006/main"/>
-          <a:ln xmlns:a="http://schemas.openxmlformats.org/drawingml/2006/main" w="0">
-            <a:noFill/>
-            <a:prstDash val="solid"/>
-          </a:ln>
-        </p:spPr>
-        <p:txBody>
-          <a:bodyPr xmlns:a="http://schemas.openxmlformats.org/drawingml/2006/main" anchor="ctr"/>
-          <a:lstStyle xmlns:a="http://schemas.openxmlformats.org/drawingml/2006/main"/>
-          <a:p xmlns:a="http://schemas.openxmlformats.org/drawingml/2006/main">
-            <a:pPr algn="l">
-              <a:defRPr sz="1050" b="0">
-                <a:solidFill>
-                  <a:srgbClr val="334155"/>
-                </a:solidFill>
-              </a:defRPr>
-            </a:pPr>
-            <a:r>
-              <a:rPr sz="1050" b="0">
-                <a:solidFill>
-                  <a:srgbClr val="334155"/>
-                </a:solidFill>
-              </a:rPr>
-              <a:t>KV is mostly hot, contexts are short, or pressure is light.</a:t>
-            </a:r>
-          </a:p>
-        </p:txBody>
-      </p:sp>
-      <p:sp>
-        <p:nvSpPr>
-          <p:cNvPr id="36" name="">
-            <a:extLst xmlns:a="http://schemas.openxmlformats.org/drawingml/2006/main">
-              <a:ext uri="{FF2B5EF4-FFF2-40B4-BE49-F238E27FC236}">
-                <a16:creationId xmlns:a16="http://schemas.microsoft.com/office/drawing/2014/main" id="{ECBAF44D-5376-4FB1-A561-1C97E755FC10}"/>
-              </a:ext>
-            </a:extLst>
-          </p:cNvPr>
-          <p:cNvSpPr>
-            <a:spLocks xmlns:a="http://schemas.openxmlformats.org/drawingml/2006/main" noGrp="1"/>
-          </p:cNvSpPr>
-          <p:nvPr/>
-        </p:nvSpPr>
-        <p:spPr>
-          <a:xfrm xmlns:a="http://schemas.openxmlformats.org/drawingml/2006/main">
-            <a:off x="7648575" y="5267325"/>
-            <a:ext cx="3543300" cy="228600"/>
-          </a:xfrm>
-          <a:prstGeom xmlns:a="http://schemas.openxmlformats.org/drawingml/2006/main" prst="rect">
-            <a:avLst/>
-          </a:prstGeom>
-          <a:noFill xmlns:a="http://schemas.openxmlformats.org/drawingml/2006/main"/>
-          <a:ln xmlns:a="http://schemas.openxmlformats.org/drawingml/2006/main" w="0">
-            <a:noFill/>
-            <a:prstDash val="solid"/>
-          </a:ln>
-        </p:spPr>
-        <p:txBody>
-          <a:bodyPr xmlns:a="http://schemas.openxmlformats.org/drawingml/2006/main" anchor="ctr"/>
-          <a:lstStyle xmlns:a="http://schemas.openxmlformats.org/drawingml/2006/main"/>
-          <a:p xmlns:a="http://schemas.openxmlformats.org/drawingml/2006/main">
-            <a:pPr algn="l">
-              <a:defRPr sz="1050" b="0">
-                <a:solidFill>
-                  <a:srgbClr val="334155"/>
-                </a:solidFill>
-              </a:defRPr>
-            </a:pPr>
-            <a:r>
-              <a:rPr sz="1050" b="0">
-                <a:solidFill>
-                  <a:srgbClr val="334155"/>
-                </a:solidFill>
-              </a:rPr>
-              <a:t>Hardware mainly removes small replay stalls.</a:t>
-            </a:r>
-          </a:p>
-        </p:txBody>
-      </p:sp>
-      <p:sp>
-        <p:nvSpPr>
-          <p:cNvPr id="37" name="">
-            <a:extLst xmlns:a="http://schemas.openxmlformats.org/drawingml/2006/main">
-              <a:ext uri="{FF2B5EF4-FFF2-40B4-BE49-F238E27FC236}">
-                <a16:creationId xmlns:a16="http://schemas.microsoft.com/office/drawing/2014/main" id="{6BDE23D1-365B-492D-9889-F8706AD0A995}"/>
-              </a:ext>
-            </a:extLst>
-          </p:cNvPr>
-          <p:cNvSpPr>
-            <a:spLocks xmlns:a="http://schemas.openxmlformats.org/drawingml/2006/main" noGrp="1"/>
-          </p:cNvSpPr>
-          <p:nvPr/>
-        </p:nvSpPr>
-        <p:spPr>
-          <a:xfrm xmlns:a="http://schemas.openxmlformats.org/drawingml/2006/main">
-            <a:off x="609600" y="5543550"/>
-            <a:ext cx="10668000" cy="361950"/>
-          </a:xfrm>
-          <a:prstGeom xmlns:a="http://schemas.openxmlformats.org/drawingml/2006/main" prst="rect">
-            <a:avLst/>
-          </a:prstGeom>
-          <a:solidFill xmlns:a="http://schemas.openxmlformats.org/drawingml/2006/main">
-            <a:srgbClr val="F8FAFC"/>
-          </a:solidFill>
-          <a:ln xmlns:a="http://schemas.openxmlformats.org/drawingml/2006/main" w="7620">
-            <a:solidFill>
-              <a:srgbClr val="CBD5E1"/>
-            </a:solidFill>
-            <a:prstDash val="solid"/>
-          </a:ln>
-        </p:spPr>
-      </p:sp>
-      <p:sp>
-        <p:nvSpPr>
-          <p:cNvPr id="38" name="">
-            <a:extLst xmlns:a="http://schemas.openxmlformats.org/drawingml/2006/main">
-              <a:ext uri="{FF2B5EF4-FFF2-40B4-BE49-F238E27FC236}">
-                <a16:creationId xmlns:a16="http://schemas.microsoft.com/office/drawing/2014/main" id="{7BE61C62-835F-4575-83E8-B04EB02CCF05}"/>
-              </a:ext>
-            </a:extLst>
-          </p:cNvPr>
-          <p:cNvSpPr>
-            <a:spLocks xmlns:a="http://schemas.openxmlformats.org/drawingml/2006/main" noGrp="1"/>
-          </p:cNvSpPr>
-          <p:nvPr/>
-        </p:nvSpPr>
-        <p:spPr>
-          <a:xfrm xmlns:a="http://schemas.openxmlformats.org/drawingml/2006/main">
-            <a:off x="695325" y="5629275"/>
-            <a:ext cx="2019300" cy="228600"/>
-          </a:xfrm>
-          <a:prstGeom xmlns:a="http://schemas.openxmlformats.org/drawingml/2006/main" prst="rect">
-            <a:avLst/>
-          </a:prstGeom>
-          <a:noFill xmlns:a="http://schemas.openxmlformats.org/drawingml/2006/main"/>
-          <a:ln xmlns:a="http://schemas.openxmlformats.org/drawingml/2006/main" w="0">
-            <a:noFill/>
-            <a:prstDash val="solid"/>
-          </a:ln>
-        </p:spPr>
-        <p:txBody>
-          <a:bodyPr xmlns:a="http://schemas.openxmlformats.org/drawingml/2006/main" anchor="ctr"/>
-          <a:lstStyle xmlns:a="http://schemas.openxmlformats.org/drawingml/2006/main"/>
-          <a:p xmlns:a="http://schemas.openxmlformats.org/drawingml/2006/main">
-            <a:pPr algn="l">
-              <a:defRPr sz="1050" b="1">
-                <a:solidFill>
-                  <a:srgbClr val="DC2626"/>
-                </a:solidFill>
-              </a:defRPr>
-            </a:pPr>
-            <a:r>
-              <a:rPr sz="1050" b="1">
-                <a:solidFill>
-                  <a:srgbClr val="DC2626"/>
-                </a:solidFill>
-              </a:rPr>
-              <a:t>High end: 25-30%+</a:t>
-            </a:r>
-          </a:p>
-        </p:txBody>
-      </p:sp>
-      <p:sp>
-        <p:nvSpPr>
-          <p:cNvPr id="39" name="">
-            <a:extLst xmlns:a="http://schemas.openxmlformats.org/drawingml/2006/main">
-              <a:ext uri="{FF2B5EF4-FFF2-40B4-BE49-F238E27FC236}">
-                <a16:creationId xmlns:a16="http://schemas.microsoft.com/office/drawing/2014/main" id="{2C6C85F1-3AC8-4547-8C0B-2C9FCCF65336}"/>
-              </a:ext>
-            </a:extLst>
-          </p:cNvPr>
-          <p:cNvSpPr>
-            <a:spLocks xmlns:a="http://schemas.openxmlformats.org/drawingml/2006/main" noGrp="1"/>
-          </p:cNvSpPr>
-          <p:nvPr/>
-        </p:nvSpPr>
-        <p:spPr>
-          <a:xfrm xmlns:a="http://schemas.openxmlformats.org/drawingml/2006/main">
-            <a:off x="2886075" y="5629275"/>
-            <a:ext cx="4591050" cy="228600"/>
-          </a:xfrm>
-          <a:prstGeom xmlns:a="http://schemas.openxmlformats.org/drawingml/2006/main" prst="rect">
-            <a:avLst/>
-          </a:prstGeom>
-          <a:noFill xmlns:a="http://schemas.openxmlformats.org/drawingml/2006/main"/>
-          <a:ln xmlns:a="http://schemas.openxmlformats.org/drawingml/2006/main" w="0">
-            <a:noFill/>
-            <a:prstDash val="solid"/>
-          </a:ln>
-        </p:spPr>
-        <p:txBody>
-          <a:bodyPr xmlns:a="http://schemas.openxmlformats.org/drawingml/2006/main" anchor="ctr"/>
-          <a:lstStyle xmlns:a="http://schemas.openxmlformats.org/drawingml/2006/main"/>
-          <a:p xmlns:a="http://schemas.openxmlformats.org/drawingml/2006/main">
-            <a:pPr algn="l">
-              <a:defRPr sz="1050" b="0">
-                <a:solidFill>
-                  <a:srgbClr val="334155"/>
-                </a:solidFill>
-              </a:defRPr>
-            </a:pPr>
-            <a:r>
-              <a:rPr sz="1050" b="0">
-                <a:solidFill>
-                  <a:srgbClr val="334155"/>
-                </a:solidFill>
-              </a:rPr>
-              <a:t>Long contexts, high pressure, frequent offload/reload, or recompute.</a:t>
-            </a:r>
-          </a:p>
-        </p:txBody>
-      </p:sp>
-      <p:sp>
-        <p:nvSpPr>
-          <p:cNvPr id="40" name="">
-            <a:extLst xmlns:a="http://schemas.openxmlformats.org/drawingml/2006/main">
-              <a:ext uri="{FF2B5EF4-FFF2-40B4-BE49-F238E27FC236}">
-                <a16:creationId xmlns:a16="http://schemas.microsoft.com/office/drawing/2014/main" id="{71048D73-7EBF-4C8B-ACB3-6EF2DB3F1FB8}"/>
-              </a:ext>
-            </a:extLst>
-          </p:cNvPr>
-          <p:cNvSpPr>
-            <a:spLocks xmlns:a="http://schemas.openxmlformats.org/drawingml/2006/main" noGrp="1"/>
-          </p:cNvSpPr>
-          <p:nvPr/>
-        </p:nvSpPr>
-        <p:spPr>
-          <a:xfrm xmlns:a="http://schemas.openxmlformats.org/drawingml/2006/main">
-            <a:off x="7648575" y="5629275"/>
-            <a:ext cx="3543300" cy="228600"/>
-          </a:xfrm>
-          <a:prstGeom xmlns:a="http://schemas.openxmlformats.org/drawingml/2006/main" prst="rect">
-            <a:avLst/>
-          </a:prstGeom>
-          <a:noFill xmlns:a="http://schemas.openxmlformats.org/drawingml/2006/main"/>
-          <a:ln xmlns:a="http://schemas.openxmlformats.org/drawingml/2006/main" w="0">
-            <a:noFill/>
-            <a:prstDash val="solid"/>
-          </a:ln>
-        </p:spPr>
-        <p:txBody>
-          <a:bodyPr xmlns:a="http://schemas.openxmlformats.org/drawingml/2006/main" anchor="ctr"/>
-          <a:lstStyle xmlns:a="http://schemas.openxmlformats.org/drawingml/2006/main"/>
-          <a:p xmlns:a="http://schemas.openxmlformats.org/drawingml/2006/main">
-            <a:pPr algn="l">
-              <a:defRPr sz="1050" b="0">
-                <a:solidFill>
-                  <a:srgbClr val="334155"/>
-                </a:solidFill>
-              </a:defRPr>
-            </a:pPr>
-            <a:r>
-              <a:rPr sz="1050" b="0">
-                <a:solidFill>
-                  <a:srgbClr val="334155"/>
-                </a:solidFill>
-              </a:rPr>
-              <a:t>Hardware avoids the expensive replay path.</a:t>
-            </a:r>
-          </a:p>
-        </p:txBody>
-      </p:sp>
-      <p:sp>
-        <p:nvSpPr>
-          <p:cNvPr id="41" name="">
-            <a:extLst xmlns:a="http://schemas.openxmlformats.org/drawingml/2006/main">
-              <a:ext uri="{FF2B5EF4-FFF2-40B4-BE49-F238E27FC236}">
-                <a16:creationId xmlns:a16="http://schemas.microsoft.com/office/drawing/2014/main" id="{3D16E2E6-695B-427B-A2BA-D569A2270624}"/>
-              </a:ext>
-            </a:extLst>
-          </p:cNvPr>
-          <p:cNvSpPr>
-            <a:spLocks xmlns:a="http://schemas.openxmlformats.org/drawingml/2006/main" noGrp="1"/>
-          </p:cNvSpPr>
-          <p:nvPr/>
-        </p:nvSpPr>
-        <p:spPr>
-          <a:xfrm xmlns:a="http://schemas.openxmlformats.org/drawingml/2006/main">
-            <a:off x="876300" y="6029325"/>
-            <a:ext cx="9906000" cy="285750"/>
-          </a:xfrm>
-          <a:prstGeom xmlns:a="http://schemas.openxmlformats.org/drawingml/2006/main" prst="rect">
-            <a:avLst/>
-          </a:prstGeom>
-          <a:noFill xmlns:a="http://schemas.openxmlformats.org/drawingml/2006/main"/>
-          <a:ln xmlns:a="http://schemas.openxmlformats.org/drawingml/2006/main" w="0">
-            <a:noFill/>
-            <a:prstDash val="solid"/>
-          </a:ln>
-        </p:spPr>
-        <p:txBody>
-          <a:bodyPr xmlns:a="http://schemas.openxmlformats.org/drawingml/2006/main" anchor="t"/>
-          <a:lstStyle xmlns:a="http://schemas.openxmlformats.org/drawingml/2006/main"/>
-          <a:p xmlns:a="http://schemas.openxmlformats.org/drawingml/2006/main">
-            <a:pPr algn="ctr">
-              <a:defRPr sz="1425" b="1">
-                <a:solidFill>
-                  <a:srgbClr val="0F172A"/>
-                </a:solidFill>
-              </a:defRPr>
-            </a:pPr>
-            <a:r>
-              <a:rPr sz="1425" b="1">
-                <a:solidFill>
-                  <a:srgbClr val="0F172A"/>
-                </a:solidFill>
-              </a:rPr>
-              <a:t>Framing: these are conservative research targets; the prototype is meant to turn them into measured numbers.</a:t>
-            </a:r>
-          </a:p>
-        </p:txBody>
-      </p:sp>
-      <p:sp>
-        <p:nvSpPr>
-          <p:cNvPr id="42" name="">
-            <a:extLst xmlns:a="http://schemas.openxmlformats.org/drawingml/2006/main">
-              <a:ext uri="{FF2B5EF4-FFF2-40B4-BE49-F238E27FC236}">
-                <a16:creationId xmlns:a16="http://schemas.microsoft.com/office/drawing/2014/main" id="{83F94061-1833-4185-B3F0-29FA684265A9}"/>
+                <a16:creationId xmlns:a16="http://schemas.microsoft.com/office/drawing/2014/main" id="{4B25D72D-63FE-410C-B487-FD327FA7C694}"/>
               </a:ext>
             </a:extLst>
           </p:cNvPr>
@@ -5553,10 +4532,10 @@
       </p:sp>
       <p:sp>
         <p:nvSpPr>
-          <p:cNvPr id="43" name="">
-            <a:extLst xmlns:a="http://schemas.openxmlformats.org/drawingml/2006/main">
-              <a:ext uri="{FF2B5EF4-FFF2-40B4-BE49-F238E27FC236}">
-                <a16:creationId xmlns:a16="http://schemas.microsoft.com/office/drawing/2014/main" id="{A8B5DDA3-30C9-494B-8E37-79B3106E508F}"/>
+          <p:cNvPr id="21" name="">
+            <a:extLst xmlns:a="http://schemas.openxmlformats.org/drawingml/2006/main">
+              <a:ext uri="{FF2B5EF4-FFF2-40B4-BE49-F238E27FC236}">
+                <a16:creationId xmlns:a16="http://schemas.microsoft.com/office/drawing/2014/main" id="{8973D742-CCA8-4568-BD95-5B776A2C38DE}"/>
               </a:ext>
             </a:extLst>
           </p:cNvPr>
@@ -5604,7 +4583,7 @@
     </p:spTree>
     <p:extLst>
       <p:ext uri="{BB962C8B-B14F-4D97-AF65-F5344CB8AC3E}">
-        <p14:creationId xmlns:p14="http://schemas.microsoft.com/office/powerpoint/2010/main" val="496324710"/>
+        <p14:creationId xmlns:p14="http://schemas.microsoft.com/office/powerpoint/2010/main" val="1347979260"/>
       </p:ext>
     </p:extLst>
   </p:cSld>
@@ -5635,7 +4614,7 @@
           <p:cNvPr id="15" name="">
             <a:extLst xmlns:a="http://schemas.openxmlformats.org/drawingml/2006/main">
               <a:ext uri="{FF2B5EF4-FFF2-40B4-BE49-F238E27FC236}">
-                <a16:creationId xmlns:a16="http://schemas.microsoft.com/office/drawing/2014/main" id="{57FF6920-A6BF-4A4F-A963-9BC9D42DBA0B}"/>
+                <a16:creationId xmlns:a16="http://schemas.microsoft.com/office/drawing/2014/main" id="{754CDFBF-37DE-4685-941A-14325A8001D9}"/>
               </a:ext>
             </a:extLst>
           </p:cNvPr>
@@ -5685,7 +4664,7 @@
           <p:cNvPr id="2" name="">
             <a:extLst xmlns:a="http://schemas.openxmlformats.org/drawingml/2006/main">
               <a:ext uri="{FF2B5EF4-FFF2-40B4-BE49-F238E27FC236}">
-                <a16:creationId xmlns:a16="http://schemas.microsoft.com/office/drawing/2014/main" id="{22C3FB72-7F7D-45CA-8CAA-EB17BB02B42D}"/>
+                <a16:creationId xmlns:a16="http://schemas.microsoft.com/office/drawing/2014/main" id="{88ED46AE-C6C2-4A2E-A3F2-027149212E84}"/>
               </a:ext>
             </a:extLst>
           </p:cNvPr>
@@ -5735,7 +4714,7 @@
           <p:cNvPr id="3" name="">
             <a:extLst xmlns:a="http://schemas.openxmlformats.org/drawingml/2006/main">
               <a:ext uri="{FF2B5EF4-FFF2-40B4-BE49-F238E27FC236}">
-                <a16:creationId xmlns:a16="http://schemas.microsoft.com/office/drawing/2014/main" id="{F29F3426-107A-49BA-8F95-2B2111188A12}"/>
+                <a16:creationId xmlns:a16="http://schemas.microsoft.com/office/drawing/2014/main" id="{9A0A206A-C485-406C-9FDD-813C57BD7355}"/>
               </a:ext>
             </a:extLst>
           </p:cNvPr>
@@ -5785,7 +4764,7 @@
           <p:cNvPr id="4" name="">
             <a:extLst xmlns:a="http://schemas.openxmlformats.org/drawingml/2006/main">
               <a:ext uri="{FF2B5EF4-FFF2-40B4-BE49-F238E27FC236}">
-                <a16:creationId xmlns:a16="http://schemas.microsoft.com/office/drawing/2014/main" id="{B67F276E-06E0-477E-934A-47FC1F0E55B3}"/>
+                <a16:creationId xmlns:a16="http://schemas.microsoft.com/office/drawing/2014/main" id="{C242997F-85E9-4FFE-B216-4C5EC65FF57D}"/>
               </a:ext>
             </a:extLst>
           </p:cNvPr>
@@ -5835,7 +4814,7 @@
           <p:cNvPr id="5" name="">
             <a:extLst xmlns:a="http://schemas.openxmlformats.org/drawingml/2006/main">
               <a:ext uri="{FF2B5EF4-FFF2-40B4-BE49-F238E27FC236}">
-                <a16:creationId xmlns:a16="http://schemas.microsoft.com/office/drawing/2014/main" id="{D14FFE8F-4AFE-4F53-B466-CBBFF05FA262}"/>
+                <a16:creationId xmlns:a16="http://schemas.microsoft.com/office/drawing/2014/main" id="{8D9756C0-B7AA-4133-8552-12ADB803185C}"/>
               </a:ext>
             </a:extLst>
           </p:cNvPr>
@@ -5885,7 +4864,7 @@
           <p:cNvPr id="6" name="">
             <a:extLst xmlns:a="http://schemas.openxmlformats.org/drawingml/2006/main">
               <a:ext uri="{FF2B5EF4-FFF2-40B4-BE49-F238E27FC236}">
-                <a16:creationId xmlns:a16="http://schemas.microsoft.com/office/drawing/2014/main" id="{6B4750E0-9356-4DDE-8CA9-5CA794160CD0}"/>
+                <a16:creationId xmlns:a16="http://schemas.microsoft.com/office/drawing/2014/main" id="{F045540A-E436-4EA3-9D6E-8DEA6F35DB6F}"/>
               </a:ext>
             </a:extLst>
           </p:cNvPr>
@@ -5935,7 +4914,7 @@
           <p:cNvPr id="7" name="">
             <a:extLst xmlns:a="http://schemas.openxmlformats.org/drawingml/2006/main">
               <a:ext uri="{FF2B5EF4-FFF2-40B4-BE49-F238E27FC236}">
-                <a16:creationId xmlns:a16="http://schemas.microsoft.com/office/drawing/2014/main" id="{8A347B0F-D736-4503-A755-E0212033ADAB}"/>
+                <a16:creationId xmlns:a16="http://schemas.microsoft.com/office/drawing/2014/main" id="{A9B5C110-53A2-4824-8D10-A67E44DAE0FC}"/>
               </a:ext>
             </a:extLst>
           </p:cNvPr>
@@ -5985,7 +4964,7 @@
           <p:cNvPr id="8" name="">
             <a:extLst xmlns:a="http://schemas.openxmlformats.org/drawingml/2006/main">
               <a:ext uri="{FF2B5EF4-FFF2-40B4-BE49-F238E27FC236}">
-                <a16:creationId xmlns:a16="http://schemas.microsoft.com/office/drawing/2014/main" id="{38052B10-C9F3-4995-91D9-C5CE375822E6}"/>
+                <a16:creationId xmlns:a16="http://schemas.microsoft.com/office/drawing/2014/main" id="{D3BE5191-7EEC-425E-AEED-50E5B0101147}"/>
               </a:ext>
             </a:extLst>
           </p:cNvPr>
@@ -6035,7 +5014,7 @@
           <p:cNvPr id="9" name="">
             <a:extLst xmlns:a="http://schemas.openxmlformats.org/drawingml/2006/main">
               <a:ext uri="{FF2B5EF4-FFF2-40B4-BE49-F238E27FC236}">
-                <a16:creationId xmlns:a16="http://schemas.microsoft.com/office/drawing/2014/main" id="{CA153E0A-45DA-483C-8DBA-3DB57AC72815}"/>
+                <a16:creationId xmlns:a16="http://schemas.microsoft.com/office/drawing/2014/main" id="{7403CB6C-EDBF-4802-8945-141FAF9FD8BB}"/>
               </a:ext>
             </a:extLst>
           </p:cNvPr>
@@ -6085,7 +5064,7 @@
           <p:cNvPr id="10" name="">
             <a:extLst xmlns:a="http://schemas.openxmlformats.org/drawingml/2006/main">
               <a:ext uri="{FF2B5EF4-FFF2-40B4-BE49-F238E27FC236}">
-                <a16:creationId xmlns:a16="http://schemas.microsoft.com/office/drawing/2014/main" id="{CAB8B715-1E09-44EB-9423-980AF2C0C312}"/>
+                <a16:creationId xmlns:a16="http://schemas.microsoft.com/office/drawing/2014/main" id="{DF68B0F6-33F1-4FD5-B64C-F1CF9B14B8D2}"/>
               </a:ext>
             </a:extLst>
           </p:cNvPr>
@@ -6135,7 +5114,7 @@
           <p:cNvPr id="11" name="">
             <a:extLst xmlns:a="http://schemas.openxmlformats.org/drawingml/2006/main">
               <a:ext uri="{FF2B5EF4-FFF2-40B4-BE49-F238E27FC236}">
-                <a16:creationId xmlns:a16="http://schemas.microsoft.com/office/drawing/2014/main" id="{9A5644F5-9A20-467E-A72B-9016BD4CC8FA}"/>
+                <a16:creationId xmlns:a16="http://schemas.microsoft.com/office/drawing/2014/main" id="{3718519A-617B-42C9-AFC3-755F13A4A955}"/>
               </a:ext>
             </a:extLst>
           </p:cNvPr>
@@ -6166,7 +5145,7 @@
           <p:cNvPr id="12" name="">
             <a:extLst xmlns:a="http://schemas.openxmlformats.org/drawingml/2006/main">
               <a:ext uri="{FF2B5EF4-FFF2-40B4-BE49-F238E27FC236}">
-                <a16:creationId xmlns:a16="http://schemas.microsoft.com/office/drawing/2014/main" id="{6AB716F4-E1D2-433A-B8D1-38767E4E5E34}"/>
+                <a16:creationId xmlns:a16="http://schemas.microsoft.com/office/drawing/2014/main" id="{67F2B537-61E6-4009-8382-92606EF41800}"/>
               </a:ext>
             </a:extLst>
           </p:cNvPr>
@@ -6216,7 +5195,7 @@
           <p:cNvPr id="13" name="">
             <a:extLst xmlns:a="http://schemas.openxmlformats.org/drawingml/2006/main">
               <a:ext uri="{FF2B5EF4-FFF2-40B4-BE49-F238E27FC236}">
-                <a16:creationId xmlns:a16="http://schemas.microsoft.com/office/drawing/2014/main" id="{65472C9F-39F7-42E3-A5CE-645F885A1B37}"/>
+                <a16:creationId xmlns:a16="http://schemas.microsoft.com/office/drawing/2014/main" id="{D728E630-EFDD-4C29-9848-DCF76AC7839D}"/>
               </a:ext>
             </a:extLst>
           </p:cNvPr>
@@ -6266,7 +5245,7 @@
           <p:cNvPr id="14" name="">
             <a:extLst xmlns:a="http://schemas.openxmlformats.org/drawingml/2006/main">
               <a:ext uri="{FF2B5EF4-FFF2-40B4-BE49-F238E27FC236}">
-                <a16:creationId xmlns:a16="http://schemas.microsoft.com/office/drawing/2014/main" id="{9318CD37-BC14-4927-AE5A-6B94EC7F3BFA}"/>
+                <a16:creationId xmlns:a16="http://schemas.microsoft.com/office/drawing/2014/main" id="{2674D2E0-1582-42AF-BFBA-8083A2FAF00D}"/>
               </a:ext>
             </a:extLst>
           </p:cNvPr>
@@ -6314,7 +5293,7 @@
     </p:spTree>
     <p:extLst>
       <p:ext uri="{BB962C8B-B14F-4D97-AF65-F5344CB8AC3E}">
-        <p14:creationId xmlns:p14="http://schemas.microsoft.com/office/powerpoint/2010/main" val="1254036893"/>
+        <p14:creationId xmlns:p14="http://schemas.microsoft.com/office/powerpoint/2010/main" val="907000079"/>
       </p:ext>
     </p:extLst>
   </p:cSld>
@@ -6345,7 +5324,7 @@
           <p:cNvPr id="12" name="">
             <a:extLst xmlns:a="http://schemas.openxmlformats.org/drawingml/2006/main">
               <a:ext uri="{FF2B5EF4-FFF2-40B4-BE49-F238E27FC236}">
-                <a16:creationId xmlns:a16="http://schemas.microsoft.com/office/drawing/2014/main" id="{B8032C68-68D8-4E50-9C99-15ACDF549D4B}"/>
+                <a16:creationId xmlns:a16="http://schemas.microsoft.com/office/drawing/2014/main" id="{F366AEBA-B025-4BA6-A3C0-AD2A00AFEA51}"/>
               </a:ext>
             </a:extLst>
           </p:cNvPr>
@@ -6395,7 +5374,7 @@
           <p:cNvPr id="2" name="">
             <a:extLst xmlns:a="http://schemas.openxmlformats.org/drawingml/2006/main">
               <a:ext uri="{FF2B5EF4-FFF2-40B4-BE49-F238E27FC236}">
-                <a16:creationId xmlns:a16="http://schemas.microsoft.com/office/drawing/2014/main" id="{7D159159-C98C-4037-80B6-758E50588C20}"/>
+                <a16:creationId xmlns:a16="http://schemas.microsoft.com/office/drawing/2014/main" id="{1C02FFB4-E9CC-489E-8400-15C3FF99D7AF}"/>
               </a:ext>
             </a:extLst>
           </p:cNvPr>
@@ -6445,7 +5424,7 @@
           <p:cNvPr id="3" name="">
             <a:extLst xmlns:a="http://schemas.openxmlformats.org/drawingml/2006/main">
               <a:ext uri="{FF2B5EF4-FFF2-40B4-BE49-F238E27FC236}">
-                <a16:creationId xmlns:a16="http://schemas.microsoft.com/office/drawing/2014/main" id="{F5AC69A0-D315-4264-A736-A12809F64593}"/>
+                <a16:creationId xmlns:a16="http://schemas.microsoft.com/office/drawing/2014/main" id="{B800EDAA-52C7-465D-8796-098C1F63E466}"/>
               </a:ext>
             </a:extLst>
           </p:cNvPr>
@@ -6495,7 +5474,7 @@
           <p:cNvPr id="4" name="">
             <a:extLst xmlns:a="http://schemas.openxmlformats.org/drawingml/2006/main">
               <a:ext uri="{FF2B5EF4-FFF2-40B4-BE49-F238E27FC236}">
-                <a16:creationId xmlns:a16="http://schemas.microsoft.com/office/drawing/2014/main" id="{FF16EFAB-93F6-4E59-BA78-7FDD2F720A99}"/>
+                <a16:creationId xmlns:a16="http://schemas.microsoft.com/office/drawing/2014/main" id="{A082A6C2-0157-4520-AFA4-F6A7E4718D8C}"/>
               </a:ext>
             </a:extLst>
           </p:cNvPr>
@@ -6545,7 +5524,7 @@
           <p:cNvPr id="5" name="">
             <a:extLst xmlns:a="http://schemas.openxmlformats.org/drawingml/2006/main">
               <a:ext uri="{FF2B5EF4-FFF2-40B4-BE49-F238E27FC236}">
-                <a16:creationId xmlns:a16="http://schemas.microsoft.com/office/drawing/2014/main" id="{29EA0E5D-ECA5-4093-9736-0CE354546050}"/>
+                <a16:creationId xmlns:a16="http://schemas.microsoft.com/office/drawing/2014/main" id="{B2AED248-E203-4F84-A524-BA17FF42E15A}"/>
               </a:ext>
             </a:extLst>
           </p:cNvPr>
@@ -6595,7 +5574,7 @@
           <p:cNvPr id="6" name="">
             <a:extLst xmlns:a="http://schemas.openxmlformats.org/drawingml/2006/main">
               <a:ext uri="{FF2B5EF4-FFF2-40B4-BE49-F238E27FC236}">
-                <a16:creationId xmlns:a16="http://schemas.microsoft.com/office/drawing/2014/main" id="{1C52FF47-2DCF-4F70-B466-7DD95BE1A772}"/>
+                <a16:creationId xmlns:a16="http://schemas.microsoft.com/office/drawing/2014/main" id="{8AEA97EA-D02A-4607-BA23-E70F0BA3484D}"/>
               </a:ext>
             </a:extLst>
           </p:cNvPr>
@@ -6645,7 +5624,7 @@
           <p:cNvPr id="7" name="">
             <a:extLst xmlns:a="http://schemas.openxmlformats.org/drawingml/2006/main">
               <a:ext uri="{FF2B5EF4-FFF2-40B4-BE49-F238E27FC236}">
-                <a16:creationId xmlns:a16="http://schemas.microsoft.com/office/drawing/2014/main" id="{E7523849-E8A3-47D8-A752-ABBD87847193}"/>
+                <a16:creationId xmlns:a16="http://schemas.microsoft.com/office/drawing/2014/main" id="{A498B437-4B4A-4F1D-85DA-CFF98080719F}"/>
               </a:ext>
             </a:extLst>
           </p:cNvPr>
@@ -6695,7 +5674,7 @@
           <p:cNvPr id="8" name="">
             <a:extLst xmlns:a="http://schemas.openxmlformats.org/drawingml/2006/main">
               <a:ext uri="{FF2B5EF4-FFF2-40B4-BE49-F238E27FC236}">
-                <a16:creationId xmlns:a16="http://schemas.microsoft.com/office/drawing/2014/main" id="{9719DDCB-3290-4CB9-88FC-470C3CEF3EED}"/>
+                <a16:creationId xmlns:a16="http://schemas.microsoft.com/office/drawing/2014/main" id="{29D5D00D-7E4C-4E77-A85F-BE570151DAD2}"/>
               </a:ext>
             </a:extLst>
           </p:cNvPr>
@@ -6745,7 +5724,7 @@
           <p:cNvPr id="9" name="">
             <a:extLst xmlns:a="http://schemas.openxmlformats.org/drawingml/2006/main">
               <a:ext uri="{FF2B5EF4-FFF2-40B4-BE49-F238E27FC236}">
-                <a16:creationId xmlns:a16="http://schemas.microsoft.com/office/drawing/2014/main" id="{6AAAF10B-62CF-450C-B501-27E3C23856C0}"/>
+                <a16:creationId xmlns:a16="http://schemas.microsoft.com/office/drawing/2014/main" id="{1A54D267-D753-4738-8EF1-4C8D87E2A077}"/>
               </a:ext>
             </a:extLst>
           </p:cNvPr>
@@ -6795,7 +5774,7 @@
           <p:cNvPr id="10" name="">
             <a:extLst xmlns:a="http://schemas.openxmlformats.org/drawingml/2006/main">
               <a:ext uri="{FF2B5EF4-FFF2-40B4-BE49-F238E27FC236}">
-                <a16:creationId xmlns:a16="http://schemas.microsoft.com/office/drawing/2014/main" id="{241BE25E-8A1B-4E3C-9E66-9831F905403D}"/>
+                <a16:creationId xmlns:a16="http://schemas.microsoft.com/office/drawing/2014/main" id="{9B69446A-ECB9-40FB-A18F-D766A8AFFCB3}"/>
               </a:ext>
             </a:extLst>
           </p:cNvPr>
@@ -6845,7 +5824,7 @@
           <p:cNvPr id="11" name="">
             <a:extLst xmlns:a="http://schemas.openxmlformats.org/drawingml/2006/main">
               <a:ext uri="{FF2B5EF4-FFF2-40B4-BE49-F238E27FC236}">
-                <a16:creationId xmlns:a16="http://schemas.microsoft.com/office/drawing/2014/main" id="{0654C8BF-1FB4-45F6-BF0C-5B83AD32AC81}"/>
+                <a16:creationId xmlns:a16="http://schemas.microsoft.com/office/drawing/2014/main" id="{E8C47FE8-C06C-40D1-BDD5-4A1C720723C5}"/>
               </a:ext>
             </a:extLst>
           </p:cNvPr>
@@ -6893,7 +5872,7 @@
     </p:spTree>
     <p:extLst>
       <p:ext uri="{BB962C8B-B14F-4D97-AF65-F5344CB8AC3E}">
-        <p14:creationId xmlns:p14="http://schemas.microsoft.com/office/powerpoint/2010/main" val="1258909754"/>
+        <p14:creationId xmlns:p14="http://schemas.microsoft.com/office/powerpoint/2010/main" val="1632150991"/>
       </p:ext>
     </p:extLst>
   </p:cSld>
@@ -6924,7 +5903,7 @@
           <p:cNvPr id="22" name="">
             <a:extLst xmlns:a="http://schemas.openxmlformats.org/drawingml/2006/main">
               <a:ext uri="{FF2B5EF4-FFF2-40B4-BE49-F238E27FC236}">
-                <a16:creationId xmlns:a16="http://schemas.microsoft.com/office/drawing/2014/main" id="{58C8B68F-261E-48B8-B1C2-257B1A54212B}"/>
+                <a16:creationId xmlns:a16="http://schemas.microsoft.com/office/drawing/2014/main" id="{CF627859-AB02-4C7D-8A06-48E8BA78DF11}"/>
               </a:ext>
             </a:extLst>
           </p:cNvPr>
@@ -6974,7 +5953,7 @@
           <p:cNvPr id="2" name="">
             <a:extLst xmlns:a="http://schemas.openxmlformats.org/drawingml/2006/main">
               <a:ext uri="{FF2B5EF4-FFF2-40B4-BE49-F238E27FC236}">
-                <a16:creationId xmlns:a16="http://schemas.microsoft.com/office/drawing/2014/main" id="{D4595595-CA61-49A5-813A-99BE2BB12F96}"/>
+                <a16:creationId xmlns:a16="http://schemas.microsoft.com/office/drawing/2014/main" id="{6B42BE96-28C6-4609-B997-9E0CB5225432}"/>
               </a:ext>
             </a:extLst>
           </p:cNvPr>
@@ -7024,7 +6003,7 @@
           <p:cNvPr id="3" name="">
             <a:extLst xmlns:a="http://schemas.openxmlformats.org/drawingml/2006/main">
               <a:ext uri="{FF2B5EF4-FFF2-40B4-BE49-F238E27FC236}">
-                <a16:creationId xmlns:a16="http://schemas.microsoft.com/office/drawing/2014/main" id="{CACF41CA-D2AD-472C-AB46-1A499C7C17A2}"/>
+                <a16:creationId xmlns:a16="http://schemas.microsoft.com/office/drawing/2014/main" id="{4DCC4CE1-7DCF-4913-B82C-BA66EFF48997}"/>
               </a:ext>
             </a:extLst>
           </p:cNvPr>
@@ -7059,7 +6038,7 @@
           <p:cNvPr id="4" name="">
             <a:extLst xmlns:a="http://schemas.openxmlformats.org/drawingml/2006/main">
               <a:ext uri="{FF2B5EF4-FFF2-40B4-BE49-F238E27FC236}">
-                <a16:creationId xmlns:a16="http://schemas.microsoft.com/office/drawing/2014/main" id="{1E61DC6F-666F-42DB-99DB-280732054B98}"/>
+                <a16:creationId xmlns:a16="http://schemas.microsoft.com/office/drawing/2014/main" id="{D07B01CA-847D-44E9-A191-53B80012434D}"/>
               </a:ext>
             </a:extLst>
           </p:cNvPr>
@@ -7126,7 +6105,7 @@
           <p:cNvPr id="5" name="">
             <a:extLst xmlns:a="http://schemas.openxmlformats.org/drawingml/2006/main">
               <a:ext uri="{FF2B5EF4-FFF2-40B4-BE49-F238E27FC236}">
-                <a16:creationId xmlns:a16="http://schemas.microsoft.com/office/drawing/2014/main" id="{D76F8753-24D0-4CA2-AA06-EBDCB4D652BE}"/>
+                <a16:creationId xmlns:a16="http://schemas.microsoft.com/office/drawing/2014/main" id="{0B2305FF-C99E-4244-8FFE-0971A775A042}"/>
               </a:ext>
             </a:extLst>
           </p:cNvPr>
@@ -7176,7 +6155,7 @@
           <p:cNvPr id="6" name="">
             <a:extLst xmlns:a="http://schemas.openxmlformats.org/drawingml/2006/main">
               <a:ext uri="{FF2B5EF4-FFF2-40B4-BE49-F238E27FC236}">
-                <a16:creationId xmlns:a16="http://schemas.microsoft.com/office/drawing/2014/main" id="{88ED699D-3AF6-4906-82E5-5140B21FE4AA}"/>
+                <a16:creationId xmlns:a16="http://schemas.microsoft.com/office/drawing/2014/main" id="{F51AB654-A528-4F5A-9950-6E2940A608DB}"/>
               </a:ext>
             </a:extLst>
           </p:cNvPr>
@@ -7211,7 +6190,7 @@
           <p:cNvPr id="7" name="">
             <a:extLst xmlns:a="http://schemas.openxmlformats.org/drawingml/2006/main">
               <a:ext uri="{FF2B5EF4-FFF2-40B4-BE49-F238E27FC236}">
-                <a16:creationId xmlns:a16="http://schemas.microsoft.com/office/drawing/2014/main" id="{4A4D3AD1-3A7F-4797-9F46-1EB04CB4BE6E}"/>
+                <a16:creationId xmlns:a16="http://schemas.microsoft.com/office/drawing/2014/main" id="{98782638-8633-49D7-9F9E-6CAC908380A1}"/>
               </a:ext>
             </a:extLst>
           </p:cNvPr>
@@ -7278,7 +6257,7 @@
           <p:cNvPr id="8" name="">
             <a:extLst xmlns:a="http://schemas.openxmlformats.org/drawingml/2006/main">
               <a:ext uri="{FF2B5EF4-FFF2-40B4-BE49-F238E27FC236}">
-                <a16:creationId xmlns:a16="http://schemas.microsoft.com/office/drawing/2014/main" id="{FAD6A26B-2D54-4ED4-8AA1-2AA078C8F0AA}"/>
+                <a16:creationId xmlns:a16="http://schemas.microsoft.com/office/drawing/2014/main" id="{0F152DED-FE32-49C2-A6D8-3F104BFE08FD}"/>
               </a:ext>
             </a:extLst>
           </p:cNvPr>
@@ -7328,7 +6307,7 @@
           <p:cNvPr id="9" name="">
             <a:extLst xmlns:a="http://schemas.openxmlformats.org/drawingml/2006/main">
               <a:ext uri="{FF2B5EF4-FFF2-40B4-BE49-F238E27FC236}">
-                <a16:creationId xmlns:a16="http://schemas.microsoft.com/office/drawing/2014/main" id="{CB38301F-CF08-4907-9249-3FD3048C3270}"/>
+                <a16:creationId xmlns:a16="http://schemas.microsoft.com/office/drawing/2014/main" id="{9ACC85D3-694C-489F-B442-19DBD80494D0}"/>
               </a:ext>
             </a:extLst>
           </p:cNvPr>
@@ -7363,7 +6342,7 @@
           <p:cNvPr id="10" name="">
             <a:extLst xmlns:a="http://schemas.openxmlformats.org/drawingml/2006/main">
               <a:ext uri="{FF2B5EF4-FFF2-40B4-BE49-F238E27FC236}">
-                <a16:creationId xmlns:a16="http://schemas.microsoft.com/office/drawing/2014/main" id="{0B183D6D-AE2F-4961-B1E2-0BCBF2C63E94}"/>
+                <a16:creationId xmlns:a16="http://schemas.microsoft.com/office/drawing/2014/main" id="{A9FEAF2A-CFBB-4AA4-9BFE-23191E9717D4}"/>
               </a:ext>
             </a:extLst>
           </p:cNvPr>
@@ -7430,7 +6409,7 @@
           <p:cNvPr id="11" name="">
             <a:extLst xmlns:a="http://schemas.openxmlformats.org/drawingml/2006/main">
               <a:ext uri="{FF2B5EF4-FFF2-40B4-BE49-F238E27FC236}">
-                <a16:creationId xmlns:a16="http://schemas.microsoft.com/office/drawing/2014/main" id="{6AEA85BB-478D-4ECC-88CE-653DC4F40D8C}"/>
+                <a16:creationId xmlns:a16="http://schemas.microsoft.com/office/drawing/2014/main" id="{0A11457D-1C9A-4B5F-96EB-1F4FB101D392}"/>
               </a:ext>
             </a:extLst>
           </p:cNvPr>
@@ -7480,7 +6459,7 @@
           <p:cNvPr id="12" name="">
             <a:extLst xmlns:a="http://schemas.openxmlformats.org/drawingml/2006/main">
               <a:ext uri="{FF2B5EF4-FFF2-40B4-BE49-F238E27FC236}">
-                <a16:creationId xmlns:a16="http://schemas.microsoft.com/office/drawing/2014/main" id="{268FFA50-31C1-40A3-8C92-0B995F5CE0CE}"/>
+                <a16:creationId xmlns:a16="http://schemas.microsoft.com/office/drawing/2014/main" id="{45123D2E-16F3-46CB-89A8-9BEF07410FF1}"/>
               </a:ext>
             </a:extLst>
           </p:cNvPr>
@@ -7515,7 +6494,7 @@
           <p:cNvPr id="13" name="">
             <a:extLst xmlns:a="http://schemas.openxmlformats.org/drawingml/2006/main">
               <a:ext uri="{FF2B5EF4-FFF2-40B4-BE49-F238E27FC236}">
-                <a16:creationId xmlns:a16="http://schemas.microsoft.com/office/drawing/2014/main" id="{AF86E3E3-11C7-41E1-A9FF-00C2AD55BAFF}"/>
+                <a16:creationId xmlns:a16="http://schemas.microsoft.com/office/drawing/2014/main" id="{138EC3F0-85B9-439D-9B72-0C8FEA314104}"/>
               </a:ext>
             </a:extLst>
           </p:cNvPr>
@@ -7582,7 +6561,7 @@
           <p:cNvPr id="14" name="">
             <a:extLst xmlns:a="http://schemas.openxmlformats.org/drawingml/2006/main">
               <a:ext uri="{FF2B5EF4-FFF2-40B4-BE49-F238E27FC236}">
-                <a16:creationId xmlns:a16="http://schemas.microsoft.com/office/drawing/2014/main" id="{D0BA1036-B8C6-4767-B710-F1BBB980F267}"/>
+                <a16:creationId xmlns:a16="http://schemas.microsoft.com/office/drawing/2014/main" id="{6B294024-E17D-48BE-A71C-850663A7A560}"/>
               </a:ext>
             </a:extLst>
           </p:cNvPr>
@@ -7632,7 +6611,7 @@
           <p:cNvPr id="15" name="">
             <a:extLst xmlns:a="http://schemas.openxmlformats.org/drawingml/2006/main">
               <a:ext uri="{FF2B5EF4-FFF2-40B4-BE49-F238E27FC236}">
-                <a16:creationId xmlns:a16="http://schemas.microsoft.com/office/drawing/2014/main" id="{4ACC93DD-B8DF-4914-B627-F3D4D0CD4FFA}"/>
+                <a16:creationId xmlns:a16="http://schemas.microsoft.com/office/drawing/2014/main" id="{7BCE3C3B-4971-4BB7-BD21-53CDF3FD3E81}"/>
               </a:ext>
             </a:extLst>
           </p:cNvPr>
@@ -7682,7 +6661,7 @@
           <p:cNvPr id="16" name="">
             <a:extLst xmlns:a="http://schemas.openxmlformats.org/drawingml/2006/main">
               <a:ext uri="{FF2B5EF4-FFF2-40B4-BE49-F238E27FC236}">
-                <a16:creationId xmlns:a16="http://schemas.microsoft.com/office/drawing/2014/main" id="{3B9EDF85-5D83-424A-960F-B2D793EF8EA4}"/>
+                <a16:creationId xmlns:a16="http://schemas.microsoft.com/office/drawing/2014/main" id="{CC82C95E-4814-46D0-BB6F-06DFA2BCB605}"/>
               </a:ext>
             </a:extLst>
           </p:cNvPr>
@@ -7732,7 +6711,7 @@
           <p:cNvPr id="17" name="">
             <a:extLst xmlns:a="http://schemas.openxmlformats.org/drawingml/2006/main">
               <a:ext uri="{FF2B5EF4-FFF2-40B4-BE49-F238E27FC236}">
-                <a16:creationId xmlns:a16="http://schemas.microsoft.com/office/drawing/2014/main" id="{C59F22D1-9137-43DC-9200-1AE4145E96D7}"/>
+                <a16:creationId xmlns:a16="http://schemas.microsoft.com/office/drawing/2014/main" id="{E2F65A74-33BA-471C-A26C-D12F415FA817}"/>
               </a:ext>
             </a:extLst>
           </p:cNvPr>
@@ -7782,7 +6761,7 @@
           <p:cNvPr id="18" name="">
             <a:extLst xmlns:a="http://schemas.openxmlformats.org/drawingml/2006/main">
               <a:ext uri="{FF2B5EF4-FFF2-40B4-BE49-F238E27FC236}">
-                <a16:creationId xmlns:a16="http://schemas.microsoft.com/office/drawing/2014/main" id="{433AADAD-D5F9-4EA1-8B39-8B1F7C47E2BA}"/>
+                <a16:creationId xmlns:a16="http://schemas.microsoft.com/office/drawing/2014/main" id="{4A68D147-703E-4637-AC5F-C9C0656F5DE3}"/>
               </a:ext>
             </a:extLst>
           </p:cNvPr>
@@ -7832,7 +6811,7 @@
           <p:cNvPr id="19" name="">
             <a:extLst xmlns:a="http://schemas.openxmlformats.org/drawingml/2006/main">
               <a:ext uri="{FF2B5EF4-FFF2-40B4-BE49-F238E27FC236}">
-                <a16:creationId xmlns:a16="http://schemas.microsoft.com/office/drawing/2014/main" id="{3B93C9A2-D2F6-4CB3-8FC4-6904602EA6BA}"/>
+                <a16:creationId xmlns:a16="http://schemas.microsoft.com/office/drawing/2014/main" id="{E74A9A7A-F300-4F31-97EB-257E8CFC3F03}"/>
               </a:ext>
             </a:extLst>
           </p:cNvPr>
@@ -7882,7 +6861,7 @@
           <p:cNvPr id="20" name="">
             <a:extLst xmlns:a="http://schemas.openxmlformats.org/drawingml/2006/main">
               <a:ext uri="{FF2B5EF4-FFF2-40B4-BE49-F238E27FC236}">
-                <a16:creationId xmlns:a16="http://schemas.microsoft.com/office/drawing/2014/main" id="{6872D377-1DB9-4B96-BAA5-7B07590C6AF7}"/>
+                <a16:creationId xmlns:a16="http://schemas.microsoft.com/office/drawing/2014/main" id="{931EF4F4-01E2-4DAF-AB06-4C753BF5C5D8}"/>
               </a:ext>
             </a:extLst>
           </p:cNvPr>
@@ -7932,7 +6911,7 @@
           <p:cNvPr id="21" name="">
             <a:extLst xmlns:a="http://schemas.openxmlformats.org/drawingml/2006/main">
               <a:ext uri="{FF2B5EF4-FFF2-40B4-BE49-F238E27FC236}">
-                <a16:creationId xmlns:a16="http://schemas.microsoft.com/office/drawing/2014/main" id="{45F6FF87-08F6-4483-B464-35BC1D98FBA7}"/>
+                <a16:creationId xmlns:a16="http://schemas.microsoft.com/office/drawing/2014/main" id="{F85F8079-4B4D-40CA-93B3-5733C0B9FA1E}"/>
               </a:ext>
             </a:extLst>
           </p:cNvPr>
@@ -7980,7 +6959,7 @@
     </p:spTree>
     <p:extLst>
       <p:ext uri="{BB962C8B-B14F-4D97-AF65-F5344CB8AC3E}">
-        <p14:creationId xmlns:p14="http://schemas.microsoft.com/office/powerpoint/2010/main" val="337880034"/>
+        <p14:creationId xmlns:p14="http://schemas.microsoft.com/office/powerpoint/2010/main" val="1302581043"/>
       </p:ext>
     </p:extLst>
   </p:cSld>
@@ -8011,7 +6990,7 @@
           <p:cNvPr id="15" name="">
             <a:extLst xmlns:a="http://schemas.openxmlformats.org/drawingml/2006/main">
               <a:ext uri="{FF2B5EF4-FFF2-40B4-BE49-F238E27FC236}">
-                <a16:creationId xmlns:a16="http://schemas.microsoft.com/office/drawing/2014/main" id="{09A504ED-D1F0-4BCF-AAD4-3E2433BAEC4D}"/>
+                <a16:creationId xmlns:a16="http://schemas.microsoft.com/office/drawing/2014/main" id="{79602FB3-19F6-4E32-B98E-A1D9E0BA98A7}"/>
               </a:ext>
             </a:extLst>
           </p:cNvPr>
@@ -8061,7 +7040,7 @@
           <p:cNvPr id="2" name="">
             <a:extLst xmlns:a="http://schemas.openxmlformats.org/drawingml/2006/main">
               <a:ext uri="{FF2B5EF4-FFF2-40B4-BE49-F238E27FC236}">
-                <a16:creationId xmlns:a16="http://schemas.microsoft.com/office/drawing/2014/main" id="{68B2278D-3BC7-4413-B38F-F10586ED9345}"/>
+                <a16:creationId xmlns:a16="http://schemas.microsoft.com/office/drawing/2014/main" id="{D7556F94-9E43-4C0F-9C5A-5D6B37C6DFB7}"/>
               </a:ext>
             </a:extLst>
           </p:cNvPr>
@@ -8111,7 +7090,7 @@
           <p:cNvPr id="3" name="">
             <a:extLst xmlns:a="http://schemas.openxmlformats.org/drawingml/2006/main">
               <a:ext uri="{FF2B5EF4-FFF2-40B4-BE49-F238E27FC236}">
-                <a16:creationId xmlns:a16="http://schemas.microsoft.com/office/drawing/2014/main" id="{0785AB17-1DF2-4113-90B6-C9E7F1307098}"/>
+                <a16:creationId xmlns:a16="http://schemas.microsoft.com/office/drawing/2014/main" id="{09BDFCE1-A0DE-4214-99F7-B73FC2AAFE31}"/>
               </a:ext>
             </a:extLst>
           </p:cNvPr>
@@ -8161,7 +7140,7 @@
           <p:cNvPr id="4" name="">
             <a:extLst xmlns:a="http://schemas.openxmlformats.org/drawingml/2006/main">
               <a:ext uri="{FF2B5EF4-FFF2-40B4-BE49-F238E27FC236}">
-                <a16:creationId xmlns:a16="http://schemas.microsoft.com/office/drawing/2014/main" id="{E432BAD8-991A-44ED-9DA3-2457524271A3}"/>
+                <a16:creationId xmlns:a16="http://schemas.microsoft.com/office/drawing/2014/main" id="{19F8B51E-1714-42B6-9EBB-7DDF11681CAC}"/>
               </a:ext>
             </a:extLst>
           </p:cNvPr>
@@ -8211,7 +7190,7 @@
           <p:cNvPr id="5" name="">
             <a:extLst xmlns:a="http://schemas.openxmlformats.org/drawingml/2006/main">
               <a:ext uri="{FF2B5EF4-FFF2-40B4-BE49-F238E27FC236}">
-                <a16:creationId xmlns:a16="http://schemas.microsoft.com/office/drawing/2014/main" id="{A9BFD9E2-0872-4DFA-ADDF-E50B1B7A7EAE}"/>
+                <a16:creationId xmlns:a16="http://schemas.microsoft.com/office/drawing/2014/main" id="{DFBE21A4-6EDD-40E9-80F6-C3E24D50F9D8}"/>
               </a:ext>
             </a:extLst>
           </p:cNvPr>
@@ -8261,7 +7240,7 @@
           <p:cNvPr id="6" name="">
             <a:extLst xmlns:a="http://schemas.openxmlformats.org/drawingml/2006/main">
               <a:ext uri="{FF2B5EF4-FFF2-40B4-BE49-F238E27FC236}">
-                <a16:creationId xmlns:a16="http://schemas.microsoft.com/office/drawing/2014/main" id="{459E9D6B-371A-4ACF-9A21-4E0323D4F274}"/>
+                <a16:creationId xmlns:a16="http://schemas.microsoft.com/office/drawing/2014/main" id="{5B269D25-3E5D-4D04-AF67-1460883832E0}"/>
               </a:ext>
             </a:extLst>
           </p:cNvPr>
@@ -8311,7 +7290,7 @@
           <p:cNvPr id="7" name="">
             <a:extLst xmlns:a="http://schemas.openxmlformats.org/drawingml/2006/main">
               <a:ext uri="{FF2B5EF4-FFF2-40B4-BE49-F238E27FC236}">
-                <a16:creationId xmlns:a16="http://schemas.microsoft.com/office/drawing/2014/main" id="{82D8BDE3-CC5B-410A-88B7-403020489D38}"/>
+                <a16:creationId xmlns:a16="http://schemas.microsoft.com/office/drawing/2014/main" id="{528310A9-45D1-4AD1-A3B5-92FB1F5ECA01}"/>
               </a:ext>
             </a:extLst>
           </p:cNvPr>
@@ -8361,7 +7340,7 @@
           <p:cNvPr id="8" name="">
             <a:extLst xmlns:a="http://schemas.openxmlformats.org/drawingml/2006/main">
               <a:ext uri="{FF2B5EF4-FFF2-40B4-BE49-F238E27FC236}">
-                <a16:creationId xmlns:a16="http://schemas.microsoft.com/office/drawing/2014/main" id="{F166C464-1515-4A80-9E7E-5203316C4B94}"/>
+                <a16:creationId xmlns:a16="http://schemas.microsoft.com/office/drawing/2014/main" id="{AE85884D-6F56-426C-8EE9-798EA0CD5293}"/>
               </a:ext>
             </a:extLst>
           </p:cNvPr>
@@ -8411,7 +7390,7 @@
           <p:cNvPr id="9" name="">
             <a:extLst xmlns:a="http://schemas.openxmlformats.org/drawingml/2006/main">
               <a:ext uri="{FF2B5EF4-FFF2-40B4-BE49-F238E27FC236}">
-                <a16:creationId xmlns:a16="http://schemas.microsoft.com/office/drawing/2014/main" id="{6DE31DEF-8F63-49CB-8455-C14319ACE546}"/>
+                <a16:creationId xmlns:a16="http://schemas.microsoft.com/office/drawing/2014/main" id="{403A50A0-6F3A-451C-A412-18896299D078}"/>
               </a:ext>
             </a:extLst>
           </p:cNvPr>
@@ -8461,7 +7440,7 @@
           <p:cNvPr id="10" name="">
             <a:extLst xmlns:a="http://schemas.openxmlformats.org/drawingml/2006/main">
               <a:ext uri="{FF2B5EF4-FFF2-40B4-BE49-F238E27FC236}">
-                <a16:creationId xmlns:a16="http://schemas.microsoft.com/office/drawing/2014/main" id="{C4677FBF-2706-4758-83AB-7306E4790457}"/>
+                <a16:creationId xmlns:a16="http://schemas.microsoft.com/office/drawing/2014/main" id="{2DFDE137-9658-4239-913D-3C1B62B790AF}"/>
               </a:ext>
             </a:extLst>
           </p:cNvPr>
@@ -8511,7 +7490,7 @@
           <p:cNvPr id="11" name="">
             <a:extLst xmlns:a="http://schemas.openxmlformats.org/drawingml/2006/main">
               <a:ext uri="{FF2B5EF4-FFF2-40B4-BE49-F238E27FC236}">
-                <a16:creationId xmlns:a16="http://schemas.microsoft.com/office/drawing/2014/main" id="{2354027A-D097-4DA0-BDDF-23100CD5061A}"/>
+                <a16:creationId xmlns:a16="http://schemas.microsoft.com/office/drawing/2014/main" id="{2AF7C44A-E089-4380-B706-A2191DDA7CC4}"/>
               </a:ext>
             </a:extLst>
           </p:cNvPr>
@@ -8542,7 +7521,7 @@
           <p:cNvPr id="12" name="">
             <a:extLst xmlns:a="http://schemas.openxmlformats.org/drawingml/2006/main">
               <a:ext uri="{FF2B5EF4-FFF2-40B4-BE49-F238E27FC236}">
-                <a16:creationId xmlns:a16="http://schemas.microsoft.com/office/drawing/2014/main" id="{96B9E938-6151-4C16-993D-80075D6C130C}"/>
+                <a16:creationId xmlns:a16="http://schemas.microsoft.com/office/drawing/2014/main" id="{5F1369A4-A693-406E-8690-616C886FEA22}"/>
               </a:ext>
             </a:extLst>
           </p:cNvPr>
@@ -8592,7 +7571,7 @@
           <p:cNvPr id="13" name="">
             <a:extLst xmlns:a="http://schemas.openxmlformats.org/drawingml/2006/main">
               <a:ext uri="{FF2B5EF4-FFF2-40B4-BE49-F238E27FC236}">
-                <a16:creationId xmlns:a16="http://schemas.microsoft.com/office/drawing/2014/main" id="{C4E9F532-5FC9-483D-A0A8-0A691F375FB1}"/>
+                <a16:creationId xmlns:a16="http://schemas.microsoft.com/office/drawing/2014/main" id="{54FF001E-154C-4FDC-9A26-58272C0F4785}"/>
               </a:ext>
             </a:extLst>
           </p:cNvPr>
@@ -8642,7 +7621,7 @@
           <p:cNvPr id="14" name="">
             <a:extLst xmlns:a="http://schemas.openxmlformats.org/drawingml/2006/main">
               <a:ext uri="{FF2B5EF4-FFF2-40B4-BE49-F238E27FC236}">
-                <a16:creationId xmlns:a16="http://schemas.microsoft.com/office/drawing/2014/main" id="{A9C268DE-EF80-462C-A3B1-9ADF1D5B714E}"/>
+                <a16:creationId xmlns:a16="http://schemas.microsoft.com/office/drawing/2014/main" id="{632D79FC-1D1C-4608-A194-D6DFDBF2DD8E}"/>
               </a:ext>
             </a:extLst>
           </p:cNvPr>
@@ -8690,7 +7669,7 @@
     </p:spTree>
     <p:extLst>
       <p:ext uri="{BB962C8B-B14F-4D97-AF65-F5344CB8AC3E}">
-        <p14:creationId xmlns:p14="http://schemas.microsoft.com/office/powerpoint/2010/main" val="843098074"/>
+        <p14:creationId xmlns:p14="http://schemas.microsoft.com/office/powerpoint/2010/main" val="2079089837"/>
       </p:ext>
     </p:extLst>
   </p:cSld>
@@ -8721,7 +7700,7 @@
           <p:cNvPr id="7" name="">
             <a:extLst xmlns:a="http://schemas.openxmlformats.org/drawingml/2006/main">
               <a:ext uri="{FF2B5EF4-FFF2-40B4-BE49-F238E27FC236}">
-                <a16:creationId xmlns:a16="http://schemas.microsoft.com/office/drawing/2014/main" id="{F6EB642C-5B29-40CF-91F5-8791F9E735E5}"/>
+                <a16:creationId xmlns:a16="http://schemas.microsoft.com/office/drawing/2014/main" id="{26743AEB-9A7E-469F-89C5-FBF353603AF5}"/>
               </a:ext>
             </a:extLst>
           </p:cNvPr>
@@ -8771,7 +7750,7 @@
           <p:cNvPr id="2" name="">
             <a:extLst xmlns:a="http://schemas.openxmlformats.org/drawingml/2006/main">
               <a:ext uri="{FF2B5EF4-FFF2-40B4-BE49-F238E27FC236}">
-                <a16:creationId xmlns:a16="http://schemas.microsoft.com/office/drawing/2014/main" id="{3989FB80-91BE-49E4-B8D2-9F52CB063719}"/>
+                <a16:creationId xmlns:a16="http://schemas.microsoft.com/office/drawing/2014/main" id="{3570B6B9-0AE0-4999-8C5A-7E0439CB1F24}"/>
               </a:ext>
             </a:extLst>
           </p:cNvPr>
@@ -8825,7 +7804,7 @@
           <p:nvPr/>
         </p:nvPicPr>
         <p:blipFill>
-          <a:blip xmlns:r="http://schemas.openxmlformats.org/officeDocument/2006/relationships" xmlns:a="http://schemas.openxmlformats.org/drawingml/2006/main" r:embed="Rd1675278ea7a4416"/>
+          <a:blip xmlns:r="http://schemas.openxmlformats.org/officeDocument/2006/relationships" xmlns:a="http://schemas.openxmlformats.org/drawingml/2006/main" r:embed="R03398cad322343bb"/>
           <a:stretch xmlns:a="http://schemas.openxmlformats.org/drawingml/2006/main"/>
         </p:blipFill>
         <p:spPr>
@@ -8843,7 +7822,7 @@
           <p:cNvPr id="4" name="">
             <a:extLst xmlns:a="http://schemas.openxmlformats.org/drawingml/2006/main">
               <a:ext uri="{FF2B5EF4-FFF2-40B4-BE49-F238E27FC236}">
-                <a16:creationId xmlns:a16="http://schemas.microsoft.com/office/drawing/2014/main" id="{73D9F1E0-4CDF-4EC7-BD83-D07F50E0B7F4}"/>
+                <a16:creationId xmlns:a16="http://schemas.microsoft.com/office/drawing/2014/main" id="{3ED940DF-D65F-4087-A1C9-D65A50DE7C4A}"/>
               </a:ext>
             </a:extLst>
           </p:cNvPr>
@@ -8893,7 +7872,7 @@
           <p:cNvPr id="5" name="">
             <a:extLst xmlns:a="http://schemas.openxmlformats.org/drawingml/2006/main">
               <a:ext uri="{FF2B5EF4-FFF2-40B4-BE49-F238E27FC236}">
-                <a16:creationId xmlns:a16="http://schemas.microsoft.com/office/drawing/2014/main" id="{4ED53949-7F52-4E29-B9F0-42C42A3FC374}"/>
+                <a16:creationId xmlns:a16="http://schemas.microsoft.com/office/drawing/2014/main" id="{B778906D-D0CB-465D-9F03-E8C4DFCF0AEC}"/>
               </a:ext>
             </a:extLst>
           </p:cNvPr>
@@ -8943,7 +7922,7 @@
           <p:cNvPr id="6" name="">
             <a:extLst xmlns:a="http://schemas.openxmlformats.org/drawingml/2006/main">
               <a:ext uri="{FF2B5EF4-FFF2-40B4-BE49-F238E27FC236}">
-                <a16:creationId xmlns:a16="http://schemas.microsoft.com/office/drawing/2014/main" id="{883CD310-6664-44B5-8937-5E779FDB9C15}"/>
+                <a16:creationId xmlns:a16="http://schemas.microsoft.com/office/drawing/2014/main" id="{AC803546-A1C5-485E-922E-D66550EF21EE}"/>
               </a:ext>
             </a:extLst>
           </p:cNvPr>
@@ -8991,7 +7970,7 @@
     </p:spTree>
     <p:extLst>
       <p:ext uri="{BB962C8B-B14F-4D97-AF65-F5344CB8AC3E}">
-        <p14:creationId xmlns:p14="http://schemas.microsoft.com/office/powerpoint/2010/main" val="910095904"/>
+        <p14:creationId xmlns:p14="http://schemas.microsoft.com/office/powerpoint/2010/main" val="1110477544"/>
       </p:ext>
     </p:extLst>
   </p:cSld>
@@ -9022,7 +8001,7 @@
           <p:cNvPr id="11" name="">
             <a:extLst xmlns:a="http://schemas.openxmlformats.org/drawingml/2006/main">
               <a:ext uri="{FF2B5EF4-FFF2-40B4-BE49-F238E27FC236}">
-                <a16:creationId xmlns:a16="http://schemas.microsoft.com/office/drawing/2014/main" id="{45DEDB76-9A0B-45B9-8BC7-92B842B99444}"/>
+                <a16:creationId xmlns:a16="http://schemas.microsoft.com/office/drawing/2014/main" id="{88ABBCBB-4814-4CEF-A3A6-B9450AA22B42}"/>
               </a:ext>
             </a:extLst>
           </p:cNvPr>
@@ -9072,7 +8051,7 @@
           <p:cNvPr id="2" name="">
             <a:extLst xmlns:a="http://schemas.openxmlformats.org/drawingml/2006/main">
               <a:ext uri="{FF2B5EF4-FFF2-40B4-BE49-F238E27FC236}">
-                <a16:creationId xmlns:a16="http://schemas.microsoft.com/office/drawing/2014/main" id="{7B312CE4-0653-4CC1-A011-C38E24005B80}"/>
+                <a16:creationId xmlns:a16="http://schemas.microsoft.com/office/drawing/2014/main" id="{B91841CD-EC97-44C4-919C-62076185024B}"/>
               </a:ext>
             </a:extLst>
           </p:cNvPr>
@@ -9126,7 +8105,7 @@
           <p:nvPr/>
         </p:nvPicPr>
         <p:blipFill>
-          <a:blip xmlns:r="http://schemas.openxmlformats.org/officeDocument/2006/relationships" xmlns:a="http://schemas.openxmlformats.org/drawingml/2006/main" r:embed="R7d62aa19976848e3"/>
+          <a:blip xmlns:r="http://schemas.openxmlformats.org/officeDocument/2006/relationships" xmlns:a="http://schemas.openxmlformats.org/drawingml/2006/main" r:embed="R87c2d830d1a44fa8"/>
           <a:stretch xmlns:a="http://schemas.openxmlformats.org/drawingml/2006/main"/>
         </p:blipFill>
         <p:spPr>
@@ -9144,7 +8123,7 @@
           <p:cNvPr id="4" name="">
             <a:extLst xmlns:a="http://schemas.openxmlformats.org/drawingml/2006/main">
               <a:ext uri="{FF2B5EF4-FFF2-40B4-BE49-F238E27FC236}">
-                <a16:creationId xmlns:a16="http://schemas.microsoft.com/office/drawing/2014/main" id="{B77D43B4-1A83-4397-B653-ED6B82C973E0}"/>
+                <a16:creationId xmlns:a16="http://schemas.microsoft.com/office/drawing/2014/main" id="{8600001A-CF78-485B-A09F-C3F566273B70}"/>
               </a:ext>
             </a:extLst>
           </p:cNvPr>
@@ -9194,7 +8173,7 @@
           <p:cNvPr id="5" name="">
             <a:extLst xmlns:a="http://schemas.openxmlformats.org/drawingml/2006/main">
               <a:ext uri="{FF2B5EF4-FFF2-40B4-BE49-F238E27FC236}">
-                <a16:creationId xmlns:a16="http://schemas.microsoft.com/office/drawing/2014/main" id="{61F16353-F6C2-4940-9355-2E598FAF0EA8}"/>
+                <a16:creationId xmlns:a16="http://schemas.microsoft.com/office/drawing/2014/main" id="{64B0B5A8-E70A-4335-AA47-F16118BDA9E4}"/>
               </a:ext>
             </a:extLst>
           </p:cNvPr>
@@ -9244,7 +8223,7 @@
           <p:cNvPr id="6" name="">
             <a:extLst xmlns:a="http://schemas.openxmlformats.org/drawingml/2006/main">
               <a:ext uri="{FF2B5EF4-FFF2-40B4-BE49-F238E27FC236}">
-                <a16:creationId xmlns:a16="http://schemas.microsoft.com/office/drawing/2014/main" id="{7869CA2A-555D-433E-8A14-ADE2ABB3D093}"/>
+                <a16:creationId xmlns:a16="http://schemas.microsoft.com/office/drawing/2014/main" id="{23E74176-2669-449B-BB38-8E7D1B88FBCE}"/>
               </a:ext>
             </a:extLst>
           </p:cNvPr>
@@ -9294,7 +8273,7 @@
           <p:cNvPr id="7" name="">
             <a:extLst xmlns:a="http://schemas.openxmlformats.org/drawingml/2006/main">
               <a:ext uri="{FF2B5EF4-FFF2-40B4-BE49-F238E27FC236}">
-                <a16:creationId xmlns:a16="http://schemas.microsoft.com/office/drawing/2014/main" id="{1E778660-C82E-476E-8143-BA4F27F2B49C}"/>
+                <a16:creationId xmlns:a16="http://schemas.microsoft.com/office/drawing/2014/main" id="{7E758037-1C1B-4577-9E57-C468AF046CD0}"/>
               </a:ext>
             </a:extLst>
           </p:cNvPr>
@@ -9344,7 +8323,7 @@
           <p:cNvPr id="8" name="">
             <a:extLst xmlns:a="http://schemas.openxmlformats.org/drawingml/2006/main">
               <a:ext uri="{FF2B5EF4-FFF2-40B4-BE49-F238E27FC236}">
-                <a16:creationId xmlns:a16="http://schemas.microsoft.com/office/drawing/2014/main" id="{7FF06F40-DCFB-4687-B1AA-A347499496AF}"/>
+                <a16:creationId xmlns:a16="http://schemas.microsoft.com/office/drawing/2014/main" id="{FC5E5F24-6A8E-4DF5-9EC9-6B75889E37F1}"/>
               </a:ext>
             </a:extLst>
           </p:cNvPr>
@@ -9394,7 +8373,7 @@
           <p:cNvPr id="9" name="">
             <a:extLst xmlns:a="http://schemas.openxmlformats.org/drawingml/2006/main">
               <a:ext uri="{FF2B5EF4-FFF2-40B4-BE49-F238E27FC236}">
-                <a16:creationId xmlns:a16="http://schemas.microsoft.com/office/drawing/2014/main" id="{24A5E46C-95D7-49ED-93F4-9DD6C4E0640F}"/>
+                <a16:creationId xmlns:a16="http://schemas.microsoft.com/office/drawing/2014/main" id="{398B5DAF-0AD4-472E-9BD9-D58908EF7667}"/>
               </a:ext>
             </a:extLst>
           </p:cNvPr>
@@ -9444,7 +8423,7 @@
           <p:cNvPr id="10" name="">
             <a:extLst xmlns:a="http://schemas.openxmlformats.org/drawingml/2006/main">
               <a:ext uri="{FF2B5EF4-FFF2-40B4-BE49-F238E27FC236}">
-                <a16:creationId xmlns:a16="http://schemas.microsoft.com/office/drawing/2014/main" id="{3828E3EF-5D5C-4C46-BCFA-0E96C935ECF9}"/>
+                <a16:creationId xmlns:a16="http://schemas.microsoft.com/office/drawing/2014/main" id="{EF8B686E-92F2-44F4-864C-36D801EFCF09}"/>
               </a:ext>
             </a:extLst>
           </p:cNvPr>
@@ -9492,7 +8471,7 @@
     </p:spTree>
     <p:extLst>
       <p:ext uri="{BB962C8B-B14F-4D97-AF65-F5344CB8AC3E}">
-        <p14:creationId xmlns:p14="http://schemas.microsoft.com/office/powerpoint/2010/main" val="1079977351"/>
+        <p14:creationId xmlns:p14="http://schemas.microsoft.com/office/powerpoint/2010/main" val="2019135362"/>
       </p:ext>
     </p:extLst>
   </p:cSld>
@@ -9523,7 +8502,7 @@
           <p:cNvPr id="13" name="">
             <a:extLst xmlns:a="http://schemas.openxmlformats.org/drawingml/2006/main">
               <a:ext uri="{FF2B5EF4-FFF2-40B4-BE49-F238E27FC236}">
-                <a16:creationId xmlns:a16="http://schemas.microsoft.com/office/drawing/2014/main" id="{420A89CC-69AD-497C-AF8D-FA5079C6EE06}"/>
+                <a16:creationId xmlns:a16="http://schemas.microsoft.com/office/drawing/2014/main" id="{6E83292B-0B01-46F3-A76F-0ECDC5E6329E}"/>
               </a:ext>
             </a:extLst>
           </p:cNvPr>
@@ -9573,7 +8552,7 @@
           <p:cNvPr id="2" name="">
             <a:extLst xmlns:a="http://schemas.openxmlformats.org/drawingml/2006/main">
               <a:ext uri="{FF2B5EF4-FFF2-40B4-BE49-F238E27FC236}">
-                <a16:creationId xmlns:a16="http://schemas.microsoft.com/office/drawing/2014/main" id="{E469EF6B-D2DB-433F-B7D1-59EE7517313E}"/>
+                <a16:creationId xmlns:a16="http://schemas.microsoft.com/office/drawing/2014/main" id="{7754D688-5339-430E-AA96-C54C58D83C38}"/>
               </a:ext>
             </a:extLst>
           </p:cNvPr>
@@ -9627,7 +8606,7 @@
           <p:nvPr/>
         </p:nvPicPr>
         <p:blipFill>
-          <a:blip xmlns:r="http://schemas.openxmlformats.org/officeDocument/2006/relationships" xmlns:a="http://schemas.openxmlformats.org/drawingml/2006/main" r:embed="Rffc454e21491477a"/>
+          <a:blip xmlns:r="http://schemas.openxmlformats.org/officeDocument/2006/relationships" xmlns:a="http://schemas.openxmlformats.org/drawingml/2006/main" r:embed="Rd228ce6e9bb1404b"/>
           <a:stretch xmlns:a="http://schemas.openxmlformats.org/drawingml/2006/main"/>
         </p:blipFill>
         <p:spPr>
@@ -9645,7 +8624,7 @@
           <p:cNvPr id="4" name="">
             <a:extLst xmlns:a="http://schemas.openxmlformats.org/drawingml/2006/main">
               <a:ext uri="{FF2B5EF4-FFF2-40B4-BE49-F238E27FC236}">
-                <a16:creationId xmlns:a16="http://schemas.microsoft.com/office/drawing/2014/main" id="{5822D81E-5978-483F-BB48-2944842FD18F}"/>
+                <a16:creationId xmlns:a16="http://schemas.microsoft.com/office/drawing/2014/main" id="{9D4344C6-5ED8-4FBD-938A-BAC0603D8AF2}"/>
               </a:ext>
             </a:extLst>
           </p:cNvPr>
@@ -9695,7 +8674,7 @@
           <p:cNvPr id="5" name="">
             <a:extLst xmlns:a="http://schemas.openxmlformats.org/drawingml/2006/main">
               <a:ext uri="{FF2B5EF4-FFF2-40B4-BE49-F238E27FC236}">
-                <a16:creationId xmlns:a16="http://schemas.microsoft.com/office/drawing/2014/main" id="{F296E73F-2FC1-4D37-828C-0165FB21803F}"/>
+                <a16:creationId xmlns:a16="http://schemas.microsoft.com/office/drawing/2014/main" id="{009C32C1-6DE0-439E-9479-48886417E459}"/>
               </a:ext>
             </a:extLst>
           </p:cNvPr>
@@ -9745,7 +8724,7 @@
           <p:cNvPr id="6" name="">
             <a:extLst xmlns:a="http://schemas.openxmlformats.org/drawingml/2006/main">
               <a:ext uri="{FF2B5EF4-FFF2-40B4-BE49-F238E27FC236}">
-                <a16:creationId xmlns:a16="http://schemas.microsoft.com/office/drawing/2014/main" id="{77C01BB6-9C5E-4401-95D9-864684348BA0}"/>
+                <a16:creationId xmlns:a16="http://schemas.microsoft.com/office/drawing/2014/main" id="{4DA370AC-4C17-4451-8A4F-988FD5B33221}"/>
               </a:ext>
             </a:extLst>
           </p:cNvPr>
@@ -9795,7 +8774,7 @@
           <p:cNvPr id="7" name="">
             <a:extLst xmlns:a="http://schemas.openxmlformats.org/drawingml/2006/main">
               <a:ext uri="{FF2B5EF4-FFF2-40B4-BE49-F238E27FC236}">
-                <a16:creationId xmlns:a16="http://schemas.microsoft.com/office/drawing/2014/main" id="{50724CF8-DC14-4C4E-87A1-94E2FC01C63B}"/>
+                <a16:creationId xmlns:a16="http://schemas.microsoft.com/office/drawing/2014/main" id="{FE6021CB-FA97-4961-82BD-25FA9C5A8F58}"/>
               </a:ext>
             </a:extLst>
           </p:cNvPr>
@@ -9845,7 +8824,7 @@
           <p:cNvPr id="8" name="">
             <a:extLst xmlns:a="http://schemas.openxmlformats.org/drawingml/2006/main">
               <a:ext uri="{FF2B5EF4-FFF2-40B4-BE49-F238E27FC236}">
-                <a16:creationId xmlns:a16="http://schemas.microsoft.com/office/drawing/2014/main" id="{BC8BB289-4DDE-46E7-8352-B627B59EDE62}"/>
+                <a16:creationId xmlns:a16="http://schemas.microsoft.com/office/drawing/2014/main" id="{AB8BC059-BA36-4134-B61A-17FFFC7BDCD1}"/>
               </a:ext>
             </a:extLst>
           </p:cNvPr>
@@ -9895,7 +8874,7 @@
           <p:cNvPr id="9" name="">
             <a:extLst xmlns:a="http://schemas.openxmlformats.org/drawingml/2006/main">
               <a:ext uri="{FF2B5EF4-FFF2-40B4-BE49-F238E27FC236}">
-                <a16:creationId xmlns:a16="http://schemas.microsoft.com/office/drawing/2014/main" id="{BB975225-ED79-4E81-A012-E44E2FE233AA}"/>
+                <a16:creationId xmlns:a16="http://schemas.microsoft.com/office/drawing/2014/main" id="{9554BC66-6BF2-4F61-989A-D1169EC6FEE9}"/>
               </a:ext>
             </a:extLst>
           </p:cNvPr>
@@ -9945,7 +8924,7 @@
           <p:cNvPr id="10" name="">
             <a:extLst xmlns:a="http://schemas.openxmlformats.org/drawingml/2006/main">
               <a:ext uri="{FF2B5EF4-FFF2-40B4-BE49-F238E27FC236}">
-                <a16:creationId xmlns:a16="http://schemas.microsoft.com/office/drawing/2014/main" id="{C938E1E5-7678-4BE5-AFF4-5E9D406E2010}"/>
+                <a16:creationId xmlns:a16="http://schemas.microsoft.com/office/drawing/2014/main" id="{9614F956-0C27-4FC3-B76B-84EBA31EBB35}"/>
               </a:ext>
             </a:extLst>
           </p:cNvPr>
@@ -9995,7 +8974,7 @@
           <p:cNvPr id="11" name="">
             <a:extLst xmlns:a="http://schemas.openxmlformats.org/drawingml/2006/main">
               <a:ext uri="{FF2B5EF4-FFF2-40B4-BE49-F238E27FC236}">
-                <a16:creationId xmlns:a16="http://schemas.microsoft.com/office/drawing/2014/main" id="{844740DF-B636-460D-97C1-AD4E8E63F06A}"/>
+                <a16:creationId xmlns:a16="http://schemas.microsoft.com/office/drawing/2014/main" id="{40156F5A-55F3-4497-9472-E4A56C93380E}"/>
               </a:ext>
             </a:extLst>
           </p:cNvPr>
@@ -10045,7 +9024,7 @@
           <p:cNvPr id="12" name="">
             <a:extLst xmlns:a="http://schemas.openxmlformats.org/drawingml/2006/main">
               <a:ext uri="{FF2B5EF4-FFF2-40B4-BE49-F238E27FC236}">
-                <a16:creationId xmlns:a16="http://schemas.microsoft.com/office/drawing/2014/main" id="{1F1A2E76-8942-4151-BF81-4A93E85AFEEF}"/>
+                <a16:creationId xmlns:a16="http://schemas.microsoft.com/office/drawing/2014/main" id="{9DE791F6-22B9-4448-AA9F-1DAA91072499}"/>
               </a:ext>
             </a:extLst>
           </p:cNvPr>
@@ -10093,7 +9072,7 @@
     </p:spTree>
     <p:extLst>
       <p:ext uri="{BB962C8B-B14F-4D97-AF65-F5344CB8AC3E}">
-        <p14:creationId xmlns:p14="http://schemas.microsoft.com/office/powerpoint/2010/main" val="1528600922"/>
+        <p14:creationId xmlns:p14="http://schemas.microsoft.com/office/powerpoint/2010/main" val="2004647577"/>
       </p:ext>
     </p:extLst>
   </p:cSld>
@@ -10124,7 +9103,7 @@
           <p:cNvPr id="9" name="">
             <a:extLst xmlns:a="http://schemas.openxmlformats.org/drawingml/2006/main">
               <a:ext uri="{FF2B5EF4-FFF2-40B4-BE49-F238E27FC236}">
-                <a16:creationId xmlns:a16="http://schemas.microsoft.com/office/drawing/2014/main" id="{5DF5D210-C04A-45D1-A4AA-45D8A764DC74}"/>
+                <a16:creationId xmlns:a16="http://schemas.microsoft.com/office/drawing/2014/main" id="{326D6C0B-3424-4847-B5B0-3A43647A9B27}"/>
               </a:ext>
             </a:extLst>
           </p:cNvPr>
@@ -10174,7 +9153,7 @@
           <p:cNvPr id="2" name="">
             <a:extLst xmlns:a="http://schemas.openxmlformats.org/drawingml/2006/main">
               <a:ext uri="{FF2B5EF4-FFF2-40B4-BE49-F238E27FC236}">
-                <a16:creationId xmlns:a16="http://schemas.microsoft.com/office/drawing/2014/main" id="{FE4FFDE3-75E1-46D0-833B-0E3869F3D7C3}"/>
+                <a16:creationId xmlns:a16="http://schemas.microsoft.com/office/drawing/2014/main" id="{44159568-B40A-4C56-ACFE-7D4F3F18014E}"/>
               </a:ext>
             </a:extLst>
           </p:cNvPr>
@@ -10228,7 +9207,7 @@
           <p:nvPr/>
         </p:nvPicPr>
         <p:blipFill>
-          <a:blip xmlns:r="http://schemas.openxmlformats.org/officeDocument/2006/relationships" xmlns:a="http://schemas.openxmlformats.org/drawingml/2006/main" r:embed="R83551dee1ca24116"/>
+          <a:blip xmlns:r="http://schemas.openxmlformats.org/officeDocument/2006/relationships" xmlns:a="http://schemas.openxmlformats.org/drawingml/2006/main" r:embed="R41f096c445f74206"/>
           <a:stretch xmlns:a="http://schemas.openxmlformats.org/drawingml/2006/main"/>
         </p:blipFill>
         <p:spPr>
@@ -10246,7 +9225,7 @@
           <p:cNvPr id="4" name="">
             <a:extLst xmlns:a="http://schemas.openxmlformats.org/drawingml/2006/main">
               <a:ext uri="{FF2B5EF4-FFF2-40B4-BE49-F238E27FC236}">
-                <a16:creationId xmlns:a16="http://schemas.microsoft.com/office/drawing/2014/main" id="{4FCF7857-70C1-4435-A928-1B258A0FACE1}"/>
+                <a16:creationId xmlns:a16="http://schemas.microsoft.com/office/drawing/2014/main" id="{18484F47-FB31-45C5-9D1F-8A936800544B}"/>
               </a:ext>
             </a:extLst>
           </p:cNvPr>
@@ -10296,7 +9275,7 @@
           <p:cNvPr id="5" name="">
             <a:extLst xmlns:a="http://schemas.openxmlformats.org/drawingml/2006/main">
               <a:ext uri="{FF2B5EF4-FFF2-40B4-BE49-F238E27FC236}">
-                <a16:creationId xmlns:a16="http://schemas.microsoft.com/office/drawing/2014/main" id="{D41D5194-78B9-49F7-A082-7971DF82B795}"/>
+                <a16:creationId xmlns:a16="http://schemas.microsoft.com/office/drawing/2014/main" id="{88E88A13-E27C-4A29-BB81-5EB038DD2ED5}"/>
               </a:ext>
             </a:extLst>
           </p:cNvPr>
@@ -10346,7 +9325,7 @@
           <p:cNvPr id="6" name="">
             <a:extLst xmlns:a="http://schemas.openxmlformats.org/drawingml/2006/main">
               <a:ext uri="{FF2B5EF4-FFF2-40B4-BE49-F238E27FC236}">
-                <a16:creationId xmlns:a16="http://schemas.microsoft.com/office/drawing/2014/main" id="{DF79C20E-972E-4653-8879-34F973531F4E}"/>
+                <a16:creationId xmlns:a16="http://schemas.microsoft.com/office/drawing/2014/main" id="{044F57E4-038E-498F-8B9C-748C4C0CEA24}"/>
               </a:ext>
             </a:extLst>
           </p:cNvPr>
@@ -10396,7 +9375,7 @@
           <p:cNvPr id="7" name="">
             <a:extLst xmlns:a="http://schemas.openxmlformats.org/drawingml/2006/main">
               <a:ext uri="{FF2B5EF4-FFF2-40B4-BE49-F238E27FC236}">
-                <a16:creationId xmlns:a16="http://schemas.microsoft.com/office/drawing/2014/main" id="{6ED84EEA-141E-4C1B-ABF4-4594CB70F98C}"/>
+                <a16:creationId xmlns:a16="http://schemas.microsoft.com/office/drawing/2014/main" id="{62112945-5444-4047-BEF0-AE3A334A7EB2}"/>
               </a:ext>
             </a:extLst>
           </p:cNvPr>
@@ -10446,7 +9425,7 @@
           <p:cNvPr id="8" name="">
             <a:extLst xmlns:a="http://schemas.openxmlformats.org/drawingml/2006/main">
               <a:ext uri="{FF2B5EF4-FFF2-40B4-BE49-F238E27FC236}">
-                <a16:creationId xmlns:a16="http://schemas.microsoft.com/office/drawing/2014/main" id="{FBA3D3DB-73F5-4D97-9477-CD7B8666EC2D}"/>
+                <a16:creationId xmlns:a16="http://schemas.microsoft.com/office/drawing/2014/main" id="{50DC2D51-0D07-4781-B20A-5496E6D21953}"/>
               </a:ext>
             </a:extLst>
           </p:cNvPr>
@@ -10494,7 +9473,7 @@
     </p:spTree>
     <p:extLst>
       <p:ext uri="{BB962C8B-B14F-4D97-AF65-F5344CB8AC3E}">
-        <p14:creationId xmlns:p14="http://schemas.microsoft.com/office/powerpoint/2010/main" val="1106869428"/>
+        <p14:creationId xmlns:p14="http://schemas.microsoft.com/office/powerpoint/2010/main" val="489482019"/>
       </p:ext>
     </p:extLst>
   </p:cSld>
@@ -10525,7 +9504,7 @@
           <p:cNvPr id="7" name="">
             <a:extLst xmlns:a="http://schemas.openxmlformats.org/drawingml/2006/main">
               <a:ext uri="{FF2B5EF4-FFF2-40B4-BE49-F238E27FC236}">
-                <a16:creationId xmlns:a16="http://schemas.microsoft.com/office/drawing/2014/main" id="{CDBEF49C-69B0-4F0E-951C-27ECBDB7FE28}"/>
+                <a16:creationId xmlns:a16="http://schemas.microsoft.com/office/drawing/2014/main" id="{5CB119E4-6D86-40F2-A3C1-E58EFD9478B4}"/>
               </a:ext>
             </a:extLst>
           </p:cNvPr>
@@ -10575,7 +9554,7 @@
           <p:cNvPr id="2" name="">
             <a:extLst xmlns:a="http://schemas.openxmlformats.org/drawingml/2006/main">
               <a:ext uri="{FF2B5EF4-FFF2-40B4-BE49-F238E27FC236}">
-                <a16:creationId xmlns:a16="http://schemas.microsoft.com/office/drawing/2014/main" id="{F48DE9FB-5859-4DE0-AC11-C626FF7B7073}"/>
+                <a16:creationId xmlns:a16="http://schemas.microsoft.com/office/drawing/2014/main" id="{61E7D273-34CF-4C08-8FA8-45201B7F7EDD}"/>
               </a:ext>
             </a:extLst>
           </p:cNvPr>
@@ -10629,7 +9608,7 @@
           <p:nvPr/>
         </p:nvPicPr>
         <p:blipFill>
-          <a:blip xmlns:r="http://schemas.openxmlformats.org/officeDocument/2006/relationships" xmlns:a="http://schemas.openxmlformats.org/drawingml/2006/main" r:embed="R12ea939e569f430e"/>
+          <a:blip xmlns:r="http://schemas.openxmlformats.org/officeDocument/2006/relationships" xmlns:a="http://schemas.openxmlformats.org/drawingml/2006/main" r:embed="R07ce41db95e24293"/>
           <a:stretch xmlns:a="http://schemas.openxmlformats.org/drawingml/2006/main"/>
         </p:blipFill>
         <p:spPr>
@@ -10647,7 +9626,7 @@
           <p:cNvPr id="4" name="">
             <a:extLst xmlns:a="http://schemas.openxmlformats.org/drawingml/2006/main">
               <a:ext uri="{FF2B5EF4-FFF2-40B4-BE49-F238E27FC236}">
-                <a16:creationId xmlns:a16="http://schemas.microsoft.com/office/drawing/2014/main" id="{F9361A23-936D-4741-9FCB-14880B88186F}"/>
+                <a16:creationId xmlns:a16="http://schemas.microsoft.com/office/drawing/2014/main" id="{DAB5A899-D014-4DF6-ABAC-BF0EF10BCD2B}"/>
               </a:ext>
             </a:extLst>
           </p:cNvPr>
@@ -10697,7 +9676,7 @@
           <p:cNvPr id="5" name="">
             <a:extLst xmlns:a="http://schemas.openxmlformats.org/drawingml/2006/main">
               <a:ext uri="{FF2B5EF4-FFF2-40B4-BE49-F238E27FC236}">
-                <a16:creationId xmlns:a16="http://schemas.microsoft.com/office/drawing/2014/main" id="{C6547F55-D01C-4F76-8864-D776F41855EE}"/>
+                <a16:creationId xmlns:a16="http://schemas.microsoft.com/office/drawing/2014/main" id="{147F55FA-BA0B-4F73-87FC-3E09630F81EA}"/>
               </a:ext>
             </a:extLst>
           </p:cNvPr>
@@ -10747,7 +9726,7 @@
           <p:cNvPr id="6" name="">
             <a:extLst xmlns:a="http://schemas.openxmlformats.org/drawingml/2006/main">
               <a:ext uri="{FF2B5EF4-FFF2-40B4-BE49-F238E27FC236}">
-                <a16:creationId xmlns:a16="http://schemas.microsoft.com/office/drawing/2014/main" id="{9F4613CE-FDCF-4F2D-9FD0-28DC6C1321DC}"/>
+                <a16:creationId xmlns:a16="http://schemas.microsoft.com/office/drawing/2014/main" id="{9AC1B0B1-A822-4C89-A1EE-93F2D1ACE404}"/>
               </a:ext>
             </a:extLst>
           </p:cNvPr>
@@ -10795,7 +9774,7 @@
     </p:spTree>
     <p:extLst>
       <p:ext uri="{BB962C8B-B14F-4D97-AF65-F5344CB8AC3E}">
-        <p14:creationId xmlns:p14="http://schemas.microsoft.com/office/powerpoint/2010/main" val="914692184"/>
+        <p14:creationId xmlns:p14="http://schemas.microsoft.com/office/powerpoint/2010/main" val="1083802453"/>
       </p:ext>
     </p:extLst>
   </p:cSld>

</xml_diff>